<commit_message>
pips 2.1.1: Owner info
</commit_message>
<xml_diff>
--- a/apps/pips/web/download/Pips-Guide.pptx
+++ b/apps/pips/web/download/Pips-Guide.pptx
@@ -3290,7 +3290,7 @@
                 </a:solidFill>
                 <a:latin typeface="Segoe UI"/>
               </a:rPr>
-              <a:t>Version 2.1.0  ·  2026-10-28</a:t>
+              <a:t>Version 2.1.1  ·  2026-10-28  ·  Owner: Juwen Lie</a:t>
             </a:r>
           </a:p>
           <a:p>
@@ -6871,7 +6871,7 @@
                 </a:solidFill>
                 <a:latin typeface="Segoe UI"/>
               </a:rPr>
-              <a:t>What's new in 2.1.0</a:t>
+              <a:t>What's new in 2.1.1</a:t>
             </a:r>
           </a:p>
         </p:txBody>
@@ -6984,7 +6984,7 @@
                 </a:solidFill>
                 <a:latin typeface="Segoe UI"/>
               </a:rPr>
-              <a:t>Interactive guide &amp; in-app updates  ·  2026-10-28</a:t>
+              <a:t>Owner info  ·  2026-10-28</a:t>
             </a:r>
           </a:p>
         </p:txBody>
@@ -7032,82 +7032,7 @@
                 </a:solidFill>
                 <a:latin typeface="Segoe UI"/>
               </a:rPr>
-              <a:t>Interactive first-run guide: your pet walks you through clicking, dragging, petting and the right-click menu</a:t>
-            </a:r>
-          </a:p>
-          <a:p>
-            <a:pPr>
-              <a:spcAft>
-                <a:spcPts val="1000"/>
-              </a:spcAft>
-            </a:pPr>
-            <a:r>
-              <a:rPr sz="1700" b="1">
-                <a:solidFill>
-                  <a:srgbClr val="4CB86B"/>
-                </a:solidFill>
-                <a:latin typeface="Segoe UI"/>
-              </a:rPr>
-              <a:t>•  </a:t>
-            </a:r>
-            <a:r>
-              <a:rPr sz="1700">
-                <a:solidFill>
-                  <a:srgbClr val="2B2A28"/>
-                </a:solidFill>
-                <a:latin typeface="Segoe UI"/>
-              </a:rPr>
-              <a:t>In-app updates: Pips tells you when a new version is out - update with one click (your settings and data are kept)</a:t>
-            </a:r>
-          </a:p>
-          <a:p>
-            <a:pPr>
-              <a:spcAft>
-                <a:spcPts val="1000"/>
-              </a:spcAft>
-            </a:pPr>
-            <a:r>
-              <a:rPr sz="1700" b="1">
-                <a:solidFill>
-                  <a:srgbClr val="4CB86B"/>
-                </a:solidFill>
-                <a:latin typeface="Segoe UI"/>
-              </a:rPr>
-              <a:t>•  </a:t>
-            </a:r>
-            <a:r>
-              <a:rPr sz="1700">
-                <a:solidFill>
-                  <a:srgbClr val="2B2A28"/>
-                </a:solidFill>
-                <a:latin typeface="Segoe UI"/>
-              </a:rPr>
-              <a:t>New Help menu: replay the guide, check for updates, see the version</a:t>
-            </a:r>
-          </a:p>
-          <a:p>
-            <a:pPr>
-              <a:spcAft>
-                <a:spcPts val="1000"/>
-              </a:spcAft>
-            </a:pPr>
-            <a:r>
-              <a:rPr sz="1700" b="1">
-                <a:solidFill>
-                  <a:srgbClr val="4CB86B"/>
-                </a:solidFill>
-                <a:latin typeface="Segoe UI"/>
-              </a:rPr>
-              <a:t>•  </a:t>
-            </a:r>
-            <a:r>
-              <a:rPr sz="1700">
-                <a:solidFill>
-                  <a:srgbClr val="2B2A28"/>
-                </a:solidFill>
-                <a:latin typeface="Segoe UI"/>
-              </a:rPr>
-              <a:t>Option to turn automatic update checks off</a:t>
+              <a:t>About Pips now shows the owner: Juwen Lie (right-click the pet → Help → About)</a:t>
             </a:r>
           </a:p>
         </p:txBody>
@@ -7238,82 +7163,7 @@
                 </a:solidFill>
                 <a:latin typeface="Segoe UI"/>
               </a:rPr>
-              <a:t>Panduan interaktif saat pertama dipakai: peliharaanmu mengajarimu klik, seret, elus, dan menu klik kanan</a:t>
-            </a:r>
-          </a:p>
-          <a:p>
-            <a:pPr>
-              <a:spcAft>
-                <a:spcPts val="500"/>
-              </a:spcAft>
-            </a:pPr>
-            <a:r>
-              <a:rPr sz="1200" b="1">
-                <a:solidFill>
-                  <a:srgbClr val="4CB86B"/>
-                </a:solidFill>
-                <a:latin typeface="Segoe UI"/>
-              </a:rPr>
-              <a:t>•  </a:t>
-            </a:r>
-            <a:r>
-              <a:rPr sz="1200">
-                <a:solidFill>
-                  <a:srgbClr val="2B2A28"/>
-                </a:solidFill>
-                <a:latin typeface="Segoe UI"/>
-              </a:rPr>
-              <a:t>Update di dalam aplikasi: Pips memberi tahu saat ada versi baru - update dengan satu klik (pengaturan dan data tetap aman)</a:t>
-            </a:r>
-          </a:p>
-          <a:p>
-            <a:pPr>
-              <a:spcAft>
-                <a:spcPts val="500"/>
-              </a:spcAft>
-            </a:pPr>
-            <a:r>
-              <a:rPr sz="1200" b="1">
-                <a:solidFill>
-                  <a:srgbClr val="4CB86B"/>
-                </a:solidFill>
-                <a:latin typeface="Segoe UI"/>
-              </a:rPr>
-              <a:t>•  </a:t>
-            </a:r>
-            <a:r>
-              <a:rPr sz="1200">
-                <a:solidFill>
-                  <a:srgbClr val="2B2A28"/>
-                </a:solidFill>
-                <a:latin typeface="Segoe UI"/>
-              </a:rPr>
-              <a:t>Menu Bantuan baru: putar ulang panduan, cek update, lihat versi</a:t>
-            </a:r>
-          </a:p>
-          <a:p>
-            <a:pPr>
-              <a:spcAft>
-                <a:spcPts val="500"/>
-              </a:spcAft>
-            </a:pPr>
-            <a:r>
-              <a:rPr sz="1200" b="1">
-                <a:solidFill>
-                  <a:srgbClr val="4CB86B"/>
-                </a:solidFill>
-                <a:latin typeface="Segoe UI"/>
-              </a:rPr>
-              <a:t>•  </a:t>
-            </a:r>
-            <a:r>
-              <a:rPr sz="1200">
-                <a:solidFill>
-                  <a:srgbClr val="2B2A28"/>
-                </a:solidFill>
-                <a:latin typeface="Segoe UI"/>
-              </a:rPr>
-              <a:t>Pilihan untuk mematikan cek update otomatis</a:t>
+              <a:t>Tentang Pips sekarang menampilkan pemilik: Juwen Lie (klik kanan peliharaan → Bantuan → Tentang)</a:t>
             </a:r>
           </a:p>
         </p:txBody>
@@ -7545,7 +7395,7 @@
         </p:nvGraphicFramePr>
         <p:xfrm>
           <a:off x="548640" y="1645920"/>
-          <a:ext cx="11155680" cy="3675888"/>
+          <a:ext cx="11155680" cy="4498848"/>
         </p:xfrm>
         <a:graphic>
           <a:graphicData uri="http://schemas.openxmlformats.org/drawingml/2006/table">
@@ -7639,7 +7489,7 @@
                           </a:solidFill>
                           <a:latin typeface="Segoe UI"/>
                         </a:rPr>
-                        <a:t>2.1.0</a:t>
+                        <a:t>2.1.1</a:t>
                       </a:r>
                     </a:p>
                   </a:txBody>
@@ -7683,7 +7533,7 @@
                           </a:solidFill>
                           <a:latin typeface="Segoe UI"/>
                         </a:rPr>
-                        <a:t>Interactive guide &amp; in-app updates</a:t>
+                        <a:t>Owner info</a:t>
                       </a:r>
                     </a:p>
                     <a:p>
@@ -7694,7 +7544,7 @@
                           </a:solidFill>
                           <a:latin typeface="Segoe UI"/>
                         </a:rPr>
-                        <a:t>Interactive first-run guide: your pet walks you through clicking, dragging, petting and the right-click menu; In-app updates: Pips tells you when a new version is out - update with one click (your settings and data are kept); New Help menu: replay the guide, check for updates, see the version; Option to turn automatic update checks off</a:t>
+                        <a:t>About Pips now shows the owner: Juwen Lie (right-click the pet → Help → About)</a:t>
                       </a:r>
                     </a:p>
                   </a:txBody>
@@ -7718,7 +7568,7 @@
                           </a:solidFill>
                           <a:latin typeface="Segoe UI"/>
                         </a:rPr>
-                        <a:t>2.0.0</a:t>
+                        <a:t>2.1.0</a:t>
                       </a:r>
                     </a:p>
                   </a:txBody>
@@ -7762,7 +7612,7 @@
                           </a:solidFill>
                           <a:latin typeface="Segoe UI"/>
                         </a:rPr>
-                        <a:t>Desktop pet, 23 animals &amp; 4 languages</a:t>
+                        <a:t>Interactive guide &amp; in-app updates</a:t>
                       </a:r>
                     </a:p>
                     <a:p>
@@ -7773,7 +7623,7 @@
                           </a:solidFill>
                           <a:latin typeface="Segoe UI"/>
                         </a:rPr>
-                        <a:t>Desktop pet that lives on your desktop and taskbar - drag it, tickle it, pet it; 23 animals in 3 groups: Land walks, Water swims with bubbles, Sky hovers and flaps; Moods (happy, sad, tired, hungry, grumpy...), naps when you're away, wakes up when you're back; Cute chat-bubble reminders: breaks, water, 20-20-20 eye rest, pomodoro done, daily goal</a:t>
+                        <a:t>Interactive first-run guide: your pet walks you through clicking, dragging, petting and the right-click menu; In-app updates: Pips tells you when a new version is out - update with one click (your settings and data are kept); New Help menu: replay the guide, check for updates, see the version; Option to turn automatic update checks off</a:t>
                       </a:r>
                     </a:p>
                   </a:txBody>
@@ -7797,7 +7647,7 @@
                           </a:solidFill>
                           <a:latin typeface="Segoe UI"/>
                         </a:rPr>
-                        <a:t>1.5.0</a:t>
+                        <a:t>2.0.0</a:t>
                       </a:r>
                     </a:p>
                   </a:txBody>
@@ -7819,13 +7669,92 @@
                           </a:solidFill>
                           <a:latin typeface="Segoe UI"/>
                         </a:rPr>
+                        <a:t>2026-10-28</a:t>
+                      </a:r>
+                    </a:p>
+                  </a:txBody>
+                  <a:tcPr marL="73152" marR="73152" marT="36576" marB="36576">
+                    <a:solidFill>
+                      <a:srgbClr val="FFFDF8"/>
+                    </a:solidFill>
+                  </a:tcPr>
+                </a:tc>
+                <a:tc>
+                  <a:txBody>
+                    <a:bodyPr wrap="square"/>
+                    <a:lstStyle/>
+                    <a:p>
+                      <a:r>
+                        <a:rPr sz="1200" b="0">
+                          <a:solidFill>
+                            <a:srgbClr val="2B2A28"/>
+                          </a:solidFill>
+                          <a:latin typeface="Segoe UI"/>
+                        </a:rPr>
+                        <a:t>Desktop pet, 23 animals &amp; 4 languages</a:t>
+                      </a:r>
+                    </a:p>
+                    <a:p>
+                      <a:r>
+                        <a:rPr sz="1200" b="0">
+                          <a:solidFill>
+                            <a:srgbClr val="2B2A28"/>
+                          </a:solidFill>
+                          <a:latin typeface="Segoe UI"/>
+                        </a:rPr>
+                        <a:t>Desktop pet that lives on your desktop and taskbar - drag it, tickle it, pet it; 23 animals in 3 groups: Land walks, Water swims with bubbles, Sky hovers and flaps; Moods (happy, sad, tired, hungry, grumpy...), naps when you're away, wakes up when you're back; Cute chat-bubble reminders: breaks, water, 20-20-20 eye rest, pomodoro done, daily goal</a:t>
+                      </a:r>
+                    </a:p>
+                  </a:txBody>
+                  <a:tcPr marL="73152" marR="73152" marT="36576" marB="36576">
+                    <a:solidFill>
+                      <a:srgbClr val="FFFDF8"/>
+                    </a:solidFill>
+                  </a:tcPr>
+                </a:tc>
+              </a:tr>
+              <a:tr h="822960">
+                <a:tc>
+                  <a:txBody>
+                    <a:bodyPr wrap="square"/>
+                    <a:lstStyle/>
+                    <a:p>
+                      <a:r>
+                        <a:rPr sz="1200" b="1">
+                          <a:solidFill>
+                            <a:srgbClr val="2B2A28"/>
+                          </a:solidFill>
+                          <a:latin typeface="Segoe UI"/>
+                        </a:rPr>
+                        <a:t>1.5.0</a:t>
+                      </a:r>
+                    </a:p>
+                  </a:txBody>
+                  <a:tcPr marL="73152" marR="73152" marT="36576" marB="36576">
+                    <a:solidFill>
+                      <a:srgbClr val="F7F4EC"/>
+                    </a:solidFill>
+                  </a:tcPr>
+                </a:tc>
+                <a:tc>
+                  <a:txBody>
+                    <a:bodyPr wrap="square"/>
+                    <a:lstStyle/>
+                    <a:p>
+                      <a:r>
+                        <a:rPr sz="1200" b="0">
+                          <a:solidFill>
+                            <a:srgbClr val="2B2A28"/>
+                          </a:solidFill>
+                          <a:latin typeface="Segoe UI"/>
+                        </a:rPr>
                         <a:t>2026-10-24</a:t>
                       </a:r>
                     </a:p>
                   </a:txBody>
                   <a:tcPr marL="73152" marR="73152" marT="36576" marB="36576">
                     <a:solidFill>
-                      <a:srgbClr val="FFFDF8"/>
+                      <a:srgbClr val="F7F4EC"/>
                     </a:solidFill>
                   </a:tcPr>
                 </a:tc>
@@ -7858,7 +7787,7 @@
                   </a:txBody>
                   <a:tcPr marL="73152" marR="73152" marT="36576" marB="36576">
                     <a:solidFill>
-                      <a:srgbClr val="FFFDF8"/>
+                      <a:srgbClr val="F7F4EC"/>
                     </a:solidFill>
                   </a:tcPr>
                 </a:tc>
@@ -7882,7 +7811,7 @@
                   </a:txBody>
                   <a:tcPr marL="73152" marR="73152" marT="36576" marB="36576">
                     <a:solidFill>
-                      <a:srgbClr val="F7F4EC"/>
+                      <a:srgbClr val="FFFDF8"/>
                     </a:solidFill>
                   </a:tcPr>
                 </a:tc>
@@ -7904,7 +7833,7 @@
                   </a:txBody>
                   <a:tcPr marL="73152" marR="73152" marT="36576" marB="36576">
                     <a:solidFill>
-                      <a:srgbClr val="F7F4EC"/>
+                      <a:srgbClr val="FFFDF8"/>
                     </a:solidFill>
                   </a:tcPr>
                 </a:tc>
@@ -7937,7 +7866,7 @@
                   </a:txBody>
                   <a:tcPr marL="73152" marR="73152" marT="36576" marB="36576">
                     <a:solidFill>
-                      <a:srgbClr val="F7F4EC"/>
+                      <a:srgbClr val="FFFDF8"/>
                     </a:solidFill>
                   </a:tcPr>
                 </a:tc>
@@ -8028,6 +7957,18 @@
             <a:spAutoFit/>
           </a:bodyPr>
           <a:lstStyle/>
+          <a:p>
+            <a:pPr algn="ctr"/>
+            <a:r>
+              <a:rPr sz="1800" b="0">
+                <a:solidFill>
+                  <a:srgbClr val="6E6A62"/>
+                </a:solidFill>
+                <a:latin typeface="Segoe UI"/>
+              </a:rPr>
+              <a:t>Pips is made and owned by Juwen Lie</a:t>
+            </a:r>
+          </a:p>
           <a:p>
             <a:pPr algn="ctr"/>
             <a:r>

</xml_diff>

<commit_message>
pips 2.1.2: Tickle-only mode
</commit_message>
<xml_diff>
--- a/apps/pips/web/download/Pips-Guide.pptx
+++ b/apps/pips/web/download/Pips-Guide.pptx
@@ -3290,7 +3290,7 @@
                 </a:solidFill>
                 <a:latin typeface="Segoe UI"/>
               </a:rPr>
-              <a:t>Version 2.1.1  ·  2026-10-28  ·  Owner: Juwen Lie</a:t>
+              <a:t>Version 2.1.2  ·  2026-10-28  ·  Owner: Juwen Lie</a:t>
             </a:r>
           </a:p>
           <a:p>
@@ -4599,7 +4599,7 @@
                 </a:solidFill>
                 <a:latin typeface="Segoe UI"/>
               </a:rPr>
-              <a:t>Click action (open card / just tickle)</a:t>
+              <a:t>Click action: open card · tickle (double-click opens) · only tickle</a:t>
             </a:r>
           </a:p>
           <a:p>
@@ -6871,7 +6871,7 @@
                 </a:solidFill>
                 <a:latin typeface="Segoe UI"/>
               </a:rPr>
-              <a:t>What's new in 2.1.1</a:t>
+              <a:t>What's new in 2.1.2</a:t>
             </a:r>
           </a:p>
         </p:txBody>
@@ -6984,7 +6984,7 @@
                 </a:solidFill>
                 <a:latin typeface="Segoe UI"/>
               </a:rPr>
-              <a:t>Owner info  ·  2026-10-28</a:t>
+              <a:t>Tickle-only mode  ·  2026-10-28</a:t>
             </a:r>
           </a:p>
         </p:txBody>
@@ -7032,7 +7032,7 @@
                 </a:solidFill>
                 <a:latin typeface="Segoe UI"/>
               </a:rPr>
-              <a:t>About Pips now shows the owner: Juwen Lie (right-click the pet → Help → About)</a:t>
+              <a:t>New click option "Only tickle (never open Pips)": click and tickle your pet as much as you like - the Pomodoro window stays closed (open it from the right-click menu). Right-click the pet → When I click</a:t>
             </a:r>
           </a:p>
         </p:txBody>
@@ -7163,7 +7163,7 @@
                 </a:solidFill>
                 <a:latin typeface="Segoe UI"/>
               </a:rPr>
-              <a:t>Tentang Pips sekarang menampilkan pemilik: Juwen Lie (klik kanan peliharaan → Bantuan → Tentang)</a:t>
+              <a:t>Opsi klik baru "Hanya gelitik (tidak membuka Pips)": klik dan gelitik peliharaanmu sepuasnya - jendela Pomodoro tetap tertutup (buka lewat menu klik kanan). Klik kanan peliharaan → Saat aku diklik</a:t>
             </a:r>
           </a:p>
         </p:txBody>
@@ -7395,7 +7395,7 @@
         </p:nvGraphicFramePr>
         <p:xfrm>
           <a:off x="548640" y="1645920"/>
-          <a:ext cx="11155680" cy="4498848"/>
+          <a:ext cx="11155680" cy="5321808"/>
         </p:xfrm>
         <a:graphic>
           <a:graphicData uri="http://schemas.openxmlformats.org/drawingml/2006/table">
@@ -7489,7 +7489,7 @@
                           </a:solidFill>
                           <a:latin typeface="Segoe UI"/>
                         </a:rPr>
-                        <a:t>2.1.1</a:t>
+                        <a:t>2.1.2</a:t>
                       </a:r>
                     </a:p>
                   </a:txBody>
@@ -7533,7 +7533,7 @@
                           </a:solidFill>
                           <a:latin typeface="Segoe UI"/>
                         </a:rPr>
-                        <a:t>Owner info</a:t>
+                        <a:t>Tickle-only mode</a:t>
                       </a:r>
                     </a:p>
                     <a:p>
@@ -7544,7 +7544,7 @@
                           </a:solidFill>
                           <a:latin typeface="Segoe UI"/>
                         </a:rPr>
-                        <a:t>About Pips now shows the owner: Juwen Lie (right-click the pet → Help → About)</a:t>
+                        <a:t>New click option "Only tickle (never open Pips)": click and tickle your pet as much as you like - the Pomodoro window stays closed (open it from the right-click menu). Right-click the pet → When I click</a:t>
                       </a:r>
                     </a:p>
                   </a:txBody>
@@ -7568,7 +7568,7 @@
                           </a:solidFill>
                           <a:latin typeface="Segoe UI"/>
                         </a:rPr>
-                        <a:t>2.1.0</a:t>
+                        <a:t>2.1.1</a:t>
                       </a:r>
                     </a:p>
                   </a:txBody>
@@ -7612,7 +7612,7 @@
                           </a:solidFill>
                           <a:latin typeface="Segoe UI"/>
                         </a:rPr>
-                        <a:t>Interactive guide &amp; in-app updates</a:t>
+                        <a:t>Owner info</a:t>
                       </a:r>
                     </a:p>
                     <a:p>
@@ -7623,7 +7623,7 @@
                           </a:solidFill>
                           <a:latin typeface="Segoe UI"/>
                         </a:rPr>
-                        <a:t>Interactive first-run guide: your pet walks you through clicking, dragging, petting and the right-click menu; In-app updates: Pips tells you when a new version is out - update with one click (your settings and data are kept); New Help menu: replay the guide, check for updates, see the version; Option to turn automatic update checks off</a:t>
+                        <a:t>About Pips now shows the owner: Juwen Lie (right-click the pet → Help → About)</a:t>
                       </a:r>
                     </a:p>
                   </a:txBody>
@@ -7647,7 +7647,7 @@
                           </a:solidFill>
                           <a:latin typeface="Segoe UI"/>
                         </a:rPr>
-                        <a:t>2.0.0</a:t>
+                        <a:t>2.1.0</a:t>
                       </a:r>
                     </a:p>
                   </a:txBody>
@@ -7691,7 +7691,7 @@
                           </a:solidFill>
                           <a:latin typeface="Segoe UI"/>
                         </a:rPr>
-                        <a:t>Desktop pet, 23 animals &amp; 4 languages</a:t>
+                        <a:t>Interactive guide &amp; in-app updates</a:t>
                       </a:r>
                     </a:p>
                     <a:p>
@@ -7702,7 +7702,7 @@
                           </a:solidFill>
                           <a:latin typeface="Segoe UI"/>
                         </a:rPr>
-                        <a:t>Desktop pet that lives on your desktop and taskbar - drag it, tickle it, pet it; 23 animals in 3 groups: Land walks, Water swims with bubbles, Sky hovers and flaps; Moods (happy, sad, tired, hungry, grumpy...), naps when you're away, wakes up when you're back; Cute chat-bubble reminders: breaks, water, 20-20-20 eye rest, pomodoro done, daily goal</a:t>
+                        <a:t>Interactive first-run guide: your pet walks you through clicking, dragging, petting and the right-click menu; In-app updates: Pips tells you when a new version is out - update with one click (your settings and data are kept); New Help menu: replay the guide, check for updates, see the version; Option to turn automatic update checks off</a:t>
                       </a:r>
                     </a:p>
                   </a:txBody>
@@ -7726,7 +7726,7 @@
                           </a:solidFill>
                           <a:latin typeface="Segoe UI"/>
                         </a:rPr>
-                        <a:t>1.5.0</a:t>
+                        <a:t>2.0.0</a:t>
                       </a:r>
                     </a:p>
                   </a:txBody>
@@ -7748,13 +7748,92 @@
                           </a:solidFill>
                           <a:latin typeface="Segoe UI"/>
                         </a:rPr>
+                        <a:t>2026-10-28</a:t>
+                      </a:r>
+                    </a:p>
+                  </a:txBody>
+                  <a:tcPr marL="73152" marR="73152" marT="36576" marB="36576">
+                    <a:solidFill>
+                      <a:srgbClr val="F7F4EC"/>
+                    </a:solidFill>
+                  </a:tcPr>
+                </a:tc>
+                <a:tc>
+                  <a:txBody>
+                    <a:bodyPr wrap="square"/>
+                    <a:lstStyle/>
+                    <a:p>
+                      <a:r>
+                        <a:rPr sz="1200" b="0">
+                          <a:solidFill>
+                            <a:srgbClr val="2B2A28"/>
+                          </a:solidFill>
+                          <a:latin typeface="Segoe UI"/>
+                        </a:rPr>
+                        <a:t>Desktop pet, 23 animals &amp; 4 languages</a:t>
+                      </a:r>
+                    </a:p>
+                    <a:p>
+                      <a:r>
+                        <a:rPr sz="1200" b="0">
+                          <a:solidFill>
+                            <a:srgbClr val="2B2A28"/>
+                          </a:solidFill>
+                          <a:latin typeface="Segoe UI"/>
+                        </a:rPr>
+                        <a:t>Desktop pet that lives on your desktop and taskbar - drag it, tickle it, pet it; 23 animals in 3 groups: Land walks, Water swims with bubbles, Sky hovers and flaps; Moods (happy, sad, tired, hungry, grumpy...), naps when you're away, wakes up when you're back; Cute chat-bubble reminders: breaks, water, 20-20-20 eye rest, pomodoro done, daily goal</a:t>
+                      </a:r>
+                    </a:p>
+                  </a:txBody>
+                  <a:tcPr marL="73152" marR="73152" marT="36576" marB="36576">
+                    <a:solidFill>
+                      <a:srgbClr val="F7F4EC"/>
+                    </a:solidFill>
+                  </a:tcPr>
+                </a:tc>
+              </a:tr>
+              <a:tr h="822960">
+                <a:tc>
+                  <a:txBody>
+                    <a:bodyPr wrap="square"/>
+                    <a:lstStyle/>
+                    <a:p>
+                      <a:r>
+                        <a:rPr sz="1200" b="1">
+                          <a:solidFill>
+                            <a:srgbClr val="2B2A28"/>
+                          </a:solidFill>
+                          <a:latin typeface="Segoe UI"/>
+                        </a:rPr>
+                        <a:t>1.5.0</a:t>
+                      </a:r>
+                    </a:p>
+                  </a:txBody>
+                  <a:tcPr marL="73152" marR="73152" marT="36576" marB="36576">
+                    <a:solidFill>
+                      <a:srgbClr val="FFFDF8"/>
+                    </a:solidFill>
+                  </a:tcPr>
+                </a:tc>
+                <a:tc>
+                  <a:txBody>
+                    <a:bodyPr wrap="square"/>
+                    <a:lstStyle/>
+                    <a:p>
+                      <a:r>
+                        <a:rPr sz="1200" b="0">
+                          <a:solidFill>
+                            <a:srgbClr val="2B2A28"/>
+                          </a:solidFill>
+                          <a:latin typeface="Segoe UI"/>
+                        </a:rPr>
                         <a:t>2026-10-24</a:t>
                       </a:r>
                     </a:p>
                   </a:txBody>
                   <a:tcPr marL="73152" marR="73152" marT="36576" marB="36576">
                     <a:solidFill>
-                      <a:srgbClr val="F7F4EC"/>
+                      <a:srgbClr val="FFFDF8"/>
                     </a:solidFill>
                   </a:tcPr>
                 </a:tc>
@@ -7787,7 +7866,7 @@
                   </a:txBody>
                   <a:tcPr marL="73152" marR="73152" marT="36576" marB="36576">
                     <a:solidFill>
-                      <a:srgbClr val="F7F4EC"/>
+                      <a:srgbClr val="FFFDF8"/>
                     </a:solidFill>
                   </a:tcPr>
                 </a:tc>
@@ -7811,7 +7890,7 @@
                   </a:txBody>
                   <a:tcPr marL="73152" marR="73152" marT="36576" marB="36576">
                     <a:solidFill>
-                      <a:srgbClr val="FFFDF8"/>
+                      <a:srgbClr val="F7F4EC"/>
                     </a:solidFill>
                   </a:tcPr>
                 </a:tc>
@@ -7833,7 +7912,7 @@
                   </a:txBody>
                   <a:tcPr marL="73152" marR="73152" marT="36576" marB="36576">
                     <a:solidFill>
-                      <a:srgbClr val="FFFDF8"/>
+                      <a:srgbClr val="F7F4EC"/>
                     </a:solidFill>
                   </a:tcPr>
                 </a:tc>
@@ -7866,7 +7945,7 @@
                   </a:txBody>
                   <a:tcPr marL="73152" marR="73152" marT="36576" marB="36576">
                     <a:solidFill>
-                      <a:srgbClr val="FFFDF8"/>
+                      <a:srgbClr val="F7F4EC"/>
                     </a:solidFill>
                   </a:tcPr>
                 </a:tc>
@@ -11651,7 +11730,7 @@
                 </a:solidFill>
                 <a:latin typeface="Segoe UI"/>
               </a:rPr>
-              <a:t>Tip: the click action can be changed in Pet status &amp; settings (e.g. click = just tickle).</a:t>
+              <a:t>Just want to tickle? Right-click → When I click → Only tickle (never open Pips).</a:t>
             </a:r>
           </a:p>
         </p:txBody>

</xml_diff>

<commit_message>
pips 2.2.0: Pet sounds
</commit_message>
<xml_diff>
--- a/apps/pips/web/download/Pips-Guide.pptx
+++ b/apps/pips/web/download/Pips-Guide.pptx
@@ -3290,7 +3290,7 @@
                 </a:solidFill>
                 <a:latin typeface="Segoe UI"/>
               </a:rPr>
-              <a:t>Version 2.1.2  ·  2026-10-28  ·  Owner: Juwen Lie</a:t>
+              <a:t>Version 2.2.0  ·  2026-10-28  ·  Owner: Juwen Lie</a:t>
             </a:r>
           </a:p>
           <a:p>
@@ -4580,7 +4580,7 @@
           <a:p>
             <a:pPr>
               <a:spcAft>
-                <a:spcPts val="400"/>
+                <a:spcPts val="300"/>
               </a:spcAft>
             </a:pPr>
             <a:r>
@@ -4605,7 +4605,7 @@
           <a:p>
             <a:pPr>
               <a:spcAft>
-                <a:spcPts val="400"/>
+                <a:spcPts val="300"/>
               </a:spcAft>
             </a:pPr>
             <a:r>
@@ -4630,7 +4630,7 @@
           <a:p>
             <a:pPr>
               <a:spcAft>
-                <a:spcPts val="400"/>
+                <a:spcPts val="300"/>
               </a:spcAft>
             </a:pPr>
             <a:r>
@@ -4655,7 +4655,7 @@
           <a:p>
             <a:pPr>
               <a:spcAft>
-                <a:spcPts val="400"/>
+                <a:spcPts val="300"/>
               </a:spcAft>
             </a:pPr>
             <a:r>
@@ -4680,7 +4680,7 @@
           <a:p>
             <a:pPr>
               <a:spcAft>
-                <a:spcPts val="400"/>
+                <a:spcPts val="300"/>
               </a:spcAft>
             </a:pPr>
             <a:r>
@@ -4705,7 +4705,7 @@
           <a:p>
             <a:pPr>
               <a:spcAft>
-                <a:spcPts val="400"/>
+                <a:spcPts val="300"/>
               </a:spcAft>
             </a:pPr>
             <a:r>
@@ -4730,7 +4730,7 @@
           <a:p>
             <a:pPr>
               <a:spcAft>
-                <a:spcPts val="400"/>
+                <a:spcPts val="300"/>
               </a:spcAft>
             </a:pPr>
             <a:r>
@@ -4755,7 +4755,7 @@
           <a:p>
             <a:pPr>
               <a:spcAft>
-                <a:spcPts val="400"/>
+                <a:spcPts val="300"/>
               </a:spcAft>
             </a:pPr>
             <a:r>
@@ -4780,7 +4780,7 @@
           <a:p>
             <a:pPr>
               <a:spcAft>
-                <a:spcPts val="400"/>
+                <a:spcPts val="300"/>
               </a:spcAft>
             </a:pPr>
             <a:r>
@@ -4800,6 +4800,31 @@
                 <a:latin typeface="Segoe UI"/>
               </a:rPr>
               <a:t>Check for updates automatically</a:t>
+            </a:r>
+          </a:p>
+          <a:p>
+            <a:pPr>
+              <a:spcAft>
+                <a:spcPts val="300"/>
+              </a:spcAft>
+            </a:pPr>
+            <a:r>
+              <a:rPr sz="1400" b="1">
+                <a:solidFill>
+                  <a:srgbClr val="4CB86B"/>
+                </a:solidFill>
+                <a:latin typeface="Segoe UI"/>
+              </a:rPr>
+              <a:t>•  </a:t>
+            </a:r>
+            <a:r>
+              <a:rPr sz="1400">
+                <a:solidFill>
+                  <a:srgbClr val="2B2A28"/>
+                </a:solidFill>
+                <a:latin typeface="Segoe UI"/>
+              </a:rPr>
+              <a:t>Animal sounds + volume (quiet while focusing)</a:t>
             </a:r>
           </a:p>
         </p:txBody>
@@ -6871,7 +6896,7 @@
                 </a:solidFill>
                 <a:latin typeface="Segoe UI"/>
               </a:rPr>
-              <a:t>What's new in 2.1.2</a:t>
+              <a:t>What's new in 2.2.0</a:t>
             </a:r>
           </a:p>
         </p:txBody>
@@ -6984,7 +7009,7 @@
                 </a:solidFill>
                 <a:latin typeface="Segoe UI"/>
               </a:rPr>
-              <a:t>Tickle-only mode  ·  2026-10-28</a:t>
+              <a:t>Pet sounds  ·  2026-10-28</a:t>
             </a:r>
           </a:p>
         </p:txBody>
@@ -7032,7 +7057,57 @@
                 </a:solidFill>
                 <a:latin typeface="Segoe UI"/>
               </a:rPr>
-              <a:t>New click option "Only tickle (never open Pips)": click and tickle your pet as much as you like - the Pomodoro window stays closed (open it from the right-click menu). Right-click the pet → When I click</a:t>
+              <a:t>Your pet has a voice! Each of the 23 animals has its own sound (meow, woof, ribbit, hoot, buzz, oink, whale song...) and it changes with its mood: happy chirps, sad whimpers, sleepy yawns, hungry calls, grumpy huffs and soft snores</a:t>
+            </a:r>
+          </a:p>
+          <a:p>
+            <a:pPr>
+              <a:spcAft>
+                <a:spcPts val="1000"/>
+              </a:spcAft>
+            </a:pPr>
+            <a:r>
+              <a:rPr sz="1700" b="1">
+                <a:solidFill>
+                  <a:srgbClr val="4CB86B"/>
+                </a:solidFill>
+                <a:latin typeface="Segoe UI"/>
+              </a:rPr>
+              <a:t>•  </a:t>
+            </a:r>
+            <a:r>
+              <a:rPr sz="1700">
+                <a:solidFill>
+                  <a:srgbClr val="2B2A28"/>
+                </a:solidFill>
+                <a:latin typeface="Segoe UI"/>
+              </a:rPr>
+              <a:t>It also reacts with sound when you tickle, pet, feed, shake or wake it</a:t>
+            </a:r>
+          </a:p>
+          <a:p>
+            <a:pPr>
+              <a:spcAft>
+                <a:spcPts val="1000"/>
+              </a:spcAft>
+            </a:pPr>
+            <a:r>
+              <a:rPr sz="1700" b="1">
+                <a:solidFill>
+                  <a:srgbClr val="4CB86B"/>
+                </a:solidFill>
+                <a:latin typeface="Segoe UI"/>
+              </a:rPr>
+              <a:t>•  </a:t>
+            </a:r>
+            <a:r>
+              <a:rPr sz="1700">
+                <a:solidFill>
+                  <a:srgbClr val="2B2A28"/>
+                </a:solidFill>
+                <a:latin typeface="Segoe UI"/>
+              </a:rPr>
+              <a:t>Settings: right-click the pet → Sounds to switch on/off; Pet status &amp; settings has a volume slider, a ▶ Hear me button and "Stay quiet while I'm focusing" (on by default)</a:t>
             </a:r>
           </a:p>
         </p:txBody>
@@ -7163,7 +7238,57 @@
                 </a:solidFill>
                 <a:latin typeface="Segoe UI"/>
               </a:rPr>
-              <a:t>Opsi klik baru "Hanya gelitik (tidak membuka Pips)": klik dan gelitik peliharaanmu sepuasnya - jendela Pomodoro tetap tertutup (buka lewat menu klik kanan). Klik kanan peliharaan → Saat aku diklik</a:t>
+              <a:t>Peliharaanmu sekarang bisa bersuara! Ke-23 hewan punya suara sendiri (meong, guk, kwek-kwek katak, hu-hu burung hantu, dengung lebah, oink, nyanyian paus...) dan berubah sesuai mood: ceria, sedih, menguap, lapar, ngambek, dan dengkur pelan</a:t>
+            </a:r>
+          </a:p>
+          <a:p>
+            <a:pPr>
+              <a:spcAft>
+                <a:spcPts val="500"/>
+              </a:spcAft>
+            </a:pPr>
+            <a:r>
+              <a:rPr sz="1200" b="1">
+                <a:solidFill>
+                  <a:srgbClr val="4CB86B"/>
+                </a:solidFill>
+                <a:latin typeface="Segoe UI"/>
+              </a:rPr>
+              <a:t>•  </a:t>
+            </a:r>
+            <a:r>
+              <a:rPr sz="1200">
+                <a:solidFill>
+                  <a:srgbClr val="2B2A28"/>
+                </a:solidFill>
+                <a:latin typeface="Segoe UI"/>
+              </a:rPr>
+              <a:t>Juga bersuara saat kamu gelitik, elus, beri makan, guncang, atau bangunkan</a:t>
+            </a:r>
+          </a:p>
+          <a:p>
+            <a:pPr>
+              <a:spcAft>
+                <a:spcPts val="500"/>
+              </a:spcAft>
+            </a:pPr>
+            <a:r>
+              <a:rPr sz="1200" b="1">
+                <a:solidFill>
+                  <a:srgbClr val="4CB86B"/>
+                </a:solidFill>
+                <a:latin typeface="Segoe UI"/>
+              </a:rPr>
+              <a:t>•  </a:t>
+            </a:r>
+            <a:r>
+              <a:rPr sz="1200">
+                <a:solidFill>
+                  <a:srgbClr val="2B2A28"/>
+                </a:solidFill>
+                <a:latin typeface="Segoe UI"/>
+              </a:rPr>
+              <a:t>Pengaturan: klik kanan peliharaan → Suara untuk nyala/mati; Status &amp; pengaturan punya slider volume, tombol ▶ Dengar, dan "Diam saat aku sedang fokus" (aktif secara default)</a:t>
             </a:r>
           </a:p>
         </p:txBody>
@@ -7395,7 +7520,7 @@
         </p:nvGraphicFramePr>
         <p:xfrm>
           <a:off x="548640" y="1645920"/>
-          <a:ext cx="11155680" cy="5321808"/>
+          <a:ext cx="11155680" cy="6144768"/>
         </p:xfrm>
         <a:graphic>
           <a:graphicData uri="http://schemas.openxmlformats.org/drawingml/2006/table">
@@ -7489,7 +7614,7 @@
                           </a:solidFill>
                           <a:latin typeface="Segoe UI"/>
                         </a:rPr>
-                        <a:t>2.1.2</a:t>
+                        <a:t>2.2.0</a:t>
                       </a:r>
                     </a:p>
                   </a:txBody>
@@ -7533,7 +7658,7 @@
                           </a:solidFill>
                           <a:latin typeface="Segoe UI"/>
                         </a:rPr>
-                        <a:t>Tickle-only mode</a:t>
+                        <a:t>Pet sounds</a:t>
                       </a:r>
                     </a:p>
                     <a:p>
@@ -7544,7 +7669,7 @@
                           </a:solidFill>
                           <a:latin typeface="Segoe UI"/>
                         </a:rPr>
-                        <a:t>New click option "Only tickle (never open Pips)": click and tickle your pet as much as you like - the Pomodoro window stays closed (open it from the right-click menu). Right-click the pet → When I click</a:t>
+                        <a:t>Your pet has a voice! Each of the 23 animals has its own sound (meow, woof, ribbit, hoot, buzz, oink, whale song...) and it changes with its mood: happy chirps, sad whimpers, sleepy yawns, hungry calls, grumpy huffs and soft snores; It also reacts with sound when you tickle, pet, feed, shake or wake it; Settings: right-click the pet → Sounds to switch on/off; Pet status &amp; settings has a volume slider, a ▶ Hear me button and "Stay quiet while I'm focusing" (on by default)</a:t>
                       </a:r>
                     </a:p>
                   </a:txBody>
@@ -7568,7 +7693,7 @@
                           </a:solidFill>
                           <a:latin typeface="Segoe UI"/>
                         </a:rPr>
-                        <a:t>2.1.1</a:t>
+                        <a:t>2.1.2</a:t>
                       </a:r>
                     </a:p>
                   </a:txBody>
@@ -7612,7 +7737,7 @@
                           </a:solidFill>
                           <a:latin typeface="Segoe UI"/>
                         </a:rPr>
-                        <a:t>Owner info</a:t>
+                        <a:t>Tickle-only mode</a:t>
                       </a:r>
                     </a:p>
                     <a:p>
@@ -7623,7 +7748,7 @@
                           </a:solidFill>
                           <a:latin typeface="Segoe UI"/>
                         </a:rPr>
-                        <a:t>About Pips now shows the owner: Juwen Lie (right-click the pet → Help → About)</a:t>
+                        <a:t>New click option "Only tickle (never open Pips)": click and tickle your pet as much as you like - the Pomodoro window stays closed (open it from the right-click menu). Right-click the pet → When I click</a:t>
                       </a:r>
                     </a:p>
                   </a:txBody>
@@ -7647,7 +7772,7 @@
                           </a:solidFill>
                           <a:latin typeface="Segoe UI"/>
                         </a:rPr>
-                        <a:t>2.1.0</a:t>
+                        <a:t>2.1.1</a:t>
                       </a:r>
                     </a:p>
                   </a:txBody>
@@ -7691,7 +7816,7 @@
                           </a:solidFill>
                           <a:latin typeface="Segoe UI"/>
                         </a:rPr>
-                        <a:t>Interactive guide &amp; in-app updates</a:t>
+                        <a:t>Owner info</a:t>
                       </a:r>
                     </a:p>
                     <a:p>
@@ -7702,7 +7827,7 @@
                           </a:solidFill>
                           <a:latin typeface="Segoe UI"/>
                         </a:rPr>
-                        <a:t>Interactive first-run guide: your pet walks you through clicking, dragging, petting and the right-click menu; In-app updates: Pips tells you when a new version is out - update with one click (your settings and data are kept); New Help menu: replay the guide, check for updates, see the version; Option to turn automatic update checks off</a:t>
+                        <a:t>About Pips now shows the owner: Juwen Lie (right-click the pet → Help → About)</a:t>
                       </a:r>
                     </a:p>
                   </a:txBody>
@@ -7726,7 +7851,7 @@
                           </a:solidFill>
                           <a:latin typeface="Segoe UI"/>
                         </a:rPr>
-                        <a:t>2.0.0</a:t>
+                        <a:t>2.1.0</a:t>
                       </a:r>
                     </a:p>
                   </a:txBody>
@@ -7770,7 +7895,7 @@
                           </a:solidFill>
                           <a:latin typeface="Segoe UI"/>
                         </a:rPr>
-                        <a:t>Desktop pet, 23 animals &amp; 4 languages</a:t>
+                        <a:t>Interactive guide &amp; in-app updates</a:t>
                       </a:r>
                     </a:p>
                     <a:p>
@@ -7781,7 +7906,7 @@
                           </a:solidFill>
                           <a:latin typeface="Segoe UI"/>
                         </a:rPr>
-                        <a:t>Desktop pet that lives on your desktop and taskbar - drag it, tickle it, pet it; 23 animals in 3 groups: Land walks, Water swims with bubbles, Sky hovers and flaps; Moods (happy, sad, tired, hungry, grumpy...), naps when you're away, wakes up when you're back; Cute chat-bubble reminders: breaks, water, 20-20-20 eye rest, pomodoro done, daily goal</a:t>
+                        <a:t>Interactive first-run guide: your pet walks you through clicking, dragging, petting and the right-click menu; In-app updates: Pips tells you when a new version is out - update with one click (your settings and data are kept); New Help menu: replay the guide, check for updates, see the version; Option to turn automatic update checks off</a:t>
                       </a:r>
                     </a:p>
                   </a:txBody>
@@ -7805,7 +7930,7 @@
                           </a:solidFill>
                           <a:latin typeface="Segoe UI"/>
                         </a:rPr>
-                        <a:t>1.5.0</a:t>
+                        <a:t>2.0.0</a:t>
                       </a:r>
                     </a:p>
                   </a:txBody>
@@ -7827,13 +7952,92 @@
                           </a:solidFill>
                           <a:latin typeface="Segoe UI"/>
                         </a:rPr>
+                        <a:t>2026-10-28</a:t>
+                      </a:r>
+                    </a:p>
+                  </a:txBody>
+                  <a:tcPr marL="73152" marR="73152" marT="36576" marB="36576">
+                    <a:solidFill>
+                      <a:srgbClr val="FFFDF8"/>
+                    </a:solidFill>
+                  </a:tcPr>
+                </a:tc>
+                <a:tc>
+                  <a:txBody>
+                    <a:bodyPr wrap="square"/>
+                    <a:lstStyle/>
+                    <a:p>
+                      <a:r>
+                        <a:rPr sz="1200" b="0">
+                          <a:solidFill>
+                            <a:srgbClr val="2B2A28"/>
+                          </a:solidFill>
+                          <a:latin typeface="Segoe UI"/>
+                        </a:rPr>
+                        <a:t>Desktop pet, 23 animals &amp; 4 languages</a:t>
+                      </a:r>
+                    </a:p>
+                    <a:p>
+                      <a:r>
+                        <a:rPr sz="1200" b="0">
+                          <a:solidFill>
+                            <a:srgbClr val="2B2A28"/>
+                          </a:solidFill>
+                          <a:latin typeface="Segoe UI"/>
+                        </a:rPr>
+                        <a:t>Desktop pet that lives on your desktop and taskbar - drag it, tickle it, pet it; 23 animals in 3 groups: Land walks, Water swims with bubbles, Sky hovers and flaps; Moods (happy, sad, tired, hungry, grumpy...), naps when you're away, wakes up when you're back; Cute chat-bubble reminders: breaks, water, 20-20-20 eye rest, pomodoro done, daily goal</a:t>
+                      </a:r>
+                    </a:p>
+                  </a:txBody>
+                  <a:tcPr marL="73152" marR="73152" marT="36576" marB="36576">
+                    <a:solidFill>
+                      <a:srgbClr val="FFFDF8"/>
+                    </a:solidFill>
+                  </a:tcPr>
+                </a:tc>
+              </a:tr>
+              <a:tr h="822960">
+                <a:tc>
+                  <a:txBody>
+                    <a:bodyPr wrap="square"/>
+                    <a:lstStyle/>
+                    <a:p>
+                      <a:r>
+                        <a:rPr sz="1200" b="1">
+                          <a:solidFill>
+                            <a:srgbClr val="2B2A28"/>
+                          </a:solidFill>
+                          <a:latin typeface="Segoe UI"/>
+                        </a:rPr>
+                        <a:t>1.5.0</a:t>
+                      </a:r>
+                    </a:p>
+                  </a:txBody>
+                  <a:tcPr marL="73152" marR="73152" marT="36576" marB="36576">
+                    <a:solidFill>
+                      <a:srgbClr val="F7F4EC"/>
+                    </a:solidFill>
+                  </a:tcPr>
+                </a:tc>
+                <a:tc>
+                  <a:txBody>
+                    <a:bodyPr wrap="square"/>
+                    <a:lstStyle/>
+                    <a:p>
+                      <a:r>
+                        <a:rPr sz="1200" b="0">
+                          <a:solidFill>
+                            <a:srgbClr val="2B2A28"/>
+                          </a:solidFill>
+                          <a:latin typeface="Segoe UI"/>
+                        </a:rPr>
                         <a:t>2026-10-24</a:t>
                       </a:r>
                     </a:p>
                   </a:txBody>
                   <a:tcPr marL="73152" marR="73152" marT="36576" marB="36576">
                     <a:solidFill>
-                      <a:srgbClr val="FFFDF8"/>
+                      <a:srgbClr val="F7F4EC"/>
                     </a:solidFill>
                   </a:tcPr>
                 </a:tc>
@@ -7866,7 +8070,7 @@
                   </a:txBody>
                   <a:tcPr marL="73152" marR="73152" marT="36576" marB="36576">
                     <a:solidFill>
-                      <a:srgbClr val="FFFDF8"/>
+                      <a:srgbClr val="F7F4EC"/>
                     </a:solidFill>
                   </a:tcPr>
                 </a:tc>
@@ -7890,7 +8094,7 @@
                   </a:txBody>
                   <a:tcPr marL="73152" marR="73152" marT="36576" marB="36576">
                     <a:solidFill>
-                      <a:srgbClr val="F7F4EC"/>
+                      <a:srgbClr val="FFFDF8"/>
                     </a:solidFill>
                   </a:tcPr>
                 </a:tc>
@@ -7912,7 +8116,7 @@
                   </a:txBody>
                   <a:tcPr marL="73152" marR="73152" marT="36576" marB="36576">
                     <a:solidFill>
-                      <a:srgbClr val="F7F4EC"/>
+                      <a:srgbClr val="FFFDF8"/>
                     </a:solidFill>
                   </a:tcPr>
                 </a:tc>
@@ -7945,7 +8149,7 @@
                   </a:txBody>
                   <a:tcPr marL="73152" marR="73152" marT="36576" marB="36576">
                     <a:solidFill>
-                      <a:srgbClr val="F7F4EC"/>
+                      <a:srgbClr val="FFFDF8"/>
                     </a:solidFill>
                   </a:tcPr>
                 </a:tc>
@@ -11252,7 +11456,7 @@
         </p:nvGraphicFramePr>
         <p:xfrm>
           <a:off x="548640" y="1645920"/>
-          <a:ext cx="7315200" cy="3968496"/>
+          <a:ext cx="7315200" cy="4187952"/>
         </p:xfrm>
         <a:graphic>
           <a:graphicData uri="http://schemas.openxmlformats.org/drawingml/2006/table">
@@ -11310,7 +11514,7 @@
                   </a:tcPr>
                 </a:tc>
               </a:tr>
-              <a:tr h="512064">
+              <a:tr h="475488">
                 <a:tc>
                   <a:txBody>
                     <a:bodyPr wrap="square"/>
@@ -11356,7 +11560,7 @@
                   </a:tcPr>
                 </a:tc>
               </a:tr>
-              <a:tr h="512064">
+              <a:tr h="475488">
                 <a:tc>
                   <a:txBody>
                     <a:bodyPr wrap="square"/>
@@ -11402,7 +11606,7 @@
                   </a:tcPr>
                 </a:tc>
               </a:tr>
-              <a:tr h="512064">
+              <a:tr h="475488">
                 <a:tc>
                   <a:txBody>
                     <a:bodyPr wrap="square"/>
@@ -11448,7 +11652,7 @@
                   </a:tcPr>
                 </a:tc>
               </a:tr>
-              <a:tr h="512064">
+              <a:tr h="475488">
                 <a:tc>
                   <a:txBody>
                     <a:bodyPr wrap="square"/>
@@ -11494,7 +11698,7 @@
                   </a:tcPr>
                 </a:tc>
               </a:tr>
-              <a:tr h="512064">
+              <a:tr h="475488">
                 <a:tc>
                   <a:txBody>
                     <a:bodyPr wrap="square"/>
@@ -11540,7 +11744,7 @@
                   </a:tcPr>
                 </a:tc>
               </a:tr>
-              <a:tr h="512064">
+              <a:tr h="475488">
                 <a:tc>
                   <a:txBody>
                     <a:bodyPr wrap="square"/>
@@ -11586,7 +11790,7 @@
                   </a:tcPr>
                 </a:tc>
               </a:tr>
-              <a:tr h="512064">
+              <a:tr h="475488">
                 <a:tc>
                   <a:txBody>
                     <a:bodyPr wrap="square"/>
@@ -11632,6 +11836,52 @@
                   </a:tcPr>
                 </a:tc>
               </a:tr>
+              <a:tr h="475488">
+                <a:tc>
+                  <a:txBody>
+                    <a:bodyPr wrap="square"/>
+                    <a:lstStyle/>
+                    <a:p>
+                      <a:r>
+                        <a:rPr sz="1400" b="1">
+                          <a:solidFill>
+                            <a:srgbClr val="2B2A28"/>
+                          </a:solidFill>
+                          <a:latin typeface="Segoe UI"/>
+                        </a:rPr>
+                        <a:t>Listen ♪</a:t>
+                      </a:r>
+                    </a:p>
+                  </a:txBody>
+                  <a:tcPr marL="73152" marR="73152" marT="36576" marB="36576">
+                    <a:solidFill>
+                      <a:srgbClr val="F7F4EC"/>
+                    </a:solidFill>
+                  </a:tcPr>
+                </a:tc>
+                <a:tc>
+                  <a:txBody>
+                    <a:bodyPr wrap="square"/>
+                    <a:lstStyle/>
+                    <a:p>
+                      <a:r>
+                        <a:rPr sz="1400" b="0">
+                          <a:solidFill>
+                            <a:srgbClr val="2B2A28"/>
+                          </a:solidFill>
+                          <a:latin typeface="Segoe UI"/>
+                        </a:rPr>
+                        <a:t>Meows, barks, ribbits, hoots… its voice changes with its mood</a:t>
+                      </a:r>
+                    </a:p>
+                  </a:txBody>
+                  <a:tcPr marL="73152" marR="73152" marT="36576" marB="36576">
+                    <a:solidFill>
+                      <a:srgbClr val="F7F4EC"/>
+                    </a:solidFill>
+                  </a:tcPr>
+                </a:tc>
+              </a:tr>
             </a:tbl>
           </a:graphicData>
         </a:graphic>
@@ -12005,7 +12255,7 @@
           <a:p>
             <a:pPr>
               <a:spcAft>
-                <a:spcPts val="900"/>
+                <a:spcPts val="800"/>
               </a:spcAft>
             </a:pPr>
             <a:r>
@@ -12039,7 +12289,7 @@
           <a:p>
             <a:pPr>
               <a:spcAft>
-                <a:spcPts val="900"/>
+                <a:spcPts val="800"/>
               </a:spcAft>
             </a:pPr>
             <a:r>
@@ -12073,7 +12323,7 @@
           <a:p>
             <a:pPr>
               <a:spcAft>
-                <a:spcPts val="900"/>
+                <a:spcPts val="800"/>
               </a:spcAft>
             </a:pPr>
             <a:r>
@@ -12107,7 +12357,7 @@
           <a:p>
             <a:pPr>
               <a:spcAft>
-                <a:spcPts val="900"/>
+                <a:spcPts val="800"/>
               </a:spcAft>
             </a:pPr>
             <a:r>
@@ -12141,7 +12391,7 @@
           <a:p>
             <a:pPr>
               <a:spcAft>
-                <a:spcPts val="900"/>
+                <a:spcPts val="800"/>
               </a:spcAft>
             </a:pPr>
             <a:r>
@@ -12170,6 +12420,40 @@
                 <a:latin typeface="Segoe UI"/>
               </a:rPr>
               <a:t>name, body colour, cheek colour and size S / M / L.</a:t>
+            </a:r>
+          </a:p>
+          <a:p>
+            <a:pPr>
+              <a:spcAft>
+                <a:spcPts val="800"/>
+              </a:spcAft>
+            </a:pPr>
+            <a:r>
+              <a:rPr sz="1500" b="1">
+                <a:solidFill>
+                  <a:srgbClr val="4CB86B"/>
+                </a:solidFill>
+                <a:latin typeface="Segoe UI"/>
+              </a:rPr>
+              <a:t>•  </a:t>
+            </a:r>
+            <a:r>
+              <a:rPr sz="1500" b="1">
+                <a:solidFill>
+                  <a:srgbClr val="2B2A28"/>
+                </a:solidFill>
+                <a:latin typeface="Segoe UI"/>
+              </a:rPr>
+              <a:t>Own voice ♪: </a:t>
+            </a:r>
+            <a:r>
+              <a:rPr sz="1500">
+                <a:solidFill>
+                  <a:srgbClr val="2B2A28"/>
+                </a:solidFill>
+                <a:latin typeface="Segoe UI"/>
+              </a:rPr>
+              <a:t>every animal sounds different - happy, sleepy, hungry or grumpy.</a:t>
             </a:r>
           </a:p>
         </p:txBody>

</xml_diff>

<commit_message>
pips 2.3.0: Friends, levels & achievements
</commit_message>
<xml_diff>
--- a/apps/pips/web/download/Pips-Guide.pptx
+++ b/apps/pips/web/download/Pips-Guide.pptx
@@ -22,6 +22,7 @@
     <p:sldId id="270" r:id="rId21"/>
     <p:sldId id="271" r:id="rId22"/>
     <p:sldId id="272" r:id="rId23"/>
+    <p:sldId id="273" r:id="rId24"/>
   </p:sldIdLst>
   <p:sldSz cx="12191695" cy="6858000" type="screen4x3"/>
   <p:notesSz cx="6858000" cy="9144000"/>
@@ -3290,7 +3291,7 @@
                 </a:solidFill>
                 <a:latin typeface="Segoe UI"/>
               </a:rPr>
-              <a:t>Version 2.2.0  ·  2026-10-28  ·  Owner: Juwen Lie</a:t>
+              <a:t>Version 2.3.0  ·  2026-10-28  ·  Owner: Juwen Lie</a:t>
             </a:r>
           </a:p>
           <a:p>
@@ -4180,7 +4181,7 @@
                 </a:solidFill>
                 <a:latin typeface="Segoe UI"/>
               </a:rPr>
-              <a:t>CUSTOMIZE</a:t>
+              <a:t>TOGETHER</a:t>
             </a:r>
           </a:p>
         </p:txBody>
@@ -4215,7 +4216,7 @@
                 </a:solidFill>
                 <a:latin typeface="Segoe UI"/>
               </a:rPr>
-              <a:t>Make it yours: Pet status &amp; settings</a:t>
+              <a:t>Friends, levels &amp; achievements</a:t>
             </a:r>
           </a:p>
         </p:txBody>
@@ -4298,45 +4299,223 @@
           </a:p>
         </p:txBody>
       </p:sp>
-      <p:pic>
-        <p:nvPicPr>
-          <p:cNvPr id="7" name="Picture 6" descr="settings.png"/>
-          <p:cNvPicPr>
-            <a:picLocks noChangeAspect="1"/>
-          </p:cNvPicPr>
-          <p:nvPr/>
-        </p:nvPicPr>
-        <p:blipFill>
-          <a:blip r:embed="rId2"/>
-          <a:stretch>
-            <a:fillRect/>
-          </a:stretch>
-        </p:blipFill>
-        <p:spPr>
-          <a:xfrm>
-            <a:off x="949470" y="1508760"/>
-            <a:ext cx="1850100" cy="4846320"/>
-          </a:xfrm>
-          <a:prstGeom prst="rect">
-            <a:avLst/>
-          </a:prstGeom>
+      <p:sp>
+        <p:nvSpPr>
+          <p:cNvPr id="7" name="TextBox 6"/>
+          <p:cNvSpPr txBox="1"/>
+          <p:nvPr/>
+        </p:nvSpPr>
+        <p:spPr>
+          <a:xfrm>
+            <a:off x="548640" y="1645920"/>
+            <a:ext cx="5577840" cy="4572000"/>
+          </a:xfrm>
+          <a:prstGeom prst="rect">
+            <a:avLst/>
+          </a:prstGeom>
+          <a:noFill/>
+        </p:spPr>
+        <p:txBody>
+          <a:bodyPr wrap="square">
+            <a:spAutoFit/>
+          </a:bodyPr>
+          <a:lstStyle/>
+          <a:p>
+            <a:pPr>
+              <a:spcAft>
+                <a:spcPts val="1000"/>
+              </a:spcAft>
+            </a:pPr>
+            <a:r>
+              <a:rPr sz="1600" b="1">
+                <a:solidFill>
+                  <a:srgbClr val="4CB86B"/>
+                </a:solidFill>
+                <a:latin typeface="Segoe UI"/>
+              </a:rPr>
+              <a:t>•  </a:t>
+            </a:r>
+            <a:r>
+              <a:rPr sz="1600" b="1">
+                <a:solidFill>
+                  <a:srgbClr val="2B2A28"/>
+                </a:solidFill>
+                <a:latin typeface="Segoe UI"/>
+              </a:rPr>
+              <a:t>Levels &amp; XP: </a:t>
+            </a:r>
+            <a:r>
+              <a:rPr sz="1600">
+                <a:solidFill>
+                  <a:srgbClr val="2B2A28"/>
+                </a:solidFill>
+                <a:latin typeface="Segoe UI"/>
+              </a:rPr>
+              <a:t>every finished pomodoro gives XP - level up as you focus.</a:t>
+            </a:r>
+          </a:p>
+          <a:p>
+            <a:pPr>
+              <a:spcAft>
+                <a:spcPts val="1000"/>
+              </a:spcAft>
+            </a:pPr>
+            <a:r>
+              <a:rPr sz="1600" b="1">
+                <a:solidFill>
+                  <a:srgbClr val="4CB86B"/>
+                </a:solidFill>
+                <a:latin typeface="Segoe UI"/>
+              </a:rPr>
+              <a:t>•  </a:t>
+            </a:r>
+            <a:r>
+              <a:rPr sz="1600" b="1">
+                <a:solidFill>
+                  <a:srgbClr val="2B2A28"/>
+                </a:solidFill>
+                <a:latin typeface="Segoe UI"/>
+              </a:rPr>
+              <a:t>20 achievements: </a:t>
+            </a:r>
+            <a:r>
+              <a:rPr sz="1600">
+                <a:solidFill>
+                  <a:srgbClr val="2B2A28"/>
+                </a:solidFill>
+                <a:latin typeface="Segoe UI"/>
+              </a:rPr>
+              <a:t>first tomato, 4 / 8 in a day, 3 / 7 / 14-day streaks, early bird, night owl, pet lover... Your pet celebrates each one.</a:t>
+            </a:r>
+          </a:p>
+          <a:p>
+            <a:pPr>
+              <a:spcAft>
+                <a:spcPts val="1000"/>
+              </a:spcAft>
+            </a:pPr>
+            <a:r>
+              <a:rPr sz="1600" b="1">
+                <a:solidFill>
+                  <a:srgbClr val="4CB86B"/>
+                </a:solidFill>
+                <a:latin typeface="Segoe UI"/>
+              </a:rPr>
+              <a:t>•  </a:t>
+            </a:r>
+            <a:r>
+              <a:rPr sz="1600" b="1">
+                <a:solidFill>
+                  <a:srgbClr val="2B2A28"/>
+                </a:solidFill>
+                <a:latin typeface="Segoe UI"/>
+              </a:rPr>
+              <a:t>Open: </a:t>
+            </a:r>
+            <a:r>
+              <a:rPr sz="1600">
+                <a:solidFill>
+                  <a:srgbClr val="2B2A28"/>
+                </a:solidFill>
+                <a:latin typeface="Segoe UI"/>
+              </a:rPr>
+              <a:t>right-click the pet → Friends &amp; achievements…</a:t>
+            </a:r>
+          </a:p>
+          <a:p>
+            <a:pPr>
+              <a:spcAft>
+                <a:spcPts val="1000"/>
+              </a:spcAft>
+            </a:pPr>
+            <a:r>
+              <a:rPr sz="1600" b="1">
+                <a:solidFill>
+                  <a:srgbClr val="4CB86B"/>
+                </a:solidFill>
+                <a:latin typeface="Segoe UI"/>
+              </a:rPr>
+              <a:t>•  </a:t>
+            </a:r>
+            <a:r>
+              <a:rPr sz="1600" b="1">
+                <a:solidFill>
+                  <a:srgbClr val="2B2A28"/>
+                </a:solidFill>
+                <a:latin typeface="Segoe UI"/>
+              </a:rPr>
+              <a:t>Works offline: </a:t>
+            </a:r>
+            <a:r>
+              <a:rPr sz="1600">
+                <a:solidFill>
+                  <a:srgbClr val="2B2A28"/>
+                </a:solidFill>
+                <a:latin typeface="Segoe UI"/>
+              </a:rPr>
+              <a:t>levels and achievements are calculated on your PC.</a:t>
+            </a:r>
+          </a:p>
+        </p:txBody>
+      </p:sp>
+      <p:sp>
+        <p:nvSpPr>
+          <p:cNvPr id="8" name="Rounded Rectangle 7"/>
+          <p:cNvSpPr/>
+          <p:nvPr/>
+        </p:nvSpPr>
+        <p:spPr>
+          <a:xfrm>
+            <a:off x="6400800" y="1645920"/>
+            <a:ext cx="5394960" cy="4389120"/>
+          </a:xfrm>
+          <a:prstGeom prst="roundRect">
+            <a:avLst>
+              <a:gd name="adj" fmla="val 6000"/>
+            </a:avLst>
+          </a:prstGeom>
+          <a:solidFill>
+            <a:srgbClr val="FFFDF8"/>
+          </a:solidFill>
           <a:ln w="12700">
             <a:solidFill>
               <a:srgbClr val="E2DCCE"/>
             </a:solidFill>
           </a:ln>
-        </p:spPr>
-      </p:pic>
-      <p:sp>
-        <p:nvSpPr>
-          <p:cNvPr id="8" name="TextBox 7"/>
+          <a:effectLst/>
+        </p:spPr>
+        <p:style>
+          <a:lnRef idx="1">
+            <a:schemeClr val="accent1"/>
+          </a:lnRef>
+          <a:fillRef idx="3">
+            <a:schemeClr val="accent1"/>
+          </a:fillRef>
+          <a:effectRef idx="2">
+            <a:schemeClr val="accent1"/>
+          </a:effectRef>
+          <a:fontRef idx="minor">
+            <a:schemeClr val="lt1"/>
+          </a:fontRef>
+        </p:style>
+        <p:txBody>
+          <a:bodyPr rtlCol="0" anchor="ctr"/>
+          <a:lstStyle/>
+          <a:p>
+            <a:pPr algn="ctr"/>
+          </a:p>
+        </p:txBody>
+      </p:sp>
+      <p:sp>
+        <p:nvSpPr>
+          <p:cNvPr id="9" name="TextBox 8"/>
           <p:cNvSpPr txBox="1"/>
           <p:nvPr/>
         </p:nvSpPr>
         <p:spPr>
           <a:xfrm>
-            <a:off x="365760" y="6382512"/>
-            <a:ext cx="3017520" cy="365760"/>
+            <a:off x="6675120" y="1783080"/>
+            <a:ext cx="4937760" cy="457200"/>
           </a:xfrm>
           <a:prstGeom prst="rect">
             <a:avLst/>
@@ -4349,50 +4528,15 @@
           </a:bodyPr>
           <a:lstStyle/>
           <a:p>
-            <a:pPr algn="ctr"/>
-            <a:r>
-              <a:rPr sz="1200" b="0">
-                <a:solidFill>
-                  <a:srgbClr val="6E6A62"/>
-                </a:solidFill>
-                <a:latin typeface="Segoe UI"/>
-              </a:rPr>
-              <a:t>(shown in Bahasa Indonesia)</a:t>
-            </a:r>
-          </a:p>
-        </p:txBody>
-      </p:sp>
-      <p:sp>
-        <p:nvSpPr>
-          <p:cNvPr id="9" name="TextBox 8"/>
-          <p:cNvSpPr txBox="1"/>
-          <p:nvPr/>
-        </p:nvSpPr>
-        <p:spPr>
-          <a:xfrm>
-            <a:off x="3474720" y="1600200"/>
-            <a:ext cx="8229600" cy="457200"/>
-          </a:xfrm>
-          <a:prstGeom prst="rect">
-            <a:avLst/>
-          </a:prstGeom>
-          <a:noFill/>
-        </p:spPr>
-        <p:txBody>
-          <a:bodyPr wrap="square" anchor="t" lIns="45720" rIns="45720" tIns="27432" bIns="27432">
-            <a:spAutoFit/>
-          </a:bodyPr>
-          <a:lstStyle/>
-          <a:p>
             <a:pPr algn="l"/>
             <a:r>
-              <a:rPr sz="1700" b="1">
-                <a:solidFill>
-                  <a:srgbClr val="8B1A1A"/>
-                </a:solidFill>
-                <a:latin typeface="Segoe UI"/>
-              </a:rPr>
-              <a:t>Right-click the pet → Pet status &amp; settings…</a:t>
+              <a:rPr sz="1600" b="1">
+                <a:solidFill>
+                  <a:srgbClr val="2B2A28"/>
+                </a:solidFill>
+                <a:latin typeface="Segoe UI"/>
+              </a:rPr>
+              <a:t>Friends (optional, off by default)</a:t>
             </a:r>
           </a:p>
         </p:txBody>
@@ -4405,8 +4549,8 @@
         </p:nvSpPr>
         <p:spPr>
           <a:xfrm>
-            <a:off x="3474720" y="2148840"/>
-            <a:ext cx="4114800" cy="4206240"/>
+            <a:off x="6675120" y="2331720"/>
+            <a:ext cx="4937760" cy="3657600"/>
           </a:xfrm>
           <a:prstGeom prst="rect">
             <a:avLst/>
@@ -4421,11 +4565,11 @@
           <a:p>
             <a:pPr>
               <a:spcAft>
-                <a:spcPts val="900"/>
+                <a:spcPts val="500"/>
               </a:spcAft>
             </a:pPr>
             <a:r>
-              <a:rPr sz="1500" b="1">
+              <a:rPr sz="1400" b="1">
                 <a:solidFill>
                   <a:srgbClr val="4CB86B"/>
                 </a:solidFill>
@@ -4434,32 +4578,23 @@
               <a:t>•  </a:t>
             </a:r>
             <a:r>
-              <a:rPr sz="1500" b="1">
-                <a:solidFill>
-                  <a:srgbClr val="2B2A28"/>
-                </a:solidFill>
-                <a:latin typeface="Segoe UI"/>
-              </a:rPr>
-              <a:t>Status: </a:t>
-            </a:r>
-            <a:r>
-              <a:rPr sz="1500">
-                <a:solidFill>
-                  <a:srgbClr val="2B2A28"/>
-                </a:solidFill>
-                <a:latin typeface="Segoe UI"/>
-              </a:rPr>
-              <a:t>mood + happiness, energy, food, bond bars.</a:t>
+              <a:rPr sz="1400">
+                <a:solidFill>
+                  <a:srgbClr val="2B2A28"/>
+                </a:solidFill>
+                <a:latin typeface="Segoe UI"/>
+              </a:rPr>
+              <a:t>Turn on Friends and get a 6-letter friend code</a:t>
             </a:r>
           </a:p>
           <a:p>
             <a:pPr>
               <a:spcAft>
-                <a:spcPts val="900"/>
+                <a:spcPts val="500"/>
               </a:spcAft>
             </a:pPr>
             <a:r>
-              <a:rPr sz="1500" b="1">
+              <a:rPr sz="1400" b="1">
                 <a:solidFill>
                   <a:srgbClr val="4CB86B"/>
                 </a:solidFill>
@@ -4468,32 +4603,23 @@
               <a:t>•  </a:t>
             </a:r>
             <a:r>
-              <a:rPr sz="1500" b="1">
-                <a:solidFill>
-                  <a:srgbClr val="2B2A28"/>
-                </a:solidFill>
-                <a:latin typeface="Segoe UI"/>
-              </a:rPr>
-              <a:t>Animal: </a:t>
-            </a:r>
-            <a:r>
-              <a:rPr sz="1500">
-                <a:solidFill>
-                  <a:srgbClr val="2B2A28"/>
-                </a:solidFill>
-                <a:latin typeface="Segoe UI"/>
-              </a:rPr>
-              <a:t>Land / Water / Sky tabs - click a tile.</a:t>
+              <a:rPr sz="1400">
+                <a:solidFill>
+                  <a:srgbClr val="2B2A28"/>
+                </a:solidFill>
+                <a:latin typeface="Segoe UI"/>
+              </a:rPr>
+              <a:t>Add colleagues by their code - see today's board</a:t>
             </a:r>
           </a:p>
           <a:p>
             <a:pPr>
               <a:spcAft>
-                <a:spcPts val="900"/>
+                <a:spcPts val="500"/>
               </a:spcAft>
             </a:pPr>
             <a:r>
-              <a:rPr sz="1500" b="1">
+              <a:rPr sz="1400" b="1">
                 <a:solidFill>
                   <a:srgbClr val="4CB86B"/>
                 </a:solidFill>
@@ -4502,32 +4628,23 @@
               <a:t>•  </a:t>
             </a:r>
             <a:r>
-              <a:rPr sz="1500" b="1">
-                <a:solidFill>
-                  <a:srgbClr val="2B2A28"/>
-                </a:solidFill>
-                <a:latin typeface="Segoe UI"/>
-              </a:rPr>
-              <a:t>Look: </a:t>
-            </a:r>
-            <a:r>
-              <a:rPr sz="1500">
-                <a:solidFill>
-                  <a:srgbClr val="2B2A28"/>
-                </a:solidFill>
-                <a:latin typeface="Segoe UI"/>
-              </a:rPr>
-              <a:t>name, colour, cheeks, size S / M / L.</a:t>
+              <a:rPr sz="1400">
+                <a:solidFill>
+                  <a:srgbClr val="2B2A28"/>
+                </a:solidFill>
+                <a:latin typeface="Segoe UI"/>
+              </a:rPr>
+              <a:t>Join a team board with a team code, e.g. PTB</a:t>
             </a:r>
           </a:p>
           <a:p>
             <a:pPr>
               <a:spcAft>
-                <a:spcPts val="900"/>
+                <a:spcPts val="500"/>
               </a:spcAft>
             </a:pPr>
             <a:r>
-              <a:rPr sz="1500" b="1">
+              <a:rPr sz="1400" b="1">
                 <a:solidFill>
                   <a:srgbClr val="4CB86B"/>
                 </a:solidFill>
@@ -4536,51 +4653,19 @@
               <a:t>•  </a:t>
             </a:r>
             <a:r>
-              <a:rPr sz="1500" b="1">
-                <a:solidFill>
-                  <a:srgbClr val="2B2A28"/>
-                </a:solidFill>
-                <a:latin typeface="Segoe UI"/>
-              </a:rPr>
-              <a:t>Language: </a:t>
-            </a:r>
-            <a:r>
-              <a:rPr sz="1500">
-                <a:solidFill>
-                  <a:srgbClr val="2B2A28"/>
-                </a:solidFill>
-                <a:latin typeface="Segoe UI"/>
-              </a:rPr>
-              <a:t>switch instantly.</a:t>
-            </a:r>
-          </a:p>
-        </p:txBody>
-      </p:sp>
-      <p:sp>
-        <p:nvSpPr>
-          <p:cNvPr id="11" name="TextBox 10"/>
-          <p:cNvSpPr txBox="1"/>
-          <p:nvPr/>
-        </p:nvSpPr>
-        <p:spPr>
-          <a:xfrm>
-            <a:off x="7772400" y="2148840"/>
-            <a:ext cx="4114800" cy="4206240"/>
-          </a:xfrm>
-          <a:prstGeom prst="rect">
-            <a:avLst/>
-          </a:prstGeom>
-          <a:noFill/>
-        </p:spPr>
-        <p:txBody>
-          <a:bodyPr wrap="square">
-            <a:spAutoFit/>
-          </a:bodyPr>
-          <a:lstStyle/>
+              <a:rPr sz="1400">
+                <a:solidFill>
+                  <a:srgbClr val="2B2A28"/>
+                </a:solidFill>
+                <a:latin typeface="Segoe UI"/>
+              </a:rPr>
+              <a:t>Your pet tells you when a friend finishes a pomodoro</a:t>
+            </a:r>
+          </a:p>
           <a:p>
             <a:pPr>
               <a:spcAft>
-                <a:spcPts val="300"/>
+                <a:spcPts val="500"/>
               </a:spcAft>
             </a:pPr>
             <a:r>
@@ -4599,13 +4684,13 @@
                 </a:solidFill>
                 <a:latin typeface="Segoe UI"/>
               </a:rPr>
-              <a:t>Click action: open card · tickle (double-click opens) · only tickle</a:t>
+              <a:t>Shared: name, pet, level, streak, pomodoro counts</a:t>
             </a:r>
           </a:p>
           <a:p>
             <a:pPr>
               <a:spcAft>
-                <a:spcPts val="300"/>
+                <a:spcPts val="500"/>
               </a:spcAft>
             </a:pPr>
             <a:r>
@@ -4624,13 +4709,13 @@
                 </a:solidFill>
                 <a:latin typeface="Segoe UI"/>
               </a:rPr>
-              <a:t>Show reminders as chat bubbles</a:t>
+              <a:t>Never shared: apps, window titles, scores, files</a:t>
             </a:r>
           </a:p>
           <a:p>
             <a:pPr>
               <a:spcAft>
-                <a:spcPts val="300"/>
+                <a:spcPts val="500"/>
               </a:spcAft>
             </a:pPr>
             <a:r>
@@ -4649,182 +4734,7 @@
                 </a:solidFill>
                 <a:latin typeface="Segoe UI"/>
               </a:rPr>
-              <a:t>Walk around on the taskbar</a:t>
-            </a:r>
-          </a:p>
-          <a:p>
-            <a:pPr>
-              <a:spcAft>
-                <a:spcPts val="300"/>
-              </a:spcAft>
-            </a:pPr>
-            <a:r>
-              <a:rPr sz="1400" b="1">
-                <a:solidFill>
-                  <a:srgbClr val="4CB86B"/>
-                </a:solidFill>
-                <a:latin typeface="Segoe UI"/>
-              </a:rPr>
-              <a:t>•  </a:t>
-            </a:r>
-            <a:r>
-              <a:rPr sz="1400">
-                <a:solidFill>
-                  <a:srgbClr val="2B2A28"/>
-                </a:solidFill>
-                <a:latin typeface="Segoe UI"/>
-              </a:rPr>
-              <a:t>Gravity (falls when dropped)</a:t>
-            </a:r>
-          </a:p>
-          <a:p>
-            <a:pPr>
-              <a:spcAft>
-                <a:spcPts val="300"/>
-              </a:spcAft>
-            </a:pPr>
-            <a:r>
-              <a:rPr sz="1400" b="1">
-                <a:solidFill>
-                  <a:srgbClr val="4CB86B"/>
-                </a:solidFill>
-                <a:latin typeface="Segoe UI"/>
-              </a:rPr>
-              <a:t>•  </a:t>
-            </a:r>
-            <a:r>
-              <a:rPr sz="1400">
-                <a:solidFill>
-                  <a:srgbClr val="2B2A28"/>
-                </a:solidFill>
-                <a:latin typeface="Segoe UI"/>
-              </a:rPr>
-              <a:t>Nap when I'm away</a:t>
-            </a:r>
-          </a:p>
-          <a:p>
-            <a:pPr>
-              <a:spcAft>
-                <a:spcPts val="300"/>
-              </a:spcAft>
-            </a:pPr>
-            <a:r>
-              <a:rPr sz="1400" b="1">
-                <a:solidFill>
-                  <a:srgbClr val="4CB86B"/>
-                </a:solidFill>
-                <a:latin typeface="Segoe UI"/>
-              </a:rPr>
-              <a:t>•  </a:t>
-            </a:r>
-            <a:r>
-              <a:rPr sz="1400">
-                <a:solidFill>
-                  <a:srgbClr val="2B2A28"/>
-                </a:solidFill>
-                <a:latin typeface="Segoe UI"/>
-              </a:rPr>
-              <a:t>Open the card next to the pet</a:t>
-            </a:r>
-          </a:p>
-          <a:p>
-            <a:pPr>
-              <a:spcAft>
-                <a:spcPts val="300"/>
-              </a:spcAft>
-            </a:pPr>
-            <a:r>
-              <a:rPr sz="1400" b="1">
-                <a:solidFill>
-                  <a:srgbClr val="4CB86B"/>
-                </a:solidFill>
-                <a:latin typeface="Segoe UI"/>
-              </a:rPr>
-              <a:t>•  </a:t>
-            </a:r>
-            <a:r>
-              <a:rPr sz="1400">
-                <a:solidFill>
-                  <a:srgbClr val="2B2A28"/>
-                </a:solidFill>
-                <a:latin typeface="Segoe UI"/>
-              </a:rPr>
-              <a:t>Chatty (little messages)</a:t>
-            </a:r>
-          </a:p>
-          <a:p>
-            <a:pPr>
-              <a:spcAft>
-                <a:spcPts val="300"/>
-              </a:spcAft>
-            </a:pPr>
-            <a:r>
-              <a:rPr sz="1400" b="1">
-                <a:solidFill>
-                  <a:srgbClr val="4CB86B"/>
-                </a:solidFill>
-                <a:latin typeface="Segoe UI"/>
-              </a:rPr>
-              <a:t>•  </a:t>
-            </a:r>
-            <a:r>
-              <a:rPr sz="1400">
-                <a:solidFill>
-                  <a:srgbClr val="2B2A28"/>
-                </a:solidFill>
-                <a:latin typeface="Segoe UI"/>
-              </a:rPr>
-              <a:t>Hide during full-screen apps</a:t>
-            </a:r>
-          </a:p>
-          <a:p>
-            <a:pPr>
-              <a:spcAft>
-                <a:spcPts val="300"/>
-              </a:spcAft>
-            </a:pPr>
-            <a:r>
-              <a:rPr sz="1400" b="1">
-                <a:solidFill>
-                  <a:srgbClr val="4CB86B"/>
-                </a:solidFill>
-                <a:latin typeface="Segoe UI"/>
-              </a:rPr>
-              <a:t>•  </a:t>
-            </a:r>
-            <a:r>
-              <a:rPr sz="1400">
-                <a:solidFill>
-                  <a:srgbClr val="2B2A28"/>
-                </a:solidFill>
-                <a:latin typeface="Segoe UI"/>
-              </a:rPr>
-              <a:t>Check for updates automatically</a:t>
-            </a:r>
-          </a:p>
-          <a:p>
-            <a:pPr>
-              <a:spcAft>
-                <a:spcPts val="300"/>
-              </a:spcAft>
-            </a:pPr>
-            <a:r>
-              <a:rPr sz="1400" b="1">
-                <a:solidFill>
-                  <a:srgbClr val="4CB86B"/>
-                </a:solidFill>
-                <a:latin typeface="Segoe UI"/>
-              </a:rPr>
-              <a:t>•  </a:t>
-            </a:r>
-            <a:r>
-              <a:rPr sz="1400">
-                <a:solidFill>
-                  <a:srgbClr val="2B2A28"/>
-                </a:solidFill>
-                <a:latin typeface="Segoe UI"/>
-              </a:rPr>
-              <a:t>Animal sounds + volume (quiet while focusing)</a:t>
+              <a:t>One click turns it off and deletes your online data</a:t>
             </a:r>
           </a:p>
         </p:txBody>
@@ -4963,7 +4873,7 @@
                 </a:solidFill>
                 <a:latin typeface="Segoe UI"/>
               </a:rPr>
-              <a:t>Languages</a:t>
+              <a:t>Make it yours: Pet status &amp; settings</a:t>
             </a:r>
           </a:p>
         </p:txBody>
@@ -5046,54 +4956,35 @@
           </a:p>
         </p:txBody>
       </p:sp>
-      <p:sp>
-        <p:nvSpPr>
-          <p:cNvPr id="7" name="Rounded Rectangle 6"/>
-          <p:cNvSpPr/>
-          <p:nvPr/>
-        </p:nvSpPr>
-        <p:spPr>
-          <a:xfrm>
-            <a:off x="548640" y="1737360"/>
-            <a:ext cx="2606040" cy="1463040"/>
-          </a:xfrm>
-          <a:prstGeom prst="roundRect">
-            <a:avLst>
-              <a:gd name="adj" fmla="val 6000"/>
-            </a:avLst>
-          </a:prstGeom>
-          <a:solidFill>
-            <a:srgbClr val="FFFDF8"/>
-          </a:solidFill>
+      <p:pic>
+        <p:nvPicPr>
+          <p:cNvPr id="7" name="Picture 6" descr="settings.png"/>
+          <p:cNvPicPr>
+            <a:picLocks noChangeAspect="1"/>
+          </p:cNvPicPr>
+          <p:nvPr/>
+        </p:nvPicPr>
+        <p:blipFill>
+          <a:blip r:embed="rId2"/>
+          <a:stretch>
+            <a:fillRect/>
+          </a:stretch>
+        </p:blipFill>
+        <p:spPr>
+          <a:xfrm>
+            <a:off x="949470" y="1508760"/>
+            <a:ext cx="1850100" cy="4846320"/>
+          </a:xfrm>
+          <a:prstGeom prst="rect">
+            <a:avLst/>
+          </a:prstGeom>
           <a:ln w="12700">
             <a:solidFill>
               <a:srgbClr val="E2DCCE"/>
             </a:solidFill>
           </a:ln>
-          <a:effectLst/>
-        </p:spPr>
-        <p:style>
-          <a:lnRef idx="1">
-            <a:schemeClr val="accent1"/>
-          </a:lnRef>
-          <a:fillRef idx="3">
-            <a:schemeClr val="accent1"/>
-          </a:fillRef>
-          <a:effectRef idx="2">
-            <a:schemeClr val="accent1"/>
-          </a:effectRef>
-          <a:fontRef idx="minor">
-            <a:schemeClr val="lt1"/>
-          </a:fontRef>
-        </p:style>
-        <p:txBody>
-          <a:bodyPr rtlCol="0" anchor="ctr"/>
-          <a:lstStyle/>
-          <a:p>
-            <a:pPr algn="ctr"/>
-          </a:p>
-        </p:txBody>
-      </p:sp>
+        </p:spPr>
+      </p:pic>
       <p:sp>
         <p:nvSpPr>
           <p:cNvPr id="8" name="TextBox 7"/>
@@ -5102,8 +4993,8 @@
         </p:nvSpPr>
         <p:spPr>
           <a:xfrm>
-            <a:off x="548640" y="1920240"/>
-            <a:ext cx="2606040" cy="548640"/>
+            <a:off x="365760" y="6382512"/>
+            <a:ext cx="3017520" cy="365760"/>
           </a:xfrm>
           <a:prstGeom prst="rect">
             <a:avLst/>
@@ -5118,13 +5009,13 @@
           <a:p>
             <a:pPr algn="ctr"/>
             <a:r>
-              <a:rPr sz="2000" b="1">
-                <a:solidFill>
-                  <a:srgbClr val="2B2A28"/>
-                </a:solidFill>
-                <a:latin typeface="Microsoft JhengHei"/>
-              </a:rPr>
-              <a:t>English</a:t>
+              <a:rPr sz="1200" b="0">
+                <a:solidFill>
+                  <a:srgbClr val="6E6A62"/>
+                </a:solidFill>
+                <a:latin typeface="Segoe UI"/>
+              </a:rPr>
+              <a:t>(shown in Bahasa Indonesia)</a:t>
             </a:r>
           </a:p>
         </p:txBody>
@@ -5137,8 +5028,8 @@
         </p:nvSpPr>
         <p:spPr>
           <a:xfrm>
-            <a:off x="548640" y="2514600"/>
-            <a:ext cx="2606040" cy="457200"/>
+            <a:off x="3474720" y="1600200"/>
+            <a:ext cx="8229600" cy="457200"/>
           </a:xfrm>
           <a:prstGeom prst="rect">
             <a:avLst/>
@@ -5151,383 +5042,29 @@
           </a:bodyPr>
           <a:lstStyle/>
           <a:p>
-            <a:pPr algn="ctr"/>
-            <a:r>
-              <a:rPr sz="1500" b="0">
-                <a:solidFill>
-                  <a:srgbClr val="6E6A62"/>
-                </a:solidFill>
-                <a:latin typeface="Microsoft JhengHei"/>
-              </a:rPr>
-              <a:t>Hello!</a:t>
-            </a:r>
-          </a:p>
-        </p:txBody>
-      </p:sp>
-      <p:sp>
-        <p:nvSpPr>
-          <p:cNvPr id="10" name="Rounded Rectangle 9"/>
-          <p:cNvSpPr/>
-          <p:nvPr/>
-        </p:nvSpPr>
-        <p:spPr>
-          <a:xfrm>
-            <a:off x="3383280" y="1737360"/>
-            <a:ext cx="2606040" cy="1463040"/>
-          </a:xfrm>
-          <a:prstGeom prst="roundRect">
-            <a:avLst>
-              <a:gd name="adj" fmla="val 6000"/>
-            </a:avLst>
-          </a:prstGeom>
-          <a:solidFill>
-            <a:srgbClr val="FFFDF8"/>
-          </a:solidFill>
-          <a:ln w="12700">
-            <a:solidFill>
-              <a:srgbClr val="E2DCCE"/>
-            </a:solidFill>
-          </a:ln>
-          <a:effectLst/>
-        </p:spPr>
-        <p:style>
-          <a:lnRef idx="1">
-            <a:schemeClr val="accent1"/>
-          </a:lnRef>
-          <a:fillRef idx="3">
-            <a:schemeClr val="accent1"/>
-          </a:fillRef>
-          <a:effectRef idx="2">
-            <a:schemeClr val="accent1"/>
-          </a:effectRef>
-          <a:fontRef idx="minor">
-            <a:schemeClr val="lt1"/>
-          </a:fontRef>
-        </p:style>
-        <p:txBody>
-          <a:bodyPr rtlCol="0" anchor="ctr"/>
-          <a:lstStyle/>
-          <a:p>
-            <a:pPr algn="ctr"/>
-          </a:p>
-        </p:txBody>
-      </p:sp>
-      <p:sp>
-        <p:nvSpPr>
-          <p:cNvPr id="11" name="TextBox 10"/>
+            <a:pPr algn="l"/>
+            <a:r>
+              <a:rPr sz="1700" b="1">
+                <a:solidFill>
+                  <a:srgbClr val="8B1A1A"/>
+                </a:solidFill>
+                <a:latin typeface="Segoe UI"/>
+              </a:rPr>
+              <a:t>Right-click the pet → Pet status &amp; settings…</a:t>
+            </a:r>
+          </a:p>
+        </p:txBody>
+      </p:sp>
+      <p:sp>
+        <p:nvSpPr>
+          <p:cNvPr id="10" name="TextBox 9"/>
           <p:cNvSpPr txBox="1"/>
           <p:nvPr/>
         </p:nvSpPr>
         <p:spPr>
           <a:xfrm>
-            <a:off x="3383280" y="1920240"/>
-            <a:ext cx="2606040" cy="548640"/>
-          </a:xfrm>
-          <a:prstGeom prst="rect">
-            <a:avLst/>
-          </a:prstGeom>
-          <a:noFill/>
-        </p:spPr>
-        <p:txBody>
-          <a:bodyPr wrap="square" anchor="t" lIns="45720" rIns="45720" tIns="27432" bIns="27432">
-            <a:spAutoFit/>
-          </a:bodyPr>
-          <a:lstStyle/>
-          <a:p>
-            <a:pPr algn="ctr"/>
-            <a:r>
-              <a:rPr sz="2000" b="1">
-                <a:solidFill>
-                  <a:srgbClr val="2B2A28"/>
-                </a:solidFill>
-                <a:latin typeface="Microsoft JhengHei"/>
-              </a:rPr>
-              <a:t>Bahasa Indonesia</a:t>
-            </a:r>
-          </a:p>
-        </p:txBody>
-      </p:sp>
-      <p:sp>
-        <p:nvSpPr>
-          <p:cNvPr id="12" name="TextBox 11"/>
-          <p:cNvSpPr txBox="1"/>
-          <p:nvPr/>
-        </p:nvSpPr>
-        <p:spPr>
-          <a:xfrm>
-            <a:off x="3383280" y="2514600"/>
-            <a:ext cx="2606040" cy="457200"/>
-          </a:xfrm>
-          <a:prstGeom prst="rect">
-            <a:avLst/>
-          </a:prstGeom>
-          <a:noFill/>
-        </p:spPr>
-        <p:txBody>
-          <a:bodyPr wrap="square" anchor="t" lIns="45720" rIns="45720" tIns="27432" bIns="27432">
-            <a:spAutoFit/>
-          </a:bodyPr>
-          <a:lstStyle/>
-          <a:p>
-            <a:pPr algn="ctr"/>
-            <a:r>
-              <a:rPr sz="1500" b="0">
-                <a:solidFill>
-                  <a:srgbClr val="6E6A62"/>
-                </a:solidFill>
-                <a:latin typeface="Microsoft JhengHei"/>
-              </a:rPr>
-              <a:t>Halo!</a:t>
-            </a:r>
-          </a:p>
-        </p:txBody>
-      </p:sp>
-      <p:sp>
-        <p:nvSpPr>
-          <p:cNvPr id="13" name="Rounded Rectangle 12"/>
-          <p:cNvSpPr/>
-          <p:nvPr/>
-        </p:nvSpPr>
-        <p:spPr>
-          <a:xfrm>
-            <a:off x="6217920" y="1737360"/>
-            <a:ext cx="2606040" cy="1463040"/>
-          </a:xfrm>
-          <a:prstGeom prst="roundRect">
-            <a:avLst>
-              <a:gd name="adj" fmla="val 6000"/>
-            </a:avLst>
-          </a:prstGeom>
-          <a:solidFill>
-            <a:srgbClr val="FFFDF8"/>
-          </a:solidFill>
-          <a:ln w="12700">
-            <a:solidFill>
-              <a:srgbClr val="E2DCCE"/>
-            </a:solidFill>
-          </a:ln>
-          <a:effectLst/>
-        </p:spPr>
-        <p:style>
-          <a:lnRef idx="1">
-            <a:schemeClr val="accent1"/>
-          </a:lnRef>
-          <a:fillRef idx="3">
-            <a:schemeClr val="accent1"/>
-          </a:fillRef>
-          <a:effectRef idx="2">
-            <a:schemeClr val="accent1"/>
-          </a:effectRef>
-          <a:fontRef idx="minor">
-            <a:schemeClr val="lt1"/>
-          </a:fontRef>
-        </p:style>
-        <p:txBody>
-          <a:bodyPr rtlCol="0" anchor="ctr"/>
-          <a:lstStyle/>
-          <a:p>
-            <a:pPr algn="ctr"/>
-          </a:p>
-        </p:txBody>
-      </p:sp>
-      <p:sp>
-        <p:nvSpPr>
-          <p:cNvPr id="14" name="TextBox 13"/>
-          <p:cNvSpPr txBox="1"/>
-          <p:nvPr/>
-        </p:nvSpPr>
-        <p:spPr>
-          <a:xfrm>
-            <a:off x="6217920" y="1920240"/>
-            <a:ext cx="2606040" cy="548640"/>
-          </a:xfrm>
-          <a:prstGeom prst="rect">
-            <a:avLst/>
-          </a:prstGeom>
-          <a:noFill/>
-        </p:spPr>
-        <p:txBody>
-          <a:bodyPr wrap="square" anchor="t" lIns="45720" rIns="45720" tIns="27432" bIns="27432">
-            <a:spAutoFit/>
-          </a:bodyPr>
-          <a:lstStyle/>
-          <a:p>
-            <a:pPr algn="ctr"/>
-            <a:r>
-              <a:rPr sz="2000" b="1">
-                <a:solidFill>
-                  <a:srgbClr val="2B2A28"/>
-                </a:solidFill>
-                <a:latin typeface="Microsoft JhengHei"/>
-              </a:rPr>
-              <a:t>繁體中文</a:t>
-            </a:r>
-          </a:p>
-        </p:txBody>
-      </p:sp>
-      <p:sp>
-        <p:nvSpPr>
-          <p:cNvPr id="15" name="TextBox 14"/>
-          <p:cNvSpPr txBox="1"/>
-          <p:nvPr/>
-        </p:nvSpPr>
-        <p:spPr>
-          <a:xfrm>
-            <a:off x="6217920" y="2514600"/>
-            <a:ext cx="2606040" cy="457200"/>
-          </a:xfrm>
-          <a:prstGeom prst="rect">
-            <a:avLst/>
-          </a:prstGeom>
-          <a:noFill/>
-        </p:spPr>
-        <p:txBody>
-          <a:bodyPr wrap="square" anchor="t" lIns="45720" rIns="45720" tIns="27432" bIns="27432">
-            <a:spAutoFit/>
-          </a:bodyPr>
-          <a:lstStyle/>
-          <a:p>
-            <a:pPr algn="ctr"/>
-            <a:r>
-              <a:rPr sz="1500" b="0">
-                <a:solidFill>
-                  <a:srgbClr val="6E6A62"/>
-                </a:solidFill>
-                <a:latin typeface="Microsoft JhengHei"/>
-              </a:rPr>
-              <a:t>你好！</a:t>
-            </a:r>
-          </a:p>
-        </p:txBody>
-      </p:sp>
-      <p:sp>
-        <p:nvSpPr>
-          <p:cNvPr id="16" name="Rounded Rectangle 15"/>
-          <p:cNvSpPr/>
-          <p:nvPr/>
-        </p:nvSpPr>
-        <p:spPr>
-          <a:xfrm>
-            <a:off x="9052560" y="1737360"/>
-            <a:ext cx="2606040" cy="1463040"/>
-          </a:xfrm>
-          <a:prstGeom prst="roundRect">
-            <a:avLst>
-              <a:gd name="adj" fmla="val 6000"/>
-            </a:avLst>
-          </a:prstGeom>
-          <a:solidFill>
-            <a:srgbClr val="FFFDF8"/>
-          </a:solidFill>
-          <a:ln w="12700">
-            <a:solidFill>
-              <a:srgbClr val="E2DCCE"/>
-            </a:solidFill>
-          </a:ln>
-          <a:effectLst/>
-        </p:spPr>
-        <p:style>
-          <a:lnRef idx="1">
-            <a:schemeClr val="accent1"/>
-          </a:lnRef>
-          <a:fillRef idx="3">
-            <a:schemeClr val="accent1"/>
-          </a:fillRef>
-          <a:effectRef idx="2">
-            <a:schemeClr val="accent1"/>
-          </a:effectRef>
-          <a:fontRef idx="minor">
-            <a:schemeClr val="lt1"/>
-          </a:fontRef>
-        </p:style>
-        <p:txBody>
-          <a:bodyPr rtlCol="0" anchor="ctr"/>
-          <a:lstStyle/>
-          <a:p>
-            <a:pPr algn="ctr"/>
-          </a:p>
-        </p:txBody>
-      </p:sp>
-      <p:sp>
-        <p:nvSpPr>
-          <p:cNvPr id="17" name="TextBox 16"/>
-          <p:cNvSpPr txBox="1"/>
-          <p:nvPr/>
-        </p:nvSpPr>
-        <p:spPr>
-          <a:xfrm>
-            <a:off x="9052560" y="1920240"/>
-            <a:ext cx="2606040" cy="548640"/>
-          </a:xfrm>
-          <a:prstGeom prst="rect">
-            <a:avLst/>
-          </a:prstGeom>
-          <a:noFill/>
-        </p:spPr>
-        <p:txBody>
-          <a:bodyPr wrap="square" anchor="t" lIns="45720" rIns="45720" tIns="27432" bIns="27432">
-            <a:spAutoFit/>
-          </a:bodyPr>
-          <a:lstStyle/>
-          <a:p>
-            <a:pPr algn="ctr"/>
-            <a:r>
-              <a:rPr sz="2000" b="1">
-                <a:solidFill>
-                  <a:srgbClr val="2B2A28"/>
-                </a:solidFill>
-                <a:latin typeface="Microsoft JhengHei"/>
-              </a:rPr>
-              <a:t>简体中文</a:t>
-            </a:r>
-          </a:p>
-        </p:txBody>
-      </p:sp>
-      <p:sp>
-        <p:nvSpPr>
-          <p:cNvPr id="18" name="TextBox 17"/>
-          <p:cNvSpPr txBox="1"/>
-          <p:nvPr/>
-        </p:nvSpPr>
-        <p:spPr>
-          <a:xfrm>
-            <a:off x="9052560" y="2514600"/>
-            <a:ext cx="2606040" cy="457200"/>
-          </a:xfrm>
-          <a:prstGeom prst="rect">
-            <a:avLst/>
-          </a:prstGeom>
-          <a:noFill/>
-        </p:spPr>
-        <p:txBody>
-          <a:bodyPr wrap="square" anchor="t" lIns="45720" rIns="45720" tIns="27432" bIns="27432">
-            <a:spAutoFit/>
-          </a:bodyPr>
-          <a:lstStyle/>
-          <a:p>
-            <a:pPr algn="ctr"/>
-            <a:r>
-              <a:rPr sz="1500" b="0">
-                <a:solidFill>
-                  <a:srgbClr val="6E6A62"/>
-                </a:solidFill>
-                <a:latin typeface="Microsoft JhengHei"/>
-              </a:rPr>
-              <a:t>你好！</a:t>
-            </a:r>
-          </a:p>
-        </p:txBody>
-      </p:sp>
-      <p:sp>
-        <p:nvSpPr>
-          <p:cNvPr id="19" name="TextBox 18"/>
-          <p:cNvSpPr txBox="1"/>
-          <p:nvPr/>
-        </p:nvSpPr>
-        <p:spPr>
-          <a:xfrm>
-            <a:off x="548640" y="3566160"/>
-            <a:ext cx="10972800" cy="2743200"/>
+            <a:off x="3474720" y="2148840"/>
+            <a:ext cx="4114800" cy="4206240"/>
           </a:xfrm>
           <a:prstGeom prst="rect">
             <a:avLst/>
@@ -5542,11 +5079,11 @@
           <a:p>
             <a:pPr>
               <a:spcAft>
-                <a:spcPts val="1000"/>
+                <a:spcPts val="900"/>
               </a:spcAft>
             </a:pPr>
             <a:r>
-              <a:rPr sz="1700" b="1">
+              <a:rPr sz="1500" b="1">
                 <a:solidFill>
                   <a:srgbClr val="4CB86B"/>
                 </a:solidFill>
@@ -5555,32 +5092,32 @@
               <a:t>•  </a:t>
             </a:r>
             <a:r>
-              <a:rPr sz="1700" b="1">
-                <a:solidFill>
-                  <a:srgbClr val="2B2A28"/>
-                </a:solidFill>
-                <a:latin typeface="Segoe UI"/>
-              </a:rPr>
-              <a:t>Change anytime: </a:t>
-            </a:r>
-            <a:r>
-              <a:rPr sz="1700">
-                <a:solidFill>
-                  <a:srgbClr val="2B2A28"/>
-                </a:solidFill>
-                <a:latin typeface="Segoe UI"/>
-              </a:rPr>
-              <a:t>right-click the pet (or the card) → Language. Everything switches instantly - menus, bubbles, reminders, the card.</a:t>
+              <a:rPr sz="1500" b="1">
+                <a:solidFill>
+                  <a:srgbClr val="2B2A28"/>
+                </a:solidFill>
+                <a:latin typeface="Segoe UI"/>
+              </a:rPr>
+              <a:t>Status: </a:t>
+            </a:r>
+            <a:r>
+              <a:rPr sz="1500">
+                <a:solidFill>
+                  <a:srgbClr val="2B2A28"/>
+                </a:solidFill>
+                <a:latin typeface="Segoe UI"/>
+              </a:rPr>
+              <a:t>mood + happiness, energy, food, bond bars.</a:t>
             </a:r>
           </a:p>
           <a:p>
             <a:pPr>
               <a:spcAft>
-                <a:spcPts val="1000"/>
+                <a:spcPts val="900"/>
               </a:spcAft>
             </a:pPr>
             <a:r>
-              <a:rPr sz="1700" b="1">
+              <a:rPr sz="1500" b="1">
                 <a:solidFill>
                   <a:srgbClr val="4CB86B"/>
                 </a:solidFill>
@@ -5589,32 +5126,32 @@
               <a:t>•  </a:t>
             </a:r>
             <a:r>
-              <a:rPr sz="1700" b="1">
-                <a:solidFill>
-                  <a:srgbClr val="2B2A28"/>
-                </a:solidFill>
-                <a:latin typeface="Segoe UI"/>
-              </a:rPr>
-              <a:t>First start: </a:t>
-            </a:r>
-            <a:r>
-              <a:rPr sz="1700">
-                <a:solidFill>
-                  <a:srgbClr val="2B2A28"/>
-                </a:solidFill>
-                <a:latin typeface="Segoe UI"/>
-              </a:rPr>
-              <a:t>Pips guesses from your Windows language and asks once.</a:t>
+              <a:rPr sz="1500" b="1">
+                <a:solidFill>
+                  <a:srgbClr val="2B2A28"/>
+                </a:solidFill>
+                <a:latin typeface="Segoe UI"/>
+              </a:rPr>
+              <a:t>Animal: </a:t>
+            </a:r>
+            <a:r>
+              <a:rPr sz="1500">
+                <a:solidFill>
+                  <a:srgbClr val="2B2A28"/>
+                </a:solidFill>
+                <a:latin typeface="Segoe UI"/>
+              </a:rPr>
+              <a:t>Land / Water / Sky tabs - click a tile.</a:t>
             </a:r>
           </a:p>
           <a:p>
             <a:pPr>
               <a:spcAft>
-                <a:spcPts val="1000"/>
+                <a:spcPts val="900"/>
               </a:spcAft>
             </a:pPr>
             <a:r>
-              <a:rPr sz="1700" b="1">
+              <a:rPr sz="1500" b="1">
                 <a:solidFill>
                   <a:srgbClr val="4CB86B"/>
                 </a:solidFill>
@@ -5623,22 +5160,329 @@
               <a:t>•  </a:t>
             </a:r>
             <a:r>
-              <a:rPr sz="1700" b="1">
-                <a:solidFill>
-                  <a:srgbClr val="2B2A28"/>
-                </a:solidFill>
-                <a:latin typeface="Segoe UI"/>
-              </a:rPr>
-              <a:t>Update notes </a:t>
-            </a:r>
-            <a:r>
-              <a:rPr sz="1700">
-                <a:solidFill>
-                  <a:srgbClr val="2B2A28"/>
-                </a:solidFill>
-                <a:latin typeface="Segoe UI"/>
-              </a:rPr>
-              <a:t>are shown in your language too.</a:t>
+              <a:rPr sz="1500" b="1">
+                <a:solidFill>
+                  <a:srgbClr val="2B2A28"/>
+                </a:solidFill>
+                <a:latin typeface="Segoe UI"/>
+              </a:rPr>
+              <a:t>Look: </a:t>
+            </a:r>
+            <a:r>
+              <a:rPr sz="1500">
+                <a:solidFill>
+                  <a:srgbClr val="2B2A28"/>
+                </a:solidFill>
+                <a:latin typeface="Segoe UI"/>
+              </a:rPr>
+              <a:t>name, colour, cheeks, size S / M / L.</a:t>
+            </a:r>
+          </a:p>
+          <a:p>
+            <a:pPr>
+              <a:spcAft>
+                <a:spcPts val="900"/>
+              </a:spcAft>
+            </a:pPr>
+            <a:r>
+              <a:rPr sz="1500" b="1">
+                <a:solidFill>
+                  <a:srgbClr val="4CB86B"/>
+                </a:solidFill>
+                <a:latin typeface="Segoe UI"/>
+              </a:rPr>
+              <a:t>•  </a:t>
+            </a:r>
+            <a:r>
+              <a:rPr sz="1500" b="1">
+                <a:solidFill>
+                  <a:srgbClr val="2B2A28"/>
+                </a:solidFill>
+                <a:latin typeface="Segoe UI"/>
+              </a:rPr>
+              <a:t>Language: </a:t>
+            </a:r>
+            <a:r>
+              <a:rPr sz="1500">
+                <a:solidFill>
+                  <a:srgbClr val="2B2A28"/>
+                </a:solidFill>
+                <a:latin typeface="Segoe UI"/>
+              </a:rPr>
+              <a:t>switch instantly.</a:t>
+            </a:r>
+          </a:p>
+        </p:txBody>
+      </p:sp>
+      <p:sp>
+        <p:nvSpPr>
+          <p:cNvPr id="11" name="TextBox 10"/>
+          <p:cNvSpPr txBox="1"/>
+          <p:nvPr/>
+        </p:nvSpPr>
+        <p:spPr>
+          <a:xfrm>
+            <a:off x="7772400" y="2148840"/>
+            <a:ext cx="4114800" cy="4206240"/>
+          </a:xfrm>
+          <a:prstGeom prst="rect">
+            <a:avLst/>
+          </a:prstGeom>
+          <a:noFill/>
+        </p:spPr>
+        <p:txBody>
+          <a:bodyPr wrap="square">
+            <a:spAutoFit/>
+          </a:bodyPr>
+          <a:lstStyle/>
+          <a:p>
+            <a:pPr>
+              <a:spcAft>
+                <a:spcPts val="300"/>
+              </a:spcAft>
+            </a:pPr>
+            <a:r>
+              <a:rPr sz="1400" b="1">
+                <a:solidFill>
+                  <a:srgbClr val="4CB86B"/>
+                </a:solidFill>
+                <a:latin typeface="Segoe UI"/>
+              </a:rPr>
+              <a:t>•  </a:t>
+            </a:r>
+            <a:r>
+              <a:rPr sz="1400">
+                <a:solidFill>
+                  <a:srgbClr val="2B2A28"/>
+                </a:solidFill>
+                <a:latin typeface="Segoe UI"/>
+              </a:rPr>
+              <a:t>Click action: open card · tickle (double-click opens) · only tickle</a:t>
+            </a:r>
+          </a:p>
+          <a:p>
+            <a:pPr>
+              <a:spcAft>
+                <a:spcPts val="300"/>
+              </a:spcAft>
+            </a:pPr>
+            <a:r>
+              <a:rPr sz="1400" b="1">
+                <a:solidFill>
+                  <a:srgbClr val="4CB86B"/>
+                </a:solidFill>
+                <a:latin typeface="Segoe UI"/>
+              </a:rPr>
+              <a:t>•  </a:t>
+            </a:r>
+            <a:r>
+              <a:rPr sz="1400">
+                <a:solidFill>
+                  <a:srgbClr val="2B2A28"/>
+                </a:solidFill>
+                <a:latin typeface="Segoe UI"/>
+              </a:rPr>
+              <a:t>Show reminders as chat bubbles</a:t>
+            </a:r>
+          </a:p>
+          <a:p>
+            <a:pPr>
+              <a:spcAft>
+                <a:spcPts val="300"/>
+              </a:spcAft>
+            </a:pPr>
+            <a:r>
+              <a:rPr sz="1400" b="1">
+                <a:solidFill>
+                  <a:srgbClr val="4CB86B"/>
+                </a:solidFill>
+                <a:latin typeface="Segoe UI"/>
+              </a:rPr>
+              <a:t>•  </a:t>
+            </a:r>
+            <a:r>
+              <a:rPr sz="1400">
+                <a:solidFill>
+                  <a:srgbClr val="2B2A28"/>
+                </a:solidFill>
+                <a:latin typeface="Segoe UI"/>
+              </a:rPr>
+              <a:t>Walk around on the taskbar</a:t>
+            </a:r>
+          </a:p>
+          <a:p>
+            <a:pPr>
+              <a:spcAft>
+                <a:spcPts val="300"/>
+              </a:spcAft>
+            </a:pPr>
+            <a:r>
+              <a:rPr sz="1400" b="1">
+                <a:solidFill>
+                  <a:srgbClr val="4CB86B"/>
+                </a:solidFill>
+                <a:latin typeface="Segoe UI"/>
+              </a:rPr>
+              <a:t>•  </a:t>
+            </a:r>
+            <a:r>
+              <a:rPr sz="1400">
+                <a:solidFill>
+                  <a:srgbClr val="2B2A28"/>
+                </a:solidFill>
+                <a:latin typeface="Segoe UI"/>
+              </a:rPr>
+              <a:t>Gravity (falls when dropped)</a:t>
+            </a:r>
+          </a:p>
+          <a:p>
+            <a:pPr>
+              <a:spcAft>
+                <a:spcPts val="300"/>
+              </a:spcAft>
+            </a:pPr>
+            <a:r>
+              <a:rPr sz="1400" b="1">
+                <a:solidFill>
+                  <a:srgbClr val="4CB86B"/>
+                </a:solidFill>
+                <a:latin typeface="Segoe UI"/>
+              </a:rPr>
+              <a:t>•  </a:t>
+            </a:r>
+            <a:r>
+              <a:rPr sz="1400">
+                <a:solidFill>
+                  <a:srgbClr val="2B2A28"/>
+                </a:solidFill>
+                <a:latin typeface="Segoe UI"/>
+              </a:rPr>
+              <a:t>Nap when I'm away</a:t>
+            </a:r>
+          </a:p>
+          <a:p>
+            <a:pPr>
+              <a:spcAft>
+                <a:spcPts val="300"/>
+              </a:spcAft>
+            </a:pPr>
+            <a:r>
+              <a:rPr sz="1400" b="1">
+                <a:solidFill>
+                  <a:srgbClr val="4CB86B"/>
+                </a:solidFill>
+                <a:latin typeface="Segoe UI"/>
+              </a:rPr>
+              <a:t>•  </a:t>
+            </a:r>
+            <a:r>
+              <a:rPr sz="1400">
+                <a:solidFill>
+                  <a:srgbClr val="2B2A28"/>
+                </a:solidFill>
+                <a:latin typeface="Segoe UI"/>
+              </a:rPr>
+              <a:t>Open the card next to the pet</a:t>
+            </a:r>
+          </a:p>
+          <a:p>
+            <a:pPr>
+              <a:spcAft>
+                <a:spcPts val="300"/>
+              </a:spcAft>
+            </a:pPr>
+            <a:r>
+              <a:rPr sz="1400" b="1">
+                <a:solidFill>
+                  <a:srgbClr val="4CB86B"/>
+                </a:solidFill>
+                <a:latin typeface="Segoe UI"/>
+              </a:rPr>
+              <a:t>•  </a:t>
+            </a:r>
+            <a:r>
+              <a:rPr sz="1400">
+                <a:solidFill>
+                  <a:srgbClr val="2B2A28"/>
+                </a:solidFill>
+                <a:latin typeface="Segoe UI"/>
+              </a:rPr>
+              <a:t>Chatty (little messages)</a:t>
+            </a:r>
+          </a:p>
+          <a:p>
+            <a:pPr>
+              <a:spcAft>
+                <a:spcPts val="300"/>
+              </a:spcAft>
+            </a:pPr>
+            <a:r>
+              <a:rPr sz="1400" b="1">
+                <a:solidFill>
+                  <a:srgbClr val="4CB86B"/>
+                </a:solidFill>
+                <a:latin typeface="Segoe UI"/>
+              </a:rPr>
+              <a:t>•  </a:t>
+            </a:r>
+            <a:r>
+              <a:rPr sz="1400">
+                <a:solidFill>
+                  <a:srgbClr val="2B2A28"/>
+                </a:solidFill>
+                <a:latin typeface="Segoe UI"/>
+              </a:rPr>
+              <a:t>Hide during full-screen apps</a:t>
+            </a:r>
+          </a:p>
+          <a:p>
+            <a:pPr>
+              <a:spcAft>
+                <a:spcPts val="300"/>
+              </a:spcAft>
+            </a:pPr>
+            <a:r>
+              <a:rPr sz="1400" b="1">
+                <a:solidFill>
+                  <a:srgbClr val="4CB86B"/>
+                </a:solidFill>
+                <a:latin typeface="Segoe UI"/>
+              </a:rPr>
+              <a:t>•  </a:t>
+            </a:r>
+            <a:r>
+              <a:rPr sz="1400">
+                <a:solidFill>
+                  <a:srgbClr val="2B2A28"/>
+                </a:solidFill>
+                <a:latin typeface="Segoe UI"/>
+              </a:rPr>
+              <a:t>Check for updates automatically</a:t>
+            </a:r>
+          </a:p>
+          <a:p>
+            <a:pPr>
+              <a:spcAft>
+                <a:spcPts val="300"/>
+              </a:spcAft>
+            </a:pPr>
+            <a:r>
+              <a:rPr sz="1400" b="1">
+                <a:solidFill>
+                  <a:srgbClr val="4CB86B"/>
+                </a:solidFill>
+                <a:latin typeface="Segoe UI"/>
+              </a:rPr>
+              <a:t>•  </a:t>
+            </a:r>
+            <a:r>
+              <a:rPr sz="1400">
+                <a:solidFill>
+                  <a:srgbClr val="2B2A28"/>
+                </a:solidFill>
+                <a:latin typeface="Segoe UI"/>
+              </a:rPr>
+              <a:t>Animal sounds + volume (quiet while focusing)</a:t>
             </a:r>
           </a:p>
         </p:txBody>
@@ -5742,7 +5586,7 @@
                 </a:solidFill>
                 <a:latin typeface="Segoe UI"/>
               </a:rPr>
-              <a:t>NEW IN 2.1</a:t>
+              <a:t>CUSTOMIZE</a:t>
             </a:r>
           </a:p>
         </p:txBody>
@@ -5777,7 +5621,7 @@
                 </a:solidFill>
                 <a:latin typeface="Segoe UI"/>
               </a:rPr>
-              <a:t>Updates - right inside Pips</a:t>
+              <a:t>Languages</a:t>
             </a:r>
           </a:p>
         </p:txBody>
@@ -5860,35 +5704,54 @@
           </a:p>
         </p:txBody>
       </p:sp>
-      <p:pic>
-        <p:nvPicPr>
-          <p:cNvPr id="7" name="Picture 6" descr="update_offer.png"/>
-          <p:cNvPicPr>
-            <a:picLocks noChangeAspect="1"/>
-          </p:cNvPicPr>
-          <p:nvPr/>
-        </p:nvPicPr>
-        <p:blipFill>
-          <a:blip r:embed="rId2"/>
-          <a:stretch>
-            <a:fillRect/>
-          </a:stretch>
-        </p:blipFill>
-        <p:spPr>
-          <a:xfrm>
-            <a:off x="572153" y="1645920"/>
-            <a:ext cx="4890733" cy="3291840"/>
-          </a:xfrm>
-          <a:prstGeom prst="rect">
-            <a:avLst/>
-          </a:prstGeom>
+      <p:sp>
+        <p:nvSpPr>
+          <p:cNvPr id="7" name="Rounded Rectangle 6"/>
+          <p:cNvSpPr/>
+          <p:nvPr/>
+        </p:nvSpPr>
+        <p:spPr>
+          <a:xfrm>
+            <a:off x="548640" y="1737360"/>
+            <a:ext cx="2606040" cy="1463040"/>
+          </a:xfrm>
+          <a:prstGeom prst="roundRect">
+            <a:avLst>
+              <a:gd name="adj" fmla="val 6000"/>
+            </a:avLst>
+          </a:prstGeom>
+          <a:solidFill>
+            <a:srgbClr val="FFFDF8"/>
+          </a:solidFill>
           <a:ln w="12700">
             <a:solidFill>
               <a:srgbClr val="E2DCCE"/>
             </a:solidFill>
           </a:ln>
-        </p:spPr>
-      </p:pic>
+          <a:effectLst/>
+        </p:spPr>
+        <p:style>
+          <a:lnRef idx="1">
+            <a:schemeClr val="accent1"/>
+          </a:lnRef>
+          <a:fillRef idx="3">
+            <a:schemeClr val="accent1"/>
+          </a:fillRef>
+          <a:effectRef idx="2">
+            <a:schemeClr val="accent1"/>
+          </a:effectRef>
+          <a:fontRef idx="minor">
+            <a:schemeClr val="lt1"/>
+          </a:fontRef>
+        </p:style>
+        <p:txBody>
+          <a:bodyPr rtlCol="0" anchor="ctr"/>
+          <a:lstStyle/>
+          <a:p>
+            <a:pPr algn="ctr"/>
+          </a:p>
+        </p:txBody>
+      </p:sp>
       <p:sp>
         <p:nvSpPr>
           <p:cNvPr id="8" name="TextBox 7"/>
@@ -5897,8 +5760,8 @@
         </p:nvSpPr>
         <p:spPr>
           <a:xfrm>
-            <a:off x="548640" y="4983480"/>
-            <a:ext cx="4937760" cy="365760"/>
+            <a:off x="548640" y="1920240"/>
+            <a:ext cx="2606040" cy="548640"/>
           </a:xfrm>
           <a:prstGeom prst="rect">
             <a:avLst/>
@@ -5913,13 +5776,13 @@
           <a:p>
             <a:pPr algn="ctr"/>
             <a:r>
-              <a:rPr sz="1200" b="0">
-                <a:solidFill>
-                  <a:srgbClr val="6E6A62"/>
-                </a:solidFill>
-                <a:latin typeface="Segoe UI"/>
-              </a:rPr>
-              <a:t>Example of an update notice (sample version text)</a:t>
+              <a:rPr sz="2000" b="1">
+                <a:solidFill>
+                  <a:srgbClr val="2B2A28"/>
+                </a:solidFill>
+                <a:latin typeface="Microsoft JhengHei"/>
+              </a:rPr>
+              <a:t>English</a:t>
             </a:r>
           </a:p>
         </p:txBody>
@@ -5932,8 +5795,397 @@
         </p:nvSpPr>
         <p:spPr>
           <a:xfrm>
-            <a:off x="5852160" y="1645920"/>
-            <a:ext cx="5943600" cy="4572000"/>
+            <a:off x="548640" y="2514600"/>
+            <a:ext cx="2606040" cy="457200"/>
+          </a:xfrm>
+          <a:prstGeom prst="rect">
+            <a:avLst/>
+          </a:prstGeom>
+          <a:noFill/>
+        </p:spPr>
+        <p:txBody>
+          <a:bodyPr wrap="square" anchor="t" lIns="45720" rIns="45720" tIns="27432" bIns="27432">
+            <a:spAutoFit/>
+          </a:bodyPr>
+          <a:lstStyle/>
+          <a:p>
+            <a:pPr algn="ctr"/>
+            <a:r>
+              <a:rPr sz="1500" b="0">
+                <a:solidFill>
+                  <a:srgbClr val="6E6A62"/>
+                </a:solidFill>
+                <a:latin typeface="Microsoft JhengHei"/>
+              </a:rPr>
+              <a:t>Hello!</a:t>
+            </a:r>
+          </a:p>
+        </p:txBody>
+      </p:sp>
+      <p:sp>
+        <p:nvSpPr>
+          <p:cNvPr id="10" name="Rounded Rectangle 9"/>
+          <p:cNvSpPr/>
+          <p:nvPr/>
+        </p:nvSpPr>
+        <p:spPr>
+          <a:xfrm>
+            <a:off x="3383280" y="1737360"/>
+            <a:ext cx="2606040" cy="1463040"/>
+          </a:xfrm>
+          <a:prstGeom prst="roundRect">
+            <a:avLst>
+              <a:gd name="adj" fmla="val 6000"/>
+            </a:avLst>
+          </a:prstGeom>
+          <a:solidFill>
+            <a:srgbClr val="FFFDF8"/>
+          </a:solidFill>
+          <a:ln w="12700">
+            <a:solidFill>
+              <a:srgbClr val="E2DCCE"/>
+            </a:solidFill>
+          </a:ln>
+          <a:effectLst/>
+        </p:spPr>
+        <p:style>
+          <a:lnRef idx="1">
+            <a:schemeClr val="accent1"/>
+          </a:lnRef>
+          <a:fillRef idx="3">
+            <a:schemeClr val="accent1"/>
+          </a:fillRef>
+          <a:effectRef idx="2">
+            <a:schemeClr val="accent1"/>
+          </a:effectRef>
+          <a:fontRef idx="minor">
+            <a:schemeClr val="lt1"/>
+          </a:fontRef>
+        </p:style>
+        <p:txBody>
+          <a:bodyPr rtlCol="0" anchor="ctr"/>
+          <a:lstStyle/>
+          <a:p>
+            <a:pPr algn="ctr"/>
+          </a:p>
+        </p:txBody>
+      </p:sp>
+      <p:sp>
+        <p:nvSpPr>
+          <p:cNvPr id="11" name="TextBox 10"/>
+          <p:cNvSpPr txBox="1"/>
+          <p:nvPr/>
+        </p:nvSpPr>
+        <p:spPr>
+          <a:xfrm>
+            <a:off x="3383280" y="1920240"/>
+            <a:ext cx="2606040" cy="548640"/>
+          </a:xfrm>
+          <a:prstGeom prst="rect">
+            <a:avLst/>
+          </a:prstGeom>
+          <a:noFill/>
+        </p:spPr>
+        <p:txBody>
+          <a:bodyPr wrap="square" anchor="t" lIns="45720" rIns="45720" tIns="27432" bIns="27432">
+            <a:spAutoFit/>
+          </a:bodyPr>
+          <a:lstStyle/>
+          <a:p>
+            <a:pPr algn="ctr"/>
+            <a:r>
+              <a:rPr sz="2000" b="1">
+                <a:solidFill>
+                  <a:srgbClr val="2B2A28"/>
+                </a:solidFill>
+                <a:latin typeface="Microsoft JhengHei"/>
+              </a:rPr>
+              <a:t>Bahasa Indonesia</a:t>
+            </a:r>
+          </a:p>
+        </p:txBody>
+      </p:sp>
+      <p:sp>
+        <p:nvSpPr>
+          <p:cNvPr id="12" name="TextBox 11"/>
+          <p:cNvSpPr txBox="1"/>
+          <p:nvPr/>
+        </p:nvSpPr>
+        <p:spPr>
+          <a:xfrm>
+            <a:off x="3383280" y="2514600"/>
+            <a:ext cx="2606040" cy="457200"/>
+          </a:xfrm>
+          <a:prstGeom prst="rect">
+            <a:avLst/>
+          </a:prstGeom>
+          <a:noFill/>
+        </p:spPr>
+        <p:txBody>
+          <a:bodyPr wrap="square" anchor="t" lIns="45720" rIns="45720" tIns="27432" bIns="27432">
+            <a:spAutoFit/>
+          </a:bodyPr>
+          <a:lstStyle/>
+          <a:p>
+            <a:pPr algn="ctr"/>
+            <a:r>
+              <a:rPr sz="1500" b="0">
+                <a:solidFill>
+                  <a:srgbClr val="6E6A62"/>
+                </a:solidFill>
+                <a:latin typeface="Microsoft JhengHei"/>
+              </a:rPr>
+              <a:t>Halo!</a:t>
+            </a:r>
+          </a:p>
+        </p:txBody>
+      </p:sp>
+      <p:sp>
+        <p:nvSpPr>
+          <p:cNvPr id="13" name="Rounded Rectangle 12"/>
+          <p:cNvSpPr/>
+          <p:nvPr/>
+        </p:nvSpPr>
+        <p:spPr>
+          <a:xfrm>
+            <a:off x="6217920" y="1737360"/>
+            <a:ext cx="2606040" cy="1463040"/>
+          </a:xfrm>
+          <a:prstGeom prst="roundRect">
+            <a:avLst>
+              <a:gd name="adj" fmla="val 6000"/>
+            </a:avLst>
+          </a:prstGeom>
+          <a:solidFill>
+            <a:srgbClr val="FFFDF8"/>
+          </a:solidFill>
+          <a:ln w="12700">
+            <a:solidFill>
+              <a:srgbClr val="E2DCCE"/>
+            </a:solidFill>
+          </a:ln>
+          <a:effectLst/>
+        </p:spPr>
+        <p:style>
+          <a:lnRef idx="1">
+            <a:schemeClr val="accent1"/>
+          </a:lnRef>
+          <a:fillRef idx="3">
+            <a:schemeClr val="accent1"/>
+          </a:fillRef>
+          <a:effectRef idx="2">
+            <a:schemeClr val="accent1"/>
+          </a:effectRef>
+          <a:fontRef idx="minor">
+            <a:schemeClr val="lt1"/>
+          </a:fontRef>
+        </p:style>
+        <p:txBody>
+          <a:bodyPr rtlCol="0" anchor="ctr"/>
+          <a:lstStyle/>
+          <a:p>
+            <a:pPr algn="ctr"/>
+          </a:p>
+        </p:txBody>
+      </p:sp>
+      <p:sp>
+        <p:nvSpPr>
+          <p:cNvPr id="14" name="TextBox 13"/>
+          <p:cNvSpPr txBox="1"/>
+          <p:nvPr/>
+        </p:nvSpPr>
+        <p:spPr>
+          <a:xfrm>
+            <a:off x="6217920" y="1920240"/>
+            <a:ext cx="2606040" cy="548640"/>
+          </a:xfrm>
+          <a:prstGeom prst="rect">
+            <a:avLst/>
+          </a:prstGeom>
+          <a:noFill/>
+        </p:spPr>
+        <p:txBody>
+          <a:bodyPr wrap="square" anchor="t" lIns="45720" rIns="45720" tIns="27432" bIns="27432">
+            <a:spAutoFit/>
+          </a:bodyPr>
+          <a:lstStyle/>
+          <a:p>
+            <a:pPr algn="ctr"/>
+            <a:r>
+              <a:rPr sz="2000" b="1">
+                <a:solidFill>
+                  <a:srgbClr val="2B2A28"/>
+                </a:solidFill>
+                <a:latin typeface="Microsoft JhengHei"/>
+              </a:rPr>
+              <a:t>繁體中文</a:t>
+            </a:r>
+          </a:p>
+        </p:txBody>
+      </p:sp>
+      <p:sp>
+        <p:nvSpPr>
+          <p:cNvPr id="15" name="TextBox 14"/>
+          <p:cNvSpPr txBox="1"/>
+          <p:nvPr/>
+        </p:nvSpPr>
+        <p:spPr>
+          <a:xfrm>
+            <a:off x="6217920" y="2514600"/>
+            <a:ext cx="2606040" cy="457200"/>
+          </a:xfrm>
+          <a:prstGeom prst="rect">
+            <a:avLst/>
+          </a:prstGeom>
+          <a:noFill/>
+        </p:spPr>
+        <p:txBody>
+          <a:bodyPr wrap="square" anchor="t" lIns="45720" rIns="45720" tIns="27432" bIns="27432">
+            <a:spAutoFit/>
+          </a:bodyPr>
+          <a:lstStyle/>
+          <a:p>
+            <a:pPr algn="ctr"/>
+            <a:r>
+              <a:rPr sz="1500" b="0">
+                <a:solidFill>
+                  <a:srgbClr val="6E6A62"/>
+                </a:solidFill>
+                <a:latin typeface="Microsoft JhengHei"/>
+              </a:rPr>
+              <a:t>你好！</a:t>
+            </a:r>
+          </a:p>
+        </p:txBody>
+      </p:sp>
+      <p:sp>
+        <p:nvSpPr>
+          <p:cNvPr id="16" name="Rounded Rectangle 15"/>
+          <p:cNvSpPr/>
+          <p:nvPr/>
+        </p:nvSpPr>
+        <p:spPr>
+          <a:xfrm>
+            <a:off x="9052560" y="1737360"/>
+            <a:ext cx="2606040" cy="1463040"/>
+          </a:xfrm>
+          <a:prstGeom prst="roundRect">
+            <a:avLst>
+              <a:gd name="adj" fmla="val 6000"/>
+            </a:avLst>
+          </a:prstGeom>
+          <a:solidFill>
+            <a:srgbClr val="FFFDF8"/>
+          </a:solidFill>
+          <a:ln w="12700">
+            <a:solidFill>
+              <a:srgbClr val="E2DCCE"/>
+            </a:solidFill>
+          </a:ln>
+          <a:effectLst/>
+        </p:spPr>
+        <p:style>
+          <a:lnRef idx="1">
+            <a:schemeClr val="accent1"/>
+          </a:lnRef>
+          <a:fillRef idx="3">
+            <a:schemeClr val="accent1"/>
+          </a:fillRef>
+          <a:effectRef idx="2">
+            <a:schemeClr val="accent1"/>
+          </a:effectRef>
+          <a:fontRef idx="minor">
+            <a:schemeClr val="lt1"/>
+          </a:fontRef>
+        </p:style>
+        <p:txBody>
+          <a:bodyPr rtlCol="0" anchor="ctr"/>
+          <a:lstStyle/>
+          <a:p>
+            <a:pPr algn="ctr"/>
+          </a:p>
+        </p:txBody>
+      </p:sp>
+      <p:sp>
+        <p:nvSpPr>
+          <p:cNvPr id="17" name="TextBox 16"/>
+          <p:cNvSpPr txBox="1"/>
+          <p:nvPr/>
+        </p:nvSpPr>
+        <p:spPr>
+          <a:xfrm>
+            <a:off x="9052560" y="1920240"/>
+            <a:ext cx="2606040" cy="548640"/>
+          </a:xfrm>
+          <a:prstGeom prst="rect">
+            <a:avLst/>
+          </a:prstGeom>
+          <a:noFill/>
+        </p:spPr>
+        <p:txBody>
+          <a:bodyPr wrap="square" anchor="t" lIns="45720" rIns="45720" tIns="27432" bIns="27432">
+            <a:spAutoFit/>
+          </a:bodyPr>
+          <a:lstStyle/>
+          <a:p>
+            <a:pPr algn="ctr"/>
+            <a:r>
+              <a:rPr sz="2000" b="1">
+                <a:solidFill>
+                  <a:srgbClr val="2B2A28"/>
+                </a:solidFill>
+                <a:latin typeface="Microsoft JhengHei"/>
+              </a:rPr>
+              <a:t>简体中文</a:t>
+            </a:r>
+          </a:p>
+        </p:txBody>
+      </p:sp>
+      <p:sp>
+        <p:nvSpPr>
+          <p:cNvPr id="18" name="TextBox 17"/>
+          <p:cNvSpPr txBox="1"/>
+          <p:nvPr/>
+        </p:nvSpPr>
+        <p:spPr>
+          <a:xfrm>
+            <a:off x="9052560" y="2514600"/>
+            <a:ext cx="2606040" cy="457200"/>
+          </a:xfrm>
+          <a:prstGeom prst="rect">
+            <a:avLst/>
+          </a:prstGeom>
+          <a:noFill/>
+        </p:spPr>
+        <p:txBody>
+          <a:bodyPr wrap="square" anchor="t" lIns="45720" rIns="45720" tIns="27432" bIns="27432">
+            <a:spAutoFit/>
+          </a:bodyPr>
+          <a:lstStyle/>
+          <a:p>
+            <a:pPr algn="ctr"/>
+            <a:r>
+              <a:rPr sz="1500" b="0">
+                <a:solidFill>
+                  <a:srgbClr val="6E6A62"/>
+                </a:solidFill>
+                <a:latin typeface="Microsoft JhengHei"/>
+              </a:rPr>
+              <a:t>你好！</a:t>
+            </a:r>
+          </a:p>
+        </p:txBody>
+      </p:sp>
+      <p:sp>
+        <p:nvSpPr>
+          <p:cNvPr id="19" name="TextBox 18"/>
+          <p:cNvSpPr txBox="1"/>
+          <p:nvPr/>
+        </p:nvSpPr>
+        <p:spPr>
+          <a:xfrm>
+            <a:off x="548640" y="3566160"/>
+            <a:ext cx="10972800" cy="2743200"/>
           </a:xfrm>
           <a:prstGeom prst="rect">
             <a:avLst/>
@@ -5948,11 +6200,11 @@
           <a:p>
             <a:pPr>
               <a:spcAft>
-                <a:spcPts val="900"/>
+                <a:spcPts val="1000"/>
               </a:spcAft>
             </a:pPr>
             <a:r>
-              <a:rPr sz="1500" b="1">
+              <a:rPr sz="1700" b="1">
                 <a:solidFill>
                   <a:srgbClr val="4CB86B"/>
                 </a:solidFill>
@@ -5961,32 +6213,32 @@
               <a:t>•  </a:t>
             </a:r>
             <a:r>
-              <a:rPr sz="1500" b="1">
-                <a:solidFill>
-                  <a:srgbClr val="2B2A28"/>
-                </a:solidFill>
-                <a:latin typeface="Segoe UI"/>
-              </a:rPr>
-              <a:t>Automatic check: </a:t>
-            </a:r>
-            <a:r>
-              <a:rPr sz="1500">
-                <a:solidFill>
-                  <a:srgbClr val="2B2A28"/>
-                </a:solidFill>
-                <a:latin typeface="Segoe UI"/>
-              </a:rPr>
-              <a:t>shortly after start and every 6 hours (needs internet).</a:t>
+              <a:rPr sz="1700" b="1">
+                <a:solidFill>
+                  <a:srgbClr val="2B2A28"/>
+                </a:solidFill>
+                <a:latin typeface="Segoe UI"/>
+              </a:rPr>
+              <a:t>Change anytime: </a:t>
+            </a:r>
+            <a:r>
+              <a:rPr sz="1700">
+                <a:solidFill>
+                  <a:srgbClr val="2B2A28"/>
+                </a:solidFill>
+                <a:latin typeface="Segoe UI"/>
+              </a:rPr>
+              <a:t>right-click the pet (or the card) → Language. Everything switches instantly - menus, bubbles, reminders, the card.</a:t>
             </a:r>
           </a:p>
           <a:p>
             <a:pPr>
               <a:spcAft>
-                <a:spcPts val="900"/>
+                <a:spcPts val="1000"/>
               </a:spcAft>
             </a:pPr>
             <a:r>
-              <a:rPr sz="1500" b="1">
+              <a:rPr sz="1700" b="1">
                 <a:solidFill>
                   <a:srgbClr val="4CB86B"/>
                 </a:solidFill>
@@ -5995,32 +6247,32 @@
               <a:t>•  </a:t>
             </a:r>
             <a:r>
-              <a:rPr sz="1500" b="1">
-                <a:solidFill>
-                  <a:srgbClr val="2B2A28"/>
-                </a:solidFill>
-                <a:latin typeface="Segoe UI"/>
-              </a:rPr>
-              <a:t>Your pet tells you </a:t>
-            </a:r>
-            <a:r>
-              <a:rPr sz="1500">
-                <a:solidFill>
-                  <a:srgbClr val="2B2A28"/>
-                </a:solidFill>
-                <a:latin typeface="Segoe UI"/>
-              </a:rPr>
-              <a:t>what's new and offers: Update now · Later · Skip this version.</a:t>
+              <a:rPr sz="1700" b="1">
+                <a:solidFill>
+                  <a:srgbClr val="2B2A28"/>
+                </a:solidFill>
+                <a:latin typeface="Segoe UI"/>
+              </a:rPr>
+              <a:t>First start: </a:t>
+            </a:r>
+            <a:r>
+              <a:rPr sz="1700">
+                <a:solidFill>
+                  <a:srgbClr val="2B2A28"/>
+                </a:solidFill>
+                <a:latin typeface="Segoe UI"/>
+              </a:rPr>
+              <a:t>Pips guesses from your Windows language and asks once.</a:t>
             </a:r>
           </a:p>
           <a:p>
             <a:pPr>
               <a:spcAft>
-                <a:spcPts val="900"/>
+                <a:spcPts val="1000"/>
               </a:spcAft>
             </a:pPr>
             <a:r>
-              <a:rPr sz="1500" b="1">
+              <a:rPr sz="1700" b="1">
                 <a:solidFill>
                   <a:srgbClr val="4CB86B"/>
                 </a:solidFill>
@@ -6029,124 +6281,22 @@
               <a:t>•  </a:t>
             </a:r>
             <a:r>
-              <a:rPr sz="1500" b="1">
-                <a:solidFill>
-                  <a:srgbClr val="2B2A28"/>
-                </a:solidFill>
-                <a:latin typeface="Segoe UI"/>
-              </a:rPr>
-              <a:t>Update now: </a:t>
-            </a:r>
-            <a:r>
-              <a:rPr sz="1500">
-                <a:solidFill>
-                  <a:srgbClr val="2B2A28"/>
-                </a:solidFill>
-                <a:latin typeface="Segoe UI"/>
-              </a:rPr>
-              <a:t>downloads, verifies (SHA-256), installs and restarts Pips by itself - about 10 seconds.</a:t>
-            </a:r>
-          </a:p>
-          <a:p>
-            <a:pPr>
-              <a:spcAft>
-                <a:spcPts val="900"/>
-              </a:spcAft>
-            </a:pPr>
-            <a:r>
-              <a:rPr sz="1500" b="1">
-                <a:solidFill>
-                  <a:srgbClr val="4CB86B"/>
-                </a:solidFill>
-                <a:latin typeface="Segoe UI"/>
-              </a:rPr>
-              <a:t>•  </a:t>
-            </a:r>
-            <a:r>
-              <a:rPr sz="1500" b="1">
-                <a:solidFill>
-                  <a:srgbClr val="2B2A28"/>
-                </a:solidFill>
-                <a:latin typeface="Segoe UI"/>
-              </a:rPr>
-              <a:t>Your stuff is safe: </a:t>
-            </a:r>
-            <a:r>
-              <a:rPr sz="1500">
-                <a:solidFill>
-                  <a:srgbClr val="2B2A28"/>
-                </a:solidFill>
-                <a:latin typeface="Segoe UI"/>
-              </a:rPr>
-              <a:t>settings, pet, history and reports are never touched. The old version is backed up in the backup\ folder.</a:t>
-            </a:r>
-          </a:p>
-          <a:p>
-            <a:pPr>
-              <a:spcAft>
-                <a:spcPts val="900"/>
-              </a:spcAft>
-            </a:pPr>
-            <a:r>
-              <a:rPr sz="1500" b="1">
-                <a:solidFill>
-                  <a:srgbClr val="4CB86B"/>
-                </a:solidFill>
-                <a:latin typeface="Segoe UI"/>
-              </a:rPr>
-              <a:t>•  </a:t>
-            </a:r>
-            <a:r>
-              <a:rPr sz="1500" b="1">
-                <a:solidFill>
-                  <a:srgbClr val="2B2A28"/>
-                </a:solidFill>
-                <a:latin typeface="Segoe UI"/>
-              </a:rPr>
-              <a:t>Manual check: </a:t>
-            </a:r>
-            <a:r>
-              <a:rPr sz="1500">
-                <a:solidFill>
-                  <a:srgbClr val="2B2A28"/>
-                </a:solidFill>
-                <a:latin typeface="Segoe UI"/>
-              </a:rPr>
-              <a:t>right-click the pet → Help → Check for updates.</a:t>
-            </a:r>
-          </a:p>
-          <a:p>
-            <a:pPr>
-              <a:spcAft>
-                <a:spcPts val="900"/>
-              </a:spcAft>
-            </a:pPr>
-            <a:r>
-              <a:rPr sz="1500" b="1">
-                <a:solidFill>
-                  <a:srgbClr val="4CB86B"/>
-                </a:solidFill>
-                <a:latin typeface="Segoe UI"/>
-              </a:rPr>
-              <a:t>•  </a:t>
-            </a:r>
-            <a:r>
-              <a:rPr sz="1500" b="1">
-                <a:solidFill>
-                  <a:srgbClr val="2B2A28"/>
-                </a:solidFill>
-                <a:latin typeface="Segoe UI"/>
-              </a:rPr>
-              <a:t>Don't want it? </a:t>
-            </a:r>
-            <a:r>
-              <a:rPr sz="1500">
-                <a:solidFill>
-                  <a:srgbClr val="2B2A28"/>
-                </a:solidFill>
-                <a:latin typeface="Segoe UI"/>
-              </a:rPr>
-              <a:t>Pet status &amp; settings → uncheck “Check for updates automatically”.</a:t>
+              <a:rPr sz="1700" b="1">
+                <a:solidFill>
+                  <a:srgbClr val="2B2A28"/>
+                </a:solidFill>
+                <a:latin typeface="Segoe UI"/>
+              </a:rPr>
+              <a:t>Update notes </a:t>
+            </a:r>
+            <a:r>
+              <a:rPr sz="1700">
+                <a:solidFill>
+                  <a:srgbClr val="2B2A28"/>
+                </a:solidFill>
+                <a:latin typeface="Segoe UI"/>
+              </a:rPr>
+              <a:t>are shown in your language too.</a:t>
             </a:r>
           </a:p>
         </p:txBody>
@@ -6250,7 +6400,7 @@
                 </a:solidFill>
                 <a:latin typeface="Segoe UI"/>
               </a:rPr>
-              <a:t>HELP</a:t>
+              <a:t>NEW IN 2.1</a:t>
             </a:r>
           </a:p>
         </p:txBody>
@@ -6285,7 +6435,7 @@
                 </a:solidFill>
                 <a:latin typeface="Segoe UI"/>
               </a:rPr>
-              <a:t>Troubleshooting &amp; FAQ</a:t>
+              <a:t>Updates - right inside Pips</a:t>
             </a:r>
           </a:p>
         </p:txBody>
@@ -6364,6 +6514,514 @@
                 <a:latin typeface="Segoe UI"/>
               </a:rPr>
               <a:t>Pips · 14</a:t>
+            </a:r>
+          </a:p>
+        </p:txBody>
+      </p:sp>
+      <p:pic>
+        <p:nvPicPr>
+          <p:cNvPr id="7" name="Picture 6" descr="update_offer.png"/>
+          <p:cNvPicPr>
+            <a:picLocks noChangeAspect="1"/>
+          </p:cNvPicPr>
+          <p:nvPr/>
+        </p:nvPicPr>
+        <p:blipFill>
+          <a:blip r:embed="rId2"/>
+          <a:stretch>
+            <a:fillRect/>
+          </a:stretch>
+        </p:blipFill>
+        <p:spPr>
+          <a:xfrm>
+            <a:off x="572153" y="1645920"/>
+            <a:ext cx="4890733" cy="3291840"/>
+          </a:xfrm>
+          <a:prstGeom prst="rect">
+            <a:avLst/>
+          </a:prstGeom>
+          <a:ln w="12700">
+            <a:solidFill>
+              <a:srgbClr val="E2DCCE"/>
+            </a:solidFill>
+          </a:ln>
+        </p:spPr>
+      </p:pic>
+      <p:sp>
+        <p:nvSpPr>
+          <p:cNvPr id="8" name="TextBox 7"/>
+          <p:cNvSpPr txBox="1"/>
+          <p:nvPr/>
+        </p:nvSpPr>
+        <p:spPr>
+          <a:xfrm>
+            <a:off x="548640" y="4983480"/>
+            <a:ext cx="4937760" cy="365760"/>
+          </a:xfrm>
+          <a:prstGeom prst="rect">
+            <a:avLst/>
+          </a:prstGeom>
+          <a:noFill/>
+        </p:spPr>
+        <p:txBody>
+          <a:bodyPr wrap="square" anchor="t" lIns="45720" rIns="45720" tIns="27432" bIns="27432">
+            <a:spAutoFit/>
+          </a:bodyPr>
+          <a:lstStyle/>
+          <a:p>
+            <a:pPr algn="ctr"/>
+            <a:r>
+              <a:rPr sz="1200" b="0">
+                <a:solidFill>
+                  <a:srgbClr val="6E6A62"/>
+                </a:solidFill>
+                <a:latin typeface="Segoe UI"/>
+              </a:rPr>
+              <a:t>Example of an update notice (sample version text)</a:t>
+            </a:r>
+          </a:p>
+        </p:txBody>
+      </p:sp>
+      <p:sp>
+        <p:nvSpPr>
+          <p:cNvPr id="9" name="TextBox 8"/>
+          <p:cNvSpPr txBox="1"/>
+          <p:nvPr/>
+        </p:nvSpPr>
+        <p:spPr>
+          <a:xfrm>
+            <a:off x="5852160" y="1645920"/>
+            <a:ext cx="5943600" cy="4572000"/>
+          </a:xfrm>
+          <a:prstGeom prst="rect">
+            <a:avLst/>
+          </a:prstGeom>
+          <a:noFill/>
+        </p:spPr>
+        <p:txBody>
+          <a:bodyPr wrap="square">
+            <a:spAutoFit/>
+          </a:bodyPr>
+          <a:lstStyle/>
+          <a:p>
+            <a:pPr>
+              <a:spcAft>
+                <a:spcPts val="900"/>
+              </a:spcAft>
+            </a:pPr>
+            <a:r>
+              <a:rPr sz="1500" b="1">
+                <a:solidFill>
+                  <a:srgbClr val="4CB86B"/>
+                </a:solidFill>
+                <a:latin typeface="Segoe UI"/>
+              </a:rPr>
+              <a:t>•  </a:t>
+            </a:r>
+            <a:r>
+              <a:rPr sz="1500" b="1">
+                <a:solidFill>
+                  <a:srgbClr val="2B2A28"/>
+                </a:solidFill>
+                <a:latin typeface="Segoe UI"/>
+              </a:rPr>
+              <a:t>Automatic check: </a:t>
+            </a:r>
+            <a:r>
+              <a:rPr sz="1500">
+                <a:solidFill>
+                  <a:srgbClr val="2B2A28"/>
+                </a:solidFill>
+                <a:latin typeface="Segoe UI"/>
+              </a:rPr>
+              <a:t>shortly after start and every 6 hours (needs internet).</a:t>
+            </a:r>
+          </a:p>
+          <a:p>
+            <a:pPr>
+              <a:spcAft>
+                <a:spcPts val="900"/>
+              </a:spcAft>
+            </a:pPr>
+            <a:r>
+              <a:rPr sz="1500" b="1">
+                <a:solidFill>
+                  <a:srgbClr val="4CB86B"/>
+                </a:solidFill>
+                <a:latin typeface="Segoe UI"/>
+              </a:rPr>
+              <a:t>•  </a:t>
+            </a:r>
+            <a:r>
+              <a:rPr sz="1500" b="1">
+                <a:solidFill>
+                  <a:srgbClr val="2B2A28"/>
+                </a:solidFill>
+                <a:latin typeface="Segoe UI"/>
+              </a:rPr>
+              <a:t>Your pet tells you </a:t>
+            </a:r>
+            <a:r>
+              <a:rPr sz="1500">
+                <a:solidFill>
+                  <a:srgbClr val="2B2A28"/>
+                </a:solidFill>
+                <a:latin typeface="Segoe UI"/>
+              </a:rPr>
+              <a:t>what's new and offers: Update now · Later · Skip this version.</a:t>
+            </a:r>
+          </a:p>
+          <a:p>
+            <a:pPr>
+              <a:spcAft>
+                <a:spcPts val="900"/>
+              </a:spcAft>
+            </a:pPr>
+            <a:r>
+              <a:rPr sz="1500" b="1">
+                <a:solidFill>
+                  <a:srgbClr val="4CB86B"/>
+                </a:solidFill>
+                <a:latin typeface="Segoe UI"/>
+              </a:rPr>
+              <a:t>•  </a:t>
+            </a:r>
+            <a:r>
+              <a:rPr sz="1500" b="1">
+                <a:solidFill>
+                  <a:srgbClr val="2B2A28"/>
+                </a:solidFill>
+                <a:latin typeface="Segoe UI"/>
+              </a:rPr>
+              <a:t>Update now: </a:t>
+            </a:r>
+            <a:r>
+              <a:rPr sz="1500">
+                <a:solidFill>
+                  <a:srgbClr val="2B2A28"/>
+                </a:solidFill>
+                <a:latin typeface="Segoe UI"/>
+              </a:rPr>
+              <a:t>downloads, verifies (SHA-256), installs and restarts Pips by itself - about 10 seconds.</a:t>
+            </a:r>
+          </a:p>
+          <a:p>
+            <a:pPr>
+              <a:spcAft>
+                <a:spcPts val="900"/>
+              </a:spcAft>
+            </a:pPr>
+            <a:r>
+              <a:rPr sz="1500" b="1">
+                <a:solidFill>
+                  <a:srgbClr val="4CB86B"/>
+                </a:solidFill>
+                <a:latin typeface="Segoe UI"/>
+              </a:rPr>
+              <a:t>•  </a:t>
+            </a:r>
+            <a:r>
+              <a:rPr sz="1500" b="1">
+                <a:solidFill>
+                  <a:srgbClr val="2B2A28"/>
+                </a:solidFill>
+                <a:latin typeface="Segoe UI"/>
+              </a:rPr>
+              <a:t>Your stuff is safe: </a:t>
+            </a:r>
+            <a:r>
+              <a:rPr sz="1500">
+                <a:solidFill>
+                  <a:srgbClr val="2B2A28"/>
+                </a:solidFill>
+                <a:latin typeface="Segoe UI"/>
+              </a:rPr>
+              <a:t>settings, pet, history and reports are never touched. The old version is backed up in the backup\ folder.</a:t>
+            </a:r>
+          </a:p>
+          <a:p>
+            <a:pPr>
+              <a:spcAft>
+                <a:spcPts val="900"/>
+              </a:spcAft>
+            </a:pPr>
+            <a:r>
+              <a:rPr sz="1500" b="1">
+                <a:solidFill>
+                  <a:srgbClr val="4CB86B"/>
+                </a:solidFill>
+                <a:latin typeface="Segoe UI"/>
+              </a:rPr>
+              <a:t>•  </a:t>
+            </a:r>
+            <a:r>
+              <a:rPr sz="1500" b="1">
+                <a:solidFill>
+                  <a:srgbClr val="2B2A28"/>
+                </a:solidFill>
+                <a:latin typeface="Segoe UI"/>
+              </a:rPr>
+              <a:t>Manual check: </a:t>
+            </a:r>
+            <a:r>
+              <a:rPr sz="1500">
+                <a:solidFill>
+                  <a:srgbClr val="2B2A28"/>
+                </a:solidFill>
+                <a:latin typeface="Segoe UI"/>
+              </a:rPr>
+              <a:t>right-click the pet → Help → Check for updates.</a:t>
+            </a:r>
+          </a:p>
+          <a:p>
+            <a:pPr>
+              <a:spcAft>
+                <a:spcPts val="900"/>
+              </a:spcAft>
+            </a:pPr>
+            <a:r>
+              <a:rPr sz="1500" b="1">
+                <a:solidFill>
+                  <a:srgbClr val="4CB86B"/>
+                </a:solidFill>
+                <a:latin typeface="Segoe UI"/>
+              </a:rPr>
+              <a:t>•  </a:t>
+            </a:r>
+            <a:r>
+              <a:rPr sz="1500" b="1">
+                <a:solidFill>
+                  <a:srgbClr val="2B2A28"/>
+                </a:solidFill>
+                <a:latin typeface="Segoe UI"/>
+              </a:rPr>
+              <a:t>Don't want it? </a:t>
+            </a:r>
+            <a:r>
+              <a:rPr sz="1500">
+                <a:solidFill>
+                  <a:srgbClr val="2B2A28"/>
+                </a:solidFill>
+                <a:latin typeface="Segoe UI"/>
+              </a:rPr>
+              <a:t>Pet status &amp; settings → uncheck “Check for updates automatically”.</a:t>
+            </a:r>
+          </a:p>
+        </p:txBody>
+      </p:sp>
+    </p:spTree>
+  </p:cSld>
+  <p:clrMapOvr>
+    <a:masterClrMapping/>
+  </p:clrMapOvr>
+</p:sld>
+</file>
+
+<file path=ppt/slides/slide15.xml><?xml version="1.0" encoding="utf-8"?>
+<p:sld xmlns:a="http://schemas.openxmlformats.org/drawingml/2006/main" xmlns:p="http://schemas.openxmlformats.org/presentationml/2006/main" xmlns:r="http://schemas.openxmlformats.org/officeDocument/2006/relationships">
+  <p:cSld>
+    <p:bg>
+      <p:bgPr>
+        <a:solidFill>
+          <a:srgbClr val="F7F4EC"/>
+        </a:solidFill>
+        <a:effectLst/>
+      </p:bgPr>
+    </p:bg>
+    <p:spTree>
+      <p:nvGrpSpPr>
+        <p:cNvPr id="1" name=""/>
+        <p:cNvGrpSpPr/>
+        <p:nvPr/>
+      </p:nvGrpSpPr>
+      <p:grpSpPr/>
+      <p:sp>
+        <p:nvSpPr>
+          <p:cNvPr id="2" name="Rectangle 1"/>
+          <p:cNvSpPr/>
+          <p:nvPr/>
+        </p:nvSpPr>
+        <p:spPr>
+          <a:xfrm>
+            <a:off x="0" y="0"/>
+            <a:ext cx="164592" cy="6858000"/>
+          </a:xfrm>
+          <a:prstGeom prst="rect">
+            <a:avLst/>
+          </a:prstGeom>
+          <a:solidFill>
+            <a:srgbClr val="8B1A1A"/>
+          </a:solidFill>
+          <a:ln>
+            <a:noFill/>
+          </a:ln>
+        </p:spPr>
+        <p:style>
+          <a:lnRef idx="1">
+            <a:schemeClr val="accent1"/>
+          </a:lnRef>
+          <a:fillRef idx="3">
+            <a:schemeClr val="accent1"/>
+          </a:fillRef>
+          <a:effectRef idx="2">
+            <a:schemeClr val="accent1"/>
+          </a:effectRef>
+          <a:fontRef idx="minor">
+            <a:schemeClr val="lt1"/>
+          </a:fontRef>
+        </p:style>
+        <p:txBody>
+          <a:bodyPr rtlCol="0" anchor="ctr"/>
+          <a:lstStyle/>
+          <a:p>
+            <a:pPr algn="ctr"/>
+          </a:p>
+        </p:txBody>
+      </p:sp>
+      <p:sp>
+        <p:nvSpPr>
+          <p:cNvPr id="3" name="TextBox 2"/>
+          <p:cNvSpPr txBox="1"/>
+          <p:nvPr/>
+        </p:nvSpPr>
+        <p:spPr>
+          <a:xfrm>
+            <a:off x="548640" y="320040"/>
+            <a:ext cx="9144000" cy="365760"/>
+          </a:xfrm>
+          <a:prstGeom prst="rect">
+            <a:avLst/>
+          </a:prstGeom>
+          <a:noFill/>
+        </p:spPr>
+        <p:txBody>
+          <a:bodyPr wrap="square" anchor="t" lIns="45720" rIns="45720" tIns="27432" bIns="27432">
+            <a:spAutoFit/>
+          </a:bodyPr>
+          <a:lstStyle/>
+          <a:p>
+            <a:pPr algn="l"/>
+            <a:r>
+              <a:rPr sz="1200" b="1">
+                <a:solidFill>
+                  <a:srgbClr val="4CB86B"/>
+                </a:solidFill>
+                <a:latin typeface="Segoe UI"/>
+              </a:rPr>
+              <a:t>HELP</a:t>
+            </a:r>
+          </a:p>
+        </p:txBody>
+      </p:sp>
+      <p:sp>
+        <p:nvSpPr>
+          <p:cNvPr id="4" name="TextBox 3"/>
+          <p:cNvSpPr txBox="1"/>
+          <p:nvPr/>
+        </p:nvSpPr>
+        <p:spPr>
+          <a:xfrm>
+            <a:off x="548640" y="566928"/>
+            <a:ext cx="10972800" cy="731520"/>
+          </a:xfrm>
+          <a:prstGeom prst="rect">
+            <a:avLst/>
+          </a:prstGeom>
+          <a:noFill/>
+        </p:spPr>
+        <p:txBody>
+          <a:bodyPr wrap="square" anchor="t" lIns="45720" rIns="45720" tIns="27432" bIns="27432">
+            <a:spAutoFit/>
+          </a:bodyPr>
+          <a:lstStyle/>
+          <a:p>
+            <a:pPr algn="l"/>
+            <a:r>
+              <a:rPr sz="3200" b="1">
+                <a:solidFill>
+                  <a:srgbClr val="2B2A28"/>
+                </a:solidFill>
+                <a:latin typeface="Segoe UI"/>
+              </a:rPr>
+              <a:t>Troubleshooting &amp; FAQ</a:t>
+            </a:r>
+          </a:p>
+        </p:txBody>
+      </p:sp>
+      <p:sp>
+        <p:nvSpPr>
+          <p:cNvPr id="5" name="Rectangle 4"/>
+          <p:cNvSpPr/>
+          <p:nvPr/>
+        </p:nvSpPr>
+        <p:spPr>
+          <a:xfrm>
+            <a:off x="566928" y="1298448"/>
+            <a:ext cx="1097280" cy="45720"/>
+          </a:xfrm>
+          <a:prstGeom prst="rect">
+            <a:avLst/>
+          </a:prstGeom>
+          <a:solidFill>
+            <a:srgbClr val="8B1A1A"/>
+          </a:solidFill>
+          <a:ln>
+            <a:noFill/>
+          </a:ln>
+        </p:spPr>
+        <p:style>
+          <a:lnRef idx="1">
+            <a:schemeClr val="accent1"/>
+          </a:lnRef>
+          <a:fillRef idx="3">
+            <a:schemeClr val="accent1"/>
+          </a:fillRef>
+          <a:effectRef idx="2">
+            <a:schemeClr val="accent1"/>
+          </a:effectRef>
+          <a:fontRef idx="minor">
+            <a:schemeClr val="lt1"/>
+          </a:fontRef>
+        </p:style>
+        <p:txBody>
+          <a:bodyPr rtlCol="0" anchor="ctr"/>
+          <a:lstStyle/>
+          <a:p>
+            <a:pPr algn="ctr"/>
+          </a:p>
+        </p:txBody>
+      </p:sp>
+      <p:sp>
+        <p:nvSpPr>
+          <p:cNvPr id="6" name="TextBox 5"/>
+          <p:cNvSpPr txBox="1"/>
+          <p:nvPr/>
+        </p:nvSpPr>
+        <p:spPr>
+          <a:xfrm>
+            <a:off x="10607040" y="6400800"/>
+            <a:ext cx="1371600" cy="320040"/>
+          </a:xfrm>
+          <a:prstGeom prst="rect">
+            <a:avLst/>
+          </a:prstGeom>
+          <a:noFill/>
+        </p:spPr>
+        <p:txBody>
+          <a:bodyPr wrap="square" anchor="t" lIns="45720" rIns="45720" tIns="27432" bIns="27432">
+            <a:spAutoFit/>
+          </a:bodyPr>
+          <a:lstStyle/>
+          <a:p>
+            <a:pPr algn="r"/>
+            <a:r>
+              <a:rPr sz="1000" b="0">
+                <a:solidFill>
+                  <a:srgbClr val="6E6A62"/>
+                </a:solidFill>
+                <a:latin typeface="Segoe UI"/>
+              </a:rPr>
+              <a:t>Pips · 15</a:t>
             </a:r>
           </a:p>
         </p:txBody>
@@ -6770,537 +7428,6 @@
 </p:sld>
 </file>
 
-<file path=ppt/slides/slide15.xml><?xml version="1.0" encoding="utf-8"?>
-<p:sld xmlns:a="http://schemas.openxmlformats.org/drawingml/2006/main" xmlns:p="http://schemas.openxmlformats.org/presentationml/2006/main" xmlns:r="http://schemas.openxmlformats.org/officeDocument/2006/relationships">
-  <p:cSld>
-    <p:bg>
-      <p:bgPr>
-        <a:solidFill>
-          <a:srgbClr val="F7F4EC"/>
-        </a:solidFill>
-        <a:effectLst/>
-      </p:bgPr>
-    </p:bg>
-    <p:spTree>
-      <p:nvGrpSpPr>
-        <p:cNvPr id="1" name=""/>
-        <p:cNvGrpSpPr/>
-        <p:nvPr/>
-      </p:nvGrpSpPr>
-      <p:grpSpPr/>
-      <p:sp>
-        <p:nvSpPr>
-          <p:cNvPr id="2" name="Rectangle 1"/>
-          <p:cNvSpPr/>
-          <p:nvPr/>
-        </p:nvSpPr>
-        <p:spPr>
-          <a:xfrm>
-            <a:off x="0" y="0"/>
-            <a:ext cx="164592" cy="6858000"/>
-          </a:xfrm>
-          <a:prstGeom prst="rect">
-            <a:avLst/>
-          </a:prstGeom>
-          <a:solidFill>
-            <a:srgbClr val="8B1A1A"/>
-          </a:solidFill>
-          <a:ln>
-            <a:noFill/>
-          </a:ln>
-        </p:spPr>
-        <p:style>
-          <a:lnRef idx="1">
-            <a:schemeClr val="accent1"/>
-          </a:lnRef>
-          <a:fillRef idx="3">
-            <a:schemeClr val="accent1"/>
-          </a:fillRef>
-          <a:effectRef idx="2">
-            <a:schemeClr val="accent1"/>
-          </a:effectRef>
-          <a:fontRef idx="minor">
-            <a:schemeClr val="lt1"/>
-          </a:fontRef>
-        </p:style>
-        <p:txBody>
-          <a:bodyPr rtlCol="0" anchor="ctr"/>
-          <a:lstStyle/>
-          <a:p>
-            <a:pPr algn="ctr"/>
-          </a:p>
-        </p:txBody>
-      </p:sp>
-      <p:sp>
-        <p:nvSpPr>
-          <p:cNvPr id="3" name="TextBox 2"/>
-          <p:cNvSpPr txBox="1"/>
-          <p:nvPr/>
-        </p:nvSpPr>
-        <p:spPr>
-          <a:xfrm>
-            <a:off x="548640" y="320040"/>
-            <a:ext cx="9144000" cy="365760"/>
-          </a:xfrm>
-          <a:prstGeom prst="rect">
-            <a:avLst/>
-          </a:prstGeom>
-          <a:noFill/>
-        </p:spPr>
-        <p:txBody>
-          <a:bodyPr wrap="square" anchor="t" lIns="45720" rIns="45720" tIns="27432" bIns="27432">
-            <a:spAutoFit/>
-          </a:bodyPr>
-          <a:lstStyle/>
-          <a:p>
-            <a:pPr algn="l"/>
-            <a:r>
-              <a:rPr sz="1200" b="1">
-                <a:solidFill>
-                  <a:srgbClr val="4CB86B"/>
-                </a:solidFill>
-                <a:latin typeface="Segoe UI"/>
-              </a:rPr>
-              <a:t>RELEASE NOTES</a:t>
-            </a:r>
-          </a:p>
-        </p:txBody>
-      </p:sp>
-      <p:sp>
-        <p:nvSpPr>
-          <p:cNvPr id="4" name="TextBox 3"/>
-          <p:cNvSpPr txBox="1"/>
-          <p:nvPr/>
-        </p:nvSpPr>
-        <p:spPr>
-          <a:xfrm>
-            <a:off x="548640" y="566928"/>
-            <a:ext cx="10972800" cy="731520"/>
-          </a:xfrm>
-          <a:prstGeom prst="rect">
-            <a:avLst/>
-          </a:prstGeom>
-          <a:noFill/>
-        </p:spPr>
-        <p:txBody>
-          <a:bodyPr wrap="square" anchor="t" lIns="45720" rIns="45720" tIns="27432" bIns="27432">
-            <a:spAutoFit/>
-          </a:bodyPr>
-          <a:lstStyle/>
-          <a:p>
-            <a:pPr algn="l"/>
-            <a:r>
-              <a:rPr sz="3200" b="1">
-                <a:solidFill>
-                  <a:srgbClr val="2B2A28"/>
-                </a:solidFill>
-                <a:latin typeface="Segoe UI"/>
-              </a:rPr>
-              <a:t>What's new in 2.2.0</a:t>
-            </a:r>
-          </a:p>
-        </p:txBody>
-      </p:sp>
-      <p:sp>
-        <p:nvSpPr>
-          <p:cNvPr id="5" name="Rectangle 4"/>
-          <p:cNvSpPr/>
-          <p:nvPr/>
-        </p:nvSpPr>
-        <p:spPr>
-          <a:xfrm>
-            <a:off x="566928" y="1298448"/>
-            <a:ext cx="1097280" cy="45720"/>
-          </a:xfrm>
-          <a:prstGeom prst="rect">
-            <a:avLst/>
-          </a:prstGeom>
-          <a:solidFill>
-            <a:srgbClr val="8B1A1A"/>
-          </a:solidFill>
-          <a:ln>
-            <a:noFill/>
-          </a:ln>
-        </p:spPr>
-        <p:style>
-          <a:lnRef idx="1">
-            <a:schemeClr val="accent1"/>
-          </a:lnRef>
-          <a:fillRef idx="3">
-            <a:schemeClr val="accent1"/>
-          </a:fillRef>
-          <a:effectRef idx="2">
-            <a:schemeClr val="accent1"/>
-          </a:effectRef>
-          <a:fontRef idx="minor">
-            <a:schemeClr val="lt1"/>
-          </a:fontRef>
-        </p:style>
-        <p:txBody>
-          <a:bodyPr rtlCol="0" anchor="ctr"/>
-          <a:lstStyle/>
-          <a:p>
-            <a:pPr algn="ctr"/>
-          </a:p>
-        </p:txBody>
-      </p:sp>
-      <p:sp>
-        <p:nvSpPr>
-          <p:cNvPr id="6" name="TextBox 5"/>
-          <p:cNvSpPr txBox="1"/>
-          <p:nvPr/>
-        </p:nvSpPr>
-        <p:spPr>
-          <a:xfrm>
-            <a:off x="10607040" y="6400800"/>
-            <a:ext cx="1371600" cy="320040"/>
-          </a:xfrm>
-          <a:prstGeom prst="rect">
-            <a:avLst/>
-          </a:prstGeom>
-          <a:noFill/>
-        </p:spPr>
-        <p:txBody>
-          <a:bodyPr wrap="square" anchor="t" lIns="45720" rIns="45720" tIns="27432" bIns="27432">
-            <a:spAutoFit/>
-          </a:bodyPr>
-          <a:lstStyle/>
-          <a:p>
-            <a:pPr algn="r"/>
-            <a:r>
-              <a:rPr sz="1000" b="0">
-                <a:solidFill>
-                  <a:srgbClr val="6E6A62"/>
-                </a:solidFill>
-                <a:latin typeface="Segoe UI"/>
-              </a:rPr>
-              <a:t>Pips · 15</a:t>
-            </a:r>
-          </a:p>
-        </p:txBody>
-      </p:sp>
-      <p:sp>
-        <p:nvSpPr>
-          <p:cNvPr id="7" name="TextBox 6"/>
-          <p:cNvSpPr txBox="1"/>
-          <p:nvPr/>
-        </p:nvSpPr>
-        <p:spPr>
-          <a:xfrm>
-            <a:off x="548640" y="1554480"/>
-            <a:ext cx="10972800" cy="457200"/>
-          </a:xfrm>
-          <a:prstGeom prst="rect">
-            <a:avLst/>
-          </a:prstGeom>
-          <a:noFill/>
-        </p:spPr>
-        <p:txBody>
-          <a:bodyPr wrap="square" anchor="t" lIns="45720" rIns="45720" tIns="27432" bIns="27432">
-            <a:spAutoFit/>
-          </a:bodyPr>
-          <a:lstStyle/>
-          <a:p>
-            <a:pPr algn="l"/>
-            <a:r>
-              <a:rPr sz="1800" b="1">
-                <a:solidFill>
-                  <a:srgbClr val="8B1A1A"/>
-                </a:solidFill>
-                <a:latin typeface="Segoe UI"/>
-              </a:rPr>
-              <a:t>Pet sounds  ·  2026-10-28</a:t>
-            </a:r>
-          </a:p>
-        </p:txBody>
-      </p:sp>
-      <p:sp>
-        <p:nvSpPr>
-          <p:cNvPr id="8" name="TextBox 7"/>
-          <p:cNvSpPr txBox="1"/>
-          <p:nvPr/>
-        </p:nvSpPr>
-        <p:spPr>
-          <a:xfrm>
-            <a:off x="548640" y="2148840"/>
-            <a:ext cx="6858000" cy="4114800"/>
-          </a:xfrm>
-          <a:prstGeom prst="rect">
-            <a:avLst/>
-          </a:prstGeom>
-          <a:noFill/>
-        </p:spPr>
-        <p:txBody>
-          <a:bodyPr wrap="square">
-            <a:spAutoFit/>
-          </a:bodyPr>
-          <a:lstStyle/>
-          <a:p>
-            <a:pPr>
-              <a:spcAft>
-                <a:spcPts val="1000"/>
-              </a:spcAft>
-            </a:pPr>
-            <a:r>
-              <a:rPr sz="1700" b="1">
-                <a:solidFill>
-                  <a:srgbClr val="4CB86B"/>
-                </a:solidFill>
-                <a:latin typeface="Segoe UI"/>
-              </a:rPr>
-              <a:t>•  </a:t>
-            </a:r>
-            <a:r>
-              <a:rPr sz="1700">
-                <a:solidFill>
-                  <a:srgbClr val="2B2A28"/>
-                </a:solidFill>
-                <a:latin typeface="Segoe UI"/>
-              </a:rPr>
-              <a:t>Your pet has a voice! Each of the 23 animals has its own sound (meow, woof, ribbit, hoot, buzz, oink, whale song...) and it changes with its mood: happy chirps, sad whimpers, sleepy yawns, hungry calls, grumpy huffs and soft snores</a:t>
-            </a:r>
-          </a:p>
-          <a:p>
-            <a:pPr>
-              <a:spcAft>
-                <a:spcPts val="1000"/>
-              </a:spcAft>
-            </a:pPr>
-            <a:r>
-              <a:rPr sz="1700" b="1">
-                <a:solidFill>
-                  <a:srgbClr val="4CB86B"/>
-                </a:solidFill>
-                <a:latin typeface="Segoe UI"/>
-              </a:rPr>
-              <a:t>•  </a:t>
-            </a:r>
-            <a:r>
-              <a:rPr sz="1700">
-                <a:solidFill>
-                  <a:srgbClr val="2B2A28"/>
-                </a:solidFill>
-                <a:latin typeface="Segoe UI"/>
-              </a:rPr>
-              <a:t>It also reacts with sound when you tickle, pet, feed, shake or wake it</a:t>
-            </a:r>
-          </a:p>
-          <a:p>
-            <a:pPr>
-              <a:spcAft>
-                <a:spcPts val="1000"/>
-              </a:spcAft>
-            </a:pPr>
-            <a:r>
-              <a:rPr sz="1700" b="1">
-                <a:solidFill>
-                  <a:srgbClr val="4CB86B"/>
-                </a:solidFill>
-                <a:latin typeface="Segoe UI"/>
-              </a:rPr>
-              <a:t>•  </a:t>
-            </a:r>
-            <a:r>
-              <a:rPr sz="1700">
-                <a:solidFill>
-                  <a:srgbClr val="2B2A28"/>
-                </a:solidFill>
-                <a:latin typeface="Segoe UI"/>
-              </a:rPr>
-              <a:t>Settings: right-click the pet → Sounds to switch on/off; Pet status &amp; settings has a volume slider, a ▶ Hear me button and "Stay quiet while I'm focusing" (on by default)</a:t>
-            </a:r>
-          </a:p>
-        </p:txBody>
-      </p:sp>
-      <p:sp>
-        <p:nvSpPr>
-          <p:cNvPr id="9" name="Rounded Rectangle 8"/>
-          <p:cNvSpPr/>
-          <p:nvPr/>
-        </p:nvSpPr>
-        <p:spPr>
-          <a:xfrm>
-            <a:off x="7680960" y="2103120"/>
-            <a:ext cx="4114800" cy="4023360"/>
-          </a:xfrm>
-          <a:prstGeom prst="roundRect">
-            <a:avLst>
-              <a:gd name="adj" fmla="val 6000"/>
-            </a:avLst>
-          </a:prstGeom>
-          <a:solidFill>
-            <a:srgbClr val="E4F5E8"/>
-          </a:solidFill>
-          <a:ln w="12700">
-            <a:solidFill>
-              <a:srgbClr val="4CB86B"/>
-            </a:solidFill>
-          </a:ln>
-          <a:effectLst/>
-        </p:spPr>
-        <p:style>
-          <a:lnRef idx="1">
-            <a:schemeClr val="accent1"/>
-          </a:lnRef>
-          <a:fillRef idx="3">
-            <a:schemeClr val="accent1"/>
-          </a:fillRef>
-          <a:effectRef idx="2">
-            <a:schemeClr val="accent1"/>
-          </a:effectRef>
-          <a:fontRef idx="minor">
-            <a:schemeClr val="lt1"/>
-          </a:fontRef>
-        </p:style>
-        <p:txBody>
-          <a:bodyPr rtlCol="0" anchor="ctr"/>
-          <a:lstStyle/>
-          <a:p>
-            <a:pPr algn="ctr"/>
-          </a:p>
-        </p:txBody>
-      </p:sp>
-      <p:sp>
-        <p:nvSpPr>
-          <p:cNvPr id="10" name="TextBox 9"/>
-          <p:cNvSpPr txBox="1"/>
-          <p:nvPr/>
-        </p:nvSpPr>
-        <p:spPr>
-          <a:xfrm>
-            <a:off x="7863840" y="2194560"/>
-            <a:ext cx="3749039" cy="365760"/>
-          </a:xfrm>
-          <a:prstGeom prst="rect">
-            <a:avLst/>
-          </a:prstGeom>
-          <a:noFill/>
-        </p:spPr>
-        <p:txBody>
-          <a:bodyPr wrap="square" anchor="t" lIns="45720" rIns="45720" tIns="27432" bIns="27432">
-            <a:spAutoFit/>
-          </a:bodyPr>
-          <a:lstStyle/>
-          <a:p>
-            <a:pPr algn="l"/>
-            <a:r>
-              <a:rPr sz="1300" b="1">
-                <a:solidFill>
-                  <a:srgbClr val="4CB86B"/>
-                </a:solidFill>
-                <a:latin typeface="Segoe UI"/>
-              </a:rPr>
-              <a:t>Bahasa Indonesia</a:t>
-            </a:r>
-          </a:p>
-        </p:txBody>
-      </p:sp>
-      <p:sp>
-        <p:nvSpPr>
-          <p:cNvPr id="11" name="TextBox 10"/>
-          <p:cNvSpPr txBox="1"/>
-          <p:nvPr/>
-        </p:nvSpPr>
-        <p:spPr>
-          <a:xfrm>
-            <a:off x="7863840" y="2560320"/>
-            <a:ext cx="3749039" cy="3474720"/>
-          </a:xfrm>
-          <a:prstGeom prst="rect">
-            <a:avLst/>
-          </a:prstGeom>
-          <a:noFill/>
-        </p:spPr>
-        <p:txBody>
-          <a:bodyPr wrap="square">
-            <a:spAutoFit/>
-          </a:bodyPr>
-          <a:lstStyle/>
-          <a:p>
-            <a:pPr>
-              <a:spcAft>
-                <a:spcPts val="500"/>
-              </a:spcAft>
-            </a:pPr>
-            <a:r>
-              <a:rPr sz="1200" b="1">
-                <a:solidFill>
-                  <a:srgbClr val="4CB86B"/>
-                </a:solidFill>
-                <a:latin typeface="Segoe UI"/>
-              </a:rPr>
-              <a:t>•  </a:t>
-            </a:r>
-            <a:r>
-              <a:rPr sz="1200">
-                <a:solidFill>
-                  <a:srgbClr val="2B2A28"/>
-                </a:solidFill>
-                <a:latin typeface="Segoe UI"/>
-              </a:rPr>
-              <a:t>Peliharaanmu sekarang bisa bersuara! Ke-23 hewan punya suara sendiri (meong, guk, kwek-kwek katak, hu-hu burung hantu, dengung lebah, oink, nyanyian paus...) dan berubah sesuai mood: ceria, sedih, menguap, lapar, ngambek, dan dengkur pelan</a:t>
-            </a:r>
-          </a:p>
-          <a:p>
-            <a:pPr>
-              <a:spcAft>
-                <a:spcPts val="500"/>
-              </a:spcAft>
-            </a:pPr>
-            <a:r>
-              <a:rPr sz="1200" b="1">
-                <a:solidFill>
-                  <a:srgbClr val="4CB86B"/>
-                </a:solidFill>
-                <a:latin typeface="Segoe UI"/>
-              </a:rPr>
-              <a:t>•  </a:t>
-            </a:r>
-            <a:r>
-              <a:rPr sz="1200">
-                <a:solidFill>
-                  <a:srgbClr val="2B2A28"/>
-                </a:solidFill>
-                <a:latin typeface="Segoe UI"/>
-              </a:rPr>
-              <a:t>Juga bersuara saat kamu gelitik, elus, beri makan, guncang, atau bangunkan</a:t>
-            </a:r>
-          </a:p>
-          <a:p>
-            <a:pPr>
-              <a:spcAft>
-                <a:spcPts val="500"/>
-              </a:spcAft>
-            </a:pPr>
-            <a:r>
-              <a:rPr sz="1200" b="1">
-                <a:solidFill>
-                  <a:srgbClr val="4CB86B"/>
-                </a:solidFill>
-                <a:latin typeface="Segoe UI"/>
-              </a:rPr>
-              <a:t>•  </a:t>
-            </a:r>
-            <a:r>
-              <a:rPr sz="1200">
-                <a:solidFill>
-                  <a:srgbClr val="2B2A28"/>
-                </a:solidFill>
-                <a:latin typeface="Segoe UI"/>
-              </a:rPr>
-              <a:t>Pengaturan: klik kanan peliharaan → Suara untuk nyala/mati; Status &amp; pengaturan punya slider volume, tombol ▶ Dengar, dan "Diam saat aku sedang fokus" (aktif secara default)</a:t>
-            </a:r>
-          </a:p>
-        </p:txBody>
-      </p:sp>
-    </p:spTree>
-  </p:cSld>
-  <p:clrMapOvr>
-    <a:masterClrMapping/>
-  </p:clrMapOvr>
-</p:sld>
-</file>
-
 <file path=ppt/slides/slide16.xml><?xml version="1.0" encoding="utf-8"?>
 <p:sld xmlns:a="http://schemas.openxmlformats.org/drawingml/2006/main" xmlns:p="http://schemas.openxmlformats.org/presentationml/2006/main" xmlns:r="http://schemas.openxmlformats.org/officeDocument/2006/relationships">
   <p:cSld>
@@ -7427,7 +7554,7 @@
                 </a:solidFill>
                 <a:latin typeface="Segoe UI"/>
               </a:rPr>
-              <a:t>Version history</a:t>
+              <a:t>What's new in 2.3.0</a:t>
             </a:r>
           </a:p>
         </p:txBody>
@@ -7510,6 +7637,537 @@
           </a:p>
         </p:txBody>
       </p:sp>
+      <p:sp>
+        <p:nvSpPr>
+          <p:cNvPr id="7" name="TextBox 6"/>
+          <p:cNvSpPr txBox="1"/>
+          <p:nvPr/>
+        </p:nvSpPr>
+        <p:spPr>
+          <a:xfrm>
+            <a:off x="548640" y="1554480"/>
+            <a:ext cx="10972800" cy="457200"/>
+          </a:xfrm>
+          <a:prstGeom prst="rect">
+            <a:avLst/>
+          </a:prstGeom>
+          <a:noFill/>
+        </p:spPr>
+        <p:txBody>
+          <a:bodyPr wrap="square" anchor="t" lIns="45720" rIns="45720" tIns="27432" bIns="27432">
+            <a:spAutoFit/>
+          </a:bodyPr>
+          <a:lstStyle/>
+          <a:p>
+            <a:pPr algn="l"/>
+            <a:r>
+              <a:rPr sz="1800" b="1">
+                <a:solidFill>
+                  <a:srgbClr val="8B1A1A"/>
+                </a:solidFill>
+                <a:latin typeface="Segoe UI"/>
+              </a:rPr>
+              <a:t>Friends, levels &amp; achievements  ·  2026-10-28</a:t>
+            </a:r>
+          </a:p>
+        </p:txBody>
+      </p:sp>
+      <p:sp>
+        <p:nvSpPr>
+          <p:cNvPr id="8" name="TextBox 7"/>
+          <p:cNvSpPr txBox="1"/>
+          <p:nvPr/>
+        </p:nvSpPr>
+        <p:spPr>
+          <a:xfrm>
+            <a:off x="548640" y="2148840"/>
+            <a:ext cx="6858000" cy="4114800"/>
+          </a:xfrm>
+          <a:prstGeom prst="rect">
+            <a:avLst/>
+          </a:prstGeom>
+          <a:noFill/>
+        </p:spPr>
+        <p:txBody>
+          <a:bodyPr wrap="square">
+            <a:spAutoFit/>
+          </a:bodyPr>
+          <a:lstStyle/>
+          <a:p>
+            <a:pPr>
+              <a:spcAft>
+                <a:spcPts val="1000"/>
+              </a:spcAft>
+            </a:pPr>
+            <a:r>
+              <a:rPr sz="1700" b="1">
+                <a:solidFill>
+                  <a:srgbClr val="4CB86B"/>
+                </a:solidFill>
+                <a:latin typeface="Segoe UI"/>
+              </a:rPr>
+              <a:t>•  </a:t>
+            </a:r>
+            <a:r>
+              <a:rPr sz="1700">
+                <a:solidFill>
+                  <a:srgbClr val="2B2A28"/>
+                </a:solidFill>
+                <a:latin typeface="Segoe UI"/>
+              </a:rPr>
+              <a:t>Levels &amp; XP: every finished pomodoro earns XP and your level grows - plus 20 achievements to unlock (first tomato, 8 in a day, 7-day streak, early bird, night owl, pet lover...). Your pet celebrates each one</a:t>
+            </a:r>
+          </a:p>
+          <a:p>
+            <a:pPr>
+              <a:spcAft>
+                <a:spcPts val="1000"/>
+              </a:spcAft>
+            </a:pPr>
+            <a:r>
+              <a:rPr sz="1700" b="1">
+                <a:solidFill>
+                  <a:srgbClr val="4CB86B"/>
+                </a:solidFill>
+                <a:latin typeface="Segoe UI"/>
+              </a:rPr>
+              <a:t>•  </a:t>
+            </a:r>
+            <a:r>
+              <a:rPr sz="1700">
+                <a:solidFill>
+                  <a:srgbClr val="2B2A28"/>
+                </a:solidFill>
+                <a:latin typeface="Segoe UI"/>
+              </a:rPr>
+              <a:t>Friends (optional, off by default): get a 6-letter friend code, add colleagues, see today's board and join a team board like PTB. Your pet tells you when a friend finishes a pomodoro</a:t>
+            </a:r>
+          </a:p>
+          <a:p>
+            <a:pPr>
+              <a:spcAft>
+                <a:spcPts val="1000"/>
+              </a:spcAft>
+            </a:pPr>
+            <a:r>
+              <a:rPr sz="1700" b="1">
+                <a:solidFill>
+                  <a:srgbClr val="4CB86B"/>
+                </a:solidFill>
+                <a:latin typeface="Segoe UI"/>
+              </a:rPr>
+              <a:t>•  </a:t>
+            </a:r>
+            <a:r>
+              <a:rPr sz="1700">
+                <a:solidFill>
+                  <a:srgbClr val="2B2A28"/>
+                </a:solidFill>
+                <a:latin typeface="Segoe UI"/>
+              </a:rPr>
+              <a:t>Privacy: only your name, pet, level, streak and pomodoro counts are shared - never apps, window titles or scores. One click turns it off and deletes your online data. Right-click the pet → Friends &amp; achievements…</a:t>
+            </a:r>
+          </a:p>
+        </p:txBody>
+      </p:sp>
+      <p:sp>
+        <p:nvSpPr>
+          <p:cNvPr id="9" name="Rounded Rectangle 8"/>
+          <p:cNvSpPr/>
+          <p:nvPr/>
+        </p:nvSpPr>
+        <p:spPr>
+          <a:xfrm>
+            <a:off x="7680960" y="2103120"/>
+            <a:ext cx="4114800" cy="4023360"/>
+          </a:xfrm>
+          <a:prstGeom prst="roundRect">
+            <a:avLst>
+              <a:gd name="adj" fmla="val 6000"/>
+            </a:avLst>
+          </a:prstGeom>
+          <a:solidFill>
+            <a:srgbClr val="E4F5E8"/>
+          </a:solidFill>
+          <a:ln w="12700">
+            <a:solidFill>
+              <a:srgbClr val="4CB86B"/>
+            </a:solidFill>
+          </a:ln>
+          <a:effectLst/>
+        </p:spPr>
+        <p:style>
+          <a:lnRef idx="1">
+            <a:schemeClr val="accent1"/>
+          </a:lnRef>
+          <a:fillRef idx="3">
+            <a:schemeClr val="accent1"/>
+          </a:fillRef>
+          <a:effectRef idx="2">
+            <a:schemeClr val="accent1"/>
+          </a:effectRef>
+          <a:fontRef idx="minor">
+            <a:schemeClr val="lt1"/>
+          </a:fontRef>
+        </p:style>
+        <p:txBody>
+          <a:bodyPr rtlCol="0" anchor="ctr"/>
+          <a:lstStyle/>
+          <a:p>
+            <a:pPr algn="ctr"/>
+          </a:p>
+        </p:txBody>
+      </p:sp>
+      <p:sp>
+        <p:nvSpPr>
+          <p:cNvPr id="10" name="TextBox 9"/>
+          <p:cNvSpPr txBox="1"/>
+          <p:nvPr/>
+        </p:nvSpPr>
+        <p:spPr>
+          <a:xfrm>
+            <a:off x="7863840" y="2194560"/>
+            <a:ext cx="3749039" cy="365760"/>
+          </a:xfrm>
+          <a:prstGeom prst="rect">
+            <a:avLst/>
+          </a:prstGeom>
+          <a:noFill/>
+        </p:spPr>
+        <p:txBody>
+          <a:bodyPr wrap="square" anchor="t" lIns="45720" rIns="45720" tIns="27432" bIns="27432">
+            <a:spAutoFit/>
+          </a:bodyPr>
+          <a:lstStyle/>
+          <a:p>
+            <a:pPr algn="l"/>
+            <a:r>
+              <a:rPr sz="1300" b="1">
+                <a:solidFill>
+                  <a:srgbClr val="4CB86B"/>
+                </a:solidFill>
+                <a:latin typeface="Segoe UI"/>
+              </a:rPr>
+              <a:t>Bahasa Indonesia</a:t>
+            </a:r>
+          </a:p>
+        </p:txBody>
+      </p:sp>
+      <p:sp>
+        <p:nvSpPr>
+          <p:cNvPr id="11" name="TextBox 10"/>
+          <p:cNvSpPr txBox="1"/>
+          <p:nvPr/>
+        </p:nvSpPr>
+        <p:spPr>
+          <a:xfrm>
+            <a:off x="7863840" y="2560320"/>
+            <a:ext cx="3749039" cy="3474720"/>
+          </a:xfrm>
+          <a:prstGeom prst="rect">
+            <a:avLst/>
+          </a:prstGeom>
+          <a:noFill/>
+        </p:spPr>
+        <p:txBody>
+          <a:bodyPr wrap="square">
+            <a:spAutoFit/>
+          </a:bodyPr>
+          <a:lstStyle/>
+          <a:p>
+            <a:pPr>
+              <a:spcAft>
+                <a:spcPts val="500"/>
+              </a:spcAft>
+            </a:pPr>
+            <a:r>
+              <a:rPr sz="1200" b="1">
+                <a:solidFill>
+                  <a:srgbClr val="4CB86B"/>
+                </a:solidFill>
+                <a:latin typeface="Segoe UI"/>
+              </a:rPr>
+              <a:t>•  </a:t>
+            </a:r>
+            <a:r>
+              <a:rPr sz="1200">
+                <a:solidFill>
+                  <a:srgbClr val="2B2A28"/>
+                </a:solidFill>
+                <a:latin typeface="Segoe UI"/>
+              </a:rPr>
+              <a:t>Level &amp; XP: setiap pomodoro selesai memberi XP dan levelmu naik - plus 20 pencapaian (tomat pertama, 8 sehari, streak 7 hari, burung pagi, burung hantu, pecinta hewan...). Peliharaanmu ikut merayakan</a:t>
+            </a:r>
+          </a:p>
+          <a:p>
+            <a:pPr>
+              <a:spcAft>
+                <a:spcPts val="500"/>
+              </a:spcAft>
+            </a:pPr>
+            <a:r>
+              <a:rPr sz="1200" b="1">
+                <a:solidFill>
+                  <a:srgbClr val="4CB86B"/>
+                </a:solidFill>
+                <a:latin typeface="Segoe UI"/>
+              </a:rPr>
+              <a:t>•  </a:t>
+            </a:r>
+            <a:r>
+              <a:rPr sz="1200">
+                <a:solidFill>
+                  <a:srgbClr val="2B2A28"/>
+                </a:solidFill>
+                <a:latin typeface="Segoe UI"/>
+              </a:rPr>
+              <a:t>Teman (opsional, mati secara default): dapatkan kode teman 6 huruf, tambahkan rekan, lihat papan hari ini dan gabung papan tim seperti PTB. Peliharaanmu memberi tahu saat teman menyelesaikan pomodoro</a:t>
+            </a:r>
+          </a:p>
+          <a:p>
+            <a:pPr>
+              <a:spcAft>
+                <a:spcPts val="500"/>
+              </a:spcAft>
+            </a:pPr>
+            <a:r>
+              <a:rPr sz="1200" b="1">
+                <a:solidFill>
+                  <a:srgbClr val="4CB86B"/>
+                </a:solidFill>
+                <a:latin typeface="Segoe UI"/>
+              </a:rPr>
+              <a:t>•  </a:t>
+            </a:r>
+            <a:r>
+              <a:rPr sz="1200">
+                <a:solidFill>
+                  <a:srgbClr val="2B2A28"/>
+                </a:solidFill>
+                <a:latin typeface="Segoe UI"/>
+              </a:rPr>
+              <a:t>Privasi: hanya nama, peliharaan, level, streak dan jumlah pomodoro yang dibagikan - tidak pernah aplikasi, judul jendela atau skor. Satu klik untuk mematikan dan menghapus data online-mu. Klik kanan peliharaan → Teman &amp; pencapaian…</a:t>
+            </a:r>
+          </a:p>
+        </p:txBody>
+      </p:sp>
+    </p:spTree>
+  </p:cSld>
+  <p:clrMapOvr>
+    <a:masterClrMapping/>
+  </p:clrMapOvr>
+</p:sld>
+</file>
+
+<file path=ppt/slides/slide17.xml><?xml version="1.0" encoding="utf-8"?>
+<p:sld xmlns:a="http://schemas.openxmlformats.org/drawingml/2006/main" xmlns:p="http://schemas.openxmlformats.org/presentationml/2006/main" xmlns:r="http://schemas.openxmlformats.org/officeDocument/2006/relationships">
+  <p:cSld>
+    <p:bg>
+      <p:bgPr>
+        <a:solidFill>
+          <a:srgbClr val="F7F4EC"/>
+        </a:solidFill>
+        <a:effectLst/>
+      </p:bgPr>
+    </p:bg>
+    <p:spTree>
+      <p:nvGrpSpPr>
+        <p:cNvPr id="1" name=""/>
+        <p:cNvGrpSpPr/>
+        <p:nvPr/>
+      </p:nvGrpSpPr>
+      <p:grpSpPr/>
+      <p:sp>
+        <p:nvSpPr>
+          <p:cNvPr id="2" name="Rectangle 1"/>
+          <p:cNvSpPr/>
+          <p:nvPr/>
+        </p:nvSpPr>
+        <p:spPr>
+          <a:xfrm>
+            <a:off x="0" y="0"/>
+            <a:ext cx="164592" cy="6858000"/>
+          </a:xfrm>
+          <a:prstGeom prst="rect">
+            <a:avLst/>
+          </a:prstGeom>
+          <a:solidFill>
+            <a:srgbClr val="8B1A1A"/>
+          </a:solidFill>
+          <a:ln>
+            <a:noFill/>
+          </a:ln>
+        </p:spPr>
+        <p:style>
+          <a:lnRef idx="1">
+            <a:schemeClr val="accent1"/>
+          </a:lnRef>
+          <a:fillRef idx="3">
+            <a:schemeClr val="accent1"/>
+          </a:fillRef>
+          <a:effectRef idx="2">
+            <a:schemeClr val="accent1"/>
+          </a:effectRef>
+          <a:fontRef idx="minor">
+            <a:schemeClr val="lt1"/>
+          </a:fontRef>
+        </p:style>
+        <p:txBody>
+          <a:bodyPr rtlCol="0" anchor="ctr"/>
+          <a:lstStyle/>
+          <a:p>
+            <a:pPr algn="ctr"/>
+          </a:p>
+        </p:txBody>
+      </p:sp>
+      <p:sp>
+        <p:nvSpPr>
+          <p:cNvPr id="3" name="TextBox 2"/>
+          <p:cNvSpPr txBox="1"/>
+          <p:nvPr/>
+        </p:nvSpPr>
+        <p:spPr>
+          <a:xfrm>
+            <a:off x="548640" y="320040"/>
+            <a:ext cx="9144000" cy="365760"/>
+          </a:xfrm>
+          <a:prstGeom prst="rect">
+            <a:avLst/>
+          </a:prstGeom>
+          <a:noFill/>
+        </p:spPr>
+        <p:txBody>
+          <a:bodyPr wrap="square" anchor="t" lIns="45720" rIns="45720" tIns="27432" bIns="27432">
+            <a:spAutoFit/>
+          </a:bodyPr>
+          <a:lstStyle/>
+          <a:p>
+            <a:pPr algn="l"/>
+            <a:r>
+              <a:rPr sz="1200" b="1">
+                <a:solidFill>
+                  <a:srgbClr val="4CB86B"/>
+                </a:solidFill>
+                <a:latin typeface="Segoe UI"/>
+              </a:rPr>
+              <a:t>RELEASE NOTES</a:t>
+            </a:r>
+          </a:p>
+        </p:txBody>
+      </p:sp>
+      <p:sp>
+        <p:nvSpPr>
+          <p:cNvPr id="4" name="TextBox 3"/>
+          <p:cNvSpPr txBox="1"/>
+          <p:nvPr/>
+        </p:nvSpPr>
+        <p:spPr>
+          <a:xfrm>
+            <a:off x="548640" y="566928"/>
+            <a:ext cx="10972800" cy="731520"/>
+          </a:xfrm>
+          <a:prstGeom prst="rect">
+            <a:avLst/>
+          </a:prstGeom>
+          <a:noFill/>
+        </p:spPr>
+        <p:txBody>
+          <a:bodyPr wrap="square" anchor="t" lIns="45720" rIns="45720" tIns="27432" bIns="27432">
+            <a:spAutoFit/>
+          </a:bodyPr>
+          <a:lstStyle/>
+          <a:p>
+            <a:pPr algn="l"/>
+            <a:r>
+              <a:rPr sz="3200" b="1">
+                <a:solidFill>
+                  <a:srgbClr val="2B2A28"/>
+                </a:solidFill>
+                <a:latin typeface="Segoe UI"/>
+              </a:rPr>
+              <a:t>Version history</a:t>
+            </a:r>
+          </a:p>
+        </p:txBody>
+      </p:sp>
+      <p:sp>
+        <p:nvSpPr>
+          <p:cNvPr id="5" name="Rectangle 4"/>
+          <p:cNvSpPr/>
+          <p:nvPr/>
+        </p:nvSpPr>
+        <p:spPr>
+          <a:xfrm>
+            <a:off x="566928" y="1298448"/>
+            <a:ext cx="1097280" cy="45720"/>
+          </a:xfrm>
+          <a:prstGeom prst="rect">
+            <a:avLst/>
+          </a:prstGeom>
+          <a:solidFill>
+            <a:srgbClr val="8B1A1A"/>
+          </a:solidFill>
+          <a:ln>
+            <a:noFill/>
+          </a:ln>
+        </p:spPr>
+        <p:style>
+          <a:lnRef idx="1">
+            <a:schemeClr val="accent1"/>
+          </a:lnRef>
+          <a:fillRef idx="3">
+            <a:schemeClr val="accent1"/>
+          </a:fillRef>
+          <a:effectRef idx="2">
+            <a:schemeClr val="accent1"/>
+          </a:effectRef>
+          <a:fontRef idx="minor">
+            <a:schemeClr val="lt1"/>
+          </a:fontRef>
+        </p:style>
+        <p:txBody>
+          <a:bodyPr rtlCol="0" anchor="ctr"/>
+          <a:lstStyle/>
+          <a:p>
+            <a:pPr algn="ctr"/>
+          </a:p>
+        </p:txBody>
+      </p:sp>
+      <p:sp>
+        <p:nvSpPr>
+          <p:cNvPr id="6" name="TextBox 5"/>
+          <p:cNvSpPr txBox="1"/>
+          <p:nvPr/>
+        </p:nvSpPr>
+        <p:spPr>
+          <a:xfrm>
+            <a:off x="10607040" y="6400800"/>
+            <a:ext cx="1371600" cy="320040"/>
+          </a:xfrm>
+          <a:prstGeom prst="rect">
+            <a:avLst/>
+          </a:prstGeom>
+          <a:noFill/>
+        </p:spPr>
+        <p:txBody>
+          <a:bodyPr wrap="square" anchor="t" lIns="45720" rIns="45720" tIns="27432" bIns="27432">
+            <a:spAutoFit/>
+          </a:bodyPr>
+          <a:lstStyle/>
+          <a:p>
+            <a:pPr algn="r"/>
+            <a:r>
+              <a:rPr sz="1000" b="0">
+                <a:solidFill>
+                  <a:srgbClr val="6E6A62"/>
+                </a:solidFill>
+                <a:latin typeface="Segoe UI"/>
+              </a:rPr>
+              <a:t>Pips · 17</a:t>
+            </a:r>
+          </a:p>
+        </p:txBody>
+      </p:sp>
       <p:graphicFrame>
         <p:nvGraphicFramePr>
           <p:cNvPr id="7" name="Table 6"/>
@@ -7520,7 +8178,7 @@
         </p:nvGraphicFramePr>
         <p:xfrm>
           <a:off x="548640" y="1645920"/>
-          <a:ext cx="11155680" cy="6144768"/>
+          <a:ext cx="11155680" cy="6967728"/>
         </p:xfrm>
         <a:graphic>
           <a:graphicData uri="http://schemas.openxmlformats.org/drawingml/2006/table">
@@ -7614,7 +8272,7 @@
                           </a:solidFill>
                           <a:latin typeface="Segoe UI"/>
                         </a:rPr>
-                        <a:t>2.2.0</a:t>
+                        <a:t>2.3.0</a:t>
                       </a:r>
                     </a:p>
                   </a:txBody>
@@ -7658,7 +8316,7 @@
                           </a:solidFill>
                           <a:latin typeface="Segoe UI"/>
                         </a:rPr>
-                        <a:t>Pet sounds</a:t>
+                        <a:t>Friends, levels &amp; achievements</a:t>
                       </a:r>
                     </a:p>
                     <a:p>
@@ -7669,7 +8327,7 @@
                           </a:solidFill>
                           <a:latin typeface="Segoe UI"/>
                         </a:rPr>
-                        <a:t>Your pet has a voice! Each of the 23 animals has its own sound (meow, woof, ribbit, hoot, buzz, oink, whale song...) and it changes with its mood: happy chirps, sad whimpers, sleepy yawns, hungry calls, grumpy huffs and soft snores; It also reacts with sound when you tickle, pet, feed, shake or wake it; Settings: right-click the pet → Sounds to switch on/off; Pet status &amp; settings has a volume slider, a ▶ Hear me button and "Stay quiet while I'm focusing" (on by default)</a:t>
+                        <a:t>Levels &amp; XP: every finished pomodoro earns XP and your level grows - plus 20 achievements to unlock (first tomato, 8 in a day, 7-day streak, early bird, night owl, pet lover...). Your pet celebrates each one; Friends (optional, off by default): get a 6-letter friend code, add colleagues, see today's board and join a team board like PTB. Your pet tells you when a friend finishes a pomodoro; Privacy: only your name, pet, level, streak and pomodoro counts are shared - never apps, window titles or scores. One click turns it off and deletes your online data. Right-click the pet → Friends &amp; achievements…</a:t>
                       </a:r>
                     </a:p>
                   </a:txBody>
@@ -7693,7 +8351,7 @@
                           </a:solidFill>
                           <a:latin typeface="Segoe UI"/>
                         </a:rPr>
-                        <a:t>2.1.2</a:t>
+                        <a:t>2.2.0</a:t>
                       </a:r>
                     </a:p>
                   </a:txBody>
@@ -7737,7 +8395,7 @@
                           </a:solidFill>
                           <a:latin typeface="Segoe UI"/>
                         </a:rPr>
-                        <a:t>Tickle-only mode</a:t>
+                        <a:t>Pet sounds</a:t>
                       </a:r>
                     </a:p>
                     <a:p>
@@ -7748,7 +8406,7 @@
                           </a:solidFill>
                           <a:latin typeface="Segoe UI"/>
                         </a:rPr>
-                        <a:t>New click option "Only tickle (never open Pips)": click and tickle your pet as much as you like - the Pomodoro window stays closed (open it from the right-click menu). Right-click the pet → When I click</a:t>
+                        <a:t>Your pet has a voice! Each of the 23 animals has its own sound (meow, woof, ribbit, hoot, buzz, oink, whale song...) and it changes with its mood: happy chirps, sad whimpers, sleepy yawns, hungry calls, grumpy huffs and soft snores; It also reacts with sound when you tickle, pet, feed, shake or wake it; Settings: right-click the pet → Sounds to switch on/off; Pet status &amp; settings has a volume slider, a ▶ Hear me button and "Stay quiet while I'm focusing" (on by default)</a:t>
                       </a:r>
                     </a:p>
                   </a:txBody>
@@ -7772,7 +8430,7 @@
                           </a:solidFill>
                           <a:latin typeface="Segoe UI"/>
                         </a:rPr>
-                        <a:t>2.1.1</a:t>
+                        <a:t>2.1.2</a:t>
                       </a:r>
                     </a:p>
                   </a:txBody>
@@ -7816,7 +8474,7 @@
                           </a:solidFill>
                           <a:latin typeface="Segoe UI"/>
                         </a:rPr>
-                        <a:t>Owner info</a:t>
+                        <a:t>Tickle-only mode</a:t>
                       </a:r>
                     </a:p>
                     <a:p>
@@ -7827,7 +8485,7 @@
                           </a:solidFill>
                           <a:latin typeface="Segoe UI"/>
                         </a:rPr>
-                        <a:t>About Pips now shows the owner: Juwen Lie (right-click the pet → Help → About)</a:t>
+                        <a:t>New click option "Only tickle (never open Pips)": click and tickle your pet as much as you like - the Pomodoro window stays closed (open it from the right-click menu). Right-click the pet → When I click</a:t>
                       </a:r>
                     </a:p>
                   </a:txBody>
@@ -7851,7 +8509,7 @@
                           </a:solidFill>
                           <a:latin typeface="Segoe UI"/>
                         </a:rPr>
-                        <a:t>2.1.0</a:t>
+                        <a:t>2.1.1</a:t>
                       </a:r>
                     </a:p>
                   </a:txBody>
@@ -7895,7 +8553,7 @@
                           </a:solidFill>
                           <a:latin typeface="Segoe UI"/>
                         </a:rPr>
-                        <a:t>Interactive guide &amp; in-app updates</a:t>
+                        <a:t>Owner info</a:t>
                       </a:r>
                     </a:p>
                     <a:p>
@@ -7906,7 +8564,7 @@
                           </a:solidFill>
                           <a:latin typeface="Segoe UI"/>
                         </a:rPr>
-                        <a:t>Interactive first-run guide: your pet walks you through clicking, dragging, petting and the right-click menu; In-app updates: Pips tells you when a new version is out - update with one click (your settings and data are kept); New Help menu: replay the guide, check for updates, see the version; Option to turn automatic update checks off</a:t>
+                        <a:t>About Pips now shows the owner: Juwen Lie (right-click the pet → Help → About)</a:t>
                       </a:r>
                     </a:p>
                   </a:txBody>
@@ -7930,7 +8588,7 @@
                           </a:solidFill>
                           <a:latin typeface="Segoe UI"/>
                         </a:rPr>
-                        <a:t>2.0.0</a:t>
+                        <a:t>2.1.0</a:t>
                       </a:r>
                     </a:p>
                   </a:txBody>
@@ -7974,7 +8632,7 @@
                           </a:solidFill>
                           <a:latin typeface="Segoe UI"/>
                         </a:rPr>
-                        <a:t>Desktop pet, 23 animals &amp; 4 languages</a:t>
+                        <a:t>Interactive guide &amp; in-app updates</a:t>
                       </a:r>
                     </a:p>
                     <a:p>
@@ -7985,7 +8643,7 @@
                           </a:solidFill>
                           <a:latin typeface="Segoe UI"/>
                         </a:rPr>
-                        <a:t>Desktop pet that lives on your desktop and taskbar - drag it, tickle it, pet it; 23 animals in 3 groups: Land walks, Water swims with bubbles, Sky hovers and flaps; Moods (happy, sad, tired, hungry, grumpy...), naps when you're away, wakes up when you're back; Cute chat-bubble reminders: breaks, water, 20-20-20 eye rest, pomodoro done, daily goal</a:t>
+                        <a:t>Interactive first-run guide: your pet walks you through clicking, dragging, petting and the right-click menu; In-app updates: Pips tells you when a new version is out - update with one click (your settings and data are kept); New Help menu: replay the guide, check for updates, see the version; Option to turn automatic update checks off</a:t>
                       </a:r>
                     </a:p>
                   </a:txBody>
@@ -8009,7 +8667,7 @@
                           </a:solidFill>
                           <a:latin typeface="Segoe UI"/>
                         </a:rPr>
-                        <a:t>1.5.0</a:t>
+                        <a:t>2.0.0</a:t>
                       </a:r>
                     </a:p>
                   </a:txBody>
@@ -8031,13 +8689,92 @@
                           </a:solidFill>
                           <a:latin typeface="Segoe UI"/>
                         </a:rPr>
+                        <a:t>2026-10-28</a:t>
+                      </a:r>
+                    </a:p>
+                  </a:txBody>
+                  <a:tcPr marL="73152" marR="73152" marT="36576" marB="36576">
+                    <a:solidFill>
+                      <a:srgbClr val="F7F4EC"/>
+                    </a:solidFill>
+                  </a:tcPr>
+                </a:tc>
+                <a:tc>
+                  <a:txBody>
+                    <a:bodyPr wrap="square"/>
+                    <a:lstStyle/>
+                    <a:p>
+                      <a:r>
+                        <a:rPr sz="1200" b="0">
+                          <a:solidFill>
+                            <a:srgbClr val="2B2A28"/>
+                          </a:solidFill>
+                          <a:latin typeface="Segoe UI"/>
+                        </a:rPr>
+                        <a:t>Desktop pet, 23 animals &amp; 4 languages</a:t>
+                      </a:r>
+                    </a:p>
+                    <a:p>
+                      <a:r>
+                        <a:rPr sz="1200" b="0">
+                          <a:solidFill>
+                            <a:srgbClr val="2B2A28"/>
+                          </a:solidFill>
+                          <a:latin typeface="Segoe UI"/>
+                        </a:rPr>
+                        <a:t>Desktop pet that lives on your desktop and taskbar - drag it, tickle it, pet it; 23 animals in 3 groups: Land walks, Water swims with bubbles, Sky hovers and flaps; Moods (happy, sad, tired, hungry, grumpy...), naps when you're away, wakes up when you're back; Cute chat-bubble reminders: breaks, water, 20-20-20 eye rest, pomodoro done, daily goal</a:t>
+                      </a:r>
+                    </a:p>
+                  </a:txBody>
+                  <a:tcPr marL="73152" marR="73152" marT="36576" marB="36576">
+                    <a:solidFill>
+                      <a:srgbClr val="F7F4EC"/>
+                    </a:solidFill>
+                  </a:tcPr>
+                </a:tc>
+              </a:tr>
+              <a:tr h="822960">
+                <a:tc>
+                  <a:txBody>
+                    <a:bodyPr wrap="square"/>
+                    <a:lstStyle/>
+                    <a:p>
+                      <a:r>
+                        <a:rPr sz="1200" b="1">
+                          <a:solidFill>
+                            <a:srgbClr val="2B2A28"/>
+                          </a:solidFill>
+                          <a:latin typeface="Segoe UI"/>
+                        </a:rPr>
+                        <a:t>1.5.0</a:t>
+                      </a:r>
+                    </a:p>
+                  </a:txBody>
+                  <a:tcPr marL="73152" marR="73152" marT="36576" marB="36576">
+                    <a:solidFill>
+                      <a:srgbClr val="FFFDF8"/>
+                    </a:solidFill>
+                  </a:tcPr>
+                </a:tc>
+                <a:tc>
+                  <a:txBody>
+                    <a:bodyPr wrap="square"/>
+                    <a:lstStyle/>
+                    <a:p>
+                      <a:r>
+                        <a:rPr sz="1200" b="0">
+                          <a:solidFill>
+                            <a:srgbClr val="2B2A28"/>
+                          </a:solidFill>
+                          <a:latin typeface="Segoe UI"/>
+                        </a:rPr>
                         <a:t>2026-10-24</a:t>
                       </a:r>
                     </a:p>
                   </a:txBody>
                   <a:tcPr marL="73152" marR="73152" marT="36576" marB="36576">
                     <a:solidFill>
-                      <a:srgbClr val="F7F4EC"/>
+                      <a:srgbClr val="FFFDF8"/>
                     </a:solidFill>
                   </a:tcPr>
                 </a:tc>
@@ -8070,7 +8807,7 @@
                   </a:txBody>
                   <a:tcPr marL="73152" marR="73152" marT="36576" marB="36576">
                     <a:solidFill>
-                      <a:srgbClr val="F7F4EC"/>
+                      <a:srgbClr val="FFFDF8"/>
                     </a:solidFill>
                   </a:tcPr>
                 </a:tc>
@@ -8094,7 +8831,7 @@
                   </a:txBody>
                   <a:tcPr marL="73152" marR="73152" marT="36576" marB="36576">
                     <a:solidFill>
-                      <a:srgbClr val="FFFDF8"/>
+                      <a:srgbClr val="F7F4EC"/>
                     </a:solidFill>
                   </a:tcPr>
                 </a:tc>
@@ -8116,7 +8853,7 @@
                   </a:txBody>
                   <a:tcPr marL="73152" marR="73152" marT="36576" marB="36576">
                     <a:solidFill>
-                      <a:srgbClr val="FFFDF8"/>
+                      <a:srgbClr val="F7F4EC"/>
                     </a:solidFill>
                   </a:tcPr>
                 </a:tc>
@@ -8149,7 +8886,7 @@
                   </a:txBody>
                   <a:tcPr marL="73152" marR="73152" marT="36576" marB="36576">
                     <a:solidFill>
-                      <a:srgbClr val="FFFDF8"/>
+                      <a:srgbClr val="F7F4EC"/>
                     </a:solidFill>
                   </a:tcPr>
                 </a:tc>
@@ -8166,7 +8903,7 @@
 </p:sld>
 </file>
 
-<file path=ppt/slides/slide17.xml><?xml version="1.0" encoding="utf-8"?>
+<file path=ppt/slides/slide18.xml><?xml version="1.0" encoding="utf-8"?>
 <p:sld xmlns:a="http://schemas.openxmlformats.org/drawingml/2006/main" xmlns:p="http://schemas.openxmlformats.org/presentationml/2006/main" xmlns:r="http://schemas.openxmlformats.org/officeDocument/2006/relationships">
   <p:cSld>
     <p:bg>

</xml_diff>

<commit_message>
pips 2.4.0: Chat, groups, affinity & pet visits
</commit_message>
<xml_diff>
--- a/apps/pips/web/download/Pips-Guide.pptx
+++ b/apps/pips/web/download/Pips-Guide.pptx
@@ -3291,7 +3291,7 @@
                 </a:solidFill>
                 <a:latin typeface="Segoe UI"/>
               </a:rPr>
-              <a:t>Version 2.3.0  ·  2026-10-28  ·  Owner: Juwen Lie</a:t>
+              <a:t>Version 2.4.0  ·  2026-10-28  ·  Owner: Juwen Lie</a:t>
             </a:r>
           </a:p>
           <a:p>
@@ -4216,7 +4216,7 @@
                 </a:solidFill>
                 <a:latin typeface="Segoe UI"/>
               </a:rPr>
-              <a:t>Friends, levels &amp; achievements</a:t>
+              <a:t>Friends, chat, groups &amp; achievements</a:t>
             </a:r>
           </a:p>
         </p:txBody>
@@ -4376,7 +4376,7 @@
                 </a:solidFill>
                 <a:latin typeface="Segoe UI"/>
               </a:rPr>
-              <a:t>20 achievements: </a:t>
+              <a:t>22 achievements: </a:t>
             </a:r>
             <a:r>
               <a:rPr sz="1600">
@@ -4565,11 +4565,11 @@
           <a:p>
             <a:pPr>
               <a:spcAft>
-                <a:spcPts val="500"/>
+                <a:spcPts val="400"/>
               </a:spcAft>
             </a:pPr>
             <a:r>
-              <a:rPr sz="1400" b="1">
+              <a:rPr sz="1300" b="1">
                 <a:solidFill>
                   <a:srgbClr val="4CB86B"/>
                 </a:solidFill>
@@ -4578,23 +4578,23 @@
               <a:t>•  </a:t>
             </a:r>
             <a:r>
-              <a:rPr sz="1400">
-                <a:solidFill>
-                  <a:srgbClr val="2B2A28"/>
-                </a:solidFill>
-                <a:latin typeface="Segoe UI"/>
-              </a:rPr>
-              <a:t>Turn on Friends and get a 6-letter friend code</a:t>
+              <a:rPr sz="1300">
+                <a:solidFill>
+                  <a:srgbClr val="2B2A28"/>
+                </a:solidFill>
+                <a:latin typeface="Segoe UI"/>
+              </a:rPr>
+              <a:t>Turn on Friends, swap 6-letter friend codes</a:t>
             </a:r>
           </a:p>
           <a:p>
             <a:pPr>
               <a:spcAft>
-                <a:spcPts val="500"/>
+                <a:spcPts val="400"/>
               </a:spcAft>
             </a:pPr>
             <a:r>
-              <a:rPr sz="1400" b="1">
+              <a:rPr sz="1300" b="1">
                 <a:solidFill>
                   <a:srgbClr val="4CB86B"/>
                 </a:solidFill>
@@ -4603,23 +4603,23 @@
               <a:t>•  </a:t>
             </a:r>
             <a:r>
-              <a:rPr sz="1400">
-                <a:solidFill>
-                  <a:srgbClr val="2B2A28"/>
-                </a:solidFill>
-                <a:latin typeface="Segoe UI"/>
-              </a:rPr>
-              <a:t>Add colleagues by their code - see today's board</a:t>
+              <a:rPr sz="1300">
+                <a:solidFill>
+                  <a:srgbClr val="2B2A28"/>
+                </a:solidFill>
+                <a:latin typeface="Segoe UI"/>
+              </a:rPr>
+              <a:t>Chat with friends and in your own groups</a:t>
             </a:r>
           </a:p>
           <a:p>
             <a:pPr>
               <a:spcAft>
-                <a:spcPts val="500"/>
+                <a:spcPts val="400"/>
               </a:spcAft>
             </a:pPr>
             <a:r>
-              <a:rPr sz="1400" b="1">
+              <a:rPr sz="1300" b="1">
                 <a:solidFill>
                   <a:srgbClr val="4CB86B"/>
                 </a:solidFill>
@@ -4628,23 +4628,23 @@
               <a:t>•  </a:t>
             </a:r>
             <a:r>
-              <a:rPr sz="1400">
-                <a:solidFill>
-                  <a:srgbClr val="2B2A28"/>
-                </a:solidFill>
-                <a:latin typeface="Segoe UI"/>
-              </a:rPr>
-              <a:t>Join a team board with a team code, e.g. PTB</a:t>
+              <a:rPr sz="1300">
+                <a:solidFill>
+                  <a:srgbClr val="2B2A28"/>
+                </a:solidFill>
+                <a:latin typeface="Segoe UI"/>
+              </a:rPr>
+              <a:t>Wave, pet, send a snack, high five - or send your pet to visit their desktop!</a:t>
             </a:r>
           </a:p>
           <a:p>
             <a:pPr>
               <a:spcAft>
-                <a:spcPts val="500"/>
+                <a:spcPts val="400"/>
               </a:spcAft>
             </a:pPr>
             <a:r>
-              <a:rPr sz="1400" b="1">
+              <a:rPr sz="1300" b="1">
                 <a:solidFill>
                   <a:srgbClr val="4CB86B"/>
                 </a:solidFill>
@@ -4653,23 +4653,23 @@
               <a:t>•  </a:t>
             </a:r>
             <a:r>
-              <a:rPr sz="1400">
-                <a:solidFill>
-                  <a:srgbClr val="2B2A28"/>
-                </a:solidFill>
-                <a:latin typeface="Segoe UI"/>
-              </a:rPr>
-              <a:t>Your pet tells you when a friend finishes a pomodoro</a:t>
+              <a:rPr sz="1300">
+                <a:solidFill>
+                  <a:srgbClr val="2B2A28"/>
+                </a:solidFill>
+                <a:latin typeface="Segoe UI"/>
+              </a:rPr>
+              <a:t>Affinity: friendship grows from Acquaintance to Soulmates</a:t>
             </a:r>
           </a:p>
           <a:p>
             <a:pPr>
               <a:spcAft>
-                <a:spcPts val="500"/>
+                <a:spcPts val="400"/>
               </a:spcAft>
             </a:pPr>
             <a:r>
-              <a:rPr sz="1400" b="1">
+              <a:rPr sz="1300" b="1">
                 <a:solidFill>
                   <a:srgbClr val="4CB86B"/>
                 </a:solidFill>
@@ -4678,23 +4678,23 @@
               <a:t>•  </a:t>
             </a:r>
             <a:r>
-              <a:rPr sz="1400">
-                <a:solidFill>
-                  <a:srgbClr val="2B2A28"/>
-                </a:solidFill>
-                <a:latin typeface="Segoe UI"/>
-              </a:rPr>
-              <a:t>Shared: name, pet, level, streak, pomodoro counts</a:t>
+              <a:rPr sz="1300">
+                <a:solidFill>
+                  <a:srgbClr val="2B2A28"/>
+                </a:solidFill>
+                <a:latin typeface="Segoe UI"/>
+              </a:rPr>
+              <a:t>Create a private group and invite friends; or join an open team (e.g. PTB)</a:t>
             </a:r>
           </a:p>
           <a:p>
             <a:pPr>
               <a:spcAft>
-                <a:spcPts val="500"/>
+                <a:spcPts val="400"/>
               </a:spcAft>
             </a:pPr>
             <a:r>
-              <a:rPr sz="1400" b="1">
+              <a:rPr sz="1300" b="1">
                 <a:solidFill>
                   <a:srgbClr val="4CB86B"/>
                 </a:solidFill>
@@ -4703,7 +4703,7 @@
               <a:t>•  </a:t>
             </a:r>
             <a:r>
-              <a:rPr sz="1400">
+              <a:rPr sz="1300">
                 <a:solidFill>
                   <a:srgbClr val="2B2A28"/>
                 </a:solidFill>
@@ -4715,11 +4715,11 @@
           <a:p>
             <a:pPr>
               <a:spcAft>
-                <a:spcPts val="500"/>
+                <a:spcPts val="400"/>
               </a:spcAft>
             </a:pPr>
             <a:r>
-              <a:rPr sz="1400" b="1">
+              <a:rPr sz="1300" b="1">
                 <a:solidFill>
                   <a:srgbClr val="4CB86B"/>
                 </a:solidFill>
@@ -4728,7 +4728,7 @@
               <a:t>•  </a:t>
             </a:r>
             <a:r>
-              <a:rPr sz="1400">
+              <a:rPr sz="1300">
                 <a:solidFill>
                   <a:srgbClr val="2B2A28"/>
                 </a:solidFill>
@@ -7554,7 +7554,7 @@
                 </a:solidFill>
                 <a:latin typeface="Segoe UI"/>
               </a:rPr>
-              <a:t>What's new in 2.3.0</a:t>
+              <a:t>What's new in 2.4.0</a:t>
             </a:r>
           </a:p>
         </p:txBody>
@@ -7667,7 +7667,7 @@
                 </a:solidFill>
                 <a:latin typeface="Segoe UI"/>
               </a:rPr>
-              <a:t>Friends, levels &amp; achievements  ·  2026-10-28</a:t>
+              <a:t>Chat, groups, affinity &amp; pet visits  ·  2026-10-28</a:t>
             </a:r>
           </a:p>
         </p:txBody>
@@ -7715,7 +7715,7 @@
                 </a:solidFill>
                 <a:latin typeface="Segoe UI"/>
               </a:rPr>
-              <a:t>Levels &amp; XP: every finished pomodoro earns XP and your level grows - plus 20 achievements to unlock (first tomato, 8 in a day, 7-day streak, early bird, night owl, pet lover...). Your pet celebrates each one</a:t>
+              <a:t>Chat: message your friends, and chat inside groups. Your pet pops up new messages as a bubble - click it to reply</a:t>
             </a:r>
           </a:p>
           <a:p>
@@ -7740,7 +7740,7 @@
                 </a:solidFill>
                 <a:latin typeface="Segoe UI"/>
               </a:rPr>
-              <a:t>Friends (optional, off by default): get a 6-letter friend code, add colleagues, see today's board and join a team board like PTB. Your pet tells you when a friend finishes a pomodoro</a:t>
+              <a:t>Pet interactions: wave, pet their pet, send a snack, high five - or send your pet to visit: it walks onto your friend's desktop for a little while!</a:t>
             </a:r>
           </a:p>
           <a:p>
@@ -7765,7 +7765,57 @@
                 </a:solidFill>
                 <a:latin typeface="Segoe UI"/>
               </a:rPr>
-              <a:t>Privacy: only your name, pet, level, streak and pomodoro counts are shared - never apps, window titles or scores. One click turns it off and deletes your online data. Right-click the pet → Friends &amp; achievements…</a:t>
+              <a:t>Affinity: every chat and interaction grows your friendship - Acquaintance → Buddy → Good friends → Close friends → Best friends → Soulmates</a:t>
+            </a:r>
+          </a:p>
+          <a:p>
+            <a:pPr>
+              <a:spcAft>
+                <a:spcPts val="1000"/>
+              </a:spcAft>
+            </a:pPr>
+            <a:r>
+              <a:rPr sz="1700" b="1">
+                <a:solidFill>
+                  <a:srgbClr val="4CB86B"/>
+                </a:solidFill>
+                <a:latin typeface="Segoe UI"/>
+              </a:rPr>
+              <a:t>•  </a:t>
+            </a:r>
+            <a:r>
+              <a:rPr sz="1700">
+                <a:solidFill>
+                  <a:srgbClr val="2B2A28"/>
+                </a:solidFill>
+                <a:latin typeface="Segoe UI"/>
+              </a:rPr>
+              <a:t>Your own groups: create a private group, invite your friends, they accept or decline. Group board + group chat; the owner can remove members</a:t>
+            </a:r>
+          </a:p>
+          <a:p>
+            <a:pPr>
+              <a:spcAft>
+                <a:spcPts val="1000"/>
+              </a:spcAft>
+            </a:pPr>
+            <a:r>
+              <a:rPr sz="1700" b="1">
+                <a:solidFill>
+                  <a:srgbClr val="4CB86B"/>
+                </a:solidFill>
+                <a:latin typeface="Segoe UI"/>
+              </a:rPr>
+              <a:t>•  </a:t>
+            </a:r>
+            <a:r>
+              <a:rPr sz="1700">
+                <a:solidFill>
+                  <a:srgbClr val="2B2A28"/>
+                </a:solidFill>
+                <a:latin typeface="Segoe UI"/>
+              </a:rPr>
+              <a:t>2 new achievements (Close friends, Globetrotter). Right-click the pet → Friends &amp; achievements…</a:t>
             </a:r>
           </a:p>
         </p:txBody>
@@ -7896,7 +7946,7 @@
                 </a:solidFill>
                 <a:latin typeface="Segoe UI"/>
               </a:rPr>
-              <a:t>Level &amp; XP: setiap pomodoro selesai memberi XP dan levelmu naik - plus 20 pencapaian (tomat pertama, 8 sehari, streak 7 hari, burung pagi, burung hantu, pecinta hewan...). Peliharaanmu ikut merayakan</a:t>
+              <a:t>Chat: kirim pesan ke teman dan chat di grup. Peliharaanmu menampilkan pesan baru sebagai gelembung - klik untuk membalas</a:t>
             </a:r>
           </a:p>
           <a:p>
@@ -7921,7 +7971,7 @@
                 </a:solidFill>
                 <a:latin typeface="Segoe UI"/>
               </a:rPr>
-              <a:t>Teman (opsional, mati secara default): dapatkan kode teman 6 huruf, tambahkan rekan, lihat papan hari ini dan gabung papan tim seperti PTB. Peliharaanmu memberi tahu saat teman menyelesaikan pomodoro</a:t>
+              <a:t>Interaksi peliharaan: lambai, elus peliharaan mereka, kirim camilan, tos - atau kirim peliharaanmu berkunjung: ia berjalan ke desktop temanmu sebentar!</a:t>
             </a:r>
           </a:p>
           <a:p>
@@ -7946,7 +7996,57 @@
                 </a:solidFill>
                 <a:latin typeface="Segoe UI"/>
               </a:rPr>
-              <a:t>Privasi: hanya nama, peliharaan, level, streak dan jumlah pomodoro yang dibagikan - tidak pernah aplikasi, judul jendela atau skor. Satu klik untuk mematikan dan menghapus data online-mu. Klik kanan peliharaan → Teman &amp; pencapaian…</a:t>
+              <a:t>Afinitas: setiap chat dan interaksi menumbuhkan pertemanan - Kenalan → Sobat → Teman baik → Teman dekat → Sahabat → Belahan jiwa</a:t>
+            </a:r>
+          </a:p>
+          <a:p>
+            <a:pPr>
+              <a:spcAft>
+                <a:spcPts val="500"/>
+              </a:spcAft>
+            </a:pPr>
+            <a:r>
+              <a:rPr sz="1200" b="1">
+                <a:solidFill>
+                  <a:srgbClr val="4CB86B"/>
+                </a:solidFill>
+                <a:latin typeface="Segoe UI"/>
+              </a:rPr>
+              <a:t>•  </a:t>
+            </a:r>
+            <a:r>
+              <a:rPr sz="1200">
+                <a:solidFill>
+                  <a:srgbClr val="2B2A28"/>
+                </a:solidFill>
+                <a:latin typeface="Segoe UI"/>
+              </a:rPr>
+              <a:t>Grup sendiri: buat grup pribadi, undang temanmu, mereka bisa menerima atau menolak. Papan grup + chat grup; pemilik bisa mengeluarkan anggota</a:t>
+            </a:r>
+          </a:p>
+          <a:p>
+            <a:pPr>
+              <a:spcAft>
+                <a:spcPts val="500"/>
+              </a:spcAft>
+            </a:pPr>
+            <a:r>
+              <a:rPr sz="1200" b="1">
+                <a:solidFill>
+                  <a:srgbClr val="4CB86B"/>
+                </a:solidFill>
+                <a:latin typeface="Segoe UI"/>
+              </a:rPr>
+              <a:t>•  </a:t>
+            </a:r>
+            <a:r>
+              <a:rPr sz="1200">
+                <a:solidFill>
+                  <a:srgbClr val="2B2A28"/>
+                </a:solidFill>
+                <a:latin typeface="Segoe UI"/>
+              </a:rPr>
+              <a:t>2 pencapaian baru (Teman dekat, Penjelajah). Klik kanan peliharaan → Teman &amp; pencapaian…</a:t>
             </a:r>
           </a:p>
         </p:txBody>
@@ -8178,7 +8278,7 @@
         </p:nvGraphicFramePr>
         <p:xfrm>
           <a:off x="548640" y="1645920"/>
-          <a:ext cx="11155680" cy="6967728"/>
+          <a:ext cx="11155680" cy="7790688"/>
         </p:xfrm>
         <a:graphic>
           <a:graphicData uri="http://schemas.openxmlformats.org/drawingml/2006/table">
@@ -8272,7 +8372,7 @@
                           </a:solidFill>
                           <a:latin typeface="Segoe UI"/>
                         </a:rPr>
-                        <a:t>2.3.0</a:t>
+                        <a:t>2.4.0</a:t>
                       </a:r>
                     </a:p>
                   </a:txBody>
@@ -8316,7 +8416,7 @@
                           </a:solidFill>
                           <a:latin typeface="Segoe UI"/>
                         </a:rPr>
-                        <a:t>Friends, levels &amp; achievements</a:t>
+                        <a:t>Chat, groups, affinity &amp; pet visits</a:t>
                       </a:r>
                     </a:p>
                     <a:p>
@@ -8327,7 +8427,7 @@
                           </a:solidFill>
                           <a:latin typeface="Segoe UI"/>
                         </a:rPr>
-                        <a:t>Levels &amp; XP: every finished pomodoro earns XP and your level grows - plus 20 achievements to unlock (first tomato, 8 in a day, 7-day streak, early bird, night owl, pet lover...). Your pet celebrates each one; Friends (optional, off by default): get a 6-letter friend code, add colleagues, see today's board and join a team board like PTB. Your pet tells you when a friend finishes a pomodoro; Privacy: only your name, pet, level, streak and pomodoro counts are shared - never apps, window titles or scores. One click turns it off and deletes your online data. Right-click the pet → Friends &amp; achievements…</a:t>
+                        <a:t>Chat: message your friends, and chat inside groups. Your pet pops up new messages as a bubble - click it to reply; Pet interactions: wave, pet their pet, send a snack, high five - or send your pet to visit: it walks onto your friend's desktop for a little while!; Affinity: every chat and interaction grows your friendship - Acquaintance → Buddy → Good friends → Close friends → Best friends → Soulmates; Your own groups: create a private group, invite your friends, they accept or decline. Group board + group chat; the owner can remove members</a:t>
                       </a:r>
                     </a:p>
                   </a:txBody>
@@ -8351,7 +8451,7 @@
                           </a:solidFill>
                           <a:latin typeface="Segoe UI"/>
                         </a:rPr>
-                        <a:t>2.2.0</a:t>
+                        <a:t>2.3.0</a:t>
                       </a:r>
                     </a:p>
                   </a:txBody>
@@ -8395,7 +8495,7 @@
                           </a:solidFill>
                           <a:latin typeface="Segoe UI"/>
                         </a:rPr>
-                        <a:t>Pet sounds</a:t>
+                        <a:t>Friends, levels &amp; achievements</a:t>
                       </a:r>
                     </a:p>
                     <a:p>
@@ -8406,7 +8506,7 @@
                           </a:solidFill>
                           <a:latin typeface="Segoe UI"/>
                         </a:rPr>
-                        <a:t>Your pet has a voice! Each of the 23 animals has its own sound (meow, woof, ribbit, hoot, buzz, oink, whale song...) and it changes with its mood: happy chirps, sad whimpers, sleepy yawns, hungry calls, grumpy huffs and soft snores; It also reacts with sound when you tickle, pet, feed, shake or wake it; Settings: right-click the pet → Sounds to switch on/off; Pet status &amp; settings has a volume slider, a ▶ Hear me button and "Stay quiet while I'm focusing" (on by default)</a:t>
+                        <a:t>Levels &amp; XP: every finished pomodoro earns XP and your level grows - plus 20 achievements to unlock (first tomato, 8 in a day, 7-day streak, early bird, night owl, pet lover...). Your pet celebrates each one; Friends (optional, off by default): get a 6-letter friend code, add colleagues, see today's board and join a team board like PTB. Your pet tells you when a friend finishes a pomodoro; Privacy: only your name, pet, level, streak and pomodoro counts are shared - never apps, window titles or scores. One click turns it off and deletes your online data. Right-click the pet → Friends &amp; achievements…</a:t>
                       </a:r>
                     </a:p>
                   </a:txBody>
@@ -8430,7 +8530,7 @@
                           </a:solidFill>
                           <a:latin typeface="Segoe UI"/>
                         </a:rPr>
-                        <a:t>2.1.2</a:t>
+                        <a:t>2.2.0</a:t>
                       </a:r>
                     </a:p>
                   </a:txBody>
@@ -8474,7 +8574,7 @@
                           </a:solidFill>
                           <a:latin typeface="Segoe UI"/>
                         </a:rPr>
-                        <a:t>Tickle-only mode</a:t>
+                        <a:t>Pet sounds</a:t>
                       </a:r>
                     </a:p>
                     <a:p>
@@ -8485,7 +8585,7 @@
                           </a:solidFill>
                           <a:latin typeface="Segoe UI"/>
                         </a:rPr>
-                        <a:t>New click option "Only tickle (never open Pips)": click and tickle your pet as much as you like - the Pomodoro window stays closed (open it from the right-click menu). Right-click the pet → When I click</a:t>
+                        <a:t>Your pet has a voice! Each of the 23 animals has its own sound (meow, woof, ribbit, hoot, buzz, oink, whale song...) and it changes with its mood: happy chirps, sad whimpers, sleepy yawns, hungry calls, grumpy huffs and soft snores; It also reacts with sound when you tickle, pet, feed, shake or wake it; Settings: right-click the pet → Sounds to switch on/off; Pet status &amp; settings has a volume slider, a ▶ Hear me button and "Stay quiet while I'm focusing" (on by default)</a:t>
                       </a:r>
                     </a:p>
                   </a:txBody>
@@ -8509,7 +8609,7 @@
                           </a:solidFill>
                           <a:latin typeface="Segoe UI"/>
                         </a:rPr>
-                        <a:t>2.1.1</a:t>
+                        <a:t>2.1.2</a:t>
                       </a:r>
                     </a:p>
                   </a:txBody>
@@ -8553,7 +8653,7 @@
                           </a:solidFill>
                           <a:latin typeface="Segoe UI"/>
                         </a:rPr>
-                        <a:t>Owner info</a:t>
+                        <a:t>Tickle-only mode</a:t>
                       </a:r>
                     </a:p>
                     <a:p>
@@ -8564,7 +8664,7 @@
                           </a:solidFill>
                           <a:latin typeface="Segoe UI"/>
                         </a:rPr>
-                        <a:t>About Pips now shows the owner: Juwen Lie (right-click the pet → Help → About)</a:t>
+                        <a:t>New click option "Only tickle (never open Pips)": click and tickle your pet as much as you like - the Pomodoro window stays closed (open it from the right-click menu). Right-click the pet → When I click</a:t>
                       </a:r>
                     </a:p>
                   </a:txBody>
@@ -8588,7 +8688,7 @@
                           </a:solidFill>
                           <a:latin typeface="Segoe UI"/>
                         </a:rPr>
-                        <a:t>2.1.0</a:t>
+                        <a:t>2.1.1</a:t>
                       </a:r>
                     </a:p>
                   </a:txBody>
@@ -8632,7 +8732,7 @@
                           </a:solidFill>
                           <a:latin typeface="Segoe UI"/>
                         </a:rPr>
-                        <a:t>Interactive guide &amp; in-app updates</a:t>
+                        <a:t>Owner info</a:t>
                       </a:r>
                     </a:p>
                     <a:p>
@@ -8643,7 +8743,7 @@
                           </a:solidFill>
                           <a:latin typeface="Segoe UI"/>
                         </a:rPr>
-                        <a:t>Interactive first-run guide: your pet walks you through clicking, dragging, petting and the right-click menu; In-app updates: Pips tells you when a new version is out - update with one click (your settings and data are kept); New Help menu: replay the guide, check for updates, see the version; Option to turn automatic update checks off</a:t>
+                        <a:t>About Pips now shows the owner: Juwen Lie (right-click the pet → Help → About)</a:t>
                       </a:r>
                     </a:p>
                   </a:txBody>
@@ -8667,7 +8767,7 @@
                           </a:solidFill>
                           <a:latin typeface="Segoe UI"/>
                         </a:rPr>
-                        <a:t>2.0.0</a:t>
+                        <a:t>2.1.0</a:t>
                       </a:r>
                     </a:p>
                   </a:txBody>
@@ -8711,7 +8811,7 @@
                           </a:solidFill>
                           <a:latin typeface="Segoe UI"/>
                         </a:rPr>
-                        <a:t>Desktop pet, 23 animals &amp; 4 languages</a:t>
+                        <a:t>Interactive guide &amp; in-app updates</a:t>
                       </a:r>
                     </a:p>
                     <a:p>
@@ -8722,7 +8822,7 @@
                           </a:solidFill>
                           <a:latin typeface="Segoe UI"/>
                         </a:rPr>
-                        <a:t>Desktop pet that lives on your desktop and taskbar - drag it, tickle it, pet it; 23 animals in 3 groups: Land walks, Water swims with bubbles, Sky hovers and flaps; Moods (happy, sad, tired, hungry, grumpy...), naps when you're away, wakes up when you're back; Cute chat-bubble reminders: breaks, water, 20-20-20 eye rest, pomodoro done, daily goal</a:t>
+                        <a:t>Interactive first-run guide: your pet walks you through clicking, dragging, petting and the right-click menu; In-app updates: Pips tells you when a new version is out - update with one click (your settings and data are kept); New Help menu: replay the guide, check for updates, see the version; Option to turn automatic update checks off</a:t>
                       </a:r>
                     </a:p>
                   </a:txBody>
@@ -8746,7 +8846,7 @@
                           </a:solidFill>
                           <a:latin typeface="Segoe UI"/>
                         </a:rPr>
-                        <a:t>1.5.0</a:t>
+                        <a:t>2.0.0</a:t>
                       </a:r>
                     </a:p>
                   </a:txBody>
@@ -8768,13 +8868,92 @@
                           </a:solidFill>
                           <a:latin typeface="Segoe UI"/>
                         </a:rPr>
+                        <a:t>2026-10-28</a:t>
+                      </a:r>
+                    </a:p>
+                  </a:txBody>
+                  <a:tcPr marL="73152" marR="73152" marT="36576" marB="36576">
+                    <a:solidFill>
+                      <a:srgbClr val="FFFDF8"/>
+                    </a:solidFill>
+                  </a:tcPr>
+                </a:tc>
+                <a:tc>
+                  <a:txBody>
+                    <a:bodyPr wrap="square"/>
+                    <a:lstStyle/>
+                    <a:p>
+                      <a:r>
+                        <a:rPr sz="1200" b="0">
+                          <a:solidFill>
+                            <a:srgbClr val="2B2A28"/>
+                          </a:solidFill>
+                          <a:latin typeface="Segoe UI"/>
+                        </a:rPr>
+                        <a:t>Desktop pet, 23 animals &amp; 4 languages</a:t>
+                      </a:r>
+                    </a:p>
+                    <a:p>
+                      <a:r>
+                        <a:rPr sz="1200" b="0">
+                          <a:solidFill>
+                            <a:srgbClr val="2B2A28"/>
+                          </a:solidFill>
+                          <a:latin typeface="Segoe UI"/>
+                        </a:rPr>
+                        <a:t>Desktop pet that lives on your desktop and taskbar - drag it, tickle it, pet it; 23 animals in 3 groups: Land walks, Water swims with bubbles, Sky hovers and flaps; Moods (happy, sad, tired, hungry, grumpy...), naps when you're away, wakes up when you're back; Cute chat-bubble reminders: breaks, water, 20-20-20 eye rest, pomodoro done, daily goal</a:t>
+                      </a:r>
+                    </a:p>
+                  </a:txBody>
+                  <a:tcPr marL="73152" marR="73152" marT="36576" marB="36576">
+                    <a:solidFill>
+                      <a:srgbClr val="FFFDF8"/>
+                    </a:solidFill>
+                  </a:tcPr>
+                </a:tc>
+              </a:tr>
+              <a:tr h="822960">
+                <a:tc>
+                  <a:txBody>
+                    <a:bodyPr wrap="square"/>
+                    <a:lstStyle/>
+                    <a:p>
+                      <a:r>
+                        <a:rPr sz="1200" b="1">
+                          <a:solidFill>
+                            <a:srgbClr val="2B2A28"/>
+                          </a:solidFill>
+                          <a:latin typeface="Segoe UI"/>
+                        </a:rPr>
+                        <a:t>1.5.0</a:t>
+                      </a:r>
+                    </a:p>
+                  </a:txBody>
+                  <a:tcPr marL="73152" marR="73152" marT="36576" marB="36576">
+                    <a:solidFill>
+                      <a:srgbClr val="F7F4EC"/>
+                    </a:solidFill>
+                  </a:tcPr>
+                </a:tc>
+                <a:tc>
+                  <a:txBody>
+                    <a:bodyPr wrap="square"/>
+                    <a:lstStyle/>
+                    <a:p>
+                      <a:r>
+                        <a:rPr sz="1200" b="0">
+                          <a:solidFill>
+                            <a:srgbClr val="2B2A28"/>
+                          </a:solidFill>
+                          <a:latin typeface="Segoe UI"/>
+                        </a:rPr>
                         <a:t>2026-10-24</a:t>
                       </a:r>
                     </a:p>
                   </a:txBody>
                   <a:tcPr marL="73152" marR="73152" marT="36576" marB="36576">
                     <a:solidFill>
-                      <a:srgbClr val="FFFDF8"/>
+                      <a:srgbClr val="F7F4EC"/>
                     </a:solidFill>
                   </a:tcPr>
                 </a:tc>
@@ -8807,7 +8986,7 @@
                   </a:txBody>
                   <a:tcPr marL="73152" marR="73152" marT="36576" marB="36576">
                     <a:solidFill>
-                      <a:srgbClr val="FFFDF8"/>
+                      <a:srgbClr val="F7F4EC"/>
                     </a:solidFill>
                   </a:tcPr>
                 </a:tc>
@@ -8831,7 +9010,7 @@
                   </a:txBody>
                   <a:tcPr marL="73152" marR="73152" marT="36576" marB="36576">
                     <a:solidFill>
-                      <a:srgbClr val="F7F4EC"/>
+                      <a:srgbClr val="FFFDF8"/>
                     </a:solidFill>
                   </a:tcPr>
                 </a:tc>
@@ -8853,7 +9032,7 @@
                   </a:txBody>
                   <a:tcPr marL="73152" marR="73152" marT="36576" marB="36576">
                     <a:solidFill>
-                      <a:srgbClr val="F7F4EC"/>
+                      <a:srgbClr val="FFFDF8"/>
                     </a:solidFill>
                   </a:tcPr>
                 </a:tc>
@@ -8886,7 +9065,7 @@
                   </a:txBody>
                   <a:tcPr marL="73152" marR="73152" marT="36576" marB="36576">
                     <a:solidFill>
-                      <a:srgbClr val="F7F4EC"/>
+                      <a:srgbClr val="FFFDF8"/>
                     </a:solidFill>
                   </a:tcPr>
                 </a:tc>

</xml_diff>

<commit_message>
pips 2.5.0: Shop, coins, props & moves
</commit_message>
<xml_diff>
--- a/apps/pips/web/download/Pips-Guide.pptx
+++ b/apps/pips/web/download/Pips-Guide.pptx
@@ -23,6 +23,7 @@
     <p:sldId id="271" r:id="rId22"/>
     <p:sldId id="272" r:id="rId23"/>
     <p:sldId id="273" r:id="rId24"/>
+    <p:sldId id="274" r:id="rId25"/>
   </p:sldIdLst>
   <p:sldSz cx="12191695" cy="6858000" type="screen4x3"/>
   <p:notesSz cx="6858000" cy="9144000"/>
@@ -3256,7 +3257,7 @@
                 </a:solidFill>
                 <a:latin typeface="Segoe UI"/>
               </a:rPr>
-              <a:t>A cute desktop pet + Pomodoro focus buddy for Windows</a:t>
+              <a:t>A cute social desktop pet for Windows - friends, chat &amp; a shop</a:t>
             </a:r>
           </a:p>
         </p:txBody>
@@ -3291,7 +3292,7 @@
                 </a:solidFill>
                 <a:latin typeface="Segoe UI"/>
               </a:rPr>
-              <a:t>Version 2.4.0  ·  2026-10-28  ·  Owner: Juwen Lie</a:t>
+              <a:t>Version 2.5.0  ·  2026-10-28  ·  Owner: Juwen Lie</a:t>
             </a:r>
           </a:p>
           <a:p>
@@ -4419,7 +4420,7 @@
                 </a:solidFill>
                 <a:latin typeface="Segoe UI"/>
               </a:rPr>
-              <a:t>right-click the pet → Friends &amp; achievements…</a:t>
+              <a:t>click the pet (or right-click → Pips hub…).</a:t>
             </a:r>
           </a:p>
           <a:p>
@@ -4838,7 +4839,7 @@
                 </a:solidFill>
                 <a:latin typeface="Segoe UI"/>
               </a:rPr>
-              <a:t>CUSTOMIZE</a:t>
+              <a:t>TOGETHER</a:t>
             </a:r>
           </a:p>
         </p:txBody>
@@ -4873,7 +4874,7 @@
                 </a:solidFill>
                 <a:latin typeface="Segoe UI"/>
               </a:rPr>
-              <a:t>Make it yours: Pet status &amp; settings</a:t>
+              <a:t>Shop: props &amp; moves for your pet</a:t>
             </a:r>
           </a:p>
         </p:txBody>
@@ -4956,9 +4957,202 @@
           </a:p>
         </p:txBody>
       </p:sp>
+      <p:sp>
+        <p:nvSpPr>
+          <p:cNvPr id="7" name="TextBox 6"/>
+          <p:cNvSpPr txBox="1"/>
+          <p:nvPr/>
+        </p:nvSpPr>
+        <p:spPr>
+          <a:xfrm>
+            <a:off x="548640" y="1645920"/>
+            <a:ext cx="5577840" cy="4572000"/>
+          </a:xfrm>
+          <a:prstGeom prst="rect">
+            <a:avLst/>
+          </a:prstGeom>
+          <a:noFill/>
+        </p:spPr>
+        <p:txBody>
+          <a:bodyPr wrap="square">
+            <a:spAutoFit/>
+          </a:bodyPr>
+          <a:lstStyle/>
+          <a:p>
+            <a:pPr>
+              <a:spcAft>
+                <a:spcPts val="900"/>
+              </a:spcAft>
+            </a:pPr>
+            <a:r>
+              <a:rPr sz="1500" b="1">
+                <a:solidFill>
+                  <a:srgbClr val="4CB86B"/>
+                </a:solidFill>
+                <a:latin typeface="Segoe UI"/>
+              </a:rPr>
+              <a:t>•  </a:t>
+            </a:r>
+            <a:r>
+              <a:rPr sz="1500" b="1">
+                <a:solidFill>
+                  <a:srgbClr val="2B2A28"/>
+                </a:solidFill>
+                <a:latin typeface="Segoe UI"/>
+              </a:rPr>
+              <a:t>Open: </a:t>
+            </a:r>
+            <a:r>
+              <a:rPr sz="1500">
+                <a:solidFill>
+                  <a:srgbClr val="2B2A28"/>
+                </a:solidFill>
+                <a:latin typeface="Segoe UI"/>
+              </a:rPr>
+              <a:t>click the pet → Shop tab (or right-click → Shop…).</a:t>
+            </a:r>
+          </a:p>
+          <a:p>
+            <a:pPr>
+              <a:spcAft>
+                <a:spcPts val="900"/>
+              </a:spcAft>
+            </a:pPr>
+            <a:r>
+              <a:rPr sz="1500" b="1">
+                <a:solidFill>
+                  <a:srgbClr val="4CB86B"/>
+                </a:solidFill>
+                <a:latin typeface="Segoe UI"/>
+              </a:rPr>
+              <a:t>•  </a:t>
+            </a:r>
+            <a:r>
+              <a:rPr sz="1500" b="1">
+                <a:solidFill>
+                  <a:srgbClr val="2B2A28"/>
+                </a:solidFill>
+                <a:latin typeface="Segoe UI"/>
+              </a:rPr>
+              <a:t>Coins: </a:t>
+            </a:r>
+            <a:r>
+              <a:rPr sz="1500">
+                <a:solidFill>
+                  <a:srgbClr val="2B2A28"/>
+                </a:solidFill>
+                <a:latin typeface="Segoe UI"/>
+              </a:rPr>
+              <a:t>level up +40, badges +25, open Pips each day +10, friendship +15 per affinity level, wave / chat / visit a friend +2, pomodoro +5. Start gift: 100.</a:t>
+            </a:r>
+          </a:p>
+          <a:p>
+            <a:pPr>
+              <a:spcAft>
+                <a:spcPts val="900"/>
+              </a:spcAft>
+            </a:pPr>
+            <a:r>
+              <a:rPr sz="1500" b="1">
+                <a:solidFill>
+                  <a:srgbClr val="4CB86B"/>
+                </a:solidFill>
+                <a:latin typeface="Segoe UI"/>
+              </a:rPr>
+              <a:t>•  </a:t>
+            </a:r>
+            <a:r>
+              <a:rPr sz="1500" b="1">
+                <a:solidFill>
+                  <a:srgbClr val="2B2A28"/>
+                </a:solidFill>
+                <a:latin typeface="Segoe UI"/>
+              </a:rPr>
+              <a:t>Props: </a:t>
+            </a:r>
+            <a:r>
+              <a:rPr sz="1500">
+                <a:solidFill>
+                  <a:srgbClr val="2B2A28"/>
+                </a:solidFill>
+                <a:latin typeface="Segoe UI"/>
+              </a:rPr>
+              <a:t>17 to collect - crown, wizard hat, headphones, shades, scarf, cape, wings... Wear one per slot: head, face, neck, back.</a:t>
+            </a:r>
+          </a:p>
+          <a:p>
+            <a:pPr>
+              <a:spcAft>
+                <a:spcPts val="900"/>
+              </a:spcAft>
+            </a:pPr>
+            <a:r>
+              <a:rPr sz="1500" b="1">
+                <a:solidFill>
+                  <a:srgbClr val="4CB86B"/>
+                </a:solidFill>
+                <a:latin typeface="Segoe UI"/>
+              </a:rPr>
+              <a:t>•  </a:t>
+            </a:r>
+            <a:r>
+              <a:rPr sz="1500" b="1">
+                <a:solidFill>
+                  <a:srgbClr val="2B2A28"/>
+                </a:solidFill>
+                <a:latin typeface="Segoe UI"/>
+              </a:rPr>
+              <a:t>Moves: </a:t>
+            </a:r>
+            <a:r>
+              <a:rPr sz="1500">
+                <a:solidFill>
+                  <a:srgbClr val="2B2A28"/>
+                </a:solidFill>
+                <a:latin typeface="Segoe UI"/>
+              </a:rPr>
+              <a:t>spin, dance, moonwalk, backflip, kung fu, spider swing. Right-click → Do a trick - your happy pet also shows off on its own.</a:t>
+            </a:r>
+          </a:p>
+          <a:p>
+            <a:pPr>
+              <a:spcAft>
+                <a:spcPts val="900"/>
+              </a:spcAft>
+            </a:pPr>
+            <a:r>
+              <a:rPr sz="1500" b="1">
+                <a:solidFill>
+                  <a:srgbClr val="4CB86B"/>
+                </a:solidFill>
+                <a:latin typeface="Segoe UI"/>
+              </a:rPr>
+              <a:t>•  </a:t>
+            </a:r>
+            <a:r>
+              <a:rPr sz="1500" b="1">
+                <a:solidFill>
+                  <a:srgbClr val="2B2A28"/>
+                </a:solidFill>
+                <a:latin typeface="Segoe UI"/>
+              </a:rPr>
+              <a:t>Friends see it: </a:t>
+            </a:r>
+            <a:r>
+              <a:rPr sz="1500">
+                <a:solidFill>
+                  <a:srgbClr val="2B2A28"/>
+                </a:solidFill>
+                <a:latin typeface="Segoe UI"/>
+              </a:rPr>
+              <a:t>your props appear on your avatar, and your pet does a move when it visits a friend's desktop.</a:t>
+            </a:r>
+          </a:p>
+        </p:txBody>
+      </p:sp>
       <p:pic>
         <p:nvPicPr>
-          <p:cNvPr id="7" name="Picture 6" descr="settings.png"/>
+          <p:cNvPr id="8" name="Picture 7" descr="shop.png"/>
           <p:cNvPicPr>
             <a:picLocks noChangeAspect="1"/>
           </p:cNvPicPr>
@@ -4972,8 +5166,8 @@
         </p:blipFill>
         <p:spPr>
           <a:xfrm>
-            <a:off x="949470" y="1508760"/>
-            <a:ext cx="1850100" cy="4846320"/>
+            <a:off x="7538085" y="1463040"/>
+            <a:ext cx="3028950" cy="4846320"/>
           </a:xfrm>
           <a:prstGeom prst="rect">
             <a:avLst/>
@@ -4987,14 +5181,14 @@
       </p:pic>
       <p:sp>
         <p:nvSpPr>
-          <p:cNvPr id="8" name="TextBox 7"/>
+          <p:cNvPr id="9" name="TextBox 8"/>
           <p:cNvSpPr txBox="1"/>
           <p:nvPr/>
         </p:nvSpPr>
         <p:spPr>
           <a:xfrm>
-            <a:off x="365760" y="6382512"/>
-            <a:ext cx="3017520" cy="365760"/>
+            <a:off x="6949440" y="6355080"/>
+            <a:ext cx="4206240" cy="365760"/>
           </a:xfrm>
           <a:prstGeom prst="rect">
             <a:avLst/>
@@ -5015,474 +5209,7 @@
                 </a:solidFill>
                 <a:latin typeface="Segoe UI"/>
               </a:rPr>
-              <a:t>(shown in Bahasa Indonesia)</a:t>
-            </a:r>
-          </a:p>
-        </p:txBody>
-      </p:sp>
-      <p:sp>
-        <p:nvSpPr>
-          <p:cNvPr id="9" name="TextBox 8"/>
-          <p:cNvSpPr txBox="1"/>
-          <p:nvPr/>
-        </p:nvSpPr>
-        <p:spPr>
-          <a:xfrm>
-            <a:off x="3474720" y="1600200"/>
-            <a:ext cx="8229600" cy="457200"/>
-          </a:xfrm>
-          <a:prstGeom prst="rect">
-            <a:avLst/>
-          </a:prstGeom>
-          <a:noFill/>
-        </p:spPr>
-        <p:txBody>
-          <a:bodyPr wrap="square" anchor="t" lIns="45720" rIns="45720" tIns="27432" bIns="27432">
-            <a:spAutoFit/>
-          </a:bodyPr>
-          <a:lstStyle/>
-          <a:p>
-            <a:pPr algn="l"/>
-            <a:r>
-              <a:rPr sz="1700" b="1">
-                <a:solidFill>
-                  <a:srgbClr val="8B1A1A"/>
-                </a:solidFill>
-                <a:latin typeface="Segoe UI"/>
-              </a:rPr>
-              <a:t>Right-click the pet → Pet status &amp; settings…</a:t>
-            </a:r>
-          </a:p>
-        </p:txBody>
-      </p:sp>
-      <p:sp>
-        <p:nvSpPr>
-          <p:cNvPr id="10" name="TextBox 9"/>
-          <p:cNvSpPr txBox="1"/>
-          <p:nvPr/>
-        </p:nvSpPr>
-        <p:spPr>
-          <a:xfrm>
-            <a:off x="3474720" y="2148840"/>
-            <a:ext cx="4114800" cy="4206240"/>
-          </a:xfrm>
-          <a:prstGeom prst="rect">
-            <a:avLst/>
-          </a:prstGeom>
-          <a:noFill/>
-        </p:spPr>
-        <p:txBody>
-          <a:bodyPr wrap="square">
-            <a:spAutoFit/>
-          </a:bodyPr>
-          <a:lstStyle/>
-          <a:p>
-            <a:pPr>
-              <a:spcAft>
-                <a:spcPts val="900"/>
-              </a:spcAft>
-            </a:pPr>
-            <a:r>
-              <a:rPr sz="1500" b="1">
-                <a:solidFill>
-                  <a:srgbClr val="4CB86B"/>
-                </a:solidFill>
-                <a:latin typeface="Segoe UI"/>
-              </a:rPr>
-              <a:t>•  </a:t>
-            </a:r>
-            <a:r>
-              <a:rPr sz="1500" b="1">
-                <a:solidFill>
-                  <a:srgbClr val="2B2A28"/>
-                </a:solidFill>
-                <a:latin typeface="Segoe UI"/>
-              </a:rPr>
-              <a:t>Status: </a:t>
-            </a:r>
-            <a:r>
-              <a:rPr sz="1500">
-                <a:solidFill>
-                  <a:srgbClr val="2B2A28"/>
-                </a:solidFill>
-                <a:latin typeface="Segoe UI"/>
-              </a:rPr>
-              <a:t>mood + happiness, energy, food, bond bars.</a:t>
-            </a:r>
-          </a:p>
-          <a:p>
-            <a:pPr>
-              <a:spcAft>
-                <a:spcPts val="900"/>
-              </a:spcAft>
-            </a:pPr>
-            <a:r>
-              <a:rPr sz="1500" b="1">
-                <a:solidFill>
-                  <a:srgbClr val="4CB86B"/>
-                </a:solidFill>
-                <a:latin typeface="Segoe UI"/>
-              </a:rPr>
-              <a:t>•  </a:t>
-            </a:r>
-            <a:r>
-              <a:rPr sz="1500" b="1">
-                <a:solidFill>
-                  <a:srgbClr val="2B2A28"/>
-                </a:solidFill>
-                <a:latin typeface="Segoe UI"/>
-              </a:rPr>
-              <a:t>Animal: </a:t>
-            </a:r>
-            <a:r>
-              <a:rPr sz="1500">
-                <a:solidFill>
-                  <a:srgbClr val="2B2A28"/>
-                </a:solidFill>
-                <a:latin typeface="Segoe UI"/>
-              </a:rPr>
-              <a:t>Land / Water / Sky tabs - click a tile.</a:t>
-            </a:r>
-          </a:p>
-          <a:p>
-            <a:pPr>
-              <a:spcAft>
-                <a:spcPts val="900"/>
-              </a:spcAft>
-            </a:pPr>
-            <a:r>
-              <a:rPr sz="1500" b="1">
-                <a:solidFill>
-                  <a:srgbClr val="4CB86B"/>
-                </a:solidFill>
-                <a:latin typeface="Segoe UI"/>
-              </a:rPr>
-              <a:t>•  </a:t>
-            </a:r>
-            <a:r>
-              <a:rPr sz="1500" b="1">
-                <a:solidFill>
-                  <a:srgbClr val="2B2A28"/>
-                </a:solidFill>
-                <a:latin typeface="Segoe UI"/>
-              </a:rPr>
-              <a:t>Look: </a:t>
-            </a:r>
-            <a:r>
-              <a:rPr sz="1500">
-                <a:solidFill>
-                  <a:srgbClr val="2B2A28"/>
-                </a:solidFill>
-                <a:latin typeface="Segoe UI"/>
-              </a:rPr>
-              <a:t>name, colour, cheeks, size S / M / L.</a:t>
-            </a:r>
-          </a:p>
-          <a:p>
-            <a:pPr>
-              <a:spcAft>
-                <a:spcPts val="900"/>
-              </a:spcAft>
-            </a:pPr>
-            <a:r>
-              <a:rPr sz="1500" b="1">
-                <a:solidFill>
-                  <a:srgbClr val="4CB86B"/>
-                </a:solidFill>
-                <a:latin typeface="Segoe UI"/>
-              </a:rPr>
-              <a:t>•  </a:t>
-            </a:r>
-            <a:r>
-              <a:rPr sz="1500" b="1">
-                <a:solidFill>
-                  <a:srgbClr val="2B2A28"/>
-                </a:solidFill>
-                <a:latin typeface="Segoe UI"/>
-              </a:rPr>
-              <a:t>Language: </a:t>
-            </a:r>
-            <a:r>
-              <a:rPr sz="1500">
-                <a:solidFill>
-                  <a:srgbClr val="2B2A28"/>
-                </a:solidFill>
-                <a:latin typeface="Segoe UI"/>
-              </a:rPr>
-              <a:t>switch instantly.</a:t>
-            </a:r>
-          </a:p>
-        </p:txBody>
-      </p:sp>
-      <p:sp>
-        <p:nvSpPr>
-          <p:cNvPr id="11" name="TextBox 10"/>
-          <p:cNvSpPr txBox="1"/>
-          <p:nvPr/>
-        </p:nvSpPr>
-        <p:spPr>
-          <a:xfrm>
-            <a:off x="7772400" y="2148840"/>
-            <a:ext cx="4114800" cy="4206240"/>
-          </a:xfrm>
-          <a:prstGeom prst="rect">
-            <a:avLst/>
-          </a:prstGeom>
-          <a:noFill/>
-        </p:spPr>
-        <p:txBody>
-          <a:bodyPr wrap="square">
-            <a:spAutoFit/>
-          </a:bodyPr>
-          <a:lstStyle/>
-          <a:p>
-            <a:pPr>
-              <a:spcAft>
-                <a:spcPts val="300"/>
-              </a:spcAft>
-            </a:pPr>
-            <a:r>
-              <a:rPr sz="1400" b="1">
-                <a:solidFill>
-                  <a:srgbClr val="4CB86B"/>
-                </a:solidFill>
-                <a:latin typeface="Segoe UI"/>
-              </a:rPr>
-              <a:t>•  </a:t>
-            </a:r>
-            <a:r>
-              <a:rPr sz="1400">
-                <a:solidFill>
-                  <a:srgbClr val="2B2A28"/>
-                </a:solidFill>
-                <a:latin typeface="Segoe UI"/>
-              </a:rPr>
-              <a:t>Click action: open card · tickle (double-click opens) · only tickle</a:t>
-            </a:r>
-          </a:p>
-          <a:p>
-            <a:pPr>
-              <a:spcAft>
-                <a:spcPts val="300"/>
-              </a:spcAft>
-            </a:pPr>
-            <a:r>
-              <a:rPr sz="1400" b="1">
-                <a:solidFill>
-                  <a:srgbClr val="4CB86B"/>
-                </a:solidFill>
-                <a:latin typeface="Segoe UI"/>
-              </a:rPr>
-              <a:t>•  </a:t>
-            </a:r>
-            <a:r>
-              <a:rPr sz="1400">
-                <a:solidFill>
-                  <a:srgbClr val="2B2A28"/>
-                </a:solidFill>
-                <a:latin typeface="Segoe UI"/>
-              </a:rPr>
-              <a:t>Show reminders as chat bubbles</a:t>
-            </a:r>
-          </a:p>
-          <a:p>
-            <a:pPr>
-              <a:spcAft>
-                <a:spcPts val="300"/>
-              </a:spcAft>
-            </a:pPr>
-            <a:r>
-              <a:rPr sz="1400" b="1">
-                <a:solidFill>
-                  <a:srgbClr val="4CB86B"/>
-                </a:solidFill>
-                <a:latin typeface="Segoe UI"/>
-              </a:rPr>
-              <a:t>•  </a:t>
-            </a:r>
-            <a:r>
-              <a:rPr sz="1400">
-                <a:solidFill>
-                  <a:srgbClr val="2B2A28"/>
-                </a:solidFill>
-                <a:latin typeface="Segoe UI"/>
-              </a:rPr>
-              <a:t>Walk around on the taskbar</a:t>
-            </a:r>
-          </a:p>
-          <a:p>
-            <a:pPr>
-              <a:spcAft>
-                <a:spcPts val="300"/>
-              </a:spcAft>
-            </a:pPr>
-            <a:r>
-              <a:rPr sz="1400" b="1">
-                <a:solidFill>
-                  <a:srgbClr val="4CB86B"/>
-                </a:solidFill>
-                <a:latin typeface="Segoe UI"/>
-              </a:rPr>
-              <a:t>•  </a:t>
-            </a:r>
-            <a:r>
-              <a:rPr sz="1400">
-                <a:solidFill>
-                  <a:srgbClr val="2B2A28"/>
-                </a:solidFill>
-                <a:latin typeface="Segoe UI"/>
-              </a:rPr>
-              <a:t>Gravity (falls when dropped)</a:t>
-            </a:r>
-          </a:p>
-          <a:p>
-            <a:pPr>
-              <a:spcAft>
-                <a:spcPts val="300"/>
-              </a:spcAft>
-            </a:pPr>
-            <a:r>
-              <a:rPr sz="1400" b="1">
-                <a:solidFill>
-                  <a:srgbClr val="4CB86B"/>
-                </a:solidFill>
-                <a:latin typeface="Segoe UI"/>
-              </a:rPr>
-              <a:t>•  </a:t>
-            </a:r>
-            <a:r>
-              <a:rPr sz="1400">
-                <a:solidFill>
-                  <a:srgbClr val="2B2A28"/>
-                </a:solidFill>
-                <a:latin typeface="Segoe UI"/>
-              </a:rPr>
-              <a:t>Nap when I'm away</a:t>
-            </a:r>
-          </a:p>
-          <a:p>
-            <a:pPr>
-              <a:spcAft>
-                <a:spcPts val="300"/>
-              </a:spcAft>
-            </a:pPr>
-            <a:r>
-              <a:rPr sz="1400" b="1">
-                <a:solidFill>
-                  <a:srgbClr val="4CB86B"/>
-                </a:solidFill>
-                <a:latin typeface="Segoe UI"/>
-              </a:rPr>
-              <a:t>•  </a:t>
-            </a:r>
-            <a:r>
-              <a:rPr sz="1400">
-                <a:solidFill>
-                  <a:srgbClr val="2B2A28"/>
-                </a:solidFill>
-                <a:latin typeface="Segoe UI"/>
-              </a:rPr>
-              <a:t>Open the card next to the pet</a:t>
-            </a:r>
-          </a:p>
-          <a:p>
-            <a:pPr>
-              <a:spcAft>
-                <a:spcPts val="300"/>
-              </a:spcAft>
-            </a:pPr>
-            <a:r>
-              <a:rPr sz="1400" b="1">
-                <a:solidFill>
-                  <a:srgbClr val="4CB86B"/>
-                </a:solidFill>
-                <a:latin typeface="Segoe UI"/>
-              </a:rPr>
-              <a:t>•  </a:t>
-            </a:r>
-            <a:r>
-              <a:rPr sz="1400">
-                <a:solidFill>
-                  <a:srgbClr val="2B2A28"/>
-                </a:solidFill>
-                <a:latin typeface="Segoe UI"/>
-              </a:rPr>
-              <a:t>Chatty (little messages)</a:t>
-            </a:r>
-          </a:p>
-          <a:p>
-            <a:pPr>
-              <a:spcAft>
-                <a:spcPts val="300"/>
-              </a:spcAft>
-            </a:pPr>
-            <a:r>
-              <a:rPr sz="1400" b="1">
-                <a:solidFill>
-                  <a:srgbClr val="4CB86B"/>
-                </a:solidFill>
-                <a:latin typeface="Segoe UI"/>
-              </a:rPr>
-              <a:t>•  </a:t>
-            </a:r>
-            <a:r>
-              <a:rPr sz="1400">
-                <a:solidFill>
-                  <a:srgbClr val="2B2A28"/>
-                </a:solidFill>
-                <a:latin typeface="Segoe UI"/>
-              </a:rPr>
-              <a:t>Hide during full-screen apps</a:t>
-            </a:r>
-          </a:p>
-          <a:p>
-            <a:pPr>
-              <a:spcAft>
-                <a:spcPts val="300"/>
-              </a:spcAft>
-            </a:pPr>
-            <a:r>
-              <a:rPr sz="1400" b="1">
-                <a:solidFill>
-                  <a:srgbClr val="4CB86B"/>
-                </a:solidFill>
-                <a:latin typeface="Segoe UI"/>
-              </a:rPr>
-              <a:t>•  </a:t>
-            </a:r>
-            <a:r>
-              <a:rPr sz="1400">
-                <a:solidFill>
-                  <a:srgbClr val="2B2A28"/>
-                </a:solidFill>
-                <a:latin typeface="Segoe UI"/>
-              </a:rPr>
-              <a:t>Check for updates automatically</a:t>
-            </a:r>
-          </a:p>
-          <a:p>
-            <a:pPr>
-              <a:spcAft>
-                <a:spcPts val="300"/>
-              </a:spcAft>
-            </a:pPr>
-            <a:r>
-              <a:rPr sz="1400" b="1">
-                <a:solidFill>
-                  <a:srgbClr val="4CB86B"/>
-                </a:solidFill>
-                <a:latin typeface="Segoe UI"/>
-              </a:rPr>
-              <a:t>•  </a:t>
-            </a:r>
-            <a:r>
-              <a:rPr sz="1400">
-                <a:solidFill>
-                  <a:srgbClr val="2B2A28"/>
-                </a:solidFill>
-                <a:latin typeface="Segoe UI"/>
-              </a:rPr>
-              <a:t>Animal sounds + volume (quiet while focusing)</a:t>
+              <a:t>The Shop tab</a:t>
             </a:r>
           </a:p>
         </p:txBody>
@@ -5621,7 +5348,7 @@
                 </a:solidFill>
                 <a:latin typeface="Segoe UI"/>
               </a:rPr>
-              <a:t>Languages</a:t>
+              <a:t>Make it yours: Pet status &amp; settings</a:t>
             </a:r>
           </a:p>
         </p:txBody>
@@ -5704,54 +5431,35 @@
           </a:p>
         </p:txBody>
       </p:sp>
-      <p:sp>
-        <p:nvSpPr>
-          <p:cNvPr id="7" name="Rounded Rectangle 6"/>
-          <p:cNvSpPr/>
-          <p:nvPr/>
-        </p:nvSpPr>
-        <p:spPr>
-          <a:xfrm>
-            <a:off x="548640" y="1737360"/>
-            <a:ext cx="2606040" cy="1463040"/>
-          </a:xfrm>
-          <a:prstGeom prst="roundRect">
-            <a:avLst>
-              <a:gd name="adj" fmla="val 6000"/>
-            </a:avLst>
-          </a:prstGeom>
-          <a:solidFill>
-            <a:srgbClr val="FFFDF8"/>
-          </a:solidFill>
+      <p:pic>
+        <p:nvPicPr>
+          <p:cNvPr id="7" name="Picture 6" descr="settings.png"/>
+          <p:cNvPicPr>
+            <a:picLocks noChangeAspect="1"/>
+          </p:cNvPicPr>
+          <p:nvPr/>
+        </p:nvPicPr>
+        <p:blipFill>
+          <a:blip r:embed="rId2"/>
+          <a:stretch>
+            <a:fillRect/>
+          </a:stretch>
+        </p:blipFill>
+        <p:spPr>
+          <a:xfrm>
+            <a:off x="949470" y="1508760"/>
+            <a:ext cx="1850100" cy="4846320"/>
+          </a:xfrm>
+          <a:prstGeom prst="rect">
+            <a:avLst/>
+          </a:prstGeom>
           <a:ln w="12700">
             <a:solidFill>
               <a:srgbClr val="E2DCCE"/>
             </a:solidFill>
           </a:ln>
-          <a:effectLst/>
-        </p:spPr>
-        <p:style>
-          <a:lnRef idx="1">
-            <a:schemeClr val="accent1"/>
-          </a:lnRef>
-          <a:fillRef idx="3">
-            <a:schemeClr val="accent1"/>
-          </a:fillRef>
-          <a:effectRef idx="2">
-            <a:schemeClr val="accent1"/>
-          </a:effectRef>
-          <a:fontRef idx="minor">
-            <a:schemeClr val="lt1"/>
-          </a:fontRef>
-        </p:style>
-        <p:txBody>
-          <a:bodyPr rtlCol="0" anchor="ctr"/>
-          <a:lstStyle/>
-          <a:p>
-            <a:pPr algn="ctr"/>
-          </a:p>
-        </p:txBody>
-      </p:sp>
+        </p:spPr>
+      </p:pic>
       <p:sp>
         <p:nvSpPr>
           <p:cNvPr id="8" name="TextBox 7"/>
@@ -5760,8 +5468,8 @@
         </p:nvSpPr>
         <p:spPr>
           <a:xfrm>
-            <a:off x="548640" y="1920240"/>
-            <a:ext cx="2606040" cy="548640"/>
+            <a:off x="365760" y="6382512"/>
+            <a:ext cx="3017520" cy="365760"/>
           </a:xfrm>
           <a:prstGeom prst="rect">
             <a:avLst/>
@@ -5776,13 +5484,13 @@
           <a:p>
             <a:pPr algn="ctr"/>
             <a:r>
-              <a:rPr sz="2000" b="1">
-                <a:solidFill>
-                  <a:srgbClr val="2B2A28"/>
-                </a:solidFill>
-                <a:latin typeface="Microsoft JhengHei"/>
-              </a:rPr>
-              <a:t>English</a:t>
+              <a:rPr sz="1200" b="0">
+                <a:solidFill>
+                  <a:srgbClr val="6E6A62"/>
+                </a:solidFill>
+                <a:latin typeface="Segoe UI"/>
+              </a:rPr>
+              <a:t>(shown in Bahasa Indonesia)</a:t>
             </a:r>
           </a:p>
         </p:txBody>
@@ -5795,8 +5503,8 @@
         </p:nvSpPr>
         <p:spPr>
           <a:xfrm>
-            <a:off x="548640" y="2514600"/>
-            <a:ext cx="2606040" cy="457200"/>
+            <a:off x="3474720" y="1600200"/>
+            <a:ext cx="8229600" cy="457200"/>
           </a:xfrm>
           <a:prstGeom prst="rect">
             <a:avLst/>
@@ -5809,383 +5517,29 @@
           </a:bodyPr>
           <a:lstStyle/>
           <a:p>
-            <a:pPr algn="ctr"/>
-            <a:r>
-              <a:rPr sz="1500" b="0">
-                <a:solidFill>
-                  <a:srgbClr val="6E6A62"/>
-                </a:solidFill>
-                <a:latin typeface="Microsoft JhengHei"/>
-              </a:rPr>
-              <a:t>Hello!</a:t>
-            </a:r>
-          </a:p>
-        </p:txBody>
-      </p:sp>
-      <p:sp>
-        <p:nvSpPr>
-          <p:cNvPr id="10" name="Rounded Rectangle 9"/>
-          <p:cNvSpPr/>
-          <p:nvPr/>
-        </p:nvSpPr>
-        <p:spPr>
-          <a:xfrm>
-            <a:off x="3383280" y="1737360"/>
-            <a:ext cx="2606040" cy="1463040"/>
-          </a:xfrm>
-          <a:prstGeom prst="roundRect">
-            <a:avLst>
-              <a:gd name="adj" fmla="val 6000"/>
-            </a:avLst>
-          </a:prstGeom>
-          <a:solidFill>
-            <a:srgbClr val="FFFDF8"/>
-          </a:solidFill>
-          <a:ln w="12700">
-            <a:solidFill>
-              <a:srgbClr val="E2DCCE"/>
-            </a:solidFill>
-          </a:ln>
-          <a:effectLst/>
-        </p:spPr>
-        <p:style>
-          <a:lnRef idx="1">
-            <a:schemeClr val="accent1"/>
-          </a:lnRef>
-          <a:fillRef idx="3">
-            <a:schemeClr val="accent1"/>
-          </a:fillRef>
-          <a:effectRef idx="2">
-            <a:schemeClr val="accent1"/>
-          </a:effectRef>
-          <a:fontRef idx="minor">
-            <a:schemeClr val="lt1"/>
-          </a:fontRef>
-        </p:style>
-        <p:txBody>
-          <a:bodyPr rtlCol="0" anchor="ctr"/>
-          <a:lstStyle/>
-          <a:p>
-            <a:pPr algn="ctr"/>
-          </a:p>
-        </p:txBody>
-      </p:sp>
-      <p:sp>
-        <p:nvSpPr>
-          <p:cNvPr id="11" name="TextBox 10"/>
+            <a:pPr algn="l"/>
+            <a:r>
+              <a:rPr sz="1700" b="1">
+                <a:solidFill>
+                  <a:srgbClr val="8B1A1A"/>
+                </a:solidFill>
+                <a:latin typeface="Segoe UI"/>
+              </a:rPr>
+              <a:t>Right-click the pet → Pet status &amp; settings…</a:t>
+            </a:r>
+          </a:p>
+        </p:txBody>
+      </p:sp>
+      <p:sp>
+        <p:nvSpPr>
+          <p:cNvPr id="10" name="TextBox 9"/>
           <p:cNvSpPr txBox="1"/>
           <p:nvPr/>
         </p:nvSpPr>
         <p:spPr>
           <a:xfrm>
-            <a:off x="3383280" y="1920240"/>
-            <a:ext cx="2606040" cy="548640"/>
-          </a:xfrm>
-          <a:prstGeom prst="rect">
-            <a:avLst/>
-          </a:prstGeom>
-          <a:noFill/>
-        </p:spPr>
-        <p:txBody>
-          <a:bodyPr wrap="square" anchor="t" lIns="45720" rIns="45720" tIns="27432" bIns="27432">
-            <a:spAutoFit/>
-          </a:bodyPr>
-          <a:lstStyle/>
-          <a:p>
-            <a:pPr algn="ctr"/>
-            <a:r>
-              <a:rPr sz="2000" b="1">
-                <a:solidFill>
-                  <a:srgbClr val="2B2A28"/>
-                </a:solidFill>
-                <a:latin typeface="Microsoft JhengHei"/>
-              </a:rPr>
-              <a:t>Bahasa Indonesia</a:t>
-            </a:r>
-          </a:p>
-        </p:txBody>
-      </p:sp>
-      <p:sp>
-        <p:nvSpPr>
-          <p:cNvPr id="12" name="TextBox 11"/>
-          <p:cNvSpPr txBox="1"/>
-          <p:nvPr/>
-        </p:nvSpPr>
-        <p:spPr>
-          <a:xfrm>
-            <a:off x="3383280" y="2514600"/>
-            <a:ext cx="2606040" cy="457200"/>
-          </a:xfrm>
-          <a:prstGeom prst="rect">
-            <a:avLst/>
-          </a:prstGeom>
-          <a:noFill/>
-        </p:spPr>
-        <p:txBody>
-          <a:bodyPr wrap="square" anchor="t" lIns="45720" rIns="45720" tIns="27432" bIns="27432">
-            <a:spAutoFit/>
-          </a:bodyPr>
-          <a:lstStyle/>
-          <a:p>
-            <a:pPr algn="ctr"/>
-            <a:r>
-              <a:rPr sz="1500" b="0">
-                <a:solidFill>
-                  <a:srgbClr val="6E6A62"/>
-                </a:solidFill>
-                <a:latin typeface="Microsoft JhengHei"/>
-              </a:rPr>
-              <a:t>Halo!</a:t>
-            </a:r>
-          </a:p>
-        </p:txBody>
-      </p:sp>
-      <p:sp>
-        <p:nvSpPr>
-          <p:cNvPr id="13" name="Rounded Rectangle 12"/>
-          <p:cNvSpPr/>
-          <p:nvPr/>
-        </p:nvSpPr>
-        <p:spPr>
-          <a:xfrm>
-            <a:off x="6217920" y="1737360"/>
-            <a:ext cx="2606040" cy="1463040"/>
-          </a:xfrm>
-          <a:prstGeom prst="roundRect">
-            <a:avLst>
-              <a:gd name="adj" fmla="val 6000"/>
-            </a:avLst>
-          </a:prstGeom>
-          <a:solidFill>
-            <a:srgbClr val="FFFDF8"/>
-          </a:solidFill>
-          <a:ln w="12700">
-            <a:solidFill>
-              <a:srgbClr val="E2DCCE"/>
-            </a:solidFill>
-          </a:ln>
-          <a:effectLst/>
-        </p:spPr>
-        <p:style>
-          <a:lnRef idx="1">
-            <a:schemeClr val="accent1"/>
-          </a:lnRef>
-          <a:fillRef idx="3">
-            <a:schemeClr val="accent1"/>
-          </a:fillRef>
-          <a:effectRef idx="2">
-            <a:schemeClr val="accent1"/>
-          </a:effectRef>
-          <a:fontRef idx="minor">
-            <a:schemeClr val="lt1"/>
-          </a:fontRef>
-        </p:style>
-        <p:txBody>
-          <a:bodyPr rtlCol="0" anchor="ctr"/>
-          <a:lstStyle/>
-          <a:p>
-            <a:pPr algn="ctr"/>
-          </a:p>
-        </p:txBody>
-      </p:sp>
-      <p:sp>
-        <p:nvSpPr>
-          <p:cNvPr id="14" name="TextBox 13"/>
-          <p:cNvSpPr txBox="1"/>
-          <p:nvPr/>
-        </p:nvSpPr>
-        <p:spPr>
-          <a:xfrm>
-            <a:off x="6217920" y="1920240"/>
-            <a:ext cx="2606040" cy="548640"/>
-          </a:xfrm>
-          <a:prstGeom prst="rect">
-            <a:avLst/>
-          </a:prstGeom>
-          <a:noFill/>
-        </p:spPr>
-        <p:txBody>
-          <a:bodyPr wrap="square" anchor="t" lIns="45720" rIns="45720" tIns="27432" bIns="27432">
-            <a:spAutoFit/>
-          </a:bodyPr>
-          <a:lstStyle/>
-          <a:p>
-            <a:pPr algn="ctr"/>
-            <a:r>
-              <a:rPr sz="2000" b="1">
-                <a:solidFill>
-                  <a:srgbClr val="2B2A28"/>
-                </a:solidFill>
-                <a:latin typeface="Microsoft JhengHei"/>
-              </a:rPr>
-              <a:t>繁體中文</a:t>
-            </a:r>
-          </a:p>
-        </p:txBody>
-      </p:sp>
-      <p:sp>
-        <p:nvSpPr>
-          <p:cNvPr id="15" name="TextBox 14"/>
-          <p:cNvSpPr txBox="1"/>
-          <p:nvPr/>
-        </p:nvSpPr>
-        <p:spPr>
-          <a:xfrm>
-            <a:off x="6217920" y="2514600"/>
-            <a:ext cx="2606040" cy="457200"/>
-          </a:xfrm>
-          <a:prstGeom prst="rect">
-            <a:avLst/>
-          </a:prstGeom>
-          <a:noFill/>
-        </p:spPr>
-        <p:txBody>
-          <a:bodyPr wrap="square" anchor="t" lIns="45720" rIns="45720" tIns="27432" bIns="27432">
-            <a:spAutoFit/>
-          </a:bodyPr>
-          <a:lstStyle/>
-          <a:p>
-            <a:pPr algn="ctr"/>
-            <a:r>
-              <a:rPr sz="1500" b="0">
-                <a:solidFill>
-                  <a:srgbClr val="6E6A62"/>
-                </a:solidFill>
-                <a:latin typeface="Microsoft JhengHei"/>
-              </a:rPr>
-              <a:t>你好！</a:t>
-            </a:r>
-          </a:p>
-        </p:txBody>
-      </p:sp>
-      <p:sp>
-        <p:nvSpPr>
-          <p:cNvPr id="16" name="Rounded Rectangle 15"/>
-          <p:cNvSpPr/>
-          <p:nvPr/>
-        </p:nvSpPr>
-        <p:spPr>
-          <a:xfrm>
-            <a:off x="9052560" y="1737360"/>
-            <a:ext cx="2606040" cy="1463040"/>
-          </a:xfrm>
-          <a:prstGeom prst="roundRect">
-            <a:avLst>
-              <a:gd name="adj" fmla="val 6000"/>
-            </a:avLst>
-          </a:prstGeom>
-          <a:solidFill>
-            <a:srgbClr val="FFFDF8"/>
-          </a:solidFill>
-          <a:ln w="12700">
-            <a:solidFill>
-              <a:srgbClr val="E2DCCE"/>
-            </a:solidFill>
-          </a:ln>
-          <a:effectLst/>
-        </p:spPr>
-        <p:style>
-          <a:lnRef idx="1">
-            <a:schemeClr val="accent1"/>
-          </a:lnRef>
-          <a:fillRef idx="3">
-            <a:schemeClr val="accent1"/>
-          </a:fillRef>
-          <a:effectRef idx="2">
-            <a:schemeClr val="accent1"/>
-          </a:effectRef>
-          <a:fontRef idx="minor">
-            <a:schemeClr val="lt1"/>
-          </a:fontRef>
-        </p:style>
-        <p:txBody>
-          <a:bodyPr rtlCol="0" anchor="ctr"/>
-          <a:lstStyle/>
-          <a:p>
-            <a:pPr algn="ctr"/>
-          </a:p>
-        </p:txBody>
-      </p:sp>
-      <p:sp>
-        <p:nvSpPr>
-          <p:cNvPr id="17" name="TextBox 16"/>
-          <p:cNvSpPr txBox="1"/>
-          <p:nvPr/>
-        </p:nvSpPr>
-        <p:spPr>
-          <a:xfrm>
-            <a:off x="9052560" y="1920240"/>
-            <a:ext cx="2606040" cy="548640"/>
-          </a:xfrm>
-          <a:prstGeom prst="rect">
-            <a:avLst/>
-          </a:prstGeom>
-          <a:noFill/>
-        </p:spPr>
-        <p:txBody>
-          <a:bodyPr wrap="square" anchor="t" lIns="45720" rIns="45720" tIns="27432" bIns="27432">
-            <a:spAutoFit/>
-          </a:bodyPr>
-          <a:lstStyle/>
-          <a:p>
-            <a:pPr algn="ctr"/>
-            <a:r>
-              <a:rPr sz="2000" b="1">
-                <a:solidFill>
-                  <a:srgbClr val="2B2A28"/>
-                </a:solidFill>
-                <a:latin typeface="Microsoft JhengHei"/>
-              </a:rPr>
-              <a:t>简体中文</a:t>
-            </a:r>
-          </a:p>
-        </p:txBody>
-      </p:sp>
-      <p:sp>
-        <p:nvSpPr>
-          <p:cNvPr id="18" name="TextBox 17"/>
-          <p:cNvSpPr txBox="1"/>
-          <p:nvPr/>
-        </p:nvSpPr>
-        <p:spPr>
-          <a:xfrm>
-            <a:off x="9052560" y="2514600"/>
-            <a:ext cx="2606040" cy="457200"/>
-          </a:xfrm>
-          <a:prstGeom prst="rect">
-            <a:avLst/>
-          </a:prstGeom>
-          <a:noFill/>
-        </p:spPr>
-        <p:txBody>
-          <a:bodyPr wrap="square" anchor="t" lIns="45720" rIns="45720" tIns="27432" bIns="27432">
-            <a:spAutoFit/>
-          </a:bodyPr>
-          <a:lstStyle/>
-          <a:p>
-            <a:pPr algn="ctr"/>
-            <a:r>
-              <a:rPr sz="1500" b="0">
-                <a:solidFill>
-                  <a:srgbClr val="6E6A62"/>
-                </a:solidFill>
-                <a:latin typeface="Microsoft JhengHei"/>
-              </a:rPr>
-              <a:t>你好！</a:t>
-            </a:r>
-          </a:p>
-        </p:txBody>
-      </p:sp>
-      <p:sp>
-        <p:nvSpPr>
-          <p:cNvPr id="19" name="TextBox 18"/>
-          <p:cNvSpPr txBox="1"/>
-          <p:nvPr/>
-        </p:nvSpPr>
-        <p:spPr>
-          <a:xfrm>
-            <a:off x="548640" y="3566160"/>
-            <a:ext cx="10972800" cy="2743200"/>
+            <a:off x="3474720" y="2148840"/>
+            <a:ext cx="4114800" cy="4206240"/>
           </a:xfrm>
           <a:prstGeom prst="rect">
             <a:avLst/>
@@ -6200,11 +5554,11 @@
           <a:p>
             <a:pPr>
               <a:spcAft>
-                <a:spcPts val="1000"/>
+                <a:spcPts val="900"/>
               </a:spcAft>
             </a:pPr>
             <a:r>
-              <a:rPr sz="1700" b="1">
+              <a:rPr sz="1500" b="1">
                 <a:solidFill>
                   <a:srgbClr val="4CB86B"/>
                 </a:solidFill>
@@ -6213,32 +5567,32 @@
               <a:t>•  </a:t>
             </a:r>
             <a:r>
-              <a:rPr sz="1700" b="1">
-                <a:solidFill>
-                  <a:srgbClr val="2B2A28"/>
-                </a:solidFill>
-                <a:latin typeface="Segoe UI"/>
-              </a:rPr>
-              <a:t>Change anytime: </a:t>
-            </a:r>
-            <a:r>
-              <a:rPr sz="1700">
-                <a:solidFill>
-                  <a:srgbClr val="2B2A28"/>
-                </a:solidFill>
-                <a:latin typeface="Segoe UI"/>
-              </a:rPr>
-              <a:t>right-click the pet (or the card) → Language. Everything switches instantly - menus, bubbles, reminders, the card.</a:t>
+              <a:rPr sz="1500" b="1">
+                <a:solidFill>
+                  <a:srgbClr val="2B2A28"/>
+                </a:solidFill>
+                <a:latin typeface="Segoe UI"/>
+              </a:rPr>
+              <a:t>Status: </a:t>
+            </a:r>
+            <a:r>
+              <a:rPr sz="1500">
+                <a:solidFill>
+                  <a:srgbClr val="2B2A28"/>
+                </a:solidFill>
+                <a:latin typeface="Segoe UI"/>
+              </a:rPr>
+              <a:t>mood + happiness, energy, food, bond bars.</a:t>
             </a:r>
           </a:p>
           <a:p>
             <a:pPr>
               <a:spcAft>
-                <a:spcPts val="1000"/>
+                <a:spcPts val="900"/>
               </a:spcAft>
             </a:pPr>
             <a:r>
-              <a:rPr sz="1700" b="1">
+              <a:rPr sz="1500" b="1">
                 <a:solidFill>
                   <a:srgbClr val="4CB86B"/>
                 </a:solidFill>
@@ -6247,32 +5601,32 @@
               <a:t>•  </a:t>
             </a:r>
             <a:r>
-              <a:rPr sz="1700" b="1">
-                <a:solidFill>
-                  <a:srgbClr val="2B2A28"/>
-                </a:solidFill>
-                <a:latin typeface="Segoe UI"/>
-              </a:rPr>
-              <a:t>First start: </a:t>
-            </a:r>
-            <a:r>
-              <a:rPr sz="1700">
-                <a:solidFill>
-                  <a:srgbClr val="2B2A28"/>
-                </a:solidFill>
-                <a:latin typeface="Segoe UI"/>
-              </a:rPr>
-              <a:t>Pips guesses from your Windows language and asks once.</a:t>
+              <a:rPr sz="1500" b="1">
+                <a:solidFill>
+                  <a:srgbClr val="2B2A28"/>
+                </a:solidFill>
+                <a:latin typeface="Segoe UI"/>
+              </a:rPr>
+              <a:t>Animal: </a:t>
+            </a:r>
+            <a:r>
+              <a:rPr sz="1500">
+                <a:solidFill>
+                  <a:srgbClr val="2B2A28"/>
+                </a:solidFill>
+                <a:latin typeface="Segoe UI"/>
+              </a:rPr>
+              <a:t>Land / Water / Sky tabs - click a tile.</a:t>
             </a:r>
           </a:p>
           <a:p>
             <a:pPr>
               <a:spcAft>
-                <a:spcPts val="1000"/>
+                <a:spcPts val="900"/>
               </a:spcAft>
             </a:pPr>
             <a:r>
-              <a:rPr sz="1700" b="1">
+              <a:rPr sz="1500" b="1">
                 <a:solidFill>
                   <a:srgbClr val="4CB86B"/>
                 </a:solidFill>
@@ -6281,22 +5635,329 @@
               <a:t>•  </a:t>
             </a:r>
             <a:r>
-              <a:rPr sz="1700" b="1">
-                <a:solidFill>
-                  <a:srgbClr val="2B2A28"/>
-                </a:solidFill>
-                <a:latin typeface="Segoe UI"/>
-              </a:rPr>
-              <a:t>Update notes </a:t>
-            </a:r>
-            <a:r>
-              <a:rPr sz="1700">
-                <a:solidFill>
-                  <a:srgbClr val="2B2A28"/>
-                </a:solidFill>
-                <a:latin typeface="Segoe UI"/>
-              </a:rPr>
-              <a:t>are shown in your language too.</a:t>
+              <a:rPr sz="1500" b="1">
+                <a:solidFill>
+                  <a:srgbClr val="2B2A28"/>
+                </a:solidFill>
+                <a:latin typeface="Segoe UI"/>
+              </a:rPr>
+              <a:t>Look: </a:t>
+            </a:r>
+            <a:r>
+              <a:rPr sz="1500">
+                <a:solidFill>
+                  <a:srgbClr val="2B2A28"/>
+                </a:solidFill>
+                <a:latin typeface="Segoe UI"/>
+              </a:rPr>
+              <a:t>name, colour, cheeks, size S / M / L.</a:t>
+            </a:r>
+          </a:p>
+          <a:p>
+            <a:pPr>
+              <a:spcAft>
+                <a:spcPts val="900"/>
+              </a:spcAft>
+            </a:pPr>
+            <a:r>
+              <a:rPr sz="1500" b="1">
+                <a:solidFill>
+                  <a:srgbClr val="4CB86B"/>
+                </a:solidFill>
+                <a:latin typeface="Segoe UI"/>
+              </a:rPr>
+              <a:t>•  </a:t>
+            </a:r>
+            <a:r>
+              <a:rPr sz="1500" b="1">
+                <a:solidFill>
+                  <a:srgbClr val="2B2A28"/>
+                </a:solidFill>
+                <a:latin typeface="Segoe UI"/>
+              </a:rPr>
+              <a:t>Language: </a:t>
+            </a:r>
+            <a:r>
+              <a:rPr sz="1500">
+                <a:solidFill>
+                  <a:srgbClr val="2B2A28"/>
+                </a:solidFill>
+                <a:latin typeface="Segoe UI"/>
+              </a:rPr>
+              <a:t>switch instantly.</a:t>
+            </a:r>
+          </a:p>
+        </p:txBody>
+      </p:sp>
+      <p:sp>
+        <p:nvSpPr>
+          <p:cNvPr id="11" name="TextBox 10"/>
+          <p:cNvSpPr txBox="1"/>
+          <p:nvPr/>
+        </p:nvSpPr>
+        <p:spPr>
+          <a:xfrm>
+            <a:off x="7772400" y="2148840"/>
+            <a:ext cx="4114800" cy="4206240"/>
+          </a:xfrm>
+          <a:prstGeom prst="rect">
+            <a:avLst/>
+          </a:prstGeom>
+          <a:noFill/>
+        </p:spPr>
+        <p:txBody>
+          <a:bodyPr wrap="square">
+            <a:spAutoFit/>
+          </a:bodyPr>
+          <a:lstStyle/>
+          <a:p>
+            <a:pPr>
+              <a:spcAft>
+                <a:spcPts val="300"/>
+              </a:spcAft>
+            </a:pPr>
+            <a:r>
+              <a:rPr sz="1400" b="1">
+                <a:solidFill>
+                  <a:srgbClr val="4CB86B"/>
+                </a:solidFill>
+                <a:latin typeface="Segoe UI"/>
+              </a:rPr>
+              <a:t>•  </a:t>
+            </a:r>
+            <a:r>
+              <a:rPr sz="1400">
+                <a:solidFill>
+                  <a:srgbClr val="2B2A28"/>
+                </a:solidFill>
+                <a:latin typeface="Segoe UI"/>
+              </a:rPr>
+              <a:t>Click action: open hub · open focus timer · tickle (double-click opens) · only tickle</a:t>
+            </a:r>
+          </a:p>
+          <a:p>
+            <a:pPr>
+              <a:spcAft>
+                <a:spcPts val="300"/>
+              </a:spcAft>
+            </a:pPr>
+            <a:r>
+              <a:rPr sz="1400" b="1">
+                <a:solidFill>
+                  <a:srgbClr val="4CB86B"/>
+                </a:solidFill>
+                <a:latin typeface="Segoe UI"/>
+              </a:rPr>
+              <a:t>•  </a:t>
+            </a:r>
+            <a:r>
+              <a:rPr sz="1400">
+                <a:solidFill>
+                  <a:srgbClr val="2B2A28"/>
+                </a:solidFill>
+                <a:latin typeface="Segoe UI"/>
+              </a:rPr>
+              <a:t>Show reminders as chat bubbles</a:t>
+            </a:r>
+          </a:p>
+          <a:p>
+            <a:pPr>
+              <a:spcAft>
+                <a:spcPts val="300"/>
+              </a:spcAft>
+            </a:pPr>
+            <a:r>
+              <a:rPr sz="1400" b="1">
+                <a:solidFill>
+                  <a:srgbClr val="4CB86B"/>
+                </a:solidFill>
+                <a:latin typeface="Segoe UI"/>
+              </a:rPr>
+              <a:t>•  </a:t>
+            </a:r>
+            <a:r>
+              <a:rPr sz="1400">
+                <a:solidFill>
+                  <a:srgbClr val="2B2A28"/>
+                </a:solidFill>
+                <a:latin typeface="Segoe UI"/>
+              </a:rPr>
+              <a:t>Walk around on the taskbar</a:t>
+            </a:r>
+          </a:p>
+          <a:p>
+            <a:pPr>
+              <a:spcAft>
+                <a:spcPts val="300"/>
+              </a:spcAft>
+            </a:pPr>
+            <a:r>
+              <a:rPr sz="1400" b="1">
+                <a:solidFill>
+                  <a:srgbClr val="4CB86B"/>
+                </a:solidFill>
+                <a:latin typeface="Segoe UI"/>
+              </a:rPr>
+              <a:t>•  </a:t>
+            </a:r>
+            <a:r>
+              <a:rPr sz="1400">
+                <a:solidFill>
+                  <a:srgbClr val="2B2A28"/>
+                </a:solidFill>
+                <a:latin typeface="Segoe UI"/>
+              </a:rPr>
+              <a:t>Gravity (falls when dropped)</a:t>
+            </a:r>
+          </a:p>
+          <a:p>
+            <a:pPr>
+              <a:spcAft>
+                <a:spcPts val="300"/>
+              </a:spcAft>
+            </a:pPr>
+            <a:r>
+              <a:rPr sz="1400" b="1">
+                <a:solidFill>
+                  <a:srgbClr val="4CB86B"/>
+                </a:solidFill>
+                <a:latin typeface="Segoe UI"/>
+              </a:rPr>
+              <a:t>•  </a:t>
+            </a:r>
+            <a:r>
+              <a:rPr sz="1400">
+                <a:solidFill>
+                  <a:srgbClr val="2B2A28"/>
+                </a:solidFill>
+                <a:latin typeface="Segoe UI"/>
+              </a:rPr>
+              <a:t>Nap when I'm away</a:t>
+            </a:r>
+          </a:p>
+          <a:p>
+            <a:pPr>
+              <a:spcAft>
+                <a:spcPts val="300"/>
+              </a:spcAft>
+            </a:pPr>
+            <a:r>
+              <a:rPr sz="1400" b="1">
+                <a:solidFill>
+                  <a:srgbClr val="4CB86B"/>
+                </a:solidFill>
+                <a:latin typeface="Segoe UI"/>
+              </a:rPr>
+              <a:t>•  </a:t>
+            </a:r>
+            <a:r>
+              <a:rPr sz="1400">
+                <a:solidFill>
+                  <a:srgbClr val="2B2A28"/>
+                </a:solidFill>
+                <a:latin typeface="Segoe UI"/>
+              </a:rPr>
+              <a:t>Open the card next to the pet</a:t>
+            </a:r>
+          </a:p>
+          <a:p>
+            <a:pPr>
+              <a:spcAft>
+                <a:spcPts val="300"/>
+              </a:spcAft>
+            </a:pPr>
+            <a:r>
+              <a:rPr sz="1400" b="1">
+                <a:solidFill>
+                  <a:srgbClr val="4CB86B"/>
+                </a:solidFill>
+                <a:latin typeface="Segoe UI"/>
+              </a:rPr>
+              <a:t>•  </a:t>
+            </a:r>
+            <a:r>
+              <a:rPr sz="1400">
+                <a:solidFill>
+                  <a:srgbClr val="2B2A28"/>
+                </a:solidFill>
+                <a:latin typeface="Segoe UI"/>
+              </a:rPr>
+              <a:t>Chatty (little messages)</a:t>
+            </a:r>
+          </a:p>
+          <a:p>
+            <a:pPr>
+              <a:spcAft>
+                <a:spcPts val="300"/>
+              </a:spcAft>
+            </a:pPr>
+            <a:r>
+              <a:rPr sz="1400" b="1">
+                <a:solidFill>
+                  <a:srgbClr val="4CB86B"/>
+                </a:solidFill>
+                <a:latin typeface="Segoe UI"/>
+              </a:rPr>
+              <a:t>•  </a:t>
+            </a:r>
+            <a:r>
+              <a:rPr sz="1400">
+                <a:solidFill>
+                  <a:srgbClr val="2B2A28"/>
+                </a:solidFill>
+                <a:latin typeface="Segoe UI"/>
+              </a:rPr>
+              <a:t>Hide during full-screen apps</a:t>
+            </a:r>
+          </a:p>
+          <a:p>
+            <a:pPr>
+              <a:spcAft>
+                <a:spcPts val="300"/>
+              </a:spcAft>
+            </a:pPr>
+            <a:r>
+              <a:rPr sz="1400" b="1">
+                <a:solidFill>
+                  <a:srgbClr val="4CB86B"/>
+                </a:solidFill>
+                <a:latin typeface="Segoe UI"/>
+              </a:rPr>
+              <a:t>•  </a:t>
+            </a:r>
+            <a:r>
+              <a:rPr sz="1400">
+                <a:solidFill>
+                  <a:srgbClr val="2B2A28"/>
+                </a:solidFill>
+                <a:latin typeface="Segoe UI"/>
+              </a:rPr>
+              <a:t>Check for updates automatically</a:t>
+            </a:r>
+          </a:p>
+          <a:p>
+            <a:pPr>
+              <a:spcAft>
+                <a:spcPts val="300"/>
+              </a:spcAft>
+            </a:pPr>
+            <a:r>
+              <a:rPr sz="1400" b="1">
+                <a:solidFill>
+                  <a:srgbClr val="4CB86B"/>
+                </a:solidFill>
+                <a:latin typeface="Segoe UI"/>
+              </a:rPr>
+              <a:t>•  </a:t>
+            </a:r>
+            <a:r>
+              <a:rPr sz="1400">
+                <a:solidFill>
+                  <a:srgbClr val="2B2A28"/>
+                </a:solidFill>
+                <a:latin typeface="Segoe UI"/>
+              </a:rPr>
+              <a:t>Animal sounds + volume (quiet while focusing)</a:t>
             </a:r>
           </a:p>
         </p:txBody>
@@ -6400,7 +6061,7 @@
                 </a:solidFill>
                 <a:latin typeface="Segoe UI"/>
               </a:rPr>
-              <a:t>NEW IN 2.1</a:t>
+              <a:t>CUSTOMIZE</a:t>
             </a:r>
           </a:p>
         </p:txBody>
@@ -6435,7 +6096,7 @@
                 </a:solidFill>
                 <a:latin typeface="Segoe UI"/>
               </a:rPr>
-              <a:t>Updates - right inside Pips</a:t>
+              <a:t>Languages</a:t>
             </a:r>
           </a:p>
         </p:txBody>
@@ -6518,35 +6179,54 @@
           </a:p>
         </p:txBody>
       </p:sp>
-      <p:pic>
-        <p:nvPicPr>
-          <p:cNvPr id="7" name="Picture 6" descr="update_offer.png"/>
-          <p:cNvPicPr>
-            <a:picLocks noChangeAspect="1"/>
-          </p:cNvPicPr>
-          <p:nvPr/>
-        </p:nvPicPr>
-        <p:blipFill>
-          <a:blip r:embed="rId2"/>
-          <a:stretch>
-            <a:fillRect/>
-          </a:stretch>
-        </p:blipFill>
-        <p:spPr>
-          <a:xfrm>
-            <a:off x="572153" y="1645920"/>
-            <a:ext cx="4890733" cy="3291840"/>
-          </a:xfrm>
-          <a:prstGeom prst="rect">
-            <a:avLst/>
-          </a:prstGeom>
+      <p:sp>
+        <p:nvSpPr>
+          <p:cNvPr id="7" name="Rounded Rectangle 6"/>
+          <p:cNvSpPr/>
+          <p:nvPr/>
+        </p:nvSpPr>
+        <p:spPr>
+          <a:xfrm>
+            <a:off x="548640" y="1737360"/>
+            <a:ext cx="2606040" cy="1463040"/>
+          </a:xfrm>
+          <a:prstGeom prst="roundRect">
+            <a:avLst>
+              <a:gd name="adj" fmla="val 6000"/>
+            </a:avLst>
+          </a:prstGeom>
+          <a:solidFill>
+            <a:srgbClr val="FFFDF8"/>
+          </a:solidFill>
           <a:ln w="12700">
             <a:solidFill>
               <a:srgbClr val="E2DCCE"/>
             </a:solidFill>
           </a:ln>
-        </p:spPr>
-      </p:pic>
+          <a:effectLst/>
+        </p:spPr>
+        <p:style>
+          <a:lnRef idx="1">
+            <a:schemeClr val="accent1"/>
+          </a:lnRef>
+          <a:fillRef idx="3">
+            <a:schemeClr val="accent1"/>
+          </a:fillRef>
+          <a:effectRef idx="2">
+            <a:schemeClr val="accent1"/>
+          </a:effectRef>
+          <a:fontRef idx="minor">
+            <a:schemeClr val="lt1"/>
+          </a:fontRef>
+        </p:style>
+        <p:txBody>
+          <a:bodyPr rtlCol="0" anchor="ctr"/>
+          <a:lstStyle/>
+          <a:p>
+            <a:pPr algn="ctr"/>
+          </a:p>
+        </p:txBody>
+      </p:sp>
       <p:sp>
         <p:nvSpPr>
           <p:cNvPr id="8" name="TextBox 7"/>
@@ -6555,8 +6235,8 @@
         </p:nvSpPr>
         <p:spPr>
           <a:xfrm>
-            <a:off x="548640" y="4983480"/>
-            <a:ext cx="4937760" cy="365760"/>
+            <a:off x="548640" y="1920240"/>
+            <a:ext cx="2606040" cy="548640"/>
           </a:xfrm>
           <a:prstGeom prst="rect">
             <a:avLst/>
@@ -6571,13 +6251,13 @@
           <a:p>
             <a:pPr algn="ctr"/>
             <a:r>
-              <a:rPr sz="1200" b="0">
-                <a:solidFill>
-                  <a:srgbClr val="6E6A62"/>
-                </a:solidFill>
-                <a:latin typeface="Segoe UI"/>
-              </a:rPr>
-              <a:t>Example of an update notice (sample version text)</a:t>
+              <a:rPr sz="2000" b="1">
+                <a:solidFill>
+                  <a:srgbClr val="2B2A28"/>
+                </a:solidFill>
+                <a:latin typeface="Microsoft JhengHei"/>
+              </a:rPr>
+              <a:t>English</a:t>
             </a:r>
           </a:p>
         </p:txBody>
@@ -6590,8 +6270,397 @@
         </p:nvSpPr>
         <p:spPr>
           <a:xfrm>
-            <a:off x="5852160" y="1645920"/>
-            <a:ext cx="5943600" cy="4572000"/>
+            <a:off x="548640" y="2514600"/>
+            <a:ext cx="2606040" cy="457200"/>
+          </a:xfrm>
+          <a:prstGeom prst="rect">
+            <a:avLst/>
+          </a:prstGeom>
+          <a:noFill/>
+        </p:spPr>
+        <p:txBody>
+          <a:bodyPr wrap="square" anchor="t" lIns="45720" rIns="45720" tIns="27432" bIns="27432">
+            <a:spAutoFit/>
+          </a:bodyPr>
+          <a:lstStyle/>
+          <a:p>
+            <a:pPr algn="ctr"/>
+            <a:r>
+              <a:rPr sz="1500" b="0">
+                <a:solidFill>
+                  <a:srgbClr val="6E6A62"/>
+                </a:solidFill>
+                <a:latin typeface="Microsoft JhengHei"/>
+              </a:rPr>
+              <a:t>Hello!</a:t>
+            </a:r>
+          </a:p>
+        </p:txBody>
+      </p:sp>
+      <p:sp>
+        <p:nvSpPr>
+          <p:cNvPr id="10" name="Rounded Rectangle 9"/>
+          <p:cNvSpPr/>
+          <p:nvPr/>
+        </p:nvSpPr>
+        <p:spPr>
+          <a:xfrm>
+            <a:off x="3383280" y="1737360"/>
+            <a:ext cx="2606040" cy="1463040"/>
+          </a:xfrm>
+          <a:prstGeom prst="roundRect">
+            <a:avLst>
+              <a:gd name="adj" fmla="val 6000"/>
+            </a:avLst>
+          </a:prstGeom>
+          <a:solidFill>
+            <a:srgbClr val="FFFDF8"/>
+          </a:solidFill>
+          <a:ln w="12700">
+            <a:solidFill>
+              <a:srgbClr val="E2DCCE"/>
+            </a:solidFill>
+          </a:ln>
+          <a:effectLst/>
+        </p:spPr>
+        <p:style>
+          <a:lnRef idx="1">
+            <a:schemeClr val="accent1"/>
+          </a:lnRef>
+          <a:fillRef idx="3">
+            <a:schemeClr val="accent1"/>
+          </a:fillRef>
+          <a:effectRef idx="2">
+            <a:schemeClr val="accent1"/>
+          </a:effectRef>
+          <a:fontRef idx="minor">
+            <a:schemeClr val="lt1"/>
+          </a:fontRef>
+        </p:style>
+        <p:txBody>
+          <a:bodyPr rtlCol="0" anchor="ctr"/>
+          <a:lstStyle/>
+          <a:p>
+            <a:pPr algn="ctr"/>
+          </a:p>
+        </p:txBody>
+      </p:sp>
+      <p:sp>
+        <p:nvSpPr>
+          <p:cNvPr id="11" name="TextBox 10"/>
+          <p:cNvSpPr txBox="1"/>
+          <p:nvPr/>
+        </p:nvSpPr>
+        <p:spPr>
+          <a:xfrm>
+            <a:off x="3383280" y="1920240"/>
+            <a:ext cx="2606040" cy="548640"/>
+          </a:xfrm>
+          <a:prstGeom prst="rect">
+            <a:avLst/>
+          </a:prstGeom>
+          <a:noFill/>
+        </p:spPr>
+        <p:txBody>
+          <a:bodyPr wrap="square" anchor="t" lIns="45720" rIns="45720" tIns="27432" bIns="27432">
+            <a:spAutoFit/>
+          </a:bodyPr>
+          <a:lstStyle/>
+          <a:p>
+            <a:pPr algn="ctr"/>
+            <a:r>
+              <a:rPr sz="2000" b="1">
+                <a:solidFill>
+                  <a:srgbClr val="2B2A28"/>
+                </a:solidFill>
+                <a:latin typeface="Microsoft JhengHei"/>
+              </a:rPr>
+              <a:t>Bahasa Indonesia</a:t>
+            </a:r>
+          </a:p>
+        </p:txBody>
+      </p:sp>
+      <p:sp>
+        <p:nvSpPr>
+          <p:cNvPr id="12" name="TextBox 11"/>
+          <p:cNvSpPr txBox="1"/>
+          <p:nvPr/>
+        </p:nvSpPr>
+        <p:spPr>
+          <a:xfrm>
+            <a:off x="3383280" y="2514600"/>
+            <a:ext cx="2606040" cy="457200"/>
+          </a:xfrm>
+          <a:prstGeom prst="rect">
+            <a:avLst/>
+          </a:prstGeom>
+          <a:noFill/>
+        </p:spPr>
+        <p:txBody>
+          <a:bodyPr wrap="square" anchor="t" lIns="45720" rIns="45720" tIns="27432" bIns="27432">
+            <a:spAutoFit/>
+          </a:bodyPr>
+          <a:lstStyle/>
+          <a:p>
+            <a:pPr algn="ctr"/>
+            <a:r>
+              <a:rPr sz="1500" b="0">
+                <a:solidFill>
+                  <a:srgbClr val="6E6A62"/>
+                </a:solidFill>
+                <a:latin typeface="Microsoft JhengHei"/>
+              </a:rPr>
+              <a:t>Halo!</a:t>
+            </a:r>
+          </a:p>
+        </p:txBody>
+      </p:sp>
+      <p:sp>
+        <p:nvSpPr>
+          <p:cNvPr id="13" name="Rounded Rectangle 12"/>
+          <p:cNvSpPr/>
+          <p:nvPr/>
+        </p:nvSpPr>
+        <p:spPr>
+          <a:xfrm>
+            <a:off x="6217920" y="1737360"/>
+            <a:ext cx="2606040" cy="1463040"/>
+          </a:xfrm>
+          <a:prstGeom prst="roundRect">
+            <a:avLst>
+              <a:gd name="adj" fmla="val 6000"/>
+            </a:avLst>
+          </a:prstGeom>
+          <a:solidFill>
+            <a:srgbClr val="FFFDF8"/>
+          </a:solidFill>
+          <a:ln w="12700">
+            <a:solidFill>
+              <a:srgbClr val="E2DCCE"/>
+            </a:solidFill>
+          </a:ln>
+          <a:effectLst/>
+        </p:spPr>
+        <p:style>
+          <a:lnRef idx="1">
+            <a:schemeClr val="accent1"/>
+          </a:lnRef>
+          <a:fillRef idx="3">
+            <a:schemeClr val="accent1"/>
+          </a:fillRef>
+          <a:effectRef idx="2">
+            <a:schemeClr val="accent1"/>
+          </a:effectRef>
+          <a:fontRef idx="minor">
+            <a:schemeClr val="lt1"/>
+          </a:fontRef>
+        </p:style>
+        <p:txBody>
+          <a:bodyPr rtlCol="0" anchor="ctr"/>
+          <a:lstStyle/>
+          <a:p>
+            <a:pPr algn="ctr"/>
+          </a:p>
+        </p:txBody>
+      </p:sp>
+      <p:sp>
+        <p:nvSpPr>
+          <p:cNvPr id="14" name="TextBox 13"/>
+          <p:cNvSpPr txBox="1"/>
+          <p:nvPr/>
+        </p:nvSpPr>
+        <p:spPr>
+          <a:xfrm>
+            <a:off x="6217920" y="1920240"/>
+            <a:ext cx="2606040" cy="548640"/>
+          </a:xfrm>
+          <a:prstGeom prst="rect">
+            <a:avLst/>
+          </a:prstGeom>
+          <a:noFill/>
+        </p:spPr>
+        <p:txBody>
+          <a:bodyPr wrap="square" anchor="t" lIns="45720" rIns="45720" tIns="27432" bIns="27432">
+            <a:spAutoFit/>
+          </a:bodyPr>
+          <a:lstStyle/>
+          <a:p>
+            <a:pPr algn="ctr"/>
+            <a:r>
+              <a:rPr sz="2000" b="1">
+                <a:solidFill>
+                  <a:srgbClr val="2B2A28"/>
+                </a:solidFill>
+                <a:latin typeface="Microsoft JhengHei"/>
+              </a:rPr>
+              <a:t>繁體中文</a:t>
+            </a:r>
+          </a:p>
+        </p:txBody>
+      </p:sp>
+      <p:sp>
+        <p:nvSpPr>
+          <p:cNvPr id="15" name="TextBox 14"/>
+          <p:cNvSpPr txBox="1"/>
+          <p:nvPr/>
+        </p:nvSpPr>
+        <p:spPr>
+          <a:xfrm>
+            <a:off x="6217920" y="2514600"/>
+            <a:ext cx="2606040" cy="457200"/>
+          </a:xfrm>
+          <a:prstGeom prst="rect">
+            <a:avLst/>
+          </a:prstGeom>
+          <a:noFill/>
+        </p:spPr>
+        <p:txBody>
+          <a:bodyPr wrap="square" anchor="t" lIns="45720" rIns="45720" tIns="27432" bIns="27432">
+            <a:spAutoFit/>
+          </a:bodyPr>
+          <a:lstStyle/>
+          <a:p>
+            <a:pPr algn="ctr"/>
+            <a:r>
+              <a:rPr sz="1500" b="0">
+                <a:solidFill>
+                  <a:srgbClr val="6E6A62"/>
+                </a:solidFill>
+                <a:latin typeface="Microsoft JhengHei"/>
+              </a:rPr>
+              <a:t>你好！</a:t>
+            </a:r>
+          </a:p>
+        </p:txBody>
+      </p:sp>
+      <p:sp>
+        <p:nvSpPr>
+          <p:cNvPr id="16" name="Rounded Rectangle 15"/>
+          <p:cNvSpPr/>
+          <p:nvPr/>
+        </p:nvSpPr>
+        <p:spPr>
+          <a:xfrm>
+            <a:off x="9052560" y="1737360"/>
+            <a:ext cx="2606040" cy="1463040"/>
+          </a:xfrm>
+          <a:prstGeom prst="roundRect">
+            <a:avLst>
+              <a:gd name="adj" fmla="val 6000"/>
+            </a:avLst>
+          </a:prstGeom>
+          <a:solidFill>
+            <a:srgbClr val="FFFDF8"/>
+          </a:solidFill>
+          <a:ln w="12700">
+            <a:solidFill>
+              <a:srgbClr val="E2DCCE"/>
+            </a:solidFill>
+          </a:ln>
+          <a:effectLst/>
+        </p:spPr>
+        <p:style>
+          <a:lnRef idx="1">
+            <a:schemeClr val="accent1"/>
+          </a:lnRef>
+          <a:fillRef idx="3">
+            <a:schemeClr val="accent1"/>
+          </a:fillRef>
+          <a:effectRef idx="2">
+            <a:schemeClr val="accent1"/>
+          </a:effectRef>
+          <a:fontRef idx="minor">
+            <a:schemeClr val="lt1"/>
+          </a:fontRef>
+        </p:style>
+        <p:txBody>
+          <a:bodyPr rtlCol="0" anchor="ctr"/>
+          <a:lstStyle/>
+          <a:p>
+            <a:pPr algn="ctr"/>
+          </a:p>
+        </p:txBody>
+      </p:sp>
+      <p:sp>
+        <p:nvSpPr>
+          <p:cNvPr id="17" name="TextBox 16"/>
+          <p:cNvSpPr txBox="1"/>
+          <p:nvPr/>
+        </p:nvSpPr>
+        <p:spPr>
+          <a:xfrm>
+            <a:off x="9052560" y="1920240"/>
+            <a:ext cx="2606040" cy="548640"/>
+          </a:xfrm>
+          <a:prstGeom prst="rect">
+            <a:avLst/>
+          </a:prstGeom>
+          <a:noFill/>
+        </p:spPr>
+        <p:txBody>
+          <a:bodyPr wrap="square" anchor="t" lIns="45720" rIns="45720" tIns="27432" bIns="27432">
+            <a:spAutoFit/>
+          </a:bodyPr>
+          <a:lstStyle/>
+          <a:p>
+            <a:pPr algn="ctr"/>
+            <a:r>
+              <a:rPr sz="2000" b="1">
+                <a:solidFill>
+                  <a:srgbClr val="2B2A28"/>
+                </a:solidFill>
+                <a:latin typeface="Microsoft JhengHei"/>
+              </a:rPr>
+              <a:t>简体中文</a:t>
+            </a:r>
+          </a:p>
+        </p:txBody>
+      </p:sp>
+      <p:sp>
+        <p:nvSpPr>
+          <p:cNvPr id="18" name="TextBox 17"/>
+          <p:cNvSpPr txBox="1"/>
+          <p:nvPr/>
+        </p:nvSpPr>
+        <p:spPr>
+          <a:xfrm>
+            <a:off x="9052560" y="2514600"/>
+            <a:ext cx="2606040" cy="457200"/>
+          </a:xfrm>
+          <a:prstGeom prst="rect">
+            <a:avLst/>
+          </a:prstGeom>
+          <a:noFill/>
+        </p:spPr>
+        <p:txBody>
+          <a:bodyPr wrap="square" anchor="t" lIns="45720" rIns="45720" tIns="27432" bIns="27432">
+            <a:spAutoFit/>
+          </a:bodyPr>
+          <a:lstStyle/>
+          <a:p>
+            <a:pPr algn="ctr"/>
+            <a:r>
+              <a:rPr sz="1500" b="0">
+                <a:solidFill>
+                  <a:srgbClr val="6E6A62"/>
+                </a:solidFill>
+                <a:latin typeface="Microsoft JhengHei"/>
+              </a:rPr>
+              <a:t>你好！</a:t>
+            </a:r>
+          </a:p>
+        </p:txBody>
+      </p:sp>
+      <p:sp>
+        <p:nvSpPr>
+          <p:cNvPr id="19" name="TextBox 18"/>
+          <p:cNvSpPr txBox="1"/>
+          <p:nvPr/>
+        </p:nvSpPr>
+        <p:spPr>
+          <a:xfrm>
+            <a:off x="548640" y="3566160"/>
+            <a:ext cx="10972800" cy="2743200"/>
           </a:xfrm>
           <a:prstGeom prst="rect">
             <a:avLst/>
@@ -6606,11 +6675,11 @@
           <a:p>
             <a:pPr>
               <a:spcAft>
-                <a:spcPts val="900"/>
+                <a:spcPts val="1000"/>
               </a:spcAft>
             </a:pPr>
             <a:r>
-              <a:rPr sz="1500" b="1">
+              <a:rPr sz="1700" b="1">
                 <a:solidFill>
                   <a:srgbClr val="4CB86B"/>
                 </a:solidFill>
@@ -6619,32 +6688,32 @@
               <a:t>•  </a:t>
             </a:r>
             <a:r>
-              <a:rPr sz="1500" b="1">
-                <a:solidFill>
-                  <a:srgbClr val="2B2A28"/>
-                </a:solidFill>
-                <a:latin typeface="Segoe UI"/>
-              </a:rPr>
-              <a:t>Automatic check: </a:t>
-            </a:r>
-            <a:r>
-              <a:rPr sz="1500">
-                <a:solidFill>
-                  <a:srgbClr val="2B2A28"/>
-                </a:solidFill>
-                <a:latin typeface="Segoe UI"/>
-              </a:rPr>
-              <a:t>shortly after start and every 6 hours (needs internet).</a:t>
+              <a:rPr sz="1700" b="1">
+                <a:solidFill>
+                  <a:srgbClr val="2B2A28"/>
+                </a:solidFill>
+                <a:latin typeface="Segoe UI"/>
+              </a:rPr>
+              <a:t>Change anytime: </a:t>
+            </a:r>
+            <a:r>
+              <a:rPr sz="1700">
+                <a:solidFill>
+                  <a:srgbClr val="2B2A28"/>
+                </a:solidFill>
+                <a:latin typeface="Segoe UI"/>
+              </a:rPr>
+              <a:t>right-click the pet (or the card) → Language. Everything switches instantly - menus, bubbles, reminders, the card.</a:t>
             </a:r>
           </a:p>
           <a:p>
             <a:pPr>
               <a:spcAft>
-                <a:spcPts val="900"/>
+                <a:spcPts val="1000"/>
               </a:spcAft>
             </a:pPr>
             <a:r>
-              <a:rPr sz="1500" b="1">
+              <a:rPr sz="1700" b="1">
                 <a:solidFill>
                   <a:srgbClr val="4CB86B"/>
                 </a:solidFill>
@@ -6653,32 +6722,32 @@
               <a:t>•  </a:t>
             </a:r>
             <a:r>
-              <a:rPr sz="1500" b="1">
-                <a:solidFill>
-                  <a:srgbClr val="2B2A28"/>
-                </a:solidFill>
-                <a:latin typeface="Segoe UI"/>
-              </a:rPr>
-              <a:t>Your pet tells you </a:t>
-            </a:r>
-            <a:r>
-              <a:rPr sz="1500">
-                <a:solidFill>
-                  <a:srgbClr val="2B2A28"/>
-                </a:solidFill>
-                <a:latin typeface="Segoe UI"/>
-              </a:rPr>
-              <a:t>what's new and offers: Update now · Later · Skip this version.</a:t>
+              <a:rPr sz="1700" b="1">
+                <a:solidFill>
+                  <a:srgbClr val="2B2A28"/>
+                </a:solidFill>
+                <a:latin typeface="Segoe UI"/>
+              </a:rPr>
+              <a:t>First start: </a:t>
+            </a:r>
+            <a:r>
+              <a:rPr sz="1700">
+                <a:solidFill>
+                  <a:srgbClr val="2B2A28"/>
+                </a:solidFill>
+                <a:latin typeface="Segoe UI"/>
+              </a:rPr>
+              <a:t>Pips guesses from your Windows language and asks once.</a:t>
             </a:r>
           </a:p>
           <a:p>
             <a:pPr>
               <a:spcAft>
-                <a:spcPts val="900"/>
+                <a:spcPts val="1000"/>
               </a:spcAft>
             </a:pPr>
             <a:r>
-              <a:rPr sz="1500" b="1">
+              <a:rPr sz="1700" b="1">
                 <a:solidFill>
                   <a:srgbClr val="4CB86B"/>
                 </a:solidFill>
@@ -6687,124 +6756,22 @@
               <a:t>•  </a:t>
             </a:r>
             <a:r>
-              <a:rPr sz="1500" b="1">
-                <a:solidFill>
-                  <a:srgbClr val="2B2A28"/>
-                </a:solidFill>
-                <a:latin typeface="Segoe UI"/>
-              </a:rPr>
-              <a:t>Update now: </a:t>
-            </a:r>
-            <a:r>
-              <a:rPr sz="1500">
-                <a:solidFill>
-                  <a:srgbClr val="2B2A28"/>
-                </a:solidFill>
-                <a:latin typeface="Segoe UI"/>
-              </a:rPr>
-              <a:t>downloads, verifies (SHA-256), installs and restarts Pips by itself - about 10 seconds.</a:t>
-            </a:r>
-          </a:p>
-          <a:p>
-            <a:pPr>
-              <a:spcAft>
-                <a:spcPts val="900"/>
-              </a:spcAft>
-            </a:pPr>
-            <a:r>
-              <a:rPr sz="1500" b="1">
-                <a:solidFill>
-                  <a:srgbClr val="4CB86B"/>
-                </a:solidFill>
-                <a:latin typeface="Segoe UI"/>
-              </a:rPr>
-              <a:t>•  </a:t>
-            </a:r>
-            <a:r>
-              <a:rPr sz="1500" b="1">
-                <a:solidFill>
-                  <a:srgbClr val="2B2A28"/>
-                </a:solidFill>
-                <a:latin typeface="Segoe UI"/>
-              </a:rPr>
-              <a:t>Your stuff is safe: </a:t>
-            </a:r>
-            <a:r>
-              <a:rPr sz="1500">
-                <a:solidFill>
-                  <a:srgbClr val="2B2A28"/>
-                </a:solidFill>
-                <a:latin typeface="Segoe UI"/>
-              </a:rPr>
-              <a:t>settings, pet, history and reports are never touched. The old version is backed up in the backup\ folder.</a:t>
-            </a:r>
-          </a:p>
-          <a:p>
-            <a:pPr>
-              <a:spcAft>
-                <a:spcPts val="900"/>
-              </a:spcAft>
-            </a:pPr>
-            <a:r>
-              <a:rPr sz="1500" b="1">
-                <a:solidFill>
-                  <a:srgbClr val="4CB86B"/>
-                </a:solidFill>
-                <a:latin typeface="Segoe UI"/>
-              </a:rPr>
-              <a:t>•  </a:t>
-            </a:r>
-            <a:r>
-              <a:rPr sz="1500" b="1">
-                <a:solidFill>
-                  <a:srgbClr val="2B2A28"/>
-                </a:solidFill>
-                <a:latin typeface="Segoe UI"/>
-              </a:rPr>
-              <a:t>Manual check: </a:t>
-            </a:r>
-            <a:r>
-              <a:rPr sz="1500">
-                <a:solidFill>
-                  <a:srgbClr val="2B2A28"/>
-                </a:solidFill>
-                <a:latin typeface="Segoe UI"/>
-              </a:rPr>
-              <a:t>right-click the pet → Help → Check for updates.</a:t>
-            </a:r>
-          </a:p>
-          <a:p>
-            <a:pPr>
-              <a:spcAft>
-                <a:spcPts val="900"/>
-              </a:spcAft>
-            </a:pPr>
-            <a:r>
-              <a:rPr sz="1500" b="1">
-                <a:solidFill>
-                  <a:srgbClr val="4CB86B"/>
-                </a:solidFill>
-                <a:latin typeface="Segoe UI"/>
-              </a:rPr>
-              <a:t>•  </a:t>
-            </a:r>
-            <a:r>
-              <a:rPr sz="1500" b="1">
-                <a:solidFill>
-                  <a:srgbClr val="2B2A28"/>
-                </a:solidFill>
-                <a:latin typeface="Segoe UI"/>
-              </a:rPr>
-              <a:t>Don't want it? </a:t>
-            </a:r>
-            <a:r>
-              <a:rPr sz="1500">
-                <a:solidFill>
-                  <a:srgbClr val="2B2A28"/>
-                </a:solidFill>
-                <a:latin typeface="Segoe UI"/>
-              </a:rPr>
-              <a:t>Pet status &amp; settings → uncheck “Check for updates automatically”.</a:t>
+              <a:rPr sz="1700" b="1">
+                <a:solidFill>
+                  <a:srgbClr val="2B2A28"/>
+                </a:solidFill>
+                <a:latin typeface="Segoe UI"/>
+              </a:rPr>
+              <a:t>Update notes </a:t>
+            </a:r>
+            <a:r>
+              <a:rPr sz="1700">
+                <a:solidFill>
+                  <a:srgbClr val="2B2A28"/>
+                </a:solidFill>
+                <a:latin typeface="Segoe UI"/>
+              </a:rPr>
+              <a:t>are shown in your language too.</a:t>
             </a:r>
           </a:p>
         </p:txBody>
@@ -6908,7 +6875,7 @@
                 </a:solidFill>
                 <a:latin typeface="Segoe UI"/>
               </a:rPr>
-              <a:t>HELP</a:t>
+              <a:t>NEW IN 2.1</a:t>
             </a:r>
           </a:p>
         </p:txBody>
@@ -6943,7 +6910,7 @@
                 </a:solidFill>
                 <a:latin typeface="Segoe UI"/>
               </a:rPr>
-              <a:t>Troubleshooting &amp; FAQ</a:t>
+              <a:t>Updates - right inside Pips</a:t>
             </a:r>
           </a:p>
         </p:txBody>
@@ -7022,6 +6989,514 @@
                 <a:latin typeface="Segoe UI"/>
               </a:rPr>
               <a:t>Pips · 15</a:t>
+            </a:r>
+          </a:p>
+        </p:txBody>
+      </p:sp>
+      <p:pic>
+        <p:nvPicPr>
+          <p:cNvPr id="7" name="Picture 6" descr="update_offer.png"/>
+          <p:cNvPicPr>
+            <a:picLocks noChangeAspect="1"/>
+          </p:cNvPicPr>
+          <p:nvPr/>
+        </p:nvPicPr>
+        <p:blipFill>
+          <a:blip r:embed="rId2"/>
+          <a:stretch>
+            <a:fillRect/>
+          </a:stretch>
+        </p:blipFill>
+        <p:spPr>
+          <a:xfrm>
+            <a:off x="572153" y="1645920"/>
+            <a:ext cx="4890733" cy="3291840"/>
+          </a:xfrm>
+          <a:prstGeom prst="rect">
+            <a:avLst/>
+          </a:prstGeom>
+          <a:ln w="12700">
+            <a:solidFill>
+              <a:srgbClr val="E2DCCE"/>
+            </a:solidFill>
+          </a:ln>
+        </p:spPr>
+      </p:pic>
+      <p:sp>
+        <p:nvSpPr>
+          <p:cNvPr id="8" name="TextBox 7"/>
+          <p:cNvSpPr txBox="1"/>
+          <p:nvPr/>
+        </p:nvSpPr>
+        <p:spPr>
+          <a:xfrm>
+            <a:off x="548640" y="4983480"/>
+            <a:ext cx="4937760" cy="365760"/>
+          </a:xfrm>
+          <a:prstGeom prst="rect">
+            <a:avLst/>
+          </a:prstGeom>
+          <a:noFill/>
+        </p:spPr>
+        <p:txBody>
+          <a:bodyPr wrap="square" anchor="t" lIns="45720" rIns="45720" tIns="27432" bIns="27432">
+            <a:spAutoFit/>
+          </a:bodyPr>
+          <a:lstStyle/>
+          <a:p>
+            <a:pPr algn="ctr"/>
+            <a:r>
+              <a:rPr sz="1200" b="0">
+                <a:solidFill>
+                  <a:srgbClr val="6E6A62"/>
+                </a:solidFill>
+                <a:latin typeface="Segoe UI"/>
+              </a:rPr>
+              <a:t>Example of an update notice (sample version text)</a:t>
+            </a:r>
+          </a:p>
+        </p:txBody>
+      </p:sp>
+      <p:sp>
+        <p:nvSpPr>
+          <p:cNvPr id="9" name="TextBox 8"/>
+          <p:cNvSpPr txBox="1"/>
+          <p:nvPr/>
+        </p:nvSpPr>
+        <p:spPr>
+          <a:xfrm>
+            <a:off x="5852160" y="1645920"/>
+            <a:ext cx="5943600" cy="4572000"/>
+          </a:xfrm>
+          <a:prstGeom prst="rect">
+            <a:avLst/>
+          </a:prstGeom>
+          <a:noFill/>
+        </p:spPr>
+        <p:txBody>
+          <a:bodyPr wrap="square">
+            <a:spAutoFit/>
+          </a:bodyPr>
+          <a:lstStyle/>
+          <a:p>
+            <a:pPr>
+              <a:spcAft>
+                <a:spcPts val="900"/>
+              </a:spcAft>
+            </a:pPr>
+            <a:r>
+              <a:rPr sz="1500" b="1">
+                <a:solidFill>
+                  <a:srgbClr val="4CB86B"/>
+                </a:solidFill>
+                <a:latin typeface="Segoe UI"/>
+              </a:rPr>
+              <a:t>•  </a:t>
+            </a:r>
+            <a:r>
+              <a:rPr sz="1500" b="1">
+                <a:solidFill>
+                  <a:srgbClr val="2B2A28"/>
+                </a:solidFill>
+                <a:latin typeface="Segoe UI"/>
+              </a:rPr>
+              <a:t>Automatic check: </a:t>
+            </a:r>
+            <a:r>
+              <a:rPr sz="1500">
+                <a:solidFill>
+                  <a:srgbClr val="2B2A28"/>
+                </a:solidFill>
+                <a:latin typeface="Segoe UI"/>
+              </a:rPr>
+              <a:t>shortly after start and every 6 hours (needs internet).</a:t>
+            </a:r>
+          </a:p>
+          <a:p>
+            <a:pPr>
+              <a:spcAft>
+                <a:spcPts val="900"/>
+              </a:spcAft>
+            </a:pPr>
+            <a:r>
+              <a:rPr sz="1500" b="1">
+                <a:solidFill>
+                  <a:srgbClr val="4CB86B"/>
+                </a:solidFill>
+                <a:latin typeface="Segoe UI"/>
+              </a:rPr>
+              <a:t>•  </a:t>
+            </a:r>
+            <a:r>
+              <a:rPr sz="1500" b="1">
+                <a:solidFill>
+                  <a:srgbClr val="2B2A28"/>
+                </a:solidFill>
+                <a:latin typeface="Segoe UI"/>
+              </a:rPr>
+              <a:t>Your pet tells you </a:t>
+            </a:r>
+            <a:r>
+              <a:rPr sz="1500">
+                <a:solidFill>
+                  <a:srgbClr val="2B2A28"/>
+                </a:solidFill>
+                <a:latin typeface="Segoe UI"/>
+              </a:rPr>
+              <a:t>what's new and offers: Update now · Later · Skip this version.</a:t>
+            </a:r>
+          </a:p>
+          <a:p>
+            <a:pPr>
+              <a:spcAft>
+                <a:spcPts val="900"/>
+              </a:spcAft>
+            </a:pPr>
+            <a:r>
+              <a:rPr sz="1500" b="1">
+                <a:solidFill>
+                  <a:srgbClr val="4CB86B"/>
+                </a:solidFill>
+                <a:latin typeface="Segoe UI"/>
+              </a:rPr>
+              <a:t>•  </a:t>
+            </a:r>
+            <a:r>
+              <a:rPr sz="1500" b="1">
+                <a:solidFill>
+                  <a:srgbClr val="2B2A28"/>
+                </a:solidFill>
+                <a:latin typeface="Segoe UI"/>
+              </a:rPr>
+              <a:t>Update now: </a:t>
+            </a:r>
+            <a:r>
+              <a:rPr sz="1500">
+                <a:solidFill>
+                  <a:srgbClr val="2B2A28"/>
+                </a:solidFill>
+                <a:latin typeface="Segoe UI"/>
+              </a:rPr>
+              <a:t>downloads, verifies (SHA-256), installs and restarts Pips by itself - about 10 seconds.</a:t>
+            </a:r>
+          </a:p>
+          <a:p>
+            <a:pPr>
+              <a:spcAft>
+                <a:spcPts val="900"/>
+              </a:spcAft>
+            </a:pPr>
+            <a:r>
+              <a:rPr sz="1500" b="1">
+                <a:solidFill>
+                  <a:srgbClr val="4CB86B"/>
+                </a:solidFill>
+                <a:latin typeface="Segoe UI"/>
+              </a:rPr>
+              <a:t>•  </a:t>
+            </a:r>
+            <a:r>
+              <a:rPr sz="1500" b="1">
+                <a:solidFill>
+                  <a:srgbClr val="2B2A28"/>
+                </a:solidFill>
+                <a:latin typeface="Segoe UI"/>
+              </a:rPr>
+              <a:t>Your stuff is safe: </a:t>
+            </a:r>
+            <a:r>
+              <a:rPr sz="1500">
+                <a:solidFill>
+                  <a:srgbClr val="2B2A28"/>
+                </a:solidFill>
+                <a:latin typeface="Segoe UI"/>
+              </a:rPr>
+              <a:t>settings, pet, history and reports are never touched. The old version is backed up in the backup\ folder.</a:t>
+            </a:r>
+          </a:p>
+          <a:p>
+            <a:pPr>
+              <a:spcAft>
+                <a:spcPts val="900"/>
+              </a:spcAft>
+            </a:pPr>
+            <a:r>
+              <a:rPr sz="1500" b="1">
+                <a:solidFill>
+                  <a:srgbClr val="4CB86B"/>
+                </a:solidFill>
+                <a:latin typeface="Segoe UI"/>
+              </a:rPr>
+              <a:t>•  </a:t>
+            </a:r>
+            <a:r>
+              <a:rPr sz="1500" b="1">
+                <a:solidFill>
+                  <a:srgbClr val="2B2A28"/>
+                </a:solidFill>
+                <a:latin typeface="Segoe UI"/>
+              </a:rPr>
+              <a:t>Manual check: </a:t>
+            </a:r>
+            <a:r>
+              <a:rPr sz="1500">
+                <a:solidFill>
+                  <a:srgbClr val="2B2A28"/>
+                </a:solidFill>
+                <a:latin typeface="Segoe UI"/>
+              </a:rPr>
+              <a:t>right-click the pet → Help → Check for updates.</a:t>
+            </a:r>
+          </a:p>
+          <a:p>
+            <a:pPr>
+              <a:spcAft>
+                <a:spcPts val="900"/>
+              </a:spcAft>
+            </a:pPr>
+            <a:r>
+              <a:rPr sz="1500" b="1">
+                <a:solidFill>
+                  <a:srgbClr val="4CB86B"/>
+                </a:solidFill>
+                <a:latin typeface="Segoe UI"/>
+              </a:rPr>
+              <a:t>•  </a:t>
+            </a:r>
+            <a:r>
+              <a:rPr sz="1500" b="1">
+                <a:solidFill>
+                  <a:srgbClr val="2B2A28"/>
+                </a:solidFill>
+                <a:latin typeface="Segoe UI"/>
+              </a:rPr>
+              <a:t>Don't want it? </a:t>
+            </a:r>
+            <a:r>
+              <a:rPr sz="1500">
+                <a:solidFill>
+                  <a:srgbClr val="2B2A28"/>
+                </a:solidFill>
+                <a:latin typeface="Segoe UI"/>
+              </a:rPr>
+              <a:t>Pet status &amp; settings → uncheck “Check for updates automatically”.</a:t>
+            </a:r>
+          </a:p>
+        </p:txBody>
+      </p:sp>
+    </p:spTree>
+  </p:cSld>
+  <p:clrMapOvr>
+    <a:masterClrMapping/>
+  </p:clrMapOvr>
+</p:sld>
+</file>
+
+<file path=ppt/slides/slide16.xml><?xml version="1.0" encoding="utf-8"?>
+<p:sld xmlns:a="http://schemas.openxmlformats.org/drawingml/2006/main" xmlns:p="http://schemas.openxmlformats.org/presentationml/2006/main" xmlns:r="http://schemas.openxmlformats.org/officeDocument/2006/relationships">
+  <p:cSld>
+    <p:bg>
+      <p:bgPr>
+        <a:solidFill>
+          <a:srgbClr val="F7F4EC"/>
+        </a:solidFill>
+        <a:effectLst/>
+      </p:bgPr>
+    </p:bg>
+    <p:spTree>
+      <p:nvGrpSpPr>
+        <p:cNvPr id="1" name=""/>
+        <p:cNvGrpSpPr/>
+        <p:nvPr/>
+      </p:nvGrpSpPr>
+      <p:grpSpPr/>
+      <p:sp>
+        <p:nvSpPr>
+          <p:cNvPr id="2" name="Rectangle 1"/>
+          <p:cNvSpPr/>
+          <p:nvPr/>
+        </p:nvSpPr>
+        <p:spPr>
+          <a:xfrm>
+            <a:off x="0" y="0"/>
+            <a:ext cx="164592" cy="6858000"/>
+          </a:xfrm>
+          <a:prstGeom prst="rect">
+            <a:avLst/>
+          </a:prstGeom>
+          <a:solidFill>
+            <a:srgbClr val="8B1A1A"/>
+          </a:solidFill>
+          <a:ln>
+            <a:noFill/>
+          </a:ln>
+        </p:spPr>
+        <p:style>
+          <a:lnRef idx="1">
+            <a:schemeClr val="accent1"/>
+          </a:lnRef>
+          <a:fillRef idx="3">
+            <a:schemeClr val="accent1"/>
+          </a:fillRef>
+          <a:effectRef idx="2">
+            <a:schemeClr val="accent1"/>
+          </a:effectRef>
+          <a:fontRef idx="minor">
+            <a:schemeClr val="lt1"/>
+          </a:fontRef>
+        </p:style>
+        <p:txBody>
+          <a:bodyPr rtlCol="0" anchor="ctr"/>
+          <a:lstStyle/>
+          <a:p>
+            <a:pPr algn="ctr"/>
+          </a:p>
+        </p:txBody>
+      </p:sp>
+      <p:sp>
+        <p:nvSpPr>
+          <p:cNvPr id="3" name="TextBox 2"/>
+          <p:cNvSpPr txBox="1"/>
+          <p:nvPr/>
+        </p:nvSpPr>
+        <p:spPr>
+          <a:xfrm>
+            <a:off x="548640" y="320040"/>
+            <a:ext cx="9144000" cy="365760"/>
+          </a:xfrm>
+          <a:prstGeom prst="rect">
+            <a:avLst/>
+          </a:prstGeom>
+          <a:noFill/>
+        </p:spPr>
+        <p:txBody>
+          <a:bodyPr wrap="square" anchor="t" lIns="45720" rIns="45720" tIns="27432" bIns="27432">
+            <a:spAutoFit/>
+          </a:bodyPr>
+          <a:lstStyle/>
+          <a:p>
+            <a:pPr algn="l"/>
+            <a:r>
+              <a:rPr sz="1200" b="1">
+                <a:solidFill>
+                  <a:srgbClr val="4CB86B"/>
+                </a:solidFill>
+                <a:latin typeface="Segoe UI"/>
+              </a:rPr>
+              <a:t>HELP</a:t>
+            </a:r>
+          </a:p>
+        </p:txBody>
+      </p:sp>
+      <p:sp>
+        <p:nvSpPr>
+          <p:cNvPr id="4" name="TextBox 3"/>
+          <p:cNvSpPr txBox="1"/>
+          <p:nvPr/>
+        </p:nvSpPr>
+        <p:spPr>
+          <a:xfrm>
+            <a:off x="548640" y="566928"/>
+            <a:ext cx="10972800" cy="731520"/>
+          </a:xfrm>
+          <a:prstGeom prst="rect">
+            <a:avLst/>
+          </a:prstGeom>
+          <a:noFill/>
+        </p:spPr>
+        <p:txBody>
+          <a:bodyPr wrap="square" anchor="t" lIns="45720" rIns="45720" tIns="27432" bIns="27432">
+            <a:spAutoFit/>
+          </a:bodyPr>
+          <a:lstStyle/>
+          <a:p>
+            <a:pPr algn="l"/>
+            <a:r>
+              <a:rPr sz="3200" b="1">
+                <a:solidFill>
+                  <a:srgbClr val="2B2A28"/>
+                </a:solidFill>
+                <a:latin typeface="Segoe UI"/>
+              </a:rPr>
+              <a:t>Troubleshooting &amp; FAQ</a:t>
+            </a:r>
+          </a:p>
+        </p:txBody>
+      </p:sp>
+      <p:sp>
+        <p:nvSpPr>
+          <p:cNvPr id="5" name="Rectangle 4"/>
+          <p:cNvSpPr/>
+          <p:nvPr/>
+        </p:nvSpPr>
+        <p:spPr>
+          <a:xfrm>
+            <a:off x="566928" y="1298448"/>
+            <a:ext cx="1097280" cy="45720"/>
+          </a:xfrm>
+          <a:prstGeom prst="rect">
+            <a:avLst/>
+          </a:prstGeom>
+          <a:solidFill>
+            <a:srgbClr val="8B1A1A"/>
+          </a:solidFill>
+          <a:ln>
+            <a:noFill/>
+          </a:ln>
+        </p:spPr>
+        <p:style>
+          <a:lnRef idx="1">
+            <a:schemeClr val="accent1"/>
+          </a:lnRef>
+          <a:fillRef idx="3">
+            <a:schemeClr val="accent1"/>
+          </a:fillRef>
+          <a:effectRef idx="2">
+            <a:schemeClr val="accent1"/>
+          </a:effectRef>
+          <a:fontRef idx="minor">
+            <a:schemeClr val="lt1"/>
+          </a:fontRef>
+        </p:style>
+        <p:txBody>
+          <a:bodyPr rtlCol="0" anchor="ctr"/>
+          <a:lstStyle/>
+          <a:p>
+            <a:pPr algn="ctr"/>
+          </a:p>
+        </p:txBody>
+      </p:sp>
+      <p:sp>
+        <p:nvSpPr>
+          <p:cNvPr id="6" name="TextBox 5"/>
+          <p:cNvSpPr txBox="1"/>
+          <p:nvPr/>
+        </p:nvSpPr>
+        <p:spPr>
+          <a:xfrm>
+            <a:off x="10607040" y="6400800"/>
+            <a:ext cx="1371600" cy="320040"/>
+          </a:xfrm>
+          <a:prstGeom prst="rect">
+            <a:avLst/>
+          </a:prstGeom>
+          <a:noFill/>
+        </p:spPr>
+        <p:txBody>
+          <a:bodyPr wrap="square" anchor="t" lIns="45720" rIns="45720" tIns="27432" bIns="27432">
+            <a:spAutoFit/>
+          </a:bodyPr>
+          <a:lstStyle/>
+          <a:p>
+            <a:pPr algn="r"/>
+            <a:r>
+              <a:rPr sz="1000" b="0">
+                <a:solidFill>
+                  <a:srgbClr val="6E6A62"/>
+                </a:solidFill>
+                <a:latin typeface="Segoe UI"/>
+              </a:rPr>
+              <a:t>Pips · 16</a:t>
             </a:r>
           </a:p>
         </p:txBody>
@@ -7245,7 +7720,7 @@
                           </a:solidFill>
                           <a:latin typeface="Segoe UI"/>
                         </a:rPr>
-                        <a:t>The card is gone</a:t>
+                        <a:t>The focus card is gone</a:t>
                       </a:r>
                     </a:p>
                   </a:txBody>
@@ -7267,7 +7742,7 @@
                           </a:solidFill>
                           <a:latin typeface="Segoe UI"/>
                         </a:rPr>
-                        <a:t>Click the pet. Or restart Pips from the shortcut.</a:t>
+                        <a:t>Right-click the pet → Focus timer → Open. Or restart Pips.</a:t>
                       </a:r>
                     </a:p>
                   </a:txBody>
@@ -7428,637 +7903,6 @@
 </p:sld>
 </file>
 
-<file path=ppt/slides/slide16.xml><?xml version="1.0" encoding="utf-8"?>
-<p:sld xmlns:a="http://schemas.openxmlformats.org/drawingml/2006/main" xmlns:p="http://schemas.openxmlformats.org/presentationml/2006/main" xmlns:r="http://schemas.openxmlformats.org/officeDocument/2006/relationships">
-  <p:cSld>
-    <p:bg>
-      <p:bgPr>
-        <a:solidFill>
-          <a:srgbClr val="F7F4EC"/>
-        </a:solidFill>
-        <a:effectLst/>
-      </p:bgPr>
-    </p:bg>
-    <p:spTree>
-      <p:nvGrpSpPr>
-        <p:cNvPr id="1" name=""/>
-        <p:cNvGrpSpPr/>
-        <p:nvPr/>
-      </p:nvGrpSpPr>
-      <p:grpSpPr/>
-      <p:sp>
-        <p:nvSpPr>
-          <p:cNvPr id="2" name="Rectangle 1"/>
-          <p:cNvSpPr/>
-          <p:nvPr/>
-        </p:nvSpPr>
-        <p:spPr>
-          <a:xfrm>
-            <a:off x="0" y="0"/>
-            <a:ext cx="164592" cy="6858000"/>
-          </a:xfrm>
-          <a:prstGeom prst="rect">
-            <a:avLst/>
-          </a:prstGeom>
-          <a:solidFill>
-            <a:srgbClr val="8B1A1A"/>
-          </a:solidFill>
-          <a:ln>
-            <a:noFill/>
-          </a:ln>
-        </p:spPr>
-        <p:style>
-          <a:lnRef idx="1">
-            <a:schemeClr val="accent1"/>
-          </a:lnRef>
-          <a:fillRef idx="3">
-            <a:schemeClr val="accent1"/>
-          </a:fillRef>
-          <a:effectRef idx="2">
-            <a:schemeClr val="accent1"/>
-          </a:effectRef>
-          <a:fontRef idx="minor">
-            <a:schemeClr val="lt1"/>
-          </a:fontRef>
-        </p:style>
-        <p:txBody>
-          <a:bodyPr rtlCol="0" anchor="ctr"/>
-          <a:lstStyle/>
-          <a:p>
-            <a:pPr algn="ctr"/>
-          </a:p>
-        </p:txBody>
-      </p:sp>
-      <p:sp>
-        <p:nvSpPr>
-          <p:cNvPr id="3" name="TextBox 2"/>
-          <p:cNvSpPr txBox="1"/>
-          <p:nvPr/>
-        </p:nvSpPr>
-        <p:spPr>
-          <a:xfrm>
-            <a:off x="548640" y="320040"/>
-            <a:ext cx="9144000" cy="365760"/>
-          </a:xfrm>
-          <a:prstGeom prst="rect">
-            <a:avLst/>
-          </a:prstGeom>
-          <a:noFill/>
-        </p:spPr>
-        <p:txBody>
-          <a:bodyPr wrap="square" anchor="t" lIns="45720" rIns="45720" tIns="27432" bIns="27432">
-            <a:spAutoFit/>
-          </a:bodyPr>
-          <a:lstStyle/>
-          <a:p>
-            <a:pPr algn="l"/>
-            <a:r>
-              <a:rPr sz="1200" b="1">
-                <a:solidFill>
-                  <a:srgbClr val="4CB86B"/>
-                </a:solidFill>
-                <a:latin typeface="Segoe UI"/>
-              </a:rPr>
-              <a:t>RELEASE NOTES</a:t>
-            </a:r>
-          </a:p>
-        </p:txBody>
-      </p:sp>
-      <p:sp>
-        <p:nvSpPr>
-          <p:cNvPr id="4" name="TextBox 3"/>
-          <p:cNvSpPr txBox="1"/>
-          <p:nvPr/>
-        </p:nvSpPr>
-        <p:spPr>
-          <a:xfrm>
-            <a:off x="548640" y="566928"/>
-            <a:ext cx="10972800" cy="731520"/>
-          </a:xfrm>
-          <a:prstGeom prst="rect">
-            <a:avLst/>
-          </a:prstGeom>
-          <a:noFill/>
-        </p:spPr>
-        <p:txBody>
-          <a:bodyPr wrap="square" anchor="t" lIns="45720" rIns="45720" tIns="27432" bIns="27432">
-            <a:spAutoFit/>
-          </a:bodyPr>
-          <a:lstStyle/>
-          <a:p>
-            <a:pPr algn="l"/>
-            <a:r>
-              <a:rPr sz="3200" b="1">
-                <a:solidFill>
-                  <a:srgbClr val="2B2A28"/>
-                </a:solidFill>
-                <a:latin typeface="Segoe UI"/>
-              </a:rPr>
-              <a:t>What's new in 2.4.0</a:t>
-            </a:r>
-          </a:p>
-        </p:txBody>
-      </p:sp>
-      <p:sp>
-        <p:nvSpPr>
-          <p:cNvPr id="5" name="Rectangle 4"/>
-          <p:cNvSpPr/>
-          <p:nvPr/>
-        </p:nvSpPr>
-        <p:spPr>
-          <a:xfrm>
-            <a:off x="566928" y="1298448"/>
-            <a:ext cx="1097280" cy="45720"/>
-          </a:xfrm>
-          <a:prstGeom prst="rect">
-            <a:avLst/>
-          </a:prstGeom>
-          <a:solidFill>
-            <a:srgbClr val="8B1A1A"/>
-          </a:solidFill>
-          <a:ln>
-            <a:noFill/>
-          </a:ln>
-        </p:spPr>
-        <p:style>
-          <a:lnRef idx="1">
-            <a:schemeClr val="accent1"/>
-          </a:lnRef>
-          <a:fillRef idx="3">
-            <a:schemeClr val="accent1"/>
-          </a:fillRef>
-          <a:effectRef idx="2">
-            <a:schemeClr val="accent1"/>
-          </a:effectRef>
-          <a:fontRef idx="minor">
-            <a:schemeClr val="lt1"/>
-          </a:fontRef>
-        </p:style>
-        <p:txBody>
-          <a:bodyPr rtlCol="0" anchor="ctr"/>
-          <a:lstStyle/>
-          <a:p>
-            <a:pPr algn="ctr"/>
-          </a:p>
-        </p:txBody>
-      </p:sp>
-      <p:sp>
-        <p:nvSpPr>
-          <p:cNvPr id="6" name="TextBox 5"/>
-          <p:cNvSpPr txBox="1"/>
-          <p:nvPr/>
-        </p:nvSpPr>
-        <p:spPr>
-          <a:xfrm>
-            <a:off x="10607040" y="6400800"/>
-            <a:ext cx="1371600" cy="320040"/>
-          </a:xfrm>
-          <a:prstGeom prst="rect">
-            <a:avLst/>
-          </a:prstGeom>
-          <a:noFill/>
-        </p:spPr>
-        <p:txBody>
-          <a:bodyPr wrap="square" anchor="t" lIns="45720" rIns="45720" tIns="27432" bIns="27432">
-            <a:spAutoFit/>
-          </a:bodyPr>
-          <a:lstStyle/>
-          <a:p>
-            <a:pPr algn="r"/>
-            <a:r>
-              <a:rPr sz="1000" b="0">
-                <a:solidFill>
-                  <a:srgbClr val="6E6A62"/>
-                </a:solidFill>
-                <a:latin typeface="Segoe UI"/>
-              </a:rPr>
-              <a:t>Pips · 16</a:t>
-            </a:r>
-          </a:p>
-        </p:txBody>
-      </p:sp>
-      <p:sp>
-        <p:nvSpPr>
-          <p:cNvPr id="7" name="TextBox 6"/>
-          <p:cNvSpPr txBox="1"/>
-          <p:nvPr/>
-        </p:nvSpPr>
-        <p:spPr>
-          <a:xfrm>
-            <a:off x="548640" y="1554480"/>
-            <a:ext cx="10972800" cy="457200"/>
-          </a:xfrm>
-          <a:prstGeom prst="rect">
-            <a:avLst/>
-          </a:prstGeom>
-          <a:noFill/>
-        </p:spPr>
-        <p:txBody>
-          <a:bodyPr wrap="square" anchor="t" lIns="45720" rIns="45720" tIns="27432" bIns="27432">
-            <a:spAutoFit/>
-          </a:bodyPr>
-          <a:lstStyle/>
-          <a:p>
-            <a:pPr algn="l"/>
-            <a:r>
-              <a:rPr sz="1800" b="1">
-                <a:solidFill>
-                  <a:srgbClr val="8B1A1A"/>
-                </a:solidFill>
-                <a:latin typeface="Segoe UI"/>
-              </a:rPr>
-              <a:t>Chat, groups, affinity &amp; pet visits  ·  2026-10-28</a:t>
-            </a:r>
-          </a:p>
-        </p:txBody>
-      </p:sp>
-      <p:sp>
-        <p:nvSpPr>
-          <p:cNvPr id="8" name="TextBox 7"/>
-          <p:cNvSpPr txBox="1"/>
-          <p:nvPr/>
-        </p:nvSpPr>
-        <p:spPr>
-          <a:xfrm>
-            <a:off x="548640" y="2148840"/>
-            <a:ext cx="6858000" cy="4114800"/>
-          </a:xfrm>
-          <a:prstGeom prst="rect">
-            <a:avLst/>
-          </a:prstGeom>
-          <a:noFill/>
-        </p:spPr>
-        <p:txBody>
-          <a:bodyPr wrap="square">
-            <a:spAutoFit/>
-          </a:bodyPr>
-          <a:lstStyle/>
-          <a:p>
-            <a:pPr>
-              <a:spcAft>
-                <a:spcPts val="1000"/>
-              </a:spcAft>
-            </a:pPr>
-            <a:r>
-              <a:rPr sz="1700" b="1">
-                <a:solidFill>
-                  <a:srgbClr val="4CB86B"/>
-                </a:solidFill>
-                <a:latin typeface="Segoe UI"/>
-              </a:rPr>
-              <a:t>•  </a:t>
-            </a:r>
-            <a:r>
-              <a:rPr sz="1700">
-                <a:solidFill>
-                  <a:srgbClr val="2B2A28"/>
-                </a:solidFill>
-                <a:latin typeface="Segoe UI"/>
-              </a:rPr>
-              <a:t>Chat: message your friends, and chat inside groups. Your pet pops up new messages as a bubble - click it to reply</a:t>
-            </a:r>
-          </a:p>
-          <a:p>
-            <a:pPr>
-              <a:spcAft>
-                <a:spcPts val="1000"/>
-              </a:spcAft>
-            </a:pPr>
-            <a:r>
-              <a:rPr sz="1700" b="1">
-                <a:solidFill>
-                  <a:srgbClr val="4CB86B"/>
-                </a:solidFill>
-                <a:latin typeface="Segoe UI"/>
-              </a:rPr>
-              <a:t>•  </a:t>
-            </a:r>
-            <a:r>
-              <a:rPr sz="1700">
-                <a:solidFill>
-                  <a:srgbClr val="2B2A28"/>
-                </a:solidFill>
-                <a:latin typeface="Segoe UI"/>
-              </a:rPr>
-              <a:t>Pet interactions: wave, pet their pet, send a snack, high five - or send your pet to visit: it walks onto your friend's desktop for a little while!</a:t>
-            </a:r>
-          </a:p>
-          <a:p>
-            <a:pPr>
-              <a:spcAft>
-                <a:spcPts val="1000"/>
-              </a:spcAft>
-            </a:pPr>
-            <a:r>
-              <a:rPr sz="1700" b="1">
-                <a:solidFill>
-                  <a:srgbClr val="4CB86B"/>
-                </a:solidFill>
-                <a:latin typeface="Segoe UI"/>
-              </a:rPr>
-              <a:t>•  </a:t>
-            </a:r>
-            <a:r>
-              <a:rPr sz="1700">
-                <a:solidFill>
-                  <a:srgbClr val="2B2A28"/>
-                </a:solidFill>
-                <a:latin typeface="Segoe UI"/>
-              </a:rPr>
-              <a:t>Affinity: every chat and interaction grows your friendship - Acquaintance → Buddy → Good friends → Close friends → Best friends → Soulmates</a:t>
-            </a:r>
-          </a:p>
-          <a:p>
-            <a:pPr>
-              <a:spcAft>
-                <a:spcPts val="1000"/>
-              </a:spcAft>
-            </a:pPr>
-            <a:r>
-              <a:rPr sz="1700" b="1">
-                <a:solidFill>
-                  <a:srgbClr val="4CB86B"/>
-                </a:solidFill>
-                <a:latin typeface="Segoe UI"/>
-              </a:rPr>
-              <a:t>•  </a:t>
-            </a:r>
-            <a:r>
-              <a:rPr sz="1700">
-                <a:solidFill>
-                  <a:srgbClr val="2B2A28"/>
-                </a:solidFill>
-                <a:latin typeface="Segoe UI"/>
-              </a:rPr>
-              <a:t>Your own groups: create a private group, invite your friends, they accept or decline. Group board + group chat; the owner can remove members</a:t>
-            </a:r>
-          </a:p>
-          <a:p>
-            <a:pPr>
-              <a:spcAft>
-                <a:spcPts val="1000"/>
-              </a:spcAft>
-            </a:pPr>
-            <a:r>
-              <a:rPr sz="1700" b="1">
-                <a:solidFill>
-                  <a:srgbClr val="4CB86B"/>
-                </a:solidFill>
-                <a:latin typeface="Segoe UI"/>
-              </a:rPr>
-              <a:t>•  </a:t>
-            </a:r>
-            <a:r>
-              <a:rPr sz="1700">
-                <a:solidFill>
-                  <a:srgbClr val="2B2A28"/>
-                </a:solidFill>
-                <a:latin typeface="Segoe UI"/>
-              </a:rPr>
-              <a:t>2 new achievements (Close friends, Globetrotter). Right-click the pet → Friends &amp; achievements…</a:t>
-            </a:r>
-          </a:p>
-        </p:txBody>
-      </p:sp>
-      <p:sp>
-        <p:nvSpPr>
-          <p:cNvPr id="9" name="Rounded Rectangle 8"/>
-          <p:cNvSpPr/>
-          <p:nvPr/>
-        </p:nvSpPr>
-        <p:spPr>
-          <a:xfrm>
-            <a:off x="7680960" y="2103120"/>
-            <a:ext cx="4114800" cy="4023360"/>
-          </a:xfrm>
-          <a:prstGeom prst="roundRect">
-            <a:avLst>
-              <a:gd name="adj" fmla="val 6000"/>
-            </a:avLst>
-          </a:prstGeom>
-          <a:solidFill>
-            <a:srgbClr val="E4F5E8"/>
-          </a:solidFill>
-          <a:ln w="12700">
-            <a:solidFill>
-              <a:srgbClr val="4CB86B"/>
-            </a:solidFill>
-          </a:ln>
-          <a:effectLst/>
-        </p:spPr>
-        <p:style>
-          <a:lnRef idx="1">
-            <a:schemeClr val="accent1"/>
-          </a:lnRef>
-          <a:fillRef idx="3">
-            <a:schemeClr val="accent1"/>
-          </a:fillRef>
-          <a:effectRef idx="2">
-            <a:schemeClr val="accent1"/>
-          </a:effectRef>
-          <a:fontRef idx="minor">
-            <a:schemeClr val="lt1"/>
-          </a:fontRef>
-        </p:style>
-        <p:txBody>
-          <a:bodyPr rtlCol="0" anchor="ctr"/>
-          <a:lstStyle/>
-          <a:p>
-            <a:pPr algn="ctr"/>
-          </a:p>
-        </p:txBody>
-      </p:sp>
-      <p:sp>
-        <p:nvSpPr>
-          <p:cNvPr id="10" name="TextBox 9"/>
-          <p:cNvSpPr txBox="1"/>
-          <p:nvPr/>
-        </p:nvSpPr>
-        <p:spPr>
-          <a:xfrm>
-            <a:off x="7863840" y="2194560"/>
-            <a:ext cx="3749039" cy="365760"/>
-          </a:xfrm>
-          <a:prstGeom prst="rect">
-            <a:avLst/>
-          </a:prstGeom>
-          <a:noFill/>
-        </p:spPr>
-        <p:txBody>
-          <a:bodyPr wrap="square" anchor="t" lIns="45720" rIns="45720" tIns="27432" bIns="27432">
-            <a:spAutoFit/>
-          </a:bodyPr>
-          <a:lstStyle/>
-          <a:p>
-            <a:pPr algn="l"/>
-            <a:r>
-              <a:rPr sz="1300" b="1">
-                <a:solidFill>
-                  <a:srgbClr val="4CB86B"/>
-                </a:solidFill>
-                <a:latin typeface="Segoe UI"/>
-              </a:rPr>
-              <a:t>Bahasa Indonesia</a:t>
-            </a:r>
-          </a:p>
-        </p:txBody>
-      </p:sp>
-      <p:sp>
-        <p:nvSpPr>
-          <p:cNvPr id="11" name="TextBox 10"/>
-          <p:cNvSpPr txBox="1"/>
-          <p:nvPr/>
-        </p:nvSpPr>
-        <p:spPr>
-          <a:xfrm>
-            <a:off x="7863840" y="2560320"/>
-            <a:ext cx="3749039" cy="3474720"/>
-          </a:xfrm>
-          <a:prstGeom prst="rect">
-            <a:avLst/>
-          </a:prstGeom>
-          <a:noFill/>
-        </p:spPr>
-        <p:txBody>
-          <a:bodyPr wrap="square">
-            <a:spAutoFit/>
-          </a:bodyPr>
-          <a:lstStyle/>
-          <a:p>
-            <a:pPr>
-              <a:spcAft>
-                <a:spcPts val="500"/>
-              </a:spcAft>
-            </a:pPr>
-            <a:r>
-              <a:rPr sz="1200" b="1">
-                <a:solidFill>
-                  <a:srgbClr val="4CB86B"/>
-                </a:solidFill>
-                <a:latin typeface="Segoe UI"/>
-              </a:rPr>
-              <a:t>•  </a:t>
-            </a:r>
-            <a:r>
-              <a:rPr sz="1200">
-                <a:solidFill>
-                  <a:srgbClr val="2B2A28"/>
-                </a:solidFill>
-                <a:latin typeface="Segoe UI"/>
-              </a:rPr>
-              <a:t>Chat: kirim pesan ke teman dan chat di grup. Peliharaanmu menampilkan pesan baru sebagai gelembung - klik untuk membalas</a:t>
-            </a:r>
-          </a:p>
-          <a:p>
-            <a:pPr>
-              <a:spcAft>
-                <a:spcPts val="500"/>
-              </a:spcAft>
-            </a:pPr>
-            <a:r>
-              <a:rPr sz="1200" b="1">
-                <a:solidFill>
-                  <a:srgbClr val="4CB86B"/>
-                </a:solidFill>
-                <a:latin typeface="Segoe UI"/>
-              </a:rPr>
-              <a:t>•  </a:t>
-            </a:r>
-            <a:r>
-              <a:rPr sz="1200">
-                <a:solidFill>
-                  <a:srgbClr val="2B2A28"/>
-                </a:solidFill>
-                <a:latin typeface="Segoe UI"/>
-              </a:rPr>
-              <a:t>Interaksi peliharaan: lambai, elus peliharaan mereka, kirim camilan, tos - atau kirim peliharaanmu berkunjung: ia berjalan ke desktop temanmu sebentar!</a:t>
-            </a:r>
-          </a:p>
-          <a:p>
-            <a:pPr>
-              <a:spcAft>
-                <a:spcPts val="500"/>
-              </a:spcAft>
-            </a:pPr>
-            <a:r>
-              <a:rPr sz="1200" b="1">
-                <a:solidFill>
-                  <a:srgbClr val="4CB86B"/>
-                </a:solidFill>
-                <a:latin typeface="Segoe UI"/>
-              </a:rPr>
-              <a:t>•  </a:t>
-            </a:r>
-            <a:r>
-              <a:rPr sz="1200">
-                <a:solidFill>
-                  <a:srgbClr val="2B2A28"/>
-                </a:solidFill>
-                <a:latin typeface="Segoe UI"/>
-              </a:rPr>
-              <a:t>Afinitas: setiap chat dan interaksi menumbuhkan pertemanan - Kenalan → Sobat → Teman baik → Teman dekat → Sahabat → Belahan jiwa</a:t>
-            </a:r>
-          </a:p>
-          <a:p>
-            <a:pPr>
-              <a:spcAft>
-                <a:spcPts val="500"/>
-              </a:spcAft>
-            </a:pPr>
-            <a:r>
-              <a:rPr sz="1200" b="1">
-                <a:solidFill>
-                  <a:srgbClr val="4CB86B"/>
-                </a:solidFill>
-                <a:latin typeface="Segoe UI"/>
-              </a:rPr>
-              <a:t>•  </a:t>
-            </a:r>
-            <a:r>
-              <a:rPr sz="1200">
-                <a:solidFill>
-                  <a:srgbClr val="2B2A28"/>
-                </a:solidFill>
-                <a:latin typeface="Segoe UI"/>
-              </a:rPr>
-              <a:t>Grup sendiri: buat grup pribadi, undang temanmu, mereka bisa menerima atau menolak. Papan grup + chat grup; pemilik bisa mengeluarkan anggota</a:t>
-            </a:r>
-          </a:p>
-          <a:p>
-            <a:pPr>
-              <a:spcAft>
-                <a:spcPts val="500"/>
-              </a:spcAft>
-            </a:pPr>
-            <a:r>
-              <a:rPr sz="1200" b="1">
-                <a:solidFill>
-                  <a:srgbClr val="4CB86B"/>
-                </a:solidFill>
-                <a:latin typeface="Segoe UI"/>
-              </a:rPr>
-              <a:t>•  </a:t>
-            </a:r>
-            <a:r>
-              <a:rPr sz="1200">
-                <a:solidFill>
-                  <a:srgbClr val="2B2A28"/>
-                </a:solidFill>
-                <a:latin typeface="Segoe UI"/>
-              </a:rPr>
-              <a:t>2 pencapaian baru (Teman dekat, Penjelajah). Klik kanan peliharaan → Teman &amp; pencapaian…</a:t>
-            </a:r>
-          </a:p>
-        </p:txBody>
-      </p:sp>
-    </p:spTree>
-  </p:cSld>
-  <p:clrMapOvr>
-    <a:masterClrMapping/>
-  </p:clrMapOvr>
-</p:sld>
-</file>
-
 <file path=ppt/slides/slide17.xml><?xml version="1.0" encoding="utf-8"?>
 <p:sld xmlns:a="http://schemas.openxmlformats.org/drawingml/2006/main" xmlns:p="http://schemas.openxmlformats.org/presentationml/2006/main" xmlns:r="http://schemas.openxmlformats.org/officeDocument/2006/relationships">
   <p:cSld>
@@ -8185,7 +8029,7 @@
                 </a:solidFill>
                 <a:latin typeface="Segoe UI"/>
               </a:rPr>
-              <a:t>Version history</a:t>
+              <a:t>What's new in 2.5.0</a:t>
             </a:r>
           </a:p>
         </p:txBody>
@@ -8268,6 +8112,637 @@
           </a:p>
         </p:txBody>
       </p:sp>
+      <p:sp>
+        <p:nvSpPr>
+          <p:cNvPr id="7" name="TextBox 6"/>
+          <p:cNvSpPr txBox="1"/>
+          <p:nvPr/>
+        </p:nvSpPr>
+        <p:spPr>
+          <a:xfrm>
+            <a:off x="548640" y="1554480"/>
+            <a:ext cx="10972800" cy="457200"/>
+          </a:xfrm>
+          <a:prstGeom prst="rect">
+            <a:avLst/>
+          </a:prstGeom>
+          <a:noFill/>
+        </p:spPr>
+        <p:txBody>
+          <a:bodyPr wrap="square" anchor="t" lIns="45720" rIns="45720" tIns="27432" bIns="27432">
+            <a:spAutoFit/>
+          </a:bodyPr>
+          <a:lstStyle/>
+          <a:p>
+            <a:pPr algn="l"/>
+            <a:r>
+              <a:rPr sz="1800" b="1">
+                <a:solidFill>
+                  <a:srgbClr val="8B1A1A"/>
+                </a:solidFill>
+                <a:latin typeface="Segoe UI"/>
+              </a:rPr>
+              <a:t>Shop, coins, props &amp; moves  ·  2026-10-28</a:t>
+            </a:r>
+          </a:p>
+        </p:txBody>
+      </p:sp>
+      <p:sp>
+        <p:nvSpPr>
+          <p:cNvPr id="8" name="TextBox 7"/>
+          <p:cNvSpPr txBox="1"/>
+          <p:nvPr/>
+        </p:nvSpPr>
+        <p:spPr>
+          <a:xfrm>
+            <a:off x="548640" y="2148840"/>
+            <a:ext cx="6858000" cy="4114800"/>
+          </a:xfrm>
+          <a:prstGeom prst="rect">
+            <a:avLst/>
+          </a:prstGeom>
+          <a:noFill/>
+        </p:spPr>
+        <p:txBody>
+          <a:bodyPr wrap="square">
+            <a:spAutoFit/>
+          </a:bodyPr>
+          <a:lstStyle/>
+          <a:p>
+            <a:pPr>
+              <a:spcAft>
+                <a:spcPts val="1000"/>
+              </a:spcAft>
+            </a:pPr>
+            <a:r>
+              <a:rPr sz="1700" b="1">
+                <a:solidFill>
+                  <a:srgbClr val="4CB86B"/>
+                </a:solidFill>
+                <a:latin typeface="Segoe UI"/>
+              </a:rPr>
+              <a:t>•  </a:t>
+            </a:r>
+            <a:r>
+              <a:rPr sz="1700">
+                <a:solidFill>
+                  <a:srgbClr val="2B2A28"/>
+                </a:solidFill>
+                <a:latin typeface="Segoe UI"/>
+              </a:rPr>
+              <a:t>Shop: earn coins and spend them on your pet - 17 props (crown, wizard hat, headphones, shades, scarf, cape, angel wings...) and 6 moves: spin, dance, moonwalk, backflip, kung fu and spider swing!</a:t>
+            </a:r>
+          </a:p>
+          <a:p>
+            <a:pPr>
+              <a:spcAft>
+                <a:spcPts val="1000"/>
+              </a:spcAft>
+            </a:pPr>
+            <a:r>
+              <a:rPr sz="1700" b="1">
+                <a:solidFill>
+                  <a:srgbClr val="4CB86B"/>
+                </a:solidFill>
+                <a:latin typeface="Segoe UI"/>
+              </a:rPr>
+              <a:t>•  </a:t>
+            </a:r>
+            <a:r>
+              <a:rPr sz="1700">
+                <a:solidFill>
+                  <a:srgbClr val="2B2A28"/>
+                </a:solidFill>
+                <a:latin typeface="Segoe UI"/>
+              </a:rPr>
+              <a:t>Coins come from leveling up (+40), badges (+25), opening Pips each day (+10), friendships (+15 per affinity level), waving / chatting / visiting friends (+2) and pomodoros (+5). Everyone starts with a 100-coin gift</a:t>
+            </a:r>
+          </a:p>
+          <a:p>
+            <a:pPr>
+              <a:spcAft>
+                <a:spcPts val="1000"/>
+              </a:spcAft>
+            </a:pPr>
+            <a:r>
+              <a:rPr sz="1700" b="1">
+                <a:solidFill>
+                  <a:srgbClr val="4CB86B"/>
+                </a:solidFill>
+                <a:latin typeface="Segoe UI"/>
+              </a:rPr>
+              <a:t>•  </a:t>
+            </a:r>
+            <a:r>
+              <a:rPr sz="1700">
+                <a:solidFill>
+                  <a:srgbClr val="2B2A28"/>
+                </a:solidFill>
+                <a:latin typeface="Segoe UI"/>
+              </a:rPr>
+              <a:t>Your friends see your props: on avatars in the hub and when your pet visits their desktop - it shows off one of your moves</a:t>
+            </a:r>
+          </a:p>
+          <a:p>
+            <a:pPr>
+              <a:spcAft>
+                <a:spcPts val="1000"/>
+              </a:spcAft>
+            </a:pPr>
+            <a:r>
+              <a:rPr sz="1700" b="1">
+                <a:solidFill>
+                  <a:srgbClr val="4CB86B"/>
+                </a:solidFill>
+                <a:latin typeface="Segoe UI"/>
+              </a:rPr>
+              <a:t>•  </a:t>
+            </a:r>
+            <a:r>
+              <a:rPr sz="1700">
+                <a:solidFill>
+                  <a:srgbClr val="2B2A28"/>
+                </a:solidFill>
+                <a:latin typeface="Segoe UI"/>
+              </a:rPr>
+              <a:t>Pips is now a social pet: clicking the pet opens the Pips hub (friends, chat, groups, shop, badges)</a:t>
+            </a:r>
+          </a:p>
+          <a:p>
+            <a:pPr>
+              <a:spcAft>
+                <a:spcPts val="1000"/>
+              </a:spcAft>
+            </a:pPr>
+            <a:r>
+              <a:rPr sz="1700" b="1">
+                <a:solidFill>
+                  <a:srgbClr val="4CB86B"/>
+                </a:solidFill>
+                <a:latin typeface="Segoe UI"/>
+              </a:rPr>
+              <a:t>•  </a:t>
+            </a:r>
+            <a:r>
+              <a:rPr sz="1700">
+                <a:solidFill>
+                  <a:srgbClr val="2B2A28"/>
+                </a:solidFill>
+                <a:latin typeface="Segoe UI"/>
+              </a:rPr>
+              <a:t>The focus timer moved to right-click → Focus timer (Pomodoro). Pomodoros still give XP and coins</a:t>
+            </a:r>
+          </a:p>
+        </p:txBody>
+      </p:sp>
+      <p:sp>
+        <p:nvSpPr>
+          <p:cNvPr id="9" name="Rounded Rectangle 8"/>
+          <p:cNvSpPr/>
+          <p:nvPr/>
+        </p:nvSpPr>
+        <p:spPr>
+          <a:xfrm>
+            <a:off x="7680960" y="2103120"/>
+            <a:ext cx="4114800" cy="4023360"/>
+          </a:xfrm>
+          <a:prstGeom prst="roundRect">
+            <a:avLst>
+              <a:gd name="adj" fmla="val 6000"/>
+            </a:avLst>
+          </a:prstGeom>
+          <a:solidFill>
+            <a:srgbClr val="E4F5E8"/>
+          </a:solidFill>
+          <a:ln w="12700">
+            <a:solidFill>
+              <a:srgbClr val="4CB86B"/>
+            </a:solidFill>
+          </a:ln>
+          <a:effectLst/>
+        </p:spPr>
+        <p:style>
+          <a:lnRef idx="1">
+            <a:schemeClr val="accent1"/>
+          </a:lnRef>
+          <a:fillRef idx="3">
+            <a:schemeClr val="accent1"/>
+          </a:fillRef>
+          <a:effectRef idx="2">
+            <a:schemeClr val="accent1"/>
+          </a:effectRef>
+          <a:fontRef idx="minor">
+            <a:schemeClr val="lt1"/>
+          </a:fontRef>
+        </p:style>
+        <p:txBody>
+          <a:bodyPr rtlCol="0" anchor="ctr"/>
+          <a:lstStyle/>
+          <a:p>
+            <a:pPr algn="ctr"/>
+          </a:p>
+        </p:txBody>
+      </p:sp>
+      <p:sp>
+        <p:nvSpPr>
+          <p:cNvPr id="10" name="TextBox 9"/>
+          <p:cNvSpPr txBox="1"/>
+          <p:nvPr/>
+        </p:nvSpPr>
+        <p:spPr>
+          <a:xfrm>
+            <a:off x="7863840" y="2194560"/>
+            <a:ext cx="3749039" cy="365760"/>
+          </a:xfrm>
+          <a:prstGeom prst="rect">
+            <a:avLst/>
+          </a:prstGeom>
+          <a:noFill/>
+        </p:spPr>
+        <p:txBody>
+          <a:bodyPr wrap="square" anchor="t" lIns="45720" rIns="45720" tIns="27432" bIns="27432">
+            <a:spAutoFit/>
+          </a:bodyPr>
+          <a:lstStyle/>
+          <a:p>
+            <a:pPr algn="l"/>
+            <a:r>
+              <a:rPr sz="1300" b="1">
+                <a:solidFill>
+                  <a:srgbClr val="4CB86B"/>
+                </a:solidFill>
+                <a:latin typeface="Segoe UI"/>
+              </a:rPr>
+              <a:t>Bahasa Indonesia</a:t>
+            </a:r>
+          </a:p>
+        </p:txBody>
+      </p:sp>
+      <p:sp>
+        <p:nvSpPr>
+          <p:cNvPr id="11" name="TextBox 10"/>
+          <p:cNvSpPr txBox="1"/>
+          <p:nvPr/>
+        </p:nvSpPr>
+        <p:spPr>
+          <a:xfrm>
+            <a:off x="7863840" y="2560320"/>
+            <a:ext cx="3749039" cy="3474720"/>
+          </a:xfrm>
+          <a:prstGeom prst="rect">
+            <a:avLst/>
+          </a:prstGeom>
+          <a:noFill/>
+        </p:spPr>
+        <p:txBody>
+          <a:bodyPr wrap="square">
+            <a:spAutoFit/>
+          </a:bodyPr>
+          <a:lstStyle/>
+          <a:p>
+            <a:pPr>
+              <a:spcAft>
+                <a:spcPts val="500"/>
+              </a:spcAft>
+            </a:pPr>
+            <a:r>
+              <a:rPr sz="1200" b="1">
+                <a:solidFill>
+                  <a:srgbClr val="4CB86B"/>
+                </a:solidFill>
+                <a:latin typeface="Segoe UI"/>
+              </a:rPr>
+              <a:t>•  </a:t>
+            </a:r>
+            <a:r>
+              <a:rPr sz="1200">
+                <a:solidFill>
+                  <a:srgbClr val="2B2A28"/>
+                </a:solidFill>
+                <a:latin typeface="Segoe UI"/>
+              </a:rPr>
+              <a:t>Toko: kumpulkan koin dan belanjakan untuk peliharaanmu - 17 aksesori (mahkota, topi penyihir, headphone, kacamata hitam, syal, jubah, sayap malaikat...) dan 6 gerakan: putar, joget, moonwalk, salto, kung fu dan ayunan laba-laba!</a:t>
+            </a:r>
+          </a:p>
+          <a:p>
+            <a:pPr>
+              <a:spcAft>
+                <a:spcPts val="500"/>
+              </a:spcAft>
+            </a:pPr>
+            <a:r>
+              <a:rPr sz="1200" b="1">
+                <a:solidFill>
+                  <a:srgbClr val="4CB86B"/>
+                </a:solidFill>
+                <a:latin typeface="Segoe UI"/>
+              </a:rPr>
+              <a:t>•  </a:t>
+            </a:r>
+            <a:r>
+              <a:rPr sz="1200">
+                <a:solidFill>
+                  <a:srgbClr val="2B2A28"/>
+                </a:solidFill>
+                <a:latin typeface="Segoe UI"/>
+              </a:rPr>
+              <a:t>Koin didapat dari naik level (+40), lencana (+25), membuka Pips tiap hari (+10), pertemanan (+15 per level afinitas), melambai / chat / berkunjung ke teman (+2) dan pomodoro (+5). Semua mulai dengan hadiah 100 koin</a:t>
+            </a:r>
+          </a:p>
+          <a:p>
+            <a:pPr>
+              <a:spcAft>
+                <a:spcPts val="500"/>
+              </a:spcAft>
+            </a:pPr>
+            <a:r>
+              <a:rPr sz="1200" b="1">
+                <a:solidFill>
+                  <a:srgbClr val="4CB86B"/>
+                </a:solidFill>
+                <a:latin typeface="Segoe UI"/>
+              </a:rPr>
+              <a:t>•  </a:t>
+            </a:r>
+            <a:r>
+              <a:rPr sz="1200">
+                <a:solidFill>
+                  <a:srgbClr val="2B2A28"/>
+                </a:solidFill>
+                <a:latin typeface="Segoe UI"/>
+              </a:rPr>
+              <a:t>Temanmu bisa melihat aksesorimu: di avatar hub dan saat peliharaanmu berkunjung ke desktop mereka - ia memamerkan salah satu gerakanmu</a:t>
+            </a:r>
+          </a:p>
+          <a:p>
+            <a:pPr>
+              <a:spcAft>
+                <a:spcPts val="500"/>
+              </a:spcAft>
+            </a:pPr>
+            <a:r>
+              <a:rPr sz="1200" b="1">
+                <a:solidFill>
+                  <a:srgbClr val="4CB86B"/>
+                </a:solidFill>
+                <a:latin typeface="Segoe UI"/>
+              </a:rPr>
+              <a:t>•  </a:t>
+            </a:r>
+            <a:r>
+              <a:rPr sz="1200">
+                <a:solidFill>
+                  <a:srgbClr val="2B2A28"/>
+                </a:solidFill>
+                <a:latin typeface="Segoe UI"/>
+              </a:rPr>
+              <a:t>Pips kini peliharaan sosial: klik peliharaan untuk membuka hub Pips (teman, chat, grup, toko, lencana)</a:t>
+            </a:r>
+          </a:p>
+          <a:p>
+            <a:pPr>
+              <a:spcAft>
+                <a:spcPts val="500"/>
+              </a:spcAft>
+            </a:pPr>
+            <a:r>
+              <a:rPr sz="1200" b="1">
+                <a:solidFill>
+                  <a:srgbClr val="4CB86B"/>
+                </a:solidFill>
+                <a:latin typeface="Segoe UI"/>
+              </a:rPr>
+              <a:t>•  </a:t>
+            </a:r>
+            <a:r>
+              <a:rPr sz="1200">
+                <a:solidFill>
+                  <a:srgbClr val="2B2A28"/>
+                </a:solidFill>
+                <a:latin typeface="Segoe UI"/>
+              </a:rPr>
+              <a:t>Timer fokus pindah ke klik kanan → Timer fokus (Pomodoro). Pomodoro tetap memberi XP dan koin</a:t>
+            </a:r>
+          </a:p>
+        </p:txBody>
+      </p:sp>
+    </p:spTree>
+  </p:cSld>
+  <p:clrMapOvr>
+    <a:masterClrMapping/>
+  </p:clrMapOvr>
+</p:sld>
+</file>
+
+<file path=ppt/slides/slide18.xml><?xml version="1.0" encoding="utf-8"?>
+<p:sld xmlns:a="http://schemas.openxmlformats.org/drawingml/2006/main" xmlns:p="http://schemas.openxmlformats.org/presentationml/2006/main" xmlns:r="http://schemas.openxmlformats.org/officeDocument/2006/relationships">
+  <p:cSld>
+    <p:bg>
+      <p:bgPr>
+        <a:solidFill>
+          <a:srgbClr val="F7F4EC"/>
+        </a:solidFill>
+        <a:effectLst/>
+      </p:bgPr>
+    </p:bg>
+    <p:spTree>
+      <p:nvGrpSpPr>
+        <p:cNvPr id="1" name=""/>
+        <p:cNvGrpSpPr/>
+        <p:nvPr/>
+      </p:nvGrpSpPr>
+      <p:grpSpPr/>
+      <p:sp>
+        <p:nvSpPr>
+          <p:cNvPr id="2" name="Rectangle 1"/>
+          <p:cNvSpPr/>
+          <p:nvPr/>
+        </p:nvSpPr>
+        <p:spPr>
+          <a:xfrm>
+            <a:off x="0" y="0"/>
+            <a:ext cx="164592" cy="6858000"/>
+          </a:xfrm>
+          <a:prstGeom prst="rect">
+            <a:avLst/>
+          </a:prstGeom>
+          <a:solidFill>
+            <a:srgbClr val="8B1A1A"/>
+          </a:solidFill>
+          <a:ln>
+            <a:noFill/>
+          </a:ln>
+        </p:spPr>
+        <p:style>
+          <a:lnRef idx="1">
+            <a:schemeClr val="accent1"/>
+          </a:lnRef>
+          <a:fillRef idx="3">
+            <a:schemeClr val="accent1"/>
+          </a:fillRef>
+          <a:effectRef idx="2">
+            <a:schemeClr val="accent1"/>
+          </a:effectRef>
+          <a:fontRef idx="minor">
+            <a:schemeClr val="lt1"/>
+          </a:fontRef>
+        </p:style>
+        <p:txBody>
+          <a:bodyPr rtlCol="0" anchor="ctr"/>
+          <a:lstStyle/>
+          <a:p>
+            <a:pPr algn="ctr"/>
+          </a:p>
+        </p:txBody>
+      </p:sp>
+      <p:sp>
+        <p:nvSpPr>
+          <p:cNvPr id="3" name="TextBox 2"/>
+          <p:cNvSpPr txBox="1"/>
+          <p:nvPr/>
+        </p:nvSpPr>
+        <p:spPr>
+          <a:xfrm>
+            <a:off x="548640" y="320040"/>
+            <a:ext cx="9144000" cy="365760"/>
+          </a:xfrm>
+          <a:prstGeom prst="rect">
+            <a:avLst/>
+          </a:prstGeom>
+          <a:noFill/>
+        </p:spPr>
+        <p:txBody>
+          <a:bodyPr wrap="square" anchor="t" lIns="45720" rIns="45720" tIns="27432" bIns="27432">
+            <a:spAutoFit/>
+          </a:bodyPr>
+          <a:lstStyle/>
+          <a:p>
+            <a:pPr algn="l"/>
+            <a:r>
+              <a:rPr sz="1200" b="1">
+                <a:solidFill>
+                  <a:srgbClr val="4CB86B"/>
+                </a:solidFill>
+                <a:latin typeface="Segoe UI"/>
+              </a:rPr>
+              <a:t>RELEASE NOTES</a:t>
+            </a:r>
+          </a:p>
+        </p:txBody>
+      </p:sp>
+      <p:sp>
+        <p:nvSpPr>
+          <p:cNvPr id="4" name="TextBox 3"/>
+          <p:cNvSpPr txBox="1"/>
+          <p:nvPr/>
+        </p:nvSpPr>
+        <p:spPr>
+          <a:xfrm>
+            <a:off x="548640" y="566928"/>
+            <a:ext cx="10972800" cy="731520"/>
+          </a:xfrm>
+          <a:prstGeom prst="rect">
+            <a:avLst/>
+          </a:prstGeom>
+          <a:noFill/>
+        </p:spPr>
+        <p:txBody>
+          <a:bodyPr wrap="square" anchor="t" lIns="45720" rIns="45720" tIns="27432" bIns="27432">
+            <a:spAutoFit/>
+          </a:bodyPr>
+          <a:lstStyle/>
+          <a:p>
+            <a:pPr algn="l"/>
+            <a:r>
+              <a:rPr sz="3200" b="1">
+                <a:solidFill>
+                  <a:srgbClr val="2B2A28"/>
+                </a:solidFill>
+                <a:latin typeface="Segoe UI"/>
+              </a:rPr>
+              <a:t>Version history</a:t>
+            </a:r>
+          </a:p>
+        </p:txBody>
+      </p:sp>
+      <p:sp>
+        <p:nvSpPr>
+          <p:cNvPr id="5" name="Rectangle 4"/>
+          <p:cNvSpPr/>
+          <p:nvPr/>
+        </p:nvSpPr>
+        <p:spPr>
+          <a:xfrm>
+            <a:off x="566928" y="1298448"/>
+            <a:ext cx="1097280" cy="45720"/>
+          </a:xfrm>
+          <a:prstGeom prst="rect">
+            <a:avLst/>
+          </a:prstGeom>
+          <a:solidFill>
+            <a:srgbClr val="8B1A1A"/>
+          </a:solidFill>
+          <a:ln>
+            <a:noFill/>
+          </a:ln>
+        </p:spPr>
+        <p:style>
+          <a:lnRef idx="1">
+            <a:schemeClr val="accent1"/>
+          </a:lnRef>
+          <a:fillRef idx="3">
+            <a:schemeClr val="accent1"/>
+          </a:fillRef>
+          <a:effectRef idx="2">
+            <a:schemeClr val="accent1"/>
+          </a:effectRef>
+          <a:fontRef idx="minor">
+            <a:schemeClr val="lt1"/>
+          </a:fontRef>
+        </p:style>
+        <p:txBody>
+          <a:bodyPr rtlCol="0" anchor="ctr"/>
+          <a:lstStyle/>
+          <a:p>
+            <a:pPr algn="ctr"/>
+          </a:p>
+        </p:txBody>
+      </p:sp>
+      <p:sp>
+        <p:nvSpPr>
+          <p:cNvPr id="6" name="TextBox 5"/>
+          <p:cNvSpPr txBox="1"/>
+          <p:nvPr/>
+        </p:nvSpPr>
+        <p:spPr>
+          <a:xfrm>
+            <a:off x="10607040" y="6400800"/>
+            <a:ext cx="1371600" cy="320040"/>
+          </a:xfrm>
+          <a:prstGeom prst="rect">
+            <a:avLst/>
+          </a:prstGeom>
+          <a:noFill/>
+        </p:spPr>
+        <p:txBody>
+          <a:bodyPr wrap="square" anchor="t" lIns="45720" rIns="45720" tIns="27432" bIns="27432">
+            <a:spAutoFit/>
+          </a:bodyPr>
+          <a:lstStyle/>
+          <a:p>
+            <a:pPr algn="r"/>
+            <a:r>
+              <a:rPr sz="1000" b="0">
+                <a:solidFill>
+                  <a:srgbClr val="6E6A62"/>
+                </a:solidFill>
+                <a:latin typeface="Segoe UI"/>
+              </a:rPr>
+              <a:t>Pips · 18</a:t>
+            </a:r>
+          </a:p>
+        </p:txBody>
+      </p:sp>
       <p:graphicFrame>
         <p:nvGraphicFramePr>
           <p:cNvPr id="7" name="Table 6"/>
@@ -8278,7 +8753,7 @@
         </p:nvGraphicFramePr>
         <p:xfrm>
           <a:off x="548640" y="1645920"/>
-          <a:ext cx="11155680" cy="7790688"/>
+          <a:ext cx="11155680" cy="8613648"/>
         </p:xfrm>
         <a:graphic>
           <a:graphicData uri="http://schemas.openxmlformats.org/drawingml/2006/table">
@@ -8372,7 +8847,7 @@
                           </a:solidFill>
                           <a:latin typeface="Segoe UI"/>
                         </a:rPr>
-                        <a:t>2.4.0</a:t>
+                        <a:t>2.5.0</a:t>
                       </a:r>
                     </a:p>
                   </a:txBody>
@@ -8416,7 +8891,7 @@
                           </a:solidFill>
                           <a:latin typeface="Segoe UI"/>
                         </a:rPr>
-                        <a:t>Chat, groups, affinity &amp; pet visits</a:t>
+                        <a:t>Shop, coins, props &amp; moves</a:t>
                       </a:r>
                     </a:p>
                     <a:p>
@@ -8427,7 +8902,7 @@
                           </a:solidFill>
                           <a:latin typeface="Segoe UI"/>
                         </a:rPr>
-                        <a:t>Chat: message your friends, and chat inside groups. Your pet pops up new messages as a bubble - click it to reply; Pet interactions: wave, pet their pet, send a snack, high five - or send your pet to visit: it walks onto your friend's desktop for a little while!; Affinity: every chat and interaction grows your friendship - Acquaintance → Buddy → Good friends → Close friends → Best friends → Soulmates; Your own groups: create a private group, invite your friends, they accept or decline. Group board + group chat; the owner can remove members</a:t>
+                        <a:t>Shop: earn coins and spend them on your pet - 17 props (crown, wizard hat, headphones, shades, scarf, cape, angel wings...) and 6 moves: spin, dance, moonwalk, backflip, kung fu and spider swing!; Coins come from leveling up (+40), badges (+25), opening Pips each day (+10), friendships (+15 per affinity level), waving / chatting / visiting friends (+2) and pomodoros (+5). Everyone starts with a 100-coin gift; Your friends see your props: on avatars in the hub and when your pet visits their desktop - it shows off one of your moves; Pips is now a social pet: clicking the pet opens the Pips hub (friends, chat, groups, shop, badges)</a:t>
                       </a:r>
                     </a:p>
                   </a:txBody>
@@ -8451,7 +8926,7 @@
                           </a:solidFill>
                           <a:latin typeface="Segoe UI"/>
                         </a:rPr>
-                        <a:t>2.3.0</a:t>
+                        <a:t>2.4.0</a:t>
                       </a:r>
                     </a:p>
                   </a:txBody>
@@ -8495,7 +8970,7 @@
                           </a:solidFill>
                           <a:latin typeface="Segoe UI"/>
                         </a:rPr>
-                        <a:t>Friends, levels &amp; achievements</a:t>
+                        <a:t>Chat, groups, affinity &amp; pet visits</a:t>
                       </a:r>
                     </a:p>
                     <a:p>
@@ -8506,7 +8981,7 @@
                           </a:solidFill>
                           <a:latin typeface="Segoe UI"/>
                         </a:rPr>
-                        <a:t>Levels &amp; XP: every finished pomodoro earns XP and your level grows - plus 20 achievements to unlock (first tomato, 8 in a day, 7-day streak, early bird, night owl, pet lover...). Your pet celebrates each one; Friends (optional, off by default): get a 6-letter friend code, add colleagues, see today's board and join a team board like PTB. Your pet tells you when a friend finishes a pomodoro; Privacy: only your name, pet, level, streak and pomodoro counts are shared - never apps, window titles or scores. One click turns it off and deletes your online data. Right-click the pet → Friends &amp; achievements…</a:t>
+                        <a:t>Chat: message your friends, and chat inside groups. Your pet pops up new messages as a bubble - click it to reply; Pet interactions: wave, pet their pet, send a snack, high five - or send your pet to visit: it walks onto your friend's desktop for a little while!; Affinity: every chat and interaction grows your friendship - Acquaintance → Buddy → Good friends → Close friends → Best friends → Soulmates; Your own groups: create a private group, invite your friends, they accept or decline. Group board + group chat; the owner can remove members</a:t>
                       </a:r>
                     </a:p>
                   </a:txBody>
@@ -8530,7 +9005,7 @@
                           </a:solidFill>
                           <a:latin typeface="Segoe UI"/>
                         </a:rPr>
-                        <a:t>2.2.0</a:t>
+                        <a:t>2.3.0</a:t>
                       </a:r>
                     </a:p>
                   </a:txBody>
@@ -8574,7 +9049,7 @@
                           </a:solidFill>
                           <a:latin typeface="Segoe UI"/>
                         </a:rPr>
-                        <a:t>Pet sounds</a:t>
+                        <a:t>Friends, levels &amp; achievements</a:t>
                       </a:r>
                     </a:p>
                     <a:p>
@@ -8585,7 +9060,7 @@
                           </a:solidFill>
                           <a:latin typeface="Segoe UI"/>
                         </a:rPr>
-                        <a:t>Your pet has a voice! Each of the 23 animals has its own sound (meow, woof, ribbit, hoot, buzz, oink, whale song...) and it changes with its mood: happy chirps, sad whimpers, sleepy yawns, hungry calls, grumpy huffs and soft snores; It also reacts with sound when you tickle, pet, feed, shake or wake it; Settings: right-click the pet → Sounds to switch on/off; Pet status &amp; settings has a volume slider, a ▶ Hear me button and "Stay quiet while I'm focusing" (on by default)</a:t>
+                        <a:t>Levels &amp; XP: every finished pomodoro earns XP and your level grows - plus 20 achievements to unlock (first tomato, 8 in a day, 7-day streak, early bird, night owl, pet lover...). Your pet celebrates each one; Friends (optional, off by default): get a 6-letter friend code, add colleagues, see today's board and join a team board like PTB. Your pet tells you when a friend finishes a pomodoro; Privacy: only your name, pet, level, streak and pomodoro counts are shared - never apps, window titles or scores. One click turns it off and deletes your online data. Right-click the pet → Friends &amp; achievements…</a:t>
                       </a:r>
                     </a:p>
                   </a:txBody>
@@ -8609,7 +9084,7 @@
                           </a:solidFill>
                           <a:latin typeface="Segoe UI"/>
                         </a:rPr>
-                        <a:t>2.1.2</a:t>
+                        <a:t>2.2.0</a:t>
                       </a:r>
                     </a:p>
                   </a:txBody>
@@ -8653,7 +9128,7 @@
                           </a:solidFill>
                           <a:latin typeface="Segoe UI"/>
                         </a:rPr>
-                        <a:t>Tickle-only mode</a:t>
+                        <a:t>Pet sounds</a:t>
                       </a:r>
                     </a:p>
                     <a:p>
@@ -8664,7 +9139,7 @@
                           </a:solidFill>
                           <a:latin typeface="Segoe UI"/>
                         </a:rPr>
-                        <a:t>New click option "Only tickle (never open Pips)": click and tickle your pet as much as you like - the Pomodoro window stays closed (open it from the right-click menu). Right-click the pet → When I click</a:t>
+                        <a:t>Your pet has a voice! Each of the 23 animals has its own sound (meow, woof, ribbit, hoot, buzz, oink, whale song...) and it changes with its mood: happy chirps, sad whimpers, sleepy yawns, hungry calls, grumpy huffs and soft snores; It also reacts with sound when you tickle, pet, feed, shake or wake it; Settings: right-click the pet → Sounds to switch on/off; Pet status &amp; settings has a volume slider, a ▶ Hear me button and "Stay quiet while I'm focusing" (on by default)</a:t>
                       </a:r>
                     </a:p>
                   </a:txBody>
@@ -8688,7 +9163,7 @@
                           </a:solidFill>
                           <a:latin typeface="Segoe UI"/>
                         </a:rPr>
-                        <a:t>2.1.1</a:t>
+                        <a:t>2.1.2</a:t>
                       </a:r>
                     </a:p>
                   </a:txBody>
@@ -8732,7 +9207,7 @@
                           </a:solidFill>
                           <a:latin typeface="Segoe UI"/>
                         </a:rPr>
-                        <a:t>Owner info</a:t>
+                        <a:t>Tickle-only mode</a:t>
                       </a:r>
                     </a:p>
                     <a:p>
@@ -8743,7 +9218,7 @@
                           </a:solidFill>
                           <a:latin typeface="Segoe UI"/>
                         </a:rPr>
-                        <a:t>About Pips now shows the owner: Juwen Lie (right-click the pet → Help → About)</a:t>
+                        <a:t>New click option "Only tickle (never open Pips)": click and tickle your pet as much as you like - the Pomodoro window stays closed (open it from the right-click menu). Right-click the pet → When I click</a:t>
                       </a:r>
                     </a:p>
                   </a:txBody>
@@ -8767,7 +9242,7 @@
                           </a:solidFill>
                           <a:latin typeface="Segoe UI"/>
                         </a:rPr>
-                        <a:t>2.1.0</a:t>
+                        <a:t>2.1.1</a:t>
                       </a:r>
                     </a:p>
                   </a:txBody>
@@ -8811,7 +9286,7 @@
                           </a:solidFill>
                           <a:latin typeface="Segoe UI"/>
                         </a:rPr>
-                        <a:t>Interactive guide &amp; in-app updates</a:t>
+                        <a:t>Owner info</a:t>
                       </a:r>
                     </a:p>
                     <a:p>
@@ -8822,7 +9297,7 @@
                           </a:solidFill>
                           <a:latin typeface="Segoe UI"/>
                         </a:rPr>
-                        <a:t>Interactive first-run guide: your pet walks you through clicking, dragging, petting and the right-click menu; In-app updates: Pips tells you when a new version is out - update with one click (your settings and data are kept); New Help menu: replay the guide, check for updates, see the version; Option to turn automatic update checks off</a:t>
+                        <a:t>About Pips now shows the owner: Juwen Lie (right-click the pet → Help → About)</a:t>
                       </a:r>
                     </a:p>
                   </a:txBody>
@@ -8846,7 +9321,7 @@
                           </a:solidFill>
                           <a:latin typeface="Segoe UI"/>
                         </a:rPr>
-                        <a:t>2.0.0</a:t>
+                        <a:t>2.1.0</a:t>
                       </a:r>
                     </a:p>
                   </a:txBody>
@@ -8890,7 +9365,7 @@
                           </a:solidFill>
                           <a:latin typeface="Segoe UI"/>
                         </a:rPr>
-                        <a:t>Desktop pet, 23 animals &amp; 4 languages</a:t>
+                        <a:t>Interactive guide &amp; in-app updates</a:t>
                       </a:r>
                     </a:p>
                     <a:p>
@@ -8901,7 +9376,7 @@
                           </a:solidFill>
                           <a:latin typeface="Segoe UI"/>
                         </a:rPr>
-                        <a:t>Desktop pet that lives on your desktop and taskbar - drag it, tickle it, pet it; 23 animals in 3 groups: Land walks, Water swims with bubbles, Sky hovers and flaps; Moods (happy, sad, tired, hungry, grumpy...), naps when you're away, wakes up when you're back; Cute chat-bubble reminders: breaks, water, 20-20-20 eye rest, pomodoro done, daily goal</a:t>
+                        <a:t>Interactive first-run guide: your pet walks you through clicking, dragging, petting and the right-click menu; In-app updates: Pips tells you when a new version is out - update with one click (your settings and data are kept); New Help menu: replay the guide, check for updates, see the version; Option to turn automatic update checks off</a:t>
                       </a:r>
                     </a:p>
                   </a:txBody>
@@ -8925,7 +9400,7 @@
                           </a:solidFill>
                           <a:latin typeface="Segoe UI"/>
                         </a:rPr>
-                        <a:t>1.5.0</a:t>
+                        <a:t>2.0.0</a:t>
                       </a:r>
                     </a:p>
                   </a:txBody>
@@ -8947,13 +9422,92 @@
                           </a:solidFill>
                           <a:latin typeface="Segoe UI"/>
                         </a:rPr>
+                        <a:t>2026-10-28</a:t>
+                      </a:r>
+                    </a:p>
+                  </a:txBody>
+                  <a:tcPr marL="73152" marR="73152" marT="36576" marB="36576">
+                    <a:solidFill>
+                      <a:srgbClr val="F7F4EC"/>
+                    </a:solidFill>
+                  </a:tcPr>
+                </a:tc>
+                <a:tc>
+                  <a:txBody>
+                    <a:bodyPr wrap="square"/>
+                    <a:lstStyle/>
+                    <a:p>
+                      <a:r>
+                        <a:rPr sz="1200" b="0">
+                          <a:solidFill>
+                            <a:srgbClr val="2B2A28"/>
+                          </a:solidFill>
+                          <a:latin typeface="Segoe UI"/>
+                        </a:rPr>
+                        <a:t>Desktop pet, 23 animals &amp; 4 languages</a:t>
+                      </a:r>
+                    </a:p>
+                    <a:p>
+                      <a:r>
+                        <a:rPr sz="1200" b="0">
+                          <a:solidFill>
+                            <a:srgbClr val="2B2A28"/>
+                          </a:solidFill>
+                          <a:latin typeface="Segoe UI"/>
+                        </a:rPr>
+                        <a:t>Desktop pet that lives on your desktop and taskbar - drag it, tickle it, pet it; 23 animals in 3 groups: Land walks, Water swims with bubbles, Sky hovers and flaps; Moods (happy, sad, tired, hungry, grumpy...), naps when you're away, wakes up when you're back; Cute chat-bubble reminders: breaks, water, 20-20-20 eye rest, pomodoro done, daily goal</a:t>
+                      </a:r>
+                    </a:p>
+                  </a:txBody>
+                  <a:tcPr marL="73152" marR="73152" marT="36576" marB="36576">
+                    <a:solidFill>
+                      <a:srgbClr val="F7F4EC"/>
+                    </a:solidFill>
+                  </a:tcPr>
+                </a:tc>
+              </a:tr>
+              <a:tr h="822960">
+                <a:tc>
+                  <a:txBody>
+                    <a:bodyPr wrap="square"/>
+                    <a:lstStyle/>
+                    <a:p>
+                      <a:r>
+                        <a:rPr sz="1200" b="1">
+                          <a:solidFill>
+                            <a:srgbClr val="2B2A28"/>
+                          </a:solidFill>
+                          <a:latin typeface="Segoe UI"/>
+                        </a:rPr>
+                        <a:t>1.5.0</a:t>
+                      </a:r>
+                    </a:p>
+                  </a:txBody>
+                  <a:tcPr marL="73152" marR="73152" marT="36576" marB="36576">
+                    <a:solidFill>
+                      <a:srgbClr val="FFFDF8"/>
+                    </a:solidFill>
+                  </a:tcPr>
+                </a:tc>
+                <a:tc>
+                  <a:txBody>
+                    <a:bodyPr wrap="square"/>
+                    <a:lstStyle/>
+                    <a:p>
+                      <a:r>
+                        <a:rPr sz="1200" b="0">
+                          <a:solidFill>
+                            <a:srgbClr val="2B2A28"/>
+                          </a:solidFill>
+                          <a:latin typeface="Segoe UI"/>
+                        </a:rPr>
                         <a:t>2026-10-24</a:t>
                       </a:r>
                     </a:p>
                   </a:txBody>
                   <a:tcPr marL="73152" marR="73152" marT="36576" marB="36576">
                     <a:solidFill>
-                      <a:srgbClr val="F7F4EC"/>
+                      <a:srgbClr val="FFFDF8"/>
                     </a:solidFill>
                   </a:tcPr>
                 </a:tc>
@@ -8986,7 +9540,7 @@
                   </a:txBody>
                   <a:tcPr marL="73152" marR="73152" marT="36576" marB="36576">
                     <a:solidFill>
-                      <a:srgbClr val="F7F4EC"/>
+                      <a:srgbClr val="FFFDF8"/>
                     </a:solidFill>
                   </a:tcPr>
                 </a:tc>
@@ -9010,7 +9564,7 @@
                   </a:txBody>
                   <a:tcPr marL="73152" marR="73152" marT="36576" marB="36576">
                     <a:solidFill>
-                      <a:srgbClr val="FFFDF8"/>
+                      <a:srgbClr val="F7F4EC"/>
                     </a:solidFill>
                   </a:tcPr>
                 </a:tc>
@@ -9032,7 +9586,7 @@
                   </a:txBody>
                   <a:tcPr marL="73152" marR="73152" marT="36576" marB="36576">
                     <a:solidFill>
-                      <a:srgbClr val="FFFDF8"/>
+                      <a:srgbClr val="F7F4EC"/>
                     </a:solidFill>
                   </a:tcPr>
                 </a:tc>
@@ -9065,7 +9619,7 @@
                   </a:txBody>
                   <a:tcPr marL="73152" marR="73152" marT="36576" marB="36576">
                     <a:solidFill>
-                      <a:srgbClr val="FFFDF8"/>
+                      <a:srgbClr val="F7F4EC"/>
                     </a:solidFill>
                   </a:tcPr>
                 </a:tc>
@@ -9082,7 +9636,7 @@
 </p:sld>
 </file>
 
-<file path=ppt/slides/slide18.xml><?xml version="1.0" encoding="utf-8"?>
+<file path=ppt/slides/slide19.xml><?xml version="1.0" encoding="utf-8"?>
 <p:sld xmlns:a="http://schemas.openxmlformats.org/drawingml/2006/main" xmlns:p="http://schemas.openxmlformats.org/presentationml/2006/main" xmlns:r="http://schemas.openxmlformats.org/officeDocument/2006/relationships">
   <p:cSld>
     <p:bg>
@@ -9512,6 +10066,40 @@
                 </a:solidFill>
                 <a:latin typeface="Segoe UI"/>
               </a:rPr>
+              <a:t>A social pet. </a:t>
+            </a:r>
+            <a:r>
+              <a:rPr sz="1800">
+                <a:solidFill>
+                  <a:srgbClr val="2B2A28"/>
+                </a:solidFill>
+                <a:latin typeface="Segoe UI"/>
+              </a:rPr>
+              <a:t>Click the pet to open the Pips hub: friends, chat, groups, and a shop with props and moves for your pet.</a:t>
+            </a:r>
+          </a:p>
+          <a:p>
+            <a:pPr>
+              <a:spcAft>
+                <a:spcPts val="1000"/>
+              </a:spcAft>
+            </a:pPr>
+            <a:r>
+              <a:rPr sz="1800" b="1">
+                <a:solidFill>
+                  <a:srgbClr val="4CB86B"/>
+                </a:solidFill>
+                <a:latin typeface="Segoe UI"/>
+              </a:rPr>
+              <a:t>•  </a:t>
+            </a:r>
+            <a:r>
+              <a:rPr sz="1800" b="1">
+                <a:solidFill>
+                  <a:srgbClr val="2B2A28"/>
+                </a:solidFill>
+                <a:latin typeface="Segoe UI"/>
+              </a:rPr>
               <a:t>A focus timer. </a:t>
             </a:r>
             <a:r>
@@ -9521,7 +10109,7 @@
                 </a:solidFill>
                 <a:latin typeface="Segoe UI"/>
               </a:rPr>
-              <a:t>Click the pet to open the Pips card: a 25-minute Pomodoro timer with relaxing soundscapes.</a:t>
+              <a:t>Right-click → Focus timer: a 25-minute Pomodoro with soundscapes.</a:t>
             </a:r>
           </a:p>
           <a:p>
@@ -11534,7 +12122,7 @@
                           </a:solidFill>
                           <a:latin typeface="Segoe UI"/>
                         </a:rPr>
-                        <a:t>Clicking the pet opens the Pips card</a:t>
+                        <a:t>Clicking the pet opens the Pips hub (friends, chat, shop)</a:t>
                       </a:r>
                     </a:p>
                   </a:txBody>
@@ -12465,7 +13053,7 @@
                           </a:solidFill>
                           <a:latin typeface="Segoe UI"/>
                         </a:rPr>
-                        <a:t>Giggles and opens / closes the Pips card</a:t>
+                        <a:t>Giggles and opens the Pips hub (friends, chat, groups, shop)</a:t>
                       </a:r>
                     </a:p>
                   </a:txBody>
@@ -14197,7 +14785,7 @@
                 </a:solidFill>
                 <a:latin typeface="Segoe UI"/>
               </a:rPr>
-              <a:t>Focus with the Pomodoro card</a:t>
+              <a:t>Focus timer (right-click → Focus timer)</a:t>
             </a:r>
           </a:p>
         </p:txBody>

</xml_diff>

<commit_message>
pips 2.5.1: New cute Pips logo
</commit_message>
<xml_diff>
--- a/apps/pips/web/download/Pips-Guide.pptx
+++ b/apps/pips/web/download/Pips-Guide.pptx
@@ -3292,7 +3292,7 @@
                 </a:solidFill>
                 <a:latin typeface="Segoe UI"/>
               </a:rPr>
-              <a:t>Version 2.5.0  ·  2026-10-28  ·  Owner: Juwen Lie</a:t>
+              <a:t>Version 2.5.1  ·  2026-10-28  ·  Owner: Juwen Lie</a:t>
             </a:r>
           </a:p>
           <a:p>
@@ -8029,7 +8029,7 @@
                 </a:solidFill>
                 <a:latin typeface="Segoe UI"/>
               </a:rPr>
-              <a:t>What's new in 2.5.0</a:t>
+              <a:t>What's new in 2.5.1</a:t>
             </a:r>
           </a:p>
         </p:txBody>
@@ -8142,7 +8142,7 @@
                 </a:solidFill>
                 <a:latin typeface="Segoe UI"/>
               </a:rPr>
-              <a:t>Shop, coins, props &amp; moves  ·  2026-10-28</a:t>
+              <a:t>New cute Pips logo  ·  2026-10-28</a:t>
             </a:r>
           </a:p>
         </p:txBody>
@@ -8190,107 +8190,7 @@
                 </a:solidFill>
                 <a:latin typeface="Segoe UI"/>
               </a:rPr>
-              <a:t>Shop: earn coins and spend them on your pet - 17 props (crown, wizard hat, headphones, shades, scarf, cape, angel wings...) and 6 moves: spin, dance, moonwalk, backflip, kung fu and spider swing!</a:t>
-            </a:r>
-          </a:p>
-          <a:p>
-            <a:pPr>
-              <a:spcAft>
-                <a:spcPts val="1000"/>
-              </a:spcAft>
-            </a:pPr>
-            <a:r>
-              <a:rPr sz="1700" b="1">
-                <a:solidFill>
-                  <a:srgbClr val="4CB86B"/>
-                </a:solidFill>
-                <a:latin typeface="Segoe UI"/>
-              </a:rPr>
-              <a:t>•  </a:t>
-            </a:r>
-            <a:r>
-              <a:rPr sz="1700">
-                <a:solidFill>
-                  <a:srgbClr val="2B2A28"/>
-                </a:solidFill>
-                <a:latin typeface="Segoe UI"/>
-              </a:rPr>
-              <a:t>Coins come from leveling up (+40), badges (+25), opening Pips each day (+10), friendships (+15 per affinity level), waving / chatting / visiting friends (+2) and pomodoros (+5). Everyone starts with a 100-coin gift</a:t>
-            </a:r>
-          </a:p>
-          <a:p>
-            <a:pPr>
-              <a:spcAft>
-                <a:spcPts val="1000"/>
-              </a:spcAft>
-            </a:pPr>
-            <a:r>
-              <a:rPr sz="1700" b="1">
-                <a:solidFill>
-                  <a:srgbClr val="4CB86B"/>
-                </a:solidFill>
-                <a:latin typeface="Segoe UI"/>
-              </a:rPr>
-              <a:t>•  </a:t>
-            </a:r>
-            <a:r>
-              <a:rPr sz="1700">
-                <a:solidFill>
-                  <a:srgbClr val="2B2A28"/>
-                </a:solidFill>
-                <a:latin typeface="Segoe UI"/>
-              </a:rPr>
-              <a:t>Your friends see your props: on avatars in the hub and when your pet visits their desktop - it shows off one of your moves</a:t>
-            </a:r>
-          </a:p>
-          <a:p>
-            <a:pPr>
-              <a:spcAft>
-                <a:spcPts val="1000"/>
-              </a:spcAft>
-            </a:pPr>
-            <a:r>
-              <a:rPr sz="1700" b="1">
-                <a:solidFill>
-                  <a:srgbClr val="4CB86B"/>
-                </a:solidFill>
-                <a:latin typeface="Segoe UI"/>
-              </a:rPr>
-              <a:t>•  </a:t>
-            </a:r>
-            <a:r>
-              <a:rPr sz="1700">
-                <a:solidFill>
-                  <a:srgbClr val="2B2A28"/>
-                </a:solidFill>
-                <a:latin typeface="Segoe UI"/>
-              </a:rPr>
-              <a:t>Pips is now a social pet: clicking the pet opens the Pips hub (friends, chat, groups, shop, badges)</a:t>
-            </a:r>
-          </a:p>
-          <a:p>
-            <a:pPr>
-              <a:spcAft>
-                <a:spcPts val="1000"/>
-              </a:spcAft>
-            </a:pPr>
-            <a:r>
-              <a:rPr sz="1700" b="1">
-                <a:solidFill>
-                  <a:srgbClr val="4CB86B"/>
-                </a:solidFill>
-                <a:latin typeface="Segoe UI"/>
-              </a:rPr>
-              <a:t>•  </a:t>
-            </a:r>
-            <a:r>
-              <a:rPr sz="1700">
-                <a:solidFill>
-                  <a:srgbClr val="2B2A28"/>
-                </a:solidFill>
-                <a:latin typeface="Segoe UI"/>
-              </a:rPr>
-              <a:t>The focus timer moved to right-click → Focus timer (Pomodoro). Pomodoros still give XP and coins</a:t>
+              <a:t>New Pips logo: Pip the cat on a Pips-red tile, matching the app colours (desktop shortcut, windows and website)</a:t>
             </a:r>
           </a:p>
         </p:txBody>
@@ -8421,107 +8321,7 @@
                 </a:solidFill>
                 <a:latin typeface="Segoe UI"/>
               </a:rPr>
-              <a:t>Toko: kumpulkan koin dan belanjakan untuk peliharaanmu - 17 aksesori (mahkota, topi penyihir, headphone, kacamata hitam, syal, jubah, sayap malaikat...) dan 6 gerakan: putar, joget, moonwalk, salto, kung fu dan ayunan laba-laba!</a:t>
-            </a:r>
-          </a:p>
-          <a:p>
-            <a:pPr>
-              <a:spcAft>
-                <a:spcPts val="500"/>
-              </a:spcAft>
-            </a:pPr>
-            <a:r>
-              <a:rPr sz="1200" b="1">
-                <a:solidFill>
-                  <a:srgbClr val="4CB86B"/>
-                </a:solidFill>
-                <a:latin typeface="Segoe UI"/>
-              </a:rPr>
-              <a:t>•  </a:t>
-            </a:r>
-            <a:r>
-              <a:rPr sz="1200">
-                <a:solidFill>
-                  <a:srgbClr val="2B2A28"/>
-                </a:solidFill>
-                <a:latin typeface="Segoe UI"/>
-              </a:rPr>
-              <a:t>Koin didapat dari naik level (+40), lencana (+25), membuka Pips tiap hari (+10), pertemanan (+15 per level afinitas), melambai / chat / berkunjung ke teman (+2) dan pomodoro (+5). Semua mulai dengan hadiah 100 koin</a:t>
-            </a:r>
-          </a:p>
-          <a:p>
-            <a:pPr>
-              <a:spcAft>
-                <a:spcPts val="500"/>
-              </a:spcAft>
-            </a:pPr>
-            <a:r>
-              <a:rPr sz="1200" b="1">
-                <a:solidFill>
-                  <a:srgbClr val="4CB86B"/>
-                </a:solidFill>
-                <a:latin typeface="Segoe UI"/>
-              </a:rPr>
-              <a:t>•  </a:t>
-            </a:r>
-            <a:r>
-              <a:rPr sz="1200">
-                <a:solidFill>
-                  <a:srgbClr val="2B2A28"/>
-                </a:solidFill>
-                <a:latin typeface="Segoe UI"/>
-              </a:rPr>
-              <a:t>Temanmu bisa melihat aksesorimu: di avatar hub dan saat peliharaanmu berkunjung ke desktop mereka - ia memamerkan salah satu gerakanmu</a:t>
-            </a:r>
-          </a:p>
-          <a:p>
-            <a:pPr>
-              <a:spcAft>
-                <a:spcPts val="500"/>
-              </a:spcAft>
-            </a:pPr>
-            <a:r>
-              <a:rPr sz="1200" b="1">
-                <a:solidFill>
-                  <a:srgbClr val="4CB86B"/>
-                </a:solidFill>
-                <a:latin typeface="Segoe UI"/>
-              </a:rPr>
-              <a:t>•  </a:t>
-            </a:r>
-            <a:r>
-              <a:rPr sz="1200">
-                <a:solidFill>
-                  <a:srgbClr val="2B2A28"/>
-                </a:solidFill>
-                <a:latin typeface="Segoe UI"/>
-              </a:rPr>
-              <a:t>Pips kini peliharaan sosial: klik peliharaan untuk membuka hub Pips (teman, chat, grup, toko, lencana)</a:t>
-            </a:r>
-          </a:p>
-          <a:p>
-            <a:pPr>
-              <a:spcAft>
-                <a:spcPts val="500"/>
-              </a:spcAft>
-            </a:pPr>
-            <a:r>
-              <a:rPr sz="1200" b="1">
-                <a:solidFill>
-                  <a:srgbClr val="4CB86B"/>
-                </a:solidFill>
-                <a:latin typeface="Segoe UI"/>
-              </a:rPr>
-              <a:t>•  </a:t>
-            </a:r>
-            <a:r>
-              <a:rPr sz="1200">
-                <a:solidFill>
-                  <a:srgbClr val="2B2A28"/>
-                </a:solidFill>
-                <a:latin typeface="Segoe UI"/>
-              </a:rPr>
-              <a:t>Timer fokus pindah ke klik kanan → Timer fokus (Pomodoro). Pomodoro tetap memberi XP dan koin</a:t>
+              <a:t>Logo Pips baru: kucing Pip di ubin merah Pips, serasi dengan warna aplikasi (shortcut desktop, jendela dan situs web)</a:t>
             </a:r>
           </a:p>
         </p:txBody>
@@ -8753,7 +8553,7 @@
         </p:nvGraphicFramePr>
         <p:xfrm>
           <a:off x="548640" y="1645920"/>
-          <a:ext cx="11155680" cy="8613648"/>
+          <a:ext cx="11155680" cy="9436608"/>
         </p:xfrm>
         <a:graphic>
           <a:graphicData uri="http://schemas.openxmlformats.org/drawingml/2006/table">
@@ -8847,7 +8647,7 @@
                           </a:solidFill>
                           <a:latin typeface="Segoe UI"/>
                         </a:rPr>
-                        <a:t>2.5.0</a:t>
+                        <a:t>2.5.1</a:t>
                       </a:r>
                     </a:p>
                   </a:txBody>
@@ -8891,7 +8691,7 @@
                           </a:solidFill>
                           <a:latin typeface="Segoe UI"/>
                         </a:rPr>
-                        <a:t>Shop, coins, props &amp; moves</a:t>
+                        <a:t>New cute Pips logo</a:t>
                       </a:r>
                     </a:p>
                     <a:p>
@@ -8902,7 +8702,7 @@
                           </a:solidFill>
                           <a:latin typeface="Segoe UI"/>
                         </a:rPr>
-                        <a:t>Shop: earn coins and spend them on your pet - 17 props (crown, wizard hat, headphones, shades, scarf, cape, angel wings...) and 6 moves: spin, dance, moonwalk, backflip, kung fu and spider swing!; Coins come from leveling up (+40), badges (+25), opening Pips each day (+10), friendships (+15 per affinity level), waving / chatting / visiting friends (+2) and pomodoros (+5). Everyone starts with a 100-coin gift; Your friends see your props: on avatars in the hub and when your pet visits their desktop - it shows off one of your moves; Pips is now a social pet: clicking the pet opens the Pips hub (friends, chat, groups, shop, badges)</a:t>
+                        <a:t>New Pips logo: Pip the cat on a Pips-red tile, matching the app colours (desktop shortcut, windows and website)</a:t>
                       </a:r>
                     </a:p>
                   </a:txBody>
@@ -8926,7 +8726,7 @@
                           </a:solidFill>
                           <a:latin typeface="Segoe UI"/>
                         </a:rPr>
-                        <a:t>2.4.0</a:t>
+                        <a:t>2.5.0</a:t>
                       </a:r>
                     </a:p>
                   </a:txBody>
@@ -8970,7 +8770,7 @@
                           </a:solidFill>
                           <a:latin typeface="Segoe UI"/>
                         </a:rPr>
-                        <a:t>Chat, groups, affinity &amp; pet visits</a:t>
+                        <a:t>Shop, coins, props &amp; moves</a:t>
                       </a:r>
                     </a:p>
                     <a:p>
@@ -8981,7 +8781,7 @@
                           </a:solidFill>
                           <a:latin typeface="Segoe UI"/>
                         </a:rPr>
-                        <a:t>Chat: message your friends, and chat inside groups. Your pet pops up new messages as a bubble - click it to reply; Pet interactions: wave, pet their pet, send a snack, high five - or send your pet to visit: it walks onto your friend's desktop for a little while!; Affinity: every chat and interaction grows your friendship - Acquaintance → Buddy → Good friends → Close friends → Best friends → Soulmates; Your own groups: create a private group, invite your friends, they accept or decline. Group board + group chat; the owner can remove members</a:t>
+                        <a:t>Shop: earn coins and spend them on your pet - 17 props (crown, wizard hat, headphones, shades, scarf, cape, angel wings...) and 6 moves: spin, dance, moonwalk, backflip, kung fu and spider swing!; Coins come from leveling up (+40), badges (+25), opening Pips each day (+10), friendships (+15 per affinity level), waving / chatting / visiting friends (+2) and pomodoros (+5). Everyone starts with a 100-coin gift; Your friends see your props: on avatars in the hub and when your pet visits their desktop - it shows off one of your moves; Pips is now a social pet: clicking the pet opens the Pips hub (friends, chat, groups, shop, badges)</a:t>
                       </a:r>
                     </a:p>
                   </a:txBody>
@@ -9005,7 +8805,7 @@
                           </a:solidFill>
                           <a:latin typeface="Segoe UI"/>
                         </a:rPr>
-                        <a:t>2.3.0</a:t>
+                        <a:t>2.4.0</a:t>
                       </a:r>
                     </a:p>
                   </a:txBody>
@@ -9049,7 +8849,7 @@
                           </a:solidFill>
                           <a:latin typeface="Segoe UI"/>
                         </a:rPr>
-                        <a:t>Friends, levels &amp; achievements</a:t>
+                        <a:t>Chat, groups, affinity &amp; pet visits</a:t>
                       </a:r>
                     </a:p>
                     <a:p>
@@ -9060,7 +8860,7 @@
                           </a:solidFill>
                           <a:latin typeface="Segoe UI"/>
                         </a:rPr>
-                        <a:t>Levels &amp; XP: every finished pomodoro earns XP and your level grows - plus 20 achievements to unlock (first tomato, 8 in a day, 7-day streak, early bird, night owl, pet lover...). Your pet celebrates each one; Friends (optional, off by default): get a 6-letter friend code, add colleagues, see today's board and join a team board like PTB. Your pet tells you when a friend finishes a pomodoro; Privacy: only your name, pet, level, streak and pomodoro counts are shared - never apps, window titles or scores. One click turns it off and deletes your online data. Right-click the pet → Friends &amp; achievements…</a:t>
+                        <a:t>Chat: message your friends, and chat inside groups. Your pet pops up new messages as a bubble - click it to reply; Pet interactions: wave, pet their pet, send a snack, high five - or send your pet to visit: it walks onto your friend's desktop for a little while!; Affinity: every chat and interaction grows your friendship - Acquaintance → Buddy → Good friends → Close friends → Best friends → Soulmates; Your own groups: create a private group, invite your friends, they accept or decline. Group board + group chat; the owner can remove members</a:t>
                       </a:r>
                     </a:p>
                   </a:txBody>
@@ -9084,7 +8884,7 @@
                           </a:solidFill>
                           <a:latin typeface="Segoe UI"/>
                         </a:rPr>
-                        <a:t>2.2.0</a:t>
+                        <a:t>2.3.0</a:t>
                       </a:r>
                     </a:p>
                   </a:txBody>
@@ -9128,7 +8928,7 @@
                           </a:solidFill>
                           <a:latin typeface="Segoe UI"/>
                         </a:rPr>
-                        <a:t>Pet sounds</a:t>
+                        <a:t>Friends, levels &amp; achievements</a:t>
                       </a:r>
                     </a:p>
                     <a:p>
@@ -9139,7 +8939,7 @@
                           </a:solidFill>
                           <a:latin typeface="Segoe UI"/>
                         </a:rPr>
-                        <a:t>Your pet has a voice! Each of the 23 animals has its own sound (meow, woof, ribbit, hoot, buzz, oink, whale song...) and it changes with its mood: happy chirps, sad whimpers, sleepy yawns, hungry calls, grumpy huffs and soft snores; It also reacts with sound when you tickle, pet, feed, shake or wake it; Settings: right-click the pet → Sounds to switch on/off; Pet status &amp; settings has a volume slider, a ▶ Hear me button and "Stay quiet while I'm focusing" (on by default)</a:t>
+                        <a:t>Levels &amp; XP: every finished pomodoro earns XP and your level grows - plus 20 achievements to unlock (first tomato, 8 in a day, 7-day streak, early bird, night owl, pet lover...). Your pet celebrates each one; Friends (optional, off by default): get a 6-letter friend code, add colleagues, see today's board and join a team board like PTB. Your pet tells you when a friend finishes a pomodoro; Privacy: only your name, pet, level, streak and pomodoro counts are shared - never apps, window titles or scores. One click turns it off and deletes your online data. Right-click the pet → Friends &amp; achievements…</a:t>
                       </a:r>
                     </a:p>
                   </a:txBody>
@@ -9163,7 +8963,7 @@
                           </a:solidFill>
                           <a:latin typeface="Segoe UI"/>
                         </a:rPr>
-                        <a:t>2.1.2</a:t>
+                        <a:t>2.2.0</a:t>
                       </a:r>
                     </a:p>
                   </a:txBody>
@@ -9207,7 +9007,7 @@
                           </a:solidFill>
                           <a:latin typeface="Segoe UI"/>
                         </a:rPr>
-                        <a:t>Tickle-only mode</a:t>
+                        <a:t>Pet sounds</a:t>
                       </a:r>
                     </a:p>
                     <a:p>
@@ -9218,7 +9018,7 @@
                           </a:solidFill>
                           <a:latin typeface="Segoe UI"/>
                         </a:rPr>
-                        <a:t>New click option "Only tickle (never open Pips)": click and tickle your pet as much as you like - the Pomodoro window stays closed (open it from the right-click menu). Right-click the pet → When I click</a:t>
+                        <a:t>Your pet has a voice! Each of the 23 animals has its own sound (meow, woof, ribbit, hoot, buzz, oink, whale song...) and it changes with its mood: happy chirps, sad whimpers, sleepy yawns, hungry calls, grumpy huffs and soft snores; It also reacts with sound when you tickle, pet, feed, shake or wake it; Settings: right-click the pet → Sounds to switch on/off; Pet status &amp; settings has a volume slider, a ▶ Hear me button and "Stay quiet while I'm focusing" (on by default)</a:t>
                       </a:r>
                     </a:p>
                   </a:txBody>
@@ -9242,7 +9042,7 @@
                           </a:solidFill>
                           <a:latin typeface="Segoe UI"/>
                         </a:rPr>
-                        <a:t>2.1.1</a:t>
+                        <a:t>2.1.2</a:t>
                       </a:r>
                     </a:p>
                   </a:txBody>
@@ -9286,7 +9086,7 @@
                           </a:solidFill>
                           <a:latin typeface="Segoe UI"/>
                         </a:rPr>
-                        <a:t>Owner info</a:t>
+                        <a:t>Tickle-only mode</a:t>
                       </a:r>
                     </a:p>
                     <a:p>
@@ -9297,7 +9097,7 @@
                           </a:solidFill>
                           <a:latin typeface="Segoe UI"/>
                         </a:rPr>
-                        <a:t>About Pips now shows the owner: Juwen Lie (right-click the pet → Help → About)</a:t>
+                        <a:t>New click option "Only tickle (never open Pips)": click and tickle your pet as much as you like - the Pomodoro window stays closed (open it from the right-click menu). Right-click the pet → When I click</a:t>
                       </a:r>
                     </a:p>
                   </a:txBody>
@@ -9321,7 +9121,7 @@
                           </a:solidFill>
                           <a:latin typeface="Segoe UI"/>
                         </a:rPr>
-                        <a:t>2.1.0</a:t>
+                        <a:t>2.1.1</a:t>
                       </a:r>
                     </a:p>
                   </a:txBody>
@@ -9365,7 +9165,7 @@
                           </a:solidFill>
                           <a:latin typeface="Segoe UI"/>
                         </a:rPr>
-                        <a:t>Interactive guide &amp; in-app updates</a:t>
+                        <a:t>Owner info</a:t>
                       </a:r>
                     </a:p>
                     <a:p>
@@ -9376,7 +9176,7 @@
                           </a:solidFill>
                           <a:latin typeface="Segoe UI"/>
                         </a:rPr>
-                        <a:t>Interactive first-run guide: your pet walks you through clicking, dragging, petting and the right-click menu; In-app updates: Pips tells you when a new version is out - update with one click (your settings and data are kept); New Help menu: replay the guide, check for updates, see the version; Option to turn automatic update checks off</a:t>
+                        <a:t>About Pips now shows the owner: Juwen Lie (right-click the pet → Help → About)</a:t>
                       </a:r>
                     </a:p>
                   </a:txBody>
@@ -9400,7 +9200,7 @@
                           </a:solidFill>
                           <a:latin typeface="Segoe UI"/>
                         </a:rPr>
-                        <a:t>2.0.0</a:t>
+                        <a:t>2.1.0</a:t>
                       </a:r>
                     </a:p>
                   </a:txBody>
@@ -9444,7 +9244,7 @@
                           </a:solidFill>
                           <a:latin typeface="Segoe UI"/>
                         </a:rPr>
-                        <a:t>Desktop pet, 23 animals &amp; 4 languages</a:t>
+                        <a:t>Interactive guide &amp; in-app updates</a:t>
                       </a:r>
                     </a:p>
                     <a:p>
@@ -9455,7 +9255,7 @@
                           </a:solidFill>
                           <a:latin typeface="Segoe UI"/>
                         </a:rPr>
-                        <a:t>Desktop pet that lives on your desktop and taskbar - drag it, tickle it, pet it; 23 animals in 3 groups: Land walks, Water swims with bubbles, Sky hovers and flaps; Moods (happy, sad, tired, hungry, grumpy...), naps when you're away, wakes up when you're back; Cute chat-bubble reminders: breaks, water, 20-20-20 eye rest, pomodoro done, daily goal</a:t>
+                        <a:t>Interactive first-run guide: your pet walks you through clicking, dragging, petting and the right-click menu; In-app updates: Pips tells you when a new version is out - update with one click (your settings and data are kept); New Help menu: replay the guide, check for updates, see the version; Option to turn automatic update checks off</a:t>
                       </a:r>
                     </a:p>
                   </a:txBody>
@@ -9479,7 +9279,7 @@
                           </a:solidFill>
                           <a:latin typeface="Segoe UI"/>
                         </a:rPr>
-                        <a:t>1.5.0</a:t>
+                        <a:t>2.0.0</a:t>
                       </a:r>
                     </a:p>
                   </a:txBody>
@@ -9501,13 +9301,92 @@
                           </a:solidFill>
                           <a:latin typeface="Segoe UI"/>
                         </a:rPr>
+                        <a:t>2026-10-28</a:t>
+                      </a:r>
+                    </a:p>
+                  </a:txBody>
+                  <a:tcPr marL="73152" marR="73152" marT="36576" marB="36576">
+                    <a:solidFill>
+                      <a:srgbClr val="FFFDF8"/>
+                    </a:solidFill>
+                  </a:tcPr>
+                </a:tc>
+                <a:tc>
+                  <a:txBody>
+                    <a:bodyPr wrap="square"/>
+                    <a:lstStyle/>
+                    <a:p>
+                      <a:r>
+                        <a:rPr sz="1200" b="0">
+                          <a:solidFill>
+                            <a:srgbClr val="2B2A28"/>
+                          </a:solidFill>
+                          <a:latin typeface="Segoe UI"/>
+                        </a:rPr>
+                        <a:t>Desktop pet, 23 animals &amp; 4 languages</a:t>
+                      </a:r>
+                    </a:p>
+                    <a:p>
+                      <a:r>
+                        <a:rPr sz="1200" b="0">
+                          <a:solidFill>
+                            <a:srgbClr val="2B2A28"/>
+                          </a:solidFill>
+                          <a:latin typeface="Segoe UI"/>
+                        </a:rPr>
+                        <a:t>Desktop pet that lives on your desktop and taskbar - drag it, tickle it, pet it; 23 animals in 3 groups: Land walks, Water swims with bubbles, Sky hovers and flaps; Moods (happy, sad, tired, hungry, grumpy...), naps when you're away, wakes up when you're back; Cute chat-bubble reminders: breaks, water, 20-20-20 eye rest, pomodoro done, daily goal</a:t>
+                      </a:r>
+                    </a:p>
+                  </a:txBody>
+                  <a:tcPr marL="73152" marR="73152" marT="36576" marB="36576">
+                    <a:solidFill>
+                      <a:srgbClr val="FFFDF8"/>
+                    </a:solidFill>
+                  </a:tcPr>
+                </a:tc>
+              </a:tr>
+              <a:tr h="822960">
+                <a:tc>
+                  <a:txBody>
+                    <a:bodyPr wrap="square"/>
+                    <a:lstStyle/>
+                    <a:p>
+                      <a:r>
+                        <a:rPr sz="1200" b="1">
+                          <a:solidFill>
+                            <a:srgbClr val="2B2A28"/>
+                          </a:solidFill>
+                          <a:latin typeface="Segoe UI"/>
+                        </a:rPr>
+                        <a:t>1.5.0</a:t>
+                      </a:r>
+                    </a:p>
+                  </a:txBody>
+                  <a:tcPr marL="73152" marR="73152" marT="36576" marB="36576">
+                    <a:solidFill>
+                      <a:srgbClr val="F7F4EC"/>
+                    </a:solidFill>
+                  </a:tcPr>
+                </a:tc>
+                <a:tc>
+                  <a:txBody>
+                    <a:bodyPr wrap="square"/>
+                    <a:lstStyle/>
+                    <a:p>
+                      <a:r>
+                        <a:rPr sz="1200" b="0">
+                          <a:solidFill>
+                            <a:srgbClr val="2B2A28"/>
+                          </a:solidFill>
+                          <a:latin typeface="Segoe UI"/>
+                        </a:rPr>
                         <a:t>2026-10-24</a:t>
                       </a:r>
                     </a:p>
                   </a:txBody>
                   <a:tcPr marL="73152" marR="73152" marT="36576" marB="36576">
                     <a:solidFill>
-                      <a:srgbClr val="FFFDF8"/>
+                      <a:srgbClr val="F7F4EC"/>
                     </a:solidFill>
                   </a:tcPr>
                 </a:tc>
@@ -9540,7 +9419,7 @@
                   </a:txBody>
                   <a:tcPr marL="73152" marR="73152" marT="36576" marB="36576">
                     <a:solidFill>
-                      <a:srgbClr val="FFFDF8"/>
+                      <a:srgbClr val="F7F4EC"/>
                     </a:solidFill>
                   </a:tcPr>
                 </a:tc>
@@ -9564,7 +9443,7 @@
                   </a:txBody>
                   <a:tcPr marL="73152" marR="73152" marT="36576" marB="36576">
                     <a:solidFill>
-                      <a:srgbClr val="F7F4EC"/>
+                      <a:srgbClr val="FFFDF8"/>
                     </a:solidFill>
                   </a:tcPr>
                 </a:tc>
@@ -9586,7 +9465,7 @@
                   </a:txBody>
                   <a:tcPr marL="73152" marR="73152" marT="36576" marB="36576">
                     <a:solidFill>
-                      <a:srgbClr val="F7F4EC"/>
+                      <a:srgbClr val="FFFDF8"/>
                     </a:solidFill>
                   </a:tcPr>
                 </a:tc>
@@ -9619,7 +9498,7 @@
                   </a:txBody>
                   <a:tcPr marL="73152" marR="73152" marT="36576" marB="36576">
                     <a:solidFill>
-                      <a:srgbClr val="F7F4EC"/>
+                      <a:srgbClr val="FFFDF8"/>
                     </a:solidFill>
                   </a:tcPr>
                 </a:tc>

</xml_diff>

<commit_message>
pips 2.6.0: Profiles, ranks, online status & dark mode
</commit_message>
<xml_diff>
--- a/apps/pips/web/download/Pips-Guide.pptx
+++ b/apps/pips/web/download/Pips-Guide.pptx
@@ -3292,7 +3292,7 @@
                 </a:solidFill>
                 <a:latin typeface="Segoe UI"/>
               </a:rPr>
-              <a:t>Version 2.5.1  ·  2026-10-28  ·  Owner: Juwen Lie</a:t>
+              <a:t>Version 2.6.0  ·  2026-10-28  ·  Owner: Juwen Lie</a:t>
             </a:r>
           </a:p>
           <a:p>
@@ -4217,7 +4217,7 @@
                 </a:solidFill>
                 <a:latin typeface="Segoe UI"/>
               </a:rPr>
-              <a:t>Friends, chat, groups &amp; achievements</a:t>
+              <a:t>Friends, profiles, ranks &amp; badges</a:t>
             </a:r>
           </a:p>
         </p:txBody>
@@ -4685,7 +4685,82 @@
                 </a:solidFill>
                 <a:latin typeface="Segoe UI"/>
               </a:rPr>
-              <a:t>Create a private group and invite friends; or join an open team (e.g. PTB)</a:t>
+              <a:t>Create a private group and invite friends</a:t>
+            </a:r>
+          </a:p>
+          <a:p>
+            <a:pPr>
+              <a:spcAft>
+                <a:spcPts val="400"/>
+              </a:spcAft>
+            </a:pPr>
+            <a:r>
+              <a:rPr sz="1300" b="1">
+                <a:solidFill>
+                  <a:srgbClr val="4CB86B"/>
+                </a:solidFill>
+                <a:latin typeface="Segoe UI"/>
+              </a:rPr>
+              <a:t>•  </a:t>
+            </a:r>
+            <a:r>
+              <a:rPr sz="1300">
+                <a:solidFill>
+                  <a:srgbClr val="2B2A28"/>
+                </a:solidFill>
+                <a:latin typeface="Segoe UI"/>
+              </a:rPr>
+              <a:t>Ranks: everyone on Pips by XP, badges or streak</a:t>
+            </a:r>
+          </a:p>
+          <a:p>
+            <a:pPr>
+              <a:spcAft>
+                <a:spcPts val="400"/>
+              </a:spcAft>
+            </a:pPr>
+            <a:r>
+              <a:rPr sz="1300" b="1">
+                <a:solidFill>
+                  <a:srgbClr val="4CB86B"/>
+                </a:solidFill>
+                <a:latin typeface="Segoe UI"/>
+              </a:rPr>
+              <a:t>•  </a:t>
+            </a:r>
+            <a:r>
+              <a:rPr sz="1300">
+                <a:solidFill>
+                  <a:srgbClr val="2B2A28"/>
+                </a:solidFill>
+                <a:latin typeface="Segoe UI"/>
+              </a:rPr>
+              <a:t>Profile: photo, bio, info, status (online / busy / away) - public or private</a:t>
+            </a:r>
+          </a:p>
+          <a:p>
+            <a:pPr>
+              <a:spcAft>
+                <a:spcPts val="400"/>
+              </a:spcAft>
+            </a:pPr>
+            <a:r>
+              <a:rPr sz="1300" b="1">
+                <a:solidFill>
+                  <a:srgbClr val="4CB86B"/>
+                </a:solidFill>
+                <a:latin typeface="Segoe UI"/>
+              </a:rPr>
+              <a:t>•  </a:t>
+            </a:r>
+            <a:r>
+              <a:rPr sz="1300">
+                <a:solidFill>
+                  <a:srgbClr val="2B2A28"/>
+                </a:solidFill>
+                <a:latin typeface="Segoe UI"/>
+              </a:rPr>
+              <a:t>Label friends: Bro, Bestie, Partner, Soulmate...</a:t>
             </a:r>
           </a:p>
           <a:p>
@@ -5958,6 +6033,31 @@
                 <a:latin typeface="Segoe UI"/>
               </a:rPr>
               <a:t>Animal sounds + volume (quiet while focusing)</a:t>
+            </a:r>
+          </a:p>
+          <a:p>
+            <a:pPr>
+              <a:spcAft>
+                <a:spcPts val="300"/>
+              </a:spcAft>
+            </a:pPr>
+            <a:r>
+              <a:rPr sz="1400" b="1">
+                <a:solidFill>
+                  <a:srgbClr val="4CB86B"/>
+                </a:solidFill>
+                <a:latin typeface="Segoe UI"/>
+              </a:rPr>
+              <a:t>•  </a:t>
+            </a:r>
+            <a:r>
+              <a:rPr sz="1400">
+                <a:solidFill>
+                  <a:srgbClr val="2B2A28"/>
+                </a:solidFill>
+                <a:latin typeface="Segoe UI"/>
+              </a:rPr>
+              <a:t>Dark mode (also: right-click the pet → Dark mode)</a:t>
             </a:r>
           </a:p>
         </p:txBody>
@@ -8029,7 +8129,7 @@
                 </a:solidFill>
                 <a:latin typeface="Segoe UI"/>
               </a:rPr>
-              <a:t>What's new in 2.5.1</a:t>
+              <a:t>What's new in 2.6.0</a:t>
             </a:r>
           </a:p>
         </p:txBody>
@@ -8142,7 +8242,7 @@
                 </a:solidFill>
                 <a:latin typeface="Segoe UI"/>
               </a:rPr>
-              <a:t>New cute Pips logo  ·  2026-10-28</a:t>
+              <a:t>Profiles, ranks, online status &amp; dark mode  ·  2026-10-28</a:t>
             </a:r>
           </a:p>
         </p:txBody>
@@ -8190,7 +8290,157 @@
                 </a:solidFill>
                 <a:latin typeface="Segoe UI"/>
               </a:rPr>
-              <a:t>New Pips logo: Pip the cat on a Pips-red tile, matching the app colours (desktop shortcut, windows and website)</a:t>
+              <a:t>Profile tab: profile picture (or your pet), about me, job, location, hobbies, birthday and a status message</a:t>
+            </a:r>
+          </a:p>
+          <a:p>
+            <a:pPr>
+              <a:spcAft>
+                <a:spcPts val="1000"/>
+              </a:spcAft>
+            </a:pPr>
+            <a:r>
+              <a:rPr sz="1700" b="1">
+                <a:solidFill>
+                  <a:srgbClr val="4CB86B"/>
+                </a:solidFill>
+                <a:latin typeface="Segoe UI"/>
+              </a:rPr>
+              <a:t>•  </a:t>
+            </a:r>
+            <a:r>
+              <a:rPr sz="1700">
+                <a:solidFill>
+                  <a:srgbClr val="2B2A28"/>
+                </a:solidFill>
+                <a:latin typeface="Segoe UI"/>
+              </a:rPr>
+              <a:t>Public or private: public profiles can be added directly and viewed in full; private profiles need a friend request that they accept, and strangers only see name, photo, pet, level and status</a:t>
+            </a:r>
+          </a:p>
+          <a:p>
+            <a:pPr>
+              <a:spcAft>
+                <a:spcPts val="1000"/>
+              </a:spcAft>
+            </a:pPr>
+            <a:r>
+              <a:rPr sz="1700" b="1">
+                <a:solidFill>
+                  <a:srgbClr val="4CB86B"/>
+                </a:solidFill>
+                <a:latin typeface="Segoe UI"/>
+              </a:rPr>
+              <a:t>•  </a:t>
+            </a:r>
+            <a:r>
+              <a:rPr sz="1700">
+                <a:solidFill>
+                  <a:srgbClr val="2B2A28"/>
+                </a:solidFill>
+                <a:latin typeface="Segoe UI"/>
+              </a:rPr>
+              <a:t>Click anyone to open their profile - badges, info, their friends - and add them, chat or wave from there</a:t>
+            </a:r>
+          </a:p>
+          <a:p>
+            <a:pPr>
+              <a:spcAft>
+                <a:spcPts val="1000"/>
+              </a:spcAft>
+            </a:pPr>
+            <a:r>
+              <a:rPr sz="1700" b="1">
+                <a:solidFill>
+                  <a:srgbClr val="4CB86B"/>
+                </a:solidFill>
+                <a:latin typeface="Segoe UI"/>
+              </a:rPr>
+              <a:t>•  </a:t>
+            </a:r>
+            <a:r>
+              <a:rPr sz="1700">
+                <a:solidFill>
+                  <a:srgbClr val="2B2A28"/>
+                </a:solidFill>
+                <a:latin typeface="Segoe UI"/>
+              </a:rPr>
+              <a:t>Ranks tab replaces Teams: everyone using Pips, sorted by XP, badges or streak</a:t>
+            </a:r>
+          </a:p>
+          <a:p>
+            <a:pPr>
+              <a:spcAft>
+                <a:spcPts val="1000"/>
+              </a:spcAft>
+            </a:pPr>
+            <a:r>
+              <a:rPr sz="1700" b="1">
+                <a:solidFill>
+                  <a:srgbClr val="4CB86B"/>
+                </a:solidFill>
+                <a:latin typeface="Segoe UI"/>
+              </a:rPr>
+              <a:t>•  </a:t>
+            </a:r>
+            <a:r>
+              <a:rPr sz="1700">
+                <a:solidFill>
+                  <a:srgbClr val="2B2A28"/>
+                </a:solidFill>
+                <a:latin typeface="Segoe UI"/>
+              </a:rPr>
+              <a:t>Online status: auto (online / away when idle / offline) or set Online, Busy, Away or Appear offline yourself</a:t>
+            </a:r>
+          </a:p>
+          <a:p>
+            <a:pPr>
+              <a:spcAft>
+                <a:spcPts val="1000"/>
+              </a:spcAft>
+            </a:pPr>
+            <a:r>
+              <a:rPr sz="1700" b="1">
+                <a:solidFill>
+                  <a:srgbClr val="4CB86B"/>
+                </a:solidFill>
+                <a:latin typeface="Segoe UI"/>
+              </a:rPr>
+              <a:t>•  </a:t>
+            </a:r>
+            <a:r>
+              <a:rPr sz="1700">
+                <a:solidFill>
+                  <a:srgbClr val="2B2A28"/>
+                </a:solidFill>
+                <a:latin typeface="Segoe UI"/>
+              </a:rPr>
+              <a:t>Relationship labels for friends: Buddy, Bro, Sis, Bestie, Partner, Soulmate, Family, Work buddy</a:t>
+            </a:r>
+          </a:p>
+          <a:p>
+            <a:pPr>
+              <a:spcAft>
+                <a:spcPts val="1000"/>
+              </a:spcAft>
+            </a:pPr>
+            <a:r>
+              <a:rPr sz="1700" b="1">
+                <a:solidFill>
+                  <a:srgbClr val="4CB86B"/>
+                </a:solidFill>
+                <a:latin typeface="Segoe UI"/>
+              </a:rPr>
+              <a:t>•  </a:t>
+            </a:r>
+            <a:r>
+              <a:rPr sz="1700">
+                <a:solidFill>
+                  <a:srgbClr val="2B2A28"/>
+                </a:solidFill>
+                <a:latin typeface="Segoe UI"/>
+              </a:rPr>
+              <a:t>Dark mode: Profile tab or right-click the pet → Dark mode (hub, settings and the focus card)</a:t>
             </a:r>
           </a:p>
         </p:txBody>
@@ -8321,7 +8571,157 @@
                 </a:solidFill>
                 <a:latin typeface="Segoe UI"/>
               </a:rPr>
-              <a:t>Logo Pips baru: kucing Pip di ubin merah Pips, serasi dengan warna aplikasi (shortcut desktop, jendela dan situs web)</a:t>
+              <a:t>Tab Profil: foto profil (atau peliharaanmu), tentang aku, pekerjaan, lokasi, hobi, ulang tahun dan pesan status</a:t>
+            </a:r>
+          </a:p>
+          <a:p>
+            <a:pPr>
+              <a:spcAft>
+                <a:spcPts val="500"/>
+              </a:spcAft>
+            </a:pPr>
+            <a:r>
+              <a:rPr sz="1200" b="1">
+                <a:solidFill>
+                  <a:srgbClr val="4CB86B"/>
+                </a:solidFill>
+                <a:latin typeface="Segoe UI"/>
+              </a:rPr>
+              <a:t>•  </a:t>
+            </a:r>
+            <a:r>
+              <a:rPr sz="1200">
+                <a:solidFill>
+                  <a:srgbClr val="2B2A28"/>
+                </a:solidFill>
+                <a:latin typeface="Segoe UI"/>
+              </a:rPr>
+              <a:t>Publik atau pribadi: profil publik bisa langsung ditambahkan dan dilihat lengkap; profil pribadi perlu permintaan pertemanan yang diterima, dan orang asing hanya melihat nama, foto, peliharaan, level dan status</a:t>
+            </a:r>
+          </a:p>
+          <a:p>
+            <a:pPr>
+              <a:spcAft>
+                <a:spcPts val="500"/>
+              </a:spcAft>
+            </a:pPr>
+            <a:r>
+              <a:rPr sz="1200" b="1">
+                <a:solidFill>
+                  <a:srgbClr val="4CB86B"/>
+                </a:solidFill>
+                <a:latin typeface="Segoe UI"/>
+              </a:rPr>
+              <a:t>•  </a:t>
+            </a:r>
+            <a:r>
+              <a:rPr sz="1200">
+                <a:solidFill>
+                  <a:srgbClr val="2B2A28"/>
+                </a:solidFill>
+                <a:latin typeface="Segoe UI"/>
+              </a:rPr>
+              <a:t>Klik siapa saja untuk membuka profilnya - lencana, info, teman-temannya - lalu tambahkan, chat atau lambaikan dari sana</a:t>
+            </a:r>
+          </a:p>
+          <a:p>
+            <a:pPr>
+              <a:spcAft>
+                <a:spcPts val="500"/>
+              </a:spcAft>
+            </a:pPr>
+            <a:r>
+              <a:rPr sz="1200" b="1">
+                <a:solidFill>
+                  <a:srgbClr val="4CB86B"/>
+                </a:solidFill>
+                <a:latin typeface="Segoe UI"/>
+              </a:rPr>
+              <a:t>•  </a:t>
+            </a:r>
+            <a:r>
+              <a:rPr sz="1200">
+                <a:solidFill>
+                  <a:srgbClr val="2B2A28"/>
+                </a:solidFill>
+                <a:latin typeface="Segoe UI"/>
+              </a:rPr>
+              <a:t>Tab Peringkat menggantikan Tim: semua pengguna Pips, diurutkan menurut XP, lencana atau beruntun</a:t>
+            </a:r>
+          </a:p>
+          <a:p>
+            <a:pPr>
+              <a:spcAft>
+                <a:spcPts val="500"/>
+              </a:spcAft>
+            </a:pPr>
+            <a:r>
+              <a:rPr sz="1200" b="1">
+                <a:solidFill>
+                  <a:srgbClr val="4CB86B"/>
+                </a:solidFill>
+                <a:latin typeface="Segoe UI"/>
+              </a:rPr>
+              <a:t>•  </a:t>
+            </a:r>
+            <a:r>
+              <a:rPr sz="1200">
+                <a:solidFill>
+                  <a:srgbClr val="2B2A28"/>
+                </a:solidFill>
+                <a:latin typeface="Segoe UI"/>
+              </a:rPr>
+              <a:t>Status online: otomatis (online / pergi saat tidak aktif / offline) atau atur sendiri Online, Sibuk, Pergi atau tampak offline</a:t>
+            </a:r>
+          </a:p>
+          <a:p>
+            <a:pPr>
+              <a:spcAft>
+                <a:spcPts val="500"/>
+              </a:spcAft>
+            </a:pPr>
+            <a:r>
+              <a:rPr sz="1200" b="1">
+                <a:solidFill>
+                  <a:srgbClr val="4CB86B"/>
+                </a:solidFill>
+                <a:latin typeface="Segoe UI"/>
+              </a:rPr>
+              <a:t>•  </a:t>
+            </a:r>
+            <a:r>
+              <a:rPr sz="1200">
+                <a:solidFill>
+                  <a:srgbClr val="2B2A28"/>
+                </a:solidFill>
+                <a:latin typeface="Segoe UI"/>
+              </a:rPr>
+              <a:t>Label hubungan untuk teman: Sobat, Bro, Sis, Sahabat, Pasangan, Belahan jiwa, Keluarga, Rekan kerja</a:t>
+            </a:r>
+          </a:p>
+          <a:p>
+            <a:pPr>
+              <a:spcAft>
+                <a:spcPts val="500"/>
+              </a:spcAft>
+            </a:pPr>
+            <a:r>
+              <a:rPr sz="1200" b="1">
+                <a:solidFill>
+                  <a:srgbClr val="4CB86B"/>
+                </a:solidFill>
+                <a:latin typeface="Segoe UI"/>
+              </a:rPr>
+              <a:t>•  </a:t>
+            </a:r>
+            <a:r>
+              <a:rPr sz="1200">
+                <a:solidFill>
+                  <a:srgbClr val="2B2A28"/>
+                </a:solidFill>
+                <a:latin typeface="Segoe UI"/>
+              </a:rPr>
+              <a:t>Mode gelap: tab Profil atau klik kanan peliharaan → Mode gelap (hub, pengaturan dan kartu fokus)</a:t>
             </a:r>
           </a:p>
         </p:txBody>
@@ -8553,7 +8953,7 @@
         </p:nvGraphicFramePr>
         <p:xfrm>
           <a:off x="548640" y="1645920"/>
-          <a:ext cx="11155680" cy="9436608"/>
+          <a:ext cx="11155680" cy="10259568"/>
         </p:xfrm>
         <a:graphic>
           <a:graphicData uri="http://schemas.openxmlformats.org/drawingml/2006/table">
@@ -8647,7 +9047,7 @@
                           </a:solidFill>
                           <a:latin typeface="Segoe UI"/>
                         </a:rPr>
-                        <a:t>2.5.1</a:t>
+                        <a:t>2.6.0</a:t>
                       </a:r>
                     </a:p>
                   </a:txBody>
@@ -8691,7 +9091,7 @@
                           </a:solidFill>
                           <a:latin typeface="Segoe UI"/>
                         </a:rPr>
-                        <a:t>New cute Pips logo</a:t>
+                        <a:t>Profiles, ranks, online status &amp; dark mode</a:t>
                       </a:r>
                     </a:p>
                     <a:p>
@@ -8702,7 +9102,7 @@
                           </a:solidFill>
                           <a:latin typeface="Segoe UI"/>
                         </a:rPr>
-                        <a:t>New Pips logo: Pip the cat on a Pips-red tile, matching the app colours (desktop shortcut, windows and website)</a:t>
+                        <a:t>Profile tab: profile picture (or your pet), about me, job, location, hobbies, birthday and a status message; Public or private: public profiles can be added directly and viewed in full; private profiles need a friend request that they accept, and strangers only see name, photo, pet, level and status; Click anyone to open their profile - badges, info, their friends - and add them, chat or wave from there; Ranks tab replaces Teams: everyone using Pips, sorted by XP, badges or streak</a:t>
                       </a:r>
                     </a:p>
                   </a:txBody>
@@ -8726,7 +9126,7 @@
                           </a:solidFill>
                           <a:latin typeface="Segoe UI"/>
                         </a:rPr>
-                        <a:t>2.5.0</a:t>
+                        <a:t>2.5.1</a:t>
                       </a:r>
                     </a:p>
                   </a:txBody>
@@ -8770,7 +9170,7 @@
                           </a:solidFill>
                           <a:latin typeface="Segoe UI"/>
                         </a:rPr>
-                        <a:t>Shop, coins, props &amp; moves</a:t>
+                        <a:t>New cute Pips logo</a:t>
                       </a:r>
                     </a:p>
                     <a:p>
@@ -8781,7 +9181,7 @@
                           </a:solidFill>
                           <a:latin typeface="Segoe UI"/>
                         </a:rPr>
-                        <a:t>Shop: earn coins and spend them on your pet - 17 props (crown, wizard hat, headphones, shades, scarf, cape, angel wings...) and 6 moves: spin, dance, moonwalk, backflip, kung fu and spider swing!; Coins come from leveling up (+40), badges (+25), opening Pips each day (+10), friendships (+15 per affinity level), waving / chatting / visiting friends (+2) and pomodoros (+5). Everyone starts with a 100-coin gift; Your friends see your props: on avatars in the hub and when your pet visits their desktop - it shows off one of your moves; Pips is now a social pet: clicking the pet opens the Pips hub (friends, chat, groups, shop, badges)</a:t>
+                        <a:t>New Pips logo: Pip the cat on a Pips-red tile, matching the app colours (desktop shortcut, windows and website)</a:t>
                       </a:r>
                     </a:p>
                   </a:txBody>
@@ -8805,7 +9205,7 @@
                           </a:solidFill>
                           <a:latin typeface="Segoe UI"/>
                         </a:rPr>
-                        <a:t>2.4.0</a:t>
+                        <a:t>2.5.0</a:t>
                       </a:r>
                     </a:p>
                   </a:txBody>
@@ -8849,7 +9249,7 @@
                           </a:solidFill>
                           <a:latin typeface="Segoe UI"/>
                         </a:rPr>
-                        <a:t>Chat, groups, affinity &amp; pet visits</a:t>
+                        <a:t>Shop, coins, props &amp; moves</a:t>
                       </a:r>
                     </a:p>
                     <a:p>
@@ -8860,7 +9260,7 @@
                           </a:solidFill>
                           <a:latin typeface="Segoe UI"/>
                         </a:rPr>
-                        <a:t>Chat: message your friends, and chat inside groups. Your pet pops up new messages as a bubble - click it to reply; Pet interactions: wave, pet their pet, send a snack, high five - or send your pet to visit: it walks onto your friend's desktop for a little while!; Affinity: every chat and interaction grows your friendship - Acquaintance → Buddy → Good friends → Close friends → Best friends → Soulmates; Your own groups: create a private group, invite your friends, they accept or decline. Group board + group chat; the owner can remove members</a:t>
+                        <a:t>Shop: earn coins and spend them on your pet - 17 props (crown, wizard hat, headphones, shades, scarf, cape, angel wings...) and 6 moves: spin, dance, moonwalk, backflip, kung fu and spider swing!; Coins come from leveling up (+40), badges (+25), opening Pips each day (+10), friendships (+15 per affinity level), waving / chatting / visiting friends (+2) and pomodoros (+5). Everyone starts with a 100-coin gift; Your friends see your props: on avatars in the hub and when your pet visits their desktop - it shows off one of your moves; Pips is now a social pet: clicking the pet opens the Pips hub (friends, chat, groups, shop, badges)</a:t>
                       </a:r>
                     </a:p>
                   </a:txBody>
@@ -8884,7 +9284,7 @@
                           </a:solidFill>
                           <a:latin typeface="Segoe UI"/>
                         </a:rPr>
-                        <a:t>2.3.0</a:t>
+                        <a:t>2.4.0</a:t>
                       </a:r>
                     </a:p>
                   </a:txBody>
@@ -8928,7 +9328,7 @@
                           </a:solidFill>
                           <a:latin typeface="Segoe UI"/>
                         </a:rPr>
-                        <a:t>Friends, levels &amp; achievements</a:t>
+                        <a:t>Chat, groups, affinity &amp; pet visits</a:t>
                       </a:r>
                     </a:p>
                     <a:p>
@@ -8939,7 +9339,7 @@
                           </a:solidFill>
                           <a:latin typeface="Segoe UI"/>
                         </a:rPr>
-                        <a:t>Levels &amp; XP: every finished pomodoro earns XP and your level grows - plus 20 achievements to unlock (first tomato, 8 in a day, 7-day streak, early bird, night owl, pet lover...). Your pet celebrates each one; Friends (optional, off by default): get a 6-letter friend code, add colleagues, see today's board and join a team board like PTB. Your pet tells you when a friend finishes a pomodoro; Privacy: only your name, pet, level, streak and pomodoro counts are shared - never apps, window titles or scores. One click turns it off and deletes your online data. Right-click the pet → Friends &amp; achievements…</a:t>
+                        <a:t>Chat: message your friends, and chat inside groups. Your pet pops up new messages as a bubble - click it to reply; Pet interactions: wave, pet their pet, send a snack, high five - or send your pet to visit: it walks onto your friend's desktop for a little while!; Affinity: every chat and interaction grows your friendship - Acquaintance → Buddy → Good friends → Close friends → Best friends → Soulmates; Your own groups: create a private group, invite your friends, they accept or decline. Group board + group chat; the owner can remove members</a:t>
                       </a:r>
                     </a:p>
                   </a:txBody>
@@ -8963,7 +9363,7 @@
                           </a:solidFill>
                           <a:latin typeface="Segoe UI"/>
                         </a:rPr>
-                        <a:t>2.2.0</a:t>
+                        <a:t>2.3.0</a:t>
                       </a:r>
                     </a:p>
                   </a:txBody>
@@ -9007,7 +9407,7 @@
                           </a:solidFill>
                           <a:latin typeface="Segoe UI"/>
                         </a:rPr>
-                        <a:t>Pet sounds</a:t>
+                        <a:t>Friends, levels &amp; achievements</a:t>
                       </a:r>
                     </a:p>
                     <a:p>
@@ -9018,7 +9418,7 @@
                           </a:solidFill>
                           <a:latin typeface="Segoe UI"/>
                         </a:rPr>
-                        <a:t>Your pet has a voice! Each of the 23 animals has its own sound (meow, woof, ribbit, hoot, buzz, oink, whale song...) and it changes with its mood: happy chirps, sad whimpers, sleepy yawns, hungry calls, grumpy huffs and soft snores; It also reacts with sound when you tickle, pet, feed, shake or wake it; Settings: right-click the pet → Sounds to switch on/off; Pet status &amp; settings has a volume slider, a ▶ Hear me button and "Stay quiet while I'm focusing" (on by default)</a:t>
+                        <a:t>Levels &amp; XP: every finished pomodoro earns XP and your level grows - plus 20 achievements to unlock (first tomato, 8 in a day, 7-day streak, early bird, night owl, pet lover...). Your pet celebrates each one; Friends (optional, off by default): get a 6-letter friend code, add colleagues, see today's board and join a team board like PTB. Your pet tells you when a friend finishes a pomodoro; Privacy: only your name, pet, level, streak and pomodoro counts are shared - never apps, window titles or scores. One click turns it off and deletes your online data. Right-click the pet → Friends &amp; achievements…</a:t>
                       </a:r>
                     </a:p>
                   </a:txBody>
@@ -9042,7 +9442,7 @@
                           </a:solidFill>
                           <a:latin typeface="Segoe UI"/>
                         </a:rPr>
-                        <a:t>2.1.2</a:t>
+                        <a:t>2.2.0</a:t>
                       </a:r>
                     </a:p>
                   </a:txBody>
@@ -9086,7 +9486,7 @@
                           </a:solidFill>
                           <a:latin typeface="Segoe UI"/>
                         </a:rPr>
-                        <a:t>Tickle-only mode</a:t>
+                        <a:t>Pet sounds</a:t>
                       </a:r>
                     </a:p>
                     <a:p>
@@ -9097,7 +9497,7 @@
                           </a:solidFill>
                           <a:latin typeface="Segoe UI"/>
                         </a:rPr>
-                        <a:t>New click option "Only tickle (never open Pips)": click and tickle your pet as much as you like - the Pomodoro window stays closed (open it from the right-click menu). Right-click the pet → When I click</a:t>
+                        <a:t>Your pet has a voice! Each of the 23 animals has its own sound (meow, woof, ribbit, hoot, buzz, oink, whale song...) and it changes with its mood: happy chirps, sad whimpers, sleepy yawns, hungry calls, grumpy huffs and soft snores; It also reacts with sound when you tickle, pet, feed, shake or wake it; Settings: right-click the pet → Sounds to switch on/off; Pet status &amp; settings has a volume slider, a ▶ Hear me button and "Stay quiet while I'm focusing" (on by default)</a:t>
                       </a:r>
                     </a:p>
                   </a:txBody>
@@ -9121,7 +9521,7 @@
                           </a:solidFill>
                           <a:latin typeface="Segoe UI"/>
                         </a:rPr>
-                        <a:t>2.1.1</a:t>
+                        <a:t>2.1.2</a:t>
                       </a:r>
                     </a:p>
                   </a:txBody>
@@ -9165,7 +9565,7 @@
                           </a:solidFill>
                           <a:latin typeface="Segoe UI"/>
                         </a:rPr>
-                        <a:t>Owner info</a:t>
+                        <a:t>Tickle-only mode</a:t>
                       </a:r>
                     </a:p>
                     <a:p>
@@ -9176,7 +9576,7 @@
                           </a:solidFill>
                           <a:latin typeface="Segoe UI"/>
                         </a:rPr>
-                        <a:t>About Pips now shows the owner: Juwen Lie (right-click the pet → Help → About)</a:t>
+                        <a:t>New click option "Only tickle (never open Pips)": click and tickle your pet as much as you like - the Pomodoro window stays closed (open it from the right-click menu). Right-click the pet → When I click</a:t>
                       </a:r>
                     </a:p>
                   </a:txBody>
@@ -9200,7 +9600,7 @@
                           </a:solidFill>
                           <a:latin typeface="Segoe UI"/>
                         </a:rPr>
-                        <a:t>2.1.0</a:t>
+                        <a:t>2.1.1</a:t>
                       </a:r>
                     </a:p>
                   </a:txBody>
@@ -9244,7 +9644,7 @@
                           </a:solidFill>
                           <a:latin typeface="Segoe UI"/>
                         </a:rPr>
-                        <a:t>Interactive guide &amp; in-app updates</a:t>
+                        <a:t>Owner info</a:t>
                       </a:r>
                     </a:p>
                     <a:p>
@@ -9255,7 +9655,7 @@
                           </a:solidFill>
                           <a:latin typeface="Segoe UI"/>
                         </a:rPr>
-                        <a:t>Interactive first-run guide: your pet walks you through clicking, dragging, petting and the right-click menu; In-app updates: Pips tells you when a new version is out - update with one click (your settings and data are kept); New Help menu: replay the guide, check for updates, see the version; Option to turn automatic update checks off</a:t>
+                        <a:t>About Pips now shows the owner: Juwen Lie (right-click the pet → Help → About)</a:t>
                       </a:r>
                     </a:p>
                   </a:txBody>
@@ -9279,7 +9679,7 @@
                           </a:solidFill>
                           <a:latin typeface="Segoe UI"/>
                         </a:rPr>
-                        <a:t>2.0.0</a:t>
+                        <a:t>2.1.0</a:t>
                       </a:r>
                     </a:p>
                   </a:txBody>
@@ -9323,7 +9723,7 @@
                           </a:solidFill>
                           <a:latin typeface="Segoe UI"/>
                         </a:rPr>
-                        <a:t>Desktop pet, 23 animals &amp; 4 languages</a:t>
+                        <a:t>Interactive guide &amp; in-app updates</a:t>
                       </a:r>
                     </a:p>
                     <a:p>
@@ -9334,7 +9734,7 @@
                           </a:solidFill>
                           <a:latin typeface="Segoe UI"/>
                         </a:rPr>
-                        <a:t>Desktop pet that lives on your desktop and taskbar - drag it, tickle it, pet it; 23 animals in 3 groups: Land walks, Water swims with bubbles, Sky hovers and flaps; Moods (happy, sad, tired, hungry, grumpy...), naps when you're away, wakes up when you're back; Cute chat-bubble reminders: breaks, water, 20-20-20 eye rest, pomodoro done, daily goal</a:t>
+                        <a:t>Interactive first-run guide: your pet walks you through clicking, dragging, petting and the right-click menu; In-app updates: Pips tells you when a new version is out - update with one click (your settings and data are kept); New Help menu: replay the guide, check for updates, see the version; Option to turn automatic update checks off</a:t>
                       </a:r>
                     </a:p>
                   </a:txBody>
@@ -9358,7 +9758,7 @@
                           </a:solidFill>
                           <a:latin typeface="Segoe UI"/>
                         </a:rPr>
-                        <a:t>1.5.0</a:t>
+                        <a:t>2.0.0</a:t>
                       </a:r>
                     </a:p>
                   </a:txBody>
@@ -9380,13 +9780,92 @@
                           </a:solidFill>
                           <a:latin typeface="Segoe UI"/>
                         </a:rPr>
+                        <a:t>2026-10-28</a:t>
+                      </a:r>
+                    </a:p>
+                  </a:txBody>
+                  <a:tcPr marL="73152" marR="73152" marT="36576" marB="36576">
+                    <a:solidFill>
+                      <a:srgbClr val="F7F4EC"/>
+                    </a:solidFill>
+                  </a:tcPr>
+                </a:tc>
+                <a:tc>
+                  <a:txBody>
+                    <a:bodyPr wrap="square"/>
+                    <a:lstStyle/>
+                    <a:p>
+                      <a:r>
+                        <a:rPr sz="1200" b="0">
+                          <a:solidFill>
+                            <a:srgbClr val="2B2A28"/>
+                          </a:solidFill>
+                          <a:latin typeface="Segoe UI"/>
+                        </a:rPr>
+                        <a:t>Desktop pet, 23 animals &amp; 4 languages</a:t>
+                      </a:r>
+                    </a:p>
+                    <a:p>
+                      <a:r>
+                        <a:rPr sz="1200" b="0">
+                          <a:solidFill>
+                            <a:srgbClr val="2B2A28"/>
+                          </a:solidFill>
+                          <a:latin typeface="Segoe UI"/>
+                        </a:rPr>
+                        <a:t>Desktop pet that lives on your desktop and taskbar - drag it, tickle it, pet it; 23 animals in 3 groups: Land walks, Water swims with bubbles, Sky hovers and flaps; Moods (happy, sad, tired, hungry, grumpy...), naps when you're away, wakes up when you're back; Cute chat-bubble reminders: breaks, water, 20-20-20 eye rest, pomodoro done, daily goal</a:t>
+                      </a:r>
+                    </a:p>
+                  </a:txBody>
+                  <a:tcPr marL="73152" marR="73152" marT="36576" marB="36576">
+                    <a:solidFill>
+                      <a:srgbClr val="F7F4EC"/>
+                    </a:solidFill>
+                  </a:tcPr>
+                </a:tc>
+              </a:tr>
+              <a:tr h="822960">
+                <a:tc>
+                  <a:txBody>
+                    <a:bodyPr wrap="square"/>
+                    <a:lstStyle/>
+                    <a:p>
+                      <a:r>
+                        <a:rPr sz="1200" b="1">
+                          <a:solidFill>
+                            <a:srgbClr val="2B2A28"/>
+                          </a:solidFill>
+                          <a:latin typeface="Segoe UI"/>
+                        </a:rPr>
+                        <a:t>1.5.0</a:t>
+                      </a:r>
+                    </a:p>
+                  </a:txBody>
+                  <a:tcPr marL="73152" marR="73152" marT="36576" marB="36576">
+                    <a:solidFill>
+                      <a:srgbClr val="FFFDF8"/>
+                    </a:solidFill>
+                  </a:tcPr>
+                </a:tc>
+                <a:tc>
+                  <a:txBody>
+                    <a:bodyPr wrap="square"/>
+                    <a:lstStyle/>
+                    <a:p>
+                      <a:r>
+                        <a:rPr sz="1200" b="0">
+                          <a:solidFill>
+                            <a:srgbClr val="2B2A28"/>
+                          </a:solidFill>
+                          <a:latin typeface="Segoe UI"/>
+                        </a:rPr>
                         <a:t>2026-10-24</a:t>
                       </a:r>
                     </a:p>
                   </a:txBody>
                   <a:tcPr marL="73152" marR="73152" marT="36576" marB="36576">
                     <a:solidFill>
-                      <a:srgbClr val="F7F4EC"/>
+                      <a:srgbClr val="FFFDF8"/>
                     </a:solidFill>
                   </a:tcPr>
                 </a:tc>
@@ -9419,7 +9898,7 @@
                   </a:txBody>
                   <a:tcPr marL="73152" marR="73152" marT="36576" marB="36576">
                     <a:solidFill>
-                      <a:srgbClr val="F7F4EC"/>
+                      <a:srgbClr val="FFFDF8"/>
                     </a:solidFill>
                   </a:tcPr>
                 </a:tc>
@@ -9443,7 +9922,7 @@
                   </a:txBody>
                   <a:tcPr marL="73152" marR="73152" marT="36576" marB="36576">
                     <a:solidFill>
-                      <a:srgbClr val="FFFDF8"/>
+                      <a:srgbClr val="F7F4EC"/>
                     </a:solidFill>
                   </a:tcPr>
                 </a:tc>
@@ -9465,7 +9944,7 @@
                   </a:txBody>
                   <a:tcPr marL="73152" marR="73152" marT="36576" marB="36576">
                     <a:solidFill>
-                      <a:srgbClr val="FFFDF8"/>
+                      <a:srgbClr val="F7F4EC"/>
                     </a:solidFill>
                   </a:tcPr>
                 </a:tc>
@@ -9498,7 +9977,7 @@
                   </a:txBody>
                   <a:tcPr marL="73152" marR="73152" marT="36576" marB="36576">
                     <a:solidFill>
-                      <a:srgbClr val="FFFDF8"/>
+                      <a:srgbClr val="F7F4EC"/>
                     </a:solidFill>
                   </a:tcPr>
                 </a:tc>

</xml_diff>

<commit_message>
pips 2.6.1: Owner badge & credits
</commit_message>
<xml_diff>
--- a/apps/pips/web/download/Pips-Guide.pptx
+++ b/apps/pips/web/download/Pips-Guide.pptx
@@ -3292,7 +3292,19 @@
                 </a:solidFill>
                 <a:latin typeface="Segoe UI"/>
               </a:rPr>
-              <a:t>Version 2.6.0  ·  2026-10-28  ·  Owner: Juwen Lie</a:t>
+              <a:t>Version 2.6.1  ·  2026-10-28  ·  Made by Juwen Lie (owner)</a:t>
+            </a:r>
+          </a:p>
+          <a:p>
+            <a:pPr algn="l"/>
+            <a:r>
+              <a:rPr sz="1500" b="0">
+                <a:solidFill>
+                  <a:srgbClr val="6E6A62"/>
+                </a:solidFill>
+                <a:latin typeface="Segoe UI"/>
+              </a:rPr>
+              <a:t>Contact: Juwen_Lie@pegatroncorp.com</a:t>
             </a:r>
           </a:p>
           <a:p>
@@ -8129,7 +8141,7 @@
                 </a:solidFill>
                 <a:latin typeface="Segoe UI"/>
               </a:rPr>
-              <a:t>What's new in 2.6.0</a:t>
+              <a:t>What's new in 2.6.1</a:t>
             </a:r>
           </a:p>
         </p:txBody>
@@ -8242,7 +8254,7 @@
                 </a:solidFill>
                 <a:latin typeface="Segoe UI"/>
               </a:rPr>
-              <a:t>Profiles, ranks, online status &amp; dark mode  ·  2026-10-28</a:t>
+              <a:t>Owner badge &amp; credits  ·  2026-10-28</a:t>
             </a:r>
           </a:p>
         </p:txBody>
@@ -8290,7 +8302,7 @@
                 </a:solidFill>
                 <a:latin typeface="Segoe UI"/>
               </a:rPr>
-              <a:t>Profile tab: profile picture (or your pet), about me, job, location, hobbies, birthday and a status message</a:t>
+              <a:t>The creator of Pips (Juwen Lie) now shows a gold ♛ Owner badge on his profile, friend list and ranks</a:t>
             </a:r>
           </a:p>
           <a:p>
@@ -8315,7 +8327,7 @@
                 </a:solidFill>
                 <a:latin typeface="Segoe UI"/>
               </a:rPr>
-              <a:t>Public or private: public profiles can be added directly and viewed in full; private profiles need a friend request that they accept, and strangers only see name, photo, pet, level and status</a:t>
+              <a:t>New About Pips card in the Profile tab: credits and how to contact the owner (Juwen_Lie@pegatroncorp.com) with Email and Copy buttons</a:t>
             </a:r>
           </a:p>
           <a:p>
@@ -8340,107 +8352,7 @@
                 </a:solidFill>
                 <a:latin typeface="Segoe UI"/>
               </a:rPr>
-              <a:t>Click anyone to open their profile - badges, info, their friends - and add them, chat or wave from there</a:t>
-            </a:r>
-          </a:p>
-          <a:p>
-            <a:pPr>
-              <a:spcAft>
-                <a:spcPts val="1000"/>
-              </a:spcAft>
-            </a:pPr>
-            <a:r>
-              <a:rPr sz="1700" b="1">
-                <a:solidFill>
-                  <a:srgbClr val="4CB86B"/>
-                </a:solidFill>
-                <a:latin typeface="Segoe UI"/>
-              </a:rPr>
-              <a:t>•  </a:t>
-            </a:r>
-            <a:r>
-              <a:rPr sz="1700">
-                <a:solidFill>
-                  <a:srgbClr val="2B2A28"/>
-                </a:solidFill>
-                <a:latin typeface="Segoe UI"/>
-              </a:rPr>
-              <a:t>Ranks tab replaces Teams: everyone using Pips, sorted by XP, badges or streak</a:t>
-            </a:r>
-          </a:p>
-          <a:p>
-            <a:pPr>
-              <a:spcAft>
-                <a:spcPts val="1000"/>
-              </a:spcAft>
-            </a:pPr>
-            <a:r>
-              <a:rPr sz="1700" b="1">
-                <a:solidFill>
-                  <a:srgbClr val="4CB86B"/>
-                </a:solidFill>
-                <a:latin typeface="Segoe UI"/>
-              </a:rPr>
-              <a:t>•  </a:t>
-            </a:r>
-            <a:r>
-              <a:rPr sz="1700">
-                <a:solidFill>
-                  <a:srgbClr val="2B2A28"/>
-                </a:solidFill>
-                <a:latin typeface="Segoe UI"/>
-              </a:rPr>
-              <a:t>Online status: auto (online / away when idle / offline) or set Online, Busy, Away or Appear offline yourself</a:t>
-            </a:r>
-          </a:p>
-          <a:p>
-            <a:pPr>
-              <a:spcAft>
-                <a:spcPts val="1000"/>
-              </a:spcAft>
-            </a:pPr>
-            <a:r>
-              <a:rPr sz="1700" b="1">
-                <a:solidFill>
-                  <a:srgbClr val="4CB86B"/>
-                </a:solidFill>
-                <a:latin typeface="Segoe UI"/>
-              </a:rPr>
-              <a:t>•  </a:t>
-            </a:r>
-            <a:r>
-              <a:rPr sz="1700">
-                <a:solidFill>
-                  <a:srgbClr val="2B2A28"/>
-                </a:solidFill>
-                <a:latin typeface="Segoe UI"/>
-              </a:rPr>
-              <a:t>Relationship labels for friends: Buddy, Bro, Sis, Bestie, Partner, Soulmate, Family, Work buddy</a:t>
-            </a:r>
-          </a:p>
-          <a:p>
-            <a:pPr>
-              <a:spcAft>
-                <a:spcPts val="1000"/>
-              </a:spcAft>
-            </a:pPr>
-            <a:r>
-              <a:rPr sz="1700" b="1">
-                <a:solidFill>
-                  <a:srgbClr val="4CB86B"/>
-                </a:solidFill>
-                <a:latin typeface="Segoe UI"/>
-              </a:rPr>
-              <a:t>•  </a:t>
-            </a:r>
-            <a:r>
-              <a:rPr sz="1700">
-                <a:solidFill>
-                  <a:srgbClr val="2B2A28"/>
-                </a:solidFill>
-                <a:latin typeface="Segoe UI"/>
-              </a:rPr>
-              <a:t>Dark mode: Profile tab or right-click the pet → Dark mode (hub, settings and the focus card)</a:t>
+              <a:t>Right-click the pet → Help → About now shows who made Pips and the contact email</a:t>
             </a:r>
           </a:p>
         </p:txBody>
@@ -8571,7 +8483,7 @@
                 </a:solidFill>
                 <a:latin typeface="Segoe UI"/>
               </a:rPr>
-              <a:t>Tab Profil: foto profil (atau peliharaanmu), tentang aku, pekerjaan, lokasi, hobi, ulang tahun dan pesan status</a:t>
+              <a:t>Pembuat Pips (Juwen Lie) sekarang memiliki lencana emas ♛ Pemilik di profil, daftar teman dan peringkat</a:t>
             </a:r>
           </a:p>
           <a:p>
@@ -8596,7 +8508,7 @@
                 </a:solidFill>
                 <a:latin typeface="Segoe UI"/>
               </a:rPr>
-              <a:t>Publik atau pribadi: profil publik bisa langsung ditambahkan dan dilihat lengkap; profil pribadi perlu permintaan pertemanan yang diterima, dan orang asing hanya melihat nama, foto, peliharaan, level dan status</a:t>
+              <a:t>Kartu Tentang Pips baru di tab Profil: kredit dan cara menghubungi pemilik (Juwen_Lie@pegatroncorp.com) dengan tombol Email dan Salin</a:t>
             </a:r>
           </a:p>
           <a:p>
@@ -8621,107 +8533,7 @@
                 </a:solidFill>
                 <a:latin typeface="Segoe UI"/>
               </a:rPr>
-              <a:t>Klik siapa saja untuk membuka profilnya - lencana, info, teman-temannya - lalu tambahkan, chat atau lambaikan dari sana</a:t>
-            </a:r>
-          </a:p>
-          <a:p>
-            <a:pPr>
-              <a:spcAft>
-                <a:spcPts val="500"/>
-              </a:spcAft>
-            </a:pPr>
-            <a:r>
-              <a:rPr sz="1200" b="1">
-                <a:solidFill>
-                  <a:srgbClr val="4CB86B"/>
-                </a:solidFill>
-                <a:latin typeface="Segoe UI"/>
-              </a:rPr>
-              <a:t>•  </a:t>
-            </a:r>
-            <a:r>
-              <a:rPr sz="1200">
-                <a:solidFill>
-                  <a:srgbClr val="2B2A28"/>
-                </a:solidFill>
-                <a:latin typeface="Segoe UI"/>
-              </a:rPr>
-              <a:t>Tab Peringkat menggantikan Tim: semua pengguna Pips, diurutkan menurut XP, lencana atau beruntun</a:t>
-            </a:r>
-          </a:p>
-          <a:p>
-            <a:pPr>
-              <a:spcAft>
-                <a:spcPts val="500"/>
-              </a:spcAft>
-            </a:pPr>
-            <a:r>
-              <a:rPr sz="1200" b="1">
-                <a:solidFill>
-                  <a:srgbClr val="4CB86B"/>
-                </a:solidFill>
-                <a:latin typeface="Segoe UI"/>
-              </a:rPr>
-              <a:t>•  </a:t>
-            </a:r>
-            <a:r>
-              <a:rPr sz="1200">
-                <a:solidFill>
-                  <a:srgbClr val="2B2A28"/>
-                </a:solidFill>
-                <a:latin typeface="Segoe UI"/>
-              </a:rPr>
-              <a:t>Status online: otomatis (online / pergi saat tidak aktif / offline) atau atur sendiri Online, Sibuk, Pergi atau tampak offline</a:t>
-            </a:r>
-          </a:p>
-          <a:p>
-            <a:pPr>
-              <a:spcAft>
-                <a:spcPts val="500"/>
-              </a:spcAft>
-            </a:pPr>
-            <a:r>
-              <a:rPr sz="1200" b="1">
-                <a:solidFill>
-                  <a:srgbClr val="4CB86B"/>
-                </a:solidFill>
-                <a:latin typeface="Segoe UI"/>
-              </a:rPr>
-              <a:t>•  </a:t>
-            </a:r>
-            <a:r>
-              <a:rPr sz="1200">
-                <a:solidFill>
-                  <a:srgbClr val="2B2A28"/>
-                </a:solidFill>
-                <a:latin typeface="Segoe UI"/>
-              </a:rPr>
-              <a:t>Label hubungan untuk teman: Sobat, Bro, Sis, Sahabat, Pasangan, Belahan jiwa, Keluarga, Rekan kerja</a:t>
-            </a:r>
-          </a:p>
-          <a:p>
-            <a:pPr>
-              <a:spcAft>
-                <a:spcPts val="500"/>
-              </a:spcAft>
-            </a:pPr>
-            <a:r>
-              <a:rPr sz="1200" b="1">
-                <a:solidFill>
-                  <a:srgbClr val="4CB86B"/>
-                </a:solidFill>
-                <a:latin typeface="Segoe UI"/>
-              </a:rPr>
-              <a:t>•  </a:t>
-            </a:r>
-            <a:r>
-              <a:rPr sz="1200">
-                <a:solidFill>
-                  <a:srgbClr val="2B2A28"/>
-                </a:solidFill>
-                <a:latin typeface="Segoe UI"/>
-              </a:rPr>
-              <a:t>Mode gelap: tab Profil atau klik kanan peliharaan → Mode gelap (hub, pengaturan dan kartu fokus)</a:t>
+              <a:t>Klik kanan peliharaan → Bantuan → Tentang sekarang menampilkan pembuat Pips dan email kontak</a:t>
             </a:r>
           </a:p>
         </p:txBody>
@@ -8953,7 +8765,7 @@
         </p:nvGraphicFramePr>
         <p:xfrm>
           <a:off x="548640" y="1645920"/>
-          <a:ext cx="11155680" cy="10259568"/>
+          <a:ext cx="11155680" cy="11082528"/>
         </p:xfrm>
         <a:graphic>
           <a:graphicData uri="http://schemas.openxmlformats.org/drawingml/2006/table">
@@ -9047,7 +8859,7 @@
                           </a:solidFill>
                           <a:latin typeface="Segoe UI"/>
                         </a:rPr>
-                        <a:t>2.6.0</a:t>
+                        <a:t>2.6.1</a:t>
                       </a:r>
                     </a:p>
                   </a:txBody>
@@ -9091,7 +8903,7 @@
                           </a:solidFill>
                           <a:latin typeface="Segoe UI"/>
                         </a:rPr>
-                        <a:t>Profiles, ranks, online status &amp; dark mode</a:t>
+                        <a:t>Owner badge &amp; credits</a:t>
                       </a:r>
                     </a:p>
                     <a:p>
@@ -9102,7 +8914,7 @@
                           </a:solidFill>
                           <a:latin typeface="Segoe UI"/>
                         </a:rPr>
-                        <a:t>Profile tab: profile picture (or your pet), about me, job, location, hobbies, birthday and a status message; Public or private: public profiles can be added directly and viewed in full; private profiles need a friend request that they accept, and strangers only see name, photo, pet, level and status; Click anyone to open their profile - badges, info, their friends - and add them, chat or wave from there; Ranks tab replaces Teams: everyone using Pips, sorted by XP, badges or streak</a:t>
+                        <a:t>The creator of Pips (Juwen Lie) now shows a gold ♛ Owner badge on his profile, friend list and ranks; New About Pips card in the Profile tab: credits and how to contact the owner (Juwen_Lie@pegatroncorp.com) with Email and Copy buttons; Right-click the pet → Help → About now shows who made Pips and the contact email</a:t>
                       </a:r>
                     </a:p>
                   </a:txBody>
@@ -9126,7 +8938,7 @@
                           </a:solidFill>
                           <a:latin typeface="Segoe UI"/>
                         </a:rPr>
-                        <a:t>2.5.1</a:t>
+                        <a:t>2.6.0</a:t>
                       </a:r>
                     </a:p>
                   </a:txBody>
@@ -9170,7 +8982,7 @@
                           </a:solidFill>
                           <a:latin typeface="Segoe UI"/>
                         </a:rPr>
-                        <a:t>New cute Pips logo</a:t>
+                        <a:t>Profiles, ranks, online status &amp; dark mode</a:t>
                       </a:r>
                     </a:p>
                     <a:p>
@@ -9181,7 +8993,7 @@
                           </a:solidFill>
                           <a:latin typeface="Segoe UI"/>
                         </a:rPr>
-                        <a:t>New Pips logo: Pip the cat on a Pips-red tile, matching the app colours (desktop shortcut, windows and website)</a:t>
+                        <a:t>Profile tab: profile picture (or your pet), about me, job, location, hobbies, birthday and a status message; Public or private: public profiles can be added directly and viewed in full; private profiles need a friend request that they accept, and strangers only see name, photo, pet, level and status; Click anyone to open their profile - badges, info, their friends - and add them, chat or wave from there; Ranks tab replaces Teams: everyone using Pips, sorted by XP, badges or streak</a:t>
                       </a:r>
                     </a:p>
                   </a:txBody>
@@ -9205,7 +9017,7 @@
                           </a:solidFill>
                           <a:latin typeface="Segoe UI"/>
                         </a:rPr>
-                        <a:t>2.5.0</a:t>
+                        <a:t>2.5.1</a:t>
                       </a:r>
                     </a:p>
                   </a:txBody>
@@ -9249,7 +9061,7 @@
                           </a:solidFill>
                           <a:latin typeface="Segoe UI"/>
                         </a:rPr>
-                        <a:t>Shop, coins, props &amp; moves</a:t>
+                        <a:t>New cute Pips logo</a:t>
                       </a:r>
                     </a:p>
                     <a:p>
@@ -9260,7 +9072,7 @@
                           </a:solidFill>
                           <a:latin typeface="Segoe UI"/>
                         </a:rPr>
-                        <a:t>Shop: earn coins and spend them on your pet - 17 props (crown, wizard hat, headphones, shades, scarf, cape, angel wings...) and 6 moves: spin, dance, moonwalk, backflip, kung fu and spider swing!; Coins come from leveling up (+40), badges (+25), opening Pips each day (+10), friendships (+15 per affinity level), waving / chatting / visiting friends (+2) and pomodoros (+5). Everyone starts with a 100-coin gift; Your friends see your props: on avatars in the hub and when your pet visits their desktop - it shows off one of your moves; Pips is now a social pet: clicking the pet opens the Pips hub (friends, chat, groups, shop, badges)</a:t>
+                        <a:t>New Pips logo: Pip the cat on a Pips-red tile, matching the app colours (desktop shortcut, windows and website)</a:t>
                       </a:r>
                     </a:p>
                   </a:txBody>
@@ -9284,7 +9096,7 @@
                           </a:solidFill>
                           <a:latin typeface="Segoe UI"/>
                         </a:rPr>
-                        <a:t>2.4.0</a:t>
+                        <a:t>2.5.0</a:t>
                       </a:r>
                     </a:p>
                   </a:txBody>
@@ -9328,7 +9140,7 @@
                           </a:solidFill>
                           <a:latin typeface="Segoe UI"/>
                         </a:rPr>
-                        <a:t>Chat, groups, affinity &amp; pet visits</a:t>
+                        <a:t>Shop, coins, props &amp; moves</a:t>
                       </a:r>
                     </a:p>
                     <a:p>
@@ -9339,7 +9151,7 @@
                           </a:solidFill>
                           <a:latin typeface="Segoe UI"/>
                         </a:rPr>
-                        <a:t>Chat: message your friends, and chat inside groups. Your pet pops up new messages as a bubble - click it to reply; Pet interactions: wave, pet their pet, send a snack, high five - or send your pet to visit: it walks onto your friend's desktop for a little while!; Affinity: every chat and interaction grows your friendship - Acquaintance → Buddy → Good friends → Close friends → Best friends → Soulmates; Your own groups: create a private group, invite your friends, they accept or decline. Group board + group chat; the owner can remove members</a:t>
+                        <a:t>Shop: earn coins and spend them on your pet - 17 props (crown, wizard hat, headphones, shades, scarf, cape, angel wings...) and 6 moves: spin, dance, moonwalk, backflip, kung fu and spider swing!; Coins come from leveling up (+40), badges (+25), opening Pips each day (+10), friendships (+15 per affinity level), waving / chatting / visiting friends (+2) and pomodoros (+5). Everyone starts with a 100-coin gift; Your friends see your props: on avatars in the hub and when your pet visits their desktop - it shows off one of your moves; Pips is now a social pet: clicking the pet opens the Pips hub (friends, chat, groups, shop, badges)</a:t>
                       </a:r>
                     </a:p>
                   </a:txBody>
@@ -9363,7 +9175,7 @@
                           </a:solidFill>
                           <a:latin typeface="Segoe UI"/>
                         </a:rPr>
-                        <a:t>2.3.0</a:t>
+                        <a:t>2.4.0</a:t>
                       </a:r>
                     </a:p>
                   </a:txBody>
@@ -9407,7 +9219,7 @@
                           </a:solidFill>
                           <a:latin typeface="Segoe UI"/>
                         </a:rPr>
-                        <a:t>Friends, levels &amp; achievements</a:t>
+                        <a:t>Chat, groups, affinity &amp; pet visits</a:t>
                       </a:r>
                     </a:p>
                     <a:p>
@@ -9418,7 +9230,7 @@
                           </a:solidFill>
                           <a:latin typeface="Segoe UI"/>
                         </a:rPr>
-                        <a:t>Levels &amp; XP: every finished pomodoro earns XP and your level grows - plus 20 achievements to unlock (first tomato, 8 in a day, 7-day streak, early bird, night owl, pet lover...). Your pet celebrates each one; Friends (optional, off by default): get a 6-letter friend code, add colleagues, see today's board and join a team board like PTB. Your pet tells you when a friend finishes a pomodoro; Privacy: only your name, pet, level, streak and pomodoro counts are shared - never apps, window titles or scores. One click turns it off and deletes your online data. Right-click the pet → Friends &amp; achievements…</a:t>
+                        <a:t>Chat: message your friends, and chat inside groups. Your pet pops up new messages as a bubble - click it to reply; Pet interactions: wave, pet their pet, send a snack, high five - or send your pet to visit: it walks onto your friend's desktop for a little while!; Affinity: every chat and interaction grows your friendship - Acquaintance → Buddy → Good friends → Close friends → Best friends → Soulmates; Your own groups: create a private group, invite your friends, they accept or decline. Group board + group chat; the owner can remove members</a:t>
                       </a:r>
                     </a:p>
                   </a:txBody>
@@ -9442,7 +9254,7 @@
                           </a:solidFill>
                           <a:latin typeface="Segoe UI"/>
                         </a:rPr>
-                        <a:t>2.2.0</a:t>
+                        <a:t>2.3.0</a:t>
                       </a:r>
                     </a:p>
                   </a:txBody>
@@ -9486,7 +9298,7 @@
                           </a:solidFill>
                           <a:latin typeface="Segoe UI"/>
                         </a:rPr>
-                        <a:t>Pet sounds</a:t>
+                        <a:t>Friends, levels &amp; achievements</a:t>
                       </a:r>
                     </a:p>
                     <a:p>
@@ -9497,7 +9309,7 @@
                           </a:solidFill>
                           <a:latin typeface="Segoe UI"/>
                         </a:rPr>
-                        <a:t>Your pet has a voice! Each of the 23 animals has its own sound (meow, woof, ribbit, hoot, buzz, oink, whale song...) and it changes with its mood: happy chirps, sad whimpers, sleepy yawns, hungry calls, grumpy huffs and soft snores; It also reacts with sound when you tickle, pet, feed, shake or wake it; Settings: right-click the pet → Sounds to switch on/off; Pet status &amp; settings has a volume slider, a ▶ Hear me button and "Stay quiet while I'm focusing" (on by default)</a:t>
+                        <a:t>Levels &amp; XP: every finished pomodoro earns XP and your level grows - plus 20 achievements to unlock (first tomato, 8 in a day, 7-day streak, early bird, night owl, pet lover...). Your pet celebrates each one; Friends (optional, off by default): get a 6-letter friend code, add colleagues, see today's board and join a team board like PTB. Your pet tells you when a friend finishes a pomodoro; Privacy: only your name, pet, level, streak and pomodoro counts are shared - never apps, window titles or scores. One click turns it off and deletes your online data. Right-click the pet → Friends &amp; achievements…</a:t>
                       </a:r>
                     </a:p>
                   </a:txBody>
@@ -9521,7 +9333,7 @@
                           </a:solidFill>
                           <a:latin typeface="Segoe UI"/>
                         </a:rPr>
-                        <a:t>2.1.2</a:t>
+                        <a:t>2.2.0</a:t>
                       </a:r>
                     </a:p>
                   </a:txBody>
@@ -9565,7 +9377,7 @@
                           </a:solidFill>
                           <a:latin typeface="Segoe UI"/>
                         </a:rPr>
-                        <a:t>Tickle-only mode</a:t>
+                        <a:t>Pet sounds</a:t>
                       </a:r>
                     </a:p>
                     <a:p>
@@ -9576,7 +9388,7 @@
                           </a:solidFill>
                           <a:latin typeface="Segoe UI"/>
                         </a:rPr>
-                        <a:t>New click option "Only tickle (never open Pips)": click and tickle your pet as much as you like - the Pomodoro window stays closed (open it from the right-click menu). Right-click the pet → When I click</a:t>
+                        <a:t>Your pet has a voice! Each of the 23 animals has its own sound (meow, woof, ribbit, hoot, buzz, oink, whale song...) and it changes with its mood: happy chirps, sad whimpers, sleepy yawns, hungry calls, grumpy huffs and soft snores; It also reacts with sound when you tickle, pet, feed, shake or wake it; Settings: right-click the pet → Sounds to switch on/off; Pet status &amp; settings has a volume slider, a ▶ Hear me button and "Stay quiet while I'm focusing" (on by default)</a:t>
                       </a:r>
                     </a:p>
                   </a:txBody>
@@ -9600,7 +9412,7 @@
                           </a:solidFill>
                           <a:latin typeface="Segoe UI"/>
                         </a:rPr>
-                        <a:t>2.1.1</a:t>
+                        <a:t>2.1.2</a:t>
                       </a:r>
                     </a:p>
                   </a:txBody>
@@ -9644,7 +9456,7 @@
                           </a:solidFill>
                           <a:latin typeface="Segoe UI"/>
                         </a:rPr>
-                        <a:t>Owner info</a:t>
+                        <a:t>Tickle-only mode</a:t>
                       </a:r>
                     </a:p>
                     <a:p>
@@ -9655,7 +9467,7 @@
                           </a:solidFill>
                           <a:latin typeface="Segoe UI"/>
                         </a:rPr>
-                        <a:t>About Pips now shows the owner: Juwen Lie (right-click the pet → Help → About)</a:t>
+                        <a:t>New click option "Only tickle (never open Pips)": click and tickle your pet as much as you like - the Pomodoro window stays closed (open it from the right-click menu). Right-click the pet → When I click</a:t>
                       </a:r>
                     </a:p>
                   </a:txBody>
@@ -9679,7 +9491,7 @@
                           </a:solidFill>
                           <a:latin typeface="Segoe UI"/>
                         </a:rPr>
-                        <a:t>2.1.0</a:t>
+                        <a:t>2.1.1</a:t>
                       </a:r>
                     </a:p>
                   </a:txBody>
@@ -9723,7 +9535,7 @@
                           </a:solidFill>
                           <a:latin typeface="Segoe UI"/>
                         </a:rPr>
-                        <a:t>Interactive guide &amp; in-app updates</a:t>
+                        <a:t>Owner info</a:t>
                       </a:r>
                     </a:p>
                     <a:p>
@@ -9734,7 +9546,7 @@
                           </a:solidFill>
                           <a:latin typeface="Segoe UI"/>
                         </a:rPr>
-                        <a:t>Interactive first-run guide: your pet walks you through clicking, dragging, petting and the right-click menu; In-app updates: Pips tells you when a new version is out - update with one click (your settings and data are kept); New Help menu: replay the guide, check for updates, see the version; Option to turn automatic update checks off</a:t>
+                        <a:t>About Pips now shows the owner: Juwen Lie (right-click the pet → Help → About)</a:t>
                       </a:r>
                     </a:p>
                   </a:txBody>
@@ -9758,7 +9570,7 @@
                           </a:solidFill>
                           <a:latin typeface="Segoe UI"/>
                         </a:rPr>
-                        <a:t>2.0.0</a:t>
+                        <a:t>2.1.0</a:t>
                       </a:r>
                     </a:p>
                   </a:txBody>
@@ -9802,7 +9614,7 @@
                           </a:solidFill>
                           <a:latin typeface="Segoe UI"/>
                         </a:rPr>
-                        <a:t>Desktop pet, 23 animals &amp; 4 languages</a:t>
+                        <a:t>Interactive guide &amp; in-app updates</a:t>
                       </a:r>
                     </a:p>
                     <a:p>
@@ -9813,7 +9625,7 @@
                           </a:solidFill>
                           <a:latin typeface="Segoe UI"/>
                         </a:rPr>
-                        <a:t>Desktop pet that lives on your desktop and taskbar - drag it, tickle it, pet it; 23 animals in 3 groups: Land walks, Water swims with bubbles, Sky hovers and flaps; Moods (happy, sad, tired, hungry, grumpy...), naps when you're away, wakes up when you're back; Cute chat-bubble reminders: breaks, water, 20-20-20 eye rest, pomodoro done, daily goal</a:t>
+                        <a:t>Interactive first-run guide: your pet walks you through clicking, dragging, petting and the right-click menu; In-app updates: Pips tells you when a new version is out - update with one click (your settings and data are kept); New Help menu: replay the guide, check for updates, see the version; Option to turn automatic update checks off</a:t>
                       </a:r>
                     </a:p>
                   </a:txBody>
@@ -9837,7 +9649,7 @@
                           </a:solidFill>
                           <a:latin typeface="Segoe UI"/>
                         </a:rPr>
-                        <a:t>1.5.0</a:t>
+                        <a:t>2.0.0</a:t>
                       </a:r>
                     </a:p>
                   </a:txBody>
@@ -9859,13 +9671,92 @@
                           </a:solidFill>
                           <a:latin typeface="Segoe UI"/>
                         </a:rPr>
+                        <a:t>2026-10-28</a:t>
+                      </a:r>
+                    </a:p>
+                  </a:txBody>
+                  <a:tcPr marL="73152" marR="73152" marT="36576" marB="36576">
+                    <a:solidFill>
+                      <a:srgbClr val="FFFDF8"/>
+                    </a:solidFill>
+                  </a:tcPr>
+                </a:tc>
+                <a:tc>
+                  <a:txBody>
+                    <a:bodyPr wrap="square"/>
+                    <a:lstStyle/>
+                    <a:p>
+                      <a:r>
+                        <a:rPr sz="1200" b="0">
+                          <a:solidFill>
+                            <a:srgbClr val="2B2A28"/>
+                          </a:solidFill>
+                          <a:latin typeface="Segoe UI"/>
+                        </a:rPr>
+                        <a:t>Desktop pet, 23 animals &amp; 4 languages</a:t>
+                      </a:r>
+                    </a:p>
+                    <a:p>
+                      <a:r>
+                        <a:rPr sz="1200" b="0">
+                          <a:solidFill>
+                            <a:srgbClr val="2B2A28"/>
+                          </a:solidFill>
+                          <a:latin typeface="Segoe UI"/>
+                        </a:rPr>
+                        <a:t>Desktop pet that lives on your desktop and taskbar - drag it, tickle it, pet it; 23 animals in 3 groups: Land walks, Water swims with bubbles, Sky hovers and flaps; Moods (happy, sad, tired, hungry, grumpy...), naps when you're away, wakes up when you're back; Cute chat-bubble reminders: breaks, water, 20-20-20 eye rest, pomodoro done, daily goal</a:t>
+                      </a:r>
+                    </a:p>
+                  </a:txBody>
+                  <a:tcPr marL="73152" marR="73152" marT="36576" marB="36576">
+                    <a:solidFill>
+                      <a:srgbClr val="FFFDF8"/>
+                    </a:solidFill>
+                  </a:tcPr>
+                </a:tc>
+              </a:tr>
+              <a:tr h="822960">
+                <a:tc>
+                  <a:txBody>
+                    <a:bodyPr wrap="square"/>
+                    <a:lstStyle/>
+                    <a:p>
+                      <a:r>
+                        <a:rPr sz="1200" b="1">
+                          <a:solidFill>
+                            <a:srgbClr val="2B2A28"/>
+                          </a:solidFill>
+                          <a:latin typeface="Segoe UI"/>
+                        </a:rPr>
+                        <a:t>1.5.0</a:t>
+                      </a:r>
+                    </a:p>
+                  </a:txBody>
+                  <a:tcPr marL="73152" marR="73152" marT="36576" marB="36576">
+                    <a:solidFill>
+                      <a:srgbClr val="F7F4EC"/>
+                    </a:solidFill>
+                  </a:tcPr>
+                </a:tc>
+                <a:tc>
+                  <a:txBody>
+                    <a:bodyPr wrap="square"/>
+                    <a:lstStyle/>
+                    <a:p>
+                      <a:r>
+                        <a:rPr sz="1200" b="0">
+                          <a:solidFill>
+                            <a:srgbClr val="2B2A28"/>
+                          </a:solidFill>
+                          <a:latin typeface="Segoe UI"/>
+                        </a:rPr>
                         <a:t>2026-10-24</a:t>
                       </a:r>
                     </a:p>
                   </a:txBody>
                   <a:tcPr marL="73152" marR="73152" marT="36576" marB="36576">
                     <a:solidFill>
-                      <a:srgbClr val="FFFDF8"/>
+                      <a:srgbClr val="F7F4EC"/>
                     </a:solidFill>
                   </a:tcPr>
                 </a:tc>
@@ -9898,7 +9789,7 @@
                   </a:txBody>
                   <a:tcPr marL="73152" marR="73152" marT="36576" marB="36576">
                     <a:solidFill>
-                      <a:srgbClr val="FFFDF8"/>
+                      <a:srgbClr val="F7F4EC"/>
                     </a:solidFill>
                   </a:tcPr>
                 </a:tc>
@@ -9922,7 +9813,7 @@
                   </a:txBody>
                   <a:tcPr marL="73152" marR="73152" marT="36576" marB="36576">
                     <a:solidFill>
-                      <a:srgbClr val="F7F4EC"/>
+                      <a:srgbClr val="FFFDF8"/>
                     </a:solidFill>
                   </a:tcPr>
                 </a:tc>
@@ -9944,7 +9835,7 @@
                   </a:txBody>
                   <a:tcPr marL="73152" marR="73152" marT="36576" marB="36576">
                     <a:solidFill>
-                      <a:srgbClr val="F7F4EC"/>
+                      <a:srgbClr val="FFFDF8"/>
                     </a:solidFill>
                   </a:tcPr>
                 </a:tc>
@@ -9977,7 +9868,7 @@
                   </a:txBody>
                   <a:tcPr marL="73152" marR="73152" marT="36576" marB="36576">
                     <a:solidFill>
-                      <a:srgbClr val="F7F4EC"/>
+                      <a:srgbClr val="FFFDF8"/>
                     </a:solidFill>
                   </a:tcPr>
                 </a:tc>

</xml_diff>

<commit_message>
pips 2.7.0: Moderators & Premium
</commit_message>
<xml_diff>
--- a/apps/pips/web/download/Pips-Guide.pptx
+++ b/apps/pips/web/download/Pips-Guide.pptx
@@ -3292,7 +3292,7 @@
                 </a:solidFill>
                 <a:latin typeface="Segoe UI"/>
               </a:rPr>
-              <a:t>Version 2.6.1  ·  2026-10-28  ·  Made by Juwen Lie (owner)</a:t>
+              <a:t>Version 2.7.0  ·  2026-10-28  ·  Made by Juwen Lie (owner)</a:t>
             </a:r>
           </a:p>
           <a:p>
@@ -8141,7 +8141,7 @@
                 </a:solidFill>
                 <a:latin typeface="Segoe UI"/>
               </a:rPr>
-              <a:t>What's new in 2.6.1</a:t>
+              <a:t>What's new in 2.7.0</a:t>
             </a:r>
           </a:p>
         </p:txBody>
@@ -8254,7 +8254,7 @@
                 </a:solidFill>
                 <a:latin typeface="Segoe UI"/>
               </a:rPr>
-              <a:t>Owner badge &amp; credits  ·  2026-10-28</a:t>
+              <a:t>Moderators &amp; Premium  ·  2026-10-28</a:t>
             </a:r>
           </a:p>
         </p:txBody>
@@ -8302,7 +8302,7 @@
                 </a:solidFill>
                 <a:latin typeface="Segoe UI"/>
               </a:rPr>
-              <a:t>The creator of Pips (Juwen Lie) now shows a gold ♛ Owner badge on his profile, friend list and ranks</a:t>
+              <a:t>★ Premium: a purple Premium badge, 4 exclusive props (tiara, star glasses, diamond necklace, fairy wings), the Fireworks move, +30 coins every day, double friend-interaction coins and room for 300 friends / 30 groups</a:t>
             </a:r>
           </a:p>
           <a:p>
@@ -8327,7 +8327,7 @@
                 </a:solidFill>
                 <a:latin typeface="Segoe UI"/>
               </a:rPr>
-              <a:t>New About Pips card in the Profile tab: credits and how to contact the owner (Juwen_Lie@pegatroncorp.com) with Email and Copy buttons</a:t>
+              <a:t>Get Premium: Profile tab → Premium → "Ask to buy" emails the owner; after payment you receive a key (PIPS-XXXX-XXXX) to redeem right there</a:t>
             </a:r>
           </a:p>
           <a:p>
@@ -8352,7 +8352,32 @@
                 </a:solidFill>
                 <a:latin typeface="Segoe UI"/>
               </a:rPr>
-              <a:t>Right-click the pet → Help → About now shows who made Pips and the contact email</a:t>
+              <a:t>🛡 Moderators: a blue Mod badge and a Mod tab with the report queue - warn, mute (1h / 24h / 7 days), clear a profile or reset a name; every action is logged</a:t>
+            </a:r>
+          </a:p>
+          <a:p>
+            <a:pPr>
+              <a:spcAft>
+                <a:spcPts val="1000"/>
+              </a:spcAft>
+            </a:pPr>
+            <a:r>
+              <a:rPr sz="1700" b="1">
+                <a:solidFill>
+                  <a:srgbClr val="4CB86B"/>
+                </a:solidFill>
+                <a:latin typeface="Segoe UI"/>
+              </a:rPr>
+              <a:t>•  </a:t>
+            </a:r>
+            <a:r>
+              <a:rPr sz="1700">
+                <a:solidFill>
+                  <a:srgbClr val="2B2A28"/>
+                </a:solidFill>
+                <a:latin typeface="Segoe UI"/>
+              </a:rPr>
+              <a:t>Report button on everyone's profile, so moderators can keep Pips friendly</a:t>
             </a:r>
           </a:p>
         </p:txBody>
@@ -8483,7 +8508,7 @@
                 </a:solidFill>
                 <a:latin typeface="Segoe UI"/>
               </a:rPr>
-              <a:t>Pembuat Pips (Juwen Lie) sekarang memiliki lencana emas ♛ Pemilik di profil, daftar teman dan peringkat</a:t>
+              <a:t>★ Premium: lencana ungu Premium, 4 aksesori eksklusif (tiara, kacamata bintang, kalung berlian, sayap peri), gerakan Kembang Api, +30 koin setiap hari, koin interaksi teman dua kali lipat dan hingga 300 teman / 30 grup</a:t>
             </a:r>
           </a:p>
           <a:p>
@@ -8508,7 +8533,7 @@
                 </a:solidFill>
                 <a:latin typeface="Segoe UI"/>
               </a:rPr>
-              <a:t>Kartu Tentang Pips baru di tab Profil: kredit dan cara menghubungi pemilik (Juwen_Lie@pegatroncorp.com) dengan tombol Email dan Salin</a:t>
+              <a:t>Dapatkan Premium: tab Profil → Premium → "Tanya cara beli" mengirim email ke pemilik; setelah membayar kamu menerima kunci (PIPS-XXXX-XXXX) untuk ditukarkan di sana</a:t>
             </a:r>
           </a:p>
           <a:p>
@@ -8533,7 +8558,32 @@
                 </a:solidFill>
                 <a:latin typeface="Segoe UI"/>
               </a:rPr>
-              <a:t>Klik kanan peliharaan → Bantuan → Tentang sekarang menampilkan pembuat Pips dan email kontak</a:t>
+              <a:t>🛡 Moderator: lencana biru Mod dan tab Mod dengan antrean laporan - peringatkan, bisukan (1 jam / 24 jam / 7 hari), hapus profil atau atur ulang nama; semua tindakan dicatat</a:t>
+            </a:r>
+          </a:p>
+          <a:p>
+            <a:pPr>
+              <a:spcAft>
+                <a:spcPts val="500"/>
+              </a:spcAft>
+            </a:pPr>
+            <a:r>
+              <a:rPr sz="1200" b="1">
+                <a:solidFill>
+                  <a:srgbClr val="4CB86B"/>
+                </a:solidFill>
+                <a:latin typeface="Segoe UI"/>
+              </a:rPr>
+              <a:t>•  </a:t>
+            </a:r>
+            <a:r>
+              <a:rPr sz="1200">
+                <a:solidFill>
+                  <a:srgbClr val="2B2A28"/>
+                </a:solidFill>
+                <a:latin typeface="Segoe UI"/>
+              </a:rPr>
+              <a:t>Tombol Laporkan di profil setiap orang, agar moderator bisa menjaga Pips tetap ramah</a:t>
             </a:r>
           </a:p>
         </p:txBody>
@@ -8765,7 +8815,7 @@
         </p:nvGraphicFramePr>
         <p:xfrm>
           <a:off x="548640" y="1645920"/>
-          <a:ext cx="11155680" cy="11082528"/>
+          <a:ext cx="11155680" cy="11905488"/>
         </p:xfrm>
         <a:graphic>
           <a:graphicData uri="http://schemas.openxmlformats.org/drawingml/2006/table">
@@ -8859,7 +8909,7 @@
                           </a:solidFill>
                           <a:latin typeface="Segoe UI"/>
                         </a:rPr>
-                        <a:t>2.6.1</a:t>
+                        <a:t>2.7.0</a:t>
                       </a:r>
                     </a:p>
                   </a:txBody>
@@ -8903,7 +8953,7 @@
                           </a:solidFill>
                           <a:latin typeface="Segoe UI"/>
                         </a:rPr>
-                        <a:t>Owner badge &amp; credits</a:t>
+                        <a:t>Moderators &amp; Premium</a:t>
                       </a:r>
                     </a:p>
                     <a:p>
@@ -8914,7 +8964,7 @@
                           </a:solidFill>
                           <a:latin typeface="Segoe UI"/>
                         </a:rPr>
-                        <a:t>The creator of Pips (Juwen Lie) now shows a gold ♛ Owner badge on his profile, friend list and ranks; New About Pips card in the Profile tab: credits and how to contact the owner (Juwen_Lie@pegatroncorp.com) with Email and Copy buttons; Right-click the pet → Help → About now shows who made Pips and the contact email</a:t>
+                        <a:t>★ Premium: a purple Premium badge, 4 exclusive props (tiara, star glasses, diamond necklace, fairy wings), the Fireworks move, +30 coins every day, double friend-interaction coins and room for 300 friends / 30 groups; Get Premium: Profile tab → Premium → "Ask to buy" emails the owner; after payment you receive a key (PIPS-XXXX-XXXX) to redeem right there; 🛡 Moderators: a blue Mod badge and a Mod tab with the report queue - warn, mute (1h / 24h / 7 days), clear a profile or reset a name; every action is logged; Report button on everyone's profile, so moderators can keep Pips friendly</a:t>
                       </a:r>
                     </a:p>
                   </a:txBody>
@@ -8938,7 +8988,7 @@
                           </a:solidFill>
                           <a:latin typeface="Segoe UI"/>
                         </a:rPr>
-                        <a:t>2.6.0</a:t>
+                        <a:t>2.6.1</a:t>
                       </a:r>
                     </a:p>
                   </a:txBody>
@@ -8982,7 +9032,7 @@
                           </a:solidFill>
                           <a:latin typeface="Segoe UI"/>
                         </a:rPr>
-                        <a:t>Profiles, ranks, online status &amp; dark mode</a:t>
+                        <a:t>Owner badge &amp; credits</a:t>
                       </a:r>
                     </a:p>
                     <a:p>
@@ -8993,7 +9043,7 @@
                           </a:solidFill>
                           <a:latin typeface="Segoe UI"/>
                         </a:rPr>
-                        <a:t>Profile tab: profile picture (or your pet), about me, job, location, hobbies, birthday and a status message; Public or private: public profiles can be added directly and viewed in full; private profiles need a friend request that they accept, and strangers only see name, photo, pet, level and status; Click anyone to open their profile - badges, info, their friends - and add them, chat or wave from there; Ranks tab replaces Teams: everyone using Pips, sorted by XP, badges or streak</a:t>
+                        <a:t>The creator of Pips (Juwen Lie) now shows a gold ♛ Owner badge on his profile, friend list and ranks; New About Pips card in the Profile tab: credits and how to contact the owner (Juwen_Lie@pegatroncorp.com) with Email and Copy buttons; Right-click the pet → Help → About now shows who made Pips and the contact email</a:t>
                       </a:r>
                     </a:p>
                   </a:txBody>
@@ -9017,7 +9067,7 @@
                           </a:solidFill>
                           <a:latin typeface="Segoe UI"/>
                         </a:rPr>
-                        <a:t>2.5.1</a:t>
+                        <a:t>2.6.0</a:t>
                       </a:r>
                     </a:p>
                   </a:txBody>
@@ -9061,7 +9111,7 @@
                           </a:solidFill>
                           <a:latin typeface="Segoe UI"/>
                         </a:rPr>
-                        <a:t>New cute Pips logo</a:t>
+                        <a:t>Profiles, ranks, online status &amp; dark mode</a:t>
                       </a:r>
                     </a:p>
                     <a:p>
@@ -9072,7 +9122,7 @@
                           </a:solidFill>
                           <a:latin typeface="Segoe UI"/>
                         </a:rPr>
-                        <a:t>New Pips logo: Pip the cat on a Pips-red tile, matching the app colours (desktop shortcut, windows and website)</a:t>
+                        <a:t>Profile tab: profile picture (or your pet), about me, job, location, hobbies, birthday and a status message; Public or private: public profiles can be added directly and viewed in full; private profiles need a friend request that they accept, and strangers only see name, photo, pet, level and status; Click anyone to open their profile - badges, info, their friends - and add them, chat or wave from there; Ranks tab replaces Teams: everyone using Pips, sorted by XP, badges or streak</a:t>
                       </a:r>
                     </a:p>
                   </a:txBody>
@@ -9096,7 +9146,7 @@
                           </a:solidFill>
                           <a:latin typeface="Segoe UI"/>
                         </a:rPr>
-                        <a:t>2.5.0</a:t>
+                        <a:t>2.5.1</a:t>
                       </a:r>
                     </a:p>
                   </a:txBody>
@@ -9140,7 +9190,7 @@
                           </a:solidFill>
                           <a:latin typeface="Segoe UI"/>
                         </a:rPr>
-                        <a:t>Shop, coins, props &amp; moves</a:t>
+                        <a:t>New cute Pips logo</a:t>
                       </a:r>
                     </a:p>
                     <a:p>
@@ -9151,7 +9201,7 @@
                           </a:solidFill>
                           <a:latin typeface="Segoe UI"/>
                         </a:rPr>
-                        <a:t>Shop: earn coins and spend them on your pet - 17 props (crown, wizard hat, headphones, shades, scarf, cape, angel wings...) and 6 moves: spin, dance, moonwalk, backflip, kung fu and spider swing!; Coins come from leveling up (+40), badges (+25), opening Pips each day (+10), friendships (+15 per affinity level), waving / chatting / visiting friends (+2) and pomodoros (+5). Everyone starts with a 100-coin gift; Your friends see your props: on avatars in the hub and when your pet visits their desktop - it shows off one of your moves; Pips is now a social pet: clicking the pet opens the Pips hub (friends, chat, groups, shop, badges)</a:t>
+                        <a:t>New Pips logo: Pip the cat on a Pips-red tile, matching the app colours (desktop shortcut, windows and website)</a:t>
                       </a:r>
                     </a:p>
                   </a:txBody>
@@ -9175,7 +9225,7 @@
                           </a:solidFill>
                           <a:latin typeface="Segoe UI"/>
                         </a:rPr>
-                        <a:t>2.4.0</a:t>
+                        <a:t>2.5.0</a:t>
                       </a:r>
                     </a:p>
                   </a:txBody>
@@ -9219,7 +9269,7 @@
                           </a:solidFill>
                           <a:latin typeface="Segoe UI"/>
                         </a:rPr>
-                        <a:t>Chat, groups, affinity &amp; pet visits</a:t>
+                        <a:t>Shop, coins, props &amp; moves</a:t>
                       </a:r>
                     </a:p>
                     <a:p>
@@ -9230,7 +9280,7 @@
                           </a:solidFill>
                           <a:latin typeface="Segoe UI"/>
                         </a:rPr>
-                        <a:t>Chat: message your friends, and chat inside groups. Your pet pops up new messages as a bubble - click it to reply; Pet interactions: wave, pet their pet, send a snack, high five - or send your pet to visit: it walks onto your friend's desktop for a little while!; Affinity: every chat and interaction grows your friendship - Acquaintance → Buddy → Good friends → Close friends → Best friends → Soulmates; Your own groups: create a private group, invite your friends, they accept or decline. Group board + group chat; the owner can remove members</a:t>
+                        <a:t>Shop: earn coins and spend them on your pet - 17 props (crown, wizard hat, headphones, shades, scarf, cape, angel wings...) and 6 moves: spin, dance, moonwalk, backflip, kung fu and spider swing!; Coins come from leveling up (+40), badges (+25), opening Pips each day (+10), friendships (+15 per affinity level), waving / chatting / visiting friends (+2) and pomodoros (+5). Everyone starts with a 100-coin gift; Your friends see your props: on avatars in the hub and when your pet visits their desktop - it shows off one of your moves; Pips is now a social pet: clicking the pet opens the Pips hub (friends, chat, groups, shop, badges)</a:t>
                       </a:r>
                     </a:p>
                   </a:txBody>
@@ -9254,7 +9304,7 @@
                           </a:solidFill>
                           <a:latin typeface="Segoe UI"/>
                         </a:rPr>
-                        <a:t>2.3.0</a:t>
+                        <a:t>2.4.0</a:t>
                       </a:r>
                     </a:p>
                   </a:txBody>
@@ -9298,7 +9348,7 @@
                           </a:solidFill>
                           <a:latin typeface="Segoe UI"/>
                         </a:rPr>
-                        <a:t>Friends, levels &amp; achievements</a:t>
+                        <a:t>Chat, groups, affinity &amp; pet visits</a:t>
                       </a:r>
                     </a:p>
                     <a:p>
@@ -9309,7 +9359,7 @@
                           </a:solidFill>
                           <a:latin typeface="Segoe UI"/>
                         </a:rPr>
-                        <a:t>Levels &amp; XP: every finished pomodoro earns XP and your level grows - plus 20 achievements to unlock (first tomato, 8 in a day, 7-day streak, early bird, night owl, pet lover...). Your pet celebrates each one; Friends (optional, off by default): get a 6-letter friend code, add colleagues, see today's board and join a team board like PTB. Your pet tells you when a friend finishes a pomodoro; Privacy: only your name, pet, level, streak and pomodoro counts are shared - never apps, window titles or scores. One click turns it off and deletes your online data. Right-click the pet → Friends &amp; achievements…</a:t>
+                        <a:t>Chat: message your friends, and chat inside groups. Your pet pops up new messages as a bubble - click it to reply; Pet interactions: wave, pet their pet, send a snack, high five - or send your pet to visit: it walks onto your friend's desktop for a little while!; Affinity: every chat and interaction grows your friendship - Acquaintance → Buddy → Good friends → Close friends → Best friends → Soulmates; Your own groups: create a private group, invite your friends, they accept or decline. Group board + group chat; the owner can remove members</a:t>
                       </a:r>
                     </a:p>
                   </a:txBody>
@@ -9333,7 +9383,7 @@
                           </a:solidFill>
                           <a:latin typeface="Segoe UI"/>
                         </a:rPr>
-                        <a:t>2.2.0</a:t>
+                        <a:t>2.3.0</a:t>
                       </a:r>
                     </a:p>
                   </a:txBody>
@@ -9377,7 +9427,7 @@
                           </a:solidFill>
                           <a:latin typeface="Segoe UI"/>
                         </a:rPr>
-                        <a:t>Pet sounds</a:t>
+                        <a:t>Friends, levels &amp; achievements</a:t>
                       </a:r>
                     </a:p>
                     <a:p>
@@ -9388,7 +9438,7 @@
                           </a:solidFill>
                           <a:latin typeface="Segoe UI"/>
                         </a:rPr>
-                        <a:t>Your pet has a voice! Each of the 23 animals has its own sound (meow, woof, ribbit, hoot, buzz, oink, whale song...) and it changes with its mood: happy chirps, sad whimpers, sleepy yawns, hungry calls, grumpy huffs and soft snores; It also reacts with sound when you tickle, pet, feed, shake or wake it; Settings: right-click the pet → Sounds to switch on/off; Pet status &amp; settings has a volume slider, a ▶ Hear me button and "Stay quiet while I'm focusing" (on by default)</a:t>
+                        <a:t>Levels &amp; XP: every finished pomodoro earns XP and your level grows - plus 20 achievements to unlock (first tomato, 8 in a day, 7-day streak, early bird, night owl, pet lover...). Your pet celebrates each one; Friends (optional, off by default): get a 6-letter friend code, add colleagues, see today's board and join a team board like PTB. Your pet tells you when a friend finishes a pomodoro; Privacy: only your name, pet, level, streak and pomodoro counts are shared - never apps, window titles or scores. One click turns it off and deletes your online data. Right-click the pet → Friends &amp; achievements…</a:t>
                       </a:r>
                     </a:p>
                   </a:txBody>
@@ -9412,7 +9462,7 @@
                           </a:solidFill>
                           <a:latin typeface="Segoe UI"/>
                         </a:rPr>
-                        <a:t>2.1.2</a:t>
+                        <a:t>2.2.0</a:t>
                       </a:r>
                     </a:p>
                   </a:txBody>
@@ -9456,7 +9506,7 @@
                           </a:solidFill>
                           <a:latin typeface="Segoe UI"/>
                         </a:rPr>
-                        <a:t>Tickle-only mode</a:t>
+                        <a:t>Pet sounds</a:t>
                       </a:r>
                     </a:p>
                     <a:p>
@@ -9467,7 +9517,7 @@
                           </a:solidFill>
                           <a:latin typeface="Segoe UI"/>
                         </a:rPr>
-                        <a:t>New click option "Only tickle (never open Pips)": click and tickle your pet as much as you like - the Pomodoro window stays closed (open it from the right-click menu). Right-click the pet → When I click</a:t>
+                        <a:t>Your pet has a voice! Each of the 23 animals has its own sound (meow, woof, ribbit, hoot, buzz, oink, whale song...) and it changes with its mood: happy chirps, sad whimpers, sleepy yawns, hungry calls, grumpy huffs and soft snores; It also reacts with sound when you tickle, pet, feed, shake or wake it; Settings: right-click the pet → Sounds to switch on/off; Pet status &amp; settings has a volume slider, a ▶ Hear me button and "Stay quiet while I'm focusing" (on by default)</a:t>
                       </a:r>
                     </a:p>
                   </a:txBody>
@@ -9491,7 +9541,7 @@
                           </a:solidFill>
                           <a:latin typeface="Segoe UI"/>
                         </a:rPr>
-                        <a:t>2.1.1</a:t>
+                        <a:t>2.1.2</a:t>
                       </a:r>
                     </a:p>
                   </a:txBody>
@@ -9535,7 +9585,7 @@
                           </a:solidFill>
                           <a:latin typeface="Segoe UI"/>
                         </a:rPr>
-                        <a:t>Owner info</a:t>
+                        <a:t>Tickle-only mode</a:t>
                       </a:r>
                     </a:p>
                     <a:p>
@@ -9546,7 +9596,7 @@
                           </a:solidFill>
                           <a:latin typeface="Segoe UI"/>
                         </a:rPr>
-                        <a:t>About Pips now shows the owner: Juwen Lie (right-click the pet → Help → About)</a:t>
+                        <a:t>New click option "Only tickle (never open Pips)": click and tickle your pet as much as you like - the Pomodoro window stays closed (open it from the right-click menu). Right-click the pet → When I click</a:t>
                       </a:r>
                     </a:p>
                   </a:txBody>
@@ -9570,7 +9620,7 @@
                           </a:solidFill>
                           <a:latin typeface="Segoe UI"/>
                         </a:rPr>
-                        <a:t>2.1.0</a:t>
+                        <a:t>2.1.1</a:t>
                       </a:r>
                     </a:p>
                   </a:txBody>
@@ -9614,7 +9664,7 @@
                           </a:solidFill>
                           <a:latin typeface="Segoe UI"/>
                         </a:rPr>
-                        <a:t>Interactive guide &amp; in-app updates</a:t>
+                        <a:t>Owner info</a:t>
                       </a:r>
                     </a:p>
                     <a:p>
@@ -9625,7 +9675,7 @@
                           </a:solidFill>
                           <a:latin typeface="Segoe UI"/>
                         </a:rPr>
-                        <a:t>Interactive first-run guide: your pet walks you through clicking, dragging, petting and the right-click menu; In-app updates: Pips tells you when a new version is out - update with one click (your settings and data are kept); New Help menu: replay the guide, check for updates, see the version; Option to turn automatic update checks off</a:t>
+                        <a:t>About Pips now shows the owner: Juwen Lie (right-click the pet → Help → About)</a:t>
                       </a:r>
                     </a:p>
                   </a:txBody>
@@ -9649,7 +9699,7 @@
                           </a:solidFill>
                           <a:latin typeface="Segoe UI"/>
                         </a:rPr>
-                        <a:t>2.0.0</a:t>
+                        <a:t>2.1.0</a:t>
                       </a:r>
                     </a:p>
                   </a:txBody>
@@ -9693,7 +9743,7 @@
                           </a:solidFill>
                           <a:latin typeface="Segoe UI"/>
                         </a:rPr>
-                        <a:t>Desktop pet, 23 animals &amp; 4 languages</a:t>
+                        <a:t>Interactive guide &amp; in-app updates</a:t>
                       </a:r>
                     </a:p>
                     <a:p>
@@ -9704,7 +9754,7 @@
                           </a:solidFill>
                           <a:latin typeface="Segoe UI"/>
                         </a:rPr>
-                        <a:t>Desktop pet that lives on your desktop and taskbar - drag it, tickle it, pet it; 23 animals in 3 groups: Land walks, Water swims with bubbles, Sky hovers and flaps; Moods (happy, sad, tired, hungry, grumpy...), naps when you're away, wakes up when you're back; Cute chat-bubble reminders: breaks, water, 20-20-20 eye rest, pomodoro done, daily goal</a:t>
+                        <a:t>Interactive first-run guide: your pet walks you through clicking, dragging, petting and the right-click menu; In-app updates: Pips tells you when a new version is out - update with one click (your settings and data are kept); New Help menu: replay the guide, check for updates, see the version; Option to turn automatic update checks off</a:t>
                       </a:r>
                     </a:p>
                   </a:txBody>
@@ -9728,7 +9778,7 @@
                           </a:solidFill>
                           <a:latin typeface="Segoe UI"/>
                         </a:rPr>
-                        <a:t>1.5.0</a:t>
+                        <a:t>2.0.0</a:t>
                       </a:r>
                     </a:p>
                   </a:txBody>
@@ -9750,13 +9800,92 @@
                           </a:solidFill>
                           <a:latin typeface="Segoe UI"/>
                         </a:rPr>
+                        <a:t>2026-10-28</a:t>
+                      </a:r>
+                    </a:p>
+                  </a:txBody>
+                  <a:tcPr marL="73152" marR="73152" marT="36576" marB="36576">
+                    <a:solidFill>
+                      <a:srgbClr val="F7F4EC"/>
+                    </a:solidFill>
+                  </a:tcPr>
+                </a:tc>
+                <a:tc>
+                  <a:txBody>
+                    <a:bodyPr wrap="square"/>
+                    <a:lstStyle/>
+                    <a:p>
+                      <a:r>
+                        <a:rPr sz="1200" b="0">
+                          <a:solidFill>
+                            <a:srgbClr val="2B2A28"/>
+                          </a:solidFill>
+                          <a:latin typeface="Segoe UI"/>
+                        </a:rPr>
+                        <a:t>Desktop pet, 23 animals &amp; 4 languages</a:t>
+                      </a:r>
+                    </a:p>
+                    <a:p>
+                      <a:r>
+                        <a:rPr sz="1200" b="0">
+                          <a:solidFill>
+                            <a:srgbClr val="2B2A28"/>
+                          </a:solidFill>
+                          <a:latin typeface="Segoe UI"/>
+                        </a:rPr>
+                        <a:t>Desktop pet that lives on your desktop and taskbar - drag it, tickle it, pet it; 23 animals in 3 groups: Land walks, Water swims with bubbles, Sky hovers and flaps; Moods (happy, sad, tired, hungry, grumpy...), naps when you're away, wakes up when you're back; Cute chat-bubble reminders: breaks, water, 20-20-20 eye rest, pomodoro done, daily goal</a:t>
+                      </a:r>
+                    </a:p>
+                  </a:txBody>
+                  <a:tcPr marL="73152" marR="73152" marT="36576" marB="36576">
+                    <a:solidFill>
+                      <a:srgbClr val="F7F4EC"/>
+                    </a:solidFill>
+                  </a:tcPr>
+                </a:tc>
+              </a:tr>
+              <a:tr h="822960">
+                <a:tc>
+                  <a:txBody>
+                    <a:bodyPr wrap="square"/>
+                    <a:lstStyle/>
+                    <a:p>
+                      <a:r>
+                        <a:rPr sz="1200" b="1">
+                          <a:solidFill>
+                            <a:srgbClr val="2B2A28"/>
+                          </a:solidFill>
+                          <a:latin typeface="Segoe UI"/>
+                        </a:rPr>
+                        <a:t>1.5.0</a:t>
+                      </a:r>
+                    </a:p>
+                  </a:txBody>
+                  <a:tcPr marL="73152" marR="73152" marT="36576" marB="36576">
+                    <a:solidFill>
+                      <a:srgbClr val="FFFDF8"/>
+                    </a:solidFill>
+                  </a:tcPr>
+                </a:tc>
+                <a:tc>
+                  <a:txBody>
+                    <a:bodyPr wrap="square"/>
+                    <a:lstStyle/>
+                    <a:p>
+                      <a:r>
+                        <a:rPr sz="1200" b="0">
+                          <a:solidFill>
+                            <a:srgbClr val="2B2A28"/>
+                          </a:solidFill>
+                          <a:latin typeface="Segoe UI"/>
+                        </a:rPr>
                         <a:t>2026-10-24</a:t>
                       </a:r>
                     </a:p>
                   </a:txBody>
                   <a:tcPr marL="73152" marR="73152" marT="36576" marB="36576">
                     <a:solidFill>
-                      <a:srgbClr val="F7F4EC"/>
+                      <a:srgbClr val="FFFDF8"/>
                     </a:solidFill>
                   </a:tcPr>
                 </a:tc>
@@ -9789,7 +9918,7 @@
                   </a:txBody>
                   <a:tcPr marL="73152" marR="73152" marT="36576" marB="36576">
                     <a:solidFill>
-                      <a:srgbClr val="F7F4EC"/>
+                      <a:srgbClr val="FFFDF8"/>
                     </a:solidFill>
                   </a:tcPr>
                 </a:tc>
@@ -9813,7 +9942,7 @@
                   </a:txBody>
                   <a:tcPr marL="73152" marR="73152" marT="36576" marB="36576">
                     <a:solidFill>
-                      <a:srgbClr val="FFFDF8"/>
+                      <a:srgbClr val="F7F4EC"/>
                     </a:solidFill>
                   </a:tcPr>
                 </a:tc>
@@ -9835,7 +9964,7 @@
                   </a:txBody>
                   <a:tcPr marL="73152" marR="73152" marT="36576" marB="36576">
                     <a:solidFill>
-                      <a:srgbClr val="FFFDF8"/>
+                      <a:srgbClr val="F7F4EC"/>
                     </a:solidFill>
                   </a:tcPr>
                 </a:tc>
@@ -9868,7 +9997,7 @@
                   </a:txBody>
                   <a:tcPr marL="73152" marR="73152" marT="36576" marB="36576">
                     <a:solidFill>
-                      <a:srgbClr val="FFFDF8"/>
+                      <a:srgbClr val="F7F4EC"/>
                     </a:solidFill>
                   </a:tcPr>
                 </a:tc>

</xml_diff>

<commit_message>
pips 2.8.0: Pips Arena - duels, gear & live battles
</commit_message>
<xml_diff>
--- a/apps/pips/web/download/Pips-Guide.pptx
+++ b/apps/pips/web/download/Pips-Guide.pptx
@@ -3292,7 +3292,7 @@
                 </a:solidFill>
                 <a:latin typeface="Segoe UI"/>
               </a:rPr>
-              <a:t>Version 2.7.0  ·  2026-10-28  ·  Made by Juwen Lie (owner)</a:t>
+              <a:t>Version 2.8.0  ·  2026-10-28  ·  Made by Juwen Lie (owner)</a:t>
             </a:r>
           </a:p>
           <a:p>
@@ -8141,7 +8141,7 @@
                 </a:solidFill>
                 <a:latin typeface="Segoe UI"/>
               </a:rPr>
-              <a:t>What's new in 2.7.0</a:t>
+              <a:t>What's new in 2.8.0</a:t>
             </a:r>
           </a:p>
         </p:txBody>
@@ -8254,7 +8254,7 @@
                 </a:solidFill>
                 <a:latin typeface="Segoe UI"/>
               </a:rPr>
-              <a:t>Moderators &amp; Premium  ·  2026-10-28</a:t>
+              <a:t>Pips Arena - duels, gear &amp; live battles  ·  2026-10-28</a:t>
             </a:r>
           </a:p>
         </p:txBody>
@@ -8302,7 +8302,7 @@
                 </a:solidFill>
                 <a:latin typeface="Segoe UI"/>
               </a:rPr>
-              <a:t>★ Premium: a purple Premium badge, 4 exclusive props (tiara, star glasses, diamond necklace, fairy wings), the Fireworks move, +30 coins every day, double friend-interaction coins and room for 300 friends / 30 groups</a:t>
+              <a:t>⚔ New Arena tab: challenge friends or anyone in the arena to a live duel - each round pick Attack, Guard or Special within 12 seconds and watch your pets fight</a:t>
             </a:r>
           </a:p>
           <a:p>
@@ -8327,7 +8327,7 @@
                 </a:solidFill>
                 <a:latin typeface="Segoe UI"/>
               </a:rPr>
-              <a:t>Get Premium: Profile tab → Premium → "Ask to buy" emails the owner; after payment you receive a key (PIPS-XXXX-XXXX) to redeem right there</a:t>
+              <a:t>⚡ Quick battle: an instant auto-fight against anyone's fighter, even when they're offline</a:t>
             </a:r>
           </a:p>
           <a:p>
@@ -8352,7 +8352,7 @@
                 </a:solidFill>
                 <a:latin typeface="Segoe UI"/>
               </a:rPr>
-              <a:t>🛡 Moderators: a blue Mod badge and a Mod tab with the report queue - warn, mute (1h / 24h / 7 days), clear a profile or reset a name; every action is logged</a:t>
+              <a:t>Arena gear in the Shop: 7 weapons (water pistol to rocket launcher), 5 armors and 5 gadgets that decide your special move - better gear and a higher level make a stronger fighter</a:t>
             </a:r>
           </a:p>
           <a:p>
@@ -8377,7 +8377,32 @@
                 </a:solidFill>
                 <a:latin typeface="Segoe UI"/>
               </a:rPr>
-              <a:t>Report button on everyone's profile, so moderators can keep Pips friendly</a:t>
+              <a:t>Live duels can be watched by everyone, plus recent battle replays, top fighters, rating and win/loss records; wins earn coins</a:t>
+            </a:r>
+          </a:p>
+          <a:p>
+            <a:pPr>
+              <a:spcAft>
+                <a:spcPts val="1000"/>
+              </a:spcAft>
+            </a:pPr>
+            <a:r>
+              <a:rPr sz="1700" b="1">
+                <a:solidFill>
+                  <a:srgbClr val="4CB86B"/>
+                </a:solidFill>
+                <a:latin typeface="Segoe UI"/>
+              </a:rPr>
+              <a:t>•  </a:t>
+            </a:r>
+            <a:r>
+              <a:rPr sz="1700">
+                <a:solidFill>
+                  <a:srgbClr val="2B2A28"/>
+                </a:solidFill>
+                <a:latin typeface="Segoe UI"/>
+              </a:rPr>
+              <a:t>★ Premium gear: plasma cannon, mech suit and force field</a:t>
             </a:r>
           </a:p>
         </p:txBody>
@@ -8508,7 +8533,7 @@
                 </a:solidFill>
                 <a:latin typeface="Segoe UI"/>
               </a:rPr>
-              <a:t>★ Premium: lencana ungu Premium, 4 aksesori eksklusif (tiara, kacamata bintang, kalung berlian, sayap peri), gerakan Kembang Api, +30 koin setiap hari, koin interaksi teman dua kali lipat dan hingga 300 teman / 30 grup</a:t>
+              <a:t>⚔ Tab Arena baru: tantang teman atau siapa saja di arena untuk duel langsung - setiap ronde pilih Serang, Bertahan atau Spesial dalam 12 detik dan tonton peliharaanmu bertarung</a:t>
             </a:r>
           </a:p>
           <a:p>
@@ -8533,7 +8558,7 @@
                 </a:solidFill>
                 <a:latin typeface="Segoe UI"/>
               </a:rPr>
-              <a:t>Dapatkan Premium: tab Profil → Premium → "Tanya cara beli" mengirim email ke pemilik; setelah membayar kamu menerima kunci (PIPS-XXXX-XXXX) untuk ditukarkan di sana</a:t>
+              <a:t>⚡ Tarung cepat: pertarungan otomatis instan melawan petarung siapa saja, bahkan saat mereka offline</a:t>
             </a:r>
           </a:p>
           <a:p>
@@ -8558,7 +8583,7 @@
                 </a:solidFill>
                 <a:latin typeface="Segoe UI"/>
               </a:rPr>
-              <a:t>🛡 Moderator: lencana biru Mod dan tab Mod dengan antrean laporan - peringatkan, bisukan (1 jam / 24 jam / 7 hari), hapus profil atau atur ulang nama; semua tindakan dicatat</a:t>
+              <a:t>Perlengkapan arena di Toko: 7 senjata (pistol air sampai peluncur roket), 5 baju zirah dan 5 gadget yang menentukan gerakan spesialmu - perlengkapan lebih baik dan level lebih tinggi membuat petarung lebih kuat</a:t>
             </a:r>
           </a:p>
           <a:p>
@@ -8583,7 +8608,32 @@
                 </a:solidFill>
                 <a:latin typeface="Segoe UI"/>
               </a:rPr>
-              <a:t>Tombol Laporkan di profil setiap orang, agar moderator bisa menjaga Pips tetap ramah</a:t>
+              <a:t>Duel langsung bisa ditonton semua orang, plus tayangan ulang, petarung teratas, rating dan rekor menang/kalah; kemenangan memberi koin</a:t>
+            </a:r>
+          </a:p>
+          <a:p>
+            <a:pPr>
+              <a:spcAft>
+                <a:spcPts val="500"/>
+              </a:spcAft>
+            </a:pPr>
+            <a:r>
+              <a:rPr sz="1200" b="1">
+                <a:solidFill>
+                  <a:srgbClr val="4CB86B"/>
+                </a:solidFill>
+                <a:latin typeface="Segoe UI"/>
+              </a:rPr>
+              <a:t>•  </a:t>
+            </a:r>
+            <a:r>
+              <a:rPr sz="1200">
+                <a:solidFill>
+                  <a:srgbClr val="2B2A28"/>
+                </a:solidFill>
+                <a:latin typeface="Segoe UI"/>
+              </a:rPr>
+              <a:t>★ Perlengkapan Premium: meriam plasma, baju robot dan medan pelindung</a:t>
             </a:r>
           </a:p>
         </p:txBody>
@@ -8815,7 +8865,7 @@
         </p:nvGraphicFramePr>
         <p:xfrm>
           <a:off x="548640" y="1645920"/>
-          <a:ext cx="11155680" cy="11905488"/>
+          <a:ext cx="11155680" cy="12728448"/>
         </p:xfrm>
         <a:graphic>
           <a:graphicData uri="http://schemas.openxmlformats.org/drawingml/2006/table">
@@ -8909,7 +8959,7 @@
                           </a:solidFill>
                           <a:latin typeface="Segoe UI"/>
                         </a:rPr>
-                        <a:t>2.7.0</a:t>
+                        <a:t>2.8.0</a:t>
                       </a:r>
                     </a:p>
                   </a:txBody>
@@ -8953,7 +9003,7 @@
                           </a:solidFill>
                           <a:latin typeface="Segoe UI"/>
                         </a:rPr>
-                        <a:t>Moderators &amp; Premium</a:t>
+                        <a:t>Pips Arena - duels, gear &amp; live battles</a:t>
                       </a:r>
                     </a:p>
                     <a:p>
@@ -8964,7 +9014,7 @@
                           </a:solidFill>
                           <a:latin typeface="Segoe UI"/>
                         </a:rPr>
-                        <a:t>★ Premium: a purple Premium badge, 4 exclusive props (tiara, star glasses, diamond necklace, fairy wings), the Fireworks move, +30 coins every day, double friend-interaction coins and room for 300 friends / 30 groups; Get Premium: Profile tab → Premium → "Ask to buy" emails the owner; after payment you receive a key (PIPS-XXXX-XXXX) to redeem right there; 🛡 Moderators: a blue Mod badge and a Mod tab with the report queue - warn, mute (1h / 24h / 7 days), clear a profile or reset a name; every action is logged; Report button on everyone's profile, so moderators can keep Pips friendly</a:t>
+                        <a:t>⚔ New Arena tab: challenge friends or anyone in the arena to a live duel - each round pick Attack, Guard or Special within 12 seconds and watch your pets fight; ⚡ Quick battle: an instant auto-fight against anyone's fighter, even when they're offline; Arena gear in the Shop: 7 weapons (water pistol to rocket launcher), 5 armors and 5 gadgets that decide your special move - better gear and a higher level make a stronger fighter; Live duels can be watched by everyone, plus recent battle replays, top fighters, rating and win/loss records; wins earn coins</a:t>
                       </a:r>
                     </a:p>
                   </a:txBody>
@@ -8988,7 +9038,7 @@
                           </a:solidFill>
                           <a:latin typeface="Segoe UI"/>
                         </a:rPr>
-                        <a:t>2.6.1</a:t>
+                        <a:t>2.7.0</a:t>
                       </a:r>
                     </a:p>
                   </a:txBody>
@@ -9032,7 +9082,7 @@
                           </a:solidFill>
                           <a:latin typeface="Segoe UI"/>
                         </a:rPr>
-                        <a:t>Owner badge &amp; credits</a:t>
+                        <a:t>Moderators &amp; Premium</a:t>
                       </a:r>
                     </a:p>
                     <a:p>
@@ -9043,7 +9093,7 @@
                           </a:solidFill>
                           <a:latin typeface="Segoe UI"/>
                         </a:rPr>
-                        <a:t>The creator of Pips (Juwen Lie) now shows a gold ♛ Owner badge on his profile, friend list and ranks; New About Pips card in the Profile tab: credits and how to contact the owner (Juwen_Lie@pegatroncorp.com) with Email and Copy buttons; Right-click the pet → Help → About now shows who made Pips and the contact email</a:t>
+                        <a:t>★ Premium: a purple Premium badge, 4 exclusive props (tiara, star glasses, diamond necklace, fairy wings), the Fireworks move, +30 coins every day, double friend-interaction coins and room for 300 friends / 30 groups; Get Premium: Profile tab → Premium → "Ask to buy" emails the owner; after payment you receive a key (PIPS-XXXX-XXXX) to redeem right there; 🛡 Moderators: a blue Mod badge and a Mod tab with the report queue - warn, mute (1h / 24h / 7 days), clear a profile or reset a name; every action is logged; Report button on everyone's profile, so moderators can keep Pips friendly</a:t>
                       </a:r>
                     </a:p>
                   </a:txBody>
@@ -9067,7 +9117,7 @@
                           </a:solidFill>
                           <a:latin typeface="Segoe UI"/>
                         </a:rPr>
-                        <a:t>2.6.0</a:t>
+                        <a:t>2.6.1</a:t>
                       </a:r>
                     </a:p>
                   </a:txBody>
@@ -9111,7 +9161,7 @@
                           </a:solidFill>
                           <a:latin typeface="Segoe UI"/>
                         </a:rPr>
-                        <a:t>Profiles, ranks, online status &amp; dark mode</a:t>
+                        <a:t>Owner badge &amp; credits</a:t>
                       </a:r>
                     </a:p>
                     <a:p>
@@ -9122,7 +9172,7 @@
                           </a:solidFill>
                           <a:latin typeface="Segoe UI"/>
                         </a:rPr>
-                        <a:t>Profile tab: profile picture (or your pet), about me, job, location, hobbies, birthday and a status message; Public or private: public profiles can be added directly and viewed in full; private profiles need a friend request that they accept, and strangers only see name, photo, pet, level and status; Click anyone to open their profile - badges, info, their friends - and add them, chat or wave from there; Ranks tab replaces Teams: everyone using Pips, sorted by XP, badges or streak</a:t>
+                        <a:t>The creator of Pips (Juwen Lie) now shows a gold ♛ Owner badge on his profile, friend list and ranks; New About Pips card in the Profile tab: credits and how to contact the owner (Juwen_Lie@pegatroncorp.com) with Email and Copy buttons; Right-click the pet → Help → About now shows who made Pips and the contact email</a:t>
                       </a:r>
                     </a:p>
                   </a:txBody>
@@ -9146,7 +9196,7 @@
                           </a:solidFill>
                           <a:latin typeface="Segoe UI"/>
                         </a:rPr>
-                        <a:t>2.5.1</a:t>
+                        <a:t>2.6.0</a:t>
                       </a:r>
                     </a:p>
                   </a:txBody>
@@ -9190,7 +9240,7 @@
                           </a:solidFill>
                           <a:latin typeface="Segoe UI"/>
                         </a:rPr>
-                        <a:t>New cute Pips logo</a:t>
+                        <a:t>Profiles, ranks, online status &amp; dark mode</a:t>
                       </a:r>
                     </a:p>
                     <a:p>
@@ -9201,7 +9251,7 @@
                           </a:solidFill>
                           <a:latin typeface="Segoe UI"/>
                         </a:rPr>
-                        <a:t>New Pips logo: Pip the cat on a Pips-red tile, matching the app colours (desktop shortcut, windows and website)</a:t>
+                        <a:t>Profile tab: profile picture (or your pet), about me, job, location, hobbies, birthday and a status message; Public or private: public profiles can be added directly and viewed in full; private profiles need a friend request that they accept, and strangers only see name, photo, pet, level and status; Click anyone to open their profile - badges, info, their friends - and add them, chat or wave from there; Ranks tab replaces Teams: everyone using Pips, sorted by XP, badges or streak</a:t>
                       </a:r>
                     </a:p>
                   </a:txBody>
@@ -9225,7 +9275,7 @@
                           </a:solidFill>
                           <a:latin typeface="Segoe UI"/>
                         </a:rPr>
-                        <a:t>2.5.0</a:t>
+                        <a:t>2.5.1</a:t>
                       </a:r>
                     </a:p>
                   </a:txBody>
@@ -9269,7 +9319,7 @@
                           </a:solidFill>
                           <a:latin typeface="Segoe UI"/>
                         </a:rPr>
-                        <a:t>Shop, coins, props &amp; moves</a:t>
+                        <a:t>New cute Pips logo</a:t>
                       </a:r>
                     </a:p>
                     <a:p>
@@ -9280,7 +9330,7 @@
                           </a:solidFill>
                           <a:latin typeface="Segoe UI"/>
                         </a:rPr>
-                        <a:t>Shop: earn coins and spend them on your pet - 17 props (crown, wizard hat, headphones, shades, scarf, cape, angel wings...) and 6 moves: spin, dance, moonwalk, backflip, kung fu and spider swing!; Coins come from leveling up (+40), badges (+25), opening Pips each day (+10), friendships (+15 per affinity level), waving / chatting / visiting friends (+2) and pomodoros (+5). Everyone starts with a 100-coin gift; Your friends see your props: on avatars in the hub and when your pet visits their desktop - it shows off one of your moves; Pips is now a social pet: clicking the pet opens the Pips hub (friends, chat, groups, shop, badges)</a:t>
+                        <a:t>New Pips logo: Pip the cat on a Pips-red tile, matching the app colours (desktop shortcut, windows and website)</a:t>
                       </a:r>
                     </a:p>
                   </a:txBody>
@@ -9304,7 +9354,7 @@
                           </a:solidFill>
                           <a:latin typeface="Segoe UI"/>
                         </a:rPr>
-                        <a:t>2.4.0</a:t>
+                        <a:t>2.5.0</a:t>
                       </a:r>
                     </a:p>
                   </a:txBody>
@@ -9348,7 +9398,7 @@
                           </a:solidFill>
                           <a:latin typeface="Segoe UI"/>
                         </a:rPr>
-                        <a:t>Chat, groups, affinity &amp; pet visits</a:t>
+                        <a:t>Shop, coins, props &amp; moves</a:t>
                       </a:r>
                     </a:p>
                     <a:p>
@@ -9359,7 +9409,7 @@
                           </a:solidFill>
                           <a:latin typeface="Segoe UI"/>
                         </a:rPr>
-                        <a:t>Chat: message your friends, and chat inside groups. Your pet pops up new messages as a bubble - click it to reply; Pet interactions: wave, pet their pet, send a snack, high five - or send your pet to visit: it walks onto your friend's desktop for a little while!; Affinity: every chat and interaction grows your friendship - Acquaintance → Buddy → Good friends → Close friends → Best friends → Soulmates; Your own groups: create a private group, invite your friends, they accept or decline. Group board + group chat; the owner can remove members</a:t>
+                        <a:t>Shop: earn coins and spend them on your pet - 17 props (crown, wizard hat, headphones, shades, scarf, cape, angel wings...) and 6 moves: spin, dance, moonwalk, backflip, kung fu and spider swing!; Coins come from leveling up (+40), badges (+25), opening Pips each day (+10), friendships (+15 per affinity level), waving / chatting / visiting friends (+2) and pomodoros (+5). Everyone starts with a 100-coin gift; Your friends see your props: on avatars in the hub and when your pet visits their desktop - it shows off one of your moves; Pips is now a social pet: clicking the pet opens the Pips hub (friends, chat, groups, shop, badges)</a:t>
                       </a:r>
                     </a:p>
                   </a:txBody>
@@ -9383,7 +9433,7 @@
                           </a:solidFill>
                           <a:latin typeface="Segoe UI"/>
                         </a:rPr>
-                        <a:t>2.3.0</a:t>
+                        <a:t>2.4.0</a:t>
                       </a:r>
                     </a:p>
                   </a:txBody>
@@ -9427,7 +9477,7 @@
                           </a:solidFill>
                           <a:latin typeface="Segoe UI"/>
                         </a:rPr>
-                        <a:t>Friends, levels &amp; achievements</a:t>
+                        <a:t>Chat, groups, affinity &amp; pet visits</a:t>
                       </a:r>
                     </a:p>
                     <a:p>
@@ -9438,7 +9488,7 @@
                           </a:solidFill>
                           <a:latin typeface="Segoe UI"/>
                         </a:rPr>
-                        <a:t>Levels &amp; XP: every finished pomodoro earns XP and your level grows - plus 20 achievements to unlock (first tomato, 8 in a day, 7-day streak, early bird, night owl, pet lover...). Your pet celebrates each one; Friends (optional, off by default): get a 6-letter friend code, add colleagues, see today's board and join a team board like PTB. Your pet tells you when a friend finishes a pomodoro; Privacy: only your name, pet, level, streak and pomodoro counts are shared - never apps, window titles or scores. One click turns it off and deletes your online data. Right-click the pet → Friends &amp; achievements…</a:t>
+                        <a:t>Chat: message your friends, and chat inside groups. Your pet pops up new messages as a bubble - click it to reply; Pet interactions: wave, pet their pet, send a snack, high five - or send your pet to visit: it walks onto your friend's desktop for a little while!; Affinity: every chat and interaction grows your friendship - Acquaintance → Buddy → Good friends → Close friends → Best friends → Soulmates; Your own groups: create a private group, invite your friends, they accept or decline. Group board + group chat; the owner can remove members</a:t>
                       </a:r>
                     </a:p>
                   </a:txBody>
@@ -9462,7 +9512,7 @@
                           </a:solidFill>
                           <a:latin typeface="Segoe UI"/>
                         </a:rPr>
-                        <a:t>2.2.0</a:t>
+                        <a:t>2.3.0</a:t>
                       </a:r>
                     </a:p>
                   </a:txBody>
@@ -9506,7 +9556,7 @@
                           </a:solidFill>
                           <a:latin typeface="Segoe UI"/>
                         </a:rPr>
-                        <a:t>Pet sounds</a:t>
+                        <a:t>Friends, levels &amp; achievements</a:t>
                       </a:r>
                     </a:p>
                     <a:p>
@@ -9517,7 +9567,7 @@
                           </a:solidFill>
                           <a:latin typeface="Segoe UI"/>
                         </a:rPr>
-                        <a:t>Your pet has a voice! Each of the 23 animals has its own sound (meow, woof, ribbit, hoot, buzz, oink, whale song...) and it changes with its mood: happy chirps, sad whimpers, sleepy yawns, hungry calls, grumpy huffs and soft snores; It also reacts with sound when you tickle, pet, feed, shake or wake it; Settings: right-click the pet → Sounds to switch on/off; Pet status &amp; settings has a volume slider, a ▶ Hear me button and "Stay quiet while I'm focusing" (on by default)</a:t>
+                        <a:t>Levels &amp; XP: every finished pomodoro earns XP and your level grows - plus 20 achievements to unlock (first tomato, 8 in a day, 7-day streak, early bird, night owl, pet lover...). Your pet celebrates each one; Friends (optional, off by default): get a 6-letter friend code, add colleagues, see today's board and join a team board like PTB. Your pet tells you when a friend finishes a pomodoro; Privacy: only your name, pet, level, streak and pomodoro counts are shared - never apps, window titles or scores. One click turns it off and deletes your online data. Right-click the pet → Friends &amp; achievements…</a:t>
                       </a:r>
                     </a:p>
                   </a:txBody>
@@ -9541,7 +9591,7 @@
                           </a:solidFill>
                           <a:latin typeface="Segoe UI"/>
                         </a:rPr>
-                        <a:t>2.1.2</a:t>
+                        <a:t>2.2.0</a:t>
                       </a:r>
                     </a:p>
                   </a:txBody>
@@ -9585,7 +9635,7 @@
                           </a:solidFill>
                           <a:latin typeface="Segoe UI"/>
                         </a:rPr>
-                        <a:t>Tickle-only mode</a:t>
+                        <a:t>Pet sounds</a:t>
                       </a:r>
                     </a:p>
                     <a:p>
@@ -9596,7 +9646,7 @@
                           </a:solidFill>
                           <a:latin typeface="Segoe UI"/>
                         </a:rPr>
-                        <a:t>New click option "Only tickle (never open Pips)": click and tickle your pet as much as you like - the Pomodoro window stays closed (open it from the right-click menu). Right-click the pet → When I click</a:t>
+                        <a:t>Your pet has a voice! Each of the 23 animals has its own sound (meow, woof, ribbit, hoot, buzz, oink, whale song...) and it changes with its mood: happy chirps, sad whimpers, sleepy yawns, hungry calls, grumpy huffs and soft snores; It also reacts with sound when you tickle, pet, feed, shake or wake it; Settings: right-click the pet → Sounds to switch on/off; Pet status &amp; settings has a volume slider, a ▶ Hear me button and "Stay quiet while I'm focusing" (on by default)</a:t>
                       </a:r>
                     </a:p>
                   </a:txBody>
@@ -9620,7 +9670,7 @@
                           </a:solidFill>
                           <a:latin typeface="Segoe UI"/>
                         </a:rPr>
-                        <a:t>2.1.1</a:t>
+                        <a:t>2.1.2</a:t>
                       </a:r>
                     </a:p>
                   </a:txBody>
@@ -9664,7 +9714,7 @@
                           </a:solidFill>
                           <a:latin typeface="Segoe UI"/>
                         </a:rPr>
-                        <a:t>Owner info</a:t>
+                        <a:t>Tickle-only mode</a:t>
                       </a:r>
                     </a:p>
                     <a:p>
@@ -9675,7 +9725,7 @@
                           </a:solidFill>
                           <a:latin typeface="Segoe UI"/>
                         </a:rPr>
-                        <a:t>About Pips now shows the owner: Juwen Lie (right-click the pet → Help → About)</a:t>
+                        <a:t>New click option "Only tickle (never open Pips)": click and tickle your pet as much as you like - the Pomodoro window stays closed (open it from the right-click menu). Right-click the pet → When I click</a:t>
                       </a:r>
                     </a:p>
                   </a:txBody>
@@ -9699,7 +9749,7 @@
                           </a:solidFill>
                           <a:latin typeface="Segoe UI"/>
                         </a:rPr>
-                        <a:t>2.1.0</a:t>
+                        <a:t>2.1.1</a:t>
                       </a:r>
                     </a:p>
                   </a:txBody>
@@ -9743,7 +9793,7 @@
                           </a:solidFill>
                           <a:latin typeface="Segoe UI"/>
                         </a:rPr>
-                        <a:t>Interactive guide &amp; in-app updates</a:t>
+                        <a:t>Owner info</a:t>
                       </a:r>
                     </a:p>
                     <a:p>
@@ -9754,7 +9804,7 @@
                           </a:solidFill>
                           <a:latin typeface="Segoe UI"/>
                         </a:rPr>
-                        <a:t>Interactive first-run guide: your pet walks you through clicking, dragging, petting and the right-click menu; In-app updates: Pips tells you when a new version is out - update with one click (your settings and data are kept); New Help menu: replay the guide, check for updates, see the version; Option to turn automatic update checks off</a:t>
+                        <a:t>About Pips now shows the owner: Juwen Lie (right-click the pet → Help → About)</a:t>
                       </a:r>
                     </a:p>
                   </a:txBody>
@@ -9778,7 +9828,7 @@
                           </a:solidFill>
                           <a:latin typeface="Segoe UI"/>
                         </a:rPr>
-                        <a:t>2.0.0</a:t>
+                        <a:t>2.1.0</a:t>
                       </a:r>
                     </a:p>
                   </a:txBody>
@@ -9822,7 +9872,7 @@
                           </a:solidFill>
                           <a:latin typeface="Segoe UI"/>
                         </a:rPr>
-                        <a:t>Desktop pet, 23 animals &amp; 4 languages</a:t>
+                        <a:t>Interactive guide &amp; in-app updates</a:t>
                       </a:r>
                     </a:p>
                     <a:p>
@@ -9833,7 +9883,7 @@
                           </a:solidFill>
                           <a:latin typeface="Segoe UI"/>
                         </a:rPr>
-                        <a:t>Desktop pet that lives on your desktop and taskbar - drag it, tickle it, pet it; 23 animals in 3 groups: Land walks, Water swims with bubbles, Sky hovers and flaps; Moods (happy, sad, tired, hungry, grumpy...), naps when you're away, wakes up when you're back; Cute chat-bubble reminders: breaks, water, 20-20-20 eye rest, pomodoro done, daily goal</a:t>
+                        <a:t>Interactive first-run guide: your pet walks you through clicking, dragging, petting and the right-click menu; In-app updates: Pips tells you when a new version is out - update with one click (your settings and data are kept); New Help menu: replay the guide, check for updates, see the version; Option to turn automatic update checks off</a:t>
                       </a:r>
                     </a:p>
                   </a:txBody>
@@ -9857,7 +9907,7 @@
                           </a:solidFill>
                           <a:latin typeface="Segoe UI"/>
                         </a:rPr>
-                        <a:t>1.5.0</a:t>
+                        <a:t>2.0.0</a:t>
                       </a:r>
                     </a:p>
                   </a:txBody>
@@ -9879,13 +9929,92 @@
                           </a:solidFill>
                           <a:latin typeface="Segoe UI"/>
                         </a:rPr>
+                        <a:t>2026-10-28</a:t>
+                      </a:r>
+                    </a:p>
+                  </a:txBody>
+                  <a:tcPr marL="73152" marR="73152" marT="36576" marB="36576">
+                    <a:solidFill>
+                      <a:srgbClr val="FFFDF8"/>
+                    </a:solidFill>
+                  </a:tcPr>
+                </a:tc>
+                <a:tc>
+                  <a:txBody>
+                    <a:bodyPr wrap="square"/>
+                    <a:lstStyle/>
+                    <a:p>
+                      <a:r>
+                        <a:rPr sz="1200" b="0">
+                          <a:solidFill>
+                            <a:srgbClr val="2B2A28"/>
+                          </a:solidFill>
+                          <a:latin typeface="Segoe UI"/>
+                        </a:rPr>
+                        <a:t>Desktop pet, 23 animals &amp; 4 languages</a:t>
+                      </a:r>
+                    </a:p>
+                    <a:p>
+                      <a:r>
+                        <a:rPr sz="1200" b="0">
+                          <a:solidFill>
+                            <a:srgbClr val="2B2A28"/>
+                          </a:solidFill>
+                          <a:latin typeface="Segoe UI"/>
+                        </a:rPr>
+                        <a:t>Desktop pet that lives on your desktop and taskbar - drag it, tickle it, pet it; 23 animals in 3 groups: Land walks, Water swims with bubbles, Sky hovers and flaps; Moods (happy, sad, tired, hungry, grumpy...), naps when you're away, wakes up when you're back; Cute chat-bubble reminders: breaks, water, 20-20-20 eye rest, pomodoro done, daily goal</a:t>
+                      </a:r>
+                    </a:p>
+                  </a:txBody>
+                  <a:tcPr marL="73152" marR="73152" marT="36576" marB="36576">
+                    <a:solidFill>
+                      <a:srgbClr val="FFFDF8"/>
+                    </a:solidFill>
+                  </a:tcPr>
+                </a:tc>
+              </a:tr>
+              <a:tr h="822960">
+                <a:tc>
+                  <a:txBody>
+                    <a:bodyPr wrap="square"/>
+                    <a:lstStyle/>
+                    <a:p>
+                      <a:r>
+                        <a:rPr sz="1200" b="1">
+                          <a:solidFill>
+                            <a:srgbClr val="2B2A28"/>
+                          </a:solidFill>
+                          <a:latin typeface="Segoe UI"/>
+                        </a:rPr>
+                        <a:t>1.5.0</a:t>
+                      </a:r>
+                    </a:p>
+                  </a:txBody>
+                  <a:tcPr marL="73152" marR="73152" marT="36576" marB="36576">
+                    <a:solidFill>
+                      <a:srgbClr val="F7F4EC"/>
+                    </a:solidFill>
+                  </a:tcPr>
+                </a:tc>
+                <a:tc>
+                  <a:txBody>
+                    <a:bodyPr wrap="square"/>
+                    <a:lstStyle/>
+                    <a:p>
+                      <a:r>
+                        <a:rPr sz="1200" b="0">
+                          <a:solidFill>
+                            <a:srgbClr val="2B2A28"/>
+                          </a:solidFill>
+                          <a:latin typeface="Segoe UI"/>
+                        </a:rPr>
                         <a:t>2026-10-24</a:t>
                       </a:r>
                     </a:p>
                   </a:txBody>
                   <a:tcPr marL="73152" marR="73152" marT="36576" marB="36576">
                     <a:solidFill>
-                      <a:srgbClr val="FFFDF8"/>
+                      <a:srgbClr val="F7F4EC"/>
                     </a:solidFill>
                   </a:tcPr>
                 </a:tc>
@@ -9918,7 +10047,7 @@
                   </a:txBody>
                   <a:tcPr marL="73152" marR="73152" marT="36576" marB="36576">
                     <a:solidFill>
-                      <a:srgbClr val="FFFDF8"/>
+                      <a:srgbClr val="F7F4EC"/>
                     </a:solidFill>
                   </a:tcPr>
                 </a:tc>
@@ -9942,7 +10071,7 @@
                   </a:txBody>
                   <a:tcPr marL="73152" marR="73152" marT="36576" marB="36576">
                     <a:solidFill>
-                      <a:srgbClr val="F7F4EC"/>
+                      <a:srgbClr val="FFFDF8"/>
                     </a:solidFill>
                   </a:tcPr>
                 </a:tc>
@@ -9964,7 +10093,7 @@
                   </a:txBody>
                   <a:tcPr marL="73152" marR="73152" marT="36576" marB="36576">
                     <a:solidFill>
-                      <a:srgbClr val="F7F4EC"/>
+                      <a:srgbClr val="FFFDF8"/>
                     </a:solidFill>
                   </a:tcPr>
                 </a:tc>
@@ -9997,7 +10126,7 @@
                   </a:txBody>
                   <a:tcPr marL="73152" marR="73152" marT="36576" marB="36576">
                     <a:solidFill>
-                      <a:srgbClr val="F7F4EC"/>
+                      <a:srgbClr val="FFFDF8"/>
                     </a:solidFill>
                   </a:tcPr>
                 </a:tc>

</xml_diff>

<commit_message>
pips 2.9.0: Location & live weather
</commit_message>
<xml_diff>
--- a/apps/pips/web/download/Pips-Guide.pptx
+++ b/apps/pips/web/download/Pips-Guide.pptx
@@ -3292,7 +3292,7 @@
                 </a:solidFill>
                 <a:latin typeface="Segoe UI"/>
               </a:rPr>
-              <a:t>Version 2.8.0  ·  2026-10-28  ·  Made by Juwen Lie (owner)</a:t>
+              <a:t>Version 2.9.0  ·  2026-10-28  ·  Made by Juwen Lie (owner)</a:t>
             </a:r>
           </a:p>
           <a:p>
@@ -8141,7 +8141,7 @@
                 </a:solidFill>
                 <a:latin typeface="Segoe UI"/>
               </a:rPr>
-              <a:t>What's new in 2.8.0</a:t>
+              <a:t>What's new in 2.9.0</a:t>
             </a:r>
           </a:p>
         </p:txBody>
@@ -8254,7 +8254,7 @@
                 </a:solidFill>
                 <a:latin typeface="Segoe UI"/>
               </a:rPr>
-              <a:t>Pips Arena - duels, gear &amp; live battles  ·  2026-10-28</a:t>
+              <a:t>Location &amp; live weather  ·  2026-10-28</a:t>
             </a:r>
           </a:p>
         </p:txBody>
@@ -8302,7 +8302,7 @@
                 </a:solidFill>
                 <a:latin typeface="Segoe UI"/>
               </a:rPr>
-              <a:t>⚔ New Arena tab: challenge friends or anyone in the arena to a live duel - each round pick Attack, Guard or Special within 12 seconds and watch your pets fight</a:t>
+              <a:t>📍 Add your city in Profile → Location &amp; weather (auto-detect or search) - only your city and country are shown, never your exact position</a:t>
             </a:r>
           </a:p>
           <a:p>
@@ -8327,7 +8327,7 @@
                 </a:solidFill>
                 <a:latin typeface="Segoe UI"/>
               </a:rPr>
-              <a:t>⚡ Quick battle: an instant auto-fight against anyone's fighter, even when they're offline</a:t>
+              <a:t>Live weather banners on every profile with animations: rain, drizzle, thunderstorms with lightning, snow, fog, clouds, sunshine or a starry night - plus temperature, feels-like, humidity, wind and local time</a:t>
             </a:r>
           </a:p>
           <a:p>
@@ -8352,7 +8352,7 @@
                 </a:solidFill>
                 <a:latin typeface="Segoe UI"/>
               </a:rPr>
-              <a:t>Arena gear in the Shop: 7 weapons (water pistol to rocket launcher), 5 armors and 5 gadgets that decide your special move - better gear and a higher level make a stronger fighter</a:t>
+              <a:t>Your own weather strip on top of the hub, and each friend's weather + local time in the friends list</a:t>
             </a:r>
           </a:p>
           <a:p>
@@ -8377,32 +8377,7 @@
                 </a:solidFill>
                 <a:latin typeface="Segoe UI"/>
               </a:rPr>
-              <a:t>Live duels can be watched by everyone, plus recent battle replays, top fighters, rating and win/loss records; wins earn coins</a:t>
-            </a:r>
-          </a:p>
-          <a:p>
-            <a:pPr>
-              <a:spcAft>
-                <a:spcPts val="1000"/>
-              </a:spcAft>
-            </a:pPr>
-            <a:r>
-              <a:rPr sz="1700" b="1">
-                <a:solidFill>
-                  <a:srgbClr val="4CB86B"/>
-                </a:solidFill>
-                <a:latin typeface="Segoe UI"/>
-              </a:rPr>
-              <a:t>•  </a:t>
-            </a:r>
-            <a:r>
-              <a:rPr sz="1700">
-                <a:solidFill>
-                  <a:srgbClr val="2B2A28"/>
-                </a:solidFill>
-                <a:latin typeface="Segoe UI"/>
-              </a:rPr>
-              <a:t>★ Premium gear: plasma cannon, mech suit and force field</a:t>
+              <a:t>Hide your location from others or remove it any time</a:t>
             </a:r>
           </a:p>
         </p:txBody>
@@ -8533,7 +8508,7 @@
                 </a:solidFill>
                 <a:latin typeface="Segoe UI"/>
               </a:rPr>
-              <a:t>⚔ Tab Arena baru: tantang teman atau siapa saja di arena untuk duel langsung - setiap ronde pilih Serang, Bertahan atau Spesial dalam 12 detik dan tonton peliharaanmu bertarung</a:t>
+              <a:t>📍 Tambahkan kotamu di Profil → Lokasi &amp; cuaca (deteksi otomatis atau cari) - hanya kota dan negaramu yang ditampilkan, tidak pernah posisi persismu</a:t>
             </a:r>
           </a:p>
           <a:p>
@@ -8558,7 +8533,7 @@
                 </a:solidFill>
                 <a:latin typeface="Segoe UI"/>
               </a:rPr>
-              <a:t>⚡ Tarung cepat: pertarungan otomatis instan melawan petarung siapa saja, bahkan saat mereka offline</a:t>
+              <a:t>Banner cuaca langsung di setiap profil dengan animasi: hujan, gerimis, badai petir dengan kilat, salju, kabut, awan, cerah atau malam berbintang - plus suhu, terasa seperti, kelembapan, angin dan waktu setempat</a:t>
             </a:r>
           </a:p>
           <a:p>
@@ -8583,7 +8558,7 @@
                 </a:solidFill>
                 <a:latin typeface="Segoe UI"/>
               </a:rPr>
-              <a:t>Perlengkapan arena di Toko: 7 senjata (pistol air sampai peluncur roket), 5 baju zirah dan 5 gadget yang menentukan gerakan spesialmu - perlengkapan lebih baik dan level lebih tinggi membuat petarung lebih kuat</a:t>
+              <a:t>Strip cuacamu sendiri di atas hub, dan cuaca + waktu setempat setiap teman di daftar teman</a:t>
             </a:r>
           </a:p>
           <a:p>
@@ -8608,32 +8583,7 @@
                 </a:solidFill>
                 <a:latin typeface="Segoe UI"/>
               </a:rPr>
-              <a:t>Duel langsung bisa ditonton semua orang, plus tayangan ulang, petarung teratas, rating dan rekor menang/kalah; kemenangan memberi koin</a:t>
-            </a:r>
-          </a:p>
-          <a:p>
-            <a:pPr>
-              <a:spcAft>
-                <a:spcPts val="500"/>
-              </a:spcAft>
-            </a:pPr>
-            <a:r>
-              <a:rPr sz="1200" b="1">
-                <a:solidFill>
-                  <a:srgbClr val="4CB86B"/>
-                </a:solidFill>
-                <a:latin typeface="Segoe UI"/>
-              </a:rPr>
-              <a:t>•  </a:t>
-            </a:r>
-            <a:r>
-              <a:rPr sz="1200">
-                <a:solidFill>
-                  <a:srgbClr val="2B2A28"/>
-                </a:solidFill>
-                <a:latin typeface="Segoe UI"/>
-              </a:rPr>
-              <a:t>★ Perlengkapan Premium: meriam plasma, baju robot dan medan pelindung</a:t>
+              <a:t>Sembunyikan lokasimu dari orang lain atau hapus kapan saja</a:t>
             </a:r>
           </a:p>
         </p:txBody>
@@ -8865,7 +8815,7 @@
         </p:nvGraphicFramePr>
         <p:xfrm>
           <a:off x="548640" y="1645920"/>
-          <a:ext cx="11155680" cy="12728448"/>
+          <a:ext cx="11155680" cy="13551408"/>
         </p:xfrm>
         <a:graphic>
           <a:graphicData uri="http://schemas.openxmlformats.org/drawingml/2006/table">
@@ -8959,7 +8909,7 @@
                           </a:solidFill>
                           <a:latin typeface="Segoe UI"/>
                         </a:rPr>
-                        <a:t>2.8.0</a:t>
+                        <a:t>2.9.0</a:t>
                       </a:r>
                     </a:p>
                   </a:txBody>
@@ -9003,7 +8953,7 @@
                           </a:solidFill>
                           <a:latin typeface="Segoe UI"/>
                         </a:rPr>
-                        <a:t>Pips Arena - duels, gear &amp; live battles</a:t>
+                        <a:t>Location &amp; live weather</a:t>
                       </a:r>
                     </a:p>
                     <a:p>
@@ -9014,7 +8964,7 @@
                           </a:solidFill>
                           <a:latin typeface="Segoe UI"/>
                         </a:rPr>
-                        <a:t>⚔ New Arena tab: challenge friends or anyone in the arena to a live duel - each round pick Attack, Guard or Special within 12 seconds and watch your pets fight; ⚡ Quick battle: an instant auto-fight against anyone's fighter, even when they're offline; Arena gear in the Shop: 7 weapons (water pistol to rocket launcher), 5 armors and 5 gadgets that decide your special move - better gear and a higher level make a stronger fighter; Live duels can be watched by everyone, plus recent battle replays, top fighters, rating and win/loss records; wins earn coins</a:t>
+                        <a:t>📍 Add your city in Profile → Location &amp; weather (auto-detect or search) - only your city and country are shown, never your exact position; Live weather banners on every profile with animations: rain, drizzle, thunderstorms with lightning, snow, fog, clouds, sunshine or a starry night - plus temperature, feels-like, humidity, wind and local time; Your own weather strip on top of the hub, and each friend's weather + local time in the friends list; Hide your location from others or remove it any time</a:t>
                       </a:r>
                     </a:p>
                   </a:txBody>
@@ -9038,7 +8988,7 @@
                           </a:solidFill>
                           <a:latin typeface="Segoe UI"/>
                         </a:rPr>
-                        <a:t>2.7.0</a:t>
+                        <a:t>2.8.0</a:t>
                       </a:r>
                     </a:p>
                   </a:txBody>
@@ -9082,7 +9032,7 @@
                           </a:solidFill>
                           <a:latin typeface="Segoe UI"/>
                         </a:rPr>
-                        <a:t>Moderators &amp; Premium</a:t>
+                        <a:t>Pips Arena - duels, gear &amp; live battles</a:t>
                       </a:r>
                     </a:p>
                     <a:p>
@@ -9093,7 +9043,7 @@
                           </a:solidFill>
                           <a:latin typeface="Segoe UI"/>
                         </a:rPr>
-                        <a:t>★ Premium: a purple Premium badge, 4 exclusive props (tiara, star glasses, diamond necklace, fairy wings), the Fireworks move, +30 coins every day, double friend-interaction coins and room for 300 friends / 30 groups; Get Premium: Profile tab → Premium → "Ask to buy" emails the owner; after payment you receive a key (PIPS-XXXX-XXXX) to redeem right there; 🛡 Moderators: a blue Mod badge and a Mod tab with the report queue - warn, mute (1h / 24h / 7 days), clear a profile or reset a name; every action is logged; Report button on everyone's profile, so moderators can keep Pips friendly</a:t>
+                        <a:t>⚔ New Arena tab: challenge friends or anyone in the arena to a live duel - each round pick Attack, Guard or Special within 12 seconds and watch your pets fight; ⚡ Quick battle: an instant auto-fight against anyone's fighter, even when they're offline; Arena gear in the Shop: 7 weapons (water pistol to rocket launcher), 5 armors and 5 gadgets that decide your special move - better gear and a higher level make a stronger fighter; Live duels can be watched by everyone, plus recent battle replays, top fighters, rating and win/loss records; wins earn coins</a:t>
                       </a:r>
                     </a:p>
                   </a:txBody>
@@ -9117,7 +9067,7 @@
                           </a:solidFill>
                           <a:latin typeface="Segoe UI"/>
                         </a:rPr>
-                        <a:t>2.6.1</a:t>
+                        <a:t>2.7.0</a:t>
                       </a:r>
                     </a:p>
                   </a:txBody>
@@ -9161,7 +9111,7 @@
                           </a:solidFill>
                           <a:latin typeface="Segoe UI"/>
                         </a:rPr>
-                        <a:t>Owner badge &amp; credits</a:t>
+                        <a:t>Moderators &amp; Premium</a:t>
                       </a:r>
                     </a:p>
                     <a:p>
@@ -9172,7 +9122,7 @@
                           </a:solidFill>
                           <a:latin typeface="Segoe UI"/>
                         </a:rPr>
-                        <a:t>The creator of Pips (Juwen Lie) now shows a gold ♛ Owner badge on his profile, friend list and ranks; New About Pips card in the Profile tab: credits and how to contact the owner (Juwen_Lie@pegatroncorp.com) with Email and Copy buttons; Right-click the pet → Help → About now shows who made Pips and the contact email</a:t>
+                        <a:t>★ Premium: a purple Premium badge, 4 exclusive props (tiara, star glasses, diamond necklace, fairy wings), the Fireworks move, +30 coins every day, double friend-interaction coins and room for 300 friends / 30 groups; Get Premium: Profile tab → Premium → "Ask to buy" emails the owner; after payment you receive a key (PIPS-XXXX-XXXX) to redeem right there; 🛡 Moderators: a blue Mod badge and a Mod tab with the report queue - warn, mute (1h / 24h / 7 days), clear a profile or reset a name; every action is logged; Report button on everyone's profile, so moderators can keep Pips friendly</a:t>
                       </a:r>
                     </a:p>
                   </a:txBody>
@@ -9196,7 +9146,7 @@
                           </a:solidFill>
                           <a:latin typeface="Segoe UI"/>
                         </a:rPr>
-                        <a:t>2.6.0</a:t>
+                        <a:t>2.6.1</a:t>
                       </a:r>
                     </a:p>
                   </a:txBody>
@@ -9240,7 +9190,7 @@
                           </a:solidFill>
                           <a:latin typeface="Segoe UI"/>
                         </a:rPr>
-                        <a:t>Profiles, ranks, online status &amp; dark mode</a:t>
+                        <a:t>Owner badge &amp; credits</a:t>
                       </a:r>
                     </a:p>
                     <a:p>
@@ -9251,7 +9201,7 @@
                           </a:solidFill>
                           <a:latin typeface="Segoe UI"/>
                         </a:rPr>
-                        <a:t>Profile tab: profile picture (or your pet), about me, job, location, hobbies, birthday and a status message; Public or private: public profiles can be added directly and viewed in full; private profiles need a friend request that they accept, and strangers only see name, photo, pet, level and status; Click anyone to open their profile - badges, info, their friends - and add them, chat or wave from there; Ranks tab replaces Teams: everyone using Pips, sorted by XP, badges or streak</a:t>
+                        <a:t>The creator of Pips (Juwen Lie) now shows a gold ♛ Owner badge on his profile, friend list and ranks; New About Pips card in the Profile tab: credits and how to contact the owner (Juwen_Lie@pegatroncorp.com) with Email and Copy buttons; Right-click the pet → Help → About now shows who made Pips and the contact email</a:t>
                       </a:r>
                     </a:p>
                   </a:txBody>
@@ -9275,7 +9225,7 @@
                           </a:solidFill>
                           <a:latin typeface="Segoe UI"/>
                         </a:rPr>
-                        <a:t>2.5.1</a:t>
+                        <a:t>2.6.0</a:t>
                       </a:r>
                     </a:p>
                   </a:txBody>
@@ -9319,7 +9269,7 @@
                           </a:solidFill>
                           <a:latin typeface="Segoe UI"/>
                         </a:rPr>
-                        <a:t>New cute Pips logo</a:t>
+                        <a:t>Profiles, ranks, online status &amp; dark mode</a:t>
                       </a:r>
                     </a:p>
                     <a:p>
@@ -9330,7 +9280,7 @@
                           </a:solidFill>
                           <a:latin typeface="Segoe UI"/>
                         </a:rPr>
-                        <a:t>New Pips logo: Pip the cat on a Pips-red tile, matching the app colours (desktop shortcut, windows and website)</a:t>
+                        <a:t>Profile tab: profile picture (or your pet), about me, job, location, hobbies, birthday and a status message; Public or private: public profiles can be added directly and viewed in full; private profiles need a friend request that they accept, and strangers only see name, photo, pet, level and status; Click anyone to open their profile - badges, info, their friends - and add them, chat or wave from there; Ranks tab replaces Teams: everyone using Pips, sorted by XP, badges or streak</a:t>
                       </a:r>
                     </a:p>
                   </a:txBody>
@@ -9354,7 +9304,7 @@
                           </a:solidFill>
                           <a:latin typeface="Segoe UI"/>
                         </a:rPr>
-                        <a:t>2.5.0</a:t>
+                        <a:t>2.5.1</a:t>
                       </a:r>
                     </a:p>
                   </a:txBody>
@@ -9398,7 +9348,7 @@
                           </a:solidFill>
                           <a:latin typeface="Segoe UI"/>
                         </a:rPr>
-                        <a:t>Shop, coins, props &amp; moves</a:t>
+                        <a:t>New cute Pips logo</a:t>
                       </a:r>
                     </a:p>
                     <a:p>
@@ -9409,7 +9359,7 @@
                           </a:solidFill>
                           <a:latin typeface="Segoe UI"/>
                         </a:rPr>
-                        <a:t>Shop: earn coins and spend them on your pet - 17 props (crown, wizard hat, headphones, shades, scarf, cape, angel wings...) and 6 moves: spin, dance, moonwalk, backflip, kung fu and spider swing!; Coins come from leveling up (+40), badges (+25), opening Pips each day (+10), friendships (+15 per affinity level), waving / chatting / visiting friends (+2) and pomodoros (+5). Everyone starts with a 100-coin gift; Your friends see your props: on avatars in the hub and when your pet visits their desktop - it shows off one of your moves; Pips is now a social pet: clicking the pet opens the Pips hub (friends, chat, groups, shop, badges)</a:t>
+                        <a:t>New Pips logo: Pip the cat on a Pips-red tile, matching the app colours (desktop shortcut, windows and website)</a:t>
                       </a:r>
                     </a:p>
                   </a:txBody>
@@ -9433,7 +9383,7 @@
                           </a:solidFill>
                           <a:latin typeface="Segoe UI"/>
                         </a:rPr>
-                        <a:t>2.4.0</a:t>
+                        <a:t>2.5.0</a:t>
                       </a:r>
                     </a:p>
                   </a:txBody>
@@ -9477,7 +9427,7 @@
                           </a:solidFill>
                           <a:latin typeface="Segoe UI"/>
                         </a:rPr>
-                        <a:t>Chat, groups, affinity &amp; pet visits</a:t>
+                        <a:t>Shop, coins, props &amp; moves</a:t>
                       </a:r>
                     </a:p>
                     <a:p>
@@ -9488,7 +9438,7 @@
                           </a:solidFill>
                           <a:latin typeface="Segoe UI"/>
                         </a:rPr>
-                        <a:t>Chat: message your friends, and chat inside groups. Your pet pops up new messages as a bubble - click it to reply; Pet interactions: wave, pet their pet, send a snack, high five - or send your pet to visit: it walks onto your friend's desktop for a little while!; Affinity: every chat and interaction grows your friendship - Acquaintance → Buddy → Good friends → Close friends → Best friends → Soulmates; Your own groups: create a private group, invite your friends, they accept or decline. Group board + group chat; the owner can remove members</a:t>
+                        <a:t>Shop: earn coins and spend them on your pet - 17 props (crown, wizard hat, headphones, shades, scarf, cape, angel wings...) and 6 moves: spin, dance, moonwalk, backflip, kung fu and spider swing!; Coins come from leveling up (+40), badges (+25), opening Pips each day (+10), friendships (+15 per affinity level), waving / chatting / visiting friends (+2) and pomodoros (+5). Everyone starts with a 100-coin gift; Your friends see your props: on avatars in the hub and when your pet visits their desktop - it shows off one of your moves; Pips is now a social pet: clicking the pet opens the Pips hub (friends, chat, groups, shop, badges)</a:t>
                       </a:r>
                     </a:p>
                   </a:txBody>
@@ -9512,7 +9462,7 @@
                           </a:solidFill>
                           <a:latin typeface="Segoe UI"/>
                         </a:rPr>
-                        <a:t>2.3.0</a:t>
+                        <a:t>2.4.0</a:t>
                       </a:r>
                     </a:p>
                   </a:txBody>
@@ -9556,7 +9506,7 @@
                           </a:solidFill>
                           <a:latin typeface="Segoe UI"/>
                         </a:rPr>
-                        <a:t>Friends, levels &amp; achievements</a:t>
+                        <a:t>Chat, groups, affinity &amp; pet visits</a:t>
                       </a:r>
                     </a:p>
                     <a:p>
@@ -9567,7 +9517,7 @@
                           </a:solidFill>
                           <a:latin typeface="Segoe UI"/>
                         </a:rPr>
-                        <a:t>Levels &amp; XP: every finished pomodoro earns XP and your level grows - plus 20 achievements to unlock (first tomato, 8 in a day, 7-day streak, early bird, night owl, pet lover...). Your pet celebrates each one; Friends (optional, off by default): get a 6-letter friend code, add colleagues, see today's board and join a team board like PTB. Your pet tells you when a friend finishes a pomodoro; Privacy: only your name, pet, level, streak and pomodoro counts are shared - never apps, window titles or scores. One click turns it off and deletes your online data. Right-click the pet → Friends &amp; achievements…</a:t>
+                        <a:t>Chat: message your friends, and chat inside groups. Your pet pops up new messages as a bubble - click it to reply; Pet interactions: wave, pet their pet, send a snack, high five - or send your pet to visit: it walks onto your friend's desktop for a little while!; Affinity: every chat and interaction grows your friendship - Acquaintance → Buddy → Good friends → Close friends → Best friends → Soulmates; Your own groups: create a private group, invite your friends, they accept or decline. Group board + group chat; the owner can remove members</a:t>
                       </a:r>
                     </a:p>
                   </a:txBody>
@@ -9591,7 +9541,7 @@
                           </a:solidFill>
                           <a:latin typeface="Segoe UI"/>
                         </a:rPr>
-                        <a:t>2.2.0</a:t>
+                        <a:t>2.3.0</a:t>
                       </a:r>
                     </a:p>
                   </a:txBody>
@@ -9635,7 +9585,7 @@
                           </a:solidFill>
                           <a:latin typeface="Segoe UI"/>
                         </a:rPr>
-                        <a:t>Pet sounds</a:t>
+                        <a:t>Friends, levels &amp; achievements</a:t>
                       </a:r>
                     </a:p>
                     <a:p>
@@ -9646,7 +9596,7 @@
                           </a:solidFill>
                           <a:latin typeface="Segoe UI"/>
                         </a:rPr>
-                        <a:t>Your pet has a voice! Each of the 23 animals has its own sound (meow, woof, ribbit, hoot, buzz, oink, whale song...) and it changes with its mood: happy chirps, sad whimpers, sleepy yawns, hungry calls, grumpy huffs and soft snores; It also reacts with sound when you tickle, pet, feed, shake or wake it; Settings: right-click the pet → Sounds to switch on/off; Pet status &amp; settings has a volume slider, a ▶ Hear me button and "Stay quiet while I'm focusing" (on by default)</a:t>
+                        <a:t>Levels &amp; XP: every finished pomodoro earns XP and your level grows - plus 20 achievements to unlock (first tomato, 8 in a day, 7-day streak, early bird, night owl, pet lover...). Your pet celebrates each one; Friends (optional, off by default): get a 6-letter friend code, add colleagues, see today's board and join a team board like PTB. Your pet tells you when a friend finishes a pomodoro; Privacy: only your name, pet, level, streak and pomodoro counts are shared - never apps, window titles or scores. One click turns it off and deletes your online data. Right-click the pet → Friends &amp; achievements…</a:t>
                       </a:r>
                     </a:p>
                   </a:txBody>
@@ -9670,7 +9620,7 @@
                           </a:solidFill>
                           <a:latin typeface="Segoe UI"/>
                         </a:rPr>
-                        <a:t>2.1.2</a:t>
+                        <a:t>2.2.0</a:t>
                       </a:r>
                     </a:p>
                   </a:txBody>
@@ -9714,7 +9664,7 @@
                           </a:solidFill>
                           <a:latin typeface="Segoe UI"/>
                         </a:rPr>
-                        <a:t>Tickle-only mode</a:t>
+                        <a:t>Pet sounds</a:t>
                       </a:r>
                     </a:p>
                     <a:p>
@@ -9725,7 +9675,7 @@
                           </a:solidFill>
                           <a:latin typeface="Segoe UI"/>
                         </a:rPr>
-                        <a:t>New click option "Only tickle (never open Pips)": click and tickle your pet as much as you like - the Pomodoro window stays closed (open it from the right-click menu). Right-click the pet → When I click</a:t>
+                        <a:t>Your pet has a voice! Each of the 23 animals has its own sound (meow, woof, ribbit, hoot, buzz, oink, whale song...) and it changes with its mood: happy chirps, sad whimpers, sleepy yawns, hungry calls, grumpy huffs and soft snores; It also reacts with sound when you tickle, pet, feed, shake or wake it; Settings: right-click the pet → Sounds to switch on/off; Pet status &amp; settings has a volume slider, a ▶ Hear me button and "Stay quiet while I'm focusing" (on by default)</a:t>
                       </a:r>
                     </a:p>
                   </a:txBody>
@@ -9749,7 +9699,7 @@
                           </a:solidFill>
                           <a:latin typeface="Segoe UI"/>
                         </a:rPr>
-                        <a:t>2.1.1</a:t>
+                        <a:t>2.1.2</a:t>
                       </a:r>
                     </a:p>
                   </a:txBody>
@@ -9793,7 +9743,7 @@
                           </a:solidFill>
                           <a:latin typeface="Segoe UI"/>
                         </a:rPr>
-                        <a:t>Owner info</a:t>
+                        <a:t>Tickle-only mode</a:t>
                       </a:r>
                     </a:p>
                     <a:p>
@@ -9804,7 +9754,7 @@
                           </a:solidFill>
                           <a:latin typeface="Segoe UI"/>
                         </a:rPr>
-                        <a:t>About Pips now shows the owner: Juwen Lie (right-click the pet → Help → About)</a:t>
+                        <a:t>New click option "Only tickle (never open Pips)": click and tickle your pet as much as you like - the Pomodoro window stays closed (open it from the right-click menu). Right-click the pet → When I click</a:t>
                       </a:r>
                     </a:p>
                   </a:txBody>
@@ -9828,7 +9778,7 @@
                           </a:solidFill>
                           <a:latin typeface="Segoe UI"/>
                         </a:rPr>
-                        <a:t>2.1.0</a:t>
+                        <a:t>2.1.1</a:t>
                       </a:r>
                     </a:p>
                   </a:txBody>
@@ -9872,7 +9822,7 @@
                           </a:solidFill>
                           <a:latin typeface="Segoe UI"/>
                         </a:rPr>
-                        <a:t>Interactive guide &amp; in-app updates</a:t>
+                        <a:t>Owner info</a:t>
                       </a:r>
                     </a:p>
                     <a:p>
@@ -9883,7 +9833,7 @@
                           </a:solidFill>
                           <a:latin typeface="Segoe UI"/>
                         </a:rPr>
-                        <a:t>Interactive first-run guide: your pet walks you through clicking, dragging, petting and the right-click menu; In-app updates: Pips tells you when a new version is out - update with one click (your settings and data are kept); New Help menu: replay the guide, check for updates, see the version; Option to turn automatic update checks off</a:t>
+                        <a:t>About Pips now shows the owner: Juwen Lie (right-click the pet → Help → About)</a:t>
                       </a:r>
                     </a:p>
                   </a:txBody>
@@ -9907,7 +9857,7 @@
                           </a:solidFill>
                           <a:latin typeface="Segoe UI"/>
                         </a:rPr>
-                        <a:t>2.0.0</a:t>
+                        <a:t>2.1.0</a:t>
                       </a:r>
                     </a:p>
                   </a:txBody>
@@ -9951,7 +9901,7 @@
                           </a:solidFill>
                           <a:latin typeface="Segoe UI"/>
                         </a:rPr>
-                        <a:t>Desktop pet, 23 animals &amp; 4 languages</a:t>
+                        <a:t>Interactive guide &amp; in-app updates</a:t>
                       </a:r>
                     </a:p>
                     <a:p>
@@ -9962,7 +9912,7 @@
                           </a:solidFill>
                           <a:latin typeface="Segoe UI"/>
                         </a:rPr>
-                        <a:t>Desktop pet that lives on your desktop and taskbar - drag it, tickle it, pet it; 23 animals in 3 groups: Land walks, Water swims with bubbles, Sky hovers and flaps; Moods (happy, sad, tired, hungry, grumpy...), naps when you're away, wakes up when you're back; Cute chat-bubble reminders: breaks, water, 20-20-20 eye rest, pomodoro done, daily goal</a:t>
+                        <a:t>Interactive first-run guide: your pet walks you through clicking, dragging, petting and the right-click menu; In-app updates: Pips tells you when a new version is out - update with one click (your settings and data are kept); New Help menu: replay the guide, check for updates, see the version; Option to turn automatic update checks off</a:t>
                       </a:r>
                     </a:p>
                   </a:txBody>
@@ -9986,7 +9936,7 @@
                           </a:solidFill>
                           <a:latin typeface="Segoe UI"/>
                         </a:rPr>
-                        <a:t>1.5.0</a:t>
+                        <a:t>2.0.0</a:t>
                       </a:r>
                     </a:p>
                   </a:txBody>
@@ -10008,13 +9958,92 @@
                           </a:solidFill>
                           <a:latin typeface="Segoe UI"/>
                         </a:rPr>
+                        <a:t>2026-10-28</a:t>
+                      </a:r>
+                    </a:p>
+                  </a:txBody>
+                  <a:tcPr marL="73152" marR="73152" marT="36576" marB="36576">
+                    <a:solidFill>
+                      <a:srgbClr val="F7F4EC"/>
+                    </a:solidFill>
+                  </a:tcPr>
+                </a:tc>
+                <a:tc>
+                  <a:txBody>
+                    <a:bodyPr wrap="square"/>
+                    <a:lstStyle/>
+                    <a:p>
+                      <a:r>
+                        <a:rPr sz="1200" b="0">
+                          <a:solidFill>
+                            <a:srgbClr val="2B2A28"/>
+                          </a:solidFill>
+                          <a:latin typeface="Segoe UI"/>
+                        </a:rPr>
+                        <a:t>Desktop pet, 23 animals &amp; 4 languages</a:t>
+                      </a:r>
+                    </a:p>
+                    <a:p>
+                      <a:r>
+                        <a:rPr sz="1200" b="0">
+                          <a:solidFill>
+                            <a:srgbClr val="2B2A28"/>
+                          </a:solidFill>
+                          <a:latin typeface="Segoe UI"/>
+                        </a:rPr>
+                        <a:t>Desktop pet that lives on your desktop and taskbar - drag it, tickle it, pet it; 23 animals in 3 groups: Land walks, Water swims with bubbles, Sky hovers and flaps; Moods (happy, sad, tired, hungry, grumpy...), naps when you're away, wakes up when you're back; Cute chat-bubble reminders: breaks, water, 20-20-20 eye rest, pomodoro done, daily goal</a:t>
+                      </a:r>
+                    </a:p>
+                  </a:txBody>
+                  <a:tcPr marL="73152" marR="73152" marT="36576" marB="36576">
+                    <a:solidFill>
+                      <a:srgbClr val="F7F4EC"/>
+                    </a:solidFill>
+                  </a:tcPr>
+                </a:tc>
+              </a:tr>
+              <a:tr h="822960">
+                <a:tc>
+                  <a:txBody>
+                    <a:bodyPr wrap="square"/>
+                    <a:lstStyle/>
+                    <a:p>
+                      <a:r>
+                        <a:rPr sz="1200" b="1">
+                          <a:solidFill>
+                            <a:srgbClr val="2B2A28"/>
+                          </a:solidFill>
+                          <a:latin typeface="Segoe UI"/>
+                        </a:rPr>
+                        <a:t>1.5.0</a:t>
+                      </a:r>
+                    </a:p>
+                  </a:txBody>
+                  <a:tcPr marL="73152" marR="73152" marT="36576" marB="36576">
+                    <a:solidFill>
+                      <a:srgbClr val="FFFDF8"/>
+                    </a:solidFill>
+                  </a:tcPr>
+                </a:tc>
+                <a:tc>
+                  <a:txBody>
+                    <a:bodyPr wrap="square"/>
+                    <a:lstStyle/>
+                    <a:p>
+                      <a:r>
+                        <a:rPr sz="1200" b="0">
+                          <a:solidFill>
+                            <a:srgbClr val="2B2A28"/>
+                          </a:solidFill>
+                          <a:latin typeface="Segoe UI"/>
+                        </a:rPr>
                         <a:t>2026-10-24</a:t>
                       </a:r>
                     </a:p>
                   </a:txBody>
                   <a:tcPr marL="73152" marR="73152" marT="36576" marB="36576">
                     <a:solidFill>
-                      <a:srgbClr val="F7F4EC"/>
+                      <a:srgbClr val="FFFDF8"/>
                     </a:solidFill>
                   </a:tcPr>
                 </a:tc>
@@ -10047,7 +10076,7 @@
                   </a:txBody>
                   <a:tcPr marL="73152" marR="73152" marT="36576" marB="36576">
                     <a:solidFill>
-                      <a:srgbClr val="F7F4EC"/>
+                      <a:srgbClr val="FFFDF8"/>
                     </a:solidFill>
                   </a:tcPr>
                 </a:tc>
@@ -10071,7 +10100,7 @@
                   </a:txBody>
                   <a:tcPr marL="73152" marR="73152" marT="36576" marB="36576">
                     <a:solidFill>
-                      <a:srgbClr val="FFFDF8"/>
+                      <a:srgbClr val="F7F4EC"/>
                     </a:solidFill>
                   </a:tcPr>
                 </a:tc>
@@ -10093,7 +10122,7 @@
                   </a:txBody>
                   <a:tcPr marL="73152" marR="73152" marT="36576" marB="36576">
                     <a:solidFill>
-                      <a:srgbClr val="FFFDF8"/>
+                      <a:srgbClr val="F7F4EC"/>
                     </a:solidFill>
                   </a:tcPr>
                 </a:tc>
@@ -10126,7 +10155,7 @@
                   </a:txBody>
                   <a:tcPr marL="73152" marR="73152" marT="36576" marB="36576">
                     <a:solidFill>
-                      <a:srgbClr val="FFFDF8"/>
+                      <a:srgbClr val="F7F4EC"/>
                     </a:solidFill>
                   </a:tcPr>
                 </a:tc>

</xml_diff>

<commit_message>
pips 2.10.0: Chat bots
</commit_message>
<xml_diff>
--- a/apps/pips/web/download/Pips-Guide.pptx
+++ b/apps/pips/web/download/Pips-Guide.pptx
@@ -3292,7 +3292,7 @@
                 </a:solidFill>
                 <a:latin typeface="Segoe UI"/>
               </a:rPr>
-              <a:t>Version 2.9.0  ·  2026-10-28  ·  Made by Juwen Lie (owner)</a:t>
+              <a:t>Version 2.10.0  ·  2026-10-28  ·  Made by Juwen Lie (owner)</a:t>
             </a:r>
           </a:p>
           <a:p>
@@ -8141,7 +8141,7 @@
                 </a:solidFill>
                 <a:latin typeface="Segoe UI"/>
               </a:rPr>
-              <a:t>What's new in 2.9.0</a:t>
+              <a:t>What's new in 2.10.0</a:t>
             </a:r>
           </a:p>
         </p:txBody>
@@ -8254,7 +8254,7 @@
                 </a:solidFill>
                 <a:latin typeface="Segoe UI"/>
               </a:rPr>
-              <a:t>Location &amp; live weather  ·  2026-10-28</a:t>
+              <a:t>Chat bots  ·  2026-10-28</a:t>
             </a:r>
           </a:p>
         </p:txBody>
@@ -8302,7 +8302,7 @@
                 </a:solidFill>
                 <a:latin typeface="Segoe UI"/>
               </a:rPr>
-              <a:t>📍 Add your city in Profile → Location &amp; weather (auto-detect or search) - only your city and country are shown, never your exact position</a:t>
+              <a:t>🤖 6 friendly chat bots in the Chat tab: Pip Helper (app questions), Coach Focus (focus tips from your real stats), Sunny (live weather for any city), Arena Master (battle tips + quick battle), Giggles (jokes &amp; games) and Guardian (safety &amp; reporting help)</a:t>
             </a:r>
           </a:p>
           <a:p>
@@ -8327,7 +8327,7 @@
                 </a:solidFill>
                 <a:latin typeface="Segoe UI"/>
               </a:rPr>
-              <a:t>Live weather banners on every profile with animations: rain, drizzle, thunderstorms with lightning, snow, fog, clouds, sunshine or a starry night - plus temperature, feels-like, humidity, wind and local time</a:t>
+              <a:t>Private bot chats with suggestion chips, typing indicator and a clear button - your bot chats stay on your PC</a:t>
             </a:r>
           </a:p>
           <a:p>
@@ -8352,7 +8352,7 @@
                 </a:solidFill>
                 <a:latin typeface="Segoe UI"/>
               </a:rPr>
-              <a:t>Your own weather strip on top of the hub, and each friend's weather + local time in the friends list</a:t>
+              <a:t>Mention a bot in a group chat (e.g. @weather Batam) and it answers in the room for everyone</a:t>
             </a:r>
           </a:p>
           <a:p>
@@ -8377,7 +8377,7 @@
                 </a:solidFill>
                 <a:latin typeface="Segoe UI"/>
               </a:rPr>
-              <a:t>Hide your location from others or remove it any time</a:t>
+              <a:t>Bots reply in your app language; up to 120 bot messages per day</a:t>
             </a:r>
           </a:p>
         </p:txBody>
@@ -8508,7 +8508,7 @@
                 </a:solidFill>
                 <a:latin typeface="Segoe UI"/>
               </a:rPr>
-              <a:t>📍 Tambahkan kotamu di Profil → Lokasi &amp; cuaca (deteksi otomatis atau cari) - hanya kota dan negaramu yang ditampilkan, tidak pernah posisi persismu</a:t>
+              <a:t>🤖 6 bot obrolan di tab Chat: Pip Helper (pertanyaan aplikasi), Coach Focus (tips fokus dari statistikmu), Sunny (cuaca langsung kota mana pun), Arena Master (tips bertarung + quick battle), Giggles (lelucon &amp; permainan) dan Guardian (bantuan keamanan &amp; laporan)</a:t>
             </a:r>
           </a:p>
           <a:p>
@@ -8533,7 +8533,7 @@
                 </a:solidFill>
                 <a:latin typeface="Segoe UI"/>
               </a:rPr>
-              <a:t>Banner cuaca langsung di setiap profil dengan animasi: hujan, gerimis, badai petir dengan kilat, salju, kabut, awan, cerah atau malam berbintang - plus suhu, terasa seperti, kelembapan, angin dan waktu setempat</a:t>
+              <a:t>Chat pribadi dengan bot lengkap dengan saran pertanyaan, indikator mengetik dan tombol hapus - chat bot tersimpan di PC-mu</a:t>
             </a:r>
           </a:p>
           <a:p>
@@ -8558,7 +8558,7 @@
                 </a:solidFill>
                 <a:latin typeface="Segoe UI"/>
               </a:rPr>
-              <a:t>Strip cuacamu sendiri di atas hub, dan cuaca + waktu setempat setiap teman di daftar teman</a:t>
+              <a:t>Sebut bot di grup (mis. @weather Batam) dan bot akan menjawab di grup untuk semua</a:t>
             </a:r>
           </a:p>
           <a:p>
@@ -8583,7 +8583,7 @@
                 </a:solidFill>
                 <a:latin typeface="Segoe UI"/>
               </a:rPr>
-              <a:t>Sembunyikan lokasimu dari orang lain atau hapus kapan saja</a:t>
+              <a:t>Bot menjawab dalam bahasa aplikasimu; maksimal 120 pesan bot per hari</a:t>
             </a:r>
           </a:p>
         </p:txBody>
@@ -8815,7 +8815,7 @@
         </p:nvGraphicFramePr>
         <p:xfrm>
           <a:off x="548640" y="1645920"/>
-          <a:ext cx="11155680" cy="13551408"/>
+          <a:ext cx="11155680" cy="14374368"/>
         </p:xfrm>
         <a:graphic>
           <a:graphicData uri="http://schemas.openxmlformats.org/drawingml/2006/table">
@@ -8909,7 +8909,7 @@
                           </a:solidFill>
                           <a:latin typeface="Segoe UI"/>
                         </a:rPr>
-                        <a:t>2.9.0</a:t>
+                        <a:t>2.10.0</a:t>
                       </a:r>
                     </a:p>
                   </a:txBody>
@@ -8953,7 +8953,7 @@
                           </a:solidFill>
                           <a:latin typeface="Segoe UI"/>
                         </a:rPr>
-                        <a:t>Location &amp; live weather</a:t>
+                        <a:t>Chat bots</a:t>
                       </a:r>
                     </a:p>
                     <a:p>
@@ -8964,7 +8964,7 @@
                           </a:solidFill>
                           <a:latin typeface="Segoe UI"/>
                         </a:rPr>
-                        <a:t>📍 Add your city in Profile → Location &amp; weather (auto-detect or search) - only your city and country are shown, never your exact position; Live weather banners on every profile with animations: rain, drizzle, thunderstorms with lightning, snow, fog, clouds, sunshine or a starry night - plus temperature, feels-like, humidity, wind and local time; Your own weather strip on top of the hub, and each friend's weather + local time in the friends list; Hide your location from others or remove it any time</a:t>
+                        <a:t>🤖 6 friendly chat bots in the Chat tab: Pip Helper (app questions), Coach Focus (focus tips from your real stats), Sunny (live weather for any city), Arena Master (battle tips + quick battle), Giggles (jokes &amp; games) and Guardian (safety &amp; reporting help); Private bot chats with suggestion chips, typing indicator and a clear button - your bot chats stay on your PC; Mention a bot in a group chat (e.g. @weather Batam) and it answers in the room for everyone; Bots reply in your app language; up to 120 bot messages per day</a:t>
                       </a:r>
                     </a:p>
                   </a:txBody>
@@ -8988,7 +8988,7 @@
                           </a:solidFill>
                           <a:latin typeface="Segoe UI"/>
                         </a:rPr>
-                        <a:t>2.8.0</a:t>
+                        <a:t>2.9.0</a:t>
                       </a:r>
                     </a:p>
                   </a:txBody>
@@ -9032,7 +9032,7 @@
                           </a:solidFill>
                           <a:latin typeface="Segoe UI"/>
                         </a:rPr>
-                        <a:t>Pips Arena - duels, gear &amp; live battles</a:t>
+                        <a:t>Location &amp; live weather</a:t>
                       </a:r>
                     </a:p>
                     <a:p>
@@ -9043,7 +9043,7 @@
                           </a:solidFill>
                           <a:latin typeface="Segoe UI"/>
                         </a:rPr>
-                        <a:t>⚔ New Arena tab: challenge friends or anyone in the arena to a live duel - each round pick Attack, Guard or Special within 12 seconds and watch your pets fight; ⚡ Quick battle: an instant auto-fight against anyone's fighter, even when they're offline; Arena gear in the Shop: 7 weapons (water pistol to rocket launcher), 5 armors and 5 gadgets that decide your special move - better gear and a higher level make a stronger fighter; Live duels can be watched by everyone, plus recent battle replays, top fighters, rating and win/loss records; wins earn coins</a:t>
+                        <a:t>📍 Add your city in Profile → Location &amp; weather (auto-detect or search) - only your city and country are shown, never your exact position; Live weather banners on every profile with animations: rain, drizzle, thunderstorms with lightning, snow, fog, clouds, sunshine or a starry night - plus temperature, feels-like, humidity, wind and local time; Your own weather strip on top of the hub, and each friend's weather + local time in the friends list; Hide your location from others or remove it any time</a:t>
                       </a:r>
                     </a:p>
                   </a:txBody>
@@ -9067,7 +9067,7 @@
                           </a:solidFill>
                           <a:latin typeface="Segoe UI"/>
                         </a:rPr>
-                        <a:t>2.7.0</a:t>
+                        <a:t>2.8.0</a:t>
                       </a:r>
                     </a:p>
                   </a:txBody>
@@ -9111,7 +9111,7 @@
                           </a:solidFill>
                           <a:latin typeface="Segoe UI"/>
                         </a:rPr>
-                        <a:t>Moderators &amp; Premium</a:t>
+                        <a:t>Pips Arena - duels, gear &amp; live battles</a:t>
                       </a:r>
                     </a:p>
                     <a:p>
@@ -9122,7 +9122,7 @@
                           </a:solidFill>
                           <a:latin typeface="Segoe UI"/>
                         </a:rPr>
-                        <a:t>★ Premium: a purple Premium badge, 4 exclusive props (tiara, star glasses, diamond necklace, fairy wings), the Fireworks move, +30 coins every day, double friend-interaction coins and room for 300 friends / 30 groups; Get Premium: Profile tab → Premium → "Ask to buy" emails the owner; after payment you receive a key (PIPS-XXXX-XXXX) to redeem right there; 🛡 Moderators: a blue Mod badge and a Mod tab with the report queue - warn, mute (1h / 24h / 7 days), clear a profile or reset a name; every action is logged; Report button on everyone's profile, so moderators can keep Pips friendly</a:t>
+                        <a:t>⚔ New Arena tab: challenge friends or anyone in the arena to a live duel - each round pick Attack, Guard or Special within 12 seconds and watch your pets fight; ⚡ Quick battle: an instant auto-fight against anyone's fighter, even when they're offline; Arena gear in the Shop: 7 weapons (water pistol to rocket launcher), 5 armors and 5 gadgets that decide your special move - better gear and a higher level make a stronger fighter; Live duels can be watched by everyone, plus recent battle replays, top fighters, rating and win/loss records; wins earn coins</a:t>
                       </a:r>
                     </a:p>
                   </a:txBody>
@@ -9146,7 +9146,7 @@
                           </a:solidFill>
                           <a:latin typeface="Segoe UI"/>
                         </a:rPr>
-                        <a:t>2.6.1</a:t>
+                        <a:t>2.7.0</a:t>
                       </a:r>
                     </a:p>
                   </a:txBody>
@@ -9190,7 +9190,7 @@
                           </a:solidFill>
                           <a:latin typeface="Segoe UI"/>
                         </a:rPr>
-                        <a:t>Owner badge &amp; credits</a:t>
+                        <a:t>Moderators &amp; Premium</a:t>
                       </a:r>
                     </a:p>
                     <a:p>
@@ -9201,7 +9201,7 @@
                           </a:solidFill>
                           <a:latin typeface="Segoe UI"/>
                         </a:rPr>
-                        <a:t>The creator of Pips (Juwen Lie) now shows a gold ♛ Owner badge on his profile, friend list and ranks; New About Pips card in the Profile tab: credits and how to contact the owner (Juwen_Lie@pegatroncorp.com) with Email and Copy buttons; Right-click the pet → Help → About now shows who made Pips and the contact email</a:t>
+                        <a:t>★ Premium: a purple Premium badge, 4 exclusive props (tiara, star glasses, diamond necklace, fairy wings), the Fireworks move, +30 coins every day, double friend-interaction coins and room for 300 friends / 30 groups; Get Premium: Profile tab → Premium → "Ask to buy" emails the owner; after payment you receive a key (PIPS-XXXX-XXXX) to redeem right there; 🛡 Moderators: a blue Mod badge and a Mod tab with the report queue - warn, mute (1h / 24h / 7 days), clear a profile or reset a name; every action is logged; Report button on everyone's profile, so moderators can keep Pips friendly</a:t>
                       </a:r>
                     </a:p>
                   </a:txBody>
@@ -9225,7 +9225,7 @@
                           </a:solidFill>
                           <a:latin typeface="Segoe UI"/>
                         </a:rPr>
-                        <a:t>2.6.0</a:t>
+                        <a:t>2.6.1</a:t>
                       </a:r>
                     </a:p>
                   </a:txBody>
@@ -9269,7 +9269,7 @@
                           </a:solidFill>
                           <a:latin typeface="Segoe UI"/>
                         </a:rPr>
-                        <a:t>Profiles, ranks, online status &amp; dark mode</a:t>
+                        <a:t>Owner badge &amp; credits</a:t>
                       </a:r>
                     </a:p>
                     <a:p>
@@ -9280,7 +9280,7 @@
                           </a:solidFill>
                           <a:latin typeface="Segoe UI"/>
                         </a:rPr>
-                        <a:t>Profile tab: profile picture (or your pet), about me, job, location, hobbies, birthday and a status message; Public or private: public profiles can be added directly and viewed in full; private profiles need a friend request that they accept, and strangers only see name, photo, pet, level and status; Click anyone to open their profile - badges, info, their friends - and add them, chat or wave from there; Ranks tab replaces Teams: everyone using Pips, sorted by XP, badges or streak</a:t>
+                        <a:t>The creator of Pips (Juwen Lie) now shows a gold ♛ Owner badge on his profile, friend list and ranks; New About Pips card in the Profile tab: credits and how to contact the owner (Juwen_Lie@pegatroncorp.com) with Email and Copy buttons; Right-click the pet → Help → About now shows who made Pips and the contact email</a:t>
                       </a:r>
                     </a:p>
                   </a:txBody>
@@ -9304,7 +9304,7 @@
                           </a:solidFill>
                           <a:latin typeface="Segoe UI"/>
                         </a:rPr>
-                        <a:t>2.5.1</a:t>
+                        <a:t>2.6.0</a:t>
                       </a:r>
                     </a:p>
                   </a:txBody>
@@ -9348,7 +9348,7 @@
                           </a:solidFill>
                           <a:latin typeface="Segoe UI"/>
                         </a:rPr>
-                        <a:t>New cute Pips logo</a:t>
+                        <a:t>Profiles, ranks, online status &amp; dark mode</a:t>
                       </a:r>
                     </a:p>
                     <a:p>
@@ -9359,7 +9359,7 @@
                           </a:solidFill>
                           <a:latin typeface="Segoe UI"/>
                         </a:rPr>
-                        <a:t>New Pips logo: Pip the cat on a Pips-red tile, matching the app colours (desktop shortcut, windows and website)</a:t>
+                        <a:t>Profile tab: profile picture (or your pet), about me, job, location, hobbies, birthday and a status message; Public or private: public profiles can be added directly and viewed in full; private profiles need a friend request that they accept, and strangers only see name, photo, pet, level and status; Click anyone to open their profile - badges, info, their friends - and add them, chat or wave from there; Ranks tab replaces Teams: everyone using Pips, sorted by XP, badges or streak</a:t>
                       </a:r>
                     </a:p>
                   </a:txBody>
@@ -9383,7 +9383,7 @@
                           </a:solidFill>
                           <a:latin typeface="Segoe UI"/>
                         </a:rPr>
-                        <a:t>2.5.0</a:t>
+                        <a:t>2.5.1</a:t>
                       </a:r>
                     </a:p>
                   </a:txBody>
@@ -9427,7 +9427,7 @@
                           </a:solidFill>
                           <a:latin typeface="Segoe UI"/>
                         </a:rPr>
-                        <a:t>Shop, coins, props &amp; moves</a:t>
+                        <a:t>New cute Pips logo</a:t>
                       </a:r>
                     </a:p>
                     <a:p>
@@ -9438,7 +9438,7 @@
                           </a:solidFill>
                           <a:latin typeface="Segoe UI"/>
                         </a:rPr>
-                        <a:t>Shop: earn coins and spend them on your pet - 17 props (crown, wizard hat, headphones, shades, scarf, cape, angel wings...) and 6 moves: spin, dance, moonwalk, backflip, kung fu and spider swing!; Coins come from leveling up (+40), badges (+25), opening Pips each day (+10), friendships (+15 per affinity level), waving / chatting / visiting friends (+2) and pomodoros (+5). Everyone starts with a 100-coin gift; Your friends see your props: on avatars in the hub and when your pet visits their desktop - it shows off one of your moves; Pips is now a social pet: clicking the pet opens the Pips hub (friends, chat, groups, shop, badges)</a:t>
+                        <a:t>New Pips logo: Pip the cat on a Pips-red tile, matching the app colours (desktop shortcut, windows and website)</a:t>
                       </a:r>
                     </a:p>
                   </a:txBody>
@@ -9462,7 +9462,7 @@
                           </a:solidFill>
                           <a:latin typeface="Segoe UI"/>
                         </a:rPr>
-                        <a:t>2.4.0</a:t>
+                        <a:t>2.5.0</a:t>
                       </a:r>
                     </a:p>
                   </a:txBody>
@@ -9506,7 +9506,7 @@
                           </a:solidFill>
                           <a:latin typeface="Segoe UI"/>
                         </a:rPr>
-                        <a:t>Chat, groups, affinity &amp; pet visits</a:t>
+                        <a:t>Shop, coins, props &amp; moves</a:t>
                       </a:r>
                     </a:p>
                     <a:p>
@@ -9517,7 +9517,7 @@
                           </a:solidFill>
                           <a:latin typeface="Segoe UI"/>
                         </a:rPr>
-                        <a:t>Chat: message your friends, and chat inside groups. Your pet pops up new messages as a bubble - click it to reply; Pet interactions: wave, pet their pet, send a snack, high five - or send your pet to visit: it walks onto your friend's desktop for a little while!; Affinity: every chat and interaction grows your friendship - Acquaintance → Buddy → Good friends → Close friends → Best friends → Soulmates; Your own groups: create a private group, invite your friends, they accept or decline. Group board + group chat; the owner can remove members</a:t>
+                        <a:t>Shop: earn coins and spend them on your pet - 17 props (crown, wizard hat, headphones, shades, scarf, cape, angel wings...) and 6 moves: spin, dance, moonwalk, backflip, kung fu and spider swing!; Coins come from leveling up (+40), badges (+25), opening Pips each day (+10), friendships (+15 per affinity level), waving / chatting / visiting friends (+2) and pomodoros (+5). Everyone starts with a 100-coin gift; Your friends see your props: on avatars in the hub and when your pet visits their desktop - it shows off one of your moves; Pips is now a social pet: clicking the pet opens the Pips hub (friends, chat, groups, shop, badges)</a:t>
                       </a:r>
                     </a:p>
                   </a:txBody>
@@ -9541,7 +9541,7 @@
                           </a:solidFill>
                           <a:latin typeface="Segoe UI"/>
                         </a:rPr>
-                        <a:t>2.3.0</a:t>
+                        <a:t>2.4.0</a:t>
                       </a:r>
                     </a:p>
                   </a:txBody>
@@ -9585,7 +9585,7 @@
                           </a:solidFill>
                           <a:latin typeface="Segoe UI"/>
                         </a:rPr>
-                        <a:t>Friends, levels &amp; achievements</a:t>
+                        <a:t>Chat, groups, affinity &amp; pet visits</a:t>
                       </a:r>
                     </a:p>
                     <a:p>
@@ -9596,7 +9596,7 @@
                           </a:solidFill>
                           <a:latin typeface="Segoe UI"/>
                         </a:rPr>
-                        <a:t>Levels &amp; XP: every finished pomodoro earns XP and your level grows - plus 20 achievements to unlock (first tomato, 8 in a day, 7-day streak, early bird, night owl, pet lover...). Your pet celebrates each one; Friends (optional, off by default): get a 6-letter friend code, add colleagues, see today's board and join a team board like PTB. Your pet tells you when a friend finishes a pomodoro; Privacy: only your name, pet, level, streak and pomodoro counts are shared - never apps, window titles or scores. One click turns it off and deletes your online data. Right-click the pet → Friends &amp; achievements…</a:t>
+                        <a:t>Chat: message your friends, and chat inside groups. Your pet pops up new messages as a bubble - click it to reply; Pet interactions: wave, pet their pet, send a snack, high five - or send your pet to visit: it walks onto your friend's desktop for a little while!; Affinity: every chat and interaction grows your friendship - Acquaintance → Buddy → Good friends → Close friends → Best friends → Soulmates; Your own groups: create a private group, invite your friends, they accept or decline. Group board + group chat; the owner can remove members</a:t>
                       </a:r>
                     </a:p>
                   </a:txBody>
@@ -9620,7 +9620,7 @@
                           </a:solidFill>
                           <a:latin typeface="Segoe UI"/>
                         </a:rPr>
-                        <a:t>2.2.0</a:t>
+                        <a:t>2.3.0</a:t>
                       </a:r>
                     </a:p>
                   </a:txBody>
@@ -9664,7 +9664,7 @@
                           </a:solidFill>
                           <a:latin typeface="Segoe UI"/>
                         </a:rPr>
-                        <a:t>Pet sounds</a:t>
+                        <a:t>Friends, levels &amp; achievements</a:t>
                       </a:r>
                     </a:p>
                     <a:p>
@@ -9675,7 +9675,7 @@
                           </a:solidFill>
                           <a:latin typeface="Segoe UI"/>
                         </a:rPr>
-                        <a:t>Your pet has a voice! Each of the 23 animals has its own sound (meow, woof, ribbit, hoot, buzz, oink, whale song...) and it changes with its mood: happy chirps, sad whimpers, sleepy yawns, hungry calls, grumpy huffs and soft snores; It also reacts with sound when you tickle, pet, feed, shake or wake it; Settings: right-click the pet → Sounds to switch on/off; Pet status &amp; settings has a volume slider, a ▶ Hear me button and "Stay quiet while I'm focusing" (on by default)</a:t>
+                        <a:t>Levels &amp; XP: every finished pomodoro earns XP and your level grows - plus 20 achievements to unlock (first tomato, 8 in a day, 7-day streak, early bird, night owl, pet lover...). Your pet celebrates each one; Friends (optional, off by default): get a 6-letter friend code, add colleagues, see today's board and join a team board like PTB. Your pet tells you when a friend finishes a pomodoro; Privacy: only your name, pet, level, streak and pomodoro counts are shared - never apps, window titles or scores. One click turns it off and deletes your online data. Right-click the pet → Friends &amp; achievements…</a:t>
                       </a:r>
                     </a:p>
                   </a:txBody>
@@ -9699,7 +9699,7 @@
                           </a:solidFill>
                           <a:latin typeface="Segoe UI"/>
                         </a:rPr>
-                        <a:t>2.1.2</a:t>
+                        <a:t>2.2.0</a:t>
                       </a:r>
                     </a:p>
                   </a:txBody>
@@ -9743,7 +9743,7 @@
                           </a:solidFill>
                           <a:latin typeface="Segoe UI"/>
                         </a:rPr>
-                        <a:t>Tickle-only mode</a:t>
+                        <a:t>Pet sounds</a:t>
                       </a:r>
                     </a:p>
                     <a:p>
@@ -9754,7 +9754,7 @@
                           </a:solidFill>
                           <a:latin typeface="Segoe UI"/>
                         </a:rPr>
-                        <a:t>New click option "Only tickle (never open Pips)": click and tickle your pet as much as you like - the Pomodoro window stays closed (open it from the right-click menu). Right-click the pet → When I click</a:t>
+                        <a:t>Your pet has a voice! Each of the 23 animals has its own sound (meow, woof, ribbit, hoot, buzz, oink, whale song...) and it changes with its mood: happy chirps, sad whimpers, sleepy yawns, hungry calls, grumpy huffs and soft snores; It also reacts with sound when you tickle, pet, feed, shake or wake it; Settings: right-click the pet → Sounds to switch on/off; Pet status &amp; settings has a volume slider, a ▶ Hear me button and "Stay quiet while I'm focusing" (on by default)</a:t>
                       </a:r>
                     </a:p>
                   </a:txBody>
@@ -9778,7 +9778,7 @@
                           </a:solidFill>
                           <a:latin typeface="Segoe UI"/>
                         </a:rPr>
-                        <a:t>2.1.1</a:t>
+                        <a:t>2.1.2</a:t>
                       </a:r>
                     </a:p>
                   </a:txBody>
@@ -9822,7 +9822,7 @@
                           </a:solidFill>
                           <a:latin typeface="Segoe UI"/>
                         </a:rPr>
-                        <a:t>Owner info</a:t>
+                        <a:t>Tickle-only mode</a:t>
                       </a:r>
                     </a:p>
                     <a:p>
@@ -9833,7 +9833,7 @@
                           </a:solidFill>
                           <a:latin typeface="Segoe UI"/>
                         </a:rPr>
-                        <a:t>About Pips now shows the owner: Juwen Lie (right-click the pet → Help → About)</a:t>
+                        <a:t>New click option "Only tickle (never open Pips)": click and tickle your pet as much as you like - the Pomodoro window stays closed (open it from the right-click menu). Right-click the pet → When I click</a:t>
                       </a:r>
                     </a:p>
                   </a:txBody>
@@ -9857,7 +9857,7 @@
                           </a:solidFill>
                           <a:latin typeface="Segoe UI"/>
                         </a:rPr>
-                        <a:t>2.1.0</a:t>
+                        <a:t>2.1.1</a:t>
                       </a:r>
                     </a:p>
                   </a:txBody>
@@ -9901,7 +9901,7 @@
                           </a:solidFill>
                           <a:latin typeface="Segoe UI"/>
                         </a:rPr>
-                        <a:t>Interactive guide &amp; in-app updates</a:t>
+                        <a:t>Owner info</a:t>
                       </a:r>
                     </a:p>
                     <a:p>
@@ -9912,7 +9912,7 @@
                           </a:solidFill>
                           <a:latin typeface="Segoe UI"/>
                         </a:rPr>
-                        <a:t>Interactive first-run guide: your pet walks you through clicking, dragging, petting and the right-click menu; In-app updates: Pips tells you when a new version is out - update with one click (your settings and data are kept); New Help menu: replay the guide, check for updates, see the version; Option to turn automatic update checks off</a:t>
+                        <a:t>About Pips now shows the owner: Juwen Lie (right-click the pet → Help → About)</a:t>
                       </a:r>
                     </a:p>
                   </a:txBody>
@@ -9936,7 +9936,7 @@
                           </a:solidFill>
                           <a:latin typeface="Segoe UI"/>
                         </a:rPr>
-                        <a:t>2.0.0</a:t>
+                        <a:t>2.1.0</a:t>
                       </a:r>
                     </a:p>
                   </a:txBody>
@@ -9980,7 +9980,7 @@
                           </a:solidFill>
                           <a:latin typeface="Segoe UI"/>
                         </a:rPr>
-                        <a:t>Desktop pet, 23 animals &amp; 4 languages</a:t>
+                        <a:t>Interactive guide &amp; in-app updates</a:t>
                       </a:r>
                     </a:p>
                     <a:p>
@@ -9991,7 +9991,7 @@
                           </a:solidFill>
                           <a:latin typeface="Segoe UI"/>
                         </a:rPr>
-                        <a:t>Desktop pet that lives on your desktop and taskbar - drag it, tickle it, pet it; 23 animals in 3 groups: Land walks, Water swims with bubbles, Sky hovers and flaps; Moods (happy, sad, tired, hungry, grumpy...), naps when you're away, wakes up when you're back; Cute chat-bubble reminders: breaks, water, 20-20-20 eye rest, pomodoro done, daily goal</a:t>
+                        <a:t>Interactive first-run guide: your pet walks you through clicking, dragging, petting and the right-click menu; In-app updates: Pips tells you when a new version is out - update with one click (your settings and data are kept); New Help menu: replay the guide, check for updates, see the version; Option to turn automatic update checks off</a:t>
                       </a:r>
                     </a:p>
                   </a:txBody>
@@ -10015,7 +10015,7 @@
                           </a:solidFill>
                           <a:latin typeface="Segoe UI"/>
                         </a:rPr>
-                        <a:t>1.5.0</a:t>
+                        <a:t>2.0.0</a:t>
                       </a:r>
                     </a:p>
                   </a:txBody>
@@ -10037,13 +10037,92 @@
                           </a:solidFill>
                           <a:latin typeface="Segoe UI"/>
                         </a:rPr>
+                        <a:t>2026-10-28</a:t>
+                      </a:r>
+                    </a:p>
+                  </a:txBody>
+                  <a:tcPr marL="73152" marR="73152" marT="36576" marB="36576">
+                    <a:solidFill>
+                      <a:srgbClr val="FFFDF8"/>
+                    </a:solidFill>
+                  </a:tcPr>
+                </a:tc>
+                <a:tc>
+                  <a:txBody>
+                    <a:bodyPr wrap="square"/>
+                    <a:lstStyle/>
+                    <a:p>
+                      <a:r>
+                        <a:rPr sz="1200" b="0">
+                          <a:solidFill>
+                            <a:srgbClr val="2B2A28"/>
+                          </a:solidFill>
+                          <a:latin typeface="Segoe UI"/>
+                        </a:rPr>
+                        <a:t>Desktop pet, 23 animals &amp; 4 languages</a:t>
+                      </a:r>
+                    </a:p>
+                    <a:p>
+                      <a:r>
+                        <a:rPr sz="1200" b="0">
+                          <a:solidFill>
+                            <a:srgbClr val="2B2A28"/>
+                          </a:solidFill>
+                          <a:latin typeface="Segoe UI"/>
+                        </a:rPr>
+                        <a:t>Desktop pet that lives on your desktop and taskbar - drag it, tickle it, pet it; 23 animals in 3 groups: Land walks, Water swims with bubbles, Sky hovers and flaps; Moods (happy, sad, tired, hungry, grumpy...), naps when you're away, wakes up when you're back; Cute chat-bubble reminders: breaks, water, 20-20-20 eye rest, pomodoro done, daily goal</a:t>
+                      </a:r>
+                    </a:p>
+                  </a:txBody>
+                  <a:tcPr marL="73152" marR="73152" marT="36576" marB="36576">
+                    <a:solidFill>
+                      <a:srgbClr val="FFFDF8"/>
+                    </a:solidFill>
+                  </a:tcPr>
+                </a:tc>
+              </a:tr>
+              <a:tr h="822960">
+                <a:tc>
+                  <a:txBody>
+                    <a:bodyPr wrap="square"/>
+                    <a:lstStyle/>
+                    <a:p>
+                      <a:r>
+                        <a:rPr sz="1200" b="1">
+                          <a:solidFill>
+                            <a:srgbClr val="2B2A28"/>
+                          </a:solidFill>
+                          <a:latin typeface="Segoe UI"/>
+                        </a:rPr>
+                        <a:t>1.5.0</a:t>
+                      </a:r>
+                    </a:p>
+                  </a:txBody>
+                  <a:tcPr marL="73152" marR="73152" marT="36576" marB="36576">
+                    <a:solidFill>
+                      <a:srgbClr val="F7F4EC"/>
+                    </a:solidFill>
+                  </a:tcPr>
+                </a:tc>
+                <a:tc>
+                  <a:txBody>
+                    <a:bodyPr wrap="square"/>
+                    <a:lstStyle/>
+                    <a:p>
+                      <a:r>
+                        <a:rPr sz="1200" b="0">
+                          <a:solidFill>
+                            <a:srgbClr val="2B2A28"/>
+                          </a:solidFill>
+                          <a:latin typeface="Segoe UI"/>
+                        </a:rPr>
                         <a:t>2026-10-24</a:t>
                       </a:r>
                     </a:p>
                   </a:txBody>
                   <a:tcPr marL="73152" marR="73152" marT="36576" marB="36576">
                     <a:solidFill>
-                      <a:srgbClr val="FFFDF8"/>
+                      <a:srgbClr val="F7F4EC"/>
                     </a:solidFill>
                   </a:tcPr>
                 </a:tc>
@@ -10076,7 +10155,7 @@
                   </a:txBody>
                   <a:tcPr marL="73152" marR="73152" marT="36576" marB="36576">
                     <a:solidFill>
-                      <a:srgbClr val="FFFDF8"/>
+                      <a:srgbClr val="F7F4EC"/>
                     </a:solidFill>
                   </a:tcPr>
                 </a:tc>
@@ -10100,7 +10179,7 @@
                   </a:txBody>
                   <a:tcPr marL="73152" marR="73152" marT="36576" marB="36576">
                     <a:solidFill>
-                      <a:srgbClr val="F7F4EC"/>
+                      <a:srgbClr val="FFFDF8"/>
                     </a:solidFill>
                   </a:tcPr>
                 </a:tc>
@@ -10122,7 +10201,7 @@
                   </a:txBody>
                   <a:tcPr marL="73152" marR="73152" marT="36576" marB="36576">
                     <a:solidFill>
-                      <a:srgbClr val="F7F4EC"/>
+                      <a:srgbClr val="FFFDF8"/>
                     </a:solidFill>
                   </a:tcPr>
                 </a:tc>
@@ -10155,7 +10234,7 @@
                   </a:txBody>
                   <a:tcPr marL="73152" marR="73152" marT="36576" marB="36576">
                     <a:solidFill>
-                      <a:srgbClr val="F7F4EC"/>
+                      <a:srgbClr val="FFFDF8"/>
                     </a:solidFill>
                   </a:tcPr>
                 </a:tc>

</xml_diff>

<commit_message>
pips 2.11.0: New right-click menus
</commit_message>
<xml_diff>
--- a/apps/pips/web/download/Pips-Guide.pptx
+++ b/apps/pips/web/download/Pips-Guide.pptx
@@ -3292,7 +3292,7 @@
                 </a:solidFill>
                 <a:latin typeface="Segoe UI"/>
               </a:rPr>
-              <a:t>Version 2.10.0  ·  2026-10-28  ·  Made by Juwen Lie (owner)</a:t>
+              <a:t>Version 2.11.0  ·  2026-10-28  ·  Made by Juwen Lie (owner)</a:t>
             </a:r>
           </a:p>
           <a:p>
@@ -8141,7 +8141,7 @@
                 </a:solidFill>
                 <a:latin typeface="Segoe UI"/>
               </a:rPr>
-              <a:t>What's new in 2.10.0</a:t>
+              <a:t>What's new in 2.11.0</a:t>
             </a:r>
           </a:p>
         </p:txBody>
@@ -8254,7 +8254,7 @@
                 </a:solidFill>
                 <a:latin typeface="Segoe UI"/>
               </a:rPr>
-              <a:t>Chat bots  ·  2026-10-28</a:t>
+              <a:t>New right-click menus  ·  2026-10-28</a:t>
             </a:r>
           </a:p>
         </p:txBody>
@@ -8302,7 +8302,7 @@
                 </a:solidFill>
                 <a:latin typeface="Segoe UI"/>
               </a:rPr>
-              <a:t>🤖 6 friendly chat bots in the Chat tab: Pip Helper (app questions), Coach Focus (focus tips from your real stats), Sunny (live weather for any city), Arena Master (battle tips + quick battle), Giggles (jokes &amp; games) and Guardian (safety &amp; reporting help)</a:t>
+              <a:t>✨ Brand-new animated right-click menu for your pet: mood &amp; stat bars, quick-action tiles (Friends, Shop, Snack, Pat, Focus, Stats, Sleep, Taskbar), hover effects and smooth fly-out submenus</a:t>
             </a:r>
           </a:p>
           <a:p>
@@ -8327,7 +8327,7 @@
                 </a:solidFill>
                 <a:latin typeface="Segoe UI"/>
               </a:rPr>
-              <a:t>Private bot chats with suggestion chips, typing indicator and a clear button - your bot chats stay on your PC</a:t>
+              <a:t>Pick colours from swatches, switch size with one click and flip Sounds / Dark mode with toggle switches - changes show instantly</a:t>
             </a:r>
           </a:p>
           <a:p>
@@ -8352,7 +8352,7 @@
                 </a:solidFill>
                 <a:latin typeface="Segoe UI"/>
               </a:rPr>
-              <a:t>Mention a bot in a group chat (e.g. @weather Batam) and it answers in the room for everyone</a:t>
+              <a:t>Updates are highlighted: a glowing banner and NEW badge appear in the menu when a new version is ready</a:t>
             </a:r>
           </a:p>
           <a:p>
@@ -8377,7 +8377,7 @@
                 </a:solidFill>
                 <a:latin typeface="Segoe UI"/>
               </a:rPr>
-              <a:t>Bots reply in your app language; up to 120 bot messages per day</a:t>
+              <a:t>The focus card's right-click menu got the same new look; keyboard arrows, Enter and Esc work too</a:t>
             </a:r>
           </a:p>
         </p:txBody>
@@ -8508,7 +8508,7 @@
                 </a:solidFill>
                 <a:latin typeface="Segoe UI"/>
               </a:rPr>
-              <a:t>🤖 6 bot obrolan di tab Chat: Pip Helper (pertanyaan aplikasi), Coach Focus (tips fokus dari statistikmu), Sunny (cuaca langsung kota mana pun), Arena Master (tips bertarung + quick battle), Giggles (lelucon &amp; permainan) dan Guardian (bantuan keamanan &amp; laporan)</a:t>
+              <a:t>✨ Menu klik kanan baru yang beranimasi untuk peliharaanmu: bar mood &amp; status, tombol cepat (Teman, Toko, Camilan, Elus, Fokus, Statistik, Tidur, Taskbar), efek hover dan submenu yang mulus</a:t>
             </a:r>
           </a:p>
           <a:p>
@@ -8533,7 +8533,7 @@
                 </a:solidFill>
                 <a:latin typeface="Segoe UI"/>
               </a:rPr>
-              <a:t>Chat pribadi dengan bot lengkap dengan saran pertanyaan, indikator mengetik dan tombol hapus - chat bot tersimpan di PC-mu</a:t>
+              <a:t>Pilih warna dari palet, ganti ukuran sekali klik, dan nyalakan Suara / Mode gelap dengan sakelar - perubahan langsung terlihat</a:t>
             </a:r>
           </a:p>
           <a:p>
@@ -8558,7 +8558,7 @@
                 </a:solidFill>
                 <a:latin typeface="Segoe UI"/>
               </a:rPr>
-              <a:t>Sebut bot di grup (mis. @weather Batam) dan bot akan menjawab di grup untuk semua</a:t>
+              <a:t>Update kini disorot: banner menyala dan lencana BARU muncul di menu saat versi baru siap</a:t>
             </a:r>
           </a:p>
           <a:p>
@@ -8583,7 +8583,7 @@
                 </a:solidFill>
                 <a:latin typeface="Segoe UI"/>
               </a:rPr>
-              <a:t>Bot menjawab dalam bahasa aplikasimu; maksimal 120 pesan bot per hari</a:t>
+              <a:t>Menu klik kanan kartu fokus juga punya tampilan baru; panah keyboard, Enter dan Esc juga bisa dipakai</a:t>
             </a:r>
           </a:p>
         </p:txBody>
@@ -8815,7 +8815,7 @@
         </p:nvGraphicFramePr>
         <p:xfrm>
           <a:off x="548640" y="1645920"/>
-          <a:ext cx="11155680" cy="14374368"/>
+          <a:ext cx="11155680" cy="15197328"/>
         </p:xfrm>
         <a:graphic>
           <a:graphicData uri="http://schemas.openxmlformats.org/drawingml/2006/table">
@@ -8909,7 +8909,7 @@
                           </a:solidFill>
                           <a:latin typeface="Segoe UI"/>
                         </a:rPr>
-                        <a:t>2.10.0</a:t>
+                        <a:t>2.11.0</a:t>
                       </a:r>
                     </a:p>
                   </a:txBody>
@@ -8953,7 +8953,7 @@
                           </a:solidFill>
                           <a:latin typeface="Segoe UI"/>
                         </a:rPr>
-                        <a:t>Chat bots</a:t>
+                        <a:t>New right-click menus</a:t>
                       </a:r>
                     </a:p>
                     <a:p>
@@ -8964,7 +8964,7 @@
                           </a:solidFill>
                           <a:latin typeface="Segoe UI"/>
                         </a:rPr>
-                        <a:t>🤖 6 friendly chat bots in the Chat tab: Pip Helper (app questions), Coach Focus (focus tips from your real stats), Sunny (live weather for any city), Arena Master (battle tips + quick battle), Giggles (jokes &amp; games) and Guardian (safety &amp; reporting help); Private bot chats with suggestion chips, typing indicator and a clear button - your bot chats stay on your PC; Mention a bot in a group chat (e.g. @weather Batam) and it answers in the room for everyone; Bots reply in your app language; up to 120 bot messages per day</a:t>
+                        <a:t>✨ Brand-new animated right-click menu for your pet: mood &amp; stat bars, quick-action tiles (Friends, Shop, Snack, Pat, Focus, Stats, Sleep, Taskbar), hover effects and smooth fly-out submenus; Pick colours from swatches, switch size with one click and flip Sounds / Dark mode with toggle switches - changes show instantly; Updates are highlighted: a glowing banner and NEW badge appear in the menu when a new version is ready; The focus card's right-click menu got the same new look; keyboard arrows, Enter and Esc work too</a:t>
                       </a:r>
                     </a:p>
                   </a:txBody>
@@ -8988,7 +8988,7 @@
                           </a:solidFill>
                           <a:latin typeface="Segoe UI"/>
                         </a:rPr>
-                        <a:t>2.9.0</a:t>
+                        <a:t>2.10.0</a:t>
                       </a:r>
                     </a:p>
                   </a:txBody>
@@ -9032,7 +9032,7 @@
                           </a:solidFill>
                           <a:latin typeface="Segoe UI"/>
                         </a:rPr>
-                        <a:t>Location &amp; live weather</a:t>
+                        <a:t>Chat bots</a:t>
                       </a:r>
                     </a:p>
                     <a:p>
@@ -9043,7 +9043,7 @@
                           </a:solidFill>
                           <a:latin typeface="Segoe UI"/>
                         </a:rPr>
-                        <a:t>📍 Add your city in Profile → Location &amp; weather (auto-detect or search) - only your city and country are shown, never your exact position; Live weather banners on every profile with animations: rain, drizzle, thunderstorms with lightning, snow, fog, clouds, sunshine or a starry night - plus temperature, feels-like, humidity, wind and local time; Your own weather strip on top of the hub, and each friend's weather + local time in the friends list; Hide your location from others or remove it any time</a:t>
+                        <a:t>🤖 6 friendly chat bots in the Chat tab: Pip Helper (app questions), Coach Focus (focus tips from your real stats), Sunny (live weather for any city), Arena Master (battle tips + quick battle), Giggles (jokes &amp; games) and Guardian (safety &amp; reporting help); Private bot chats with suggestion chips, typing indicator and a clear button - your bot chats stay on your PC; Mention a bot in a group chat (e.g. @weather Batam) and it answers in the room for everyone; Bots reply in your app language; up to 120 bot messages per day</a:t>
                       </a:r>
                     </a:p>
                   </a:txBody>
@@ -9067,7 +9067,7 @@
                           </a:solidFill>
                           <a:latin typeface="Segoe UI"/>
                         </a:rPr>
-                        <a:t>2.8.0</a:t>
+                        <a:t>2.9.0</a:t>
                       </a:r>
                     </a:p>
                   </a:txBody>
@@ -9111,7 +9111,7 @@
                           </a:solidFill>
                           <a:latin typeface="Segoe UI"/>
                         </a:rPr>
-                        <a:t>Pips Arena - duels, gear &amp; live battles</a:t>
+                        <a:t>Location &amp; live weather</a:t>
                       </a:r>
                     </a:p>
                     <a:p>
@@ -9122,7 +9122,7 @@
                           </a:solidFill>
                           <a:latin typeface="Segoe UI"/>
                         </a:rPr>
-                        <a:t>⚔ New Arena tab: challenge friends or anyone in the arena to a live duel - each round pick Attack, Guard or Special within 12 seconds and watch your pets fight; ⚡ Quick battle: an instant auto-fight against anyone's fighter, even when they're offline; Arena gear in the Shop: 7 weapons (water pistol to rocket launcher), 5 armors and 5 gadgets that decide your special move - better gear and a higher level make a stronger fighter; Live duels can be watched by everyone, plus recent battle replays, top fighters, rating and win/loss records; wins earn coins</a:t>
+                        <a:t>📍 Add your city in Profile → Location &amp; weather (auto-detect or search) - only your city and country are shown, never your exact position; Live weather banners on every profile with animations: rain, drizzle, thunderstorms with lightning, snow, fog, clouds, sunshine or a starry night - plus temperature, feels-like, humidity, wind and local time; Your own weather strip on top of the hub, and each friend's weather + local time in the friends list; Hide your location from others or remove it any time</a:t>
                       </a:r>
                     </a:p>
                   </a:txBody>
@@ -9146,7 +9146,7 @@
                           </a:solidFill>
                           <a:latin typeface="Segoe UI"/>
                         </a:rPr>
-                        <a:t>2.7.0</a:t>
+                        <a:t>2.8.0</a:t>
                       </a:r>
                     </a:p>
                   </a:txBody>
@@ -9190,7 +9190,7 @@
                           </a:solidFill>
                           <a:latin typeface="Segoe UI"/>
                         </a:rPr>
-                        <a:t>Moderators &amp; Premium</a:t>
+                        <a:t>Pips Arena - duels, gear &amp; live battles</a:t>
                       </a:r>
                     </a:p>
                     <a:p>
@@ -9201,7 +9201,7 @@
                           </a:solidFill>
                           <a:latin typeface="Segoe UI"/>
                         </a:rPr>
-                        <a:t>★ Premium: a purple Premium badge, 4 exclusive props (tiara, star glasses, diamond necklace, fairy wings), the Fireworks move, +30 coins every day, double friend-interaction coins and room for 300 friends / 30 groups; Get Premium: Profile tab → Premium → "Ask to buy" emails the owner; after payment you receive a key (PIPS-XXXX-XXXX) to redeem right there; 🛡 Moderators: a blue Mod badge and a Mod tab with the report queue - warn, mute (1h / 24h / 7 days), clear a profile or reset a name; every action is logged; Report button on everyone's profile, so moderators can keep Pips friendly</a:t>
+                        <a:t>⚔ New Arena tab: challenge friends or anyone in the arena to a live duel - each round pick Attack, Guard or Special within 12 seconds and watch your pets fight; ⚡ Quick battle: an instant auto-fight against anyone's fighter, even when they're offline; Arena gear in the Shop: 7 weapons (water pistol to rocket launcher), 5 armors and 5 gadgets that decide your special move - better gear and a higher level make a stronger fighter; Live duels can be watched by everyone, plus recent battle replays, top fighters, rating and win/loss records; wins earn coins</a:t>
                       </a:r>
                     </a:p>
                   </a:txBody>
@@ -9225,7 +9225,7 @@
                           </a:solidFill>
                           <a:latin typeface="Segoe UI"/>
                         </a:rPr>
-                        <a:t>2.6.1</a:t>
+                        <a:t>2.7.0</a:t>
                       </a:r>
                     </a:p>
                   </a:txBody>
@@ -9269,7 +9269,7 @@
                           </a:solidFill>
                           <a:latin typeface="Segoe UI"/>
                         </a:rPr>
-                        <a:t>Owner badge &amp; credits</a:t>
+                        <a:t>Moderators &amp; Premium</a:t>
                       </a:r>
                     </a:p>
                     <a:p>
@@ -9280,7 +9280,7 @@
                           </a:solidFill>
                           <a:latin typeface="Segoe UI"/>
                         </a:rPr>
-                        <a:t>The creator of Pips (Juwen Lie) now shows a gold ♛ Owner badge on his profile, friend list and ranks; New About Pips card in the Profile tab: credits and how to contact the owner (Juwen_Lie@pegatroncorp.com) with Email and Copy buttons; Right-click the pet → Help → About now shows who made Pips and the contact email</a:t>
+                        <a:t>★ Premium: a purple Premium badge, 4 exclusive props (tiara, star glasses, diamond necklace, fairy wings), the Fireworks move, +30 coins every day, double friend-interaction coins and room for 300 friends / 30 groups; Get Premium: Profile tab → Premium → "Ask to buy" emails the owner; after payment you receive a key (PIPS-XXXX-XXXX) to redeem right there; 🛡 Moderators: a blue Mod badge and a Mod tab with the report queue - warn, mute (1h / 24h / 7 days), clear a profile or reset a name; every action is logged; Report button on everyone's profile, so moderators can keep Pips friendly</a:t>
                       </a:r>
                     </a:p>
                   </a:txBody>
@@ -9304,7 +9304,7 @@
                           </a:solidFill>
                           <a:latin typeface="Segoe UI"/>
                         </a:rPr>
-                        <a:t>2.6.0</a:t>
+                        <a:t>2.6.1</a:t>
                       </a:r>
                     </a:p>
                   </a:txBody>
@@ -9348,7 +9348,7 @@
                           </a:solidFill>
                           <a:latin typeface="Segoe UI"/>
                         </a:rPr>
-                        <a:t>Profiles, ranks, online status &amp; dark mode</a:t>
+                        <a:t>Owner badge &amp; credits</a:t>
                       </a:r>
                     </a:p>
                     <a:p>
@@ -9359,7 +9359,7 @@
                           </a:solidFill>
                           <a:latin typeface="Segoe UI"/>
                         </a:rPr>
-                        <a:t>Profile tab: profile picture (or your pet), about me, job, location, hobbies, birthday and a status message; Public or private: public profiles can be added directly and viewed in full; private profiles need a friend request that they accept, and strangers only see name, photo, pet, level and status; Click anyone to open their profile - badges, info, their friends - and add them, chat or wave from there; Ranks tab replaces Teams: everyone using Pips, sorted by XP, badges or streak</a:t>
+                        <a:t>The creator of Pips (Juwen Lie) now shows a gold ♛ Owner badge on his profile, friend list and ranks; New About Pips card in the Profile tab: credits and how to contact the owner (Juwen_Lie@pegatroncorp.com) with Email and Copy buttons; Right-click the pet → Help → About now shows who made Pips and the contact email</a:t>
                       </a:r>
                     </a:p>
                   </a:txBody>
@@ -9383,7 +9383,7 @@
                           </a:solidFill>
                           <a:latin typeface="Segoe UI"/>
                         </a:rPr>
-                        <a:t>2.5.1</a:t>
+                        <a:t>2.6.0</a:t>
                       </a:r>
                     </a:p>
                   </a:txBody>
@@ -9427,7 +9427,7 @@
                           </a:solidFill>
                           <a:latin typeface="Segoe UI"/>
                         </a:rPr>
-                        <a:t>New cute Pips logo</a:t>
+                        <a:t>Profiles, ranks, online status &amp; dark mode</a:t>
                       </a:r>
                     </a:p>
                     <a:p>
@@ -9438,7 +9438,7 @@
                           </a:solidFill>
                           <a:latin typeface="Segoe UI"/>
                         </a:rPr>
-                        <a:t>New Pips logo: Pip the cat on a Pips-red tile, matching the app colours (desktop shortcut, windows and website)</a:t>
+                        <a:t>Profile tab: profile picture (or your pet), about me, job, location, hobbies, birthday and a status message; Public or private: public profiles can be added directly and viewed in full; private profiles need a friend request that they accept, and strangers only see name, photo, pet, level and status; Click anyone to open their profile - badges, info, their friends - and add them, chat or wave from there; Ranks tab replaces Teams: everyone using Pips, sorted by XP, badges or streak</a:t>
                       </a:r>
                     </a:p>
                   </a:txBody>
@@ -9462,7 +9462,7 @@
                           </a:solidFill>
                           <a:latin typeface="Segoe UI"/>
                         </a:rPr>
-                        <a:t>2.5.0</a:t>
+                        <a:t>2.5.1</a:t>
                       </a:r>
                     </a:p>
                   </a:txBody>
@@ -9506,7 +9506,7 @@
                           </a:solidFill>
                           <a:latin typeface="Segoe UI"/>
                         </a:rPr>
-                        <a:t>Shop, coins, props &amp; moves</a:t>
+                        <a:t>New cute Pips logo</a:t>
                       </a:r>
                     </a:p>
                     <a:p>
@@ -9517,7 +9517,7 @@
                           </a:solidFill>
                           <a:latin typeface="Segoe UI"/>
                         </a:rPr>
-                        <a:t>Shop: earn coins and spend them on your pet - 17 props (crown, wizard hat, headphones, shades, scarf, cape, angel wings...) and 6 moves: spin, dance, moonwalk, backflip, kung fu and spider swing!; Coins come from leveling up (+40), badges (+25), opening Pips each day (+10), friendships (+15 per affinity level), waving / chatting / visiting friends (+2) and pomodoros (+5). Everyone starts with a 100-coin gift; Your friends see your props: on avatars in the hub and when your pet visits their desktop - it shows off one of your moves; Pips is now a social pet: clicking the pet opens the Pips hub (friends, chat, groups, shop, badges)</a:t>
+                        <a:t>New Pips logo: Pip the cat on a Pips-red tile, matching the app colours (desktop shortcut, windows and website)</a:t>
                       </a:r>
                     </a:p>
                   </a:txBody>
@@ -9541,7 +9541,7 @@
                           </a:solidFill>
                           <a:latin typeface="Segoe UI"/>
                         </a:rPr>
-                        <a:t>2.4.0</a:t>
+                        <a:t>2.5.0</a:t>
                       </a:r>
                     </a:p>
                   </a:txBody>
@@ -9585,7 +9585,7 @@
                           </a:solidFill>
                           <a:latin typeface="Segoe UI"/>
                         </a:rPr>
-                        <a:t>Chat, groups, affinity &amp; pet visits</a:t>
+                        <a:t>Shop, coins, props &amp; moves</a:t>
                       </a:r>
                     </a:p>
                     <a:p>
@@ -9596,7 +9596,7 @@
                           </a:solidFill>
                           <a:latin typeface="Segoe UI"/>
                         </a:rPr>
-                        <a:t>Chat: message your friends, and chat inside groups. Your pet pops up new messages as a bubble - click it to reply; Pet interactions: wave, pet their pet, send a snack, high five - or send your pet to visit: it walks onto your friend's desktop for a little while!; Affinity: every chat and interaction grows your friendship - Acquaintance → Buddy → Good friends → Close friends → Best friends → Soulmates; Your own groups: create a private group, invite your friends, they accept or decline. Group board + group chat; the owner can remove members</a:t>
+                        <a:t>Shop: earn coins and spend them on your pet - 17 props (crown, wizard hat, headphones, shades, scarf, cape, angel wings...) and 6 moves: spin, dance, moonwalk, backflip, kung fu and spider swing!; Coins come from leveling up (+40), badges (+25), opening Pips each day (+10), friendships (+15 per affinity level), waving / chatting / visiting friends (+2) and pomodoros (+5). Everyone starts with a 100-coin gift; Your friends see your props: on avatars in the hub and when your pet visits their desktop - it shows off one of your moves; Pips is now a social pet: clicking the pet opens the Pips hub (friends, chat, groups, shop, badges)</a:t>
                       </a:r>
                     </a:p>
                   </a:txBody>
@@ -9620,7 +9620,7 @@
                           </a:solidFill>
                           <a:latin typeface="Segoe UI"/>
                         </a:rPr>
-                        <a:t>2.3.0</a:t>
+                        <a:t>2.4.0</a:t>
                       </a:r>
                     </a:p>
                   </a:txBody>
@@ -9664,7 +9664,7 @@
                           </a:solidFill>
                           <a:latin typeface="Segoe UI"/>
                         </a:rPr>
-                        <a:t>Friends, levels &amp; achievements</a:t>
+                        <a:t>Chat, groups, affinity &amp; pet visits</a:t>
                       </a:r>
                     </a:p>
                     <a:p>
@@ -9675,7 +9675,7 @@
                           </a:solidFill>
                           <a:latin typeface="Segoe UI"/>
                         </a:rPr>
-                        <a:t>Levels &amp; XP: every finished pomodoro earns XP and your level grows - plus 20 achievements to unlock (first tomato, 8 in a day, 7-day streak, early bird, night owl, pet lover...). Your pet celebrates each one; Friends (optional, off by default): get a 6-letter friend code, add colleagues, see today's board and join a team board like PTB. Your pet tells you when a friend finishes a pomodoro; Privacy: only your name, pet, level, streak and pomodoro counts are shared - never apps, window titles or scores. One click turns it off and deletes your online data. Right-click the pet → Friends &amp; achievements…</a:t>
+                        <a:t>Chat: message your friends, and chat inside groups. Your pet pops up new messages as a bubble - click it to reply; Pet interactions: wave, pet their pet, send a snack, high five - or send your pet to visit: it walks onto your friend's desktop for a little while!; Affinity: every chat and interaction grows your friendship - Acquaintance → Buddy → Good friends → Close friends → Best friends → Soulmates; Your own groups: create a private group, invite your friends, they accept or decline. Group board + group chat; the owner can remove members</a:t>
                       </a:r>
                     </a:p>
                   </a:txBody>
@@ -9699,7 +9699,7 @@
                           </a:solidFill>
                           <a:latin typeface="Segoe UI"/>
                         </a:rPr>
-                        <a:t>2.2.0</a:t>
+                        <a:t>2.3.0</a:t>
                       </a:r>
                     </a:p>
                   </a:txBody>
@@ -9743,7 +9743,7 @@
                           </a:solidFill>
                           <a:latin typeface="Segoe UI"/>
                         </a:rPr>
-                        <a:t>Pet sounds</a:t>
+                        <a:t>Friends, levels &amp; achievements</a:t>
                       </a:r>
                     </a:p>
                     <a:p>
@@ -9754,7 +9754,7 @@
                           </a:solidFill>
                           <a:latin typeface="Segoe UI"/>
                         </a:rPr>
-                        <a:t>Your pet has a voice! Each of the 23 animals has its own sound (meow, woof, ribbit, hoot, buzz, oink, whale song...) and it changes with its mood: happy chirps, sad whimpers, sleepy yawns, hungry calls, grumpy huffs and soft snores; It also reacts with sound when you tickle, pet, feed, shake or wake it; Settings: right-click the pet → Sounds to switch on/off; Pet status &amp; settings has a volume slider, a ▶ Hear me button and "Stay quiet while I'm focusing" (on by default)</a:t>
+                        <a:t>Levels &amp; XP: every finished pomodoro earns XP and your level grows - plus 20 achievements to unlock (first tomato, 8 in a day, 7-day streak, early bird, night owl, pet lover...). Your pet celebrates each one; Friends (optional, off by default): get a 6-letter friend code, add colleagues, see today's board and join a team board like PTB. Your pet tells you when a friend finishes a pomodoro; Privacy: only your name, pet, level, streak and pomodoro counts are shared - never apps, window titles or scores. One click turns it off and deletes your online data. Right-click the pet → Friends &amp; achievements…</a:t>
                       </a:r>
                     </a:p>
                   </a:txBody>
@@ -9778,7 +9778,7 @@
                           </a:solidFill>
                           <a:latin typeface="Segoe UI"/>
                         </a:rPr>
-                        <a:t>2.1.2</a:t>
+                        <a:t>2.2.0</a:t>
                       </a:r>
                     </a:p>
                   </a:txBody>
@@ -9822,7 +9822,7 @@
                           </a:solidFill>
                           <a:latin typeface="Segoe UI"/>
                         </a:rPr>
-                        <a:t>Tickle-only mode</a:t>
+                        <a:t>Pet sounds</a:t>
                       </a:r>
                     </a:p>
                     <a:p>
@@ -9833,7 +9833,7 @@
                           </a:solidFill>
                           <a:latin typeface="Segoe UI"/>
                         </a:rPr>
-                        <a:t>New click option "Only tickle (never open Pips)": click and tickle your pet as much as you like - the Pomodoro window stays closed (open it from the right-click menu). Right-click the pet → When I click</a:t>
+                        <a:t>Your pet has a voice! Each of the 23 animals has its own sound (meow, woof, ribbit, hoot, buzz, oink, whale song...) and it changes with its mood: happy chirps, sad whimpers, sleepy yawns, hungry calls, grumpy huffs and soft snores; It also reacts with sound when you tickle, pet, feed, shake or wake it; Settings: right-click the pet → Sounds to switch on/off; Pet status &amp; settings has a volume slider, a ▶ Hear me button and "Stay quiet while I'm focusing" (on by default)</a:t>
                       </a:r>
                     </a:p>
                   </a:txBody>
@@ -9857,7 +9857,7 @@
                           </a:solidFill>
                           <a:latin typeface="Segoe UI"/>
                         </a:rPr>
-                        <a:t>2.1.1</a:t>
+                        <a:t>2.1.2</a:t>
                       </a:r>
                     </a:p>
                   </a:txBody>
@@ -9901,7 +9901,7 @@
                           </a:solidFill>
                           <a:latin typeface="Segoe UI"/>
                         </a:rPr>
-                        <a:t>Owner info</a:t>
+                        <a:t>Tickle-only mode</a:t>
                       </a:r>
                     </a:p>
                     <a:p>
@@ -9912,7 +9912,7 @@
                           </a:solidFill>
                           <a:latin typeface="Segoe UI"/>
                         </a:rPr>
-                        <a:t>About Pips now shows the owner: Juwen Lie (right-click the pet → Help → About)</a:t>
+                        <a:t>New click option "Only tickle (never open Pips)": click and tickle your pet as much as you like - the Pomodoro window stays closed (open it from the right-click menu). Right-click the pet → When I click</a:t>
                       </a:r>
                     </a:p>
                   </a:txBody>
@@ -9936,7 +9936,7 @@
                           </a:solidFill>
                           <a:latin typeface="Segoe UI"/>
                         </a:rPr>
-                        <a:t>2.1.0</a:t>
+                        <a:t>2.1.1</a:t>
                       </a:r>
                     </a:p>
                   </a:txBody>
@@ -9980,7 +9980,7 @@
                           </a:solidFill>
                           <a:latin typeface="Segoe UI"/>
                         </a:rPr>
-                        <a:t>Interactive guide &amp; in-app updates</a:t>
+                        <a:t>Owner info</a:t>
                       </a:r>
                     </a:p>
                     <a:p>
@@ -9991,7 +9991,7 @@
                           </a:solidFill>
                           <a:latin typeface="Segoe UI"/>
                         </a:rPr>
-                        <a:t>Interactive first-run guide: your pet walks you through clicking, dragging, petting and the right-click menu; In-app updates: Pips tells you when a new version is out - update with one click (your settings and data are kept); New Help menu: replay the guide, check for updates, see the version; Option to turn automatic update checks off</a:t>
+                        <a:t>About Pips now shows the owner: Juwen Lie (right-click the pet → Help → About)</a:t>
                       </a:r>
                     </a:p>
                   </a:txBody>
@@ -10015,7 +10015,7 @@
                           </a:solidFill>
                           <a:latin typeface="Segoe UI"/>
                         </a:rPr>
-                        <a:t>2.0.0</a:t>
+                        <a:t>2.1.0</a:t>
                       </a:r>
                     </a:p>
                   </a:txBody>
@@ -10059,7 +10059,7 @@
                           </a:solidFill>
                           <a:latin typeface="Segoe UI"/>
                         </a:rPr>
-                        <a:t>Desktop pet, 23 animals &amp; 4 languages</a:t>
+                        <a:t>Interactive guide &amp; in-app updates</a:t>
                       </a:r>
                     </a:p>
                     <a:p>
@@ -10070,7 +10070,7 @@
                           </a:solidFill>
                           <a:latin typeface="Segoe UI"/>
                         </a:rPr>
-                        <a:t>Desktop pet that lives on your desktop and taskbar - drag it, tickle it, pet it; 23 animals in 3 groups: Land walks, Water swims with bubbles, Sky hovers and flaps; Moods (happy, sad, tired, hungry, grumpy...), naps when you're away, wakes up when you're back; Cute chat-bubble reminders: breaks, water, 20-20-20 eye rest, pomodoro done, daily goal</a:t>
+                        <a:t>Interactive first-run guide: your pet walks you through clicking, dragging, petting and the right-click menu; In-app updates: Pips tells you when a new version is out - update with one click (your settings and data are kept); New Help menu: replay the guide, check for updates, see the version; Option to turn automatic update checks off</a:t>
                       </a:r>
                     </a:p>
                   </a:txBody>
@@ -10094,7 +10094,7 @@
                           </a:solidFill>
                           <a:latin typeface="Segoe UI"/>
                         </a:rPr>
-                        <a:t>1.5.0</a:t>
+                        <a:t>2.0.0</a:t>
                       </a:r>
                     </a:p>
                   </a:txBody>
@@ -10116,13 +10116,92 @@
                           </a:solidFill>
                           <a:latin typeface="Segoe UI"/>
                         </a:rPr>
+                        <a:t>2026-10-28</a:t>
+                      </a:r>
+                    </a:p>
+                  </a:txBody>
+                  <a:tcPr marL="73152" marR="73152" marT="36576" marB="36576">
+                    <a:solidFill>
+                      <a:srgbClr val="F7F4EC"/>
+                    </a:solidFill>
+                  </a:tcPr>
+                </a:tc>
+                <a:tc>
+                  <a:txBody>
+                    <a:bodyPr wrap="square"/>
+                    <a:lstStyle/>
+                    <a:p>
+                      <a:r>
+                        <a:rPr sz="1200" b="0">
+                          <a:solidFill>
+                            <a:srgbClr val="2B2A28"/>
+                          </a:solidFill>
+                          <a:latin typeface="Segoe UI"/>
+                        </a:rPr>
+                        <a:t>Desktop pet, 23 animals &amp; 4 languages</a:t>
+                      </a:r>
+                    </a:p>
+                    <a:p>
+                      <a:r>
+                        <a:rPr sz="1200" b="0">
+                          <a:solidFill>
+                            <a:srgbClr val="2B2A28"/>
+                          </a:solidFill>
+                          <a:latin typeface="Segoe UI"/>
+                        </a:rPr>
+                        <a:t>Desktop pet that lives on your desktop and taskbar - drag it, tickle it, pet it; 23 animals in 3 groups: Land walks, Water swims with bubbles, Sky hovers and flaps; Moods (happy, sad, tired, hungry, grumpy...), naps when you're away, wakes up when you're back; Cute chat-bubble reminders: breaks, water, 20-20-20 eye rest, pomodoro done, daily goal</a:t>
+                      </a:r>
+                    </a:p>
+                  </a:txBody>
+                  <a:tcPr marL="73152" marR="73152" marT="36576" marB="36576">
+                    <a:solidFill>
+                      <a:srgbClr val="F7F4EC"/>
+                    </a:solidFill>
+                  </a:tcPr>
+                </a:tc>
+              </a:tr>
+              <a:tr h="822960">
+                <a:tc>
+                  <a:txBody>
+                    <a:bodyPr wrap="square"/>
+                    <a:lstStyle/>
+                    <a:p>
+                      <a:r>
+                        <a:rPr sz="1200" b="1">
+                          <a:solidFill>
+                            <a:srgbClr val="2B2A28"/>
+                          </a:solidFill>
+                          <a:latin typeface="Segoe UI"/>
+                        </a:rPr>
+                        <a:t>1.5.0</a:t>
+                      </a:r>
+                    </a:p>
+                  </a:txBody>
+                  <a:tcPr marL="73152" marR="73152" marT="36576" marB="36576">
+                    <a:solidFill>
+                      <a:srgbClr val="FFFDF8"/>
+                    </a:solidFill>
+                  </a:tcPr>
+                </a:tc>
+                <a:tc>
+                  <a:txBody>
+                    <a:bodyPr wrap="square"/>
+                    <a:lstStyle/>
+                    <a:p>
+                      <a:r>
+                        <a:rPr sz="1200" b="0">
+                          <a:solidFill>
+                            <a:srgbClr val="2B2A28"/>
+                          </a:solidFill>
+                          <a:latin typeface="Segoe UI"/>
+                        </a:rPr>
                         <a:t>2026-10-24</a:t>
                       </a:r>
                     </a:p>
                   </a:txBody>
                   <a:tcPr marL="73152" marR="73152" marT="36576" marB="36576">
                     <a:solidFill>
-                      <a:srgbClr val="F7F4EC"/>
+                      <a:srgbClr val="FFFDF8"/>
                     </a:solidFill>
                   </a:tcPr>
                 </a:tc>
@@ -10155,7 +10234,7 @@
                   </a:txBody>
                   <a:tcPr marL="73152" marR="73152" marT="36576" marB="36576">
                     <a:solidFill>
-                      <a:srgbClr val="F7F4EC"/>
+                      <a:srgbClr val="FFFDF8"/>
                     </a:solidFill>
                   </a:tcPr>
                 </a:tc>
@@ -10179,7 +10258,7 @@
                   </a:txBody>
                   <a:tcPr marL="73152" marR="73152" marT="36576" marB="36576">
                     <a:solidFill>
-                      <a:srgbClr val="FFFDF8"/>
+                      <a:srgbClr val="F7F4EC"/>
                     </a:solidFill>
                   </a:tcPr>
                 </a:tc>
@@ -10201,7 +10280,7 @@
                   </a:txBody>
                   <a:tcPr marL="73152" marR="73152" marT="36576" marB="36576">
                     <a:solidFill>
-                      <a:srgbClr val="FFFDF8"/>
+                      <a:srgbClr val="F7F4EC"/>
                     </a:solidFill>
                   </a:tcPr>
                 </a:tc>
@@ -10234,7 +10313,7 @@
                   </a:txBody>
                   <a:tcPr marL="73152" marR="73152" marT="36576" marB="36576">
                     <a:solidFill>
-                      <a:srgbClr val="FFFDF8"/>
+                      <a:srgbClr val="F7F4EC"/>
                     </a:solidFill>
                   </a:tcPr>
                 </a:tc>

</xml_diff>

<commit_message>
pips 2.12.0: Mega update: 28 new animals, 31 shop items, 13 moves
</commit_message>
<xml_diff>
--- a/apps/pips/web/download/Pips-Guide.pptx
+++ b/apps/pips/web/download/Pips-Guide.pptx
@@ -3292,7 +3292,7 @@
                 </a:solidFill>
                 <a:latin typeface="Segoe UI"/>
               </a:rPr>
-              <a:t>Version 2.11.0  ·  2026-10-28  ·  Made by Juwen Lie (owner)</a:t>
+              <a:t>Version 2.12.0  ·  2026-10-28  ·  Made by Juwen Lie (owner)</a:t>
             </a:r>
           </a:p>
           <a:p>
@@ -8141,7 +8141,7 @@
                 </a:solidFill>
                 <a:latin typeface="Segoe UI"/>
               </a:rPr>
-              <a:t>What's new in 2.11.0</a:t>
+              <a:t>What's new in 2.12.0</a:t>
             </a:r>
           </a:p>
         </p:txBody>
@@ -8254,7 +8254,7 @@
                 </a:solidFill>
                 <a:latin typeface="Segoe UI"/>
               </a:rPr>
-              <a:t>New right-click menus  ·  2026-10-28</a:t>
+              <a:t>Mega update: 28 new animals, 31 shop items, 13 moves  ·  2026-10-28</a:t>
             </a:r>
           </a:p>
         </p:txBody>
@@ -8302,7 +8302,7 @@
                 </a:solidFill>
                 <a:latin typeface="Segoe UI"/>
               </a:rPr>
-              <a:t>✨ Brand-new animated right-click menu for your pet: mood &amp; stat bars, quick-action tiles (Friends, Shop, Snack, Pat, Focus, Stats, Sleep, Taskbar), hover effects and smooth fly-out submenus</a:t>
+              <a:t>🦁 28 new animals (51 total): lion, tiger, unicorn, deer, sheep, cow, raccoon, red panda, monkey, hedgehog, dino, squirrel, mouse, koala, shark, dolphin, seal, otter, pufferfish, duck, crab, parrot, chick, ladybug, phoenix, pegasus, ghost and flamingo</a:t>
             </a:r>
           </a:p>
           <a:p>
@@ -8327,7 +8327,7 @@
                 </a:solidFill>
                 <a:latin typeface="Segoe UI"/>
               </a:rPr>
-              <a:t>Pick colours from swatches, switch size with one click and flip Sounds / Dark mode with toggle switches - changes show instantly</a:t>
+              <a:t>🎩 31 new shop items: top hat, cowboy, chef, pirate, Santa, viking, graduation cap, beret, bow, propeller cap, flower crown, nerd glasses, eyepatch, mustache, goggles, masquerade mask, tie, pearls, flower lei, gold chain, balloon, backpack, guitar, shield, butterfly / devil wings and more - plus Premium galaxy crown, galaxy cape and dragon wings</a:t>
             </a:r>
           </a:p>
           <a:p>
@@ -8352,7 +8352,7 @@
                 </a:solidFill>
                 <a:latin typeface="Segoe UI"/>
               </a:rPr>
-              <a:t>Updates are highlighted: a glowing banner and NEW badge appear in the menu when a new version is ready</a:t>
+              <a:t>💃 13 new moves: wave, jump, hearts, sing, yoga, zoomies, cartwheel, juggle, rain dance, breakdance, magic, confetti and the Premium rocket launch</a:t>
             </a:r>
           </a:p>
           <a:p>
@@ -8377,7 +8377,7 @@
                 </a:solidFill>
                 <a:latin typeface="Segoe UI"/>
               </a:rPr>
-              <a:t>The focus card's right-click menu got the same new look; keyboard arrows, Enter and Esc work too</a:t>
+              <a:t>The Shop is now split into sections (Hats, Face, Neck, Back, Moves, Arena gear) with an owned counter for each</a:t>
             </a:r>
           </a:p>
         </p:txBody>
@@ -8508,7 +8508,7 @@
                 </a:solidFill>
                 <a:latin typeface="Segoe UI"/>
               </a:rPr>
-              <a:t>✨ Menu klik kanan baru yang beranimasi untuk peliharaanmu: bar mood &amp; status, tombol cepat (Teman, Toko, Camilan, Elus, Fokus, Statistik, Tidur, Taskbar), efek hover dan submenu yang mulus</a:t>
+              <a:t>🦁 28 hewan baru (total 51): singa, harimau, unicorn, rusa, domba, sapi, rakun, panda merah, monyet, landak, dino, tupai, tikus, koala, hiu, lumba-lumba, anjing laut, berang-berang, ikan buntal, bebek, kepiting, beo, anak ayam, kepik, phoenix, pegasus, hantu dan flamingo</a:t>
             </a:r>
           </a:p>
           <a:p>
@@ -8533,7 +8533,7 @@
                 </a:solidFill>
                 <a:latin typeface="Segoe UI"/>
               </a:rPr>
-              <a:t>Pilih warna dari palet, ganti ukuran sekali klik, dan nyalakan Suara / Mode gelap dengan sakelar - perubahan langsung terlihat</a:t>
+              <a:t>🎩 31 item toko baru: topi tinggi, koboi, koki, bajak laut, Sinterklas, viking, topi wisuda, baret, pita, topi baling-baling, mahkota bunga, kacamata kutu buku, penutup mata, kumis, kacamata renang, topeng pesta, dasi, mutiara, kalung bunga, kalung emas, balon, ransel, gitar, perisai, sayap kupu-kupu / iblis dan lainnya - plus mahkota galaksi, jubah galaksi dan sayap naga khusus Premium</a:t>
             </a:r>
           </a:p>
           <a:p>
@@ -8558,7 +8558,7 @@
                 </a:solidFill>
                 <a:latin typeface="Segoe UI"/>
               </a:rPr>
-              <a:t>Update kini disorot: banner menyala dan lencana BARU muncul di menu saat versi baru siap</a:t>
+              <a:t>💃 13 gerakan baru: lambai, lompat, hati, nyanyi, yoga, lari kencang, roda, juggling, tari hujan, breakdance, sulap, konfeti dan peluncuran roket Premium</a:t>
             </a:r>
           </a:p>
           <a:p>
@@ -8583,7 +8583,7 @@
                 </a:solidFill>
                 <a:latin typeface="Segoe UI"/>
               </a:rPr>
-              <a:t>Menu klik kanan kartu fokus juga punya tampilan baru; panah keyboard, Enter dan Esc juga bisa dipakai</a:t>
+              <a:t>Toko kini dibagi per bagian (Topi, Wajah, Leher, Punggung, Gerakan, Perlengkapan arena) dengan penghitung item yang dimiliki</a:t>
             </a:r>
           </a:p>
         </p:txBody>
@@ -8815,7 +8815,7 @@
         </p:nvGraphicFramePr>
         <p:xfrm>
           <a:off x="548640" y="1645920"/>
-          <a:ext cx="11155680" cy="15197328"/>
+          <a:ext cx="11155680" cy="16020288"/>
         </p:xfrm>
         <a:graphic>
           <a:graphicData uri="http://schemas.openxmlformats.org/drawingml/2006/table">
@@ -8909,7 +8909,7 @@
                           </a:solidFill>
                           <a:latin typeface="Segoe UI"/>
                         </a:rPr>
-                        <a:t>2.11.0</a:t>
+                        <a:t>2.12.0</a:t>
                       </a:r>
                     </a:p>
                   </a:txBody>
@@ -8953,7 +8953,7 @@
                           </a:solidFill>
                           <a:latin typeface="Segoe UI"/>
                         </a:rPr>
-                        <a:t>New right-click menus</a:t>
+                        <a:t>Mega update: 28 new animals, 31 shop items, 13 moves</a:t>
                       </a:r>
                     </a:p>
                     <a:p>
@@ -8964,7 +8964,7 @@
                           </a:solidFill>
                           <a:latin typeface="Segoe UI"/>
                         </a:rPr>
-                        <a:t>✨ Brand-new animated right-click menu for your pet: mood &amp; stat bars, quick-action tiles (Friends, Shop, Snack, Pat, Focus, Stats, Sleep, Taskbar), hover effects and smooth fly-out submenus; Pick colours from swatches, switch size with one click and flip Sounds / Dark mode with toggle switches - changes show instantly; Updates are highlighted: a glowing banner and NEW badge appear in the menu when a new version is ready; The focus card's right-click menu got the same new look; keyboard arrows, Enter and Esc work too</a:t>
+                        <a:t>🦁 28 new animals (51 total): lion, tiger, unicorn, deer, sheep, cow, raccoon, red panda, monkey, hedgehog, dino, squirrel, mouse, koala, shark, dolphin, seal, otter, pufferfish, duck, crab, parrot, chick, ladybug, phoenix, pegasus, ghost and flamingo; 🎩 31 new shop items: top hat, cowboy, chef, pirate, Santa, viking, graduation cap, beret, bow, propeller cap, flower crown, nerd glasses, eyepatch, mustache, goggles, masquerade mask, tie, pearls, flower lei, gold chain, balloon, backpack, guitar, shield, butterfly / devil wings and more - plus Premium galaxy crown, galaxy cape and dragon wings; 💃 13 new moves: wave, jump, hearts, sing, yoga, zoomies, cartwheel, juggle, rain dance, breakdance, magic, confetti and the Premium rocket launch; The Shop is now split into sections (Hats, Face, Neck, Back, Moves, Arena gear) with an owned counter for each</a:t>
                       </a:r>
                     </a:p>
                   </a:txBody>
@@ -8988,7 +8988,7 @@
                           </a:solidFill>
                           <a:latin typeface="Segoe UI"/>
                         </a:rPr>
-                        <a:t>2.10.0</a:t>
+                        <a:t>2.11.0</a:t>
                       </a:r>
                     </a:p>
                   </a:txBody>
@@ -9032,7 +9032,7 @@
                           </a:solidFill>
                           <a:latin typeface="Segoe UI"/>
                         </a:rPr>
-                        <a:t>Chat bots</a:t>
+                        <a:t>New right-click menus</a:t>
                       </a:r>
                     </a:p>
                     <a:p>
@@ -9043,7 +9043,7 @@
                           </a:solidFill>
                           <a:latin typeface="Segoe UI"/>
                         </a:rPr>
-                        <a:t>🤖 6 friendly chat bots in the Chat tab: Pip Helper (app questions), Coach Focus (focus tips from your real stats), Sunny (live weather for any city), Arena Master (battle tips + quick battle), Giggles (jokes &amp; games) and Guardian (safety &amp; reporting help); Private bot chats with suggestion chips, typing indicator and a clear button - your bot chats stay on your PC; Mention a bot in a group chat (e.g. @weather Batam) and it answers in the room for everyone; Bots reply in your app language; up to 120 bot messages per day</a:t>
+                        <a:t>✨ Brand-new animated right-click menu for your pet: mood &amp; stat bars, quick-action tiles (Friends, Shop, Snack, Pat, Focus, Stats, Sleep, Taskbar), hover effects and smooth fly-out submenus; Pick colours from swatches, switch size with one click and flip Sounds / Dark mode with toggle switches - changes show instantly; Updates are highlighted: a glowing banner and NEW badge appear in the menu when a new version is ready; The focus card's right-click menu got the same new look; keyboard arrows, Enter and Esc work too</a:t>
                       </a:r>
                     </a:p>
                   </a:txBody>
@@ -9067,7 +9067,7 @@
                           </a:solidFill>
                           <a:latin typeface="Segoe UI"/>
                         </a:rPr>
-                        <a:t>2.9.0</a:t>
+                        <a:t>2.10.0</a:t>
                       </a:r>
                     </a:p>
                   </a:txBody>
@@ -9111,7 +9111,7 @@
                           </a:solidFill>
                           <a:latin typeface="Segoe UI"/>
                         </a:rPr>
-                        <a:t>Location &amp; live weather</a:t>
+                        <a:t>Chat bots</a:t>
                       </a:r>
                     </a:p>
                     <a:p>
@@ -9122,7 +9122,7 @@
                           </a:solidFill>
                           <a:latin typeface="Segoe UI"/>
                         </a:rPr>
-                        <a:t>📍 Add your city in Profile → Location &amp; weather (auto-detect or search) - only your city and country are shown, never your exact position; Live weather banners on every profile with animations: rain, drizzle, thunderstorms with lightning, snow, fog, clouds, sunshine or a starry night - plus temperature, feels-like, humidity, wind and local time; Your own weather strip on top of the hub, and each friend's weather + local time in the friends list; Hide your location from others or remove it any time</a:t>
+                        <a:t>🤖 6 friendly chat bots in the Chat tab: Pip Helper (app questions), Coach Focus (focus tips from your real stats), Sunny (live weather for any city), Arena Master (battle tips + quick battle), Giggles (jokes &amp; games) and Guardian (safety &amp; reporting help); Private bot chats with suggestion chips, typing indicator and a clear button - your bot chats stay on your PC; Mention a bot in a group chat (e.g. @weather Batam) and it answers in the room for everyone; Bots reply in your app language; up to 120 bot messages per day</a:t>
                       </a:r>
                     </a:p>
                   </a:txBody>
@@ -9146,7 +9146,7 @@
                           </a:solidFill>
                           <a:latin typeface="Segoe UI"/>
                         </a:rPr>
-                        <a:t>2.8.0</a:t>
+                        <a:t>2.9.0</a:t>
                       </a:r>
                     </a:p>
                   </a:txBody>
@@ -9190,7 +9190,7 @@
                           </a:solidFill>
                           <a:latin typeface="Segoe UI"/>
                         </a:rPr>
-                        <a:t>Pips Arena - duels, gear &amp; live battles</a:t>
+                        <a:t>Location &amp; live weather</a:t>
                       </a:r>
                     </a:p>
                     <a:p>
@@ -9201,7 +9201,7 @@
                           </a:solidFill>
                           <a:latin typeface="Segoe UI"/>
                         </a:rPr>
-                        <a:t>⚔ New Arena tab: challenge friends or anyone in the arena to a live duel - each round pick Attack, Guard or Special within 12 seconds and watch your pets fight; ⚡ Quick battle: an instant auto-fight against anyone's fighter, even when they're offline; Arena gear in the Shop: 7 weapons (water pistol to rocket launcher), 5 armors and 5 gadgets that decide your special move - better gear and a higher level make a stronger fighter; Live duels can be watched by everyone, plus recent battle replays, top fighters, rating and win/loss records; wins earn coins</a:t>
+                        <a:t>📍 Add your city in Profile → Location &amp; weather (auto-detect or search) - only your city and country are shown, never your exact position; Live weather banners on every profile with animations: rain, drizzle, thunderstorms with lightning, snow, fog, clouds, sunshine or a starry night - plus temperature, feels-like, humidity, wind and local time; Your own weather strip on top of the hub, and each friend's weather + local time in the friends list; Hide your location from others or remove it any time</a:t>
                       </a:r>
                     </a:p>
                   </a:txBody>
@@ -9225,7 +9225,7 @@
                           </a:solidFill>
                           <a:latin typeface="Segoe UI"/>
                         </a:rPr>
-                        <a:t>2.7.0</a:t>
+                        <a:t>2.8.0</a:t>
                       </a:r>
                     </a:p>
                   </a:txBody>
@@ -9269,7 +9269,7 @@
                           </a:solidFill>
                           <a:latin typeface="Segoe UI"/>
                         </a:rPr>
-                        <a:t>Moderators &amp; Premium</a:t>
+                        <a:t>Pips Arena - duels, gear &amp; live battles</a:t>
                       </a:r>
                     </a:p>
                     <a:p>
@@ -9280,7 +9280,7 @@
                           </a:solidFill>
                           <a:latin typeface="Segoe UI"/>
                         </a:rPr>
-                        <a:t>★ Premium: a purple Premium badge, 4 exclusive props (tiara, star glasses, diamond necklace, fairy wings), the Fireworks move, +30 coins every day, double friend-interaction coins and room for 300 friends / 30 groups; Get Premium: Profile tab → Premium → "Ask to buy" emails the owner; after payment you receive a key (PIPS-XXXX-XXXX) to redeem right there; 🛡 Moderators: a blue Mod badge and a Mod tab with the report queue - warn, mute (1h / 24h / 7 days), clear a profile or reset a name; every action is logged; Report button on everyone's profile, so moderators can keep Pips friendly</a:t>
+                        <a:t>⚔ New Arena tab: challenge friends or anyone in the arena to a live duel - each round pick Attack, Guard or Special within 12 seconds and watch your pets fight; ⚡ Quick battle: an instant auto-fight against anyone's fighter, even when they're offline; Arena gear in the Shop: 7 weapons (water pistol to rocket launcher), 5 armors and 5 gadgets that decide your special move - better gear and a higher level make a stronger fighter; Live duels can be watched by everyone, plus recent battle replays, top fighters, rating and win/loss records; wins earn coins</a:t>
                       </a:r>
                     </a:p>
                   </a:txBody>
@@ -9304,7 +9304,7 @@
                           </a:solidFill>
                           <a:latin typeface="Segoe UI"/>
                         </a:rPr>
-                        <a:t>2.6.1</a:t>
+                        <a:t>2.7.0</a:t>
                       </a:r>
                     </a:p>
                   </a:txBody>
@@ -9348,7 +9348,7 @@
                           </a:solidFill>
                           <a:latin typeface="Segoe UI"/>
                         </a:rPr>
-                        <a:t>Owner badge &amp; credits</a:t>
+                        <a:t>Moderators &amp; Premium</a:t>
                       </a:r>
                     </a:p>
                     <a:p>
@@ -9359,7 +9359,7 @@
                           </a:solidFill>
                           <a:latin typeface="Segoe UI"/>
                         </a:rPr>
-                        <a:t>The creator of Pips (Juwen Lie) now shows a gold ♛ Owner badge on his profile, friend list and ranks; New About Pips card in the Profile tab: credits and how to contact the owner (Juwen_Lie@pegatroncorp.com) with Email and Copy buttons; Right-click the pet → Help → About now shows who made Pips and the contact email</a:t>
+                        <a:t>★ Premium: a purple Premium badge, 4 exclusive props (tiara, star glasses, diamond necklace, fairy wings), the Fireworks move, +30 coins every day, double friend-interaction coins and room for 300 friends / 30 groups; Get Premium: Profile tab → Premium → "Ask to buy" emails the owner; after payment you receive a key (PIPS-XXXX-XXXX) to redeem right there; 🛡 Moderators: a blue Mod badge and a Mod tab with the report queue - warn, mute (1h / 24h / 7 days), clear a profile or reset a name; every action is logged; Report button on everyone's profile, so moderators can keep Pips friendly</a:t>
                       </a:r>
                     </a:p>
                   </a:txBody>
@@ -9383,7 +9383,7 @@
                           </a:solidFill>
                           <a:latin typeface="Segoe UI"/>
                         </a:rPr>
-                        <a:t>2.6.0</a:t>
+                        <a:t>2.6.1</a:t>
                       </a:r>
                     </a:p>
                   </a:txBody>
@@ -9427,7 +9427,7 @@
                           </a:solidFill>
                           <a:latin typeface="Segoe UI"/>
                         </a:rPr>
-                        <a:t>Profiles, ranks, online status &amp; dark mode</a:t>
+                        <a:t>Owner badge &amp; credits</a:t>
                       </a:r>
                     </a:p>
                     <a:p>
@@ -9438,7 +9438,7 @@
                           </a:solidFill>
                           <a:latin typeface="Segoe UI"/>
                         </a:rPr>
-                        <a:t>Profile tab: profile picture (or your pet), about me, job, location, hobbies, birthday and a status message; Public or private: public profiles can be added directly and viewed in full; private profiles need a friend request that they accept, and strangers only see name, photo, pet, level and status; Click anyone to open their profile - badges, info, their friends - and add them, chat or wave from there; Ranks tab replaces Teams: everyone using Pips, sorted by XP, badges or streak</a:t>
+                        <a:t>The creator of Pips (Juwen Lie) now shows a gold ♛ Owner badge on his profile, friend list and ranks; New About Pips card in the Profile tab: credits and how to contact the owner (Juwen_Lie@pegatroncorp.com) with Email and Copy buttons; Right-click the pet → Help → About now shows who made Pips and the contact email</a:t>
                       </a:r>
                     </a:p>
                   </a:txBody>
@@ -9462,7 +9462,7 @@
                           </a:solidFill>
                           <a:latin typeface="Segoe UI"/>
                         </a:rPr>
-                        <a:t>2.5.1</a:t>
+                        <a:t>2.6.0</a:t>
                       </a:r>
                     </a:p>
                   </a:txBody>
@@ -9506,7 +9506,7 @@
                           </a:solidFill>
                           <a:latin typeface="Segoe UI"/>
                         </a:rPr>
-                        <a:t>New cute Pips logo</a:t>
+                        <a:t>Profiles, ranks, online status &amp; dark mode</a:t>
                       </a:r>
                     </a:p>
                     <a:p>
@@ -9517,7 +9517,7 @@
                           </a:solidFill>
                           <a:latin typeface="Segoe UI"/>
                         </a:rPr>
-                        <a:t>New Pips logo: Pip the cat on a Pips-red tile, matching the app colours (desktop shortcut, windows and website)</a:t>
+                        <a:t>Profile tab: profile picture (or your pet), about me, job, location, hobbies, birthday and a status message; Public or private: public profiles can be added directly and viewed in full; private profiles need a friend request that they accept, and strangers only see name, photo, pet, level and status; Click anyone to open their profile - badges, info, their friends - and add them, chat or wave from there; Ranks tab replaces Teams: everyone using Pips, sorted by XP, badges or streak</a:t>
                       </a:r>
                     </a:p>
                   </a:txBody>
@@ -9541,7 +9541,7 @@
                           </a:solidFill>
                           <a:latin typeface="Segoe UI"/>
                         </a:rPr>
-                        <a:t>2.5.0</a:t>
+                        <a:t>2.5.1</a:t>
                       </a:r>
                     </a:p>
                   </a:txBody>
@@ -9585,7 +9585,7 @@
                           </a:solidFill>
                           <a:latin typeface="Segoe UI"/>
                         </a:rPr>
-                        <a:t>Shop, coins, props &amp; moves</a:t>
+                        <a:t>New cute Pips logo</a:t>
                       </a:r>
                     </a:p>
                     <a:p>
@@ -9596,7 +9596,7 @@
                           </a:solidFill>
                           <a:latin typeface="Segoe UI"/>
                         </a:rPr>
-                        <a:t>Shop: earn coins and spend them on your pet - 17 props (crown, wizard hat, headphones, shades, scarf, cape, angel wings...) and 6 moves: spin, dance, moonwalk, backflip, kung fu and spider swing!; Coins come from leveling up (+40), badges (+25), opening Pips each day (+10), friendships (+15 per affinity level), waving / chatting / visiting friends (+2) and pomodoros (+5). Everyone starts with a 100-coin gift; Your friends see your props: on avatars in the hub and when your pet visits their desktop - it shows off one of your moves; Pips is now a social pet: clicking the pet opens the Pips hub (friends, chat, groups, shop, badges)</a:t>
+                        <a:t>New Pips logo: Pip the cat on a Pips-red tile, matching the app colours (desktop shortcut, windows and website)</a:t>
                       </a:r>
                     </a:p>
                   </a:txBody>
@@ -9620,7 +9620,7 @@
                           </a:solidFill>
                           <a:latin typeface="Segoe UI"/>
                         </a:rPr>
-                        <a:t>2.4.0</a:t>
+                        <a:t>2.5.0</a:t>
                       </a:r>
                     </a:p>
                   </a:txBody>
@@ -9664,7 +9664,7 @@
                           </a:solidFill>
                           <a:latin typeface="Segoe UI"/>
                         </a:rPr>
-                        <a:t>Chat, groups, affinity &amp; pet visits</a:t>
+                        <a:t>Shop, coins, props &amp; moves</a:t>
                       </a:r>
                     </a:p>
                     <a:p>
@@ -9675,7 +9675,7 @@
                           </a:solidFill>
                           <a:latin typeface="Segoe UI"/>
                         </a:rPr>
-                        <a:t>Chat: message your friends, and chat inside groups. Your pet pops up new messages as a bubble - click it to reply; Pet interactions: wave, pet their pet, send a snack, high five - or send your pet to visit: it walks onto your friend's desktop for a little while!; Affinity: every chat and interaction grows your friendship - Acquaintance → Buddy → Good friends → Close friends → Best friends → Soulmates; Your own groups: create a private group, invite your friends, they accept or decline. Group board + group chat; the owner can remove members</a:t>
+                        <a:t>Shop: earn coins and spend them on your pet - 17 props (crown, wizard hat, headphones, shades, scarf, cape, angel wings...) and 6 moves: spin, dance, moonwalk, backflip, kung fu and spider swing!; Coins come from leveling up (+40), badges (+25), opening Pips each day (+10), friendships (+15 per affinity level), waving / chatting / visiting friends (+2) and pomodoros (+5). Everyone starts with a 100-coin gift; Your friends see your props: on avatars in the hub and when your pet visits their desktop - it shows off one of your moves; Pips is now a social pet: clicking the pet opens the Pips hub (friends, chat, groups, shop, badges)</a:t>
                       </a:r>
                     </a:p>
                   </a:txBody>
@@ -9699,7 +9699,7 @@
                           </a:solidFill>
                           <a:latin typeface="Segoe UI"/>
                         </a:rPr>
-                        <a:t>2.3.0</a:t>
+                        <a:t>2.4.0</a:t>
                       </a:r>
                     </a:p>
                   </a:txBody>
@@ -9743,7 +9743,7 @@
                           </a:solidFill>
                           <a:latin typeface="Segoe UI"/>
                         </a:rPr>
-                        <a:t>Friends, levels &amp; achievements</a:t>
+                        <a:t>Chat, groups, affinity &amp; pet visits</a:t>
                       </a:r>
                     </a:p>
                     <a:p>
@@ -9754,7 +9754,7 @@
                           </a:solidFill>
                           <a:latin typeface="Segoe UI"/>
                         </a:rPr>
-                        <a:t>Levels &amp; XP: every finished pomodoro earns XP and your level grows - plus 20 achievements to unlock (first tomato, 8 in a day, 7-day streak, early bird, night owl, pet lover...). Your pet celebrates each one; Friends (optional, off by default): get a 6-letter friend code, add colleagues, see today's board and join a team board like PTB. Your pet tells you when a friend finishes a pomodoro; Privacy: only your name, pet, level, streak and pomodoro counts are shared - never apps, window titles or scores. One click turns it off and deletes your online data. Right-click the pet → Friends &amp; achievements…</a:t>
+                        <a:t>Chat: message your friends, and chat inside groups. Your pet pops up new messages as a bubble - click it to reply; Pet interactions: wave, pet their pet, send a snack, high five - or send your pet to visit: it walks onto your friend's desktop for a little while!; Affinity: every chat and interaction grows your friendship - Acquaintance → Buddy → Good friends → Close friends → Best friends → Soulmates; Your own groups: create a private group, invite your friends, they accept or decline. Group board + group chat; the owner can remove members</a:t>
                       </a:r>
                     </a:p>
                   </a:txBody>
@@ -9778,7 +9778,7 @@
                           </a:solidFill>
                           <a:latin typeface="Segoe UI"/>
                         </a:rPr>
-                        <a:t>2.2.0</a:t>
+                        <a:t>2.3.0</a:t>
                       </a:r>
                     </a:p>
                   </a:txBody>
@@ -9822,7 +9822,7 @@
                           </a:solidFill>
                           <a:latin typeface="Segoe UI"/>
                         </a:rPr>
-                        <a:t>Pet sounds</a:t>
+                        <a:t>Friends, levels &amp; achievements</a:t>
                       </a:r>
                     </a:p>
                     <a:p>
@@ -9833,7 +9833,7 @@
                           </a:solidFill>
                           <a:latin typeface="Segoe UI"/>
                         </a:rPr>
-                        <a:t>Your pet has a voice! Each of the 23 animals has its own sound (meow, woof, ribbit, hoot, buzz, oink, whale song...) and it changes with its mood: happy chirps, sad whimpers, sleepy yawns, hungry calls, grumpy huffs and soft snores; It also reacts with sound when you tickle, pet, feed, shake or wake it; Settings: right-click the pet → Sounds to switch on/off; Pet status &amp; settings has a volume slider, a ▶ Hear me button and "Stay quiet while I'm focusing" (on by default)</a:t>
+                        <a:t>Levels &amp; XP: every finished pomodoro earns XP and your level grows - plus 20 achievements to unlock (first tomato, 8 in a day, 7-day streak, early bird, night owl, pet lover...). Your pet celebrates each one; Friends (optional, off by default): get a 6-letter friend code, add colleagues, see today's board and join a team board like PTB. Your pet tells you when a friend finishes a pomodoro; Privacy: only your name, pet, level, streak and pomodoro counts are shared - never apps, window titles or scores. One click turns it off and deletes your online data. Right-click the pet → Friends &amp; achievements…</a:t>
                       </a:r>
                     </a:p>
                   </a:txBody>
@@ -9857,7 +9857,7 @@
                           </a:solidFill>
                           <a:latin typeface="Segoe UI"/>
                         </a:rPr>
-                        <a:t>2.1.2</a:t>
+                        <a:t>2.2.0</a:t>
                       </a:r>
                     </a:p>
                   </a:txBody>
@@ -9901,7 +9901,7 @@
                           </a:solidFill>
                           <a:latin typeface="Segoe UI"/>
                         </a:rPr>
-                        <a:t>Tickle-only mode</a:t>
+                        <a:t>Pet sounds</a:t>
                       </a:r>
                     </a:p>
                     <a:p>
@@ -9912,7 +9912,7 @@
                           </a:solidFill>
                           <a:latin typeface="Segoe UI"/>
                         </a:rPr>
-                        <a:t>New click option "Only tickle (never open Pips)": click and tickle your pet as much as you like - the Pomodoro window stays closed (open it from the right-click menu). Right-click the pet → When I click</a:t>
+                        <a:t>Your pet has a voice! Each of the 23 animals has its own sound (meow, woof, ribbit, hoot, buzz, oink, whale song...) and it changes with its mood: happy chirps, sad whimpers, sleepy yawns, hungry calls, grumpy huffs and soft snores; It also reacts with sound when you tickle, pet, feed, shake or wake it; Settings: right-click the pet → Sounds to switch on/off; Pet status &amp; settings has a volume slider, a ▶ Hear me button and "Stay quiet while I'm focusing" (on by default)</a:t>
                       </a:r>
                     </a:p>
                   </a:txBody>
@@ -9936,7 +9936,7 @@
                           </a:solidFill>
                           <a:latin typeface="Segoe UI"/>
                         </a:rPr>
-                        <a:t>2.1.1</a:t>
+                        <a:t>2.1.2</a:t>
                       </a:r>
                     </a:p>
                   </a:txBody>
@@ -9980,7 +9980,7 @@
                           </a:solidFill>
                           <a:latin typeface="Segoe UI"/>
                         </a:rPr>
-                        <a:t>Owner info</a:t>
+                        <a:t>Tickle-only mode</a:t>
                       </a:r>
                     </a:p>
                     <a:p>
@@ -9991,7 +9991,7 @@
                           </a:solidFill>
                           <a:latin typeface="Segoe UI"/>
                         </a:rPr>
-                        <a:t>About Pips now shows the owner: Juwen Lie (right-click the pet → Help → About)</a:t>
+                        <a:t>New click option "Only tickle (never open Pips)": click and tickle your pet as much as you like - the Pomodoro window stays closed (open it from the right-click menu). Right-click the pet → When I click</a:t>
                       </a:r>
                     </a:p>
                   </a:txBody>
@@ -10015,7 +10015,7 @@
                           </a:solidFill>
                           <a:latin typeface="Segoe UI"/>
                         </a:rPr>
-                        <a:t>2.1.0</a:t>
+                        <a:t>2.1.1</a:t>
                       </a:r>
                     </a:p>
                   </a:txBody>
@@ -10059,7 +10059,7 @@
                           </a:solidFill>
                           <a:latin typeface="Segoe UI"/>
                         </a:rPr>
-                        <a:t>Interactive guide &amp; in-app updates</a:t>
+                        <a:t>Owner info</a:t>
                       </a:r>
                     </a:p>
                     <a:p>
@@ -10070,7 +10070,7 @@
                           </a:solidFill>
                           <a:latin typeface="Segoe UI"/>
                         </a:rPr>
-                        <a:t>Interactive first-run guide: your pet walks you through clicking, dragging, petting and the right-click menu; In-app updates: Pips tells you when a new version is out - update with one click (your settings and data are kept); New Help menu: replay the guide, check for updates, see the version; Option to turn automatic update checks off</a:t>
+                        <a:t>About Pips now shows the owner: Juwen Lie (right-click the pet → Help → About)</a:t>
                       </a:r>
                     </a:p>
                   </a:txBody>
@@ -10094,7 +10094,7 @@
                           </a:solidFill>
                           <a:latin typeface="Segoe UI"/>
                         </a:rPr>
-                        <a:t>2.0.0</a:t>
+                        <a:t>2.1.0</a:t>
                       </a:r>
                     </a:p>
                   </a:txBody>
@@ -10138,7 +10138,7 @@
                           </a:solidFill>
                           <a:latin typeface="Segoe UI"/>
                         </a:rPr>
-                        <a:t>Desktop pet, 23 animals &amp; 4 languages</a:t>
+                        <a:t>Interactive guide &amp; in-app updates</a:t>
                       </a:r>
                     </a:p>
                     <a:p>
@@ -10149,7 +10149,7 @@
                           </a:solidFill>
                           <a:latin typeface="Segoe UI"/>
                         </a:rPr>
-                        <a:t>Desktop pet that lives on your desktop and taskbar - drag it, tickle it, pet it; 23 animals in 3 groups: Land walks, Water swims with bubbles, Sky hovers and flaps; Moods (happy, sad, tired, hungry, grumpy...), naps when you're away, wakes up when you're back; Cute chat-bubble reminders: breaks, water, 20-20-20 eye rest, pomodoro done, daily goal</a:t>
+                        <a:t>Interactive first-run guide: your pet walks you through clicking, dragging, petting and the right-click menu; In-app updates: Pips tells you when a new version is out - update with one click (your settings and data are kept); New Help menu: replay the guide, check for updates, see the version; Option to turn automatic update checks off</a:t>
                       </a:r>
                     </a:p>
                   </a:txBody>
@@ -10173,7 +10173,7 @@
                           </a:solidFill>
                           <a:latin typeface="Segoe UI"/>
                         </a:rPr>
-                        <a:t>1.5.0</a:t>
+                        <a:t>2.0.0</a:t>
                       </a:r>
                     </a:p>
                   </a:txBody>
@@ -10195,13 +10195,92 @@
                           </a:solidFill>
                           <a:latin typeface="Segoe UI"/>
                         </a:rPr>
+                        <a:t>2026-10-28</a:t>
+                      </a:r>
+                    </a:p>
+                  </a:txBody>
+                  <a:tcPr marL="73152" marR="73152" marT="36576" marB="36576">
+                    <a:solidFill>
+                      <a:srgbClr val="FFFDF8"/>
+                    </a:solidFill>
+                  </a:tcPr>
+                </a:tc>
+                <a:tc>
+                  <a:txBody>
+                    <a:bodyPr wrap="square"/>
+                    <a:lstStyle/>
+                    <a:p>
+                      <a:r>
+                        <a:rPr sz="1200" b="0">
+                          <a:solidFill>
+                            <a:srgbClr val="2B2A28"/>
+                          </a:solidFill>
+                          <a:latin typeface="Segoe UI"/>
+                        </a:rPr>
+                        <a:t>Desktop pet, 23 animals &amp; 4 languages</a:t>
+                      </a:r>
+                    </a:p>
+                    <a:p>
+                      <a:r>
+                        <a:rPr sz="1200" b="0">
+                          <a:solidFill>
+                            <a:srgbClr val="2B2A28"/>
+                          </a:solidFill>
+                          <a:latin typeface="Segoe UI"/>
+                        </a:rPr>
+                        <a:t>Desktop pet that lives on your desktop and taskbar - drag it, tickle it, pet it; 23 animals in 3 groups: Land walks, Water swims with bubbles, Sky hovers and flaps; Moods (happy, sad, tired, hungry, grumpy...), naps when you're away, wakes up when you're back; Cute chat-bubble reminders: breaks, water, 20-20-20 eye rest, pomodoro done, daily goal</a:t>
+                      </a:r>
+                    </a:p>
+                  </a:txBody>
+                  <a:tcPr marL="73152" marR="73152" marT="36576" marB="36576">
+                    <a:solidFill>
+                      <a:srgbClr val="FFFDF8"/>
+                    </a:solidFill>
+                  </a:tcPr>
+                </a:tc>
+              </a:tr>
+              <a:tr h="822960">
+                <a:tc>
+                  <a:txBody>
+                    <a:bodyPr wrap="square"/>
+                    <a:lstStyle/>
+                    <a:p>
+                      <a:r>
+                        <a:rPr sz="1200" b="1">
+                          <a:solidFill>
+                            <a:srgbClr val="2B2A28"/>
+                          </a:solidFill>
+                          <a:latin typeface="Segoe UI"/>
+                        </a:rPr>
+                        <a:t>1.5.0</a:t>
+                      </a:r>
+                    </a:p>
+                  </a:txBody>
+                  <a:tcPr marL="73152" marR="73152" marT="36576" marB="36576">
+                    <a:solidFill>
+                      <a:srgbClr val="F7F4EC"/>
+                    </a:solidFill>
+                  </a:tcPr>
+                </a:tc>
+                <a:tc>
+                  <a:txBody>
+                    <a:bodyPr wrap="square"/>
+                    <a:lstStyle/>
+                    <a:p>
+                      <a:r>
+                        <a:rPr sz="1200" b="0">
+                          <a:solidFill>
+                            <a:srgbClr val="2B2A28"/>
+                          </a:solidFill>
+                          <a:latin typeface="Segoe UI"/>
+                        </a:rPr>
                         <a:t>2026-10-24</a:t>
                       </a:r>
                     </a:p>
                   </a:txBody>
                   <a:tcPr marL="73152" marR="73152" marT="36576" marB="36576">
                     <a:solidFill>
-                      <a:srgbClr val="FFFDF8"/>
+                      <a:srgbClr val="F7F4EC"/>
                     </a:solidFill>
                   </a:tcPr>
                 </a:tc>
@@ -10234,7 +10313,7 @@
                   </a:txBody>
                   <a:tcPr marL="73152" marR="73152" marT="36576" marB="36576">
                     <a:solidFill>
-                      <a:srgbClr val="FFFDF8"/>
+                      <a:srgbClr val="F7F4EC"/>
                     </a:solidFill>
                   </a:tcPr>
                 </a:tc>
@@ -10258,7 +10337,7 @@
                   </a:txBody>
                   <a:tcPr marL="73152" marR="73152" marT="36576" marB="36576">
                     <a:solidFill>
-                      <a:srgbClr val="F7F4EC"/>
+                      <a:srgbClr val="FFFDF8"/>
                     </a:solidFill>
                   </a:tcPr>
                 </a:tc>
@@ -10280,7 +10359,7 @@
                   </a:txBody>
                   <a:tcPr marL="73152" marR="73152" marT="36576" marB="36576">
                     <a:solidFill>
-                      <a:srgbClr val="F7F4EC"/>
+                      <a:srgbClr val="FFFDF8"/>
                     </a:solidFill>
                   </a:tcPr>
                 </a:tc>
@@ -10313,7 +10392,7 @@
                   </a:txBody>
                   <a:tcPr marL="73152" marR="73152" marT="36576" marB="36576">
                     <a:solidFill>
-                      <a:srgbClr val="F7F4EC"/>
+                      <a:srgbClr val="FFFDF8"/>
                     </a:solidFill>
                   </a:tcPr>
                 </a:tc>

</xml_diff>

<commit_message>
pips 2.13.0: Birthdays, parties & gifts
</commit_message>
<xml_diff>
--- a/apps/pips/web/download/Pips-Guide.pptx
+++ b/apps/pips/web/download/Pips-Guide.pptx
@@ -3292,7 +3292,7 @@
                 </a:solidFill>
                 <a:latin typeface="Segoe UI"/>
               </a:rPr>
-              <a:t>Version 2.12.0  ·  2026-10-28  ·  Made by Juwen Lie (owner)</a:t>
+              <a:t>Version 2.13.0  ·  2026-10-28  ·  Made by Juwen Lie (owner)</a:t>
             </a:r>
           </a:p>
           <a:p>
@@ -8141,7 +8141,7 @@
                 </a:solidFill>
                 <a:latin typeface="Segoe UI"/>
               </a:rPr>
-              <a:t>What's new in 2.12.0</a:t>
+              <a:t>What's new in 2.13.0</a:t>
             </a:r>
           </a:p>
         </p:txBody>
@@ -8254,7 +8254,7 @@
                 </a:solidFill>
                 <a:latin typeface="Segoe UI"/>
               </a:rPr>
-              <a:t>Mega update: 28 new animals, 31 shop items, 13 moves  ·  2026-10-28</a:t>
+              <a:t>Birthdays, parties &amp; gifts  ·  2026-10-28</a:t>
             </a:r>
           </a:p>
         </p:txBody>
@@ -8302,7 +8302,7 @@
                 </a:solidFill>
                 <a:latin typeface="Segoe UI"/>
               </a:rPr>
-              <a:t>🦁 28 new animals (51 total): lion, tiger, unicorn, deer, sheep, cow, raccoon, red panda, monkey, hedgehog, dino, squirrel, mouse, koala, shark, dolphin, seal, otter, pufferfish, duck, crab, parrot, chick, ladybug, phoenix, pegasus, ghost and flamingo</a:t>
+              <a:t>Set your birthday in Social → Profile (month + day, optionally visible to friends).</a:t>
             </a:r>
           </a:p>
           <a:p>
@@ -8327,7 +8327,7 @@
                 </a:solidFill>
                 <a:latin typeface="Segoe UI"/>
               </a:rPr>
-              <a:t>🎩 31 new shop items: top hat, cowboy, chef, pirate, Santa, viking, graduation cap, beret, bow, propeller cap, flower crown, nerd glasses, eyepatch, mustache, goggles, masquerade mask, tie, pearls, flower lei, gold chain, balloon, backpack, guitar, shield, butterfly / devil wings and more - plus Premium galaxy crown, galaxy cape and dragon wings</a:t>
+              <a:t>On your birthday Pips throws confetti and gives you 100 bonus coins.</a:t>
             </a:r>
           </a:p>
           <a:p>
@@ -8352,7 +8352,7 @@
                 </a:solidFill>
                 <a:latin typeface="Segoe UI"/>
               </a:rPr>
-              <a:t>💃 13 new moves: wave, jump, hearts, sing, yoga, zoomies, cartwheel, juggle, rain dance, breakdance, magic, confetti and the Premium rocket launch</a:t>
+              <a:t>Friends tab shows upcoming birthdays; you get reminders 3 days, 1 day and on the day.</a:t>
             </a:r>
           </a:p>
           <a:p>
@@ -8377,7 +8377,32 @@
                 </a:solidFill>
                 <a:latin typeface="Segoe UI"/>
               </a:rPr>
-              <a:t>The Shop is now split into sections (Hats, Face, Neck, Back, Moves, Arena gear) with an owned counter for each</a:t>
+              <a:t>Birthday parties: join a friend's party, see who's there, sign the guestbook and celebrate together.</a:t>
+            </a:r>
+          </a:p>
+          <a:p>
+            <a:pPr>
+              <a:spcAft>
+                <a:spcPts val="1000"/>
+              </a:spcAft>
+            </a:pPr>
+            <a:r>
+              <a:rPr sz="1700" b="1">
+                <a:solidFill>
+                  <a:srgbClr val="4CB86B"/>
+                </a:solidFill>
+                <a:latin typeface="Segoe UI"/>
+              </a:rPr>
+              <a:t>•  </a:t>
+            </a:r>
+            <a:r>
+              <a:rPr sz="1700">
+                <a:solidFill>
+                  <a:srgbClr val="2B2A28"/>
+                </a:solidFill>
+                <a:latin typeface="Segoe UI"/>
+              </a:rPr>
+              <a:t>Send gifts: any shop item (previewed on their pet), coins, or both, with a message — paid from your own coins.</a:t>
             </a:r>
           </a:p>
         </p:txBody>
@@ -8508,7 +8533,7 @@
                 </a:solidFill>
                 <a:latin typeface="Segoe UI"/>
               </a:rPr>
-              <a:t>🦁 28 hewan baru (total 51): singa, harimau, unicorn, rusa, domba, sapi, rakun, panda merah, monyet, landak, dino, tupai, tikus, koala, hiu, lumba-lumba, anjing laut, berang-berang, ikan buntal, bebek, kepiting, beo, anak ayam, kepik, phoenix, pegasus, hantu dan flamingo</a:t>
+              <a:t>Atur ulang tahunmu di Sosial → Profil (bulan + tanggal, bisa ditampilkan ke teman).</a:t>
             </a:r>
           </a:p>
           <a:p>
@@ -8533,7 +8558,7 @@
                 </a:solidFill>
                 <a:latin typeface="Segoe UI"/>
               </a:rPr>
-              <a:t>🎩 31 item toko baru: topi tinggi, koboi, koki, bajak laut, Sinterklas, viking, topi wisuda, baret, pita, topi baling-baling, mahkota bunga, kacamata kutu buku, penutup mata, kumis, kacamata renang, topeng pesta, dasi, mutiara, kalung bunga, kalung emas, balon, ransel, gitar, perisai, sayap kupu-kupu / iblis dan lainnya - plus mahkota galaksi, jubah galaksi dan sayap naga khusus Premium</a:t>
+              <a:t>Di hari ulang tahunmu Pips menebar konfeti dan memberi 100 koin bonus.</a:t>
             </a:r>
           </a:p>
           <a:p>
@@ -8558,7 +8583,7 @@
                 </a:solidFill>
                 <a:latin typeface="Segoe UI"/>
               </a:rPr>
-              <a:t>💃 13 gerakan baru: lambai, lompat, hati, nyanyi, yoga, lari kencang, roda, juggling, tari hujan, breakdance, sulap, konfeti dan peluncuran roket Premium</a:t>
+              <a:t>Tab Teman menampilkan ulang tahun terdekat; pengingat 3 hari, 1 hari, dan di hari-H.</a:t>
             </a:r>
           </a:p>
           <a:p>
@@ -8583,7 +8608,32 @@
                 </a:solidFill>
                 <a:latin typeface="Segoe UI"/>
               </a:rPr>
-              <a:t>Toko kini dibagi per bagian (Topi, Wajah, Leher, Punggung, Gerakan, Perlengkapan arena) dengan penghitung item yang dimiliki</a:t>
+              <a:t>Pesta ulang tahun: datang ke pesta teman, lihat siapa yang hadir, tulis di buku tamu dan rayakan bersama.</a:t>
+            </a:r>
+          </a:p>
+          <a:p>
+            <a:pPr>
+              <a:spcAft>
+                <a:spcPts val="500"/>
+              </a:spcAft>
+            </a:pPr>
+            <a:r>
+              <a:rPr sz="1200" b="1">
+                <a:solidFill>
+                  <a:srgbClr val="4CB86B"/>
+                </a:solidFill>
+                <a:latin typeface="Segoe UI"/>
+              </a:rPr>
+              <a:t>•  </a:t>
+            </a:r>
+            <a:r>
+              <a:rPr sz="1200">
+                <a:solidFill>
+                  <a:srgbClr val="2B2A28"/>
+                </a:solidFill>
+                <a:latin typeface="Segoe UI"/>
+              </a:rPr>
+              <a:t>Kirim hadiah: item toko (pratinjau di pet mereka), koin, atau keduanya, dengan pesan — dibayar dari koinmu.</a:t>
             </a:r>
           </a:p>
         </p:txBody>
@@ -8815,7 +8865,7 @@
         </p:nvGraphicFramePr>
         <p:xfrm>
           <a:off x="548640" y="1645920"/>
-          <a:ext cx="11155680" cy="16020288"/>
+          <a:ext cx="11155680" cy="16843248"/>
         </p:xfrm>
         <a:graphic>
           <a:graphicData uri="http://schemas.openxmlformats.org/drawingml/2006/table">
@@ -8909,7 +8959,7 @@
                           </a:solidFill>
                           <a:latin typeface="Segoe UI"/>
                         </a:rPr>
-                        <a:t>2.12.0</a:t>
+                        <a:t>2.13.0</a:t>
                       </a:r>
                     </a:p>
                   </a:txBody>
@@ -8953,7 +9003,7 @@
                           </a:solidFill>
                           <a:latin typeface="Segoe UI"/>
                         </a:rPr>
-                        <a:t>Mega update: 28 new animals, 31 shop items, 13 moves</a:t>
+                        <a:t>Birthdays, parties &amp; gifts</a:t>
                       </a:r>
                     </a:p>
                     <a:p>
@@ -8964,7 +9014,7 @@
                           </a:solidFill>
                           <a:latin typeface="Segoe UI"/>
                         </a:rPr>
-                        <a:t>🦁 28 new animals (51 total): lion, tiger, unicorn, deer, sheep, cow, raccoon, red panda, monkey, hedgehog, dino, squirrel, mouse, koala, shark, dolphin, seal, otter, pufferfish, duck, crab, parrot, chick, ladybug, phoenix, pegasus, ghost and flamingo; 🎩 31 new shop items: top hat, cowboy, chef, pirate, Santa, viking, graduation cap, beret, bow, propeller cap, flower crown, nerd glasses, eyepatch, mustache, goggles, masquerade mask, tie, pearls, flower lei, gold chain, balloon, backpack, guitar, shield, butterfly / devil wings and more - plus Premium galaxy crown, galaxy cape and dragon wings; 💃 13 new moves: wave, jump, hearts, sing, yoga, zoomies, cartwheel, juggle, rain dance, breakdance, magic, confetti and the Premium rocket launch; The Shop is now split into sections (Hats, Face, Neck, Back, Moves, Arena gear) with an owned counter for each</a:t>
+                        <a:t>Set your birthday in Social → Profile (month + day, optionally visible to friends).; On your birthday Pips throws confetti and gives you 100 bonus coins.; Friends tab shows upcoming birthdays; you get reminders 3 days, 1 day and on the day.; Birthday parties: join a friend's party, see who's there, sign the guestbook and celebrate together.</a:t>
                       </a:r>
                     </a:p>
                   </a:txBody>
@@ -8988,7 +9038,7 @@
                           </a:solidFill>
                           <a:latin typeface="Segoe UI"/>
                         </a:rPr>
-                        <a:t>2.11.0</a:t>
+                        <a:t>2.12.0</a:t>
                       </a:r>
                     </a:p>
                   </a:txBody>
@@ -9032,7 +9082,7 @@
                           </a:solidFill>
                           <a:latin typeface="Segoe UI"/>
                         </a:rPr>
-                        <a:t>New right-click menus</a:t>
+                        <a:t>Mega update: 28 new animals, 31 shop items, 13 moves</a:t>
                       </a:r>
                     </a:p>
                     <a:p>
@@ -9043,7 +9093,7 @@
                           </a:solidFill>
                           <a:latin typeface="Segoe UI"/>
                         </a:rPr>
-                        <a:t>✨ Brand-new animated right-click menu for your pet: mood &amp; stat bars, quick-action tiles (Friends, Shop, Snack, Pat, Focus, Stats, Sleep, Taskbar), hover effects and smooth fly-out submenus; Pick colours from swatches, switch size with one click and flip Sounds / Dark mode with toggle switches - changes show instantly; Updates are highlighted: a glowing banner and NEW badge appear in the menu when a new version is ready; The focus card's right-click menu got the same new look; keyboard arrows, Enter and Esc work too</a:t>
+                        <a:t>🦁 28 new animals (51 total): lion, tiger, unicorn, deer, sheep, cow, raccoon, red panda, monkey, hedgehog, dino, squirrel, mouse, koala, shark, dolphin, seal, otter, pufferfish, duck, crab, parrot, chick, ladybug, phoenix, pegasus, ghost and flamingo; 🎩 31 new shop items: top hat, cowboy, chef, pirate, Santa, viking, graduation cap, beret, bow, propeller cap, flower crown, nerd glasses, eyepatch, mustache, goggles, masquerade mask, tie, pearls, flower lei, gold chain, balloon, backpack, guitar, shield, butterfly / devil wings and more - plus Premium galaxy crown, galaxy cape and dragon wings; 💃 13 new moves: wave, jump, hearts, sing, yoga, zoomies, cartwheel, juggle, rain dance, breakdance, magic, confetti and the Premium rocket launch; The Shop is now split into sections (Hats, Face, Neck, Back, Moves, Arena gear) with an owned counter for each</a:t>
                       </a:r>
                     </a:p>
                   </a:txBody>
@@ -9067,7 +9117,7 @@
                           </a:solidFill>
                           <a:latin typeface="Segoe UI"/>
                         </a:rPr>
-                        <a:t>2.10.0</a:t>
+                        <a:t>2.11.0</a:t>
                       </a:r>
                     </a:p>
                   </a:txBody>
@@ -9111,7 +9161,7 @@
                           </a:solidFill>
                           <a:latin typeface="Segoe UI"/>
                         </a:rPr>
-                        <a:t>Chat bots</a:t>
+                        <a:t>New right-click menus</a:t>
                       </a:r>
                     </a:p>
                     <a:p>
@@ -9122,7 +9172,7 @@
                           </a:solidFill>
                           <a:latin typeface="Segoe UI"/>
                         </a:rPr>
-                        <a:t>🤖 6 friendly chat bots in the Chat tab: Pip Helper (app questions), Coach Focus (focus tips from your real stats), Sunny (live weather for any city), Arena Master (battle tips + quick battle), Giggles (jokes &amp; games) and Guardian (safety &amp; reporting help); Private bot chats with suggestion chips, typing indicator and a clear button - your bot chats stay on your PC; Mention a bot in a group chat (e.g. @weather Batam) and it answers in the room for everyone; Bots reply in your app language; up to 120 bot messages per day</a:t>
+                        <a:t>✨ Brand-new animated right-click menu for your pet: mood &amp; stat bars, quick-action tiles (Friends, Shop, Snack, Pat, Focus, Stats, Sleep, Taskbar), hover effects and smooth fly-out submenus; Pick colours from swatches, switch size with one click and flip Sounds / Dark mode with toggle switches - changes show instantly; Updates are highlighted: a glowing banner and NEW badge appear in the menu when a new version is ready; The focus card's right-click menu got the same new look; keyboard arrows, Enter and Esc work too</a:t>
                       </a:r>
                     </a:p>
                   </a:txBody>
@@ -9146,7 +9196,7 @@
                           </a:solidFill>
                           <a:latin typeface="Segoe UI"/>
                         </a:rPr>
-                        <a:t>2.9.0</a:t>
+                        <a:t>2.10.0</a:t>
                       </a:r>
                     </a:p>
                   </a:txBody>
@@ -9190,7 +9240,7 @@
                           </a:solidFill>
                           <a:latin typeface="Segoe UI"/>
                         </a:rPr>
-                        <a:t>Location &amp; live weather</a:t>
+                        <a:t>Chat bots</a:t>
                       </a:r>
                     </a:p>
                     <a:p>
@@ -9201,7 +9251,7 @@
                           </a:solidFill>
                           <a:latin typeface="Segoe UI"/>
                         </a:rPr>
-                        <a:t>📍 Add your city in Profile → Location &amp; weather (auto-detect or search) - only your city and country are shown, never your exact position; Live weather banners on every profile with animations: rain, drizzle, thunderstorms with lightning, snow, fog, clouds, sunshine or a starry night - plus temperature, feels-like, humidity, wind and local time; Your own weather strip on top of the hub, and each friend's weather + local time in the friends list; Hide your location from others or remove it any time</a:t>
+                        <a:t>🤖 6 friendly chat bots in the Chat tab: Pip Helper (app questions), Coach Focus (focus tips from your real stats), Sunny (live weather for any city), Arena Master (battle tips + quick battle), Giggles (jokes &amp; games) and Guardian (safety &amp; reporting help); Private bot chats with suggestion chips, typing indicator and a clear button - your bot chats stay on your PC; Mention a bot in a group chat (e.g. @weather Batam) and it answers in the room for everyone; Bots reply in your app language; up to 120 bot messages per day</a:t>
                       </a:r>
                     </a:p>
                   </a:txBody>
@@ -9225,7 +9275,7 @@
                           </a:solidFill>
                           <a:latin typeface="Segoe UI"/>
                         </a:rPr>
-                        <a:t>2.8.0</a:t>
+                        <a:t>2.9.0</a:t>
                       </a:r>
                     </a:p>
                   </a:txBody>
@@ -9269,7 +9319,7 @@
                           </a:solidFill>
                           <a:latin typeface="Segoe UI"/>
                         </a:rPr>
-                        <a:t>Pips Arena - duels, gear &amp; live battles</a:t>
+                        <a:t>Location &amp; live weather</a:t>
                       </a:r>
                     </a:p>
                     <a:p>
@@ -9280,7 +9330,7 @@
                           </a:solidFill>
                           <a:latin typeface="Segoe UI"/>
                         </a:rPr>
-                        <a:t>⚔ New Arena tab: challenge friends or anyone in the arena to a live duel - each round pick Attack, Guard or Special within 12 seconds and watch your pets fight; ⚡ Quick battle: an instant auto-fight against anyone's fighter, even when they're offline; Arena gear in the Shop: 7 weapons (water pistol to rocket launcher), 5 armors and 5 gadgets that decide your special move - better gear and a higher level make a stronger fighter; Live duels can be watched by everyone, plus recent battle replays, top fighters, rating and win/loss records; wins earn coins</a:t>
+                        <a:t>📍 Add your city in Profile → Location &amp; weather (auto-detect or search) - only your city and country are shown, never your exact position; Live weather banners on every profile with animations: rain, drizzle, thunderstorms with lightning, snow, fog, clouds, sunshine or a starry night - plus temperature, feels-like, humidity, wind and local time; Your own weather strip on top of the hub, and each friend's weather + local time in the friends list; Hide your location from others or remove it any time</a:t>
                       </a:r>
                     </a:p>
                   </a:txBody>
@@ -9304,7 +9354,7 @@
                           </a:solidFill>
                           <a:latin typeface="Segoe UI"/>
                         </a:rPr>
-                        <a:t>2.7.0</a:t>
+                        <a:t>2.8.0</a:t>
                       </a:r>
                     </a:p>
                   </a:txBody>
@@ -9348,7 +9398,7 @@
                           </a:solidFill>
                           <a:latin typeface="Segoe UI"/>
                         </a:rPr>
-                        <a:t>Moderators &amp; Premium</a:t>
+                        <a:t>Pips Arena - duels, gear &amp; live battles</a:t>
                       </a:r>
                     </a:p>
                     <a:p>
@@ -9359,7 +9409,7 @@
                           </a:solidFill>
                           <a:latin typeface="Segoe UI"/>
                         </a:rPr>
-                        <a:t>★ Premium: a purple Premium badge, 4 exclusive props (tiara, star glasses, diamond necklace, fairy wings), the Fireworks move, +30 coins every day, double friend-interaction coins and room for 300 friends / 30 groups; Get Premium: Profile tab → Premium → "Ask to buy" emails the owner; after payment you receive a key (PIPS-XXXX-XXXX) to redeem right there; 🛡 Moderators: a blue Mod badge and a Mod tab with the report queue - warn, mute (1h / 24h / 7 days), clear a profile or reset a name; every action is logged; Report button on everyone's profile, so moderators can keep Pips friendly</a:t>
+                        <a:t>⚔ New Arena tab: challenge friends or anyone in the arena to a live duel - each round pick Attack, Guard or Special within 12 seconds and watch your pets fight; ⚡ Quick battle: an instant auto-fight against anyone's fighter, even when they're offline; Arena gear in the Shop: 7 weapons (water pistol to rocket launcher), 5 armors and 5 gadgets that decide your special move - better gear and a higher level make a stronger fighter; Live duels can be watched by everyone, plus recent battle replays, top fighters, rating and win/loss records; wins earn coins</a:t>
                       </a:r>
                     </a:p>
                   </a:txBody>
@@ -9383,7 +9433,7 @@
                           </a:solidFill>
                           <a:latin typeface="Segoe UI"/>
                         </a:rPr>
-                        <a:t>2.6.1</a:t>
+                        <a:t>2.7.0</a:t>
                       </a:r>
                     </a:p>
                   </a:txBody>
@@ -9427,7 +9477,7 @@
                           </a:solidFill>
                           <a:latin typeface="Segoe UI"/>
                         </a:rPr>
-                        <a:t>Owner badge &amp; credits</a:t>
+                        <a:t>Moderators &amp; Premium</a:t>
                       </a:r>
                     </a:p>
                     <a:p>
@@ -9438,7 +9488,7 @@
                           </a:solidFill>
                           <a:latin typeface="Segoe UI"/>
                         </a:rPr>
-                        <a:t>The creator of Pips (Juwen Lie) now shows a gold ♛ Owner badge on his profile, friend list and ranks; New About Pips card in the Profile tab: credits and how to contact the owner (Juwen_Lie@pegatroncorp.com) with Email and Copy buttons; Right-click the pet → Help → About now shows who made Pips and the contact email</a:t>
+                        <a:t>★ Premium: a purple Premium badge, 4 exclusive props (tiara, star glasses, diamond necklace, fairy wings), the Fireworks move, +30 coins every day, double friend-interaction coins and room for 300 friends / 30 groups; Get Premium: Profile tab → Premium → "Ask to buy" emails the owner; after payment you receive a key (PIPS-XXXX-XXXX) to redeem right there; 🛡 Moderators: a blue Mod badge and a Mod tab with the report queue - warn, mute (1h / 24h / 7 days), clear a profile or reset a name; every action is logged; Report button on everyone's profile, so moderators can keep Pips friendly</a:t>
                       </a:r>
                     </a:p>
                   </a:txBody>
@@ -9462,7 +9512,7 @@
                           </a:solidFill>
                           <a:latin typeface="Segoe UI"/>
                         </a:rPr>
-                        <a:t>2.6.0</a:t>
+                        <a:t>2.6.1</a:t>
                       </a:r>
                     </a:p>
                   </a:txBody>
@@ -9506,7 +9556,7 @@
                           </a:solidFill>
                           <a:latin typeface="Segoe UI"/>
                         </a:rPr>
-                        <a:t>Profiles, ranks, online status &amp; dark mode</a:t>
+                        <a:t>Owner badge &amp; credits</a:t>
                       </a:r>
                     </a:p>
                     <a:p>
@@ -9517,7 +9567,7 @@
                           </a:solidFill>
                           <a:latin typeface="Segoe UI"/>
                         </a:rPr>
-                        <a:t>Profile tab: profile picture (or your pet), about me, job, location, hobbies, birthday and a status message; Public or private: public profiles can be added directly and viewed in full; private profiles need a friend request that they accept, and strangers only see name, photo, pet, level and status; Click anyone to open their profile - badges, info, their friends - and add them, chat or wave from there; Ranks tab replaces Teams: everyone using Pips, sorted by XP, badges or streak</a:t>
+                        <a:t>The creator of Pips (Juwen Lie) now shows a gold ♛ Owner badge on his profile, friend list and ranks; New About Pips card in the Profile tab: credits and how to contact the owner (Juwen_Lie@pegatroncorp.com) with Email and Copy buttons; Right-click the pet → Help → About now shows who made Pips and the contact email</a:t>
                       </a:r>
                     </a:p>
                   </a:txBody>
@@ -9541,7 +9591,7 @@
                           </a:solidFill>
                           <a:latin typeface="Segoe UI"/>
                         </a:rPr>
-                        <a:t>2.5.1</a:t>
+                        <a:t>2.6.0</a:t>
                       </a:r>
                     </a:p>
                   </a:txBody>
@@ -9585,7 +9635,7 @@
                           </a:solidFill>
                           <a:latin typeface="Segoe UI"/>
                         </a:rPr>
-                        <a:t>New cute Pips logo</a:t>
+                        <a:t>Profiles, ranks, online status &amp; dark mode</a:t>
                       </a:r>
                     </a:p>
                     <a:p>
@@ -9596,7 +9646,7 @@
                           </a:solidFill>
                           <a:latin typeface="Segoe UI"/>
                         </a:rPr>
-                        <a:t>New Pips logo: Pip the cat on a Pips-red tile, matching the app colours (desktop shortcut, windows and website)</a:t>
+                        <a:t>Profile tab: profile picture (or your pet), about me, job, location, hobbies, birthday and a status message; Public or private: public profiles can be added directly and viewed in full; private profiles need a friend request that they accept, and strangers only see name, photo, pet, level and status; Click anyone to open their profile - badges, info, their friends - and add them, chat or wave from there; Ranks tab replaces Teams: everyone using Pips, sorted by XP, badges or streak</a:t>
                       </a:r>
                     </a:p>
                   </a:txBody>
@@ -9620,7 +9670,7 @@
                           </a:solidFill>
                           <a:latin typeface="Segoe UI"/>
                         </a:rPr>
-                        <a:t>2.5.0</a:t>
+                        <a:t>2.5.1</a:t>
                       </a:r>
                     </a:p>
                   </a:txBody>
@@ -9664,7 +9714,7 @@
                           </a:solidFill>
                           <a:latin typeface="Segoe UI"/>
                         </a:rPr>
-                        <a:t>Shop, coins, props &amp; moves</a:t>
+                        <a:t>New cute Pips logo</a:t>
                       </a:r>
                     </a:p>
                     <a:p>
@@ -9675,7 +9725,7 @@
                           </a:solidFill>
                           <a:latin typeface="Segoe UI"/>
                         </a:rPr>
-                        <a:t>Shop: earn coins and spend them on your pet - 17 props (crown, wizard hat, headphones, shades, scarf, cape, angel wings...) and 6 moves: spin, dance, moonwalk, backflip, kung fu and spider swing!; Coins come from leveling up (+40), badges (+25), opening Pips each day (+10), friendships (+15 per affinity level), waving / chatting / visiting friends (+2) and pomodoros (+5). Everyone starts with a 100-coin gift; Your friends see your props: on avatars in the hub and when your pet visits their desktop - it shows off one of your moves; Pips is now a social pet: clicking the pet opens the Pips hub (friends, chat, groups, shop, badges)</a:t>
+                        <a:t>New Pips logo: Pip the cat on a Pips-red tile, matching the app colours (desktop shortcut, windows and website)</a:t>
                       </a:r>
                     </a:p>
                   </a:txBody>
@@ -9699,7 +9749,7 @@
                           </a:solidFill>
                           <a:latin typeface="Segoe UI"/>
                         </a:rPr>
-                        <a:t>2.4.0</a:t>
+                        <a:t>2.5.0</a:t>
                       </a:r>
                     </a:p>
                   </a:txBody>
@@ -9743,7 +9793,7 @@
                           </a:solidFill>
                           <a:latin typeface="Segoe UI"/>
                         </a:rPr>
-                        <a:t>Chat, groups, affinity &amp; pet visits</a:t>
+                        <a:t>Shop, coins, props &amp; moves</a:t>
                       </a:r>
                     </a:p>
                     <a:p>
@@ -9754,7 +9804,7 @@
                           </a:solidFill>
                           <a:latin typeface="Segoe UI"/>
                         </a:rPr>
-                        <a:t>Chat: message your friends, and chat inside groups. Your pet pops up new messages as a bubble - click it to reply; Pet interactions: wave, pet their pet, send a snack, high five - or send your pet to visit: it walks onto your friend's desktop for a little while!; Affinity: every chat and interaction grows your friendship - Acquaintance → Buddy → Good friends → Close friends → Best friends → Soulmates; Your own groups: create a private group, invite your friends, they accept or decline. Group board + group chat; the owner can remove members</a:t>
+                        <a:t>Shop: earn coins and spend them on your pet - 17 props (crown, wizard hat, headphones, shades, scarf, cape, angel wings...) and 6 moves: spin, dance, moonwalk, backflip, kung fu and spider swing!; Coins come from leveling up (+40), badges (+25), opening Pips each day (+10), friendships (+15 per affinity level), waving / chatting / visiting friends (+2) and pomodoros (+5). Everyone starts with a 100-coin gift; Your friends see your props: on avatars in the hub and when your pet visits their desktop - it shows off one of your moves; Pips is now a social pet: clicking the pet opens the Pips hub (friends, chat, groups, shop, badges)</a:t>
                       </a:r>
                     </a:p>
                   </a:txBody>
@@ -9778,7 +9828,7 @@
                           </a:solidFill>
                           <a:latin typeface="Segoe UI"/>
                         </a:rPr>
-                        <a:t>2.3.0</a:t>
+                        <a:t>2.4.0</a:t>
                       </a:r>
                     </a:p>
                   </a:txBody>
@@ -9822,7 +9872,7 @@
                           </a:solidFill>
                           <a:latin typeface="Segoe UI"/>
                         </a:rPr>
-                        <a:t>Friends, levels &amp; achievements</a:t>
+                        <a:t>Chat, groups, affinity &amp; pet visits</a:t>
                       </a:r>
                     </a:p>
                     <a:p>
@@ -9833,7 +9883,7 @@
                           </a:solidFill>
                           <a:latin typeface="Segoe UI"/>
                         </a:rPr>
-                        <a:t>Levels &amp; XP: every finished pomodoro earns XP and your level grows - plus 20 achievements to unlock (first tomato, 8 in a day, 7-day streak, early bird, night owl, pet lover...). Your pet celebrates each one; Friends (optional, off by default): get a 6-letter friend code, add colleagues, see today's board and join a team board like PTB. Your pet tells you when a friend finishes a pomodoro; Privacy: only your name, pet, level, streak and pomodoro counts are shared - never apps, window titles or scores. One click turns it off and deletes your online data. Right-click the pet → Friends &amp; achievements…</a:t>
+                        <a:t>Chat: message your friends, and chat inside groups. Your pet pops up new messages as a bubble - click it to reply; Pet interactions: wave, pet their pet, send a snack, high five - or send your pet to visit: it walks onto your friend's desktop for a little while!; Affinity: every chat and interaction grows your friendship - Acquaintance → Buddy → Good friends → Close friends → Best friends → Soulmates; Your own groups: create a private group, invite your friends, they accept or decline. Group board + group chat; the owner can remove members</a:t>
                       </a:r>
                     </a:p>
                   </a:txBody>
@@ -9857,7 +9907,7 @@
                           </a:solidFill>
                           <a:latin typeface="Segoe UI"/>
                         </a:rPr>
-                        <a:t>2.2.0</a:t>
+                        <a:t>2.3.0</a:t>
                       </a:r>
                     </a:p>
                   </a:txBody>
@@ -9901,7 +9951,7 @@
                           </a:solidFill>
                           <a:latin typeface="Segoe UI"/>
                         </a:rPr>
-                        <a:t>Pet sounds</a:t>
+                        <a:t>Friends, levels &amp; achievements</a:t>
                       </a:r>
                     </a:p>
                     <a:p>
@@ -9912,7 +9962,7 @@
                           </a:solidFill>
                           <a:latin typeface="Segoe UI"/>
                         </a:rPr>
-                        <a:t>Your pet has a voice! Each of the 23 animals has its own sound (meow, woof, ribbit, hoot, buzz, oink, whale song...) and it changes with its mood: happy chirps, sad whimpers, sleepy yawns, hungry calls, grumpy huffs and soft snores; It also reacts with sound when you tickle, pet, feed, shake or wake it; Settings: right-click the pet → Sounds to switch on/off; Pet status &amp; settings has a volume slider, a ▶ Hear me button and "Stay quiet while I'm focusing" (on by default)</a:t>
+                        <a:t>Levels &amp; XP: every finished pomodoro earns XP and your level grows - plus 20 achievements to unlock (first tomato, 8 in a day, 7-day streak, early bird, night owl, pet lover...). Your pet celebrates each one; Friends (optional, off by default): get a 6-letter friend code, add colleagues, see today's board and join a team board like PTB. Your pet tells you when a friend finishes a pomodoro; Privacy: only your name, pet, level, streak and pomodoro counts are shared - never apps, window titles or scores. One click turns it off and deletes your online data. Right-click the pet → Friends &amp; achievements…</a:t>
                       </a:r>
                     </a:p>
                   </a:txBody>
@@ -9936,7 +9986,7 @@
                           </a:solidFill>
                           <a:latin typeface="Segoe UI"/>
                         </a:rPr>
-                        <a:t>2.1.2</a:t>
+                        <a:t>2.2.0</a:t>
                       </a:r>
                     </a:p>
                   </a:txBody>
@@ -9980,7 +10030,7 @@
                           </a:solidFill>
                           <a:latin typeface="Segoe UI"/>
                         </a:rPr>
-                        <a:t>Tickle-only mode</a:t>
+                        <a:t>Pet sounds</a:t>
                       </a:r>
                     </a:p>
                     <a:p>
@@ -9991,7 +10041,7 @@
                           </a:solidFill>
                           <a:latin typeface="Segoe UI"/>
                         </a:rPr>
-                        <a:t>New click option "Only tickle (never open Pips)": click and tickle your pet as much as you like - the Pomodoro window stays closed (open it from the right-click menu). Right-click the pet → When I click</a:t>
+                        <a:t>Your pet has a voice! Each of the 23 animals has its own sound (meow, woof, ribbit, hoot, buzz, oink, whale song...) and it changes with its mood: happy chirps, sad whimpers, sleepy yawns, hungry calls, grumpy huffs and soft snores; It also reacts with sound when you tickle, pet, feed, shake or wake it; Settings: right-click the pet → Sounds to switch on/off; Pet status &amp; settings has a volume slider, a ▶ Hear me button and "Stay quiet while I'm focusing" (on by default)</a:t>
                       </a:r>
                     </a:p>
                   </a:txBody>
@@ -10015,7 +10065,7 @@
                           </a:solidFill>
                           <a:latin typeface="Segoe UI"/>
                         </a:rPr>
-                        <a:t>2.1.1</a:t>
+                        <a:t>2.1.2</a:t>
                       </a:r>
                     </a:p>
                   </a:txBody>
@@ -10059,7 +10109,7 @@
                           </a:solidFill>
                           <a:latin typeface="Segoe UI"/>
                         </a:rPr>
-                        <a:t>Owner info</a:t>
+                        <a:t>Tickle-only mode</a:t>
                       </a:r>
                     </a:p>
                     <a:p>
@@ -10070,7 +10120,7 @@
                           </a:solidFill>
                           <a:latin typeface="Segoe UI"/>
                         </a:rPr>
-                        <a:t>About Pips now shows the owner: Juwen Lie (right-click the pet → Help → About)</a:t>
+                        <a:t>New click option "Only tickle (never open Pips)": click and tickle your pet as much as you like - the Pomodoro window stays closed (open it from the right-click menu). Right-click the pet → When I click</a:t>
                       </a:r>
                     </a:p>
                   </a:txBody>
@@ -10094,7 +10144,7 @@
                           </a:solidFill>
                           <a:latin typeface="Segoe UI"/>
                         </a:rPr>
-                        <a:t>2.1.0</a:t>
+                        <a:t>2.1.1</a:t>
                       </a:r>
                     </a:p>
                   </a:txBody>
@@ -10138,7 +10188,7 @@
                           </a:solidFill>
                           <a:latin typeface="Segoe UI"/>
                         </a:rPr>
-                        <a:t>Interactive guide &amp; in-app updates</a:t>
+                        <a:t>Owner info</a:t>
                       </a:r>
                     </a:p>
                     <a:p>
@@ -10149,7 +10199,7 @@
                           </a:solidFill>
                           <a:latin typeface="Segoe UI"/>
                         </a:rPr>
-                        <a:t>Interactive first-run guide: your pet walks you through clicking, dragging, petting and the right-click menu; In-app updates: Pips tells you when a new version is out - update with one click (your settings and data are kept); New Help menu: replay the guide, check for updates, see the version; Option to turn automatic update checks off</a:t>
+                        <a:t>About Pips now shows the owner: Juwen Lie (right-click the pet → Help → About)</a:t>
                       </a:r>
                     </a:p>
                   </a:txBody>
@@ -10173,7 +10223,7 @@
                           </a:solidFill>
                           <a:latin typeface="Segoe UI"/>
                         </a:rPr>
-                        <a:t>2.0.0</a:t>
+                        <a:t>2.1.0</a:t>
                       </a:r>
                     </a:p>
                   </a:txBody>
@@ -10217,7 +10267,7 @@
                           </a:solidFill>
                           <a:latin typeface="Segoe UI"/>
                         </a:rPr>
-                        <a:t>Desktop pet, 23 animals &amp; 4 languages</a:t>
+                        <a:t>Interactive guide &amp; in-app updates</a:t>
                       </a:r>
                     </a:p>
                     <a:p>
@@ -10228,7 +10278,7 @@
                           </a:solidFill>
                           <a:latin typeface="Segoe UI"/>
                         </a:rPr>
-                        <a:t>Desktop pet that lives on your desktop and taskbar - drag it, tickle it, pet it; 23 animals in 3 groups: Land walks, Water swims with bubbles, Sky hovers and flaps; Moods (happy, sad, tired, hungry, grumpy...), naps when you're away, wakes up when you're back; Cute chat-bubble reminders: breaks, water, 20-20-20 eye rest, pomodoro done, daily goal</a:t>
+                        <a:t>Interactive first-run guide: your pet walks you through clicking, dragging, petting and the right-click menu; In-app updates: Pips tells you when a new version is out - update with one click (your settings and data are kept); New Help menu: replay the guide, check for updates, see the version; Option to turn automatic update checks off</a:t>
                       </a:r>
                     </a:p>
                   </a:txBody>
@@ -10252,7 +10302,7 @@
                           </a:solidFill>
                           <a:latin typeface="Segoe UI"/>
                         </a:rPr>
-                        <a:t>1.5.0</a:t>
+                        <a:t>2.0.0</a:t>
                       </a:r>
                     </a:p>
                   </a:txBody>
@@ -10274,13 +10324,92 @@
                           </a:solidFill>
                           <a:latin typeface="Segoe UI"/>
                         </a:rPr>
+                        <a:t>2026-10-28</a:t>
+                      </a:r>
+                    </a:p>
+                  </a:txBody>
+                  <a:tcPr marL="73152" marR="73152" marT="36576" marB="36576">
+                    <a:solidFill>
+                      <a:srgbClr val="F7F4EC"/>
+                    </a:solidFill>
+                  </a:tcPr>
+                </a:tc>
+                <a:tc>
+                  <a:txBody>
+                    <a:bodyPr wrap="square"/>
+                    <a:lstStyle/>
+                    <a:p>
+                      <a:r>
+                        <a:rPr sz="1200" b="0">
+                          <a:solidFill>
+                            <a:srgbClr val="2B2A28"/>
+                          </a:solidFill>
+                          <a:latin typeface="Segoe UI"/>
+                        </a:rPr>
+                        <a:t>Desktop pet, 23 animals &amp; 4 languages</a:t>
+                      </a:r>
+                    </a:p>
+                    <a:p>
+                      <a:r>
+                        <a:rPr sz="1200" b="0">
+                          <a:solidFill>
+                            <a:srgbClr val="2B2A28"/>
+                          </a:solidFill>
+                          <a:latin typeface="Segoe UI"/>
+                        </a:rPr>
+                        <a:t>Desktop pet that lives on your desktop and taskbar - drag it, tickle it, pet it; 23 animals in 3 groups: Land walks, Water swims with bubbles, Sky hovers and flaps; Moods (happy, sad, tired, hungry, grumpy...), naps when you're away, wakes up when you're back; Cute chat-bubble reminders: breaks, water, 20-20-20 eye rest, pomodoro done, daily goal</a:t>
+                      </a:r>
+                    </a:p>
+                  </a:txBody>
+                  <a:tcPr marL="73152" marR="73152" marT="36576" marB="36576">
+                    <a:solidFill>
+                      <a:srgbClr val="F7F4EC"/>
+                    </a:solidFill>
+                  </a:tcPr>
+                </a:tc>
+              </a:tr>
+              <a:tr h="822960">
+                <a:tc>
+                  <a:txBody>
+                    <a:bodyPr wrap="square"/>
+                    <a:lstStyle/>
+                    <a:p>
+                      <a:r>
+                        <a:rPr sz="1200" b="1">
+                          <a:solidFill>
+                            <a:srgbClr val="2B2A28"/>
+                          </a:solidFill>
+                          <a:latin typeface="Segoe UI"/>
+                        </a:rPr>
+                        <a:t>1.5.0</a:t>
+                      </a:r>
+                    </a:p>
+                  </a:txBody>
+                  <a:tcPr marL="73152" marR="73152" marT="36576" marB="36576">
+                    <a:solidFill>
+                      <a:srgbClr val="FFFDF8"/>
+                    </a:solidFill>
+                  </a:tcPr>
+                </a:tc>
+                <a:tc>
+                  <a:txBody>
+                    <a:bodyPr wrap="square"/>
+                    <a:lstStyle/>
+                    <a:p>
+                      <a:r>
+                        <a:rPr sz="1200" b="0">
+                          <a:solidFill>
+                            <a:srgbClr val="2B2A28"/>
+                          </a:solidFill>
+                          <a:latin typeface="Segoe UI"/>
+                        </a:rPr>
                         <a:t>2026-10-24</a:t>
                       </a:r>
                     </a:p>
                   </a:txBody>
                   <a:tcPr marL="73152" marR="73152" marT="36576" marB="36576">
                     <a:solidFill>
-                      <a:srgbClr val="F7F4EC"/>
+                      <a:srgbClr val="FFFDF8"/>
                     </a:solidFill>
                   </a:tcPr>
                 </a:tc>
@@ -10313,7 +10442,7 @@
                   </a:txBody>
                   <a:tcPr marL="73152" marR="73152" marT="36576" marB="36576">
                     <a:solidFill>
-                      <a:srgbClr val="F7F4EC"/>
+                      <a:srgbClr val="FFFDF8"/>
                     </a:solidFill>
                   </a:tcPr>
                 </a:tc>
@@ -10337,7 +10466,7 @@
                   </a:txBody>
                   <a:tcPr marL="73152" marR="73152" marT="36576" marB="36576">
                     <a:solidFill>
-                      <a:srgbClr val="FFFDF8"/>
+                      <a:srgbClr val="F7F4EC"/>
                     </a:solidFill>
                   </a:tcPr>
                 </a:tc>
@@ -10359,7 +10488,7 @@
                   </a:txBody>
                   <a:tcPr marL="73152" marR="73152" marT="36576" marB="36576">
                     <a:solidFill>
-                      <a:srgbClr val="FFFDF8"/>
+                      <a:srgbClr val="F7F4EC"/>
                     </a:solidFill>
                   </a:tcPr>
                 </a:tc>
@@ -10392,7 +10521,7 @@
                   </a:txBody>
                   <a:tcPr marL="73152" marR="73152" marT="36576" marB="36576">
                     <a:solidFill>
-                      <a:srgbClr val="FFFDF8"/>
+                      <a:srgbClr val="F7F4EC"/>
                     </a:solidFill>
                   </a:tcPr>
                 </a:tc>

</xml_diff>

<commit_message>
pips 2.13.1: One-click Windows installer
</commit_message>
<xml_diff>
--- a/apps/pips/web/download/Pips-Guide.pptx
+++ b/apps/pips/web/download/Pips-Guide.pptx
@@ -3292,7 +3292,7 @@
                 </a:solidFill>
                 <a:latin typeface="Segoe UI"/>
               </a:rPr>
-              <a:t>Version 2.13.0  ·  2026-10-28  ·  Made by Juwen Lie (owner)</a:t>
+              <a:t>Version 2.13.1  ·  2026-10-28  ·  Made by Juwen Lie (owner)</a:t>
             </a:r>
           </a:p>
           <a:p>
@@ -7716,7 +7716,7 @@
                           </a:solidFill>
                           <a:latin typeface="Segoe UI"/>
                         </a:rPr>
-                        <a:t>Install Python 3 from python.org (tick “Add to PATH”), then run Start Pips.bat again.</a:t>
+                        <a:t>Use the Pips Desktop / Start Menu shortcut. If needed, quit Pips and run Pips-Setup.exe again.</a:t>
                       </a:r>
                     </a:p>
                   </a:txBody>
@@ -7762,7 +7762,7 @@
                           </a:solidFill>
                           <a:latin typeface="Segoe UI"/>
                         </a:rPr>
-                        <a:t>Click More info → Run anyway (the .bat just starts Python).</a:t>
+                        <a:t>The installer is unsigned. For the trusted official download: More info → Run anyway, if allowed. Otherwise ask IT.</a:t>
                       </a:r>
                     </a:p>
                   </a:txBody>
@@ -7900,7 +7900,7 @@
                           </a:solidFill>
                           <a:latin typeface="Segoe UI"/>
                         </a:rPr>
-                        <a:t>Check internet / proxy, try Help → Check for updates later, or download the zip again and unzip over the old folder.</a:t>
+                        <a:t>Try Help → Check for updates later. Installed users can quit Pips and rerun setup; ZIP users should keep their original folder.</a:t>
                       </a:r>
                     </a:p>
                   </a:txBody>
@@ -7924,7 +7924,7 @@
                           </a:solidFill>
                           <a:latin typeface="Segoe UI"/>
                         </a:rPr>
-                        <a:t>Move Pips to another PC</a:t>
+                        <a:t>Where are my settings?</a:t>
                       </a:r>
                     </a:p>
                   </a:txBody>
@@ -7946,7 +7946,7 @@
                           </a:solidFill>
                           <a:latin typeface="Segoe UI"/>
                         </a:rPr>
-                        <a:t>Copy the whole folder - config.json and data\ keep your settings and history.</a:t>
+                        <a:t>Installed app: %LOCALAPPDATA%\Programs\Pips. config.json and data\ hold your profile and progress; back them up before moving.</a:t>
                       </a:r>
                     </a:p>
                   </a:txBody>
@@ -7992,7 +7992,7 @@
                           </a:solidFill>
                           <a:latin typeface="Segoe UI"/>
                         </a:rPr>
-                        <a:t>Quit (right-click → Quit), disable Autostart, delete the folder.</a:t>
+                        <a:t>Quit Pips, then Windows Settings → Apps → Pips → Uninstall. Settings and progress are left in place for a later reinstall.</a:t>
                       </a:r>
                     </a:p>
                   </a:txBody>
@@ -8141,7 +8141,7 @@
                 </a:solidFill>
                 <a:latin typeface="Segoe UI"/>
               </a:rPr>
-              <a:t>What's new in 2.13.0</a:t>
+              <a:t>What's new in 2.13.1</a:t>
             </a:r>
           </a:p>
         </p:txBody>
@@ -8254,7 +8254,7 @@
                 </a:solidFill>
                 <a:latin typeface="Segoe UI"/>
               </a:rPr>
-              <a:t>Birthdays, parties &amp; gifts  ·  2026-10-28</a:t>
+              <a:t>One-click Windows installer  ·  2026-10-28</a:t>
             </a:r>
           </a:p>
         </p:txBody>
@@ -8302,7 +8302,7 @@
                 </a:solidFill>
                 <a:latin typeface="Segoe UI"/>
               </a:rPr>
-              <a:t>Set your birthday in Social → Profile (month + day, optionally visible to friends).</a:t>
+              <a:t>One Windows installer: no ZIP extraction, Python installation or command line. Download, open and click Install Pips.</a:t>
             </a:r>
           </a:p>
           <a:p>
@@ -8327,7 +8327,7 @@
                 </a:solidFill>
                 <a:latin typeface="Segoe UI"/>
               </a:rPr>
-              <a:t>On your birthday Pips throws confetti and gives you 100 bonus coins.</a:t>
+              <a:t>Installs for your Windows account without administrator access, adds Desktop and Start Menu shortcuts, and opens Pips automatically.</a:t>
             </a:r>
           </a:p>
           <a:p>
@@ -8352,7 +8352,7 @@
                 </a:solidFill>
                 <a:latin typeface="Segoe UI"/>
               </a:rPr>
-              <a:t>Friends tab shows upcoming birthdays; you get reminders 3 days, 1 day and on the day.</a:t>
+              <a:t>Reinstalling in the same location keeps your settings and pet progress. Existing ZIP users can keep updating in place from Help → Check for updates.</a:t>
             </a:r>
           </a:p>
           <a:p>
@@ -8377,32 +8377,7 @@
                 </a:solidFill>
                 <a:latin typeface="Segoe UI"/>
               </a:rPr>
-              <a:t>Birthday parties: join a friend's party, see who's there, sign the guestbook and celebrate together.</a:t>
-            </a:r>
-          </a:p>
-          <a:p>
-            <a:pPr>
-              <a:spcAft>
-                <a:spcPts val="1000"/>
-              </a:spcAft>
-            </a:pPr>
-            <a:r>
-              <a:rPr sz="1700" b="1">
-                <a:solidFill>
-                  <a:srgbClr val="4CB86B"/>
-                </a:solidFill>
-                <a:latin typeface="Segoe UI"/>
-              </a:rPr>
-              <a:t>•  </a:t>
-            </a:r>
-            <a:r>
-              <a:rPr sz="1700">
-                <a:solidFill>
-                  <a:srgbClr val="2B2A28"/>
-                </a:solidFill>
-                <a:latin typeface="Segoe UI"/>
-              </a:rPr>
-              <a:t>Send gifts: any shop item (previewed on their pet), coins, or both, with a message — paid from your own coins.</a:t>
+              <a:t>A simpler download page and updated user guide; the bundled runtime stays separate from small in-app updates.</a:t>
             </a:r>
           </a:p>
         </p:txBody>
@@ -8533,7 +8508,7 @@
                 </a:solidFill>
                 <a:latin typeface="Segoe UI"/>
               </a:rPr>
-              <a:t>Atur ulang tahunmu di Sosial → Profil (bulan + tanggal, bisa ditampilkan ke teman).</a:t>
+              <a:t>Satu installer Windows: tanpa ekstrak ZIP, instal Python, atau terminal. Unduh, buka, lalu klik Install Pips.</a:t>
             </a:r>
           </a:p>
           <a:p>
@@ -8558,7 +8533,7 @@
                 </a:solidFill>
                 <a:latin typeface="Segoe UI"/>
               </a:rPr>
-              <a:t>Di hari ulang tahunmu Pips menebar konfeti dan memberi 100 koin bonus.</a:t>
+              <a:t>Dipasang untuk akun Windows Anda tanpa akses administrator, membuat pintasan Desktop dan Start Menu, lalu membuka Pips otomatis.</a:t>
             </a:r>
           </a:p>
           <a:p>
@@ -8583,7 +8558,7 @@
                 </a:solidFill>
                 <a:latin typeface="Segoe UI"/>
               </a:rPr>
-              <a:t>Tab Teman menampilkan ulang tahun terdekat; pengingat 3 hari, 1 hari, dan di hari-H.</a:t>
+              <a:t>Instal ulang di lokasi yang sama tetap menyimpan pengaturan dan progres pet. Pengguna ZIP tetap dapat memperbarui lewat Bantuan → Periksa pembaruan.</a:t>
             </a:r>
           </a:p>
           <a:p>
@@ -8608,32 +8583,7 @@
                 </a:solidFill>
                 <a:latin typeface="Segoe UI"/>
               </a:rPr>
-              <a:t>Pesta ulang tahun: datang ke pesta teman, lihat siapa yang hadir, tulis di buku tamu dan rayakan bersama.</a:t>
-            </a:r>
-          </a:p>
-          <a:p>
-            <a:pPr>
-              <a:spcAft>
-                <a:spcPts val="500"/>
-              </a:spcAft>
-            </a:pPr>
-            <a:r>
-              <a:rPr sz="1200" b="1">
-                <a:solidFill>
-                  <a:srgbClr val="4CB86B"/>
-                </a:solidFill>
-                <a:latin typeface="Segoe UI"/>
-              </a:rPr>
-              <a:t>•  </a:t>
-            </a:r>
-            <a:r>
-              <a:rPr sz="1200">
-                <a:solidFill>
-                  <a:srgbClr val="2B2A28"/>
-                </a:solidFill>
-                <a:latin typeface="Segoe UI"/>
-              </a:rPr>
-              <a:t>Kirim hadiah: item toko (pratinjau di pet mereka), koin, atau keduanya, dengan pesan — dibayar dari koinmu.</a:t>
+              <a:t>Halaman unduhan dan panduan kini lebih sederhana; runtime bawaan terpisah dari pembaruan kecil dalam aplikasi.</a:t>
             </a:r>
           </a:p>
         </p:txBody>
@@ -8865,7 +8815,7 @@
         </p:nvGraphicFramePr>
         <p:xfrm>
           <a:off x="548640" y="1645920"/>
-          <a:ext cx="11155680" cy="16843248"/>
+          <a:ext cx="11155680" cy="17666208"/>
         </p:xfrm>
         <a:graphic>
           <a:graphicData uri="http://schemas.openxmlformats.org/drawingml/2006/table">
@@ -8959,7 +8909,7 @@
                           </a:solidFill>
                           <a:latin typeface="Segoe UI"/>
                         </a:rPr>
-                        <a:t>2.13.0</a:t>
+                        <a:t>2.13.1</a:t>
                       </a:r>
                     </a:p>
                   </a:txBody>
@@ -9003,7 +8953,7 @@
                           </a:solidFill>
                           <a:latin typeface="Segoe UI"/>
                         </a:rPr>
-                        <a:t>Birthdays, parties &amp; gifts</a:t>
+                        <a:t>One-click Windows installer</a:t>
                       </a:r>
                     </a:p>
                     <a:p>
@@ -9014,7 +8964,7 @@
                           </a:solidFill>
                           <a:latin typeface="Segoe UI"/>
                         </a:rPr>
-                        <a:t>Set your birthday in Social → Profile (month + day, optionally visible to friends).; On your birthday Pips throws confetti and gives you 100 bonus coins.; Friends tab shows upcoming birthdays; you get reminders 3 days, 1 day and on the day.; Birthday parties: join a friend's party, see who's there, sign the guestbook and celebrate together.</a:t>
+                        <a:t>One Windows installer: no ZIP extraction, Python installation or command line. Download, open and click Install Pips.; Installs for your Windows account without administrator access, adds Desktop and Start Menu shortcuts, and opens Pips automatically.; Reinstalling in the same location keeps your settings and pet progress. Existing ZIP users can keep updating in place from Help → Check for updates.; A simpler download page and updated user guide; the bundled runtime stays separate from small in-app updates.</a:t>
                       </a:r>
                     </a:p>
                   </a:txBody>
@@ -9038,7 +8988,7 @@
                           </a:solidFill>
                           <a:latin typeface="Segoe UI"/>
                         </a:rPr>
-                        <a:t>2.12.0</a:t>
+                        <a:t>2.13.0</a:t>
                       </a:r>
                     </a:p>
                   </a:txBody>
@@ -9082,7 +9032,7 @@
                           </a:solidFill>
                           <a:latin typeface="Segoe UI"/>
                         </a:rPr>
-                        <a:t>Mega update: 28 new animals, 31 shop items, 13 moves</a:t>
+                        <a:t>Birthdays, parties &amp; gifts</a:t>
                       </a:r>
                     </a:p>
                     <a:p>
@@ -9093,7 +9043,7 @@
                           </a:solidFill>
                           <a:latin typeface="Segoe UI"/>
                         </a:rPr>
-                        <a:t>🦁 28 new animals (51 total): lion, tiger, unicorn, deer, sheep, cow, raccoon, red panda, monkey, hedgehog, dino, squirrel, mouse, koala, shark, dolphin, seal, otter, pufferfish, duck, crab, parrot, chick, ladybug, phoenix, pegasus, ghost and flamingo; 🎩 31 new shop items: top hat, cowboy, chef, pirate, Santa, viking, graduation cap, beret, bow, propeller cap, flower crown, nerd glasses, eyepatch, mustache, goggles, masquerade mask, tie, pearls, flower lei, gold chain, balloon, backpack, guitar, shield, butterfly / devil wings and more - plus Premium galaxy crown, galaxy cape and dragon wings; 💃 13 new moves: wave, jump, hearts, sing, yoga, zoomies, cartwheel, juggle, rain dance, breakdance, magic, confetti and the Premium rocket launch; The Shop is now split into sections (Hats, Face, Neck, Back, Moves, Arena gear) with an owned counter for each</a:t>
+                        <a:t>Set your birthday in Social → Profile (month + day, optionally visible to friends).; On your birthday Pips throws confetti and gives you 100 bonus coins.; Friends tab shows upcoming birthdays; you get reminders 3 days, 1 day and on the day.; Birthday parties: join a friend's party, see who's there, sign the guestbook and celebrate together.</a:t>
                       </a:r>
                     </a:p>
                   </a:txBody>
@@ -9117,7 +9067,7 @@
                           </a:solidFill>
                           <a:latin typeface="Segoe UI"/>
                         </a:rPr>
-                        <a:t>2.11.0</a:t>
+                        <a:t>2.12.0</a:t>
                       </a:r>
                     </a:p>
                   </a:txBody>
@@ -9161,7 +9111,7 @@
                           </a:solidFill>
                           <a:latin typeface="Segoe UI"/>
                         </a:rPr>
-                        <a:t>New right-click menus</a:t>
+                        <a:t>Mega update: 28 new animals, 31 shop items, 13 moves</a:t>
                       </a:r>
                     </a:p>
                     <a:p>
@@ -9172,7 +9122,7 @@
                           </a:solidFill>
                           <a:latin typeface="Segoe UI"/>
                         </a:rPr>
-                        <a:t>✨ Brand-new animated right-click menu for your pet: mood &amp; stat bars, quick-action tiles (Friends, Shop, Snack, Pat, Focus, Stats, Sleep, Taskbar), hover effects and smooth fly-out submenus; Pick colours from swatches, switch size with one click and flip Sounds / Dark mode with toggle switches - changes show instantly; Updates are highlighted: a glowing banner and NEW badge appear in the menu when a new version is ready; The focus card's right-click menu got the same new look; keyboard arrows, Enter and Esc work too</a:t>
+                        <a:t>🦁 28 new animals (51 total): lion, tiger, unicorn, deer, sheep, cow, raccoon, red panda, monkey, hedgehog, dino, squirrel, mouse, koala, shark, dolphin, seal, otter, pufferfish, duck, crab, parrot, chick, ladybug, phoenix, pegasus, ghost and flamingo; 🎩 31 new shop items: top hat, cowboy, chef, pirate, Santa, viking, graduation cap, beret, bow, propeller cap, flower crown, nerd glasses, eyepatch, mustache, goggles, masquerade mask, tie, pearls, flower lei, gold chain, balloon, backpack, guitar, shield, butterfly / devil wings and more - plus Premium galaxy crown, galaxy cape and dragon wings; 💃 13 new moves: wave, jump, hearts, sing, yoga, zoomies, cartwheel, juggle, rain dance, breakdance, magic, confetti and the Premium rocket launch; The Shop is now split into sections (Hats, Face, Neck, Back, Moves, Arena gear) with an owned counter for each</a:t>
                       </a:r>
                     </a:p>
                   </a:txBody>
@@ -9196,7 +9146,7 @@
                           </a:solidFill>
                           <a:latin typeface="Segoe UI"/>
                         </a:rPr>
-                        <a:t>2.10.0</a:t>
+                        <a:t>2.11.0</a:t>
                       </a:r>
                     </a:p>
                   </a:txBody>
@@ -9240,7 +9190,7 @@
                           </a:solidFill>
                           <a:latin typeface="Segoe UI"/>
                         </a:rPr>
-                        <a:t>Chat bots</a:t>
+                        <a:t>New right-click menus</a:t>
                       </a:r>
                     </a:p>
                     <a:p>
@@ -9251,7 +9201,7 @@
                           </a:solidFill>
                           <a:latin typeface="Segoe UI"/>
                         </a:rPr>
-                        <a:t>🤖 6 friendly chat bots in the Chat tab: Pip Helper (app questions), Coach Focus (focus tips from your real stats), Sunny (live weather for any city), Arena Master (battle tips + quick battle), Giggles (jokes &amp; games) and Guardian (safety &amp; reporting help); Private bot chats with suggestion chips, typing indicator and a clear button - your bot chats stay on your PC; Mention a bot in a group chat (e.g. @weather Batam) and it answers in the room for everyone; Bots reply in your app language; up to 120 bot messages per day</a:t>
+                        <a:t>✨ Brand-new animated right-click menu for your pet: mood &amp; stat bars, quick-action tiles (Friends, Shop, Snack, Pat, Focus, Stats, Sleep, Taskbar), hover effects and smooth fly-out submenus; Pick colours from swatches, switch size with one click and flip Sounds / Dark mode with toggle switches - changes show instantly; Updates are highlighted: a glowing banner and NEW badge appear in the menu when a new version is ready; The focus card's right-click menu got the same new look; keyboard arrows, Enter and Esc work too</a:t>
                       </a:r>
                     </a:p>
                   </a:txBody>
@@ -9275,7 +9225,7 @@
                           </a:solidFill>
                           <a:latin typeface="Segoe UI"/>
                         </a:rPr>
-                        <a:t>2.9.0</a:t>
+                        <a:t>2.10.0</a:t>
                       </a:r>
                     </a:p>
                   </a:txBody>
@@ -9319,7 +9269,7 @@
                           </a:solidFill>
                           <a:latin typeface="Segoe UI"/>
                         </a:rPr>
-                        <a:t>Location &amp; live weather</a:t>
+                        <a:t>Chat bots</a:t>
                       </a:r>
                     </a:p>
                     <a:p>
@@ -9330,7 +9280,7 @@
                           </a:solidFill>
                           <a:latin typeface="Segoe UI"/>
                         </a:rPr>
-                        <a:t>📍 Add your city in Profile → Location &amp; weather (auto-detect or search) - only your city and country are shown, never your exact position; Live weather banners on every profile with animations: rain, drizzle, thunderstorms with lightning, snow, fog, clouds, sunshine or a starry night - plus temperature, feels-like, humidity, wind and local time; Your own weather strip on top of the hub, and each friend's weather + local time in the friends list; Hide your location from others or remove it any time</a:t>
+                        <a:t>🤖 6 friendly chat bots in the Chat tab: Pip Helper (app questions), Coach Focus (focus tips from your real stats), Sunny (live weather for any city), Arena Master (battle tips + quick battle), Giggles (jokes &amp; games) and Guardian (safety &amp; reporting help); Private bot chats with suggestion chips, typing indicator and a clear button - your bot chats stay on your PC; Mention a bot in a group chat (e.g. @weather Batam) and it answers in the room for everyone; Bots reply in your app language; up to 120 bot messages per day</a:t>
                       </a:r>
                     </a:p>
                   </a:txBody>
@@ -9354,7 +9304,7 @@
                           </a:solidFill>
                           <a:latin typeface="Segoe UI"/>
                         </a:rPr>
-                        <a:t>2.8.0</a:t>
+                        <a:t>2.9.0</a:t>
                       </a:r>
                     </a:p>
                   </a:txBody>
@@ -9398,7 +9348,7 @@
                           </a:solidFill>
                           <a:latin typeface="Segoe UI"/>
                         </a:rPr>
-                        <a:t>Pips Arena - duels, gear &amp; live battles</a:t>
+                        <a:t>Location &amp; live weather</a:t>
                       </a:r>
                     </a:p>
                     <a:p>
@@ -9409,7 +9359,7 @@
                           </a:solidFill>
                           <a:latin typeface="Segoe UI"/>
                         </a:rPr>
-                        <a:t>⚔ New Arena tab: challenge friends or anyone in the arena to a live duel - each round pick Attack, Guard or Special within 12 seconds and watch your pets fight; ⚡ Quick battle: an instant auto-fight against anyone's fighter, even when they're offline; Arena gear in the Shop: 7 weapons (water pistol to rocket launcher), 5 armors and 5 gadgets that decide your special move - better gear and a higher level make a stronger fighter; Live duels can be watched by everyone, plus recent battle replays, top fighters, rating and win/loss records; wins earn coins</a:t>
+                        <a:t>📍 Add your city in Profile → Location &amp; weather (auto-detect or search) - only your city and country are shown, never your exact position; Live weather banners on every profile with animations: rain, drizzle, thunderstorms with lightning, snow, fog, clouds, sunshine or a starry night - plus temperature, feels-like, humidity, wind and local time; Your own weather strip on top of the hub, and each friend's weather + local time in the friends list; Hide your location from others or remove it any time</a:t>
                       </a:r>
                     </a:p>
                   </a:txBody>
@@ -9433,7 +9383,7 @@
                           </a:solidFill>
                           <a:latin typeface="Segoe UI"/>
                         </a:rPr>
-                        <a:t>2.7.0</a:t>
+                        <a:t>2.8.0</a:t>
                       </a:r>
                     </a:p>
                   </a:txBody>
@@ -9477,7 +9427,7 @@
                           </a:solidFill>
                           <a:latin typeface="Segoe UI"/>
                         </a:rPr>
-                        <a:t>Moderators &amp; Premium</a:t>
+                        <a:t>Pips Arena - duels, gear &amp; live battles</a:t>
                       </a:r>
                     </a:p>
                     <a:p>
@@ -9488,7 +9438,7 @@
                           </a:solidFill>
                           <a:latin typeface="Segoe UI"/>
                         </a:rPr>
-                        <a:t>★ Premium: a purple Premium badge, 4 exclusive props (tiara, star glasses, diamond necklace, fairy wings), the Fireworks move, +30 coins every day, double friend-interaction coins and room for 300 friends / 30 groups; Get Premium: Profile tab → Premium → "Ask to buy" emails the owner; after payment you receive a key (PIPS-XXXX-XXXX) to redeem right there; 🛡 Moderators: a blue Mod badge and a Mod tab with the report queue - warn, mute (1h / 24h / 7 days), clear a profile or reset a name; every action is logged; Report button on everyone's profile, so moderators can keep Pips friendly</a:t>
+                        <a:t>⚔ New Arena tab: challenge friends or anyone in the arena to a live duel - each round pick Attack, Guard or Special within 12 seconds and watch your pets fight; ⚡ Quick battle: an instant auto-fight against anyone's fighter, even when they're offline; Arena gear in the Shop: 7 weapons (water pistol to rocket launcher), 5 armors and 5 gadgets that decide your special move - better gear and a higher level make a stronger fighter; Live duels can be watched by everyone, plus recent battle replays, top fighters, rating and win/loss records; wins earn coins</a:t>
                       </a:r>
                     </a:p>
                   </a:txBody>
@@ -9512,7 +9462,7 @@
                           </a:solidFill>
                           <a:latin typeface="Segoe UI"/>
                         </a:rPr>
-                        <a:t>2.6.1</a:t>
+                        <a:t>2.7.0</a:t>
                       </a:r>
                     </a:p>
                   </a:txBody>
@@ -9556,7 +9506,7 @@
                           </a:solidFill>
                           <a:latin typeface="Segoe UI"/>
                         </a:rPr>
-                        <a:t>Owner badge &amp; credits</a:t>
+                        <a:t>Moderators &amp; Premium</a:t>
                       </a:r>
                     </a:p>
                     <a:p>
@@ -9567,7 +9517,7 @@
                           </a:solidFill>
                           <a:latin typeface="Segoe UI"/>
                         </a:rPr>
-                        <a:t>The creator of Pips (Juwen Lie) now shows a gold ♛ Owner badge on his profile, friend list and ranks; New About Pips card in the Profile tab: credits and how to contact the owner (Juwen_Lie@pegatroncorp.com) with Email and Copy buttons; Right-click the pet → Help → About now shows who made Pips and the contact email</a:t>
+                        <a:t>★ Premium: a purple Premium badge, 4 exclusive props (tiara, star glasses, diamond necklace, fairy wings), the Fireworks move, +30 coins every day, double friend-interaction coins and room for 300 friends / 30 groups; Get Premium: Profile tab → Premium → "Ask to buy" emails the owner; after payment you receive a key (PIPS-XXXX-XXXX) to redeem right there; 🛡 Moderators: a blue Mod badge and a Mod tab with the report queue - warn, mute (1h / 24h / 7 days), clear a profile or reset a name; every action is logged; Report button on everyone's profile, so moderators can keep Pips friendly</a:t>
                       </a:r>
                     </a:p>
                   </a:txBody>
@@ -9591,7 +9541,7 @@
                           </a:solidFill>
                           <a:latin typeface="Segoe UI"/>
                         </a:rPr>
-                        <a:t>2.6.0</a:t>
+                        <a:t>2.6.1</a:t>
                       </a:r>
                     </a:p>
                   </a:txBody>
@@ -9635,7 +9585,7 @@
                           </a:solidFill>
                           <a:latin typeface="Segoe UI"/>
                         </a:rPr>
-                        <a:t>Profiles, ranks, online status &amp; dark mode</a:t>
+                        <a:t>Owner badge &amp; credits</a:t>
                       </a:r>
                     </a:p>
                     <a:p>
@@ -9646,7 +9596,7 @@
                           </a:solidFill>
                           <a:latin typeface="Segoe UI"/>
                         </a:rPr>
-                        <a:t>Profile tab: profile picture (or your pet), about me, job, location, hobbies, birthday and a status message; Public or private: public profiles can be added directly and viewed in full; private profiles need a friend request that they accept, and strangers only see name, photo, pet, level and status; Click anyone to open their profile - badges, info, their friends - and add them, chat or wave from there; Ranks tab replaces Teams: everyone using Pips, sorted by XP, badges or streak</a:t>
+                        <a:t>The creator of Pips (Juwen Lie) now shows a gold ♛ Owner badge on his profile, friend list and ranks; New About Pips card in the Profile tab: credits and how to contact the owner (Juwen_Lie@pegatroncorp.com) with Email and Copy buttons; Right-click the pet → Help → About now shows who made Pips and the contact email</a:t>
                       </a:r>
                     </a:p>
                   </a:txBody>
@@ -9670,7 +9620,7 @@
                           </a:solidFill>
                           <a:latin typeface="Segoe UI"/>
                         </a:rPr>
-                        <a:t>2.5.1</a:t>
+                        <a:t>2.6.0</a:t>
                       </a:r>
                     </a:p>
                   </a:txBody>
@@ -9714,7 +9664,7 @@
                           </a:solidFill>
                           <a:latin typeface="Segoe UI"/>
                         </a:rPr>
-                        <a:t>New cute Pips logo</a:t>
+                        <a:t>Profiles, ranks, online status &amp; dark mode</a:t>
                       </a:r>
                     </a:p>
                     <a:p>
@@ -9725,7 +9675,7 @@
                           </a:solidFill>
                           <a:latin typeface="Segoe UI"/>
                         </a:rPr>
-                        <a:t>New Pips logo: Pip the cat on a Pips-red tile, matching the app colours (desktop shortcut, windows and website)</a:t>
+                        <a:t>Profile tab: profile picture (or your pet), about me, job, location, hobbies, birthday and a status message; Public or private: public profiles can be added directly and viewed in full; private profiles need a friend request that they accept, and strangers only see name, photo, pet, level and status; Click anyone to open their profile - badges, info, their friends - and add them, chat or wave from there; Ranks tab replaces Teams: everyone using Pips, sorted by XP, badges or streak</a:t>
                       </a:r>
                     </a:p>
                   </a:txBody>
@@ -9749,7 +9699,7 @@
                           </a:solidFill>
                           <a:latin typeface="Segoe UI"/>
                         </a:rPr>
-                        <a:t>2.5.0</a:t>
+                        <a:t>2.5.1</a:t>
                       </a:r>
                     </a:p>
                   </a:txBody>
@@ -9793,7 +9743,7 @@
                           </a:solidFill>
                           <a:latin typeface="Segoe UI"/>
                         </a:rPr>
-                        <a:t>Shop, coins, props &amp; moves</a:t>
+                        <a:t>New cute Pips logo</a:t>
                       </a:r>
                     </a:p>
                     <a:p>
@@ -9804,7 +9754,7 @@
                           </a:solidFill>
                           <a:latin typeface="Segoe UI"/>
                         </a:rPr>
-                        <a:t>Shop: earn coins and spend them on your pet - 17 props (crown, wizard hat, headphones, shades, scarf, cape, angel wings...) and 6 moves: spin, dance, moonwalk, backflip, kung fu and spider swing!; Coins come from leveling up (+40), badges (+25), opening Pips each day (+10), friendships (+15 per affinity level), waving / chatting / visiting friends (+2) and pomodoros (+5). Everyone starts with a 100-coin gift; Your friends see your props: on avatars in the hub and when your pet visits their desktop - it shows off one of your moves; Pips is now a social pet: clicking the pet opens the Pips hub (friends, chat, groups, shop, badges)</a:t>
+                        <a:t>New Pips logo: Pip the cat on a Pips-red tile, matching the app colours (desktop shortcut, windows and website)</a:t>
                       </a:r>
                     </a:p>
                   </a:txBody>
@@ -9828,7 +9778,7 @@
                           </a:solidFill>
                           <a:latin typeface="Segoe UI"/>
                         </a:rPr>
-                        <a:t>2.4.0</a:t>
+                        <a:t>2.5.0</a:t>
                       </a:r>
                     </a:p>
                   </a:txBody>
@@ -9872,7 +9822,7 @@
                           </a:solidFill>
                           <a:latin typeface="Segoe UI"/>
                         </a:rPr>
-                        <a:t>Chat, groups, affinity &amp; pet visits</a:t>
+                        <a:t>Shop, coins, props &amp; moves</a:t>
                       </a:r>
                     </a:p>
                     <a:p>
@@ -9883,7 +9833,7 @@
                           </a:solidFill>
                           <a:latin typeface="Segoe UI"/>
                         </a:rPr>
-                        <a:t>Chat: message your friends, and chat inside groups. Your pet pops up new messages as a bubble - click it to reply; Pet interactions: wave, pet their pet, send a snack, high five - or send your pet to visit: it walks onto your friend's desktop for a little while!; Affinity: every chat and interaction grows your friendship - Acquaintance → Buddy → Good friends → Close friends → Best friends → Soulmates; Your own groups: create a private group, invite your friends, they accept or decline. Group board + group chat; the owner can remove members</a:t>
+                        <a:t>Shop: earn coins and spend them on your pet - 17 props (crown, wizard hat, headphones, shades, scarf, cape, angel wings...) and 6 moves: spin, dance, moonwalk, backflip, kung fu and spider swing!; Coins come from leveling up (+40), badges (+25), opening Pips each day (+10), friendships (+15 per affinity level), waving / chatting / visiting friends (+2) and pomodoros (+5). Everyone starts with a 100-coin gift; Your friends see your props: on avatars in the hub and when your pet visits their desktop - it shows off one of your moves; Pips is now a social pet: clicking the pet opens the Pips hub (friends, chat, groups, shop, badges)</a:t>
                       </a:r>
                     </a:p>
                   </a:txBody>
@@ -9907,7 +9857,7 @@
                           </a:solidFill>
                           <a:latin typeface="Segoe UI"/>
                         </a:rPr>
-                        <a:t>2.3.0</a:t>
+                        <a:t>2.4.0</a:t>
                       </a:r>
                     </a:p>
                   </a:txBody>
@@ -9951,7 +9901,7 @@
                           </a:solidFill>
                           <a:latin typeface="Segoe UI"/>
                         </a:rPr>
-                        <a:t>Friends, levels &amp; achievements</a:t>
+                        <a:t>Chat, groups, affinity &amp; pet visits</a:t>
                       </a:r>
                     </a:p>
                     <a:p>
@@ -9962,7 +9912,7 @@
                           </a:solidFill>
                           <a:latin typeface="Segoe UI"/>
                         </a:rPr>
-                        <a:t>Levels &amp; XP: every finished pomodoro earns XP and your level grows - plus 20 achievements to unlock (first tomato, 8 in a day, 7-day streak, early bird, night owl, pet lover...). Your pet celebrates each one; Friends (optional, off by default): get a 6-letter friend code, add colleagues, see today's board and join a team board like PTB. Your pet tells you when a friend finishes a pomodoro; Privacy: only your name, pet, level, streak and pomodoro counts are shared - never apps, window titles or scores. One click turns it off and deletes your online data. Right-click the pet → Friends &amp; achievements…</a:t>
+                        <a:t>Chat: message your friends, and chat inside groups. Your pet pops up new messages as a bubble - click it to reply; Pet interactions: wave, pet their pet, send a snack, high five - or send your pet to visit: it walks onto your friend's desktop for a little while!; Affinity: every chat and interaction grows your friendship - Acquaintance → Buddy → Good friends → Close friends → Best friends → Soulmates; Your own groups: create a private group, invite your friends, they accept or decline. Group board + group chat; the owner can remove members</a:t>
                       </a:r>
                     </a:p>
                   </a:txBody>
@@ -9986,7 +9936,7 @@
                           </a:solidFill>
                           <a:latin typeface="Segoe UI"/>
                         </a:rPr>
-                        <a:t>2.2.0</a:t>
+                        <a:t>2.3.0</a:t>
                       </a:r>
                     </a:p>
                   </a:txBody>
@@ -10030,7 +9980,7 @@
                           </a:solidFill>
                           <a:latin typeface="Segoe UI"/>
                         </a:rPr>
-                        <a:t>Pet sounds</a:t>
+                        <a:t>Friends, levels &amp; achievements</a:t>
                       </a:r>
                     </a:p>
                     <a:p>
@@ -10041,7 +9991,7 @@
                           </a:solidFill>
                           <a:latin typeface="Segoe UI"/>
                         </a:rPr>
-                        <a:t>Your pet has a voice! Each of the 23 animals has its own sound (meow, woof, ribbit, hoot, buzz, oink, whale song...) and it changes with its mood: happy chirps, sad whimpers, sleepy yawns, hungry calls, grumpy huffs and soft snores; It also reacts with sound when you tickle, pet, feed, shake or wake it; Settings: right-click the pet → Sounds to switch on/off; Pet status &amp; settings has a volume slider, a ▶ Hear me button and "Stay quiet while I'm focusing" (on by default)</a:t>
+                        <a:t>Levels &amp; XP: every finished pomodoro earns XP and your level grows - plus 20 achievements to unlock (first tomato, 8 in a day, 7-day streak, early bird, night owl, pet lover...). Your pet celebrates each one; Friends (optional, off by default): get a 6-letter friend code, add colleagues, see today's board and join a team board like PTB. Your pet tells you when a friend finishes a pomodoro; Privacy: only your name, pet, level, streak and pomodoro counts are shared - never apps, window titles or scores. One click turns it off and deletes your online data. Right-click the pet → Friends &amp; achievements…</a:t>
                       </a:r>
                     </a:p>
                   </a:txBody>
@@ -10065,7 +10015,7 @@
                           </a:solidFill>
                           <a:latin typeface="Segoe UI"/>
                         </a:rPr>
-                        <a:t>2.1.2</a:t>
+                        <a:t>2.2.0</a:t>
                       </a:r>
                     </a:p>
                   </a:txBody>
@@ -10109,7 +10059,7 @@
                           </a:solidFill>
                           <a:latin typeface="Segoe UI"/>
                         </a:rPr>
-                        <a:t>Tickle-only mode</a:t>
+                        <a:t>Pet sounds</a:t>
                       </a:r>
                     </a:p>
                     <a:p>
@@ -10120,7 +10070,7 @@
                           </a:solidFill>
                           <a:latin typeface="Segoe UI"/>
                         </a:rPr>
-                        <a:t>New click option "Only tickle (never open Pips)": click and tickle your pet as much as you like - the Pomodoro window stays closed (open it from the right-click menu). Right-click the pet → When I click</a:t>
+                        <a:t>Your pet has a voice! Each of the 23 animals has its own sound (meow, woof, ribbit, hoot, buzz, oink, whale song...) and it changes with its mood: happy chirps, sad whimpers, sleepy yawns, hungry calls, grumpy huffs and soft snores; It also reacts with sound when you tickle, pet, feed, shake or wake it; Settings: right-click the pet → Sounds to switch on/off; Pet status &amp; settings has a volume slider, a ▶ Hear me button and "Stay quiet while I'm focusing" (on by default)</a:t>
                       </a:r>
                     </a:p>
                   </a:txBody>
@@ -10144,7 +10094,7 @@
                           </a:solidFill>
                           <a:latin typeface="Segoe UI"/>
                         </a:rPr>
-                        <a:t>2.1.1</a:t>
+                        <a:t>2.1.2</a:t>
                       </a:r>
                     </a:p>
                   </a:txBody>
@@ -10188,7 +10138,7 @@
                           </a:solidFill>
                           <a:latin typeface="Segoe UI"/>
                         </a:rPr>
-                        <a:t>Owner info</a:t>
+                        <a:t>Tickle-only mode</a:t>
                       </a:r>
                     </a:p>
                     <a:p>
@@ -10199,7 +10149,7 @@
                           </a:solidFill>
                           <a:latin typeface="Segoe UI"/>
                         </a:rPr>
-                        <a:t>About Pips now shows the owner: Juwen Lie (right-click the pet → Help → About)</a:t>
+                        <a:t>New click option "Only tickle (never open Pips)": click and tickle your pet as much as you like - the Pomodoro window stays closed (open it from the right-click menu). Right-click the pet → When I click</a:t>
                       </a:r>
                     </a:p>
                   </a:txBody>
@@ -10223,7 +10173,7 @@
                           </a:solidFill>
                           <a:latin typeface="Segoe UI"/>
                         </a:rPr>
-                        <a:t>2.1.0</a:t>
+                        <a:t>2.1.1</a:t>
                       </a:r>
                     </a:p>
                   </a:txBody>
@@ -10267,7 +10217,7 @@
                           </a:solidFill>
                           <a:latin typeface="Segoe UI"/>
                         </a:rPr>
-                        <a:t>Interactive guide &amp; in-app updates</a:t>
+                        <a:t>Owner info</a:t>
                       </a:r>
                     </a:p>
                     <a:p>
@@ -10278,7 +10228,7 @@
                           </a:solidFill>
                           <a:latin typeface="Segoe UI"/>
                         </a:rPr>
-                        <a:t>Interactive first-run guide: your pet walks you through clicking, dragging, petting and the right-click menu; In-app updates: Pips tells you when a new version is out - update with one click (your settings and data are kept); New Help menu: replay the guide, check for updates, see the version; Option to turn automatic update checks off</a:t>
+                        <a:t>About Pips now shows the owner: Juwen Lie (right-click the pet → Help → About)</a:t>
                       </a:r>
                     </a:p>
                   </a:txBody>
@@ -10302,7 +10252,7 @@
                           </a:solidFill>
                           <a:latin typeface="Segoe UI"/>
                         </a:rPr>
-                        <a:t>2.0.0</a:t>
+                        <a:t>2.1.0</a:t>
                       </a:r>
                     </a:p>
                   </a:txBody>
@@ -10346,7 +10296,7 @@
                           </a:solidFill>
                           <a:latin typeface="Segoe UI"/>
                         </a:rPr>
-                        <a:t>Desktop pet, 23 animals &amp; 4 languages</a:t>
+                        <a:t>Interactive guide &amp; in-app updates</a:t>
                       </a:r>
                     </a:p>
                     <a:p>
@@ -10357,7 +10307,7 @@
                           </a:solidFill>
                           <a:latin typeface="Segoe UI"/>
                         </a:rPr>
-                        <a:t>Desktop pet that lives on your desktop and taskbar - drag it, tickle it, pet it; 23 animals in 3 groups: Land walks, Water swims with bubbles, Sky hovers and flaps; Moods (happy, sad, tired, hungry, grumpy...), naps when you're away, wakes up when you're back; Cute chat-bubble reminders: breaks, water, 20-20-20 eye rest, pomodoro done, daily goal</a:t>
+                        <a:t>Interactive first-run guide: your pet walks you through clicking, dragging, petting and the right-click menu; In-app updates: Pips tells you when a new version is out - update with one click (your settings and data are kept); New Help menu: replay the guide, check for updates, see the version; Option to turn automatic update checks off</a:t>
                       </a:r>
                     </a:p>
                   </a:txBody>
@@ -10381,7 +10331,7 @@
                           </a:solidFill>
                           <a:latin typeface="Segoe UI"/>
                         </a:rPr>
-                        <a:t>1.5.0</a:t>
+                        <a:t>2.0.0</a:t>
                       </a:r>
                     </a:p>
                   </a:txBody>
@@ -10403,13 +10353,92 @@
                           </a:solidFill>
                           <a:latin typeface="Segoe UI"/>
                         </a:rPr>
+                        <a:t>2026-10-28</a:t>
+                      </a:r>
+                    </a:p>
+                  </a:txBody>
+                  <a:tcPr marL="73152" marR="73152" marT="36576" marB="36576">
+                    <a:solidFill>
+                      <a:srgbClr val="FFFDF8"/>
+                    </a:solidFill>
+                  </a:tcPr>
+                </a:tc>
+                <a:tc>
+                  <a:txBody>
+                    <a:bodyPr wrap="square"/>
+                    <a:lstStyle/>
+                    <a:p>
+                      <a:r>
+                        <a:rPr sz="1200" b="0">
+                          <a:solidFill>
+                            <a:srgbClr val="2B2A28"/>
+                          </a:solidFill>
+                          <a:latin typeface="Segoe UI"/>
+                        </a:rPr>
+                        <a:t>Desktop pet, 23 animals &amp; 4 languages</a:t>
+                      </a:r>
+                    </a:p>
+                    <a:p>
+                      <a:r>
+                        <a:rPr sz="1200" b="0">
+                          <a:solidFill>
+                            <a:srgbClr val="2B2A28"/>
+                          </a:solidFill>
+                          <a:latin typeface="Segoe UI"/>
+                        </a:rPr>
+                        <a:t>Desktop pet that lives on your desktop and taskbar - drag it, tickle it, pet it; 23 animals in 3 groups: Land walks, Water swims with bubbles, Sky hovers and flaps; Moods (happy, sad, tired, hungry, grumpy...), naps when you're away, wakes up when you're back; Cute chat-bubble reminders: breaks, water, 20-20-20 eye rest, pomodoro done, daily goal</a:t>
+                      </a:r>
+                    </a:p>
+                  </a:txBody>
+                  <a:tcPr marL="73152" marR="73152" marT="36576" marB="36576">
+                    <a:solidFill>
+                      <a:srgbClr val="FFFDF8"/>
+                    </a:solidFill>
+                  </a:tcPr>
+                </a:tc>
+              </a:tr>
+              <a:tr h="822960">
+                <a:tc>
+                  <a:txBody>
+                    <a:bodyPr wrap="square"/>
+                    <a:lstStyle/>
+                    <a:p>
+                      <a:r>
+                        <a:rPr sz="1200" b="1">
+                          <a:solidFill>
+                            <a:srgbClr val="2B2A28"/>
+                          </a:solidFill>
+                          <a:latin typeface="Segoe UI"/>
+                        </a:rPr>
+                        <a:t>1.5.0</a:t>
+                      </a:r>
+                    </a:p>
+                  </a:txBody>
+                  <a:tcPr marL="73152" marR="73152" marT="36576" marB="36576">
+                    <a:solidFill>
+                      <a:srgbClr val="F7F4EC"/>
+                    </a:solidFill>
+                  </a:tcPr>
+                </a:tc>
+                <a:tc>
+                  <a:txBody>
+                    <a:bodyPr wrap="square"/>
+                    <a:lstStyle/>
+                    <a:p>
+                      <a:r>
+                        <a:rPr sz="1200" b="0">
+                          <a:solidFill>
+                            <a:srgbClr val="2B2A28"/>
+                          </a:solidFill>
+                          <a:latin typeface="Segoe UI"/>
+                        </a:rPr>
                         <a:t>2026-10-24</a:t>
                       </a:r>
                     </a:p>
                   </a:txBody>
                   <a:tcPr marL="73152" marR="73152" marT="36576" marB="36576">
                     <a:solidFill>
-                      <a:srgbClr val="FFFDF8"/>
+                      <a:srgbClr val="F7F4EC"/>
                     </a:solidFill>
                   </a:tcPr>
                 </a:tc>
@@ -10442,7 +10471,7 @@
                   </a:txBody>
                   <a:tcPr marL="73152" marR="73152" marT="36576" marB="36576">
                     <a:solidFill>
-                      <a:srgbClr val="FFFDF8"/>
+                      <a:srgbClr val="F7F4EC"/>
                     </a:solidFill>
                   </a:tcPr>
                 </a:tc>
@@ -10466,7 +10495,7 @@
                   </a:txBody>
                   <a:tcPr marL="73152" marR="73152" marT="36576" marB="36576">
                     <a:solidFill>
-                      <a:srgbClr val="F7F4EC"/>
+                      <a:srgbClr val="FFFDF8"/>
                     </a:solidFill>
                   </a:tcPr>
                 </a:tc>
@@ -10488,7 +10517,7 @@
                   </a:txBody>
                   <a:tcPr marL="73152" marR="73152" marT="36576" marB="36576">
                     <a:solidFill>
-                      <a:srgbClr val="F7F4EC"/>
+                      <a:srgbClr val="FFFDF8"/>
                     </a:solidFill>
                   </a:tcPr>
                 </a:tc>
@@ -10521,7 +10550,7 @@
                   </a:txBody>
                   <a:tcPr marL="73152" marR="73152" marT="36576" marB="36576">
                     <a:solidFill>
-                      <a:srgbClr val="F7F4EC"/>
+                      <a:srgbClr val="FFFDF8"/>
                     </a:solidFill>
                   </a:tcPr>
                 </a:tc>
@@ -11662,7 +11691,7 @@
                 </a:solidFill>
                 <a:latin typeface="Segoe UI"/>
               </a:rPr>
-              <a:t>Get Pips-Windows.zip from</a:t>
+              <a:t>Click Download Pips for Windows at</a:t>
             </a:r>
           </a:p>
           <a:p>
@@ -11674,7 +11703,7 @@
                 </a:solidFill>
                 <a:latin typeface="Segoe UI"/>
               </a:rPr>
-              <a:t>https://juw12.github.io/projects/pips/download/Pips-Windows.zip</a:t>
+              <a:t>https://juw12.github.io/projects/pips/</a:t>
             </a:r>
           </a:p>
         </p:txBody>
@@ -11809,7 +11838,7 @@
                 </a:solidFill>
                 <a:latin typeface="Segoe UI"/>
               </a:rPr>
-              <a:t>Unzip</a:t>
+              <a:t>Install</a:t>
             </a:r>
           </a:p>
         </p:txBody>
@@ -11844,7 +11873,7 @@
                 </a:solidFill>
                 <a:latin typeface="Segoe UI"/>
               </a:rPr>
-              <a:t>Right-click the zip → Extract All…</a:t>
+              <a:t>Open Pips-Setup.exe, then click Install Pips.</a:t>
             </a:r>
           </a:p>
           <a:p>
@@ -11856,7 +11885,7 @@
                 </a:solidFill>
                 <a:latin typeface="Segoe UI"/>
               </a:rPr>
-              <a:t>Put the folder somewhere permanent, e.g. Documents\Pips (not inside the zip!).</a:t>
+              <a:t>Python and every helper are included. Nothing to unzip.</a:t>
             </a:r>
           </a:p>
         </p:txBody>
@@ -11991,7 +12020,7 @@
                 </a:solidFill>
                 <a:latin typeface="Segoe UI"/>
               </a:rPr>
-              <a:t>Start</a:t>
+              <a:t>Meet your pet</a:t>
             </a:r>
           </a:p>
         </p:txBody>
@@ -12026,7 +12055,7 @@
                 </a:solidFill>
                 <a:latin typeface="Segoe UI"/>
               </a:rPr>
-              <a:t>Double-click  “Start Pips.bat”.</a:t>
+              <a:t>Pips opens automatically. Choose your language.</a:t>
             </a:r>
           </a:p>
           <a:p>
@@ -12038,7 +12067,7 @@
                 </a:solidFill>
                 <a:latin typeface="Segoe UI"/>
               </a:rPr>
-              <a:t>The first start installs two small helpers (pywin32, Pillow) - takes ~30 s.</a:t>
+              <a:t>Desktop and Start Menu shortcuts are ready for next time.</a:t>
             </a:r>
           </a:p>
         </p:txBody>
@@ -12134,7 +12163,7 @@
                 </a:solidFill>
                 <a:latin typeface="Segoe UI"/>
               </a:rPr>
-              <a:t>Needs Python 3.10+ </a:t>
+              <a:t>Windows 10/11, 64-bit: </a:t>
             </a:r>
             <a:r>
               <a:rPr sz="1400">
@@ -12143,7 +12172,7 @@
                 </a:solidFill>
                 <a:latin typeface="Segoe UI"/>
               </a:rPr>
-              <a:t>(free from python.org - tick “Add python.exe to PATH” when installing). Windows 10 or 11.</a:t>
+              <a:t>no separate Python setup, terminal or administrator password.</a:t>
             </a:r>
           </a:p>
           <a:p>
@@ -12168,7 +12197,7 @@
                 </a:solidFill>
                 <a:latin typeface="Segoe UI"/>
               </a:rPr>
-              <a:t>Start with Windows: </a:t>
+              <a:t>Already have Pips? </a:t>
             </a:r>
             <a:r>
               <a:rPr sz="1400">
@@ -12177,7 +12206,7 @@
                 </a:solidFill>
                 <a:latin typeface="Segoe UI"/>
               </a:rPr>
-              <a:t>right-click the Pips card → Autostart, or run install_autostart.ps1 (right-click → Run with PowerShell).</a:t>
+              <a:t>use Help → Check for updates in your current copy. No reinstall needed.</a:t>
             </a:r>
           </a:p>
         </p:txBody>

</xml_diff>

<commit_message>
pips 2.14.0: Pokes, tickles & teases
</commit_message>
<xml_diff>
--- a/apps/pips/web/download/Pips-Guide.pptx
+++ b/apps/pips/web/download/Pips-Guide.pptx
@@ -3292,7 +3292,7 @@
                 </a:solidFill>
                 <a:latin typeface="Segoe UI"/>
               </a:rPr>
-              <a:t>Version 2.13.1  ·  2026-10-28  ·  Made by Juwen Lie (owner)</a:t>
+              <a:t>Version 2.14.0  ·  2026-10-29  ·  Made by Juwen Lie (owner)</a:t>
             </a:r>
           </a:p>
           <a:p>
@@ -4648,6 +4648,31 @@
                 <a:latin typeface="Segoe UI"/>
               </a:rPr>
               <a:t>Wave, pet, send a snack, high five - or send your pet to visit their desktop!</a:t>
+            </a:r>
+          </a:p>
+          <a:p>
+            <a:pPr>
+              <a:spcAft>
+                <a:spcPts val="400"/>
+              </a:spcAft>
+            </a:pPr>
+            <a:r>
+              <a:rPr sz="1300" b="1">
+                <a:solidFill>
+                  <a:srgbClr val="4CB86B"/>
+                </a:solidFill>
+                <a:latin typeface="Segoe UI"/>
+              </a:rPr>
+              <a:t>•  </a:t>
+            </a:r>
+            <a:r>
+              <a:rPr sz="1300">
+                <a:solidFill>
+                  <a:srgbClr val="2B2A28"/>
+                </a:solidFill>
+                <a:latin typeface="Segoe UI"/>
+              </a:rPr>
+              <a:t>Poke, tickle, tease, boop or hug a friend from afar - it pops up on their screen</a:t>
             </a:r>
           </a:p>
           <a:p>
@@ -8141,7 +8166,7 @@
                 </a:solidFill>
                 <a:latin typeface="Segoe UI"/>
               </a:rPr>
-              <a:t>What's new in 2.13.1</a:t>
+              <a:t>What's new in 2.14.0</a:t>
             </a:r>
           </a:p>
         </p:txBody>
@@ -8254,7 +8279,7 @@
                 </a:solidFill>
                 <a:latin typeface="Segoe UI"/>
               </a:rPr>
-              <a:t>One-click Windows installer  ·  2026-10-28</a:t>
+              <a:t>Pokes, tickles &amp; teases  ·  2026-10-29</a:t>
             </a:r>
           </a:p>
         </p:txBody>
@@ -8302,7 +8327,7 @@
                 </a:solidFill>
                 <a:latin typeface="Segoe UI"/>
               </a:rPr>
-              <a:t>One Windows installer: no ZIP extraction, Python installation or command line. Download, open and click Install Pips.</a:t>
+              <a:t>Poke, tickle, tease, boop or hug a friend from afar - no pet visit needed.</a:t>
             </a:r>
           </a:p>
           <a:p>
@@ -8327,7 +8352,7 @@
                 </a:solidFill>
                 <a:latin typeface="Segoe UI"/>
               </a:rPr>
-              <a:t>Installs for your Windows account without administrator access, adds Desktop and Start Menu shortcuts, and opens Pips automatically.</a:t>
+              <a:t>Right-click your pet → Poke a friend, or use the Poke button in Friends, chat and profiles.</a:t>
             </a:r>
           </a:p>
           <a:p>
@@ -8352,7 +8377,7 @@
                 </a:solidFill>
                 <a:latin typeface="Segoe UI"/>
               </a:rPr>
-              <a:t>Reinstalling in the same location keeps your settings and pet progress. Existing ZIP users can keep updating in place from Help → Check for updates.</a:t>
+              <a:t>Your friend gets a pop-up ("Wendy is teasing you!"), their pet reacts, and they can poke back with one click.</a:t>
             </a:r>
           </a:p>
           <a:p>
@@ -8377,7 +8402,32 @@
                 </a:solidFill>
                 <a:latin typeface="Segoe UI"/>
               </a:rPr>
-              <a:t>A simpler download page and updated user guide; the bundled runtime stays separate from small in-app updates.</a:t>
+              <a:t>During a focus session pokes wait quietly until your break; when your pet is hidden they show in the screen corner.</a:t>
+            </a:r>
+          </a:p>
+          <a:p>
+            <a:pPr>
+              <a:spcAft>
+                <a:spcPts val="1000"/>
+              </a:spcAft>
+            </a:pPr>
+            <a:r>
+              <a:rPr sz="1700" b="1">
+                <a:solidFill>
+                  <a:srgbClr val="4CB86B"/>
+                </a:solidFill>
+                <a:latin typeface="Segoe UI"/>
+              </a:rPr>
+              <a:t>•  </a:t>
+            </a:r>
+            <a:r>
+              <a:rPr sz="1700">
+                <a:solidFill>
+                  <a:srgbClr val="2B2A28"/>
+                </a:solidFill>
+                <a:latin typeface="Segoe UI"/>
+              </a:rPr>
+              <a:t>Don't want it? Profile → untick "Let friends poke, tickle &amp; tease me".</a:t>
             </a:r>
           </a:p>
         </p:txBody>
@@ -8508,7 +8558,7 @@
                 </a:solidFill>
                 <a:latin typeface="Segoe UI"/>
               </a:rPr>
-              <a:t>Satu installer Windows: tanpa ekstrak ZIP, instal Python, atau terminal. Unduh, buka, lalu klik Install Pips.</a:t>
+              <a:t>Colek, gelitik, goda, toel hidung atau peluk teman dari jauh - tanpa perlu pet berkunjung.</a:t>
             </a:r>
           </a:p>
           <a:p>
@@ -8533,7 +8583,7 @@
                 </a:solidFill>
                 <a:latin typeface="Segoe UI"/>
               </a:rPr>
-              <a:t>Dipasang untuk akun Windows Anda tanpa akses administrator, membuat pintasan Desktop dan Start Menu, lalu membuka Pips otomatis.</a:t>
+              <a:t>Klik kanan pet → Colek teman, atau pakai tombol Colek di Teman, chat dan profil.</a:t>
             </a:r>
           </a:p>
           <a:p>
@@ -8558,7 +8608,7 @@
                 </a:solidFill>
                 <a:latin typeface="Segoe UI"/>
               </a:rPr>
-              <a:t>Instal ulang di lokasi yang sama tetap menyimpan pengaturan dan progres pet. Pengguna ZIP tetap dapat memperbarui lewat Bantuan → Periksa pembaruan.</a:t>
+              <a:t>Temanmu mendapat notifikasi ("Wendy lagi godain kamu!"), pet-nya bereaksi, dan bisa colek balik dengan satu klik.</a:t>
             </a:r>
           </a:p>
           <a:p>
@@ -8583,7 +8633,32 @@
                 </a:solidFill>
                 <a:latin typeface="Segoe UI"/>
               </a:rPr>
-              <a:t>Halaman unduhan dan panduan kini lebih sederhana; runtime bawaan terpisah dari pembaruan kecil dalam aplikasi.</a:t>
+              <a:t>Saat sesi fokus, colekan menunggu sampai istirahat; jika pet disembunyikan, muncul di pojok layar.</a:t>
+            </a:r>
+          </a:p>
+          <a:p>
+            <a:pPr>
+              <a:spcAft>
+                <a:spcPts val="500"/>
+              </a:spcAft>
+            </a:pPr>
+            <a:r>
+              <a:rPr sz="1200" b="1">
+                <a:solidFill>
+                  <a:srgbClr val="4CB86B"/>
+                </a:solidFill>
+                <a:latin typeface="Segoe UI"/>
+              </a:rPr>
+              <a:t>•  </a:t>
+            </a:r>
+            <a:r>
+              <a:rPr sz="1200">
+                <a:solidFill>
+                  <a:srgbClr val="2B2A28"/>
+                </a:solidFill>
+                <a:latin typeface="Segoe UI"/>
+              </a:rPr>
+              <a:t>Tidak mau? Profil → hapus centang "Izinkan teman mencolek, menggelitik &amp; menggoda saya".</a:t>
             </a:r>
           </a:p>
         </p:txBody>
@@ -8815,7 +8890,7 @@
         </p:nvGraphicFramePr>
         <p:xfrm>
           <a:off x="548640" y="1645920"/>
-          <a:ext cx="11155680" cy="17666208"/>
+          <a:ext cx="11155680" cy="18489168"/>
         </p:xfrm>
         <a:graphic>
           <a:graphicData uri="http://schemas.openxmlformats.org/drawingml/2006/table">
@@ -8909,7 +8984,165 @@
                           </a:solidFill>
                           <a:latin typeface="Segoe UI"/>
                         </a:rPr>
+                        <a:t>2.14.0</a:t>
+                      </a:r>
+                    </a:p>
+                  </a:txBody>
+                  <a:tcPr marL="73152" marR="73152" marT="36576" marB="36576">
+                    <a:solidFill>
+                      <a:srgbClr val="FFFDF8"/>
+                    </a:solidFill>
+                  </a:tcPr>
+                </a:tc>
+                <a:tc>
+                  <a:txBody>
+                    <a:bodyPr wrap="square"/>
+                    <a:lstStyle/>
+                    <a:p>
+                      <a:r>
+                        <a:rPr sz="1200" b="0">
+                          <a:solidFill>
+                            <a:srgbClr val="2B2A28"/>
+                          </a:solidFill>
+                          <a:latin typeface="Segoe UI"/>
+                        </a:rPr>
+                        <a:t>2026-10-29</a:t>
+                      </a:r>
+                    </a:p>
+                  </a:txBody>
+                  <a:tcPr marL="73152" marR="73152" marT="36576" marB="36576">
+                    <a:solidFill>
+                      <a:srgbClr val="FFFDF8"/>
+                    </a:solidFill>
+                  </a:tcPr>
+                </a:tc>
+                <a:tc>
+                  <a:txBody>
+                    <a:bodyPr wrap="square"/>
+                    <a:lstStyle/>
+                    <a:p>
+                      <a:r>
+                        <a:rPr sz="1200" b="0">
+                          <a:solidFill>
+                            <a:srgbClr val="2B2A28"/>
+                          </a:solidFill>
+                          <a:latin typeface="Segoe UI"/>
+                        </a:rPr>
+                        <a:t>Pokes, tickles &amp; teases</a:t>
+                      </a:r>
+                    </a:p>
+                    <a:p>
+                      <a:r>
+                        <a:rPr sz="1200" b="0">
+                          <a:solidFill>
+                            <a:srgbClr val="2B2A28"/>
+                          </a:solidFill>
+                          <a:latin typeface="Segoe UI"/>
+                        </a:rPr>
+                        <a:t>Poke, tickle, tease, boop or hug a friend from afar - no pet visit needed.; Right-click your pet → Poke a friend, or use the Poke button in Friends, chat and profiles.; Your friend gets a pop-up ("Wendy is teasing you!"), their pet reacts, and they can poke back with one click.; During a focus session pokes wait quietly until your break; when your pet is hidden they show in the screen corner.</a:t>
+                      </a:r>
+                    </a:p>
+                  </a:txBody>
+                  <a:tcPr marL="73152" marR="73152" marT="36576" marB="36576">
+                    <a:solidFill>
+                      <a:srgbClr val="FFFDF8"/>
+                    </a:solidFill>
+                  </a:tcPr>
+                </a:tc>
+              </a:tr>
+              <a:tr h="822960">
+                <a:tc>
+                  <a:txBody>
+                    <a:bodyPr wrap="square"/>
+                    <a:lstStyle/>
+                    <a:p>
+                      <a:r>
+                        <a:rPr sz="1200" b="1">
+                          <a:solidFill>
+                            <a:srgbClr val="2B2A28"/>
+                          </a:solidFill>
+                          <a:latin typeface="Segoe UI"/>
+                        </a:rPr>
                         <a:t>2.13.1</a:t>
+                      </a:r>
+                    </a:p>
+                  </a:txBody>
+                  <a:tcPr marL="73152" marR="73152" marT="36576" marB="36576">
+                    <a:solidFill>
+                      <a:srgbClr val="F7F4EC"/>
+                    </a:solidFill>
+                  </a:tcPr>
+                </a:tc>
+                <a:tc>
+                  <a:txBody>
+                    <a:bodyPr wrap="square"/>
+                    <a:lstStyle/>
+                    <a:p>
+                      <a:r>
+                        <a:rPr sz="1200" b="0">
+                          <a:solidFill>
+                            <a:srgbClr val="2B2A28"/>
+                          </a:solidFill>
+                          <a:latin typeface="Segoe UI"/>
+                        </a:rPr>
+                        <a:t>2026-10-28</a:t>
+                      </a:r>
+                    </a:p>
+                  </a:txBody>
+                  <a:tcPr marL="73152" marR="73152" marT="36576" marB="36576">
+                    <a:solidFill>
+                      <a:srgbClr val="F7F4EC"/>
+                    </a:solidFill>
+                  </a:tcPr>
+                </a:tc>
+                <a:tc>
+                  <a:txBody>
+                    <a:bodyPr wrap="square"/>
+                    <a:lstStyle/>
+                    <a:p>
+                      <a:r>
+                        <a:rPr sz="1200" b="0">
+                          <a:solidFill>
+                            <a:srgbClr val="2B2A28"/>
+                          </a:solidFill>
+                          <a:latin typeface="Segoe UI"/>
+                        </a:rPr>
+                        <a:t>One-click Windows installer</a:t>
+                      </a:r>
+                    </a:p>
+                    <a:p>
+                      <a:r>
+                        <a:rPr sz="1200" b="0">
+                          <a:solidFill>
+                            <a:srgbClr val="2B2A28"/>
+                          </a:solidFill>
+                          <a:latin typeface="Segoe UI"/>
+                        </a:rPr>
+                        <a:t>One Windows installer: no ZIP extraction, Python installation or command line. Download, open and click Install Pips.; Installs for your Windows account without administrator access, adds Desktop and Start Menu shortcuts, and opens Pips automatically.; Reinstalling in the same location keeps your settings and pet progress. Existing ZIP users can keep updating in place from Help → Check for updates.; A simpler download page and updated user guide; the bundled runtime stays separate from small in-app updates.</a:t>
+                      </a:r>
+                    </a:p>
+                  </a:txBody>
+                  <a:tcPr marL="73152" marR="73152" marT="36576" marB="36576">
+                    <a:solidFill>
+                      <a:srgbClr val="F7F4EC"/>
+                    </a:solidFill>
+                  </a:tcPr>
+                </a:tc>
+              </a:tr>
+              <a:tr h="822960">
+                <a:tc>
+                  <a:txBody>
+                    <a:bodyPr wrap="square"/>
+                    <a:lstStyle/>
+                    <a:p>
+                      <a:r>
+                        <a:rPr sz="1200" b="1">
+                          <a:solidFill>
+                            <a:srgbClr val="2B2A28"/>
+                          </a:solidFill>
+                          <a:latin typeface="Segoe UI"/>
+                        </a:rPr>
+                        <a:t>2.13.0</a:t>
                       </a:r>
                     </a:p>
                   </a:txBody>
@@ -8953,7 +9186,7 @@
                           </a:solidFill>
                           <a:latin typeface="Segoe UI"/>
                         </a:rPr>
-                        <a:t>One-click Windows installer</a:t>
+                        <a:t>Birthdays, parties &amp; gifts</a:t>
                       </a:r>
                     </a:p>
                     <a:p>
@@ -8964,7 +9197,7 @@
                           </a:solidFill>
                           <a:latin typeface="Segoe UI"/>
                         </a:rPr>
-                        <a:t>One Windows installer: no ZIP extraction, Python installation or command line. Download, open and click Install Pips.; Installs for your Windows account without administrator access, adds Desktop and Start Menu shortcuts, and opens Pips automatically.; Reinstalling in the same location keeps your settings and pet progress. Existing ZIP users can keep updating in place from Help → Check for updates.; A simpler download page and updated user guide; the bundled runtime stays separate from small in-app updates.</a:t>
+                        <a:t>Set your birthday in Social → Profile (month + day, optionally visible to friends).; On your birthday Pips throws confetti and gives you 100 bonus coins.; Friends tab shows upcoming birthdays; you get reminders 3 days, 1 day and on the day.; Birthday parties: join a friend's party, see who's there, sign the guestbook and celebrate together.</a:t>
                       </a:r>
                     </a:p>
                   </a:txBody>
@@ -8988,7 +9221,7 @@
                           </a:solidFill>
                           <a:latin typeface="Segoe UI"/>
                         </a:rPr>
-                        <a:t>2.13.0</a:t>
+                        <a:t>2.12.0</a:t>
                       </a:r>
                     </a:p>
                   </a:txBody>
@@ -9032,7 +9265,7 @@
                           </a:solidFill>
                           <a:latin typeface="Segoe UI"/>
                         </a:rPr>
-                        <a:t>Birthdays, parties &amp; gifts</a:t>
+                        <a:t>Mega update: 28 new animals, 31 shop items, 13 moves</a:t>
                       </a:r>
                     </a:p>
                     <a:p>
@@ -9043,7 +9276,7 @@
                           </a:solidFill>
                           <a:latin typeface="Segoe UI"/>
                         </a:rPr>
-                        <a:t>Set your birthday in Social → Profile (month + day, optionally visible to friends).; On your birthday Pips throws confetti and gives you 100 bonus coins.; Friends tab shows upcoming birthdays; you get reminders 3 days, 1 day and on the day.; Birthday parties: join a friend's party, see who's there, sign the guestbook and celebrate together.</a:t>
+                        <a:t>🦁 28 new animals (51 total): lion, tiger, unicorn, deer, sheep, cow, raccoon, red panda, monkey, hedgehog, dino, squirrel, mouse, koala, shark, dolphin, seal, otter, pufferfish, duck, crab, parrot, chick, ladybug, phoenix, pegasus, ghost and flamingo; 🎩 31 new shop items: top hat, cowboy, chef, pirate, Santa, viking, graduation cap, beret, bow, propeller cap, flower crown, nerd glasses, eyepatch, mustache, goggles, masquerade mask, tie, pearls, flower lei, gold chain, balloon, backpack, guitar, shield, butterfly / devil wings and more - plus Premium galaxy crown, galaxy cape and dragon wings; 💃 13 new moves: wave, jump, hearts, sing, yoga, zoomies, cartwheel, juggle, rain dance, breakdance, magic, confetti and the Premium rocket launch; The Shop is now split into sections (Hats, Face, Neck, Back, Moves, Arena gear) with an owned counter for each</a:t>
                       </a:r>
                     </a:p>
                   </a:txBody>
@@ -9067,7 +9300,7 @@
                           </a:solidFill>
                           <a:latin typeface="Segoe UI"/>
                         </a:rPr>
-                        <a:t>2.12.0</a:t>
+                        <a:t>2.11.0</a:t>
                       </a:r>
                     </a:p>
                   </a:txBody>
@@ -9111,7 +9344,7 @@
                           </a:solidFill>
                           <a:latin typeface="Segoe UI"/>
                         </a:rPr>
-                        <a:t>Mega update: 28 new animals, 31 shop items, 13 moves</a:t>
+                        <a:t>New right-click menus</a:t>
                       </a:r>
                     </a:p>
                     <a:p>
@@ -9122,7 +9355,7 @@
                           </a:solidFill>
                           <a:latin typeface="Segoe UI"/>
                         </a:rPr>
-                        <a:t>🦁 28 new animals (51 total): lion, tiger, unicorn, deer, sheep, cow, raccoon, red panda, monkey, hedgehog, dino, squirrel, mouse, koala, shark, dolphin, seal, otter, pufferfish, duck, crab, parrot, chick, ladybug, phoenix, pegasus, ghost and flamingo; 🎩 31 new shop items: top hat, cowboy, chef, pirate, Santa, viking, graduation cap, beret, bow, propeller cap, flower crown, nerd glasses, eyepatch, mustache, goggles, masquerade mask, tie, pearls, flower lei, gold chain, balloon, backpack, guitar, shield, butterfly / devil wings and more - plus Premium galaxy crown, galaxy cape and dragon wings; 💃 13 new moves: wave, jump, hearts, sing, yoga, zoomies, cartwheel, juggle, rain dance, breakdance, magic, confetti and the Premium rocket launch; The Shop is now split into sections (Hats, Face, Neck, Back, Moves, Arena gear) with an owned counter for each</a:t>
+                        <a:t>✨ Brand-new animated right-click menu for your pet: mood &amp; stat bars, quick-action tiles (Friends, Shop, Snack, Pat, Focus, Stats, Sleep, Taskbar), hover effects and smooth fly-out submenus; Pick colours from swatches, switch size with one click and flip Sounds / Dark mode with toggle switches - changes show instantly; Updates are highlighted: a glowing banner and NEW badge appear in the menu when a new version is ready; The focus card's right-click menu got the same new look; keyboard arrows, Enter and Esc work too</a:t>
                       </a:r>
                     </a:p>
                   </a:txBody>
@@ -9146,7 +9379,7 @@
                           </a:solidFill>
                           <a:latin typeface="Segoe UI"/>
                         </a:rPr>
-                        <a:t>2.11.0</a:t>
+                        <a:t>2.10.0</a:t>
                       </a:r>
                     </a:p>
                   </a:txBody>
@@ -9190,7 +9423,7 @@
                           </a:solidFill>
                           <a:latin typeface="Segoe UI"/>
                         </a:rPr>
-                        <a:t>New right-click menus</a:t>
+                        <a:t>Chat bots</a:t>
                       </a:r>
                     </a:p>
                     <a:p>
@@ -9201,7 +9434,7 @@
                           </a:solidFill>
                           <a:latin typeface="Segoe UI"/>
                         </a:rPr>
-                        <a:t>✨ Brand-new animated right-click menu for your pet: mood &amp; stat bars, quick-action tiles (Friends, Shop, Snack, Pat, Focus, Stats, Sleep, Taskbar), hover effects and smooth fly-out submenus; Pick colours from swatches, switch size with one click and flip Sounds / Dark mode with toggle switches - changes show instantly; Updates are highlighted: a glowing banner and NEW badge appear in the menu when a new version is ready; The focus card's right-click menu got the same new look; keyboard arrows, Enter and Esc work too</a:t>
+                        <a:t>🤖 6 friendly chat bots in the Chat tab: Pip Helper (app questions), Coach Focus (focus tips from your real stats), Sunny (live weather for any city), Arena Master (battle tips + quick battle), Giggles (jokes &amp; games) and Guardian (safety &amp; reporting help); Private bot chats with suggestion chips, typing indicator and a clear button - your bot chats stay on your PC; Mention a bot in a group chat (e.g. @weather Batam) and it answers in the room for everyone; Bots reply in your app language; up to 120 bot messages per day</a:t>
                       </a:r>
                     </a:p>
                   </a:txBody>
@@ -9225,7 +9458,7 @@
                           </a:solidFill>
                           <a:latin typeface="Segoe UI"/>
                         </a:rPr>
-                        <a:t>2.10.0</a:t>
+                        <a:t>2.9.0</a:t>
                       </a:r>
                     </a:p>
                   </a:txBody>
@@ -9269,7 +9502,7 @@
                           </a:solidFill>
                           <a:latin typeface="Segoe UI"/>
                         </a:rPr>
-                        <a:t>Chat bots</a:t>
+                        <a:t>Location &amp; live weather</a:t>
                       </a:r>
                     </a:p>
                     <a:p>
@@ -9280,7 +9513,7 @@
                           </a:solidFill>
                           <a:latin typeface="Segoe UI"/>
                         </a:rPr>
-                        <a:t>🤖 6 friendly chat bots in the Chat tab: Pip Helper (app questions), Coach Focus (focus tips from your real stats), Sunny (live weather for any city), Arena Master (battle tips + quick battle), Giggles (jokes &amp; games) and Guardian (safety &amp; reporting help); Private bot chats with suggestion chips, typing indicator and a clear button - your bot chats stay on your PC; Mention a bot in a group chat (e.g. @weather Batam) and it answers in the room for everyone; Bots reply in your app language; up to 120 bot messages per day</a:t>
+                        <a:t>📍 Add your city in Profile → Location &amp; weather (auto-detect or search) - only your city and country are shown, never your exact position; Live weather banners on every profile with animations: rain, drizzle, thunderstorms with lightning, snow, fog, clouds, sunshine or a starry night - plus temperature, feels-like, humidity, wind and local time; Your own weather strip on top of the hub, and each friend's weather + local time in the friends list; Hide your location from others or remove it any time</a:t>
                       </a:r>
                     </a:p>
                   </a:txBody>
@@ -9304,7 +9537,7 @@
                           </a:solidFill>
                           <a:latin typeface="Segoe UI"/>
                         </a:rPr>
-                        <a:t>2.9.0</a:t>
+                        <a:t>2.8.0</a:t>
                       </a:r>
                     </a:p>
                   </a:txBody>
@@ -9348,7 +9581,7 @@
                           </a:solidFill>
                           <a:latin typeface="Segoe UI"/>
                         </a:rPr>
-                        <a:t>Location &amp; live weather</a:t>
+                        <a:t>Pips Arena - duels, gear &amp; live battles</a:t>
                       </a:r>
                     </a:p>
                     <a:p>
@@ -9359,7 +9592,7 @@
                           </a:solidFill>
                           <a:latin typeface="Segoe UI"/>
                         </a:rPr>
-                        <a:t>📍 Add your city in Profile → Location &amp; weather (auto-detect or search) - only your city and country are shown, never your exact position; Live weather banners on every profile with animations: rain, drizzle, thunderstorms with lightning, snow, fog, clouds, sunshine or a starry night - plus temperature, feels-like, humidity, wind and local time; Your own weather strip on top of the hub, and each friend's weather + local time in the friends list; Hide your location from others or remove it any time</a:t>
+                        <a:t>⚔ New Arena tab: challenge friends or anyone in the arena to a live duel - each round pick Attack, Guard or Special within 12 seconds and watch your pets fight; ⚡ Quick battle: an instant auto-fight against anyone's fighter, even when they're offline; Arena gear in the Shop: 7 weapons (water pistol to rocket launcher), 5 armors and 5 gadgets that decide your special move - better gear and a higher level make a stronger fighter; Live duels can be watched by everyone, plus recent battle replays, top fighters, rating and win/loss records; wins earn coins</a:t>
                       </a:r>
                     </a:p>
                   </a:txBody>
@@ -9383,7 +9616,7 @@
                           </a:solidFill>
                           <a:latin typeface="Segoe UI"/>
                         </a:rPr>
-                        <a:t>2.8.0</a:t>
+                        <a:t>2.7.0</a:t>
                       </a:r>
                     </a:p>
                   </a:txBody>
@@ -9427,7 +9660,7 @@
                           </a:solidFill>
                           <a:latin typeface="Segoe UI"/>
                         </a:rPr>
-                        <a:t>Pips Arena - duels, gear &amp; live battles</a:t>
+                        <a:t>Moderators &amp; Premium</a:t>
                       </a:r>
                     </a:p>
                     <a:p>
@@ -9438,7 +9671,7 @@
                           </a:solidFill>
                           <a:latin typeface="Segoe UI"/>
                         </a:rPr>
-                        <a:t>⚔ New Arena tab: challenge friends or anyone in the arena to a live duel - each round pick Attack, Guard or Special within 12 seconds and watch your pets fight; ⚡ Quick battle: an instant auto-fight against anyone's fighter, even when they're offline; Arena gear in the Shop: 7 weapons (water pistol to rocket launcher), 5 armors and 5 gadgets that decide your special move - better gear and a higher level make a stronger fighter; Live duels can be watched by everyone, plus recent battle replays, top fighters, rating and win/loss records; wins earn coins</a:t>
+                        <a:t>★ Premium: a purple Premium badge, 4 exclusive props (tiara, star glasses, diamond necklace, fairy wings), the Fireworks move, +30 coins every day, double friend-interaction coins and room for 300 friends / 30 groups; Get Premium: Profile tab → Premium → "Ask to buy" emails the owner; after payment you receive a key (PIPS-XXXX-XXXX) to redeem right there; 🛡 Moderators: a blue Mod badge and a Mod tab with the report queue - warn, mute (1h / 24h / 7 days), clear a profile or reset a name; every action is logged; Report button on everyone's profile, so moderators can keep Pips friendly</a:t>
                       </a:r>
                     </a:p>
                   </a:txBody>
@@ -9462,7 +9695,7 @@
                           </a:solidFill>
                           <a:latin typeface="Segoe UI"/>
                         </a:rPr>
-                        <a:t>2.7.0</a:t>
+                        <a:t>2.6.1</a:t>
                       </a:r>
                     </a:p>
                   </a:txBody>
@@ -9506,7 +9739,7 @@
                           </a:solidFill>
                           <a:latin typeface="Segoe UI"/>
                         </a:rPr>
-                        <a:t>Moderators &amp; Premium</a:t>
+                        <a:t>Owner badge &amp; credits</a:t>
                       </a:r>
                     </a:p>
                     <a:p>
@@ -9517,7 +9750,7 @@
                           </a:solidFill>
                           <a:latin typeface="Segoe UI"/>
                         </a:rPr>
-                        <a:t>★ Premium: a purple Premium badge, 4 exclusive props (tiara, star glasses, diamond necklace, fairy wings), the Fireworks move, +30 coins every day, double friend-interaction coins and room for 300 friends / 30 groups; Get Premium: Profile tab → Premium → "Ask to buy" emails the owner; after payment you receive a key (PIPS-XXXX-XXXX) to redeem right there; 🛡 Moderators: a blue Mod badge and a Mod tab with the report queue - warn, mute (1h / 24h / 7 days), clear a profile or reset a name; every action is logged; Report button on everyone's profile, so moderators can keep Pips friendly</a:t>
+                        <a:t>The creator of Pips (Juwen Lie) now shows a gold ♛ Owner badge on his profile, friend list and ranks; New About Pips card in the Profile tab: credits and how to contact the owner (Juwen_Lie@pegatroncorp.com) with Email and Copy buttons; Right-click the pet → Help → About now shows who made Pips and the contact email</a:t>
                       </a:r>
                     </a:p>
                   </a:txBody>
@@ -9541,7 +9774,7 @@
                           </a:solidFill>
                           <a:latin typeface="Segoe UI"/>
                         </a:rPr>
-                        <a:t>2.6.1</a:t>
+                        <a:t>2.6.0</a:t>
                       </a:r>
                     </a:p>
                   </a:txBody>
@@ -9585,7 +9818,7 @@
                           </a:solidFill>
                           <a:latin typeface="Segoe UI"/>
                         </a:rPr>
-                        <a:t>Owner badge &amp; credits</a:t>
+                        <a:t>Profiles, ranks, online status &amp; dark mode</a:t>
                       </a:r>
                     </a:p>
                     <a:p>
@@ -9596,7 +9829,7 @@
                           </a:solidFill>
                           <a:latin typeface="Segoe UI"/>
                         </a:rPr>
-                        <a:t>The creator of Pips (Juwen Lie) now shows a gold ♛ Owner badge on his profile, friend list and ranks; New About Pips card in the Profile tab: credits and how to contact the owner (Juwen_Lie@pegatroncorp.com) with Email and Copy buttons; Right-click the pet → Help → About now shows who made Pips and the contact email</a:t>
+                        <a:t>Profile tab: profile picture (or your pet), about me, job, location, hobbies, birthday and a status message; Public or private: public profiles can be added directly and viewed in full; private profiles need a friend request that they accept, and strangers only see name, photo, pet, level and status; Click anyone to open their profile - badges, info, their friends - and add them, chat or wave from there; Ranks tab replaces Teams: everyone using Pips, sorted by XP, badges or streak</a:t>
                       </a:r>
                     </a:p>
                   </a:txBody>
@@ -9620,7 +9853,7 @@
                           </a:solidFill>
                           <a:latin typeface="Segoe UI"/>
                         </a:rPr>
-                        <a:t>2.6.0</a:t>
+                        <a:t>2.5.1</a:t>
                       </a:r>
                     </a:p>
                   </a:txBody>
@@ -9664,7 +9897,7 @@
                           </a:solidFill>
                           <a:latin typeface="Segoe UI"/>
                         </a:rPr>
-                        <a:t>Profiles, ranks, online status &amp; dark mode</a:t>
+                        <a:t>New cute Pips logo</a:t>
                       </a:r>
                     </a:p>
                     <a:p>
@@ -9675,7 +9908,7 @@
                           </a:solidFill>
                           <a:latin typeface="Segoe UI"/>
                         </a:rPr>
-                        <a:t>Profile tab: profile picture (or your pet), about me, job, location, hobbies, birthday and a status message; Public or private: public profiles can be added directly and viewed in full; private profiles need a friend request that they accept, and strangers only see name, photo, pet, level and status; Click anyone to open their profile - badges, info, their friends - and add them, chat or wave from there; Ranks tab replaces Teams: everyone using Pips, sorted by XP, badges or streak</a:t>
+                        <a:t>New Pips logo: Pip the cat on a Pips-red tile, matching the app colours (desktop shortcut, windows and website)</a:t>
                       </a:r>
                     </a:p>
                   </a:txBody>
@@ -9699,7 +9932,7 @@
                           </a:solidFill>
                           <a:latin typeface="Segoe UI"/>
                         </a:rPr>
-                        <a:t>2.5.1</a:t>
+                        <a:t>2.5.0</a:t>
                       </a:r>
                     </a:p>
                   </a:txBody>
@@ -9743,7 +9976,7 @@
                           </a:solidFill>
                           <a:latin typeface="Segoe UI"/>
                         </a:rPr>
-                        <a:t>New cute Pips logo</a:t>
+                        <a:t>Shop, coins, props &amp; moves</a:t>
                       </a:r>
                     </a:p>
                     <a:p>
@@ -9754,7 +9987,7 @@
                           </a:solidFill>
                           <a:latin typeface="Segoe UI"/>
                         </a:rPr>
-                        <a:t>New Pips logo: Pip the cat on a Pips-red tile, matching the app colours (desktop shortcut, windows and website)</a:t>
+                        <a:t>Shop: earn coins and spend them on your pet - 17 props (crown, wizard hat, headphones, shades, scarf, cape, angel wings...) and 6 moves: spin, dance, moonwalk, backflip, kung fu and spider swing!; Coins come from leveling up (+40), badges (+25), opening Pips each day (+10), friendships (+15 per affinity level), waving / chatting / visiting friends (+2) and pomodoros (+5). Everyone starts with a 100-coin gift; Your friends see your props: on avatars in the hub and when your pet visits their desktop - it shows off one of your moves; Pips is now a social pet: clicking the pet opens the Pips hub (friends, chat, groups, shop, badges)</a:t>
                       </a:r>
                     </a:p>
                   </a:txBody>
@@ -9778,7 +10011,7 @@
                           </a:solidFill>
                           <a:latin typeface="Segoe UI"/>
                         </a:rPr>
-                        <a:t>2.5.0</a:t>
+                        <a:t>2.4.0</a:t>
                       </a:r>
                     </a:p>
                   </a:txBody>
@@ -9822,7 +10055,7 @@
                           </a:solidFill>
                           <a:latin typeface="Segoe UI"/>
                         </a:rPr>
-                        <a:t>Shop, coins, props &amp; moves</a:t>
+                        <a:t>Chat, groups, affinity &amp; pet visits</a:t>
                       </a:r>
                     </a:p>
                     <a:p>
@@ -9833,7 +10066,7 @@
                           </a:solidFill>
                           <a:latin typeface="Segoe UI"/>
                         </a:rPr>
-                        <a:t>Shop: earn coins and spend them on your pet - 17 props (crown, wizard hat, headphones, shades, scarf, cape, angel wings...) and 6 moves: spin, dance, moonwalk, backflip, kung fu and spider swing!; Coins come from leveling up (+40), badges (+25), opening Pips each day (+10), friendships (+15 per affinity level), waving / chatting / visiting friends (+2) and pomodoros (+5). Everyone starts with a 100-coin gift; Your friends see your props: on avatars in the hub and when your pet visits their desktop - it shows off one of your moves; Pips is now a social pet: clicking the pet opens the Pips hub (friends, chat, groups, shop, badges)</a:t>
+                        <a:t>Chat: message your friends, and chat inside groups. Your pet pops up new messages as a bubble - click it to reply; Pet interactions: wave, pet their pet, send a snack, high five - or send your pet to visit: it walks onto your friend's desktop for a little while!; Affinity: every chat and interaction grows your friendship - Acquaintance → Buddy → Good friends → Close friends → Best friends → Soulmates; Your own groups: create a private group, invite your friends, they accept or decline. Group board + group chat; the owner can remove members</a:t>
                       </a:r>
                     </a:p>
                   </a:txBody>
@@ -9857,7 +10090,7 @@
                           </a:solidFill>
                           <a:latin typeface="Segoe UI"/>
                         </a:rPr>
-                        <a:t>2.4.0</a:t>
+                        <a:t>2.3.0</a:t>
                       </a:r>
                     </a:p>
                   </a:txBody>
@@ -9901,7 +10134,7 @@
                           </a:solidFill>
                           <a:latin typeface="Segoe UI"/>
                         </a:rPr>
-                        <a:t>Chat, groups, affinity &amp; pet visits</a:t>
+                        <a:t>Friends, levels &amp; achievements</a:t>
                       </a:r>
                     </a:p>
                     <a:p>
@@ -9912,7 +10145,7 @@
                           </a:solidFill>
                           <a:latin typeface="Segoe UI"/>
                         </a:rPr>
-                        <a:t>Chat: message your friends, and chat inside groups. Your pet pops up new messages as a bubble - click it to reply; Pet interactions: wave, pet their pet, send a snack, high five - or send your pet to visit: it walks onto your friend's desktop for a little while!; Affinity: every chat and interaction grows your friendship - Acquaintance → Buddy → Good friends → Close friends → Best friends → Soulmates; Your own groups: create a private group, invite your friends, they accept or decline. Group board + group chat; the owner can remove members</a:t>
+                        <a:t>Levels &amp; XP: every finished pomodoro earns XP and your level grows - plus 20 achievements to unlock (first tomato, 8 in a day, 7-day streak, early bird, night owl, pet lover...). Your pet celebrates each one; Friends (optional, off by default): get a 6-letter friend code, add colleagues, see today's board and join a team board like PTB. Your pet tells you when a friend finishes a pomodoro; Privacy: only your name, pet, level, streak and pomodoro counts are shared - never apps, window titles or scores. One click turns it off and deletes your online data. Right-click the pet → Friends &amp; achievements…</a:t>
                       </a:r>
                     </a:p>
                   </a:txBody>
@@ -9936,7 +10169,7 @@
                           </a:solidFill>
                           <a:latin typeface="Segoe UI"/>
                         </a:rPr>
-                        <a:t>2.3.0</a:t>
+                        <a:t>2.2.0</a:t>
                       </a:r>
                     </a:p>
                   </a:txBody>
@@ -9980,7 +10213,7 @@
                           </a:solidFill>
                           <a:latin typeface="Segoe UI"/>
                         </a:rPr>
-                        <a:t>Friends, levels &amp; achievements</a:t>
+                        <a:t>Pet sounds</a:t>
                       </a:r>
                     </a:p>
                     <a:p>
@@ -9991,7 +10224,7 @@
                           </a:solidFill>
                           <a:latin typeface="Segoe UI"/>
                         </a:rPr>
-                        <a:t>Levels &amp; XP: every finished pomodoro earns XP and your level grows - plus 20 achievements to unlock (first tomato, 8 in a day, 7-day streak, early bird, night owl, pet lover...). Your pet celebrates each one; Friends (optional, off by default): get a 6-letter friend code, add colleagues, see today's board and join a team board like PTB. Your pet tells you when a friend finishes a pomodoro; Privacy: only your name, pet, level, streak and pomodoro counts are shared - never apps, window titles or scores. One click turns it off and deletes your online data. Right-click the pet → Friends &amp; achievements…</a:t>
+                        <a:t>Your pet has a voice! Each of the 23 animals has its own sound (meow, woof, ribbit, hoot, buzz, oink, whale song...) and it changes with its mood: happy chirps, sad whimpers, sleepy yawns, hungry calls, grumpy huffs and soft snores; It also reacts with sound when you tickle, pet, feed, shake or wake it; Settings: right-click the pet → Sounds to switch on/off; Pet status &amp; settings has a volume slider, a ▶ Hear me button and "Stay quiet while I'm focusing" (on by default)</a:t>
                       </a:r>
                     </a:p>
                   </a:txBody>
@@ -10015,7 +10248,7 @@
                           </a:solidFill>
                           <a:latin typeface="Segoe UI"/>
                         </a:rPr>
-                        <a:t>2.2.0</a:t>
+                        <a:t>2.1.2</a:t>
                       </a:r>
                     </a:p>
                   </a:txBody>
@@ -10059,7 +10292,7 @@
                           </a:solidFill>
                           <a:latin typeface="Segoe UI"/>
                         </a:rPr>
-                        <a:t>Pet sounds</a:t>
+                        <a:t>Tickle-only mode</a:t>
                       </a:r>
                     </a:p>
                     <a:p>
@@ -10070,7 +10303,7 @@
                           </a:solidFill>
                           <a:latin typeface="Segoe UI"/>
                         </a:rPr>
-                        <a:t>Your pet has a voice! Each of the 23 animals has its own sound (meow, woof, ribbit, hoot, buzz, oink, whale song...) and it changes with its mood: happy chirps, sad whimpers, sleepy yawns, hungry calls, grumpy huffs and soft snores; It also reacts with sound when you tickle, pet, feed, shake or wake it; Settings: right-click the pet → Sounds to switch on/off; Pet status &amp; settings has a volume slider, a ▶ Hear me button and "Stay quiet while I'm focusing" (on by default)</a:t>
+                        <a:t>New click option "Only tickle (never open Pips)": click and tickle your pet as much as you like - the Pomodoro window stays closed (open it from the right-click menu). Right-click the pet → When I click</a:t>
                       </a:r>
                     </a:p>
                   </a:txBody>
@@ -10094,7 +10327,7 @@
                           </a:solidFill>
                           <a:latin typeface="Segoe UI"/>
                         </a:rPr>
-                        <a:t>2.1.2</a:t>
+                        <a:t>2.1.1</a:t>
                       </a:r>
                     </a:p>
                   </a:txBody>
@@ -10138,7 +10371,7 @@
                           </a:solidFill>
                           <a:latin typeface="Segoe UI"/>
                         </a:rPr>
-                        <a:t>Tickle-only mode</a:t>
+                        <a:t>Owner info</a:t>
                       </a:r>
                     </a:p>
                     <a:p>
@@ -10149,7 +10382,7 @@
                           </a:solidFill>
                           <a:latin typeface="Segoe UI"/>
                         </a:rPr>
-                        <a:t>New click option "Only tickle (never open Pips)": click and tickle your pet as much as you like - the Pomodoro window stays closed (open it from the right-click menu). Right-click the pet → When I click</a:t>
+                        <a:t>About Pips now shows the owner: Juwen Lie (right-click the pet → Help → About)</a:t>
                       </a:r>
                     </a:p>
                   </a:txBody>
@@ -10173,7 +10406,7 @@
                           </a:solidFill>
                           <a:latin typeface="Segoe UI"/>
                         </a:rPr>
-                        <a:t>2.1.1</a:t>
+                        <a:t>2.1.0</a:t>
                       </a:r>
                     </a:p>
                   </a:txBody>
@@ -10217,7 +10450,7 @@
                           </a:solidFill>
                           <a:latin typeface="Segoe UI"/>
                         </a:rPr>
-                        <a:t>Owner info</a:t>
+                        <a:t>Interactive guide &amp; in-app updates</a:t>
                       </a:r>
                     </a:p>
                     <a:p>
@@ -10228,7 +10461,7 @@
                           </a:solidFill>
                           <a:latin typeface="Segoe UI"/>
                         </a:rPr>
-                        <a:t>About Pips now shows the owner: Juwen Lie (right-click the pet → Help → About)</a:t>
+                        <a:t>Interactive first-run guide: your pet walks you through clicking, dragging, petting and the right-click menu; In-app updates: Pips tells you when a new version is out - update with one click (your settings and data are kept); New Help menu: replay the guide, check for updates, see the version; Option to turn automatic update checks off</a:t>
                       </a:r>
                     </a:p>
                   </a:txBody>
@@ -10252,7 +10485,7 @@
                           </a:solidFill>
                           <a:latin typeface="Segoe UI"/>
                         </a:rPr>
-                        <a:t>2.1.0</a:t>
+                        <a:t>2.0.0</a:t>
                       </a:r>
                     </a:p>
                   </a:txBody>
@@ -10296,7 +10529,7 @@
                           </a:solidFill>
                           <a:latin typeface="Segoe UI"/>
                         </a:rPr>
-                        <a:t>Interactive guide &amp; in-app updates</a:t>
+                        <a:t>Desktop pet, 23 animals &amp; 4 languages</a:t>
                       </a:r>
                     </a:p>
                     <a:p>
@@ -10307,7 +10540,7 @@
                           </a:solidFill>
                           <a:latin typeface="Segoe UI"/>
                         </a:rPr>
-                        <a:t>Interactive first-run guide: your pet walks you through clicking, dragging, petting and the right-click menu; In-app updates: Pips tells you when a new version is out - update with one click (your settings and data are kept); New Help menu: replay the guide, check for updates, see the version; Option to turn automatic update checks off</a:t>
+                        <a:t>Desktop pet that lives on your desktop and taskbar - drag it, tickle it, pet it; 23 animals in 3 groups: Land walks, Water swims with bubbles, Sky hovers and flaps; Moods (happy, sad, tired, hungry, grumpy...), naps when you're away, wakes up when you're back; Cute chat-bubble reminders: breaks, water, 20-20-20 eye rest, pomodoro done, daily goal</a:t>
                       </a:r>
                     </a:p>
                   </a:txBody>
@@ -10331,7 +10564,7 @@
                           </a:solidFill>
                           <a:latin typeface="Segoe UI"/>
                         </a:rPr>
-                        <a:t>2.0.0</a:t>
+                        <a:t>1.5.0</a:t>
                       </a:r>
                     </a:p>
                   </a:txBody>
@@ -10353,92 +10586,13 @@
                           </a:solidFill>
                           <a:latin typeface="Segoe UI"/>
                         </a:rPr>
-                        <a:t>2026-10-28</a:t>
+                        <a:t>2026-10-24</a:t>
                       </a:r>
                     </a:p>
                   </a:txBody>
                   <a:tcPr marL="73152" marR="73152" marT="36576" marB="36576">
                     <a:solidFill>
                       <a:srgbClr val="FFFDF8"/>
-                    </a:solidFill>
-                  </a:tcPr>
-                </a:tc>
-                <a:tc>
-                  <a:txBody>
-                    <a:bodyPr wrap="square"/>
-                    <a:lstStyle/>
-                    <a:p>
-                      <a:r>
-                        <a:rPr sz="1200" b="0">
-                          <a:solidFill>
-                            <a:srgbClr val="2B2A28"/>
-                          </a:solidFill>
-                          <a:latin typeface="Segoe UI"/>
-                        </a:rPr>
-                        <a:t>Desktop pet, 23 animals &amp; 4 languages</a:t>
-                      </a:r>
-                    </a:p>
-                    <a:p>
-                      <a:r>
-                        <a:rPr sz="1200" b="0">
-                          <a:solidFill>
-                            <a:srgbClr val="2B2A28"/>
-                          </a:solidFill>
-                          <a:latin typeface="Segoe UI"/>
-                        </a:rPr>
-                        <a:t>Desktop pet that lives on your desktop and taskbar - drag it, tickle it, pet it; 23 animals in 3 groups: Land walks, Water swims with bubbles, Sky hovers and flaps; Moods (happy, sad, tired, hungry, grumpy...), naps when you're away, wakes up when you're back; Cute chat-bubble reminders: breaks, water, 20-20-20 eye rest, pomodoro done, daily goal</a:t>
-                      </a:r>
-                    </a:p>
-                  </a:txBody>
-                  <a:tcPr marL="73152" marR="73152" marT="36576" marB="36576">
-                    <a:solidFill>
-                      <a:srgbClr val="FFFDF8"/>
-                    </a:solidFill>
-                  </a:tcPr>
-                </a:tc>
-              </a:tr>
-              <a:tr h="822960">
-                <a:tc>
-                  <a:txBody>
-                    <a:bodyPr wrap="square"/>
-                    <a:lstStyle/>
-                    <a:p>
-                      <a:r>
-                        <a:rPr sz="1200" b="1">
-                          <a:solidFill>
-                            <a:srgbClr val="2B2A28"/>
-                          </a:solidFill>
-                          <a:latin typeface="Segoe UI"/>
-                        </a:rPr>
-                        <a:t>1.5.0</a:t>
-                      </a:r>
-                    </a:p>
-                  </a:txBody>
-                  <a:tcPr marL="73152" marR="73152" marT="36576" marB="36576">
-                    <a:solidFill>
-                      <a:srgbClr val="F7F4EC"/>
-                    </a:solidFill>
-                  </a:tcPr>
-                </a:tc>
-                <a:tc>
-                  <a:txBody>
-                    <a:bodyPr wrap="square"/>
-                    <a:lstStyle/>
-                    <a:p>
-                      <a:r>
-                        <a:rPr sz="1200" b="0">
-                          <a:solidFill>
-                            <a:srgbClr val="2B2A28"/>
-                          </a:solidFill>
-                          <a:latin typeface="Segoe UI"/>
-                        </a:rPr>
-                        <a:t>2026-10-24</a:t>
-                      </a:r>
-                    </a:p>
-                  </a:txBody>
-                  <a:tcPr marL="73152" marR="73152" marT="36576" marB="36576">
-                    <a:solidFill>
-                      <a:srgbClr val="F7F4EC"/>
                     </a:solidFill>
                   </a:tcPr>
                 </a:tc>
@@ -10471,7 +10625,7 @@
                   </a:txBody>
                   <a:tcPr marL="73152" marR="73152" marT="36576" marB="36576">
                     <a:solidFill>
-                      <a:srgbClr val="F7F4EC"/>
+                      <a:srgbClr val="FFFDF8"/>
                     </a:solidFill>
                   </a:tcPr>
                 </a:tc>
@@ -10495,7 +10649,7 @@
                   </a:txBody>
                   <a:tcPr marL="73152" marR="73152" marT="36576" marB="36576">
                     <a:solidFill>
-                      <a:srgbClr val="FFFDF8"/>
+                      <a:srgbClr val="F7F4EC"/>
                     </a:solidFill>
                   </a:tcPr>
                 </a:tc>
@@ -10517,7 +10671,7 @@
                   </a:txBody>
                   <a:tcPr marL="73152" marR="73152" marT="36576" marB="36576">
                     <a:solidFill>
-                      <a:srgbClr val="FFFDF8"/>
+                      <a:srgbClr val="F7F4EC"/>
                     </a:solidFill>
                   </a:tcPr>
                 </a:tc>
@@ -10550,7 +10704,7 @@
                   </a:txBody>
                   <a:tcPr marL="73152" marR="73152" marT="36576" marB="36576">
                     <a:solidFill>
-                      <a:srgbClr val="FFFDF8"/>
+                      <a:srgbClr val="F7F4EC"/>
                     </a:solidFill>
                   </a:tcPr>
                 </a:tc>

</xml_diff>

<commit_message>
pips 2.14.1: One pet at a time
</commit_message>
<xml_diff>
--- a/apps/pips/web/download/Pips-Guide.pptx
+++ b/apps/pips/web/download/Pips-Guide.pptx
@@ -3292,7 +3292,7 @@
                 </a:solidFill>
                 <a:latin typeface="Segoe UI"/>
               </a:rPr>
-              <a:t>Version 2.14.0  ·  2026-10-29  ·  Made by Juwen Lie (owner)</a:t>
+              <a:t>Version 2.14.1  ·  2026-10-29  ·  Made by Juwen Lie (owner)</a:t>
             </a:r>
           </a:p>
           <a:p>
@@ -8166,7 +8166,7 @@
                 </a:solidFill>
                 <a:latin typeface="Segoe UI"/>
               </a:rPr>
-              <a:t>What's new in 2.14.0</a:t>
+              <a:t>What's new in 2.14.1</a:t>
             </a:r>
           </a:p>
         </p:txBody>
@@ -8279,7 +8279,7 @@
                 </a:solidFill>
                 <a:latin typeface="Segoe UI"/>
               </a:rPr>
-              <a:t>Pokes, tickles &amp; teases  ·  2026-10-29</a:t>
+              <a:t>One pet at a time  ·  2026-10-29</a:t>
             </a:r>
           </a:p>
         </p:txBody>
@@ -8327,7 +8327,7 @@
                 </a:solidFill>
                 <a:latin typeface="Segoe UI"/>
               </a:rPr>
-              <a:t>Poke, tickle, tease, boop or hug a friend from afar - no pet visit needed.</a:t>
+              <a:t>Opening Pips again (Desktop / Start Menu shortcut, autostart) no longer starts a second pet - your pet just pops up and says hi.</a:t>
             </a:r>
           </a:p>
           <a:p>
@@ -8352,82 +8352,7 @@
                 </a:solidFill>
                 <a:latin typeface="Segoe UI"/>
               </a:rPr>
-              <a:t>Right-click your pet → Poke a friend, or use the Poke button in Friends, chat and profiles.</a:t>
-            </a:r>
-          </a:p>
-          <a:p>
-            <a:pPr>
-              <a:spcAft>
-                <a:spcPts val="1000"/>
-              </a:spcAft>
-            </a:pPr>
-            <a:r>
-              <a:rPr sz="1700" b="1">
-                <a:solidFill>
-                  <a:srgbClr val="4CB86B"/>
-                </a:solidFill>
-                <a:latin typeface="Segoe UI"/>
-              </a:rPr>
-              <a:t>•  </a:t>
-            </a:r>
-            <a:r>
-              <a:rPr sz="1700">
-                <a:solidFill>
-                  <a:srgbClr val="2B2A28"/>
-                </a:solidFill>
-                <a:latin typeface="Segoe UI"/>
-              </a:rPr>
-              <a:t>Your friend gets a pop-up ("Wendy is teasing you!"), their pet reacts, and they can poke back with one click.</a:t>
-            </a:r>
-          </a:p>
-          <a:p>
-            <a:pPr>
-              <a:spcAft>
-                <a:spcPts val="1000"/>
-              </a:spcAft>
-            </a:pPr>
-            <a:r>
-              <a:rPr sz="1700" b="1">
-                <a:solidFill>
-                  <a:srgbClr val="4CB86B"/>
-                </a:solidFill>
-                <a:latin typeface="Segoe UI"/>
-              </a:rPr>
-              <a:t>•  </a:t>
-            </a:r>
-            <a:r>
-              <a:rPr sz="1700">
-                <a:solidFill>
-                  <a:srgbClr val="2B2A28"/>
-                </a:solidFill>
-                <a:latin typeface="Segoe UI"/>
-              </a:rPr>
-              <a:t>During a focus session pokes wait quietly until your break; when your pet is hidden they show in the screen corner.</a:t>
-            </a:r>
-          </a:p>
-          <a:p>
-            <a:pPr>
-              <a:spcAft>
-                <a:spcPts val="1000"/>
-              </a:spcAft>
-            </a:pPr>
-            <a:r>
-              <a:rPr sz="1700" b="1">
-                <a:solidFill>
-                  <a:srgbClr val="4CB86B"/>
-                </a:solidFill>
-                <a:latin typeface="Segoe UI"/>
-              </a:rPr>
-              <a:t>•  </a:t>
-            </a:r>
-            <a:r>
-              <a:rPr sz="1700">
-                <a:solidFill>
-                  <a:srgbClr val="2B2A28"/>
-                </a:solidFill>
-                <a:latin typeface="Segoe UI"/>
-              </a:rPr>
-              <a:t>Don't want it? Profile → untick "Let friends poke, tickle &amp; tease me".</a:t>
+              <a:t>Fixes lag caused by two copies of Pips running at once.</a:t>
             </a:r>
           </a:p>
         </p:txBody>
@@ -8558,7 +8483,7 @@
                 </a:solidFill>
                 <a:latin typeface="Segoe UI"/>
               </a:rPr>
-              <a:t>Colek, gelitik, goda, toel hidung atau peluk teman dari jauh - tanpa perlu pet berkunjung.</a:t>
+              <a:t>Membuka Pips lagi (pintasan Desktop / Start Menu, autostart) tidak lagi memunculkan pet kedua - pet-mu cukup muncul dan menyapa.</a:t>
             </a:r>
           </a:p>
           <a:p>
@@ -8583,82 +8508,7 @@
                 </a:solidFill>
                 <a:latin typeface="Segoe UI"/>
               </a:rPr>
-              <a:t>Klik kanan pet → Colek teman, atau pakai tombol Colek di Teman, chat dan profil.</a:t>
-            </a:r>
-          </a:p>
-          <a:p>
-            <a:pPr>
-              <a:spcAft>
-                <a:spcPts val="500"/>
-              </a:spcAft>
-            </a:pPr>
-            <a:r>
-              <a:rPr sz="1200" b="1">
-                <a:solidFill>
-                  <a:srgbClr val="4CB86B"/>
-                </a:solidFill>
-                <a:latin typeface="Segoe UI"/>
-              </a:rPr>
-              <a:t>•  </a:t>
-            </a:r>
-            <a:r>
-              <a:rPr sz="1200">
-                <a:solidFill>
-                  <a:srgbClr val="2B2A28"/>
-                </a:solidFill>
-                <a:latin typeface="Segoe UI"/>
-              </a:rPr>
-              <a:t>Temanmu mendapat notifikasi ("Wendy lagi godain kamu!"), pet-nya bereaksi, dan bisa colek balik dengan satu klik.</a:t>
-            </a:r>
-          </a:p>
-          <a:p>
-            <a:pPr>
-              <a:spcAft>
-                <a:spcPts val="500"/>
-              </a:spcAft>
-            </a:pPr>
-            <a:r>
-              <a:rPr sz="1200" b="1">
-                <a:solidFill>
-                  <a:srgbClr val="4CB86B"/>
-                </a:solidFill>
-                <a:latin typeface="Segoe UI"/>
-              </a:rPr>
-              <a:t>•  </a:t>
-            </a:r>
-            <a:r>
-              <a:rPr sz="1200">
-                <a:solidFill>
-                  <a:srgbClr val="2B2A28"/>
-                </a:solidFill>
-                <a:latin typeface="Segoe UI"/>
-              </a:rPr>
-              <a:t>Saat sesi fokus, colekan menunggu sampai istirahat; jika pet disembunyikan, muncul di pojok layar.</a:t>
-            </a:r>
-          </a:p>
-          <a:p>
-            <a:pPr>
-              <a:spcAft>
-                <a:spcPts val="500"/>
-              </a:spcAft>
-            </a:pPr>
-            <a:r>
-              <a:rPr sz="1200" b="1">
-                <a:solidFill>
-                  <a:srgbClr val="4CB86B"/>
-                </a:solidFill>
-                <a:latin typeface="Segoe UI"/>
-              </a:rPr>
-              <a:t>•  </a:t>
-            </a:r>
-            <a:r>
-              <a:rPr sz="1200">
-                <a:solidFill>
-                  <a:srgbClr val="2B2A28"/>
-                </a:solidFill>
-                <a:latin typeface="Segoe UI"/>
-              </a:rPr>
-              <a:t>Tidak mau? Profil → hapus centang "Izinkan teman mencolek, menggelitik &amp; menggoda saya".</a:t>
+              <a:t>Memperbaiki lag karena dua salinan Pips berjalan bersamaan.</a:t>
             </a:r>
           </a:p>
         </p:txBody>
@@ -8890,7 +8740,7 @@
         </p:nvGraphicFramePr>
         <p:xfrm>
           <a:off x="548640" y="1645920"/>
-          <a:ext cx="11155680" cy="18489168"/>
+          <a:ext cx="11155680" cy="19312128"/>
         </p:xfrm>
         <a:graphic>
           <a:graphicData uri="http://schemas.openxmlformats.org/drawingml/2006/table">
@@ -8984,7 +8834,7 @@
                           </a:solidFill>
                           <a:latin typeface="Segoe UI"/>
                         </a:rPr>
-                        <a:t>2.14.0</a:t>
+                        <a:t>2.14.1</a:t>
                       </a:r>
                     </a:p>
                   </a:txBody>
@@ -9028,7 +8878,7 @@
                           </a:solidFill>
                           <a:latin typeface="Segoe UI"/>
                         </a:rPr>
-                        <a:t>Pokes, tickles &amp; teases</a:t>
+                        <a:t>One pet at a time</a:t>
                       </a:r>
                     </a:p>
                     <a:p>
@@ -9039,7 +8889,7 @@
                           </a:solidFill>
                           <a:latin typeface="Segoe UI"/>
                         </a:rPr>
-                        <a:t>Poke, tickle, tease, boop or hug a friend from afar - no pet visit needed.; Right-click your pet → Poke a friend, or use the Poke button in Friends, chat and profiles.; Your friend gets a pop-up ("Wendy is teasing you!"), their pet reacts, and they can poke back with one click.; During a focus session pokes wait quietly until your break; when your pet is hidden they show in the screen corner.</a:t>
+                        <a:t>Opening Pips again (Desktop / Start Menu shortcut, autostart) no longer starts a second pet - your pet just pops up and says hi.; Fixes lag caused by two copies of Pips running at once.</a:t>
                       </a:r>
                     </a:p>
                   </a:txBody>
@@ -9063,7 +8913,165 @@
                           </a:solidFill>
                           <a:latin typeface="Segoe UI"/>
                         </a:rPr>
+                        <a:t>2.14.0</a:t>
+                      </a:r>
+                    </a:p>
+                  </a:txBody>
+                  <a:tcPr marL="73152" marR="73152" marT="36576" marB="36576">
+                    <a:solidFill>
+                      <a:srgbClr val="F7F4EC"/>
+                    </a:solidFill>
+                  </a:tcPr>
+                </a:tc>
+                <a:tc>
+                  <a:txBody>
+                    <a:bodyPr wrap="square"/>
+                    <a:lstStyle/>
+                    <a:p>
+                      <a:r>
+                        <a:rPr sz="1200" b="0">
+                          <a:solidFill>
+                            <a:srgbClr val="2B2A28"/>
+                          </a:solidFill>
+                          <a:latin typeface="Segoe UI"/>
+                        </a:rPr>
+                        <a:t>2026-10-29</a:t>
+                      </a:r>
+                    </a:p>
+                  </a:txBody>
+                  <a:tcPr marL="73152" marR="73152" marT="36576" marB="36576">
+                    <a:solidFill>
+                      <a:srgbClr val="F7F4EC"/>
+                    </a:solidFill>
+                  </a:tcPr>
+                </a:tc>
+                <a:tc>
+                  <a:txBody>
+                    <a:bodyPr wrap="square"/>
+                    <a:lstStyle/>
+                    <a:p>
+                      <a:r>
+                        <a:rPr sz="1200" b="0">
+                          <a:solidFill>
+                            <a:srgbClr val="2B2A28"/>
+                          </a:solidFill>
+                          <a:latin typeface="Segoe UI"/>
+                        </a:rPr>
+                        <a:t>Pokes, tickles &amp; teases</a:t>
+                      </a:r>
+                    </a:p>
+                    <a:p>
+                      <a:r>
+                        <a:rPr sz="1200" b="0">
+                          <a:solidFill>
+                            <a:srgbClr val="2B2A28"/>
+                          </a:solidFill>
+                          <a:latin typeface="Segoe UI"/>
+                        </a:rPr>
+                        <a:t>Poke, tickle, tease, boop or hug a friend from afar - no pet visit needed.; Right-click your pet → Poke a friend, or use the Poke button in Friends, chat and profiles.; Your friend gets a pop-up ("Wendy is teasing you!"), their pet reacts, and they can poke back with one click.; During a focus session pokes wait quietly until your break; when your pet is hidden they show in the screen corner.</a:t>
+                      </a:r>
+                    </a:p>
+                  </a:txBody>
+                  <a:tcPr marL="73152" marR="73152" marT="36576" marB="36576">
+                    <a:solidFill>
+                      <a:srgbClr val="F7F4EC"/>
+                    </a:solidFill>
+                  </a:tcPr>
+                </a:tc>
+              </a:tr>
+              <a:tr h="822960">
+                <a:tc>
+                  <a:txBody>
+                    <a:bodyPr wrap="square"/>
+                    <a:lstStyle/>
+                    <a:p>
+                      <a:r>
+                        <a:rPr sz="1200" b="1">
+                          <a:solidFill>
+                            <a:srgbClr val="2B2A28"/>
+                          </a:solidFill>
+                          <a:latin typeface="Segoe UI"/>
+                        </a:rPr>
                         <a:t>2.13.1</a:t>
+                      </a:r>
+                    </a:p>
+                  </a:txBody>
+                  <a:tcPr marL="73152" marR="73152" marT="36576" marB="36576">
+                    <a:solidFill>
+                      <a:srgbClr val="FFFDF8"/>
+                    </a:solidFill>
+                  </a:tcPr>
+                </a:tc>
+                <a:tc>
+                  <a:txBody>
+                    <a:bodyPr wrap="square"/>
+                    <a:lstStyle/>
+                    <a:p>
+                      <a:r>
+                        <a:rPr sz="1200" b="0">
+                          <a:solidFill>
+                            <a:srgbClr val="2B2A28"/>
+                          </a:solidFill>
+                          <a:latin typeface="Segoe UI"/>
+                        </a:rPr>
+                        <a:t>2026-10-28</a:t>
+                      </a:r>
+                    </a:p>
+                  </a:txBody>
+                  <a:tcPr marL="73152" marR="73152" marT="36576" marB="36576">
+                    <a:solidFill>
+                      <a:srgbClr val="FFFDF8"/>
+                    </a:solidFill>
+                  </a:tcPr>
+                </a:tc>
+                <a:tc>
+                  <a:txBody>
+                    <a:bodyPr wrap="square"/>
+                    <a:lstStyle/>
+                    <a:p>
+                      <a:r>
+                        <a:rPr sz="1200" b="0">
+                          <a:solidFill>
+                            <a:srgbClr val="2B2A28"/>
+                          </a:solidFill>
+                          <a:latin typeface="Segoe UI"/>
+                        </a:rPr>
+                        <a:t>One-click Windows installer</a:t>
+                      </a:r>
+                    </a:p>
+                    <a:p>
+                      <a:r>
+                        <a:rPr sz="1200" b="0">
+                          <a:solidFill>
+                            <a:srgbClr val="2B2A28"/>
+                          </a:solidFill>
+                          <a:latin typeface="Segoe UI"/>
+                        </a:rPr>
+                        <a:t>One Windows installer: no ZIP extraction, Python installation or command line. Download, open and click Install Pips.; Installs for your Windows account without administrator access, adds Desktop and Start Menu shortcuts, and opens Pips automatically.; Reinstalling in the same location keeps your settings and pet progress. Existing ZIP users can keep updating in place from Help → Check for updates.; A simpler download page and updated user guide; the bundled runtime stays separate from small in-app updates.</a:t>
+                      </a:r>
+                    </a:p>
+                  </a:txBody>
+                  <a:tcPr marL="73152" marR="73152" marT="36576" marB="36576">
+                    <a:solidFill>
+                      <a:srgbClr val="FFFDF8"/>
+                    </a:solidFill>
+                  </a:tcPr>
+                </a:tc>
+              </a:tr>
+              <a:tr h="822960">
+                <a:tc>
+                  <a:txBody>
+                    <a:bodyPr wrap="square"/>
+                    <a:lstStyle/>
+                    <a:p>
+                      <a:r>
+                        <a:rPr sz="1200" b="1">
+                          <a:solidFill>
+                            <a:srgbClr val="2B2A28"/>
+                          </a:solidFill>
+                          <a:latin typeface="Segoe UI"/>
+                        </a:rPr>
+                        <a:t>2.13.0</a:t>
                       </a:r>
                     </a:p>
                   </a:txBody>
@@ -9107,7 +9115,7 @@
                           </a:solidFill>
                           <a:latin typeface="Segoe UI"/>
                         </a:rPr>
-                        <a:t>One-click Windows installer</a:t>
+                        <a:t>Birthdays, parties &amp; gifts</a:t>
                       </a:r>
                     </a:p>
                     <a:p>
@@ -9118,7 +9126,7 @@
                           </a:solidFill>
                           <a:latin typeface="Segoe UI"/>
                         </a:rPr>
-                        <a:t>One Windows installer: no ZIP extraction, Python installation or command line. Download, open and click Install Pips.; Installs for your Windows account without administrator access, adds Desktop and Start Menu shortcuts, and opens Pips automatically.; Reinstalling in the same location keeps your settings and pet progress. Existing ZIP users can keep updating in place from Help → Check for updates.; A simpler download page and updated user guide; the bundled runtime stays separate from small in-app updates.</a:t>
+                        <a:t>Set your birthday in Social → Profile (month + day, optionally visible to friends).; On your birthday Pips throws confetti and gives you 100 bonus coins.; Friends tab shows upcoming birthdays; you get reminders 3 days, 1 day and on the day.; Birthday parties: join a friend's party, see who's there, sign the guestbook and celebrate together.</a:t>
                       </a:r>
                     </a:p>
                   </a:txBody>
@@ -9142,7 +9150,7 @@
                           </a:solidFill>
                           <a:latin typeface="Segoe UI"/>
                         </a:rPr>
-                        <a:t>2.13.0</a:t>
+                        <a:t>2.12.0</a:t>
                       </a:r>
                     </a:p>
                   </a:txBody>
@@ -9186,7 +9194,7 @@
                           </a:solidFill>
                           <a:latin typeface="Segoe UI"/>
                         </a:rPr>
-                        <a:t>Birthdays, parties &amp; gifts</a:t>
+                        <a:t>Mega update: 28 new animals, 31 shop items, 13 moves</a:t>
                       </a:r>
                     </a:p>
                     <a:p>
@@ -9197,7 +9205,7 @@
                           </a:solidFill>
                           <a:latin typeface="Segoe UI"/>
                         </a:rPr>
-                        <a:t>Set your birthday in Social → Profile (month + day, optionally visible to friends).; On your birthday Pips throws confetti and gives you 100 bonus coins.; Friends tab shows upcoming birthdays; you get reminders 3 days, 1 day and on the day.; Birthday parties: join a friend's party, see who's there, sign the guestbook and celebrate together.</a:t>
+                        <a:t>🦁 28 new animals (51 total): lion, tiger, unicorn, deer, sheep, cow, raccoon, red panda, monkey, hedgehog, dino, squirrel, mouse, koala, shark, dolphin, seal, otter, pufferfish, duck, crab, parrot, chick, ladybug, phoenix, pegasus, ghost and flamingo; 🎩 31 new shop items: top hat, cowboy, chef, pirate, Santa, viking, graduation cap, beret, bow, propeller cap, flower crown, nerd glasses, eyepatch, mustache, goggles, masquerade mask, tie, pearls, flower lei, gold chain, balloon, backpack, guitar, shield, butterfly / devil wings and more - plus Premium galaxy crown, galaxy cape and dragon wings; 💃 13 new moves: wave, jump, hearts, sing, yoga, zoomies, cartwheel, juggle, rain dance, breakdance, magic, confetti and the Premium rocket launch; The Shop is now split into sections (Hats, Face, Neck, Back, Moves, Arena gear) with an owned counter for each</a:t>
                       </a:r>
                     </a:p>
                   </a:txBody>
@@ -9221,7 +9229,7 @@
                           </a:solidFill>
                           <a:latin typeface="Segoe UI"/>
                         </a:rPr>
-                        <a:t>2.12.0</a:t>
+                        <a:t>2.11.0</a:t>
                       </a:r>
                     </a:p>
                   </a:txBody>
@@ -9265,7 +9273,7 @@
                           </a:solidFill>
                           <a:latin typeface="Segoe UI"/>
                         </a:rPr>
-                        <a:t>Mega update: 28 new animals, 31 shop items, 13 moves</a:t>
+                        <a:t>New right-click menus</a:t>
                       </a:r>
                     </a:p>
                     <a:p>
@@ -9276,7 +9284,7 @@
                           </a:solidFill>
                           <a:latin typeface="Segoe UI"/>
                         </a:rPr>
-                        <a:t>🦁 28 new animals (51 total): lion, tiger, unicorn, deer, sheep, cow, raccoon, red panda, monkey, hedgehog, dino, squirrel, mouse, koala, shark, dolphin, seal, otter, pufferfish, duck, crab, parrot, chick, ladybug, phoenix, pegasus, ghost and flamingo; 🎩 31 new shop items: top hat, cowboy, chef, pirate, Santa, viking, graduation cap, beret, bow, propeller cap, flower crown, nerd glasses, eyepatch, mustache, goggles, masquerade mask, tie, pearls, flower lei, gold chain, balloon, backpack, guitar, shield, butterfly / devil wings and more - plus Premium galaxy crown, galaxy cape and dragon wings; 💃 13 new moves: wave, jump, hearts, sing, yoga, zoomies, cartwheel, juggle, rain dance, breakdance, magic, confetti and the Premium rocket launch; The Shop is now split into sections (Hats, Face, Neck, Back, Moves, Arena gear) with an owned counter for each</a:t>
+                        <a:t>✨ Brand-new animated right-click menu for your pet: mood &amp; stat bars, quick-action tiles (Friends, Shop, Snack, Pat, Focus, Stats, Sleep, Taskbar), hover effects and smooth fly-out submenus; Pick colours from swatches, switch size with one click and flip Sounds / Dark mode with toggle switches - changes show instantly; Updates are highlighted: a glowing banner and NEW badge appear in the menu when a new version is ready; The focus card's right-click menu got the same new look; keyboard arrows, Enter and Esc work too</a:t>
                       </a:r>
                     </a:p>
                   </a:txBody>
@@ -9300,7 +9308,7 @@
                           </a:solidFill>
                           <a:latin typeface="Segoe UI"/>
                         </a:rPr>
-                        <a:t>2.11.0</a:t>
+                        <a:t>2.10.0</a:t>
                       </a:r>
                     </a:p>
                   </a:txBody>
@@ -9344,7 +9352,7 @@
                           </a:solidFill>
                           <a:latin typeface="Segoe UI"/>
                         </a:rPr>
-                        <a:t>New right-click menus</a:t>
+                        <a:t>Chat bots</a:t>
                       </a:r>
                     </a:p>
                     <a:p>
@@ -9355,7 +9363,7 @@
                           </a:solidFill>
                           <a:latin typeface="Segoe UI"/>
                         </a:rPr>
-                        <a:t>✨ Brand-new animated right-click menu for your pet: mood &amp; stat bars, quick-action tiles (Friends, Shop, Snack, Pat, Focus, Stats, Sleep, Taskbar), hover effects and smooth fly-out submenus; Pick colours from swatches, switch size with one click and flip Sounds / Dark mode with toggle switches - changes show instantly; Updates are highlighted: a glowing banner and NEW badge appear in the menu when a new version is ready; The focus card's right-click menu got the same new look; keyboard arrows, Enter and Esc work too</a:t>
+                        <a:t>🤖 6 friendly chat bots in the Chat tab: Pip Helper (app questions), Coach Focus (focus tips from your real stats), Sunny (live weather for any city), Arena Master (battle tips + quick battle), Giggles (jokes &amp; games) and Guardian (safety &amp; reporting help); Private bot chats with suggestion chips, typing indicator and a clear button - your bot chats stay on your PC; Mention a bot in a group chat (e.g. @weather Batam) and it answers in the room for everyone; Bots reply in your app language; up to 120 bot messages per day</a:t>
                       </a:r>
                     </a:p>
                   </a:txBody>
@@ -9379,7 +9387,7 @@
                           </a:solidFill>
                           <a:latin typeface="Segoe UI"/>
                         </a:rPr>
-                        <a:t>2.10.0</a:t>
+                        <a:t>2.9.0</a:t>
                       </a:r>
                     </a:p>
                   </a:txBody>
@@ -9423,7 +9431,7 @@
                           </a:solidFill>
                           <a:latin typeface="Segoe UI"/>
                         </a:rPr>
-                        <a:t>Chat bots</a:t>
+                        <a:t>Location &amp; live weather</a:t>
                       </a:r>
                     </a:p>
                     <a:p>
@@ -9434,7 +9442,7 @@
                           </a:solidFill>
                           <a:latin typeface="Segoe UI"/>
                         </a:rPr>
-                        <a:t>🤖 6 friendly chat bots in the Chat tab: Pip Helper (app questions), Coach Focus (focus tips from your real stats), Sunny (live weather for any city), Arena Master (battle tips + quick battle), Giggles (jokes &amp; games) and Guardian (safety &amp; reporting help); Private bot chats with suggestion chips, typing indicator and a clear button - your bot chats stay on your PC; Mention a bot in a group chat (e.g. @weather Batam) and it answers in the room for everyone; Bots reply in your app language; up to 120 bot messages per day</a:t>
+                        <a:t>📍 Add your city in Profile → Location &amp; weather (auto-detect or search) - only your city and country are shown, never your exact position; Live weather banners on every profile with animations: rain, drizzle, thunderstorms with lightning, snow, fog, clouds, sunshine or a starry night - plus temperature, feels-like, humidity, wind and local time; Your own weather strip on top of the hub, and each friend's weather + local time in the friends list; Hide your location from others or remove it any time</a:t>
                       </a:r>
                     </a:p>
                   </a:txBody>
@@ -9458,7 +9466,7 @@
                           </a:solidFill>
                           <a:latin typeface="Segoe UI"/>
                         </a:rPr>
-                        <a:t>2.9.0</a:t>
+                        <a:t>2.8.0</a:t>
                       </a:r>
                     </a:p>
                   </a:txBody>
@@ -9502,7 +9510,7 @@
                           </a:solidFill>
                           <a:latin typeface="Segoe UI"/>
                         </a:rPr>
-                        <a:t>Location &amp; live weather</a:t>
+                        <a:t>Pips Arena - duels, gear &amp; live battles</a:t>
                       </a:r>
                     </a:p>
                     <a:p>
@@ -9513,7 +9521,7 @@
                           </a:solidFill>
                           <a:latin typeface="Segoe UI"/>
                         </a:rPr>
-                        <a:t>📍 Add your city in Profile → Location &amp; weather (auto-detect or search) - only your city and country are shown, never your exact position; Live weather banners on every profile with animations: rain, drizzle, thunderstorms with lightning, snow, fog, clouds, sunshine or a starry night - plus temperature, feels-like, humidity, wind and local time; Your own weather strip on top of the hub, and each friend's weather + local time in the friends list; Hide your location from others or remove it any time</a:t>
+                        <a:t>⚔ New Arena tab: challenge friends or anyone in the arena to a live duel - each round pick Attack, Guard or Special within 12 seconds and watch your pets fight; ⚡ Quick battle: an instant auto-fight against anyone's fighter, even when they're offline; Arena gear in the Shop: 7 weapons (water pistol to rocket launcher), 5 armors and 5 gadgets that decide your special move - better gear and a higher level make a stronger fighter; Live duels can be watched by everyone, plus recent battle replays, top fighters, rating and win/loss records; wins earn coins</a:t>
                       </a:r>
                     </a:p>
                   </a:txBody>
@@ -9537,7 +9545,7 @@
                           </a:solidFill>
                           <a:latin typeface="Segoe UI"/>
                         </a:rPr>
-                        <a:t>2.8.0</a:t>
+                        <a:t>2.7.0</a:t>
                       </a:r>
                     </a:p>
                   </a:txBody>
@@ -9581,7 +9589,7 @@
                           </a:solidFill>
                           <a:latin typeface="Segoe UI"/>
                         </a:rPr>
-                        <a:t>Pips Arena - duels, gear &amp; live battles</a:t>
+                        <a:t>Moderators &amp; Premium</a:t>
                       </a:r>
                     </a:p>
                     <a:p>
@@ -9592,7 +9600,7 @@
                           </a:solidFill>
                           <a:latin typeface="Segoe UI"/>
                         </a:rPr>
-                        <a:t>⚔ New Arena tab: challenge friends or anyone in the arena to a live duel - each round pick Attack, Guard or Special within 12 seconds and watch your pets fight; ⚡ Quick battle: an instant auto-fight against anyone's fighter, even when they're offline; Arena gear in the Shop: 7 weapons (water pistol to rocket launcher), 5 armors and 5 gadgets that decide your special move - better gear and a higher level make a stronger fighter; Live duels can be watched by everyone, plus recent battle replays, top fighters, rating and win/loss records; wins earn coins</a:t>
+                        <a:t>★ Premium: a purple Premium badge, 4 exclusive props (tiara, star glasses, diamond necklace, fairy wings), the Fireworks move, +30 coins every day, double friend-interaction coins and room for 300 friends / 30 groups; Get Premium: Profile tab → Premium → "Ask to buy" emails the owner; after payment you receive a key (PIPS-XXXX-XXXX) to redeem right there; 🛡 Moderators: a blue Mod badge and a Mod tab with the report queue - warn, mute (1h / 24h / 7 days), clear a profile or reset a name; every action is logged; Report button on everyone's profile, so moderators can keep Pips friendly</a:t>
                       </a:r>
                     </a:p>
                   </a:txBody>
@@ -9616,7 +9624,7 @@
                           </a:solidFill>
                           <a:latin typeface="Segoe UI"/>
                         </a:rPr>
-                        <a:t>2.7.0</a:t>
+                        <a:t>2.6.1</a:t>
                       </a:r>
                     </a:p>
                   </a:txBody>
@@ -9660,7 +9668,7 @@
                           </a:solidFill>
                           <a:latin typeface="Segoe UI"/>
                         </a:rPr>
-                        <a:t>Moderators &amp; Premium</a:t>
+                        <a:t>Owner badge &amp; credits</a:t>
                       </a:r>
                     </a:p>
                     <a:p>
@@ -9671,7 +9679,7 @@
                           </a:solidFill>
                           <a:latin typeface="Segoe UI"/>
                         </a:rPr>
-                        <a:t>★ Premium: a purple Premium badge, 4 exclusive props (tiara, star glasses, diamond necklace, fairy wings), the Fireworks move, +30 coins every day, double friend-interaction coins and room for 300 friends / 30 groups; Get Premium: Profile tab → Premium → "Ask to buy" emails the owner; after payment you receive a key (PIPS-XXXX-XXXX) to redeem right there; 🛡 Moderators: a blue Mod badge and a Mod tab with the report queue - warn, mute (1h / 24h / 7 days), clear a profile or reset a name; every action is logged; Report button on everyone's profile, so moderators can keep Pips friendly</a:t>
+                        <a:t>The creator of Pips (Juwen Lie) now shows a gold ♛ Owner badge on his profile, friend list and ranks; New About Pips card in the Profile tab: credits and how to contact the owner (Juwen_Lie@pegatroncorp.com) with Email and Copy buttons; Right-click the pet → Help → About now shows who made Pips and the contact email</a:t>
                       </a:r>
                     </a:p>
                   </a:txBody>
@@ -9695,7 +9703,7 @@
                           </a:solidFill>
                           <a:latin typeface="Segoe UI"/>
                         </a:rPr>
-                        <a:t>2.6.1</a:t>
+                        <a:t>2.6.0</a:t>
                       </a:r>
                     </a:p>
                   </a:txBody>
@@ -9739,7 +9747,7 @@
                           </a:solidFill>
                           <a:latin typeface="Segoe UI"/>
                         </a:rPr>
-                        <a:t>Owner badge &amp; credits</a:t>
+                        <a:t>Profiles, ranks, online status &amp; dark mode</a:t>
                       </a:r>
                     </a:p>
                     <a:p>
@@ -9750,7 +9758,7 @@
                           </a:solidFill>
                           <a:latin typeface="Segoe UI"/>
                         </a:rPr>
-                        <a:t>The creator of Pips (Juwen Lie) now shows a gold ♛ Owner badge on his profile, friend list and ranks; New About Pips card in the Profile tab: credits and how to contact the owner (Juwen_Lie@pegatroncorp.com) with Email and Copy buttons; Right-click the pet → Help → About now shows who made Pips and the contact email</a:t>
+                        <a:t>Profile tab: profile picture (or your pet), about me, job, location, hobbies, birthday and a status message; Public or private: public profiles can be added directly and viewed in full; private profiles need a friend request that they accept, and strangers only see name, photo, pet, level and status; Click anyone to open their profile - badges, info, their friends - and add them, chat or wave from there; Ranks tab replaces Teams: everyone using Pips, sorted by XP, badges or streak</a:t>
                       </a:r>
                     </a:p>
                   </a:txBody>
@@ -9774,7 +9782,7 @@
                           </a:solidFill>
                           <a:latin typeface="Segoe UI"/>
                         </a:rPr>
-                        <a:t>2.6.0</a:t>
+                        <a:t>2.5.1</a:t>
                       </a:r>
                     </a:p>
                   </a:txBody>
@@ -9818,7 +9826,7 @@
                           </a:solidFill>
                           <a:latin typeface="Segoe UI"/>
                         </a:rPr>
-                        <a:t>Profiles, ranks, online status &amp; dark mode</a:t>
+                        <a:t>New cute Pips logo</a:t>
                       </a:r>
                     </a:p>
                     <a:p>
@@ -9829,7 +9837,7 @@
                           </a:solidFill>
                           <a:latin typeface="Segoe UI"/>
                         </a:rPr>
-                        <a:t>Profile tab: profile picture (or your pet), about me, job, location, hobbies, birthday and a status message; Public or private: public profiles can be added directly and viewed in full; private profiles need a friend request that they accept, and strangers only see name, photo, pet, level and status; Click anyone to open their profile - badges, info, their friends - and add them, chat or wave from there; Ranks tab replaces Teams: everyone using Pips, sorted by XP, badges or streak</a:t>
+                        <a:t>New Pips logo: Pip the cat on a Pips-red tile, matching the app colours (desktop shortcut, windows and website)</a:t>
                       </a:r>
                     </a:p>
                   </a:txBody>
@@ -9853,7 +9861,7 @@
                           </a:solidFill>
                           <a:latin typeface="Segoe UI"/>
                         </a:rPr>
-                        <a:t>2.5.1</a:t>
+                        <a:t>2.5.0</a:t>
                       </a:r>
                     </a:p>
                   </a:txBody>
@@ -9897,7 +9905,7 @@
                           </a:solidFill>
                           <a:latin typeface="Segoe UI"/>
                         </a:rPr>
-                        <a:t>New cute Pips logo</a:t>
+                        <a:t>Shop, coins, props &amp; moves</a:t>
                       </a:r>
                     </a:p>
                     <a:p>
@@ -9908,7 +9916,7 @@
                           </a:solidFill>
                           <a:latin typeface="Segoe UI"/>
                         </a:rPr>
-                        <a:t>New Pips logo: Pip the cat on a Pips-red tile, matching the app colours (desktop shortcut, windows and website)</a:t>
+                        <a:t>Shop: earn coins and spend them on your pet - 17 props (crown, wizard hat, headphones, shades, scarf, cape, angel wings...) and 6 moves: spin, dance, moonwalk, backflip, kung fu and spider swing!; Coins come from leveling up (+40), badges (+25), opening Pips each day (+10), friendships (+15 per affinity level), waving / chatting / visiting friends (+2) and pomodoros (+5). Everyone starts with a 100-coin gift; Your friends see your props: on avatars in the hub and when your pet visits their desktop - it shows off one of your moves; Pips is now a social pet: clicking the pet opens the Pips hub (friends, chat, groups, shop, badges)</a:t>
                       </a:r>
                     </a:p>
                   </a:txBody>
@@ -9932,7 +9940,7 @@
                           </a:solidFill>
                           <a:latin typeface="Segoe UI"/>
                         </a:rPr>
-                        <a:t>2.5.0</a:t>
+                        <a:t>2.4.0</a:t>
                       </a:r>
                     </a:p>
                   </a:txBody>
@@ -9976,7 +9984,7 @@
                           </a:solidFill>
                           <a:latin typeface="Segoe UI"/>
                         </a:rPr>
-                        <a:t>Shop, coins, props &amp; moves</a:t>
+                        <a:t>Chat, groups, affinity &amp; pet visits</a:t>
                       </a:r>
                     </a:p>
                     <a:p>
@@ -9987,7 +9995,7 @@
                           </a:solidFill>
                           <a:latin typeface="Segoe UI"/>
                         </a:rPr>
-                        <a:t>Shop: earn coins and spend them on your pet - 17 props (crown, wizard hat, headphones, shades, scarf, cape, angel wings...) and 6 moves: spin, dance, moonwalk, backflip, kung fu and spider swing!; Coins come from leveling up (+40), badges (+25), opening Pips each day (+10), friendships (+15 per affinity level), waving / chatting / visiting friends (+2) and pomodoros (+5). Everyone starts with a 100-coin gift; Your friends see your props: on avatars in the hub and when your pet visits their desktop - it shows off one of your moves; Pips is now a social pet: clicking the pet opens the Pips hub (friends, chat, groups, shop, badges)</a:t>
+                        <a:t>Chat: message your friends, and chat inside groups. Your pet pops up new messages as a bubble - click it to reply; Pet interactions: wave, pet their pet, send a snack, high five - or send your pet to visit: it walks onto your friend's desktop for a little while!; Affinity: every chat and interaction grows your friendship - Acquaintance → Buddy → Good friends → Close friends → Best friends → Soulmates; Your own groups: create a private group, invite your friends, they accept or decline. Group board + group chat; the owner can remove members</a:t>
                       </a:r>
                     </a:p>
                   </a:txBody>
@@ -10011,7 +10019,7 @@
                           </a:solidFill>
                           <a:latin typeface="Segoe UI"/>
                         </a:rPr>
-                        <a:t>2.4.0</a:t>
+                        <a:t>2.3.0</a:t>
                       </a:r>
                     </a:p>
                   </a:txBody>
@@ -10055,7 +10063,7 @@
                           </a:solidFill>
                           <a:latin typeface="Segoe UI"/>
                         </a:rPr>
-                        <a:t>Chat, groups, affinity &amp; pet visits</a:t>
+                        <a:t>Friends, levels &amp; achievements</a:t>
                       </a:r>
                     </a:p>
                     <a:p>
@@ -10066,7 +10074,7 @@
                           </a:solidFill>
                           <a:latin typeface="Segoe UI"/>
                         </a:rPr>
-                        <a:t>Chat: message your friends, and chat inside groups. Your pet pops up new messages as a bubble - click it to reply; Pet interactions: wave, pet their pet, send a snack, high five - or send your pet to visit: it walks onto your friend's desktop for a little while!; Affinity: every chat and interaction grows your friendship - Acquaintance → Buddy → Good friends → Close friends → Best friends → Soulmates; Your own groups: create a private group, invite your friends, they accept or decline. Group board + group chat; the owner can remove members</a:t>
+                        <a:t>Levels &amp; XP: every finished pomodoro earns XP and your level grows - plus 20 achievements to unlock (first tomato, 8 in a day, 7-day streak, early bird, night owl, pet lover...). Your pet celebrates each one; Friends (optional, off by default): get a 6-letter friend code, add colleagues, see today's board and join a team board like PTB. Your pet tells you when a friend finishes a pomodoro; Privacy: only your name, pet, level, streak and pomodoro counts are shared - never apps, window titles or scores. One click turns it off and deletes your online data. Right-click the pet → Friends &amp; achievements…</a:t>
                       </a:r>
                     </a:p>
                   </a:txBody>
@@ -10090,7 +10098,7 @@
                           </a:solidFill>
                           <a:latin typeface="Segoe UI"/>
                         </a:rPr>
-                        <a:t>2.3.0</a:t>
+                        <a:t>2.2.0</a:t>
                       </a:r>
                     </a:p>
                   </a:txBody>
@@ -10134,7 +10142,7 @@
                           </a:solidFill>
                           <a:latin typeface="Segoe UI"/>
                         </a:rPr>
-                        <a:t>Friends, levels &amp; achievements</a:t>
+                        <a:t>Pet sounds</a:t>
                       </a:r>
                     </a:p>
                     <a:p>
@@ -10145,7 +10153,7 @@
                           </a:solidFill>
                           <a:latin typeface="Segoe UI"/>
                         </a:rPr>
-                        <a:t>Levels &amp; XP: every finished pomodoro earns XP and your level grows - plus 20 achievements to unlock (first tomato, 8 in a day, 7-day streak, early bird, night owl, pet lover...). Your pet celebrates each one; Friends (optional, off by default): get a 6-letter friend code, add colleagues, see today's board and join a team board like PTB. Your pet tells you when a friend finishes a pomodoro; Privacy: only your name, pet, level, streak and pomodoro counts are shared - never apps, window titles or scores. One click turns it off and deletes your online data. Right-click the pet → Friends &amp; achievements…</a:t>
+                        <a:t>Your pet has a voice! Each of the 23 animals has its own sound (meow, woof, ribbit, hoot, buzz, oink, whale song...) and it changes with its mood: happy chirps, sad whimpers, sleepy yawns, hungry calls, grumpy huffs and soft snores; It also reacts with sound when you tickle, pet, feed, shake or wake it; Settings: right-click the pet → Sounds to switch on/off; Pet status &amp; settings has a volume slider, a ▶ Hear me button and "Stay quiet while I'm focusing" (on by default)</a:t>
                       </a:r>
                     </a:p>
                   </a:txBody>
@@ -10169,7 +10177,7 @@
                           </a:solidFill>
                           <a:latin typeface="Segoe UI"/>
                         </a:rPr>
-                        <a:t>2.2.0</a:t>
+                        <a:t>2.1.2</a:t>
                       </a:r>
                     </a:p>
                   </a:txBody>
@@ -10213,7 +10221,7 @@
                           </a:solidFill>
                           <a:latin typeface="Segoe UI"/>
                         </a:rPr>
-                        <a:t>Pet sounds</a:t>
+                        <a:t>Tickle-only mode</a:t>
                       </a:r>
                     </a:p>
                     <a:p>
@@ -10224,7 +10232,7 @@
                           </a:solidFill>
                           <a:latin typeface="Segoe UI"/>
                         </a:rPr>
-                        <a:t>Your pet has a voice! Each of the 23 animals has its own sound (meow, woof, ribbit, hoot, buzz, oink, whale song...) and it changes with its mood: happy chirps, sad whimpers, sleepy yawns, hungry calls, grumpy huffs and soft snores; It also reacts with sound when you tickle, pet, feed, shake or wake it; Settings: right-click the pet → Sounds to switch on/off; Pet status &amp; settings has a volume slider, a ▶ Hear me button and "Stay quiet while I'm focusing" (on by default)</a:t>
+                        <a:t>New click option "Only tickle (never open Pips)": click and tickle your pet as much as you like - the Pomodoro window stays closed (open it from the right-click menu). Right-click the pet → When I click</a:t>
                       </a:r>
                     </a:p>
                   </a:txBody>
@@ -10248,7 +10256,7 @@
                           </a:solidFill>
                           <a:latin typeface="Segoe UI"/>
                         </a:rPr>
-                        <a:t>2.1.2</a:t>
+                        <a:t>2.1.1</a:t>
                       </a:r>
                     </a:p>
                   </a:txBody>
@@ -10292,7 +10300,7 @@
                           </a:solidFill>
                           <a:latin typeface="Segoe UI"/>
                         </a:rPr>
-                        <a:t>Tickle-only mode</a:t>
+                        <a:t>Owner info</a:t>
                       </a:r>
                     </a:p>
                     <a:p>
@@ -10303,7 +10311,7 @@
                           </a:solidFill>
                           <a:latin typeface="Segoe UI"/>
                         </a:rPr>
-                        <a:t>New click option "Only tickle (never open Pips)": click and tickle your pet as much as you like - the Pomodoro window stays closed (open it from the right-click menu). Right-click the pet → When I click</a:t>
+                        <a:t>About Pips now shows the owner: Juwen Lie (right-click the pet → Help → About)</a:t>
                       </a:r>
                     </a:p>
                   </a:txBody>
@@ -10327,7 +10335,7 @@
                           </a:solidFill>
                           <a:latin typeface="Segoe UI"/>
                         </a:rPr>
-                        <a:t>2.1.1</a:t>
+                        <a:t>2.1.0</a:t>
                       </a:r>
                     </a:p>
                   </a:txBody>
@@ -10371,7 +10379,7 @@
                           </a:solidFill>
                           <a:latin typeface="Segoe UI"/>
                         </a:rPr>
-                        <a:t>Owner info</a:t>
+                        <a:t>Interactive guide &amp; in-app updates</a:t>
                       </a:r>
                     </a:p>
                     <a:p>
@@ -10382,7 +10390,7 @@
                           </a:solidFill>
                           <a:latin typeface="Segoe UI"/>
                         </a:rPr>
-                        <a:t>About Pips now shows the owner: Juwen Lie (right-click the pet → Help → About)</a:t>
+                        <a:t>Interactive first-run guide: your pet walks you through clicking, dragging, petting and the right-click menu; In-app updates: Pips tells you when a new version is out - update with one click (your settings and data are kept); New Help menu: replay the guide, check for updates, see the version; Option to turn automatic update checks off</a:t>
                       </a:r>
                     </a:p>
                   </a:txBody>
@@ -10406,7 +10414,7 @@
                           </a:solidFill>
                           <a:latin typeface="Segoe UI"/>
                         </a:rPr>
-                        <a:t>2.1.0</a:t>
+                        <a:t>2.0.0</a:t>
                       </a:r>
                     </a:p>
                   </a:txBody>
@@ -10450,7 +10458,7 @@
                           </a:solidFill>
                           <a:latin typeface="Segoe UI"/>
                         </a:rPr>
-                        <a:t>Interactive guide &amp; in-app updates</a:t>
+                        <a:t>Desktop pet, 23 animals &amp; 4 languages</a:t>
                       </a:r>
                     </a:p>
                     <a:p>
@@ -10461,7 +10469,7 @@
                           </a:solidFill>
                           <a:latin typeface="Segoe UI"/>
                         </a:rPr>
-                        <a:t>Interactive first-run guide: your pet walks you through clicking, dragging, petting and the right-click menu; In-app updates: Pips tells you when a new version is out - update with one click (your settings and data are kept); New Help menu: replay the guide, check for updates, see the version; Option to turn automatic update checks off</a:t>
+                        <a:t>Desktop pet that lives on your desktop and taskbar - drag it, tickle it, pet it; 23 animals in 3 groups: Land walks, Water swims with bubbles, Sky hovers and flaps; Moods (happy, sad, tired, hungry, grumpy...), naps when you're away, wakes up when you're back; Cute chat-bubble reminders: breaks, water, 20-20-20 eye rest, pomodoro done, daily goal</a:t>
                       </a:r>
                     </a:p>
                   </a:txBody>
@@ -10485,7 +10493,7 @@
                           </a:solidFill>
                           <a:latin typeface="Segoe UI"/>
                         </a:rPr>
-                        <a:t>2.0.0</a:t>
+                        <a:t>1.5.0</a:t>
                       </a:r>
                     </a:p>
                   </a:txBody>
@@ -10507,92 +10515,13 @@
                           </a:solidFill>
                           <a:latin typeface="Segoe UI"/>
                         </a:rPr>
-                        <a:t>2026-10-28</a:t>
+                        <a:t>2026-10-24</a:t>
                       </a:r>
                     </a:p>
                   </a:txBody>
                   <a:tcPr marL="73152" marR="73152" marT="36576" marB="36576">
                     <a:solidFill>
                       <a:srgbClr val="F7F4EC"/>
-                    </a:solidFill>
-                  </a:tcPr>
-                </a:tc>
-                <a:tc>
-                  <a:txBody>
-                    <a:bodyPr wrap="square"/>
-                    <a:lstStyle/>
-                    <a:p>
-                      <a:r>
-                        <a:rPr sz="1200" b="0">
-                          <a:solidFill>
-                            <a:srgbClr val="2B2A28"/>
-                          </a:solidFill>
-                          <a:latin typeface="Segoe UI"/>
-                        </a:rPr>
-                        <a:t>Desktop pet, 23 animals &amp; 4 languages</a:t>
-                      </a:r>
-                    </a:p>
-                    <a:p>
-                      <a:r>
-                        <a:rPr sz="1200" b="0">
-                          <a:solidFill>
-                            <a:srgbClr val="2B2A28"/>
-                          </a:solidFill>
-                          <a:latin typeface="Segoe UI"/>
-                        </a:rPr>
-                        <a:t>Desktop pet that lives on your desktop and taskbar - drag it, tickle it, pet it; 23 animals in 3 groups: Land walks, Water swims with bubbles, Sky hovers and flaps; Moods (happy, sad, tired, hungry, grumpy...), naps when you're away, wakes up when you're back; Cute chat-bubble reminders: breaks, water, 20-20-20 eye rest, pomodoro done, daily goal</a:t>
-                      </a:r>
-                    </a:p>
-                  </a:txBody>
-                  <a:tcPr marL="73152" marR="73152" marT="36576" marB="36576">
-                    <a:solidFill>
-                      <a:srgbClr val="F7F4EC"/>
-                    </a:solidFill>
-                  </a:tcPr>
-                </a:tc>
-              </a:tr>
-              <a:tr h="822960">
-                <a:tc>
-                  <a:txBody>
-                    <a:bodyPr wrap="square"/>
-                    <a:lstStyle/>
-                    <a:p>
-                      <a:r>
-                        <a:rPr sz="1200" b="1">
-                          <a:solidFill>
-                            <a:srgbClr val="2B2A28"/>
-                          </a:solidFill>
-                          <a:latin typeface="Segoe UI"/>
-                        </a:rPr>
-                        <a:t>1.5.0</a:t>
-                      </a:r>
-                    </a:p>
-                  </a:txBody>
-                  <a:tcPr marL="73152" marR="73152" marT="36576" marB="36576">
-                    <a:solidFill>
-                      <a:srgbClr val="FFFDF8"/>
-                    </a:solidFill>
-                  </a:tcPr>
-                </a:tc>
-                <a:tc>
-                  <a:txBody>
-                    <a:bodyPr wrap="square"/>
-                    <a:lstStyle/>
-                    <a:p>
-                      <a:r>
-                        <a:rPr sz="1200" b="0">
-                          <a:solidFill>
-                            <a:srgbClr val="2B2A28"/>
-                          </a:solidFill>
-                          <a:latin typeface="Segoe UI"/>
-                        </a:rPr>
-                        <a:t>2026-10-24</a:t>
-                      </a:r>
-                    </a:p>
-                  </a:txBody>
-                  <a:tcPr marL="73152" marR="73152" marT="36576" marB="36576">
-                    <a:solidFill>
-                      <a:srgbClr val="FFFDF8"/>
                     </a:solidFill>
                   </a:tcPr>
                 </a:tc>
@@ -10625,7 +10554,7 @@
                   </a:txBody>
                   <a:tcPr marL="73152" marR="73152" marT="36576" marB="36576">
                     <a:solidFill>
-                      <a:srgbClr val="FFFDF8"/>
+                      <a:srgbClr val="F7F4EC"/>
                     </a:solidFill>
                   </a:tcPr>
                 </a:tc>
@@ -10649,7 +10578,7 @@
                   </a:txBody>
                   <a:tcPr marL="73152" marR="73152" marT="36576" marB="36576">
                     <a:solidFill>
-                      <a:srgbClr val="F7F4EC"/>
+                      <a:srgbClr val="FFFDF8"/>
                     </a:solidFill>
                   </a:tcPr>
                 </a:tc>
@@ -10671,7 +10600,7 @@
                   </a:txBody>
                   <a:tcPr marL="73152" marR="73152" marT="36576" marB="36576">
                     <a:solidFill>
-                      <a:srgbClr val="F7F4EC"/>
+                      <a:srgbClr val="FFFDF8"/>
                     </a:solidFill>
                   </a:tcPr>
                 </a:tc>
@@ -10704,7 +10633,7 @@
                   </a:txBody>
                   <a:tcPr marL="73152" marR="73152" marT="36576" marB="36576">
                     <a:solidFill>
-                      <a:srgbClr val="F7F4EC"/>
+                      <a:srgbClr val="FFFDF8"/>
                     </a:solidFill>
                   </a:tcPr>
                 </a:tc>

</xml_diff>

<commit_message>
pips 2.14.2: Never miss an update
</commit_message>
<xml_diff>
--- a/apps/pips/web/download/Pips-Guide.pptx
+++ b/apps/pips/web/download/Pips-Guide.pptx
@@ -3292,7 +3292,7 @@
                 </a:solidFill>
                 <a:latin typeface="Segoe UI"/>
               </a:rPr>
-              <a:t>Version 2.14.1  ·  2026-10-29  ·  Made by Juwen Lie (owner)</a:t>
+              <a:t>Version 2.14.2  ·  2026-10-29  ·  Made by Juwen Lie (owner)</a:t>
             </a:r>
           </a:p>
           <a:p>
@@ -8166,7 +8166,7 @@
                 </a:solidFill>
                 <a:latin typeface="Segoe UI"/>
               </a:rPr>
-              <a:t>What's new in 2.14.1</a:t>
+              <a:t>What's new in 2.14.2</a:t>
             </a:r>
           </a:p>
         </p:txBody>
@@ -8279,7 +8279,7 @@
                 </a:solidFill>
                 <a:latin typeface="Segoe UI"/>
               </a:rPr>
-              <a:t>One pet at a time  ·  2026-10-29</a:t>
+              <a:t>Never miss an update  ·  2026-10-29</a:t>
             </a:r>
           </a:p>
         </p:txBody>
@@ -8327,7 +8327,7 @@
                 </a:solidFill>
                 <a:latin typeface="Segoe UI"/>
               </a:rPr>
-              <a:t>Opening Pips again (Desktop / Start Menu shortcut, autostart) no longer starts a second pet - your pet just pops up and says hi.</a:t>
+              <a:t>Your pet now reminds you every 2 hours while a new version is waiting (instead of every 6 hours).</a:t>
             </a:r>
           </a:p>
           <a:p>
@@ -8352,7 +8352,32 @@
                 </a:solidFill>
                 <a:latin typeface="Segoe UI"/>
               </a:rPr>
-              <a:t>Fixes lag caused by two copies of Pips running at once.</a:t>
+              <a:t>If the reminder can't show (fullscreen app, guided tour, another message), your pet tries again a few minutes later.</a:t>
+            </a:r>
+          </a:p>
+          <a:p>
+            <a:pPr>
+              <a:spcAft>
+                <a:spcPts val="1000"/>
+              </a:spcAft>
+            </a:pPr>
+            <a:r>
+              <a:rPr sz="1700" b="1">
+                <a:solidFill>
+                  <a:srgbClr val="4CB86B"/>
+                </a:solidFill>
+                <a:latin typeface="Segoe UI"/>
+              </a:rPr>
+              <a:t>•  </a:t>
+            </a:r>
+            <a:r>
+              <a:rPr sz="1700">
+                <a:solidFill>
+                  <a:srgbClr val="2B2A28"/>
+                </a:solidFill>
+                <a:latin typeface="Segoe UI"/>
+              </a:rPr>
+              <a:t>No internet when Pips starts (e.g. VPN off)? It checks again after an hour.</a:t>
             </a:r>
           </a:p>
         </p:txBody>
@@ -8483,7 +8508,7 @@
                 </a:solidFill>
                 <a:latin typeface="Segoe UI"/>
               </a:rPr>
-              <a:t>Membuka Pips lagi (pintasan Desktop / Start Menu, autostart) tidak lagi memunculkan pet kedua - pet-mu cukup muncul dan menyapa.</a:t>
+              <a:t>Pet-mu kini mengingatkan setiap 2 jam selama ada versi baru (bukan lagi setiap 6 jam).</a:t>
             </a:r>
           </a:p>
           <a:p>
@@ -8508,7 +8533,32 @@
                 </a:solidFill>
                 <a:latin typeface="Segoe UI"/>
               </a:rPr>
-              <a:t>Memperbaiki lag karena dua salinan Pips berjalan bersamaan.</a:t>
+              <a:t>Jika pengingat tidak bisa tampil (aplikasi layar penuh, panduan, pesan lain), pet-mu mencoba lagi beberapa menit kemudian.</a:t>
+            </a:r>
+          </a:p>
+          <a:p>
+            <a:pPr>
+              <a:spcAft>
+                <a:spcPts val="500"/>
+              </a:spcAft>
+            </a:pPr>
+            <a:r>
+              <a:rPr sz="1200" b="1">
+                <a:solidFill>
+                  <a:srgbClr val="4CB86B"/>
+                </a:solidFill>
+                <a:latin typeface="Segoe UI"/>
+              </a:rPr>
+              <a:t>•  </a:t>
+            </a:r>
+            <a:r>
+              <a:rPr sz="1200">
+                <a:solidFill>
+                  <a:srgbClr val="2B2A28"/>
+                </a:solidFill>
+                <a:latin typeface="Segoe UI"/>
+              </a:rPr>
+              <a:t>Tidak ada internet saat Pips mulai (mis. VPN mati)? Pips memeriksa lagi setelah satu jam.</a:t>
             </a:r>
           </a:p>
         </p:txBody>
@@ -8740,7 +8790,7 @@
         </p:nvGraphicFramePr>
         <p:xfrm>
           <a:off x="548640" y="1645920"/>
-          <a:ext cx="11155680" cy="19312128"/>
+          <a:ext cx="11155680" cy="20135088"/>
         </p:xfrm>
         <a:graphic>
           <a:graphicData uri="http://schemas.openxmlformats.org/drawingml/2006/table">
@@ -8834,7 +8884,7 @@
                           </a:solidFill>
                           <a:latin typeface="Segoe UI"/>
                         </a:rPr>
-                        <a:t>2.14.1</a:t>
+                        <a:t>2.14.2</a:t>
                       </a:r>
                     </a:p>
                   </a:txBody>
@@ -8878,7 +8928,7 @@
                           </a:solidFill>
                           <a:latin typeface="Segoe UI"/>
                         </a:rPr>
-                        <a:t>One pet at a time</a:t>
+                        <a:t>Never miss an update</a:t>
                       </a:r>
                     </a:p>
                     <a:p>
@@ -8889,7 +8939,7 @@
                           </a:solidFill>
                           <a:latin typeface="Segoe UI"/>
                         </a:rPr>
-                        <a:t>Opening Pips again (Desktop / Start Menu shortcut, autostart) no longer starts a second pet - your pet just pops up and says hi.; Fixes lag caused by two copies of Pips running at once.</a:t>
+                        <a:t>Your pet now reminds you every 2 hours while a new version is waiting (instead of every 6 hours).; If the reminder can't show (fullscreen app, guided tour, another message), your pet tries again a few minutes later.; No internet when Pips starts (e.g. VPN off)? It checks again after an hour.</a:t>
                       </a:r>
                     </a:p>
                   </a:txBody>
@@ -8913,7 +8963,7 @@
                           </a:solidFill>
                           <a:latin typeface="Segoe UI"/>
                         </a:rPr>
-                        <a:t>2.14.0</a:t>
+                        <a:t>2.14.1</a:t>
                       </a:r>
                     </a:p>
                   </a:txBody>
@@ -8957,7 +9007,7 @@
                           </a:solidFill>
                           <a:latin typeface="Segoe UI"/>
                         </a:rPr>
-                        <a:t>Pokes, tickles &amp; teases</a:t>
+                        <a:t>One pet at a time</a:t>
                       </a:r>
                     </a:p>
                     <a:p>
@@ -8968,7 +9018,7 @@
                           </a:solidFill>
                           <a:latin typeface="Segoe UI"/>
                         </a:rPr>
-                        <a:t>Poke, tickle, tease, boop or hug a friend from afar - no pet visit needed.; Right-click your pet → Poke a friend, or use the Poke button in Friends, chat and profiles.; Your friend gets a pop-up ("Wendy is teasing you!"), their pet reacts, and they can poke back with one click.; During a focus session pokes wait quietly until your break; when your pet is hidden they show in the screen corner.</a:t>
+                        <a:t>Opening Pips again (Desktop / Start Menu shortcut, autostart) no longer starts a second pet - your pet just pops up and says hi.; Fixes lag caused by two copies of Pips running at once.</a:t>
                       </a:r>
                     </a:p>
                   </a:txBody>
@@ -8992,7 +9042,7 @@
                           </a:solidFill>
                           <a:latin typeface="Segoe UI"/>
                         </a:rPr>
-                        <a:t>2.13.1</a:t>
+                        <a:t>2.14.0</a:t>
                       </a:r>
                     </a:p>
                   </a:txBody>
@@ -9014,7 +9064,7 @@
                           </a:solidFill>
                           <a:latin typeface="Segoe UI"/>
                         </a:rPr>
-                        <a:t>2026-10-28</a:t>
+                        <a:t>2026-10-29</a:t>
                       </a:r>
                     </a:p>
                   </a:txBody>
@@ -9036,7 +9086,7 @@
                           </a:solidFill>
                           <a:latin typeface="Segoe UI"/>
                         </a:rPr>
-                        <a:t>One-click Windows installer</a:t>
+                        <a:t>Pokes, tickles &amp; teases</a:t>
                       </a:r>
                     </a:p>
                     <a:p>
@@ -9047,7 +9097,7 @@
                           </a:solidFill>
                           <a:latin typeface="Segoe UI"/>
                         </a:rPr>
-                        <a:t>One Windows installer: no ZIP extraction, Python installation or command line. Download, open and click Install Pips.; Installs for your Windows account without administrator access, adds Desktop and Start Menu shortcuts, and opens Pips automatically.; Reinstalling in the same location keeps your settings and pet progress. Existing ZIP users can keep updating in place from Help → Check for updates.; A simpler download page and updated user guide; the bundled runtime stays separate from small in-app updates.</a:t>
+                        <a:t>Poke, tickle, tease, boop or hug a friend from afar - no pet visit needed.; Right-click your pet → Poke a friend, or use the Poke button in Friends, chat and profiles.; Your friend gets a pop-up ("Wendy is teasing you!"), their pet reacts, and they can poke back with one click.; During a focus session pokes wait quietly until your break; when your pet is hidden they show in the screen corner.</a:t>
                       </a:r>
                     </a:p>
                   </a:txBody>
@@ -9071,7 +9121,7 @@
                           </a:solidFill>
                           <a:latin typeface="Segoe UI"/>
                         </a:rPr>
-                        <a:t>2.13.0</a:t>
+                        <a:t>2.13.1</a:t>
                       </a:r>
                     </a:p>
                   </a:txBody>
@@ -9115,7 +9165,7 @@
                           </a:solidFill>
                           <a:latin typeface="Segoe UI"/>
                         </a:rPr>
-                        <a:t>Birthdays, parties &amp; gifts</a:t>
+                        <a:t>One-click Windows installer</a:t>
                       </a:r>
                     </a:p>
                     <a:p>
@@ -9126,7 +9176,7 @@
                           </a:solidFill>
                           <a:latin typeface="Segoe UI"/>
                         </a:rPr>
-                        <a:t>Set your birthday in Social → Profile (month + day, optionally visible to friends).; On your birthday Pips throws confetti and gives you 100 bonus coins.; Friends tab shows upcoming birthdays; you get reminders 3 days, 1 day and on the day.; Birthday parties: join a friend's party, see who's there, sign the guestbook and celebrate together.</a:t>
+                        <a:t>One Windows installer: no ZIP extraction, Python installation or command line. Download, open and click Install Pips.; Installs for your Windows account without administrator access, adds Desktop and Start Menu shortcuts, and opens Pips automatically.; Reinstalling in the same location keeps your settings and pet progress. Existing ZIP users can keep updating in place from Help → Check for updates.; A simpler download page and updated user guide; the bundled runtime stays separate from small in-app updates.</a:t>
                       </a:r>
                     </a:p>
                   </a:txBody>
@@ -9150,7 +9200,7 @@
                           </a:solidFill>
                           <a:latin typeface="Segoe UI"/>
                         </a:rPr>
-                        <a:t>2.12.0</a:t>
+                        <a:t>2.13.0</a:t>
                       </a:r>
                     </a:p>
                   </a:txBody>
@@ -9194,7 +9244,7 @@
                           </a:solidFill>
                           <a:latin typeface="Segoe UI"/>
                         </a:rPr>
-                        <a:t>Mega update: 28 new animals, 31 shop items, 13 moves</a:t>
+                        <a:t>Birthdays, parties &amp; gifts</a:t>
                       </a:r>
                     </a:p>
                     <a:p>
@@ -9205,7 +9255,7 @@
                           </a:solidFill>
                           <a:latin typeface="Segoe UI"/>
                         </a:rPr>
-                        <a:t>🦁 28 new animals (51 total): lion, tiger, unicorn, deer, sheep, cow, raccoon, red panda, monkey, hedgehog, dino, squirrel, mouse, koala, shark, dolphin, seal, otter, pufferfish, duck, crab, parrot, chick, ladybug, phoenix, pegasus, ghost and flamingo; 🎩 31 new shop items: top hat, cowboy, chef, pirate, Santa, viking, graduation cap, beret, bow, propeller cap, flower crown, nerd glasses, eyepatch, mustache, goggles, masquerade mask, tie, pearls, flower lei, gold chain, balloon, backpack, guitar, shield, butterfly / devil wings and more - plus Premium galaxy crown, galaxy cape and dragon wings; 💃 13 new moves: wave, jump, hearts, sing, yoga, zoomies, cartwheel, juggle, rain dance, breakdance, magic, confetti and the Premium rocket launch; The Shop is now split into sections (Hats, Face, Neck, Back, Moves, Arena gear) with an owned counter for each</a:t>
+                        <a:t>Set your birthday in Social → Profile (month + day, optionally visible to friends).; On your birthday Pips throws confetti and gives you 100 bonus coins.; Friends tab shows upcoming birthdays; you get reminders 3 days, 1 day and on the day.; Birthday parties: join a friend's party, see who's there, sign the guestbook and celebrate together.</a:t>
                       </a:r>
                     </a:p>
                   </a:txBody>
@@ -9229,7 +9279,7 @@
                           </a:solidFill>
                           <a:latin typeface="Segoe UI"/>
                         </a:rPr>
-                        <a:t>2.11.0</a:t>
+                        <a:t>2.12.0</a:t>
                       </a:r>
                     </a:p>
                   </a:txBody>
@@ -9273,7 +9323,7 @@
                           </a:solidFill>
                           <a:latin typeface="Segoe UI"/>
                         </a:rPr>
-                        <a:t>New right-click menus</a:t>
+                        <a:t>Mega update: 28 new animals, 31 shop items, 13 moves</a:t>
                       </a:r>
                     </a:p>
                     <a:p>
@@ -9284,7 +9334,7 @@
                           </a:solidFill>
                           <a:latin typeface="Segoe UI"/>
                         </a:rPr>
-                        <a:t>✨ Brand-new animated right-click menu for your pet: mood &amp; stat bars, quick-action tiles (Friends, Shop, Snack, Pat, Focus, Stats, Sleep, Taskbar), hover effects and smooth fly-out submenus; Pick colours from swatches, switch size with one click and flip Sounds / Dark mode with toggle switches - changes show instantly; Updates are highlighted: a glowing banner and NEW badge appear in the menu when a new version is ready; The focus card's right-click menu got the same new look; keyboard arrows, Enter and Esc work too</a:t>
+                        <a:t>🦁 28 new animals (51 total): lion, tiger, unicorn, deer, sheep, cow, raccoon, red panda, monkey, hedgehog, dino, squirrel, mouse, koala, shark, dolphin, seal, otter, pufferfish, duck, crab, parrot, chick, ladybug, phoenix, pegasus, ghost and flamingo; 🎩 31 new shop items: top hat, cowboy, chef, pirate, Santa, viking, graduation cap, beret, bow, propeller cap, flower crown, nerd glasses, eyepatch, mustache, goggles, masquerade mask, tie, pearls, flower lei, gold chain, balloon, backpack, guitar, shield, butterfly / devil wings and more - plus Premium galaxy crown, galaxy cape and dragon wings; 💃 13 new moves: wave, jump, hearts, sing, yoga, zoomies, cartwheel, juggle, rain dance, breakdance, magic, confetti and the Premium rocket launch; The Shop is now split into sections (Hats, Face, Neck, Back, Moves, Arena gear) with an owned counter for each</a:t>
                       </a:r>
                     </a:p>
                   </a:txBody>
@@ -9308,7 +9358,7 @@
                           </a:solidFill>
                           <a:latin typeface="Segoe UI"/>
                         </a:rPr>
-                        <a:t>2.10.0</a:t>
+                        <a:t>2.11.0</a:t>
                       </a:r>
                     </a:p>
                   </a:txBody>
@@ -9352,7 +9402,7 @@
                           </a:solidFill>
                           <a:latin typeface="Segoe UI"/>
                         </a:rPr>
-                        <a:t>Chat bots</a:t>
+                        <a:t>New right-click menus</a:t>
                       </a:r>
                     </a:p>
                     <a:p>
@@ -9363,7 +9413,7 @@
                           </a:solidFill>
                           <a:latin typeface="Segoe UI"/>
                         </a:rPr>
-                        <a:t>🤖 6 friendly chat bots in the Chat tab: Pip Helper (app questions), Coach Focus (focus tips from your real stats), Sunny (live weather for any city), Arena Master (battle tips + quick battle), Giggles (jokes &amp; games) and Guardian (safety &amp; reporting help); Private bot chats with suggestion chips, typing indicator and a clear button - your bot chats stay on your PC; Mention a bot in a group chat (e.g. @weather Batam) and it answers in the room for everyone; Bots reply in your app language; up to 120 bot messages per day</a:t>
+                        <a:t>✨ Brand-new animated right-click menu for your pet: mood &amp; stat bars, quick-action tiles (Friends, Shop, Snack, Pat, Focus, Stats, Sleep, Taskbar), hover effects and smooth fly-out submenus; Pick colours from swatches, switch size with one click and flip Sounds / Dark mode with toggle switches - changes show instantly; Updates are highlighted: a glowing banner and NEW badge appear in the menu when a new version is ready; The focus card's right-click menu got the same new look; keyboard arrows, Enter and Esc work too</a:t>
                       </a:r>
                     </a:p>
                   </a:txBody>
@@ -9387,7 +9437,7 @@
                           </a:solidFill>
                           <a:latin typeface="Segoe UI"/>
                         </a:rPr>
-                        <a:t>2.9.0</a:t>
+                        <a:t>2.10.0</a:t>
                       </a:r>
                     </a:p>
                   </a:txBody>
@@ -9431,7 +9481,7 @@
                           </a:solidFill>
                           <a:latin typeface="Segoe UI"/>
                         </a:rPr>
-                        <a:t>Location &amp; live weather</a:t>
+                        <a:t>Chat bots</a:t>
                       </a:r>
                     </a:p>
                     <a:p>
@@ -9442,7 +9492,7 @@
                           </a:solidFill>
                           <a:latin typeface="Segoe UI"/>
                         </a:rPr>
-                        <a:t>📍 Add your city in Profile → Location &amp; weather (auto-detect or search) - only your city and country are shown, never your exact position; Live weather banners on every profile with animations: rain, drizzle, thunderstorms with lightning, snow, fog, clouds, sunshine or a starry night - plus temperature, feels-like, humidity, wind and local time; Your own weather strip on top of the hub, and each friend's weather + local time in the friends list; Hide your location from others or remove it any time</a:t>
+                        <a:t>🤖 6 friendly chat bots in the Chat tab: Pip Helper (app questions), Coach Focus (focus tips from your real stats), Sunny (live weather for any city), Arena Master (battle tips + quick battle), Giggles (jokes &amp; games) and Guardian (safety &amp; reporting help); Private bot chats with suggestion chips, typing indicator and a clear button - your bot chats stay on your PC; Mention a bot in a group chat (e.g. @weather Batam) and it answers in the room for everyone; Bots reply in your app language; up to 120 bot messages per day</a:t>
                       </a:r>
                     </a:p>
                   </a:txBody>
@@ -9466,7 +9516,7 @@
                           </a:solidFill>
                           <a:latin typeface="Segoe UI"/>
                         </a:rPr>
-                        <a:t>2.8.0</a:t>
+                        <a:t>2.9.0</a:t>
                       </a:r>
                     </a:p>
                   </a:txBody>
@@ -9510,7 +9560,7 @@
                           </a:solidFill>
                           <a:latin typeface="Segoe UI"/>
                         </a:rPr>
-                        <a:t>Pips Arena - duels, gear &amp; live battles</a:t>
+                        <a:t>Location &amp; live weather</a:t>
                       </a:r>
                     </a:p>
                     <a:p>
@@ -9521,7 +9571,7 @@
                           </a:solidFill>
                           <a:latin typeface="Segoe UI"/>
                         </a:rPr>
-                        <a:t>⚔ New Arena tab: challenge friends or anyone in the arena to a live duel - each round pick Attack, Guard or Special within 12 seconds and watch your pets fight; ⚡ Quick battle: an instant auto-fight against anyone's fighter, even when they're offline; Arena gear in the Shop: 7 weapons (water pistol to rocket launcher), 5 armors and 5 gadgets that decide your special move - better gear and a higher level make a stronger fighter; Live duels can be watched by everyone, plus recent battle replays, top fighters, rating and win/loss records; wins earn coins</a:t>
+                        <a:t>📍 Add your city in Profile → Location &amp; weather (auto-detect or search) - only your city and country are shown, never your exact position; Live weather banners on every profile with animations: rain, drizzle, thunderstorms with lightning, snow, fog, clouds, sunshine or a starry night - plus temperature, feels-like, humidity, wind and local time; Your own weather strip on top of the hub, and each friend's weather + local time in the friends list; Hide your location from others or remove it any time</a:t>
                       </a:r>
                     </a:p>
                   </a:txBody>
@@ -9545,7 +9595,7 @@
                           </a:solidFill>
                           <a:latin typeface="Segoe UI"/>
                         </a:rPr>
-                        <a:t>2.7.0</a:t>
+                        <a:t>2.8.0</a:t>
                       </a:r>
                     </a:p>
                   </a:txBody>
@@ -9589,7 +9639,7 @@
                           </a:solidFill>
                           <a:latin typeface="Segoe UI"/>
                         </a:rPr>
-                        <a:t>Moderators &amp; Premium</a:t>
+                        <a:t>Pips Arena - duels, gear &amp; live battles</a:t>
                       </a:r>
                     </a:p>
                     <a:p>
@@ -9600,7 +9650,7 @@
                           </a:solidFill>
                           <a:latin typeface="Segoe UI"/>
                         </a:rPr>
-                        <a:t>★ Premium: a purple Premium badge, 4 exclusive props (tiara, star glasses, diamond necklace, fairy wings), the Fireworks move, +30 coins every day, double friend-interaction coins and room for 300 friends / 30 groups; Get Premium: Profile tab → Premium → "Ask to buy" emails the owner; after payment you receive a key (PIPS-XXXX-XXXX) to redeem right there; 🛡 Moderators: a blue Mod badge and a Mod tab with the report queue - warn, mute (1h / 24h / 7 days), clear a profile or reset a name; every action is logged; Report button on everyone's profile, so moderators can keep Pips friendly</a:t>
+                        <a:t>⚔ New Arena tab: challenge friends or anyone in the arena to a live duel - each round pick Attack, Guard or Special within 12 seconds and watch your pets fight; ⚡ Quick battle: an instant auto-fight against anyone's fighter, even when they're offline; Arena gear in the Shop: 7 weapons (water pistol to rocket launcher), 5 armors and 5 gadgets that decide your special move - better gear and a higher level make a stronger fighter; Live duels can be watched by everyone, plus recent battle replays, top fighters, rating and win/loss records; wins earn coins</a:t>
                       </a:r>
                     </a:p>
                   </a:txBody>
@@ -9624,7 +9674,7 @@
                           </a:solidFill>
                           <a:latin typeface="Segoe UI"/>
                         </a:rPr>
-                        <a:t>2.6.1</a:t>
+                        <a:t>2.7.0</a:t>
                       </a:r>
                     </a:p>
                   </a:txBody>
@@ -9668,7 +9718,7 @@
                           </a:solidFill>
                           <a:latin typeface="Segoe UI"/>
                         </a:rPr>
-                        <a:t>Owner badge &amp; credits</a:t>
+                        <a:t>Moderators &amp; Premium</a:t>
                       </a:r>
                     </a:p>
                     <a:p>
@@ -9679,7 +9729,7 @@
                           </a:solidFill>
                           <a:latin typeface="Segoe UI"/>
                         </a:rPr>
-                        <a:t>The creator of Pips (Juwen Lie) now shows a gold ♛ Owner badge on his profile, friend list and ranks; New About Pips card in the Profile tab: credits and how to contact the owner (Juwen_Lie@pegatroncorp.com) with Email and Copy buttons; Right-click the pet → Help → About now shows who made Pips and the contact email</a:t>
+                        <a:t>★ Premium: a purple Premium badge, 4 exclusive props (tiara, star glasses, diamond necklace, fairy wings), the Fireworks move, +30 coins every day, double friend-interaction coins and room for 300 friends / 30 groups; Get Premium: Profile tab → Premium → "Ask to buy" emails the owner; after payment you receive a key (PIPS-XXXX-XXXX) to redeem right there; 🛡 Moderators: a blue Mod badge and a Mod tab with the report queue - warn, mute (1h / 24h / 7 days), clear a profile or reset a name; every action is logged; Report button on everyone's profile, so moderators can keep Pips friendly</a:t>
                       </a:r>
                     </a:p>
                   </a:txBody>
@@ -9703,7 +9753,7 @@
                           </a:solidFill>
                           <a:latin typeface="Segoe UI"/>
                         </a:rPr>
-                        <a:t>2.6.0</a:t>
+                        <a:t>2.6.1</a:t>
                       </a:r>
                     </a:p>
                   </a:txBody>
@@ -9747,7 +9797,7 @@
                           </a:solidFill>
                           <a:latin typeface="Segoe UI"/>
                         </a:rPr>
-                        <a:t>Profiles, ranks, online status &amp; dark mode</a:t>
+                        <a:t>Owner badge &amp; credits</a:t>
                       </a:r>
                     </a:p>
                     <a:p>
@@ -9758,7 +9808,7 @@
                           </a:solidFill>
                           <a:latin typeface="Segoe UI"/>
                         </a:rPr>
-                        <a:t>Profile tab: profile picture (or your pet), about me, job, location, hobbies, birthday and a status message; Public or private: public profiles can be added directly and viewed in full; private profiles need a friend request that they accept, and strangers only see name, photo, pet, level and status; Click anyone to open their profile - badges, info, their friends - and add them, chat or wave from there; Ranks tab replaces Teams: everyone using Pips, sorted by XP, badges or streak</a:t>
+                        <a:t>The creator of Pips (Juwen Lie) now shows a gold ♛ Owner badge on his profile, friend list and ranks; New About Pips card in the Profile tab: credits and how to contact the owner (Juwen_Lie@pegatroncorp.com) with Email and Copy buttons; Right-click the pet → Help → About now shows who made Pips and the contact email</a:t>
                       </a:r>
                     </a:p>
                   </a:txBody>
@@ -9782,7 +9832,7 @@
                           </a:solidFill>
                           <a:latin typeface="Segoe UI"/>
                         </a:rPr>
-                        <a:t>2.5.1</a:t>
+                        <a:t>2.6.0</a:t>
                       </a:r>
                     </a:p>
                   </a:txBody>
@@ -9826,7 +9876,7 @@
                           </a:solidFill>
                           <a:latin typeface="Segoe UI"/>
                         </a:rPr>
-                        <a:t>New cute Pips logo</a:t>
+                        <a:t>Profiles, ranks, online status &amp; dark mode</a:t>
                       </a:r>
                     </a:p>
                     <a:p>
@@ -9837,7 +9887,7 @@
                           </a:solidFill>
                           <a:latin typeface="Segoe UI"/>
                         </a:rPr>
-                        <a:t>New Pips logo: Pip the cat on a Pips-red tile, matching the app colours (desktop shortcut, windows and website)</a:t>
+                        <a:t>Profile tab: profile picture (or your pet), about me, job, location, hobbies, birthday and a status message; Public or private: public profiles can be added directly and viewed in full; private profiles need a friend request that they accept, and strangers only see name, photo, pet, level and status; Click anyone to open their profile - badges, info, their friends - and add them, chat or wave from there; Ranks tab replaces Teams: everyone using Pips, sorted by XP, badges or streak</a:t>
                       </a:r>
                     </a:p>
                   </a:txBody>
@@ -9861,7 +9911,7 @@
                           </a:solidFill>
                           <a:latin typeface="Segoe UI"/>
                         </a:rPr>
-                        <a:t>2.5.0</a:t>
+                        <a:t>2.5.1</a:t>
                       </a:r>
                     </a:p>
                   </a:txBody>
@@ -9905,7 +9955,7 @@
                           </a:solidFill>
                           <a:latin typeface="Segoe UI"/>
                         </a:rPr>
-                        <a:t>Shop, coins, props &amp; moves</a:t>
+                        <a:t>New cute Pips logo</a:t>
                       </a:r>
                     </a:p>
                     <a:p>
@@ -9916,7 +9966,7 @@
                           </a:solidFill>
                           <a:latin typeface="Segoe UI"/>
                         </a:rPr>
-                        <a:t>Shop: earn coins and spend them on your pet - 17 props (crown, wizard hat, headphones, shades, scarf, cape, angel wings...) and 6 moves: spin, dance, moonwalk, backflip, kung fu and spider swing!; Coins come from leveling up (+40), badges (+25), opening Pips each day (+10), friendships (+15 per affinity level), waving / chatting / visiting friends (+2) and pomodoros (+5). Everyone starts with a 100-coin gift; Your friends see your props: on avatars in the hub and when your pet visits their desktop - it shows off one of your moves; Pips is now a social pet: clicking the pet opens the Pips hub (friends, chat, groups, shop, badges)</a:t>
+                        <a:t>New Pips logo: Pip the cat on a Pips-red tile, matching the app colours (desktop shortcut, windows and website)</a:t>
                       </a:r>
                     </a:p>
                   </a:txBody>
@@ -9940,7 +9990,7 @@
                           </a:solidFill>
                           <a:latin typeface="Segoe UI"/>
                         </a:rPr>
-                        <a:t>2.4.0</a:t>
+                        <a:t>2.5.0</a:t>
                       </a:r>
                     </a:p>
                   </a:txBody>
@@ -9984,7 +10034,7 @@
                           </a:solidFill>
                           <a:latin typeface="Segoe UI"/>
                         </a:rPr>
-                        <a:t>Chat, groups, affinity &amp; pet visits</a:t>
+                        <a:t>Shop, coins, props &amp; moves</a:t>
                       </a:r>
                     </a:p>
                     <a:p>
@@ -9995,7 +10045,7 @@
                           </a:solidFill>
                           <a:latin typeface="Segoe UI"/>
                         </a:rPr>
-                        <a:t>Chat: message your friends, and chat inside groups. Your pet pops up new messages as a bubble - click it to reply; Pet interactions: wave, pet their pet, send a snack, high five - or send your pet to visit: it walks onto your friend's desktop for a little while!; Affinity: every chat and interaction grows your friendship - Acquaintance → Buddy → Good friends → Close friends → Best friends → Soulmates; Your own groups: create a private group, invite your friends, they accept or decline. Group board + group chat; the owner can remove members</a:t>
+                        <a:t>Shop: earn coins and spend them on your pet - 17 props (crown, wizard hat, headphones, shades, scarf, cape, angel wings...) and 6 moves: spin, dance, moonwalk, backflip, kung fu and spider swing!; Coins come from leveling up (+40), badges (+25), opening Pips each day (+10), friendships (+15 per affinity level), waving / chatting / visiting friends (+2) and pomodoros (+5). Everyone starts with a 100-coin gift; Your friends see your props: on avatars in the hub and when your pet visits their desktop - it shows off one of your moves; Pips is now a social pet: clicking the pet opens the Pips hub (friends, chat, groups, shop, badges)</a:t>
                       </a:r>
                     </a:p>
                   </a:txBody>
@@ -10019,7 +10069,7 @@
                           </a:solidFill>
                           <a:latin typeface="Segoe UI"/>
                         </a:rPr>
-                        <a:t>2.3.0</a:t>
+                        <a:t>2.4.0</a:t>
                       </a:r>
                     </a:p>
                   </a:txBody>
@@ -10063,7 +10113,7 @@
                           </a:solidFill>
                           <a:latin typeface="Segoe UI"/>
                         </a:rPr>
-                        <a:t>Friends, levels &amp; achievements</a:t>
+                        <a:t>Chat, groups, affinity &amp; pet visits</a:t>
                       </a:r>
                     </a:p>
                     <a:p>
@@ -10074,7 +10124,7 @@
                           </a:solidFill>
                           <a:latin typeface="Segoe UI"/>
                         </a:rPr>
-                        <a:t>Levels &amp; XP: every finished pomodoro earns XP and your level grows - plus 20 achievements to unlock (first tomato, 8 in a day, 7-day streak, early bird, night owl, pet lover...). Your pet celebrates each one; Friends (optional, off by default): get a 6-letter friend code, add colleagues, see today's board and join a team board like PTB. Your pet tells you when a friend finishes a pomodoro; Privacy: only your name, pet, level, streak and pomodoro counts are shared - never apps, window titles or scores. One click turns it off and deletes your online data. Right-click the pet → Friends &amp; achievements…</a:t>
+                        <a:t>Chat: message your friends, and chat inside groups. Your pet pops up new messages as a bubble - click it to reply; Pet interactions: wave, pet their pet, send a snack, high five - or send your pet to visit: it walks onto your friend's desktop for a little while!; Affinity: every chat and interaction grows your friendship - Acquaintance → Buddy → Good friends → Close friends → Best friends → Soulmates; Your own groups: create a private group, invite your friends, they accept or decline. Group board + group chat; the owner can remove members</a:t>
                       </a:r>
                     </a:p>
                   </a:txBody>
@@ -10098,7 +10148,7 @@
                           </a:solidFill>
                           <a:latin typeface="Segoe UI"/>
                         </a:rPr>
-                        <a:t>2.2.0</a:t>
+                        <a:t>2.3.0</a:t>
                       </a:r>
                     </a:p>
                   </a:txBody>
@@ -10142,7 +10192,7 @@
                           </a:solidFill>
                           <a:latin typeface="Segoe UI"/>
                         </a:rPr>
-                        <a:t>Pet sounds</a:t>
+                        <a:t>Friends, levels &amp; achievements</a:t>
                       </a:r>
                     </a:p>
                     <a:p>
@@ -10153,7 +10203,7 @@
                           </a:solidFill>
                           <a:latin typeface="Segoe UI"/>
                         </a:rPr>
-                        <a:t>Your pet has a voice! Each of the 23 animals has its own sound (meow, woof, ribbit, hoot, buzz, oink, whale song...) and it changes with its mood: happy chirps, sad whimpers, sleepy yawns, hungry calls, grumpy huffs and soft snores; It also reacts with sound when you tickle, pet, feed, shake or wake it; Settings: right-click the pet → Sounds to switch on/off; Pet status &amp; settings has a volume slider, a ▶ Hear me button and "Stay quiet while I'm focusing" (on by default)</a:t>
+                        <a:t>Levels &amp; XP: every finished pomodoro earns XP and your level grows - plus 20 achievements to unlock (first tomato, 8 in a day, 7-day streak, early bird, night owl, pet lover...). Your pet celebrates each one; Friends (optional, off by default): get a 6-letter friend code, add colleagues, see today's board and join a team board like PTB. Your pet tells you when a friend finishes a pomodoro; Privacy: only your name, pet, level, streak and pomodoro counts are shared - never apps, window titles or scores. One click turns it off and deletes your online data. Right-click the pet → Friends &amp; achievements…</a:t>
                       </a:r>
                     </a:p>
                   </a:txBody>
@@ -10177,7 +10227,7 @@
                           </a:solidFill>
                           <a:latin typeface="Segoe UI"/>
                         </a:rPr>
-                        <a:t>2.1.2</a:t>
+                        <a:t>2.2.0</a:t>
                       </a:r>
                     </a:p>
                   </a:txBody>
@@ -10221,7 +10271,7 @@
                           </a:solidFill>
                           <a:latin typeface="Segoe UI"/>
                         </a:rPr>
-                        <a:t>Tickle-only mode</a:t>
+                        <a:t>Pet sounds</a:t>
                       </a:r>
                     </a:p>
                     <a:p>
@@ -10232,7 +10282,7 @@
                           </a:solidFill>
                           <a:latin typeface="Segoe UI"/>
                         </a:rPr>
-                        <a:t>New click option "Only tickle (never open Pips)": click and tickle your pet as much as you like - the Pomodoro window stays closed (open it from the right-click menu). Right-click the pet → When I click</a:t>
+                        <a:t>Your pet has a voice! Each of the 23 animals has its own sound (meow, woof, ribbit, hoot, buzz, oink, whale song...) and it changes with its mood: happy chirps, sad whimpers, sleepy yawns, hungry calls, grumpy huffs and soft snores; It also reacts with sound when you tickle, pet, feed, shake or wake it; Settings: right-click the pet → Sounds to switch on/off; Pet status &amp; settings has a volume slider, a ▶ Hear me button and "Stay quiet while I'm focusing" (on by default)</a:t>
                       </a:r>
                     </a:p>
                   </a:txBody>
@@ -10256,7 +10306,7 @@
                           </a:solidFill>
                           <a:latin typeface="Segoe UI"/>
                         </a:rPr>
-                        <a:t>2.1.1</a:t>
+                        <a:t>2.1.2</a:t>
                       </a:r>
                     </a:p>
                   </a:txBody>
@@ -10300,7 +10350,7 @@
                           </a:solidFill>
                           <a:latin typeface="Segoe UI"/>
                         </a:rPr>
-                        <a:t>Owner info</a:t>
+                        <a:t>Tickle-only mode</a:t>
                       </a:r>
                     </a:p>
                     <a:p>
@@ -10311,7 +10361,7 @@
                           </a:solidFill>
                           <a:latin typeface="Segoe UI"/>
                         </a:rPr>
-                        <a:t>About Pips now shows the owner: Juwen Lie (right-click the pet → Help → About)</a:t>
+                        <a:t>New click option "Only tickle (never open Pips)": click and tickle your pet as much as you like - the Pomodoro window stays closed (open it from the right-click menu). Right-click the pet → When I click</a:t>
                       </a:r>
                     </a:p>
                   </a:txBody>
@@ -10335,7 +10385,7 @@
                           </a:solidFill>
                           <a:latin typeface="Segoe UI"/>
                         </a:rPr>
-                        <a:t>2.1.0</a:t>
+                        <a:t>2.1.1</a:t>
                       </a:r>
                     </a:p>
                   </a:txBody>
@@ -10379,7 +10429,7 @@
                           </a:solidFill>
                           <a:latin typeface="Segoe UI"/>
                         </a:rPr>
-                        <a:t>Interactive guide &amp; in-app updates</a:t>
+                        <a:t>Owner info</a:t>
                       </a:r>
                     </a:p>
                     <a:p>
@@ -10390,7 +10440,7 @@
                           </a:solidFill>
                           <a:latin typeface="Segoe UI"/>
                         </a:rPr>
-                        <a:t>Interactive first-run guide: your pet walks you through clicking, dragging, petting and the right-click menu; In-app updates: Pips tells you when a new version is out - update with one click (your settings and data are kept); New Help menu: replay the guide, check for updates, see the version; Option to turn automatic update checks off</a:t>
+                        <a:t>About Pips now shows the owner: Juwen Lie (right-click the pet → Help → About)</a:t>
                       </a:r>
                     </a:p>
                   </a:txBody>
@@ -10414,7 +10464,7 @@
                           </a:solidFill>
                           <a:latin typeface="Segoe UI"/>
                         </a:rPr>
-                        <a:t>2.0.0</a:t>
+                        <a:t>2.1.0</a:t>
                       </a:r>
                     </a:p>
                   </a:txBody>
@@ -10458,7 +10508,7 @@
                           </a:solidFill>
                           <a:latin typeface="Segoe UI"/>
                         </a:rPr>
-                        <a:t>Desktop pet, 23 animals &amp; 4 languages</a:t>
+                        <a:t>Interactive guide &amp; in-app updates</a:t>
                       </a:r>
                     </a:p>
                     <a:p>
@@ -10469,7 +10519,7 @@
                           </a:solidFill>
                           <a:latin typeface="Segoe UI"/>
                         </a:rPr>
-                        <a:t>Desktop pet that lives on your desktop and taskbar - drag it, tickle it, pet it; 23 animals in 3 groups: Land walks, Water swims with bubbles, Sky hovers and flaps; Moods (happy, sad, tired, hungry, grumpy...), naps when you're away, wakes up when you're back; Cute chat-bubble reminders: breaks, water, 20-20-20 eye rest, pomodoro done, daily goal</a:t>
+                        <a:t>Interactive first-run guide: your pet walks you through clicking, dragging, petting and the right-click menu; In-app updates: Pips tells you when a new version is out - update with one click (your settings and data are kept); New Help menu: replay the guide, check for updates, see the version; Option to turn automatic update checks off</a:t>
                       </a:r>
                     </a:p>
                   </a:txBody>
@@ -10493,7 +10543,7 @@
                           </a:solidFill>
                           <a:latin typeface="Segoe UI"/>
                         </a:rPr>
-                        <a:t>1.5.0</a:t>
+                        <a:t>2.0.0</a:t>
                       </a:r>
                     </a:p>
                   </a:txBody>
@@ -10515,7 +10565,7 @@
                           </a:solidFill>
                           <a:latin typeface="Segoe UI"/>
                         </a:rPr>
-                        <a:t>2026-10-24</a:t>
+                        <a:t>2026-10-28</a:t>
                       </a:r>
                     </a:p>
                   </a:txBody>
@@ -10537,7 +10587,7 @@
                           </a:solidFill>
                           <a:latin typeface="Segoe UI"/>
                         </a:rPr>
-                        <a:t>Renamed to Pips + insights</a:t>
+                        <a:t>Desktop pet, 23 animals &amp; 4 languages</a:t>
                       </a:r>
                     </a:p>
                     <a:p>
@@ -10548,7 +10598,7 @@
                           </a:solidFill>
                           <a:latin typeface="Segoe UI"/>
                         </a:rPr>
-                        <a:t>Renamed from Productivity Widget to Pips; Dashboard charts: focus timeline, hour heatmap, 7-day score trend, pomodoros per day; AI token usage on the card and dashboard; Daily diary export and weekly / monthly reports</a:t>
+                        <a:t>Desktop pet that lives on your desktop and taskbar - drag it, tickle it, pet it; 23 animals in 3 groups: Land walks, Water swims with bubbles, Sky hovers and flaps; Moods (happy, sad, tired, hungry, grumpy...), naps when you're away, wakes up when you're back; Cute chat-bubble reminders: breaks, water, 20-20-20 eye rest, pomodoro done, daily goal</a:t>
                       </a:r>
                     </a:p>
                   </a:txBody>
@@ -10572,7 +10622,7 @@
                           </a:solidFill>
                           <a:latin typeface="Segoe UI"/>
                         </a:rPr>
-                        <a:t>1.0.0</a:t>
+                        <a:t>1.5.0</a:t>
                       </a:r>
                     </a:p>
                   </a:txBody>
@@ -10594,7 +10644,7 @@
                           </a:solidFill>
                           <a:latin typeface="Segoe UI"/>
                         </a:rPr>
-                        <a:t>2026-10-21</a:t>
+                        <a:t>2026-10-24</a:t>
                       </a:r>
                     </a:p>
                   </a:txBody>
@@ -10616,7 +10666,7 @@
                           </a:solidFill>
                           <a:latin typeface="Segoe UI"/>
                         </a:rPr>
-                        <a:t>First release</a:t>
+                        <a:t>Renamed to Pips + insights</a:t>
                       </a:r>
                     </a:p>
                     <a:p>
@@ -10627,13 +10677,92 @@
                           </a:solidFill>
                           <a:latin typeface="Segoe UI"/>
                         </a:rPr>
-                        <a:t>Always-on-top Pomodoro card with progress ring; Rain / thunder / brown-noise / cafe soundscapes; Live app-usage tracking and a daily 1-5 star focus score; Goals, streaks, XP, coach tips and break reminders</a:t>
+                        <a:t>Renamed from Productivity Widget to Pips; Dashboard charts: focus timeline, hour heatmap, 7-day score trend, pomodoros per day; AI token usage on the card and dashboard; Daily diary export and weekly / monthly reports</a:t>
                       </a:r>
                     </a:p>
                   </a:txBody>
                   <a:tcPr marL="73152" marR="73152" marT="36576" marB="36576">
                     <a:solidFill>
                       <a:srgbClr val="FFFDF8"/>
+                    </a:solidFill>
+                  </a:tcPr>
+                </a:tc>
+              </a:tr>
+              <a:tr h="822960">
+                <a:tc>
+                  <a:txBody>
+                    <a:bodyPr wrap="square"/>
+                    <a:lstStyle/>
+                    <a:p>
+                      <a:r>
+                        <a:rPr sz="1200" b="1">
+                          <a:solidFill>
+                            <a:srgbClr val="2B2A28"/>
+                          </a:solidFill>
+                          <a:latin typeface="Segoe UI"/>
+                        </a:rPr>
+                        <a:t>1.0.0</a:t>
+                      </a:r>
+                    </a:p>
+                  </a:txBody>
+                  <a:tcPr marL="73152" marR="73152" marT="36576" marB="36576">
+                    <a:solidFill>
+                      <a:srgbClr val="F7F4EC"/>
+                    </a:solidFill>
+                  </a:tcPr>
+                </a:tc>
+                <a:tc>
+                  <a:txBody>
+                    <a:bodyPr wrap="square"/>
+                    <a:lstStyle/>
+                    <a:p>
+                      <a:r>
+                        <a:rPr sz="1200" b="0">
+                          <a:solidFill>
+                            <a:srgbClr val="2B2A28"/>
+                          </a:solidFill>
+                          <a:latin typeface="Segoe UI"/>
+                        </a:rPr>
+                        <a:t>2026-10-21</a:t>
+                      </a:r>
+                    </a:p>
+                  </a:txBody>
+                  <a:tcPr marL="73152" marR="73152" marT="36576" marB="36576">
+                    <a:solidFill>
+                      <a:srgbClr val="F7F4EC"/>
+                    </a:solidFill>
+                  </a:tcPr>
+                </a:tc>
+                <a:tc>
+                  <a:txBody>
+                    <a:bodyPr wrap="square"/>
+                    <a:lstStyle/>
+                    <a:p>
+                      <a:r>
+                        <a:rPr sz="1200" b="0">
+                          <a:solidFill>
+                            <a:srgbClr val="2B2A28"/>
+                          </a:solidFill>
+                          <a:latin typeface="Segoe UI"/>
+                        </a:rPr>
+                        <a:t>First release</a:t>
+                      </a:r>
+                    </a:p>
+                    <a:p>
+                      <a:r>
+                        <a:rPr sz="1200" b="0">
+                          <a:solidFill>
+                            <a:srgbClr val="2B2A28"/>
+                          </a:solidFill>
+                          <a:latin typeface="Segoe UI"/>
+                        </a:rPr>
+                        <a:t>Always-on-top Pomodoro card with progress ring; Rain / thunder / brown-noise / cafe soundscapes; Live app-usage tracking and a daily 1-5 star focus score; Goals, streaks, XP, coach tips and break reminders</a:t>
+                      </a:r>
+                    </a:p>
+                  </a:txBody>
+                  <a:tcPr marL="73152" marR="73152" marT="36576" marB="36576">
+                    <a:solidFill>
+                      <a:srgbClr val="F7F4EC"/>
                     </a:solidFill>
                   </a:tcPr>
                 </a:tc>

</xml_diff>

<commit_message>
pips 2.14.3: Tidy menus
</commit_message>
<xml_diff>
--- a/apps/pips/web/download/Pips-Guide.pptx
+++ b/apps/pips/web/download/Pips-Guide.pptx
@@ -3292,7 +3292,7 @@
                 </a:solidFill>
                 <a:latin typeface="Segoe UI"/>
               </a:rPr>
-              <a:t>Version 2.14.2  ·  2026-10-29  ·  Made by Juwen Lie (owner)</a:t>
+              <a:t>Version 2.14.3  ·  2026-10-29  ·  Made by Juwen Lie (owner)</a:t>
             </a:r>
           </a:p>
           <a:p>
@@ -8166,7 +8166,7 @@
                 </a:solidFill>
                 <a:latin typeface="Segoe UI"/>
               </a:rPr>
-              <a:t>What's new in 2.14.2</a:t>
+              <a:t>What's new in 2.14.3</a:t>
             </a:r>
           </a:p>
         </p:txBody>
@@ -8279,7 +8279,7 @@
                 </a:solidFill>
                 <a:latin typeface="Segoe UI"/>
               </a:rPr>
-              <a:t>Never miss an update  ·  2026-10-29</a:t>
+              <a:t>Tidy menus  ·  2026-10-29</a:t>
             </a:r>
           </a:p>
         </p:txBody>
@@ -8327,7 +8327,7 @@
                 </a:solidFill>
                 <a:latin typeface="Segoe UI"/>
               </a:rPr>
-              <a:t>Your pet now reminds you every 2 hours while a new version is waiting (instead of every 6 hours).</a:t>
+              <a:t>Fixed: a submenu (e.g. Poke a friend) could stay floating on the screen after the right-click menu closed.</a:t>
             </a:r>
           </a:p>
           <a:p>
@@ -8352,32 +8352,7 @@
                 </a:solidFill>
                 <a:latin typeface="Segoe UI"/>
               </a:rPr>
-              <a:t>If the reminder can't show (fullscreen app, guided tour, another message), your pet tries again a few minutes later.</a:t>
-            </a:r>
-          </a:p>
-          <a:p>
-            <a:pPr>
-              <a:spcAft>
-                <a:spcPts val="1000"/>
-              </a:spcAft>
-            </a:pPr>
-            <a:r>
-              <a:rPr sz="1700" b="1">
-                <a:solidFill>
-                  <a:srgbClr val="4CB86B"/>
-                </a:solidFill>
-                <a:latin typeface="Segoe UI"/>
-              </a:rPr>
-              <a:t>•  </a:t>
-            </a:r>
-            <a:r>
-              <a:rPr sz="1700">
-                <a:solidFill>
-                  <a:srgbClr val="2B2A28"/>
-                </a:solidFill>
-                <a:latin typeface="Segoe UI"/>
-              </a:rPr>
-              <a:t>No internet when Pips starts (e.g. VPN off)? It checks again after an hour.</a:t>
+              <a:t>Menus now close by themselves when you move the mouse away and leave them for a few seconds.</a:t>
             </a:r>
           </a:p>
         </p:txBody>
@@ -8508,7 +8483,7 @@
                 </a:solidFill>
                 <a:latin typeface="Segoe UI"/>
               </a:rPr>
-              <a:t>Pet-mu kini mengingatkan setiap 2 jam selama ada versi baru (bukan lagi setiap 6 jam).</a:t>
+              <a:t>Diperbaiki: submenu (mis. Colek teman) bisa tertinggal melayang di layar setelah menu klik kanan ditutup.</a:t>
             </a:r>
           </a:p>
           <a:p>
@@ -8533,32 +8508,7 @@
                 </a:solidFill>
                 <a:latin typeface="Segoe UI"/>
               </a:rPr>
-              <a:t>Jika pengingat tidak bisa tampil (aplikasi layar penuh, panduan, pesan lain), pet-mu mencoba lagi beberapa menit kemudian.</a:t>
-            </a:r>
-          </a:p>
-          <a:p>
-            <a:pPr>
-              <a:spcAft>
-                <a:spcPts val="500"/>
-              </a:spcAft>
-            </a:pPr>
-            <a:r>
-              <a:rPr sz="1200" b="1">
-                <a:solidFill>
-                  <a:srgbClr val="4CB86B"/>
-                </a:solidFill>
-                <a:latin typeface="Segoe UI"/>
-              </a:rPr>
-              <a:t>•  </a:t>
-            </a:r>
-            <a:r>
-              <a:rPr sz="1200">
-                <a:solidFill>
-                  <a:srgbClr val="2B2A28"/>
-                </a:solidFill>
-                <a:latin typeface="Segoe UI"/>
-              </a:rPr>
-              <a:t>Tidak ada internet saat Pips mulai (mis. VPN mati)? Pips memeriksa lagi setelah satu jam.</a:t>
+              <a:t>Menu kini menutup sendiri jika mouse dijauhkan dan dibiarkan beberapa detik.</a:t>
             </a:r>
           </a:p>
         </p:txBody>
@@ -8790,7 +8740,7 @@
         </p:nvGraphicFramePr>
         <p:xfrm>
           <a:off x="548640" y="1645920"/>
-          <a:ext cx="11155680" cy="20135088"/>
+          <a:ext cx="11155680" cy="20958048"/>
         </p:xfrm>
         <a:graphic>
           <a:graphicData uri="http://schemas.openxmlformats.org/drawingml/2006/table">
@@ -8884,7 +8834,7 @@
                           </a:solidFill>
                           <a:latin typeface="Segoe UI"/>
                         </a:rPr>
-                        <a:t>2.14.2</a:t>
+                        <a:t>2.14.3</a:t>
                       </a:r>
                     </a:p>
                   </a:txBody>
@@ -8928,7 +8878,7 @@
                           </a:solidFill>
                           <a:latin typeface="Segoe UI"/>
                         </a:rPr>
-                        <a:t>Never miss an update</a:t>
+                        <a:t>Tidy menus</a:t>
                       </a:r>
                     </a:p>
                     <a:p>
@@ -8939,7 +8889,7 @@
                           </a:solidFill>
                           <a:latin typeface="Segoe UI"/>
                         </a:rPr>
-                        <a:t>Your pet now reminds you every 2 hours while a new version is waiting (instead of every 6 hours).; If the reminder can't show (fullscreen app, guided tour, another message), your pet tries again a few minutes later.; No internet when Pips starts (e.g. VPN off)? It checks again after an hour.</a:t>
+                        <a:t>Fixed: a submenu (e.g. Poke a friend) could stay floating on the screen after the right-click menu closed.; Menus now close by themselves when you move the mouse away and leave them for a few seconds.</a:t>
                       </a:r>
                     </a:p>
                   </a:txBody>
@@ -8963,7 +8913,7 @@
                           </a:solidFill>
                           <a:latin typeface="Segoe UI"/>
                         </a:rPr>
-                        <a:t>2.14.1</a:t>
+                        <a:t>2.14.2</a:t>
                       </a:r>
                     </a:p>
                   </a:txBody>
@@ -9007,7 +8957,7 @@
                           </a:solidFill>
                           <a:latin typeface="Segoe UI"/>
                         </a:rPr>
-                        <a:t>One pet at a time</a:t>
+                        <a:t>Never miss an update</a:t>
                       </a:r>
                     </a:p>
                     <a:p>
@@ -9018,7 +8968,7 @@
                           </a:solidFill>
                           <a:latin typeface="Segoe UI"/>
                         </a:rPr>
-                        <a:t>Opening Pips again (Desktop / Start Menu shortcut, autostart) no longer starts a second pet - your pet just pops up and says hi.; Fixes lag caused by two copies of Pips running at once.</a:t>
+                        <a:t>Your pet now reminds you every 2 hours while a new version is waiting (instead of every 6 hours).; If the reminder can't show (fullscreen app, guided tour, another message), your pet tries again a few minutes later.; No internet when Pips starts (e.g. VPN off)? It checks again after an hour.</a:t>
                       </a:r>
                     </a:p>
                   </a:txBody>
@@ -9042,7 +8992,7 @@
                           </a:solidFill>
                           <a:latin typeface="Segoe UI"/>
                         </a:rPr>
-                        <a:t>2.14.0</a:t>
+                        <a:t>2.14.1</a:t>
                       </a:r>
                     </a:p>
                   </a:txBody>
@@ -9086,7 +9036,7 @@
                           </a:solidFill>
                           <a:latin typeface="Segoe UI"/>
                         </a:rPr>
-                        <a:t>Pokes, tickles &amp; teases</a:t>
+                        <a:t>One pet at a time</a:t>
                       </a:r>
                     </a:p>
                     <a:p>
@@ -9097,7 +9047,7 @@
                           </a:solidFill>
                           <a:latin typeface="Segoe UI"/>
                         </a:rPr>
-                        <a:t>Poke, tickle, tease, boop or hug a friend from afar - no pet visit needed.; Right-click your pet → Poke a friend, or use the Poke button in Friends, chat and profiles.; Your friend gets a pop-up ("Wendy is teasing you!"), their pet reacts, and they can poke back with one click.; During a focus session pokes wait quietly until your break; when your pet is hidden they show in the screen corner.</a:t>
+                        <a:t>Opening Pips again (Desktop / Start Menu shortcut, autostart) no longer starts a second pet - your pet just pops up and says hi.; Fixes lag caused by two copies of Pips running at once.</a:t>
                       </a:r>
                     </a:p>
                   </a:txBody>
@@ -9121,7 +9071,7 @@
                           </a:solidFill>
                           <a:latin typeface="Segoe UI"/>
                         </a:rPr>
-                        <a:t>2.13.1</a:t>
+                        <a:t>2.14.0</a:t>
                       </a:r>
                     </a:p>
                   </a:txBody>
@@ -9143,7 +9093,7 @@
                           </a:solidFill>
                           <a:latin typeface="Segoe UI"/>
                         </a:rPr>
-                        <a:t>2026-10-28</a:t>
+                        <a:t>2026-10-29</a:t>
                       </a:r>
                     </a:p>
                   </a:txBody>
@@ -9165,7 +9115,7 @@
                           </a:solidFill>
                           <a:latin typeface="Segoe UI"/>
                         </a:rPr>
-                        <a:t>One-click Windows installer</a:t>
+                        <a:t>Pokes, tickles &amp; teases</a:t>
                       </a:r>
                     </a:p>
                     <a:p>
@@ -9176,7 +9126,7 @@
                           </a:solidFill>
                           <a:latin typeface="Segoe UI"/>
                         </a:rPr>
-                        <a:t>One Windows installer: no ZIP extraction, Python installation or command line. Download, open and click Install Pips.; Installs for your Windows account without administrator access, adds Desktop and Start Menu shortcuts, and opens Pips automatically.; Reinstalling in the same location keeps your settings and pet progress. Existing ZIP users can keep updating in place from Help → Check for updates.; A simpler download page and updated user guide; the bundled runtime stays separate from small in-app updates.</a:t>
+                        <a:t>Poke, tickle, tease, boop or hug a friend from afar - no pet visit needed.; Right-click your pet → Poke a friend, or use the Poke button in Friends, chat and profiles.; Your friend gets a pop-up ("Wendy is teasing you!"), their pet reacts, and they can poke back with one click.; During a focus session pokes wait quietly until your break; when your pet is hidden they show in the screen corner.</a:t>
                       </a:r>
                     </a:p>
                   </a:txBody>
@@ -9200,7 +9150,7 @@
                           </a:solidFill>
                           <a:latin typeface="Segoe UI"/>
                         </a:rPr>
-                        <a:t>2.13.0</a:t>
+                        <a:t>2.13.1</a:t>
                       </a:r>
                     </a:p>
                   </a:txBody>
@@ -9244,7 +9194,7 @@
                           </a:solidFill>
                           <a:latin typeface="Segoe UI"/>
                         </a:rPr>
-                        <a:t>Birthdays, parties &amp; gifts</a:t>
+                        <a:t>One-click Windows installer</a:t>
                       </a:r>
                     </a:p>
                     <a:p>
@@ -9255,7 +9205,7 @@
                           </a:solidFill>
                           <a:latin typeface="Segoe UI"/>
                         </a:rPr>
-                        <a:t>Set your birthday in Social → Profile (month + day, optionally visible to friends).; On your birthday Pips throws confetti and gives you 100 bonus coins.; Friends tab shows upcoming birthdays; you get reminders 3 days, 1 day and on the day.; Birthday parties: join a friend's party, see who's there, sign the guestbook and celebrate together.</a:t>
+                        <a:t>One Windows installer: no ZIP extraction, Python installation or command line. Download, open and click Install Pips.; Installs for your Windows account without administrator access, adds Desktop and Start Menu shortcuts, and opens Pips automatically.; Reinstalling in the same location keeps your settings and pet progress. Existing ZIP users can keep updating in place from Help → Check for updates.; A simpler download page and updated user guide; the bundled runtime stays separate from small in-app updates.</a:t>
                       </a:r>
                     </a:p>
                   </a:txBody>
@@ -9279,7 +9229,7 @@
                           </a:solidFill>
                           <a:latin typeface="Segoe UI"/>
                         </a:rPr>
-                        <a:t>2.12.0</a:t>
+                        <a:t>2.13.0</a:t>
                       </a:r>
                     </a:p>
                   </a:txBody>
@@ -9323,7 +9273,7 @@
                           </a:solidFill>
                           <a:latin typeface="Segoe UI"/>
                         </a:rPr>
-                        <a:t>Mega update: 28 new animals, 31 shop items, 13 moves</a:t>
+                        <a:t>Birthdays, parties &amp; gifts</a:t>
                       </a:r>
                     </a:p>
                     <a:p>
@@ -9334,7 +9284,7 @@
                           </a:solidFill>
                           <a:latin typeface="Segoe UI"/>
                         </a:rPr>
-                        <a:t>🦁 28 new animals (51 total): lion, tiger, unicorn, deer, sheep, cow, raccoon, red panda, monkey, hedgehog, dino, squirrel, mouse, koala, shark, dolphin, seal, otter, pufferfish, duck, crab, parrot, chick, ladybug, phoenix, pegasus, ghost and flamingo; 🎩 31 new shop items: top hat, cowboy, chef, pirate, Santa, viking, graduation cap, beret, bow, propeller cap, flower crown, nerd glasses, eyepatch, mustache, goggles, masquerade mask, tie, pearls, flower lei, gold chain, balloon, backpack, guitar, shield, butterfly / devil wings and more - plus Premium galaxy crown, galaxy cape and dragon wings; 💃 13 new moves: wave, jump, hearts, sing, yoga, zoomies, cartwheel, juggle, rain dance, breakdance, magic, confetti and the Premium rocket launch; The Shop is now split into sections (Hats, Face, Neck, Back, Moves, Arena gear) with an owned counter for each</a:t>
+                        <a:t>Set your birthday in Social → Profile (month + day, optionally visible to friends).; On your birthday Pips throws confetti and gives you 100 bonus coins.; Friends tab shows upcoming birthdays; you get reminders 3 days, 1 day and on the day.; Birthday parties: join a friend's party, see who's there, sign the guestbook and celebrate together.</a:t>
                       </a:r>
                     </a:p>
                   </a:txBody>
@@ -9358,7 +9308,7 @@
                           </a:solidFill>
                           <a:latin typeface="Segoe UI"/>
                         </a:rPr>
-                        <a:t>2.11.0</a:t>
+                        <a:t>2.12.0</a:t>
                       </a:r>
                     </a:p>
                   </a:txBody>
@@ -9402,7 +9352,7 @@
                           </a:solidFill>
                           <a:latin typeface="Segoe UI"/>
                         </a:rPr>
-                        <a:t>New right-click menus</a:t>
+                        <a:t>Mega update: 28 new animals, 31 shop items, 13 moves</a:t>
                       </a:r>
                     </a:p>
                     <a:p>
@@ -9413,7 +9363,7 @@
                           </a:solidFill>
                           <a:latin typeface="Segoe UI"/>
                         </a:rPr>
-                        <a:t>✨ Brand-new animated right-click menu for your pet: mood &amp; stat bars, quick-action tiles (Friends, Shop, Snack, Pat, Focus, Stats, Sleep, Taskbar), hover effects and smooth fly-out submenus; Pick colours from swatches, switch size with one click and flip Sounds / Dark mode with toggle switches - changes show instantly; Updates are highlighted: a glowing banner and NEW badge appear in the menu when a new version is ready; The focus card's right-click menu got the same new look; keyboard arrows, Enter and Esc work too</a:t>
+                        <a:t>🦁 28 new animals (51 total): lion, tiger, unicorn, deer, sheep, cow, raccoon, red panda, monkey, hedgehog, dino, squirrel, mouse, koala, shark, dolphin, seal, otter, pufferfish, duck, crab, parrot, chick, ladybug, phoenix, pegasus, ghost and flamingo; 🎩 31 new shop items: top hat, cowboy, chef, pirate, Santa, viking, graduation cap, beret, bow, propeller cap, flower crown, nerd glasses, eyepatch, mustache, goggles, masquerade mask, tie, pearls, flower lei, gold chain, balloon, backpack, guitar, shield, butterfly / devil wings and more - plus Premium galaxy crown, galaxy cape and dragon wings; 💃 13 new moves: wave, jump, hearts, sing, yoga, zoomies, cartwheel, juggle, rain dance, breakdance, magic, confetti and the Premium rocket launch; The Shop is now split into sections (Hats, Face, Neck, Back, Moves, Arena gear) with an owned counter for each</a:t>
                       </a:r>
                     </a:p>
                   </a:txBody>
@@ -9437,7 +9387,7 @@
                           </a:solidFill>
                           <a:latin typeface="Segoe UI"/>
                         </a:rPr>
-                        <a:t>2.10.0</a:t>
+                        <a:t>2.11.0</a:t>
                       </a:r>
                     </a:p>
                   </a:txBody>
@@ -9481,7 +9431,7 @@
                           </a:solidFill>
                           <a:latin typeface="Segoe UI"/>
                         </a:rPr>
-                        <a:t>Chat bots</a:t>
+                        <a:t>New right-click menus</a:t>
                       </a:r>
                     </a:p>
                     <a:p>
@@ -9492,7 +9442,7 @@
                           </a:solidFill>
                           <a:latin typeface="Segoe UI"/>
                         </a:rPr>
-                        <a:t>🤖 6 friendly chat bots in the Chat tab: Pip Helper (app questions), Coach Focus (focus tips from your real stats), Sunny (live weather for any city), Arena Master (battle tips + quick battle), Giggles (jokes &amp; games) and Guardian (safety &amp; reporting help); Private bot chats with suggestion chips, typing indicator and a clear button - your bot chats stay on your PC; Mention a bot in a group chat (e.g. @weather Batam) and it answers in the room for everyone; Bots reply in your app language; up to 120 bot messages per day</a:t>
+                        <a:t>✨ Brand-new animated right-click menu for your pet: mood &amp; stat bars, quick-action tiles (Friends, Shop, Snack, Pat, Focus, Stats, Sleep, Taskbar), hover effects and smooth fly-out submenus; Pick colours from swatches, switch size with one click and flip Sounds / Dark mode with toggle switches - changes show instantly; Updates are highlighted: a glowing banner and NEW badge appear in the menu when a new version is ready; The focus card's right-click menu got the same new look; keyboard arrows, Enter and Esc work too</a:t>
                       </a:r>
                     </a:p>
                   </a:txBody>
@@ -9516,7 +9466,7 @@
                           </a:solidFill>
                           <a:latin typeface="Segoe UI"/>
                         </a:rPr>
-                        <a:t>2.9.0</a:t>
+                        <a:t>2.10.0</a:t>
                       </a:r>
                     </a:p>
                   </a:txBody>
@@ -9560,7 +9510,7 @@
                           </a:solidFill>
                           <a:latin typeface="Segoe UI"/>
                         </a:rPr>
-                        <a:t>Location &amp; live weather</a:t>
+                        <a:t>Chat bots</a:t>
                       </a:r>
                     </a:p>
                     <a:p>
@@ -9571,7 +9521,7 @@
                           </a:solidFill>
                           <a:latin typeface="Segoe UI"/>
                         </a:rPr>
-                        <a:t>📍 Add your city in Profile → Location &amp; weather (auto-detect or search) - only your city and country are shown, never your exact position; Live weather banners on every profile with animations: rain, drizzle, thunderstorms with lightning, snow, fog, clouds, sunshine or a starry night - plus temperature, feels-like, humidity, wind and local time; Your own weather strip on top of the hub, and each friend's weather + local time in the friends list; Hide your location from others or remove it any time</a:t>
+                        <a:t>🤖 6 friendly chat bots in the Chat tab: Pip Helper (app questions), Coach Focus (focus tips from your real stats), Sunny (live weather for any city), Arena Master (battle tips + quick battle), Giggles (jokes &amp; games) and Guardian (safety &amp; reporting help); Private bot chats with suggestion chips, typing indicator and a clear button - your bot chats stay on your PC; Mention a bot in a group chat (e.g. @weather Batam) and it answers in the room for everyone; Bots reply in your app language; up to 120 bot messages per day</a:t>
                       </a:r>
                     </a:p>
                   </a:txBody>
@@ -9595,7 +9545,7 @@
                           </a:solidFill>
                           <a:latin typeface="Segoe UI"/>
                         </a:rPr>
-                        <a:t>2.8.0</a:t>
+                        <a:t>2.9.0</a:t>
                       </a:r>
                     </a:p>
                   </a:txBody>
@@ -9639,7 +9589,7 @@
                           </a:solidFill>
                           <a:latin typeface="Segoe UI"/>
                         </a:rPr>
-                        <a:t>Pips Arena - duels, gear &amp; live battles</a:t>
+                        <a:t>Location &amp; live weather</a:t>
                       </a:r>
                     </a:p>
                     <a:p>
@@ -9650,7 +9600,7 @@
                           </a:solidFill>
                           <a:latin typeface="Segoe UI"/>
                         </a:rPr>
-                        <a:t>⚔ New Arena tab: challenge friends or anyone in the arena to a live duel - each round pick Attack, Guard or Special within 12 seconds and watch your pets fight; ⚡ Quick battle: an instant auto-fight against anyone's fighter, even when they're offline; Arena gear in the Shop: 7 weapons (water pistol to rocket launcher), 5 armors and 5 gadgets that decide your special move - better gear and a higher level make a stronger fighter; Live duels can be watched by everyone, plus recent battle replays, top fighters, rating and win/loss records; wins earn coins</a:t>
+                        <a:t>📍 Add your city in Profile → Location &amp; weather (auto-detect or search) - only your city and country are shown, never your exact position; Live weather banners on every profile with animations: rain, drizzle, thunderstorms with lightning, snow, fog, clouds, sunshine or a starry night - plus temperature, feels-like, humidity, wind and local time; Your own weather strip on top of the hub, and each friend's weather + local time in the friends list; Hide your location from others or remove it any time</a:t>
                       </a:r>
                     </a:p>
                   </a:txBody>
@@ -9674,7 +9624,7 @@
                           </a:solidFill>
                           <a:latin typeface="Segoe UI"/>
                         </a:rPr>
-                        <a:t>2.7.0</a:t>
+                        <a:t>2.8.0</a:t>
                       </a:r>
                     </a:p>
                   </a:txBody>
@@ -9718,7 +9668,7 @@
                           </a:solidFill>
                           <a:latin typeface="Segoe UI"/>
                         </a:rPr>
-                        <a:t>Moderators &amp; Premium</a:t>
+                        <a:t>Pips Arena - duels, gear &amp; live battles</a:t>
                       </a:r>
                     </a:p>
                     <a:p>
@@ -9729,7 +9679,7 @@
                           </a:solidFill>
                           <a:latin typeface="Segoe UI"/>
                         </a:rPr>
-                        <a:t>★ Premium: a purple Premium badge, 4 exclusive props (tiara, star glasses, diamond necklace, fairy wings), the Fireworks move, +30 coins every day, double friend-interaction coins and room for 300 friends / 30 groups; Get Premium: Profile tab → Premium → "Ask to buy" emails the owner; after payment you receive a key (PIPS-XXXX-XXXX) to redeem right there; 🛡 Moderators: a blue Mod badge and a Mod tab with the report queue - warn, mute (1h / 24h / 7 days), clear a profile or reset a name; every action is logged; Report button on everyone's profile, so moderators can keep Pips friendly</a:t>
+                        <a:t>⚔ New Arena tab: challenge friends or anyone in the arena to a live duel - each round pick Attack, Guard or Special within 12 seconds and watch your pets fight; ⚡ Quick battle: an instant auto-fight against anyone's fighter, even when they're offline; Arena gear in the Shop: 7 weapons (water pistol to rocket launcher), 5 armors and 5 gadgets that decide your special move - better gear and a higher level make a stronger fighter; Live duels can be watched by everyone, plus recent battle replays, top fighters, rating and win/loss records; wins earn coins</a:t>
                       </a:r>
                     </a:p>
                   </a:txBody>
@@ -9753,7 +9703,7 @@
                           </a:solidFill>
                           <a:latin typeface="Segoe UI"/>
                         </a:rPr>
-                        <a:t>2.6.1</a:t>
+                        <a:t>2.7.0</a:t>
                       </a:r>
                     </a:p>
                   </a:txBody>
@@ -9797,7 +9747,7 @@
                           </a:solidFill>
                           <a:latin typeface="Segoe UI"/>
                         </a:rPr>
-                        <a:t>Owner badge &amp; credits</a:t>
+                        <a:t>Moderators &amp; Premium</a:t>
                       </a:r>
                     </a:p>
                     <a:p>
@@ -9808,7 +9758,7 @@
                           </a:solidFill>
                           <a:latin typeface="Segoe UI"/>
                         </a:rPr>
-                        <a:t>The creator of Pips (Juwen Lie) now shows a gold ♛ Owner badge on his profile, friend list and ranks; New About Pips card in the Profile tab: credits and how to contact the owner (Juwen_Lie@pegatroncorp.com) with Email and Copy buttons; Right-click the pet → Help → About now shows who made Pips and the contact email</a:t>
+                        <a:t>★ Premium: a purple Premium badge, 4 exclusive props (tiara, star glasses, diamond necklace, fairy wings), the Fireworks move, +30 coins every day, double friend-interaction coins and room for 300 friends / 30 groups; Get Premium: Profile tab → Premium → "Ask to buy" emails the owner; after payment you receive a key (PIPS-XXXX-XXXX) to redeem right there; 🛡 Moderators: a blue Mod badge and a Mod tab with the report queue - warn, mute (1h / 24h / 7 days), clear a profile or reset a name; every action is logged; Report button on everyone's profile, so moderators can keep Pips friendly</a:t>
                       </a:r>
                     </a:p>
                   </a:txBody>
@@ -9832,7 +9782,7 @@
                           </a:solidFill>
                           <a:latin typeface="Segoe UI"/>
                         </a:rPr>
-                        <a:t>2.6.0</a:t>
+                        <a:t>2.6.1</a:t>
                       </a:r>
                     </a:p>
                   </a:txBody>
@@ -9876,7 +9826,7 @@
                           </a:solidFill>
                           <a:latin typeface="Segoe UI"/>
                         </a:rPr>
-                        <a:t>Profiles, ranks, online status &amp; dark mode</a:t>
+                        <a:t>Owner badge &amp; credits</a:t>
                       </a:r>
                     </a:p>
                     <a:p>
@@ -9887,7 +9837,7 @@
                           </a:solidFill>
                           <a:latin typeface="Segoe UI"/>
                         </a:rPr>
-                        <a:t>Profile tab: profile picture (or your pet), about me, job, location, hobbies, birthday and a status message; Public or private: public profiles can be added directly and viewed in full; private profiles need a friend request that they accept, and strangers only see name, photo, pet, level and status; Click anyone to open their profile - badges, info, their friends - and add them, chat or wave from there; Ranks tab replaces Teams: everyone using Pips, sorted by XP, badges or streak</a:t>
+                        <a:t>The creator of Pips (Juwen Lie) now shows a gold ♛ Owner badge on his profile, friend list and ranks; New About Pips card in the Profile tab: credits and how to contact the owner (Juwen_Lie@pegatroncorp.com) with Email and Copy buttons; Right-click the pet → Help → About now shows who made Pips and the contact email</a:t>
                       </a:r>
                     </a:p>
                   </a:txBody>
@@ -9911,7 +9861,7 @@
                           </a:solidFill>
                           <a:latin typeface="Segoe UI"/>
                         </a:rPr>
-                        <a:t>2.5.1</a:t>
+                        <a:t>2.6.0</a:t>
                       </a:r>
                     </a:p>
                   </a:txBody>
@@ -9955,7 +9905,7 @@
                           </a:solidFill>
                           <a:latin typeface="Segoe UI"/>
                         </a:rPr>
-                        <a:t>New cute Pips logo</a:t>
+                        <a:t>Profiles, ranks, online status &amp; dark mode</a:t>
                       </a:r>
                     </a:p>
                     <a:p>
@@ -9966,7 +9916,7 @@
                           </a:solidFill>
                           <a:latin typeface="Segoe UI"/>
                         </a:rPr>
-                        <a:t>New Pips logo: Pip the cat on a Pips-red tile, matching the app colours (desktop shortcut, windows and website)</a:t>
+                        <a:t>Profile tab: profile picture (or your pet), about me, job, location, hobbies, birthday and a status message; Public or private: public profiles can be added directly and viewed in full; private profiles need a friend request that they accept, and strangers only see name, photo, pet, level and status; Click anyone to open their profile - badges, info, their friends - and add them, chat or wave from there; Ranks tab replaces Teams: everyone using Pips, sorted by XP, badges or streak</a:t>
                       </a:r>
                     </a:p>
                   </a:txBody>
@@ -9990,7 +9940,7 @@
                           </a:solidFill>
                           <a:latin typeface="Segoe UI"/>
                         </a:rPr>
-                        <a:t>2.5.0</a:t>
+                        <a:t>2.5.1</a:t>
                       </a:r>
                     </a:p>
                   </a:txBody>
@@ -10034,7 +9984,7 @@
                           </a:solidFill>
                           <a:latin typeface="Segoe UI"/>
                         </a:rPr>
-                        <a:t>Shop, coins, props &amp; moves</a:t>
+                        <a:t>New cute Pips logo</a:t>
                       </a:r>
                     </a:p>
                     <a:p>
@@ -10045,7 +9995,7 @@
                           </a:solidFill>
                           <a:latin typeface="Segoe UI"/>
                         </a:rPr>
-                        <a:t>Shop: earn coins and spend them on your pet - 17 props (crown, wizard hat, headphones, shades, scarf, cape, angel wings...) and 6 moves: spin, dance, moonwalk, backflip, kung fu and spider swing!; Coins come from leveling up (+40), badges (+25), opening Pips each day (+10), friendships (+15 per affinity level), waving / chatting / visiting friends (+2) and pomodoros (+5). Everyone starts with a 100-coin gift; Your friends see your props: on avatars in the hub and when your pet visits their desktop - it shows off one of your moves; Pips is now a social pet: clicking the pet opens the Pips hub (friends, chat, groups, shop, badges)</a:t>
+                        <a:t>New Pips logo: Pip the cat on a Pips-red tile, matching the app colours (desktop shortcut, windows and website)</a:t>
                       </a:r>
                     </a:p>
                   </a:txBody>
@@ -10069,7 +10019,7 @@
                           </a:solidFill>
                           <a:latin typeface="Segoe UI"/>
                         </a:rPr>
-                        <a:t>2.4.0</a:t>
+                        <a:t>2.5.0</a:t>
                       </a:r>
                     </a:p>
                   </a:txBody>
@@ -10113,7 +10063,7 @@
                           </a:solidFill>
                           <a:latin typeface="Segoe UI"/>
                         </a:rPr>
-                        <a:t>Chat, groups, affinity &amp; pet visits</a:t>
+                        <a:t>Shop, coins, props &amp; moves</a:t>
                       </a:r>
                     </a:p>
                     <a:p>
@@ -10124,7 +10074,7 @@
                           </a:solidFill>
                           <a:latin typeface="Segoe UI"/>
                         </a:rPr>
-                        <a:t>Chat: message your friends, and chat inside groups. Your pet pops up new messages as a bubble - click it to reply; Pet interactions: wave, pet their pet, send a snack, high five - or send your pet to visit: it walks onto your friend's desktop for a little while!; Affinity: every chat and interaction grows your friendship - Acquaintance → Buddy → Good friends → Close friends → Best friends → Soulmates; Your own groups: create a private group, invite your friends, they accept or decline. Group board + group chat; the owner can remove members</a:t>
+                        <a:t>Shop: earn coins and spend them on your pet - 17 props (crown, wizard hat, headphones, shades, scarf, cape, angel wings...) and 6 moves: spin, dance, moonwalk, backflip, kung fu and spider swing!; Coins come from leveling up (+40), badges (+25), opening Pips each day (+10), friendships (+15 per affinity level), waving / chatting / visiting friends (+2) and pomodoros (+5). Everyone starts with a 100-coin gift; Your friends see your props: on avatars in the hub and when your pet visits their desktop - it shows off one of your moves; Pips is now a social pet: clicking the pet opens the Pips hub (friends, chat, groups, shop, badges)</a:t>
                       </a:r>
                     </a:p>
                   </a:txBody>
@@ -10148,7 +10098,7 @@
                           </a:solidFill>
                           <a:latin typeface="Segoe UI"/>
                         </a:rPr>
-                        <a:t>2.3.0</a:t>
+                        <a:t>2.4.0</a:t>
                       </a:r>
                     </a:p>
                   </a:txBody>
@@ -10192,7 +10142,7 @@
                           </a:solidFill>
                           <a:latin typeface="Segoe UI"/>
                         </a:rPr>
-                        <a:t>Friends, levels &amp; achievements</a:t>
+                        <a:t>Chat, groups, affinity &amp; pet visits</a:t>
                       </a:r>
                     </a:p>
                     <a:p>
@@ -10203,7 +10153,7 @@
                           </a:solidFill>
                           <a:latin typeface="Segoe UI"/>
                         </a:rPr>
-                        <a:t>Levels &amp; XP: every finished pomodoro earns XP and your level grows - plus 20 achievements to unlock (first tomato, 8 in a day, 7-day streak, early bird, night owl, pet lover...). Your pet celebrates each one; Friends (optional, off by default): get a 6-letter friend code, add colleagues, see today's board and join a team board like PTB. Your pet tells you when a friend finishes a pomodoro; Privacy: only your name, pet, level, streak and pomodoro counts are shared - never apps, window titles or scores. One click turns it off and deletes your online data. Right-click the pet → Friends &amp; achievements…</a:t>
+                        <a:t>Chat: message your friends, and chat inside groups. Your pet pops up new messages as a bubble - click it to reply; Pet interactions: wave, pet their pet, send a snack, high five - or send your pet to visit: it walks onto your friend's desktop for a little while!; Affinity: every chat and interaction grows your friendship - Acquaintance → Buddy → Good friends → Close friends → Best friends → Soulmates; Your own groups: create a private group, invite your friends, they accept or decline. Group board + group chat; the owner can remove members</a:t>
                       </a:r>
                     </a:p>
                   </a:txBody>
@@ -10227,7 +10177,7 @@
                           </a:solidFill>
                           <a:latin typeface="Segoe UI"/>
                         </a:rPr>
-                        <a:t>2.2.0</a:t>
+                        <a:t>2.3.0</a:t>
                       </a:r>
                     </a:p>
                   </a:txBody>
@@ -10271,7 +10221,7 @@
                           </a:solidFill>
                           <a:latin typeface="Segoe UI"/>
                         </a:rPr>
-                        <a:t>Pet sounds</a:t>
+                        <a:t>Friends, levels &amp; achievements</a:t>
                       </a:r>
                     </a:p>
                     <a:p>
@@ -10282,7 +10232,7 @@
                           </a:solidFill>
                           <a:latin typeface="Segoe UI"/>
                         </a:rPr>
-                        <a:t>Your pet has a voice! Each of the 23 animals has its own sound (meow, woof, ribbit, hoot, buzz, oink, whale song...) and it changes with its mood: happy chirps, sad whimpers, sleepy yawns, hungry calls, grumpy huffs and soft snores; It also reacts with sound when you tickle, pet, feed, shake or wake it; Settings: right-click the pet → Sounds to switch on/off; Pet status &amp; settings has a volume slider, a ▶ Hear me button and "Stay quiet while I'm focusing" (on by default)</a:t>
+                        <a:t>Levels &amp; XP: every finished pomodoro earns XP and your level grows - plus 20 achievements to unlock (first tomato, 8 in a day, 7-day streak, early bird, night owl, pet lover...). Your pet celebrates each one; Friends (optional, off by default): get a 6-letter friend code, add colleagues, see today's board and join a team board like PTB. Your pet tells you when a friend finishes a pomodoro; Privacy: only your name, pet, level, streak and pomodoro counts are shared - never apps, window titles or scores. One click turns it off and deletes your online data. Right-click the pet → Friends &amp; achievements…</a:t>
                       </a:r>
                     </a:p>
                   </a:txBody>
@@ -10306,7 +10256,7 @@
                           </a:solidFill>
                           <a:latin typeface="Segoe UI"/>
                         </a:rPr>
-                        <a:t>2.1.2</a:t>
+                        <a:t>2.2.0</a:t>
                       </a:r>
                     </a:p>
                   </a:txBody>
@@ -10350,7 +10300,7 @@
                           </a:solidFill>
                           <a:latin typeface="Segoe UI"/>
                         </a:rPr>
-                        <a:t>Tickle-only mode</a:t>
+                        <a:t>Pet sounds</a:t>
                       </a:r>
                     </a:p>
                     <a:p>
@@ -10361,7 +10311,7 @@
                           </a:solidFill>
                           <a:latin typeface="Segoe UI"/>
                         </a:rPr>
-                        <a:t>New click option "Only tickle (never open Pips)": click and tickle your pet as much as you like - the Pomodoro window stays closed (open it from the right-click menu). Right-click the pet → When I click</a:t>
+                        <a:t>Your pet has a voice! Each of the 23 animals has its own sound (meow, woof, ribbit, hoot, buzz, oink, whale song...) and it changes with its mood: happy chirps, sad whimpers, sleepy yawns, hungry calls, grumpy huffs and soft snores; It also reacts with sound when you tickle, pet, feed, shake or wake it; Settings: right-click the pet → Sounds to switch on/off; Pet status &amp; settings has a volume slider, a ▶ Hear me button and "Stay quiet while I'm focusing" (on by default)</a:t>
                       </a:r>
                     </a:p>
                   </a:txBody>
@@ -10385,7 +10335,7 @@
                           </a:solidFill>
                           <a:latin typeface="Segoe UI"/>
                         </a:rPr>
-                        <a:t>2.1.1</a:t>
+                        <a:t>2.1.2</a:t>
                       </a:r>
                     </a:p>
                   </a:txBody>
@@ -10429,7 +10379,7 @@
                           </a:solidFill>
                           <a:latin typeface="Segoe UI"/>
                         </a:rPr>
-                        <a:t>Owner info</a:t>
+                        <a:t>Tickle-only mode</a:t>
                       </a:r>
                     </a:p>
                     <a:p>
@@ -10440,7 +10390,7 @@
                           </a:solidFill>
                           <a:latin typeface="Segoe UI"/>
                         </a:rPr>
-                        <a:t>About Pips now shows the owner: Juwen Lie (right-click the pet → Help → About)</a:t>
+                        <a:t>New click option "Only tickle (never open Pips)": click and tickle your pet as much as you like - the Pomodoro window stays closed (open it from the right-click menu). Right-click the pet → When I click</a:t>
                       </a:r>
                     </a:p>
                   </a:txBody>
@@ -10464,7 +10414,7 @@
                           </a:solidFill>
                           <a:latin typeface="Segoe UI"/>
                         </a:rPr>
-                        <a:t>2.1.0</a:t>
+                        <a:t>2.1.1</a:t>
                       </a:r>
                     </a:p>
                   </a:txBody>
@@ -10508,7 +10458,7 @@
                           </a:solidFill>
                           <a:latin typeface="Segoe UI"/>
                         </a:rPr>
-                        <a:t>Interactive guide &amp; in-app updates</a:t>
+                        <a:t>Owner info</a:t>
                       </a:r>
                     </a:p>
                     <a:p>
@@ -10519,7 +10469,7 @@
                           </a:solidFill>
                           <a:latin typeface="Segoe UI"/>
                         </a:rPr>
-                        <a:t>Interactive first-run guide: your pet walks you through clicking, dragging, petting and the right-click menu; In-app updates: Pips tells you when a new version is out - update with one click (your settings and data are kept); New Help menu: replay the guide, check for updates, see the version; Option to turn automatic update checks off</a:t>
+                        <a:t>About Pips now shows the owner: Juwen Lie (right-click the pet → Help → About)</a:t>
                       </a:r>
                     </a:p>
                   </a:txBody>
@@ -10543,7 +10493,7 @@
                           </a:solidFill>
                           <a:latin typeface="Segoe UI"/>
                         </a:rPr>
-                        <a:t>2.0.0</a:t>
+                        <a:t>2.1.0</a:t>
                       </a:r>
                     </a:p>
                   </a:txBody>
@@ -10587,7 +10537,7 @@
                           </a:solidFill>
                           <a:latin typeface="Segoe UI"/>
                         </a:rPr>
-                        <a:t>Desktop pet, 23 animals &amp; 4 languages</a:t>
+                        <a:t>Interactive guide &amp; in-app updates</a:t>
                       </a:r>
                     </a:p>
                     <a:p>
@@ -10598,7 +10548,7 @@
                           </a:solidFill>
                           <a:latin typeface="Segoe UI"/>
                         </a:rPr>
-                        <a:t>Desktop pet that lives on your desktop and taskbar - drag it, tickle it, pet it; 23 animals in 3 groups: Land walks, Water swims with bubbles, Sky hovers and flaps; Moods (happy, sad, tired, hungry, grumpy...), naps when you're away, wakes up when you're back; Cute chat-bubble reminders: breaks, water, 20-20-20 eye rest, pomodoro done, daily goal</a:t>
+                        <a:t>Interactive first-run guide: your pet walks you through clicking, dragging, petting and the right-click menu; In-app updates: Pips tells you when a new version is out - update with one click (your settings and data are kept); New Help menu: replay the guide, check for updates, see the version; Option to turn automatic update checks off</a:t>
                       </a:r>
                     </a:p>
                   </a:txBody>
@@ -10622,7 +10572,7 @@
                           </a:solidFill>
                           <a:latin typeface="Segoe UI"/>
                         </a:rPr>
-                        <a:t>1.5.0</a:t>
+                        <a:t>2.0.0</a:t>
                       </a:r>
                     </a:p>
                   </a:txBody>
@@ -10644,7 +10594,7 @@
                           </a:solidFill>
                           <a:latin typeface="Segoe UI"/>
                         </a:rPr>
-                        <a:t>2026-10-24</a:t>
+                        <a:t>2026-10-28</a:t>
                       </a:r>
                     </a:p>
                   </a:txBody>
@@ -10666,7 +10616,7 @@
                           </a:solidFill>
                           <a:latin typeface="Segoe UI"/>
                         </a:rPr>
-                        <a:t>Renamed to Pips + insights</a:t>
+                        <a:t>Desktop pet, 23 animals &amp; 4 languages</a:t>
                       </a:r>
                     </a:p>
                     <a:p>
@@ -10677,7 +10627,7 @@
                           </a:solidFill>
                           <a:latin typeface="Segoe UI"/>
                         </a:rPr>
-                        <a:t>Renamed from Productivity Widget to Pips; Dashboard charts: focus timeline, hour heatmap, 7-day score trend, pomodoros per day; AI token usage on the card and dashboard; Daily diary export and weekly / monthly reports</a:t>
+                        <a:t>Desktop pet that lives on your desktop and taskbar - drag it, tickle it, pet it; 23 animals in 3 groups: Land walks, Water swims with bubbles, Sky hovers and flaps; Moods (happy, sad, tired, hungry, grumpy...), naps when you're away, wakes up when you're back; Cute chat-bubble reminders: breaks, water, 20-20-20 eye rest, pomodoro done, daily goal</a:t>
                       </a:r>
                     </a:p>
                   </a:txBody>
@@ -10701,7 +10651,7 @@
                           </a:solidFill>
                           <a:latin typeface="Segoe UI"/>
                         </a:rPr>
-                        <a:t>1.0.0</a:t>
+                        <a:t>1.5.0</a:t>
                       </a:r>
                     </a:p>
                   </a:txBody>
@@ -10723,7 +10673,7 @@
                           </a:solidFill>
                           <a:latin typeface="Segoe UI"/>
                         </a:rPr>
-                        <a:t>2026-10-21</a:t>
+                        <a:t>2026-10-24</a:t>
                       </a:r>
                     </a:p>
                   </a:txBody>
@@ -10745,7 +10695,7 @@
                           </a:solidFill>
                           <a:latin typeface="Segoe UI"/>
                         </a:rPr>
-                        <a:t>First release</a:t>
+                        <a:t>Renamed to Pips + insights</a:t>
                       </a:r>
                     </a:p>
                     <a:p>
@@ -10756,13 +10706,92 @@
                           </a:solidFill>
                           <a:latin typeface="Segoe UI"/>
                         </a:rPr>
-                        <a:t>Always-on-top Pomodoro card with progress ring; Rain / thunder / brown-noise / cafe soundscapes; Live app-usage tracking and a daily 1-5 star focus score; Goals, streaks, XP, coach tips and break reminders</a:t>
+                        <a:t>Renamed from Productivity Widget to Pips; Dashboard charts: focus timeline, hour heatmap, 7-day score trend, pomodoros per day; AI token usage on the card and dashboard; Daily diary export and weekly / monthly reports</a:t>
                       </a:r>
                     </a:p>
                   </a:txBody>
                   <a:tcPr marL="73152" marR="73152" marT="36576" marB="36576">
                     <a:solidFill>
                       <a:srgbClr val="F7F4EC"/>
+                    </a:solidFill>
+                  </a:tcPr>
+                </a:tc>
+              </a:tr>
+              <a:tr h="822960">
+                <a:tc>
+                  <a:txBody>
+                    <a:bodyPr wrap="square"/>
+                    <a:lstStyle/>
+                    <a:p>
+                      <a:r>
+                        <a:rPr sz="1200" b="1">
+                          <a:solidFill>
+                            <a:srgbClr val="2B2A28"/>
+                          </a:solidFill>
+                          <a:latin typeface="Segoe UI"/>
+                        </a:rPr>
+                        <a:t>1.0.0</a:t>
+                      </a:r>
+                    </a:p>
+                  </a:txBody>
+                  <a:tcPr marL="73152" marR="73152" marT="36576" marB="36576">
+                    <a:solidFill>
+                      <a:srgbClr val="FFFDF8"/>
+                    </a:solidFill>
+                  </a:tcPr>
+                </a:tc>
+                <a:tc>
+                  <a:txBody>
+                    <a:bodyPr wrap="square"/>
+                    <a:lstStyle/>
+                    <a:p>
+                      <a:r>
+                        <a:rPr sz="1200" b="0">
+                          <a:solidFill>
+                            <a:srgbClr val="2B2A28"/>
+                          </a:solidFill>
+                          <a:latin typeface="Segoe UI"/>
+                        </a:rPr>
+                        <a:t>2026-10-21</a:t>
+                      </a:r>
+                    </a:p>
+                  </a:txBody>
+                  <a:tcPr marL="73152" marR="73152" marT="36576" marB="36576">
+                    <a:solidFill>
+                      <a:srgbClr val="FFFDF8"/>
+                    </a:solidFill>
+                  </a:tcPr>
+                </a:tc>
+                <a:tc>
+                  <a:txBody>
+                    <a:bodyPr wrap="square"/>
+                    <a:lstStyle/>
+                    <a:p>
+                      <a:r>
+                        <a:rPr sz="1200" b="0">
+                          <a:solidFill>
+                            <a:srgbClr val="2B2A28"/>
+                          </a:solidFill>
+                          <a:latin typeface="Segoe UI"/>
+                        </a:rPr>
+                        <a:t>First release</a:t>
+                      </a:r>
+                    </a:p>
+                    <a:p>
+                      <a:r>
+                        <a:rPr sz="1200" b="0">
+                          <a:solidFill>
+                            <a:srgbClr val="2B2A28"/>
+                          </a:solidFill>
+                          <a:latin typeface="Segoe UI"/>
+                        </a:rPr>
+                        <a:t>Always-on-top Pomodoro card with progress ring; Rain / thunder / brown-noise / cafe soundscapes; Live app-usage tracking and a daily 1-5 star focus score; Goals, streaks, XP, coach tips and break reminders</a:t>
+                      </a:r>
+                    </a:p>
+                  </a:txBody>
+                  <a:tcPr marL="73152" marR="73152" marT="36576" marB="36576">
+                    <a:solidFill>
+                      <a:srgbClr val="FFFDF8"/>
                     </a:solidFill>
                   </a:tcPr>
                 </a:tc>

</xml_diff>

<commit_message>
pips 2.15.0: Update reminders
</commit_message>
<xml_diff>
--- a/apps/pips/web/download/Pips-Guide.pptx
+++ b/apps/pips/web/download/Pips-Guide.pptx
@@ -3292,7 +3292,7 @@
                 </a:solidFill>
                 <a:latin typeface="Segoe UI"/>
               </a:rPr>
-              <a:t>Version 2.14.3  ·  2026-10-29  ·  Made by Juwen Lie (owner)</a:t>
+              <a:t>Version 2.15.0  ·  2026-10-29  ·  Made by Juwen Lie (owner)</a:t>
             </a:r>
           </a:p>
           <a:p>
@@ -8166,7 +8166,7 @@
                 </a:solidFill>
                 <a:latin typeface="Segoe UI"/>
               </a:rPr>
-              <a:t>What's new in 2.14.3</a:t>
+              <a:t>What's new in 2.15.0</a:t>
             </a:r>
           </a:p>
         </p:txBody>
@@ -8279,7 +8279,7 @@
                 </a:solidFill>
                 <a:latin typeface="Segoe UI"/>
               </a:rPr>
-              <a:t>Tidy menus  ·  2026-10-29</a:t>
+              <a:t>Update reminders  ·  2026-10-29</a:t>
             </a:r>
           </a:p>
         </p:txBody>
@@ -8327,7 +8327,7 @@
                 </a:solidFill>
                 <a:latin typeface="Segoe UI"/>
               </a:rPr>
-              <a:t>Fixed: a submenu (e.g. Poke a friend) could stay floating on the screen after the right-click menu closed.</a:t>
+              <a:t>Owner &amp; moderators: the Mod tab now lists who hasn't updated Pips yet (their version and when they were last seen), with one-click reminders by e-mail (sent from your Outlook) or a ready-to-send Teams chat.</a:t>
             </a:r>
           </a:p>
           <a:p>
@@ -8352,7 +8352,57 @@
                 </a:solidFill>
                 <a:latin typeface="Segoe UI"/>
               </a:rPr>
-              <a:t>Menus now close by themselves when you move the mouse away and leave them for a few seconds.</a:t>
+              <a:t>New Work e-mail field in your Profile, filled in from Outlook. Only the owner and moderators can see it (for update reminders and support) - clear it to hide it.</a:t>
+            </a:r>
+          </a:p>
+          <a:p>
+            <a:pPr>
+              <a:spcAft>
+                <a:spcPts val="1000"/>
+              </a:spcAft>
+            </a:pPr>
+            <a:r>
+              <a:rPr sz="1700" b="1">
+                <a:solidFill>
+                  <a:srgbClr val="4CB86B"/>
+                </a:solidFill>
+                <a:latin typeface="Segoe UI"/>
+              </a:rPr>
+              <a:t>•  </a:t>
+            </a:r>
+            <a:r>
+              <a:rPr sz="1700">
+                <a:solidFill>
+                  <a:srgbClr val="2B2A28"/>
+                </a:solidFill>
+                <a:latin typeface="Segoe UI"/>
+              </a:rPr>
+              <a:t>Pips now tells the Friends server which version it runs, so the update list is always accurate.</a:t>
+            </a:r>
+          </a:p>
+          <a:p>
+            <a:pPr>
+              <a:spcAft>
+                <a:spcPts val="1000"/>
+              </a:spcAft>
+            </a:pPr>
+            <a:r>
+              <a:rPr sz="1700" b="1">
+                <a:solidFill>
+                  <a:srgbClr val="4CB86B"/>
+                </a:solidFill>
+                <a:latin typeface="Segoe UI"/>
+              </a:rPr>
+              <a:t>•  </a:t>
+            </a:r>
+            <a:r>
+              <a:rPr sz="1700">
+                <a:solidFill>
+                  <a:srgbClr val="2B2A28"/>
+                </a:solidFill>
+                <a:latin typeface="Segoe UI"/>
+              </a:rPr>
+              <a:t>Friends keeps working when a local proxy tool stops answering - Pips falls back to the Windows proxy settings.</a:t>
             </a:r>
           </a:p>
         </p:txBody>
@@ -8483,7 +8533,7 @@
                 </a:solidFill>
                 <a:latin typeface="Segoe UI"/>
               </a:rPr>
-              <a:t>Diperbaiki: submenu (mis. Colek teman) bisa tertinggal melayang di layar setelah menu klik kanan ditutup.</a:t>
+              <a:t>Pemilik &amp; moderator: tab Mod kini menampilkan siapa yang belum update Pips (versinya dan kapan terakhir terlihat), dengan pengingat sekali klik lewat email (dikirim dari Outlook-mu) atau chat Teams yang siap kirim.</a:t>
             </a:r>
           </a:p>
           <a:p>
@@ -8508,7 +8558,57 @@
                 </a:solidFill>
                 <a:latin typeface="Segoe UI"/>
               </a:rPr>
-              <a:t>Menu kini menutup sendiri jika mouse dijauhkan dan dibiarkan beberapa detik.</a:t>
+              <a:t>Kolom baru Email kerja di Profil, diisi otomatis dari Outlook. Hanya pemilik dan moderator yang bisa melihatnya (untuk pengingat update dan bantuan) - kosongkan untuk menyembunyikan.</a:t>
+            </a:r>
+          </a:p>
+          <a:p>
+            <a:pPr>
+              <a:spcAft>
+                <a:spcPts val="500"/>
+              </a:spcAft>
+            </a:pPr>
+            <a:r>
+              <a:rPr sz="1200" b="1">
+                <a:solidFill>
+                  <a:srgbClr val="4CB86B"/>
+                </a:solidFill>
+                <a:latin typeface="Segoe UI"/>
+              </a:rPr>
+              <a:t>•  </a:t>
+            </a:r>
+            <a:r>
+              <a:rPr sz="1200">
+                <a:solidFill>
+                  <a:srgbClr val="2B2A28"/>
+                </a:solidFill>
+                <a:latin typeface="Segoe UI"/>
+              </a:rPr>
+              <a:t>Pips kini memberi tahu server Teman versi yang dipakai, jadi daftar update selalu akurat.</a:t>
+            </a:r>
+          </a:p>
+          <a:p>
+            <a:pPr>
+              <a:spcAft>
+                <a:spcPts val="500"/>
+              </a:spcAft>
+            </a:pPr>
+            <a:r>
+              <a:rPr sz="1200" b="1">
+                <a:solidFill>
+                  <a:srgbClr val="4CB86B"/>
+                </a:solidFill>
+                <a:latin typeface="Segoe UI"/>
+              </a:rPr>
+              <a:t>•  </a:t>
+            </a:r>
+            <a:r>
+              <a:rPr sz="1200">
+                <a:solidFill>
+                  <a:srgbClr val="2B2A28"/>
+                </a:solidFill>
+                <a:latin typeface="Segoe UI"/>
+              </a:rPr>
+              <a:t>Fitur Teman tetap jalan saat alat proxy lokal tidak merespons - Pips beralih ke pengaturan proxy Windows.</a:t>
             </a:r>
           </a:p>
         </p:txBody>
@@ -8740,7 +8840,7 @@
         </p:nvGraphicFramePr>
         <p:xfrm>
           <a:off x="548640" y="1645920"/>
-          <a:ext cx="11155680" cy="20958048"/>
+          <a:ext cx="11155680" cy="21781008"/>
         </p:xfrm>
         <a:graphic>
           <a:graphicData uri="http://schemas.openxmlformats.org/drawingml/2006/table">
@@ -8834,7 +8934,7 @@
                           </a:solidFill>
                           <a:latin typeface="Segoe UI"/>
                         </a:rPr>
-                        <a:t>2.14.3</a:t>
+                        <a:t>2.15.0</a:t>
                       </a:r>
                     </a:p>
                   </a:txBody>
@@ -8878,7 +8978,7 @@
                           </a:solidFill>
                           <a:latin typeface="Segoe UI"/>
                         </a:rPr>
-                        <a:t>Tidy menus</a:t>
+                        <a:t>Update reminders</a:t>
                       </a:r>
                     </a:p>
                     <a:p>
@@ -8889,7 +8989,7 @@
                           </a:solidFill>
                           <a:latin typeface="Segoe UI"/>
                         </a:rPr>
-                        <a:t>Fixed: a submenu (e.g. Poke a friend) could stay floating on the screen after the right-click menu closed.; Menus now close by themselves when you move the mouse away and leave them for a few seconds.</a:t>
+                        <a:t>Owner &amp; moderators: the Mod tab now lists who hasn't updated Pips yet (their version and when they were last seen), with one-click reminders by e-mail (sent from your Outlook) or a ready-to-send Teams chat.; New Work e-mail field in your Profile, filled in from Outlook. Only the owner and moderators can see it (for update reminders and support) - clear it to hide it.; Pips now tells the Friends server which version it runs, so the update list is always accurate.; Friends keeps working when a local proxy tool stops answering - Pips falls back to the Windows proxy settings.</a:t>
                       </a:r>
                     </a:p>
                   </a:txBody>
@@ -8913,7 +9013,7 @@
                           </a:solidFill>
                           <a:latin typeface="Segoe UI"/>
                         </a:rPr>
-                        <a:t>2.14.2</a:t>
+                        <a:t>2.14.3</a:t>
                       </a:r>
                     </a:p>
                   </a:txBody>
@@ -8957,7 +9057,7 @@
                           </a:solidFill>
                           <a:latin typeface="Segoe UI"/>
                         </a:rPr>
-                        <a:t>Never miss an update</a:t>
+                        <a:t>Tidy menus</a:t>
                       </a:r>
                     </a:p>
                     <a:p>
@@ -8968,7 +9068,7 @@
                           </a:solidFill>
                           <a:latin typeface="Segoe UI"/>
                         </a:rPr>
-                        <a:t>Your pet now reminds you every 2 hours while a new version is waiting (instead of every 6 hours).; If the reminder can't show (fullscreen app, guided tour, another message), your pet tries again a few minutes later.; No internet when Pips starts (e.g. VPN off)? It checks again after an hour.</a:t>
+                        <a:t>Fixed: a submenu (e.g. Poke a friend) could stay floating on the screen after the right-click menu closed.; Menus now close by themselves when you move the mouse away and leave them for a few seconds.</a:t>
                       </a:r>
                     </a:p>
                   </a:txBody>
@@ -8992,7 +9092,7 @@
                           </a:solidFill>
                           <a:latin typeface="Segoe UI"/>
                         </a:rPr>
-                        <a:t>2.14.1</a:t>
+                        <a:t>2.14.2</a:t>
                       </a:r>
                     </a:p>
                   </a:txBody>
@@ -9036,7 +9136,7 @@
                           </a:solidFill>
                           <a:latin typeface="Segoe UI"/>
                         </a:rPr>
-                        <a:t>One pet at a time</a:t>
+                        <a:t>Never miss an update</a:t>
                       </a:r>
                     </a:p>
                     <a:p>
@@ -9047,7 +9147,7 @@
                           </a:solidFill>
                           <a:latin typeface="Segoe UI"/>
                         </a:rPr>
-                        <a:t>Opening Pips again (Desktop / Start Menu shortcut, autostart) no longer starts a second pet - your pet just pops up and says hi.; Fixes lag caused by two copies of Pips running at once.</a:t>
+                        <a:t>Your pet now reminds you every 2 hours while a new version is waiting (instead of every 6 hours).; If the reminder can't show (fullscreen app, guided tour, another message), your pet tries again a few minutes later.; No internet when Pips starts (e.g. VPN off)? It checks again after an hour.</a:t>
                       </a:r>
                     </a:p>
                   </a:txBody>
@@ -9071,7 +9171,7 @@
                           </a:solidFill>
                           <a:latin typeface="Segoe UI"/>
                         </a:rPr>
-                        <a:t>2.14.0</a:t>
+                        <a:t>2.14.1</a:t>
                       </a:r>
                     </a:p>
                   </a:txBody>
@@ -9115,7 +9215,7 @@
                           </a:solidFill>
                           <a:latin typeface="Segoe UI"/>
                         </a:rPr>
-                        <a:t>Pokes, tickles &amp; teases</a:t>
+                        <a:t>One pet at a time</a:t>
                       </a:r>
                     </a:p>
                     <a:p>
@@ -9126,7 +9226,7 @@
                           </a:solidFill>
                           <a:latin typeface="Segoe UI"/>
                         </a:rPr>
-                        <a:t>Poke, tickle, tease, boop or hug a friend from afar - no pet visit needed.; Right-click your pet → Poke a friend, or use the Poke button in Friends, chat and profiles.; Your friend gets a pop-up ("Wendy is teasing you!"), their pet reacts, and they can poke back with one click.; During a focus session pokes wait quietly until your break; when your pet is hidden they show in the screen corner.</a:t>
+                        <a:t>Opening Pips again (Desktop / Start Menu shortcut, autostart) no longer starts a second pet - your pet just pops up and says hi.; Fixes lag caused by two copies of Pips running at once.</a:t>
                       </a:r>
                     </a:p>
                   </a:txBody>
@@ -9150,7 +9250,7 @@
                           </a:solidFill>
                           <a:latin typeface="Segoe UI"/>
                         </a:rPr>
-                        <a:t>2.13.1</a:t>
+                        <a:t>2.14.0</a:t>
                       </a:r>
                     </a:p>
                   </a:txBody>
@@ -9172,7 +9272,7 @@
                           </a:solidFill>
                           <a:latin typeface="Segoe UI"/>
                         </a:rPr>
-                        <a:t>2026-10-28</a:t>
+                        <a:t>2026-10-29</a:t>
                       </a:r>
                     </a:p>
                   </a:txBody>
@@ -9194,7 +9294,7 @@
                           </a:solidFill>
                           <a:latin typeface="Segoe UI"/>
                         </a:rPr>
-                        <a:t>One-click Windows installer</a:t>
+                        <a:t>Pokes, tickles &amp; teases</a:t>
                       </a:r>
                     </a:p>
                     <a:p>
@@ -9205,7 +9305,7 @@
                           </a:solidFill>
                           <a:latin typeface="Segoe UI"/>
                         </a:rPr>
-                        <a:t>One Windows installer: no ZIP extraction, Python installation or command line. Download, open and click Install Pips.; Installs for your Windows account without administrator access, adds Desktop and Start Menu shortcuts, and opens Pips automatically.; Reinstalling in the same location keeps your settings and pet progress. Existing ZIP users can keep updating in place from Help → Check for updates.; A simpler download page and updated user guide; the bundled runtime stays separate from small in-app updates.</a:t>
+                        <a:t>Poke, tickle, tease, boop or hug a friend from afar - no pet visit needed.; Right-click your pet → Poke a friend, or use the Poke button in Friends, chat and profiles.; Your friend gets a pop-up ("Wendy is teasing you!"), their pet reacts, and they can poke back with one click.; During a focus session pokes wait quietly until your break; when your pet is hidden they show in the screen corner.</a:t>
                       </a:r>
                     </a:p>
                   </a:txBody>
@@ -9229,7 +9329,7 @@
                           </a:solidFill>
                           <a:latin typeface="Segoe UI"/>
                         </a:rPr>
-                        <a:t>2.13.0</a:t>
+                        <a:t>2.13.1</a:t>
                       </a:r>
                     </a:p>
                   </a:txBody>
@@ -9273,7 +9373,7 @@
                           </a:solidFill>
                           <a:latin typeface="Segoe UI"/>
                         </a:rPr>
-                        <a:t>Birthdays, parties &amp; gifts</a:t>
+                        <a:t>One-click Windows installer</a:t>
                       </a:r>
                     </a:p>
                     <a:p>
@@ -9284,7 +9384,7 @@
                           </a:solidFill>
                           <a:latin typeface="Segoe UI"/>
                         </a:rPr>
-                        <a:t>Set your birthday in Social → Profile (month + day, optionally visible to friends).; On your birthday Pips throws confetti and gives you 100 bonus coins.; Friends tab shows upcoming birthdays; you get reminders 3 days, 1 day and on the day.; Birthday parties: join a friend's party, see who's there, sign the guestbook and celebrate together.</a:t>
+                        <a:t>One Windows installer: no ZIP extraction, Python installation or command line. Download, open and click Install Pips.; Installs for your Windows account without administrator access, adds Desktop and Start Menu shortcuts, and opens Pips automatically.; Reinstalling in the same location keeps your settings and pet progress. Existing ZIP users can keep updating in place from Help → Check for updates.; A simpler download page and updated user guide; the bundled runtime stays separate from small in-app updates.</a:t>
                       </a:r>
                     </a:p>
                   </a:txBody>
@@ -9308,7 +9408,7 @@
                           </a:solidFill>
                           <a:latin typeface="Segoe UI"/>
                         </a:rPr>
-                        <a:t>2.12.0</a:t>
+                        <a:t>2.13.0</a:t>
                       </a:r>
                     </a:p>
                   </a:txBody>
@@ -9352,7 +9452,7 @@
                           </a:solidFill>
                           <a:latin typeface="Segoe UI"/>
                         </a:rPr>
-                        <a:t>Mega update: 28 new animals, 31 shop items, 13 moves</a:t>
+                        <a:t>Birthdays, parties &amp; gifts</a:t>
                       </a:r>
                     </a:p>
                     <a:p>
@@ -9363,7 +9463,7 @@
                           </a:solidFill>
                           <a:latin typeface="Segoe UI"/>
                         </a:rPr>
-                        <a:t>🦁 28 new animals (51 total): lion, tiger, unicorn, deer, sheep, cow, raccoon, red panda, monkey, hedgehog, dino, squirrel, mouse, koala, shark, dolphin, seal, otter, pufferfish, duck, crab, parrot, chick, ladybug, phoenix, pegasus, ghost and flamingo; 🎩 31 new shop items: top hat, cowboy, chef, pirate, Santa, viking, graduation cap, beret, bow, propeller cap, flower crown, nerd glasses, eyepatch, mustache, goggles, masquerade mask, tie, pearls, flower lei, gold chain, balloon, backpack, guitar, shield, butterfly / devil wings and more - plus Premium galaxy crown, galaxy cape and dragon wings; 💃 13 new moves: wave, jump, hearts, sing, yoga, zoomies, cartwheel, juggle, rain dance, breakdance, magic, confetti and the Premium rocket launch; The Shop is now split into sections (Hats, Face, Neck, Back, Moves, Arena gear) with an owned counter for each</a:t>
+                        <a:t>Set your birthday in Social → Profile (month + day, optionally visible to friends).; On your birthday Pips throws confetti and gives you 100 bonus coins.; Friends tab shows upcoming birthdays; you get reminders 3 days, 1 day and on the day.; Birthday parties: join a friend's party, see who's there, sign the guestbook and celebrate together.</a:t>
                       </a:r>
                     </a:p>
                   </a:txBody>
@@ -9387,7 +9487,7 @@
                           </a:solidFill>
                           <a:latin typeface="Segoe UI"/>
                         </a:rPr>
-                        <a:t>2.11.0</a:t>
+                        <a:t>2.12.0</a:t>
                       </a:r>
                     </a:p>
                   </a:txBody>
@@ -9431,7 +9531,7 @@
                           </a:solidFill>
                           <a:latin typeface="Segoe UI"/>
                         </a:rPr>
-                        <a:t>New right-click menus</a:t>
+                        <a:t>Mega update: 28 new animals, 31 shop items, 13 moves</a:t>
                       </a:r>
                     </a:p>
                     <a:p>
@@ -9442,7 +9542,7 @@
                           </a:solidFill>
                           <a:latin typeface="Segoe UI"/>
                         </a:rPr>
-                        <a:t>✨ Brand-new animated right-click menu for your pet: mood &amp; stat bars, quick-action tiles (Friends, Shop, Snack, Pat, Focus, Stats, Sleep, Taskbar), hover effects and smooth fly-out submenus; Pick colours from swatches, switch size with one click and flip Sounds / Dark mode with toggle switches - changes show instantly; Updates are highlighted: a glowing banner and NEW badge appear in the menu when a new version is ready; The focus card's right-click menu got the same new look; keyboard arrows, Enter and Esc work too</a:t>
+                        <a:t>🦁 28 new animals (51 total): lion, tiger, unicorn, deer, sheep, cow, raccoon, red panda, monkey, hedgehog, dino, squirrel, mouse, koala, shark, dolphin, seal, otter, pufferfish, duck, crab, parrot, chick, ladybug, phoenix, pegasus, ghost and flamingo; 🎩 31 new shop items: top hat, cowboy, chef, pirate, Santa, viking, graduation cap, beret, bow, propeller cap, flower crown, nerd glasses, eyepatch, mustache, goggles, masquerade mask, tie, pearls, flower lei, gold chain, balloon, backpack, guitar, shield, butterfly / devil wings and more - plus Premium galaxy crown, galaxy cape and dragon wings; 💃 13 new moves: wave, jump, hearts, sing, yoga, zoomies, cartwheel, juggle, rain dance, breakdance, magic, confetti and the Premium rocket launch; The Shop is now split into sections (Hats, Face, Neck, Back, Moves, Arena gear) with an owned counter for each</a:t>
                       </a:r>
                     </a:p>
                   </a:txBody>
@@ -9466,7 +9566,7 @@
                           </a:solidFill>
                           <a:latin typeface="Segoe UI"/>
                         </a:rPr>
-                        <a:t>2.10.0</a:t>
+                        <a:t>2.11.0</a:t>
                       </a:r>
                     </a:p>
                   </a:txBody>
@@ -9510,7 +9610,7 @@
                           </a:solidFill>
                           <a:latin typeface="Segoe UI"/>
                         </a:rPr>
-                        <a:t>Chat bots</a:t>
+                        <a:t>New right-click menus</a:t>
                       </a:r>
                     </a:p>
                     <a:p>
@@ -9521,7 +9621,7 @@
                           </a:solidFill>
                           <a:latin typeface="Segoe UI"/>
                         </a:rPr>
-                        <a:t>🤖 6 friendly chat bots in the Chat tab: Pip Helper (app questions), Coach Focus (focus tips from your real stats), Sunny (live weather for any city), Arena Master (battle tips + quick battle), Giggles (jokes &amp; games) and Guardian (safety &amp; reporting help); Private bot chats with suggestion chips, typing indicator and a clear button - your bot chats stay on your PC; Mention a bot in a group chat (e.g. @weather Batam) and it answers in the room for everyone; Bots reply in your app language; up to 120 bot messages per day</a:t>
+                        <a:t>✨ Brand-new animated right-click menu for your pet: mood &amp; stat bars, quick-action tiles (Friends, Shop, Snack, Pat, Focus, Stats, Sleep, Taskbar), hover effects and smooth fly-out submenus; Pick colours from swatches, switch size with one click and flip Sounds / Dark mode with toggle switches - changes show instantly; Updates are highlighted: a glowing banner and NEW badge appear in the menu when a new version is ready; The focus card's right-click menu got the same new look; keyboard arrows, Enter and Esc work too</a:t>
                       </a:r>
                     </a:p>
                   </a:txBody>
@@ -9545,7 +9645,7 @@
                           </a:solidFill>
                           <a:latin typeface="Segoe UI"/>
                         </a:rPr>
-                        <a:t>2.9.0</a:t>
+                        <a:t>2.10.0</a:t>
                       </a:r>
                     </a:p>
                   </a:txBody>
@@ -9589,7 +9689,7 @@
                           </a:solidFill>
                           <a:latin typeface="Segoe UI"/>
                         </a:rPr>
-                        <a:t>Location &amp; live weather</a:t>
+                        <a:t>Chat bots</a:t>
                       </a:r>
                     </a:p>
                     <a:p>
@@ -9600,7 +9700,7 @@
                           </a:solidFill>
                           <a:latin typeface="Segoe UI"/>
                         </a:rPr>
-                        <a:t>📍 Add your city in Profile → Location &amp; weather (auto-detect or search) - only your city and country are shown, never your exact position; Live weather banners on every profile with animations: rain, drizzle, thunderstorms with lightning, snow, fog, clouds, sunshine or a starry night - plus temperature, feels-like, humidity, wind and local time; Your own weather strip on top of the hub, and each friend's weather + local time in the friends list; Hide your location from others or remove it any time</a:t>
+                        <a:t>🤖 6 friendly chat bots in the Chat tab: Pip Helper (app questions), Coach Focus (focus tips from your real stats), Sunny (live weather for any city), Arena Master (battle tips + quick battle), Giggles (jokes &amp; games) and Guardian (safety &amp; reporting help); Private bot chats with suggestion chips, typing indicator and a clear button - your bot chats stay on your PC; Mention a bot in a group chat (e.g. @weather Batam) and it answers in the room for everyone; Bots reply in your app language; up to 120 bot messages per day</a:t>
                       </a:r>
                     </a:p>
                   </a:txBody>
@@ -9624,7 +9724,7 @@
                           </a:solidFill>
                           <a:latin typeface="Segoe UI"/>
                         </a:rPr>
-                        <a:t>2.8.0</a:t>
+                        <a:t>2.9.0</a:t>
                       </a:r>
                     </a:p>
                   </a:txBody>
@@ -9668,7 +9768,7 @@
                           </a:solidFill>
                           <a:latin typeface="Segoe UI"/>
                         </a:rPr>
-                        <a:t>Pips Arena - duels, gear &amp; live battles</a:t>
+                        <a:t>Location &amp; live weather</a:t>
                       </a:r>
                     </a:p>
                     <a:p>
@@ -9679,7 +9779,7 @@
                           </a:solidFill>
                           <a:latin typeface="Segoe UI"/>
                         </a:rPr>
-                        <a:t>⚔ New Arena tab: challenge friends or anyone in the arena to a live duel - each round pick Attack, Guard or Special within 12 seconds and watch your pets fight; ⚡ Quick battle: an instant auto-fight against anyone's fighter, even when they're offline; Arena gear in the Shop: 7 weapons (water pistol to rocket launcher), 5 armors and 5 gadgets that decide your special move - better gear and a higher level make a stronger fighter; Live duels can be watched by everyone, plus recent battle replays, top fighters, rating and win/loss records; wins earn coins</a:t>
+                        <a:t>📍 Add your city in Profile → Location &amp; weather (auto-detect or search) - only your city and country are shown, never your exact position; Live weather banners on every profile with animations: rain, drizzle, thunderstorms with lightning, snow, fog, clouds, sunshine or a starry night - plus temperature, feels-like, humidity, wind and local time; Your own weather strip on top of the hub, and each friend's weather + local time in the friends list; Hide your location from others or remove it any time</a:t>
                       </a:r>
                     </a:p>
                   </a:txBody>
@@ -9703,7 +9803,7 @@
                           </a:solidFill>
                           <a:latin typeface="Segoe UI"/>
                         </a:rPr>
-                        <a:t>2.7.0</a:t>
+                        <a:t>2.8.0</a:t>
                       </a:r>
                     </a:p>
                   </a:txBody>
@@ -9747,7 +9847,7 @@
                           </a:solidFill>
                           <a:latin typeface="Segoe UI"/>
                         </a:rPr>
-                        <a:t>Moderators &amp; Premium</a:t>
+                        <a:t>Pips Arena - duels, gear &amp; live battles</a:t>
                       </a:r>
                     </a:p>
                     <a:p>
@@ -9758,7 +9858,7 @@
                           </a:solidFill>
                           <a:latin typeface="Segoe UI"/>
                         </a:rPr>
-                        <a:t>★ Premium: a purple Premium badge, 4 exclusive props (tiara, star glasses, diamond necklace, fairy wings), the Fireworks move, +30 coins every day, double friend-interaction coins and room for 300 friends / 30 groups; Get Premium: Profile tab → Premium → "Ask to buy" emails the owner; after payment you receive a key (PIPS-XXXX-XXXX) to redeem right there; 🛡 Moderators: a blue Mod badge and a Mod tab with the report queue - warn, mute (1h / 24h / 7 days), clear a profile or reset a name; every action is logged; Report button on everyone's profile, so moderators can keep Pips friendly</a:t>
+                        <a:t>⚔ New Arena tab: challenge friends or anyone in the arena to a live duel - each round pick Attack, Guard or Special within 12 seconds and watch your pets fight; ⚡ Quick battle: an instant auto-fight against anyone's fighter, even when they're offline; Arena gear in the Shop: 7 weapons (water pistol to rocket launcher), 5 armors and 5 gadgets that decide your special move - better gear and a higher level make a stronger fighter; Live duels can be watched by everyone, plus recent battle replays, top fighters, rating and win/loss records; wins earn coins</a:t>
                       </a:r>
                     </a:p>
                   </a:txBody>
@@ -9782,7 +9882,7 @@
                           </a:solidFill>
                           <a:latin typeface="Segoe UI"/>
                         </a:rPr>
-                        <a:t>2.6.1</a:t>
+                        <a:t>2.7.0</a:t>
                       </a:r>
                     </a:p>
                   </a:txBody>
@@ -9826,7 +9926,7 @@
                           </a:solidFill>
                           <a:latin typeface="Segoe UI"/>
                         </a:rPr>
-                        <a:t>Owner badge &amp; credits</a:t>
+                        <a:t>Moderators &amp; Premium</a:t>
                       </a:r>
                     </a:p>
                     <a:p>
@@ -9837,7 +9937,7 @@
                           </a:solidFill>
                           <a:latin typeface="Segoe UI"/>
                         </a:rPr>
-                        <a:t>The creator of Pips (Juwen Lie) now shows a gold ♛ Owner badge on his profile, friend list and ranks; New About Pips card in the Profile tab: credits and how to contact the owner (Juwen_Lie@pegatroncorp.com) with Email and Copy buttons; Right-click the pet → Help → About now shows who made Pips and the contact email</a:t>
+                        <a:t>★ Premium: a purple Premium badge, 4 exclusive props (tiara, star glasses, diamond necklace, fairy wings), the Fireworks move, +30 coins every day, double friend-interaction coins and room for 300 friends / 30 groups; Get Premium: Profile tab → Premium → "Ask to buy" emails the owner; after payment you receive a key (PIPS-XXXX-XXXX) to redeem right there; 🛡 Moderators: a blue Mod badge and a Mod tab with the report queue - warn, mute (1h / 24h / 7 days), clear a profile or reset a name; every action is logged; Report button on everyone's profile, so moderators can keep Pips friendly</a:t>
                       </a:r>
                     </a:p>
                   </a:txBody>
@@ -9861,7 +9961,7 @@
                           </a:solidFill>
                           <a:latin typeface="Segoe UI"/>
                         </a:rPr>
-                        <a:t>2.6.0</a:t>
+                        <a:t>2.6.1</a:t>
                       </a:r>
                     </a:p>
                   </a:txBody>
@@ -9905,7 +10005,7 @@
                           </a:solidFill>
                           <a:latin typeface="Segoe UI"/>
                         </a:rPr>
-                        <a:t>Profiles, ranks, online status &amp; dark mode</a:t>
+                        <a:t>Owner badge &amp; credits</a:t>
                       </a:r>
                     </a:p>
                     <a:p>
@@ -9916,7 +10016,7 @@
                           </a:solidFill>
                           <a:latin typeface="Segoe UI"/>
                         </a:rPr>
-                        <a:t>Profile tab: profile picture (or your pet), about me, job, location, hobbies, birthday and a status message; Public or private: public profiles can be added directly and viewed in full; private profiles need a friend request that they accept, and strangers only see name, photo, pet, level and status; Click anyone to open their profile - badges, info, their friends - and add them, chat or wave from there; Ranks tab replaces Teams: everyone using Pips, sorted by XP, badges or streak</a:t>
+                        <a:t>The creator of Pips (Juwen Lie) now shows a gold ♛ Owner badge on his profile, friend list and ranks; New About Pips card in the Profile tab: credits and how to contact the owner (Juwen_Lie@pegatroncorp.com) with Email and Copy buttons; Right-click the pet → Help → About now shows who made Pips and the contact email</a:t>
                       </a:r>
                     </a:p>
                   </a:txBody>
@@ -9940,7 +10040,7 @@
                           </a:solidFill>
                           <a:latin typeface="Segoe UI"/>
                         </a:rPr>
-                        <a:t>2.5.1</a:t>
+                        <a:t>2.6.0</a:t>
                       </a:r>
                     </a:p>
                   </a:txBody>
@@ -9984,7 +10084,7 @@
                           </a:solidFill>
                           <a:latin typeface="Segoe UI"/>
                         </a:rPr>
-                        <a:t>New cute Pips logo</a:t>
+                        <a:t>Profiles, ranks, online status &amp; dark mode</a:t>
                       </a:r>
                     </a:p>
                     <a:p>
@@ -9995,7 +10095,7 @@
                           </a:solidFill>
                           <a:latin typeface="Segoe UI"/>
                         </a:rPr>
-                        <a:t>New Pips logo: Pip the cat on a Pips-red tile, matching the app colours (desktop shortcut, windows and website)</a:t>
+                        <a:t>Profile tab: profile picture (or your pet), about me, job, location, hobbies, birthday and a status message; Public or private: public profiles can be added directly and viewed in full; private profiles need a friend request that they accept, and strangers only see name, photo, pet, level and status; Click anyone to open their profile - badges, info, their friends - and add them, chat or wave from there; Ranks tab replaces Teams: everyone using Pips, sorted by XP, badges or streak</a:t>
                       </a:r>
                     </a:p>
                   </a:txBody>
@@ -10019,7 +10119,7 @@
                           </a:solidFill>
                           <a:latin typeface="Segoe UI"/>
                         </a:rPr>
-                        <a:t>2.5.0</a:t>
+                        <a:t>2.5.1</a:t>
                       </a:r>
                     </a:p>
                   </a:txBody>
@@ -10063,7 +10163,7 @@
                           </a:solidFill>
                           <a:latin typeface="Segoe UI"/>
                         </a:rPr>
-                        <a:t>Shop, coins, props &amp; moves</a:t>
+                        <a:t>New cute Pips logo</a:t>
                       </a:r>
                     </a:p>
                     <a:p>
@@ -10074,7 +10174,7 @@
                           </a:solidFill>
                           <a:latin typeface="Segoe UI"/>
                         </a:rPr>
-                        <a:t>Shop: earn coins and spend them on your pet - 17 props (crown, wizard hat, headphones, shades, scarf, cape, angel wings...) and 6 moves: spin, dance, moonwalk, backflip, kung fu and spider swing!; Coins come from leveling up (+40), badges (+25), opening Pips each day (+10), friendships (+15 per affinity level), waving / chatting / visiting friends (+2) and pomodoros (+5). Everyone starts with a 100-coin gift; Your friends see your props: on avatars in the hub and when your pet visits their desktop - it shows off one of your moves; Pips is now a social pet: clicking the pet opens the Pips hub (friends, chat, groups, shop, badges)</a:t>
+                        <a:t>New Pips logo: Pip the cat on a Pips-red tile, matching the app colours (desktop shortcut, windows and website)</a:t>
                       </a:r>
                     </a:p>
                   </a:txBody>
@@ -10098,7 +10198,7 @@
                           </a:solidFill>
                           <a:latin typeface="Segoe UI"/>
                         </a:rPr>
-                        <a:t>2.4.0</a:t>
+                        <a:t>2.5.0</a:t>
                       </a:r>
                     </a:p>
                   </a:txBody>
@@ -10142,7 +10242,7 @@
                           </a:solidFill>
                           <a:latin typeface="Segoe UI"/>
                         </a:rPr>
-                        <a:t>Chat, groups, affinity &amp; pet visits</a:t>
+                        <a:t>Shop, coins, props &amp; moves</a:t>
                       </a:r>
                     </a:p>
                     <a:p>
@@ -10153,7 +10253,7 @@
                           </a:solidFill>
                           <a:latin typeface="Segoe UI"/>
                         </a:rPr>
-                        <a:t>Chat: message your friends, and chat inside groups. Your pet pops up new messages as a bubble - click it to reply; Pet interactions: wave, pet their pet, send a snack, high five - or send your pet to visit: it walks onto your friend's desktop for a little while!; Affinity: every chat and interaction grows your friendship - Acquaintance → Buddy → Good friends → Close friends → Best friends → Soulmates; Your own groups: create a private group, invite your friends, they accept or decline. Group board + group chat; the owner can remove members</a:t>
+                        <a:t>Shop: earn coins and spend them on your pet - 17 props (crown, wizard hat, headphones, shades, scarf, cape, angel wings...) and 6 moves: spin, dance, moonwalk, backflip, kung fu and spider swing!; Coins come from leveling up (+40), badges (+25), opening Pips each day (+10), friendships (+15 per affinity level), waving / chatting / visiting friends (+2) and pomodoros (+5). Everyone starts with a 100-coin gift; Your friends see your props: on avatars in the hub and when your pet visits their desktop - it shows off one of your moves; Pips is now a social pet: clicking the pet opens the Pips hub (friends, chat, groups, shop, badges)</a:t>
                       </a:r>
                     </a:p>
                   </a:txBody>
@@ -10177,7 +10277,7 @@
                           </a:solidFill>
                           <a:latin typeface="Segoe UI"/>
                         </a:rPr>
-                        <a:t>2.3.0</a:t>
+                        <a:t>2.4.0</a:t>
                       </a:r>
                     </a:p>
                   </a:txBody>
@@ -10221,7 +10321,7 @@
                           </a:solidFill>
                           <a:latin typeface="Segoe UI"/>
                         </a:rPr>
-                        <a:t>Friends, levels &amp; achievements</a:t>
+                        <a:t>Chat, groups, affinity &amp; pet visits</a:t>
                       </a:r>
                     </a:p>
                     <a:p>
@@ -10232,7 +10332,7 @@
                           </a:solidFill>
                           <a:latin typeface="Segoe UI"/>
                         </a:rPr>
-                        <a:t>Levels &amp; XP: every finished pomodoro earns XP and your level grows - plus 20 achievements to unlock (first tomato, 8 in a day, 7-day streak, early bird, night owl, pet lover...). Your pet celebrates each one; Friends (optional, off by default): get a 6-letter friend code, add colleagues, see today's board and join a team board like PTB. Your pet tells you when a friend finishes a pomodoro; Privacy: only your name, pet, level, streak and pomodoro counts are shared - never apps, window titles or scores. One click turns it off and deletes your online data. Right-click the pet → Friends &amp; achievements…</a:t>
+                        <a:t>Chat: message your friends, and chat inside groups. Your pet pops up new messages as a bubble - click it to reply; Pet interactions: wave, pet their pet, send a snack, high five - or send your pet to visit: it walks onto your friend's desktop for a little while!; Affinity: every chat and interaction grows your friendship - Acquaintance → Buddy → Good friends → Close friends → Best friends → Soulmates; Your own groups: create a private group, invite your friends, they accept or decline. Group board + group chat; the owner can remove members</a:t>
                       </a:r>
                     </a:p>
                   </a:txBody>
@@ -10256,7 +10356,7 @@
                           </a:solidFill>
                           <a:latin typeface="Segoe UI"/>
                         </a:rPr>
-                        <a:t>2.2.0</a:t>
+                        <a:t>2.3.0</a:t>
                       </a:r>
                     </a:p>
                   </a:txBody>
@@ -10300,7 +10400,7 @@
                           </a:solidFill>
                           <a:latin typeface="Segoe UI"/>
                         </a:rPr>
-                        <a:t>Pet sounds</a:t>
+                        <a:t>Friends, levels &amp; achievements</a:t>
                       </a:r>
                     </a:p>
                     <a:p>
@@ -10311,7 +10411,7 @@
                           </a:solidFill>
                           <a:latin typeface="Segoe UI"/>
                         </a:rPr>
-                        <a:t>Your pet has a voice! Each of the 23 animals has its own sound (meow, woof, ribbit, hoot, buzz, oink, whale song...) and it changes with its mood: happy chirps, sad whimpers, sleepy yawns, hungry calls, grumpy huffs and soft snores; It also reacts with sound when you tickle, pet, feed, shake or wake it; Settings: right-click the pet → Sounds to switch on/off; Pet status &amp; settings has a volume slider, a ▶ Hear me button and "Stay quiet while I'm focusing" (on by default)</a:t>
+                        <a:t>Levels &amp; XP: every finished pomodoro earns XP and your level grows - plus 20 achievements to unlock (first tomato, 8 in a day, 7-day streak, early bird, night owl, pet lover...). Your pet celebrates each one; Friends (optional, off by default): get a 6-letter friend code, add colleagues, see today's board and join a team board like PTB. Your pet tells you when a friend finishes a pomodoro; Privacy: only your name, pet, level, streak and pomodoro counts are shared - never apps, window titles or scores. One click turns it off and deletes your online data. Right-click the pet → Friends &amp; achievements…</a:t>
                       </a:r>
                     </a:p>
                   </a:txBody>
@@ -10335,7 +10435,7 @@
                           </a:solidFill>
                           <a:latin typeface="Segoe UI"/>
                         </a:rPr>
-                        <a:t>2.1.2</a:t>
+                        <a:t>2.2.0</a:t>
                       </a:r>
                     </a:p>
                   </a:txBody>
@@ -10379,7 +10479,7 @@
                           </a:solidFill>
                           <a:latin typeface="Segoe UI"/>
                         </a:rPr>
-                        <a:t>Tickle-only mode</a:t>
+                        <a:t>Pet sounds</a:t>
                       </a:r>
                     </a:p>
                     <a:p>
@@ -10390,7 +10490,7 @@
                           </a:solidFill>
                           <a:latin typeface="Segoe UI"/>
                         </a:rPr>
-                        <a:t>New click option "Only tickle (never open Pips)": click and tickle your pet as much as you like - the Pomodoro window stays closed (open it from the right-click menu). Right-click the pet → When I click</a:t>
+                        <a:t>Your pet has a voice! Each of the 23 animals has its own sound (meow, woof, ribbit, hoot, buzz, oink, whale song...) and it changes with its mood: happy chirps, sad whimpers, sleepy yawns, hungry calls, grumpy huffs and soft snores; It also reacts with sound when you tickle, pet, feed, shake or wake it; Settings: right-click the pet → Sounds to switch on/off; Pet status &amp; settings has a volume slider, a ▶ Hear me button and "Stay quiet while I'm focusing" (on by default)</a:t>
                       </a:r>
                     </a:p>
                   </a:txBody>
@@ -10414,7 +10514,7 @@
                           </a:solidFill>
                           <a:latin typeface="Segoe UI"/>
                         </a:rPr>
-                        <a:t>2.1.1</a:t>
+                        <a:t>2.1.2</a:t>
                       </a:r>
                     </a:p>
                   </a:txBody>
@@ -10458,7 +10558,7 @@
                           </a:solidFill>
                           <a:latin typeface="Segoe UI"/>
                         </a:rPr>
-                        <a:t>Owner info</a:t>
+                        <a:t>Tickle-only mode</a:t>
                       </a:r>
                     </a:p>
                     <a:p>
@@ -10469,7 +10569,7 @@
                           </a:solidFill>
                           <a:latin typeface="Segoe UI"/>
                         </a:rPr>
-                        <a:t>About Pips now shows the owner: Juwen Lie (right-click the pet → Help → About)</a:t>
+                        <a:t>New click option "Only tickle (never open Pips)": click and tickle your pet as much as you like - the Pomodoro window stays closed (open it from the right-click menu). Right-click the pet → When I click</a:t>
                       </a:r>
                     </a:p>
                   </a:txBody>
@@ -10493,7 +10593,7 @@
                           </a:solidFill>
                           <a:latin typeface="Segoe UI"/>
                         </a:rPr>
-                        <a:t>2.1.0</a:t>
+                        <a:t>2.1.1</a:t>
                       </a:r>
                     </a:p>
                   </a:txBody>
@@ -10537,7 +10637,7 @@
                           </a:solidFill>
                           <a:latin typeface="Segoe UI"/>
                         </a:rPr>
-                        <a:t>Interactive guide &amp; in-app updates</a:t>
+                        <a:t>Owner info</a:t>
                       </a:r>
                     </a:p>
                     <a:p>
@@ -10548,7 +10648,7 @@
                           </a:solidFill>
                           <a:latin typeface="Segoe UI"/>
                         </a:rPr>
-                        <a:t>Interactive first-run guide: your pet walks you through clicking, dragging, petting and the right-click menu; In-app updates: Pips tells you when a new version is out - update with one click (your settings and data are kept); New Help menu: replay the guide, check for updates, see the version; Option to turn automatic update checks off</a:t>
+                        <a:t>About Pips now shows the owner: Juwen Lie (right-click the pet → Help → About)</a:t>
                       </a:r>
                     </a:p>
                   </a:txBody>
@@ -10572,7 +10672,7 @@
                           </a:solidFill>
                           <a:latin typeface="Segoe UI"/>
                         </a:rPr>
-                        <a:t>2.0.0</a:t>
+                        <a:t>2.1.0</a:t>
                       </a:r>
                     </a:p>
                   </a:txBody>
@@ -10616,7 +10716,7 @@
                           </a:solidFill>
                           <a:latin typeface="Segoe UI"/>
                         </a:rPr>
-                        <a:t>Desktop pet, 23 animals &amp; 4 languages</a:t>
+                        <a:t>Interactive guide &amp; in-app updates</a:t>
                       </a:r>
                     </a:p>
                     <a:p>
@@ -10627,7 +10727,7 @@
                           </a:solidFill>
                           <a:latin typeface="Segoe UI"/>
                         </a:rPr>
-                        <a:t>Desktop pet that lives on your desktop and taskbar - drag it, tickle it, pet it; 23 animals in 3 groups: Land walks, Water swims with bubbles, Sky hovers and flaps; Moods (happy, sad, tired, hungry, grumpy...), naps when you're away, wakes up when you're back; Cute chat-bubble reminders: breaks, water, 20-20-20 eye rest, pomodoro done, daily goal</a:t>
+                        <a:t>Interactive first-run guide: your pet walks you through clicking, dragging, petting and the right-click menu; In-app updates: Pips tells you when a new version is out - update with one click (your settings and data are kept); New Help menu: replay the guide, check for updates, see the version; Option to turn automatic update checks off</a:t>
                       </a:r>
                     </a:p>
                   </a:txBody>
@@ -10651,7 +10751,7 @@
                           </a:solidFill>
                           <a:latin typeface="Segoe UI"/>
                         </a:rPr>
-                        <a:t>1.5.0</a:t>
+                        <a:t>2.0.0</a:t>
                       </a:r>
                     </a:p>
                   </a:txBody>
@@ -10673,7 +10773,7 @@
                           </a:solidFill>
                           <a:latin typeface="Segoe UI"/>
                         </a:rPr>
-                        <a:t>2026-10-24</a:t>
+                        <a:t>2026-10-28</a:t>
                       </a:r>
                     </a:p>
                   </a:txBody>
@@ -10695,7 +10795,7 @@
                           </a:solidFill>
                           <a:latin typeface="Segoe UI"/>
                         </a:rPr>
-                        <a:t>Renamed to Pips + insights</a:t>
+                        <a:t>Desktop pet, 23 animals &amp; 4 languages</a:t>
                       </a:r>
                     </a:p>
                     <a:p>
@@ -10706,7 +10806,7 @@
                           </a:solidFill>
                           <a:latin typeface="Segoe UI"/>
                         </a:rPr>
-                        <a:t>Renamed from Productivity Widget to Pips; Dashboard charts: focus timeline, hour heatmap, 7-day score trend, pomodoros per day; AI token usage on the card and dashboard; Daily diary export and weekly / monthly reports</a:t>
+                        <a:t>Desktop pet that lives on your desktop and taskbar - drag it, tickle it, pet it; 23 animals in 3 groups: Land walks, Water swims with bubbles, Sky hovers and flaps; Moods (happy, sad, tired, hungry, grumpy...), naps when you're away, wakes up when you're back; Cute chat-bubble reminders: breaks, water, 20-20-20 eye rest, pomodoro done, daily goal</a:t>
                       </a:r>
                     </a:p>
                   </a:txBody>
@@ -10730,7 +10830,7 @@
                           </a:solidFill>
                           <a:latin typeface="Segoe UI"/>
                         </a:rPr>
-                        <a:t>1.0.0</a:t>
+                        <a:t>1.5.0</a:t>
                       </a:r>
                     </a:p>
                   </a:txBody>
@@ -10752,7 +10852,7 @@
                           </a:solidFill>
                           <a:latin typeface="Segoe UI"/>
                         </a:rPr>
-                        <a:t>2026-10-21</a:t>
+                        <a:t>2026-10-24</a:t>
                       </a:r>
                     </a:p>
                   </a:txBody>
@@ -10774,7 +10874,7 @@
                           </a:solidFill>
                           <a:latin typeface="Segoe UI"/>
                         </a:rPr>
-                        <a:t>First release</a:t>
+                        <a:t>Renamed to Pips + insights</a:t>
                       </a:r>
                     </a:p>
                     <a:p>
@@ -10785,13 +10885,92 @@
                           </a:solidFill>
                           <a:latin typeface="Segoe UI"/>
                         </a:rPr>
-                        <a:t>Always-on-top Pomodoro card with progress ring; Rain / thunder / brown-noise / cafe soundscapes; Live app-usage tracking and a daily 1-5 star focus score; Goals, streaks, XP, coach tips and break reminders</a:t>
+                        <a:t>Renamed from Productivity Widget to Pips; Dashboard charts: focus timeline, hour heatmap, 7-day score trend, pomodoros per day; AI token usage on the card and dashboard; Daily diary export and weekly / monthly reports</a:t>
                       </a:r>
                     </a:p>
                   </a:txBody>
                   <a:tcPr marL="73152" marR="73152" marT="36576" marB="36576">
                     <a:solidFill>
                       <a:srgbClr val="FFFDF8"/>
+                    </a:solidFill>
+                  </a:tcPr>
+                </a:tc>
+              </a:tr>
+              <a:tr h="822960">
+                <a:tc>
+                  <a:txBody>
+                    <a:bodyPr wrap="square"/>
+                    <a:lstStyle/>
+                    <a:p>
+                      <a:r>
+                        <a:rPr sz="1200" b="1">
+                          <a:solidFill>
+                            <a:srgbClr val="2B2A28"/>
+                          </a:solidFill>
+                          <a:latin typeface="Segoe UI"/>
+                        </a:rPr>
+                        <a:t>1.0.0</a:t>
+                      </a:r>
+                    </a:p>
+                  </a:txBody>
+                  <a:tcPr marL="73152" marR="73152" marT="36576" marB="36576">
+                    <a:solidFill>
+                      <a:srgbClr val="F7F4EC"/>
+                    </a:solidFill>
+                  </a:tcPr>
+                </a:tc>
+                <a:tc>
+                  <a:txBody>
+                    <a:bodyPr wrap="square"/>
+                    <a:lstStyle/>
+                    <a:p>
+                      <a:r>
+                        <a:rPr sz="1200" b="0">
+                          <a:solidFill>
+                            <a:srgbClr val="2B2A28"/>
+                          </a:solidFill>
+                          <a:latin typeface="Segoe UI"/>
+                        </a:rPr>
+                        <a:t>2026-10-21</a:t>
+                      </a:r>
+                    </a:p>
+                  </a:txBody>
+                  <a:tcPr marL="73152" marR="73152" marT="36576" marB="36576">
+                    <a:solidFill>
+                      <a:srgbClr val="F7F4EC"/>
+                    </a:solidFill>
+                  </a:tcPr>
+                </a:tc>
+                <a:tc>
+                  <a:txBody>
+                    <a:bodyPr wrap="square"/>
+                    <a:lstStyle/>
+                    <a:p>
+                      <a:r>
+                        <a:rPr sz="1200" b="0">
+                          <a:solidFill>
+                            <a:srgbClr val="2B2A28"/>
+                          </a:solidFill>
+                          <a:latin typeface="Segoe UI"/>
+                        </a:rPr>
+                        <a:t>First release</a:t>
+                      </a:r>
+                    </a:p>
+                    <a:p>
+                      <a:r>
+                        <a:rPr sz="1200" b="0">
+                          <a:solidFill>
+                            <a:srgbClr val="2B2A28"/>
+                          </a:solidFill>
+                          <a:latin typeface="Segoe UI"/>
+                        </a:rPr>
+                        <a:t>Always-on-top Pomodoro card with progress ring; Rain / thunder / brown-noise / cafe soundscapes; Live app-usage tracking and a daily 1-5 star focus score; Goals, streaks, XP, coach tips and break reminders</a:t>
+                      </a:r>
+                    </a:p>
+                  </a:txBody>
+                  <a:tcPr marL="73152" marR="73152" marT="36576" marB="36576">
+                    <a:solidFill>
+                      <a:srgbClr val="F7F4EC"/>
                     </a:solidFill>
                   </a:tcPr>
                 </a:tc>

</xml_diff>

<commit_message>
pips 2.16.0: Pips Community
</commit_message>
<xml_diff>
--- a/apps/pips/web/download/Pips-Guide.pptx
+++ b/apps/pips/web/download/Pips-Guide.pptx
@@ -3292,7 +3292,7 @@
                 </a:solidFill>
                 <a:latin typeface="Segoe UI"/>
               </a:rPr>
-              <a:t>Version 2.15.0  ·  2026-10-29  ·  Made by Juwen Lie (owner)</a:t>
+              <a:t>Version 2.16.0  ·  2026-10-29  ·  Made by Juwen Lie (owner)</a:t>
             </a:r>
           </a:p>
           <a:p>
@@ -8166,7 +8166,7 @@
                 </a:solidFill>
                 <a:latin typeface="Segoe UI"/>
               </a:rPr>
-              <a:t>What's new in 2.15.0</a:t>
+              <a:t>What's new in 2.16.0</a:t>
             </a:r>
           </a:p>
         </p:txBody>
@@ -8279,7 +8279,7 @@
                 </a:solidFill>
                 <a:latin typeface="Segoe UI"/>
               </a:rPr>
-              <a:t>Update reminders  ·  2026-10-29</a:t>
+              <a:t>Pips Community  ·  2026-10-29</a:t>
             </a:r>
           </a:p>
         </p:txBody>
@@ -8327,7 +8327,7 @@
                 </a:solidFill>
                 <a:latin typeface="Segoe UI"/>
               </a:rPr>
-              <a:t>Owner &amp; moderators: the Mod tab now lists who hasn't updated Pips yet (their version and when they were last seen), with one-click reminders by e-mail (sent from your Outlook) or a ready-to-send Teams chat.</a:t>
+              <a:t>New Pips Community at the top of the Chat tab: a #general channel to chat with everyone who uses Pips, plus #announcements with news from the Pips team.</a:t>
             </a:r>
           </a:p>
           <a:p>
@@ -8352,7 +8352,7 @@
                 </a:solidFill>
                 <a:latin typeface="Segoe UI"/>
               </a:rPr>
-              <a:t>New Work e-mail field in your Profile, filled in from Outlook. Only the owner and moderators can see it (for update reminders and support) - clear it to hide it.</a:t>
+              <a:t>Every new Pips version is announced there automatically - see what's new and update with one click.</a:t>
             </a:r>
           </a:p>
           <a:p>
@@ -8377,7 +8377,7 @@
                 </a:solidFill>
                 <a:latin typeface="Segoe UI"/>
               </a:rPr>
-              <a:t>Pips now tells the Friends server which version it runs, so the update list is always accurate.</a:t>
+              <a:t>Type @name to ping someone in #general. Mute #general any time; owner and moderators can remove messages.</a:t>
             </a:r>
           </a:p>
           <a:p>
@@ -8402,7 +8402,7 @@
                 </a:solidFill>
                 <a:latin typeface="Segoe UI"/>
               </a:rPr>
-              <a:t>Friends keeps working when a local proxy tool stops answering - Pips falls back to the Windows proxy settings.</a:t>
+              <a:t>Open it from your pet's menu too (Pips Community). Fixed: chats no longer clear what you're typing when Pips refreshes in the background.</a:t>
             </a:r>
           </a:p>
         </p:txBody>
@@ -8533,7 +8533,7 @@
                 </a:solidFill>
                 <a:latin typeface="Segoe UI"/>
               </a:rPr>
-              <a:t>Pemilik &amp; moderator: tab Mod kini menampilkan siapa yang belum update Pips (versinya dan kapan terakhir terlihat), dengan pengingat sekali klik lewat email (dikirim dari Outlook-mu) atau chat Teams yang siap kirim.</a:t>
+              <a:t>Komunitas Pips baru di bagian atas tab Chat: kanal #umum untuk ngobrol dengan semua pengguna Pips, plus #pengumuman berisi kabar dari tim Pips.</a:t>
             </a:r>
           </a:p>
           <a:p>
@@ -8558,7 +8558,7 @@
                 </a:solidFill>
                 <a:latin typeface="Segoe UI"/>
               </a:rPr>
-              <a:t>Kolom baru Email kerja di Profil, diisi otomatis dari Outlook. Hanya pemilik dan moderator yang bisa melihatnya (untuk pengingat update dan bantuan) - kosongkan untuk menyembunyikan.</a:t>
+              <a:t>Setiap versi Pips baru diumumkan di sana secara otomatis - lihat yang baru dan update dengan sekali klik.</a:t>
             </a:r>
           </a:p>
           <a:p>
@@ -8583,7 +8583,7 @@
                 </a:solidFill>
                 <a:latin typeface="Segoe UI"/>
               </a:rPr>
-              <a:t>Pips kini memberi tahu server Teman versi yang dipakai, jadi daftar update selalu akurat.</a:t>
+              <a:t>Ketik @nama untuk memanggil seseorang di #umum. Bisukan #umum kapan saja; pemilik dan moderator bisa menghapus pesan.</a:t>
             </a:r>
           </a:p>
           <a:p>
@@ -8608,7 +8608,7 @@
                 </a:solidFill>
                 <a:latin typeface="Segoe UI"/>
               </a:rPr>
-              <a:t>Fitur Teman tetap jalan saat alat proxy lokal tidak merespons - Pips beralih ke pengaturan proxy Windows.</a:t>
+              <a:t>Bisa juga dibuka dari menu pet (Komunitas Pips). Diperbaiki: chat tidak lagi menghapus ketikanmu saat Pips memperbarui di latar belakang.</a:t>
             </a:r>
           </a:p>
         </p:txBody>
@@ -8840,7 +8840,7 @@
         </p:nvGraphicFramePr>
         <p:xfrm>
           <a:off x="548640" y="1645920"/>
-          <a:ext cx="11155680" cy="21781008"/>
+          <a:ext cx="11155680" cy="22603968"/>
         </p:xfrm>
         <a:graphic>
           <a:graphicData uri="http://schemas.openxmlformats.org/drawingml/2006/table">
@@ -8934,7 +8934,7 @@
                           </a:solidFill>
                           <a:latin typeface="Segoe UI"/>
                         </a:rPr>
-                        <a:t>2.15.0</a:t>
+                        <a:t>2.16.0</a:t>
                       </a:r>
                     </a:p>
                   </a:txBody>
@@ -8978,7 +8978,7 @@
                           </a:solidFill>
                           <a:latin typeface="Segoe UI"/>
                         </a:rPr>
-                        <a:t>Update reminders</a:t>
+                        <a:t>Pips Community</a:t>
                       </a:r>
                     </a:p>
                     <a:p>
@@ -8989,7 +8989,7 @@
                           </a:solidFill>
                           <a:latin typeface="Segoe UI"/>
                         </a:rPr>
-                        <a:t>Owner &amp; moderators: the Mod tab now lists who hasn't updated Pips yet (their version and when they were last seen), with one-click reminders by e-mail (sent from your Outlook) or a ready-to-send Teams chat.; New Work e-mail field in your Profile, filled in from Outlook. Only the owner and moderators can see it (for update reminders and support) - clear it to hide it.; Pips now tells the Friends server which version it runs, so the update list is always accurate.; Friends keeps working when a local proxy tool stops answering - Pips falls back to the Windows proxy settings.</a:t>
+                        <a:t>New Pips Community at the top of the Chat tab: a #general channel to chat with everyone who uses Pips, plus #announcements with news from the Pips team.; Every new Pips version is announced there automatically - see what's new and update with one click.; Type @name to ping someone in #general. Mute #general any time; owner and moderators can remove messages.; Open it from your pet's menu too (Pips Community). Fixed: chats no longer clear what you're typing when Pips refreshes in the background.</a:t>
                       </a:r>
                     </a:p>
                   </a:txBody>
@@ -9013,7 +9013,7 @@
                           </a:solidFill>
                           <a:latin typeface="Segoe UI"/>
                         </a:rPr>
-                        <a:t>2.14.3</a:t>
+                        <a:t>2.15.0</a:t>
                       </a:r>
                     </a:p>
                   </a:txBody>
@@ -9057,7 +9057,7 @@
                           </a:solidFill>
                           <a:latin typeface="Segoe UI"/>
                         </a:rPr>
-                        <a:t>Tidy menus</a:t>
+                        <a:t>Update reminders</a:t>
                       </a:r>
                     </a:p>
                     <a:p>
@@ -9068,7 +9068,7 @@
                           </a:solidFill>
                           <a:latin typeface="Segoe UI"/>
                         </a:rPr>
-                        <a:t>Fixed: a submenu (e.g. Poke a friend) could stay floating on the screen after the right-click menu closed.; Menus now close by themselves when you move the mouse away and leave them for a few seconds.</a:t>
+                        <a:t>Owner &amp; moderators: the Mod tab now lists who hasn't updated Pips yet (their version and when they were last seen), with one-click reminders by e-mail (sent from your Outlook) or a ready-to-send Teams chat.; New Work e-mail field in your Profile, filled in from Outlook. Only the owner and moderators can see it (for update reminders and support) - clear it to hide it.; Pips now tells the Friends server which version it runs, so the update list is always accurate.; Friends keeps working when a local proxy tool stops answering - Pips falls back to the Windows proxy settings.</a:t>
                       </a:r>
                     </a:p>
                   </a:txBody>
@@ -9092,7 +9092,7 @@
                           </a:solidFill>
                           <a:latin typeface="Segoe UI"/>
                         </a:rPr>
-                        <a:t>2.14.2</a:t>
+                        <a:t>2.14.3</a:t>
                       </a:r>
                     </a:p>
                   </a:txBody>
@@ -9136,7 +9136,7 @@
                           </a:solidFill>
                           <a:latin typeface="Segoe UI"/>
                         </a:rPr>
-                        <a:t>Never miss an update</a:t>
+                        <a:t>Tidy menus</a:t>
                       </a:r>
                     </a:p>
                     <a:p>
@@ -9147,7 +9147,7 @@
                           </a:solidFill>
                           <a:latin typeface="Segoe UI"/>
                         </a:rPr>
-                        <a:t>Your pet now reminds you every 2 hours while a new version is waiting (instead of every 6 hours).; If the reminder can't show (fullscreen app, guided tour, another message), your pet tries again a few minutes later.; No internet when Pips starts (e.g. VPN off)? It checks again after an hour.</a:t>
+                        <a:t>Fixed: a submenu (e.g. Poke a friend) could stay floating on the screen after the right-click menu closed.; Menus now close by themselves when you move the mouse away and leave them for a few seconds.</a:t>
                       </a:r>
                     </a:p>
                   </a:txBody>
@@ -9171,7 +9171,7 @@
                           </a:solidFill>
                           <a:latin typeface="Segoe UI"/>
                         </a:rPr>
-                        <a:t>2.14.1</a:t>
+                        <a:t>2.14.2</a:t>
                       </a:r>
                     </a:p>
                   </a:txBody>
@@ -9215,7 +9215,7 @@
                           </a:solidFill>
                           <a:latin typeface="Segoe UI"/>
                         </a:rPr>
-                        <a:t>One pet at a time</a:t>
+                        <a:t>Never miss an update</a:t>
                       </a:r>
                     </a:p>
                     <a:p>
@@ -9226,7 +9226,7 @@
                           </a:solidFill>
                           <a:latin typeface="Segoe UI"/>
                         </a:rPr>
-                        <a:t>Opening Pips again (Desktop / Start Menu shortcut, autostart) no longer starts a second pet - your pet just pops up and says hi.; Fixes lag caused by two copies of Pips running at once.</a:t>
+                        <a:t>Your pet now reminds you every 2 hours while a new version is waiting (instead of every 6 hours).; If the reminder can't show (fullscreen app, guided tour, another message), your pet tries again a few minutes later.; No internet when Pips starts (e.g. VPN off)? It checks again after an hour.</a:t>
                       </a:r>
                     </a:p>
                   </a:txBody>
@@ -9250,7 +9250,7 @@
                           </a:solidFill>
                           <a:latin typeface="Segoe UI"/>
                         </a:rPr>
-                        <a:t>2.14.0</a:t>
+                        <a:t>2.14.1</a:t>
                       </a:r>
                     </a:p>
                   </a:txBody>
@@ -9294,7 +9294,7 @@
                           </a:solidFill>
                           <a:latin typeface="Segoe UI"/>
                         </a:rPr>
-                        <a:t>Pokes, tickles &amp; teases</a:t>
+                        <a:t>One pet at a time</a:t>
                       </a:r>
                     </a:p>
                     <a:p>
@@ -9305,7 +9305,7 @@
                           </a:solidFill>
                           <a:latin typeface="Segoe UI"/>
                         </a:rPr>
-                        <a:t>Poke, tickle, tease, boop or hug a friend from afar - no pet visit needed.; Right-click your pet → Poke a friend, or use the Poke button in Friends, chat and profiles.; Your friend gets a pop-up ("Wendy is teasing you!"), their pet reacts, and they can poke back with one click.; During a focus session pokes wait quietly until your break; when your pet is hidden they show in the screen corner.</a:t>
+                        <a:t>Opening Pips again (Desktop / Start Menu shortcut, autostart) no longer starts a second pet - your pet just pops up and says hi.; Fixes lag caused by two copies of Pips running at once.</a:t>
                       </a:r>
                     </a:p>
                   </a:txBody>
@@ -9329,7 +9329,7 @@
                           </a:solidFill>
                           <a:latin typeface="Segoe UI"/>
                         </a:rPr>
-                        <a:t>2.13.1</a:t>
+                        <a:t>2.14.0</a:t>
                       </a:r>
                     </a:p>
                   </a:txBody>
@@ -9351,7 +9351,7 @@
                           </a:solidFill>
                           <a:latin typeface="Segoe UI"/>
                         </a:rPr>
-                        <a:t>2026-10-28</a:t>
+                        <a:t>2026-10-29</a:t>
                       </a:r>
                     </a:p>
                   </a:txBody>
@@ -9373,7 +9373,7 @@
                           </a:solidFill>
                           <a:latin typeface="Segoe UI"/>
                         </a:rPr>
-                        <a:t>One-click Windows installer</a:t>
+                        <a:t>Pokes, tickles &amp; teases</a:t>
                       </a:r>
                     </a:p>
                     <a:p>
@@ -9384,7 +9384,7 @@
                           </a:solidFill>
                           <a:latin typeface="Segoe UI"/>
                         </a:rPr>
-                        <a:t>One Windows installer: no ZIP extraction, Python installation or command line. Download, open and click Install Pips.; Installs for your Windows account without administrator access, adds Desktop and Start Menu shortcuts, and opens Pips automatically.; Reinstalling in the same location keeps your settings and pet progress. Existing ZIP users can keep updating in place from Help → Check for updates.; A simpler download page and updated user guide; the bundled runtime stays separate from small in-app updates.</a:t>
+                        <a:t>Poke, tickle, tease, boop or hug a friend from afar - no pet visit needed.; Right-click your pet → Poke a friend, or use the Poke button in Friends, chat and profiles.; Your friend gets a pop-up ("Wendy is teasing you!"), their pet reacts, and they can poke back with one click.; During a focus session pokes wait quietly until your break; when your pet is hidden they show in the screen corner.</a:t>
                       </a:r>
                     </a:p>
                   </a:txBody>
@@ -9408,7 +9408,7 @@
                           </a:solidFill>
                           <a:latin typeface="Segoe UI"/>
                         </a:rPr>
-                        <a:t>2.13.0</a:t>
+                        <a:t>2.13.1</a:t>
                       </a:r>
                     </a:p>
                   </a:txBody>
@@ -9452,7 +9452,7 @@
                           </a:solidFill>
                           <a:latin typeface="Segoe UI"/>
                         </a:rPr>
-                        <a:t>Birthdays, parties &amp; gifts</a:t>
+                        <a:t>One-click Windows installer</a:t>
                       </a:r>
                     </a:p>
                     <a:p>
@@ -9463,7 +9463,7 @@
                           </a:solidFill>
                           <a:latin typeface="Segoe UI"/>
                         </a:rPr>
-                        <a:t>Set your birthday in Social → Profile (month + day, optionally visible to friends).; On your birthday Pips throws confetti and gives you 100 bonus coins.; Friends tab shows upcoming birthdays; you get reminders 3 days, 1 day and on the day.; Birthday parties: join a friend's party, see who's there, sign the guestbook and celebrate together.</a:t>
+                        <a:t>One Windows installer: no ZIP extraction, Python installation or command line. Download, open and click Install Pips.; Installs for your Windows account without administrator access, adds Desktop and Start Menu shortcuts, and opens Pips automatically.; Reinstalling in the same location keeps your settings and pet progress. Existing ZIP users can keep updating in place from Help → Check for updates.; A simpler download page and updated user guide; the bundled runtime stays separate from small in-app updates.</a:t>
                       </a:r>
                     </a:p>
                   </a:txBody>
@@ -9487,7 +9487,7 @@
                           </a:solidFill>
                           <a:latin typeface="Segoe UI"/>
                         </a:rPr>
-                        <a:t>2.12.0</a:t>
+                        <a:t>2.13.0</a:t>
                       </a:r>
                     </a:p>
                   </a:txBody>
@@ -9531,7 +9531,7 @@
                           </a:solidFill>
                           <a:latin typeface="Segoe UI"/>
                         </a:rPr>
-                        <a:t>Mega update: 28 new animals, 31 shop items, 13 moves</a:t>
+                        <a:t>Birthdays, parties &amp; gifts</a:t>
                       </a:r>
                     </a:p>
                     <a:p>
@@ -9542,7 +9542,7 @@
                           </a:solidFill>
                           <a:latin typeface="Segoe UI"/>
                         </a:rPr>
-                        <a:t>🦁 28 new animals (51 total): lion, tiger, unicorn, deer, sheep, cow, raccoon, red panda, monkey, hedgehog, dino, squirrel, mouse, koala, shark, dolphin, seal, otter, pufferfish, duck, crab, parrot, chick, ladybug, phoenix, pegasus, ghost and flamingo; 🎩 31 new shop items: top hat, cowboy, chef, pirate, Santa, viking, graduation cap, beret, bow, propeller cap, flower crown, nerd glasses, eyepatch, mustache, goggles, masquerade mask, tie, pearls, flower lei, gold chain, balloon, backpack, guitar, shield, butterfly / devil wings and more - plus Premium galaxy crown, galaxy cape and dragon wings; 💃 13 new moves: wave, jump, hearts, sing, yoga, zoomies, cartwheel, juggle, rain dance, breakdance, magic, confetti and the Premium rocket launch; The Shop is now split into sections (Hats, Face, Neck, Back, Moves, Arena gear) with an owned counter for each</a:t>
+                        <a:t>Set your birthday in Social → Profile (month + day, optionally visible to friends).; On your birthday Pips throws confetti and gives you 100 bonus coins.; Friends tab shows upcoming birthdays; you get reminders 3 days, 1 day and on the day.; Birthday parties: join a friend's party, see who's there, sign the guestbook and celebrate together.</a:t>
                       </a:r>
                     </a:p>
                   </a:txBody>
@@ -9566,7 +9566,7 @@
                           </a:solidFill>
                           <a:latin typeface="Segoe UI"/>
                         </a:rPr>
-                        <a:t>2.11.0</a:t>
+                        <a:t>2.12.0</a:t>
                       </a:r>
                     </a:p>
                   </a:txBody>
@@ -9610,7 +9610,7 @@
                           </a:solidFill>
                           <a:latin typeface="Segoe UI"/>
                         </a:rPr>
-                        <a:t>New right-click menus</a:t>
+                        <a:t>Mega update: 28 new animals, 31 shop items, 13 moves</a:t>
                       </a:r>
                     </a:p>
                     <a:p>
@@ -9621,7 +9621,7 @@
                           </a:solidFill>
                           <a:latin typeface="Segoe UI"/>
                         </a:rPr>
-                        <a:t>✨ Brand-new animated right-click menu for your pet: mood &amp; stat bars, quick-action tiles (Friends, Shop, Snack, Pat, Focus, Stats, Sleep, Taskbar), hover effects and smooth fly-out submenus; Pick colours from swatches, switch size with one click and flip Sounds / Dark mode with toggle switches - changes show instantly; Updates are highlighted: a glowing banner and NEW badge appear in the menu when a new version is ready; The focus card's right-click menu got the same new look; keyboard arrows, Enter and Esc work too</a:t>
+                        <a:t>🦁 28 new animals (51 total): lion, tiger, unicorn, deer, sheep, cow, raccoon, red panda, monkey, hedgehog, dino, squirrel, mouse, koala, shark, dolphin, seal, otter, pufferfish, duck, crab, parrot, chick, ladybug, phoenix, pegasus, ghost and flamingo; 🎩 31 new shop items: top hat, cowboy, chef, pirate, Santa, viking, graduation cap, beret, bow, propeller cap, flower crown, nerd glasses, eyepatch, mustache, goggles, masquerade mask, tie, pearls, flower lei, gold chain, balloon, backpack, guitar, shield, butterfly / devil wings and more - plus Premium galaxy crown, galaxy cape and dragon wings; 💃 13 new moves: wave, jump, hearts, sing, yoga, zoomies, cartwheel, juggle, rain dance, breakdance, magic, confetti and the Premium rocket launch; The Shop is now split into sections (Hats, Face, Neck, Back, Moves, Arena gear) with an owned counter for each</a:t>
                       </a:r>
                     </a:p>
                   </a:txBody>
@@ -9645,7 +9645,7 @@
                           </a:solidFill>
                           <a:latin typeface="Segoe UI"/>
                         </a:rPr>
-                        <a:t>2.10.0</a:t>
+                        <a:t>2.11.0</a:t>
                       </a:r>
                     </a:p>
                   </a:txBody>
@@ -9689,7 +9689,7 @@
                           </a:solidFill>
                           <a:latin typeface="Segoe UI"/>
                         </a:rPr>
-                        <a:t>Chat bots</a:t>
+                        <a:t>New right-click menus</a:t>
                       </a:r>
                     </a:p>
                     <a:p>
@@ -9700,7 +9700,7 @@
                           </a:solidFill>
                           <a:latin typeface="Segoe UI"/>
                         </a:rPr>
-                        <a:t>🤖 6 friendly chat bots in the Chat tab: Pip Helper (app questions), Coach Focus (focus tips from your real stats), Sunny (live weather for any city), Arena Master (battle tips + quick battle), Giggles (jokes &amp; games) and Guardian (safety &amp; reporting help); Private bot chats with suggestion chips, typing indicator and a clear button - your bot chats stay on your PC; Mention a bot in a group chat (e.g. @weather Batam) and it answers in the room for everyone; Bots reply in your app language; up to 120 bot messages per day</a:t>
+                        <a:t>✨ Brand-new animated right-click menu for your pet: mood &amp; stat bars, quick-action tiles (Friends, Shop, Snack, Pat, Focus, Stats, Sleep, Taskbar), hover effects and smooth fly-out submenus; Pick colours from swatches, switch size with one click and flip Sounds / Dark mode with toggle switches - changes show instantly; Updates are highlighted: a glowing banner and NEW badge appear in the menu when a new version is ready; The focus card's right-click menu got the same new look; keyboard arrows, Enter and Esc work too</a:t>
                       </a:r>
                     </a:p>
                   </a:txBody>
@@ -9724,7 +9724,7 @@
                           </a:solidFill>
                           <a:latin typeface="Segoe UI"/>
                         </a:rPr>
-                        <a:t>2.9.0</a:t>
+                        <a:t>2.10.0</a:t>
                       </a:r>
                     </a:p>
                   </a:txBody>
@@ -9768,7 +9768,7 @@
                           </a:solidFill>
                           <a:latin typeface="Segoe UI"/>
                         </a:rPr>
-                        <a:t>Location &amp; live weather</a:t>
+                        <a:t>Chat bots</a:t>
                       </a:r>
                     </a:p>
                     <a:p>
@@ -9779,7 +9779,7 @@
                           </a:solidFill>
                           <a:latin typeface="Segoe UI"/>
                         </a:rPr>
-                        <a:t>📍 Add your city in Profile → Location &amp; weather (auto-detect or search) - only your city and country are shown, never your exact position; Live weather banners on every profile with animations: rain, drizzle, thunderstorms with lightning, snow, fog, clouds, sunshine or a starry night - plus temperature, feels-like, humidity, wind and local time; Your own weather strip on top of the hub, and each friend's weather + local time in the friends list; Hide your location from others or remove it any time</a:t>
+                        <a:t>🤖 6 friendly chat bots in the Chat tab: Pip Helper (app questions), Coach Focus (focus tips from your real stats), Sunny (live weather for any city), Arena Master (battle tips + quick battle), Giggles (jokes &amp; games) and Guardian (safety &amp; reporting help); Private bot chats with suggestion chips, typing indicator and a clear button - your bot chats stay on your PC; Mention a bot in a group chat (e.g. @weather Batam) and it answers in the room for everyone; Bots reply in your app language; up to 120 bot messages per day</a:t>
                       </a:r>
                     </a:p>
                   </a:txBody>
@@ -9803,7 +9803,7 @@
                           </a:solidFill>
                           <a:latin typeface="Segoe UI"/>
                         </a:rPr>
-                        <a:t>2.8.0</a:t>
+                        <a:t>2.9.0</a:t>
                       </a:r>
                     </a:p>
                   </a:txBody>
@@ -9847,7 +9847,7 @@
                           </a:solidFill>
                           <a:latin typeface="Segoe UI"/>
                         </a:rPr>
-                        <a:t>Pips Arena - duels, gear &amp; live battles</a:t>
+                        <a:t>Location &amp; live weather</a:t>
                       </a:r>
                     </a:p>
                     <a:p>
@@ -9858,7 +9858,7 @@
                           </a:solidFill>
                           <a:latin typeface="Segoe UI"/>
                         </a:rPr>
-                        <a:t>⚔ New Arena tab: challenge friends or anyone in the arena to a live duel - each round pick Attack, Guard or Special within 12 seconds and watch your pets fight; ⚡ Quick battle: an instant auto-fight against anyone's fighter, even when they're offline; Arena gear in the Shop: 7 weapons (water pistol to rocket launcher), 5 armors and 5 gadgets that decide your special move - better gear and a higher level make a stronger fighter; Live duels can be watched by everyone, plus recent battle replays, top fighters, rating and win/loss records; wins earn coins</a:t>
+                        <a:t>📍 Add your city in Profile → Location &amp; weather (auto-detect or search) - only your city and country are shown, never your exact position; Live weather banners on every profile with animations: rain, drizzle, thunderstorms with lightning, snow, fog, clouds, sunshine or a starry night - plus temperature, feels-like, humidity, wind and local time; Your own weather strip on top of the hub, and each friend's weather + local time in the friends list; Hide your location from others or remove it any time</a:t>
                       </a:r>
                     </a:p>
                   </a:txBody>
@@ -9882,7 +9882,7 @@
                           </a:solidFill>
                           <a:latin typeface="Segoe UI"/>
                         </a:rPr>
-                        <a:t>2.7.0</a:t>
+                        <a:t>2.8.0</a:t>
                       </a:r>
                     </a:p>
                   </a:txBody>
@@ -9926,7 +9926,7 @@
                           </a:solidFill>
                           <a:latin typeface="Segoe UI"/>
                         </a:rPr>
-                        <a:t>Moderators &amp; Premium</a:t>
+                        <a:t>Pips Arena - duels, gear &amp; live battles</a:t>
                       </a:r>
                     </a:p>
                     <a:p>
@@ -9937,7 +9937,7 @@
                           </a:solidFill>
                           <a:latin typeface="Segoe UI"/>
                         </a:rPr>
-                        <a:t>★ Premium: a purple Premium badge, 4 exclusive props (tiara, star glasses, diamond necklace, fairy wings), the Fireworks move, +30 coins every day, double friend-interaction coins and room for 300 friends / 30 groups; Get Premium: Profile tab → Premium → "Ask to buy" emails the owner; after payment you receive a key (PIPS-XXXX-XXXX) to redeem right there; 🛡 Moderators: a blue Mod badge and a Mod tab with the report queue - warn, mute (1h / 24h / 7 days), clear a profile or reset a name; every action is logged; Report button on everyone's profile, so moderators can keep Pips friendly</a:t>
+                        <a:t>⚔ New Arena tab: challenge friends or anyone in the arena to a live duel - each round pick Attack, Guard or Special within 12 seconds and watch your pets fight; ⚡ Quick battle: an instant auto-fight against anyone's fighter, even when they're offline; Arena gear in the Shop: 7 weapons (water pistol to rocket launcher), 5 armors and 5 gadgets that decide your special move - better gear and a higher level make a stronger fighter; Live duels can be watched by everyone, plus recent battle replays, top fighters, rating and win/loss records; wins earn coins</a:t>
                       </a:r>
                     </a:p>
                   </a:txBody>
@@ -9961,7 +9961,7 @@
                           </a:solidFill>
                           <a:latin typeface="Segoe UI"/>
                         </a:rPr>
-                        <a:t>2.6.1</a:t>
+                        <a:t>2.7.0</a:t>
                       </a:r>
                     </a:p>
                   </a:txBody>
@@ -10005,7 +10005,7 @@
                           </a:solidFill>
                           <a:latin typeface="Segoe UI"/>
                         </a:rPr>
-                        <a:t>Owner badge &amp; credits</a:t>
+                        <a:t>Moderators &amp; Premium</a:t>
                       </a:r>
                     </a:p>
                     <a:p>
@@ -10016,7 +10016,7 @@
                           </a:solidFill>
                           <a:latin typeface="Segoe UI"/>
                         </a:rPr>
-                        <a:t>The creator of Pips (Juwen Lie) now shows a gold ♛ Owner badge on his profile, friend list and ranks; New About Pips card in the Profile tab: credits and how to contact the owner (Juwen_Lie@pegatroncorp.com) with Email and Copy buttons; Right-click the pet → Help → About now shows who made Pips and the contact email</a:t>
+                        <a:t>★ Premium: a purple Premium badge, 4 exclusive props (tiara, star glasses, diamond necklace, fairy wings), the Fireworks move, +30 coins every day, double friend-interaction coins and room for 300 friends / 30 groups; Get Premium: Profile tab → Premium → "Ask to buy" emails the owner; after payment you receive a key (PIPS-XXXX-XXXX) to redeem right there; 🛡 Moderators: a blue Mod badge and a Mod tab with the report queue - warn, mute (1h / 24h / 7 days), clear a profile or reset a name; every action is logged; Report button on everyone's profile, so moderators can keep Pips friendly</a:t>
                       </a:r>
                     </a:p>
                   </a:txBody>
@@ -10040,7 +10040,7 @@
                           </a:solidFill>
                           <a:latin typeface="Segoe UI"/>
                         </a:rPr>
-                        <a:t>2.6.0</a:t>
+                        <a:t>2.6.1</a:t>
                       </a:r>
                     </a:p>
                   </a:txBody>
@@ -10084,7 +10084,7 @@
                           </a:solidFill>
                           <a:latin typeface="Segoe UI"/>
                         </a:rPr>
-                        <a:t>Profiles, ranks, online status &amp; dark mode</a:t>
+                        <a:t>Owner badge &amp; credits</a:t>
                       </a:r>
                     </a:p>
                     <a:p>
@@ -10095,7 +10095,7 @@
                           </a:solidFill>
                           <a:latin typeface="Segoe UI"/>
                         </a:rPr>
-                        <a:t>Profile tab: profile picture (or your pet), about me, job, location, hobbies, birthday and a status message; Public or private: public profiles can be added directly and viewed in full; private profiles need a friend request that they accept, and strangers only see name, photo, pet, level and status; Click anyone to open their profile - badges, info, their friends - and add them, chat or wave from there; Ranks tab replaces Teams: everyone using Pips, sorted by XP, badges or streak</a:t>
+                        <a:t>The creator of Pips (Juwen Lie) now shows a gold ♛ Owner badge on his profile, friend list and ranks; New About Pips card in the Profile tab: credits and how to contact the owner (Juwen_Lie@pegatroncorp.com) with Email and Copy buttons; Right-click the pet → Help → About now shows who made Pips and the contact email</a:t>
                       </a:r>
                     </a:p>
                   </a:txBody>
@@ -10119,7 +10119,7 @@
                           </a:solidFill>
                           <a:latin typeface="Segoe UI"/>
                         </a:rPr>
-                        <a:t>2.5.1</a:t>
+                        <a:t>2.6.0</a:t>
                       </a:r>
                     </a:p>
                   </a:txBody>
@@ -10163,7 +10163,7 @@
                           </a:solidFill>
                           <a:latin typeface="Segoe UI"/>
                         </a:rPr>
-                        <a:t>New cute Pips logo</a:t>
+                        <a:t>Profiles, ranks, online status &amp; dark mode</a:t>
                       </a:r>
                     </a:p>
                     <a:p>
@@ -10174,7 +10174,7 @@
                           </a:solidFill>
                           <a:latin typeface="Segoe UI"/>
                         </a:rPr>
-                        <a:t>New Pips logo: Pip the cat on a Pips-red tile, matching the app colours (desktop shortcut, windows and website)</a:t>
+                        <a:t>Profile tab: profile picture (or your pet), about me, job, location, hobbies, birthday and a status message; Public or private: public profiles can be added directly and viewed in full; private profiles need a friend request that they accept, and strangers only see name, photo, pet, level and status; Click anyone to open their profile - badges, info, their friends - and add them, chat or wave from there; Ranks tab replaces Teams: everyone using Pips, sorted by XP, badges or streak</a:t>
                       </a:r>
                     </a:p>
                   </a:txBody>
@@ -10198,7 +10198,7 @@
                           </a:solidFill>
                           <a:latin typeface="Segoe UI"/>
                         </a:rPr>
-                        <a:t>2.5.0</a:t>
+                        <a:t>2.5.1</a:t>
                       </a:r>
                     </a:p>
                   </a:txBody>
@@ -10242,7 +10242,7 @@
                           </a:solidFill>
                           <a:latin typeface="Segoe UI"/>
                         </a:rPr>
-                        <a:t>Shop, coins, props &amp; moves</a:t>
+                        <a:t>New cute Pips logo</a:t>
                       </a:r>
                     </a:p>
                     <a:p>
@@ -10253,7 +10253,7 @@
                           </a:solidFill>
                           <a:latin typeface="Segoe UI"/>
                         </a:rPr>
-                        <a:t>Shop: earn coins and spend them on your pet - 17 props (crown, wizard hat, headphones, shades, scarf, cape, angel wings...) and 6 moves: spin, dance, moonwalk, backflip, kung fu and spider swing!; Coins come from leveling up (+40), badges (+25), opening Pips each day (+10), friendships (+15 per affinity level), waving / chatting / visiting friends (+2) and pomodoros (+5). Everyone starts with a 100-coin gift; Your friends see your props: on avatars in the hub and when your pet visits their desktop - it shows off one of your moves; Pips is now a social pet: clicking the pet opens the Pips hub (friends, chat, groups, shop, badges)</a:t>
+                        <a:t>New Pips logo: Pip the cat on a Pips-red tile, matching the app colours (desktop shortcut, windows and website)</a:t>
                       </a:r>
                     </a:p>
                   </a:txBody>
@@ -10277,7 +10277,7 @@
                           </a:solidFill>
                           <a:latin typeface="Segoe UI"/>
                         </a:rPr>
-                        <a:t>2.4.0</a:t>
+                        <a:t>2.5.0</a:t>
                       </a:r>
                     </a:p>
                   </a:txBody>
@@ -10321,7 +10321,7 @@
                           </a:solidFill>
                           <a:latin typeface="Segoe UI"/>
                         </a:rPr>
-                        <a:t>Chat, groups, affinity &amp; pet visits</a:t>
+                        <a:t>Shop, coins, props &amp; moves</a:t>
                       </a:r>
                     </a:p>
                     <a:p>
@@ -10332,7 +10332,7 @@
                           </a:solidFill>
                           <a:latin typeface="Segoe UI"/>
                         </a:rPr>
-                        <a:t>Chat: message your friends, and chat inside groups. Your pet pops up new messages as a bubble - click it to reply; Pet interactions: wave, pet their pet, send a snack, high five - or send your pet to visit: it walks onto your friend's desktop for a little while!; Affinity: every chat and interaction grows your friendship - Acquaintance → Buddy → Good friends → Close friends → Best friends → Soulmates; Your own groups: create a private group, invite your friends, they accept or decline. Group board + group chat; the owner can remove members</a:t>
+                        <a:t>Shop: earn coins and spend them on your pet - 17 props (crown, wizard hat, headphones, shades, scarf, cape, angel wings...) and 6 moves: spin, dance, moonwalk, backflip, kung fu and spider swing!; Coins come from leveling up (+40), badges (+25), opening Pips each day (+10), friendships (+15 per affinity level), waving / chatting / visiting friends (+2) and pomodoros (+5). Everyone starts with a 100-coin gift; Your friends see your props: on avatars in the hub and when your pet visits their desktop - it shows off one of your moves; Pips is now a social pet: clicking the pet opens the Pips hub (friends, chat, groups, shop, badges)</a:t>
                       </a:r>
                     </a:p>
                   </a:txBody>
@@ -10356,7 +10356,7 @@
                           </a:solidFill>
                           <a:latin typeface="Segoe UI"/>
                         </a:rPr>
-                        <a:t>2.3.0</a:t>
+                        <a:t>2.4.0</a:t>
                       </a:r>
                     </a:p>
                   </a:txBody>
@@ -10400,7 +10400,7 @@
                           </a:solidFill>
                           <a:latin typeface="Segoe UI"/>
                         </a:rPr>
-                        <a:t>Friends, levels &amp; achievements</a:t>
+                        <a:t>Chat, groups, affinity &amp; pet visits</a:t>
                       </a:r>
                     </a:p>
                     <a:p>
@@ -10411,7 +10411,7 @@
                           </a:solidFill>
                           <a:latin typeface="Segoe UI"/>
                         </a:rPr>
-                        <a:t>Levels &amp; XP: every finished pomodoro earns XP and your level grows - plus 20 achievements to unlock (first tomato, 8 in a day, 7-day streak, early bird, night owl, pet lover...). Your pet celebrates each one; Friends (optional, off by default): get a 6-letter friend code, add colleagues, see today's board and join a team board like PTB. Your pet tells you when a friend finishes a pomodoro; Privacy: only your name, pet, level, streak and pomodoro counts are shared - never apps, window titles or scores. One click turns it off and deletes your online data. Right-click the pet → Friends &amp; achievements…</a:t>
+                        <a:t>Chat: message your friends, and chat inside groups. Your pet pops up new messages as a bubble - click it to reply; Pet interactions: wave, pet their pet, send a snack, high five - or send your pet to visit: it walks onto your friend's desktop for a little while!; Affinity: every chat and interaction grows your friendship - Acquaintance → Buddy → Good friends → Close friends → Best friends → Soulmates; Your own groups: create a private group, invite your friends, they accept or decline. Group board + group chat; the owner can remove members</a:t>
                       </a:r>
                     </a:p>
                   </a:txBody>
@@ -10435,7 +10435,7 @@
                           </a:solidFill>
                           <a:latin typeface="Segoe UI"/>
                         </a:rPr>
-                        <a:t>2.2.0</a:t>
+                        <a:t>2.3.0</a:t>
                       </a:r>
                     </a:p>
                   </a:txBody>
@@ -10479,7 +10479,7 @@
                           </a:solidFill>
                           <a:latin typeface="Segoe UI"/>
                         </a:rPr>
-                        <a:t>Pet sounds</a:t>
+                        <a:t>Friends, levels &amp; achievements</a:t>
                       </a:r>
                     </a:p>
                     <a:p>
@@ -10490,7 +10490,7 @@
                           </a:solidFill>
                           <a:latin typeface="Segoe UI"/>
                         </a:rPr>
-                        <a:t>Your pet has a voice! Each of the 23 animals has its own sound (meow, woof, ribbit, hoot, buzz, oink, whale song...) and it changes with its mood: happy chirps, sad whimpers, sleepy yawns, hungry calls, grumpy huffs and soft snores; It also reacts with sound when you tickle, pet, feed, shake or wake it; Settings: right-click the pet → Sounds to switch on/off; Pet status &amp; settings has a volume slider, a ▶ Hear me button and "Stay quiet while I'm focusing" (on by default)</a:t>
+                        <a:t>Levels &amp; XP: every finished pomodoro earns XP and your level grows - plus 20 achievements to unlock (first tomato, 8 in a day, 7-day streak, early bird, night owl, pet lover...). Your pet celebrates each one; Friends (optional, off by default): get a 6-letter friend code, add colleagues, see today's board and join a team board like PTB. Your pet tells you when a friend finishes a pomodoro; Privacy: only your name, pet, level, streak and pomodoro counts are shared - never apps, window titles or scores. One click turns it off and deletes your online data. Right-click the pet → Friends &amp; achievements…</a:t>
                       </a:r>
                     </a:p>
                   </a:txBody>
@@ -10514,7 +10514,7 @@
                           </a:solidFill>
                           <a:latin typeface="Segoe UI"/>
                         </a:rPr>
-                        <a:t>2.1.2</a:t>
+                        <a:t>2.2.0</a:t>
                       </a:r>
                     </a:p>
                   </a:txBody>
@@ -10558,7 +10558,7 @@
                           </a:solidFill>
                           <a:latin typeface="Segoe UI"/>
                         </a:rPr>
-                        <a:t>Tickle-only mode</a:t>
+                        <a:t>Pet sounds</a:t>
                       </a:r>
                     </a:p>
                     <a:p>
@@ -10569,7 +10569,7 @@
                           </a:solidFill>
                           <a:latin typeface="Segoe UI"/>
                         </a:rPr>
-                        <a:t>New click option "Only tickle (never open Pips)": click and tickle your pet as much as you like - the Pomodoro window stays closed (open it from the right-click menu). Right-click the pet → When I click</a:t>
+                        <a:t>Your pet has a voice! Each of the 23 animals has its own sound (meow, woof, ribbit, hoot, buzz, oink, whale song...) and it changes with its mood: happy chirps, sad whimpers, sleepy yawns, hungry calls, grumpy huffs and soft snores; It also reacts with sound when you tickle, pet, feed, shake or wake it; Settings: right-click the pet → Sounds to switch on/off; Pet status &amp; settings has a volume slider, a ▶ Hear me button and "Stay quiet while I'm focusing" (on by default)</a:t>
                       </a:r>
                     </a:p>
                   </a:txBody>
@@ -10593,7 +10593,7 @@
                           </a:solidFill>
                           <a:latin typeface="Segoe UI"/>
                         </a:rPr>
-                        <a:t>2.1.1</a:t>
+                        <a:t>2.1.2</a:t>
                       </a:r>
                     </a:p>
                   </a:txBody>
@@ -10637,7 +10637,7 @@
                           </a:solidFill>
                           <a:latin typeface="Segoe UI"/>
                         </a:rPr>
-                        <a:t>Owner info</a:t>
+                        <a:t>Tickle-only mode</a:t>
                       </a:r>
                     </a:p>
                     <a:p>
@@ -10648,7 +10648,7 @@
                           </a:solidFill>
                           <a:latin typeface="Segoe UI"/>
                         </a:rPr>
-                        <a:t>About Pips now shows the owner: Juwen Lie (right-click the pet → Help → About)</a:t>
+                        <a:t>New click option "Only tickle (never open Pips)": click and tickle your pet as much as you like - the Pomodoro window stays closed (open it from the right-click menu). Right-click the pet → When I click</a:t>
                       </a:r>
                     </a:p>
                   </a:txBody>
@@ -10672,7 +10672,7 @@
                           </a:solidFill>
                           <a:latin typeface="Segoe UI"/>
                         </a:rPr>
-                        <a:t>2.1.0</a:t>
+                        <a:t>2.1.1</a:t>
                       </a:r>
                     </a:p>
                   </a:txBody>
@@ -10716,7 +10716,7 @@
                           </a:solidFill>
                           <a:latin typeface="Segoe UI"/>
                         </a:rPr>
-                        <a:t>Interactive guide &amp; in-app updates</a:t>
+                        <a:t>Owner info</a:t>
                       </a:r>
                     </a:p>
                     <a:p>
@@ -10727,7 +10727,7 @@
                           </a:solidFill>
                           <a:latin typeface="Segoe UI"/>
                         </a:rPr>
-                        <a:t>Interactive first-run guide: your pet walks you through clicking, dragging, petting and the right-click menu; In-app updates: Pips tells you when a new version is out - update with one click (your settings and data are kept); New Help menu: replay the guide, check for updates, see the version; Option to turn automatic update checks off</a:t>
+                        <a:t>About Pips now shows the owner: Juwen Lie (right-click the pet → Help → About)</a:t>
                       </a:r>
                     </a:p>
                   </a:txBody>
@@ -10751,7 +10751,7 @@
                           </a:solidFill>
                           <a:latin typeface="Segoe UI"/>
                         </a:rPr>
-                        <a:t>2.0.0</a:t>
+                        <a:t>2.1.0</a:t>
                       </a:r>
                     </a:p>
                   </a:txBody>
@@ -10795,7 +10795,7 @@
                           </a:solidFill>
                           <a:latin typeface="Segoe UI"/>
                         </a:rPr>
-                        <a:t>Desktop pet, 23 animals &amp; 4 languages</a:t>
+                        <a:t>Interactive guide &amp; in-app updates</a:t>
                       </a:r>
                     </a:p>
                     <a:p>
@@ -10806,7 +10806,7 @@
                           </a:solidFill>
                           <a:latin typeface="Segoe UI"/>
                         </a:rPr>
-                        <a:t>Desktop pet that lives on your desktop and taskbar - drag it, tickle it, pet it; 23 animals in 3 groups: Land walks, Water swims with bubbles, Sky hovers and flaps; Moods (happy, sad, tired, hungry, grumpy...), naps when you're away, wakes up when you're back; Cute chat-bubble reminders: breaks, water, 20-20-20 eye rest, pomodoro done, daily goal</a:t>
+                        <a:t>Interactive first-run guide: your pet walks you through clicking, dragging, petting and the right-click menu; In-app updates: Pips tells you when a new version is out - update with one click (your settings and data are kept); New Help menu: replay the guide, check for updates, see the version; Option to turn automatic update checks off</a:t>
                       </a:r>
                     </a:p>
                   </a:txBody>
@@ -10830,7 +10830,7 @@
                           </a:solidFill>
                           <a:latin typeface="Segoe UI"/>
                         </a:rPr>
-                        <a:t>1.5.0</a:t>
+                        <a:t>2.0.0</a:t>
                       </a:r>
                     </a:p>
                   </a:txBody>
@@ -10852,7 +10852,7 @@
                           </a:solidFill>
                           <a:latin typeface="Segoe UI"/>
                         </a:rPr>
-                        <a:t>2026-10-24</a:t>
+                        <a:t>2026-10-28</a:t>
                       </a:r>
                     </a:p>
                   </a:txBody>
@@ -10874,7 +10874,7 @@
                           </a:solidFill>
                           <a:latin typeface="Segoe UI"/>
                         </a:rPr>
-                        <a:t>Renamed to Pips + insights</a:t>
+                        <a:t>Desktop pet, 23 animals &amp; 4 languages</a:t>
                       </a:r>
                     </a:p>
                     <a:p>
@@ -10885,7 +10885,7 @@
                           </a:solidFill>
                           <a:latin typeface="Segoe UI"/>
                         </a:rPr>
-                        <a:t>Renamed from Productivity Widget to Pips; Dashboard charts: focus timeline, hour heatmap, 7-day score trend, pomodoros per day; AI token usage on the card and dashboard; Daily diary export and weekly / monthly reports</a:t>
+                        <a:t>Desktop pet that lives on your desktop and taskbar - drag it, tickle it, pet it; 23 animals in 3 groups: Land walks, Water swims with bubbles, Sky hovers and flaps; Moods (happy, sad, tired, hungry, grumpy...), naps when you're away, wakes up when you're back; Cute chat-bubble reminders: breaks, water, 20-20-20 eye rest, pomodoro done, daily goal</a:t>
                       </a:r>
                     </a:p>
                   </a:txBody>
@@ -10909,7 +10909,7 @@
                           </a:solidFill>
                           <a:latin typeface="Segoe UI"/>
                         </a:rPr>
-                        <a:t>1.0.0</a:t>
+                        <a:t>1.5.0</a:t>
                       </a:r>
                     </a:p>
                   </a:txBody>
@@ -10931,7 +10931,7 @@
                           </a:solidFill>
                           <a:latin typeface="Segoe UI"/>
                         </a:rPr>
-                        <a:t>2026-10-21</a:t>
+                        <a:t>2026-10-24</a:t>
                       </a:r>
                     </a:p>
                   </a:txBody>
@@ -10953,7 +10953,7 @@
                           </a:solidFill>
                           <a:latin typeface="Segoe UI"/>
                         </a:rPr>
-                        <a:t>First release</a:t>
+                        <a:t>Renamed to Pips + insights</a:t>
                       </a:r>
                     </a:p>
                     <a:p>
@@ -10964,13 +10964,92 @@
                           </a:solidFill>
                           <a:latin typeface="Segoe UI"/>
                         </a:rPr>
-                        <a:t>Always-on-top Pomodoro card with progress ring; Rain / thunder / brown-noise / cafe soundscapes; Live app-usage tracking and a daily 1-5 star focus score; Goals, streaks, XP, coach tips and break reminders</a:t>
+                        <a:t>Renamed from Productivity Widget to Pips; Dashboard charts: focus timeline, hour heatmap, 7-day score trend, pomodoros per day; AI token usage on the card and dashboard; Daily diary export and weekly / monthly reports</a:t>
                       </a:r>
                     </a:p>
                   </a:txBody>
                   <a:tcPr marL="73152" marR="73152" marT="36576" marB="36576">
                     <a:solidFill>
                       <a:srgbClr val="F7F4EC"/>
+                    </a:solidFill>
+                  </a:tcPr>
+                </a:tc>
+              </a:tr>
+              <a:tr h="822960">
+                <a:tc>
+                  <a:txBody>
+                    <a:bodyPr wrap="square"/>
+                    <a:lstStyle/>
+                    <a:p>
+                      <a:r>
+                        <a:rPr sz="1200" b="1">
+                          <a:solidFill>
+                            <a:srgbClr val="2B2A28"/>
+                          </a:solidFill>
+                          <a:latin typeface="Segoe UI"/>
+                        </a:rPr>
+                        <a:t>1.0.0</a:t>
+                      </a:r>
+                    </a:p>
+                  </a:txBody>
+                  <a:tcPr marL="73152" marR="73152" marT="36576" marB="36576">
+                    <a:solidFill>
+                      <a:srgbClr val="FFFDF8"/>
+                    </a:solidFill>
+                  </a:tcPr>
+                </a:tc>
+                <a:tc>
+                  <a:txBody>
+                    <a:bodyPr wrap="square"/>
+                    <a:lstStyle/>
+                    <a:p>
+                      <a:r>
+                        <a:rPr sz="1200" b="0">
+                          <a:solidFill>
+                            <a:srgbClr val="2B2A28"/>
+                          </a:solidFill>
+                          <a:latin typeface="Segoe UI"/>
+                        </a:rPr>
+                        <a:t>2026-10-21</a:t>
+                      </a:r>
+                    </a:p>
+                  </a:txBody>
+                  <a:tcPr marL="73152" marR="73152" marT="36576" marB="36576">
+                    <a:solidFill>
+                      <a:srgbClr val="FFFDF8"/>
+                    </a:solidFill>
+                  </a:tcPr>
+                </a:tc>
+                <a:tc>
+                  <a:txBody>
+                    <a:bodyPr wrap="square"/>
+                    <a:lstStyle/>
+                    <a:p>
+                      <a:r>
+                        <a:rPr sz="1200" b="0">
+                          <a:solidFill>
+                            <a:srgbClr val="2B2A28"/>
+                          </a:solidFill>
+                          <a:latin typeface="Segoe UI"/>
+                        </a:rPr>
+                        <a:t>First release</a:t>
+                      </a:r>
+                    </a:p>
+                    <a:p>
+                      <a:r>
+                        <a:rPr sz="1200" b="0">
+                          <a:solidFill>
+                            <a:srgbClr val="2B2A28"/>
+                          </a:solidFill>
+                          <a:latin typeface="Segoe UI"/>
+                        </a:rPr>
+                        <a:t>Always-on-top Pomodoro card with progress ring; Rain / thunder / brown-noise / cafe soundscapes; Live app-usage tracking and a daily 1-5 star focus score; Goals, streaks, XP, coach tips and break reminders</a:t>
+                      </a:r>
+                    </a:p>
+                  </a:txBody>
+                  <a:tcPr marL="73152" marR="73152" marT="36576" marB="36576">
+                    <a:solidFill>
+                      <a:srgbClr val="FFFDF8"/>
                     </a:solidFill>
                   </a:tcPr>
                 </a:tc>

</xml_diff>

<commit_message>
pips 2.17.0: Find your pet anytime
</commit_message>
<xml_diff>
--- a/apps/pips/web/download/Pips-Guide.pptx
+++ b/apps/pips/web/download/Pips-Guide.pptx
@@ -3292,7 +3292,7 @@
                 </a:solidFill>
                 <a:latin typeface="Segoe UI"/>
               </a:rPr>
-              <a:t>Version 2.16.0  ·  2026-10-29  ·  Made by Juwen Lie (owner)</a:t>
+              <a:t>Version 2.17.0  ·  2026-10-29  ·  Made by Juwen Lie (owner)</a:t>
             </a:r>
           </a:p>
           <a:p>
@@ -7833,7 +7833,7 @@
                           </a:solidFill>
                           <a:latin typeface="Segoe UI"/>
                         </a:rPr>
-                        <a:t>Look on the taskbar. Right-click the card → Pet → Show. It hides during full-screen apps.</a:t>
+                        <a:t>Click the Pips icon next to the clock (it may be under ^) or press Ctrl+Alt+P. Opening Pips again also brings it back. It hides during full-screen apps.</a:t>
                       </a:r>
                     </a:p>
                   </a:txBody>
@@ -8166,7 +8166,7 @@
                 </a:solidFill>
                 <a:latin typeface="Segoe UI"/>
               </a:rPr>
-              <a:t>What's new in 2.16.0</a:t>
+              <a:t>What's new in 2.17.0</a:t>
             </a:r>
           </a:p>
         </p:txBody>
@@ -8279,7 +8279,7 @@
                 </a:solidFill>
                 <a:latin typeface="Segoe UI"/>
               </a:rPr>
-              <a:t>Pips Community  ·  2026-10-29</a:t>
+              <a:t>Find your pet anytime  ·  2026-10-29</a:t>
             </a:r>
           </a:p>
         </p:txBody>
@@ -8327,7 +8327,7 @@
                 </a:solidFill>
                 <a:latin typeface="Segoe UI"/>
               </a:rPr>
-              <a:t>New Pips Community at the top of the Chat tab: a #general channel to chat with everyone who uses Pips, plus #announcements with news from the Pips team.</a:t>
+              <a:t>Pips now has an icon next to the clock: click it to bring your pet back; right-click for the focus timer, Friends &amp; chat or Quit.</a:t>
             </a:r>
           </a:p>
           <a:p>
@@ -8352,7 +8352,7 @@
                 </a:solidFill>
                 <a:latin typeface="Segoe UI"/>
               </a:rPr>
-              <a:t>Every new Pips version is announced there automatically - see what's new and update with one click.</a:t>
+              <a:t>Press Ctrl+Alt+P anywhere to call your pet - it pops up on the screen you're using, even if it was hidden, asleep or behind a fullscreen app.</a:t>
             </a:r>
           </a:p>
           <a:p>
@@ -8377,7 +8377,7 @@
                 </a:solidFill>
                 <a:latin typeface="Segoe UI"/>
               </a:rPr>
-              <a:t>Type @name to ping someone in #general. Mute #general any time; owner and moderators can remove messages.</a:t>
+              <a:t>Opening Pips again from the Start menu or desktop does the same, and your pet walks back by itself if it ever ends up off-screen (e.g. after unplugging a monitor).</a:t>
             </a:r>
           </a:p>
           <a:p>
@@ -8402,7 +8402,7 @@
                 </a:solidFill>
                 <a:latin typeface="Segoe UI"/>
               </a:rPr>
-              <a:t>Open it from your pet's menu too (Pips Community). Fixed: chats no longer clear what you're typing when Pips refreshes in the background.</a:t>
+              <a:t>Hiding your pet now tells you how to bring it back.</a:t>
             </a:r>
           </a:p>
         </p:txBody>
@@ -8533,7 +8533,7 @@
                 </a:solidFill>
                 <a:latin typeface="Segoe UI"/>
               </a:rPr>
-              <a:t>Komunitas Pips baru di bagian atas tab Chat: kanal #umum untuk ngobrol dengan semua pengguna Pips, plus #pengumuman berisi kabar dari tim Pips.</a:t>
+              <a:t>Pips kini punya ikon di dekat jam: klik untuk memanggil pet kembali; klik kanan untuk timer fokus, Teman &amp; chat, atau Keluar.</a:t>
             </a:r>
           </a:p>
           <a:p>
@@ -8558,7 +8558,7 @@
                 </a:solidFill>
                 <a:latin typeface="Segoe UI"/>
               </a:rPr>
-              <a:t>Setiap versi Pips baru diumumkan di sana secara otomatis - lihat yang baru dan update dengan sekali klik.</a:t>
+              <a:t>Tekan Ctrl+Alt+P di mana saja untuk memanggil pet - ia muncul di layar yang sedang kamu pakai, bahkan saat tersembunyi, tidur, atau tertutup aplikasi layar penuh.</a:t>
             </a:r>
           </a:p>
           <a:p>
@@ -8583,7 +8583,7 @@
                 </a:solidFill>
                 <a:latin typeface="Segoe UI"/>
               </a:rPr>
-              <a:t>Ketik @nama untuk memanggil seseorang di #umum. Bisukan #umum kapan saja; pemilik dan moderator bisa menghapus pesan.</a:t>
+              <a:t>Membuka Pips lagi dari menu Start atau desktop juga memanggilnya, dan pet akan kembali sendiri jika sampai keluar layar (misalnya setelah monitor dicabut).</a:t>
             </a:r>
           </a:p>
           <a:p>
@@ -8608,7 +8608,7 @@
                 </a:solidFill>
                 <a:latin typeface="Segoe UI"/>
               </a:rPr>
-              <a:t>Bisa juga dibuka dari menu pet (Komunitas Pips). Diperbaiki: chat tidak lagi menghapus ketikanmu saat Pips memperbarui di latar belakang.</a:t>
+              <a:t>Saat menyembunyikan pet, Pips kini memberi tahu cara memanggilnya kembali.</a:t>
             </a:r>
           </a:p>
         </p:txBody>
@@ -8840,7 +8840,7 @@
         </p:nvGraphicFramePr>
         <p:xfrm>
           <a:off x="548640" y="1645920"/>
-          <a:ext cx="11155680" cy="22603968"/>
+          <a:ext cx="11155680" cy="23426928"/>
         </p:xfrm>
         <a:graphic>
           <a:graphicData uri="http://schemas.openxmlformats.org/drawingml/2006/table">
@@ -8934,7 +8934,7 @@
                           </a:solidFill>
                           <a:latin typeface="Segoe UI"/>
                         </a:rPr>
-                        <a:t>2.16.0</a:t>
+                        <a:t>2.17.0</a:t>
                       </a:r>
                     </a:p>
                   </a:txBody>
@@ -8978,7 +8978,7 @@
                           </a:solidFill>
                           <a:latin typeface="Segoe UI"/>
                         </a:rPr>
-                        <a:t>Pips Community</a:t>
+                        <a:t>Find your pet anytime</a:t>
                       </a:r>
                     </a:p>
                     <a:p>
@@ -8989,7 +8989,7 @@
                           </a:solidFill>
                           <a:latin typeface="Segoe UI"/>
                         </a:rPr>
-                        <a:t>New Pips Community at the top of the Chat tab: a #general channel to chat with everyone who uses Pips, plus #announcements with news from the Pips team.; Every new Pips version is announced there automatically - see what's new and update with one click.; Type @name to ping someone in #general. Mute #general any time; owner and moderators can remove messages.; Open it from your pet's menu too (Pips Community). Fixed: chats no longer clear what you're typing when Pips refreshes in the background.</a:t>
+                        <a:t>Pips now has an icon next to the clock: click it to bring your pet back; right-click for the focus timer, Friends &amp; chat or Quit.; Press Ctrl+Alt+P anywhere to call your pet - it pops up on the screen you're using, even if it was hidden, asleep or behind a fullscreen app.; Opening Pips again from the Start menu or desktop does the same, and your pet walks back by itself if it ever ends up off-screen (e.g. after unplugging a monitor).; Hiding your pet now tells you how to bring it back.</a:t>
                       </a:r>
                     </a:p>
                   </a:txBody>
@@ -9013,7 +9013,7 @@
                           </a:solidFill>
                           <a:latin typeface="Segoe UI"/>
                         </a:rPr>
-                        <a:t>2.15.0</a:t>
+                        <a:t>2.16.0</a:t>
                       </a:r>
                     </a:p>
                   </a:txBody>
@@ -9057,7 +9057,7 @@
                           </a:solidFill>
                           <a:latin typeface="Segoe UI"/>
                         </a:rPr>
-                        <a:t>Update reminders</a:t>
+                        <a:t>Pips Community</a:t>
                       </a:r>
                     </a:p>
                     <a:p>
@@ -9068,7 +9068,7 @@
                           </a:solidFill>
                           <a:latin typeface="Segoe UI"/>
                         </a:rPr>
-                        <a:t>Owner &amp; moderators: the Mod tab now lists who hasn't updated Pips yet (their version and when they were last seen), with one-click reminders by e-mail (sent from your Outlook) or a ready-to-send Teams chat.; New Work e-mail field in your Profile, filled in from Outlook. Only the owner and moderators can see it (for update reminders and support) - clear it to hide it.; Pips now tells the Friends server which version it runs, so the update list is always accurate.; Friends keeps working when a local proxy tool stops answering - Pips falls back to the Windows proxy settings.</a:t>
+                        <a:t>New Pips Community at the top of the Chat tab: a #general channel to chat with everyone who uses Pips, plus #announcements with news from the Pips team.; Every new Pips version is announced there automatically - see what's new and update with one click.; Type @name to ping someone in #general. Mute #general any time; owner and moderators can remove messages.; Open it from your pet's menu too (Pips Community). Fixed: chats no longer clear what you're typing when Pips refreshes in the background.</a:t>
                       </a:r>
                     </a:p>
                   </a:txBody>
@@ -9092,7 +9092,7 @@
                           </a:solidFill>
                           <a:latin typeface="Segoe UI"/>
                         </a:rPr>
-                        <a:t>2.14.3</a:t>
+                        <a:t>2.15.0</a:t>
                       </a:r>
                     </a:p>
                   </a:txBody>
@@ -9136,7 +9136,7 @@
                           </a:solidFill>
                           <a:latin typeface="Segoe UI"/>
                         </a:rPr>
-                        <a:t>Tidy menus</a:t>
+                        <a:t>Update reminders</a:t>
                       </a:r>
                     </a:p>
                     <a:p>
@@ -9147,7 +9147,7 @@
                           </a:solidFill>
                           <a:latin typeface="Segoe UI"/>
                         </a:rPr>
-                        <a:t>Fixed: a submenu (e.g. Poke a friend) could stay floating on the screen after the right-click menu closed.; Menus now close by themselves when you move the mouse away and leave them for a few seconds.</a:t>
+                        <a:t>Owner &amp; moderators: the Mod tab now lists who hasn't updated Pips yet (their version and when they were last seen), with one-click reminders by e-mail (sent from your Outlook) or a ready-to-send Teams chat.; New Work e-mail field in your Profile, filled in from Outlook. Only the owner and moderators can see it (for update reminders and support) - clear it to hide it.; Pips now tells the Friends server which version it runs, so the update list is always accurate.; Friends keeps working when a local proxy tool stops answering - Pips falls back to the Windows proxy settings.</a:t>
                       </a:r>
                     </a:p>
                   </a:txBody>
@@ -9171,7 +9171,7 @@
                           </a:solidFill>
                           <a:latin typeface="Segoe UI"/>
                         </a:rPr>
-                        <a:t>2.14.2</a:t>
+                        <a:t>2.14.3</a:t>
                       </a:r>
                     </a:p>
                   </a:txBody>
@@ -9215,7 +9215,7 @@
                           </a:solidFill>
                           <a:latin typeface="Segoe UI"/>
                         </a:rPr>
-                        <a:t>Never miss an update</a:t>
+                        <a:t>Tidy menus</a:t>
                       </a:r>
                     </a:p>
                     <a:p>
@@ -9226,7 +9226,7 @@
                           </a:solidFill>
                           <a:latin typeface="Segoe UI"/>
                         </a:rPr>
-                        <a:t>Your pet now reminds you every 2 hours while a new version is waiting (instead of every 6 hours).; If the reminder can't show (fullscreen app, guided tour, another message), your pet tries again a few minutes later.; No internet when Pips starts (e.g. VPN off)? It checks again after an hour.</a:t>
+                        <a:t>Fixed: a submenu (e.g. Poke a friend) could stay floating on the screen after the right-click menu closed.; Menus now close by themselves when you move the mouse away and leave them for a few seconds.</a:t>
                       </a:r>
                     </a:p>
                   </a:txBody>
@@ -9250,7 +9250,7 @@
                           </a:solidFill>
                           <a:latin typeface="Segoe UI"/>
                         </a:rPr>
-                        <a:t>2.14.1</a:t>
+                        <a:t>2.14.2</a:t>
                       </a:r>
                     </a:p>
                   </a:txBody>
@@ -9294,7 +9294,7 @@
                           </a:solidFill>
                           <a:latin typeface="Segoe UI"/>
                         </a:rPr>
-                        <a:t>One pet at a time</a:t>
+                        <a:t>Never miss an update</a:t>
                       </a:r>
                     </a:p>
                     <a:p>
@@ -9305,7 +9305,7 @@
                           </a:solidFill>
                           <a:latin typeface="Segoe UI"/>
                         </a:rPr>
-                        <a:t>Opening Pips again (Desktop / Start Menu shortcut, autostart) no longer starts a second pet - your pet just pops up and says hi.; Fixes lag caused by two copies of Pips running at once.</a:t>
+                        <a:t>Your pet now reminds you every 2 hours while a new version is waiting (instead of every 6 hours).; If the reminder can't show (fullscreen app, guided tour, another message), your pet tries again a few minutes later.; No internet when Pips starts (e.g. VPN off)? It checks again after an hour.</a:t>
                       </a:r>
                     </a:p>
                   </a:txBody>
@@ -9329,7 +9329,7 @@
                           </a:solidFill>
                           <a:latin typeface="Segoe UI"/>
                         </a:rPr>
-                        <a:t>2.14.0</a:t>
+                        <a:t>2.14.1</a:t>
                       </a:r>
                     </a:p>
                   </a:txBody>
@@ -9373,7 +9373,7 @@
                           </a:solidFill>
                           <a:latin typeface="Segoe UI"/>
                         </a:rPr>
-                        <a:t>Pokes, tickles &amp; teases</a:t>
+                        <a:t>One pet at a time</a:t>
                       </a:r>
                     </a:p>
                     <a:p>
@@ -9384,7 +9384,7 @@
                           </a:solidFill>
                           <a:latin typeface="Segoe UI"/>
                         </a:rPr>
-                        <a:t>Poke, tickle, tease, boop or hug a friend from afar - no pet visit needed.; Right-click your pet → Poke a friend, or use the Poke button in Friends, chat and profiles.; Your friend gets a pop-up ("Wendy is teasing you!"), their pet reacts, and they can poke back with one click.; During a focus session pokes wait quietly until your break; when your pet is hidden they show in the screen corner.</a:t>
+                        <a:t>Opening Pips again (Desktop / Start Menu shortcut, autostart) no longer starts a second pet - your pet just pops up and says hi.; Fixes lag caused by two copies of Pips running at once.</a:t>
                       </a:r>
                     </a:p>
                   </a:txBody>
@@ -9408,7 +9408,7 @@
                           </a:solidFill>
                           <a:latin typeface="Segoe UI"/>
                         </a:rPr>
-                        <a:t>2.13.1</a:t>
+                        <a:t>2.14.0</a:t>
                       </a:r>
                     </a:p>
                   </a:txBody>
@@ -9430,7 +9430,7 @@
                           </a:solidFill>
                           <a:latin typeface="Segoe UI"/>
                         </a:rPr>
-                        <a:t>2026-10-28</a:t>
+                        <a:t>2026-10-29</a:t>
                       </a:r>
                     </a:p>
                   </a:txBody>
@@ -9452,7 +9452,7 @@
                           </a:solidFill>
                           <a:latin typeface="Segoe UI"/>
                         </a:rPr>
-                        <a:t>One-click Windows installer</a:t>
+                        <a:t>Pokes, tickles &amp; teases</a:t>
                       </a:r>
                     </a:p>
                     <a:p>
@@ -9463,7 +9463,7 @@
                           </a:solidFill>
                           <a:latin typeface="Segoe UI"/>
                         </a:rPr>
-                        <a:t>One Windows installer: no ZIP extraction, Python installation or command line. Download, open and click Install Pips.; Installs for your Windows account without administrator access, adds Desktop and Start Menu shortcuts, and opens Pips automatically.; Reinstalling in the same location keeps your settings and pet progress. Existing ZIP users can keep updating in place from Help → Check for updates.; A simpler download page and updated user guide; the bundled runtime stays separate from small in-app updates.</a:t>
+                        <a:t>Poke, tickle, tease, boop or hug a friend from afar - no pet visit needed.; Right-click your pet → Poke a friend, or use the Poke button in Friends, chat and profiles.; Your friend gets a pop-up ("Wendy is teasing you!"), their pet reacts, and they can poke back with one click.; During a focus session pokes wait quietly until your break; when your pet is hidden they show in the screen corner.</a:t>
                       </a:r>
                     </a:p>
                   </a:txBody>
@@ -9487,7 +9487,7 @@
                           </a:solidFill>
                           <a:latin typeface="Segoe UI"/>
                         </a:rPr>
-                        <a:t>2.13.0</a:t>
+                        <a:t>2.13.1</a:t>
                       </a:r>
                     </a:p>
                   </a:txBody>
@@ -9531,7 +9531,7 @@
                           </a:solidFill>
                           <a:latin typeface="Segoe UI"/>
                         </a:rPr>
-                        <a:t>Birthdays, parties &amp; gifts</a:t>
+                        <a:t>One-click Windows installer</a:t>
                       </a:r>
                     </a:p>
                     <a:p>
@@ -9542,7 +9542,7 @@
                           </a:solidFill>
                           <a:latin typeface="Segoe UI"/>
                         </a:rPr>
-                        <a:t>Set your birthday in Social → Profile (month + day, optionally visible to friends).; On your birthday Pips throws confetti and gives you 100 bonus coins.; Friends tab shows upcoming birthdays; you get reminders 3 days, 1 day and on the day.; Birthday parties: join a friend's party, see who's there, sign the guestbook and celebrate together.</a:t>
+                        <a:t>One Windows installer: no ZIP extraction, Python installation or command line. Download, open and click Install Pips.; Installs for your Windows account without administrator access, adds Desktop and Start Menu shortcuts, and opens Pips automatically.; Reinstalling in the same location keeps your settings and pet progress. Existing ZIP users can keep updating in place from Help → Check for updates.; A simpler download page and updated user guide; the bundled runtime stays separate from small in-app updates.</a:t>
                       </a:r>
                     </a:p>
                   </a:txBody>
@@ -9566,7 +9566,7 @@
                           </a:solidFill>
                           <a:latin typeface="Segoe UI"/>
                         </a:rPr>
-                        <a:t>2.12.0</a:t>
+                        <a:t>2.13.0</a:t>
                       </a:r>
                     </a:p>
                   </a:txBody>
@@ -9610,7 +9610,7 @@
                           </a:solidFill>
                           <a:latin typeface="Segoe UI"/>
                         </a:rPr>
-                        <a:t>Mega update: 28 new animals, 31 shop items, 13 moves</a:t>
+                        <a:t>Birthdays, parties &amp; gifts</a:t>
                       </a:r>
                     </a:p>
                     <a:p>
@@ -9621,7 +9621,7 @@
                           </a:solidFill>
                           <a:latin typeface="Segoe UI"/>
                         </a:rPr>
-                        <a:t>🦁 28 new animals (51 total): lion, tiger, unicorn, deer, sheep, cow, raccoon, red panda, monkey, hedgehog, dino, squirrel, mouse, koala, shark, dolphin, seal, otter, pufferfish, duck, crab, parrot, chick, ladybug, phoenix, pegasus, ghost and flamingo; 🎩 31 new shop items: top hat, cowboy, chef, pirate, Santa, viking, graduation cap, beret, bow, propeller cap, flower crown, nerd glasses, eyepatch, mustache, goggles, masquerade mask, tie, pearls, flower lei, gold chain, balloon, backpack, guitar, shield, butterfly / devil wings and more - plus Premium galaxy crown, galaxy cape and dragon wings; 💃 13 new moves: wave, jump, hearts, sing, yoga, zoomies, cartwheel, juggle, rain dance, breakdance, magic, confetti and the Premium rocket launch; The Shop is now split into sections (Hats, Face, Neck, Back, Moves, Arena gear) with an owned counter for each</a:t>
+                        <a:t>Set your birthday in Social → Profile (month + day, optionally visible to friends).; On your birthday Pips throws confetti and gives you 100 bonus coins.; Friends tab shows upcoming birthdays; you get reminders 3 days, 1 day and on the day.; Birthday parties: join a friend's party, see who's there, sign the guestbook and celebrate together.</a:t>
                       </a:r>
                     </a:p>
                   </a:txBody>
@@ -9645,7 +9645,7 @@
                           </a:solidFill>
                           <a:latin typeface="Segoe UI"/>
                         </a:rPr>
-                        <a:t>2.11.0</a:t>
+                        <a:t>2.12.0</a:t>
                       </a:r>
                     </a:p>
                   </a:txBody>
@@ -9689,7 +9689,7 @@
                           </a:solidFill>
                           <a:latin typeface="Segoe UI"/>
                         </a:rPr>
-                        <a:t>New right-click menus</a:t>
+                        <a:t>Mega update: 28 new animals, 31 shop items, 13 moves</a:t>
                       </a:r>
                     </a:p>
                     <a:p>
@@ -9700,7 +9700,7 @@
                           </a:solidFill>
                           <a:latin typeface="Segoe UI"/>
                         </a:rPr>
-                        <a:t>✨ Brand-new animated right-click menu for your pet: mood &amp; stat bars, quick-action tiles (Friends, Shop, Snack, Pat, Focus, Stats, Sleep, Taskbar), hover effects and smooth fly-out submenus; Pick colours from swatches, switch size with one click and flip Sounds / Dark mode with toggle switches - changes show instantly; Updates are highlighted: a glowing banner and NEW badge appear in the menu when a new version is ready; The focus card's right-click menu got the same new look; keyboard arrows, Enter and Esc work too</a:t>
+                        <a:t>🦁 28 new animals (51 total): lion, tiger, unicorn, deer, sheep, cow, raccoon, red panda, monkey, hedgehog, dino, squirrel, mouse, koala, shark, dolphin, seal, otter, pufferfish, duck, crab, parrot, chick, ladybug, phoenix, pegasus, ghost and flamingo; 🎩 31 new shop items: top hat, cowboy, chef, pirate, Santa, viking, graduation cap, beret, bow, propeller cap, flower crown, nerd glasses, eyepatch, mustache, goggles, masquerade mask, tie, pearls, flower lei, gold chain, balloon, backpack, guitar, shield, butterfly / devil wings and more - plus Premium galaxy crown, galaxy cape and dragon wings; 💃 13 new moves: wave, jump, hearts, sing, yoga, zoomies, cartwheel, juggle, rain dance, breakdance, magic, confetti and the Premium rocket launch; The Shop is now split into sections (Hats, Face, Neck, Back, Moves, Arena gear) with an owned counter for each</a:t>
                       </a:r>
                     </a:p>
                   </a:txBody>
@@ -9724,7 +9724,7 @@
                           </a:solidFill>
                           <a:latin typeface="Segoe UI"/>
                         </a:rPr>
-                        <a:t>2.10.0</a:t>
+                        <a:t>2.11.0</a:t>
                       </a:r>
                     </a:p>
                   </a:txBody>
@@ -9768,7 +9768,7 @@
                           </a:solidFill>
                           <a:latin typeface="Segoe UI"/>
                         </a:rPr>
-                        <a:t>Chat bots</a:t>
+                        <a:t>New right-click menus</a:t>
                       </a:r>
                     </a:p>
                     <a:p>
@@ -9779,7 +9779,7 @@
                           </a:solidFill>
                           <a:latin typeface="Segoe UI"/>
                         </a:rPr>
-                        <a:t>🤖 6 friendly chat bots in the Chat tab: Pip Helper (app questions), Coach Focus (focus tips from your real stats), Sunny (live weather for any city), Arena Master (battle tips + quick battle), Giggles (jokes &amp; games) and Guardian (safety &amp; reporting help); Private bot chats with suggestion chips, typing indicator and a clear button - your bot chats stay on your PC; Mention a bot in a group chat (e.g. @weather Batam) and it answers in the room for everyone; Bots reply in your app language; up to 120 bot messages per day</a:t>
+                        <a:t>✨ Brand-new animated right-click menu for your pet: mood &amp; stat bars, quick-action tiles (Friends, Shop, Snack, Pat, Focus, Stats, Sleep, Taskbar), hover effects and smooth fly-out submenus; Pick colours from swatches, switch size with one click and flip Sounds / Dark mode with toggle switches - changes show instantly; Updates are highlighted: a glowing banner and NEW badge appear in the menu when a new version is ready; The focus card's right-click menu got the same new look; keyboard arrows, Enter and Esc work too</a:t>
                       </a:r>
                     </a:p>
                   </a:txBody>
@@ -9803,7 +9803,7 @@
                           </a:solidFill>
                           <a:latin typeface="Segoe UI"/>
                         </a:rPr>
-                        <a:t>2.9.0</a:t>
+                        <a:t>2.10.0</a:t>
                       </a:r>
                     </a:p>
                   </a:txBody>
@@ -9847,7 +9847,7 @@
                           </a:solidFill>
                           <a:latin typeface="Segoe UI"/>
                         </a:rPr>
-                        <a:t>Location &amp; live weather</a:t>
+                        <a:t>Chat bots</a:t>
                       </a:r>
                     </a:p>
                     <a:p>
@@ -9858,7 +9858,7 @@
                           </a:solidFill>
                           <a:latin typeface="Segoe UI"/>
                         </a:rPr>
-                        <a:t>📍 Add your city in Profile → Location &amp; weather (auto-detect or search) - only your city and country are shown, never your exact position; Live weather banners on every profile with animations: rain, drizzle, thunderstorms with lightning, snow, fog, clouds, sunshine or a starry night - plus temperature, feels-like, humidity, wind and local time; Your own weather strip on top of the hub, and each friend's weather + local time in the friends list; Hide your location from others or remove it any time</a:t>
+                        <a:t>🤖 6 friendly chat bots in the Chat tab: Pip Helper (app questions), Coach Focus (focus tips from your real stats), Sunny (live weather for any city), Arena Master (battle tips + quick battle), Giggles (jokes &amp; games) and Guardian (safety &amp; reporting help); Private bot chats with suggestion chips, typing indicator and a clear button - your bot chats stay on your PC; Mention a bot in a group chat (e.g. @weather Batam) and it answers in the room for everyone; Bots reply in your app language; up to 120 bot messages per day</a:t>
                       </a:r>
                     </a:p>
                   </a:txBody>
@@ -9882,7 +9882,7 @@
                           </a:solidFill>
                           <a:latin typeface="Segoe UI"/>
                         </a:rPr>
-                        <a:t>2.8.0</a:t>
+                        <a:t>2.9.0</a:t>
                       </a:r>
                     </a:p>
                   </a:txBody>
@@ -9926,7 +9926,7 @@
                           </a:solidFill>
                           <a:latin typeface="Segoe UI"/>
                         </a:rPr>
-                        <a:t>Pips Arena - duels, gear &amp; live battles</a:t>
+                        <a:t>Location &amp; live weather</a:t>
                       </a:r>
                     </a:p>
                     <a:p>
@@ -9937,7 +9937,7 @@
                           </a:solidFill>
                           <a:latin typeface="Segoe UI"/>
                         </a:rPr>
-                        <a:t>⚔ New Arena tab: challenge friends or anyone in the arena to a live duel - each round pick Attack, Guard or Special within 12 seconds and watch your pets fight; ⚡ Quick battle: an instant auto-fight against anyone's fighter, even when they're offline; Arena gear in the Shop: 7 weapons (water pistol to rocket launcher), 5 armors and 5 gadgets that decide your special move - better gear and a higher level make a stronger fighter; Live duels can be watched by everyone, plus recent battle replays, top fighters, rating and win/loss records; wins earn coins</a:t>
+                        <a:t>📍 Add your city in Profile → Location &amp; weather (auto-detect or search) - only your city and country are shown, never your exact position; Live weather banners on every profile with animations: rain, drizzle, thunderstorms with lightning, snow, fog, clouds, sunshine or a starry night - plus temperature, feels-like, humidity, wind and local time; Your own weather strip on top of the hub, and each friend's weather + local time in the friends list; Hide your location from others or remove it any time</a:t>
                       </a:r>
                     </a:p>
                   </a:txBody>
@@ -9961,7 +9961,7 @@
                           </a:solidFill>
                           <a:latin typeface="Segoe UI"/>
                         </a:rPr>
-                        <a:t>2.7.0</a:t>
+                        <a:t>2.8.0</a:t>
                       </a:r>
                     </a:p>
                   </a:txBody>
@@ -10005,7 +10005,7 @@
                           </a:solidFill>
                           <a:latin typeface="Segoe UI"/>
                         </a:rPr>
-                        <a:t>Moderators &amp; Premium</a:t>
+                        <a:t>Pips Arena - duels, gear &amp; live battles</a:t>
                       </a:r>
                     </a:p>
                     <a:p>
@@ -10016,7 +10016,7 @@
                           </a:solidFill>
                           <a:latin typeface="Segoe UI"/>
                         </a:rPr>
-                        <a:t>★ Premium: a purple Premium badge, 4 exclusive props (tiara, star glasses, diamond necklace, fairy wings), the Fireworks move, +30 coins every day, double friend-interaction coins and room for 300 friends / 30 groups; Get Premium: Profile tab → Premium → "Ask to buy" emails the owner; after payment you receive a key (PIPS-XXXX-XXXX) to redeem right there; 🛡 Moderators: a blue Mod badge and a Mod tab with the report queue - warn, mute (1h / 24h / 7 days), clear a profile or reset a name; every action is logged; Report button on everyone's profile, so moderators can keep Pips friendly</a:t>
+                        <a:t>⚔ New Arena tab: challenge friends or anyone in the arena to a live duel - each round pick Attack, Guard or Special within 12 seconds and watch your pets fight; ⚡ Quick battle: an instant auto-fight against anyone's fighter, even when they're offline; Arena gear in the Shop: 7 weapons (water pistol to rocket launcher), 5 armors and 5 gadgets that decide your special move - better gear and a higher level make a stronger fighter; Live duels can be watched by everyone, plus recent battle replays, top fighters, rating and win/loss records; wins earn coins</a:t>
                       </a:r>
                     </a:p>
                   </a:txBody>
@@ -10040,7 +10040,7 @@
                           </a:solidFill>
                           <a:latin typeface="Segoe UI"/>
                         </a:rPr>
-                        <a:t>2.6.1</a:t>
+                        <a:t>2.7.0</a:t>
                       </a:r>
                     </a:p>
                   </a:txBody>
@@ -10084,7 +10084,7 @@
                           </a:solidFill>
                           <a:latin typeface="Segoe UI"/>
                         </a:rPr>
-                        <a:t>Owner badge &amp; credits</a:t>
+                        <a:t>Moderators &amp; Premium</a:t>
                       </a:r>
                     </a:p>
                     <a:p>
@@ -10095,7 +10095,7 @@
                           </a:solidFill>
                           <a:latin typeface="Segoe UI"/>
                         </a:rPr>
-                        <a:t>The creator of Pips (Juwen Lie) now shows a gold ♛ Owner badge on his profile, friend list and ranks; New About Pips card in the Profile tab: credits and how to contact the owner (Juwen_Lie@pegatroncorp.com) with Email and Copy buttons; Right-click the pet → Help → About now shows who made Pips and the contact email</a:t>
+                        <a:t>★ Premium: a purple Premium badge, 4 exclusive props (tiara, star glasses, diamond necklace, fairy wings), the Fireworks move, +30 coins every day, double friend-interaction coins and room for 300 friends / 30 groups; Get Premium: Profile tab → Premium → "Ask to buy" emails the owner; after payment you receive a key (PIPS-XXXX-XXXX) to redeem right there; 🛡 Moderators: a blue Mod badge and a Mod tab with the report queue - warn, mute (1h / 24h / 7 days), clear a profile or reset a name; every action is logged; Report button on everyone's profile, so moderators can keep Pips friendly</a:t>
                       </a:r>
                     </a:p>
                   </a:txBody>
@@ -10119,7 +10119,7 @@
                           </a:solidFill>
                           <a:latin typeface="Segoe UI"/>
                         </a:rPr>
-                        <a:t>2.6.0</a:t>
+                        <a:t>2.6.1</a:t>
                       </a:r>
                     </a:p>
                   </a:txBody>
@@ -10163,7 +10163,7 @@
                           </a:solidFill>
                           <a:latin typeface="Segoe UI"/>
                         </a:rPr>
-                        <a:t>Profiles, ranks, online status &amp; dark mode</a:t>
+                        <a:t>Owner badge &amp; credits</a:t>
                       </a:r>
                     </a:p>
                     <a:p>
@@ -10174,7 +10174,7 @@
                           </a:solidFill>
                           <a:latin typeface="Segoe UI"/>
                         </a:rPr>
-                        <a:t>Profile tab: profile picture (or your pet), about me, job, location, hobbies, birthday and a status message; Public or private: public profiles can be added directly and viewed in full; private profiles need a friend request that they accept, and strangers only see name, photo, pet, level and status; Click anyone to open their profile - badges, info, their friends - and add them, chat or wave from there; Ranks tab replaces Teams: everyone using Pips, sorted by XP, badges or streak</a:t>
+                        <a:t>The creator of Pips (Juwen Lie) now shows a gold ♛ Owner badge on his profile, friend list and ranks; New About Pips card in the Profile tab: credits and how to contact the owner (Juwen_Lie@pegatroncorp.com) with Email and Copy buttons; Right-click the pet → Help → About now shows who made Pips and the contact email</a:t>
                       </a:r>
                     </a:p>
                   </a:txBody>
@@ -10198,7 +10198,7 @@
                           </a:solidFill>
                           <a:latin typeface="Segoe UI"/>
                         </a:rPr>
-                        <a:t>2.5.1</a:t>
+                        <a:t>2.6.0</a:t>
                       </a:r>
                     </a:p>
                   </a:txBody>
@@ -10242,7 +10242,7 @@
                           </a:solidFill>
                           <a:latin typeface="Segoe UI"/>
                         </a:rPr>
-                        <a:t>New cute Pips logo</a:t>
+                        <a:t>Profiles, ranks, online status &amp; dark mode</a:t>
                       </a:r>
                     </a:p>
                     <a:p>
@@ -10253,7 +10253,7 @@
                           </a:solidFill>
                           <a:latin typeface="Segoe UI"/>
                         </a:rPr>
-                        <a:t>New Pips logo: Pip the cat on a Pips-red tile, matching the app colours (desktop shortcut, windows and website)</a:t>
+                        <a:t>Profile tab: profile picture (or your pet), about me, job, location, hobbies, birthday and a status message; Public or private: public profiles can be added directly and viewed in full; private profiles need a friend request that they accept, and strangers only see name, photo, pet, level and status; Click anyone to open their profile - badges, info, their friends - and add them, chat or wave from there; Ranks tab replaces Teams: everyone using Pips, sorted by XP, badges or streak</a:t>
                       </a:r>
                     </a:p>
                   </a:txBody>
@@ -10277,7 +10277,7 @@
                           </a:solidFill>
                           <a:latin typeface="Segoe UI"/>
                         </a:rPr>
-                        <a:t>2.5.0</a:t>
+                        <a:t>2.5.1</a:t>
                       </a:r>
                     </a:p>
                   </a:txBody>
@@ -10321,7 +10321,7 @@
                           </a:solidFill>
                           <a:latin typeface="Segoe UI"/>
                         </a:rPr>
-                        <a:t>Shop, coins, props &amp; moves</a:t>
+                        <a:t>New cute Pips logo</a:t>
                       </a:r>
                     </a:p>
                     <a:p>
@@ -10332,7 +10332,7 @@
                           </a:solidFill>
                           <a:latin typeface="Segoe UI"/>
                         </a:rPr>
-                        <a:t>Shop: earn coins and spend them on your pet - 17 props (crown, wizard hat, headphones, shades, scarf, cape, angel wings...) and 6 moves: spin, dance, moonwalk, backflip, kung fu and spider swing!; Coins come from leveling up (+40), badges (+25), opening Pips each day (+10), friendships (+15 per affinity level), waving / chatting / visiting friends (+2) and pomodoros (+5). Everyone starts with a 100-coin gift; Your friends see your props: on avatars in the hub and when your pet visits their desktop - it shows off one of your moves; Pips is now a social pet: clicking the pet opens the Pips hub (friends, chat, groups, shop, badges)</a:t>
+                        <a:t>New Pips logo: Pip the cat on a Pips-red tile, matching the app colours (desktop shortcut, windows and website)</a:t>
                       </a:r>
                     </a:p>
                   </a:txBody>
@@ -10356,7 +10356,7 @@
                           </a:solidFill>
                           <a:latin typeface="Segoe UI"/>
                         </a:rPr>
-                        <a:t>2.4.0</a:t>
+                        <a:t>2.5.0</a:t>
                       </a:r>
                     </a:p>
                   </a:txBody>
@@ -10400,7 +10400,7 @@
                           </a:solidFill>
                           <a:latin typeface="Segoe UI"/>
                         </a:rPr>
-                        <a:t>Chat, groups, affinity &amp; pet visits</a:t>
+                        <a:t>Shop, coins, props &amp; moves</a:t>
                       </a:r>
                     </a:p>
                     <a:p>
@@ -10411,7 +10411,7 @@
                           </a:solidFill>
                           <a:latin typeface="Segoe UI"/>
                         </a:rPr>
-                        <a:t>Chat: message your friends, and chat inside groups. Your pet pops up new messages as a bubble - click it to reply; Pet interactions: wave, pet their pet, send a snack, high five - or send your pet to visit: it walks onto your friend's desktop for a little while!; Affinity: every chat and interaction grows your friendship - Acquaintance → Buddy → Good friends → Close friends → Best friends → Soulmates; Your own groups: create a private group, invite your friends, they accept or decline. Group board + group chat; the owner can remove members</a:t>
+                        <a:t>Shop: earn coins and spend them on your pet - 17 props (crown, wizard hat, headphones, shades, scarf, cape, angel wings...) and 6 moves: spin, dance, moonwalk, backflip, kung fu and spider swing!; Coins come from leveling up (+40), badges (+25), opening Pips each day (+10), friendships (+15 per affinity level), waving / chatting / visiting friends (+2) and pomodoros (+5). Everyone starts with a 100-coin gift; Your friends see your props: on avatars in the hub and when your pet visits their desktop - it shows off one of your moves; Pips is now a social pet: clicking the pet opens the Pips hub (friends, chat, groups, shop, badges)</a:t>
                       </a:r>
                     </a:p>
                   </a:txBody>
@@ -10435,7 +10435,7 @@
                           </a:solidFill>
                           <a:latin typeface="Segoe UI"/>
                         </a:rPr>
-                        <a:t>2.3.0</a:t>
+                        <a:t>2.4.0</a:t>
                       </a:r>
                     </a:p>
                   </a:txBody>
@@ -10479,7 +10479,7 @@
                           </a:solidFill>
                           <a:latin typeface="Segoe UI"/>
                         </a:rPr>
-                        <a:t>Friends, levels &amp; achievements</a:t>
+                        <a:t>Chat, groups, affinity &amp; pet visits</a:t>
                       </a:r>
                     </a:p>
                     <a:p>
@@ -10490,7 +10490,7 @@
                           </a:solidFill>
                           <a:latin typeface="Segoe UI"/>
                         </a:rPr>
-                        <a:t>Levels &amp; XP: every finished pomodoro earns XP and your level grows - plus 20 achievements to unlock (first tomato, 8 in a day, 7-day streak, early bird, night owl, pet lover...). Your pet celebrates each one; Friends (optional, off by default): get a 6-letter friend code, add colleagues, see today's board and join a team board like PTB. Your pet tells you when a friend finishes a pomodoro; Privacy: only your name, pet, level, streak and pomodoro counts are shared - never apps, window titles or scores. One click turns it off and deletes your online data. Right-click the pet → Friends &amp; achievements…</a:t>
+                        <a:t>Chat: message your friends, and chat inside groups. Your pet pops up new messages as a bubble - click it to reply; Pet interactions: wave, pet their pet, send a snack, high five - or send your pet to visit: it walks onto your friend's desktop for a little while!; Affinity: every chat and interaction grows your friendship - Acquaintance → Buddy → Good friends → Close friends → Best friends → Soulmates; Your own groups: create a private group, invite your friends, they accept or decline. Group board + group chat; the owner can remove members</a:t>
                       </a:r>
                     </a:p>
                   </a:txBody>
@@ -10514,7 +10514,7 @@
                           </a:solidFill>
                           <a:latin typeface="Segoe UI"/>
                         </a:rPr>
-                        <a:t>2.2.0</a:t>
+                        <a:t>2.3.0</a:t>
                       </a:r>
                     </a:p>
                   </a:txBody>
@@ -10558,7 +10558,7 @@
                           </a:solidFill>
                           <a:latin typeface="Segoe UI"/>
                         </a:rPr>
-                        <a:t>Pet sounds</a:t>
+                        <a:t>Friends, levels &amp; achievements</a:t>
                       </a:r>
                     </a:p>
                     <a:p>
@@ -10569,7 +10569,7 @@
                           </a:solidFill>
                           <a:latin typeface="Segoe UI"/>
                         </a:rPr>
-                        <a:t>Your pet has a voice! Each of the 23 animals has its own sound (meow, woof, ribbit, hoot, buzz, oink, whale song...) and it changes with its mood: happy chirps, sad whimpers, sleepy yawns, hungry calls, grumpy huffs and soft snores; It also reacts with sound when you tickle, pet, feed, shake or wake it; Settings: right-click the pet → Sounds to switch on/off; Pet status &amp; settings has a volume slider, a ▶ Hear me button and "Stay quiet while I'm focusing" (on by default)</a:t>
+                        <a:t>Levels &amp; XP: every finished pomodoro earns XP and your level grows - plus 20 achievements to unlock (first tomato, 8 in a day, 7-day streak, early bird, night owl, pet lover...). Your pet celebrates each one; Friends (optional, off by default): get a 6-letter friend code, add colleagues, see today's board and join a team board like PTB. Your pet tells you when a friend finishes a pomodoro; Privacy: only your name, pet, level, streak and pomodoro counts are shared - never apps, window titles or scores. One click turns it off and deletes your online data. Right-click the pet → Friends &amp; achievements…</a:t>
                       </a:r>
                     </a:p>
                   </a:txBody>
@@ -10593,7 +10593,7 @@
                           </a:solidFill>
                           <a:latin typeface="Segoe UI"/>
                         </a:rPr>
-                        <a:t>2.1.2</a:t>
+                        <a:t>2.2.0</a:t>
                       </a:r>
                     </a:p>
                   </a:txBody>
@@ -10637,7 +10637,7 @@
                           </a:solidFill>
                           <a:latin typeface="Segoe UI"/>
                         </a:rPr>
-                        <a:t>Tickle-only mode</a:t>
+                        <a:t>Pet sounds</a:t>
                       </a:r>
                     </a:p>
                     <a:p>
@@ -10648,7 +10648,7 @@
                           </a:solidFill>
                           <a:latin typeface="Segoe UI"/>
                         </a:rPr>
-                        <a:t>New click option "Only tickle (never open Pips)": click and tickle your pet as much as you like - the Pomodoro window stays closed (open it from the right-click menu). Right-click the pet → When I click</a:t>
+                        <a:t>Your pet has a voice! Each of the 23 animals has its own sound (meow, woof, ribbit, hoot, buzz, oink, whale song...) and it changes with its mood: happy chirps, sad whimpers, sleepy yawns, hungry calls, grumpy huffs and soft snores; It also reacts with sound when you tickle, pet, feed, shake or wake it; Settings: right-click the pet → Sounds to switch on/off; Pet status &amp; settings has a volume slider, a ▶ Hear me button and "Stay quiet while I'm focusing" (on by default)</a:t>
                       </a:r>
                     </a:p>
                   </a:txBody>
@@ -10672,7 +10672,7 @@
                           </a:solidFill>
                           <a:latin typeface="Segoe UI"/>
                         </a:rPr>
-                        <a:t>2.1.1</a:t>
+                        <a:t>2.1.2</a:t>
                       </a:r>
                     </a:p>
                   </a:txBody>
@@ -10716,7 +10716,7 @@
                           </a:solidFill>
                           <a:latin typeface="Segoe UI"/>
                         </a:rPr>
-                        <a:t>Owner info</a:t>
+                        <a:t>Tickle-only mode</a:t>
                       </a:r>
                     </a:p>
                     <a:p>
@@ -10727,7 +10727,7 @@
                           </a:solidFill>
                           <a:latin typeface="Segoe UI"/>
                         </a:rPr>
-                        <a:t>About Pips now shows the owner: Juwen Lie (right-click the pet → Help → About)</a:t>
+                        <a:t>New click option "Only tickle (never open Pips)": click and tickle your pet as much as you like - the Pomodoro window stays closed (open it from the right-click menu). Right-click the pet → When I click</a:t>
                       </a:r>
                     </a:p>
                   </a:txBody>
@@ -10751,7 +10751,7 @@
                           </a:solidFill>
                           <a:latin typeface="Segoe UI"/>
                         </a:rPr>
-                        <a:t>2.1.0</a:t>
+                        <a:t>2.1.1</a:t>
                       </a:r>
                     </a:p>
                   </a:txBody>
@@ -10795,7 +10795,7 @@
                           </a:solidFill>
                           <a:latin typeface="Segoe UI"/>
                         </a:rPr>
-                        <a:t>Interactive guide &amp; in-app updates</a:t>
+                        <a:t>Owner info</a:t>
                       </a:r>
                     </a:p>
                     <a:p>
@@ -10806,7 +10806,7 @@
                           </a:solidFill>
                           <a:latin typeface="Segoe UI"/>
                         </a:rPr>
-                        <a:t>Interactive first-run guide: your pet walks you through clicking, dragging, petting and the right-click menu; In-app updates: Pips tells you when a new version is out - update with one click (your settings and data are kept); New Help menu: replay the guide, check for updates, see the version; Option to turn automatic update checks off</a:t>
+                        <a:t>About Pips now shows the owner: Juwen Lie (right-click the pet → Help → About)</a:t>
                       </a:r>
                     </a:p>
                   </a:txBody>
@@ -10830,7 +10830,7 @@
                           </a:solidFill>
                           <a:latin typeface="Segoe UI"/>
                         </a:rPr>
-                        <a:t>2.0.0</a:t>
+                        <a:t>2.1.0</a:t>
                       </a:r>
                     </a:p>
                   </a:txBody>
@@ -10874,7 +10874,7 @@
                           </a:solidFill>
                           <a:latin typeface="Segoe UI"/>
                         </a:rPr>
-                        <a:t>Desktop pet, 23 animals &amp; 4 languages</a:t>
+                        <a:t>Interactive guide &amp; in-app updates</a:t>
                       </a:r>
                     </a:p>
                     <a:p>
@@ -10885,7 +10885,7 @@
                           </a:solidFill>
                           <a:latin typeface="Segoe UI"/>
                         </a:rPr>
-                        <a:t>Desktop pet that lives on your desktop and taskbar - drag it, tickle it, pet it; 23 animals in 3 groups: Land walks, Water swims with bubbles, Sky hovers and flaps; Moods (happy, sad, tired, hungry, grumpy...), naps when you're away, wakes up when you're back; Cute chat-bubble reminders: breaks, water, 20-20-20 eye rest, pomodoro done, daily goal</a:t>
+                        <a:t>Interactive first-run guide: your pet walks you through clicking, dragging, petting and the right-click menu; In-app updates: Pips tells you when a new version is out - update with one click (your settings and data are kept); New Help menu: replay the guide, check for updates, see the version; Option to turn automatic update checks off</a:t>
                       </a:r>
                     </a:p>
                   </a:txBody>
@@ -10909,7 +10909,7 @@
                           </a:solidFill>
                           <a:latin typeface="Segoe UI"/>
                         </a:rPr>
-                        <a:t>1.5.0</a:t>
+                        <a:t>2.0.0</a:t>
                       </a:r>
                     </a:p>
                   </a:txBody>
@@ -10931,7 +10931,7 @@
                           </a:solidFill>
                           <a:latin typeface="Segoe UI"/>
                         </a:rPr>
-                        <a:t>2026-10-24</a:t>
+                        <a:t>2026-10-28</a:t>
                       </a:r>
                     </a:p>
                   </a:txBody>
@@ -10953,7 +10953,7 @@
                           </a:solidFill>
                           <a:latin typeface="Segoe UI"/>
                         </a:rPr>
-                        <a:t>Renamed to Pips + insights</a:t>
+                        <a:t>Desktop pet, 23 animals &amp; 4 languages</a:t>
                       </a:r>
                     </a:p>
                     <a:p>
@@ -10964,7 +10964,7 @@
                           </a:solidFill>
                           <a:latin typeface="Segoe UI"/>
                         </a:rPr>
-                        <a:t>Renamed from Productivity Widget to Pips; Dashboard charts: focus timeline, hour heatmap, 7-day score trend, pomodoros per day; AI token usage on the card and dashboard; Daily diary export and weekly / monthly reports</a:t>
+                        <a:t>Desktop pet that lives on your desktop and taskbar - drag it, tickle it, pet it; 23 animals in 3 groups: Land walks, Water swims with bubbles, Sky hovers and flaps; Moods (happy, sad, tired, hungry, grumpy...), naps when you're away, wakes up when you're back; Cute chat-bubble reminders: breaks, water, 20-20-20 eye rest, pomodoro done, daily goal</a:t>
                       </a:r>
                     </a:p>
                   </a:txBody>
@@ -10988,7 +10988,7 @@
                           </a:solidFill>
                           <a:latin typeface="Segoe UI"/>
                         </a:rPr>
-                        <a:t>1.0.0</a:t>
+                        <a:t>1.5.0</a:t>
                       </a:r>
                     </a:p>
                   </a:txBody>
@@ -11010,7 +11010,7 @@
                           </a:solidFill>
                           <a:latin typeface="Segoe UI"/>
                         </a:rPr>
-                        <a:t>2026-10-21</a:t>
+                        <a:t>2026-10-24</a:t>
                       </a:r>
                     </a:p>
                   </a:txBody>
@@ -11032,7 +11032,7 @@
                           </a:solidFill>
                           <a:latin typeface="Segoe UI"/>
                         </a:rPr>
-                        <a:t>First release</a:t>
+                        <a:t>Renamed to Pips + insights</a:t>
                       </a:r>
                     </a:p>
                     <a:p>
@@ -11043,13 +11043,92 @@
                           </a:solidFill>
                           <a:latin typeface="Segoe UI"/>
                         </a:rPr>
-                        <a:t>Always-on-top Pomodoro card with progress ring; Rain / thunder / brown-noise / cafe soundscapes; Live app-usage tracking and a daily 1-5 star focus score; Goals, streaks, XP, coach tips and break reminders</a:t>
+                        <a:t>Renamed from Productivity Widget to Pips; Dashboard charts: focus timeline, hour heatmap, 7-day score trend, pomodoros per day; AI token usage on the card and dashboard; Daily diary export and weekly / monthly reports</a:t>
                       </a:r>
                     </a:p>
                   </a:txBody>
                   <a:tcPr marL="73152" marR="73152" marT="36576" marB="36576">
                     <a:solidFill>
                       <a:srgbClr val="FFFDF8"/>
+                    </a:solidFill>
+                  </a:tcPr>
+                </a:tc>
+              </a:tr>
+              <a:tr h="822960">
+                <a:tc>
+                  <a:txBody>
+                    <a:bodyPr wrap="square"/>
+                    <a:lstStyle/>
+                    <a:p>
+                      <a:r>
+                        <a:rPr sz="1200" b="1">
+                          <a:solidFill>
+                            <a:srgbClr val="2B2A28"/>
+                          </a:solidFill>
+                          <a:latin typeface="Segoe UI"/>
+                        </a:rPr>
+                        <a:t>1.0.0</a:t>
+                      </a:r>
+                    </a:p>
+                  </a:txBody>
+                  <a:tcPr marL="73152" marR="73152" marT="36576" marB="36576">
+                    <a:solidFill>
+                      <a:srgbClr val="F7F4EC"/>
+                    </a:solidFill>
+                  </a:tcPr>
+                </a:tc>
+                <a:tc>
+                  <a:txBody>
+                    <a:bodyPr wrap="square"/>
+                    <a:lstStyle/>
+                    <a:p>
+                      <a:r>
+                        <a:rPr sz="1200" b="0">
+                          <a:solidFill>
+                            <a:srgbClr val="2B2A28"/>
+                          </a:solidFill>
+                          <a:latin typeface="Segoe UI"/>
+                        </a:rPr>
+                        <a:t>2026-10-21</a:t>
+                      </a:r>
+                    </a:p>
+                  </a:txBody>
+                  <a:tcPr marL="73152" marR="73152" marT="36576" marB="36576">
+                    <a:solidFill>
+                      <a:srgbClr val="F7F4EC"/>
+                    </a:solidFill>
+                  </a:tcPr>
+                </a:tc>
+                <a:tc>
+                  <a:txBody>
+                    <a:bodyPr wrap="square"/>
+                    <a:lstStyle/>
+                    <a:p>
+                      <a:r>
+                        <a:rPr sz="1200" b="0">
+                          <a:solidFill>
+                            <a:srgbClr val="2B2A28"/>
+                          </a:solidFill>
+                          <a:latin typeface="Segoe UI"/>
+                        </a:rPr>
+                        <a:t>First release</a:t>
+                      </a:r>
+                    </a:p>
+                    <a:p>
+                      <a:r>
+                        <a:rPr sz="1200" b="0">
+                          <a:solidFill>
+                            <a:srgbClr val="2B2A28"/>
+                          </a:solidFill>
+                          <a:latin typeface="Segoe UI"/>
+                        </a:rPr>
+                        <a:t>Always-on-top Pomodoro card with progress ring; Rain / thunder / brown-noise / cafe soundscapes; Live app-usage tracking and a daily 1-5 star focus score; Goals, streaks, XP, coach tips and break reminders</a:t>
+                      </a:r>
+                    </a:p>
+                  </a:txBody>
+                  <a:tcPr marL="73152" marR="73152" marT="36576" marB="36576">
+                    <a:solidFill>
+                      <a:srgbClr val="F7F4EC"/>
                     </a:solidFill>
                   </a:tcPr>
                 </a:tc>

</xml_diff>

<commit_message>
pips 2.18.0: Raise your pet
</commit_message>
<xml_diff>
--- a/apps/pips/web/download/Pips-Guide.pptx
+++ b/apps/pips/web/download/Pips-Guide.pptx
@@ -3292,7 +3292,7 @@
                 </a:solidFill>
                 <a:latin typeface="Segoe UI"/>
               </a:rPr>
-              <a:t>Version 2.17.0  ·  2026-10-29  ·  Made by Juwen Lie (owner)</a:t>
+              <a:t>Version 2.18.0  ·  2026-10-29  ·  Made by Juwen Lie (owner)</a:t>
             </a:r>
           </a:p>
           <a:p>
@@ -7647,8 +7647,8 @@
           <p:nvPr/>
         </p:nvGraphicFramePr>
         <p:xfrm>
-          <a:off x="548640" y="1645920"/>
-          <a:ext cx="11155680" cy="4096512"/>
+          <a:off x="548640" y="1554480"/>
+          <a:ext cx="11155680" cy="4498848"/>
         </p:xfrm>
         <a:graphic>
           <a:graphicData uri="http://schemas.openxmlformats.org/drawingml/2006/table">
@@ -7667,7 +7667,7 @@
                     <a:lstStyle/>
                     <a:p>
                       <a:r>
-                        <a:rPr sz="1300" b="1">
+                        <a:rPr sz="1200" b="1">
                           <a:solidFill>
                             <a:srgbClr val="FFFFFF"/>
                           </a:solidFill>
@@ -7689,7 +7689,7 @@
                     <a:lstStyle/>
                     <a:p>
                       <a:r>
-                        <a:rPr sz="1300" b="1">
+                        <a:rPr sz="1200" b="1">
                           <a:solidFill>
                             <a:srgbClr val="FFFFFF"/>
                           </a:solidFill>
@@ -7706,14 +7706,14 @@
                   </a:tcPr>
                 </a:tc>
               </a:tr>
-              <a:tr h="530352">
+              <a:tr h="457200">
                 <a:tc>
                   <a:txBody>
                     <a:bodyPr wrap="square"/>
                     <a:lstStyle/>
                     <a:p>
                       <a:r>
-                        <a:rPr sz="1300" b="1">
+                        <a:rPr sz="1200" b="1">
                           <a:solidFill>
                             <a:srgbClr val="2B2A28"/>
                           </a:solidFill>
@@ -7735,7 +7735,7 @@
                     <a:lstStyle/>
                     <a:p>
                       <a:r>
-                        <a:rPr sz="1300" b="0">
+                        <a:rPr sz="1200" b="0">
                           <a:solidFill>
                             <a:srgbClr val="2B2A28"/>
                           </a:solidFill>
@@ -7752,14 +7752,14 @@
                   </a:tcPr>
                 </a:tc>
               </a:tr>
-              <a:tr h="530352">
+              <a:tr h="457200">
                 <a:tc>
                   <a:txBody>
                     <a:bodyPr wrap="square"/>
                     <a:lstStyle/>
                     <a:p>
                       <a:r>
-                        <a:rPr sz="1300" b="1">
+                        <a:rPr sz="1200" b="1">
                           <a:solidFill>
                             <a:srgbClr val="2B2A28"/>
                           </a:solidFill>
@@ -7781,7 +7781,7 @@
                     <a:lstStyle/>
                     <a:p>
                       <a:r>
-                        <a:rPr sz="1300" b="0">
+                        <a:rPr sz="1200" b="0">
                           <a:solidFill>
                             <a:srgbClr val="2B2A28"/>
                           </a:solidFill>
@@ -7798,14 +7798,14 @@
                   </a:tcPr>
                 </a:tc>
               </a:tr>
-              <a:tr h="530352">
+              <a:tr h="457200">
                 <a:tc>
                   <a:txBody>
                     <a:bodyPr wrap="square"/>
                     <a:lstStyle/>
                     <a:p>
                       <a:r>
-                        <a:rPr sz="1300" b="1">
+                        <a:rPr sz="1200" b="1">
                           <a:solidFill>
                             <a:srgbClr val="2B2A28"/>
                           </a:solidFill>
@@ -7827,7 +7827,7 @@
                     <a:lstStyle/>
                     <a:p>
                       <a:r>
-                        <a:rPr sz="1300" b="0">
+                        <a:rPr sz="1200" b="0">
                           <a:solidFill>
                             <a:srgbClr val="2B2A28"/>
                           </a:solidFill>
@@ -7844,20 +7844,20 @@
                   </a:tcPr>
                 </a:tc>
               </a:tr>
-              <a:tr h="530352">
+              <a:tr h="457200">
                 <a:tc>
                   <a:txBody>
                     <a:bodyPr wrap="square"/>
                     <a:lstStyle/>
                     <a:p>
                       <a:r>
-                        <a:rPr sz="1300" b="1">
-                          <a:solidFill>
-                            <a:srgbClr val="2B2A28"/>
-                          </a:solidFill>
-                          <a:latin typeface="Segoe UI"/>
-                        </a:rPr>
-                        <a:t>The focus card is gone</a:t>
+                        <a:rPr sz="1200" b="1">
+                          <a:solidFill>
+                            <a:srgbClr val="2B2A28"/>
+                          </a:solidFill>
+                          <a:latin typeface="Segoe UI"/>
+                        </a:rPr>
+                        <a:t>My pet is small / a baby</a:t>
                       </a:r>
                     </a:p>
                   </a:txBody>
@@ -7873,13 +7873,13 @@
                     <a:lstStyle/>
                     <a:p>
                       <a:r>
-                        <a:rPr sz="1300" b="0">
-                          <a:solidFill>
-                            <a:srgbClr val="2B2A28"/>
-                          </a:solidFill>
-                          <a:latin typeface="Segoe UI"/>
-                        </a:rPr>
-                        <a:t>Right-click the pet → Focus timer → Open. Or restart Pips.</a:t>
+                        <a:rPr sz="1200" b="0">
+                          <a:solidFill>
+                            <a:srgbClr val="2B2A28"/>
+                          </a:solidFill>
+                          <a:latin typeface="Segoe UI"/>
+                        </a:rPr>
+                        <a:t>Pets grow up: baby → child → teen → grown-up, with focus sessions, daily visits, games and cuddles. Pet settings show the progress; 🍼 Raise again starts over.</a:t>
                       </a:r>
                     </a:p>
                   </a:txBody>
@@ -7890,20 +7890,20 @@
                   </a:tcPr>
                 </a:tc>
               </a:tr>
-              <a:tr h="530352">
+              <a:tr h="457200">
                 <a:tc>
                   <a:txBody>
                     <a:bodyPr wrap="square"/>
                     <a:lstStyle/>
                     <a:p>
                       <a:r>
-                        <a:rPr sz="1300" b="1">
-                          <a:solidFill>
-                            <a:srgbClr val="2B2A28"/>
-                          </a:solidFill>
-                          <a:latin typeface="Segoe UI"/>
-                        </a:rPr>
-                        <a:t>Update failed</a:t>
+                        <a:rPr sz="1200" b="1">
+                          <a:solidFill>
+                            <a:srgbClr val="2B2A28"/>
+                          </a:solidFill>
+                          <a:latin typeface="Segoe UI"/>
+                        </a:rPr>
+                        <a:t>My pet is sick 🤧</a:t>
                       </a:r>
                     </a:p>
                   </a:txBody>
@@ -7919,13 +7919,13 @@
                     <a:lstStyle/>
                     <a:p>
                       <a:r>
-                        <a:rPr sz="1300" b="0">
-                          <a:solidFill>
-                            <a:srgbClr val="2B2A28"/>
-                          </a:solidFill>
-                          <a:latin typeface="Segoe UI"/>
-                        </a:rPr>
-                        <a:t>Try Help → Check for updates later. Installed users can quit Pips and rerun setup; ZIP users should keep their original folder.</a:t>
+                        <a:rPr sz="1200" b="0">
+                          <a:solidFill>
+                            <a:srgbClr val="2B2A28"/>
+                          </a:solidFill>
+                          <a:latin typeface="Segoe UI"/>
+                        </a:rPr>
+                        <a:t>You worked 2.5 h without a 5-minute break. Take a short break (or right-click → Medicine) and it feels better. Turn off: Pet settings → Behaviour.</a:t>
                       </a:r>
                     </a:p>
                   </a:txBody>
@@ -7936,20 +7936,20 @@
                   </a:tcPr>
                 </a:tc>
               </a:tr>
-              <a:tr h="530352">
+              <a:tr h="457200">
                 <a:tc>
                   <a:txBody>
                     <a:bodyPr wrap="square"/>
                     <a:lstStyle/>
                     <a:p>
                       <a:r>
-                        <a:rPr sz="1300" b="1">
-                          <a:solidFill>
-                            <a:srgbClr val="2B2A28"/>
-                          </a:solidFill>
-                          <a:latin typeface="Segoe UI"/>
-                        </a:rPr>
-                        <a:t>Where are my settings?</a:t>
+                        <a:rPr sz="1200" b="1">
+                          <a:solidFill>
+                            <a:srgbClr val="2B2A28"/>
+                          </a:solidFill>
+                          <a:latin typeface="Segoe UI"/>
+                        </a:rPr>
+                        <a:t>The focus card is gone</a:t>
                       </a:r>
                     </a:p>
                   </a:txBody>
@@ -7965,13 +7965,13 @@
                     <a:lstStyle/>
                     <a:p>
                       <a:r>
-                        <a:rPr sz="1300" b="0">
-                          <a:solidFill>
-                            <a:srgbClr val="2B2A28"/>
-                          </a:solidFill>
-                          <a:latin typeface="Segoe UI"/>
-                        </a:rPr>
-                        <a:t>Installed app: %LOCALAPPDATA%\Programs\Pips. config.json and data\ hold your profile and progress; back them up before moving.</a:t>
+                        <a:rPr sz="1200" b="0">
+                          <a:solidFill>
+                            <a:srgbClr val="2B2A28"/>
+                          </a:solidFill>
+                          <a:latin typeface="Segoe UI"/>
+                        </a:rPr>
+                        <a:t>Right-click the pet → Focus timer → Open. Or restart Pips.</a:t>
                       </a:r>
                     </a:p>
                   </a:txBody>
@@ -7982,20 +7982,20 @@
                   </a:tcPr>
                 </a:tc>
               </a:tr>
-              <a:tr h="530352">
+              <a:tr h="457200">
                 <a:tc>
                   <a:txBody>
                     <a:bodyPr wrap="square"/>
                     <a:lstStyle/>
                     <a:p>
                       <a:r>
-                        <a:rPr sz="1300" b="1">
-                          <a:solidFill>
-                            <a:srgbClr val="2B2A28"/>
-                          </a:solidFill>
-                          <a:latin typeface="Segoe UI"/>
-                        </a:rPr>
-                        <a:t>Uninstall</a:t>
+                        <a:rPr sz="1200" b="1">
+                          <a:solidFill>
+                            <a:srgbClr val="2B2A28"/>
+                          </a:solidFill>
+                          <a:latin typeface="Segoe UI"/>
+                        </a:rPr>
+                        <a:t>Update failed</a:t>
                       </a:r>
                     </a:p>
                   </a:txBody>
@@ -8011,7 +8011,99 @@
                     <a:lstStyle/>
                     <a:p>
                       <a:r>
-                        <a:rPr sz="1300" b="0">
+                        <a:rPr sz="1200" b="0">
+                          <a:solidFill>
+                            <a:srgbClr val="2B2A28"/>
+                          </a:solidFill>
+                          <a:latin typeface="Segoe UI"/>
+                        </a:rPr>
+                        <a:t>Try Help → Check for updates later. Installed users can quit Pips and rerun setup; ZIP users should keep their original folder.</a:t>
+                      </a:r>
+                    </a:p>
+                  </a:txBody>
+                  <a:tcPr marL="73152" marR="73152" marT="36576" marB="36576">
+                    <a:solidFill>
+                      <a:srgbClr val="FFFDF8"/>
+                    </a:solidFill>
+                  </a:tcPr>
+                </a:tc>
+              </a:tr>
+              <a:tr h="457200">
+                <a:tc>
+                  <a:txBody>
+                    <a:bodyPr wrap="square"/>
+                    <a:lstStyle/>
+                    <a:p>
+                      <a:r>
+                        <a:rPr sz="1200" b="1">
+                          <a:solidFill>
+                            <a:srgbClr val="2B2A28"/>
+                          </a:solidFill>
+                          <a:latin typeface="Segoe UI"/>
+                        </a:rPr>
+                        <a:t>Where are my settings?</a:t>
+                      </a:r>
+                    </a:p>
+                  </a:txBody>
+                  <a:tcPr marL="73152" marR="73152" marT="36576" marB="36576">
+                    <a:solidFill>
+                      <a:srgbClr val="F7F4EC"/>
+                    </a:solidFill>
+                  </a:tcPr>
+                </a:tc>
+                <a:tc>
+                  <a:txBody>
+                    <a:bodyPr wrap="square"/>
+                    <a:lstStyle/>
+                    <a:p>
+                      <a:r>
+                        <a:rPr sz="1200" b="0">
+                          <a:solidFill>
+                            <a:srgbClr val="2B2A28"/>
+                          </a:solidFill>
+                          <a:latin typeface="Segoe UI"/>
+                        </a:rPr>
+                        <a:t>Installed app: %LOCALAPPDATA%\Programs\Pips. config.json and data\ hold your profile and progress; back them up before moving.</a:t>
+                      </a:r>
+                    </a:p>
+                  </a:txBody>
+                  <a:tcPr marL="73152" marR="73152" marT="36576" marB="36576">
+                    <a:solidFill>
+                      <a:srgbClr val="F7F4EC"/>
+                    </a:solidFill>
+                  </a:tcPr>
+                </a:tc>
+              </a:tr>
+              <a:tr h="457200">
+                <a:tc>
+                  <a:txBody>
+                    <a:bodyPr wrap="square"/>
+                    <a:lstStyle/>
+                    <a:p>
+                      <a:r>
+                        <a:rPr sz="1200" b="1">
+                          <a:solidFill>
+                            <a:srgbClr val="2B2A28"/>
+                          </a:solidFill>
+                          <a:latin typeface="Segoe UI"/>
+                        </a:rPr>
+                        <a:t>Uninstall</a:t>
+                      </a:r>
+                    </a:p>
+                  </a:txBody>
+                  <a:tcPr marL="73152" marR="73152" marT="36576" marB="36576">
+                    <a:solidFill>
+                      <a:srgbClr val="FFFDF8"/>
+                    </a:solidFill>
+                  </a:tcPr>
+                </a:tc>
+                <a:tc>
+                  <a:txBody>
+                    <a:bodyPr wrap="square"/>
+                    <a:lstStyle/>
+                    <a:p>
+                      <a:r>
+                        <a:rPr sz="1200" b="0">
                           <a:solidFill>
                             <a:srgbClr val="2B2A28"/>
                           </a:solidFill>
@@ -8166,7 +8258,7 @@
                 </a:solidFill>
                 <a:latin typeface="Segoe UI"/>
               </a:rPr>
-              <a:t>What's new in 2.17.0</a:t>
+              <a:t>What's new in 2.18.0</a:t>
             </a:r>
           </a:p>
         </p:txBody>
@@ -8279,7 +8371,7 @@
                 </a:solidFill>
                 <a:latin typeface="Segoe UI"/>
               </a:rPr>
-              <a:t>Find your pet anytime  ·  2026-10-29</a:t>
+              <a:t>Raise your pet  ·  2026-10-29</a:t>
             </a:r>
           </a:p>
         </p:txBody>
@@ -8327,7 +8419,7 @@
                 </a:solidFill>
                 <a:latin typeface="Segoe UI"/>
               </a:rPr>
-              <a:t>Pips now has an icon next to the clock: click it to bring your pet back; right-click for the focus timer, Friends &amp; chat or Quit.</a:t>
+              <a:t>Boy or girl? Pick your pet's gender in Settings: boys get a little hair tuft, girls a pink bow and eyelashes, and a ♂ / ♀ shows next to its name. You can add your own gender to your profile too - friends see a small ♂ / ♀ next to your name.</a:t>
             </a:r>
           </a:p>
           <a:p>
@@ -8352,7 +8444,7 @@
                 </a:solidFill>
                 <a:latin typeface="Segoe UI"/>
               </a:rPr>
-              <a:t>Press Ctrl+Alt+P anywhere to call your pet - it pops up on the screen you're using, even if it was hidden, asleep or behind a fullscreen app.</a:t>
+              <a:t>Pets grow up now: baby → child → teen → grown-up. Focus sessions, opening Pips each day, games and cuddles help them grow - no care mistakes, no bad endings. Already have a grown-up pet? It will ask whether you'd like to raise it again from a baby (coins, items and stats stay).</a:t>
             </a:r>
           </a:p>
           <a:p>
@@ -8377,7 +8469,7 @@
                 </a:solidFill>
                 <a:latin typeface="Segoe UI"/>
               </a:rPr>
-              <a:t>Opening Pips again from the Start menu or desktop does the same, and your pet walks back by itself if it ever ends up off-screen (e.g. after unplugging a monitor).</a:t>
+              <a:t>Sick days: work 2.5 hours without a 5-minute break and your pet catches a little cold (sneezes, thermometer, slow steps). A short break cures it - or give medicine from the menu. You can turn this off in Settings.</a:t>
             </a:r>
           </a:p>
           <a:p>
@@ -8402,7 +8494,7 @@
                 </a:solidFill>
                 <a:latin typeface="Segoe UI"/>
               </a:rPr>
-              <a:t>Hiding your pet now tells you how to bring it back.</a:t>
+              <a:t>New mini-game Left or Right? (pet menu → Play): guess which way your pet will look - 3 out of 5 wins, with coins for your first wins each day.</a:t>
             </a:r>
           </a:p>
         </p:txBody>
@@ -8533,7 +8625,7 @@
                 </a:solidFill>
                 <a:latin typeface="Segoe UI"/>
               </a:rPr>
-              <a:t>Pips kini punya ikon di dekat jam: klik untuk memanggil pet kembali; klik kanan untuk timer fokus, Teman &amp; chat, atau Keluar.</a:t>
+              <a:t>Jantan atau betina? Pilih jenis kelamin pet di Pengaturan: jantan punya jambul rambut kecil, betina pita pink dan bulu mata, dan ♂ / ♀ muncul di samping namanya. Kamu juga bisa menambahkan jenis kelaminmu di profil - teman melihat ♂ / ♀ kecil di samping namamu.</a:t>
             </a:r>
           </a:p>
           <a:p>
@@ -8558,7 +8650,7 @@
                 </a:solidFill>
                 <a:latin typeface="Segoe UI"/>
               </a:rPr>
-              <a:t>Tekan Ctrl+Alt+P di mana saja untuk memanggil pet - ia muncul di layar yang sedang kamu pakai, bahkan saat tersembunyi, tidur, atau tertutup aplikasi layar penuh.</a:t>
+              <a:t>Pet kini bisa tumbuh: bayi → anak → remaja → dewasa. Sesi fokus, membuka Pips setiap hari, permainan, dan pelukan membantunya tumbuh - tanpa kesalahan perawatan, tanpa akhir yang buruk. Pet-mu sudah dewasa? Ia akan bertanya apakah kamu mau membesarkannya lagi dari bayi (koin, item, dan statistik tetap).</a:t>
             </a:r>
           </a:p>
           <a:p>
@@ -8583,7 +8675,7 @@
                 </a:solidFill>
                 <a:latin typeface="Segoe UI"/>
               </a:rPr>
-              <a:t>Membuka Pips lagi dari menu Start atau desktop juga memanggilnya, dan pet akan kembali sendiri jika sampai keluar layar (misalnya setelah monitor dicabut).</a:t>
+              <a:t>Hari sakit: bekerja 2,5 jam tanpa istirahat 5 menit dan pet-mu masuk angin (bersin, termometer, langkah pelan). Istirahat sebentar menyembuhkannya - atau beri obat dari menu. Bisa dimatikan di Pengaturan.</a:t>
             </a:r>
           </a:p>
           <a:p>
@@ -8608,7 +8700,7 @@
                 </a:solidFill>
                 <a:latin typeface="Segoe UI"/>
               </a:rPr>
-              <a:t>Saat menyembunyikan pet, Pips kini memberi tahu cara memanggilnya kembali.</a:t>
+              <a:t>Mini-game baru Kiri atau Kanan? (menu pet → Main): tebak ke mana pet-mu akan menoleh - 3 dari 5 menang, dengan koin untuk kemenangan pertama setiap hari.</a:t>
             </a:r>
           </a:p>
         </p:txBody>
@@ -8840,7 +8932,7 @@
         </p:nvGraphicFramePr>
         <p:xfrm>
           <a:off x="548640" y="1645920"/>
-          <a:ext cx="11155680" cy="23426928"/>
+          <a:ext cx="11155680" cy="24249888"/>
         </p:xfrm>
         <a:graphic>
           <a:graphicData uri="http://schemas.openxmlformats.org/drawingml/2006/table">
@@ -8934,7 +9026,7 @@
                           </a:solidFill>
                           <a:latin typeface="Segoe UI"/>
                         </a:rPr>
-                        <a:t>2.17.0</a:t>
+                        <a:t>2.18.0</a:t>
                       </a:r>
                     </a:p>
                   </a:txBody>
@@ -8978,7 +9070,7 @@
                           </a:solidFill>
                           <a:latin typeface="Segoe UI"/>
                         </a:rPr>
-                        <a:t>Find your pet anytime</a:t>
+                        <a:t>Raise your pet</a:t>
                       </a:r>
                     </a:p>
                     <a:p>
@@ -8989,7 +9081,7 @@
                           </a:solidFill>
                           <a:latin typeface="Segoe UI"/>
                         </a:rPr>
-                        <a:t>Pips now has an icon next to the clock: click it to bring your pet back; right-click for the focus timer, Friends &amp; chat or Quit.; Press Ctrl+Alt+P anywhere to call your pet - it pops up on the screen you're using, even if it was hidden, asleep or behind a fullscreen app.; Opening Pips again from the Start menu or desktop does the same, and your pet walks back by itself if it ever ends up off-screen (e.g. after unplugging a monitor).; Hiding your pet now tells you how to bring it back.</a:t>
+                        <a:t>Boy or girl? Pick your pet's gender in Settings: boys get a little hair tuft, girls a pink bow and eyelashes, and a ♂ / ♀ shows next to its name. You can add your own gender to your profile too - friends see a small ♂ / ♀ next to your name.; Pets grow up now: baby → child → teen → grown-up. Focus sessions, opening Pips each day, games and cuddles help them grow - no care mistakes, no bad endings. Already have a grown-up pet? It will ask whether you'd like to raise it again from a baby (coins, items and stats stay).; Sick days: work 2.5 hours without a 5-minute break and your pet catches a little cold (sneezes, thermometer, slow steps). A short break cures it - or give medicine from the menu. You can turn this off in Settings.; New mini-game Left or Right? (pet menu → Play): guess which way your pet will look - 3 out of 5 wins, with coins for your first wins each day.</a:t>
                       </a:r>
                     </a:p>
                   </a:txBody>
@@ -9013,7 +9105,7 @@
                           </a:solidFill>
                           <a:latin typeface="Segoe UI"/>
                         </a:rPr>
-                        <a:t>2.16.0</a:t>
+                        <a:t>2.17.0</a:t>
                       </a:r>
                     </a:p>
                   </a:txBody>
@@ -9057,7 +9149,7 @@
                           </a:solidFill>
                           <a:latin typeface="Segoe UI"/>
                         </a:rPr>
-                        <a:t>Pips Community</a:t>
+                        <a:t>Find your pet anytime</a:t>
                       </a:r>
                     </a:p>
                     <a:p>
@@ -9068,7 +9160,7 @@
                           </a:solidFill>
                           <a:latin typeface="Segoe UI"/>
                         </a:rPr>
-                        <a:t>New Pips Community at the top of the Chat tab: a #general channel to chat with everyone who uses Pips, plus #announcements with news from the Pips team.; Every new Pips version is announced there automatically - see what's new and update with one click.; Type @name to ping someone in #general. Mute #general any time; owner and moderators can remove messages.; Open it from your pet's menu too (Pips Community). Fixed: chats no longer clear what you're typing when Pips refreshes in the background.</a:t>
+                        <a:t>Pips now has an icon next to the clock: click it to bring your pet back; right-click for the focus timer, Friends &amp; chat or Quit.; Press Ctrl+Alt+P anywhere to call your pet - it pops up on the screen you're using, even if it was hidden, asleep or behind a fullscreen app.; Opening Pips again from the Start menu or desktop does the same, and your pet walks back by itself if it ever ends up off-screen (e.g. after unplugging a monitor).; Hiding your pet now tells you how to bring it back.</a:t>
                       </a:r>
                     </a:p>
                   </a:txBody>
@@ -9092,7 +9184,7 @@
                           </a:solidFill>
                           <a:latin typeface="Segoe UI"/>
                         </a:rPr>
-                        <a:t>2.15.0</a:t>
+                        <a:t>2.16.0</a:t>
                       </a:r>
                     </a:p>
                   </a:txBody>
@@ -9136,7 +9228,7 @@
                           </a:solidFill>
                           <a:latin typeface="Segoe UI"/>
                         </a:rPr>
-                        <a:t>Update reminders</a:t>
+                        <a:t>Pips Community</a:t>
                       </a:r>
                     </a:p>
                     <a:p>
@@ -9147,7 +9239,7 @@
                           </a:solidFill>
                           <a:latin typeface="Segoe UI"/>
                         </a:rPr>
-                        <a:t>Owner &amp; moderators: the Mod tab now lists who hasn't updated Pips yet (their version and when they were last seen), with one-click reminders by e-mail (sent from your Outlook) or a ready-to-send Teams chat.; New Work e-mail field in your Profile, filled in from Outlook. Only the owner and moderators can see it (for update reminders and support) - clear it to hide it.; Pips now tells the Friends server which version it runs, so the update list is always accurate.; Friends keeps working when a local proxy tool stops answering - Pips falls back to the Windows proxy settings.</a:t>
+                        <a:t>New Pips Community at the top of the Chat tab: a #general channel to chat with everyone who uses Pips, plus #announcements with news from the Pips team.; Every new Pips version is announced there automatically - see what's new and update with one click.; Type @name to ping someone in #general. Mute #general any time; owner and moderators can remove messages.; Open it from your pet's menu too (Pips Community). Fixed: chats no longer clear what you're typing when Pips refreshes in the background.</a:t>
                       </a:r>
                     </a:p>
                   </a:txBody>
@@ -9171,7 +9263,7 @@
                           </a:solidFill>
                           <a:latin typeface="Segoe UI"/>
                         </a:rPr>
-                        <a:t>2.14.3</a:t>
+                        <a:t>2.15.0</a:t>
                       </a:r>
                     </a:p>
                   </a:txBody>
@@ -9215,7 +9307,7 @@
                           </a:solidFill>
                           <a:latin typeface="Segoe UI"/>
                         </a:rPr>
-                        <a:t>Tidy menus</a:t>
+                        <a:t>Update reminders</a:t>
                       </a:r>
                     </a:p>
                     <a:p>
@@ -9226,7 +9318,7 @@
                           </a:solidFill>
                           <a:latin typeface="Segoe UI"/>
                         </a:rPr>
-                        <a:t>Fixed: a submenu (e.g. Poke a friend) could stay floating on the screen after the right-click menu closed.; Menus now close by themselves when you move the mouse away and leave them for a few seconds.</a:t>
+                        <a:t>Owner &amp; moderators: the Mod tab now lists who hasn't updated Pips yet (their version and when they were last seen), with one-click reminders by e-mail (sent from your Outlook) or a ready-to-send Teams chat.; New Work e-mail field in your Profile, filled in from Outlook. Only the owner and moderators can see it (for update reminders and support) - clear it to hide it.; Pips now tells the Friends server which version it runs, so the update list is always accurate.; Friends keeps working when a local proxy tool stops answering - Pips falls back to the Windows proxy settings.</a:t>
                       </a:r>
                     </a:p>
                   </a:txBody>
@@ -9250,7 +9342,7 @@
                           </a:solidFill>
                           <a:latin typeface="Segoe UI"/>
                         </a:rPr>
-                        <a:t>2.14.2</a:t>
+                        <a:t>2.14.3</a:t>
                       </a:r>
                     </a:p>
                   </a:txBody>
@@ -9294,7 +9386,7 @@
                           </a:solidFill>
                           <a:latin typeface="Segoe UI"/>
                         </a:rPr>
-                        <a:t>Never miss an update</a:t>
+                        <a:t>Tidy menus</a:t>
                       </a:r>
                     </a:p>
                     <a:p>
@@ -9305,7 +9397,7 @@
                           </a:solidFill>
                           <a:latin typeface="Segoe UI"/>
                         </a:rPr>
-                        <a:t>Your pet now reminds you every 2 hours while a new version is waiting (instead of every 6 hours).; If the reminder can't show (fullscreen app, guided tour, another message), your pet tries again a few minutes later.; No internet when Pips starts (e.g. VPN off)? It checks again after an hour.</a:t>
+                        <a:t>Fixed: a submenu (e.g. Poke a friend) could stay floating on the screen after the right-click menu closed.; Menus now close by themselves when you move the mouse away and leave them for a few seconds.</a:t>
                       </a:r>
                     </a:p>
                   </a:txBody>
@@ -9329,7 +9421,7 @@
                           </a:solidFill>
                           <a:latin typeface="Segoe UI"/>
                         </a:rPr>
-                        <a:t>2.14.1</a:t>
+                        <a:t>2.14.2</a:t>
                       </a:r>
                     </a:p>
                   </a:txBody>
@@ -9373,7 +9465,7 @@
                           </a:solidFill>
                           <a:latin typeface="Segoe UI"/>
                         </a:rPr>
-                        <a:t>One pet at a time</a:t>
+                        <a:t>Never miss an update</a:t>
                       </a:r>
                     </a:p>
                     <a:p>
@@ -9384,7 +9476,7 @@
                           </a:solidFill>
                           <a:latin typeface="Segoe UI"/>
                         </a:rPr>
-                        <a:t>Opening Pips again (Desktop / Start Menu shortcut, autostart) no longer starts a second pet - your pet just pops up and says hi.; Fixes lag caused by two copies of Pips running at once.</a:t>
+                        <a:t>Your pet now reminds you every 2 hours while a new version is waiting (instead of every 6 hours).; If the reminder can't show (fullscreen app, guided tour, another message), your pet tries again a few minutes later.; No internet when Pips starts (e.g. VPN off)? It checks again after an hour.</a:t>
                       </a:r>
                     </a:p>
                   </a:txBody>
@@ -9408,7 +9500,7 @@
                           </a:solidFill>
                           <a:latin typeface="Segoe UI"/>
                         </a:rPr>
-                        <a:t>2.14.0</a:t>
+                        <a:t>2.14.1</a:t>
                       </a:r>
                     </a:p>
                   </a:txBody>
@@ -9452,7 +9544,7 @@
                           </a:solidFill>
                           <a:latin typeface="Segoe UI"/>
                         </a:rPr>
-                        <a:t>Pokes, tickles &amp; teases</a:t>
+                        <a:t>One pet at a time</a:t>
                       </a:r>
                     </a:p>
                     <a:p>
@@ -9463,7 +9555,7 @@
                           </a:solidFill>
                           <a:latin typeface="Segoe UI"/>
                         </a:rPr>
-                        <a:t>Poke, tickle, tease, boop or hug a friend from afar - no pet visit needed.; Right-click your pet → Poke a friend, or use the Poke button in Friends, chat and profiles.; Your friend gets a pop-up ("Wendy is teasing you!"), their pet reacts, and they can poke back with one click.; During a focus session pokes wait quietly until your break; when your pet is hidden they show in the screen corner.</a:t>
+                        <a:t>Opening Pips again (Desktop / Start Menu shortcut, autostart) no longer starts a second pet - your pet just pops up and says hi.; Fixes lag caused by two copies of Pips running at once.</a:t>
                       </a:r>
                     </a:p>
                   </a:txBody>
@@ -9487,7 +9579,7 @@
                           </a:solidFill>
                           <a:latin typeface="Segoe UI"/>
                         </a:rPr>
-                        <a:t>2.13.1</a:t>
+                        <a:t>2.14.0</a:t>
                       </a:r>
                     </a:p>
                   </a:txBody>
@@ -9509,7 +9601,7 @@
                           </a:solidFill>
                           <a:latin typeface="Segoe UI"/>
                         </a:rPr>
-                        <a:t>2026-10-28</a:t>
+                        <a:t>2026-10-29</a:t>
                       </a:r>
                     </a:p>
                   </a:txBody>
@@ -9531,7 +9623,7 @@
                           </a:solidFill>
                           <a:latin typeface="Segoe UI"/>
                         </a:rPr>
-                        <a:t>One-click Windows installer</a:t>
+                        <a:t>Pokes, tickles &amp; teases</a:t>
                       </a:r>
                     </a:p>
                     <a:p>
@@ -9542,7 +9634,7 @@
                           </a:solidFill>
                           <a:latin typeface="Segoe UI"/>
                         </a:rPr>
-                        <a:t>One Windows installer: no ZIP extraction, Python installation or command line. Download, open and click Install Pips.; Installs for your Windows account without administrator access, adds Desktop and Start Menu shortcuts, and opens Pips automatically.; Reinstalling in the same location keeps your settings and pet progress. Existing ZIP users can keep updating in place from Help → Check for updates.; A simpler download page and updated user guide; the bundled runtime stays separate from small in-app updates.</a:t>
+                        <a:t>Poke, tickle, tease, boop or hug a friend from afar - no pet visit needed.; Right-click your pet → Poke a friend, or use the Poke button in Friends, chat and profiles.; Your friend gets a pop-up ("Wendy is teasing you!"), their pet reacts, and they can poke back with one click.; During a focus session pokes wait quietly until your break; when your pet is hidden they show in the screen corner.</a:t>
                       </a:r>
                     </a:p>
                   </a:txBody>
@@ -9566,7 +9658,7 @@
                           </a:solidFill>
                           <a:latin typeface="Segoe UI"/>
                         </a:rPr>
-                        <a:t>2.13.0</a:t>
+                        <a:t>2.13.1</a:t>
                       </a:r>
                     </a:p>
                   </a:txBody>
@@ -9610,7 +9702,7 @@
                           </a:solidFill>
                           <a:latin typeface="Segoe UI"/>
                         </a:rPr>
-                        <a:t>Birthdays, parties &amp; gifts</a:t>
+                        <a:t>One-click Windows installer</a:t>
                       </a:r>
                     </a:p>
                     <a:p>
@@ -9621,7 +9713,7 @@
                           </a:solidFill>
                           <a:latin typeface="Segoe UI"/>
                         </a:rPr>
-                        <a:t>Set your birthday in Social → Profile (month + day, optionally visible to friends).; On your birthday Pips throws confetti and gives you 100 bonus coins.; Friends tab shows upcoming birthdays; you get reminders 3 days, 1 day and on the day.; Birthday parties: join a friend's party, see who's there, sign the guestbook and celebrate together.</a:t>
+                        <a:t>One Windows installer: no ZIP extraction, Python installation or command line. Download, open and click Install Pips.; Installs for your Windows account without administrator access, adds Desktop and Start Menu shortcuts, and opens Pips automatically.; Reinstalling in the same location keeps your settings and pet progress. Existing ZIP users can keep updating in place from Help → Check for updates.; A simpler download page and updated user guide; the bundled runtime stays separate from small in-app updates.</a:t>
                       </a:r>
                     </a:p>
                   </a:txBody>
@@ -9645,7 +9737,7 @@
                           </a:solidFill>
                           <a:latin typeface="Segoe UI"/>
                         </a:rPr>
-                        <a:t>2.12.0</a:t>
+                        <a:t>2.13.0</a:t>
                       </a:r>
                     </a:p>
                   </a:txBody>
@@ -9689,7 +9781,7 @@
                           </a:solidFill>
                           <a:latin typeface="Segoe UI"/>
                         </a:rPr>
-                        <a:t>Mega update: 28 new animals, 31 shop items, 13 moves</a:t>
+                        <a:t>Birthdays, parties &amp; gifts</a:t>
                       </a:r>
                     </a:p>
                     <a:p>
@@ -9700,7 +9792,7 @@
                           </a:solidFill>
                           <a:latin typeface="Segoe UI"/>
                         </a:rPr>
-                        <a:t>🦁 28 new animals (51 total): lion, tiger, unicorn, deer, sheep, cow, raccoon, red panda, monkey, hedgehog, dino, squirrel, mouse, koala, shark, dolphin, seal, otter, pufferfish, duck, crab, parrot, chick, ladybug, phoenix, pegasus, ghost and flamingo; 🎩 31 new shop items: top hat, cowboy, chef, pirate, Santa, viking, graduation cap, beret, bow, propeller cap, flower crown, nerd glasses, eyepatch, mustache, goggles, masquerade mask, tie, pearls, flower lei, gold chain, balloon, backpack, guitar, shield, butterfly / devil wings and more - plus Premium galaxy crown, galaxy cape and dragon wings; 💃 13 new moves: wave, jump, hearts, sing, yoga, zoomies, cartwheel, juggle, rain dance, breakdance, magic, confetti and the Premium rocket launch; The Shop is now split into sections (Hats, Face, Neck, Back, Moves, Arena gear) with an owned counter for each</a:t>
+                        <a:t>Set your birthday in Social → Profile (month + day, optionally visible to friends).; On your birthday Pips throws confetti and gives you 100 bonus coins.; Friends tab shows upcoming birthdays; you get reminders 3 days, 1 day and on the day.; Birthday parties: join a friend's party, see who's there, sign the guestbook and celebrate together.</a:t>
                       </a:r>
                     </a:p>
                   </a:txBody>
@@ -9724,7 +9816,7 @@
                           </a:solidFill>
                           <a:latin typeface="Segoe UI"/>
                         </a:rPr>
-                        <a:t>2.11.0</a:t>
+                        <a:t>2.12.0</a:t>
                       </a:r>
                     </a:p>
                   </a:txBody>
@@ -9768,7 +9860,7 @@
                           </a:solidFill>
                           <a:latin typeface="Segoe UI"/>
                         </a:rPr>
-                        <a:t>New right-click menus</a:t>
+                        <a:t>Mega update: 28 new animals, 31 shop items, 13 moves</a:t>
                       </a:r>
                     </a:p>
                     <a:p>
@@ -9779,7 +9871,7 @@
                           </a:solidFill>
                           <a:latin typeface="Segoe UI"/>
                         </a:rPr>
-                        <a:t>✨ Brand-new animated right-click menu for your pet: mood &amp; stat bars, quick-action tiles (Friends, Shop, Snack, Pat, Focus, Stats, Sleep, Taskbar), hover effects and smooth fly-out submenus; Pick colours from swatches, switch size with one click and flip Sounds / Dark mode with toggle switches - changes show instantly; Updates are highlighted: a glowing banner and NEW badge appear in the menu when a new version is ready; The focus card's right-click menu got the same new look; keyboard arrows, Enter and Esc work too</a:t>
+                        <a:t>🦁 28 new animals (51 total): lion, tiger, unicorn, deer, sheep, cow, raccoon, red panda, monkey, hedgehog, dino, squirrel, mouse, koala, shark, dolphin, seal, otter, pufferfish, duck, crab, parrot, chick, ladybug, phoenix, pegasus, ghost and flamingo; 🎩 31 new shop items: top hat, cowboy, chef, pirate, Santa, viking, graduation cap, beret, bow, propeller cap, flower crown, nerd glasses, eyepatch, mustache, goggles, masquerade mask, tie, pearls, flower lei, gold chain, balloon, backpack, guitar, shield, butterfly / devil wings and more - plus Premium galaxy crown, galaxy cape and dragon wings; 💃 13 new moves: wave, jump, hearts, sing, yoga, zoomies, cartwheel, juggle, rain dance, breakdance, magic, confetti and the Premium rocket launch; The Shop is now split into sections (Hats, Face, Neck, Back, Moves, Arena gear) with an owned counter for each</a:t>
                       </a:r>
                     </a:p>
                   </a:txBody>
@@ -9803,7 +9895,7 @@
                           </a:solidFill>
                           <a:latin typeface="Segoe UI"/>
                         </a:rPr>
-                        <a:t>2.10.0</a:t>
+                        <a:t>2.11.0</a:t>
                       </a:r>
                     </a:p>
                   </a:txBody>
@@ -9847,7 +9939,7 @@
                           </a:solidFill>
                           <a:latin typeface="Segoe UI"/>
                         </a:rPr>
-                        <a:t>Chat bots</a:t>
+                        <a:t>New right-click menus</a:t>
                       </a:r>
                     </a:p>
                     <a:p>
@@ -9858,7 +9950,7 @@
                           </a:solidFill>
                           <a:latin typeface="Segoe UI"/>
                         </a:rPr>
-                        <a:t>🤖 6 friendly chat bots in the Chat tab: Pip Helper (app questions), Coach Focus (focus tips from your real stats), Sunny (live weather for any city), Arena Master (battle tips + quick battle), Giggles (jokes &amp; games) and Guardian (safety &amp; reporting help); Private bot chats with suggestion chips, typing indicator and a clear button - your bot chats stay on your PC; Mention a bot in a group chat (e.g. @weather Batam) and it answers in the room for everyone; Bots reply in your app language; up to 120 bot messages per day</a:t>
+                        <a:t>✨ Brand-new animated right-click menu for your pet: mood &amp; stat bars, quick-action tiles (Friends, Shop, Snack, Pat, Focus, Stats, Sleep, Taskbar), hover effects and smooth fly-out submenus; Pick colours from swatches, switch size with one click and flip Sounds / Dark mode with toggle switches - changes show instantly; Updates are highlighted: a glowing banner and NEW badge appear in the menu when a new version is ready; The focus card's right-click menu got the same new look; keyboard arrows, Enter and Esc work too</a:t>
                       </a:r>
                     </a:p>
                   </a:txBody>
@@ -9882,7 +9974,7 @@
                           </a:solidFill>
                           <a:latin typeface="Segoe UI"/>
                         </a:rPr>
-                        <a:t>2.9.0</a:t>
+                        <a:t>2.10.0</a:t>
                       </a:r>
                     </a:p>
                   </a:txBody>
@@ -9926,7 +10018,7 @@
                           </a:solidFill>
                           <a:latin typeface="Segoe UI"/>
                         </a:rPr>
-                        <a:t>Location &amp; live weather</a:t>
+                        <a:t>Chat bots</a:t>
                       </a:r>
                     </a:p>
                     <a:p>
@@ -9937,7 +10029,7 @@
                           </a:solidFill>
                           <a:latin typeface="Segoe UI"/>
                         </a:rPr>
-                        <a:t>📍 Add your city in Profile → Location &amp; weather (auto-detect or search) - only your city and country are shown, never your exact position; Live weather banners on every profile with animations: rain, drizzle, thunderstorms with lightning, snow, fog, clouds, sunshine or a starry night - plus temperature, feels-like, humidity, wind and local time; Your own weather strip on top of the hub, and each friend's weather + local time in the friends list; Hide your location from others or remove it any time</a:t>
+                        <a:t>🤖 6 friendly chat bots in the Chat tab: Pip Helper (app questions), Coach Focus (focus tips from your real stats), Sunny (live weather for any city), Arena Master (battle tips + quick battle), Giggles (jokes &amp; games) and Guardian (safety &amp; reporting help); Private bot chats with suggestion chips, typing indicator and a clear button - your bot chats stay on your PC; Mention a bot in a group chat (e.g. @weather Batam) and it answers in the room for everyone; Bots reply in your app language; up to 120 bot messages per day</a:t>
                       </a:r>
                     </a:p>
                   </a:txBody>
@@ -9961,7 +10053,7 @@
                           </a:solidFill>
                           <a:latin typeface="Segoe UI"/>
                         </a:rPr>
-                        <a:t>2.8.0</a:t>
+                        <a:t>2.9.0</a:t>
                       </a:r>
                     </a:p>
                   </a:txBody>
@@ -10005,7 +10097,7 @@
                           </a:solidFill>
                           <a:latin typeface="Segoe UI"/>
                         </a:rPr>
-                        <a:t>Pips Arena - duels, gear &amp; live battles</a:t>
+                        <a:t>Location &amp; live weather</a:t>
                       </a:r>
                     </a:p>
                     <a:p>
@@ -10016,7 +10108,7 @@
                           </a:solidFill>
                           <a:latin typeface="Segoe UI"/>
                         </a:rPr>
-                        <a:t>⚔ New Arena tab: challenge friends or anyone in the arena to a live duel - each round pick Attack, Guard or Special within 12 seconds and watch your pets fight; ⚡ Quick battle: an instant auto-fight against anyone's fighter, even when they're offline; Arena gear in the Shop: 7 weapons (water pistol to rocket launcher), 5 armors and 5 gadgets that decide your special move - better gear and a higher level make a stronger fighter; Live duels can be watched by everyone, plus recent battle replays, top fighters, rating and win/loss records; wins earn coins</a:t>
+                        <a:t>📍 Add your city in Profile → Location &amp; weather (auto-detect or search) - only your city and country are shown, never your exact position; Live weather banners on every profile with animations: rain, drizzle, thunderstorms with lightning, snow, fog, clouds, sunshine or a starry night - plus temperature, feels-like, humidity, wind and local time; Your own weather strip on top of the hub, and each friend's weather + local time in the friends list; Hide your location from others or remove it any time</a:t>
                       </a:r>
                     </a:p>
                   </a:txBody>
@@ -10040,7 +10132,7 @@
                           </a:solidFill>
                           <a:latin typeface="Segoe UI"/>
                         </a:rPr>
-                        <a:t>2.7.0</a:t>
+                        <a:t>2.8.0</a:t>
                       </a:r>
                     </a:p>
                   </a:txBody>
@@ -10084,7 +10176,7 @@
                           </a:solidFill>
                           <a:latin typeface="Segoe UI"/>
                         </a:rPr>
-                        <a:t>Moderators &amp; Premium</a:t>
+                        <a:t>Pips Arena - duels, gear &amp; live battles</a:t>
                       </a:r>
                     </a:p>
                     <a:p>
@@ -10095,7 +10187,7 @@
                           </a:solidFill>
                           <a:latin typeface="Segoe UI"/>
                         </a:rPr>
-                        <a:t>★ Premium: a purple Premium badge, 4 exclusive props (tiara, star glasses, diamond necklace, fairy wings), the Fireworks move, +30 coins every day, double friend-interaction coins and room for 300 friends / 30 groups; Get Premium: Profile tab → Premium → "Ask to buy" emails the owner; after payment you receive a key (PIPS-XXXX-XXXX) to redeem right there; 🛡 Moderators: a blue Mod badge and a Mod tab with the report queue - warn, mute (1h / 24h / 7 days), clear a profile or reset a name; every action is logged; Report button on everyone's profile, so moderators can keep Pips friendly</a:t>
+                        <a:t>⚔ New Arena tab: challenge friends or anyone in the arena to a live duel - each round pick Attack, Guard or Special within 12 seconds and watch your pets fight; ⚡ Quick battle: an instant auto-fight against anyone's fighter, even when they're offline; Arena gear in the Shop: 7 weapons (water pistol to rocket launcher), 5 armors and 5 gadgets that decide your special move - better gear and a higher level make a stronger fighter; Live duels can be watched by everyone, plus recent battle replays, top fighters, rating and win/loss records; wins earn coins</a:t>
                       </a:r>
                     </a:p>
                   </a:txBody>
@@ -10119,7 +10211,7 @@
                           </a:solidFill>
                           <a:latin typeface="Segoe UI"/>
                         </a:rPr>
-                        <a:t>2.6.1</a:t>
+                        <a:t>2.7.0</a:t>
                       </a:r>
                     </a:p>
                   </a:txBody>
@@ -10163,7 +10255,7 @@
                           </a:solidFill>
                           <a:latin typeface="Segoe UI"/>
                         </a:rPr>
-                        <a:t>Owner badge &amp; credits</a:t>
+                        <a:t>Moderators &amp; Premium</a:t>
                       </a:r>
                     </a:p>
                     <a:p>
@@ -10174,7 +10266,7 @@
                           </a:solidFill>
                           <a:latin typeface="Segoe UI"/>
                         </a:rPr>
-                        <a:t>The creator of Pips (Juwen Lie) now shows a gold ♛ Owner badge on his profile, friend list and ranks; New About Pips card in the Profile tab: credits and how to contact the owner (Juwen_Lie@pegatroncorp.com) with Email and Copy buttons; Right-click the pet → Help → About now shows who made Pips and the contact email</a:t>
+                        <a:t>★ Premium: a purple Premium badge, 4 exclusive props (tiara, star glasses, diamond necklace, fairy wings), the Fireworks move, +30 coins every day, double friend-interaction coins and room for 300 friends / 30 groups; Get Premium: Profile tab → Premium → "Ask to buy" emails the owner; after payment you receive a key (PIPS-XXXX-XXXX) to redeem right there; 🛡 Moderators: a blue Mod badge and a Mod tab with the report queue - warn, mute (1h / 24h / 7 days), clear a profile or reset a name; every action is logged; Report button on everyone's profile, so moderators can keep Pips friendly</a:t>
                       </a:r>
                     </a:p>
                   </a:txBody>
@@ -10198,7 +10290,7 @@
                           </a:solidFill>
                           <a:latin typeface="Segoe UI"/>
                         </a:rPr>
-                        <a:t>2.6.0</a:t>
+                        <a:t>2.6.1</a:t>
                       </a:r>
                     </a:p>
                   </a:txBody>
@@ -10242,7 +10334,7 @@
                           </a:solidFill>
                           <a:latin typeface="Segoe UI"/>
                         </a:rPr>
-                        <a:t>Profiles, ranks, online status &amp; dark mode</a:t>
+                        <a:t>Owner badge &amp; credits</a:t>
                       </a:r>
                     </a:p>
                     <a:p>
@@ -10253,7 +10345,7 @@
                           </a:solidFill>
                           <a:latin typeface="Segoe UI"/>
                         </a:rPr>
-                        <a:t>Profile tab: profile picture (or your pet), about me, job, location, hobbies, birthday and a status message; Public or private: public profiles can be added directly and viewed in full; private profiles need a friend request that they accept, and strangers only see name, photo, pet, level and status; Click anyone to open their profile - badges, info, their friends - and add them, chat or wave from there; Ranks tab replaces Teams: everyone using Pips, sorted by XP, badges or streak</a:t>
+                        <a:t>The creator of Pips (Juwen Lie) now shows a gold ♛ Owner badge on his profile, friend list and ranks; New About Pips card in the Profile tab: credits and how to contact the owner (Juwen_Lie@pegatroncorp.com) with Email and Copy buttons; Right-click the pet → Help → About now shows who made Pips and the contact email</a:t>
                       </a:r>
                     </a:p>
                   </a:txBody>
@@ -10277,7 +10369,7 @@
                           </a:solidFill>
                           <a:latin typeface="Segoe UI"/>
                         </a:rPr>
-                        <a:t>2.5.1</a:t>
+                        <a:t>2.6.0</a:t>
                       </a:r>
                     </a:p>
                   </a:txBody>
@@ -10321,7 +10413,7 @@
                           </a:solidFill>
                           <a:latin typeface="Segoe UI"/>
                         </a:rPr>
-                        <a:t>New cute Pips logo</a:t>
+                        <a:t>Profiles, ranks, online status &amp; dark mode</a:t>
                       </a:r>
                     </a:p>
                     <a:p>
@@ -10332,7 +10424,7 @@
                           </a:solidFill>
                           <a:latin typeface="Segoe UI"/>
                         </a:rPr>
-                        <a:t>New Pips logo: Pip the cat on a Pips-red tile, matching the app colours (desktop shortcut, windows and website)</a:t>
+                        <a:t>Profile tab: profile picture (or your pet), about me, job, location, hobbies, birthday and a status message; Public or private: public profiles can be added directly and viewed in full; private profiles need a friend request that they accept, and strangers only see name, photo, pet, level and status; Click anyone to open their profile - badges, info, their friends - and add them, chat or wave from there; Ranks tab replaces Teams: everyone using Pips, sorted by XP, badges or streak</a:t>
                       </a:r>
                     </a:p>
                   </a:txBody>
@@ -10356,7 +10448,7 @@
                           </a:solidFill>
                           <a:latin typeface="Segoe UI"/>
                         </a:rPr>
-                        <a:t>2.5.0</a:t>
+                        <a:t>2.5.1</a:t>
                       </a:r>
                     </a:p>
                   </a:txBody>
@@ -10400,7 +10492,7 @@
                           </a:solidFill>
                           <a:latin typeface="Segoe UI"/>
                         </a:rPr>
-                        <a:t>Shop, coins, props &amp; moves</a:t>
+                        <a:t>New cute Pips logo</a:t>
                       </a:r>
                     </a:p>
                     <a:p>
@@ -10411,7 +10503,7 @@
                           </a:solidFill>
                           <a:latin typeface="Segoe UI"/>
                         </a:rPr>
-                        <a:t>Shop: earn coins and spend them on your pet - 17 props (crown, wizard hat, headphones, shades, scarf, cape, angel wings...) and 6 moves: spin, dance, moonwalk, backflip, kung fu and spider swing!; Coins come from leveling up (+40), badges (+25), opening Pips each day (+10), friendships (+15 per affinity level), waving / chatting / visiting friends (+2) and pomodoros (+5). Everyone starts with a 100-coin gift; Your friends see your props: on avatars in the hub and when your pet visits their desktop - it shows off one of your moves; Pips is now a social pet: clicking the pet opens the Pips hub (friends, chat, groups, shop, badges)</a:t>
+                        <a:t>New Pips logo: Pip the cat on a Pips-red tile, matching the app colours (desktop shortcut, windows and website)</a:t>
                       </a:r>
                     </a:p>
                   </a:txBody>
@@ -10435,7 +10527,7 @@
                           </a:solidFill>
                           <a:latin typeface="Segoe UI"/>
                         </a:rPr>
-                        <a:t>2.4.0</a:t>
+                        <a:t>2.5.0</a:t>
                       </a:r>
                     </a:p>
                   </a:txBody>
@@ -10479,7 +10571,7 @@
                           </a:solidFill>
                           <a:latin typeface="Segoe UI"/>
                         </a:rPr>
-                        <a:t>Chat, groups, affinity &amp; pet visits</a:t>
+                        <a:t>Shop, coins, props &amp; moves</a:t>
                       </a:r>
                     </a:p>
                     <a:p>
@@ -10490,7 +10582,7 @@
                           </a:solidFill>
                           <a:latin typeface="Segoe UI"/>
                         </a:rPr>
-                        <a:t>Chat: message your friends, and chat inside groups. Your pet pops up new messages as a bubble - click it to reply; Pet interactions: wave, pet their pet, send a snack, high five - or send your pet to visit: it walks onto your friend's desktop for a little while!; Affinity: every chat and interaction grows your friendship - Acquaintance → Buddy → Good friends → Close friends → Best friends → Soulmates; Your own groups: create a private group, invite your friends, they accept or decline. Group board + group chat; the owner can remove members</a:t>
+                        <a:t>Shop: earn coins and spend them on your pet - 17 props (crown, wizard hat, headphones, shades, scarf, cape, angel wings...) and 6 moves: spin, dance, moonwalk, backflip, kung fu and spider swing!; Coins come from leveling up (+40), badges (+25), opening Pips each day (+10), friendships (+15 per affinity level), waving / chatting / visiting friends (+2) and pomodoros (+5). Everyone starts with a 100-coin gift; Your friends see your props: on avatars in the hub and when your pet visits their desktop - it shows off one of your moves; Pips is now a social pet: clicking the pet opens the Pips hub (friends, chat, groups, shop, badges)</a:t>
                       </a:r>
                     </a:p>
                   </a:txBody>
@@ -10514,7 +10606,7 @@
                           </a:solidFill>
                           <a:latin typeface="Segoe UI"/>
                         </a:rPr>
-                        <a:t>2.3.0</a:t>
+                        <a:t>2.4.0</a:t>
                       </a:r>
                     </a:p>
                   </a:txBody>
@@ -10558,7 +10650,7 @@
                           </a:solidFill>
                           <a:latin typeface="Segoe UI"/>
                         </a:rPr>
-                        <a:t>Friends, levels &amp; achievements</a:t>
+                        <a:t>Chat, groups, affinity &amp; pet visits</a:t>
                       </a:r>
                     </a:p>
                     <a:p>
@@ -10569,7 +10661,7 @@
                           </a:solidFill>
                           <a:latin typeface="Segoe UI"/>
                         </a:rPr>
-                        <a:t>Levels &amp; XP: every finished pomodoro earns XP and your level grows - plus 20 achievements to unlock (first tomato, 8 in a day, 7-day streak, early bird, night owl, pet lover...). Your pet celebrates each one; Friends (optional, off by default): get a 6-letter friend code, add colleagues, see today's board and join a team board like PTB. Your pet tells you when a friend finishes a pomodoro; Privacy: only your name, pet, level, streak and pomodoro counts are shared - never apps, window titles or scores. One click turns it off and deletes your online data. Right-click the pet → Friends &amp; achievements…</a:t>
+                        <a:t>Chat: message your friends, and chat inside groups. Your pet pops up new messages as a bubble - click it to reply; Pet interactions: wave, pet their pet, send a snack, high five - or send your pet to visit: it walks onto your friend's desktop for a little while!; Affinity: every chat and interaction grows your friendship - Acquaintance → Buddy → Good friends → Close friends → Best friends → Soulmates; Your own groups: create a private group, invite your friends, they accept or decline. Group board + group chat; the owner can remove members</a:t>
                       </a:r>
                     </a:p>
                   </a:txBody>
@@ -10593,7 +10685,7 @@
                           </a:solidFill>
                           <a:latin typeface="Segoe UI"/>
                         </a:rPr>
-                        <a:t>2.2.0</a:t>
+                        <a:t>2.3.0</a:t>
                       </a:r>
                     </a:p>
                   </a:txBody>
@@ -10637,7 +10729,7 @@
                           </a:solidFill>
                           <a:latin typeface="Segoe UI"/>
                         </a:rPr>
-                        <a:t>Pet sounds</a:t>
+                        <a:t>Friends, levels &amp; achievements</a:t>
                       </a:r>
                     </a:p>
                     <a:p>
@@ -10648,7 +10740,7 @@
                           </a:solidFill>
                           <a:latin typeface="Segoe UI"/>
                         </a:rPr>
-                        <a:t>Your pet has a voice! Each of the 23 animals has its own sound (meow, woof, ribbit, hoot, buzz, oink, whale song...) and it changes with its mood: happy chirps, sad whimpers, sleepy yawns, hungry calls, grumpy huffs and soft snores; It also reacts with sound when you tickle, pet, feed, shake or wake it; Settings: right-click the pet → Sounds to switch on/off; Pet status &amp; settings has a volume slider, a ▶ Hear me button and "Stay quiet while I'm focusing" (on by default)</a:t>
+                        <a:t>Levels &amp; XP: every finished pomodoro earns XP and your level grows - plus 20 achievements to unlock (first tomato, 8 in a day, 7-day streak, early bird, night owl, pet lover...). Your pet celebrates each one; Friends (optional, off by default): get a 6-letter friend code, add colleagues, see today's board and join a team board like PTB. Your pet tells you when a friend finishes a pomodoro; Privacy: only your name, pet, level, streak and pomodoro counts are shared - never apps, window titles or scores. One click turns it off and deletes your online data. Right-click the pet → Friends &amp; achievements…</a:t>
                       </a:r>
                     </a:p>
                   </a:txBody>
@@ -10672,7 +10764,7 @@
                           </a:solidFill>
                           <a:latin typeface="Segoe UI"/>
                         </a:rPr>
-                        <a:t>2.1.2</a:t>
+                        <a:t>2.2.0</a:t>
                       </a:r>
                     </a:p>
                   </a:txBody>
@@ -10716,7 +10808,7 @@
                           </a:solidFill>
                           <a:latin typeface="Segoe UI"/>
                         </a:rPr>
-                        <a:t>Tickle-only mode</a:t>
+                        <a:t>Pet sounds</a:t>
                       </a:r>
                     </a:p>
                     <a:p>
@@ -10727,7 +10819,7 @@
                           </a:solidFill>
                           <a:latin typeface="Segoe UI"/>
                         </a:rPr>
-                        <a:t>New click option "Only tickle (never open Pips)": click and tickle your pet as much as you like - the Pomodoro window stays closed (open it from the right-click menu). Right-click the pet → When I click</a:t>
+                        <a:t>Your pet has a voice! Each of the 23 animals has its own sound (meow, woof, ribbit, hoot, buzz, oink, whale song...) and it changes with its mood: happy chirps, sad whimpers, sleepy yawns, hungry calls, grumpy huffs and soft snores; It also reacts with sound when you tickle, pet, feed, shake or wake it; Settings: right-click the pet → Sounds to switch on/off; Pet status &amp; settings has a volume slider, a ▶ Hear me button and "Stay quiet while I'm focusing" (on by default)</a:t>
                       </a:r>
                     </a:p>
                   </a:txBody>
@@ -10751,7 +10843,7 @@
                           </a:solidFill>
                           <a:latin typeface="Segoe UI"/>
                         </a:rPr>
-                        <a:t>2.1.1</a:t>
+                        <a:t>2.1.2</a:t>
                       </a:r>
                     </a:p>
                   </a:txBody>
@@ -10795,7 +10887,7 @@
                           </a:solidFill>
                           <a:latin typeface="Segoe UI"/>
                         </a:rPr>
-                        <a:t>Owner info</a:t>
+                        <a:t>Tickle-only mode</a:t>
                       </a:r>
                     </a:p>
                     <a:p>
@@ -10806,7 +10898,7 @@
                           </a:solidFill>
                           <a:latin typeface="Segoe UI"/>
                         </a:rPr>
-                        <a:t>About Pips now shows the owner: Juwen Lie (right-click the pet → Help → About)</a:t>
+                        <a:t>New click option "Only tickle (never open Pips)": click and tickle your pet as much as you like - the Pomodoro window stays closed (open it from the right-click menu). Right-click the pet → When I click</a:t>
                       </a:r>
                     </a:p>
                   </a:txBody>
@@ -10830,7 +10922,7 @@
                           </a:solidFill>
                           <a:latin typeface="Segoe UI"/>
                         </a:rPr>
-                        <a:t>2.1.0</a:t>
+                        <a:t>2.1.1</a:t>
                       </a:r>
                     </a:p>
                   </a:txBody>
@@ -10874,7 +10966,7 @@
                           </a:solidFill>
                           <a:latin typeface="Segoe UI"/>
                         </a:rPr>
-                        <a:t>Interactive guide &amp; in-app updates</a:t>
+                        <a:t>Owner info</a:t>
                       </a:r>
                     </a:p>
                     <a:p>
@@ -10885,7 +10977,7 @@
                           </a:solidFill>
                           <a:latin typeface="Segoe UI"/>
                         </a:rPr>
-                        <a:t>Interactive first-run guide: your pet walks you through clicking, dragging, petting and the right-click menu; In-app updates: Pips tells you when a new version is out - update with one click (your settings and data are kept); New Help menu: replay the guide, check for updates, see the version; Option to turn automatic update checks off</a:t>
+                        <a:t>About Pips now shows the owner: Juwen Lie (right-click the pet → Help → About)</a:t>
                       </a:r>
                     </a:p>
                   </a:txBody>
@@ -10909,7 +11001,7 @@
                           </a:solidFill>
                           <a:latin typeface="Segoe UI"/>
                         </a:rPr>
-                        <a:t>2.0.0</a:t>
+                        <a:t>2.1.0</a:t>
                       </a:r>
                     </a:p>
                   </a:txBody>
@@ -10953,7 +11045,7 @@
                           </a:solidFill>
                           <a:latin typeface="Segoe UI"/>
                         </a:rPr>
-                        <a:t>Desktop pet, 23 animals &amp; 4 languages</a:t>
+                        <a:t>Interactive guide &amp; in-app updates</a:t>
                       </a:r>
                     </a:p>
                     <a:p>
@@ -10964,7 +11056,7 @@
                           </a:solidFill>
                           <a:latin typeface="Segoe UI"/>
                         </a:rPr>
-                        <a:t>Desktop pet that lives on your desktop and taskbar - drag it, tickle it, pet it; 23 animals in 3 groups: Land walks, Water swims with bubbles, Sky hovers and flaps; Moods (happy, sad, tired, hungry, grumpy...), naps when you're away, wakes up when you're back; Cute chat-bubble reminders: breaks, water, 20-20-20 eye rest, pomodoro done, daily goal</a:t>
+                        <a:t>Interactive first-run guide: your pet walks you through clicking, dragging, petting and the right-click menu; In-app updates: Pips tells you when a new version is out - update with one click (your settings and data are kept); New Help menu: replay the guide, check for updates, see the version; Option to turn automatic update checks off</a:t>
                       </a:r>
                     </a:p>
                   </a:txBody>
@@ -10988,7 +11080,7 @@
                           </a:solidFill>
                           <a:latin typeface="Segoe UI"/>
                         </a:rPr>
-                        <a:t>1.5.0</a:t>
+                        <a:t>2.0.0</a:t>
                       </a:r>
                     </a:p>
                   </a:txBody>
@@ -11010,7 +11102,7 @@
                           </a:solidFill>
                           <a:latin typeface="Segoe UI"/>
                         </a:rPr>
-                        <a:t>2026-10-24</a:t>
+                        <a:t>2026-10-28</a:t>
                       </a:r>
                     </a:p>
                   </a:txBody>
@@ -11032,7 +11124,7 @@
                           </a:solidFill>
                           <a:latin typeface="Segoe UI"/>
                         </a:rPr>
-                        <a:t>Renamed to Pips + insights</a:t>
+                        <a:t>Desktop pet, 23 animals &amp; 4 languages</a:t>
                       </a:r>
                     </a:p>
                     <a:p>
@@ -11043,7 +11135,7 @@
                           </a:solidFill>
                           <a:latin typeface="Segoe UI"/>
                         </a:rPr>
-                        <a:t>Renamed from Productivity Widget to Pips; Dashboard charts: focus timeline, hour heatmap, 7-day score trend, pomodoros per day; AI token usage on the card and dashboard; Daily diary export and weekly / monthly reports</a:t>
+                        <a:t>Desktop pet that lives on your desktop and taskbar - drag it, tickle it, pet it; 23 animals in 3 groups: Land walks, Water swims with bubbles, Sky hovers and flaps; Moods (happy, sad, tired, hungry, grumpy...), naps when you're away, wakes up when you're back; Cute chat-bubble reminders: breaks, water, 20-20-20 eye rest, pomodoro done, daily goal</a:t>
                       </a:r>
                     </a:p>
                   </a:txBody>
@@ -11067,7 +11159,7 @@
                           </a:solidFill>
                           <a:latin typeface="Segoe UI"/>
                         </a:rPr>
-                        <a:t>1.0.0</a:t>
+                        <a:t>1.5.0</a:t>
                       </a:r>
                     </a:p>
                   </a:txBody>
@@ -11089,7 +11181,7 @@
                           </a:solidFill>
                           <a:latin typeface="Segoe UI"/>
                         </a:rPr>
-                        <a:t>2026-10-21</a:t>
+                        <a:t>2026-10-24</a:t>
                       </a:r>
                     </a:p>
                   </a:txBody>
@@ -11111,7 +11203,7 @@
                           </a:solidFill>
                           <a:latin typeface="Segoe UI"/>
                         </a:rPr>
-                        <a:t>First release</a:t>
+                        <a:t>Renamed to Pips + insights</a:t>
                       </a:r>
                     </a:p>
                     <a:p>
@@ -11122,13 +11214,92 @@
                           </a:solidFill>
                           <a:latin typeface="Segoe UI"/>
                         </a:rPr>
-                        <a:t>Always-on-top Pomodoro card with progress ring; Rain / thunder / brown-noise / cafe soundscapes; Live app-usage tracking and a daily 1-5 star focus score; Goals, streaks, XP, coach tips and break reminders</a:t>
+                        <a:t>Renamed from Productivity Widget to Pips; Dashboard charts: focus timeline, hour heatmap, 7-day score trend, pomodoros per day; AI token usage on the card and dashboard; Daily diary export and weekly / monthly reports</a:t>
                       </a:r>
                     </a:p>
                   </a:txBody>
                   <a:tcPr marL="73152" marR="73152" marT="36576" marB="36576">
                     <a:solidFill>
                       <a:srgbClr val="F7F4EC"/>
+                    </a:solidFill>
+                  </a:tcPr>
+                </a:tc>
+              </a:tr>
+              <a:tr h="822960">
+                <a:tc>
+                  <a:txBody>
+                    <a:bodyPr wrap="square"/>
+                    <a:lstStyle/>
+                    <a:p>
+                      <a:r>
+                        <a:rPr sz="1200" b="1">
+                          <a:solidFill>
+                            <a:srgbClr val="2B2A28"/>
+                          </a:solidFill>
+                          <a:latin typeface="Segoe UI"/>
+                        </a:rPr>
+                        <a:t>1.0.0</a:t>
+                      </a:r>
+                    </a:p>
+                  </a:txBody>
+                  <a:tcPr marL="73152" marR="73152" marT="36576" marB="36576">
+                    <a:solidFill>
+                      <a:srgbClr val="FFFDF8"/>
+                    </a:solidFill>
+                  </a:tcPr>
+                </a:tc>
+                <a:tc>
+                  <a:txBody>
+                    <a:bodyPr wrap="square"/>
+                    <a:lstStyle/>
+                    <a:p>
+                      <a:r>
+                        <a:rPr sz="1200" b="0">
+                          <a:solidFill>
+                            <a:srgbClr val="2B2A28"/>
+                          </a:solidFill>
+                          <a:latin typeface="Segoe UI"/>
+                        </a:rPr>
+                        <a:t>2026-10-21</a:t>
+                      </a:r>
+                    </a:p>
+                  </a:txBody>
+                  <a:tcPr marL="73152" marR="73152" marT="36576" marB="36576">
+                    <a:solidFill>
+                      <a:srgbClr val="FFFDF8"/>
+                    </a:solidFill>
+                  </a:tcPr>
+                </a:tc>
+                <a:tc>
+                  <a:txBody>
+                    <a:bodyPr wrap="square"/>
+                    <a:lstStyle/>
+                    <a:p>
+                      <a:r>
+                        <a:rPr sz="1200" b="0">
+                          <a:solidFill>
+                            <a:srgbClr val="2B2A28"/>
+                          </a:solidFill>
+                          <a:latin typeface="Segoe UI"/>
+                        </a:rPr>
+                        <a:t>First release</a:t>
+                      </a:r>
+                    </a:p>
+                    <a:p>
+                      <a:r>
+                        <a:rPr sz="1200" b="0">
+                          <a:solidFill>
+                            <a:srgbClr val="2B2A28"/>
+                          </a:solidFill>
+                          <a:latin typeface="Segoe UI"/>
+                        </a:rPr>
+                        <a:t>Always-on-top Pomodoro card with progress ring; Rain / thunder / brown-noise / cafe soundscapes; Live app-usage tracking and a daily 1-5 star focus score; Goals, streaks, XP, coach tips and break reminders</a:t>
+                      </a:r>
+                    </a:p>
+                  </a:txBody>
+                  <a:tcPr marL="73152" marR="73152" marT="36576" marB="36576">
+                    <a:solidFill>
+                      <a:srgbClr val="FFFDF8"/>
                     </a:solidFill>
                   </a:tcPr>
                 </a:tc>

</xml_diff>

<commit_message>
pips 2.19.0: Land, sea & sky
</commit_message>
<xml_diff>
--- a/apps/pips/web/download/Pips-Guide.pptx
+++ b/apps/pips/web/download/Pips-Guide.pptx
@@ -3292,7 +3292,7 @@
                 </a:solidFill>
                 <a:latin typeface="Segoe UI"/>
               </a:rPr>
-              <a:t>Version 2.18.0  ·  2026-10-29  ·  Made by Juwen Lie (owner)</a:t>
+              <a:t>Version 2.19.0  ·  2026-10-29  ·  Made by Juwen Lie (owner)</a:t>
             </a:r>
           </a:p>
           <a:p>
@@ -5894,32 +5894,7 @@
                 </a:solidFill>
                 <a:latin typeface="Segoe UI"/>
               </a:rPr>
-              <a:t>Walk around on the taskbar</a:t>
-            </a:r>
-          </a:p>
-          <a:p>
-            <a:pPr>
-              <a:spcAft>
-                <a:spcPts val="300"/>
-              </a:spcAft>
-            </a:pPr>
-            <a:r>
-              <a:rPr sz="1400" b="1">
-                <a:solidFill>
-                  <a:srgbClr val="4CB86B"/>
-                </a:solidFill>
-                <a:latin typeface="Segoe UI"/>
-              </a:rPr>
-              <a:t>•  </a:t>
-            </a:r>
-            <a:r>
-              <a:rPr sz="1400">
-                <a:solidFill>
-                  <a:srgbClr val="2B2A28"/>
-                </a:solidFill>
-                <a:latin typeface="Segoe UI"/>
-              </a:rPr>
-              <a:t>Gravity (falls when dropped)</a:t>
+              <a:t>Move around by myself (walk on windows / swim &amp; splash / fly)</a:t>
             </a:r>
           </a:p>
           <a:p>
@@ -7706,7 +7681,7 @@
                   </a:tcPr>
                 </a:tc>
               </a:tr>
-              <a:tr h="457200">
+              <a:tr h="411480">
                 <a:tc>
                   <a:txBody>
                     <a:bodyPr wrap="square"/>
@@ -7752,7 +7727,7 @@
                   </a:tcPr>
                 </a:tc>
               </a:tr>
-              <a:tr h="457200">
+              <a:tr h="411480">
                 <a:tc>
                   <a:txBody>
                     <a:bodyPr wrap="square"/>
@@ -7798,7 +7773,7 @@
                   </a:tcPr>
                 </a:tc>
               </a:tr>
-              <a:tr h="457200">
+              <a:tr h="411480">
                 <a:tc>
                   <a:txBody>
                     <a:bodyPr wrap="square"/>
@@ -7844,7 +7819,7 @@
                   </a:tcPr>
                 </a:tc>
               </a:tr>
-              <a:tr h="457200">
+              <a:tr h="411480">
                 <a:tc>
                   <a:txBody>
                     <a:bodyPr wrap="square"/>
@@ -7890,7 +7865,7 @@
                   </a:tcPr>
                 </a:tc>
               </a:tr>
-              <a:tr h="457200">
+              <a:tr h="411480">
                 <a:tc>
                   <a:txBody>
                     <a:bodyPr wrap="square"/>
@@ -7936,7 +7911,7 @@
                   </a:tcPr>
                 </a:tc>
               </a:tr>
-              <a:tr h="457200">
+              <a:tr h="411480">
                 <a:tc>
                   <a:txBody>
                     <a:bodyPr wrap="square"/>
@@ -7949,7 +7924,7 @@
                           </a:solidFill>
                           <a:latin typeface="Segoe UI"/>
                         </a:rPr>
-                        <a:t>The focus card is gone</a:t>
+                        <a:t>My pet is up on a window / flying</a:t>
                       </a:r>
                     </a:p>
                   </a:txBody>
@@ -7971,7 +7946,7 @@
                           </a:solidFill>
                           <a:latin typeface="Segoe UI"/>
                         </a:rPr>
-                        <a:t>Right-click the pet → Focus timer → Open. Or restart Pips.</a:t>
+                        <a:t>Land animals walk on window tops, flyers fly anywhere. Right-click → Go to the taskbar / Rest on the taskbar, or turn off "Move around by myself" in Pet settings.</a:t>
                       </a:r>
                     </a:p>
                   </a:txBody>
@@ -7982,7 +7957,7 @@
                   </a:tcPr>
                 </a:tc>
               </a:tr>
-              <a:tr h="457200">
+              <a:tr h="411480">
                 <a:tc>
                   <a:txBody>
                     <a:bodyPr wrap="square"/>
@@ -7995,7 +7970,7 @@
                           </a:solidFill>
                           <a:latin typeface="Segoe UI"/>
                         </a:rPr>
-                        <a:t>Update failed</a:t>
+                        <a:t>The focus card is gone</a:t>
                       </a:r>
                     </a:p>
                   </a:txBody>
@@ -8017,7 +7992,7 @@
                           </a:solidFill>
                           <a:latin typeface="Segoe UI"/>
                         </a:rPr>
-                        <a:t>Try Help → Check for updates later. Installed users can quit Pips and rerun setup; ZIP users should keep their original folder.</a:t>
+                        <a:t>Right-click the pet → Focus timer → Open. Or restart Pips.</a:t>
                       </a:r>
                     </a:p>
                   </a:txBody>
@@ -8028,7 +8003,7 @@
                   </a:tcPr>
                 </a:tc>
               </a:tr>
-              <a:tr h="457200">
+              <a:tr h="411480">
                 <a:tc>
                   <a:txBody>
                     <a:bodyPr wrap="square"/>
@@ -8041,7 +8016,7 @@
                           </a:solidFill>
                           <a:latin typeface="Segoe UI"/>
                         </a:rPr>
-                        <a:t>Where are my settings?</a:t>
+                        <a:t>Update failed</a:t>
                       </a:r>
                     </a:p>
                   </a:txBody>
@@ -8063,7 +8038,7 @@
                           </a:solidFill>
                           <a:latin typeface="Segoe UI"/>
                         </a:rPr>
-                        <a:t>Installed app: %LOCALAPPDATA%\Programs\Pips. config.json and data\ hold your profile and progress; back them up before moving.</a:t>
+                        <a:t>Try Help → Check for updates later. Installed users can quit Pips and rerun setup; ZIP users should keep their original folder.</a:t>
                       </a:r>
                     </a:p>
                   </a:txBody>
@@ -8074,7 +8049,7 @@
                   </a:tcPr>
                 </a:tc>
               </a:tr>
-              <a:tr h="457200">
+              <a:tr h="411480">
                 <a:tc>
                   <a:txBody>
                     <a:bodyPr wrap="square"/>
@@ -8087,7 +8062,7 @@
                           </a:solidFill>
                           <a:latin typeface="Segoe UI"/>
                         </a:rPr>
-                        <a:t>Uninstall</a:t>
+                        <a:t>Where are my settings?</a:t>
                       </a:r>
                     </a:p>
                   </a:txBody>
@@ -8109,13 +8084,59 @@
                           </a:solidFill>
                           <a:latin typeface="Segoe UI"/>
                         </a:rPr>
-                        <a:t>Quit Pips, then Windows Settings → Apps → Pips → Uninstall. Settings and progress are left in place for a later reinstall.</a:t>
+                        <a:t>Installed app: %LOCALAPPDATA%\Programs\Pips. config.json and data\ hold your profile and progress; back them up before moving.</a:t>
                       </a:r>
                     </a:p>
                   </a:txBody>
                   <a:tcPr marL="73152" marR="73152" marT="36576" marB="36576">
                     <a:solidFill>
                       <a:srgbClr val="FFFDF8"/>
+                    </a:solidFill>
+                  </a:tcPr>
+                </a:tc>
+              </a:tr>
+              <a:tr h="411480">
+                <a:tc>
+                  <a:txBody>
+                    <a:bodyPr wrap="square"/>
+                    <a:lstStyle/>
+                    <a:p>
+                      <a:r>
+                        <a:rPr sz="1200" b="1">
+                          <a:solidFill>
+                            <a:srgbClr val="2B2A28"/>
+                          </a:solidFill>
+                          <a:latin typeface="Segoe UI"/>
+                        </a:rPr>
+                        <a:t>Uninstall</a:t>
+                      </a:r>
+                    </a:p>
+                  </a:txBody>
+                  <a:tcPr marL="73152" marR="73152" marT="36576" marB="36576">
+                    <a:solidFill>
+                      <a:srgbClr val="F7F4EC"/>
+                    </a:solidFill>
+                  </a:tcPr>
+                </a:tc>
+                <a:tc>
+                  <a:txBody>
+                    <a:bodyPr wrap="square"/>
+                    <a:lstStyle/>
+                    <a:p>
+                      <a:r>
+                        <a:rPr sz="1200" b="0">
+                          <a:solidFill>
+                            <a:srgbClr val="2B2A28"/>
+                          </a:solidFill>
+                          <a:latin typeface="Segoe UI"/>
+                        </a:rPr>
+                        <a:t>Quit Pips, then Windows Settings → Apps → Pips → Uninstall. Settings and progress are left in place for a later reinstall.</a:t>
+                      </a:r>
+                    </a:p>
+                  </a:txBody>
+                  <a:tcPr marL="73152" marR="73152" marT="36576" marB="36576">
+                    <a:solidFill>
+                      <a:srgbClr val="F7F4EC"/>
                     </a:solidFill>
                   </a:tcPr>
                 </a:tc>
@@ -8258,7 +8279,7 @@
                 </a:solidFill>
                 <a:latin typeface="Segoe UI"/>
               </a:rPr>
-              <a:t>What's new in 2.18.0</a:t>
+              <a:t>What's new in 2.19.0</a:t>
             </a:r>
           </a:p>
         </p:txBody>
@@ -8371,7 +8392,7 @@
                 </a:solidFill>
                 <a:latin typeface="Segoe UI"/>
               </a:rPr>
-              <a:t>Raise your pet  ·  2026-10-29</a:t>
+              <a:t>Land, sea &amp; sky  ·  2026-10-29</a:t>
             </a:r>
           </a:p>
         </p:txBody>
@@ -8419,7 +8440,7 @@
                 </a:solidFill>
                 <a:latin typeface="Segoe UI"/>
               </a:rPr>
-              <a:t>Boy or girl? Pick your pet's gender in Settings: boys get a little hair tuft, girls a pink bow and eyelashes, and a ♂ / ♀ shows next to its name. You can add your own gender to your profile too - friends see a small ♂ / ♀ next to your name.</a:t>
+              <a:t>Land animals walk on the taskbar and on top of your open windows now: they jump up onto window edges, walk along them, ride along when you move the window and hop down when it closes, gets covered or is maximised. They always have gravity - let go of one in mid-air and it lands on the window below or on the taskbar.</a:t>
             </a:r>
           </a:p>
           <a:p>
@@ -8444,7 +8465,7 @@
                 </a:solidFill>
                 <a:latin typeface="Segoe UI"/>
               </a:rPr>
-              <a:t>Pets grow up now: baby → child → teen → grown-up. Focus sessions, opening Pips each day, games and cuddles help them grow - no care mistakes, no bad endings. Already have a grown-up pet? It will ask whether you'd like to raise it again from a baby (coins, items and stats stay).</a:t>
+              <a:t>Water animals swim along the taskbar (their water) and every now and then leap high out of it in a big arc, diving back in with a splash, ripples and spray. Drop one anywhere and it dives back into the water.</a:t>
             </a:r>
           </a:p>
           <a:p>
@@ -8469,7 +8490,7 @@
                 </a:solidFill>
                 <a:latin typeface="Segoe UI"/>
               </a:rPr>
-              <a:t>Sick days: work 2.5 hours without a 5-minute break and your pet catches a little cold (sneezes, thermometer, slow steps). A short break cures it - or give medicine from the menu. You can turn this off in Settings.</a:t>
+              <a:t>Flying animals fly anywhere on the screen: they flutter from place to place, hover, come say hi near your mouse, and sometimes perch on the taskbar or a window edge for a rest. Point at one and it waits for you; they glide down to a perch before a nap.</a:t>
             </a:r>
           </a:p>
           <a:p>
@@ -8494,7 +8515,7 @@
                 </a:solidFill>
                 <a:latin typeface="Segoe UI"/>
               </a:rPr>
-              <a:t>New mini-game Left or Right? (pet menu → Play): guess which way your pet will look - 3 out of 5 wins, with coins for your first wins each day.</a:t>
+              <a:t>New menu moves: Jump onto a window, Splash jump!, Fly around / Rest on the taskbar. "Move around by myself" in Pet settings keeps your pet still if you prefer (the old Gravity option is gone - land animals always fall now).</a:t>
             </a:r>
           </a:p>
         </p:txBody>
@@ -8625,7 +8646,7 @@
                 </a:solidFill>
                 <a:latin typeface="Segoe UI"/>
               </a:rPr>
-              <a:t>Jantan atau betina? Pilih jenis kelamin pet di Pengaturan: jantan punya jambul rambut kecil, betina pita pink dan bulu mata, dan ♂ / ♀ muncul di samping namanya. Kamu juga bisa menambahkan jenis kelaminmu di profil - teman melihat ♂ / ♀ kecil di samping namamu.</a:t>
+              <a:t>Hewan darat sekarang berjalan di taskbar dan di atas jendela yang terbuka: mereka melompat ke tepi jendela, berjalan di atasnya, ikut bergerak saat jendela dipindahkan, dan turun saat jendela ditutup, tertutup, atau dimaksimalkan. Mereka selalu punya gravitasi - lepaskan di udara dan ia mendarat di jendela di bawahnya atau di taskbar.</a:t>
             </a:r>
           </a:p>
           <a:p>
@@ -8650,7 +8671,7 @@
                 </a:solidFill>
                 <a:latin typeface="Segoe UI"/>
               </a:rPr>
-              <a:t>Pet kini bisa tumbuh: bayi → anak → remaja → dewasa. Sesi fokus, membuka Pips setiap hari, permainan, dan pelukan membantunya tumbuh - tanpa kesalahan perawatan, tanpa akhir yang buruk. Pet-mu sudah dewasa? Ia akan bertanya apakah kamu mau membesarkannya lagi dari bayi (koin, item, dan statistik tetap).</a:t>
+              <a:t>Hewan air berenang di taskbar (airnya) dan sesekali melompat tinggi membentuk lengkungan besar, lalu menyelam kembali dengan cipratan, riak, dan percikan. Lepaskan di mana saja dan ia menyelam kembali ke air.</a:t>
             </a:r>
           </a:p>
           <a:p>
@@ -8675,7 +8696,7 @@
                 </a:solidFill>
                 <a:latin typeface="Segoe UI"/>
               </a:rPr>
-              <a:t>Hari sakit: bekerja 2,5 jam tanpa istirahat 5 menit dan pet-mu masuk angin (bersin, termometer, langkah pelan). Istirahat sebentar menyembuhkannya - atau beri obat dari menu. Bisa dimatikan di Pengaturan.</a:t>
+              <a:t>Hewan terbang bisa terbang ke mana saja di layar: berpindah-pindah, melayang, menyapa di dekat mouse-mu, dan kadang hinggap di taskbar atau tepi jendela untuk istirahat. Arahkan mouse ke atasnya dan ia menunggu; sebelum tidur ia turun ke tempat hinggap.</a:t>
             </a:r>
           </a:p>
           <a:p>
@@ -8700,7 +8721,7 @@
                 </a:solidFill>
                 <a:latin typeface="Segoe UI"/>
               </a:rPr>
-              <a:t>Mini-game baru Kiri atau Kanan? (menu pet → Main): tebak ke mana pet-mu akan menoleh - 3 dari 5 menang, dengan koin untuk kemenangan pertama setiap hari.</a:t>
+              <a:t>Gerakan baru di menu: Lompat ke atas jendela, Lompat cipratan!, Terbang berkeliling / Istirahat di taskbar. "Bergerak sendiri" di Pengaturan pet membuat pet diam jika kamu mau (opsi Gravitasi lama dihapus - hewan darat sekarang selalu jatuh).</a:t>
             </a:r>
           </a:p>
         </p:txBody>
@@ -8932,7 +8953,7 @@
         </p:nvGraphicFramePr>
         <p:xfrm>
           <a:off x="548640" y="1645920"/>
-          <a:ext cx="11155680" cy="24249888"/>
+          <a:ext cx="11155680" cy="25072848"/>
         </p:xfrm>
         <a:graphic>
           <a:graphicData uri="http://schemas.openxmlformats.org/drawingml/2006/table">
@@ -9026,7 +9047,7 @@
                           </a:solidFill>
                           <a:latin typeface="Segoe UI"/>
                         </a:rPr>
-                        <a:t>2.18.0</a:t>
+                        <a:t>2.19.0</a:t>
                       </a:r>
                     </a:p>
                   </a:txBody>
@@ -9070,7 +9091,7 @@
                           </a:solidFill>
                           <a:latin typeface="Segoe UI"/>
                         </a:rPr>
-                        <a:t>Raise your pet</a:t>
+                        <a:t>Land, sea &amp; sky</a:t>
                       </a:r>
                     </a:p>
                     <a:p>
@@ -9081,7 +9102,7 @@
                           </a:solidFill>
                           <a:latin typeface="Segoe UI"/>
                         </a:rPr>
-                        <a:t>Boy or girl? Pick your pet's gender in Settings: boys get a little hair tuft, girls a pink bow and eyelashes, and a ♂ / ♀ shows next to its name. You can add your own gender to your profile too - friends see a small ♂ / ♀ next to your name.; Pets grow up now: baby → child → teen → grown-up. Focus sessions, opening Pips each day, games and cuddles help them grow - no care mistakes, no bad endings. Already have a grown-up pet? It will ask whether you'd like to raise it again from a baby (coins, items and stats stay).; Sick days: work 2.5 hours without a 5-minute break and your pet catches a little cold (sneezes, thermometer, slow steps). A short break cures it - or give medicine from the menu. You can turn this off in Settings.; New mini-game Left or Right? (pet menu → Play): guess which way your pet will look - 3 out of 5 wins, with coins for your first wins each day.</a:t>
+                        <a:t>Land animals walk on the taskbar and on top of your open windows now: they jump up onto window edges, walk along them, ride along when you move the window and hop down when it closes, gets covered or is maximised. They always have gravity - let go of one in mid-air and it lands on the window below or on the taskbar.; Water animals swim along the taskbar (their water) and every now and then leap high out of it in a big arc, diving back in with a splash, ripples and spray. Drop one anywhere and it dives back into the water.; Flying animals fly anywhere on the screen: they flutter from place to place, hover, come say hi near your mouse, and sometimes perch on the taskbar or a window edge for a rest. Point at one and it waits for you; they glide down to a perch before a nap.; New menu moves: Jump onto a window, Splash jump!, Fly around / Rest on the taskbar. "Move around by myself" in Pet settings keeps your pet still if you prefer (the old Gravity option is gone - land animals always fall now).</a:t>
                       </a:r>
                     </a:p>
                   </a:txBody>
@@ -9105,7 +9126,7 @@
                           </a:solidFill>
                           <a:latin typeface="Segoe UI"/>
                         </a:rPr>
-                        <a:t>2.17.0</a:t>
+                        <a:t>2.18.0</a:t>
                       </a:r>
                     </a:p>
                   </a:txBody>
@@ -9149,7 +9170,7 @@
                           </a:solidFill>
                           <a:latin typeface="Segoe UI"/>
                         </a:rPr>
-                        <a:t>Find your pet anytime</a:t>
+                        <a:t>Raise your pet</a:t>
                       </a:r>
                     </a:p>
                     <a:p>
@@ -9160,7 +9181,7 @@
                           </a:solidFill>
                           <a:latin typeface="Segoe UI"/>
                         </a:rPr>
-                        <a:t>Pips now has an icon next to the clock: click it to bring your pet back; right-click for the focus timer, Friends &amp; chat or Quit.; Press Ctrl+Alt+P anywhere to call your pet - it pops up on the screen you're using, even if it was hidden, asleep or behind a fullscreen app.; Opening Pips again from the Start menu or desktop does the same, and your pet walks back by itself if it ever ends up off-screen (e.g. after unplugging a monitor).; Hiding your pet now tells you how to bring it back.</a:t>
+                        <a:t>Boy or girl? Pick your pet's gender in Settings: boys get a little hair tuft, girls a pink bow and eyelashes, and a ♂ / ♀ shows next to its name. You can add your own gender to your profile too - friends see a small ♂ / ♀ next to your name.; Pets grow up now: baby → child → teen → grown-up. Focus sessions, opening Pips each day, games and cuddles help them grow - no care mistakes, no bad endings. Already have a grown-up pet? It will ask whether you'd like to raise it again from a baby (coins, items and stats stay).; Sick days: work 2.5 hours without a 5-minute break and your pet catches a little cold (sneezes, thermometer, slow steps). A short break cures it - or give medicine from the menu. You can turn this off in Settings.; New mini-game Left or Right? (pet menu → Play): guess which way your pet will look - 3 out of 5 wins, with coins for your first wins each day.</a:t>
                       </a:r>
                     </a:p>
                   </a:txBody>
@@ -9184,7 +9205,7 @@
                           </a:solidFill>
                           <a:latin typeface="Segoe UI"/>
                         </a:rPr>
-                        <a:t>2.16.0</a:t>
+                        <a:t>2.17.0</a:t>
                       </a:r>
                     </a:p>
                   </a:txBody>
@@ -9228,7 +9249,7 @@
                           </a:solidFill>
                           <a:latin typeface="Segoe UI"/>
                         </a:rPr>
-                        <a:t>Pips Community</a:t>
+                        <a:t>Find your pet anytime</a:t>
                       </a:r>
                     </a:p>
                     <a:p>
@@ -9239,7 +9260,7 @@
                           </a:solidFill>
                           <a:latin typeface="Segoe UI"/>
                         </a:rPr>
-                        <a:t>New Pips Community at the top of the Chat tab: a #general channel to chat with everyone who uses Pips, plus #announcements with news from the Pips team.; Every new Pips version is announced there automatically - see what's new and update with one click.; Type @name to ping someone in #general. Mute #general any time; owner and moderators can remove messages.; Open it from your pet's menu too (Pips Community). Fixed: chats no longer clear what you're typing when Pips refreshes in the background.</a:t>
+                        <a:t>Pips now has an icon next to the clock: click it to bring your pet back; right-click for the focus timer, Friends &amp; chat or Quit.; Press Ctrl+Alt+P anywhere to call your pet - it pops up on the screen you're using, even if it was hidden, asleep or behind a fullscreen app.; Opening Pips again from the Start menu or desktop does the same, and your pet walks back by itself if it ever ends up off-screen (e.g. after unplugging a monitor).; Hiding your pet now tells you how to bring it back.</a:t>
                       </a:r>
                     </a:p>
                   </a:txBody>
@@ -9263,7 +9284,7 @@
                           </a:solidFill>
                           <a:latin typeface="Segoe UI"/>
                         </a:rPr>
-                        <a:t>2.15.0</a:t>
+                        <a:t>2.16.0</a:t>
                       </a:r>
                     </a:p>
                   </a:txBody>
@@ -9307,7 +9328,7 @@
                           </a:solidFill>
                           <a:latin typeface="Segoe UI"/>
                         </a:rPr>
-                        <a:t>Update reminders</a:t>
+                        <a:t>Pips Community</a:t>
                       </a:r>
                     </a:p>
                     <a:p>
@@ -9318,7 +9339,7 @@
                           </a:solidFill>
                           <a:latin typeface="Segoe UI"/>
                         </a:rPr>
-                        <a:t>Owner &amp; moderators: the Mod tab now lists who hasn't updated Pips yet (their version and when they were last seen), with one-click reminders by e-mail (sent from your Outlook) or a ready-to-send Teams chat.; New Work e-mail field in your Profile, filled in from Outlook. Only the owner and moderators can see it (for update reminders and support) - clear it to hide it.; Pips now tells the Friends server which version it runs, so the update list is always accurate.; Friends keeps working when a local proxy tool stops answering - Pips falls back to the Windows proxy settings.</a:t>
+                        <a:t>New Pips Community at the top of the Chat tab: a #general channel to chat with everyone who uses Pips, plus #announcements with news from the Pips team.; Every new Pips version is announced there automatically - see what's new and update with one click.; Type @name to ping someone in #general. Mute #general any time; owner and moderators can remove messages.; Open it from your pet's menu too (Pips Community). Fixed: chats no longer clear what you're typing when Pips refreshes in the background.</a:t>
                       </a:r>
                     </a:p>
                   </a:txBody>
@@ -9342,7 +9363,7 @@
                           </a:solidFill>
                           <a:latin typeface="Segoe UI"/>
                         </a:rPr>
-                        <a:t>2.14.3</a:t>
+                        <a:t>2.15.0</a:t>
                       </a:r>
                     </a:p>
                   </a:txBody>
@@ -9386,7 +9407,7 @@
                           </a:solidFill>
                           <a:latin typeface="Segoe UI"/>
                         </a:rPr>
-                        <a:t>Tidy menus</a:t>
+                        <a:t>Update reminders</a:t>
                       </a:r>
                     </a:p>
                     <a:p>
@@ -9397,7 +9418,7 @@
                           </a:solidFill>
                           <a:latin typeface="Segoe UI"/>
                         </a:rPr>
-                        <a:t>Fixed: a submenu (e.g. Poke a friend) could stay floating on the screen after the right-click menu closed.; Menus now close by themselves when you move the mouse away and leave them for a few seconds.</a:t>
+                        <a:t>Owner &amp; moderators: the Mod tab now lists who hasn't updated Pips yet (their version and when they were last seen), with one-click reminders by e-mail (sent from your Outlook) or a ready-to-send Teams chat.; New Work e-mail field in your Profile, filled in from Outlook. Only the owner and moderators can see it (for update reminders and support) - clear it to hide it.; Pips now tells the Friends server which version it runs, so the update list is always accurate.; Friends keeps working when a local proxy tool stops answering - Pips falls back to the Windows proxy settings.</a:t>
                       </a:r>
                     </a:p>
                   </a:txBody>
@@ -9421,7 +9442,7 @@
                           </a:solidFill>
                           <a:latin typeface="Segoe UI"/>
                         </a:rPr>
-                        <a:t>2.14.2</a:t>
+                        <a:t>2.14.3</a:t>
                       </a:r>
                     </a:p>
                   </a:txBody>
@@ -9465,7 +9486,7 @@
                           </a:solidFill>
                           <a:latin typeface="Segoe UI"/>
                         </a:rPr>
-                        <a:t>Never miss an update</a:t>
+                        <a:t>Tidy menus</a:t>
                       </a:r>
                     </a:p>
                     <a:p>
@@ -9476,7 +9497,7 @@
                           </a:solidFill>
                           <a:latin typeface="Segoe UI"/>
                         </a:rPr>
-                        <a:t>Your pet now reminds you every 2 hours while a new version is waiting (instead of every 6 hours).; If the reminder can't show (fullscreen app, guided tour, another message), your pet tries again a few minutes later.; No internet when Pips starts (e.g. VPN off)? It checks again after an hour.</a:t>
+                        <a:t>Fixed: a submenu (e.g. Poke a friend) could stay floating on the screen after the right-click menu closed.; Menus now close by themselves when you move the mouse away and leave them for a few seconds.</a:t>
                       </a:r>
                     </a:p>
                   </a:txBody>
@@ -9500,7 +9521,7 @@
                           </a:solidFill>
                           <a:latin typeface="Segoe UI"/>
                         </a:rPr>
-                        <a:t>2.14.1</a:t>
+                        <a:t>2.14.2</a:t>
                       </a:r>
                     </a:p>
                   </a:txBody>
@@ -9544,7 +9565,7 @@
                           </a:solidFill>
                           <a:latin typeface="Segoe UI"/>
                         </a:rPr>
-                        <a:t>One pet at a time</a:t>
+                        <a:t>Never miss an update</a:t>
                       </a:r>
                     </a:p>
                     <a:p>
@@ -9555,7 +9576,7 @@
                           </a:solidFill>
                           <a:latin typeface="Segoe UI"/>
                         </a:rPr>
-                        <a:t>Opening Pips again (Desktop / Start Menu shortcut, autostart) no longer starts a second pet - your pet just pops up and says hi.; Fixes lag caused by two copies of Pips running at once.</a:t>
+                        <a:t>Your pet now reminds you every 2 hours while a new version is waiting (instead of every 6 hours).; If the reminder can't show (fullscreen app, guided tour, another message), your pet tries again a few minutes later.; No internet when Pips starts (e.g. VPN off)? It checks again after an hour.</a:t>
                       </a:r>
                     </a:p>
                   </a:txBody>
@@ -9579,7 +9600,7 @@
                           </a:solidFill>
                           <a:latin typeface="Segoe UI"/>
                         </a:rPr>
-                        <a:t>2.14.0</a:t>
+                        <a:t>2.14.1</a:t>
                       </a:r>
                     </a:p>
                   </a:txBody>
@@ -9623,7 +9644,7 @@
                           </a:solidFill>
                           <a:latin typeface="Segoe UI"/>
                         </a:rPr>
-                        <a:t>Pokes, tickles &amp; teases</a:t>
+                        <a:t>One pet at a time</a:t>
                       </a:r>
                     </a:p>
                     <a:p>
@@ -9634,7 +9655,7 @@
                           </a:solidFill>
                           <a:latin typeface="Segoe UI"/>
                         </a:rPr>
-                        <a:t>Poke, tickle, tease, boop or hug a friend from afar - no pet visit needed.; Right-click your pet → Poke a friend, or use the Poke button in Friends, chat and profiles.; Your friend gets a pop-up ("Wendy is teasing you!"), their pet reacts, and they can poke back with one click.; During a focus session pokes wait quietly until your break; when your pet is hidden they show in the screen corner.</a:t>
+                        <a:t>Opening Pips again (Desktop / Start Menu shortcut, autostart) no longer starts a second pet - your pet just pops up and says hi.; Fixes lag caused by two copies of Pips running at once.</a:t>
                       </a:r>
                     </a:p>
                   </a:txBody>
@@ -9658,7 +9679,7 @@
                           </a:solidFill>
                           <a:latin typeface="Segoe UI"/>
                         </a:rPr>
-                        <a:t>2.13.1</a:t>
+                        <a:t>2.14.0</a:t>
                       </a:r>
                     </a:p>
                   </a:txBody>
@@ -9680,7 +9701,7 @@
                           </a:solidFill>
                           <a:latin typeface="Segoe UI"/>
                         </a:rPr>
-                        <a:t>2026-10-28</a:t>
+                        <a:t>2026-10-29</a:t>
                       </a:r>
                     </a:p>
                   </a:txBody>
@@ -9702,7 +9723,7 @@
                           </a:solidFill>
                           <a:latin typeface="Segoe UI"/>
                         </a:rPr>
-                        <a:t>One-click Windows installer</a:t>
+                        <a:t>Pokes, tickles &amp; teases</a:t>
                       </a:r>
                     </a:p>
                     <a:p>
@@ -9713,7 +9734,7 @@
                           </a:solidFill>
                           <a:latin typeface="Segoe UI"/>
                         </a:rPr>
-                        <a:t>One Windows installer: no ZIP extraction, Python installation or command line. Download, open and click Install Pips.; Installs for your Windows account without administrator access, adds Desktop and Start Menu shortcuts, and opens Pips automatically.; Reinstalling in the same location keeps your settings and pet progress. Existing ZIP users can keep updating in place from Help → Check for updates.; A simpler download page and updated user guide; the bundled runtime stays separate from small in-app updates.</a:t>
+                        <a:t>Poke, tickle, tease, boop or hug a friend from afar - no pet visit needed.; Right-click your pet → Poke a friend, or use the Poke button in Friends, chat and profiles.; Your friend gets a pop-up ("Wendy is teasing you!"), their pet reacts, and they can poke back with one click.; During a focus session pokes wait quietly until your break; when your pet is hidden they show in the screen corner.</a:t>
                       </a:r>
                     </a:p>
                   </a:txBody>
@@ -9737,7 +9758,7 @@
                           </a:solidFill>
                           <a:latin typeface="Segoe UI"/>
                         </a:rPr>
-                        <a:t>2.13.0</a:t>
+                        <a:t>2.13.1</a:t>
                       </a:r>
                     </a:p>
                   </a:txBody>
@@ -9781,7 +9802,7 @@
                           </a:solidFill>
                           <a:latin typeface="Segoe UI"/>
                         </a:rPr>
-                        <a:t>Birthdays, parties &amp; gifts</a:t>
+                        <a:t>One-click Windows installer</a:t>
                       </a:r>
                     </a:p>
                     <a:p>
@@ -9792,7 +9813,7 @@
                           </a:solidFill>
                           <a:latin typeface="Segoe UI"/>
                         </a:rPr>
-                        <a:t>Set your birthday in Social → Profile (month + day, optionally visible to friends).; On your birthday Pips throws confetti and gives you 100 bonus coins.; Friends tab shows upcoming birthdays; you get reminders 3 days, 1 day and on the day.; Birthday parties: join a friend's party, see who's there, sign the guestbook and celebrate together.</a:t>
+                        <a:t>One Windows installer: no ZIP extraction, Python installation or command line. Download, open and click Install Pips.; Installs for your Windows account without administrator access, adds Desktop and Start Menu shortcuts, and opens Pips automatically.; Reinstalling in the same location keeps your settings and pet progress. Existing ZIP users can keep updating in place from Help → Check for updates.; A simpler download page and updated user guide; the bundled runtime stays separate from small in-app updates.</a:t>
                       </a:r>
                     </a:p>
                   </a:txBody>
@@ -9816,7 +9837,7 @@
                           </a:solidFill>
                           <a:latin typeface="Segoe UI"/>
                         </a:rPr>
-                        <a:t>2.12.0</a:t>
+                        <a:t>2.13.0</a:t>
                       </a:r>
                     </a:p>
                   </a:txBody>
@@ -9860,7 +9881,7 @@
                           </a:solidFill>
                           <a:latin typeface="Segoe UI"/>
                         </a:rPr>
-                        <a:t>Mega update: 28 new animals, 31 shop items, 13 moves</a:t>
+                        <a:t>Birthdays, parties &amp; gifts</a:t>
                       </a:r>
                     </a:p>
                     <a:p>
@@ -9871,7 +9892,7 @@
                           </a:solidFill>
                           <a:latin typeface="Segoe UI"/>
                         </a:rPr>
-                        <a:t>🦁 28 new animals (51 total): lion, tiger, unicorn, deer, sheep, cow, raccoon, red panda, monkey, hedgehog, dino, squirrel, mouse, koala, shark, dolphin, seal, otter, pufferfish, duck, crab, parrot, chick, ladybug, phoenix, pegasus, ghost and flamingo; 🎩 31 new shop items: top hat, cowboy, chef, pirate, Santa, viking, graduation cap, beret, bow, propeller cap, flower crown, nerd glasses, eyepatch, mustache, goggles, masquerade mask, tie, pearls, flower lei, gold chain, balloon, backpack, guitar, shield, butterfly / devil wings and more - plus Premium galaxy crown, galaxy cape and dragon wings; 💃 13 new moves: wave, jump, hearts, sing, yoga, zoomies, cartwheel, juggle, rain dance, breakdance, magic, confetti and the Premium rocket launch; The Shop is now split into sections (Hats, Face, Neck, Back, Moves, Arena gear) with an owned counter for each</a:t>
+                        <a:t>Set your birthday in Social → Profile (month + day, optionally visible to friends).; On your birthday Pips throws confetti and gives you 100 bonus coins.; Friends tab shows upcoming birthdays; you get reminders 3 days, 1 day and on the day.; Birthday parties: join a friend's party, see who's there, sign the guestbook and celebrate together.</a:t>
                       </a:r>
                     </a:p>
                   </a:txBody>
@@ -9895,7 +9916,7 @@
                           </a:solidFill>
                           <a:latin typeface="Segoe UI"/>
                         </a:rPr>
-                        <a:t>2.11.0</a:t>
+                        <a:t>2.12.0</a:t>
                       </a:r>
                     </a:p>
                   </a:txBody>
@@ -9939,7 +9960,7 @@
                           </a:solidFill>
                           <a:latin typeface="Segoe UI"/>
                         </a:rPr>
-                        <a:t>New right-click menus</a:t>
+                        <a:t>Mega update: 28 new animals, 31 shop items, 13 moves</a:t>
                       </a:r>
                     </a:p>
                     <a:p>
@@ -9950,7 +9971,7 @@
                           </a:solidFill>
                           <a:latin typeface="Segoe UI"/>
                         </a:rPr>
-                        <a:t>✨ Brand-new animated right-click menu for your pet: mood &amp; stat bars, quick-action tiles (Friends, Shop, Snack, Pat, Focus, Stats, Sleep, Taskbar), hover effects and smooth fly-out submenus; Pick colours from swatches, switch size with one click and flip Sounds / Dark mode with toggle switches - changes show instantly; Updates are highlighted: a glowing banner and NEW badge appear in the menu when a new version is ready; The focus card's right-click menu got the same new look; keyboard arrows, Enter and Esc work too</a:t>
+                        <a:t>🦁 28 new animals (51 total): lion, tiger, unicorn, deer, sheep, cow, raccoon, red panda, monkey, hedgehog, dino, squirrel, mouse, koala, shark, dolphin, seal, otter, pufferfish, duck, crab, parrot, chick, ladybug, phoenix, pegasus, ghost and flamingo; 🎩 31 new shop items: top hat, cowboy, chef, pirate, Santa, viking, graduation cap, beret, bow, propeller cap, flower crown, nerd glasses, eyepatch, mustache, goggles, masquerade mask, tie, pearls, flower lei, gold chain, balloon, backpack, guitar, shield, butterfly / devil wings and more - plus Premium galaxy crown, galaxy cape and dragon wings; 💃 13 new moves: wave, jump, hearts, sing, yoga, zoomies, cartwheel, juggle, rain dance, breakdance, magic, confetti and the Premium rocket launch; The Shop is now split into sections (Hats, Face, Neck, Back, Moves, Arena gear) with an owned counter for each</a:t>
                       </a:r>
                     </a:p>
                   </a:txBody>
@@ -9974,7 +9995,7 @@
                           </a:solidFill>
                           <a:latin typeface="Segoe UI"/>
                         </a:rPr>
-                        <a:t>2.10.0</a:t>
+                        <a:t>2.11.0</a:t>
                       </a:r>
                     </a:p>
                   </a:txBody>
@@ -10018,7 +10039,7 @@
                           </a:solidFill>
                           <a:latin typeface="Segoe UI"/>
                         </a:rPr>
-                        <a:t>Chat bots</a:t>
+                        <a:t>New right-click menus</a:t>
                       </a:r>
                     </a:p>
                     <a:p>
@@ -10029,7 +10050,7 @@
                           </a:solidFill>
                           <a:latin typeface="Segoe UI"/>
                         </a:rPr>
-                        <a:t>🤖 6 friendly chat bots in the Chat tab: Pip Helper (app questions), Coach Focus (focus tips from your real stats), Sunny (live weather for any city), Arena Master (battle tips + quick battle), Giggles (jokes &amp; games) and Guardian (safety &amp; reporting help); Private bot chats with suggestion chips, typing indicator and a clear button - your bot chats stay on your PC; Mention a bot in a group chat (e.g. @weather Batam) and it answers in the room for everyone; Bots reply in your app language; up to 120 bot messages per day</a:t>
+                        <a:t>✨ Brand-new animated right-click menu for your pet: mood &amp; stat bars, quick-action tiles (Friends, Shop, Snack, Pat, Focus, Stats, Sleep, Taskbar), hover effects and smooth fly-out submenus; Pick colours from swatches, switch size with one click and flip Sounds / Dark mode with toggle switches - changes show instantly; Updates are highlighted: a glowing banner and NEW badge appear in the menu when a new version is ready; The focus card's right-click menu got the same new look; keyboard arrows, Enter and Esc work too</a:t>
                       </a:r>
                     </a:p>
                   </a:txBody>
@@ -10053,7 +10074,7 @@
                           </a:solidFill>
                           <a:latin typeface="Segoe UI"/>
                         </a:rPr>
-                        <a:t>2.9.0</a:t>
+                        <a:t>2.10.0</a:t>
                       </a:r>
                     </a:p>
                   </a:txBody>
@@ -10097,7 +10118,7 @@
                           </a:solidFill>
                           <a:latin typeface="Segoe UI"/>
                         </a:rPr>
-                        <a:t>Location &amp; live weather</a:t>
+                        <a:t>Chat bots</a:t>
                       </a:r>
                     </a:p>
                     <a:p>
@@ -10108,7 +10129,7 @@
                           </a:solidFill>
                           <a:latin typeface="Segoe UI"/>
                         </a:rPr>
-                        <a:t>📍 Add your city in Profile → Location &amp; weather (auto-detect or search) - only your city and country are shown, never your exact position; Live weather banners on every profile with animations: rain, drizzle, thunderstorms with lightning, snow, fog, clouds, sunshine or a starry night - plus temperature, feels-like, humidity, wind and local time; Your own weather strip on top of the hub, and each friend's weather + local time in the friends list; Hide your location from others or remove it any time</a:t>
+                        <a:t>🤖 6 friendly chat bots in the Chat tab: Pip Helper (app questions), Coach Focus (focus tips from your real stats), Sunny (live weather for any city), Arena Master (battle tips + quick battle), Giggles (jokes &amp; games) and Guardian (safety &amp; reporting help); Private bot chats with suggestion chips, typing indicator and a clear button - your bot chats stay on your PC; Mention a bot in a group chat (e.g. @weather Batam) and it answers in the room for everyone; Bots reply in your app language; up to 120 bot messages per day</a:t>
                       </a:r>
                     </a:p>
                   </a:txBody>
@@ -10132,7 +10153,7 @@
                           </a:solidFill>
                           <a:latin typeface="Segoe UI"/>
                         </a:rPr>
-                        <a:t>2.8.0</a:t>
+                        <a:t>2.9.0</a:t>
                       </a:r>
                     </a:p>
                   </a:txBody>
@@ -10176,7 +10197,7 @@
                           </a:solidFill>
                           <a:latin typeface="Segoe UI"/>
                         </a:rPr>
-                        <a:t>Pips Arena - duels, gear &amp; live battles</a:t>
+                        <a:t>Location &amp; live weather</a:t>
                       </a:r>
                     </a:p>
                     <a:p>
@@ -10187,7 +10208,7 @@
                           </a:solidFill>
                           <a:latin typeface="Segoe UI"/>
                         </a:rPr>
-                        <a:t>⚔ New Arena tab: challenge friends or anyone in the arena to a live duel - each round pick Attack, Guard or Special within 12 seconds and watch your pets fight; ⚡ Quick battle: an instant auto-fight against anyone's fighter, even when they're offline; Arena gear in the Shop: 7 weapons (water pistol to rocket launcher), 5 armors and 5 gadgets that decide your special move - better gear and a higher level make a stronger fighter; Live duels can be watched by everyone, plus recent battle replays, top fighters, rating and win/loss records; wins earn coins</a:t>
+                        <a:t>📍 Add your city in Profile → Location &amp; weather (auto-detect or search) - only your city and country are shown, never your exact position; Live weather banners on every profile with animations: rain, drizzle, thunderstorms with lightning, snow, fog, clouds, sunshine or a starry night - plus temperature, feels-like, humidity, wind and local time; Your own weather strip on top of the hub, and each friend's weather + local time in the friends list; Hide your location from others or remove it any time</a:t>
                       </a:r>
                     </a:p>
                   </a:txBody>
@@ -10211,7 +10232,7 @@
                           </a:solidFill>
                           <a:latin typeface="Segoe UI"/>
                         </a:rPr>
-                        <a:t>2.7.0</a:t>
+                        <a:t>2.8.0</a:t>
                       </a:r>
                     </a:p>
                   </a:txBody>
@@ -10255,7 +10276,7 @@
                           </a:solidFill>
                           <a:latin typeface="Segoe UI"/>
                         </a:rPr>
-                        <a:t>Moderators &amp; Premium</a:t>
+                        <a:t>Pips Arena - duels, gear &amp; live battles</a:t>
                       </a:r>
                     </a:p>
                     <a:p>
@@ -10266,7 +10287,7 @@
                           </a:solidFill>
                           <a:latin typeface="Segoe UI"/>
                         </a:rPr>
-                        <a:t>★ Premium: a purple Premium badge, 4 exclusive props (tiara, star glasses, diamond necklace, fairy wings), the Fireworks move, +30 coins every day, double friend-interaction coins and room for 300 friends / 30 groups; Get Premium: Profile tab → Premium → "Ask to buy" emails the owner; after payment you receive a key (PIPS-XXXX-XXXX) to redeem right there; 🛡 Moderators: a blue Mod badge and a Mod tab with the report queue - warn, mute (1h / 24h / 7 days), clear a profile or reset a name; every action is logged; Report button on everyone's profile, so moderators can keep Pips friendly</a:t>
+                        <a:t>⚔ New Arena tab: challenge friends or anyone in the arena to a live duel - each round pick Attack, Guard or Special within 12 seconds and watch your pets fight; ⚡ Quick battle: an instant auto-fight against anyone's fighter, even when they're offline; Arena gear in the Shop: 7 weapons (water pistol to rocket launcher), 5 armors and 5 gadgets that decide your special move - better gear and a higher level make a stronger fighter; Live duels can be watched by everyone, plus recent battle replays, top fighters, rating and win/loss records; wins earn coins</a:t>
                       </a:r>
                     </a:p>
                   </a:txBody>
@@ -10290,7 +10311,7 @@
                           </a:solidFill>
                           <a:latin typeface="Segoe UI"/>
                         </a:rPr>
-                        <a:t>2.6.1</a:t>
+                        <a:t>2.7.0</a:t>
                       </a:r>
                     </a:p>
                   </a:txBody>
@@ -10334,7 +10355,7 @@
                           </a:solidFill>
                           <a:latin typeface="Segoe UI"/>
                         </a:rPr>
-                        <a:t>Owner badge &amp; credits</a:t>
+                        <a:t>Moderators &amp; Premium</a:t>
                       </a:r>
                     </a:p>
                     <a:p>
@@ -10345,7 +10366,7 @@
                           </a:solidFill>
                           <a:latin typeface="Segoe UI"/>
                         </a:rPr>
-                        <a:t>The creator of Pips (Juwen Lie) now shows a gold ♛ Owner badge on his profile, friend list and ranks; New About Pips card in the Profile tab: credits and how to contact the owner (Juwen_Lie@pegatroncorp.com) with Email and Copy buttons; Right-click the pet → Help → About now shows who made Pips and the contact email</a:t>
+                        <a:t>★ Premium: a purple Premium badge, 4 exclusive props (tiara, star glasses, diamond necklace, fairy wings), the Fireworks move, +30 coins every day, double friend-interaction coins and room for 300 friends / 30 groups; Get Premium: Profile tab → Premium → "Ask to buy" emails the owner; after payment you receive a key (PIPS-XXXX-XXXX) to redeem right there; 🛡 Moderators: a blue Mod badge and a Mod tab with the report queue - warn, mute (1h / 24h / 7 days), clear a profile or reset a name; every action is logged; Report button on everyone's profile, so moderators can keep Pips friendly</a:t>
                       </a:r>
                     </a:p>
                   </a:txBody>
@@ -10369,7 +10390,7 @@
                           </a:solidFill>
                           <a:latin typeface="Segoe UI"/>
                         </a:rPr>
-                        <a:t>2.6.0</a:t>
+                        <a:t>2.6.1</a:t>
                       </a:r>
                     </a:p>
                   </a:txBody>
@@ -10413,7 +10434,7 @@
                           </a:solidFill>
                           <a:latin typeface="Segoe UI"/>
                         </a:rPr>
-                        <a:t>Profiles, ranks, online status &amp; dark mode</a:t>
+                        <a:t>Owner badge &amp; credits</a:t>
                       </a:r>
                     </a:p>
                     <a:p>
@@ -10424,7 +10445,7 @@
                           </a:solidFill>
                           <a:latin typeface="Segoe UI"/>
                         </a:rPr>
-                        <a:t>Profile tab: profile picture (or your pet), about me, job, location, hobbies, birthday and a status message; Public or private: public profiles can be added directly and viewed in full; private profiles need a friend request that they accept, and strangers only see name, photo, pet, level and status; Click anyone to open their profile - badges, info, their friends - and add them, chat or wave from there; Ranks tab replaces Teams: everyone using Pips, sorted by XP, badges or streak</a:t>
+                        <a:t>The creator of Pips (Juwen Lie) now shows a gold ♛ Owner badge on his profile, friend list and ranks; New About Pips card in the Profile tab: credits and how to contact the owner (Juwen_Lie@pegatroncorp.com) with Email and Copy buttons; Right-click the pet → Help → About now shows who made Pips and the contact email</a:t>
                       </a:r>
                     </a:p>
                   </a:txBody>
@@ -10448,7 +10469,7 @@
                           </a:solidFill>
                           <a:latin typeface="Segoe UI"/>
                         </a:rPr>
-                        <a:t>2.5.1</a:t>
+                        <a:t>2.6.0</a:t>
                       </a:r>
                     </a:p>
                   </a:txBody>
@@ -10492,7 +10513,7 @@
                           </a:solidFill>
                           <a:latin typeface="Segoe UI"/>
                         </a:rPr>
-                        <a:t>New cute Pips logo</a:t>
+                        <a:t>Profiles, ranks, online status &amp; dark mode</a:t>
                       </a:r>
                     </a:p>
                     <a:p>
@@ -10503,7 +10524,7 @@
                           </a:solidFill>
                           <a:latin typeface="Segoe UI"/>
                         </a:rPr>
-                        <a:t>New Pips logo: Pip the cat on a Pips-red tile, matching the app colours (desktop shortcut, windows and website)</a:t>
+                        <a:t>Profile tab: profile picture (or your pet), about me, job, location, hobbies, birthday and a status message; Public or private: public profiles can be added directly and viewed in full; private profiles need a friend request that they accept, and strangers only see name, photo, pet, level and status; Click anyone to open their profile - badges, info, their friends - and add them, chat or wave from there; Ranks tab replaces Teams: everyone using Pips, sorted by XP, badges or streak</a:t>
                       </a:r>
                     </a:p>
                   </a:txBody>
@@ -10527,7 +10548,7 @@
                           </a:solidFill>
                           <a:latin typeface="Segoe UI"/>
                         </a:rPr>
-                        <a:t>2.5.0</a:t>
+                        <a:t>2.5.1</a:t>
                       </a:r>
                     </a:p>
                   </a:txBody>
@@ -10571,7 +10592,7 @@
                           </a:solidFill>
                           <a:latin typeface="Segoe UI"/>
                         </a:rPr>
-                        <a:t>Shop, coins, props &amp; moves</a:t>
+                        <a:t>New cute Pips logo</a:t>
                       </a:r>
                     </a:p>
                     <a:p>
@@ -10582,7 +10603,7 @@
                           </a:solidFill>
                           <a:latin typeface="Segoe UI"/>
                         </a:rPr>
-                        <a:t>Shop: earn coins and spend them on your pet - 17 props (crown, wizard hat, headphones, shades, scarf, cape, angel wings...) and 6 moves: spin, dance, moonwalk, backflip, kung fu and spider swing!; Coins come from leveling up (+40), badges (+25), opening Pips each day (+10), friendships (+15 per affinity level), waving / chatting / visiting friends (+2) and pomodoros (+5). Everyone starts with a 100-coin gift; Your friends see your props: on avatars in the hub and when your pet visits their desktop - it shows off one of your moves; Pips is now a social pet: clicking the pet opens the Pips hub (friends, chat, groups, shop, badges)</a:t>
+                        <a:t>New Pips logo: Pip the cat on a Pips-red tile, matching the app colours (desktop shortcut, windows and website)</a:t>
                       </a:r>
                     </a:p>
                   </a:txBody>
@@ -10606,7 +10627,7 @@
                           </a:solidFill>
                           <a:latin typeface="Segoe UI"/>
                         </a:rPr>
-                        <a:t>2.4.0</a:t>
+                        <a:t>2.5.0</a:t>
                       </a:r>
                     </a:p>
                   </a:txBody>
@@ -10650,7 +10671,7 @@
                           </a:solidFill>
                           <a:latin typeface="Segoe UI"/>
                         </a:rPr>
-                        <a:t>Chat, groups, affinity &amp; pet visits</a:t>
+                        <a:t>Shop, coins, props &amp; moves</a:t>
                       </a:r>
                     </a:p>
                     <a:p>
@@ -10661,7 +10682,7 @@
                           </a:solidFill>
                           <a:latin typeface="Segoe UI"/>
                         </a:rPr>
-                        <a:t>Chat: message your friends, and chat inside groups. Your pet pops up new messages as a bubble - click it to reply; Pet interactions: wave, pet their pet, send a snack, high five - or send your pet to visit: it walks onto your friend's desktop for a little while!; Affinity: every chat and interaction grows your friendship - Acquaintance → Buddy → Good friends → Close friends → Best friends → Soulmates; Your own groups: create a private group, invite your friends, they accept or decline. Group board + group chat; the owner can remove members</a:t>
+                        <a:t>Shop: earn coins and spend them on your pet - 17 props (crown, wizard hat, headphones, shades, scarf, cape, angel wings...) and 6 moves: spin, dance, moonwalk, backflip, kung fu and spider swing!; Coins come from leveling up (+40), badges (+25), opening Pips each day (+10), friendships (+15 per affinity level), waving / chatting / visiting friends (+2) and pomodoros (+5). Everyone starts with a 100-coin gift; Your friends see your props: on avatars in the hub and when your pet visits their desktop - it shows off one of your moves; Pips is now a social pet: clicking the pet opens the Pips hub (friends, chat, groups, shop, badges)</a:t>
                       </a:r>
                     </a:p>
                   </a:txBody>
@@ -10685,7 +10706,7 @@
                           </a:solidFill>
                           <a:latin typeface="Segoe UI"/>
                         </a:rPr>
-                        <a:t>2.3.0</a:t>
+                        <a:t>2.4.0</a:t>
                       </a:r>
                     </a:p>
                   </a:txBody>
@@ -10729,7 +10750,7 @@
                           </a:solidFill>
                           <a:latin typeface="Segoe UI"/>
                         </a:rPr>
-                        <a:t>Friends, levels &amp; achievements</a:t>
+                        <a:t>Chat, groups, affinity &amp; pet visits</a:t>
                       </a:r>
                     </a:p>
                     <a:p>
@@ -10740,7 +10761,7 @@
                           </a:solidFill>
                           <a:latin typeface="Segoe UI"/>
                         </a:rPr>
-                        <a:t>Levels &amp; XP: every finished pomodoro earns XP and your level grows - plus 20 achievements to unlock (first tomato, 8 in a day, 7-day streak, early bird, night owl, pet lover...). Your pet celebrates each one; Friends (optional, off by default): get a 6-letter friend code, add colleagues, see today's board and join a team board like PTB. Your pet tells you when a friend finishes a pomodoro; Privacy: only your name, pet, level, streak and pomodoro counts are shared - never apps, window titles or scores. One click turns it off and deletes your online data. Right-click the pet → Friends &amp; achievements…</a:t>
+                        <a:t>Chat: message your friends, and chat inside groups. Your pet pops up new messages as a bubble - click it to reply; Pet interactions: wave, pet their pet, send a snack, high five - or send your pet to visit: it walks onto your friend's desktop for a little while!; Affinity: every chat and interaction grows your friendship - Acquaintance → Buddy → Good friends → Close friends → Best friends → Soulmates; Your own groups: create a private group, invite your friends, they accept or decline. Group board + group chat; the owner can remove members</a:t>
                       </a:r>
                     </a:p>
                   </a:txBody>
@@ -10764,7 +10785,7 @@
                           </a:solidFill>
                           <a:latin typeface="Segoe UI"/>
                         </a:rPr>
-                        <a:t>2.2.0</a:t>
+                        <a:t>2.3.0</a:t>
                       </a:r>
                     </a:p>
                   </a:txBody>
@@ -10808,7 +10829,7 @@
                           </a:solidFill>
                           <a:latin typeface="Segoe UI"/>
                         </a:rPr>
-                        <a:t>Pet sounds</a:t>
+                        <a:t>Friends, levels &amp; achievements</a:t>
                       </a:r>
                     </a:p>
                     <a:p>
@@ -10819,7 +10840,7 @@
                           </a:solidFill>
                           <a:latin typeface="Segoe UI"/>
                         </a:rPr>
-                        <a:t>Your pet has a voice! Each of the 23 animals has its own sound (meow, woof, ribbit, hoot, buzz, oink, whale song...) and it changes with its mood: happy chirps, sad whimpers, sleepy yawns, hungry calls, grumpy huffs and soft snores; It also reacts with sound when you tickle, pet, feed, shake or wake it; Settings: right-click the pet → Sounds to switch on/off; Pet status &amp; settings has a volume slider, a ▶ Hear me button and "Stay quiet while I'm focusing" (on by default)</a:t>
+                        <a:t>Levels &amp; XP: every finished pomodoro earns XP and your level grows - plus 20 achievements to unlock (first tomato, 8 in a day, 7-day streak, early bird, night owl, pet lover...). Your pet celebrates each one; Friends (optional, off by default): get a 6-letter friend code, add colleagues, see today's board and join a team board like PTB. Your pet tells you when a friend finishes a pomodoro; Privacy: only your name, pet, level, streak and pomodoro counts are shared - never apps, window titles or scores. One click turns it off and deletes your online data. Right-click the pet → Friends &amp; achievements…</a:t>
                       </a:r>
                     </a:p>
                   </a:txBody>
@@ -10843,7 +10864,7 @@
                           </a:solidFill>
                           <a:latin typeface="Segoe UI"/>
                         </a:rPr>
-                        <a:t>2.1.2</a:t>
+                        <a:t>2.2.0</a:t>
                       </a:r>
                     </a:p>
                   </a:txBody>
@@ -10887,7 +10908,7 @@
                           </a:solidFill>
                           <a:latin typeface="Segoe UI"/>
                         </a:rPr>
-                        <a:t>Tickle-only mode</a:t>
+                        <a:t>Pet sounds</a:t>
                       </a:r>
                     </a:p>
                     <a:p>
@@ -10898,7 +10919,7 @@
                           </a:solidFill>
                           <a:latin typeface="Segoe UI"/>
                         </a:rPr>
-                        <a:t>New click option "Only tickle (never open Pips)": click and tickle your pet as much as you like - the Pomodoro window stays closed (open it from the right-click menu). Right-click the pet → When I click</a:t>
+                        <a:t>Your pet has a voice! Each of the 23 animals has its own sound (meow, woof, ribbit, hoot, buzz, oink, whale song...) and it changes with its mood: happy chirps, sad whimpers, sleepy yawns, hungry calls, grumpy huffs and soft snores; It also reacts with sound when you tickle, pet, feed, shake or wake it; Settings: right-click the pet → Sounds to switch on/off; Pet status &amp; settings has a volume slider, a ▶ Hear me button and "Stay quiet while I'm focusing" (on by default)</a:t>
                       </a:r>
                     </a:p>
                   </a:txBody>
@@ -10922,7 +10943,7 @@
                           </a:solidFill>
                           <a:latin typeface="Segoe UI"/>
                         </a:rPr>
-                        <a:t>2.1.1</a:t>
+                        <a:t>2.1.2</a:t>
                       </a:r>
                     </a:p>
                   </a:txBody>
@@ -10966,7 +10987,7 @@
                           </a:solidFill>
                           <a:latin typeface="Segoe UI"/>
                         </a:rPr>
-                        <a:t>Owner info</a:t>
+                        <a:t>Tickle-only mode</a:t>
                       </a:r>
                     </a:p>
                     <a:p>
@@ -10977,7 +10998,7 @@
                           </a:solidFill>
                           <a:latin typeface="Segoe UI"/>
                         </a:rPr>
-                        <a:t>About Pips now shows the owner: Juwen Lie (right-click the pet → Help → About)</a:t>
+                        <a:t>New click option "Only tickle (never open Pips)": click and tickle your pet as much as you like - the Pomodoro window stays closed (open it from the right-click menu). Right-click the pet → When I click</a:t>
                       </a:r>
                     </a:p>
                   </a:txBody>
@@ -11001,7 +11022,7 @@
                           </a:solidFill>
                           <a:latin typeface="Segoe UI"/>
                         </a:rPr>
-                        <a:t>2.1.0</a:t>
+                        <a:t>2.1.1</a:t>
                       </a:r>
                     </a:p>
                   </a:txBody>
@@ -11045,7 +11066,7 @@
                           </a:solidFill>
                           <a:latin typeface="Segoe UI"/>
                         </a:rPr>
-                        <a:t>Interactive guide &amp; in-app updates</a:t>
+                        <a:t>Owner info</a:t>
                       </a:r>
                     </a:p>
                     <a:p>
@@ -11056,7 +11077,7 @@
                           </a:solidFill>
                           <a:latin typeface="Segoe UI"/>
                         </a:rPr>
-                        <a:t>Interactive first-run guide: your pet walks you through clicking, dragging, petting and the right-click menu; In-app updates: Pips tells you when a new version is out - update with one click (your settings and data are kept); New Help menu: replay the guide, check for updates, see the version; Option to turn automatic update checks off</a:t>
+                        <a:t>About Pips now shows the owner: Juwen Lie (right-click the pet → Help → About)</a:t>
                       </a:r>
                     </a:p>
                   </a:txBody>
@@ -11080,7 +11101,7 @@
                           </a:solidFill>
                           <a:latin typeface="Segoe UI"/>
                         </a:rPr>
-                        <a:t>2.0.0</a:t>
+                        <a:t>2.1.0</a:t>
                       </a:r>
                     </a:p>
                   </a:txBody>
@@ -11124,7 +11145,7 @@
                           </a:solidFill>
                           <a:latin typeface="Segoe UI"/>
                         </a:rPr>
-                        <a:t>Desktop pet, 23 animals &amp; 4 languages</a:t>
+                        <a:t>Interactive guide &amp; in-app updates</a:t>
                       </a:r>
                     </a:p>
                     <a:p>
@@ -11135,7 +11156,7 @@
                           </a:solidFill>
                           <a:latin typeface="Segoe UI"/>
                         </a:rPr>
-                        <a:t>Desktop pet that lives on your desktop and taskbar - drag it, tickle it, pet it; 23 animals in 3 groups: Land walks, Water swims with bubbles, Sky hovers and flaps; Moods (happy, sad, tired, hungry, grumpy...), naps when you're away, wakes up when you're back; Cute chat-bubble reminders: breaks, water, 20-20-20 eye rest, pomodoro done, daily goal</a:t>
+                        <a:t>Interactive first-run guide: your pet walks you through clicking, dragging, petting and the right-click menu; In-app updates: Pips tells you when a new version is out - update with one click (your settings and data are kept); New Help menu: replay the guide, check for updates, see the version; Option to turn automatic update checks off</a:t>
                       </a:r>
                     </a:p>
                   </a:txBody>
@@ -11159,7 +11180,7 @@
                           </a:solidFill>
                           <a:latin typeface="Segoe UI"/>
                         </a:rPr>
-                        <a:t>1.5.0</a:t>
+                        <a:t>2.0.0</a:t>
                       </a:r>
                     </a:p>
                   </a:txBody>
@@ -11181,7 +11202,7 @@
                           </a:solidFill>
                           <a:latin typeface="Segoe UI"/>
                         </a:rPr>
-                        <a:t>2026-10-24</a:t>
+                        <a:t>2026-10-28</a:t>
                       </a:r>
                     </a:p>
                   </a:txBody>
@@ -11203,7 +11224,7 @@
                           </a:solidFill>
                           <a:latin typeface="Segoe UI"/>
                         </a:rPr>
-                        <a:t>Renamed to Pips + insights</a:t>
+                        <a:t>Desktop pet, 23 animals &amp; 4 languages</a:t>
                       </a:r>
                     </a:p>
                     <a:p>
@@ -11214,7 +11235,7 @@
                           </a:solidFill>
                           <a:latin typeface="Segoe UI"/>
                         </a:rPr>
-                        <a:t>Renamed from Productivity Widget to Pips; Dashboard charts: focus timeline, hour heatmap, 7-day score trend, pomodoros per day; AI token usage on the card and dashboard; Daily diary export and weekly / monthly reports</a:t>
+                        <a:t>Desktop pet that lives on your desktop and taskbar - drag it, tickle it, pet it; 23 animals in 3 groups: Land walks, Water swims with bubbles, Sky hovers and flaps; Moods (happy, sad, tired, hungry, grumpy...), naps when you're away, wakes up when you're back; Cute chat-bubble reminders: breaks, water, 20-20-20 eye rest, pomodoro done, daily goal</a:t>
                       </a:r>
                     </a:p>
                   </a:txBody>
@@ -11238,7 +11259,7 @@
                           </a:solidFill>
                           <a:latin typeface="Segoe UI"/>
                         </a:rPr>
-                        <a:t>1.0.0</a:t>
+                        <a:t>1.5.0</a:t>
                       </a:r>
                     </a:p>
                   </a:txBody>
@@ -11260,7 +11281,7 @@
                           </a:solidFill>
                           <a:latin typeface="Segoe UI"/>
                         </a:rPr>
-                        <a:t>2026-10-21</a:t>
+                        <a:t>2026-10-24</a:t>
                       </a:r>
                     </a:p>
                   </a:txBody>
@@ -11282,7 +11303,7 @@
                           </a:solidFill>
                           <a:latin typeface="Segoe UI"/>
                         </a:rPr>
-                        <a:t>First release</a:t>
+                        <a:t>Renamed to Pips + insights</a:t>
                       </a:r>
                     </a:p>
                     <a:p>
@@ -11293,13 +11314,92 @@
                           </a:solidFill>
                           <a:latin typeface="Segoe UI"/>
                         </a:rPr>
-                        <a:t>Always-on-top Pomodoro card with progress ring; Rain / thunder / brown-noise / cafe soundscapes; Live app-usage tracking and a daily 1-5 star focus score; Goals, streaks, XP, coach tips and break reminders</a:t>
+                        <a:t>Renamed from Productivity Widget to Pips; Dashboard charts: focus timeline, hour heatmap, 7-day score trend, pomodoros per day; AI token usage on the card and dashboard; Daily diary export and weekly / monthly reports</a:t>
                       </a:r>
                     </a:p>
                   </a:txBody>
                   <a:tcPr marL="73152" marR="73152" marT="36576" marB="36576">
                     <a:solidFill>
                       <a:srgbClr val="FFFDF8"/>
+                    </a:solidFill>
+                  </a:tcPr>
+                </a:tc>
+              </a:tr>
+              <a:tr h="822960">
+                <a:tc>
+                  <a:txBody>
+                    <a:bodyPr wrap="square"/>
+                    <a:lstStyle/>
+                    <a:p>
+                      <a:r>
+                        <a:rPr sz="1200" b="1">
+                          <a:solidFill>
+                            <a:srgbClr val="2B2A28"/>
+                          </a:solidFill>
+                          <a:latin typeface="Segoe UI"/>
+                        </a:rPr>
+                        <a:t>1.0.0</a:t>
+                      </a:r>
+                    </a:p>
+                  </a:txBody>
+                  <a:tcPr marL="73152" marR="73152" marT="36576" marB="36576">
+                    <a:solidFill>
+                      <a:srgbClr val="F7F4EC"/>
+                    </a:solidFill>
+                  </a:tcPr>
+                </a:tc>
+                <a:tc>
+                  <a:txBody>
+                    <a:bodyPr wrap="square"/>
+                    <a:lstStyle/>
+                    <a:p>
+                      <a:r>
+                        <a:rPr sz="1200" b="0">
+                          <a:solidFill>
+                            <a:srgbClr val="2B2A28"/>
+                          </a:solidFill>
+                          <a:latin typeface="Segoe UI"/>
+                        </a:rPr>
+                        <a:t>2026-10-21</a:t>
+                      </a:r>
+                    </a:p>
+                  </a:txBody>
+                  <a:tcPr marL="73152" marR="73152" marT="36576" marB="36576">
+                    <a:solidFill>
+                      <a:srgbClr val="F7F4EC"/>
+                    </a:solidFill>
+                  </a:tcPr>
+                </a:tc>
+                <a:tc>
+                  <a:txBody>
+                    <a:bodyPr wrap="square"/>
+                    <a:lstStyle/>
+                    <a:p>
+                      <a:r>
+                        <a:rPr sz="1200" b="0">
+                          <a:solidFill>
+                            <a:srgbClr val="2B2A28"/>
+                          </a:solidFill>
+                          <a:latin typeface="Segoe UI"/>
+                        </a:rPr>
+                        <a:t>First release</a:t>
+                      </a:r>
+                    </a:p>
+                    <a:p>
+                      <a:r>
+                        <a:rPr sz="1200" b="0">
+                          <a:solidFill>
+                            <a:srgbClr val="2B2A28"/>
+                          </a:solidFill>
+                          <a:latin typeface="Segoe UI"/>
+                        </a:rPr>
+                        <a:t>Always-on-top Pomodoro card with progress ring; Rain / thunder / brown-noise / cafe soundscapes; Live app-usage tracking and a daily 1-5 star focus score; Goals, streaks, XP, coach tips and break reminders</a:t>
+                      </a:r>
+                    </a:p>
+                  </a:txBody>
+                  <a:tcPr marL="73152" marR="73152" marT="36576" marB="36576">
+                    <a:solidFill>
+                      <a:srgbClr val="F7F4EC"/>
                     </a:solidFill>
                   </a:tcPr>
                 </a:tc>
@@ -11721,7 +11821,7 @@
                 </a:solidFill>
                 <a:latin typeface="Segoe UI"/>
               </a:rPr>
-              <a:t>A little animal lives on your taskbar - it walks, naps, chats and reacts when you play with it.</a:t>
+              <a:t>A little animal lives on your desktop - land animals walk on the taskbar and on top of windows, water animals swim and splash, flyers fly around. It naps, chats and reacts when you play with it.</a:t>
             </a:r>
           </a:p>
           <a:p>
@@ -13938,7 +14038,7 @@
                           </a:solidFill>
                           <a:latin typeface="Segoe UI"/>
                         </a:rPr>
-                        <a:t>Move the pet; drop it on the taskbar to walk there</a:t>
+                        <a:t>Move the pet; land animals drop onto a window or the taskbar, water animals dive back in, flyers stay where you let go</a:t>
                       </a:r>
                     </a:p>
                   </a:txBody>
@@ -14779,7 +14879,7 @@
                           </a:solidFill>
                           <a:latin typeface="Segoe UI"/>
                         </a:rPr>
-                        <a:t>Carry it anywhere. Drop on the taskbar → it walks along it</a:t>
+                        <a:t>Carry it anywhere. Land animals fall onto the window edge below (or the taskbar), water animals splash back into the water, flyers hover where you let go</a:t>
                       </a:r>
                     </a:p>
                   </a:txBody>

</xml_diff>

<commit_message>
pips 2.20.0: Come over
</commit_message>
<xml_diff>
--- a/apps/pips/web/download/Pips-Guide.pptx
+++ b/apps/pips/web/download/Pips-Guide.pptx
@@ -3292,7 +3292,7 @@
                 </a:solidFill>
                 <a:latin typeface="Segoe UI"/>
               </a:rPr>
-              <a:t>Version 2.19.0  ·  2026-10-29  ·  Made by Juwen Lie (owner)</a:t>
+              <a:t>Version 2.20.0  ·  2026-10-29  ·  Made by Juwen Lie (owner)</a:t>
             </a:r>
           </a:p>
           <a:p>
@@ -4647,7 +4647,7 @@
                 </a:solidFill>
                 <a:latin typeface="Segoe UI"/>
               </a:rPr>
-              <a:t>Wave, pet, send a snack, high five - or send your pet to visit their desktop!</a:t>
+              <a:t>Wave, pet, snack, high five, visit - point at a visiting pet's name tag to play</a:t>
             </a:r>
           </a:p>
           <a:p>
@@ -8279,7 +8279,7 @@
                 </a:solidFill>
                 <a:latin typeface="Segoe UI"/>
               </a:rPr>
-              <a:t>What's new in 2.19.0</a:t>
+              <a:t>What's new in 2.20.0</a:t>
             </a:r>
           </a:p>
         </p:txBody>
@@ -8392,7 +8392,7 @@
                 </a:solidFill>
                 <a:latin typeface="Segoe UI"/>
               </a:rPr>
-              <a:t>Land, sea &amp; sky  ·  2026-10-29</a:t>
+              <a:t>Come over  ·  2026-10-29</a:t>
             </a:r>
           </a:p>
         </p:txBody>
@@ -8440,7 +8440,7 @@
                 </a:solidFill>
                 <a:latin typeface="Segoe UI"/>
               </a:rPr>
-              <a:t>Land animals walk on the taskbar and on top of your open windows now: they jump up onto window edges, walk along them, ride along when you move the window and hop down when it closes, gets covered or is maximised. They always have gravity - let go of one in mid-air and it lands on the window below or on the taskbar.</a:t>
+              <a:t>When a friend's pet comes over it now wears a name tag: your friend's name (or the nickname you gave them), ♂/♀ and an online dot. It walks up to your pet, says hi, and looks at your mouse when you point at it.</a:t>
             </a:r>
           </a:p>
           <a:p>
@@ -8465,7 +8465,7 @@
                 </a:solidFill>
                 <a:latin typeface="Segoe UI"/>
               </a:rPr>
-              <a:t>Water animals swim along the taskbar (their water) and every now and then leap high out of it in a big arc, diving back in with a splash, ripples and spray. Drop one anywhere and it dives back into the water.</a:t>
+              <a:t>Point at the visitor (or click its name tag) to open its card: whose pet it is, level, how close you two are, and buttons to wave, pet it, give it a snack, visit back or chat. It reacts to everything - hearts, crumbs, happy faces - and your friend sees it too.</a:t>
             </a:r>
           </a:p>
           <a:p>
@@ -8490,32 +8490,7 @@
                 </a:solidFill>
                 <a:latin typeface="Segoe UI"/>
               </a:rPr>
-              <a:t>Flying animals fly anywhere on the screen: they flutter from place to place, hover, come say hi near your mouse, and sometimes perch on the taskbar or a window edge for a rest. Point at one and it waits for you; they glide down to a perch before a nap.</a:t>
-            </a:r>
-          </a:p>
-          <a:p>
-            <a:pPr>
-              <a:spcAft>
-                <a:spcPts val="1000"/>
-              </a:spcAft>
-            </a:pPr>
-            <a:r>
-              <a:rPr sz="1700" b="1">
-                <a:solidFill>
-                  <a:srgbClr val="4CB86B"/>
-                </a:solidFill>
-                <a:latin typeface="Segoe UI"/>
-              </a:rPr>
-              <a:t>•  </a:t>
-            </a:r>
-            <a:r>
-              <a:rPr sz="1700">
-                <a:solidFill>
-                  <a:srgbClr val="2B2A28"/>
-                </a:solidFill>
-                <a:latin typeface="Segoe UI"/>
-              </a:rPr>
-              <a:t>New menu moves: Jump onto a window, Splash jump!, Fly around / Rest on the taskbar. "Move around by myself" in Pet settings keeps your pet still if you prefer (the old Gravity option is gone - land animals always fall now).</a:t>
+              <a:t>Rub your mouse over the visitor to pet it. Playing with it makes it stay longer, and your pet comes down from a window or the sky to meet it.</a:t>
             </a:r>
           </a:p>
         </p:txBody>
@@ -8646,7 +8621,7 @@
                 </a:solidFill>
                 <a:latin typeface="Segoe UI"/>
               </a:rPr>
-              <a:t>Hewan darat sekarang berjalan di taskbar dan di atas jendela yang terbuka: mereka melompat ke tepi jendela, berjalan di atasnya, ikut bergerak saat jendela dipindahkan, dan turun saat jendela ditutup, tertutup, atau dimaksimalkan. Mereka selalu punya gravitasi - lepaskan di udara dan ia mendarat di jendela di bawahnya atau di taskbar.</a:t>
+              <a:t>Saat peliharaan teman datang berkunjung, sekarang ia memakai papan nama: nama temanmu (atau julukan yang kamu berikan), ♂/♀ dan titik status online. Ia berjalan mendekati pet-mu, menyapa, dan melihat ke arah mouse saat kamu mengarahkannya.</a:t>
             </a:r>
           </a:p>
           <a:p>
@@ -8671,7 +8646,7 @@
                 </a:solidFill>
                 <a:latin typeface="Segoe UI"/>
               </a:rPr>
-              <a:t>Hewan air berenang di taskbar (airnya) dan sesekali melompat tinggi membentuk lengkungan besar, lalu menyelam kembali dengan cipratan, riak, dan percikan. Lepaskan di mana saja dan ia menyelam kembali ke air.</a:t>
+              <a:t>Arahkan mouse ke pengunjung (atau klik papan namanya) untuk membuka kartunya: pet milik siapa, level, seberapa dekat kalian, dan tombol untuk menyapa, mengelus, memberi camilan, balas berkunjung, atau chat. Ia bereaksi pada semuanya - hati, remah, wajah senang - dan temanmu juga melihatnya.</a:t>
             </a:r>
           </a:p>
           <a:p>
@@ -8696,32 +8671,7 @@
                 </a:solidFill>
                 <a:latin typeface="Segoe UI"/>
               </a:rPr>
-              <a:t>Hewan terbang bisa terbang ke mana saja di layar: berpindah-pindah, melayang, menyapa di dekat mouse-mu, dan kadang hinggap di taskbar atau tepi jendela untuk istirahat. Arahkan mouse ke atasnya dan ia menunggu; sebelum tidur ia turun ke tempat hinggap.</a:t>
-            </a:r>
-          </a:p>
-          <a:p>
-            <a:pPr>
-              <a:spcAft>
-                <a:spcPts val="500"/>
-              </a:spcAft>
-            </a:pPr>
-            <a:r>
-              <a:rPr sz="1200" b="1">
-                <a:solidFill>
-                  <a:srgbClr val="4CB86B"/>
-                </a:solidFill>
-                <a:latin typeface="Segoe UI"/>
-              </a:rPr>
-              <a:t>•  </a:t>
-            </a:r>
-            <a:r>
-              <a:rPr sz="1200">
-                <a:solidFill>
-                  <a:srgbClr val="2B2A28"/>
-                </a:solidFill>
-                <a:latin typeface="Segoe UI"/>
-              </a:rPr>
-              <a:t>Gerakan baru di menu: Lompat ke atas jendela, Lompat cipratan!, Terbang berkeliling / Istirahat di taskbar. "Bergerak sendiri" di Pengaturan pet membuat pet diam jika kamu mau (opsi Gravitasi lama dihapus - hewan darat sekarang selalu jatuh).</a:t>
+              <a:t>Gosok-gosokkan mouse di atas pengunjung untuk mengelusnya. Makin sering diajak main, makin lama ia tinggal, dan pet-mu turun dari jendela atau langit untuk menyambutnya.</a:t>
             </a:r>
           </a:p>
         </p:txBody>
@@ -8953,7 +8903,7 @@
         </p:nvGraphicFramePr>
         <p:xfrm>
           <a:off x="548640" y="1645920"/>
-          <a:ext cx="11155680" cy="25072848"/>
+          <a:ext cx="11155680" cy="25895808"/>
         </p:xfrm>
         <a:graphic>
           <a:graphicData uri="http://schemas.openxmlformats.org/drawingml/2006/table">
@@ -9047,7 +8997,7 @@
                           </a:solidFill>
                           <a:latin typeface="Segoe UI"/>
                         </a:rPr>
-                        <a:t>2.19.0</a:t>
+                        <a:t>2.20.0</a:t>
                       </a:r>
                     </a:p>
                   </a:txBody>
@@ -9091,7 +9041,7 @@
                           </a:solidFill>
                           <a:latin typeface="Segoe UI"/>
                         </a:rPr>
-                        <a:t>Land, sea &amp; sky</a:t>
+                        <a:t>Come over</a:t>
                       </a:r>
                     </a:p>
                     <a:p>
@@ -9102,7 +9052,7 @@
                           </a:solidFill>
                           <a:latin typeface="Segoe UI"/>
                         </a:rPr>
-                        <a:t>Land animals walk on the taskbar and on top of your open windows now: they jump up onto window edges, walk along them, ride along when you move the window and hop down when it closes, gets covered or is maximised. They always have gravity - let go of one in mid-air and it lands on the window below or on the taskbar.; Water animals swim along the taskbar (their water) and every now and then leap high out of it in a big arc, diving back in with a splash, ripples and spray. Drop one anywhere and it dives back into the water.; Flying animals fly anywhere on the screen: they flutter from place to place, hover, come say hi near your mouse, and sometimes perch on the taskbar or a window edge for a rest. Point at one and it waits for you; they glide down to a perch before a nap.; New menu moves: Jump onto a window, Splash jump!, Fly around / Rest on the taskbar. "Move around by myself" in Pet settings keeps your pet still if you prefer (the old Gravity option is gone - land animals always fall now).</a:t>
+                        <a:t>When a friend's pet comes over it now wears a name tag: your friend's name (or the nickname you gave them), ♂/♀ and an online dot. It walks up to your pet, says hi, and looks at your mouse when you point at it.; Point at the visitor (or click its name tag) to open its card: whose pet it is, level, how close you two are, and buttons to wave, pet it, give it a snack, visit back or chat. It reacts to everything - hearts, crumbs, happy faces - and your friend sees it too.; Rub your mouse over the visitor to pet it. Playing with it makes it stay longer, and your pet comes down from a window or the sky to meet it.</a:t>
                       </a:r>
                     </a:p>
                   </a:txBody>
@@ -9126,7 +9076,7 @@
                           </a:solidFill>
                           <a:latin typeface="Segoe UI"/>
                         </a:rPr>
-                        <a:t>2.18.0</a:t>
+                        <a:t>2.19.0</a:t>
                       </a:r>
                     </a:p>
                   </a:txBody>
@@ -9170,7 +9120,7 @@
                           </a:solidFill>
                           <a:latin typeface="Segoe UI"/>
                         </a:rPr>
-                        <a:t>Raise your pet</a:t>
+                        <a:t>Land, sea &amp; sky</a:t>
                       </a:r>
                     </a:p>
                     <a:p>
@@ -9181,7 +9131,7 @@
                           </a:solidFill>
                           <a:latin typeface="Segoe UI"/>
                         </a:rPr>
-                        <a:t>Boy or girl? Pick your pet's gender in Settings: boys get a little hair tuft, girls a pink bow and eyelashes, and a ♂ / ♀ shows next to its name. You can add your own gender to your profile too - friends see a small ♂ / ♀ next to your name.; Pets grow up now: baby → child → teen → grown-up. Focus sessions, opening Pips each day, games and cuddles help them grow - no care mistakes, no bad endings. Already have a grown-up pet? It will ask whether you'd like to raise it again from a baby (coins, items and stats stay).; Sick days: work 2.5 hours without a 5-minute break and your pet catches a little cold (sneezes, thermometer, slow steps). A short break cures it - or give medicine from the menu. You can turn this off in Settings.; New mini-game Left or Right? (pet menu → Play): guess which way your pet will look - 3 out of 5 wins, with coins for your first wins each day.</a:t>
+                        <a:t>Land animals walk on the taskbar and on top of your open windows now: they jump up onto window edges, walk along them, ride along when you move the window and hop down when it closes, gets covered or is maximised. They always have gravity - let go of one in mid-air and it lands on the window below or on the taskbar.; Water animals swim along the taskbar (their water) and every now and then leap high out of it in a big arc, diving back in with a splash, ripples and spray. Drop one anywhere and it dives back into the water.; Flying animals fly anywhere on the screen: they flutter from place to place, hover, come say hi near your mouse, and sometimes perch on the taskbar or a window edge for a rest. Point at one and it waits for you; they glide down to a perch before a nap.; New menu moves: Jump onto a window, Splash jump!, Fly around / Rest on the taskbar. "Move around by myself" in Pet settings keeps your pet still if you prefer (the old Gravity option is gone - land animals always fall now).</a:t>
                       </a:r>
                     </a:p>
                   </a:txBody>
@@ -9205,7 +9155,7 @@
                           </a:solidFill>
                           <a:latin typeface="Segoe UI"/>
                         </a:rPr>
-                        <a:t>2.17.0</a:t>
+                        <a:t>2.18.0</a:t>
                       </a:r>
                     </a:p>
                   </a:txBody>
@@ -9249,7 +9199,7 @@
                           </a:solidFill>
                           <a:latin typeface="Segoe UI"/>
                         </a:rPr>
-                        <a:t>Find your pet anytime</a:t>
+                        <a:t>Raise your pet</a:t>
                       </a:r>
                     </a:p>
                     <a:p>
@@ -9260,7 +9210,7 @@
                           </a:solidFill>
                           <a:latin typeface="Segoe UI"/>
                         </a:rPr>
-                        <a:t>Pips now has an icon next to the clock: click it to bring your pet back; right-click for the focus timer, Friends &amp; chat or Quit.; Press Ctrl+Alt+P anywhere to call your pet - it pops up on the screen you're using, even if it was hidden, asleep or behind a fullscreen app.; Opening Pips again from the Start menu or desktop does the same, and your pet walks back by itself if it ever ends up off-screen (e.g. after unplugging a monitor).; Hiding your pet now tells you how to bring it back.</a:t>
+                        <a:t>Boy or girl? Pick your pet's gender in Settings: boys get a little hair tuft, girls a pink bow and eyelashes, and a ♂ / ♀ shows next to its name. You can add your own gender to your profile too - friends see a small ♂ / ♀ next to your name.; Pets grow up now: baby → child → teen → grown-up. Focus sessions, opening Pips each day, games and cuddles help them grow - no care mistakes, no bad endings. Already have a grown-up pet? It will ask whether you'd like to raise it again from a baby (coins, items and stats stay).; Sick days: work 2.5 hours without a 5-minute break and your pet catches a little cold (sneezes, thermometer, slow steps). A short break cures it - or give medicine from the menu. You can turn this off in Settings.; New mini-game Left or Right? (pet menu → Play): guess which way your pet will look - 3 out of 5 wins, with coins for your first wins each day.</a:t>
                       </a:r>
                     </a:p>
                   </a:txBody>
@@ -9284,7 +9234,7 @@
                           </a:solidFill>
                           <a:latin typeface="Segoe UI"/>
                         </a:rPr>
-                        <a:t>2.16.0</a:t>
+                        <a:t>2.17.0</a:t>
                       </a:r>
                     </a:p>
                   </a:txBody>
@@ -9328,7 +9278,7 @@
                           </a:solidFill>
                           <a:latin typeface="Segoe UI"/>
                         </a:rPr>
-                        <a:t>Pips Community</a:t>
+                        <a:t>Find your pet anytime</a:t>
                       </a:r>
                     </a:p>
                     <a:p>
@@ -9339,7 +9289,7 @@
                           </a:solidFill>
                           <a:latin typeface="Segoe UI"/>
                         </a:rPr>
-                        <a:t>New Pips Community at the top of the Chat tab: a #general channel to chat with everyone who uses Pips, plus #announcements with news from the Pips team.; Every new Pips version is announced there automatically - see what's new and update with one click.; Type @name to ping someone in #general. Mute #general any time; owner and moderators can remove messages.; Open it from your pet's menu too (Pips Community). Fixed: chats no longer clear what you're typing when Pips refreshes in the background.</a:t>
+                        <a:t>Pips now has an icon next to the clock: click it to bring your pet back; right-click for the focus timer, Friends &amp; chat or Quit.; Press Ctrl+Alt+P anywhere to call your pet - it pops up on the screen you're using, even if it was hidden, asleep or behind a fullscreen app.; Opening Pips again from the Start menu or desktop does the same, and your pet walks back by itself if it ever ends up off-screen (e.g. after unplugging a monitor).; Hiding your pet now tells you how to bring it back.</a:t>
                       </a:r>
                     </a:p>
                   </a:txBody>
@@ -9363,7 +9313,7 @@
                           </a:solidFill>
                           <a:latin typeface="Segoe UI"/>
                         </a:rPr>
-                        <a:t>2.15.0</a:t>
+                        <a:t>2.16.0</a:t>
                       </a:r>
                     </a:p>
                   </a:txBody>
@@ -9407,7 +9357,7 @@
                           </a:solidFill>
                           <a:latin typeface="Segoe UI"/>
                         </a:rPr>
-                        <a:t>Update reminders</a:t>
+                        <a:t>Pips Community</a:t>
                       </a:r>
                     </a:p>
                     <a:p>
@@ -9418,7 +9368,7 @@
                           </a:solidFill>
                           <a:latin typeface="Segoe UI"/>
                         </a:rPr>
-                        <a:t>Owner &amp; moderators: the Mod tab now lists who hasn't updated Pips yet (their version and when they were last seen), with one-click reminders by e-mail (sent from your Outlook) or a ready-to-send Teams chat.; New Work e-mail field in your Profile, filled in from Outlook. Only the owner and moderators can see it (for update reminders and support) - clear it to hide it.; Pips now tells the Friends server which version it runs, so the update list is always accurate.; Friends keeps working when a local proxy tool stops answering - Pips falls back to the Windows proxy settings.</a:t>
+                        <a:t>New Pips Community at the top of the Chat tab: a #general channel to chat with everyone who uses Pips, plus #announcements with news from the Pips team.; Every new Pips version is announced there automatically - see what's new and update with one click.; Type @name to ping someone in #general. Mute #general any time; owner and moderators can remove messages.; Open it from your pet's menu too (Pips Community). Fixed: chats no longer clear what you're typing when Pips refreshes in the background.</a:t>
                       </a:r>
                     </a:p>
                   </a:txBody>
@@ -9442,7 +9392,7 @@
                           </a:solidFill>
                           <a:latin typeface="Segoe UI"/>
                         </a:rPr>
-                        <a:t>2.14.3</a:t>
+                        <a:t>2.15.0</a:t>
                       </a:r>
                     </a:p>
                   </a:txBody>
@@ -9486,7 +9436,7 @@
                           </a:solidFill>
                           <a:latin typeface="Segoe UI"/>
                         </a:rPr>
-                        <a:t>Tidy menus</a:t>
+                        <a:t>Update reminders</a:t>
                       </a:r>
                     </a:p>
                     <a:p>
@@ -9497,7 +9447,7 @@
                           </a:solidFill>
                           <a:latin typeface="Segoe UI"/>
                         </a:rPr>
-                        <a:t>Fixed: a submenu (e.g. Poke a friend) could stay floating on the screen after the right-click menu closed.; Menus now close by themselves when you move the mouse away and leave them for a few seconds.</a:t>
+                        <a:t>Owner &amp; moderators: the Mod tab now lists who hasn't updated Pips yet (their version and when they were last seen), with one-click reminders by e-mail (sent from your Outlook) or a ready-to-send Teams chat.; New Work e-mail field in your Profile, filled in from Outlook. Only the owner and moderators can see it (for update reminders and support) - clear it to hide it.; Pips now tells the Friends server which version it runs, so the update list is always accurate.; Friends keeps working when a local proxy tool stops answering - Pips falls back to the Windows proxy settings.</a:t>
                       </a:r>
                     </a:p>
                   </a:txBody>
@@ -9521,7 +9471,7 @@
                           </a:solidFill>
                           <a:latin typeface="Segoe UI"/>
                         </a:rPr>
-                        <a:t>2.14.2</a:t>
+                        <a:t>2.14.3</a:t>
                       </a:r>
                     </a:p>
                   </a:txBody>
@@ -9565,7 +9515,7 @@
                           </a:solidFill>
                           <a:latin typeface="Segoe UI"/>
                         </a:rPr>
-                        <a:t>Never miss an update</a:t>
+                        <a:t>Tidy menus</a:t>
                       </a:r>
                     </a:p>
                     <a:p>
@@ -9576,7 +9526,7 @@
                           </a:solidFill>
                           <a:latin typeface="Segoe UI"/>
                         </a:rPr>
-                        <a:t>Your pet now reminds you every 2 hours while a new version is waiting (instead of every 6 hours).; If the reminder can't show (fullscreen app, guided tour, another message), your pet tries again a few minutes later.; No internet when Pips starts (e.g. VPN off)? It checks again after an hour.</a:t>
+                        <a:t>Fixed: a submenu (e.g. Poke a friend) could stay floating on the screen after the right-click menu closed.; Menus now close by themselves when you move the mouse away and leave them for a few seconds.</a:t>
                       </a:r>
                     </a:p>
                   </a:txBody>
@@ -9600,7 +9550,7 @@
                           </a:solidFill>
                           <a:latin typeface="Segoe UI"/>
                         </a:rPr>
-                        <a:t>2.14.1</a:t>
+                        <a:t>2.14.2</a:t>
                       </a:r>
                     </a:p>
                   </a:txBody>
@@ -9644,7 +9594,7 @@
                           </a:solidFill>
                           <a:latin typeface="Segoe UI"/>
                         </a:rPr>
-                        <a:t>One pet at a time</a:t>
+                        <a:t>Never miss an update</a:t>
                       </a:r>
                     </a:p>
                     <a:p>
@@ -9655,7 +9605,7 @@
                           </a:solidFill>
                           <a:latin typeface="Segoe UI"/>
                         </a:rPr>
-                        <a:t>Opening Pips again (Desktop / Start Menu shortcut, autostart) no longer starts a second pet - your pet just pops up and says hi.; Fixes lag caused by two copies of Pips running at once.</a:t>
+                        <a:t>Your pet now reminds you every 2 hours while a new version is waiting (instead of every 6 hours).; If the reminder can't show (fullscreen app, guided tour, another message), your pet tries again a few minutes later.; No internet when Pips starts (e.g. VPN off)? It checks again after an hour.</a:t>
                       </a:r>
                     </a:p>
                   </a:txBody>
@@ -9679,7 +9629,7 @@
                           </a:solidFill>
                           <a:latin typeface="Segoe UI"/>
                         </a:rPr>
-                        <a:t>2.14.0</a:t>
+                        <a:t>2.14.1</a:t>
                       </a:r>
                     </a:p>
                   </a:txBody>
@@ -9723,7 +9673,7 @@
                           </a:solidFill>
                           <a:latin typeface="Segoe UI"/>
                         </a:rPr>
-                        <a:t>Pokes, tickles &amp; teases</a:t>
+                        <a:t>One pet at a time</a:t>
                       </a:r>
                     </a:p>
                     <a:p>
@@ -9734,7 +9684,7 @@
                           </a:solidFill>
                           <a:latin typeface="Segoe UI"/>
                         </a:rPr>
-                        <a:t>Poke, tickle, tease, boop or hug a friend from afar - no pet visit needed.; Right-click your pet → Poke a friend, or use the Poke button in Friends, chat and profiles.; Your friend gets a pop-up ("Wendy is teasing you!"), their pet reacts, and they can poke back with one click.; During a focus session pokes wait quietly until your break; when your pet is hidden they show in the screen corner.</a:t>
+                        <a:t>Opening Pips again (Desktop / Start Menu shortcut, autostart) no longer starts a second pet - your pet just pops up and says hi.; Fixes lag caused by two copies of Pips running at once.</a:t>
                       </a:r>
                     </a:p>
                   </a:txBody>
@@ -9758,7 +9708,7 @@
                           </a:solidFill>
                           <a:latin typeface="Segoe UI"/>
                         </a:rPr>
-                        <a:t>2.13.1</a:t>
+                        <a:t>2.14.0</a:t>
                       </a:r>
                     </a:p>
                   </a:txBody>
@@ -9780,7 +9730,7 @@
                           </a:solidFill>
                           <a:latin typeface="Segoe UI"/>
                         </a:rPr>
-                        <a:t>2026-10-28</a:t>
+                        <a:t>2026-10-29</a:t>
                       </a:r>
                     </a:p>
                   </a:txBody>
@@ -9802,7 +9752,7 @@
                           </a:solidFill>
                           <a:latin typeface="Segoe UI"/>
                         </a:rPr>
-                        <a:t>One-click Windows installer</a:t>
+                        <a:t>Pokes, tickles &amp; teases</a:t>
                       </a:r>
                     </a:p>
                     <a:p>
@@ -9813,7 +9763,7 @@
                           </a:solidFill>
                           <a:latin typeface="Segoe UI"/>
                         </a:rPr>
-                        <a:t>One Windows installer: no ZIP extraction, Python installation or command line. Download, open and click Install Pips.; Installs for your Windows account without administrator access, adds Desktop and Start Menu shortcuts, and opens Pips automatically.; Reinstalling in the same location keeps your settings and pet progress. Existing ZIP users can keep updating in place from Help → Check for updates.; A simpler download page and updated user guide; the bundled runtime stays separate from small in-app updates.</a:t>
+                        <a:t>Poke, tickle, tease, boop or hug a friend from afar - no pet visit needed.; Right-click your pet → Poke a friend, or use the Poke button in Friends, chat and profiles.; Your friend gets a pop-up ("Wendy is teasing you!"), their pet reacts, and they can poke back with one click.; During a focus session pokes wait quietly until your break; when your pet is hidden they show in the screen corner.</a:t>
                       </a:r>
                     </a:p>
                   </a:txBody>
@@ -9837,7 +9787,7 @@
                           </a:solidFill>
                           <a:latin typeface="Segoe UI"/>
                         </a:rPr>
-                        <a:t>2.13.0</a:t>
+                        <a:t>2.13.1</a:t>
                       </a:r>
                     </a:p>
                   </a:txBody>
@@ -9881,7 +9831,7 @@
                           </a:solidFill>
                           <a:latin typeface="Segoe UI"/>
                         </a:rPr>
-                        <a:t>Birthdays, parties &amp; gifts</a:t>
+                        <a:t>One-click Windows installer</a:t>
                       </a:r>
                     </a:p>
                     <a:p>
@@ -9892,7 +9842,7 @@
                           </a:solidFill>
                           <a:latin typeface="Segoe UI"/>
                         </a:rPr>
-                        <a:t>Set your birthday in Social → Profile (month + day, optionally visible to friends).; On your birthday Pips throws confetti and gives you 100 bonus coins.; Friends tab shows upcoming birthdays; you get reminders 3 days, 1 day and on the day.; Birthday parties: join a friend's party, see who's there, sign the guestbook and celebrate together.</a:t>
+                        <a:t>One Windows installer: no ZIP extraction, Python installation or command line. Download, open and click Install Pips.; Installs for your Windows account without administrator access, adds Desktop and Start Menu shortcuts, and opens Pips automatically.; Reinstalling in the same location keeps your settings and pet progress. Existing ZIP users can keep updating in place from Help → Check for updates.; A simpler download page and updated user guide; the bundled runtime stays separate from small in-app updates.</a:t>
                       </a:r>
                     </a:p>
                   </a:txBody>
@@ -9916,7 +9866,7 @@
                           </a:solidFill>
                           <a:latin typeface="Segoe UI"/>
                         </a:rPr>
-                        <a:t>2.12.0</a:t>
+                        <a:t>2.13.0</a:t>
                       </a:r>
                     </a:p>
                   </a:txBody>
@@ -9960,7 +9910,7 @@
                           </a:solidFill>
                           <a:latin typeface="Segoe UI"/>
                         </a:rPr>
-                        <a:t>Mega update: 28 new animals, 31 shop items, 13 moves</a:t>
+                        <a:t>Birthdays, parties &amp; gifts</a:t>
                       </a:r>
                     </a:p>
                     <a:p>
@@ -9971,7 +9921,7 @@
                           </a:solidFill>
                           <a:latin typeface="Segoe UI"/>
                         </a:rPr>
-                        <a:t>🦁 28 new animals (51 total): lion, tiger, unicorn, deer, sheep, cow, raccoon, red panda, monkey, hedgehog, dino, squirrel, mouse, koala, shark, dolphin, seal, otter, pufferfish, duck, crab, parrot, chick, ladybug, phoenix, pegasus, ghost and flamingo; 🎩 31 new shop items: top hat, cowboy, chef, pirate, Santa, viking, graduation cap, beret, bow, propeller cap, flower crown, nerd glasses, eyepatch, mustache, goggles, masquerade mask, tie, pearls, flower lei, gold chain, balloon, backpack, guitar, shield, butterfly / devil wings and more - plus Premium galaxy crown, galaxy cape and dragon wings; 💃 13 new moves: wave, jump, hearts, sing, yoga, zoomies, cartwheel, juggle, rain dance, breakdance, magic, confetti and the Premium rocket launch; The Shop is now split into sections (Hats, Face, Neck, Back, Moves, Arena gear) with an owned counter for each</a:t>
+                        <a:t>Set your birthday in Social → Profile (month + day, optionally visible to friends).; On your birthday Pips throws confetti and gives you 100 bonus coins.; Friends tab shows upcoming birthdays; you get reminders 3 days, 1 day and on the day.; Birthday parties: join a friend's party, see who's there, sign the guestbook and celebrate together.</a:t>
                       </a:r>
                     </a:p>
                   </a:txBody>
@@ -9995,7 +9945,7 @@
                           </a:solidFill>
                           <a:latin typeface="Segoe UI"/>
                         </a:rPr>
-                        <a:t>2.11.0</a:t>
+                        <a:t>2.12.0</a:t>
                       </a:r>
                     </a:p>
                   </a:txBody>
@@ -10039,7 +9989,7 @@
                           </a:solidFill>
                           <a:latin typeface="Segoe UI"/>
                         </a:rPr>
-                        <a:t>New right-click menus</a:t>
+                        <a:t>Mega update: 28 new animals, 31 shop items, 13 moves</a:t>
                       </a:r>
                     </a:p>
                     <a:p>
@@ -10050,7 +10000,7 @@
                           </a:solidFill>
                           <a:latin typeface="Segoe UI"/>
                         </a:rPr>
-                        <a:t>✨ Brand-new animated right-click menu for your pet: mood &amp; stat bars, quick-action tiles (Friends, Shop, Snack, Pat, Focus, Stats, Sleep, Taskbar), hover effects and smooth fly-out submenus; Pick colours from swatches, switch size with one click and flip Sounds / Dark mode with toggle switches - changes show instantly; Updates are highlighted: a glowing banner and NEW badge appear in the menu when a new version is ready; The focus card's right-click menu got the same new look; keyboard arrows, Enter and Esc work too</a:t>
+                        <a:t>🦁 28 new animals (51 total): lion, tiger, unicorn, deer, sheep, cow, raccoon, red panda, monkey, hedgehog, dino, squirrel, mouse, koala, shark, dolphin, seal, otter, pufferfish, duck, crab, parrot, chick, ladybug, phoenix, pegasus, ghost and flamingo; 🎩 31 new shop items: top hat, cowboy, chef, pirate, Santa, viking, graduation cap, beret, bow, propeller cap, flower crown, nerd glasses, eyepatch, mustache, goggles, masquerade mask, tie, pearls, flower lei, gold chain, balloon, backpack, guitar, shield, butterfly / devil wings and more - plus Premium galaxy crown, galaxy cape and dragon wings; 💃 13 new moves: wave, jump, hearts, sing, yoga, zoomies, cartwheel, juggle, rain dance, breakdance, magic, confetti and the Premium rocket launch; The Shop is now split into sections (Hats, Face, Neck, Back, Moves, Arena gear) with an owned counter for each</a:t>
                       </a:r>
                     </a:p>
                   </a:txBody>
@@ -10074,7 +10024,7 @@
                           </a:solidFill>
                           <a:latin typeface="Segoe UI"/>
                         </a:rPr>
-                        <a:t>2.10.0</a:t>
+                        <a:t>2.11.0</a:t>
                       </a:r>
                     </a:p>
                   </a:txBody>
@@ -10118,7 +10068,7 @@
                           </a:solidFill>
                           <a:latin typeface="Segoe UI"/>
                         </a:rPr>
-                        <a:t>Chat bots</a:t>
+                        <a:t>New right-click menus</a:t>
                       </a:r>
                     </a:p>
                     <a:p>
@@ -10129,7 +10079,7 @@
                           </a:solidFill>
                           <a:latin typeface="Segoe UI"/>
                         </a:rPr>
-                        <a:t>🤖 6 friendly chat bots in the Chat tab: Pip Helper (app questions), Coach Focus (focus tips from your real stats), Sunny (live weather for any city), Arena Master (battle tips + quick battle), Giggles (jokes &amp; games) and Guardian (safety &amp; reporting help); Private bot chats with suggestion chips, typing indicator and a clear button - your bot chats stay on your PC; Mention a bot in a group chat (e.g. @weather Batam) and it answers in the room for everyone; Bots reply in your app language; up to 120 bot messages per day</a:t>
+                        <a:t>✨ Brand-new animated right-click menu for your pet: mood &amp; stat bars, quick-action tiles (Friends, Shop, Snack, Pat, Focus, Stats, Sleep, Taskbar), hover effects and smooth fly-out submenus; Pick colours from swatches, switch size with one click and flip Sounds / Dark mode with toggle switches - changes show instantly; Updates are highlighted: a glowing banner and NEW badge appear in the menu when a new version is ready; The focus card's right-click menu got the same new look; keyboard arrows, Enter and Esc work too</a:t>
                       </a:r>
                     </a:p>
                   </a:txBody>
@@ -10153,7 +10103,7 @@
                           </a:solidFill>
                           <a:latin typeface="Segoe UI"/>
                         </a:rPr>
-                        <a:t>2.9.0</a:t>
+                        <a:t>2.10.0</a:t>
                       </a:r>
                     </a:p>
                   </a:txBody>
@@ -10197,7 +10147,7 @@
                           </a:solidFill>
                           <a:latin typeface="Segoe UI"/>
                         </a:rPr>
-                        <a:t>Location &amp; live weather</a:t>
+                        <a:t>Chat bots</a:t>
                       </a:r>
                     </a:p>
                     <a:p>
@@ -10208,7 +10158,7 @@
                           </a:solidFill>
                           <a:latin typeface="Segoe UI"/>
                         </a:rPr>
-                        <a:t>📍 Add your city in Profile → Location &amp; weather (auto-detect or search) - only your city and country are shown, never your exact position; Live weather banners on every profile with animations: rain, drizzle, thunderstorms with lightning, snow, fog, clouds, sunshine or a starry night - plus temperature, feels-like, humidity, wind and local time; Your own weather strip on top of the hub, and each friend's weather + local time in the friends list; Hide your location from others or remove it any time</a:t>
+                        <a:t>🤖 6 friendly chat bots in the Chat tab: Pip Helper (app questions), Coach Focus (focus tips from your real stats), Sunny (live weather for any city), Arena Master (battle tips + quick battle), Giggles (jokes &amp; games) and Guardian (safety &amp; reporting help); Private bot chats with suggestion chips, typing indicator and a clear button - your bot chats stay on your PC; Mention a bot in a group chat (e.g. @weather Batam) and it answers in the room for everyone; Bots reply in your app language; up to 120 bot messages per day</a:t>
                       </a:r>
                     </a:p>
                   </a:txBody>
@@ -10232,7 +10182,7 @@
                           </a:solidFill>
                           <a:latin typeface="Segoe UI"/>
                         </a:rPr>
-                        <a:t>2.8.0</a:t>
+                        <a:t>2.9.0</a:t>
                       </a:r>
                     </a:p>
                   </a:txBody>
@@ -10276,7 +10226,7 @@
                           </a:solidFill>
                           <a:latin typeface="Segoe UI"/>
                         </a:rPr>
-                        <a:t>Pips Arena - duels, gear &amp; live battles</a:t>
+                        <a:t>Location &amp; live weather</a:t>
                       </a:r>
                     </a:p>
                     <a:p>
@@ -10287,7 +10237,7 @@
                           </a:solidFill>
                           <a:latin typeface="Segoe UI"/>
                         </a:rPr>
-                        <a:t>⚔ New Arena tab: challenge friends or anyone in the arena to a live duel - each round pick Attack, Guard or Special within 12 seconds and watch your pets fight; ⚡ Quick battle: an instant auto-fight against anyone's fighter, even when they're offline; Arena gear in the Shop: 7 weapons (water pistol to rocket launcher), 5 armors and 5 gadgets that decide your special move - better gear and a higher level make a stronger fighter; Live duels can be watched by everyone, plus recent battle replays, top fighters, rating and win/loss records; wins earn coins</a:t>
+                        <a:t>📍 Add your city in Profile → Location &amp; weather (auto-detect or search) - only your city and country are shown, never your exact position; Live weather banners on every profile with animations: rain, drizzle, thunderstorms with lightning, snow, fog, clouds, sunshine or a starry night - plus temperature, feels-like, humidity, wind and local time; Your own weather strip on top of the hub, and each friend's weather + local time in the friends list; Hide your location from others or remove it any time</a:t>
                       </a:r>
                     </a:p>
                   </a:txBody>
@@ -10311,7 +10261,7 @@
                           </a:solidFill>
                           <a:latin typeface="Segoe UI"/>
                         </a:rPr>
-                        <a:t>2.7.0</a:t>
+                        <a:t>2.8.0</a:t>
                       </a:r>
                     </a:p>
                   </a:txBody>
@@ -10355,7 +10305,7 @@
                           </a:solidFill>
                           <a:latin typeface="Segoe UI"/>
                         </a:rPr>
-                        <a:t>Moderators &amp; Premium</a:t>
+                        <a:t>Pips Arena - duels, gear &amp; live battles</a:t>
                       </a:r>
                     </a:p>
                     <a:p>
@@ -10366,7 +10316,7 @@
                           </a:solidFill>
                           <a:latin typeface="Segoe UI"/>
                         </a:rPr>
-                        <a:t>★ Premium: a purple Premium badge, 4 exclusive props (tiara, star glasses, diamond necklace, fairy wings), the Fireworks move, +30 coins every day, double friend-interaction coins and room for 300 friends / 30 groups; Get Premium: Profile tab → Premium → "Ask to buy" emails the owner; after payment you receive a key (PIPS-XXXX-XXXX) to redeem right there; 🛡 Moderators: a blue Mod badge and a Mod tab with the report queue - warn, mute (1h / 24h / 7 days), clear a profile or reset a name; every action is logged; Report button on everyone's profile, so moderators can keep Pips friendly</a:t>
+                        <a:t>⚔ New Arena tab: challenge friends or anyone in the arena to a live duel - each round pick Attack, Guard or Special within 12 seconds and watch your pets fight; ⚡ Quick battle: an instant auto-fight against anyone's fighter, even when they're offline; Arena gear in the Shop: 7 weapons (water pistol to rocket launcher), 5 armors and 5 gadgets that decide your special move - better gear and a higher level make a stronger fighter; Live duels can be watched by everyone, plus recent battle replays, top fighters, rating and win/loss records; wins earn coins</a:t>
                       </a:r>
                     </a:p>
                   </a:txBody>
@@ -10390,7 +10340,7 @@
                           </a:solidFill>
                           <a:latin typeface="Segoe UI"/>
                         </a:rPr>
-                        <a:t>2.6.1</a:t>
+                        <a:t>2.7.0</a:t>
                       </a:r>
                     </a:p>
                   </a:txBody>
@@ -10434,7 +10384,7 @@
                           </a:solidFill>
                           <a:latin typeface="Segoe UI"/>
                         </a:rPr>
-                        <a:t>Owner badge &amp; credits</a:t>
+                        <a:t>Moderators &amp; Premium</a:t>
                       </a:r>
                     </a:p>
                     <a:p>
@@ -10445,7 +10395,7 @@
                           </a:solidFill>
                           <a:latin typeface="Segoe UI"/>
                         </a:rPr>
-                        <a:t>The creator of Pips (Juwen Lie) now shows a gold ♛ Owner badge on his profile, friend list and ranks; New About Pips card in the Profile tab: credits and how to contact the owner (Juwen_Lie@pegatroncorp.com) with Email and Copy buttons; Right-click the pet → Help → About now shows who made Pips and the contact email</a:t>
+                        <a:t>★ Premium: a purple Premium badge, 4 exclusive props (tiara, star glasses, diamond necklace, fairy wings), the Fireworks move, +30 coins every day, double friend-interaction coins and room for 300 friends / 30 groups; Get Premium: Profile tab → Premium → "Ask to buy" emails the owner; after payment you receive a key (PIPS-XXXX-XXXX) to redeem right there; 🛡 Moderators: a blue Mod badge and a Mod tab with the report queue - warn, mute (1h / 24h / 7 days), clear a profile or reset a name; every action is logged; Report button on everyone's profile, so moderators can keep Pips friendly</a:t>
                       </a:r>
                     </a:p>
                   </a:txBody>
@@ -10469,7 +10419,7 @@
                           </a:solidFill>
                           <a:latin typeface="Segoe UI"/>
                         </a:rPr>
-                        <a:t>2.6.0</a:t>
+                        <a:t>2.6.1</a:t>
                       </a:r>
                     </a:p>
                   </a:txBody>
@@ -10513,7 +10463,7 @@
                           </a:solidFill>
                           <a:latin typeface="Segoe UI"/>
                         </a:rPr>
-                        <a:t>Profiles, ranks, online status &amp; dark mode</a:t>
+                        <a:t>Owner badge &amp; credits</a:t>
                       </a:r>
                     </a:p>
                     <a:p>
@@ -10524,7 +10474,7 @@
                           </a:solidFill>
                           <a:latin typeface="Segoe UI"/>
                         </a:rPr>
-                        <a:t>Profile tab: profile picture (or your pet), about me, job, location, hobbies, birthday and a status message; Public or private: public profiles can be added directly and viewed in full; private profiles need a friend request that they accept, and strangers only see name, photo, pet, level and status; Click anyone to open their profile - badges, info, their friends - and add them, chat or wave from there; Ranks tab replaces Teams: everyone using Pips, sorted by XP, badges or streak</a:t>
+                        <a:t>The creator of Pips (Juwen Lie) now shows a gold ♛ Owner badge on his profile, friend list and ranks; New About Pips card in the Profile tab: credits and how to contact the owner (Juwen_Lie@pegatroncorp.com) with Email and Copy buttons; Right-click the pet → Help → About now shows who made Pips and the contact email</a:t>
                       </a:r>
                     </a:p>
                   </a:txBody>
@@ -10548,7 +10498,7 @@
                           </a:solidFill>
                           <a:latin typeface="Segoe UI"/>
                         </a:rPr>
-                        <a:t>2.5.1</a:t>
+                        <a:t>2.6.0</a:t>
                       </a:r>
                     </a:p>
                   </a:txBody>
@@ -10592,7 +10542,7 @@
                           </a:solidFill>
                           <a:latin typeface="Segoe UI"/>
                         </a:rPr>
-                        <a:t>New cute Pips logo</a:t>
+                        <a:t>Profiles, ranks, online status &amp; dark mode</a:t>
                       </a:r>
                     </a:p>
                     <a:p>
@@ -10603,7 +10553,7 @@
                           </a:solidFill>
                           <a:latin typeface="Segoe UI"/>
                         </a:rPr>
-                        <a:t>New Pips logo: Pip the cat on a Pips-red tile, matching the app colours (desktop shortcut, windows and website)</a:t>
+                        <a:t>Profile tab: profile picture (or your pet), about me, job, location, hobbies, birthday and a status message; Public or private: public profiles can be added directly and viewed in full; private profiles need a friend request that they accept, and strangers only see name, photo, pet, level and status; Click anyone to open their profile - badges, info, their friends - and add them, chat or wave from there; Ranks tab replaces Teams: everyone using Pips, sorted by XP, badges or streak</a:t>
                       </a:r>
                     </a:p>
                   </a:txBody>
@@ -10627,7 +10577,7 @@
                           </a:solidFill>
                           <a:latin typeface="Segoe UI"/>
                         </a:rPr>
-                        <a:t>2.5.0</a:t>
+                        <a:t>2.5.1</a:t>
                       </a:r>
                     </a:p>
                   </a:txBody>
@@ -10671,7 +10621,7 @@
                           </a:solidFill>
                           <a:latin typeface="Segoe UI"/>
                         </a:rPr>
-                        <a:t>Shop, coins, props &amp; moves</a:t>
+                        <a:t>New cute Pips logo</a:t>
                       </a:r>
                     </a:p>
                     <a:p>
@@ -10682,7 +10632,7 @@
                           </a:solidFill>
                           <a:latin typeface="Segoe UI"/>
                         </a:rPr>
-                        <a:t>Shop: earn coins and spend them on your pet - 17 props (crown, wizard hat, headphones, shades, scarf, cape, angel wings...) and 6 moves: spin, dance, moonwalk, backflip, kung fu and spider swing!; Coins come from leveling up (+40), badges (+25), opening Pips each day (+10), friendships (+15 per affinity level), waving / chatting / visiting friends (+2) and pomodoros (+5). Everyone starts with a 100-coin gift; Your friends see your props: on avatars in the hub and when your pet visits their desktop - it shows off one of your moves; Pips is now a social pet: clicking the pet opens the Pips hub (friends, chat, groups, shop, badges)</a:t>
+                        <a:t>New Pips logo: Pip the cat on a Pips-red tile, matching the app colours (desktop shortcut, windows and website)</a:t>
                       </a:r>
                     </a:p>
                   </a:txBody>
@@ -10706,7 +10656,7 @@
                           </a:solidFill>
                           <a:latin typeface="Segoe UI"/>
                         </a:rPr>
-                        <a:t>2.4.0</a:t>
+                        <a:t>2.5.0</a:t>
                       </a:r>
                     </a:p>
                   </a:txBody>
@@ -10750,7 +10700,7 @@
                           </a:solidFill>
                           <a:latin typeface="Segoe UI"/>
                         </a:rPr>
-                        <a:t>Chat, groups, affinity &amp; pet visits</a:t>
+                        <a:t>Shop, coins, props &amp; moves</a:t>
                       </a:r>
                     </a:p>
                     <a:p>
@@ -10761,7 +10711,7 @@
                           </a:solidFill>
                           <a:latin typeface="Segoe UI"/>
                         </a:rPr>
-                        <a:t>Chat: message your friends, and chat inside groups. Your pet pops up new messages as a bubble - click it to reply; Pet interactions: wave, pet their pet, send a snack, high five - or send your pet to visit: it walks onto your friend's desktop for a little while!; Affinity: every chat and interaction grows your friendship - Acquaintance → Buddy → Good friends → Close friends → Best friends → Soulmates; Your own groups: create a private group, invite your friends, they accept or decline. Group board + group chat; the owner can remove members</a:t>
+                        <a:t>Shop: earn coins and spend them on your pet - 17 props (crown, wizard hat, headphones, shades, scarf, cape, angel wings...) and 6 moves: spin, dance, moonwalk, backflip, kung fu and spider swing!; Coins come from leveling up (+40), badges (+25), opening Pips each day (+10), friendships (+15 per affinity level), waving / chatting / visiting friends (+2) and pomodoros (+5). Everyone starts with a 100-coin gift; Your friends see your props: on avatars in the hub and when your pet visits their desktop - it shows off one of your moves; Pips is now a social pet: clicking the pet opens the Pips hub (friends, chat, groups, shop, badges)</a:t>
                       </a:r>
                     </a:p>
                   </a:txBody>
@@ -10785,7 +10735,7 @@
                           </a:solidFill>
                           <a:latin typeface="Segoe UI"/>
                         </a:rPr>
-                        <a:t>2.3.0</a:t>
+                        <a:t>2.4.0</a:t>
                       </a:r>
                     </a:p>
                   </a:txBody>
@@ -10829,7 +10779,7 @@
                           </a:solidFill>
                           <a:latin typeface="Segoe UI"/>
                         </a:rPr>
-                        <a:t>Friends, levels &amp; achievements</a:t>
+                        <a:t>Chat, groups, affinity &amp; pet visits</a:t>
                       </a:r>
                     </a:p>
                     <a:p>
@@ -10840,7 +10790,7 @@
                           </a:solidFill>
                           <a:latin typeface="Segoe UI"/>
                         </a:rPr>
-                        <a:t>Levels &amp; XP: every finished pomodoro earns XP and your level grows - plus 20 achievements to unlock (first tomato, 8 in a day, 7-day streak, early bird, night owl, pet lover...). Your pet celebrates each one; Friends (optional, off by default): get a 6-letter friend code, add colleagues, see today's board and join a team board like PTB. Your pet tells you when a friend finishes a pomodoro; Privacy: only your name, pet, level, streak and pomodoro counts are shared - never apps, window titles or scores. One click turns it off and deletes your online data. Right-click the pet → Friends &amp; achievements…</a:t>
+                        <a:t>Chat: message your friends, and chat inside groups. Your pet pops up new messages as a bubble - click it to reply; Pet interactions: wave, pet their pet, send a snack, high five - or send your pet to visit: it walks onto your friend's desktop for a little while!; Affinity: every chat and interaction grows your friendship - Acquaintance → Buddy → Good friends → Close friends → Best friends → Soulmates; Your own groups: create a private group, invite your friends, they accept or decline. Group board + group chat; the owner can remove members</a:t>
                       </a:r>
                     </a:p>
                   </a:txBody>
@@ -10864,7 +10814,7 @@
                           </a:solidFill>
                           <a:latin typeface="Segoe UI"/>
                         </a:rPr>
-                        <a:t>2.2.0</a:t>
+                        <a:t>2.3.0</a:t>
                       </a:r>
                     </a:p>
                   </a:txBody>
@@ -10908,7 +10858,7 @@
                           </a:solidFill>
                           <a:latin typeface="Segoe UI"/>
                         </a:rPr>
-                        <a:t>Pet sounds</a:t>
+                        <a:t>Friends, levels &amp; achievements</a:t>
                       </a:r>
                     </a:p>
                     <a:p>
@@ -10919,7 +10869,7 @@
                           </a:solidFill>
                           <a:latin typeface="Segoe UI"/>
                         </a:rPr>
-                        <a:t>Your pet has a voice! Each of the 23 animals has its own sound (meow, woof, ribbit, hoot, buzz, oink, whale song...) and it changes with its mood: happy chirps, sad whimpers, sleepy yawns, hungry calls, grumpy huffs and soft snores; It also reacts with sound when you tickle, pet, feed, shake or wake it; Settings: right-click the pet → Sounds to switch on/off; Pet status &amp; settings has a volume slider, a ▶ Hear me button and "Stay quiet while I'm focusing" (on by default)</a:t>
+                        <a:t>Levels &amp; XP: every finished pomodoro earns XP and your level grows - plus 20 achievements to unlock (first tomato, 8 in a day, 7-day streak, early bird, night owl, pet lover...). Your pet celebrates each one; Friends (optional, off by default): get a 6-letter friend code, add colleagues, see today's board and join a team board like PTB. Your pet tells you when a friend finishes a pomodoro; Privacy: only your name, pet, level, streak and pomodoro counts are shared - never apps, window titles or scores. One click turns it off and deletes your online data. Right-click the pet → Friends &amp; achievements…</a:t>
                       </a:r>
                     </a:p>
                   </a:txBody>
@@ -10943,7 +10893,7 @@
                           </a:solidFill>
                           <a:latin typeface="Segoe UI"/>
                         </a:rPr>
-                        <a:t>2.1.2</a:t>
+                        <a:t>2.2.0</a:t>
                       </a:r>
                     </a:p>
                   </a:txBody>
@@ -10987,7 +10937,7 @@
                           </a:solidFill>
                           <a:latin typeface="Segoe UI"/>
                         </a:rPr>
-                        <a:t>Tickle-only mode</a:t>
+                        <a:t>Pet sounds</a:t>
                       </a:r>
                     </a:p>
                     <a:p>
@@ -10998,7 +10948,7 @@
                           </a:solidFill>
                           <a:latin typeface="Segoe UI"/>
                         </a:rPr>
-                        <a:t>New click option "Only tickle (never open Pips)": click and tickle your pet as much as you like - the Pomodoro window stays closed (open it from the right-click menu). Right-click the pet → When I click</a:t>
+                        <a:t>Your pet has a voice! Each of the 23 animals has its own sound (meow, woof, ribbit, hoot, buzz, oink, whale song...) and it changes with its mood: happy chirps, sad whimpers, sleepy yawns, hungry calls, grumpy huffs and soft snores; It also reacts with sound when you tickle, pet, feed, shake or wake it; Settings: right-click the pet → Sounds to switch on/off; Pet status &amp; settings has a volume slider, a ▶ Hear me button and "Stay quiet while I'm focusing" (on by default)</a:t>
                       </a:r>
                     </a:p>
                   </a:txBody>
@@ -11022,7 +10972,7 @@
                           </a:solidFill>
                           <a:latin typeface="Segoe UI"/>
                         </a:rPr>
-                        <a:t>2.1.1</a:t>
+                        <a:t>2.1.2</a:t>
                       </a:r>
                     </a:p>
                   </a:txBody>
@@ -11066,7 +11016,7 @@
                           </a:solidFill>
                           <a:latin typeface="Segoe UI"/>
                         </a:rPr>
-                        <a:t>Owner info</a:t>
+                        <a:t>Tickle-only mode</a:t>
                       </a:r>
                     </a:p>
                     <a:p>
@@ -11077,7 +11027,7 @@
                           </a:solidFill>
                           <a:latin typeface="Segoe UI"/>
                         </a:rPr>
-                        <a:t>About Pips now shows the owner: Juwen Lie (right-click the pet → Help → About)</a:t>
+                        <a:t>New click option "Only tickle (never open Pips)": click and tickle your pet as much as you like - the Pomodoro window stays closed (open it from the right-click menu). Right-click the pet → When I click</a:t>
                       </a:r>
                     </a:p>
                   </a:txBody>
@@ -11101,7 +11051,7 @@
                           </a:solidFill>
                           <a:latin typeface="Segoe UI"/>
                         </a:rPr>
-                        <a:t>2.1.0</a:t>
+                        <a:t>2.1.1</a:t>
                       </a:r>
                     </a:p>
                   </a:txBody>
@@ -11145,7 +11095,7 @@
                           </a:solidFill>
                           <a:latin typeface="Segoe UI"/>
                         </a:rPr>
-                        <a:t>Interactive guide &amp; in-app updates</a:t>
+                        <a:t>Owner info</a:t>
                       </a:r>
                     </a:p>
                     <a:p>
@@ -11156,7 +11106,7 @@
                           </a:solidFill>
                           <a:latin typeface="Segoe UI"/>
                         </a:rPr>
-                        <a:t>Interactive first-run guide: your pet walks you through clicking, dragging, petting and the right-click menu; In-app updates: Pips tells you when a new version is out - update with one click (your settings and data are kept); New Help menu: replay the guide, check for updates, see the version; Option to turn automatic update checks off</a:t>
+                        <a:t>About Pips now shows the owner: Juwen Lie (right-click the pet → Help → About)</a:t>
                       </a:r>
                     </a:p>
                   </a:txBody>
@@ -11180,7 +11130,7 @@
                           </a:solidFill>
                           <a:latin typeface="Segoe UI"/>
                         </a:rPr>
-                        <a:t>2.0.0</a:t>
+                        <a:t>2.1.0</a:t>
                       </a:r>
                     </a:p>
                   </a:txBody>
@@ -11224,7 +11174,7 @@
                           </a:solidFill>
                           <a:latin typeface="Segoe UI"/>
                         </a:rPr>
-                        <a:t>Desktop pet, 23 animals &amp; 4 languages</a:t>
+                        <a:t>Interactive guide &amp; in-app updates</a:t>
                       </a:r>
                     </a:p>
                     <a:p>
@@ -11235,7 +11185,7 @@
                           </a:solidFill>
                           <a:latin typeface="Segoe UI"/>
                         </a:rPr>
-                        <a:t>Desktop pet that lives on your desktop and taskbar - drag it, tickle it, pet it; 23 animals in 3 groups: Land walks, Water swims with bubbles, Sky hovers and flaps; Moods (happy, sad, tired, hungry, grumpy...), naps when you're away, wakes up when you're back; Cute chat-bubble reminders: breaks, water, 20-20-20 eye rest, pomodoro done, daily goal</a:t>
+                        <a:t>Interactive first-run guide: your pet walks you through clicking, dragging, petting and the right-click menu; In-app updates: Pips tells you when a new version is out - update with one click (your settings and data are kept); New Help menu: replay the guide, check for updates, see the version; Option to turn automatic update checks off</a:t>
                       </a:r>
                     </a:p>
                   </a:txBody>
@@ -11259,7 +11209,7 @@
                           </a:solidFill>
                           <a:latin typeface="Segoe UI"/>
                         </a:rPr>
-                        <a:t>1.5.0</a:t>
+                        <a:t>2.0.0</a:t>
                       </a:r>
                     </a:p>
                   </a:txBody>
@@ -11281,7 +11231,7 @@
                           </a:solidFill>
                           <a:latin typeface="Segoe UI"/>
                         </a:rPr>
-                        <a:t>2026-10-24</a:t>
+                        <a:t>2026-10-28</a:t>
                       </a:r>
                     </a:p>
                   </a:txBody>
@@ -11303,7 +11253,7 @@
                           </a:solidFill>
                           <a:latin typeface="Segoe UI"/>
                         </a:rPr>
-                        <a:t>Renamed to Pips + insights</a:t>
+                        <a:t>Desktop pet, 23 animals &amp; 4 languages</a:t>
                       </a:r>
                     </a:p>
                     <a:p>
@@ -11314,7 +11264,7 @@
                           </a:solidFill>
                           <a:latin typeface="Segoe UI"/>
                         </a:rPr>
-                        <a:t>Renamed from Productivity Widget to Pips; Dashboard charts: focus timeline, hour heatmap, 7-day score trend, pomodoros per day; AI token usage on the card and dashboard; Daily diary export and weekly / monthly reports</a:t>
+                        <a:t>Desktop pet that lives on your desktop and taskbar - drag it, tickle it, pet it; 23 animals in 3 groups: Land walks, Water swims with bubbles, Sky hovers and flaps; Moods (happy, sad, tired, hungry, grumpy...), naps when you're away, wakes up when you're back; Cute chat-bubble reminders: breaks, water, 20-20-20 eye rest, pomodoro done, daily goal</a:t>
                       </a:r>
                     </a:p>
                   </a:txBody>
@@ -11338,7 +11288,7 @@
                           </a:solidFill>
                           <a:latin typeface="Segoe UI"/>
                         </a:rPr>
-                        <a:t>1.0.0</a:t>
+                        <a:t>1.5.0</a:t>
                       </a:r>
                     </a:p>
                   </a:txBody>
@@ -11360,7 +11310,7 @@
                           </a:solidFill>
                           <a:latin typeface="Segoe UI"/>
                         </a:rPr>
-                        <a:t>2026-10-21</a:t>
+                        <a:t>2026-10-24</a:t>
                       </a:r>
                     </a:p>
                   </a:txBody>
@@ -11382,7 +11332,7 @@
                           </a:solidFill>
                           <a:latin typeface="Segoe UI"/>
                         </a:rPr>
-                        <a:t>First release</a:t>
+                        <a:t>Renamed to Pips + insights</a:t>
                       </a:r>
                     </a:p>
                     <a:p>
@@ -11393,13 +11343,92 @@
                           </a:solidFill>
                           <a:latin typeface="Segoe UI"/>
                         </a:rPr>
-                        <a:t>Always-on-top Pomodoro card with progress ring; Rain / thunder / brown-noise / cafe soundscapes; Live app-usage tracking and a daily 1-5 star focus score; Goals, streaks, XP, coach tips and break reminders</a:t>
+                        <a:t>Renamed from Productivity Widget to Pips; Dashboard charts: focus timeline, hour heatmap, 7-day score trend, pomodoros per day; AI token usage on the card and dashboard; Daily diary export and weekly / monthly reports</a:t>
                       </a:r>
                     </a:p>
                   </a:txBody>
                   <a:tcPr marL="73152" marR="73152" marT="36576" marB="36576">
                     <a:solidFill>
                       <a:srgbClr val="F7F4EC"/>
+                    </a:solidFill>
+                  </a:tcPr>
+                </a:tc>
+              </a:tr>
+              <a:tr h="822960">
+                <a:tc>
+                  <a:txBody>
+                    <a:bodyPr wrap="square"/>
+                    <a:lstStyle/>
+                    <a:p>
+                      <a:r>
+                        <a:rPr sz="1200" b="1">
+                          <a:solidFill>
+                            <a:srgbClr val="2B2A28"/>
+                          </a:solidFill>
+                          <a:latin typeface="Segoe UI"/>
+                        </a:rPr>
+                        <a:t>1.0.0</a:t>
+                      </a:r>
+                    </a:p>
+                  </a:txBody>
+                  <a:tcPr marL="73152" marR="73152" marT="36576" marB="36576">
+                    <a:solidFill>
+                      <a:srgbClr val="FFFDF8"/>
+                    </a:solidFill>
+                  </a:tcPr>
+                </a:tc>
+                <a:tc>
+                  <a:txBody>
+                    <a:bodyPr wrap="square"/>
+                    <a:lstStyle/>
+                    <a:p>
+                      <a:r>
+                        <a:rPr sz="1200" b="0">
+                          <a:solidFill>
+                            <a:srgbClr val="2B2A28"/>
+                          </a:solidFill>
+                          <a:latin typeface="Segoe UI"/>
+                        </a:rPr>
+                        <a:t>2026-10-21</a:t>
+                      </a:r>
+                    </a:p>
+                  </a:txBody>
+                  <a:tcPr marL="73152" marR="73152" marT="36576" marB="36576">
+                    <a:solidFill>
+                      <a:srgbClr val="FFFDF8"/>
+                    </a:solidFill>
+                  </a:tcPr>
+                </a:tc>
+                <a:tc>
+                  <a:txBody>
+                    <a:bodyPr wrap="square"/>
+                    <a:lstStyle/>
+                    <a:p>
+                      <a:r>
+                        <a:rPr sz="1200" b="0">
+                          <a:solidFill>
+                            <a:srgbClr val="2B2A28"/>
+                          </a:solidFill>
+                          <a:latin typeface="Segoe UI"/>
+                        </a:rPr>
+                        <a:t>First release</a:t>
+                      </a:r>
+                    </a:p>
+                    <a:p>
+                      <a:r>
+                        <a:rPr sz="1200" b="0">
+                          <a:solidFill>
+                            <a:srgbClr val="2B2A28"/>
+                          </a:solidFill>
+                          <a:latin typeface="Segoe UI"/>
+                        </a:rPr>
+                        <a:t>Always-on-top Pomodoro card with progress ring; Rain / thunder / brown-noise / cafe soundscapes; Live app-usage tracking and a daily 1-5 star focus score; Goals, streaks, XP, coach tips and break reminders</a:t>
+                      </a:r>
+                    </a:p>
+                  </a:txBody>
+                  <a:tcPr marL="73152" marR="73152" marT="36576" marB="36576">
+                    <a:solidFill>
+                      <a:srgbClr val="FFFDF8"/>
                     </a:solidFill>
                   </a:tcPr>
                 </a:tc>

</xml_diff>

<commit_message>
pips 2.21.0: Every animal has a voice
</commit_message>
<xml_diff>
--- a/apps/pips/web/download/Pips-Guide.pptx
+++ b/apps/pips/web/download/Pips-Guide.pptx
@@ -3292,7 +3292,7 @@
                 </a:solidFill>
                 <a:latin typeface="Segoe UI"/>
               </a:rPr>
-              <a:t>Version 2.20.0  ·  2026-10-29  ·  Made by Juwen Lie (owner)</a:t>
+              <a:t>Version 2.21.0  ·  2026-10-29  ·  Made by Juwen Lie (owner)</a:t>
             </a:r>
           </a:p>
           <a:p>
@@ -8279,7 +8279,7 @@
                 </a:solidFill>
                 <a:latin typeface="Segoe UI"/>
               </a:rPr>
-              <a:t>What's new in 2.20.0</a:t>
+              <a:t>What's new in 2.21.0</a:t>
             </a:r>
           </a:p>
         </p:txBody>
@@ -8392,7 +8392,7 @@
                 </a:solidFill>
                 <a:latin typeface="Segoe UI"/>
               </a:rPr>
-              <a:t>Come over  ·  2026-10-29</a:t>
+              <a:t>Every animal has a voice  ·  2026-10-29</a:t>
             </a:r>
           </a:p>
         </p:txBody>
@@ -8440,7 +8440,7 @@
                 </a:solidFill>
                 <a:latin typeface="Segoe UI"/>
               </a:rPr>
-              <a:t>When a friend's pet comes over it now wears a name tag: your friend's name (or the nickname you gave them), ♂/♀ and an online dot. It walks up to your pet, says hi, and looks at your mouse when you point at it.</a:t>
+              <a:t>All 51 animals now have their own sound. Before, more than half of them borrowed the cat's meow - now the dog woofs, the cow moos, the sheep baas, the lion roars, the duck quacks, the dolphin clicks and whistles, the dragon flaps and roars with a puff of fire, the ghost goes wooo... and so on.</a:t>
             </a:r>
           </a:p>
           <a:p>
@@ -8465,7 +8465,7 @@
                 </a:solidFill>
                 <a:latin typeface="Segoe UI"/>
               </a:rPr>
-              <a:t>Point at the visitor (or click its name tag) to open its card: whose pet it is, level, how close you two are, and buttons to wave, pet it, give it a snack, visit back or chat. It reacts to everything - hearts, crumbs, happy faces - and your friend sees it too.</a:t>
+              <a:t>Every mood sounds different too: happy, sad, sleepy, hungry or grumpy. Petting, eating and snoring sound right for each kind of animal - furry ones purr and crunch, birds trill and peck, sea animals blow bubbles, bugs hum and magic pets chime.</a:t>
             </a:r>
           </a:p>
           <a:p>
@@ -8490,7 +8490,7 @@
                 </a:solidFill>
                 <a:latin typeface="Segoe UI"/>
               </a:rPr>
-              <a:t>Rub your mouse over the visitor to pet it. Playing with it makes it stay longer, and your pet comes down from a window or the sky to meet it.</a:t>
+              <a:t>A friend's pet that comes to visit now talks in its own voice: it says hi when it arrives and answers when you wave, pet it or give it a snack (it follows your sound settings).</a:t>
             </a:r>
           </a:p>
         </p:txBody>
@@ -8621,7 +8621,7 @@
                 </a:solidFill>
                 <a:latin typeface="Segoe UI"/>
               </a:rPr>
-              <a:t>Saat peliharaan teman datang berkunjung, sekarang ia memakai papan nama: nama temanmu (atau julukan yang kamu berikan), ♂/♀ dan titik status online. Ia berjalan mendekati pet-mu, menyapa, dan melihat ke arah mouse saat kamu mengarahkannya.</a:t>
+              <a:t>Ke-51 hewan sekarang punya suaranya sendiri. Sebelumnya lebih dari separuhnya meminjam suara meong kucing - sekarang anjing menggonggong, sapi melenguh, domba mengembik, singa mengaum, bebek berkwek, lumba-lumba berdecit dan bersiul, naga mengepakkan sayap dan mengaum dengan semburan api, hantu bersuara huuu... dan seterusnya.</a:t>
             </a:r>
           </a:p>
           <a:p>
@@ -8646,7 +8646,7 @@
                 </a:solidFill>
                 <a:latin typeface="Segoe UI"/>
               </a:rPr>
-              <a:t>Arahkan mouse ke pengunjung (atau klik papan namanya) untuk membuka kartunya: pet milik siapa, level, seberapa dekat kalian, dan tombol untuk menyapa, mengelus, memberi camilan, balas berkunjung, atau chat. Ia bereaksi pada semuanya - hati, remah, wajah senang - dan temanmu juga melihatnya.</a:t>
+              <a:t>Setiap suasana hati juga terdengar berbeda: senang, sedih, mengantuk, lapar, atau kesal. Suara dielus, makan, dan mendengkur cocok dengan jenis hewannya - hewan berbulu mendengkur dan mengunyah, burung berkicau dan mematuk, hewan laut membuat gelembung, serangga berdengung, dan pet ajaib berdenting.</a:t>
             </a:r>
           </a:p>
           <a:p>
@@ -8671,7 +8671,7 @@
                 </a:solidFill>
                 <a:latin typeface="Segoe UI"/>
               </a:rPr>
-              <a:t>Gosok-gosokkan mouse di atas pengunjung untuk mengelusnya. Makin sering diajak main, makin lama ia tinggal, dan pet-mu turun dari jendela atau langit untuk menyambutnya.</a:t>
+              <a:t>Pet teman yang datang berkunjung sekarang bicara dengan suaranya sendiri: ia menyapa saat tiba dan membalas saat kamu melambai, mengelus, atau memberinya camilan (mengikuti pengaturan suaramu).</a:t>
             </a:r>
           </a:p>
         </p:txBody>
@@ -8903,7 +8903,7 @@
         </p:nvGraphicFramePr>
         <p:xfrm>
           <a:off x="548640" y="1645920"/>
-          <a:ext cx="11155680" cy="25895808"/>
+          <a:ext cx="11155680" cy="26718768"/>
         </p:xfrm>
         <a:graphic>
           <a:graphicData uri="http://schemas.openxmlformats.org/drawingml/2006/table">
@@ -8997,7 +8997,7 @@
                           </a:solidFill>
                           <a:latin typeface="Segoe UI"/>
                         </a:rPr>
-                        <a:t>2.20.0</a:t>
+                        <a:t>2.21.0</a:t>
                       </a:r>
                     </a:p>
                   </a:txBody>
@@ -9041,7 +9041,7 @@
                           </a:solidFill>
                           <a:latin typeface="Segoe UI"/>
                         </a:rPr>
-                        <a:t>Come over</a:t>
+                        <a:t>Every animal has a voice</a:t>
                       </a:r>
                     </a:p>
                     <a:p>
@@ -9052,7 +9052,7 @@
                           </a:solidFill>
                           <a:latin typeface="Segoe UI"/>
                         </a:rPr>
-                        <a:t>When a friend's pet comes over it now wears a name tag: your friend's name (or the nickname you gave them), ♂/♀ and an online dot. It walks up to your pet, says hi, and looks at your mouse when you point at it.; Point at the visitor (or click its name tag) to open its card: whose pet it is, level, how close you two are, and buttons to wave, pet it, give it a snack, visit back or chat. It reacts to everything - hearts, crumbs, happy faces - and your friend sees it too.; Rub your mouse over the visitor to pet it. Playing with it makes it stay longer, and your pet comes down from a window or the sky to meet it.</a:t>
+                        <a:t>All 51 animals now have their own sound. Before, more than half of them borrowed the cat's meow - now the dog woofs, the cow moos, the sheep baas, the lion roars, the duck quacks, the dolphin clicks and whistles, the dragon flaps and roars with a puff of fire, the ghost goes wooo... and so on.; Every mood sounds different too: happy, sad, sleepy, hungry or grumpy. Petting, eating and snoring sound right for each kind of animal - furry ones purr and crunch, birds trill and peck, sea animals blow bubbles, bugs hum and magic pets chime.; A friend's pet that comes to visit now talks in its own voice: it says hi when it arrives and answers when you wave, pet it or give it a snack (it follows your sound settings).</a:t>
                       </a:r>
                     </a:p>
                   </a:txBody>
@@ -9076,7 +9076,7 @@
                           </a:solidFill>
                           <a:latin typeface="Segoe UI"/>
                         </a:rPr>
-                        <a:t>2.19.0</a:t>
+                        <a:t>2.20.0</a:t>
                       </a:r>
                     </a:p>
                   </a:txBody>
@@ -9120,7 +9120,7 @@
                           </a:solidFill>
                           <a:latin typeface="Segoe UI"/>
                         </a:rPr>
-                        <a:t>Land, sea &amp; sky</a:t>
+                        <a:t>Come over</a:t>
                       </a:r>
                     </a:p>
                     <a:p>
@@ -9131,7 +9131,7 @@
                           </a:solidFill>
                           <a:latin typeface="Segoe UI"/>
                         </a:rPr>
-                        <a:t>Land animals walk on the taskbar and on top of your open windows now: they jump up onto window edges, walk along them, ride along when you move the window and hop down when it closes, gets covered or is maximised. They always have gravity - let go of one in mid-air and it lands on the window below or on the taskbar.; Water animals swim along the taskbar (their water) and every now and then leap high out of it in a big arc, diving back in with a splash, ripples and spray. Drop one anywhere and it dives back into the water.; Flying animals fly anywhere on the screen: they flutter from place to place, hover, come say hi near your mouse, and sometimes perch on the taskbar or a window edge for a rest. Point at one and it waits for you; they glide down to a perch before a nap.; New menu moves: Jump onto a window, Splash jump!, Fly around / Rest on the taskbar. "Move around by myself" in Pet settings keeps your pet still if you prefer (the old Gravity option is gone - land animals always fall now).</a:t>
+                        <a:t>When a friend's pet comes over it now wears a name tag: your friend's name (or the nickname you gave them), ♂/♀ and an online dot. It walks up to your pet, says hi, and looks at your mouse when you point at it.; Point at the visitor (or click its name tag) to open its card: whose pet it is, level, how close you two are, and buttons to wave, pet it, give it a snack, visit back or chat. It reacts to everything - hearts, crumbs, happy faces - and your friend sees it too.; Rub your mouse over the visitor to pet it. Playing with it makes it stay longer, and your pet comes down from a window or the sky to meet it.</a:t>
                       </a:r>
                     </a:p>
                   </a:txBody>
@@ -9155,7 +9155,7 @@
                           </a:solidFill>
                           <a:latin typeface="Segoe UI"/>
                         </a:rPr>
-                        <a:t>2.18.0</a:t>
+                        <a:t>2.19.0</a:t>
                       </a:r>
                     </a:p>
                   </a:txBody>
@@ -9199,7 +9199,7 @@
                           </a:solidFill>
                           <a:latin typeface="Segoe UI"/>
                         </a:rPr>
-                        <a:t>Raise your pet</a:t>
+                        <a:t>Land, sea &amp; sky</a:t>
                       </a:r>
                     </a:p>
                     <a:p>
@@ -9210,7 +9210,7 @@
                           </a:solidFill>
                           <a:latin typeface="Segoe UI"/>
                         </a:rPr>
-                        <a:t>Boy or girl? Pick your pet's gender in Settings: boys get a little hair tuft, girls a pink bow and eyelashes, and a ♂ / ♀ shows next to its name. You can add your own gender to your profile too - friends see a small ♂ / ♀ next to your name.; Pets grow up now: baby → child → teen → grown-up. Focus sessions, opening Pips each day, games and cuddles help them grow - no care mistakes, no bad endings. Already have a grown-up pet? It will ask whether you'd like to raise it again from a baby (coins, items and stats stay).; Sick days: work 2.5 hours without a 5-minute break and your pet catches a little cold (sneezes, thermometer, slow steps). A short break cures it - or give medicine from the menu. You can turn this off in Settings.; New mini-game Left or Right? (pet menu → Play): guess which way your pet will look - 3 out of 5 wins, with coins for your first wins each day.</a:t>
+                        <a:t>Land animals walk on the taskbar and on top of your open windows now: they jump up onto window edges, walk along them, ride along when you move the window and hop down when it closes, gets covered or is maximised. They always have gravity - let go of one in mid-air and it lands on the window below or on the taskbar.; Water animals swim along the taskbar (their water) and every now and then leap high out of it in a big arc, diving back in with a splash, ripples and spray. Drop one anywhere and it dives back into the water.; Flying animals fly anywhere on the screen: they flutter from place to place, hover, come say hi near your mouse, and sometimes perch on the taskbar or a window edge for a rest. Point at one and it waits for you; they glide down to a perch before a nap.; New menu moves: Jump onto a window, Splash jump!, Fly around / Rest on the taskbar. "Move around by myself" in Pet settings keeps your pet still if you prefer (the old Gravity option is gone - land animals always fall now).</a:t>
                       </a:r>
                     </a:p>
                   </a:txBody>
@@ -9234,7 +9234,7 @@
                           </a:solidFill>
                           <a:latin typeface="Segoe UI"/>
                         </a:rPr>
-                        <a:t>2.17.0</a:t>
+                        <a:t>2.18.0</a:t>
                       </a:r>
                     </a:p>
                   </a:txBody>
@@ -9278,7 +9278,7 @@
                           </a:solidFill>
                           <a:latin typeface="Segoe UI"/>
                         </a:rPr>
-                        <a:t>Find your pet anytime</a:t>
+                        <a:t>Raise your pet</a:t>
                       </a:r>
                     </a:p>
                     <a:p>
@@ -9289,7 +9289,7 @@
                           </a:solidFill>
                           <a:latin typeface="Segoe UI"/>
                         </a:rPr>
-                        <a:t>Pips now has an icon next to the clock: click it to bring your pet back; right-click for the focus timer, Friends &amp; chat or Quit.; Press Ctrl+Alt+P anywhere to call your pet - it pops up on the screen you're using, even if it was hidden, asleep or behind a fullscreen app.; Opening Pips again from the Start menu or desktop does the same, and your pet walks back by itself if it ever ends up off-screen (e.g. after unplugging a monitor).; Hiding your pet now tells you how to bring it back.</a:t>
+                        <a:t>Boy or girl? Pick your pet's gender in Settings: boys get a little hair tuft, girls a pink bow and eyelashes, and a ♂ / ♀ shows next to its name. You can add your own gender to your profile too - friends see a small ♂ / ♀ next to your name.; Pets grow up now: baby → child → teen → grown-up. Focus sessions, opening Pips each day, games and cuddles help them grow - no care mistakes, no bad endings. Already have a grown-up pet? It will ask whether you'd like to raise it again from a baby (coins, items and stats stay).; Sick days: work 2.5 hours without a 5-minute break and your pet catches a little cold (sneezes, thermometer, slow steps). A short break cures it - or give medicine from the menu. You can turn this off in Settings.; New mini-game Left or Right? (pet menu → Play): guess which way your pet will look - 3 out of 5 wins, with coins for your first wins each day.</a:t>
                       </a:r>
                     </a:p>
                   </a:txBody>
@@ -9313,7 +9313,7 @@
                           </a:solidFill>
                           <a:latin typeface="Segoe UI"/>
                         </a:rPr>
-                        <a:t>2.16.0</a:t>
+                        <a:t>2.17.0</a:t>
                       </a:r>
                     </a:p>
                   </a:txBody>
@@ -9357,7 +9357,7 @@
                           </a:solidFill>
                           <a:latin typeface="Segoe UI"/>
                         </a:rPr>
-                        <a:t>Pips Community</a:t>
+                        <a:t>Find your pet anytime</a:t>
                       </a:r>
                     </a:p>
                     <a:p>
@@ -9368,7 +9368,7 @@
                           </a:solidFill>
                           <a:latin typeface="Segoe UI"/>
                         </a:rPr>
-                        <a:t>New Pips Community at the top of the Chat tab: a #general channel to chat with everyone who uses Pips, plus #announcements with news from the Pips team.; Every new Pips version is announced there automatically - see what's new and update with one click.; Type @name to ping someone in #general. Mute #general any time; owner and moderators can remove messages.; Open it from your pet's menu too (Pips Community). Fixed: chats no longer clear what you're typing when Pips refreshes in the background.</a:t>
+                        <a:t>Pips now has an icon next to the clock: click it to bring your pet back; right-click for the focus timer, Friends &amp; chat or Quit.; Press Ctrl+Alt+P anywhere to call your pet - it pops up on the screen you're using, even if it was hidden, asleep or behind a fullscreen app.; Opening Pips again from the Start menu or desktop does the same, and your pet walks back by itself if it ever ends up off-screen (e.g. after unplugging a monitor).; Hiding your pet now tells you how to bring it back.</a:t>
                       </a:r>
                     </a:p>
                   </a:txBody>
@@ -9392,7 +9392,7 @@
                           </a:solidFill>
                           <a:latin typeface="Segoe UI"/>
                         </a:rPr>
-                        <a:t>2.15.0</a:t>
+                        <a:t>2.16.0</a:t>
                       </a:r>
                     </a:p>
                   </a:txBody>
@@ -9436,7 +9436,7 @@
                           </a:solidFill>
                           <a:latin typeface="Segoe UI"/>
                         </a:rPr>
-                        <a:t>Update reminders</a:t>
+                        <a:t>Pips Community</a:t>
                       </a:r>
                     </a:p>
                     <a:p>
@@ -9447,7 +9447,7 @@
                           </a:solidFill>
                           <a:latin typeface="Segoe UI"/>
                         </a:rPr>
-                        <a:t>Owner &amp; moderators: the Mod tab now lists who hasn't updated Pips yet (their version and when they were last seen), with one-click reminders by e-mail (sent from your Outlook) or a ready-to-send Teams chat.; New Work e-mail field in your Profile, filled in from Outlook. Only the owner and moderators can see it (for update reminders and support) - clear it to hide it.; Pips now tells the Friends server which version it runs, so the update list is always accurate.; Friends keeps working when a local proxy tool stops answering - Pips falls back to the Windows proxy settings.</a:t>
+                        <a:t>New Pips Community at the top of the Chat tab: a #general channel to chat with everyone who uses Pips, plus #announcements with news from the Pips team.; Every new Pips version is announced there automatically - see what's new and update with one click.; Type @name to ping someone in #general. Mute #general any time; owner and moderators can remove messages.; Open it from your pet's menu too (Pips Community). Fixed: chats no longer clear what you're typing when Pips refreshes in the background.</a:t>
                       </a:r>
                     </a:p>
                   </a:txBody>
@@ -9471,7 +9471,7 @@
                           </a:solidFill>
                           <a:latin typeface="Segoe UI"/>
                         </a:rPr>
-                        <a:t>2.14.3</a:t>
+                        <a:t>2.15.0</a:t>
                       </a:r>
                     </a:p>
                   </a:txBody>
@@ -9515,7 +9515,7 @@
                           </a:solidFill>
                           <a:latin typeface="Segoe UI"/>
                         </a:rPr>
-                        <a:t>Tidy menus</a:t>
+                        <a:t>Update reminders</a:t>
                       </a:r>
                     </a:p>
                     <a:p>
@@ -9526,7 +9526,7 @@
                           </a:solidFill>
                           <a:latin typeface="Segoe UI"/>
                         </a:rPr>
-                        <a:t>Fixed: a submenu (e.g. Poke a friend) could stay floating on the screen after the right-click menu closed.; Menus now close by themselves when you move the mouse away and leave them for a few seconds.</a:t>
+                        <a:t>Owner &amp; moderators: the Mod tab now lists who hasn't updated Pips yet (their version and when they were last seen), with one-click reminders by e-mail (sent from your Outlook) or a ready-to-send Teams chat.; New Work e-mail field in your Profile, filled in from Outlook. Only the owner and moderators can see it (for update reminders and support) - clear it to hide it.; Pips now tells the Friends server which version it runs, so the update list is always accurate.; Friends keeps working when a local proxy tool stops answering - Pips falls back to the Windows proxy settings.</a:t>
                       </a:r>
                     </a:p>
                   </a:txBody>
@@ -9550,7 +9550,7 @@
                           </a:solidFill>
                           <a:latin typeface="Segoe UI"/>
                         </a:rPr>
-                        <a:t>2.14.2</a:t>
+                        <a:t>2.14.3</a:t>
                       </a:r>
                     </a:p>
                   </a:txBody>
@@ -9594,7 +9594,7 @@
                           </a:solidFill>
                           <a:latin typeface="Segoe UI"/>
                         </a:rPr>
-                        <a:t>Never miss an update</a:t>
+                        <a:t>Tidy menus</a:t>
                       </a:r>
                     </a:p>
                     <a:p>
@@ -9605,7 +9605,7 @@
                           </a:solidFill>
                           <a:latin typeface="Segoe UI"/>
                         </a:rPr>
-                        <a:t>Your pet now reminds you every 2 hours while a new version is waiting (instead of every 6 hours).; If the reminder can't show (fullscreen app, guided tour, another message), your pet tries again a few minutes later.; No internet when Pips starts (e.g. VPN off)? It checks again after an hour.</a:t>
+                        <a:t>Fixed: a submenu (e.g. Poke a friend) could stay floating on the screen after the right-click menu closed.; Menus now close by themselves when you move the mouse away and leave them for a few seconds.</a:t>
                       </a:r>
                     </a:p>
                   </a:txBody>
@@ -9629,7 +9629,7 @@
                           </a:solidFill>
                           <a:latin typeface="Segoe UI"/>
                         </a:rPr>
-                        <a:t>2.14.1</a:t>
+                        <a:t>2.14.2</a:t>
                       </a:r>
                     </a:p>
                   </a:txBody>
@@ -9673,7 +9673,7 @@
                           </a:solidFill>
                           <a:latin typeface="Segoe UI"/>
                         </a:rPr>
-                        <a:t>One pet at a time</a:t>
+                        <a:t>Never miss an update</a:t>
                       </a:r>
                     </a:p>
                     <a:p>
@@ -9684,7 +9684,7 @@
                           </a:solidFill>
                           <a:latin typeface="Segoe UI"/>
                         </a:rPr>
-                        <a:t>Opening Pips again (Desktop / Start Menu shortcut, autostart) no longer starts a second pet - your pet just pops up and says hi.; Fixes lag caused by two copies of Pips running at once.</a:t>
+                        <a:t>Your pet now reminds you every 2 hours while a new version is waiting (instead of every 6 hours).; If the reminder can't show (fullscreen app, guided tour, another message), your pet tries again a few minutes later.; No internet when Pips starts (e.g. VPN off)? It checks again after an hour.</a:t>
                       </a:r>
                     </a:p>
                   </a:txBody>
@@ -9708,7 +9708,7 @@
                           </a:solidFill>
                           <a:latin typeface="Segoe UI"/>
                         </a:rPr>
-                        <a:t>2.14.0</a:t>
+                        <a:t>2.14.1</a:t>
                       </a:r>
                     </a:p>
                   </a:txBody>
@@ -9752,7 +9752,7 @@
                           </a:solidFill>
                           <a:latin typeface="Segoe UI"/>
                         </a:rPr>
-                        <a:t>Pokes, tickles &amp; teases</a:t>
+                        <a:t>One pet at a time</a:t>
                       </a:r>
                     </a:p>
                     <a:p>
@@ -9763,7 +9763,7 @@
                           </a:solidFill>
                           <a:latin typeface="Segoe UI"/>
                         </a:rPr>
-                        <a:t>Poke, tickle, tease, boop or hug a friend from afar - no pet visit needed.; Right-click your pet → Poke a friend, or use the Poke button in Friends, chat and profiles.; Your friend gets a pop-up ("Wendy is teasing you!"), their pet reacts, and they can poke back with one click.; During a focus session pokes wait quietly until your break; when your pet is hidden they show in the screen corner.</a:t>
+                        <a:t>Opening Pips again (Desktop / Start Menu shortcut, autostart) no longer starts a second pet - your pet just pops up and says hi.; Fixes lag caused by two copies of Pips running at once.</a:t>
                       </a:r>
                     </a:p>
                   </a:txBody>
@@ -9787,7 +9787,7 @@
                           </a:solidFill>
                           <a:latin typeface="Segoe UI"/>
                         </a:rPr>
-                        <a:t>2.13.1</a:t>
+                        <a:t>2.14.0</a:t>
                       </a:r>
                     </a:p>
                   </a:txBody>
@@ -9809,7 +9809,7 @@
                           </a:solidFill>
                           <a:latin typeface="Segoe UI"/>
                         </a:rPr>
-                        <a:t>2026-10-28</a:t>
+                        <a:t>2026-10-29</a:t>
                       </a:r>
                     </a:p>
                   </a:txBody>
@@ -9831,7 +9831,7 @@
                           </a:solidFill>
                           <a:latin typeface="Segoe UI"/>
                         </a:rPr>
-                        <a:t>One-click Windows installer</a:t>
+                        <a:t>Pokes, tickles &amp; teases</a:t>
                       </a:r>
                     </a:p>
                     <a:p>
@@ -9842,7 +9842,7 @@
                           </a:solidFill>
                           <a:latin typeface="Segoe UI"/>
                         </a:rPr>
-                        <a:t>One Windows installer: no ZIP extraction, Python installation or command line. Download, open and click Install Pips.; Installs for your Windows account without administrator access, adds Desktop and Start Menu shortcuts, and opens Pips automatically.; Reinstalling in the same location keeps your settings and pet progress. Existing ZIP users can keep updating in place from Help → Check for updates.; A simpler download page and updated user guide; the bundled runtime stays separate from small in-app updates.</a:t>
+                        <a:t>Poke, tickle, tease, boop or hug a friend from afar - no pet visit needed.; Right-click your pet → Poke a friend, or use the Poke button in Friends, chat and profiles.; Your friend gets a pop-up ("Wendy is teasing you!"), their pet reacts, and they can poke back with one click.; During a focus session pokes wait quietly until your break; when your pet is hidden they show in the screen corner.</a:t>
                       </a:r>
                     </a:p>
                   </a:txBody>
@@ -9866,7 +9866,7 @@
                           </a:solidFill>
                           <a:latin typeface="Segoe UI"/>
                         </a:rPr>
-                        <a:t>2.13.0</a:t>
+                        <a:t>2.13.1</a:t>
                       </a:r>
                     </a:p>
                   </a:txBody>
@@ -9910,7 +9910,7 @@
                           </a:solidFill>
                           <a:latin typeface="Segoe UI"/>
                         </a:rPr>
-                        <a:t>Birthdays, parties &amp; gifts</a:t>
+                        <a:t>One-click Windows installer</a:t>
                       </a:r>
                     </a:p>
                     <a:p>
@@ -9921,7 +9921,7 @@
                           </a:solidFill>
                           <a:latin typeface="Segoe UI"/>
                         </a:rPr>
-                        <a:t>Set your birthday in Social → Profile (month + day, optionally visible to friends).; On your birthday Pips throws confetti and gives you 100 bonus coins.; Friends tab shows upcoming birthdays; you get reminders 3 days, 1 day and on the day.; Birthday parties: join a friend's party, see who's there, sign the guestbook and celebrate together.</a:t>
+                        <a:t>One Windows installer: no ZIP extraction, Python installation or command line. Download, open and click Install Pips.; Installs for your Windows account without administrator access, adds Desktop and Start Menu shortcuts, and opens Pips automatically.; Reinstalling in the same location keeps your settings and pet progress. Existing ZIP users can keep updating in place from Help → Check for updates.; A simpler download page and updated user guide; the bundled runtime stays separate from small in-app updates.</a:t>
                       </a:r>
                     </a:p>
                   </a:txBody>
@@ -9945,7 +9945,7 @@
                           </a:solidFill>
                           <a:latin typeface="Segoe UI"/>
                         </a:rPr>
-                        <a:t>2.12.0</a:t>
+                        <a:t>2.13.0</a:t>
                       </a:r>
                     </a:p>
                   </a:txBody>
@@ -9989,7 +9989,7 @@
                           </a:solidFill>
                           <a:latin typeface="Segoe UI"/>
                         </a:rPr>
-                        <a:t>Mega update: 28 new animals, 31 shop items, 13 moves</a:t>
+                        <a:t>Birthdays, parties &amp; gifts</a:t>
                       </a:r>
                     </a:p>
                     <a:p>
@@ -10000,7 +10000,7 @@
                           </a:solidFill>
                           <a:latin typeface="Segoe UI"/>
                         </a:rPr>
-                        <a:t>🦁 28 new animals (51 total): lion, tiger, unicorn, deer, sheep, cow, raccoon, red panda, monkey, hedgehog, dino, squirrel, mouse, koala, shark, dolphin, seal, otter, pufferfish, duck, crab, parrot, chick, ladybug, phoenix, pegasus, ghost and flamingo; 🎩 31 new shop items: top hat, cowboy, chef, pirate, Santa, viking, graduation cap, beret, bow, propeller cap, flower crown, nerd glasses, eyepatch, mustache, goggles, masquerade mask, tie, pearls, flower lei, gold chain, balloon, backpack, guitar, shield, butterfly / devil wings and more - plus Premium galaxy crown, galaxy cape and dragon wings; 💃 13 new moves: wave, jump, hearts, sing, yoga, zoomies, cartwheel, juggle, rain dance, breakdance, magic, confetti and the Premium rocket launch; The Shop is now split into sections (Hats, Face, Neck, Back, Moves, Arena gear) with an owned counter for each</a:t>
+                        <a:t>Set your birthday in Social → Profile (month + day, optionally visible to friends).; On your birthday Pips throws confetti and gives you 100 bonus coins.; Friends tab shows upcoming birthdays; you get reminders 3 days, 1 day and on the day.; Birthday parties: join a friend's party, see who's there, sign the guestbook and celebrate together.</a:t>
                       </a:r>
                     </a:p>
                   </a:txBody>
@@ -10024,7 +10024,7 @@
                           </a:solidFill>
                           <a:latin typeface="Segoe UI"/>
                         </a:rPr>
-                        <a:t>2.11.0</a:t>
+                        <a:t>2.12.0</a:t>
                       </a:r>
                     </a:p>
                   </a:txBody>
@@ -10068,7 +10068,7 @@
                           </a:solidFill>
                           <a:latin typeface="Segoe UI"/>
                         </a:rPr>
-                        <a:t>New right-click menus</a:t>
+                        <a:t>Mega update: 28 new animals, 31 shop items, 13 moves</a:t>
                       </a:r>
                     </a:p>
                     <a:p>
@@ -10079,7 +10079,7 @@
                           </a:solidFill>
                           <a:latin typeface="Segoe UI"/>
                         </a:rPr>
-                        <a:t>✨ Brand-new animated right-click menu for your pet: mood &amp; stat bars, quick-action tiles (Friends, Shop, Snack, Pat, Focus, Stats, Sleep, Taskbar), hover effects and smooth fly-out submenus; Pick colours from swatches, switch size with one click and flip Sounds / Dark mode with toggle switches - changes show instantly; Updates are highlighted: a glowing banner and NEW badge appear in the menu when a new version is ready; The focus card's right-click menu got the same new look; keyboard arrows, Enter and Esc work too</a:t>
+                        <a:t>🦁 28 new animals (51 total): lion, tiger, unicorn, deer, sheep, cow, raccoon, red panda, monkey, hedgehog, dino, squirrel, mouse, koala, shark, dolphin, seal, otter, pufferfish, duck, crab, parrot, chick, ladybug, phoenix, pegasus, ghost and flamingo; 🎩 31 new shop items: top hat, cowboy, chef, pirate, Santa, viking, graduation cap, beret, bow, propeller cap, flower crown, nerd glasses, eyepatch, mustache, goggles, masquerade mask, tie, pearls, flower lei, gold chain, balloon, backpack, guitar, shield, butterfly / devil wings and more - plus Premium galaxy crown, galaxy cape and dragon wings; 💃 13 new moves: wave, jump, hearts, sing, yoga, zoomies, cartwheel, juggle, rain dance, breakdance, magic, confetti and the Premium rocket launch; The Shop is now split into sections (Hats, Face, Neck, Back, Moves, Arena gear) with an owned counter for each</a:t>
                       </a:r>
                     </a:p>
                   </a:txBody>
@@ -10103,7 +10103,7 @@
                           </a:solidFill>
                           <a:latin typeface="Segoe UI"/>
                         </a:rPr>
-                        <a:t>2.10.0</a:t>
+                        <a:t>2.11.0</a:t>
                       </a:r>
                     </a:p>
                   </a:txBody>
@@ -10147,7 +10147,7 @@
                           </a:solidFill>
                           <a:latin typeface="Segoe UI"/>
                         </a:rPr>
-                        <a:t>Chat bots</a:t>
+                        <a:t>New right-click menus</a:t>
                       </a:r>
                     </a:p>
                     <a:p>
@@ -10158,7 +10158,7 @@
                           </a:solidFill>
                           <a:latin typeface="Segoe UI"/>
                         </a:rPr>
-                        <a:t>🤖 6 friendly chat bots in the Chat tab: Pip Helper (app questions), Coach Focus (focus tips from your real stats), Sunny (live weather for any city), Arena Master (battle tips + quick battle), Giggles (jokes &amp; games) and Guardian (safety &amp; reporting help); Private bot chats with suggestion chips, typing indicator and a clear button - your bot chats stay on your PC; Mention a bot in a group chat (e.g. @weather Batam) and it answers in the room for everyone; Bots reply in your app language; up to 120 bot messages per day</a:t>
+                        <a:t>✨ Brand-new animated right-click menu for your pet: mood &amp; stat bars, quick-action tiles (Friends, Shop, Snack, Pat, Focus, Stats, Sleep, Taskbar), hover effects and smooth fly-out submenus; Pick colours from swatches, switch size with one click and flip Sounds / Dark mode with toggle switches - changes show instantly; Updates are highlighted: a glowing banner and NEW badge appear in the menu when a new version is ready; The focus card's right-click menu got the same new look; keyboard arrows, Enter and Esc work too</a:t>
                       </a:r>
                     </a:p>
                   </a:txBody>
@@ -10182,7 +10182,7 @@
                           </a:solidFill>
                           <a:latin typeface="Segoe UI"/>
                         </a:rPr>
-                        <a:t>2.9.0</a:t>
+                        <a:t>2.10.0</a:t>
                       </a:r>
                     </a:p>
                   </a:txBody>
@@ -10226,7 +10226,7 @@
                           </a:solidFill>
                           <a:latin typeface="Segoe UI"/>
                         </a:rPr>
-                        <a:t>Location &amp; live weather</a:t>
+                        <a:t>Chat bots</a:t>
                       </a:r>
                     </a:p>
                     <a:p>
@@ -10237,7 +10237,7 @@
                           </a:solidFill>
                           <a:latin typeface="Segoe UI"/>
                         </a:rPr>
-                        <a:t>📍 Add your city in Profile → Location &amp; weather (auto-detect or search) - only your city and country are shown, never your exact position; Live weather banners on every profile with animations: rain, drizzle, thunderstorms with lightning, snow, fog, clouds, sunshine or a starry night - plus temperature, feels-like, humidity, wind and local time; Your own weather strip on top of the hub, and each friend's weather + local time in the friends list; Hide your location from others or remove it any time</a:t>
+                        <a:t>🤖 6 friendly chat bots in the Chat tab: Pip Helper (app questions), Coach Focus (focus tips from your real stats), Sunny (live weather for any city), Arena Master (battle tips + quick battle), Giggles (jokes &amp; games) and Guardian (safety &amp; reporting help); Private bot chats with suggestion chips, typing indicator and a clear button - your bot chats stay on your PC; Mention a bot in a group chat (e.g. @weather Batam) and it answers in the room for everyone; Bots reply in your app language; up to 120 bot messages per day</a:t>
                       </a:r>
                     </a:p>
                   </a:txBody>
@@ -10261,7 +10261,7 @@
                           </a:solidFill>
                           <a:latin typeface="Segoe UI"/>
                         </a:rPr>
-                        <a:t>2.8.0</a:t>
+                        <a:t>2.9.0</a:t>
                       </a:r>
                     </a:p>
                   </a:txBody>
@@ -10305,7 +10305,7 @@
                           </a:solidFill>
                           <a:latin typeface="Segoe UI"/>
                         </a:rPr>
-                        <a:t>Pips Arena - duels, gear &amp; live battles</a:t>
+                        <a:t>Location &amp; live weather</a:t>
                       </a:r>
                     </a:p>
                     <a:p>
@@ -10316,7 +10316,7 @@
                           </a:solidFill>
                           <a:latin typeface="Segoe UI"/>
                         </a:rPr>
-                        <a:t>⚔ New Arena tab: challenge friends or anyone in the arena to a live duel - each round pick Attack, Guard or Special within 12 seconds and watch your pets fight; ⚡ Quick battle: an instant auto-fight against anyone's fighter, even when they're offline; Arena gear in the Shop: 7 weapons (water pistol to rocket launcher), 5 armors and 5 gadgets that decide your special move - better gear and a higher level make a stronger fighter; Live duels can be watched by everyone, plus recent battle replays, top fighters, rating and win/loss records; wins earn coins</a:t>
+                        <a:t>📍 Add your city in Profile → Location &amp; weather (auto-detect or search) - only your city and country are shown, never your exact position; Live weather banners on every profile with animations: rain, drizzle, thunderstorms with lightning, snow, fog, clouds, sunshine or a starry night - plus temperature, feels-like, humidity, wind and local time; Your own weather strip on top of the hub, and each friend's weather + local time in the friends list; Hide your location from others or remove it any time</a:t>
                       </a:r>
                     </a:p>
                   </a:txBody>
@@ -10340,7 +10340,7 @@
                           </a:solidFill>
                           <a:latin typeface="Segoe UI"/>
                         </a:rPr>
-                        <a:t>2.7.0</a:t>
+                        <a:t>2.8.0</a:t>
                       </a:r>
                     </a:p>
                   </a:txBody>
@@ -10384,7 +10384,7 @@
                           </a:solidFill>
                           <a:latin typeface="Segoe UI"/>
                         </a:rPr>
-                        <a:t>Moderators &amp; Premium</a:t>
+                        <a:t>Pips Arena - duels, gear &amp; live battles</a:t>
                       </a:r>
                     </a:p>
                     <a:p>
@@ -10395,7 +10395,7 @@
                           </a:solidFill>
                           <a:latin typeface="Segoe UI"/>
                         </a:rPr>
-                        <a:t>★ Premium: a purple Premium badge, 4 exclusive props (tiara, star glasses, diamond necklace, fairy wings), the Fireworks move, +30 coins every day, double friend-interaction coins and room for 300 friends / 30 groups; Get Premium: Profile tab → Premium → "Ask to buy" emails the owner; after payment you receive a key (PIPS-XXXX-XXXX) to redeem right there; 🛡 Moderators: a blue Mod badge and a Mod tab with the report queue - warn, mute (1h / 24h / 7 days), clear a profile or reset a name; every action is logged; Report button on everyone's profile, so moderators can keep Pips friendly</a:t>
+                        <a:t>⚔ New Arena tab: challenge friends or anyone in the arena to a live duel - each round pick Attack, Guard or Special within 12 seconds and watch your pets fight; ⚡ Quick battle: an instant auto-fight against anyone's fighter, even when they're offline; Arena gear in the Shop: 7 weapons (water pistol to rocket launcher), 5 armors and 5 gadgets that decide your special move - better gear and a higher level make a stronger fighter; Live duels can be watched by everyone, plus recent battle replays, top fighters, rating and win/loss records; wins earn coins</a:t>
                       </a:r>
                     </a:p>
                   </a:txBody>
@@ -10419,7 +10419,7 @@
                           </a:solidFill>
                           <a:latin typeface="Segoe UI"/>
                         </a:rPr>
-                        <a:t>2.6.1</a:t>
+                        <a:t>2.7.0</a:t>
                       </a:r>
                     </a:p>
                   </a:txBody>
@@ -10463,7 +10463,7 @@
                           </a:solidFill>
                           <a:latin typeface="Segoe UI"/>
                         </a:rPr>
-                        <a:t>Owner badge &amp; credits</a:t>
+                        <a:t>Moderators &amp; Premium</a:t>
                       </a:r>
                     </a:p>
                     <a:p>
@@ -10474,7 +10474,7 @@
                           </a:solidFill>
                           <a:latin typeface="Segoe UI"/>
                         </a:rPr>
-                        <a:t>The creator of Pips (Juwen Lie) now shows a gold ♛ Owner badge on his profile, friend list and ranks; New About Pips card in the Profile tab: credits and how to contact the owner (Juwen_Lie@pegatroncorp.com) with Email and Copy buttons; Right-click the pet → Help → About now shows who made Pips and the contact email</a:t>
+                        <a:t>★ Premium: a purple Premium badge, 4 exclusive props (tiara, star glasses, diamond necklace, fairy wings), the Fireworks move, +30 coins every day, double friend-interaction coins and room for 300 friends / 30 groups; Get Premium: Profile tab → Premium → "Ask to buy" emails the owner; after payment you receive a key (PIPS-XXXX-XXXX) to redeem right there; 🛡 Moderators: a blue Mod badge and a Mod tab with the report queue - warn, mute (1h / 24h / 7 days), clear a profile or reset a name; every action is logged; Report button on everyone's profile, so moderators can keep Pips friendly</a:t>
                       </a:r>
                     </a:p>
                   </a:txBody>
@@ -10498,7 +10498,7 @@
                           </a:solidFill>
                           <a:latin typeface="Segoe UI"/>
                         </a:rPr>
-                        <a:t>2.6.0</a:t>
+                        <a:t>2.6.1</a:t>
                       </a:r>
                     </a:p>
                   </a:txBody>
@@ -10542,7 +10542,7 @@
                           </a:solidFill>
                           <a:latin typeface="Segoe UI"/>
                         </a:rPr>
-                        <a:t>Profiles, ranks, online status &amp; dark mode</a:t>
+                        <a:t>Owner badge &amp; credits</a:t>
                       </a:r>
                     </a:p>
                     <a:p>
@@ -10553,7 +10553,7 @@
                           </a:solidFill>
                           <a:latin typeface="Segoe UI"/>
                         </a:rPr>
-                        <a:t>Profile tab: profile picture (or your pet), about me, job, location, hobbies, birthday and a status message; Public or private: public profiles can be added directly and viewed in full; private profiles need a friend request that they accept, and strangers only see name, photo, pet, level and status; Click anyone to open their profile - badges, info, their friends - and add them, chat or wave from there; Ranks tab replaces Teams: everyone using Pips, sorted by XP, badges or streak</a:t>
+                        <a:t>The creator of Pips (Juwen Lie) now shows a gold ♛ Owner badge on his profile, friend list and ranks; New About Pips card in the Profile tab: credits and how to contact the owner (Juwen_Lie@pegatroncorp.com) with Email and Copy buttons; Right-click the pet → Help → About now shows who made Pips and the contact email</a:t>
                       </a:r>
                     </a:p>
                   </a:txBody>
@@ -10577,7 +10577,7 @@
                           </a:solidFill>
                           <a:latin typeface="Segoe UI"/>
                         </a:rPr>
-                        <a:t>2.5.1</a:t>
+                        <a:t>2.6.0</a:t>
                       </a:r>
                     </a:p>
                   </a:txBody>
@@ -10621,7 +10621,7 @@
                           </a:solidFill>
                           <a:latin typeface="Segoe UI"/>
                         </a:rPr>
-                        <a:t>New cute Pips logo</a:t>
+                        <a:t>Profiles, ranks, online status &amp; dark mode</a:t>
                       </a:r>
                     </a:p>
                     <a:p>
@@ -10632,7 +10632,7 @@
                           </a:solidFill>
                           <a:latin typeface="Segoe UI"/>
                         </a:rPr>
-                        <a:t>New Pips logo: Pip the cat on a Pips-red tile, matching the app colours (desktop shortcut, windows and website)</a:t>
+                        <a:t>Profile tab: profile picture (or your pet), about me, job, location, hobbies, birthday and a status message; Public or private: public profiles can be added directly and viewed in full; private profiles need a friend request that they accept, and strangers only see name, photo, pet, level and status; Click anyone to open their profile - badges, info, their friends - and add them, chat or wave from there; Ranks tab replaces Teams: everyone using Pips, sorted by XP, badges or streak</a:t>
                       </a:r>
                     </a:p>
                   </a:txBody>
@@ -10656,7 +10656,7 @@
                           </a:solidFill>
                           <a:latin typeface="Segoe UI"/>
                         </a:rPr>
-                        <a:t>2.5.0</a:t>
+                        <a:t>2.5.1</a:t>
                       </a:r>
                     </a:p>
                   </a:txBody>
@@ -10700,7 +10700,7 @@
                           </a:solidFill>
                           <a:latin typeface="Segoe UI"/>
                         </a:rPr>
-                        <a:t>Shop, coins, props &amp; moves</a:t>
+                        <a:t>New cute Pips logo</a:t>
                       </a:r>
                     </a:p>
                     <a:p>
@@ -10711,7 +10711,7 @@
                           </a:solidFill>
                           <a:latin typeface="Segoe UI"/>
                         </a:rPr>
-                        <a:t>Shop: earn coins and spend them on your pet - 17 props (crown, wizard hat, headphones, shades, scarf, cape, angel wings...) and 6 moves: spin, dance, moonwalk, backflip, kung fu and spider swing!; Coins come from leveling up (+40), badges (+25), opening Pips each day (+10), friendships (+15 per affinity level), waving / chatting / visiting friends (+2) and pomodoros (+5). Everyone starts with a 100-coin gift; Your friends see your props: on avatars in the hub and when your pet visits their desktop - it shows off one of your moves; Pips is now a social pet: clicking the pet opens the Pips hub (friends, chat, groups, shop, badges)</a:t>
+                        <a:t>New Pips logo: Pip the cat on a Pips-red tile, matching the app colours (desktop shortcut, windows and website)</a:t>
                       </a:r>
                     </a:p>
                   </a:txBody>
@@ -10735,7 +10735,7 @@
                           </a:solidFill>
                           <a:latin typeface="Segoe UI"/>
                         </a:rPr>
-                        <a:t>2.4.0</a:t>
+                        <a:t>2.5.0</a:t>
                       </a:r>
                     </a:p>
                   </a:txBody>
@@ -10779,7 +10779,7 @@
                           </a:solidFill>
                           <a:latin typeface="Segoe UI"/>
                         </a:rPr>
-                        <a:t>Chat, groups, affinity &amp; pet visits</a:t>
+                        <a:t>Shop, coins, props &amp; moves</a:t>
                       </a:r>
                     </a:p>
                     <a:p>
@@ -10790,7 +10790,7 @@
                           </a:solidFill>
                           <a:latin typeface="Segoe UI"/>
                         </a:rPr>
-                        <a:t>Chat: message your friends, and chat inside groups. Your pet pops up new messages as a bubble - click it to reply; Pet interactions: wave, pet their pet, send a snack, high five - or send your pet to visit: it walks onto your friend's desktop for a little while!; Affinity: every chat and interaction grows your friendship - Acquaintance → Buddy → Good friends → Close friends → Best friends → Soulmates; Your own groups: create a private group, invite your friends, they accept or decline. Group board + group chat; the owner can remove members</a:t>
+                        <a:t>Shop: earn coins and spend them on your pet - 17 props (crown, wizard hat, headphones, shades, scarf, cape, angel wings...) and 6 moves: spin, dance, moonwalk, backflip, kung fu and spider swing!; Coins come from leveling up (+40), badges (+25), opening Pips each day (+10), friendships (+15 per affinity level), waving / chatting / visiting friends (+2) and pomodoros (+5). Everyone starts with a 100-coin gift; Your friends see your props: on avatars in the hub and when your pet visits their desktop - it shows off one of your moves; Pips is now a social pet: clicking the pet opens the Pips hub (friends, chat, groups, shop, badges)</a:t>
                       </a:r>
                     </a:p>
                   </a:txBody>
@@ -10814,7 +10814,7 @@
                           </a:solidFill>
                           <a:latin typeface="Segoe UI"/>
                         </a:rPr>
-                        <a:t>2.3.0</a:t>
+                        <a:t>2.4.0</a:t>
                       </a:r>
                     </a:p>
                   </a:txBody>
@@ -10858,7 +10858,7 @@
                           </a:solidFill>
                           <a:latin typeface="Segoe UI"/>
                         </a:rPr>
-                        <a:t>Friends, levels &amp; achievements</a:t>
+                        <a:t>Chat, groups, affinity &amp; pet visits</a:t>
                       </a:r>
                     </a:p>
                     <a:p>
@@ -10869,7 +10869,7 @@
                           </a:solidFill>
                           <a:latin typeface="Segoe UI"/>
                         </a:rPr>
-                        <a:t>Levels &amp; XP: every finished pomodoro earns XP and your level grows - plus 20 achievements to unlock (first tomato, 8 in a day, 7-day streak, early bird, night owl, pet lover...). Your pet celebrates each one; Friends (optional, off by default): get a 6-letter friend code, add colleagues, see today's board and join a team board like PTB. Your pet tells you when a friend finishes a pomodoro; Privacy: only your name, pet, level, streak and pomodoro counts are shared - never apps, window titles or scores. One click turns it off and deletes your online data. Right-click the pet → Friends &amp; achievements…</a:t>
+                        <a:t>Chat: message your friends, and chat inside groups. Your pet pops up new messages as a bubble - click it to reply; Pet interactions: wave, pet their pet, send a snack, high five - or send your pet to visit: it walks onto your friend's desktop for a little while!; Affinity: every chat and interaction grows your friendship - Acquaintance → Buddy → Good friends → Close friends → Best friends → Soulmates; Your own groups: create a private group, invite your friends, they accept or decline. Group board + group chat; the owner can remove members</a:t>
                       </a:r>
                     </a:p>
                   </a:txBody>
@@ -10893,7 +10893,7 @@
                           </a:solidFill>
                           <a:latin typeface="Segoe UI"/>
                         </a:rPr>
-                        <a:t>2.2.0</a:t>
+                        <a:t>2.3.0</a:t>
                       </a:r>
                     </a:p>
                   </a:txBody>
@@ -10937,7 +10937,7 @@
                           </a:solidFill>
                           <a:latin typeface="Segoe UI"/>
                         </a:rPr>
-                        <a:t>Pet sounds</a:t>
+                        <a:t>Friends, levels &amp; achievements</a:t>
                       </a:r>
                     </a:p>
                     <a:p>
@@ -10948,7 +10948,7 @@
                           </a:solidFill>
                           <a:latin typeface="Segoe UI"/>
                         </a:rPr>
-                        <a:t>Your pet has a voice! Each of the 23 animals has its own sound (meow, woof, ribbit, hoot, buzz, oink, whale song...) and it changes with its mood: happy chirps, sad whimpers, sleepy yawns, hungry calls, grumpy huffs and soft snores; It also reacts with sound when you tickle, pet, feed, shake or wake it; Settings: right-click the pet → Sounds to switch on/off; Pet status &amp; settings has a volume slider, a ▶ Hear me button and "Stay quiet while I'm focusing" (on by default)</a:t>
+                        <a:t>Levels &amp; XP: every finished pomodoro earns XP and your level grows - plus 20 achievements to unlock (first tomato, 8 in a day, 7-day streak, early bird, night owl, pet lover...). Your pet celebrates each one; Friends (optional, off by default): get a 6-letter friend code, add colleagues, see today's board and join a team board like PTB. Your pet tells you when a friend finishes a pomodoro; Privacy: only your name, pet, level, streak and pomodoro counts are shared - never apps, window titles or scores. One click turns it off and deletes your online data. Right-click the pet → Friends &amp; achievements…</a:t>
                       </a:r>
                     </a:p>
                   </a:txBody>
@@ -10972,7 +10972,7 @@
                           </a:solidFill>
                           <a:latin typeface="Segoe UI"/>
                         </a:rPr>
-                        <a:t>2.1.2</a:t>
+                        <a:t>2.2.0</a:t>
                       </a:r>
                     </a:p>
                   </a:txBody>
@@ -11016,7 +11016,7 @@
                           </a:solidFill>
                           <a:latin typeface="Segoe UI"/>
                         </a:rPr>
-                        <a:t>Tickle-only mode</a:t>
+                        <a:t>Pet sounds</a:t>
                       </a:r>
                     </a:p>
                     <a:p>
@@ -11027,7 +11027,7 @@
                           </a:solidFill>
                           <a:latin typeface="Segoe UI"/>
                         </a:rPr>
-                        <a:t>New click option "Only tickle (never open Pips)": click and tickle your pet as much as you like - the Pomodoro window stays closed (open it from the right-click menu). Right-click the pet → When I click</a:t>
+                        <a:t>Your pet has a voice! Each of the 23 animals has its own sound (meow, woof, ribbit, hoot, buzz, oink, whale song...) and it changes with its mood: happy chirps, sad whimpers, sleepy yawns, hungry calls, grumpy huffs and soft snores; It also reacts with sound when you tickle, pet, feed, shake or wake it; Settings: right-click the pet → Sounds to switch on/off; Pet status &amp; settings has a volume slider, a ▶ Hear me button and "Stay quiet while I'm focusing" (on by default)</a:t>
                       </a:r>
                     </a:p>
                   </a:txBody>
@@ -11051,7 +11051,7 @@
                           </a:solidFill>
                           <a:latin typeface="Segoe UI"/>
                         </a:rPr>
-                        <a:t>2.1.1</a:t>
+                        <a:t>2.1.2</a:t>
                       </a:r>
                     </a:p>
                   </a:txBody>
@@ -11095,7 +11095,7 @@
                           </a:solidFill>
                           <a:latin typeface="Segoe UI"/>
                         </a:rPr>
-                        <a:t>Owner info</a:t>
+                        <a:t>Tickle-only mode</a:t>
                       </a:r>
                     </a:p>
                     <a:p>
@@ -11106,7 +11106,7 @@
                           </a:solidFill>
                           <a:latin typeface="Segoe UI"/>
                         </a:rPr>
-                        <a:t>About Pips now shows the owner: Juwen Lie (right-click the pet → Help → About)</a:t>
+                        <a:t>New click option "Only tickle (never open Pips)": click and tickle your pet as much as you like - the Pomodoro window stays closed (open it from the right-click menu). Right-click the pet → When I click</a:t>
                       </a:r>
                     </a:p>
                   </a:txBody>
@@ -11130,7 +11130,7 @@
                           </a:solidFill>
                           <a:latin typeface="Segoe UI"/>
                         </a:rPr>
-                        <a:t>2.1.0</a:t>
+                        <a:t>2.1.1</a:t>
                       </a:r>
                     </a:p>
                   </a:txBody>
@@ -11174,7 +11174,7 @@
                           </a:solidFill>
                           <a:latin typeface="Segoe UI"/>
                         </a:rPr>
-                        <a:t>Interactive guide &amp; in-app updates</a:t>
+                        <a:t>Owner info</a:t>
                       </a:r>
                     </a:p>
                     <a:p>
@@ -11185,7 +11185,7 @@
                           </a:solidFill>
                           <a:latin typeface="Segoe UI"/>
                         </a:rPr>
-                        <a:t>Interactive first-run guide: your pet walks you through clicking, dragging, petting and the right-click menu; In-app updates: Pips tells you when a new version is out - update with one click (your settings and data are kept); New Help menu: replay the guide, check for updates, see the version; Option to turn automatic update checks off</a:t>
+                        <a:t>About Pips now shows the owner: Juwen Lie (right-click the pet → Help → About)</a:t>
                       </a:r>
                     </a:p>
                   </a:txBody>
@@ -11209,7 +11209,7 @@
                           </a:solidFill>
                           <a:latin typeface="Segoe UI"/>
                         </a:rPr>
-                        <a:t>2.0.0</a:t>
+                        <a:t>2.1.0</a:t>
                       </a:r>
                     </a:p>
                   </a:txBody>
@@ -11253,7 +11253,7 @@
                           </a:solidFill>
                           <a:latin typeface="Segoe UI"/>
                         </a:rPr>
-                        <a:t>Desktop pet, 23 animals &amp; 4 languages</a:t>
+                        <a:t>Interactive guide &amp; in-app updates</a:t>
                       </a:r>
                     </a:p>
                     <a:p>
@@ -11264,7 +11264,7 @@
                           </a:solidFill>
                           <a:latin typeface="Segoe UI"/>
                         </a:rPr>
-                        <a:t>Desktop pet that lives on your desktop and taskbar - drag it, tickle it, pet it; 23 animals in 3 groups: Land walks, Water swims with bubbles, Sky hovers and flaps; Moods (happy, sad, tired, hungry, grumpy...), naps when you're away, wakes up when you're back; Cute chat-bubble reminders: breaks, water, 20-20-20 eye rest, pomodoro done, daily goal</a:t>
+                        <a:t>Interactive first-run guide: your pet walks you through clicking, dragging, petting and the right-click menu; In-app updates: Pips tells you when a new version is out - update with one click (your settings and data are kept); New Help menu: replay the guide, check for updates, see the version; Option to turn automatic update checks off</a:t>
                       </a:r>
                     </a:p>
                   </a:txBody>
@@ -11288,7 +11288,7 @@
                           </a:solidFill>
                           <a:latin typeface="Segoe UI"/>
                         </a:rPr>
-                        <a:t>1.5.0</a:t>
+                        <a:t>2.0.0</a:t>
                       </a:r>
                     </a:p>
                   </a:txBody>
@@ -11310,7 +11310,7 @@
                           </a:solidFill>
                           <a:latin typeface="Segoe UI"/>
                         </a:rPr>
-                        <a:t>2026-10-24</a:t>
+                        <a:t>2026-10-28</a:t>
                       </a:r>
                     </a:p>
                   </a:txBody>
@@ -11332,7 +11332,7 @@
                           </a:solidFill>
                           <a:latin typeface="Segoe UI"/>
                         </a:rPr>
-                        <a:t>Renamed to Pips + insights</a:t>
+                        <a:t>Desktop pet, 23 animals &amp; 4 languages</a:t>
                       </a:r>
                     </a:p>
                     <a:p>
@@ -11343,7 +11343,7 @@
                           </a:solidFill>
                           <a:latin typeface="Segoe UI"/>
                         </a:rPr>
-                        <a:t>Renamed from Productivity Widget to Pips; Dashboard charts: focus timeline, hour heatmap, 7-day score trend, pomodoros per day; AI token usage on the card and dashboard; Daily diary export and weekly / monthly reports</a:t>
+                        <a:t>Desktop pet that lives on your desktop and taskbar - drag it, tickle it, pet it; 23 animals in 3 groups: Land walks, Water swims with bubbles, Sky hovers and flaps; Moods (happy, sad, tired, hungry, grumpy...), naps when you're away, wakes up when you're back; Cute chat-bubble reminders: breaks, water, 20-20-20 eye rest, pomodoro done, daily goal</a:t>
                       </a:r>
                     </a:p>
                   </a:txBody>
@@ -11367,13 +11367,92 @@
                           </a:solidFill>
                           <a:latin typeface="Segoe UI"/>
                         </a:rPr>
+                        <a:t>1.5.0</a:t>
+                      </a:r>
+                    </a:p>
+                  </a:txBody>
+                  <a:tcPr marL="73152" marR="73152" marT="36576" marB="36576">
+                    <a:solidFill>
+                      <a:srgbClr val="FFFDF8"/>
+                    </a:solidFill>
+                  </a:tcPr>
+                </a:tc>
+                <a:tc>
+                  <a:txBody>
+                    <a:bodyPr wrap="square"/>
+                    <a:lstStyle/>
+                    <a:p>
+                      <a:r>
+                        <a:rPr sz="1200" b="0">
+                          <a:solidFill>
+                            <a:srgbClr val="2B2A28"/>
+                          </a:solidFill>
+                          <a:latin typeface="Segoe UI"/>
+                        </a:rPr>
+                        <a:t>2026-10-24</a:t>
+                      </a:r>
+                    </a:p>
+                  </a:txBody>
+                  <a:tcPr marL="73152" marR="73152" marT="36576" marB="36576">
+                    <a:solidFill>
+                      <a:srgbClr val="FFFDF8"/>
+                    </a:solidFill>
+                  </a:tcPr>
+                </a:tc>
+                <a:tc>
+                  <a:txBody>
+                    <a:bodyPr wrap="square"/>
+                    <a:lstStyle/>
+                    <a:p>
+                      <a:r>
+                        <a:rPr sz="1200" b="0">
+                          <a:solidFill>
+                            <a:srgbClr val="2B2A28"/>
+                          </a:solidFill>
+                          <a:latin typeface="Segoe UI"/>
+                        </a:rPr>
+                        <a:t>Renamed to Pips + insights</a:t>
+                      </a:r>
+                    </a:p>
+                    <a:p>
+                      <a:r>
+                        <a:rPr sz="1200" b="0">
+                          <a:solidFill>
+                            <a:srgbClr val="2B2A28"/>
+                          </a:solidFill>
+                          <a:latin typeface="Segoe UI"/>
+                        </a:rPr>
+                        <a:t>Renamed from Productivity Widget to Pips; Dashboard charts: focus timeline, hour heatmap, 7-day score trend, pomodoros per day; AI token usage on the card and dashboard; Daily diary export and weekly / monthly reports</a:t>
+                      </a:r>
+                    </a:p>
+                  </a:txBody>
+                  <a:tcPr marL="73152" marR="73152" marT="36576" marB="36576">
+                    <a:solidFill>
+                      <a:srgbClr val="FFFDF8"/>
+                    </a:solidFill>
+                  </a:tcPr>
+                </a:tc>
+              </a:tr>
+              <a:tr h="822960">
+                <a:tc>
+                  <a:txBody>
+                    <a:bodyPr wrap="square"/>
+                    <a:lstStyle/>
+                    <a:p>
+                      <a:r>
+                        <a:rPr sz="1200" b="1">
+                          <a:solidFill>
+                            <a:srgbClr val="2B2A28"/>
+                          </a:solidFill>
+                          <a:latin typeface="Segoe UI"/>
+                        </a:rPr>
                         <a:t>1.0.0</a:t>
                       </a:r>
                     </a:p>
                   </a:txBody>
                   <a:tcPr marL="73152" marR="73152" marT="36576" marB="36576">
                     <a:solidFill>
-                      <a:srgbClr val="FFFDF8"/>
+                      <a:srgbClr val="F7F4EC"/>
                     </a:solidFill>
                   </a:tcPr>
                 </a:tc>
@@ -11395,7 +11474,7 @@
                   </a:txBody>
                   <a:tcPr marL="73152" marR="73152" marT="36576" marB="36576">
                     <a:solidFill>
-                      <a:srgbClr val="FFFDF8"/>
+                      <a:srgbClr val="F7F4EC"/>
                     </a:solidFill>
                   </a:tcPr>
                 </a:tc>
@@ -11428,7 +11507,7 @@
                   </a:txBody>
                   <a:tcPr marL="73152" marR="73152" marT="36576" marB="36576">
                     <a:solidFill>
-                      <a:srgbClr val="FFFDF8"/>
+                      <a:srgbClr val="F7F4EC"/>
                     </a:solidFill>
                   </a:tcPr>
                 </a:tc>
@@ -15184,7 +15263,7 @@
                           </a:solidFill>
                           <a:latin typeface="Segoe UI"/>
                         </a:rPr>
-                        <a:t>Meows, barks, ribbits, hoots… its voice changes with its mood</a:t>
+                        <a:t>Woofs, moos, roars, quacks… 51 voices that change with its mood</a:t>
                       </a:r>
                     </a:p>
                   </a:txBody>

</xml_diff>

<commit_message>
pips 2.22.0: Sing & dance with music
</commit_message>
<xml_diff>
--- a/apps/pips/web/download/Pips-Guide.pptx
+++ b/apps/pips/web/download/Pips-Guide.pptx
@@ -3292,7 +3292,7 @@
                 </a:solidFill>
                 <a:latin typeface="Segoe UI"/>
               </a:rPr>
-              <a:t>Version 2.21.0  ·  2026-10-29  ·  Made by Juwen Lie (owner)</a:t>
+              <a:t>Version 2.22.0  ·  2026-10-29  ·  Made by Juwen Lie (owner)</a:t>
             </a:r>
           </a:p>
           <a:p>
@@ -8279,7 +8279,7 @@
                 </a:solidFill>
                 <a:latin typeface="Segoe UI"/>
               </a:rPr>
-              <a:t>What's new in 2.21.0</a:t>
+              <a:t>What's new in 2.22.0</a:t>
             </a:r>
           </a:p>
         </p:txBody>
@@ -8392,7 +8392,7 @@
                 </a:solidFill>
                 <a:latin typeface="Segoe UI"/>
               </a:rPr>
-              <a:t>Every animal has a voice  ·  2026-10-29</a:t>
+              <a:t>Sing &amp; dance with music  ·  2026-10-29</a:t>
             </a:r>
           </a:p>
         </p:txBody>
@@ -8440,7 +8440,7 @@
                 </a:solidFill>
                 <a:latin typeface="Segoe UI"/>
               </a:rPr>
-              <a:t>All 51 animals now have their own sound. Before, more than half of them borrowed the cat's meow - now the dog woofs, the cow moos, the sheep baas, the lion roars, the duck quacks, the dolphin clicks and whistles, the dragon flaps and roars with a puff of fire, the ghost goes wooo... and so on.</a:t>
+              <a:t>Sing, Dance, Moonwalk, Breakdance, Yoga, Rain dance and the show tricks now play real music. When your pet sings, it sings the melody in its own voice - a cat meows the tune, a frog ribbits it, a whale hums it - and when it dances, its animal call joins the beat.</a:t>
             </a:r>
           </a:p>
           <a:p>
@@ -8465,7 +8465,7 @@
                 </a:solidFill>
                 <a:latin typeface="Segoe UI"/>
               </a:rPr>
-              <a:t>Every mood sounds different too: happy, sad, sleepy, hungry or grumpy. Petting, eating and snoring sound right for each kind of animal - furry ones purr and crunch, birds trill and peck, sea animals blow bubbles, bugs hum and magic pets chime.</a:t>
+              <a:t>Pick the song: right-click → Do a trick → Song for sing &amp; dance. Choose your animal's own song (every one of the 51 animals has its own tune), the song for its type (Meadow Hoedown for land, Ocean Calypso for water, Cloud Waltz for sky), Happy Pop, Disco Night, 8-bit Adventure, Lullaby, Lo-fi Chill, any other animal's song, Surprise me or No music.</a:t>
             </a:r>
           </a:p>
           <a:p>
@@ -8490,7 +8490,7 @@
                 </a:solidFill>
                 <a:latin typeface="Segoe UI"/>
               </a:rPr>
-              <a:t>A friend's pet that comes to visit now talks in its own voice: it says hi when it arrives and answers when you wave, pet it or give it a snack (it follows your sound settings).</a:t>
+              <a:t>Songs follow your sound settings (volume, sounds off, quiet during focus) and stop as soon as the trick is interrupted. Tricks your pet does by itself stay quiet.</a:t>
             </a:r>
           </a:p>
         </p:txBody>
@@ -8621,7 +8621,7 @@
                 </a:solidFill>
                 <a:latin typeface="Segoe UI"/>
               </a:rPr>
-              <a:t>Ke-51 hewan sekarang punya suaranya sendiri. Sebelumnya lebih dari separuhnya meminjam suara meong kucing - sekarang anjing menggonggong, sapi melenguh, domba mengembik, singa mengaum, bebek berkwek, lumba-lumba berdecit dan bersiul, naga mengepakkan sayap dan mengaum dengan semburan api, hantu bersuara huuu... dan seterusnya.</a:t>
+              <a:t>Nyanyi, Dansa, Moonwalk, Breakdance, Yoga, Tari hujan, dan trik pertunjukan sekarang memutar musik sungguhan. Saat pet bernyanyi, ia menyanyikan melodinya dengan suaranya sendiri - kucing mengeong mengikuti nada, katak berkwak, paus bersenandung - dan saat berdansa, suara khas hewannya ikut mengikuti irama.</a:t>
             </a:r>
           </a:p>
           <a:p>
@@ -8646,7 +8646,7 @@
                 </a:solidFill>
                 <a:latin typeface="Segoe UI"/>
               </a:rPr>
-              <a:t>Setiap suasana hati juga terdengar berbeda: senang, sedih, mengantuk, lapar, atau kesal. Suara dielus, makan, dan mendengkur cocok dengan jenis hewannya - hewan berbulu mendengkur dan mengunyah, burung berkicau dan mematuk, hewan laut membuat gelembung, serangga berdengung, dan pet ajaib berdenting.</a:t>
+              <a:t>Pilih lagunya: klik kanan → Lakukan trik → Lagu untuk nyanyi &amp; dansa. Pilih lagu khas hewanmu (ke-51 hewan punya lagu sendiri), lagu untuk tipenya (Dansa Padang Rumput untuk darat, Calypso Samudra untuk air, Waltz Awan untuk udara), Pop Ceria, Malam Disko, Petualangan 8-bit, Nina Bobo, Lo-fi Santai, lagu hewan lain, Kejutkan aku, atau Tanpa musik.</a:t>
             </a:r>
           </a:p>
           <a:p>
@@ -8671,7 +8671,7 @@
                 </a:solidFill>
                 <a:latin typeface="Segoe UI"/>
               </a:rPr>
-              <a:t>Pet teman yang datang berkunjung sekarang bicara dengan suaranya sendiri: ia menyapa saat tiba dan membalas saat kamu melambai, mengelus, atau memberinya camilan (mengikuti pengaturan suaramu).</a:t>
+              <a:t>Lagu mengikuti pengaturan suara (volume, suara mati, senyap saat fokus) dan langsung berhenti saat trik terganggu. Trik yang dilakukan pet sendiri tetap tanpa musik.</a:t>
             </a:r>
           </a:p>
         </p:txBody>
@@ -8903,7 +8903,7 @@
         </p:nvGraphicFramePr>
         <p:xfrm>
           <a:off x="548640" y="1645920"/>
-          <a:ext cx="11155680" cy="26718768"/>
+          <a:ext cx="11155680" cy="27541728"/>
         </p:xfrm>
         <a:graphic>
           <a:graphicData uri="http://schemas.openxmlformats.org/drawingml/2006/table">
@@ -8997,7 +8997,7 @@
                           </a:solidFill>
                           <a:latin typeface="Segoe UI"/>
                         </a:rPr>
-                        <a:t>2.21.0</a:t>
+                        <a:t>2.22.0</a:t>
                       </a:r>
                     </a:p>
                   </a:txBody>
@@ -9041,7 +9041,7 @@
                           </a:solidFill>
                           <a:latin typeface="Segoe UI"/>
                         </a:rPr>
-                        <a:t>Every animal has a voice</a:t>
+                        <a:t>Sing &amp; dance with music</a:t>
                       </a:r>
                     </a:p>
                     <a:p>
@@ -9052,7 +9052,7 @@
                           </a:solidFill>
                           <a:latin typeface="Segoe UI"/>
                         </a:rPr>
-                        <a:t>All 51 animals now have their own sound. Before, more than half of them borrowed the cat's meow - now the dog woofs, the cow moos, the sheep baas, the lion roars, the duck quacks, the dolphin clicks and whistles, the dragon flaps and roars with a puff of fire, the ghost goes wooo... and so on.; Every mood sounds different too: happy, sad, sleepy, hungry or grumpy. Petting, eating and snoring sound right for each kind of animal - furry ones purr and crunch, birds trill and peck, sea animals blow bubbles, bugs hum and magic pets chime.; A friend's pet that comes to visit now talks in its own voice: it says hi when it arrives and answers when you wave, pet it or give it a snack (it follows your sound settings).</a:t>
+                        <a:t>Sing, Dance, Moonwalk, Breakdance, Yoga, Rain dance and the show tricks now play real music. When your pet sings, it sings the melody in its own voice - a cat meows the tune, a frog ribbits it, a whale hums it - and when it dances, its animal call joins the beat.; Pick the song: right-click → Do a trick → Song for sing &amp; dance. Choose your animal's own song (every one of the 51 animals has its own tune), the song for its type (Meadow Hoedown for land, Ocean Calypso for water, Cloud Waltz for sky), Happy Pop, Disco Night, 8-bit Adventure, Lullaby, Lo-fi Chill, any other animal's song, Surprise me or No music.; Songs follow your sound settings (volume, sounds off, quiet during focus) and stop as soon as the trick is interrupted. Tricks your pet does by itself stay quiet.</a:t>
                       </a:r>
                     </a:p>
                   </a:txBody>
@@ -9076,7 +9076,7 @@
                           </a:solidFill>
                           <a:latin typeface="Segoe UI"/>
                         </a:rPr>
-                        <a:t>2.20.0</a:t>
+                        <a:t>2.21.0</a:t>
                       </a:r>
                     </a:p>
                   </a:txBody>
@@ -9120,7 +9120,7 @@
                           </a:solidFill>
                           <a:latin typeface="Segoe UI"/>
                         </a:rPr>
-                        <a:t>Come over</a:t>
+                        <a:t>Every animal has a voice</a:t>
                       </a:r>
                     </a:p>
                     <a:p>
@@ -9131,7 +9131,7 @@
                           </a:solidFill>
                           <a:latin typeface="Segoe UI"/>
                         </a:rPr>
-                        <a:t>When a friend's pet comes over it now wears a name tag: your friend's name (or the nickname you gave them), ♂/♀ and an online dot. It walks up to your pet, says hi, and looks at your mouse when you point at it.; Point at the visitor (or click its name tag) to open its card: whose pet it is, level, how close you two are, and buttons to wave, pet it, give it a snack, visit back or chat. It reacts to everything - hearts, crumbs, happy faces - and your friend sees it too.; Rub your mouse over the visitor to pet it. Playing with it makes it stay longer, and your pet comes down from a window or the sky to meet it.</a:t>
+                        <a:t>All 51 animals now have their own sound. Before, more than half of them borrowed the cat's meow - now the dog woofs, the cow moos, the sheep baas, the lion roars, the duck quacks, the dolphin clicks and whistles, the dragon flaps and roars with a puff of fire, the ghost goes wooo... and so on.; Every mood sounds different too: happy, sad, sleepy, hungry or grumpy. Petting, eating and snoring sound right for each kind of animal - furry ones purr and crunch, birds trill and peck, sea animals blow bubbles, bugs hum and magic pets chime.; A friend's pet that comes to visit now talks in its own voice: it says hi when it arrives and answers when you wave, pet it or give it a snack (it follows your sound settings).</a:t>
                       </a:r>
                     </a:p>
                   </a:txBody>
@@ -9155,7 +9155,7 @@
                           </a:solidFill>
                           <a:latin typeface="Segoe UI"/>
                         </a:rPr>
-                        <a:t>2.19.0</a:t>
+                        <a:t>2.20.0</a:t>
                       </a:r>
                     </a:p>
                   </a:txBody>
@@ -9199,7 +9199,7 @@
                           </a:solidFill>
                           <a:latin typeface="Segoe UI"/>
                         </a:rPr>
-                        <a:t>Land, sea &amp; sky</a:t>
+                        <a:t>Come over</a:t>
                       </a:r>
                     </a:p>
                     <a:p>
@@ -9210,7 +9210,7 @@
                           </a:solidFill>
                           <a:latin typeface="Segoe UI"/>
                         </a:rPr>
-                        <a:t>Land animals walk on the taskbar and on top of your open windows now: they jump up onto window edges, walk along them, ride along when you move the window and hop down when it closes, gets covered or is maximised. They always have gravity - let go of one in mid-air and it lands on the window below or on the taskbar.; Water animals swim along the taskbar (their water) and every now and then leap high out of it in a big arc, diving back in with a splash, ripples and spray. Drop one anywhere and it dives back into the water.; Flying animals fly anywhere on the screen: they flutter from place to place, hover, come say hi near your mouse, and sometimes perch on the taskbar or a window edge for a rest. Point at one and it waits for you; they glide down to a perch before a nap.; New menu moves: Jump onto a window, Splash jump!, Fly around / Rest on the taskbar. "Move around by myself" in Pet settings keeps your pet still if you prefer (the old Gravity option is gone - land animals always fall now).</a:t>
+                        <a:t>When a friend's pet comes over it now wears a name tag: your friend's name (or the nickname you gave them), ♂/♀ and an online dot. It walks up to your pet, says hi, and looks at your mouse when you point at it.; Point at the visitor (or click its name tag) to open its card: whose pet it is, level, how close you two are, and buttons to wave, pet it, give it a snack, visit back or chat. It reacts to everything - hearts, crumbs, happy faces - and your friend sees it too.; Rub your mouse over the visitor to pet it. Playing with it makes it stay longer, and your pet comes down from a window or the sky to meet it.</a:t>
                       </a:r>
                     </a:p>
                   </a:txBody>
@@ -9234,7 +9234,7 @@
                           </a:solidFill>
                           <a:latin typeface="Segoe UI"/>
                         </a:rPr>
-                        <a:t>2.18.0</a:t>
+                        <a:t>2.19.0</a:t>
                       </a:r>
                     </a:p>
                   </a:txBody>
@@ -9278,7 +9278,7 @@
                           </a:solidFill>
                           <a:latin typeface="Segoe UI"/>
                         </a:rPr>
-                        <a:t>Raise your pet</a:t>
+                        <a:t>Land, sea &amp; sky</a:t>
                       </a:r>
                     </a:p>
                     <a:p>
@@ -9289,7 +9289,7 @@
                           </a:solidFill>
                           <a:latin typeface="Segoe UI"/>
                         </a:rPr>
-                        <a:t>Boy or girl? Pick your pet's gender in Settings: boys get a little hair tuft, girls a pink bow and eyelashes, and a ♂ / ♀ shows next to its name. You can add your own gender to your profile too - friends see a small ♂ / ♀ next to your name.; Pets grow up now: baby → child → teen → grown-up. Focus sessions, opening Pips each day, games and cuddles help them grow - no care mistakes, no bad endings. Already have a grown-up pet? It will ask whether you'd like to raise it again from a baby (coins, items and stats stay).; Sick days: work 2.5 hours without a 5-minute break and your pet catches a little cold (sneezes, thermometer, slow steps). A short break cures it - or give medicine from the menu. You can turn this off in Settings.; New mini-game Left or Right? (pet menu → Play): guess which way your pet will look - 3 out of 5 wins, with coins for your first wins each day.</a:t>
+                        <a:t>Land animals walk on the taskbar and on top of your open windows now: they jump up onto window edges, walk along them, ride along when you move the window and hop down when it closes, gets covered or is maximised. They always have gravity - let go of one in mid-air and it lands on the window below or on the taskbar.; Water animals swim along the taskbar (their water) and every now and then leap high out of it in a big arc, diving back in with a splash, ripples and spray. Drop one anywhere and it dives back into the water.; Flying animals fly anywhere on the screen: they flutter from place to place, hover, come say hi near your mouse, and sometimes perch on the taskbar or a window edge for a rest. Point at one and it waits for you; they glide down to a perch before a nap.; New menu moves: Jump onto a window, Splash jump!, Fly around / Rest on the taskbar. "Move around by myself" in Pet settings keeps your pet still if you prefer (the old Gravity option is gone - land animals always fall now).</a:t>
                       </a:r>
                     </a:p>
                   </a:txBody>
@@ -9313,7 +9313,7 @@
                           </a:solidFill>
                           <a:latin typeface="Segoe UI"/>
                         </a:rPr>
-                        <a:t>2.17.0</a:t>
+                        <a:t>2.18.0</a:t>
                       </a:r>
                     </a:p>
                   </a:txBody>
@@ -9357,7 +9357,7 @@
                           </a:solidFill>
                           <a:latin typeface="Segoe UI"/>
                         </a:rPr>
-                        <a:t>Find your pet anytime</a:t>
+                        <a:t>Raise your pet</a:t>
                       </a:r>
                     </a:p>
                     <a:p>
@@ -9368,7 +9368,7 @@
                           </a:solidFill>
                           <a:latin typeface="Segoe UI"/>
                         </a:rPr>
-                        <a:t>Pips now has an icon next to the clock: click it to bring your pet back; right-click for the focus timer, Friends &amp; chat or Quit.; Press Ctrl+Alt+P anywhere to call your pet - it pops up on the screen you're using, even if it was hidden, asleep or behind a fullscreen app.; Opening Pips again from the Start menu or desktop does the same, and your pet walks back by itself if it ever ends up off-screen (e.g. after unplugging a monitor).; Hiding your pet now tells you how to bring it back.</a:t>
+                        <a:t>Boy or girl? Pick your pet's gender in Settings: boys get a little hair tuft, girls a pink bow and eyelashes, and a ♂ / ♀ shows next to its name. You can add your own gender to your profile too - friends see a small ♂ / ♀ next to your name.; Pets grow up now: baby → child → teen → grown-up. Focus sessions, opening Pips each day, games and cuddles help them grow - no care mistakes, no bad endings. Already have a grown-up pet? It will ask whether you'd like to raise it again from a baby (coins, items and stats stay).; Sick days: work 2.5 hours without a 5-minute break and your pet catches a little cold (sneezes, thermometer, slow steps). A short break cures it - or give medicine from the menu. You can turn this off in Settings.; New mini-game Left or Right? (pet menu → Play): guess which way your pet will look - 3 out of 5 wins, with coins for your first wins each day.</a:t>
                       </a:r>
                     </a:p>
                   </a:txBody>
@@ -9392,7 +9392,7 @@
                           </a:solidFill>
                           <a:latin typeface="Segoe UI"/>
                         </a:rPr>
-                        <a:t>2.16.0</a:t>
+                        <a:t>2.17.0</a:t>
                       </a:r>
                     </a:p>
                   </a:txBody>
@@ -9436,7 +9436,7 @@
                           </a:solidFill>
                           <a:latin typeface="Segoe UI"/>
                         </a:rPr>
-                        <a:t>Pips Community</a:t>
+                        <a:t>Find your pet anytime</a:t>
                       </a:r>
                     </a:p>
                     <a:p>
@@ -9447,7 +9447,7 @@
                           </a:solidFill>
                           <a:latin typeface="Segoe UI"/>
                         </a:rPr>
-                        <a:t>New Pips Community at the top of the Chat tab: a #general channel to chat with everyone who uses Pips, plus #announcements with news from the Pips team.; Every new Pips version is announced there automatically - see what's new and update with one click.; Type @name to ping someone in #general. Mute #general any time; owner and moderators can remove messages.; Open it from your pet's menu too (Pips Community). Fixed: chats no longer clear what you're typing when Pips refreshes in the background.</a:t>
+                        <a:t>Pips now has an icon next to the clock: click it to bring your pet back; right-click for the focus timer, Friends &amp; chat or Quit.; Press Ctrl+Alt+P anywhere to call your pet - it pops up on the screen you're using, even if it was hidden, asleep or behind a fullscreen app.; Opening Pips again from the Start menu or desktop does the same, and your pet walks back by itself if it ever ends up off-screen (e.g. after unplugging a monitor).; Hiding your pet now tells you how to bring it back.</a:t>
                       </a:r>
                     </a:p>
                   </a:txBody>
@@ -9471,7 +9471,7 @@
                           </a:solidFill>
                           <a:latin typeface="Segoe UI"/>
                         </a:rPr>
-                        <a:t>2.15.0</a:t>
+                        <a:t>2.16.0</a:t>
                       </a:r>
                     </a:p>
                   </a:txBody>
@@ -9515,7 +9515,7 @@
                           </a:solidFill>
                           <a:latin typeface="Segoe UI"/>
                         </a:rPr>
-                        <a:t>Update reminders</a:t>
+                        <a:t>Pips Community</a:t>
                       </a:r>
                     </a:p>
                     <a:p>
@@ -9526,7 +9526,7 @@
                           </a:solidFill>
                           <a:latin typeface="Segoe UI"/>
                         </a:rPr>
-                        <a:t>Owner &amp; moderators: the Mod tab now lists who hasn't updated Pips yet (their version and when they were last seen), with one-click reminders by e-mail (sent from your Outlook) or a ready-to-send Teams chat.; New Work e-mail field in your Profile, filled in from Outlook. Only the owner and moderators can see it (for update reminders and support) - clear it to hide it.; Pips now tells the Friends server which version it runs, so the update list is always accurate.; Friends keeps working when a local proxy tool stops answering - Pips falls back to the Windows proxy settings.</a:t>
+                        <a:t>New Pips Community at the top of the Chat tab: a #general channel to chat with everyone who uses Pips, plus #announcements with news from the Pips team.; Every new Pips version is announced there automatically - see what's new and update with one click.; Type @name to ping someone in #general. Mute #general any time; owner and moderators can remove messages.; Open it from your pet's menu too (Pips Community). Fixed: chats no longer clear what you're typing when Pips refreshes in the background.</a:t>
                       </a:r>
                     </a:p>
                   </a:txBody>
@@ -9550,7 +9550,7 @@
                           </a:solidFill>
                           <a:latin typeface="Segoe UI"/>
                         </a:rPr>
-                        <a:t>2.14.3</a:t>
+                        <a:t>2.15.0</a:t>
                       </a:r>
                     </a:p>
                   </a:txBody>
@@ -9594,7 +9594,7 @@
                           </a:solidFill>
                           <a:latin typeface="Segoe UI"/>
                         </a:rPr>
-                        <a:t>Tidy menus</a:t>
+                        <a:t>Update reminders</a:t>
                       </a:r>
                     </a:p>
                     <a:p>
@@ -9605,7 +9605,7 @@
                           </a:solidFill>
                           <a:latin typeface="Segoe UI"/>
                         </a:rPr>
-                        <a:t>Fixed: a submenu (e.g. Poke a friend) could stay floating on the screen after the right-click menu closed.; Menus now close by themselves when you move the mouse away and leave them for a few seconds.</a:t>
+                        <a:t>Owner &amp; moderators: the Mod tab now lists who hasn't updated Pips yet (their version and when they were last seen), with one-click reminders by e-mail (sent from your Outlook) or a ready-to-send Teams chat.; New Work e-mail field in your Profile, filled in from Outlook. Only the owner and moderators can see it (for update reminders and support) - clear it to hide it.; Pips now tells the Friends server which version it runs, so the update list is always accurate.; Friends keeps working when a local proxy tool stops answering - Pips falls back to the Windows proxy settings.</a:t>
                       </a:r>
                     </a:p>
                   </a:txBody>
@@ -9629,7 +9629,7 @@
                           </a:solidFill>
                           <a:latin typeface="Segoe UI"/>
                         </a:rPr>
-                        <a:t>2.14.2</a:t>
+                        <a:t>2.14.3</a:t>
                       </a:r>
                     </a:p>
                   </a:txBody>
@@ -9673,7 +9673,7 @@
                           </a:solidFill>
                           <a:latin typeface="Segoe UI"/>
                         </a:rPr>
-                        <a:t>Never miss an update</a:t>
+                        <a:t>Tidy menus</a:t>
                       </a:r>
                     </a:p>
                     <a:p>
@@ -9684,7 +9684,7 @@
                           </a:solidFill>
                           <a:latin typeface="Segoe UI"/>
                         </a:rPr>
-                        <a:t>Your pet now reminds you every 2 hours while a new version is waiting (instead of every 6 hours).; If the reminder can't show (fullscreen app, guided tour, another message), your pet tries again a few minutes later.; No internet when Pips starts (e.g. VPN off)? It checks again after an hour.</a:t>
+                        <a:t>Fixed: a submenu (e.g. Poke a friend) could stay floating on the screen after the right-click menu closed.; Menus now close by themselves when you move the mouse away and leave them for a few seconds.</a:t>
                       </a:r>
                     </a:p>
                   </a:txBody>
@@ -9708,7 +9708,7 @@
                           </a:solidFill>
                           <a:latin typeface="Segoe UI"/>
                         </a:rPr>
-                        <a:t>2.14.1</a:t>
+                        <a:t>2.14.2</a:t>
                       </a:r>
                     </a:p>
                   </a:txBody>
@@ -9752,7 +9752,7 @@
                           </a:solidFill>
                           <a:latin typeface="Segoe UI"/>
                         </a:rPr>
-                        <a:t>One pet at a time</a:t>
+                        <a:t>Never miss an update</a:t>
                       </a:r>
                     </a:p>
                     <a:p>
@@ -9763,7 +9763,7 @@
                           </a:solidFill>
                           <a:latin typeface="Segoe UI"/>
                         </a:rPr>
-                        <a:t>Opening Pips again (Desktop / Start Menu shortcut, autostart) no longer starts a second pet - your pet just pops up and says hi.; Fixes lag caused by two copies of Pips running at once.</a:t>
+                        <a:t>Your pet now reminds you every 2 hours while a new version is waiting (instead of every 6 hours).; If the reminder can't show (fullscreen app, guided tour, another message), your pet tries again a few minutes later.; No internet when Pips starts (e.g. VPN off)? It checks again after an hour.</a:t>
                       </a:r>
                     </a:p>
                   </a:txBody>
@@ -9787,7 +9787,7 @@
                           </a:solidFill>
                           <a:latin typeface="Segoe UI"/>
                         </a:rPr>
-                        <a:t>2.14.0</a:t>
+                        <a:t>2.14.1</a:t>
                       </a:r>
                     </a:p>
                   </a:txBody>
@@ -9831,7 +9831,7 @@
                           </a:solidFill>
                           <a:latin typeface="Segoe UI"/>
                         </a:rPr>
-                        <a:t>Pokes, tickles &amp; teases</a:t>
+                        <a:t>One pet at a time</a:t>
                       </a:r>
                     </a:p>
                     <a:p>
@@ -9842,7 +9842,7 @@
                           </a:solidFill>
                           <a:latin typeface="Segoe UI"/>
                         </a:rPr>
-                        <a:t>Poke, tickle, tease, boop or hug a friend from afar - no pet visit needed.; Right-click your pet → Poke a friend, or use the Poke button in Friends, chat and profiles.; Your friend gets a pop-up ("Wendy is teasing you!"), their pet reacts, and they can poke back with one click.; During a focus session pokes wait quietly until your break; when your pet is hidden they show in the screen corner.</a:t>
+                        <a:t>Opening Pips again (Desktop / Start Menu shortcut, autostart) no longer starts a second pet - your pet just pops up and says hi.; Fixes lag caused by two copies of Pips running at once.</a:t>
                       </a:r>
                     </a:p>
                   </a:txBody>
@@ -9866,7 +9866,7 @@
                           </a:solidFill>
                           <a:latin typeface="Segoe UI"/>
                         </a:rPr>
-                        <a:t>2.13.1</a:t>
+                        <a:t>2.14.0</a:t>
                       </a:r>
                     </a:p>
                   </a:txBody>
@@ -9888,7 +9888,7 @@
                           </a:solidFill>
                           <a:latin typeface="Segoe UI"/>
                         </a:rPr>
-                        <a:t>2026-10-28</a:t>
+                        <a:t>2026-10-29</a:t>
                       </a:r>
                     </a:p>
                   </a:txBody>
@@ -9910,7 +9910,7 @@
                           </a:solidFill>
                           <a:latin typeface="Segoe UI"/>
                         </a:rPr>
-                        <a:t>One-click Windows installer</a:t>
+                        <a:t>Pokes, tickles &amp; teases</a:t>
                       </a:r>
                     </a:p>
                     <a:p>
@@ -9921,7 +9921,7 @@
                           </a:solidFill>
                           <a:latin typeface="Segoe UI"/>
                         </a:rPr>
-                        <a:t>One Windows installer: no ZIP extraction, Python installation or command line. Download, open and click Install Pips.; Installs for your Windows account without administrator access, adds Desktop and Start Menu shortcuts, and opens Pips automatically.; Reinstalling in the same location keeps your settings and pet progress. Existing ZIP users can keep updating in place from Help → Check for updates.; A simpler download page and updated user guide; the bundled runtime stays separate from small in-app updates.</a:t>
+                        <a:t>Poke, tickle, tease, boop or hug a friend from afar - no pet visit needed.; Right-click your pet → Poke a friend, or use the Poke button in Friends, chat and profiles.; Your friend gets a pop-up ("Wendy is teasing you!"), their pet reacts, and they can poke back with one click.; During a focus session pokes wait quietly until your break; when your pet is hidden they show in the screen corner.</a:t>
                       </a:r>
                     </a:p>
                   </a:txBody>
@@ -9945,7 +9945,7 @@
                           </a:solidFill>
                           <a:latin typeface="Segoe UI"/>
                         </a:rPr>
-                        <a:t>2.13.0</a:t>
+                        <a:t>2.13.1</a:t>
                       </a:r>
                     </a:p>
                   </a:txBody>
@@ -9989,7 +9989,7 @@
                           </a:solidFill>
                           <a:latin typeface="Segoe UI"/>
                         </a:rPr>
-                        <a:t>Birthdays, parties &amp; gifts</a:t>
+                        <a:t>One-click Windows installer</a:t>
                       </a:r>
                     </a:p>
                     <a:p>
@@ -10000,7 +10000,7 @@
                           </a:solidFill>
                           <a:latin typeface="Segoe UI"/>
                         </a:rPr>
-                        <a:t>Set your birthday in Social → Profile (month + day, optionally visible to friends).; On your birthday Pips throws confetti and gives you 100 bonus coins.; Friends tab shows upcoming birthdays; you get reminders 3 days, 1 day and on the day.; Birthday parties: join a friend's party, see who's there, sign the guestbook and celebrate together.</a:t>
+                        <a:t>One Windows installer: no ZIP extraction, Python installation or command line. Download, open and click Install Pips.; Installs for your Windows account without administrator access, adds Desktop and Start Menu shortcuts, and opens Pips automatically.; Reinstalling in the same location keeps your settings and pet progress. Existing ZIP users can keep updating in place from Help → Check for updates.; A simpler download page and updated user guide; the bundled runtime stays separate from small in-app updates.</a:t>
                       </a:r>
                     </a:p>
                   </a:txBody>
@@ -10024,7 +10024,7 @@
                           </a:solidFill>
                           <a:latin typeface="Segoe UI"/>
                         </a:rPr>
-                        <a:t>2.12.0</a:t>
+                        <a:t>2.13.0</a:t>
                       </a:r>
                     </a:p>
                   </a:txBody>
@@ -10068,7 +10068,7 @@
                           </a:solidFill>
                           <a:latin typeface="Segoe UI"/>
                         </a:rPr>
-                        <a:t>Mega update: 28 new animals, 31 shop items, 13 moves</a:t>
+                        <a:t>Birthdays, parties &amp; gifts</a:t>
                       </a:r>
                     </a:p>
                     <a:p>
@@ -10079,7 +10079,7 @@
                           </a:solidFill>
                           <a:latin typeface="Segoe UI"/>
                         </a:rPr>
-                        <a:t>🦁 28 new animals (51 total): lion, tiger, unicorn, deer, sheep, cow, raccoon, red panda, monkey, hedgehog, dino, squirrel, mouse, koala, shark, dolphin, seal, otter, pufferfish, duck, crab, parrot, chick, ladybug, phoenix, pegasus, ghost and flamingo; 🎩 31 new shop items: top hat, cowboy, chef, pirate, Santa, viking, graduation cap, beret, bow, propeller cap, flower crown, nerd glasses, eyepatch, mustache, goggles, masquerade mask, tie, pearls, flower lei, gold chain, balloon, backpack, guitar, shield, butterfly / devil wings and more - plus Premium galaxy crown, galaxy cape and dragon wings; 💃 13 new moves: wave, jump, hearts, sing, yoga, zoomies, cartwheel, juggle, rain dance, breakdance, magic, confetti and the Premium rocket launch; The Shop is now split into sections (Hats, Face, Neck, Back, Moves, Arena gear) with an owned counter for each</a:t>
+                        <a:t>Set your birthday in Social → Profile (month + day, optionally visible to friends).; On your birthday Pips throws confetti and gives you 100 bonus coins.; Friends tab shows upcoming birthdays; you get reminders 3 days, 1 day and on the day.; Birthday parties: join a friend's party, see who's there, sign the guestbook and celebrate together.</a:t>
                       </a:r>
                     </a:p>
                   </a:txBody>
@@ -10103,7 +10103,7 @@
                           </a:solidFill>
                           <a:latin typeface="Segoe UI"/>
                         </a:rPr>
-                        <a:t>2.11.0</a:t>
+                        <a:t>2.12.0</a:t>
                       </a:r>
                     </a:p>
                   </a:txBody>
@@ -10147,7 +10147,7 @@
                           </a:solidFill>
                           <a:latin typeface="Segoe UI"/>
                         </a:rPr>
-                        <a:t>New right-click menus</a:t>
+                        <a:t>Mega update: 28 new animals, 31 shop items, 13 moves</a:t>
                       </a:r>
                     </a:p>
                     <a:p>
@@ -10158,7 +10158,7 @@
                           </a:solidFill>
                           <a:latin typeface="Segoe UI"/>
                         </a:rPr>
-                        <a:t>✨ Brand-new animated right-click menu for your pet: mood &amp; stat bars, quick-action tiles (Friends, Shop, Snack, Pat, Focus, Stats, Sleep, Taskbar), hover effects and smooth fly-out submenus; Pick colours from swatches, switch size with one click and flip Sounds / Dark mode with toggle switches - changes show instantly; Updates are highlighted: a glowing banner and NEW badge appear in the menu when a new version is ready; The focus card's right-click menu got the same new look; keyboard arrows, Enter and Esc work too</a:t>
+                        <a:t>🦁 28 new animals (51 total): lion, tiger, unicorn, deer, sheep, cow, raccoon, red panda, monkey, hedgehog, dino, squirrel, mouse, koala, shark, dolphin, seal, otter, pufferfish, duck, crab, parrot, chick, ladybug, phoenix, pegasus, ghost and flamingo; 🎩 31 new shop items: top hat, cowboy, chef, pirate, Santa, viking, graduation cap, beret, bow, propeller cap, flower crown, nerd glasses, eyepatch, mustache, goggles, masquerade mask, tie, pearls, flower lei, gold chain, balloon, backpack, guitar, shield, butterfly / devil wings and more - plus Premium galaxy crown, galaxy cape and dragon wings; 💃 13 new moves: wave, jump, hearts, sing, yoga, zoomies, cartwheel, juggle, rain dance, breakdance, magic, confetti and the Premium rocket launch; The Shop is now split into sections (Hats, Face, Neck, Back, Moves, Arena gear) with an owned counter for each</a:t>
                       </a:r>
                     </a:p>
                   </a:txBody>
@@ -10182,7 +10182,7 @@
                           </a:solidFill>
                           <a:latin typeface="Segoe UI"/>
                         </a:rPr>
-                        <a:t>2.10.0</a:t>
+                        <a:t>2.11.0</a:t>
                       </a:r>
                     </a:p>
                   </a:txBody>
@@ -10226,7 +10226,7 @@
                           </a:solidFill>
                           <a:latin typeface="Segoe UI"/>
                         </a:rPr>
-                        <a:t>Chat bots</a:t>
+                        <a:t>New right-click menus</a:t>
                       </a:r>
                     </a:p>
                     <a:p>
@@ -10237,7 +10237,7 @@
                           </a:solidFill>
                           <a:latin typeface="Segoe UI"/>
                         </a:rPr>
-                        <a:t>🤖 6 friendly chat bots in the Chat tab: Pip Helper (app questions), Coach Focus (focus tips from your real stats), Sunny (live weather for any city), Arena Master (battle tips + quick battle), Giggles (jokes &amp; games) and Guardian (safety &amp; reporting help); Private bot chats with suggestion chips, typing indicator and a clear button - your bot chats stay on your PC; Mention a bot in a group chat (e.g. @weather Batam) and it answers in the room for everyone; Bots reply in your app language; up to 120 bot messages per day</a:t>
+                        <a:t>✨ Brand-new animated right-click menu for your pet: mood &amp; stat bars, quick-action tiles (Friends, Shop, Snack, Pat, Focus, Stats, Sleep, Taskbar), hover effects and smooth fly-out submenus; Pick colours from swatches, switch size with one click and flip Sounds / Dark mode with toggle switches - changes show instantly; Updates are highlighted: a glowing banner and NEW badge appear in the menu when a new version is ready; The focus card's right-click menu got the same new look; keyboard arrows, Enter and Esc work too</a:t>
                       </a:r>
                     </a:p>
                   </a:txBody>
@@ -10261,7 +10261,7 @@
                           </a:solidFill>
                           <a:latin typeface="Segoe UI"/>
                         </a:rPr>
-                        <a:t>2.9.0</a:t>
+                        <a:t>2.10.0</a:t>
                       </a:r>
                     </a:p>
                   </a:txBody>
@@ -10305,7 +10305,7 @@
                           </a:solidFill>
                           <a:latin typeface="Segoe UI"/>
                         </a:rPr>
-                        <a:t>Location &amp; live weather</a:t>
+                        <a:t>Chat bots</a:t>
                       </a:r>
                     </a:p>
                     <a:p>
@@ -10316,7 +10316,7 @@
                           </a:solidFill>
                           <a:latin typeface="Segoe UI"/>
                         </a:rPr>
-                        <a:t>📍 Add your city in Profile → Location &amp; weather (auto-detect or search) - only your city and country are shown, never your exact position; Live weather banners on every profile with animations: rain, drizzle, thunderstorms with lightning, snow, fog, clouds, sunshine or a starry night - plus temperature, feels-like, humidity, wind and local time; Your own weather strip on top of the hub, and each friend's weather + local time in the friends list; Hide your location from others or remove it any time</a:t>
+                        <a:t>🤖 6 friendly chat bots in the Chat tab: Pip Helper (app questions), Coach Focus (focus tips from your real stats), Sunny (live weather for any city), Arena Master (battle tips + quick battle), Giggles (jokes &amp; games) and Guardian (safety &amp; reporting help); Private bot chats with suggestion chips, typing indicator and a clear button - your bot chats stay on your PC; Mention a bot in a group chat (e.g. @weather Batam) and it answers in the room for everyone; Bots reply in your app language; up to 120 bot messages per day</a:t>
                       </a:r>
                     </a:p>
                   </a:txBody>
@@ -10340,7 +10340,7 @@
                           </a:solidFill>
                           <a:latin typeface="Segoe UI"/>
                         </a:rPr>
-                        <a:t>2.8.0</a:t>
+                        <a:t>2.9.0</a:t>
                       </a:r>
                     </a:p>
                   </a:txBody>
@@ -10384,7 +10384,7 @@
                           </a:solidFill>
                           <a:latin typeface="Segoe UI"/>
                         </a:rPr>
-                        <a:t>Pips Arena - duels, gear &amp; live battles</a:t>
+                        <a:t>Location &amp; live weather</a:t>
                       </a:r>
                     </a:p>
                     <a:p>
@@ -10395,7 +10395,7 @@
                           </a:solidFill>
                           <a:latin typeface="Segoe UI"/>
                         </a:rPr>
-                        <a:t>⚔ New Arena tab: challenge friends or anyone in the arena to a live duel - each round pick Attack, Guard or Special within 12 seconds and watch your pets fight; ⚡ Quick battle: an instant auto-fight against anyone's fighter, even when they're offline; Arena gear in the Shop: 7 weapons (water pistol to rocket launcher), 5 armors and 5 gadgets that decide your special move - better gear and a higher level make a stronger fighter; Live duels can be watched by everyone, plus recent battle replays, top fighters, rating and win/loss records; wins earn coins</a:t>
+                        <a:t>📍 Add your city in Profile → Location &amp; weather (auto-detect or search) - only your city and country are shown, never your exact position; Live weather banners on every profile with animations: rain, drizzle, thunderstorms with lightning, snow, fog, clouds, sunshine or a starry night - plus temperature, feels-like, humidity, wind and local time; Your own weather strip on top of the hub, and each friend's weather + local time in the friends list; Hide your location from others or remove it any time</a:t>
                       </a:r>
                     </a:p>
                   </a:txBody>
@@ -10419,7 +10419,7 @@
                           </a:solidFill>
                           <a:latin typeface="Segoe UI"/>
                         </a:rPr>
-                        <a:t>2.7.0</a:t>
+                        <a:t>2.8.0</a:t>
                       </a:r>
                     </a:p>
                   </a:txBody>
@@ -10463,7 +10463,7 @@
                           </a:solidFill>
                           <a:latin typeface="Segoe UI"/>
                         </a:rPr>
-                        <a:t>Moderators &amp; Premium</a:t>
+                        <a:t>Pips Arena - duels, gear &amp; live battles</a:t>
                       </a:r>
                     </a:p>
                     <a:p>
@@ -10474,7 +10474,7 @@
                           </a:solidFill>
                           <a:latin typeface="Segoe UI"/>
                         </a:rPr>
-                        <a:t>★ Premium: a purple Premium badge, 4 exclusive props (tiara, star glasses, diamond necklace, fairy wings), the Fireworks move, +30 coins every day, double friend-interaction coins and room for 300 friends / 30 groups; Get Premium: Profile tab → Premium → "Ask to buy" emails the owner; after payment you receive a key (PIPS-XXXX-XXXX) to redeem right there; 🛡 Moderators: a blue Mod badge and a Mod tab with the report queue - warn, mute (1h / 24h / 7 days), clear a profile or reset a name; every action is logged; Report button on everyone's profile, so moderators can keep Pips friendly</a:t>
+                        <a:t>⚔ New Arena tab: challenge friends or anyone in the arena to a live duel - each round pick Attack, Guard or Special within 12 seconds and watch your pets fight; ⚡ Quick battle: an instant auto-fight against anyone's fighter, even when they're offline; Arena gear in the Shop: 7 weapons (water pistol to rocket launcher), 5 armors and 5 gadgets that decide your special move - better gear and a higher level make a stronger fighter; Live duels can be watched by everyone, plus recent battle replays, top fighters, rating and win/loss records; wins earn coins</a:t>
                       </a:r>
                     </a:p>
                   </a:txBody>
@@ -10498,7 +10498,7 @@
                           </a:solidFill>
                           <a:latin typeface="Segoe UI"/>
                         </a:rPr>
-                        <a:t>2.6.1</a:t>
+                        <a:t>2.7.0</a:t>
                       </a:r>
                     </a:p>
                   </a:txBody>
@@ -10542,7 +10542,7 @@
                           </a:solidFill>
                           <a:latin typeface="Segoe UI"/>
                         </a:rPr>
-                        <a:t>Owner badge &amp; credits</a:t>
+                        <a:t>Moderators &amp; Premium</a:t>
                       </a:r>
                     </a:p>
                     <a:p>
@@ -10553,7 +10553,7 @@
                           </a:solidFill>
                           <a:latin typeface="Segoe UI"/>
                         </a:rPr>
-                        <a:t>The creator of Pips (Juwen Lie) now shows a gold ♛ Owner badge on his profile, friend list and ranks; New About Pips card in the Profile tab: credits and how to contact the owner (Juwen_Lie@pegatroncorp.com) with Email and Copy buttons; Right-click the pet → Help → About now shows who made Pips and the contact email</a:t>
+                        <a:t>★ Premium: a purple Premium badge, 4 exclusive props (tiara, star glasses, diamond necklace, fairy wings), the Fireworks move, +30 coins every day, double friend-interaction coins and room for 300 friends / 30 groups; Get Premium: Profile tab → Premium → "Ask to buy" emails the owner; after payment you receive a key (PIPS-XXXX-XXXX) to redeem right there; 🛡 Moderators: a blue Mod badge and a Mod tab with the report queue - warn, mute (1h / 24h / 7 days), clear a profile or reset a name; every action is logged; Report button on everyone's profile, so moderators can keep Pips friendly</a:t>
                       </a:r>
                     </a:p>
                   </a:txBody>
@@ -10577,7 +10577,7 @@
                           </a:solidFill>
                           <a:latin typeface="Segoe UI"/>
                         </a:rPr>
-                        <a:t>2.6.0</a:t>
+                        <a:t>2.6.1</a:t>
                       </a:r>
                     </a:p>
                   </a:txBody>
@@ -10621,7 +10621,7 @@
                           </a:solidFill>
                           <a:latin typeface="Segoe UI"/>
                         </a:rPr>
-                        <a:t>Profiles, ranks, online status &amp; dark mode</a:t>
+                        <a:t>Owner badge &amp; credits</a:t>
                       </a:r>
                     </a:p>
                     <a:p>
@@ -10632,7 +10632,7 @@
                           </a:solidFill>
                           <a:latin typeface="Segoe UI"/>
                         </a:rPr>
-                        <a:t>Profile tab: profile picture (or your pet), about me, job, location, hobbies, birthday and a status message; Public or private: public profiles can be added directly and viewed in full; private profiles need a friend request that they accept, and strangers only see name, photo, pet, level and status; Click anyone to open their profile - badges, info, their friends - and add them, chat or wave from there; Ranks tab replaces Teams: everyone using Pips, sorted by XP, badges or streak</a:t>
+                        <a:t>The creator of Pips (Juwen Lie) now shows a gold ♛ Owner badge on his profile, friend list and ranks; New About Pips card in the Profile tab: credits and how to contact the owner (Juwen_Lie@pegatroncorp.com) with Email and Copy buttons; Right-click the pet → Help → About now shows who made Pips and the contact email</a:t>
                       </a:r>
                     </a:p>
                   </a:txBody>
@@ -10656,7 +10656,7 @@
                           </a:solidFill>
                           <a:latin typeface="Segoe UI"/>
                         </a:rPr>
-                        <a:t>2.5.1</a:t>
+                        <a:t>2.6.0</a:t>
                       </a:r>
                     </a:p>
                   </a:txBody>
@@ -10700,7 +10700,7 @@
                           </a:solidFill>
                           <a:latin typeface="Segoe UI"/>
                         </a:rPr>
-                        <a:t>New cute Pips logo</a:t>
+                        <a:t>Profiles, ranks, online status &amp; dark mode</a:t>
                       </a:r>
                     </a:p>
                     <a:p>
@@ -10711,7 +10711,7 @@
                           </a:solidFill>
                           <a:latin typeface="Segoe UI"/>
                         </a:rPr>
-                        <a:t>New Pips logo: Pip the cat on a Pips-red tile, matching the app colours (desktop shortcut, windows and website)</a:t>
+                        <a:t>Profile tab: profile picture (or your pet), about me, job, location, hobbies, birthday and a status message; Public or private: public profiles can be added directly and viewed in full; private profiles need a friend request that they accept, and strangers only see name, photo, pet, level and status; Click anyone to open their profile - badges, info, their friends - and add them, chat or wave from there; Ranks tab replaces Teams: everyone using Pips, sorted by XP, badges or streak</a:t>
                       </a:r>
                     </a:p>
                   </a:txBody>
@@ -10735,7 +10735,7 @@
                           </a:solidFill>
                           <a:latin typeface="Segoe UI"/>
                         </a:rPr>
-                        <a:t>2.5.0</a:t>
+                        <a:t>2.5.1</a:t>
                       </a:r>
                     </a:p>
                   </a:txBody>
@@ -10779,7 +10779,7 @@
                           </a:solidFill>
                           <a:latin typeface="Segoe UI"/>
                         </a:rPr>
-                        <a:t>Shop, coins, props &amp; moves</a:t>
+                        <a:t>New cute Pips logo</a:t>
                       </a:r>
                     </a:p>
                     <a:p>
@@ -10790,7 +10790,7 @@
                           </a:solidFill>
                           <a:latin typeface="Segoe UI"/>
                         </a:rPr>
-                        <a:t>Shop: earn coins and spend them on your pet - 17 props (crown, wizard hat, headphones, shades, scarf, cape, angel wings...) and 6 moves: spin, dance, moonwalk, backflip, kung fu and spider swing!; Coins come from leveling up (+40), badges (+25), opening Pips each day (+10), friendships (+15 per affinity level), waving / chatting / visiting friends (+2) and pomodoros (+5). Everyone starts with a 100-coin gift; Your friends see your props: on avatars in the hub and when your pet visits their desktop - it shows off one of your moves; Pips is now a social pet: clicking the pet opens the Pips hub (friends, chat, groups, shop, badges)</a:t>
+                        <a:t>New Pips logo: Pip the cat on a Pips-red tile, matching the app colours (desktop shortcut, windows and website)</a:t>
                       </a:r>
                     </a:p>
                   </a:txBody>
@@ -10814,7 +10814,7 @@
                           </a:solidFill>
                           <a:latin typeface="Segoe UI"/>
                         </a:rPr>
-                        <a:t>2.4.0</a:t>
+                        <a:t>2.5.0</a:t>
                       </a:r>
                     </a:p>
                   </a:txBody>
@@ -10858,7 +10858,7 @@
                           </a:solidFill>
                           <a:latin typeface="Segoe UI"/>
                         </a:rPr>
-                        <a:t>Chat, groups, affinity &amp; pet visits</a:t>
+                        <a:t>Shop, coins, props &amp; moves</a:t>
                       </a:r>
                     </a:p>
                     <a:p>
@@ -10869,7 +10869,7 @@
                           </a:solidFill>
                           <a:latin typeface="Segoe UI"/>
                         </a:rPr>
-                        <a:t>Chat: message your friends, and chat inside groups. Your pet pops up new messages as a bubble - click it to reply; Pet interactions: wave, pet their pet, send a snack, high five - or send your pet to visit: it walks onto your friend's desktop for a little while!; Affinity: every chat and interaction grows your friendship - Acquaintance → Buddy → Good friends → Close friends → Best friends → Soulmates; Your own groups: create a private group, invite your friends, they accept or decline. Group board + group chat; the owner can remove members</a:t>
+                        <a:t>Shop: earn coins and spend them on your pet - 17 props (crown, wizard hat, headphones, shades, scarf, cape, angel wings...) and 6 moves: spin, dance, moonwalk, backflip, kung fu and spider swing!; Coins come from leveling up (+40), badges (+25), opening Pips each day (+10), friendships (+15 per affinity level), waving / chatting / visiting friends (+2) and pomodoros (+5). Everyone starts with a 100-coin gift; Your friends see your props: on avatars in the hub and when your pet visits their desktop - it shows off one of your moves; Pips is now a social pet: clicking the pet opens the Pips hub (friends, chat, groups, shop, badges)</a:t>
                       </a:r>
                     </a:p>
                   </a:txBody>
@@ -10893,7 +10893,7 @@
                           </a:solidFill>
                           <a:latin typeface="Segoe UI"/>
                         </a:rPr>
-                        <a:t>2.3.0</a:t>
+                        <a:t>2.4.0</a:t>
                       </a:r>
                     </a:p>
                   </a:txBody>
@@ -10937,7 +10937,7 @@
                           </a:solidFill>
                           <a:latin typeface="Segoe UI"/>
                         </a:rPr>
-                        <a:t>Friends, levels &amp; achievements</a:t>
+                        <a:t>Chat, groups, affinity &amp; pet visits</a:t>
                       </a:r>
                     </a:p>
                     <a:p>
@@ -10948,7 +10948,7 @@
                           </a:solidFill>
                           <a:latin typeface="Segoe UI"/>
                         </a:rPr>
-                        <a:t>Levels &amp; XP: every finished pomodoro earns XP and your level grows - plus 20 achievements to unlock (first tomato, 8 in a day, 7-day streak, early bird, night owl, pet lover...). Your pet celebrates each one; Friends (optional, off by default): get a 6-letter friend code, add colleagues, see today's board and join a team board like PTB. Your pet tells you when a friend finishes a pomodoro; Privacy: only your name, pet, level, streak and pomodoro counts are shared - never apps, window titles or scores. One click turns it off and deletes your online data. Right-click the pet → Friends &amp; achievements…</a:t>
+                        <a:t>Chat: message your friends, and chat inside groups. Your pet pops up new messages as a bubble - click it to reply; Pet interactions: wave, pet their pet, send a snack, high five - or send your pet to visit: it walks onto your friend's desktop for a little while!; Affinity: every chat and interaction grows your friendship - Acquaintance → Buddy → Good friends → Close friends → Best friends → Soulmates; Your own groups: create a private group, invite your friends, they accept or decline. Group board + group chat; the owner can remove members</a:t>
                       </a:r>
                     </a:p>
                   </a:txBody>
@@ -10972,7 +10972,7 @@
                           </a:solidFill>
                           <a:latin typeface="Segoe UI"/>
                         </a:rPr>
-                        <a:t>2.2.0</a:t>
+                        <a:t>2.3.0</a:t>
                       </a:r>
                     </a:p>
                   </a:txBody>
@@ -11016,7 +11016,7 @@
                           </a:solidFill>
                           <a:latin typeface="Segoe UI"/>
                         </a:rPr>
-                        <a:t>Pet sounds</a:t>
+                        <a:t>Friends, levels &amp; achievements</a:t>
                       </a:r>
                     </a:p>
                     <a:p>
@@ -11027,7 +11027,7 @@
                           </a:solidFill>
                           <a:latin typeface="Segoe UI"/>
                         </a:rPr>
-                        <a:t>Your pet has a voice! Each of the 23 animals has its own sound (meow, woof, ribbit, hoot, buzz, oink, whale song...) and it changes with its mood: happy chirps, sad whimpers, sleepy yawns, hungry calls, grumpy huffs and soft snores; It also reacts with sound when you tickle, pet, feed, shake or wake it; Settings: right-click the pet → Sounds to switch on/off; Pet status &amp; settings has a volume slider, a ▶ Hear me button and "Stay quiet while I'm focusing" (on by default)</a:t>
+                        <a:t>Levels &amp; XP: every finished pomodoro earns XP and your level grows - plus 20 achievements to unlock (first tomato, 8 in a day, 7-day streak, early bird, night owl, pet lover...). Your pet celebrates each one; Friends (optional, off by default): get a 6-letter friend code, add colleagues, see today's board and join a team board like PTB. Your pet tells you when a friend finishes a pomodoro; Privacy: only your name, pet, level, streak and pomodoro counts are shared - never apps, window titles or scores. One click turns it off and deletes your online data. Right-click the pet → Friends &amp; achievements…</a:t>
                       </a:r>
                     </a:p>
                   </a:txBody>
@@ -11051,7 +11051,7 @@
                           </a:solidFill>
                           <a:latin typeface="Segoe UI"/>
                         </a:rPr>
-                        <a:t>2.1.2</a:t>
+                        <a:t>2.2.0</a:t>
                       </a:r>
                     </a:p>
                   </a:txBody>
@@ -11095,7 +11095,7 @@
                           </a:solidFill>
                           <a:latin typeface="Segoe UI"/>
                         </a:rPr>
-                        <a:t>Tickle-only mode</a:t>
+                        <a:t>Pet sounds</a:t>
                       </a:r>
                     </a:p>
                     <a:p>
@@ -11106,7 +11106,7 @@
                           </a:solidFill>
                           <a:latin typeface="Segoe UI"/>
                         </a:rPr>
-                        <a:t>New click option "Only tickle (never open Pips)": click and tickle your pet as much as you like - the Pomodoro window stays closed (open it from the right-click menu). Right-click the pet → When I click</a:t>
+                        <a:t>Your pet has a voice! Each of the 23 animals has its own sound (meow, woof, ribbit, hoot, buzz, oink, whale song...) and it changes with its mood: happy chirps, sad whimpers, sleepy yawns, hungry calls, grumpy huffs and soft snores; It also reacts with sound when you tickle, pet, feed, shake or wake it; Settings: right-click the pet → Sounds to switch on/off; Pet status &amp; settings has a volume slider, a ▶ Hear me button and "Stay quiet while I'm focusing" (on by default)</a:t>
                       </a:r>
                     </a:p>
                   </a:txBody>
@@ -11130,7 +11130,7 @@
                           </a:solidFill>
                           <a:latin typeface="Segoe UI"/>
                         </a:rPr>
-                        <a:t>2.1.1</a:t>
+                        <a:t>2.1.2</a:t>
                       </a:r>
                     </a:p>
                   </a:txBody>
@@ -11174,7 +11174,7 @@
                           </a:solidFill>
                           <a:latin typeface="Segoe UI"/>
                         </a:rPr>
-                        <a:t>Owner info</a:t>
+                        <a:t>Tickle-only mode</a:t>
                       </a:r>
                     </a:p>
                     <a:p>
@@ -11185,7 +11185,7 @@
                           </a:solidFill>
                           <a:latin typeface="Segoe UI"/>
                         </a:rPr>
-                        <a:t>About Pips now shows the owner: Juwen Lie (right-click the pet → Help → About)</a:t>
+                        <a:t>New click option "Only tickle (never open Pips)": click and tickle your pet as much as you like - the Pomodoro window stays closed (open it from the right-click menu). Right-click the pet → When I click</a:t>
                       </a:r>
                     </a:p>
                   </a:txBody>
@@ -11209,7 +11209,7 @@
                           </a:solidFill>
                           <a:latin typeface="Segoe UI"/>
                         </a:rPr>
-                        <a:t>2.1.0</a:t>
+                        <a:t>2.1.1</a:t>
                       </a:r>
                     </a:p>
                   </a:txBody>
@@ -11253,7 +11253,7 @@
                           </a:solidFill>
                           <a:latin typeface="Segoe UI"/>
                         </a:rPr>
-                        <a:t>Interactive guide &amp; in-app updates</a:t>
+                        <a:t>Owner info</a:t>
                       </a:r>
                     </a:p>
                     <a:p>
@@ -11264,7 +11264,7 @@
                           </a:solidFill>
                           <a:latin typeface="Segoe UI"/>
                         </a:rPr>
-                        <a:t>Interactive first-run guide: your pet walks you through clicking, dragging, petting and the right-click menu; In-app updates: Pips tells you when a new version is out - update with one click (your settings and data are kept); New Help menu: replay the guide, check for updates, see the version; Option to turn automatic update checks off</a:t>
+                        <a:t>About Pips now shows the owner: Juwen Lie (right-click the pet → Help → About)</a:t>
                       </a:r>
                     </a:p>
                   </a:txBody>
@@ -11288,7 +11288,7 @@
                           </a:solidFill>
                           <a:latin typeface="Segoe UI"/>
                         </a:rPr>
-                        <a:t>2.0.0</a:t>
+                        <a:t>2.1.0</a:t>
                       </a:r>
                     </a:p>
                   </a:txBody>
@@ -11332,7 +11332,7 @@
                           </a:solidFill>
                           <a:latin typeface="Segoe UI"/>
                         </a:rPr>
-                        <a:t>Desktop pet, 23 animals &amp; 4 languages</a:t>
+                        <a:t>Interactive guide &amp; in-app updates</a:t>
                       </a:r>
                     </a:p>
                     <a:p>
@@ -11343,7 +11343,7 @@
                           </a:solidFill>
                           <a:latin typeface="Segoe UI"/>
                         </a:rPr>
-                        <a:t>Desktop pet that lives on your desktop and taskbar - drag it, tickle it, pet it; 23 animals in 3 groups: Land walks, Water swims with bubbles, Sky hovers and flaps; Moods (happy, sad, tired, hungry, grumpy...), naps when you're away, wakes up when you're back; Cute chat-bubble reminders: breaks, water, 20-20-20 eye rest, pomodoro done, daily goal</a:t>
+                        <a:t>Interactive first-run guide: your pet walks you through clicking, dragging, petting and the right-click menu; In-app updates: Pips tells you when a new version is out - update with one click (your settings and data are kept); New Help menu: replay the guide, check for updates, see the version; Option to turn automatic update checks off</a:t>
                       </a:r>
                     </a:p>
                   </a:txBody>
@@ -11367,7 +11367,7 @@
                           </a:solidFill>
                           <a:latin typeface="Segoe UI"/>
                         </a:rPr>
-                        <a:t>1.5.0</a:t>
+                        <a:t>2.0.0</a:t>
                       </a:r>
                     </a:p>
                   </a:txBody>
@@ -11389,7 +11389,7 @@
                           </a:solidFill>
                           <a:latin typeface="Segoe UI"/>
                         </a:rPr>
-                        <a:t>2026-10-24</a:t>
+                        <a:t>2026-10-28</a:t>
                       </a:r>
                     </a:p>
                   </a:txBody>
@@ -11411,7 +11411,7 @@
                           </a:solidFill>
                           <a:latin typeface="Segoe UI"/>
                         </a:rPr>
-                        <a:t>Renamed to Pips + insights</a:t>
+                        <a:t>Desktop pet, 23 animals &amp; 4 languages</a:t>
                       </a:r>
                     </a:p>
                     <a:p>
@@ -11422,7 +11422,7 @@
                           </a:solidFill>
                           <a:latin typeface="Segoe UI"/>
                         </a:rPr>
-                        <a:t>Renamed from Productivity Widget to Pips; Dashboard charts: focus timeline, hour heatmap, 7-day score trend, pomodoros per day; AI token usage on the card and dashboard; Daily diary export and weekly / monthly reports</a:t>
+                        <a:t>Desktop pet that lives on your desktop and taskbar - drag it, tickle it, pet it; 23 animals in 3 groups: Land walks, Water swims with bubbles, Sky hovers and flaps; Moods (happy, sad, tired, hungry, grumpy...), naps when you're away, wakes up when you're back; Cute chat-bubble reminders: breaks, water, 20-20-20 eye rest, pomodoro done, daily goal</a:t>
                       </a:r>
                     </a:p>
                   </a:txBody>
@@ -11446,13 +11446,92 @@
                           </a:solidFill>
                           <a:latin typeface="Segoe UI"/>
                         </a:rPr>
+                        <a:t>1.5.0</a:t>
+                      </a:r>
+                    </a:p>
+                  </a:txBody>
+                  <a:tcPr marL="73152" marR="73152" marT="36576" marB="36576">
+                    <a:solidFill>
+                      <a:srgbClr val="F7F4EC"/>
+                    </a:solidFill>
+                  </a:tcPr>
+                </a:tc>
+                <a:tc>
+                  <a:txBody>
+                    <a:bodyPr wrap="square"/>
+                    <a:lstStyle/>
+                    <a:p>
+                      <a:r>
+                        <a:rPr sz="1200" b="0">
+                          <a:solidFill>
+                            <a:srgbClr val="2B2A28"/>
+                          </a:solidFill>
+                          <a:latin typeface="Segoe UI"/>
+                        </a:rPr>
+                        <a:t>2026-10-24</a:t>
+                      </a:r>
+                    </a:p>
+                  </a:txBody>
+                  <a:tcPr marL="73152" marR="73152" marT="36576" marB="36576">
+                    <a:solidFill>
+                      <a:srgbClr val="F7F4EC"/>
+                    </a:solidFill>
+                  </a:tcPr>
+                </a:tc>
+                <a:tc>
+                  <a:txBody>
+                    <a:bodyPr wrap="square"/>
+                    <a:lstStyle/>
+                    <a:p>
+                      <a:r>
+                        <a:rPr sz="1200" b="0">
+                          <a:solidFill>
+                            <a:srgbClr val="2B2A28"/>
+                          </a:solidFill>
+                          <a:latin typeface="Segoe UI"/>
+                        </a:rPr>
+                        <a:t>Renamed to Pips + insights</a:t>
+                      </a:r>
+                    </a:p>
+                    <a:p>
+                      <a:r>
+                        <a:rPr sz="1200" b="0">
+                          <a:solidFill>
+                            <a:srgbClr val="2B2A28"/>
+                          </a:solidFill>
+                          <a:latin typeface="Segoe UI"/>
+                        </a:rPr>
+                        <a:t>Renamed from Productivity Widget to Pips; Dashboard charts: focus timeline, hour heatmap, 7-day score trend, pomodoros per day; AI token usage on the card and dashboard; Daily diary export and weekly / monthly reports</a:t>
+                      </a:r>
+                    </a:p>
+                  </a:txBody>
+                  <a:tcPr marL="73152" marR="73152" marT="36576" marB="36576">
+                    <a:solidFill>
+                      <a:srgbClr val="F7F4EC"/>
+                    </a:solidFill>
+                  </a:tcPr>
+                </a:tc>
+              </a:tr>
+              <a:tr h="822960">
+                <a:tc>
+                  <a:txBody>
+                    <a:bodyPr wrap="square"/>
+                    <a:lstStyle/>
+                    <a:p>
+                      <a:r>
+                        <a:rPr sz="1200" b="1">
+                          <a:solidFill>
+                            <a:srgbClr val="2B2A28"/>
+                          </a:solidFill>
+                          <a:latin typeface="Segoe UI"/>
+                        </a:rPr>
                         <a:t>1.0.0</a:t>
                       </a:r>
                     </a:p>
                   </a:txBody>
                   <a:tcPr marL="73152" marR="73152" marT="36576" marB="36576">
                     <a:solidFill>
-                      <a:srgbClr val="F7F4EC"/>
+                      <a:srgbClr val="FFFDF8"/>
                     </a:solidFill>
                   </a:tcPr>
                 </a:tc>
@@ -11474,7 +11553,7 @@
                   </a:txBody>
                   <a:tcPr marL="73152" marR="73152" marT="36576" marB="36576">
                     <a:solidFill>
-                      <a:srgbClr val="F7F4EC"/>
+                      <a:srgbClr val="FFFDF8"/>
                     </a:solidFill>
                   </a:tcPr>
                 </a:tc>
@@ -11507,7 +11586,7 @@
                   </a:txBody>
                   <a:tcPr marL="73152" marR="73152" marT="36576" marB="36576">
                     <a:solidFill>
-                      <a:srgbClr val="F7F4EC"/>
+                      <a:srgbClr val="FFFDF8"/>
                     </a:solidFill>
                   </a:tcPr>
                 </a:tc>
@@ -15263,7 +15342,7 @@
                           </a:solidFill>
                           <a:latin typeface="Segoe UI"/>
                         </a:rPr>
-                        <a:t>Woofs, moos, roars, quacks… 51 voices that change with its mood</a:t>
+                        <a:t>51 animal voices that change with its mood. Sing &amp; dance tricks play a song you pick: right-click → Do a trick → Song</a:t>
                       </a:r>
                     </a:p>
                   </a:txBody>

</xml_diff>

<commit_message>
pips 2.23.0: Weather on your desktop
</commit_message>
<xml_diff>
--- a/apps/pips/web/download/Pips-Guide.pptx
+++ b/apps/pips/web/download/Pips-Guide.pptx
@@ -3292,7 +3292,7 @@
                 </a:solidFill>
                 <a:latin typeface="Segoe UI"/>
               </a:rPr>
-              <a:t>Version 2.22.0  ·  2026-10-29  ·  Made by Juwen Lie (owner)</a:t>
+              <a:t>Version 2.23.0  ·  2026-10-29  ·  Made by Juwen Lie (owner)</a:t>
             </a:r>
           </a:p>
           <a:p>
@@ -8279,7 +8279,7 @@
                 </a:solidFill>
                 <a:latin typeface="Segoe UI"/>
               </a:rPr>
-              <a:t>What's new in 2.22.0</a:t>
+              <a:t>What's new in 2.23.0</a:t>
             </a:r>
           </a:p>
         </p:txBody>
@@ -8392,7 +8392,7 @@
                 </a:solidFill>
                 <a:latin typeface="Segoe UI"/>
               </a:rPr>
-              <a:t>Sing &amp; dance with music  ·  2026-10-29</a:t>
+              <a:t>Weather on your desktop  ·  2026-10-29</a:t>
             </a:r>
           </a:p>
         </p:txBody>
@@ -8440,7 +8440,7 @@
                 </a:solidFill>
                 <a:latin typeface="Segoe UI"/>
               </a:rPr>
-              <a:t>Sing, Dance, Moonwalk, Breakdance, Yoga, Rain dance and the show tricks now play real music. When your pet sings, it sings the melody in its own voice - a cat meows the tune, a frog ribbits it, a whale hums it - and when it dances, its animal call joins the beat.</a:t>
+              <a:t>Your pet now shows the live weather right on your desktop: its own little rain cloud with an umbrella when it rains, a dark storm cloud with lightning, snow piling up at its feet, the sun, the moon and twinkling stars at night, drifting fog and leaves blowing in the wind. Prefer more? Switch the animation to the whole screen - or turn it off.</a:t>
             </a:r>
           </a:p>
           <a:p>
@@ -8465,7 +8465,7 @@
                 </a:solidFill>
                 <a:latin typeface="Segoe UI"/>
               </a:rPr>
-              <a:t>Pick the song: right-click → Do a trick → Song for sing &amp; dance. Choose your animal's own song (every one of the 51 animals has its own tune), the song for its type (Meadow Hoedown for land, Ocean Calypso for water, Cloud Waltz for sky), Happy Pop, Disco Night, 8-bit Adventure, Lullaby, Lo-fi Chill, any other animal's song, Surprise me or No music.</a:t>
+              <a:t>New right-click menu → Weather &amp; location: Follow my exact location (Windows location; a laptop is followed as you move), Approximate (from your internet connection), or Pick a place - search a city or paste exact coordinates from Google Maps. The pet tells you when the weather changes.</a:t>
             </a:r>
           </a:p>
           <a:p>
@@ -8490,7 +8490,7 @@
                 </a:solidFill>
                 <a:latin typeface="Segoe UI"/>
               </a:rPr>
-              <a:t>Songs follow your sound settings (volume, sounds off, quiet during focus) and stop as soon as the trick is interrupted. Tricks your pet does by itself stay quiet.</a:t>
+              <a:t>Works without Pips Friends (weather from Open-Meteo, no account needed). With Friends on, your profile city follows you too - but a city you hid stays hidden. If Windows location is turned off on your PC, Pips explains how to turn it on and uses your internet location meanwhile.</a:t>
             </a:r>
           </a:p>
         </p:txBody>
@@ -8621,7 +8621,7 @@
                 </a:solidFill>
                 <a:latin typeface="Segoe UI"/>
               </a:rPr>
-              <a:t>Nyanyi, Dansa, Moonwalk, Breakdance, Yoga, Tari hujan, dan trik pertunjukan sekarang memutar musik sungguhan. Saat pet bernyanyi, ia menyanyikan melodinya dengan suaranya sendiri - kucing mengeong mengikuti nada, katak berkwak, paus bersenandung - dan saat berdansa, suara khas hewannya ikut mengikuti irama.</a:t>
+              <a:t>Pet-mu sekarang menampilkan cuaca langsung di desktop: awan hujan kecil miliknya sendiri lengkap dengan payung saat hujan, awan badai gelap dengan petir, salju yang menumpuk di kakinya, matahari, bulan dan bintang berkelip di malam hari, kabut yang melayang dan daun yang tertiup angin. Mau lebih? Pindahkan animasinya ke seluruh layar - atau matikan.</a:t>
             </a:r>
           </a:p>
           <a:p>
@@ -8646,7 +8646,7 @@
                 </a:solidFill>
                 <a:latin typeface="Segoe UI"/>
               </a:rPr>
-              <a:t>Pilih lagunya: klik kanan → Lakukan trik → Lagu untuk nyanyi &amp; dansa. Pilih lagu khas hewanmu (ke-51 hewan punya lagu sendiri), lagu untuk tipenya (Dansa Padang Rumput untuk darat, Calypso Samudra untuk air, Waltz Awan untuk udara), Pop Ceria, Malam Disko, Petualangan 8-bit, Nina Bobo, Lo-fi Santai, lagu hewan lain, Kejutkan aku, atau Tanpa musik.</a:t>
+              <a:t>Menu klik kanan baru → Cuaca &amp; lokasi: Ikuti lokasi persisku (lokasi Windows; laptop diikuti saat kamu berpindah), Perkiraan (dari koneksi internet), atau Pilih tempat - cari kota atau tempel koordinat persis dari Google Maps. Pet memberi tahu saat cuaca berubah.</a:t>
             </a:r>
           </a:p>
           <a:p>
@@ -8671,7 +8671,7 @@
                 </a:solidFill>
                 <a:latin typeface="Segoe UI"/>
               </a:rPr>
-              <a:t>Lagu mengikuti pengaturan suara (volume, suara mati, senyap saat fokus) dan langsung berhenti saat trik terganggu. Trik yang dilakukan pet sendiri tetap tanpa musik.</a:t>
+              <a:t>Berfungsi tanpa Pips Friends (cuaca dari Open-Meteo, tanpa akun). Jika Friends aktif, kota di profilmu ikut berpindah - tapi kota yang kamu sembunyikan tetap tersembunyi. Jika lokasi Windows dimatikan di PC-mu, Pips menjelaskan cara menyalakannya dan sementara memakai lokasi internet.</a:t>
             </a:r>
           </a:p>
         </p:txBody>
@@ -8903,7 +8903,7 @@
         </p:nvGraphicFramePr>
         <p:xfrm>
           <a:off x="548640" y="1645920"/>
-          <a:ext cx="11155680" cy="27541728"/>
+          <a:ext cx="11155680" cy="28364688"/>
         </p:xfrm>
         <a:graphic>
           <a:graphicData uri="http://schemas.openxmlformats.org/drawingml/2006/table">
@@ -8997,7 +8997,7 @@
                           </a:solidFill>
                           <a:latin typeface="Segoe UI"/>
                         </a:rPr>
-                        <a:t>2.22.0</a:t>
+                        <a:t>2.23.0</a:t>
                       </a:r>
                     </a:p>
                   </a:txBody>
@@ -9041,7 +9041,7 @@
                           </a:solidFill>
                           <a:latin typeface="Segoe UI"/>
                         </a:rPr>
-                        <a:t>Sing &amp; dance with music</a:t>
+                        <a:t>Weather on your desktop</a:t>
                       </a:r>
                     </a:p>
                     <a:p>
@@ -9052,7 +9052,7 @@
                           </a:solidFill>
                           <a:latin typeface="Segoe UI"/>
                         </a:rPr>
-                        <a:t>Sing, Dance, Moonwalk, Breakdance, Yoga, Rain dance and the show tricks now play real music. When your pet sings, it sings the melody in its own voice - a cat meows the tune, a frog ribbits it, a whale hums it - and when it dances, its animal call joins the beat.; Pick the song: right-click → Do a trick → Song for sing &amp; dance. Choose your animal's own song (every one of the 51 animals has its own tune), the song for its type (Meadow Hoedown for land, Ocean Calypso for water, Cloud Waltz for sky), Happy Pop, Disco Night, 8-bit Adventure, Lullaby, Lo-fi Chill, any other animal's song, Surprise me or No music.; Songs follow your sound settings (volume, sounds off, quiet during focus) and stop as soon as the trick is interrupted. Tricks your pet does by itself stay quiet.</a:t>
+                        <a:t>Your pet now shows the live weather right on your desktop: its own little rain cloud with an umbrella when it rains, a dark storm cloud with lightning, snow piling up at its feet, the sun, the moon and twinkling stars at night, drifting fog and leaves blowing in the wind. Prefer more? Switch the animation to the whole screen - or turn it off.; New right-click menu → Weather &amp; location: Follow my exact location (Windows location; a laptop is followed as you move), Approximate (from your internet connection), or Pick a place - search a city or paste exact coordinates from Google Maps. The pet tells you when the weather changes.; Works without Pips Friends (weather from Open-Meteo, no account needed). With Friends on, your profile city follows you too - but a city you hid stays hidden. If Windows location is turned off on your PC, Pips explains how to turn it on and uses your internet location meanwhile.</a:t>
                       </a:r>
                     </a:p>
                   </a:txBody>
@@ -9076,7 +9076,7 @@
                           </a:solidFill>
                           <a:latin typeface="Segoe UI"/>
                         </a:rPr>
-                        <a:t>2.21.0</a:t>
+                        <a:t>2.22.0</a:t>
                       </a:r>
                     </a:p>
                   </a:txBody>
@@ -9120,7 +9120,7 @@
                           </a:solidFill>
                           <a:latin typeface="Segoe UI"/>
                         </a:rPr>
-                        <a:t>Every animal has a voice</a:t>
+                        <a:t>Sing &amp; dance with music</a:t>
                       </a:r>
                     </a:p>
                     <a:p>
@@ -9131,7 +9131,7 @@
                           </a:solidFill>
                           <a:latin typeface="Segoe UI"/>
                         </a:rPr>
-                        <a:t>All 51 animals now have their own sound. Before, more than half of them borrowed the cat's meow - now the dog woofs, the cow moos, the sheep baas, the lion roars, the duck quacks, the dolphin clicks and whistles, the dragon flaps and roars with a puff of fire, the ghost goes wooo... and so on.; Every mood sounds different too: happy, sad, sleepy, hungry or grumpy. Petting, eating and snoring sound right for each kind of animal - furry ones purr and crunch, birds trill and peck, sea animals blow bubbles, bugs hum and magic pets chime.; A friend's pet that comes to visit now talks in its own voice: it says hi when it arrives and answers when you wave, pet it or give it a snack (it follows your sound settings).</a:t>
+                        <a:t>Sing, Dance, Moonwalk, Breakdance, Yoga, Rain dance and the show tricks now play real music. When your pet sings, it sings the melody in its own voice - a cat meows the tune, a frog ribbits it, a whale hums it - and when it dances, its animal call joins the beat.; Pick the song: right-click → Do a trick → Song for sing &amp; dance. Choose your animal's own song (every one of the 51 animals has its own tune), the song for its type (Meadow Hoedown for land, Ocean Calypso for water, Cloud Waltz for sky), Happy Pop, Disco Night, 8-bit Adventure, Lullaby, Lo-fi Chill, any other animal's song, Surprise me or No music.; Songs follow your sound settings (volume, sounds off, quiet during focus) and stop as soon as the trick is interrupted. Tricks your pet does by itself stay quiet.</a:t>
                       </a:r>
                     </a:p>
                   </a:txBody>
@@ -9155,7 +9155,7 @@
                           </a:solidFill>
                           <a:latin typeface="Segoe UI"/>
                         </a:rPr>
-                        <a:t>2.20.0</a:t>
+                        <a:t>2.21.0</a:t>
                       </a:r>
                     </a:p>
                   </a:txBody>
@@ -9199,7 +9199,7 @@
                           </a:solidFill>
                           <a:latin typeface="Segoe UI"/>
                         </a:rPr>
-                        <a:t>Come over</a:t>
+                        <a:t>Every animal has a voice</a:t>
                       </a:r>
                     </a:p>
                     <a:p>
@@ -9210,7 +9210,7 @@
                           </a:solidFill>
                           <a:latin typeface="Segoe UI"/>
                         </a:rPr>
-                        <a:t>When a friend's pet comes over it now wears a name tag: your friend's name (or the nickname you gave them), ♂/♀ and an online dot. It walks up to your pet, says hi, and looks at your mouse when you point at it.; Point at the visitor (or click its name tag) to open its card: whose pet it is, level, how close you two are, and buttons to wave, pet it, give it a snack, visit back or chat. It reacts to everything - hearts, crumbs, happy faces - and your friend sees it too.; Rub your mouse over the visitor to pet it. Playing with it makes it stay longer, and your pet comes down from a window or the sky to meet it.</a:t>
+                        <a:t>All 51 animals now have their own sound. Before, more than half of them borrowed the cat's meow - now the dog woofs, the cow moos, the sheep baas, the lion roars, the duck quacks, the dolphin clicks and whistles, the dragon flaps and roars with a puff of fire, the ghost goes wooo... and so on.; Every mood sounds different too: happy, sad, sleepy, hungry or grumpy. Petting, eating and snoring sound right for each kind of animal - furry ones purr and crunch, birds trill and peck, sea animals blow bubbles, bugs hum and magic pets chime.; A friend's pet that comes to visit now talks in its own voice: it says hi when it arrives and answers when you wave, pet it or give it a snack (it follows your sound settings).</a:t>
                       </a:r>
                     </a:p>
                   </a:txBody>
@@ -9234,7 +9234,7 @@
                           </a:solidFill>
                           <a:latin typeface="Segoe UI"/>
                         </a:rPr>
-                        <a:t>2.19.0</a:t>
+                        <a:t>2.20.0</a:t>
                       </a:r>
                     </a:p>
                   </a:txBody>
@@ -9278,7 +9278,7 @@
                           </a:solidFill>
                           <a:latin typeface="Segoe UI"/>
                         </a:rPr>
-                        <a:t>Land, sea &amp; sky</a:t>
+                        <a:t>Come over</a:t>
                       </a:r>
                     </a:p>
                     <a:p>
@@ -9289,7 +9289,7 @@
                           </a:solidFill>
                           <a:latin typeface="Segoe UI"/>
                         </a:rPr>
-                        <a:t>Land animals walk on the taskbar and on top of your open windows now: they jump up onto window edges, walk along them, ride along when you move the window and hop down when it closes, gets covered or is maximised. They always have gravity - let go of one in mid-air and it lands on the window below or on the taskbar.; Water animals swim along the taskbar (their water) and every now and then leap high out of it in a big arc, diving back in with a splash, ripples and spray. Drop one anywhere and it dives back into the water.; Flying animals fly anywhere on the screen: they flutter from place to place, hover, come say hi near your mouse, and sometimes perch on the taskbar or a window edge for a rest. Point at one and it waits for you; they glide down to a perch before a nap.; New menu moves: Jump onto a window, Splash jump!, Fly around / Rest on the taskbar. "Move around by myself" in Pet settings keeps your pet still if you prefer (the old Gravity option is gone - land animals always fall now).</a:t>
+                        <a:t>When a friend's pet comes over it now wears a name tag: your friend's name (or the nickname you gave them), ♂/♀ and an online dot. It walks up to your pet, says hi, and looks at your mouse when you point at it.; Point at the visitor (or click its name tag) to open its card: whose pet it is, level, how close you two are, and buttons to wave, pet it, give it a snack, visit back or chat. It reacts to everything - hearts, crumbs, happy faces - and your friend sees it too.; Rub your mouse over the visitor to pet it. Playing with it makes it stay longer, and your pet comes down from a window or the sky to meet it.</a:t>
                       </a:r>
                     </a:p>
                   </a:txBody>
@@ -9313,7 +9313,7 @@
                           </a:solidFill>
                           <a:latin typeface="Segoe UI"/>
                         </a:rPr>
-                        <a:t>2.18.0</a:t>
+                        <a:t>2.19.0</a:t>
                       </a:r>
                     </a:p>
                   </a:txBody>
@@ -9357,7 +9357,7 @@
                           </a:solidFill>
                           <a:latin typeface="Segoe UI"/>
                         </a:rPr>
-                        <a:t>Raise your pet</a:t>
+                        <a:t>Land, sea &amp; sky</a:t>
                       </a:r>
                     </a:p>
                     <a:p>
@@ -9368,7 +9368,7 @@
                           </a:solidFill>
                           <a:latin typeface="Segoe UI"/>
                         </a:rPr>
-                        <a:t>Boy or girl? Pick your pet's gender in Settings: boys get a little hair tuft, girls a pink bow and eyelashes, and a ♂ / ♀ shows next to its name. You can add your own gender to your profile too - friends see a small ♂ / ♀ next to your name.; Pets grow up now: baby → child → teen → grown-up. Focus sessions, opening Pips each day, games and cuddles help them grow - no care mistakes, no bad endings. Already have a grown-up pet? It will ask whether you'd like to raise it again from a baby (coins, items and stats stay).; Sick days: work 2.5 hours without a 5-minute break and your pet catches a little cold (sneezes, thermometer, slow steps). A short break cures it - or give medicine from the menu. You can turn this off in Settings.; New mini-game Left or Right? (pet menu → Play): guess which way your pet will look - 3 out of 5 wins, with coins for your first wins each day.</a:t>
+                        <a:t>Land animals walk on the taskbar and on top of your open windows now: they jump up onto window edges, walk along them, ride along when you move the window and hop down when it closes, gets covered or is maximised. They always have gravity - let go of one in mid-air and it lands on the window below or on the taskbar.; Water animals swim along the taskbar (their water) and every now and then leap high out of it in a big arc, diving back in with a splash, ripples and spray. Drop one anywhere and it dives back into the water.; Flying animals fly anywhere on the screen: they flutter from place to place, hover, come say hi near your mouse, and sometimes perch on the taskbar or a window edge for a rest. Point at one and it waits for you; they glide down to a perch before a nap.; New menu moves: Jump onto a window, Splash jump!, Fly around / Rest on the taskbar. "Move around by myself" in Pet settings keeps your pet still if you prefer (the old Gravity option is gone - land animals always fall now).</a:t>
                       </a:r>
                     </a:p>
                   </a:txBody>
@@ -9392,7 +9392,7 @@
                           </a:solidFill>
                           <a:latin typeface="Segoe UI"/>
                         </a:rPr>
-                        <a:t>2.17.0</a:t>
+                        <a:t>2.18.0</a:t>
                       </a:r>
                     </a:p>
                   </a:txBody>
@@ -9436,7 +9436,7 @@
                           </a:solidFill>
                           <a:latin typeface="Segoe UI"/>
                         </a:rPr>
-                        <a:t>Find your pet anytime</a:t>
+                        <a:t>Raise your pet</a:t>
                       </a:r>
                     </a:p>
                     <a:p>
@@ -9447,7 +9447,7 @@
                           </a:solidFill>
                           <a:latin typeface="Segoe UI"/>
                         </a:rPr>
-                        <a:t>Pips now has an icon next to the clock: click it to bring your pet back; right-click for the focus timer, Friends &amp; chat or Quit.; Press Ctrl+Alt+P anywhere to call your pet - it pops up on the screen you're using, even if it was hidden, asleep or behind a fullscreen app.; Opening Pips again from the Start menu or desktop does the same, and your pet walks back by itself if it ever ends up off-screen (e.g. after unplugging a monitor).; Hiding your pet now tells you how to bring it back.</a:t>
+                        <a:t>Boy or girl? Pick your pet's gender in Settings: boys get a little hair tuft, girls a pink bow and eyelashes, and a ♂ / ♀ shows next to its name. You can add your own gender to your profile too - friends see a small ♂ / ♀ next to your name.; Pets grow up now: baby → child → teen → grown-up. Focus sessions, opening Pips each day, games and cuddles help them grow - no care mistakes, no bad endings. Already have a grown-up pet? It will ask whether you'd like to raise it again from a baby (coins, items and stats stay).; Sick days: work 2.5 hours without a 5-minute break and your pet catches a little cold (sneezes, thermometer, slow steps). A short break cures it - or give medicine from the menu. You can turn this off in Settings.; New mini-game Left or Right? (pet menu → Play): guess which way your pet will look - 3 out of 5 wins, with coins for your first wins each day.</a:t>
                       </a:r>
                     </a:p>
                   </a:txBody>
@@ -9471,7 +9471,7 @@
                           </a:solidFill>
                           <a:latin typeface="Segoe UI"/>
                         </a:rPr>
-                        <a:t>2.16.0</a:t>
+                        <a:t>2.17.0</a:t>
                       </a:r>
                     </a:p>
                   </a:txBody>
@@ -9515,7 +9515,7 @@
                           </a:solidFill>
                           <a:latin typeface="Segoe UI"/>
                         </a:rPr>
-                        <a:t>Pips Community</a:t>
+                        <a:t>Find your pet anytime</a:t>
                       </a:r>
                     </a:p>
                     <a:p>
@@ -9526,7 +9526,7 @@
                           </a:solidFill>
                           <a:latin typeface="Segoe UI"/>
                         </a:rPr>
-                        <a:t>New Pips Community at the top of the Chat tab: a #general channel to chat with everyone who uses Pips, plus #announcements with news from the Pips team.; Every new Pips version is announced there automatically - see what's new and update with one click.; Type @name to ping someone in #general. Mute #general any time; owner and moderators can remove messages.; Open it from your pet's menu too (Pips Community). Fixed: chats no longer clear what you're typing when Pips refreshes in the background.</a:t>
+                        <a:t>Pips now has an icon next to the clock: click it to bring your pet back; right-click for the focus timer, Friends &amp; chat or Quit.; Press Ctrl+Alt+P anywhere to call your pet - it pops up on the screen you're using, even if it was hidden, asleep or behind a fullscreen app.; Opening Pips again from the Start menu or desktop does the same, and your pet walks back by itself if it ever ends up off-screen (e.g. after unplugging a monitor).; Hiding your pet now tells you how to bring it back.</a:t>
                       </a:r>
                     </a:p>
                   </a:txBody>
@@ -9550,7 +9550,7 @@
                           </a:solidFill>
                           <a:latin typeface="Segoe UI"/>
                         </a:rPr>
-                        <a:t>2.15.0</a:t>
+                        <a:t>2.16.0</a:t>
                       </a:r>
                     </a:p>
                   </a:txBody>
@@ -9594,7 +9594,7 @@
                           </a:solidFill>
                           <a:latin typeface="Segoe UI"/>
                         </a:rPr>
-                        <a:t>Update reminders</a:t>
+                        <a:t>Pips Community</a:t>
                       </a:r>
                     </a:p>
                     <a:p>
@@ -9605,7 +9605,7 @@
                           </a:solidFill>
                           <a:latin typeface="Segoe UI"/>
                         </a:rPr>
-                        <a:t>Owner &amp; moderators: the Mod tab now lists who hasn't updated Pips yet (their version and when they were last seen), with one-click reminders by e-mail (sent from your Outlook) or a ready-to-send Teams chat.; New Work e-mail field in your Profile, filled in from Outlook. Only the owner and moderators can see it (for update reminders and support) - clear it to hide it.; Pips now tells the Friends server which version it runs, so the update list is always accurate.; Friends keeps working when a local proxy tool stops answering - Pips falls back to the Windows proxy settings.</a:t>
+                        <a:t>New Pips Community at the top of the Chat tab: a #general channel to chat with everyone who uses Pips, plus #announcements with news from the Pips team.; Every new Pips version is announced there automatically - see what's new and update with one click.; Type @name to ping someone in #general. Mute #general any time; owner and moderators can remove messages.; Open it from your pet's menu too (Pips Community). Fixed: chats no longer clear what you're typing when Pips refreshes in the background.</a:t>
                       </a:r>
                     </a:p>
                   </a:txBody>
@@ -9629,7 +9629,7 @@
                           </a:solidFill>
                           <a:latin typeface="Segoe UI"/>
                         </a:rPr>
-                        <a:t>2.14.3</a:t>
+                        <a:t>2.15.0</a:t>
                       </a:r>
                     </a:p>
                   </a:txBody>
@@ -9673,7 +9673,7 @@
                           </a:solidFill>
                           <a:latin typeface="Segoe UI"/>
                         </a:rPr>
-                        <a:t>Tidy menus</a:t>
+                        <a:t>Update reminders</a:t>
                       </a:r>
                     </a:p>
                     <a:p>
@@ -9684,7 +9684,7 @@
                           </a:solidFill>
                           <a:latin typeface="Segoe UI"/>
                         </a:rPr>
-                        <a:t>Fixed: a submenu (e.g. Poke a friend) could stay floating on the screen after the right-click menu closed.; Menus now close by themselves when you move the mouse away and leave them for a few seconds.</a:t>
+                        <a:t>Owner &amp; moderators: the Mod tab now lists who hasn't updated Pips yet (their version and when they were last seen), with one-click reminders by e-mail (sent from your Outlook) or a ready-to-send Teams chat.; New Work e-mail field in your Profile, filled in from Outlook. Only the owner and moderators can see it (for update reminders and support) - clear it to hide it.; Pips now tells the Friends server which version it runs, so the update list is always accurate.; Friends keeps working when a local proxy tool stops answering - Pips falls back to the Windows proxy settings.</a:t>
                       </a:r>
                     </a:p>
                   </a:txBody>
@@ -9708,7 +9708,7 @@
                           </a:solidFill>
                           <a:latin typeface="Segoe UI"/>
                         </a:rPr>
-                        <a:t>2.14.2</a:t>
+                        <a:t>2.14.3</a:t>
                       </a:r>
                     </a:p>
                   </a:txBody>
@@ -9752,7 +9752,7 @@
                           </a:solidFill>
                           <a:latin typeface="Segoe UI"/>
                         </a:rPr>
-                        <a:t>Never miss an update</a:t>
+                        <a:t>Tidy menus</a:t>
                       </a:r>
                     </a:p>
                     <a:p>
@@ -9763,7 +9763,7 @@
                           </a:solidFill>
                           <a:latin typeface="Segoe UI"/>
                         </a:rPr>
-                        <a:t>Your pet now reminds you every 2 hours while a new version is waiting (instead of every 6 hours).; If the reminder can't show (fullscreen app, guided tour, another message), your pet tries again a few minutes later.; No internet when Pips starts (e.g. VPN off)? It checks again after an hour.</a:t>
+                        <a:t>Fixed: a submenu (e.g. Poke a friend) could stay floating on the screen after the right-click menu closed.; Menus now close by themselves when you move the mouse away and leave them for a few seconds.</a:t>
                       </a:r>
                     </a:p>
                   </a:txBody>
@@ -9787,7 +9787,7 @@
                           </a:solidFill>
                           <a:latin typeface="Segoe UI"/>
                         </a:rPr>
-                        <a:t>2.14.1</a:t>
+                        <a:t>2.14.2</a:t>
                       </a:r>
                     </a:p>
                   </a:txBody>
@@ -9831,7 +9831,7 @@
                           </a:solidFill>
                           <a:latin typeface="Segoe UI"/>
                         </a:rPr>
-                        <a:t>One pet at a time</a:t>
+                        <a:t>Never miss an update</a:t>
                       </a:r>
                     </a:p>
                     <a:p>
@@ -9842,7 +9842,7 @@
                           </a:solidFill>
                           <a:latin typeface="Segoe UI"/>
                         </a:rPr>
-                        <a:t>Opening Pips again (Desktop / Start Menu shortcut, autostart) no longer starts a second pet - your pet just pops up and says hi.; Fixes lag caused by two copies of Pips running at once.</a:t>
+                        <a:t>Your pet now reminds you every 2 hours while a new version is waiting (instead of every 6 hours).; If the reminder can't show (fullscreen app, guided tour, another message), your pet tries again a few minutes later.; No internet when Pips starts (e.g. VPN off)? It checks again after an hour.</a:t>
                       </a:r>
                     </a:p>
                   </a:txBody>
@@ -9866,7 +9866,7 @@
                           </a:solidFill>
                           <a:latin typeface="Segoe UI"/>
                         </a:rPr>
-                        <a:t>2.14.0</a:t>
+                        <a:t>2.14.1</a:t>
                       </a:r>
                     </a:p>
                   </a:txBody>
@@ -9910,7 +9910,7 @@
                           </a:solidFill>
                           <a:latin typeface="Segoe UI"/>
                         </a:rPr>
-                        <a:t>Pokes, tickles &amp; teases</a:t>
+                        <a:t>One pet at a time</a:t>
                       </a:r>
                     </a:p>
                     <a:p>
@@ -9921,7 +9921,7 @@
                           </a:solidFill>
                           <a:latin typeface="Segoe UI"/>
                         </a:rPr>
-                        <a:t>Poke, tickle, tease, boop or hug a friend from afar - no pet visit needed.; Right-click your pet → Poke a friend, or use the Poke button in Friends, chat and profiles.; Your friend gets a pop-up ("Wendy is teasing you!"), their pet reacts, and they can poke back with one click.; During a focus session pokes wait quietly until your break; when your pet is hidden they show in the screen corner.</a:t>
+                        <a:t>Opening Pips again (Desktop / Start Menu shortcut, autostart) no longer starts a second pet - your pet just pops up and says hi.; Fixes lag caused by two copies of Pips running at once.</a:t>
                       </a:r>
                     </a:p>
                   </a:txBody>
@@ -9945,7 +9945,7 @@
                           </a:solidFill>
                           <a:latin typeface="Segoe UI"/>
                         </a:rPr>
-                        <a:t>2.13.1</a:t>
+                        <a:t>2.14.0</a:t>
                       </a:r>
                     </a:p>
                   </a:txBody>
@@ -9967,7 +9967,7 @@
                           </a:solidFill>
                           <a:latin typeface="Segoe UI"/>
                         </a:rPr>
-                        <a:t>2026-10-28</a:t>
+                        <a:t>2026-10-29</a:t>
                       </a:r>
                     </a:p>
                   </a:txBody>
@@ -9989,7 +9989,7 @@
                           </a:solidFill>
                           <a:latin typeface="Segoe UI"/>
                         </a:rPr>
-                        <a:t>One-click Windows installer</a:t>
+                        <a:t>Pokes, tickles &amp; teases</a:t>
                       </a:r>
                     </a:p>
                     <a:p>
@@ -10000,7 +10000,7 @@
                           </a:solidFill>
                           <a:latin typeface="Segoe UI"/>
                         </a:rPr>
-                        <a:t>One Windows installer: no ZIP extraction, Python installation or command line. Download, open and click Install Pips.; Installs for your Windows account without administrator access, adds Desktop and Start Menu shortcuts, and opens Pips automatically.; Reinstalling in the same location keeps your settings and pet progress. Existing ZIP users can keep updating in place from Help → Check for updates.; A simpler download page and updated user guide; the bundled runtime stays separate from small in-app updates.</a:t>
+                        <a:t>Poke, tickle, tease, boop or hug a friend from afar - no pet visit needed.; Right-click your pet → Poke a friend, or use the Poke button in Friends, chat and profiles.; Your friend gets a pop-up ("Wendy is teasing you!"), their pet reacts, and they can poke back with one click.; During a focus session pokes wait quietly until your break; when your pet is hidden they show in the screen corner.</a:t>
                       </a:r>
                     </a:p>
                   </a:txBody>
@@ -10024,7 +10024,7 @@
                           </a:solidFill>
                           <a:latin typeface="Segoe UI"/>
                         </a:rPr>
-                        <a:t>2.13.0</a:t>
+                        <a:t>2.13.1</a:t>
                       </a:r>
                     </a:p>
                   </a:txBody>
@@ -10068,7 +10068,7 @@
                           </a:solidFill>
                           <a:latin typeface="Segoe UI"/>
                         </a:rPr>
-                        <a:t>Birthdays, parties &amp; gifts</a:t>
+                        <a:t>One-click Windows installer</a:t>
                       </a:r>
                     </a:p>
                     <a:p>
@@ -10079,7 +10079,7 @@
                           </a:solidFill>
                           <a:latin typeface="Segoe UI"/>
                         </a:rPr>
-                        <a:t>Set your birthday in Social → Profile (month + day, optionally visible to friends).; On your birthday Pips throws confetti and gives you 100 bonus coins.; Friends tab shows upcoming birthdays; you get reminders 3 days, 1 day and on the day.; Birthday parties: join a friend's party, see who's there, sign the guestbook and celebrate together.</a:t>
+                        <a:t>One Windows installer: no ZIP extraction, Python installation or command line. Download, open and click Install Pips.; Installs for your Windows account without administrator access, adds Desktop and Start Menu shortcuts, and opens Pips automatically.; Reinstalling in the same location keeps your settings and pet progress. Existing ZIP users can keep updating in place from Help → Check for updates.; A simpler download page and updated user guide; the bundled runtime stays separate from small in-app updates.</a:t>
                       </a:r>
                     </a:p>
                   </a:txBody>
@@ -10103,7 +10103,7 @@
                           </a:solidFill>
                           <a:latin typeface="Segoe UI"/>
                         </a:rPr>
-                        <a:t>2.12.0</a:t>
+                        <a:t>2.13.0</a:t>
                       </a:r>
                     </a:p>
                   </a:txBody>
@@ -10147,7 +10147,7 @@
                           </a:solidFill>
                           <a:latin typeface="Segoe UI"/>
                         </a:rPr>
-                        <a:t>Mega update: 28 new animals, 31 shop items, 13 moves</a:t>
+                        <a:t>Birthdays, parties &amp; gifts</a:t>
                       </a:r>
                     </a:p>
                     <a:p>
@@ -10158,7 +10158,7 @@
                           </a:solidFill>
                           <a:latin typeface="Segoe UI"/>
                         </a:rPr>
-                        <a:t>🦁 28 new animals (51 total): lion, tiger, unicorn, deer, sheep, cow, raccoon, red panda, monkey, hedgehog, dino, squirrel, mouse, koala, shark, dolphin, seal, otter, pufferfish, duck, crab, parrot, chick, ladybug, phoenix, pegasus, ghost and flamingo; 🎩 31 new shop items: top hat, cowboy, chef, pirate, Santa, viking, graduation cap, beret, bow, propeller cap, flower crown, nerd glasses, eyepatch, mustache, goggles, masquerade mask, tie, pearls, flower lei, gold chain, balloon, backpack, guitar, shield, butterfly / devil wings and more - plus Premium galaxy crown, galaxy cape and dragon wings; 💃 13 new moves: wave, jump, hearts, sing, yoga, zoomies, cartwheel, juggle, rain dance, breakdance, magic, confetti and the Premium rocket launch; The Shop is now split into sections (Hats, Face, Neck, Back, Moves, Arena gear) with an owned counter for each</a:t>
+                        <a:t>Set your birthday in Social → Profile (month + day, optionally visible to friends).; On your birthday Pips throws confetti and gives you 100 bonus coins.; Friends tab shows upcoming birthdays; you get reminders 3 days, 1 day and on the day.; Birthday parties: join a friend's party, see who's there, sign the guestbook and celebrate together.</a:t>
                       </a:r>
                     </a:p>
                   </a:txBody>
@@ -10182,7 +10182,7 @@
                           </a:solidFill>
                           <a:latin typeface="Segoe UI"/>
                         </a:rPr>
-                        <a:t>2.11.0</a:t>
+                        <a:t>2.12.0</a:t>
                       </a:r>
                     </a:p>
                   </a:txBody>
@@ -10226,7 +10226,7 @@
                           </a:solidFill>
                           <a:latin typeface="Segoe UI"/>
                         </a:rPr>
-                        <a:t>New right-click menus</a:t>
+                        <a:t>Mega update: 28 new animals, 31 shop items, 13 moves</a:t>
                       </a:r>
                     </a:p>
                     <a:p>
@@ -10237,7 +10237,7 @@
                           </a:solidFill>
                           <a:latin typeface="Segoe UI"/>
                         </a:rPr>
-                        <a:t>✨ Brand-new animated right-click menu for your pet: mood &amp; stat bars, quick-action tiles (Friends, Shop, Snack, Pat, Focus, Stats, Sleep, Taskbar), hover effects and smooth fly-out submenus; Pick colours from swatches, switch size with one click and flip Sounds / Dark mode with toggle switches - changes show instantly; Updates are highlighted: a glowing banner and NEW badge appear in the menu when a new version is ready; The focus card's right-click menu got the same new look; keyboard arrows, Enter and Esc work too</a:t>
+                        <a:t>🦁 28 new animals (51 total): lion, tiger, unicorn, deer, sheep, cow, raccoon, red panda, monkey, hedgehog, dino, squirrel, mouse, koala, shark, dolphin, seal, otter, pufferfish, duck, crab, parrot, chick, ladybug, phoenix, pegasus, ghost and flamingo; 🎩 31 new shop items: top hat, cowboy, chef, pirate, Santa, viking, graduation cap, beret, bow, propeller cap, flower crown, nerd glasses, eyepatch, mustache, goggles, masquerade mask, tie, pearls, flower lei, gold chain, balloon, backpack, guitar, shield, butterfly / devil wings and more - plus Premium galaxy crown, galaxy cape and dragon wings; 💃 13 new moves: wave, jump, hearts, sing, yoga, zoomies, cartwheel, juggle, rain dance, breakdance, magic, confetti and the Premium rocket launch; The Shop is now split into sections (Hats, Face, Neck, Back, Moves, Arena gear) with an owned counter for each</a:t>
                       </a:r>
                     </a:p>
                   </a:txBody>
@@ -10261,7 +10261,7 @@
                           </a:solidFill>
                           <a:latin typeface="Segoe UI"/>
                         </a:rPr>
-                        <a:t>2.10.0</a:t>
+                        <a:t>2.11.0</a:t>
                       </a:r>
                     </a:p>
                   </a:txBody>
@@ -10305,7 +10305,7 @@
                           </a:solidFill>
                           <a:latin typeface="Segoe UI"/>
                         </a:rPr>
-                        <a:t>Chat bots</a:t>
+                        <a:t>New right-click menus</a:t>
                       </a:r>
                     </a:p>
                     <a:p>
@@ -10316,7 +10316,7 @@
                           </a:solidFill>
                           <a:latin typeface="Segoe UI"/>
                         </a:rPr>
-                        <a:t>🤖 6 friendly chat bots in the Chat tab: Pip Helper (app questions), Coach Focus (focus tips from your real stats), Sunny (live weather for any city), Arena Master (battle tips + quick battle), Giggles (jokes &amp; games) and Guardian (safety &amp; reporting help); Private bot chats with suggestion chips, typing indicator and a clear button - your bot chats stay on your PC; Mention a bot in a group chat (e.g. @weather Batam) and it answers in the room for everyone; Bots reply in your app language; up to 120 bot messages per day</a:t>
+                        <a:t>✨ Brand-new animated right-click menu for your pet: mood &amp; stat bars, quick-action tiles (Friends, Shop, Snack, Pat, Focus, Stats, Sleep, Taskbar), hover effects and smooth fly-out submenus; Pick colours from swatches, switch size with one click and flip Sounds / Dark mode with toggle switches - changes show instantly; Updates are highlighted: a glowing banner and NEW badge appear in the menu when a new version is ready; The focus card's right-click menu got the same new look; keyboard arrows, Enter and Esc work too</a:t>
                       </a:r>
                     </a:p>
                   </a:txBody>
@@ -10340,7 +10340,7 @@
                           </a:solidFill>
                           <a:latin typeface="Segoe UI"/>
                         </a:rPr>
-                        <a:t>2.9.0</a:t>
+                        <a:t>2.10.0</a:t>
                       </a:r>
                     </a:p>
                   </a:txBody>
@@ -10384,7 +10384,7 @@
                           </a:solidFill>
                           <a:latin typeface="Segoe UI"/>
                         </a:rPr>
-                        <a:t>Location &amp; live weather</a:t>
+                        <a:t>Chat bots</a:t>
                       </a:r>
                     </a:p>
                     <a:p>
@@ -10395,7 +10395,7 @@
                           </a:solidFill>
                           <a:latin typeface="Segoe UI"/>
                         </a:rPr>
-                        <a:t>📍 Add your city in Profile → Location &amp; weather (auto-detect or search) - only your city and country are shown, never your exact position; Live weather banners on every profile with animations: rain, drizzle, thunderstorms with lightning, snow, fog, clouds, sunshine or a starry night - plus temperature, feels-like, humidity, wind and local time; Your own weather strip on top of the hub, and each friend's weather + local time in the friends list; Hide your location from others or remove it any time</a:t>
+                        <a:t>🤖 6 friendly chat bots in the Chat tab: Pip Helper (app questions), Coach Focus (focus tips from your real stats), Sunny (live weather for any city), Arena Master (battle tips + quick battle), Giggles (jokes &amp; games) and Guardian (safety &amp; reporting help); Private bot chats with suggestion chips, typing indicator and a clear button - your bot chats stay on your PC; Mention a bot in a group chat (e.g. @weather Batam) and it answers in the room for everyone; Bots reply in your app language; up to 120 bot messages per day</a:t>
                       </a:r>
                     </a:p>
                   </a:txBody>
@@ -10419,7 +10419,7 @@
                           </a:solidFill>
                           <a:latin typeface="Segoe UI"/>
                         </a:rPr>
-                        <a:t>2.8.0</a:t>
+                        <a:t>2.9.0</a:t>
                       </a:r>
                     </a:p>
                   </a:txBody>
@@ -10463,7 +10463,7 @@
                           </a:solidFill>
                           <a:latin typeface="Segoe UI"/>
                         </a:rPr>
-                        <a:t>Pips Arena - duels, gear &amp; live battles</a:t>
+                        <a:t>Location &amp; live weather</a:t>
                       </a:r>
                     </a:p>
                     <a:p>
@@ -10474,7 +10474,7 @@
                           </a:solidFill>
                           <a:latin typeface="Segoe UI"/>
                         </a:rPr>
-                        <a:t>⚔ New Arena tab: challenge friends or anyone in the arena to a live duel - each round pick Attack, Guard or Special within 12 seconds and watch your pets fight; ⚡ Quick battle: an instant auto-fight against anyone's fighter, even when they're offline; Arena gear in the Shop: 7 weapons (water pistol to rocket launcher), 5 armors and 5 gadgets that decide your special move - better gear and a higher level make a stronger fighter; Live duels can be watched by everyone, plus recent battle replays, top fighters, rating and win/loss records; wins earn coins</a:t>
+                        <a:t>📍 Add your city in Profile → Location &amp; weather (auto-detect or search) - only your city and country are shown, never your exact position; Live weather banners on every profile with animations: rain, drizzle, thunderstorms with lightning, snow, fog, clouds, sunshine or a starry night - plus temperature, feels-like, humidity, wind and local time; Your own weather strip on top of the hub, and each friend's weather + local time in the friends list; Hide your location from others or remove it any time</a:t>
                       </a:r>
                     </a:p>
                   </a:txBody>
@@ -10498,7 +10498,7 @@
                           </a:solidFill>
                           <a:latin typeface="Segoe UI"/>
                         </a:rPr>
-                        <a:t>2.7.0</a:t>
+                        <a:t>2.8.0</a:t>
                       </a:r>
                     </a:p>
                   </a:txBody>
@@ -10542,7 +10542,7 @@
                           </a:solidFill>
                           <a:latin typeface="Segoe UI"/>
                         </a:rPr>
-                        <a:t>Moderators &amp; Premium</a:t>
+                        <a:t>Pips Arena - duels, gear &amp; live battles</a:t>
                       </a:r>
                     </a:p>
                     <a:p>
@@ -10553,7 +10553,7 @@
                           </a:solidFill>
                           <a:latin typeface="Segoe UI"/>
                         </a:rPr>
-                        <a:t>★ Premium: a purple Premium badge, 4 exclusive props (tiara, star glasses, diamond necklace, fairy wings), the Fireworks move, +30 coins every day, double friend-interaction coins and room for 300 friends / 30 groups; Get Premium: Profile tab → Premium → "Ask to buy" emails the owner; after payment you receive a key (PIPS-XXXX-XXXX) to redeem right there; 🛡 Moderators: a blue Mod badge and a Mod tab with the report queue - warn, mute (1h / 24h / 7 days), clear a profile or reset a name; every action is logged; Report button on everyone's profile, so moderators can keep Pips friendly</a:t>
+                        <a:t>⚔ New Arena tab: challenge friends or anyone in the arena to a live duel - each round pick Attack, Guard or Special within 12 seconds and watch your pets fight; ⚡ Quick battle: an instant auto-fight against anyone's fighter, even when they're offline; Arena gear in the Shop: 7 weapons (water pistol to rocket launcher), 5 armors and 5 gadgets that decide your special move - better gear and a higher level make a stronger fighter; Live duels can be watched by everyone, plus recent battle replays, top fighters, rating and win/loss records; wins earn coins</a:t>
                       </a:r>
                     </a:p>
                   </a:txBody>
@@ -10577,7 +10577,7 @@
                           </a:solidFill>
                           <a:latin typeface="Segoe UI"/>
                         </a:rPr>
-                        <a:t>2.6.1</a:t>
+                        <a:t>2.7.0</a:t>
                       </a:r>
                     </a:p>
                   </a:txBody>
@@ -10621,7 +10621,7 @@
                           </a:solidFill>
                           <a:latin typeface="Segoe UI"/>
                         </a:rPr>
-                        <a:t>Owner badge &amp; credits</a:t>
+                        <a:t>Moderators &amp; Premium</a:t>
                       </a:r>
                     </a:p>
                     <a:p>
@@ -10632,7 +10632,7 @@
                           </a:solidFill>
                           <a:latin typeface="Segoe UI"/>
                         </a:rPr>
-                        <a:t>The creator of Pips (Juwen Lie) now shows a gold ♛ Owner badge on his profile, friend list and ranks; New About Pips card in the Profile tab: credits and how to contact the owner (Juwen_Lie@pegatroncorp.com) with Email and Copy buttons; Right-click the pet → Help → About now shows who made Pips and the contact email</a:t>
+                        <a:t>★ Premium: a purple Premium badge, 4 exclusive props (tiara, star glasses, diamond necklace, fairy wings), the Fireworks move, +30 coins every day, double friend-interaction coins and room for 300 friends / 30 groups; Get Premium: Profile tab → Premium → "Ask to buy" emails the owner; after payment you receive a key (PIPS-XXXX-XXXX) to redeem right there; 🛡 Moderators: a blue Mod badge and a Mod tab with the report queue - warn, mute (1h / 24h / 7 days), clear a profile or reset a name; every action is logged; Report button on everyone's profile, so moderators can keep Pips friendly</a:t>
                       </a:r>
                     </a:p>
                   </a:txBody>
@@ -10656,7 +10656,7 @@
                           </a:solidFill>
                           <a:latin typeface="Segoe UI"/>
                         </a:rPr>
-                        <a:t>2.6.0</a:t>
+                        <a:t>2.6.1</a:t>
                       </a:r>
                     </a:p>
                   </a:txBody>
@@ -10700,7 +10700,7 @@
                           </a:solidFill>
                           <a:latin typeface="Segoe UI"/>
                         </a:rPr>
-                        <a:t>Profiles, ranks, online status &amp; dark mode</a:t>
+                        <a:t>Owner badge &amp; credits</a:t>
                       </a:r>
                     </a:p>
                     <a:p>
@@ -10711,7 +10711,7 @@
                           </a:solidFill>
                           <a:latin typeface="Segoe UI"/>
                         </a:rPr>
-                        <a:t>Profile tab: profile picture (or your pet), about me, job, location, hobbies, birthday and a status message; Public or private: public profiles can be added directly and viewed in full; private profiles need a friend request that they accept, and strangers only see name, photo, pet, level and status; Click anyone to open their profile - badges, info, their friends - and add them, chat or wave from there; Ranks tab replaces Teams: everyone using Pips, sorted by XP, badges or streak</a:t>
+                        <a:t>The creator of Pips (Juwen Lie) now shows a gold ♛ Owner badge on his profile, friend list and ranks; New About Pips card in the Profile tab: credits and how to contact the owner (Juwen_Lie@pegatroncorp.com) with Email and Copy buttons; Right-click the pet → Help → About now shows who made Pips and the contact email</a:t>
                       </a:r>
                     </a:p>
                   </a:txBody>
@@ -10735,7 +10735,7 @@
                           </a:solidFill>
                           <a:latin typeface="Segoe UI"/>
                         </a:rPr>
-                        <a:t>2.5.1</a:t>
+                        <a:t>2.6.0</a:t>
                       </a:r>
                     </a:p>
                   </a:txBody>
@@ -10779,7 +10779,7 @@
                           </a:solidFill>
                           <a:latin typeface="Segoe UI"/>
                         </a:rPr>
-                        <a:t>New cute Pips logo</a:t>
+                        <a:t>Profiles, ranks, online status &amp; dark mode</a:t>
                       </a:r>
                     </a:p>
                     <a:p>
@@ -10790,7 +10790,7 @@
                           </a:solidFill>
                           <a:latin typeface="Segoe UI"/>
                         </a:rPr>
-                        <a:t>New Pips logo: Pip the cat on a Pips-red tile, matching the app colours (desktop shortcut, windows and website)</a:t>
+                        <a:t>Profile tab: profile picture (or your pet), about me, job, location, hobbies, birthday and a status message; Public or private: public profiles can be added directly and viewed in full; private profiles need a friend request that they accept, and strangers only see name, photo, pet, level and status; Click anyone to open their profile - badges, info, their friends - and add them, chat or wave from there; Ranks tab replaces Teams: everyone using Pips, sorted by XP, badges or streak</a:t>
                       </a:r>
                     </a:p>
                   </a:txBody>
@@ -10814,7 +10814,7 @@
                           </a:solidFill>
                           <a:latin typeface="Segoe UI"/>
                         </a:rPr>
-                        <a:t>2.5.0</a:t>
+                        <a:t>2.5.1</a:t>
                       </a:r>
                     </a:p>
                   </a:txBody>
@@ -10858,7 +10858,7 @@
                           </a:solidFill>
                           <a:latin typeface="Segoe UI"/>
                         </a:rPr>
-                        <a:t>Shop, coins, props &amp; moves</a:t>
+                        <a:t>New cute Pips logo</a:t>
                       </a:r>
                     </a:p>
                     <a:p>
@@ -10869,7 +10869,7 @@
                           </a:solidFill>
                           <a:latin typeface="Segoe UI"/>
                         </a:rPr>
-                        <a:t>Shop: earn coins and spend them on your pet - 17 props (crown, wizard hat, headphones, shades, scarf, cape, angel wings...) and 6 moves: spin, dance, moonwalk, backflip, kung fu and spider swing!; Coins come from leveling up (+40), badges (+25), opening Pips each day (+10), friendships (+15 per affinity level), waving / chatting / visiting friends (+2) and pomodoros (+5). Everyone starts with a 100-coin gift; Your friends see your props: on avatars in the hub and when your pet visits their desktop - it shows off one of your moves; Pips is now a social pet: clicking the pet opens the Pips hub (friends, chat, groups, shop, badges)</a:t>
+                        <a:t>New Pips logo: Pip the cat on a Pips-red tile, matching the app colours (desktop shortcut, windows and website)</a:t>
                       </a:r>
                     </a:p>
                   </a:txBody>
@@ -10893,7 +10893,7 @@
                           </a:solidFill>
                           <a:latin typeface="Segoe UI"/>
                         </a:rPr>
-                        <a:t>2.4.0</a:t>
+                        <a:t>2.5.0</a:t>
                       </a:r>
                     </a:p>
                   </a:txBody>
@@ -10937,7 +10937,7 @@
                           </a:solidFill>
                           <a:latin typeface="Segoe UI"/>
                         </a:rPr>
-                        <a:t>Chat, groups, affinity &amp; pet visits</a:t>
+                        <a:t>Shop, coins, props &amp; moves</a:t>
                       </a:r>
                     </a:p>
                     <a:p>
@@ -10948,7 +10948,7 @@
                           </a:solidFill>
                           <a:latin typeface="Segoe UI"/>
                         </a:rPr>
-                        <a:t>Chat: message your friends, and chat inside groups. Your pet pops up new messages as a bubble - click it to reply; Pet interactions: wave, pet their pet, send a snack, high five - or send your pet to visit: it walks onto your friend's desktop for a little while!; Affinity: every chat and interaction grows your friendship - Acquaintance → Buddy → Good friends → Close friends → Best friends → Soulmates; Your own groups: create a private group, invite your friends, they accept or decline. Group board + group chat; the owner can remove members</a:t>
+                        <a:t>Shop: earn coins and spend them on your pet - 17 props (crown, wizard hat, headphones, shades, scarf, cape, angel wings...) and 6 moves: spin, dance, moonwalk, backflip, kung fu and spider swing!; Coins come from leveling up (+40), badges (+25), opening Pips each day (+10), friendships (+15 per affinity level), waving / chatting / visiting friends (+2) and pomodoros (+5). Everyone starts with a 100-coin gift; Your friends see your props: on avatars in the hub and when your pet visits their desktop - it shows off one of your moves; Pips is now a social pet: clicking the pet opens the Pips hub (friends, chat, groups, shop, badges)</a:t>
                       </a:r>
                     </a:p>
                   </a:txBody>
@@ -10972,7 +10972,7 @@
                           </a:solidFill>
                           <a:latin typeface="Segoe UI"/>
                         </a:rPr>
-                        <a:t>2.3.0</a:t>
+                        <a:t>2.4.0</a:t>
                       </a:r>
                     </a:p>
                   </a:txBody>
@@ -11016,7 +11016,7 @@
                           </a:solidFill>
                           <a:latin typeface="Segoe UI"/>
                         </a:rPr>
-                        <a:t>Friends, levels &amp; achievements</a:t>
+                        <a:t>Chat, groups, affinity &amp; pet visits</a:t>
                       </a:r>
                     </a:p>
                     <a:p>
@@ -11027,7 +11027,7 @@
                           </a:solidFill>
                           <a:latin typeface="Segoe UI"/>
                         </a:rPr>
-                        <a:t>Levels &amp; XP: every finished pomodoro earns XP and your level grows - plus 20 achievements to unlock (first tomato, 8 in a day, 7-day streak, early bird, night owl, pet lover...). Your pet celebrates each one; Friends (optional, off by default): get a 6-letter friend code, add colleagues, see today's board and join a team board like PTB. Your pet tells you when a friend finishes a pomodoro; Privacy: only your name, pet, level, streak and pomodoro counts are shared - never apps, window titles or scores. One click turns it off and deletes your online data. Right-click the pet → Friends &amp; achievements…</a:t>
+                        <a:t>Chat: message your friends, and chat inside groups. Your pet pops up new messages as a bubble - click it to reply; Pet interactions: wave, pet their pet, send a snack, high five - or send your pet to visit: it walks onto your friend's desktop for a little while!; Affinity: every chat and interaction grows your friendship - Acquaintance → Buddy → Good friends → Close friends → Best friends → Soulmates; Your own groups: create a private group, invite your friends, they accept or decline. Group board + group chat; the owner can remove members</a:t>
                       </a:r>
                     </a:p>
                   </a:txBody>
@@ -11051,7 +11051,7 @@
                           </a:solidFill>
                           <a:latin typeface="Segoe UI"/>
                         </a:rPr>
-                        <a:t>2.2.0</a:t>
+                        <a:t>2.3.0</a:t>
                       </a:r>
                     </a:p>
                   </a:txBody>
@@ -11095,7 +11095,7 @@
                           </a:solidFill>
                           <a:latin typeface="Segoe UI"/>
                         </a:rPr>
-                        <a:t>Pet sounds</a:t>
+                        <a:t>Friends, levels &amp; achievements</a:t>
                       </a:r>
                     </a:p>
                     <a:p>
@@ -11106,7 +11106,7 @@
                           </a:solidFill>
                           <a:latin typeface="Segoe UI"/>
                         </a:rPr>
-                        <a:t>Your pet has a voice! Each of the 23 animals has its own sound (meow, woof, ribbit, hoot, buzz, oink, whale song...) and it changes with its mood: happy chirps, sad whimpers, sleepy yawns, hungry calls, grumpy huffs and soft snores; It also reacts with sound when you tickle, pet, feed, shake or wake it; Settings: right-click the pet → Sounds to switch on/off; Pet status &amp; settings has a volume slider, a ▶ Hear me button and "Stay quiet while I'm focusing" (on by default)</a:t>
+                        <a:t>Levels &amp; XP: every finished pomodoro earns XP and your level grows - plus 20 achievements to unlock (first tomato, 8 in a day, 7-day streak, early bird, night owl, pet lover...). Your pet celebrates each one; Friends (optional, off by default): get a 6-letter friend code, add colleagues, see today's board and join a team board like PTB. Your pet tells you when a friend finishes a pomodoro; Privacy: only your name, pet, level, streak and pomodoro counts are shared - never apps, window titles or scores. One click turns it off and deletes your online data. Right-click the pet → Friends &amp; achievements…</a:t>
                       </a:r>
                     </a:p>
                   </a:txBody>
@@ -11130,7 +11130,7 @@
                           </a:solidFill>
                           <a:latin typeface="Segoe UI"/>
                         </a:rPr>
-                        <a:t>2.1.2</a:t>
+                        <a:t>2.2.0</a:t>
                       </a:r>
                     </a:p>
                   </a:txBody>
@@ -11174,7 +11174,7 @@
                           </a:solidFill>
                           <a:latin typeface="Segoe UI"/>
                         </a:rPr>
-                        <a:t>Tickle-only mode</a:t>
+                        <a:t>Pet sounds</a:t>
                       </a:r>
                     </a:p>
                     <a:p>
@@ -11185,7 +11185,7 @@
                           </a:solidFill>
                           <a:latin typeface="Segoe UI"/>
                         </a:rPr>
-                        <a:t>New click option "Only tickle (never open Pips)": click and tickle your pet as much as you like - the Pomodoro window stays closed (open it from the right-click menu). Right-click the pet → When I click</a:t>
+                        <a:t>Your pet has a voice! Each of the 23 animals has its own sound (meow, woof, ribbit, hoot, buzz, oink, whale song...) and it changes with its mood: happy chirps, sad whimpers, sleepy yawns, hungry calls, grumpy huffs and soft snores; It also reacts with sound when you tickle, pet, feed, shake or wake it; Settings: right-click the pet → Sounds to switch on/off; Pet status &amp; settings has a volume slider, a ▶ Hear me button and "Stay quiet while I'm focusing" (on by default)</a:t>
                       </a:r>
                     </a:p>
                   </a:txBody>
@@ -11209,7 +11209,7 @@
                           </a:solidFill>
                           <a:latin typeface="Segoe UI"/>
                         </a:rPr>
-                        <a:t>2.1.1</a:t>
+                        <a:t>2.1.2</a:t>
                       </a:r>
                     </a:p>
                   </a:txBody>
@@ -11253,7 +11253,7 @@
                           </a:solidFill>
                           <a:latin typeface="Segoe UI"/>
                         </a:rPr>
-                        <a:t>Owner info</a:t>
+                        <a:t>Tickle-only mode</a:t>
                       </a:r>
                     </a:p>
                     <a:p>
@@ -11264,7 +11264,7 @@
                           </a:solidFill>
                           <a:latin typeface="Segoe UI"/>
                         </a:rPr>
-                        <a:t>About Pips now shows the owner: Juwen Lie (right-click the pet → Help → About)</a:t>
+                        <a:t>New click option "Only tickle (never open Pips)": click and tickle your pet as much as you like - the Pomodoro window stays closed (open it from the right-click menu). Right-click the pet → When I click</a:t>
                       </a:r>
                     </a:p>
                   </a:txBody>
@@ -11288,7 +11288,7 @@
                           </a:solidFill>
                           <a:latin typeface="Segoe UI"/>
                         </a:rPr>
-                        <a:t>2.1.0</a:t>
+                        <a:t>2.1.1</a:t>
                       </a:r>
                     </a:p>
                   </a:txBody>
@@ -11332,7 +11332,7 @@
                           </a:solidFill>
                           <a:latin typeface="Segoe UI"/>
                         </a:rPr>
-                        <a:t>Interactive guide &amp; in-app updates</a:t>
+                        <a:t>Owner info</a:t>
                       </a:r>
                     </a:p>
                     <a:p>
@@ -11343,7 +11343,7 @@
                           </a:solidFill>
                           <a:latin typeface="Segoe UI"/>
                         </a:rPr>
-                        <a:t>Interactive first-run guide: your pet walks you through clicking, dragging, petting and the right-click menu; In-app updates: Pips tells you when a new version is out - update with one click (your settings and data are kept); New Help menu: replay the guide, check for updates, see the version; Option to turn automatic update checks off</a:t>
+                        <a:t>About Pips now shows the owner: Juwen Lie (right-click the pet → Help → About)</a:t>
                       </a:r>
                     </a:p>
                   </a:txBody>
@@ -11367,7 +11367,7 @@
                           </a:solidFill>
                           <a:latin typeface="Segoe UI"/>
                         </a:rPr>
-                        <a:t>2.0.0</a:t>
+                        <a:t>2.1.0</a:t>
                       </a:r>
                     </a:p>
                   </a:txBody>
@@ -11411,7 +11411,7 @@
                           </a:solidFill>
                           <a:latin typeface="Segoe UI"/>
                         </a:rPr>
-                        <a:t>Desktop pet, 23 animals &amp; 4 languages</a:t>
+                        <a:t>Interactive guide &amp; in-app updates</a:t>
                       </a:r>
                     </a:p>
                     <a:p>
@@ -11422,7 +11422,7 @@
                           </a:solidFill>
                           <a:latin typeface="Segoe UI"/>
                         </a:rPr>
-                        <a:t>Desktop pet that lives on your desktop and taskbar - drag it, tickle it, pet it; 23 animals in 3 groups: Land walks, Water swims with bubbles, Sky hovers and flaps; Moods (happy, sad, tired, hungry, grumpy...), naps when you're away, wakes up when you're back; Cute chat-bubble reminders: breaks, water, 20-20-20 eye rest, pomodoro done, daily goal</a:t>
+                        <a:t>Interactive first-run guide: your pet walks you through clicking, dragging, petting and the right-click menu; In-app updates: Pips tells you when a new version is out - update with one click (your settings and data are kept); New Help menu: replay the guide, check for updates, see the version; Option to turn automatic update checks off</a:t>
                       </a:r>
                     </a:p>
                   </a:txBody>
@@ -11446,7 +11446,7 @@
                           </a:solidFill>
                           <a:latin typeface="Segoe UI"/>
                         </a:rPr>
-                        <a:t>1.5.0</a:t>
+                        <a:t>2.0.0</a:t>
                       </a:r>
                     </a:p>
                   </a:txBody>
@@ -11468,7 +11468,7 @@
                           </a:solidFill>
                           <a:latin typeface="Segoe UI"/>
                         </a:rPr>
-                        <a:t>2026-10-24</a:t>
+                        <a:t>2026-10-28</a:t>
                       </a:r>
                     </a:p>
                   </a:txBody>
@@ -11490,7 +11490,7 @@
                           </a:solidFill>
                           <a:latin typeface="Segoe UI"/>
                         </a:rPr>
-                        <a:t>Renamed to Pips + insights</a:t>
+                        <a:t>Desktop pet, 23 animals &amp; 4 languages</a:t>
                       </a:r>
                     </a:p>
                     <a:p>
@@ -11501,7 +11501,7 @@
                           </a:solidFill>
                           <a:latin typeface="Segoe UI"/>
                         </a:rPr>
-                        <a:t>Renamed from Productivity Widget to Pips; Dashboard charts: focus timeline, hour heatmap, 7-day score trend, pomodoros per day; AI token usage on the card and dashboard; Daily diary export and weekly / monthly reports</a:t>
+                        <a:t>Desktop pet that lives on your desktop and taskbar - drag it, tickle it, pet it; 23 animals in 3 groups: Land walks, Water swims with bubbles, Sky hovers and flaps; Moods (happy, sad, tired, hungry, grumpy...), naps when you're away, wakes up when you're back; Cute chat-bubble reminders: breaks, water, 20-20-20 eye rest, pomodoro done, daily goal</a:t>
                       </a:r>
                     </a:p>
                   </a:txBody>
@@ -11525,13 +11525,92 @@
                           </a:solidFill>
                           <a:latin typeface="Segoe UI"/>
                         </a:rPr>
+                        <a:t>1.5.0</a:t>
+                      </a:r>
+                    </a:p>
+                  </a:txBody>
+                  <a:tcPr marL="73152" marR="73152" marT="36576" marB="36576">
+                    <a:solidFill>
+                      <a:srgbClr val="FFFDF8"/>
+                    </a:solidFill>
+                  </a:tcPr>
+                </a:tc>
+                <a:tc>
+                  <a:txBody>
+                    <a:bodyPr wrap="square"/>
+                    <a:lstStyle/>
+                    <a:p>
+                      <a:r>
+                        <a:rPr sz="1200" b="0">
+                          <a:solidFill>
+                            <a:srgbClr val="2B2A28"/>
+                          </a:solidFill>
+                          <a:latin typeface="Segoe UI"/>
+                        </a:rPr>
+                        <a:t>2026-10-24</a:t>
+                      </a:r>
+                    </a:p>
+                  </a:txBody>
+                  <a:tcPr marL="73152" marR="73152" marT="36576" marB="36576">
+                    <a:solidFill>
+                      <a:srgbClr val="FFFDF8"/>
+                    </a:solidFill>
+                  </a:tcPr>
+                </a:tc>
+                <a:tc>
+                  <a:txBody>
+                    <a:bodyPr wrap="square"/>
+                    <a:lstStyle/>
+                    <a:p>
+                      <a:r>
+                        <a:rPr sz="1200" b="0">
+                          <a:solidFill>
+                            <a:srgbClr val="2B2A28"/>
+                          </a:solidFill>
+                          <a:latin typeface="Segoe UI"/>
+                        </a:rPr>
+                        <a:t>Renamed to Pips + insights</a:t>
+                      </a:r>
+                    </a:p>
+                    <a:p>
+                      <a:r>
+                        <a:rPr sz="1200" b="0">
+                          <a:solidFill>
+                            <a:srgbClr val="2B2A28"/>
+                          </a:solidFill>
+                          <a:latin typeface="Segoe UI"/>
+                        </a:rPr>
+                        <a:t>Renamed from Productivity Widget to Pips; Dashboard charts: focus timeline, hour heatmap, 7-day score trend, pomodoros per day; AI token usage on the card and dashboard; Daily diary export and weekly / monthly reports</a:t>
+                      </a:r>
+                    </a:p>
+                  </a:txBody>
+                  <a:tcPr marL="73152" marR="73152" marT="36576" marB="36576">
+                    <a:solidFill>
+                      <a:srgbClr val="FFFDF8"/>
+                    </a:solidFill>
+                  </a:tcPr>
+                </a:tc>
+              </a:tr>
+              <a:tr h="822960">
+                <a:tc>
+                  <a:txBody>
+                    <a:bodyPr wrap="square"/>
+                    <a:lstStyle/>
+                    <a:p>
+                      <a:r>
+                        <a:rPr sz="1200" b="1">
+                          <a:solidFill>
+                            <a:srgbClr val="2B2A28"/>
+                          </a:solidFill>
+                          <a:latin typeface="Segoe UI"/>
+                        </a:rPr>
                         <a:t>1.0.0</a:t>
                       </a:r>
                     </a:p>
                   </a:txBody>
                   <a:tcPr marL="73152" marR="73152" marT="36576" marB="36576">
                     <a:solidFill>
-                      <a:srgbClr val="FFFDF8"/>
+                      <a:srgbClr val="F7F4EC"/>
                     </a:solidFill>
                   </a:tcPr>
                 </a:tc>
@@ -11553,7 +11632,7 @@
                   </a:txBody>
                   <a:tcPr marL="73152" marR="73152" marT="36576" marB="36576">
                     <a:solidFill>
-                      <a:srgbClr val="FFFDF8"/>
+                      <a:srgbClr val="F7F4EC"/>
                     </a:solidFill>
                   </a:tcPr>
                 </a:tc>
@@ -11586,7 +11665,7 @@
                   </a:txBody>
                   <a:tcPr marL="73152" marR="73152" marT="36576" marB="36576">
                     <a:solidFill>
-                      <a:srgbClr val="FFFDF8"/>
+                      <a:srgbClr val="F7F4EC"/>
                     </a:solidFill>
                   </a:tcPr>
                 </a:tc>
@@ -14927,7 +15006,7 @@
         </p:nvGraphicFramePr>
         <p:xfrm>
           <a:off x="548640" y="1645920"/>
-          <a:ext cx="7315200" cy="4187952"/>
+          <a:ext cx="7315200" cy="4663440"/>
         </p:xfrm>
         <a:graphic>
           <a:graphicData uri="http://schemas.openxmlformats.org/drawingml/2006/table">
@@ -15349,6 +15428,52 @@
                   <a:tcPr marL="73152" marR="73152" marT="36576" marB="36576">
                     <a:solidFill>
                       <a:srgbClr val="F7F4EC"/>
+                    </a:solidFill>
+                  </a:tcPr>
+                </a:tc>
+              </a:tr>
+              <a:tr h="475488">
+                <a:tc>
+                  <a:txBody>
+                    <a:bodyPr wrap="square"/>
+                    <a:lstStyle/>
+                    <a:p>
+                      <a:r>
+                        <a:rPr sz="1400" b="1">
+                          <a:solidFill>
+                            <a:srgbClr val="2B2A28"/>
+                          </a:solidFill>
+                          <a:latin typeface="Segoe UI"/>
+                        </a:rPr>
+                        <a:t>Weather ☔</a:t>
+                      </a:r>
+                    </a:p>
+                  </a:txBody>
+                  <a:tcPr marL="73152" marR="73152" marT="36576" marB="36576">
+                    <a:solidFill>
+                      <a:srgbClr val="FFFDF8"/>
+                    </a:solidFill>
+                  </a:tcPr>
+                </a:tc>
+                <a:tc>
+                  <a:txBody>
+                    <a:bodyPr wrap="square"/>
+                    <a:lstStyle/>
+                    <a:p>
+                      <a:r>
+                        <a:rPr sz="1400" b="0">
+                          <a:solidFill>
+                            <a:srgbClr val="2B2A28"/>
+                          </a:solidFill>
+                          <a:latin typeface="Segoe UI"/>
+                        </a:rPr>
+                        <a:t>Live weather around your pet (rain cloud + umbrella, snow, sun, stars, storms). Right-click → Weather &amp; location to follow your exact spot or pick a place</a:t>
+                      </a:r>
+                    </a:p>
+                  </a:txBody>
+                  <a:tcPr marL="73152" marR="73152" marT="36576" marB="36576">
+                    <a:solidFill>
+                      <a:srgbClr val="FFFDF8"/>
                     </a:solidFill>
                   </a:tcPr>
                 </a:tc>

</xml_diff>

<commit_message>
pips 2.24.0: Skill battles, minigames & a simpler Hub
</commit_message>
<xml_diff>
--- a/apps/pips/web/download/Pips-Guide.pptx
+++ b/apps/pips/web/download/Pips-Guide.pptx
@@ -3292,7 +3292,7 @@
                 </a:solidFill>
                 <a:latin typeface="Segoe UI"/>
               </a:rPr>
-              <a:t>Version 2.23.0  ·  2026-10-29  ·  Made by Juwen Lie (owner)</a:t>
+              <a:t>Version 2.24.0  ·  2026-10-29  ·  Made by Juwen Lie (owner)</a:t>
             </a:r>
           </a:p>
           <a:p>
@@ -8279,7 +8279,7 @@
                 </a:solidFill>
                 <a:latin typeface="Segoe UI"/>
               </a:rPr>
-              <a:t>What's new in 2.23.0</a:t>
+              <a:t>What's new in 2.24.0</a:t>
             </a:r>
           </a:p>
         </p:txBody>
@@ -8392,7 +8392,7 @@
                 </a:solidFill>
                 <a:latin typeface="Segoe UI"/>
               </a:rPr>
-              <a:t>Weather on your desktop  ·  2026-10-29</a:t>
+              <a:t>Skill battles, minigames &amp; a simpler Hub  ·  2026-10-29</a:t>
             </a:r>
           </a:p>
         </p:txBody>
@@ -8440,7 +8440,7 @@
                 </a:solidFill>
                 <a:latin typeface="Segoe UI"/>
               </a:rPr>
-              <a:t>Your pet now shows the live weather right on your desktop: its own little rain cloud with an umbrella when it rains, a dark storm cloud with lightning, snow piling up at its feet, the sun, the moon and twinkling stars at night, drifting fog and leaves blowing in the wind. Prefer more? Switch the animation to the whole screen - or turn it off.</a:t>
+              <a:t>Arena battles are now turn-based: before a fight compare both pets' stats (level + gear), pick 3 skills, and the challenger chooses best of 1, 3 or 5 rounds. Take turns until one pet is knocked out - new skills unlock as you level up and with weapons and gadgets.</a:t>
             </a:r>
           </a:p>
           <a:p>
@@ -8465,7 +8465,7 @@
                 </a:solidFill>
                 <a:latin typeface="Segoe UI"/>
               </a:rPr>
-              <a:t>New right-click menu → Weather &amp; location: Follow my exact location (Windows location; a laptop is followed as you move), Approximate (from your internet connection), or Pick a place - search a city or paste exact coordinates from Google Maps. The pet tells you when the weather changes.</a:t>
+              <a:t>5 new minigames to play with your pet: Treat Catch, Bonk the Bugs, Memory Match, Pet Says and Hop Hop. Best scores are saved and great scores earn a few coins (right-click → Games, or Hub → Play).</a:t>
             </a:r>
           </a:p>
           <a:p>
@@ -8490,7 +8490,7 @@
                 </a:solidFill>
                 <a:latin typeface="Segoe UI"/>
               </a:rPr>
-              <a:t>Works without Pips Friends (weather from Open-Meteo, no account needed). With Friends on, your profile city follows you too - but a city you hid stays hidden. If Windows location is turned off on your PC, Pips explains how to turn it on and uses your internet location meanwhile.</a:t>
+              <a:t>The Hub is simpler: 5 tabs - Friends, Chat (messages + groups), Play (arena, minigames, ranks), Shop and Me (profile + achievements).</a:t>
             </a:r>
           </a:p>
         </p:txBody>
@@ -8621,7 +8621,7 @@
                 </a:solidFill>
                 <a:latin typeface="Segoe UI"/>
               </a:rPr>
-              <a:t>Pet-mu sekarang menampilkan cuaca langsung di desktop: awan hujan kecil miliknya sendiri lengkap dengan payung saat hujan, awan badai gelap dengan petir, salju yang menumpuk di kakinya, matahari, bulan dan bintang berkelip di malam hari, kabut yang melayang dan daun yang tertiup angin. Mau lebih? Pindahkan animasinya ke seluruh layar - atau matikan.</a:t>
+              <a:t>Duel arena kini bergiliran: sebelum bertarung bandingkan statistik kedua pet (level + gear), pilih 3 skill, dan penantang memilih best of 1, 3 atau 5 ronde. Bergantian sampai salah satu KO - skill baru terbuka saat naik level dan dengan senjata serta gadget.</a:t>
             </a:r>
           </a:p>
           <a:p>
@@ -8646,7 +8646,7 @@
                 </a:solidFill>
                 <a:latin typeface="Segoe UI"/>
               </a:rPr>
-              <a:t>Menu klik kanan baru → Cuaca &amp; lokasi: Ikuti lokasi persisku (lokasi Windows; laptop diikuti saat kamu berpindah), Perkiraan (dari koneksi internet), atau Pilih tempat - cari kota atau tempel koordinat persis dari Google Maps. Pet memberi tahu saat cuaca berubah.</a:t>
+              <a:t>5 minigame baru untuk bermain dengan pet: Tangkap Camilan, Pukul Serangga, Cocokkan Kartu, Kata Pet dan Lompat Lompat. Skor terbaik disimpan dan skor hebat dapat beberapa koin (klik kanan → Permainan, atau Hub → Main).</a:t>
             </a:r>
           </a:p>
           <a:p>
@@ -8671,7 +8671,7 @@
                 </a:solidFill>
                 <a:latin typeface="Segoe UI"/>
               </a:rPr>
-              <a:t>Berfungsi tanpa Pips Friends (cuaca dari Open-Meteo, tanpa akun). Jika Friends aktif, kota di profilmu ikut berpindah - tapi kota yang kamu sembunyikan tetap tersembunyi. Jika lokasi Windows dimatikan di PC-mu, Pips menjelaskan cara menyalakannya dan sementara memakai lokasi internet.</a:t>
+              <a:t>Hub lebih sederhana: 5 tab - Teman, Chat (pesan + grup), Main (arena, minigame, peringkat), Toko dan Saya (profil + pencapaian).</a:t>
             </a:r>
           </a:p>
         </p:txBody>
@@ -8903,7 +8903,7 @@
         </p:nvGraphicFramePr>
         <p:xfrm>
           <a:off x="548640" y="1645920"/>
-          <a:ext cx="11155680" cy="28364688"/>
+          <a:ext cx="11155680" cy="29187648"/>
         </p:xfrm>
         <a:graphic>
           <a:graphicData uri="http://schemas.openxmlformats.org/drawingml/2006/table">
@@ -8997,7 +8997,7 @@
                           </a:solidFill>
                           <a:latin typeface="Segoe UI"/>
                         </a:rPr>
-                        <a:t>2.23.0</a:t>
+                        <a:t>2.24.0</a:t>
                       </a:r>
                     </a:p>
                   </a:txBody>
@@ -9041,7 +9041,7 @@
                           </a:solidFill>
                           <a:latin typeface="Segoe UI"/>
                         </a:rPr>
-                        <a:t>Weather on your desktop</a:t>
+                        <a:t>Skill battles, minigames &amp; a simpler Hub</a:t>
                       </a:r>
                     </a:p>
                     <a:p>
@@ -9052,7 +9052,7 @@
                           </a:solidFill>
                           <a:latin typeface="Segoe UI"/>
                         </a:rPr>
-                        <a:t>Your pet now shows the live weather right on your desktop: its own little rain cloud with an umbrella when it rains, a dark storm cloud with lightning, snow piling up at its feet, the sun, the moon and twinkling stars at night, drifting fog and leaves blowing in the wind. Prefer more? Switch the animation to the whole screen - or turn it off.; New right-click menu → Weather &amp; location: Follow my exact location (Windows location; a laptop is followed as you move), Approximate (from your internet connection), or Pick a place - search a city or paste exact coordinates from Google Maps. The pet tells you when the weather changes.; Works without Pips Friends (weather from Open-Meteo, no account needed). With Friends on, your profile city follows you too - but a city you hid stays hidden. If Windows location is turned off on your PC, Pips explains how to turn it on and uses your internet location meanwhile.</a:t>
+                        <a:t>Arena battles are now turn-based: before a fight compare both pets' stats (level + gear), pick 3 skills, and the challenger chooses best of 1, 3 or 5 rounds. Take turns until one pet is knocked out - new skills unlock as you level up and with weapons and gadgets.; 5 new minigames to play with your pet: Treat Catch, Bonk the Bugs, Memory Match, Pet Says and Hop Hop. Best scores are saved and great scores earn a few coins (right-click → Games, or Hub → Play).; The Hub is simpler: 5 tabs - Friends, Chat (messages + groups), Play (arena, minigames, ranks), Shop and Me (profile + achievements).</a:t>
                       </a:r>
                     </a:p>
                   </a:txBody>
@@ -9076,7 +9076,7 @@
                           </a:solidFill>
                           <a:latin typeface="Segoe UI"/>
                         </a:rPr>
-                        <a:t>2.22.0</a:t>
+                        <a:t>2.23.0</a:t>
                       </a:r>
                     </a:p>
                   </a:txBody>
@@ -9120,7 +9120,7 @@
                           </a:solidFill>
                           <a:latin typeface="Segoe UI"/>
                         </a:rPr>
-                        <a:t>Sing &amp; dance with music</a:t>
+                        <a:t>Weather on your desktop</a:t>
                       </a:r>
                     </a:p>
                     <a:p>
@@ -9131,7 +9131,7 @@
                           </a:solidFill>
                           <a:latin typeface="Segoe UI"/>
                         </a:rPr>
-                        <a:t>Sing, Dance, Moonwalk, Breakdance, Yoga, Rain dance and the show tricks now play real music. When your pet sings, it sings the melody in its own voice - a cat meows the tune, a frog ribbits it, a whale hums it - and when it dances, its animal call joins the beat.; Pick the song: right-click → Do a trick → Song for sing &amp; dance. Choose your animal's own song (every one of the 51 animals has its own tune), the song for its type (Meadow Hoedown for land, Ocean Calypso for water, Cloud Waltz for sky), Happy Pop, Disco Night, 8-bit Adventure, Lullaby, Lo-fi Chill, any other animal's song, Surprise me or No music.; Songs follow your sound settings (volume, sounds off, quiet during focus) and stop as soon as the trick is interrupted. Tricks your pet does by itself stay quiet.</a:t>
+                        <a:t>Your pet now shows the live weather right on your desktop: its own little rain cloud with an umbrella when it rains, a dark storm cloud with lightning, snow piling up at its feet, the sun, the moon and twinkling stars at night, drifting fog and leaves blowing in the wind. Prefer more? Switch the animation to the whole screen - or turn it off.; New right-click menu → Weather &amp; location: Follow my exact location (Windows location; a laptop is followed as you move), Approximate (from your internet connection), or Pick a place - search a city or paste exact coordinates from Google Maps. The pet tells you when the weather changes.; Works without Pips Friends (weather from Open-Meteo, no account needed). With Friends on, your profile city follows you too - but a city you hid stays hidden. If Windows location is turned off on your PC, Pips explains how to turn it on and uses your internet location meanwhile.</a:t>
                       </a:r>
                     </a:p>
                   </a:txBody>
@@ -9155,7 +9155,7 @@
                           </a:solidFill>
                           <a:latin typeface="Segoe UI"/>
                         </a:rPr>
-                        <a:t>2.21.0</a:t>
+                        <a:t>2.22.0</a:t>
                       </a:r>
                     </a:p>
                   </a:txBody>
@@ -9199,7 +9199,7 @@
                           </a:solidFill>
                           <a:latin typeface="Segoe UI"/>
                         </a:rPr>
-                        <a:t>Every animal has a voice</a:t>
+                        <a:t>Sing &amp; dance with music</a:t>
                       </a:r>
                     </a:p>
                     <a:p>
@@ -9210,7 +9210,7 @@
                           </a:solidFill>
                           <a:latin typeface="Segoe UI"/>
                         </a:rPr>
-                        <a:t>All 51 animals now have their own sound. Before, more than half of them borrowed the cat's meow - now the dog woofs, the cow moos, the sheep baas, the lion roars, the duck quacks, the dolphin clicks and whistles, the dragon flaps and roars with a puff of fire, the ghost goes wooo... and so on.; Every mood sounds different too: happy, sad, sleepy, hungry or grumpy. Petting, eating and snoring sound right for each kind of animal - furry ones purr and crunch, birds trill and peck, sea animals blow bubbles, bugs hum and magic pets chime.; A friend's pet that comes to visit now talks in its own voice: it says hi when it arrives and answers when you wave, pet it or give it a snack (it follows your sound settings).</a:t>
+                        <a:t>Sing, Dance, Moonwalk, Breakdance, Yoga, Rain dance and the show tricks now play real music. When your pet sings, it sings the melody in its own voice - a cat meows the tune, a frog ribbits it, a whale hums it - and when it dances, its animal call joins the beat.; Pick the song: right-click → Do a trick → Song for sing &amp; dance. Choose your animal's own song (every one of the 51 animals has its own tune), the song for its type (Meadow Hoedown for land, Ocean Calypso for water, Cloud Waltz for sky), Happy Pop, Disco Night, 8-bit Adventure, Lullaby, Lo-fi Chill, any other animal's song, Surprise me or No music.; Songs follow your sound settings (volume, sounds off, quiet during focus) and stop as soon as the trick is interrupted. Tricks your pet does by itself stay quiet.</a:t>
                       </a:r>
                     </a:p>
                   </a:txBody>
@@ -9234,7 +9234,7 @@
                           </a:solidFill>
                           <a:latin typeface="Segoe UI"/>
                         </a:rPr>
-                        <a:t>2.20.0</a:t>
+                        <a:t>2.21.0</a:t>
                       </a:r>
                     </a:p>
                   </a:txBody>
@@ -9278,7 +9278,7 @@
                           </a:solidFill>
                           <a:latin typeface="Segoe UI"/>
                         </a:rPr>
-                        <a:t>Come over</a:t>
+                        <a:t>Every animal has a voice</a:t>
                       </a:r>
                     </a:p>
                     <a:p>
@@ -9289,7 +9289,7 @@
                           </a:solidFill>
                           <a:latin typeface="Segoe UI"/>
                         </a:rPr>
-                        <a:t>When a friend's pet comes over it now wears a name tag: your friend's name (or the nickname you gave them), ♂/♀ and an online dot. It walks up to your pet, says hi, and looks at your mouse when you point at it.; Point at the visitor (or click its name tag) to open its card: whose pet it is, level, how close you two are, and buttons to wave, pet it, give it a snack, visit back or chat. It reacts to everything - hearts, crumbs, happy faces - and your friend sees it too.; Rub your mouse over the visitor to pet it. Playing with it makes it stay longer, and your pet comes down from a window or the sky to meet it.</a:t>
+                        <a:t>All 51 animals now have their own sound. Before, more than half of them borrowed the cat's meow - now the dog woofs, the cow moos, the sheep baas, the lion roars, the duck quacks, the dolphin clicks and whistles, the dragon flaps and roars with a puff of fire, the ghost goes wooo... and so on.; Every mood sounds different too: happy, sad, sleepy, hungry or grumpy. Petting, eating and snoring sound right for each kind of animal - furry ones purr and crunch, birds trill and peck, sea animals blow bubbles, bugs hum and magic pets chime.; A friend's pet that comes to visit now talks in its own voice: it says hi when it arrives and answers when you wave, pet it or give it a snack (it follows your sound settings).</a:t>
                       </a:r>
                     </a:p>
                   </a:txBody>
@@ -9313,7 +9313,7 @@
                           </a:solidFill>
                           <a:latin typeface="Segoe UI"/>
                         </a:rPr>
-                        <a:t>2.19.0</a:t>
+                        <a:t>2.20.0</a:t>
                       </a:r>
                     </a:p>
                   </a:txBody>
@@ -9357,7 +9357,7 @@
                           </a:solidFill>
                           <a:latin typeface="Segoe UI"/>
                         </a:rPr>
-                        <a:t>Land, sea &amp; sky</a:t>
+                        <a:t>Come over</a:t>
                       </a:r>
                     </a:p>
                     <a:p>
@@ -9368,7 +9368,7 @@
                           </a:solidFill>
                           <a:latin typeface="Segoe UI"/>
                         </a:rPr>
-                        <a:t>Land animals walk on the taskbar and on top of your open windows now: they jump up onto window edges, walk along them, ride along when you move the window and hop down when it closes, gets covered or is maximised. They always have gravity - let go of one in mid-air and it lands on the window below or on the taskbar.; Water animals swim along the taskbar (their water) and every now and then leap high out of it in a big arc, diving back in with a splash, ripples and spray. Drop one anywhere and it dives back into the water.; Flying animals fly anywhere on the screen: they flutter from place to place, hover, come say hi near your mouse, and sometimes perch on the taskbar or a window edge for a rest. Point at one and it waits for you; they glide down to a perch before a nap.; New menu moves: Jump onto a window, Splash jump!, Fly around / Rest on the taskbar. "Move around by myself" in Pet settings keeps your pet still if you prefer (the old Gravity option is gone - land animals always fall now).</a:t>
+                        <a:t>When a friend's pet comes over it now wears a name tag: your friend's name (or the nickname you gave them), ♂/♀ and an online dot. It walks up to your pet, says hi, and looks at your mouse when you point at it.; Point at the visitor (or click its name tag) to open its card: whose pet it is, level, how close you two are, and buttons to wave, pet it, give it a snack, visit back or chat. It reacts to everything - hearts, crumbs, happy faces - and your friend sees it too.; Rub your mouse over the visitor to pet it. Playing with it makes it stay longer, and your pet comes down from a window or the sky to meet it.</a:t>
                       </a:r>
                     </a:p>
                   </a:txBody>
@@ -9392,7 +9392,7 @@
                           </a:solidFill>
                           <a:latin typeface="Segoe UI"/>
                         </a:rPr>
-                        <a:t>2.18.0</a:t>
+                        <a:t>2.19.0</a:t>
                       </a:r>
                     </a:p>
                   </a:txBody>
@@ -9436,7 +9436,7 @@
                           </a:solidFill>
                           <a:latin typeface="Segoe UI"/>
                         </a:rPr>
-                        <a:t>Raise your pet</a:t>
+                        <a:t>Land, sea &amp; sky</a:t>
                       </a:r>
                     </a:p>
                     <a:p>
@@ -9447,7 +9447,7 @@
                           </a:solidFill>
                           <a:latin typeface="Segoe UI"/>
                         </a:rPr>
-                        <a:t>Boy or girl? Pick your pet's gender in Settings: boys get a little hair tuft, girls a pink bow and eyelashes, and a ♂ / ♀ shows next to its name. You can add your own gender to your profile too - friends see a small ♂ / ♀ next to your name.; Pets grow up now: baby → child → teen → grown-up. Focus sessions, opening Pips each day, games and cuddles help them grow - no care mistakes, no bad endings. Already have a grown-up pet? It will ask whether you'd like to raise it again from a baby (coins, items and stats stay).; Sick days: work 2.5 hours without a 5-minute break and your pet catches a little cold (sneezes, thermometer, slow steps). A short break cures it - or give medicine from the menu. You can turn this off in Settings.; New mini-game Left or Right? (pet menu → Play): guess which way your pet will look - 3 out of 5 wins, with coins for your first wins each day.</a:t>
+                        <a:t>Land animals walk on the taskbar and on top of your open windows now: they jump up onto window edges, walk along them, ride along when you move the window and hop down when it closes, gets covered or is maximised. They always have gravity - let go of one in mid-air and it lands on the window below or on the taskbar.; Water animals swim along the taskbar (their water) and every now and then leap high out of it in a big arc, diving back in with a splash, ripples and spray. Drop one anywhere and it dives back into the water.; Flying animals fly anywhere on the screen: they flutter from place to place, hover, come say hi near your mouse, and sometimes perch on the taskbar or a window edge for a rest. Point at one and it waits for you; they glide down to a perch before a nap.; New menu moves: Jump onto a window, Splash jump!, Fly around / Rest on the taskbar. "Move around by myself" in Pet settings keeps your pet still if you prefer (the old Gravity option is gone - land animals always fall now).</a:t>
                       </a:r>
                     </a:p>
                   </a:txBody>
@@ -9471,7 +9471,7 @@
                           </a:solidFill>
                           <a:latin typeface="Segoe UI"/>
                         </a:rPr>
-                        <a:t>2.17.0</a:t>
+                        <a:t>2.18.0</a:t>
                       </a:r>
                     </a:p>
                   </a:txBody>
@@ -9515,7 +9515,7 @@
                           </a:solidFill>
                           <a:latin typeface="Segoe UI"/>
                         </a:rPr>
-                        <a:t>Find your pet anytime</a:t>
+                        <a:t>Raise your pet</a:t>
                       </a:r>
                     </a:p>
                     <a:p>
@@ -9526,7 +9526,7 @@
                           </a:solidFill>
                           <a:latin typeface="Segoe UI"/>
                         </a:rPr>
-                        <a:t>Pips now has an icon next to the clock: click it to bring your pet back; right-click for the focus timer, Friends &amp; chat or Quit.; Press Ctrl+Alt+P anywhere to call your pet - it pops up on the screen you're using, even if it was hidden, asleep or behind a fullscreen app.; Opening Pips again from the Start menu or desktop does the same, and your pet walks back by itself if it ever ends up off-screen (e.g. after unplugging a monitor).; Hiding your pet now tells you how to bring it back.</a:t>
+                        <a:t>Boy or girl? Pick your pet's gender in Settings: boys get a little hair tuft, girls a pink bow and eyelashes, and a ♂ / ♀ shows next to its name. You can add your own gender to your profile too - friends see a small ♂ / ♀ next to your name.; Pets grow up now: baby → child → teen → grown-up. Focus sessions, opening Pips each day, games and cuddles help them grow - no care mistakes, no bad endings. Already have a grown-up pet? It will ask whether you'd like to raise it again from a baby (coins, items and stats stay).; Sick days: work 2.5 hours without a 5-minute break and your pet catches a little cold (sneezes, thermometer, slow steps). A short break cures it - or give medicine from the menu. You can turn this off in Settings.; New mini-game Left or Right? (pet menu → Play): guess which way your pet will look - 3 out of 5 wins, with coins for your first wins each day.</a:t>
                       </a:r>
                     </a:p>
                   </a:txBody>
@@ -9550,7 +9550,7 @@
                           </a:solidFill>
                           <a:latin typeface="Segoe UI"/>
                         </a:rPr>
-                        <a:t>2.16.0</a:t>
+                        <a:t>2.17.0</a:t>
                       </a:r>
                     </a:p>
                   </a:txBody>
@@ -9594,7 +9594,7 @@
                           </a:solidFill>
                           <a:latin typeface="Segoe UI"/>
                         </a:rPr>
-                        <a:t>Pips Community</a:t>
+                        <a:t>Find your pet anytime</a:t>
                       </a:r>
                     </a:p>
                     <a:p>
@@ -9605,7 +9605,7 @@
                           </a:solidFill>
                           <a:latin typeface="Segoe UI"/>
                         </a:rPr>
-                        <a:t>New Pips Community at the top of the Chat tab: a #general channel to chat with everyone who uses Pips, plus #announcements with news from the Pips team.; Every new Pips version is announced there automatically - see what's new and update with one click.; Type @name to ping someone in #general. Mute #general any time; owner and moderators can remove messages.; Open it from your pet's menu too (Pips Community). Fixed: chats no longer clear what you're typing when Pips refreshes in the background.</a:t>
+                        <a:t>Pips now has an icon next to the clock: click it to bring your pet back; right-click for the focus timer, Friends &amp; chat or Quit.; Press Ctrl+Alt+P anywhere to call your pet - it pops up on the screen you're using, even if it was hidden, asleep or behind a fullscreen app.; Opening Pips again from the Start menu or desktop does the same, and your pet walks back by itself if it ever ends up off-screen (e.g. after unplugging a monitor).; Hiding your pet now tells you how to bring it back.</a:t>
                       </a:r>
                     </a:p>
                   </a:txBody>
@@ -9629,7 +9629,7 @@
                           </a:solidFill>
                           <a:latin typeface="Segoe UI"/>
                         </a:rPr>
-                        <a:t>2.15.0</a:t>
+                        <a:t>2.16.0</a:t>
                       </a:r>
                     </a:p>
                   </a:txBody>
@@ -9673,7 +9673,7 @@
                           </a:solidFill>
                           <a:latin typeface="Segoe UI"/>
                         </a:rPr>
-                        <a:t>Update reminders</a:t>
+                        <a:t>Pips Community</a:t>
                       </a:r>
                     </a:p>
                     <a:p>
@@ -9684,7 +9684,7 @@
                           </a:solidFill>
                           <a:latin typeface="Segoe UI"/>
                         </a:rPr>
-                        <a:t>Owner &amp; moderators: the Mod tab now lists who hasn't updated Pips yet (their version and when they were last seen), with one-click reminders by e-mail (sent from your Outlook) or a ready-to-send Teams chat.; New Work e-mail field in your Profile, filled in from Outlook. Only the owner and moderators can see it (for update reminders and support) - clear it to hide it.; Pips now tells the Friends server which version it runs, so the update list is always accurate.; Friends keeps working when a local proxy tool stops answering - Pips falls back to the Windows proxy settings.</a:t>
+                        <a:t>New Pips Community at the top of the Chat tab: a #general channel to chat with everyone who uses Pips, plus #announcements with news from the Pips team.; Every new Pips version is announced there automatically - see what's new and update with one click.; Type @name to ping someone in #general. Mute #general any time; owner and moderators can remove messages.; Open it from your pet's menu too (Pips Community). Fixed: chats no longer clear what you're typing when Pips refreshes in the background.</a:t>
                       </a:r>
                     </a:p>
                   </a:txBody>
@@ -9708,7 +9708,7 @@
                           </a:solidFill>
                           <a:latin typeface="Segoe UI"/>
                         </a:rPr>
-                        <a:t>2.14.3</a:t>
+                        <a:t>2.15.0</a:t>
                       </a:r>
                     </a:p>
                   </a:txBody>
@@ -9752,7 +9752,7 @@
                           </a:solidFill>
                           <a:latin typeface="Segoe UI"/>
                         </a:rPr>
-                        <a:t>Tidy menus</a:t>
+                        <a:t>Update reminders</a:t>
                       </a:r>
                     </a:p>
                     <a:p>
@@ -9763,7 +9763,7 @@
                           </a:solidFill>
                           <a:latin typeface="Segoe UI"/>
                         </a:rPr>
-                        <a:t>Fixed: a submenu (e.g. Poke a friend) could stay floating on the screen after the right-click menu closed.; Menus now close by themselves when you move the mouse away and leave them for a few seconds.</a:t>
+                        <a:t>Owner &amp; moderators: the Mod tab now lists who hasn't updated Pips yet (their version and when they were last seen), with one-click reminders by e-mail (sent from your Outlook) or a ready-to-send Teams chat.; New Work e-mail field in your Profile, filled in from Outlook. Only the owner and moderators can see it (for update reminders and support) - clear it to hide it.; Pips now tells the Friends server which version it runs, so the update list is always accurate.; Friends keeps working when a local proxy tool stops answering - Pips falls back to the Windows proxy settings.</a:t>
                       </a:r>
                     </a:p>
                   </a:txBody>
@@ -9787,7 +9787,7 @@
                           </a:solidFill>
                           <a:latin typeface="Segoe UI"/>
                         </a:rPr>
-                        <a:t>2.14.2</a:t>
+                        <a:t>2.14.3</a:t>
                       </a:r>
                     </a:p>
                   </a:txBody>
@@ -9831,7 +9831,7 @@
                           </a:solidFill>
                           <a:latin typeface="Segoe UI"/>
                         </a:rPr>
-                        <a:t>Never miss an update</a:t>
+                        <a:t>Tidy menus</a:t>
                       </a:r>
                     </a:p>
                     <a:p>
@@ -9842,7 +9842,7 @@
                           </a:solidFill>
                           <a:latin typeface="Segoe UI"/>
                         </a:rPr>
-                        <a:t>Your pet now reminds you every 2 hours while a new version is waiting (instead of every 6 hours).; If the reminder can't show (fullscreen app, guided tour, another message), your pet tries again a few minutes later.; No internet when Pips starts (e.g. VPN off)? It checks again after an hour.</a:t>
+                        <a:t>Fixed: a submenu (e.g. Poke a friend) could stay floating on the screen after the right-click menu closed.; Menus now close by themselves when you move the mouse away and leave them for a few seconds.</a:t>
                       </a:r>
                     </a:p>
                   </a:txBody>
@@ -9866,7 +9866,7 @@
                           </a:solidFill>
                           <a:latin typeface="Segoe UI"/>
                         </a:rPr>
-                        <a:t>2.14.1</a:t>
+                        <a:t>2.14.2</a:t>
                       </a:r>
                     </a:p>
                   </a:txBody>
@@ -9910,7 +9910,7 @@
                           </a:solidFill>
                           <a:latin typeface="Segoe UI"/>
                         </a:rPr>
-                        <a:t>One pet at a time</a:t>
+                        <a:t>Never miss an update</a:t>
                       </a:r>
                     </a:p>
                     <a:p>
@@ -9921,7 +9921,7 @@
                           </a:solidFill>
                           <a:latin typeface="Segoe UI"/>
                         </a:rPr>
-                        <a:t>Opening Pips again (Desktop / Start Menu shortcut, autostart) no longer starts a second pet - your pet just pops up and says hi.; Fixes lag caused by two copies of Pips running at once.</a:t>
+                        <a:t>Your pet now reminds you every 2 hours while a new version is waiting (instead of every 6 hours).; If the reminder can't show (fullscreen app, guided tour, another message), your pet tries again a few minutes later.; No internet when Pips starts (e.g. VPN off)? It checks again after an hour.</a:t>
                       </a:r>
                     </a:p>
                   </a:txBody>
@@ -9945,7 +9945,7 @@
                           </a:solidFill>
                           <a:latin typeface="Segoe UI"/>
                         </a:rPr>
-                        <a:t>2.14.0</a:t>
+                        <a:t>2.14.1</a:t>
                       </a:r>
                     </a:p>
                   </a:txBody>
@@ -9989,7 +9989,7 @@
                           </a:solidFill>
                           <a:latin typeface="Segoe UI"/>
                         </a:rPr>
-                        <a:t>Pokes, tickles &amp; teases</a:t>
+                        <a:t>One pet at a time</a:t>
                       </a:r>
                     </a:p>
                     <a:p>
@@ -10000,7 +10000,7 @@
                           </a:solidFill>
                           <a:latin typeface="Segoe UI"/>
                         </a:rPr>
-                        <a:t>Poke, tickle, tease, boop or hug a friend from afar - no pet visit needed.; Right-click your pet → Poke a friend, or use the Poke button in Friends, chat and profiles.; Your friend gets a pop-up ("Wendy is teasing you!"), their pet reacts, and they can poke back with one click.; During a focus session pokes wait quietly until your break; when your pet is hidden they show in the screen corner.</a:t>
+                        <a:t>Opening Pips again (Desktop / Start Menu shortcut, autostart) no longer starts a second pet - your pet just pops up and says hi.; Fixes lag caused by two copies of Pips running at once.</a:t>
                       </a:r>
                     </a:p>
                   </a:txBody>
@@ -10024,7 +10024,7 @@
                           </a:solidFill>
                           <a:latin typeface="Segoe UI"/>
                         </a:rPr>
-                        <a:t>2.13.1</a:t>
+                        <a:t>2.14.0</a:t>
                       </a:r>
                     </a:p>
                   </a:txBody>
@@ -10046,7 +10046,7 @@
                           </a:solidFill>
                           <a:latin typeface="Segoe UI"/>
                         </a:rPr>
-                        <a:t>2026-10-28</a:t>
+                        <a:t>2026-10-29</a:t>
                       </a:r>
                     </a:p>
                   </a:txBody>
@@ -10068,7 +10068,7 @@
                           </a:solidFill>
                           <a:latin typeface="Segoe UI"/>
                         </a:rPr>
-                        <a:t>One-click Windows installer</a:t>
+                        <a:t>Pokes, tickles &amp; teases</a:t>
                       </a:r>
                     </a:p>
                     <a:p>
@@ -10079,7 +10079,7 @@
                           </a:solidFill>
                           <a:latin typeface="Segoe UI"/>
                         </a:rPr>
-                        <a:t>One Windows installer: no ZIP extraction, Python installation or command line. Download, open and click Install Pips.; Installs for your Windows account without administrator access, adds Desktop and Start Menu shortcuts, and opens Pips automatically.; Reinstalling in the same location keeps your settings and pet progress. Existing ZIP users can keep updating in place from Help → Check for updates.; A simpler download page and updated user guide; the bundled runtime stays separate from small in-app updates.</a:t>
+                        <a:t>Poke, tickle, tease, boop or hug a friend from afar - no pet visit needed.; Right-click your pet → Poke a friend, or use the Poke button in Friends, chat and profiles.; Your friend gets a pop-up ("Wendy is teasing you!"), their pet reacts, and they can poke back with one click.; During a focus session pokes wait quietly until your break; when your pet is hidden they show in the screen corner.</a:t>
                       </a:r>
                     </a:p>
                   </a:txBody>
@@ -10103,7 +10103,7 @@
                           </a:solidFill>
                           <a:latin typeface="Segoe UI"/>
                         </a:rPr>
-                        <a:t>2.13.0</a:t>
+                        <a:t>2.13.1</a:t>
                       </a:r>
                     </a:p>
                   </a:txBody>
@@ -10147,7 +10147,7 @@
                           </a:solidFill>
                           <a:latin typeface="Segoe UI"/>
                         </a:rPr>
-                        <a:t>Birthdays, parties &amp; gifts</a:t>
+                        <a:t>One-click Windows installer</a:t>
                       </a:r>
                     </a:p>
                     <a:p>
@@ -10158,7 +10158,7 @@
                           </a:solidFill>
                           <a:latin typeface="Segoe UI"/>
                         </a:rPr>
-                        <a:t>Set your birthday in Social → Profile (month + day, optionally visible to friends).; On your birthday Pips throws confetti and gives you 100 bonus coins.; Friends tab shows upcoming birthdays; you get reminders 3 days, 1 day and on the day.; Birthday parties: join a friend's party, see who's there, sign the guestbook and celebrate together.</a:t>
+                        <a:t>One Windows installer: no ZIP extraction, Python installation or command line. Download, open and click Install Pips.; Installs for your Windows account without administrator access, adds Desktop and Start Menu shortcuts, and opens Pips automatically.; Reinstalling in the same location keeps your settings and pet progress. Existing ZIP users can keep updating in place from Help → Check for updates.; A simpler download page and updated user guide; the bundled runtime stays separate from small in-app updates.</a:t>
                       </a:r>
                     </a:p>
                   </a:txBody>
@@ -10182,7 +10182,7 @@
                           </a:solidFill>
                           <a:latin typeface="Segoe UI"/>
                         </a:rPr>
-                        <a:t>2.12.0</a:t>
+                        <a:t>2.13.0</a:t>
                       </a:r>
                     </a:p>
                   </a:txBody>
@@ -10226,7 +10226,7 @@
                           </a:solidFill>
                           <a:latin typeface="Segoe UI"/>
                         </a:rPr>
-                        <a:t>Mega update: 28 new animals, 31 shop items, 13 moves</a:t>
+                        <a:t>Birthdays, parties &amp; gifts</a:t>
                       </a:r>
                     </a:p>
                     <a:p>
@@ -10237,7 +10237,7 @@
                           </a:solidFill>
                           <a:latin typeface="Segoe UI"/>
                         </a:rPr>
-                        <a:t>🦁 28 new animals (51 total): lion, tiger, unicorn, deer, sheep, cow, raccoon, red panda, monkey, hedgehog, dino, squirrel, mouse, koala, shark, dolphin, seal, otter, pufferfish, duck, crab, parrot, chick, ladybug, phoenix, pegasus, ghost and flamingo; 🎩 31 new shop items: top hat, cowboy, chef, pirate, Santa, viking, graduation cap, beret, bow, propeller cap, flower crown, nerd glasses, eyepatch, mustache, goggles, masquerade mask, tie, pearls, flower lei, gold chain, balloon, backpack, guitar, shield, butterfly / devil wings and more - plus Premium galaxy crown, galaxy cape and dragon wings; 💃 13 new moves: wave, jump, hearts, sing, yoga, zoomies, cartwheel, juggle, rain dance, breakdance, magic, confetti and the Premium rocket launch; The Shop is now split into sections (Hats, Face, Neck, Back, Moves, Arena gear) with an owned counter for each</a:t>
+                        <a:t>Set your birthday in Social → Profile (month + day, optionally visible to friends).; On your birthday Pips throws confetti and gives you 100 bonus coins.; Friends tab shows upcoming birthdays; you get reminders 3 days, 1 day and on the day.; Birthday parties: join a friend's party, see who's there, sign the guestbook and celebrate together.</a:t>
                       </a:r>
                     </a:p>
                   </a:txBody>
@@ -10261,7 +10261,7 @@
                           </a:solidFill>
                           <a:latin typeface="Segoe UI"/>
                         </a:rPr>
-                        <a:t>2.11.0</a:t>
+                        <a:t>2.12.0</a:t>
                       </a:r>
                     </a:p>
                   </a:txBody>
@@ -10305,7 +10305,7 @@
                           </a:solidFill>
                           <a:latin typeface="Segoe UI"/>
                         </a:rPr>
-                        <a:t>New right-click menus</a:t>
+                        <a:t>Mega update: 28 new animals, 31 shop items, 13 moves</a:t>
                       </a:r>
                     </a:p>
                     <a:p>
@@ -10316,7 +10316,7 @@
                           </a:solidFill>
                           <a:latin typeface="Segoe UI"/>
                         </a:rPr>
-                        <a:t>✨ Brand-new animated right-click menu for your pet: mood &amp; stat bars, quick-action tiles (Friends, Shop, Snack, Pat, Focus, Stats, Sleep, Taskbar), hover effects and smooth fly-out submenus; Pick colours from swatches, switch size with one click and flip Sounds / Dark mode with toggle switches - changes show instantly; Updates are highlighted: a glowing banner and NEW badge appear in the menu when a new version is ready; The focus card's right-click menu got the same new look; keyboard arrows, Enter and Esc work too</a:t>
+                        <a:t>🦁 28 new animals (51 total): lion, tiger, unicorn, deer, sheep, cow, raccoon, red panda, monkey, hedgehog, dino, squirrel, mouse, koala, shark, dolphin, seal, otter, pufferfish, duck, crab, parrot, chick, ladybug, phoenix, pegasus, ghost and flamingo; 🎩 31 new shop items: top hat, cowboy, chef, pirate, Santa, viking, graduation cap, beret, bow, propeller cap, flower crown, nerd glasses, eyepatch, mustache, goggles, masquerade mask, tie, pearls, flower lei, gold chain, balloon, backpack, guitar, shield, butterfly / devil wings and more - plus Premium galaxy crown, galaxy cape and dragon wings; 💃 13 new moves: wave, jump, hearts, sing, yoga, zoomies, cartwheel, juggle, rain dance, breakdance, magic, confetti and the Premium rocket launch; The Shop is now split into sections (Hats, Face, Neck, Back, Moves, Arena gear) with an owned counter for each</a:t>
                       </a:r>
                     </a:p>
                   </a:txBody>
@@ -10340,7 +10340,7 @@
                           </a:solidFill>
                           <a:latin typeface="Segoe UI"/>
                         </a:rPr>
-                        <a:t>2.10.0</a:t>
+                        <a:t>2.11.0</a:t>
                       </a:r>
                     </a:p>
                   </a:txBody>
@@ -10384,7 +10384,7 @@
                           </a:solidFill>
                           <a:latin typeface="Segoe UI"/>
                         </a:rPr>
-                        <a:t>Chat bots</a:t>
+                        <a:t>New right-click menus</a:t>
                       </a:r>
                     </a:p>
                     <a:p>
@@ -10395,7 +10395,7 @@
                           </a:solidFill>
                           <a:latin typeface="Segoe UI"/>
                         </a:rPr>
-                        <a:t>🤖 6 friendly chat bots in the Chat tab: Pip Helper (app questions), Coach Focus (focus tips from your real stats), Sunny (live weather for any city), Arena Master (battle tips + quick battle), Giggles (jokes &amp; games) and Guardian (safety &amp; reporting help); Private bot chats with suggestion chips, typing indicator and a clear button - your bot chats stay on your PC; Mention a bot in a group chat (e.g. @weather Batam) and it answers in the room for everyone; Bots reply in your app language; up to 120 bot messages per day</a:t>
+                        <a:t>✨ Brand-new animated right-click menu for your pet: mood &amp; stat bars, quick-action tiles (Friends, Shop, Snack, Pat, Focus, Stats, Sleep, Taskbar), hover effects and smooth fly-out submenus; Pick colours from swatches, switch size with one click and flip Sounds / Dark mode with toggle switches - changes show instantly; Updates are highlighted: a glowing banner and NEW badge appear in the menu when a new version is ready; The focus card's right-click menu got the same new look; keyboard arrows, Enter and Esc work too</a:t>
                       </a:r>
                     </a:p>
                   </a:txBody>
@@ -10419,7 +10419,7 @@
                           </a:solidFill>
                           <a:latin typeface="Segoe UI"/>
                         </a:rPr>
-                        <a:t>2.9.0</a:t>
+                        <a:t>2.10.0</a:t>
                       </a:r>
                     </a:p>
                   </a:txBody>
@@ -10463,7 +10463,7 @@
                           </a:solidFill>
                           <a:latin typeface="Segoe UI"/>
                         </a:rPr>
-                        <a:t>Location &amp; live weather</a:t>
+                        <a:t>Chat bots</a:t>
                       </a:r>
                     </a:p>
                     <a:p>
@@ -10474,7 +10474,7 @@
                           </a:solidFill>
                           <a:latin typeface="Segoe UI"/>
                         </a:rPr>
-                        <a:t>📍 Add your city in Profile → Location &amp; weather (auto-detect or search) - only your city and country are shown, never your exact position; Live weather banners on every profile with animations: rain, drizzle, thunderstorms with lightning, snow, fog, clouds, sunshine or a starry night - plus temperature, feels-like, humidity, wind and local time; Your own weather strip on top of the hub, and each friend's weather + local time in the friends list; Hide your location from others or remove it any time</a:t>
+                        <a:t>🤖 6 friendly chat bots in the Chat tab: Pip Helper (app questions), Coach Focus (focus tips from your real stats), Sunny (live weather for any city), Arena Master (battle tips + quick battle), Giggles (jokes &amp; games) and Guardian (safety &amp; reporting help); Private bot chats with suggestion chips, typing indicator and a clear button - your bot chats stay on your PC; Mention a bot in a group chat (e.g. @weather Batam) and it answers in the room for everyone; Bots reply in your app language; up to 120 bot messages per day</a:t>
                       </a:r>
                     </a:p>
                   </a:txBody>
@@ -10498,7 +10498,7 @@
                           </a:solidFill>
                           <a:latin typeface="Segoe UI"/>
                         </a:rPr>
-                        <a:t>2.8.0</a:t>
+                        <a:t>2.9.0</a:t>
                       </a:r>
                     </a:p>
                   </a:txBody>
@@ -10542,7 +10542,7 @@
                           </a:solidFill>
                           <a:latin typeface="Segoe UI"/>
                         </a:rPr>
-                        <a:t>Pips Arena - duels, gear &amp; live battles</a:t>
+                        <a:t>Location &amp; live weather</a:t>
                       </a:r>
                     </a:p>
                     <a:p>
@@ -10553,7 +10553,7 @@
                           </a:solidFill>
                           <a:latin typeface="Segoe UI"/>
                         </a:rPr>
-                        <a:t>⚔ New Arena tab: challenge friends or anyone in the arena to a live duel - each round pick Attack, Guard or Special within 12 seconds and watch your pets fight; ⚡ Quick battle: an instant auto-fight against anyone's fighter, even when they're offline; Arena gear in the Shop: 7 weapons (water pistol to rocket launcher), 5 armors and 5 gadgets that decide your special move - better gear and a higher level make a stronger fighter; Live duels can be watched by everyone, plus recent battle replays, top fighters, rating and win/loss records; wins earn coins</a:t>
+                        <a:t>📍 Add your city in Profile → Location &amp; weather (auto-detect or search) - only your city and country are shown, never your exact position; Live weather banners on every profile with animations: rain, drizzle, thunderstorms with lightning, snow, fog, clouds, sunshine or a starry night - plus temperature, feels-like, humidity, wind and local time; Your own weather strip on top of the hub, and each friend's weather + local time in the friends list; Hide your location from others or remove it any time</a:t>
                       </a:r>
                     </a:p>
                   </a:txBody>
@@ -10577,7 +10577,7 @@
                           </a:solidFill>
                           <a:latin typeface="Segoe UI"/>
                         </a:rPr>
-                        <a:t>2.7.0</a:t>
+                        <a:t>2.8.0</a:t>
                       </a:r>
                     </a:p>
                   </a:txBody>
@@ -10621,7 +10621,7 @@
                           </a:solidFill>
                           <a:latin typeface="Segoe UI"/>
                         </a:rPr>
-                        <a:t>Moderators &amp; Premium</a:t>
+                        <a:t>Pips Arena - duels, gear &amp; live battles</a:t>
                       </a:r>
                     </a:p>
                     <a:p>
@@ -10632,7 +10632,7 @@
                           </a:solidFill>
                           <a:latin typeface="Segoe UI"/>
                         </a:rPr>
-                        <a:t>★ Premium: a purple Premium badge, 4 exclusive props (tiara, star glasses, diamond necklace, fairy wings), the Fireworks move, +30 coins every day, double friend-interaction coins and room for 300 friends / 30 groups; Get Premium: Profile tab → Premium → "Ask to buy" emails the owner; after payment you receive a key (PIPS-XXXX-XXXX) to redeem right there; 🛡 Moderators: a blue Mod badge and a Mod tab with the report queue - warn, mute (1h / 24h / 7 days), clear a profile or reset a name; every action is logged; Report button on everyone's profile, so moderators can keep Pips friendly</a:t>
+                        <a:t>⚔ New Arena tab: challenge friends or anyone in the arena to a live duel - each round pick Attack, Guard or Special within 12 seconds and watch your pets fight; ⚡ Quick battle: an instant auto-fight against anyone's fighter, even when they're offline; Arena gear in the Shop: 7 weapons (water pistol to rocket launcher), 5 armors and 5 gadgets that decide your special move - better gear and a higher level make a stronger fighter; Live duels can be watched by everyone, plus recent battle replays, top fighters, rating and win/loss records; wins earn coins</a:t>
                       </a:r>
                     </a:p>
                   </a:txBody>
@@ -10656,7 +10656,7 @@
                           </a:solidFill>
                           <a:latin typeface="Segoe UI"/>
                         </a:rPr>
-                        <a:t>2.6.1</a:t>
+                        <a:t>2.7.0</a:t>
                       </a:r>
                     </a:p>
                   </a:txBody>
@@ -10700,7 +10700,7 @@
                           </a:solidFill>
                           <a:latin typeface="Segoe UI"/>
                         </a:rPr>
-                        <a:t>Owner badge &amp; credits</a:t>
+                        <a:t>Moderators &amp; Premium</a:t>
                       </a:r>
                     </a:p>
                     <a:p>
@@ -10711,7 +10711,7 @@
                           </a:solidFill>
                           <a:latin typeface="Segoe UI"/>
                         </a:rPr>
-                        <a:t>The creator of Pips (Juwen Lie) now shows a gold ♛ Owner badge on his profile, friend list and ranks; New About Pips card in the Profile tab: credits and how to contact the owner (Juwen_Lie@pegatroncorp.com) with Email and Copy buttons; Right-click the pet → Help → About now shows who made Pips and the contact email</a:t>
+                        <a:t>★ Premium: a purple Premium badge, 4 exclusive props (tiara, star glasses, diamond necklace, fairy wings), the Fireworks move, +30 coins every day, double friend-interaction coins and room for 300 friends / 30 groups; Get Premium: Profile tab → Premium → "Ask to buy" emails the owner; after payment you receive a key (PIPS-XXXX-XXXX) to redeem right there; 🛡 Moderators: a blue Mod badge and a Mod tab with the report queue - warn, mute (1h / 24h / 7 days), clear a profile or reset a name; every action is logged; Report button on everyone's profile, so moderators can keep Pips friendly</a:t>
                       </a:r>
                     </a:p>
                   </a:txBody>
@@ -10735,7 +10735,7 @@
                           </a:solidFill>
                           <a:latin typeface="Segoe UI"/>
                         </a:rPr>
-                        <a:t>2.6.0</a:t>
+                        <a:t>2.6.1</a:t>
                       </a:r>
                     </a:p>
                   </a:txBody>
@@ -10779,7 +10779,7 @@
                           </a:solidFill>
                           <a:latin typeface="Segoe UI"/>
                         </a:rPr>
-                        <a:t>Profiles, ranks, online status &amp; dark mode</a:t>
+                        <a:t>Owner badge &amp; credits</a:t>
                       </a:r>
                     </a:p>
                     <a:p>
@@ -10790,7 +10790,7 @@
                           </a:solidFill>
                           <a:latin typeface="Segoe UI"/>
                         </a:rPr>
-                        <a:t>Profile tab: profile picture (or your pet), about me, job, location, hobbies, birthday and a status message; Public or private: public profiles can be added directly and viewed in full; private profiles need a friend request that they accept, and strangers only see name, photo, pet, level and status; Click anyone to open their profile - badges, info, their friends - and add them, chat or wave from there; Ranks tab replaces Teams: everyone using Pips, sorted by XP, badges or streak</a:t>
+                        <a:t>The creator of Pips (Juwen Lie) now shows a gold ♛ Owner badge on his profile, friend list and ranks; New About Pips card in the Profile tab: credits and how to contact the owner (Juwen_Lie@pegatroncorp.com) with Email and Copy buttons; Right-click the pet → Help → About now shows who made Pips and the contact email</a:t>
                       </a:r>
                     </a:p>
                   </a:txBody>
@@ -10814,7 +10814,7 @@
                           </a:solidFill>
                           <a:latin typeface="Segoe UI"/>
                         </a:rPr>
-                        <a:t>2.5.1</a:t>
+                        <a:t>2.6.0</a:t>
                       </a:r>
                     </a:p>
                   </a:txBody>
@@ -10858,7 +10858,7 @@
                           </a:solidFill>
                           <a:latin typeface="Segoe UI"/>
                         </a:rPr>
-                        <a:t>New cute Pips logo</a:t>
+                        <a:t>Profiles, ranks, online status &amp; dark mode</a:t>
                       </a:r>
                     </a:p>
                     <a:p>
@@ -10869,7 +10869,7 @@
                           </a:solidFill>
                           <a:latin typeface="Segoe UI"/>
                         </a:rPr>
-                        <a:t>New Pips logo: Pip the cat on a Pips-red tile, matching the app colours (desktop shortcut, windows and website)</a:t>
+                        <a:t>Profile tab: profile picture (or your pet), about me, job, location, hobbies, birthday and a status message; Public or private: public profiles can be added directly and viewed in full; private profiles need a friend request that they accept, and strangers only see name, photo, pet, level and status; Click anyone to open their profile - badges, info, their friends - and add them, chat or wave from there; Ranks tab replaces Teams: everyone using Pips, sorted by XP, badges or streak</a:t>
                       </a:r>
                     </a:p>
                   </a:txBody>
@@ -10893,7 +10893,7 @@
                           </a:solidFill>
                           <a:latin typeface="Segoe UI"/>
                         </a:rPr>
-                        <a:t>2.5.0</a:t>
+                        <a:t>2.5.1</a:t>
                       </a:r>
                     </a:p>
                   </a:txBody>
@@ -10937,7 +10937,7 @@
                           </a:solidFill>
                           <a:latin typeface="Segoe UI"/>
                         </a:rPr>
-                        <a:t>Shop, coins, props &amp; moves</a:t>
+                        <a:t>New cute Pips logo</a:t>
                       </a:r>
                     </a:p>
                     <a:p>
@@ -10948,7 +10948,7 @@
                           </a:solidFill>
                           <a:latin typeface="Segoe UI"/>
                         </a:rPr>
-                        <a:t>Shop: earn coins and spend them on your pet - 17 props (crown, wizard hat, headphones, shades, scarf, cape, angel wings...) and 6 moves: spin, dance, moonwalk, backflip, kung fu and spider swing!; Coins come from leveling up (+40), badges (+25), opening Pips each day (+10), friendships (+15 per affinity level), waving / chatting / visiting friends (+2) and pomodoros (+5). Everyone starts with a 100-coin gift; Your friends see your props: on avatars in the hub and when your pet visits their desktop - it shows off one of your moves; Pips is now a social pet: clicking the pet opens the Pips hub (friends, chat, groups, shop, badges)</a:t>
+                        <a:t>New Pips logo: Pip the cat on a Pips-red tile, matching the app colours (desktop shortcut, windows and website)</a:t>
                       </a:r>
                     </a:p>
                   </a:txBody>
@@ -10972,7 +10972,7 @@
                           </a:solidFill>
                           <a:latin typeface="Segoe UI"/>
                         </a:rPr>
-                        <a:t>2.4.0</a:t>
+                        <a:t>2.5.0</a:t>
                       </a:r>
                     </a:p>
                   </a:txBody>
@@ -11016,7 +11016,7 @@
                           </a:solidFill>
                           <a:latin typeface="Segoe UI"/>
                         </a:rPr>
-                        <a:t>Chat, groups, affinity &amp; pet visits</a:t>
+                        <a:t>Shop, coins, props &amp; moves</a:t>
                       </a:r>
                     </a:p>
                     <a:p>
@@ -11027,7 +11027,7 @@
                           </a:solidFill>
                           <a:latin typeface="Segoe UI"/>
                         </a:rPr>
-                        <a:t>Chat: message your friends, and chat inside groups. Your pet pops up new messages as a bubble - click it to reply; Pet interactions: wave, pet their pet, send a snack, high five - or send your pet to visit: it walks onto your friend's desktop for a little while!; Affinity: every chat and interaction grows your friendship - Acquaintance → Buddy → Good friends → Close friends → Best friends → Soulmates; Your own groups: create a private group, invite your friends, they accept or decline. Group board + group chat; the owner can remove members</a:t>
+                        <a:t>Shop: earn coins and spend them on your pet - 17 props (crown, wizard hat, headphones, shades, scarf, cape, angel wings...) and 6 moves: spin, dance, moonwalk, backflip, kung fu and spider swing!; Coins come from leveling up (+40), badges (+25), opening Pips each day (+10), friendships (+15 per affinity level), waving / chatting / visiting friends (+2) and pomodoros (+5). Everyone starts with a 100-coin gift; Your friends see your props: on avatars in the hub and when your pet visits their desktop - it shows off one of your moves; Pips is now a social pet: clicking the pet opens the Pips hub (friends, chat, groups, shop, badges)</a:t>
                       </a:r>
                     </a:p>
                   </a:txBody>
@@ -11051,7 +11051,7 @@
                           </a:solidFill>
                           <a:latin typeface="Segoe UI"/>
                         </a:rPr>
-                        <a:t>2.3.0</a:t>
+                        <a:t>2.4.0</a:t>
                       </a:r>
                     </a:p>
                   </a:txBody>
@@ -11095,7 +11095,7 @@
                           </a:solidFill>
                           <a:latin typeface="Segoe UI"/>
                         </a:rPr>
-                        <a:t>Friends, levels &amp; achievements</a:t>
+                        <a:t>Chat, groups, affinity &amp; pet visits</a:t>
                       </a:r>
                     </a:p>
                     <a:p>
@@ -11106,7 +11106,7 @@
                           </a:solidFill>
                           <a:latin typeface="Segoe UI"/>
                         </a:rPr>
-                        <a:t>Levels &amp; XP: every finished pomodoro earns XP and your level grows - plus 20 achievements to unlock (first tomato, 8 in a day, 7-day streak, early bird, night owl, pet lover...). Your pet celebrates each one; Friends (optional, off by default): get a 6-letter friend code, add colleagues, see today's board and join a team board like PTB. Your pet tells you when a friend finishes a pomodoro; Privacy: only your name, pet, level, streak and pomodoro counts are shared - never apps, window titles or scores. One click turns it off and deletes your online data. Right-click the pet → Friends &amp; achievements…</a:t>
+                        <a:t>Chat: message your friends, and chat inside groups. Your pet pops up new messages as a bubble - click it to reply; Pet interactions: wave, pet their pet, send a snack, high five - or send your pet to visit: it walks onto your friend's desktop for a little while!; Affinity: every chat and interaction grows your friendship - Acquaintance → Buddy → Good friends → Close friends → Best friends → Soulmates; Your own groups: create a private group, invite your friends, they accept or decline. Group board + group chat; the owner can remove members</a:t>
                       </a:r>
                     </a:p>
                   </a:txBody>
@@ -11130,7 +11130,7 @@
                           </a:solidFill>
                           <a:latin typeface="Segoe UI"/>
                         </a:rPr>
-                        <a:t>2.2.0</a:t>
+                        <a:t>2.3.0</a:t>
                       </a:r>
                     </a:p>
                   </a:txBody>
@@ -11174,7 +11174,7 @@
                           </a:solidFill>
                           <a:latin typeface="Segoe UI"/>
                         </a:rPr>
-                        <a:t>Pet sounds</a:t>
+                        <a:t>Friends, levels &amp; achievements</a:t>
                       </a:r>
                     </a:p>
                     <a:p>
@@ -11185,7 +11185,7 @@
                           </a:solidFill>
                           <a:latin typeface="Segoe UI"/>
                         </a:rPr>
-                        <a:t>Your pet has a voice! Each of the 23 animals has its own sound (meow, woof, ribbit, hoot, buzz, oink, whale song...) and it changes with its mood: happy chirps, sad whimpers, sleepy yawns, hungry calls, grumpy huffs and soft snores; It also reacts with sound when you tickle, pet, feed, shake or wake it; Settings: right-click the pet → Sounds to switch on/off; Pet status &amp; settings has a volume slider, a ▶ Hear me button and "Stay quiet while I'm focusing" (on by default)</a:t>
+                        <a:t>Levels &amp; XP: every finished pomodoro earns XP and your level grows - plus 20 achievements to unlock (first tomato, 8 in a day, 7-day streak, early bird, night owl, pet lover...). Your pet celebrates each one; Friends (optional, off by default): get a 6-letter friend code, add colleagues, see today's board and join a team board like PTB. Your pet tells you when a friend finishes a pomodoro; Privacy: only your name, pet, level, streak and pomodoro counts are shared - never apps, window titles or scores. One click turns it off and deletes your online data. Right-click the pet → Friends &amp; achievements…</a:t>
                       </a:r>
                     </a:p>
                   </a:txBody>
@@ -11209,7 +11209,7 @@
                           </a:solidFill>
                           <a:latin typeface="Segoe UI"/>
                         </a:rPr>
-                        <a:t>2.1.2</a:t>
+                        <a:t>2.2.0</a:t>
                       </a:r>
                     </a:p>
                   </a:txBody>
@@ -11253,7 +11253,7 @@
                           </a:solidFill>
                           <a:latin typeface="Segoe UI"/>
                         </a:rPr>
-                        <a:t>Tickle-only mode</a:t>
+                        <a:t>Pet sounds</a:t>
                       </a:r>
                     </a:p>
                     <a:p>
@@ -11264,7 +11264,7 @@
                           </a:solidFill>
                           <a:latin typeface="Segoe UI"/>
                         </a:rPr>
-                        <a:t>New click option "Only tickle (never open Pips)": click and tickle your pet as much as you like - the Pomodoro window stays closed (open it from the right-click menu). Right-click the pet → When I click</a:t>
+                        <a:t>Your pet has a voice! Each of the 23 animals has its own sound (meow, woof, ribbit, hoot, buzz, oink, whale song...) and it changes with its mood: happy chirps, sad whimpers, sleepy yawns, hungry calls, grumpy huffs and soft snores; It also reacts with sound when you tickle, pet, feed, shake or wake it; Settings: right-click the pet → Sounds to switch on/off; Pet status &amp; settings has a volume slider, a ▶ Hear me button and "Stay quiet while I'm focusing" (on by default)</a:t>
                       </a:r>
                     </a:p>
                   </a:txBody>
@@ -11288,7 +11288,7 @@
                           </a:solidFill>
                           <a:latin typeface="Segoe UI"/>
                         </a:rPr>
-                        <a:t>2.1.1</a:t>
+                        <a:t>2.1.2</a:t>
                       </a:r>
                     </a:p>
                   </a:txBody>
@@ -11332,7 +11332,7 @@
                           </a:solidFill>
                           <a:latin typeface="Segoe UI"/>
                         </a:rPr>
-                        <a:t>Owner info</a:t>
+                        <a:t>Tickle-only mode</a:t>
                       </a:r>
                     </a:p>
                     <a:p>
@@ -11343,7 +11343,7 @@
                           </a:solidFill>
                           <a:latin typeface="Segoe UI"/>
                         </a:rPr>
-                        <a:t>About Pips now shows the owner: Juwen Lie (right-click the pet → Help → About)</a:t>
+                        <a:t>New click option "Only tickle (never open Pips)": click and tickle your pet as much as you like - the Pomodoro window stays closed (open it from the right-click menu). Right-click the pet → When I click</a:t>
                       </a:r>
                     </a:p>
                   </a:txBody>
@@ -11367,7 +11367,7 @@
                           </a:solidFill>
                           <a:latin typeface="Segoe UI"/>
                         </a:rPr>
-                        <a:t>2.1.0</a:t>
+                        <a:t>2.1.1</a:t>
                       </a:r>
                     </a:p>
                   </a:txBody>
@@ -11411,7 +11411,7 @@
                           </a:solidFill>
                           <a:latin typeface="Segoe UI"/>
                         </a:rPr>
-                        <a:t>Interactive guide &amp; in-app updates</a:t>
+                        <a:t>Owner info</a:t>
                       </a:r>
                     </a:p>
                     <a:p>
@@ -11422,7 +11422,7 @@
                           </a:solidFill>
                           <a:latin typeface="Segoe UI"/>
                         </a:rPr>
-                        <a:t>Interactive first-run guide: your pet walks you through clicking, dragging, petting and the right-click menu; In-app updates: Pips tells you when a new version is out - update with one click (your settings and data are kept); New Help menu: replay the guide, check for updates, see the version; Option to turn automatic update checks off</a:t>
+                        <a:t>About Pips now shows the owner: Juwen Lie (right-click the pet → Help → About)</a:t>
                       </a:r>
                     </a:p>
                   </a:txBody>
@@ -11446,7 +11446,7 @@
                           </a:solidFill>
                           <a:latin typeface="Segoe UI"/>
                         </a:rPr>
-                        <a:t>2.0.0</a:t>
+                        <a:t>2.1.0</a:t>
                       </a:r>
                     </a:p>
                   </a:txBody>
@@ -11490,7 +11490,7 @@
                           </a:solidFill>
                           <a:latin typeface="Segoe UI"/>
                         </a:rPr>
-                        <a:t>Desktop pet, 23 animals &amp; 4 languages</a:t>
+                        <a:t>Interactive guide &amp; in-app updates</a:t>
                       </a:r>
                     </a:p>
                     <a:p>
@@ -11501,7 +11501,7 @@
                           </a:solidFill>
                           <a:latin typeface="Segoe UI"/>
                         </a:rPr>
-                        <a:t>Desktop pet that lives on your desktop and taskbar - drag it, tickle it, pet it; 23 animals in 3 groups: Land walks, Water swims with bubbles, Sky hovers and flaps; Moods (happy, sad, tired, hungry, grumpy...), naps when you're away, wakes up when you're back; Cute chat-bubble reminders: breaks, water, 20-20-20 eye rest, pomodoro done, daily goal</a:t>
+                        <a:t>Interactive first-run guide: your pet walks you through clicking, dragging, petting and the right-click menu; In-app updates: Pips tells you when a new version is out - update with one click (your settings and data are kept); New Help menu: replay the guide, check for updates, see the version; Option to turn automatic update checks off</a:t>
                       </a:r>
                     </a:p>
                   </a:txBody>
@@ -11525,7 +11525,7 @@
                           </a:solidFill>
                           <a:latin typeface="Segoe UI"/>
                         </a:rPr>
-                        <a:t>1.5.0</a:t>
+                        <a:t>2.0.0</a:t>
                       </a:r>
                     </a:p>
                   </a:txBody>
@@ -11547,7 +11547,7 @@
                           </a:solidFill>
                           <a:latin typeface="Segoe UI"/>
                         </a:rPr>
-                        <a:t>2026-10-24</a:t>
+                        <a:t>2026-10-28</a:t>
                       </a:r>
                     </a:p>
                   </a:txBody>
@@ -11569,7 +11569,7 @@
                           </a:solidFill>
                           <a:latin typeface="Segoe UI"/>
                         </a:rPr>
-                        <a:t>Renamed to Pips + insights</a:t>
+                        <a:t>Desktop pet, 23 animals &amp; 4 languages</a:t>
                       </a:r>
                     </a:p>
                     <a:p>
@@ -11580,7 +11580,7 @@
                           </a:solidFill>
                           <a:latin typeface="Segoe UI"/>
                         </a:rPr>
-                        <a:t>Renamed from Productivity Widget to Pips; Dashboard charts: focus timeline, hour heatmap, 7-day score trend, pomodoros per day; AI token usage on the card and dashboard; Daily diary export and weekly / monthly reports</a:t>
+                        <a:t>Desktop pet that lives on your desktop and taskbar - drag it, tickle it, pet it; 23 animals in 3 groups: Land walks, Water swims with bubbles, Sky hovers and flaps; Moods (happy, sad, tired, hungry, grumpy...), naps when you're away, wakes up when you're back; Cute chat-bubble reminders: breaks, water, 20-20-20 eye rest, pomodoro done, daily goal</a:t>
                       </a:r>
                     </a:p>
                   </a:txBody>
@@ -11604,13 +11604,92 @@
                           </a:solidFill>
                           <a:latin typeface="Segoe UI"/>
                         </a:rPr>
+                        <a:t>1.5.0</a:t>
+                      </a:r>
+                    </a:p>
+                  </a:txBody>
+                  <a:tcPr marL="73152" marR="73152" marT="36576" marB="36576">
+                    <a:solidFill>
+                      <a:srgbClr val="F7F4EC"/>
+                    </a:solidFill>
+                  </a:tcPr>
+                </a:tc>
+                <a:tc>
+                  <a:txBody>
+                    <a:bodyPr wrap="square"/>
+                    <a:lstStyle/>
+                    <a:p>
+                      <a:r>
+                        <a:rPr sz="1200" b="0">
+                          <a:solidFill>
+                            <a:srgbClr val="2B2A28"/>
+                          </a:solidFill>
+                          <a:latin typeface="Segoe UI"/>
+                        </a:rPr>
+                        <a:t>2026-10-24</a:t>
+                      </a:r>
+                    </a:p>
+                  </a:txBody>
+                  <a:tcPr marL="73152" marR="73152" marT="36576" marB="36576">
+                    <a:solidFill>
+                      <a:srgbClr val="F7F4EC"/>
+                    </a:solidFill>
+                  </a:tcPr>
+                </a:tc>
+                <a:tc>
+                  <a:txBody>
+                    <a:bodyPr wrap="square"/>
+                    <a:lstStyle/>
+                    <a:p>
+                      <a:r>
+                        <a:rPr sz="1200" b="0">
+                          <a:solidFill>
+                            <a:srgbClr val="2B2A28"/>
+                          </a:solidFill>
+                          <a:latin typeface="Segoe UI"/>
+                        </a:rPr>
+                        <a:t>Renamed to Pips + insights</a:t>
+                      </a:r>
+                    </a:p>
+                    <a:p>
+                      <a:r>
+                        <a:rPr sz="1200" b="0">
+                          <a:solidFill>
+                            <a:srgbClr val="2B2A28"/>
+                          </a:solidFill>
+                          <a:latin typeface="Segoe UI"/>
+                        </a:rPr>
+                        <a:t>Renamed from Productivity Widget to Pips; Dashboard charts: focus timeline, hour heatmap, 7-day score trend, pomodoros per day; AI token usage on the card and dashboard; Daily diary export and weekly / monthly reports</a:t>
+                      </a:r>
+                    </a:p>
+                  </a:txBody>
+                  <a:tcPr marL="73152" marR="73152" marT="36576" marB="36576">
+                    <a:solidFill>
+                      <a:srgbClr val="F7F4EC"/>
+                    </a:solidFill>
+                  </a:tcPr>
+                </a:tc>
+              </a:tr>
+              <a:tr h="822960">
+                <a:tc>
+                  <a:txBody>
+                    <a:bodyPr wrap="square"/>
+                    <a:lstStyle/>
+                    <a:p>
+                      <a:r>
+                        <a:rPr sz="1200" b="1">
+                          <a:solidFill>
+                            <a:srgbClr val="2B2A28"/>
+                          </a:solidFill>
+                          <a:latin typeface="Segoe UI"/>
+                        </a:rPr>
                         <a:t>1.0.0</a:t>
                       </a:r>
                     </a:p>
                   </a:txBody>
                   <a:tcPr marL="73152" marR="73152" marT="36576" marB="36576">
                     <a:solidFill>
-                      <a:srgbClr val="F7F4EC"/>
+                      <a:srgbClr val="FFFDF8"/>
                     </a:solidFill>
                   </a:tcPr>
                 </a:tc>
@@ -11632,7 +11711,7 @@
                   </a:txBody>
                   <a:tcPr marL="73152" marR="73152" marT="36576" marB="36576">
                     <a:solidFill>
-                      <a:srgbClr val="F7F4EC"/>
+                      <a:srgbClr val="FFFDF8"/>
                     </a:solidFill>
                   </a:tcPr>
                 </a:tc>
@@ -11665,7 +11744,7 @@
                   </a:txBody>
                   <a:tcPr marL="73152" marR="73152" marT="36576" marB="36576">
                     <a:solidFill>
-                      <a:srgbClr val="F7F4EC"/>
+                      <a:srgbClr val="FFFDF8"/>
                     </a:solidFill>
                   </a:tcPr>
                 </a:tc>
@@ -15006,7 +15085,7 @@
         </p:nvGraphicFramePr>
         <p:xfrm>
           <a:off x="548640" y="1645920"/>
-          <a:ext cx="7315200" cy="4663440"/>
+          <a:ext cx="7315200" cy="5614416"/>
         </p:xfrm>
         <a:graphic>
           <a:graphicData uri="http://schemas.openxmlformats.org/drawingml/2006/table">
@@ -15422,6 +15501,98 @@
                           <a:latin typeface="Segoe UI"/>
                         </a:rPr>
                         <a:t>51 animal voices that change with its mood. Sing &amp; dance tricks play a song you pick: right-click → Do a trick → Song</a:t>
+                      </a:r>
+                    </a:p>
+                  </a:txBody>
+                  <a:tcPr marL="73152" marR="73152" marT="36576" marB="36576">
+                    <a:solidFill>
+                      <a:srgbClr val="F7F4EC"/>
+                    </a:solidFill>
+                  </a:tcPr>
+                </a:tc>
+              </a:tr>
+              <a:tr h="475488">
+                <a:tc>
+                  <a:txBody>
+                    <a:bodyPr wrap="square"/>
+                    <a:lstStyle/>
+                    <a:p>
+                      <a:r>
+                        <a:rPr sz="1400" b="1">
+                          <a:solidFill>
+                            <a:srgbClr val="2B2A28"/>
+                          </a:solidFill>
+                          <a:latin typeface="Segoe UI"/>
+                        </a:rPr>
+                        <a:t>Battle ⚔</a:t>
+                      </a:r>
+                    </a:p>
+                  </a:txBody>
+                  <a:tcPr marL="73152" marR="73152" marT="36576" marB="36576">
+                    <a:solidFill>
+                      <a:srgbClr val="FFFDF8"/>
+                    </a:solidFill>
+                  </a:tcPr>
+                </a:tc>
+                <a:tc>
+                  <a:txBody>
+                    <a:bodyPr wrap="square"/>
+                    <a:lstStyle/>
+                    <a:p>
+                      <a:r>
+                        <a:rPr sz="1400" b="0">
+                          <a:solidFill>
+                            <a:srgbClr val="2B2A28"/>
+                          </a:solidFill>
+                          <a:latin typeface="Segoe UI"/>
+                        </a:rPr>
+                        <a:t>Arena duels: compare stats (level + gear), pick 3 skills, choose best of 1/3/5 rounds and take turns until one pet is knocked out</a:t>
+                      </a:r>
+                    </a:p>
+                  </a:txBody>
+                  <a:tcPr marL="73152" marR="73152" marT="36576" marB="36576">
+                    <a:solidFill>
+                      <a:srgbClr val="FFFDF8"/>
+                    </a:solidFill>
+                  </a:tcPr>
+                </a:tc>
+              </a:tr>
+              <a:tr h="475488">
+                <a:tc>
+                  <a:txBody>
+                    <a:bodyPr wrap="square"/>
+                    <a:lstStyle/>
+                    <a:p>
+                      <a:r>
+                        <a:rPr sz="1400" b="1">
+                          <a:solidFill>
+                            <a:srgbClr val="2B2A28"/>
+                          </a:solidFill>
+                          <a:latin typeface="Segoe UI"/>
+                        </a:rPr>
+                        <a:t>Games 🎲</a:t>
+                      </a:r>
+                    </a:p>
+                  </a:txBody>
+                  <a:tcPr marL="73152" marR="73152" marT="36576" marB="36576">
+                    <a:solidFill>
+                      <a:srgbClr val="F7F4EC"/>
+                    </a:solidFill>
+                  </a:tcPr>
+                </a:tc>
+                <a:tc>
+                  <a:txBody>
+                    <a:bodyPr wrap="square"/>
+                    <a:lstStyle/>
+                    <a:p>
+                      <a:r>
+                        <a:rPr sz="1400" b="0">
+                          <a:solidFill>
+                            <a:srgbClr val="2B2A28"/>
+                          </a:solidFill>
+                          <a:latin typeface="Segoe UI"/>
+                        </a:rPr>
+                        <a:t>5 minigames - Treat Catch, Bonk the Bugs, Memory Match, Pet Says, Hop Hop (Hub → Play → Minigames or right-click → Games)</a:t>
                       </a:r>
                     </a:p>
                   </a:txBody>

</xml_diff>

<commit_message>
pips 2.24.1: No more surprise pop-ups
</commit_message>
<xml_diff>
--- a/apps/pips/web/download/Pips-Guide.pptx
+++ b/apps/pips/web/download/Pips-Guide.pptx
@@ -3292,7 +3292,7 @@
                 </a:solidFill>
                 <a:latin typeface="Segoe UI"/>
               </a:rPr>
-              <a:t>Version 2.24.0  ·  2026-10-29  ·  Made by Juwen Lie (owner)</a:t>
+              <a:t>Version 2.24.1  ·  2026-10-29  ·  Made by Juwen Lie (owner)</a:t>
             </a:r>
           </a:p>
           <a:p>
@@ -8279,7 +8279,7 @@
                 </a:solidFill>
                 <a:latin typeface="Segoe UI"/>
               </a:rPr>
-              <a:t>What's new in 2.24.0</a:t>
+              <a:t>What's new in 2.24.1</a:t>
             </a:r>
           </a:p>
         </p:txBody>
@@ -8392,7 +8392,7 @@
                 </a:solidFill>
                 <a:latin typeface="Segoe UI"/>
               </a:rPr>
-              <a:t>Skill battles, minigames &amp; a simpler Hub  ·  2026-10-29</a:t>
+              <a:t>No more surprise pop-ups  ·  2026-10-29</a:t>
             </a:r>
           </a:p>
         </p:txBody>
@@ -8440,7 +8440,7 @@
                 </a:solidFill>
                 <a:latin typeface="Segoe UI"/>
               </a:rPr>
-              <a:t>Arena battles are now turn-based: before a fight compare both pets' stats (level + gear), pick 3 skills, and the challenger chooses best of 1, 3 or 5 rounds. Take turns until one pet is knocked out - new skills unlock as you level up and with weapons and gadgets.</a:t>
+              <a:t>Clicking your pet now only tickles it - no window pops up. Double-click the pet to open the hub (or use the right-click menu).</a:t>
             </a:r>
           </a:p>
           <a:p>
@@ -8465,7 +8465,7 @@
                 </a:solidFill>
                 <a:latin typeface="Segoe UI"/>
               </a:rPr>
-              <a:t>5 new minigames to play with your pet: Treat Catch, Bonk the Bugs, Memory Match, Pet Says and Hop Hop. Best scores are saved and great scores earn a few coins (right-click → Games, or Hub → Play).</a:t>
+              <a:t>The focus card and the dashboard stay hidden when Pips starts; open them only when you want them.</a:t>
             </a:r>
           </a:p>
           <a:p>
@@ -8490,7 +8490,7 @@
                 </a:solidFill>
                 <a:latin typeface="Segoe UI"/>
               </a:rPr>
-              <a:t>The Hub is simpler: 5 tabs - Friends, Chat (messages + groups), Play (arena, minigames, ranks), Shop and Me (profile + achievements).</a:t>
+              <a:t>Prefer the old way? Right-click → Settings → When I click the pet.</a:t>
             </a:r>
           </a:p>
         </p:txBody>
@@ -8621,7 +8621,7 @@
                 </a:solidFill>
                 <a:latin typeface="Segoe UI"/>
               </a:rPr>
-              <a:t>Duel arena kini bergiliran: sebelum bertarung bandingkan statistik kedua pet (level + gear), pilih 3 skill, dan penantang memilih best of 1, 3 atau 5 ronde. Bergantian sampai salah satu KO - skill baru terbuka saat naik level dan dengan senjata serta gadget.</a:t>
+              <a:t>Klik pet sekarang hanya menggelitik - tidak ada jendela yang muncul. Klik dua kali pet untuk membuka hub (atau pakai menu klik kanan).</a:t>
             </a:r>
           </a:p>
           <a:p>
@@ -8646,7 +8646,7 @@
                 </a:solidFill>
                 <a:latin typeface="Segoe UI"/>
               </a:rPr>
-              <a:t>5 minigame baru untuk bermain dengan pet: Tangkap Camilan, Pukul Serangga, Cocokkan Kartu, Kata Pet dan Lompat Lompat. Skor terbaik disimpan dan skor hebat dapat beberapa koin (klik kanan → Permainan, atau Hub → Main).</a:t>
+              <a:t>Kartu fokus dan dashboard tetap tersembunyi saat Pips dimulai; buka hanya saat kamu mau.</a:t>
             </a:r>
           </a:p>
           <a:p>
@@ -8671,7 +8671,7 @@
                 </a:solidFill>
                 <a:latin typeface="Segoe UI"/>
               </a:rPr>
-              <a:t>Hub lebih sederhana: 5 tab - Teman, Chat (pesan + grup), Main (arena, minigame, peringkat), Toko dan Saya (profil + pencapaian).</a:t>
+              <a:t>Suka cara lama? Klik kanan → Pengaturan → Saat peliharaan diklik.</a:t>
             </a:r>
           </a:p>
         </p:txBody>
@@ -8903,7 +8903,7 @@
         </p:nvGraphicFramePr>
         <p:xfrm>
           <a:off x="548640" y="1645920"/>
-          <a:ext cx="11155680" cy="29187648"/>
+          <a:ext cx="11155680" cy="30010608"/>
         </p:xfrm>
         <a:graphic>
           <a:graphicData uri="http://schemas.openxmlformats.org/drawingml/2006/table">
@@ -8997,7 +8997,7 @@
                           </a:solidFill>
                           <a:latin typeface="Segoe UI"/>
                         </a:rPr>
-                        <a:t>2.24.0</a:t>
+                        <a:t>2.24.1</a:t>
                       </a:r>
                     </a:p>
                   </a:txBody>
@@ -9041,7 +9041,7 @@
                           </a:solidFill>
                           <a:latin typeface="Segoe UI"/>
                         </a:rPr>
-                        <a:t>Skill battles, minigames &amp; a simpler Hub</a:t>
+                        <a:t>No more surprise pop-ups</a:t>
                       </a:r>
                     </a:p>
                     <a:p>
@@ -9052,7 +9052,7 @@
                           </a:solidFill>
                           <a:latin typeface="Segoe UI"/>
                         </a:rPr>
-                        <a:t>Arena battles are now turn-based: before a fight compare both pets' stats (level + gear), pick 3 skills, and the challenger chooses best of 1, 3 or 5 rounds. Take turns until one pet is knocked out - new skills unlock as you level up and with weapons and gadgets.; 5 new minigames to play with your pet: Treat Catch, Bonk the Bugs, Memory Match, Pet Says and Hop Hop. Best scores are saved and great scores earn a few coins (right-click → Games, or Hub → Play).; The Hub is simpler: 5 tabs - Friends, Chat (messages + groups), Play (arena, minigames, ranks), Shop and Me (profile + achievements).</a:t>
+                        <a:t>Clicking your pet now only tickles it - no window pops up. Double-click the pet to open the hub (or use the right-click menu).; The focus card and the dashboard stay hidden when Pips starts; open them only when you want them.; Prefer the old way? Right-click → Settings → When I click the pet.</a:t>
                       </a:r>
                     </a:p>
                   </a:txBody>
@@ -9076,7 +9076,7 @@
                           </a:solidFill>
                           <a:latin typeface="Segoe UI"/>
                         </a:rPr>
-                        <a:t>2.23.0</a:t>
+                        <a:t>2.24.0</a:t>
                       </a:r>
                     </a:p>
                   </a:txBody>
@@ -9120,7 +9120,7 @@
                           </a:solidFill>
                           <a:latin typeface="Segoe UI"/>
                         </a:rPr>
-                        <a:t>Weather on your desktop</a:t>
+                        <a:t>Skill battles, minigames &amp; a simpler Hub</a:t>
                       </a:r>
                     </a:p>
                     <a:p>
@@ -9131,7 +9131,7 @@
                           </a:solidFill>
                           <a:latin typeface="Segoe UI"/>
                         </a:rPr>
-                        <a:t>Your pet now shows the live weather right on your desktop: its own little rain cloud with an umbrella when it rains, a dark storm cloud with lightning, snow piling up at its feet, the sun, the moon and twinkling stars at night, drifting fog and leaves blowing in the wind. Prefer more? Switch the animation to the whole screen - or turn it off.; New right-click menu → Weather &amp; location: Follow my exact location (Windows location; a laptop is followed as you move), Approximate (from your internet connection), or Pick a place - search a city or paste exact coordinates from Google Maps. The pet tells you when the weather changes.; Works without Pips Friends (weather from Open-Meteo, no account needed). With Friends on, your profile city follows you too - but a city you hid stays hidden. If Windows location is turned off on your PC, Pips explains how to turn it on and uses your internet location meanwhile.</a:t>
+                        <a:t>Arena battles are now turn-based: before a fight compare both pets' stats (level + gear), pick 3 skills, and the challenger chooses best of 1, 3 or 5 rounds. Take turns until one pet is knocked out - new skills unlock as you level up and with weapons and gadgets.; 5 new minigames to play with your pet: Treat Catch, Bonk the Bugs, Memory Match, Pet Says and Hop Hop. Best scores are saved and great scores earn a few coins (right-click → Games, or Hub → Play).; The Hub is simpler: 5 tabs - Friends, Chat (messages + groups), Play (arena, minigames, ranks), Shop and Me (profile + achievements).</a:t>
                       </a:r>
                     </a:p>
                   </a:txBody>
@@ -9155,7 +9155,7 @@
                           </a:solidFill>
                           <a:latin typeface="Segoe UI"/>
                         </a:rPr>
-                        <a:t>2.22.0</a:t>
+                        <a:t>2.23.0</a:t>
                       </a:r>
                     </a:p>
                   </a:txBody>
@@ -9199,7 +9199,7 @@
                           </a:solidFill>
                           <a:latin typeface="Segoe UI"/>
                         </a:rPr>
-                        <a:t>Sing &amp; dance with music</a:t>
+                        <a:t>Weather on your desktop</a:t>
                       </a:r>
                     </a:p>
                     <a:p>
@@ -9210,7 +9210,7 @@
                           </a:solidFill>
                           <a:latin typeface="Segoe UI"/>
                         </a:rPr>
-                        <a:t>Sing, Dance, Moonwalk, Breakdance, Yoga, Rain dance and the show tricks now play real music. When your pet sings, it sings the melody in its own voice - a cat meows the tune, a frog ribbits it, a whale hums it - and when it dances, its animal call joins the beat.; Pick the song: right-click → Do a trick → Song for sing &amp; dance. Choose your animal's own song (every one of the 51 animals has its own tune), the song for its type (Meadow Hoedown for land, Ocean Calypso for water, Cloud Waltz for sky), Happy Pop, Disco Night, 8-bit Adventure, Lullaby, Lo-fi Chill, any other animal's song, Surprise me or No music.; Songs follow your sound settings (volume, sounds off, quiet during focus) and stop as soon as the trick is interrupted. Tricks your pet does by itself stay quiet.</a:t>
+                        <a:t>Your pet now shows the live weather right on your desktop: its own little rain cloud with an umbrella when it rains, a dark storm cloud with lightning, snow piling up at its feet, the sun, the moon and twinkling stars at night, drifting fog and leaves blowing in the wind. Prefer more? Switch the animation to the whole screen - or turn it off.; New right-click menu → Weather &amp; location: Follow my exact location (Windows location; a laptop is followed as you move), Approximate (from your internet connection), or Pick a place - search a city or paste exact coordinates from Google Maps. The pet tells you when the weather changes.; Works without Pips Friends (weather from Open-Meteo, no account needed). With Friends on, your profile city follows you too - but a city you hid stays hidden. If Windows location is turned off on your PC, Pips explains how to turn it on and uses your internet location meanwhile.</a:t>
                       </a:r>
                     </a:p>
                   </a:txBody>
@@ -9234,7 +9234,7 @@
                           </a:solidFill>
                           <a:latin typeface="Segoe UI"/>
                         </a:rPr>
-                        <a:t>2.21.0</a:t>
+                        <a:t>2.22.0</a:t>
                       </a:r>
                     </a:p>
                   </a:txBody>
@@ -9278,7 +9278,7 @@
                           </a:solidFill>
                           <a:latin typeface="Segoe UI"/>
                         </a:rPr>
-                        <a:t>Every animal has a voice</a:t>
+                        <a:t>Sing &amp; dance with music</a:t>
                       </a:r>
                     </a:p>
                     <a:p>
@@ -9289,7 +9289,7 @@
                           </a:solidFill>
                           <a:latin typeface="Segoe UI"/>
                         </a:rPr>
-                        <a:t>All 51 animals now have their own sound. Before, more than half of them borrowed the cat's meow - now the dog woofs, the cow moos, the sheep baas, the lion roars, the duck quacks, the dolphin clicks and whistles, the dragon flaps and roars with a puff of fire, the ghost goes wooo... and so on.; Every mood sounds different too: happy, sad, sleepy, hungry or grumpy. Petting, eating and snoring sound right for each kind of animal - furry ones purr and crunch, birds trill and peck, sea animals blow bubbles, bugs hum and magic pets chime.; A friend's pet that comes to visit now talks in its own voice: it says hi when it arrives and answers when you wave, pet it or give it a snack (it follows your sound settings).</a:t>
+                        <a:t>Sing, Dance, Moonwalk, Breakdance, Yoga, Rain dance and the show tricks now play real music. When your pet sings, it sings the melody in its own voice - a cat meows the tune, a frog ribbits it, a whale hums it - and when it dances, its animal call joins the beat.; Pick the song: right-click → Do a trick → Song for sing &amp; dance. Choose your animal's own song (every one of the 51 animals has its own tune), the song for its type (Meadow Hoedown for land, Ocean Calypso for water, Cloud Waltz for sky), Happy Pop, Disco Night, 8-bit Adventure, Lullaby, Lo-fi Chill, any other animal's song, Surprise me or No music.; Songs follow your sound settings (volume, sounds off, quiet during focus) and stop as soon as the trick is interrupted. Tricks your pet does by itself stay quiet.</a:t>
                       </a:r>
                     </a:p>
                   </a:txBody>
@@ -9313,7 +9313,7 @@
                           </a:solidFill>
                           <a:latin typeface="Segoe UI"/>
                         </a:rPr>
-                        <a:t>2.20.0</a:t>
+                        <a:t>2.21.0</a:t>
                       </a:r>
                     </a:p>
                   </a:txBody>
@@ -9357,7 +9357,7 @@
                           </a:solidFill>
                           <a:latin typeface="Segoe UI"/>
                         </a:rPr>
-                        <a:t>Come over</a:t>
+                        <a:t>Every animal has a voice</a:t>
                       </a:r>
                     </a:p>
                     <a:p>
@@ -9368,7 +9368,7 @@
                           </a:solidFill>
                           <a:latin typeface="Segoe UI"/>
                         </a:rPr>
-                        <a:t>When a friend's pet comes over it now wears a name tag: your friend's name (or the nickname you gave them), ♂/♀ and an online dot. It walks up to your pet, says hi, and looks at your mouse when you point at it.; Point at the visitor (or click its name tag) to open its card: whose pet it is, level, how close you two are, and buttons to wave, pet it, give it a snack, visit back or chat. It reacts to everything - hearts, crumbs, happy faces - and your friend sees it too.; Rub your mouse over the visitor to pet it. Playing with it makes it stay longer, and your pet comes down from a window or the sky to meet it.</a:t>
+                        <a:t>All 51 animals now have their own sound. Before, more than half of them borrowed the cat's meow - now the dog woofs, the cow moos, the sheep baas, the lion roars, the duck quacks, the dolphin clicks and whistles, the dragon flaps and roars with a puff of fire, the ghost goes wooo... and so on.; Every mood sounds different too: happy, sad, sleepy, hungry or grumpy. Petting, eating and snoring sound right for each kind of animal - furry ones purr and crunch, birds trill and peck, sea animals blow bubbles, bugs hum and magic pets chime.; A friend's pet that comes to visit now talks in its own voice: it says hi when it arrives and answers when you wave, pet it or give it a snack (it follows your sound settings).</a:t>
                       </a:r>
                     </a:p>
                   </a:txBody>
@@ -9392,7 +9392,7 @@
                           </a:solidFill>
                           <a:latin typeface="Segoe UI"/>
                         </a:rPr>
-                        <a:t>2.19.0</a:t>
+                        <a:t>2.20.0</a:t>
                       </a:r>
                     </a:p>
                   </a:txBody>
@@ -9436,7 +9436,7 @@
                           </a:solidFill>
                           <a:latin typeface="Segoe UI"/>
                         </a:rPr>
-                        <a:t>Land, sea &amp; sky</a:t>
+                        <a:t>Come over</a:t>
                       </a:r>
                     </a:p>
                     <a:p>
@@ -9447,7 +9447,7 @@
                           </a:solidFill>
                           <a:latin typeface="Segoe UI"/>
                         </a:rPr>
-                        <a:t>Land animals walk on the taskbar and on top of your open windows now: they jump up onto window edges, walk along them, ride along when you move the window and hop down when it closes, gets covered or is maximised. They always have gravity - let go of one in mid-air and it lands on the window below or on the taskbar.; Water animals swim along the taskbar (their water) and every now and then leap high out of it in a big arc, diving back in with a splash, ripples and spray. Drop one anywhere and it dives back into the water.; Flying animals fly anywhere on the screen: they flutter from place to place, hover, come say hi near your mouse, and sometimes perch on the taskbar or a window edge for a rest. Point at one and it waits for you; they glide down to a perch before a nap.; New menu moves: Jump onto a window, Splash jump!, Fly around / Rest on the taskbar. "Move around by myself" in Pet settings keeps your pet still if you prefer (the old Gravity option is gone - land animals always fall now).</a:t>
+                        <a:t>When a friend's pet comes over it now wears a name tag: your friend's name (or the nickname you gave them), ♂/♀ and an online dot. It walks up to your pet, says hi, and looks at your mouse when you point at it.; Point at the visitor (or click its name tag) to open its card: whose pet it is, level, how close you two are, and buttons to wave, pet it, give it a snack, visit back or chat. It reacts to everything - hearts, crumbs, happy faces - and your friend sees it too.; Rub your mouse over the visitor to pet it. Playing with it makes it stay longer, and your pet comes down from a window or the sky to meet it.</a:t>
                       </a:r>
                     </a:p>
                   </a:txBody>
@@ -9471,7 +9471,7 @@
                           </a:solidFill>
                           <a:latin typeface="Segoe UI"/>
                         </a:rPr>
-                        <a:t>2.18.0</a:t>
+                        <a:t>2.19.0</a:t>
                       </a:r>
                     </a:p>
                   </a:txBody>
@@ -9515,7 +9515,7 @@
                           </a:solidFill>
                           <a:latin typeface="Segoe UI"/>
                         </a:rPr>
-                        <a:t>Raise your pet</a:t>
+                        <a:t>Land, sea &amp; sky</a:t>
                       </a:r>
                     </a:p>
                     <a:p>
@@ -9526,7 +9526,7 @@
                           </a:solidFill>
                           <a:latin typeface="Segoe UI"/>
                         </a:rPr>
-                        <a:t>Boy or girl? Pick your pet's gender in Settings: boys get a little hair tuft, girls a pink bow and eyelashes, and a ♂ / ♀ shows next to its name. You can add your own gender to your profile too - friends see a small ♂ / ♀ next to your name.; Pets grow up now: baby → child → teen → grown-up. Focus sessions, opening Pips each day, games and cuddles help them grow - no care mistakes, no bad endings. Already have a grown-up pet? It will ask whether you'd like to raise it again from a baby (coins, items and stats stay).; Sick days: work 2.5 hours without a 5-minute break and your pet catches a little cold (sneezes, thermometer, slow steps). A short break cures it - or give medicine from the menu. You can turn this off in Settings.; New mini-game Left or Right? (pet menu → Play): guess which way your pet will look - 3 out of 5 wins, with coins for your first wins each day.</a:t>
+                        <a:t>Land animals walk on the taskbar and on top of your open windows now: they jump up onto window edges, walk along them, ride along when you move the window and hop down when it closes, gets covered or is maximised. They always have gravity - let go of one in mid-air and it lands on the window below or on the taskbar.; Water animals swim along the taskbar (their water) and every now and then leap high out of it in a big arc, diving back in with a splash, ripples and spray. Drop one anywhere and it dives back into the water.; Flying animals fly anywhere on the screen: they flutter from place to place, hover, come say hi near your mouse, and sometimes perch on the taskbar or a window edge for a rest. Point at one and it waits for you; they glide down to a perch before a nap.; New menu moves: Jump onto a window, Splash jump!, Fly around / Rest on the taskbar. "Move around by myself" in Pet settings keeps your pet still if you prefer (the old Gravity option is gone - land animals always fall now).</a:t>
                       </a:r>
                     </a:p>
                   </a:txBody>
@@ -9550,7 +9550,7 @@
                           </a:solidFill>
                           <a:latin typeface="Segoe UI"/>
                         </a:rPr>
-                        <a:t>2.17.0</a:t>
+                        <a:t>2.18.0</a:t>
                       </a:r>
                     </a:p>
                   </a:txBody>
@@ -9594,7 +9594,7 @@
                           </a:solidFill>
                           <a:latin typeface="Segoe UI"/>
                         </a:rPr>
-                        <a:t>Find your pet anytime</a:t>
+                        <a:t>Raise your pet</a:t>
                       </a:r>
                     </a:p>
                     <a:p>
@@ -9605,7 +9605,7 @@
                           </a:solidFill>
                           <a:latin typeface="Segoe UI"/>
                         </a:rPr>
-                        <a:t>Pips now has an icon next to the clock: click it to bring your pet back; right-click for the focus timer, Friends &amp; chat or Quit.; Press Ctrl+Alt+P anywhere to call your pet - it pops up on the screen you're using, even if it was hidden, asleep or behind a fullscreen app.; Opening Pips again from the Start menu or desktop does the same, and your pet walks back by itself if it ever ends up off-screen (e.g. after unplugging a monitor).; Hiding your pet now tells you how to bring it back.</a:t>
+                        <a:t>Boy or girl? Pick your pet's gender in Settings: boys get a little hair tuft, girls a pink bow and eyelashes, and a ♂ / ♀ shows next to its name. You can add your own gender to your profile too - friends see a small ♂ / ♀ next to your name.; Pets grow up now: baby → child → teen → grown-up. Focus sessions, opening Pips each day, games and cuddles help them grow - no care mistakes, no bad endings. Already have a grown-up pet? It will ask whether you'd like to raise it again from a baby (coins, items and stats stay).; Sick days: work 2.5 hours without a 5-minute break and your pet catches a little cold (sneezes, thermometer, slow steps). A short break cures it - or give medicine from the menu. You can turn this off in Settings.; New mini-game Left or Right? (pet menu → Play): guess which way your pet will look - 3 out of 5 wins, with coins for your first wins each day.</a:t>
                       </a:r>
                     </a:p>
                   </a:txBody>
@@ -9629,7 +9629,7 @@
                           </a:solidFill>
                           <a:latin typeface="Segoe UI"/>
                         </a:rPr>
-                        <a:t>2.16.0</a:t>
+                        <a:t>2.17.0</a:t>
                       </a:r>
                     </a:p>
                   </a:txBody>
@@ -9673,7 +9673,7 @@
                           </a:solidFill>
                           <a:latin typeface="Segoe UI"/>
                         </a:rPr>
-                        <a:t>Pips Community</a:t>
+                        <a:t>Find your pet anytime</a:t>
                       </a:r>
                     </a:p>
                     <a:p>
@@ -9684,7 +9684,7 @@
                           </a:solidFill>
                           <a:latin typeface="Segoe UI"/>
                         </a:rPr>
-                        <a:t>New Pips Community at the top of the Chat tab: a #general channel to chat with everyone who uses Pips, plus #announcements with news from the Pips team.; Every new Pips version is announced there automatically - see what's new and update with one click.; Type @name to ping someone in #general. Mute #general any time; owner and moderators can remove messages.; Open it from your pet's menu too (Pips Community). Fixed: chats no longer clear what you're typing when Pips refreshes in the background.</a:t>
+                        <a:t>Pips now has an icon next to the clock: click it to bring your pet back; right-click for the focus timer, Friends &amp; chat or Quit.; Press Ctrl+Alt+P anywhere to call your pet - it pops up on the screen you're using, even if it was hidden, asleep or behind a fullscreen app.; Opening Pips again from the Start menu or desktop does the same, and your pet walks back by itself if it ever ends up off-screen (e.g. after unplugging a monitor).; Hiding your pet now tells you how to bring it back.</a:t>
                       </a:r>
                     </a:p>
                   </a:txBody>
@@ -9708,7 +9708,7 @@
                           </a:solidFill>
                           <a:latin typeface="Segoe UI"/>
                         </a:rPr>
-                        <a:t>2.15.0</a:t>
+                        <a:t>2.16.0</a:t>
                       </a:r>
                     </a:p>
                   </a:txBody>
@@ -9752,7 +9752,7 @@
                           </a:solidFill>
                           <a:latin typeface="Segoe UI"/>
                         </a:rPr>
-                        <a:t>Update reminders</a:t>
+                        <a:t>Pips Community</a:t>
                       </a:r>
                     </a:p>
                     <a:p>
@@ -9763,7 +9763,7 @@
                           </a:solidFill>
                           <a:latin typeface="Segoe UI"/>
                         </a:rPr>
-                        <a:t>Owner &amp; moderators: the Mod tab now lists who hasn't updated Pips yet (their version and when they were last seen), with one-click reminders by e-mail (sent from your Outlook) or a ready-to-send Teams chat.; New Work e-mail field in your Profile, filled in from Outlook. Only the owner and moderators can see it (for update reminders and support) - clear it to hide it.; Pips now tells the Friends server which version it runs, so the update list is always accurate.; Friends keeps working when a local proxy tool stops answering - Pips falls back to the Windows proxy settings.</a:t>
+                        <a:t>New Pips Community at the top of the Chat tab: a #general channel to chat with everyone who uses Pips, plus #announcements with news from the Pips team.; Every new Pips version is announced there automatically - see what's new and update with one click.; Type @name to ping someone in #general. Mute #general any time; owner and moderators can remove messages.; Open it from your pet's menu too (Pips Community). Fixed: chats no longer clear what you're typing when Pips refreshes in the background.</a:t>
                       </a:r>
                     </a:p>
                   </a:txBody>
@@ -9787,7 +9787,7 @@
                           </a:solidFill>
                           <a:latin typeface="Segoe UI"/>
                         </a:rPr>
-                        <a:t>2.14.3</a:t>
+                        <a:t>2.15.0</a:t>
                       </a:r>
                     </a:p>
                   </a:txBody>
@@ -9831,7 +9831,7 @@
                           </a:solidFill>
                           <a:latin typeface="Segoe UI"/>
                         </a:rPr>
-                        <a:t>Tidy menus</a:t>
+                        <a:t>Update reminders</a:t>
                       </a:r>
                     </a:p>
                     <a:p>
@@ -9842,7 +9842,7 @@
                           </a:solidFill>
                           <a:latin typeface="Segoe UI"/>
                         </a:rPr>
-                        <a:t>Fixed: a submenu (e.g. Poke a friend) could stay floating on the screen after the right-click menu closed.; Menus now close by themselves when you move the mouse away and leave them for a few seconds.</a:t>
+                        <a:t>Owner &amp; moderators: the Mod tab now lists who hasn't updated Pips yet (their version and when they were last seen), with one-click reminders by e-mail (sent from your Outlook) or a ready-to-send Teams chat.; New Work e-mail field in your Profile, filled in from Outlook. Only the owner and moderators can see it (for update reminders and support) - clear it to hide it.; Pips now tells the Friends server which version it runs, so the update list is always accurate.; Friends keeps working when a local proxy tool stops answering - Pips falls back to the Windows proxy settings.</a:t>
                       </a:r>
                     </a:p>
                   </a:txBody>
@@ -9866,7 +9866,7 @@
                           </a:solidFill>
                           <a:latin typeface="Segoe UI"/>
                         </a:rPr>
-                        <a:t>2.14.2</a:t>
+                        <a:t>2.14.3</a:t>
                       </a:r>
                     </a:p>
                   </a:txBody>
@@ -9910,7 +9910,7 @@
                           </a:solidFill>
                           <a:latin typeface="Segoe UI"/>
                         </a:rPr>
-                        <a:t>Never miss an update</a:t>
+                        <a:t>Tidy menus</a:t>
                       </a:r>
                     </a:p>
                     <a:p>
@@ -9921,7 +9921,7 @@
                           </a:solidFill>
                           <a:latin typeface="Segoe UI"/>
                         </a:rPr>
-                        <a:t>Your pet now reminds you every 2 hours while a new version is waiting (instead of every 6 hours).; If the reminder can't show (fullscreen app, guided tour, another message), your pet tries again a few minutes later.; No internet when Pips starts (e.g. VPN off)? It checks again after an hour.</a:t>
+                        <a:t>Fixed: a submenu (e.g. Poke a friend) could stay floating on the screen after the right-click menu closed.; Menus now close by themselves when you move the mouse away and leave them for a few seconds.</a:t>
                       </a:r>
                     </a:p>
                   </a:txBody>
@@ -9945,7 +9945,7 @@
                           </a:solidFill>
                           <a:latin typeface="Segoe UI"/>
                         </a:rPr>
-                        <a:t>2.14.1</a:t>
+                        <a:t>2.14.2</a:t>
                       </a:r>
                     </a:p>
                   </a:txBody>
@@ -9989,7 +9989,7 @@
                           </a:solidFill>
                           <a:latin typeface="Segoe UI"/>
                         </a:rPr>
-                        <a:t>One pet at a time</a:t>
+                        <a:t>Never miss an update</a:t>
                       </a:r>
                     </a:p>
                     <a:p>
@@ -10000,7 +10000,7 @@
                           </a:solidFill>
                           <a:latin typeface="Segoe UI"/>
                         </a:rPr>
-                        <a:t>Opening Pips again (Desktop / Start Menu shortcut, autostart) no longer starts a second pet - your pet just pops up and says hi.; Fixes lag caused by two copies of Pips running at once.</a:t>
+                        <a:t>Your pet now reminds you every 2 hours while a new version is waiting (instead of every 6 hours).; If the reminder can't show (fullscreen app, guided tour, another message), your pet tries again a few minutes later.; No internet when Pips starts (e.g. VPN off)? It checks again after an hour.</a:t>
                       </a:r>
                     </a:p>
                   </a:txBody>
@@ -10024,7 +10024,7 @@
                           </a:solidFill>
                           <a:latin typeface="Segoe UI"/>
                         </a:rPr>
-                        <a:t>2.14.0</a:t>
+                        <a:t>2.14.1</a:t>
                       </a:r>
                     </a:p>
                   </a:txBody>
@@ -10068,7 +10068,7 @@
                           </a:solidFill>
                           <a:latin typeface="Segoe UI"/>
                         </a:rPr>
-                        <a:t>Pokes, tickles &amp; teases</a:t>
+                        <a:t>One pet at a time</a:t>
                       </a:r>
                     </a:p>
                     <a:p>
@@ -10079,7 +10079,7 @@
                           </a:solidFill>
                           <a:latin typeface="Segoe UI"/>
                         </a:rPr>
-                        <a:t>Poke, tickle, tease, boop or hug a friend from afar - no pet visit needed.; Right-click your pet → Poke a friend, or use the Poke button in Friends, chat and profiles.; Your friend gets a pop-up ("Wendy is teasing you!"), their pet reacts, and they can poke back with one click.; During a focus session pokes wait quietly until your break; when your pet is hidden they show in the screen corner.</a:t>
+                        <a:t>Opening Pips again (Desktop / Start Menu shortcut, autostart) no longer starts a second pet - your pet just pops up and says hi.; Fixes lag caused by two copies of Pips running at once.</a:t>
                       </a:r>
                     </a:p>
                   </a:txBody>
@@ -10103,7 +10103,7 @@
                           </a:solidFill>
                           <a:latin typeface="Segoe UI"/>
                         </a:rPr>
-                        <a:t>2.13.1</a:t>
+                        <a:t>2.14.0</a:t>
                       </a:r>
                     </a:p>
                   </a:txBody>
@@ -10125,7 +10125,7 @@
                           </a:solidFill>
                           <a:latin typeface="Segoe UI"/>
                         </a:rPr>
-                        <a:t>2026-10-28</a:t>
+                        <a:t>2026-10-29</a:t>
                       </a:r>
                     </a:p>
                   </a:txBody>
@@ -10147,7 +10147,7 @@
                           </a:solidFill>
                           <a:latin typeface="Segoe UI"/>
                         </a:rPr>
-                        <a:t>One-click Windows installer</a:t>
+                        <a:t>Pokes, tickles &amp; teases</a:t>
                       </a:r>
                     </a:p>
                     <a:p>
@@ -10158,7 +10158,7 @@
                           </a:solidFill>
                           <a:latin typeface="Segoe UI"/>
                         </a:rPr>
-                        <a:t>One Windows installer: no ZIP extraction, Python installation or command line. Download, open and click Install Pips.; Installs for your Windows account without administrator access, adds Desktop and Start Menu shortcuts, and opens Pips automatically.; Reinstalling in the same location keeps your settings and pet progress. Existing ZIP users can keep updating in place from Help → Check for updates.; A simpler download page and updated user guide; the bundled runtime stays separate from small in-app updates.</a:t>
+                        <a:t>Poke, tickle, tease, boop or hug a friend from afar - no pet visit needed.; Right-click your pet → Poke a friend, or use the Poke button in Friends, chat and profiles.; Your friend gets a pop-up ("Wendy is teasing you!"), their pet reacts, and they can poke back with one click.; During a focus session pokes wait quietly until your break; when your pet is hidden they show in the screen corner.</a:t>
                       </a:r>
                     </a:p>
                   </a:txBody>
@@ -10182,7 +10182,7 @@
                           </a:solidFill>
                           <a:latin typeface="Segoe UI"/>
                         </a:rPr>
-                        <a:t>2.13.0</a:t>
+                        <a:t>2.13.1</a:t>
                       </a:r>
                     </a:p>
                   </a:txBody>
@@ -10226,7 +10226,7 @@
                           </a:solidFill>
                           <a:latin typeface="Segoe UI"/>
                         </a:rPr>
-                        <a:t>Birthdays, parties &amp; gifts</a:t>
+                        <a:t>One-click Windows installer</a:t>
                       </a:r>
                     </a:p>
                     <a:p>
@@ -10237,7 +10237,7 @@
                           </a:solidFill>
                           <a:latin typeface="Segoe UI"/>
                         </a:rPr>
-                        <a:t>Set your birthday in Social → Profile (month + day, optionally visible to friends).; On your birthday Pips throws confetti and gives you 100 bonus coins.; Friends tab shows upcoming birthdays; you get reminders 3 days, 1 day and on the day.; Birthday parties: join a friend's party, see who's there, sign the guestbook and celebrate together.</a:t>
+                        <a:t>One Windows installer: no ZIP extraction, Python installation or command line. Download, open and click Install Pips.; Installs for your Windows account without administrator access, adds Desktop and Start Menu shortcuts, and opens Pips automatically.; Reinstalling in the same location keeps your settings and pet progress. Existing ZIP users can keep updating in place from Help → Check for updates.; A simpler download page and updated user guide; the bundled runtime stays separate from small in-app updates.</a:t>
                       </a:r>
                     </a:p>
                   </a:txBody>
@@ -10261,7 +10261,7 @@
                           </a:solidFill>
                           <a:latin typeface="Segoe UI"/>
                         </a:rPr>
-                        <a:t>2.12.0</a:t>
+                        <a:t>2.13.0</a:t>
                       </a:r>
                     </a:p>
                   </a:txBody>
@@ -10305,7 +10305,7 @@
                           </a:solidFill>
                           <a:latin typeface="Segoe UI"/>
                         </a:rPr>
-                        <a:t>Mega update: 28 new animals, 31 shop items, 13 moves</a:t>
+                        <a:t>Birthdays, parties &amp; gifts</a:t>
                       </a:r>
                     </a:p>
                     <a:p>
@@ -10316,7 +10316,7 @@
                           </a:solidFill>
                           <a:latin typeface="Segoe UI"/>
                         </a:rPr>
-                        <a:t>🦁 28 new animals (51 total): lion, tiger, unicorn, deer, sheep, cow, raccoon, red panda, monkey, hedgehog, dino, squirrel, mouse, koala, shark, dolphin, seal, otter, pufferfish, duck, crab, parrot, chick, ladybug, phoenix, pegasus, ghost and flamingo; 🎩 31 new shop items: top hat, cowboy, chef, pirate, Santa, viking, graduation cap, beret, bow, propeller cap, flower crown, nerd glasses, eyepatch, mustache, goggles, masquerade mask, tie, pearls, flower lei, gold chain, balloon, backpack, guitar, shield, butterfly / devil wings and more - plus Premium galaxy crown, galaxy cape and dragon wings; 💃 13 new moves: wave, jump, hearts, sing, yoga, zoomies, cartwheel, juggle, rain dance, breakdance, magic, confetti and the Premium rocket launch; The Shop is now split into sections (Hats, Face, Neck, Back, Moves, Arena gear) with an owned counter for each</a:t>
+                        <a:t>Set your birthday in Social → Profile (month + day, optionally visible to friends).; On your birthday Pips throws confetti and gives you 100 bonus coins.; Friends tab shows upcoming birthdays; you get reminders 3 days, 1 day and on the day.; Birthday parties: join a friend's party, see who's there, sign the guestbook and celebrate together.</a:t>
                       </a:r>
                     </a:p>
                   </a:txBody>
@@ -10340,7 +10340,7 @@
                           </a:solidFill>
                           <a:latin typeface="Segoe UI"/>
                         </a:rPr>
-                        <a:t>2.11.0</a:t>
+                        <a:t>2.12.0</a:t>
                       </a:r>
                     </a:p>
                   </a:txBody>
@@ -10384,7 +10384,7 @@
                           </a:solidFill>
                           <a:latin typeface="Segoe UI"/>
                         </a:rPr>
-                        <a:t>New right-click menus</a:t>
+                        <a:t>Mega update: 28 new animals, 31 shop items, 13 moves</a:t>
                       </a:r>
                     </a:p>
                     <a:p>
@@ -10395,7 +10395,7 @@
                           </a:solidFill>
                           <a:latin typeface="Segoe UI"/>
                         </a:rPr>
-                        <a:t>✨ Brand-new animated right-click menu for your pet: mood &amp; stat bars, quick-action tiles (Friends, Shop, Snack, Pat, Focus, Stats, Sleep, Taskbar), hover effects and smooth fly-out submenus; Pick colours from swatches, switch size with one click and flip Sounds / Dark mode with toggle switches - changes show instantly; Updates are highlighted: a glowing banner and NEW badge appear in the menu when a new version is ready; The focus card's right-click menu got the same new look; keyboard arrows, Enter and Esc work too</a:t>
+                        <a:t>🦁 28 new animals (51 total): lion, tiger, unicorn, deer, sheep, cow, raccoon, red panda, monkey, hedgehog, dino, squirrel, mouse, koala, shark, dolphin, seal, otter, pufferfish, duck, crab, parrot, chick, ladybug, phoenix, pegasus, ghost and flamingo; 🎩 31 new shop items: top hat, cowboy, chef, pirate, Santa, viking, graduation cap, beret, bow, propeller cap, flower crown, nerd glasses, eyepatch, mustache, goggles, masquerade mask, tie, pearls, flower lei, gold chain, balloon, backpack, guitar, shield, butterfly / devil wings and more - plus Premium galaxy crown, galaxy cape and dragon wings; 💃 13 new moves: wave, jump, hearts, sing, yoga, zoomies, cartwheel, juggle, rain dance, breakdance, magic, confetti and the Premium rocket launch; The Shop is now split into sections (Hats, Face, Neck, Back, Moves, Arena gear) with an owned counter for each</a:t>
                       </a:r>
                     </a:p>
                   </a:txBody>
@@ -10419,7 +10419,7 @@
                           </a:solidFill>
                           <a:latin typeface="Segoe UI"/>
                         </a:rPr>
-                        <a:t>2.10.0</a:t>
+                        <a:t>2.11.0</a:t>
                       </a:r>
                     </a:p>
                   </a:txBody>
@@ -10463,7 +10463,7 @@
                           </a:solidFill>
                           <a:latin typeface="Segoe UI"/>
                         </a:rPr>
-                        <a:t>Chat bots</a:t>
+                        <a:t>New right-click menus</a:t>
                       </a:r>
                     </a:p>
                     <a:p>
@@ -10474,7 +10474,7 @@
                           </a:solidFill>
                           <a:latin typeface="Segoe UI"/>
                         </a:rPr>
-                        <a:t>🤖 6 friendly chat bots in the Chat tab: Pip Helper (app questions), Coach Focus (focus tips from your real stats), Sunny (live weather for any city), Arena Master (battle tips + quick battle), Giggles (jokes &amp; games) and Guardian (safety &amp; reporting help); Private bot chats with suggestion chips, typing indicator and a clear button - your bot chats stay on your PC; Mention a bot in a group chat (e.g. @weather Batam) and it answers in the room for everyone; Bots reply in your app language; up to 120 bot messages per day</a:t>
+                        <a:t>✨ Brand-new animated right-click menu for your pet: mood &amp; stat bars, quick-action tiles (Friends, Shop, Snack, Pat, Focus, Stats, Sleep, Taskbar), hover effects and smooth fly-out submenus; Pick colours from swatches, switch size with one click and flip Sounds / Dark mode with toggle switches - changes show instantly; Updates are highlighted: a glowing banner and NEW badge appear in the menu when a new version is ready; The focus card's right-click menu got the same new look; keyboard arrows, Enter and Esc work too</a:t>
                       </a:r>
                     </a:p>
                   </a:txBody>
@@ -10498,7 +10498,7 @@
                           </a:solidFill>
                           <a:latin typeface="Segoe UI"/>
                         </a:rPr>
-                        <a:t>2.9.0</a:t>
+                        <a:t>2.10.0</a:t>
                       </a:r>
                     </a:p>
                   </a:txBody>
@@ -10542,7 +10542,7 @@
                           </a:solidFill>
                           <a:latin typeface="Segoe UI"/>
                         </a:rPr>
-                        <a:t>Location &amp; live weather</a:t>
+                        <a:t>Chat bots</a:t>
                       </a:r>
                     </a:p>
                     <a:p>
@@ -10553,7 +10553,7 @@
                           </a:solidFill>
                           <a:latin typeface="Segoe UI"/>
                         </a:rPr>
-                        <a:t>📍 Add your city in Profile → Location &amp; weather (auto-detect or search) - only your city and country are shown, never your exact position; Live weather banners on every profile with animations: rain, drizzle, thunderstorms with lightning, snow, fog, clouds, sunshine or a starry night - plus temperature, feels-like, humidity, wind and local time; Your own weather strip on top of the hub, and each friend's weather + local time in the friends list; Hide your location from others or remove it any time</a:t>
+                        <a:t>🤖 6 friendly chat bots in the Chat tab: Pip Helper (app questions), Coach Focus (focus tips from your real stats), Sunny (live weather for any city), Arena Master (battle tips + quick battle), Giggles (jokes &amp; games) and Guardian (safety &amp; reporting help); Private bot chats with suggestion chips, typing indicator and a clear button - your bot chats stay on your PC; Mention a bot in a group chat (e.g. @weather Batam) and it answers in the room for everyone; Bots reply in your app language; up to 120 bot messages per day</a:t>
                       </a:r>
                     </a:p>
                   </a:txBody>
@@ -10577,7 +10577,7 @@
                           </a:solidFill>
                           <a:latin typeface="Segoe UI"/>
                         </a:rPr>
-                        <a:t>2.8.0</a:t>
+                        <a:t>2.9.0</a:t>
                       </a:r>
                     </a:p>
                   </a:txBody>
@@ -10621,7 +10621,7 @@
                           </a:solidFill>
                           <a:latin typeface="Segoe UI"/>
                         </a:rPr>
-                        <a:t>Pips Arena - duels, gear &amp; live battles</a:t>
+                        <a:t>Location &amp; live weather</a:t>
                       </a:r>
                     </a:p>
                     <a:p>
@@ -10632,7 +10632,7 @@
                           </a:solidFill>
                           <a:latin typeface="Segoe UI"/>
                         </a:rPr>
-                        <a:t>⚔ New Arena tab: challenge friends or anyone in the arena to a live duel - each round pick Attack, Guard or Special within 12 seconds and watch your pets fight; ⚡ Quick battle: an instant auto-fight against anyone's fighter, even when they're offline; Arena gear in the Shop: 7 weapons (water pistol to rocket launcher), 5 armors and 5 gadgets that decide your special move - better gear and a higher level make a stronger fighter; Live duels can be watched by everyone, plus recent battle replays, top fighters, rating and win/loss records; wins earn coins</a:t>
+                        <a:t>📍 Add your city in Profile → Location &amp; weather (auto-detect or search) - only your city and country are shown, never your exact position; Live weather banners on every profile with animations: rain, drizzle, thunderstorms with lightning, snow, fog, clouds, sunshine or a starry night - plus temperature, feels-like, humidity, wind and local time; Your own weather strip on top of the hub, and each friend's weather + local time in the friends list; Hide your location from others or remove it any time</a:t>
                       </a:r>
                     </a:p>
                   </a:txBody>
@@ -10656,7 +10656,7 @@
                           </a:solidFill>
                           <a:latin typeface="Segoe UI"/>
                         </a:rPr>
-                        <a:t>2.7.0</a:t>
+                        <a:t>2.8.0</a:t>
                       </a:r>
                     </a:p>
                   </a:txBody>
@@ -10700,7 +10700,7 @@
                           </a:solidFill>
                           <a:latin typeface="Segoe UI"/>
                         </a:rPr>
-                        <a:t>Moderators &amp; Premium</a:t>
+                        <a:t>Pips Arena - duels, gear &amp; live battles</a:t>
                       </a:r>
                     </a:p>
                     <a:p>
@@ -10711,7 +10711,7 @@
                           </a:solidFill>
                           <a:latin typeface="Segoe UI"/>
                         </a:rPr>
-                        <a:t>★ Premium: a purple Premium badge, 4 exclusive props (tiara, star glasses, diamond necklace, fairy wings), the Fireworks move, +30 coins every day, double friend-interaction coins and room for 300 friends / 30 groups; Get Premium: Profile tab → Premium → "Ask to buy" emails the owner; after payment you receive a key (PIPS-XXXX-XXXX) to redeem right there; 🛡 Moderators: a blue Mod badge and a Mod tab with the report queue - warn, mute (1h / 24h / 7 days), clear a profile or reset a name; every action is logged; Report button on everyone's profile, so moderators can keep Pips friendly</a:t>
+                        <a:t>⚔ New Arena tab: challenge friends or anyone in the arena to a live duel - each round pick Attack, Guard or Special within 12 seconds and watch your pets fight; ⚡ Quick battle: an instant auto-fight against anyone's fighter, even when they're offline; Arena gear in the Shop: 7 weapons (water pistol to rocket launcher), 5 armors and 5 gadgets that decide your special move - better gear and a higher level make a stronger fighter; Live duels can be watched by everyone, plus recent battle replays, top fighters, rating and win/loss records; wins earn coins</a:t>
                       </a:r>
                     </a:p>
                   </a:txBody>
@@ -10735,7 +10735,7 @@
                           </a:solidFill>
                           <a:latin typeface="Segoe UI"/>
                         </a:rPr>
-                        <a:t>2.6.1</a:t>
+                        <a:t>2.7.0</a:t>
                       </a:r>
                     </a:p>
                   </a:txBody>
@@ -10779,7 +10779,7 @@
                           </a:solidFill>
                           <a:latin typeface="Segoe UI"/>
                         </a:rPr>
-                        <a:t>Owner badge &amp; credits</a:t>
+                        <a:t>Moderators &amp; Premium</a:t>
                       </a:r>
                     </a:p>
                     <a:p>
@@ -10790,7 +10790,7 @@
                           </a:solidFill>
                           <a:latin typeface="Segoe UI"/>
                         </a:rPr>
-                        <a:t>The creator of Pips (Juwen Lie) now shows a gold ♛ Owner badge on his profile, friend list and ranks; New About Pips card in the Profile tab: credits and how to contact the owner (Juwen_Lie@pegatroncorp.com) with Email and Copy buttons; Right-click the pet → Help → About now shows who made Pips and the contact email</a:t>
+                        <a:t>★ Premium: a purple Premium badge, 4 exclusive props (tiara, star glasses, diamond necklace, fairy wings), the Fireworks move, +30 coins every day, double friend-interaction coins and room for 300 friends / 30 groups; Get Premium: Profile tab → Premium → "Ask to buy" emails the owner; after payment you receive a key (PIPS-XXXX-XXXX) to redeem right there; 🛡 Moderators: a blue Mod badge and a Mod tab with the report queue - warn, mute (1h / 24h / 7 days), clear a profile or reset a name; every action is logged; Report button on everyone's profile, so moderators can keep Pips friendly</a:t>
                       </a:r>
                     </a:p>
                   </a:txBody>
@@ -10814,7 +10814,7 @@
                           </a:solidFill>
                           <a:latin typeface="Segoe UI"/>
                         </a:rPr>
-                        <a:t>2.6.0</a:t>
+                        <a:t>2.6.1</a:t>
                       </a:r>
                     </a:p>
                   </a:txBody>
@@ -10858,7 +10858,7 @@
                           </a:solidFill>
                           <a:latin typeface="Segoe UI"/>
                         </a:rPr>
-                        <a:t>Profiles, ranks, online status &amp; dark mode</a:t>
+                        <a:t>Owner badge &amp; credits</a:t>
                       </a:r>
                     </a:p>
                     <a:p>
@@ -10869,7 +10869,7 @@
                           </a:solidFill>
                           <a:latin typeface="Segoe UI"/>
                         </a:rPr>
-                        <a:t>Profile tab: profile picture (or your pet), about me, job, location, hobbies, birthday and a status message; Public or private: public profiles can be added directly and viewed in full; private profiles need a friend request that they accept, and strangers only see name, photo, pet, level and status; Click anyone to open their profile - badges, info, their friends - and add them, chat or wave from there; Ranks tab replaces Teams: everyone using Pips, sorted by XP, badges or streak</a:t>
+                        <a:t>The creator of Pips (Juwen Lie) now shows a gold ♛ Owner badge on his profile, friend list and ranks; New About Pips card in the Profile tab: credits and how to contact the owner (Juwen_Lie@pegatroncorp.com) with Email and Copy buttons; Right-click the pet → Help → About now shows who made Pips and the contact email</a:t>
                       </a:r>
                     </a:p>
                   </a:txBody>
@@ -10893,7 +10893,7 @@
                           </a:solidFill>
                           <a:latin typeface="Segoe UI"/>
                         </a:rPr>
-                        <a:t>2.5.1</a:t>
+                        <a:t>2.6.0</a:t>
                       </a:r>
                     </a:p>
                   </a:txBody>
@@ -10937,7 +10937,7 @@
                           </a:solidFill>
                           <a:latin typeface="Segoe UI"/>
                         </a:rPr>
-                        <a:t>New cute Pips logo</a:t>
+                        <a:t>Profiles, ranks, online status &amp; dark mode</a:t>
                       </a:r>
                     </a:p>
                     <a:p>
@@ -10948,7 +10948,7 @@
                           </a:solidFill>
                           <a:latin typeface="Segoe UI"/>
                         </a:rPr>
-                        <a:t>New Pips logo: Pip the cat on a Pips-red tile, matching the app colours (desktop shortcut, windows and website)</a:t>
+                        <a:t>Profile tab: profile picture (or your pet), about me, job, location, hobbies, birthday and a status message; Public or private: public profiles can be added directly and viewed in full; private profiles need a friend request that they accept, and strangers only see name, photo, pet, level and status; Click anyone to open their profile - badges, info, their friends - and add them, chat or wave from there; Ranks tab replaces Teams: everyone using Pips, sorted by XP, badges or streak</a:t>
                       </a:r>
                     </a:p>
                   </a:txBody>
@@ -10972,7 +10972,7 @@
                           </a:solidFill>
                           <a:latin typeface="Segoe UI"/>
                         </a:rPr>
-                        <a:t>2.5.0</a:t>
+                        <a:t>2.5.1</a:t>
                       </a:r>
                     </a:p>
                   </a:txBody>
@@ -11016,7 +11016,7 @@
                           </a:solidFill>
                           <a:latin typeface="Segoe UI"/>
                         </a:rPr>
-                        <a:t>Shop, coins, props &amp; moves</a:t>
+                        <a:t>New cute Pips logo</a:t>
                       </a:r>
                     </a:p>
                     <a:p>
@@ -11027,7 +11027,7 @@
                           </a:solidFill>
                           <a:latin typeface="Segoe UI"/>
                         </a:rPr>
-                        <a:t>Shop: earn coins and spend them on your pet - 17 props (crown, wizard hat, headphones, shades, scarf, cape, angel wings...) and 6 moves: spin, dance, moonwalk, backflip, kung fu and spider swing!; Coins come from leveling up (+40), badges (+25), opening Pips each day (+10), friendships (+15 per affinity level), waving / chatting / visiting friends (+2) and pomodoros (+5). Everyone starts with a 100-coin gift; Your friends see your props: on avatars in the hub and when your pet visits their desktop - it shows off one of your moves; Pips is now a social pet: clicking the pet opens the Pips hub (friends, chat, groups, shop, badges)</a:t>
+                        <a:t>New Pips logo: Pip the cat on a Pips-red tile, matching the app colours (desktop shortcut, windows and website)</a:t>
                       </a:r>
                     </a:p>
                   </a:txBody>
@@ -11051,7 +11051,7 @@
                           </a:solidFill>
                           <a:latin typeface="Segoe UI"/>
                         </a:rPr>
-                        <a:t>2.4.0</a:t>
+                        <a:t>2.5.0</a:t>
                       </a:r>
                     </a:p>
                   </a:txBody>
@@ -11095,7 +11095,7 @@
                           </a:solidFill>
                           <a:latin typeface="Segoe UI"/>
                         </a:rPr>
-                        <a:t>Chat, groups, affinity &amp; pet visits</a:t>
+                        <a:t>Shop, coins, props &amp; moves</a:t>
                       </a:r>
                     </a:p>
                     <a:p>
@@ -11106,7 +11106,7 @@
                           </a:solidFill>
                           <a:latin typeface="Segoe UI"/>
                         </a:rPr>
-                        <a:t>Chat: message your friends, and chat inside groups. Your pet pops up new messages as a bubble - click it to reply; Pet interactions: wave, pet their pet, send a snack, high five - or send your pet to visit: it walks onto your friend's desktop for a little while!; Affinity: every chat and interaction grows your friendship - Acquaintance → Buddy → Good friends → Close friends → Best friends → Soulmates; Your own groups: create a private group, invite your friends, they accept or decline. Group board + group chat; the owner can remove members</a:t>
+                        <a:t>Shop: earn coins and spend them on your pet - 17 props (crown, wizard hat, headphones, shades, scarf, cape, angel wings...) and 6 moves: spin, dance, moonwalk, backflip, kung fu and spider swing!; Coins come from leveling up (+40), badges (+25), opening Pips each day (+10), friendships (+15 per affinity level), waving / chatting / visiting friends (+2) and pomodoros (+5). Everyone starts with a 100-coin gift; Your friends see your props: on avatars in the hub and when your pet visits their desktop - it shows off one of your moves; Pips is now a social pet: clicking the pet opens the Pips hub (friends, chat, groups, shop, badges)</a:t>
                       </a:r>
                     </a:p>
                   </a:txBody>
@@ -11130,7 +11130,7 @@
                           </a:solidFill>
                           <a:latin typeface="Segoe UI"/>
                         </a:rPr>
-                        <a:t>2.3.0</a:t>
+                        <a:t>2.4.0</a:t>
                       </a:r>
                     </a:p>
                   </a:txBody>
@@ -11174,7 +11174,7 @@
                           </a:solidFill>
                           <a:latin typeface="Segoe UI"/>
                         </a:rPr>
-                        <a:t>Friends, levels &amp; achievements</a:t>
+                        <a:t>Chat, groups, affinity &amp; pet visits</a:t>
                       </a:r>
                     </a:p>
                     <a:p>
@@ -11185,7 +11185,7 @@
                           </a:solidFill>
                           <a:latin typeface="Segoe UI"/>
                         </a:rPr>
-                        <a:t>Levels &amp; XP: every finished pomodoro earns XP and your level grows - plus 20 achievements to unlock (first tomato, 8 in a day, 7-day streak, early bird, night owl, pet lover...). Your pet celebrates each one; Friends (optional, off by default): get a 6-letter friend code, add colleagues, see today's board and join a team board like PTB. Your pet tells you when a friend finishes a pomodoro; Privacy: only your name, pet, level, streak and pomodoro counts are shared - never apps, window titles or scores. One click turns it off and deletes your online data. Right-click the pet → Friends &amp; achievements…</a:t>
+                        <a:t>Chat: message your friends, and chat inside groups. Your pet pops up new messages as a bubble - click it to reply; Pet interactions: wave, pet their pet, send a snack, high five - or send your pet to visit: it walks onto your friend's desktop for a little while!; Affinity: every chat and interaction grows your friendship - Acquaintance → Buddy → Good friends → Close friends → Best friends → Soulmates; Your own groups: create a private group, invite your friends, they accept or decline. Group board + group chat; the owner can remove members</a:t>
                       </a:r>
                     </a:p>
                   </a:txBody>
@@ -11209,7 +11209,7 @@
                           </a:solidFill>
                           <a:latin typeface="Segoe UI"/>
                         </a:rPr>
-                        <a:t>2.2.0</a:t>
+                        <a:t>2.3.0</a:t>
                       </a:r>
                     </a:p>
                   </a:txBody>
@@ -11253,7 +11253,7 @@
                           </a:solidFill>
                           <a:latin typeface="Segoe UI"/>
                         </a:rPr>
-                        <a:t>Pet sounds</a:t>
+                        <a:t>Friends, levels &amp; achievements</a:t>
                       </a:r>
                     </a:p>
                     <a:p>
@@ -11264,7 +11264,7 @@
                           </a:solidFill>
                           <a:latin typeface="Segoe UI"/>
                         </a:rPr>
-                        <a:t>Your pet has a voice! Each of the 23 animals has its own sound (meow, woof, ribbit, hoot, buzz, oink, whale song...) and it changes with its mood: happy chirps, sad whimpers, sleepy yawns, hungry calls, grumpy huffs and soft snores; It also reacts with sound when you tickle, pet, feed, shake or wake it; Settings: right-click the pet → Sounds to switch on/off; Pet status &amp; settings has a volume slider, a ▶ Hear me button and "Stay quiet while I'm focusing" (on by default)</a:t>
+                        <a:t>Levels &amp; XP: every finished pomodoro earns XP and your level grows - plus 20 achievements to unlock (first tomato, 8 in a day, 7-day streak, early bird, night owl, pet lover...). Your pet celebrates each one; Friends (optional, off by default): get a 6-letter friend code, add colleagues, see today's board and join a team board like PTB. Your pet tells you when a friend finishes a pomodoro; Privacy: only your name, pet, level, streak and pomodoro counts are shared - never apps, window titles or scores. One click turns it off and deletes your online data. Right-click the pet → Friends &amp; achievements…</a:t>
                       </a:r>
                     </a:p>
                   </a:txBody>
@@ -11288,7 +11288,7 @@
                           </a:solidFill>
                           <a:latin typeface="Segoe UI"/>
                         </a:rPr>
-                        <a:t>2.1.2</a:t>
+                        <a:t>2.2.0</a:t>
                       </a:r>
                     </a:p>
                   </a:txBody>
@@ -11332,7 +11332,7 @@
                           </a:solidFill>
                           <a:latin typeface="Segoe UI"/>
                         </a:rPr>
-                        <a:t>Tickle-only mode</a:t>
+                        <a:t>Pet sounds</a:t>
                       </a:r>
                     </a:p>
                     <a:p>
@@ -11343,7 +11343,7 @@
                           </a:solidFill>
                           <a:latin typeface="Segoe UI"/>
                         </a:rPr>
-                        <a:t>New click option "Only tickle (never open Pips)": click and tickle your pet as much as you like - the Pomodoro window stays closed (open it from the right-click menu). Right-click the pet → When I click</a:t>
+                        <a:t>Your pet has a voice! Each of the 23 animals has its own sound (meow, woof, ribbit, hoot, buzz, oink, whale song...) and it changes with its mood: happy chirps, sad whimpers, sleepy yawns, hungry calls, grumpy huffs and soft snores; It also reacts with sound when you tickle, pet, feed, shake or wake it; Settings: right-click the pet → Sounds to switch on/off; Pet status &amp; settings has a volume slider, a ▶ Hear me button and "Stay quiet while I'm focusing" (on by default)</a:t>
                       </a:r>
                     </a:p>
                   </a:txBody>
@@ -11367,7 +11367,7 @@
                           </a:solidFill>
                           <a:latin typeface="Segoe UI"/>
                         </a:rPr>
-                        <a:t>2.1.1</a:t>
+                        <a:t>2.1.2</a:t>
                       </a:r>
                     </a:p>
                   </a:txBody>
@@ -11411,7 +11411,7 @@
                           </a:solidFill>
                           <a:latin typeface="Segoe UI"/>
                         </a:rPr>
-                        <a:t>Owner info</a:t>
+                        <a:t>Tickle-only mode</a:t>
                       </a:r>
                     </a:p>
                     <a:p>
@@ -11422,7 +11422,7 @@
                           </a:solidFill>
                           <a:latin typeface="Segoe UI"/>
                         </a:rPr>
-                        <a:t>About Pips now shows the owner: Juwen Lie (right-click the pet → Help → About)</a:t>
+                        <a:t>New click option "Only tickle (never open Pips)": click and tickle your pet as much as you like - the Pomodoro window stays closed (open it from the right-click menu). Right-click the pet → When I click</a:t>
                       </a:r>
                     </a:p>
                   </a:txBody>
@@ -11446,7 +11446,7 @@
                           </a:solidFill>
                           <a:latin typeface="Segoe UI"/>
                         </a:rPr>
-                        <a:t>2.1.0</a:t>
+                        <a:t>2.1.1</a:t>
                       </a:r>
                     </a:p>
                   </a:txBody>
@@ -11490,7 +11490,7 @@
                           </a:solidFill>
                           <a:latin typeface="Segoe UI"/>
                         </a:rPr>
-                        <a:t>Interactive guide &amp; in-app updates</a:t>
+                        <a:t>Owner info</a:t>
                       </a:r>
                     </a:p>
                     <a:p>
@@ -11501,7 +11501,7 @@
                           </a:solidFill>
                           <a:latin typeface="Segoe UI"/>
                         </a:rPr>
-                        <a:t>Interactive first-run guide: your pet walks you through clicking, dragging, petting and the right-click menu; In-app updates: Pips tells you when a new version is out - update with one click (your settings and data are kept); New Help menu: replay the guide, check for updates, see the version; Option to turn automatic update checks off</a:t>
+                        <a:t>About Pips now shows the owner: Juwen Lie (right-click the pet → Help → About)</a:t>
                       </a:r>
                     </a:p>
                   </a:txBody>
@@ -11525,7 +11525,7 @@
                           </a:solidFill>
                           <a:latin typeface="Segoe UI"/>
                         </a:rPr>
-                        <a:t>2.0.0</a:t>
+                        <a:t>2.1.0</a:t>
                       </a:r>
                     </a:p>
                   </a:txBody>
@@ -11569,7 +11569,7 @@
                           </a:solidFill>
                           <a:latin typeface="Segoe UI"/>
                         </a:rPr>
-                        <a:t>Desktop pet, 23 animals &amp; 4 languages</a:t>
+                        <a:t>Interactive guide &amp; in-app updates</a:t>
                       </a:r>
                     </a:p>
                     <a:p>
@@ -11580,7 +11580,7 @@
                           </a:solidFill>
                           <a:latin typeface="Segoe UI"/>
                         </a:rPr>
-                        <a:t>Desktop pet that lives on your desktop and taskbar - drag it, tickle it, pet it; 23 animals in 3 groups: Land walks, Water swims with bubbles, Sky hovers and flaps; Moods (happy, sad, tired, hungry, grumpy...), naps when you're away, wakes up when you're back; Cute chat-bubble reminders: breaks, water, 20-20-20 eye rest, pomodoro done, daily goal</a:t>
+                        <a:t>Interactive first-run guide: your pet walks you through clicking, dragging, petting and the right-click menu; In-app updates: Pips tells you when a new version is out - update with one click (your settings and data are kept); New Help menu: replay the guide, check for updates, see the version; Option to turn automatic update checks off</a:t>
                       </a:r>
                     </a:p>
                   </a:txBody>
@@ -11604,7 +11604,7 @@
                           </a:solidFill>
                           <a:latin typeface="Segoe UI"/>
                         </a:rPr>
-                        <a:t>1.5.0</a:t>
+                        <a:t>2.0.0</a:t>
                       </a:r>
                     </a:p>
                   </a:txBody>
@@ -11626,7 +11626,7 @@
                           </a:solidFill>
                           <a:latin typeface="Segoe UI"/>
                         </a:rPr>
-                        <a:t>2026-10-24</a:t>
+                        <a:t>2026-10-28</a:t>
                       </a:r>
                     </a:p>
                   </a:txBody>
@@ -11648,7 +11648,7 @@
                           </a:solidFill>
                           <a:latin typeface="Segoe UI"/>
                         </a:rPr>
-                        <a:t>Renamed to Pips + insights</a:t>
+                        <a:t>Desktop pet, 23 animals &amp; 4 languages</a:t>
                       </a:r>
                     </a:p>
                     <a:p>
@@ -11659,7 +11659,7 @@
                           </a:solidFill>
                           <a:latin typeface="Segoe UI"/>
                         </a:rPr>
-                        <a:t>Renamed from Productivity Widget to Pips; Dashboard charts: focus timeline, hour heatmap, 7-day score trend, pomodoros per day; AI token usage on the card and dashboard; Daily diary export and weekly / monthly reports</a:t>
+                        <a:t>Desktop pet that lives on your desktop and taskbar - drag it, tickle it, pet it; 23 animals in 3 groups: Land walks, Water swims with bubbles, Sky hovers and flaps; Moods (happy, sad, tired, hungry, grumpy...), naps when you're away, wakes up when you're back; Cute chat-bubble reminders: breaks, water, 20-20-20 eye rest, pomodoro done, daily goal</a:t>
                       </a:r>
                     </a:p>
                   </a:txBody>
@@ -11683,13 +11683,92 @@
                           </a:solidFill>
                           <a:latin typeface="Segoe UI"/>
                         </a:rPr>
+                        <a:t>1.5.0</a:t>
+                      </a:r>
+                    </a:p>
+                  </a:txBody>
+                  <a:tcPr marL="73152" marR="73152" marT="36576" marB="36576">
+                    <a:solidFill>
+                      <a:srgbClr val="FFFDF8"/>
+                    </a:solidFill>
+                  </a:tcPr>
+                </a:tc>
+                <a:tc>
+                  <a:txBody>
+                    <a:bodyPr wrap="square"/>
+                    <a:lstStyle/>
+                    <a:p>
+                      <a:r>
+                        <a:rPr sz="1200" b="0">
+                          <a:solidFill>
+                            <a:srgbClr val="2B2A28"/>
+                          </a:solidFill>
+                          <a:latin typeface="Segoe UI"/>
+                        </a:rPr>
+                        <a:t>2026-10-24</a:t>
+                      </a:r>
+                    </a:p>
+                  </a:txBody>
+                  <a:tcPr marL="73152" marR="73152" marT="36576" marB="36576">
+                    <a:solidFill>
+                      <a:srgbClr val="FFFDF8"/>
+                    </a:solidFill>
+                  </a:tcPr>
+                </a:tc>
+                <a:tc>
+                  <a:txBody>
+                    <a:bodyPr wrap="square"/>
+                    <a:lstStyle/>
+                    <a:p>
+                      <a:r>
+                        <a:rPr sz="1200" b="0">
+                          <a:solidFill>
+                            <a:srgbClr val="2B2A28"/>
+                          </a:solidFill>
+                          <a:latin typeface="Segoe UI"/>
+                        </a:rPr>
+                        <a:t>Renamed to Pips + insights</a:t>
+                      </a:r>
+                    </a:p>
+                    <a:p>
+                      <a:r>
+                        <a:rPr sz="1200" b="0">
+                          <a:solidFill>
+                            <a:srgbClr val="2B2A28"/>
+                          </a:solidFill>
+                          <a:latin typeface="Segoe UI"/>
+                        </a:rPr>
+                        <a:t>Renamed from Productivity Widget to Pips; Dashboard charts: focus timeline, hour heatmap, 7-day score trend, pomodoros per day; AI token usage on the card and dashboard; Daily diary export and weekly / monthly reports</a:t>
+                      </a:r>
+                    </a:p>
+                  </a:txBody>
+                  <a:tcPr marL="73152" marR="73152" marT="36576" marB="36576">
+                    <a:solidFill>
+                      <a:srgbClr val="FFFDF8"/>
+                    </a:solidFill>
+                  </a:tcPr>
+                </a:tc>
+              </a:tr>
+              <a:tr h="822960">
+                <a:tc>
+                  <a:txBody>
+                    <a:bodyPr wrap="square"/>
+                    <a:lstStyle/>
+                    <a:p>
+                      <a:r>
+                        <a:rPr sz="1200" b="1">
+                          <a:solidFill>
+                            <a:srgbClr val="2B2A28"/>
+                          </a:solidFill>
+                          <a:latin typeface="Segoe UI"/>
+                        </a:rPr>
                         <a:t>1.0.0</a:t>
                       </a:r>
                     </a:p>
                   </a:txBody>
                   <a:tcPr marL="73152" marR="73152" marT="36576" marB="36576">
                     <a:solidFill>
-                      <a:srgbClr val="FFFDF8"/>
+                      <a:srgbClr val="F7F4EC"/>
                     </a:solidFill>
                   </a:tcPr>
                 </a:tc>
@@ -11711,7 +11790,7 @@
                   </a:txBody>
                   <a:tcPr marL="73152" marR="73152" marT="36576" marB="36576">
                     <a:solidFill>
-                      <a:srgbClr val="FFFDF8"/>
+                      <a:srgbClr val="F7F4EC"/>
                     </a:solidFill>
                   </a:tcPr>
                 </a:tc>
@@ -11744,7 +11823,7 @@
                   </a:txBody>
                   <a:tcPr marL="73152" marR="73152" marT="36576" marB="36576">
                     <a:solidFill>
-                      <a:srgbClr val="FFFDF8"/>
+                      <a:srgbClr val="F7F4EC"/>
                     </a:solidFill>
                   </a:tcPr>
                 </a:tc>

</xml_diff>

<commit_message>
pips 2.24.2: Auto battle
</commit_message>
<xml_diff>
--- a/apps/pips/web/download/Pips-Guide.pptx
+++ b/apps/pips/web/download/Pips-Guide.pptx
@@ -3292,7 +3292,7 @@
                 </a:solidFill>
                 <a:latin typeface="Segoe UI"/>
               </a:rPr>
-              <a:t>Version 2.24.1  ·  2026-10-29  ·  Made by Juwen Lie (owner)</a:t>
+              <a:t>Version 2.24.2  ·  2026-10-29  ·  Made by Juwen Lie (owner)</a:t>
             </a:r>
           </a:p>
           <a:p>
@@ -8279,7 +8279,7 @@
                 </a:solidFill>
                 <a:latin typeface="Segoe UI"/>
               </a:rPr>
-              <a:t>What's new in 2.24.1</a:t>
+              <a:t>What's new in 2.24.2</a:t>
             </a:r>
           </a:p>
         </p:txBody>
@@ -8392,7 +8392,7 @@
                 </a:solidFill>
                 <a:latin typeface="Segoe UI"/>
               </a:rPr>
-              <a:t>No more surprise pop-ups  ·  2026-10-29</a:t>
+              <a:t>Auto battle  ·  2026-10-29</a:t>
             </a:r>
           </a:p>
         </p:txBody>
@@ -8440,7 +8440,7 @@
                 </a:solidFill>
                 <a:latin typeface="Segoe UI"/>
               </a:rPr>
-              <a:t>Clicking your pet now only tickles it - no window pops up. Double-click the pet to open the hub (or use the right-click menu).</a:t>
+              <a:t>Arena battles can now play themselves: switch on 🤖 Auto (button in the battle, the A key, or the tick box before a fight) and your pet picks its skills - it finishes off a weak opponent, heals when low and saves Focus for long fights.</a:t>
             </a:r>
           </a:p>
           <a:p>
@@ -8465,7 +8465,7 @@
                 </a:solidFill>
                 <a:latin typeface="Segoe UI"/>
               </a:rPr>
-              <a:t>The focus card and the dashboard stay hidden when Pips starts; open them only when you want them.</a:t>
+              <a:t>Prefer to play yourself? Leave Auto off and press the skill buttons (or keys 1-3) as before. You can switch any time, even mid-battle.</a:t>
             </a:r>
           </a:p>
           <a:p>
@@ -8490,7 +8490,7 @@
                 </a:solidFill>
                 <a:latin typeface="Segoe UI"/>
               </a:rPr>
-              <a:t>Prefer the old way? Right-click → Settings → When I click the pet.</a:t>
+              <a:t>Your choice is remembered for the next fight.</a:t>
             </a:r>
           </a:p>
         </p:txBody>
@@ -8621,7 +8621,7 @@
                 </a:solidFill>
                 <a:latin typeface="Segoe UI"/>
               </a:rPr>
-              <a:t>Klik pet sekarang hanya menggelitik - tidak ada jendela yang muncul. Klik dua kali pet untuk membuka hub (atau pakai menu klik kanan).</a:t>
+              <a:t>Duel arena kini bisa main sendiri: nyalakan 🤖 Otomatis (tombol di pertarungan, tombol A, atau centang sebelum bertarung) dan pet memilih skill sendiri - menghabisi lawan yang lemah, menyembuhkan diri saat HP rendah, dan memakai Fokus di pertarungan panjang.</a:t>
             </a:r>
           </a:p>
           <a:p>
@@ -8646,7 +8646,7 @@
                 </a:solidFill>
                 <a:latin typeface="Segoe UI"/>
               </a:rPr>
-              <a:t>Kartu fokus dan dashboard tetap tersembunyi saat Pips dimulai; buka hanya saat kamu mau.</a:t>
+              <a:t>Mau main sendiri? Biarkan Otomatis mati dan tekan tombol skill (atau 1-3) seperti biasa. Bisa diganti kapan saja, bahkan di tengah pertarungan.</a:t>
             </a:r>
           </a:p>
           <a:p>
@@ -8671,7 +8671,7 @@
                 </a:solidFill>
                 <a:latin typeface="Segoe UI"/>
               </a:rPr>
-              <a:t>Suka cara lama? Klik kanan → Pengaturan → Saat peliharaan diklik.</a:t>
+              <a:t>Pilihanmu diingat untuk pertarungan berikutnya.</a:t>
             </a:r>
           </a:p>
         </p:txBody>
@@ -8903,7 +8903,7 @@
         </p:nvGraphicFramePr>
         <p:xfrm>
           <a:off x="548640" y="1645920"/>
-          <a:ext cx="11155680" cy="30010608"/>
+          <a:ext cx="11155680" cy="30833568"/>
         </p:xfrm>
         <a:graphic>
           <a:graphicData uri="http://schemas.openxmlformats.org/drawingml/2006/table">
@@ -8997,7 +8997,7 @@
                           </a:solidFill>
                           <a:latin typeface="Segoe UI"/>
                         </a:rPr>
-                        <a:t>2.24.1</a:t>
+                        <a:t>2.24.2</a:t>
                       </a:r>
                     </a:p>
                   </a:txBody>
@@ -9041,7 +9041,7 @@
                           </a:solidFill>
                           <a:latin typeface="Segoe UI"/>
                         </a:rPr>
-                        <a:t>No more surprise pop-ups</a:t>
+                        <a:t>Auto battle</a:t>
                       </a:r>
                     </a:p>
                     <a:p>
@@ -9052,7 +9052,7 @@
                           </a:solidFill>
                           <a:latin typeface="Segoe UI"/>
                         </a:rPr>
-                        <a:t>Clicking your pet now only tickles it - no window pops up. Double-click the pet to open the hub (or use the right-click menu).; The focus card and the dashboard stay hidden when Pips starts; open them only when you want them.; Prefer the old way? Right-click → Settings → When I click the pet.</a:t>
+                        <a:t>Arena battles can now play themselves: switch on 🤖 Auto (button in the battle, the A key, or the tick box before a fight) and your pet picks its skills - it finishes off a weak opponent, heals when low and saves Focus for long fights.; Prefer to play yourself? Leave Auto off and press the skill buttons (or keys 1-3) as before. You can switch any time, even mid-battle.; Your choice is remembered for the next fight.</a:t>
                       </a:r>
                     </a:p>
                   </a:txBody>
@@ -9076,7 +9076,7 @@
                           </a:solidFill>
                           <a:latin typeface="Segoe UI"/>
                         </a:rPr>
-                        <a:t>2.24.0</a:t>
+                        <a:t>2.24.1</a:t>
                       </a:r>
                     </a:p>
                   </a:txBody>
@@ -9120,7 +9120,7 @@
                           </a:solidFill>
                           <a:latin typeface="Segoe UI"/>
                         </a:rPr>
-                        <a:t>Skill battles, minigames &amp; a simpler Hub</a:t>
+                        <a:t>No more surprise pop-ups</a:t>
                       </a:r>
                     </a:p>
                     <a:p>
@@ -9131,7 +9131,7 @@
                           </a:solidFill>
                           <a:latin typeface="Segoe UI"/>
                         </a:rPr>
-                        <a:t>Arena battles are now turn-based: before a fight compare both pets' stats (level + gear), pick 3 skills, and the challenger chooses best of 1, 3 or 5 rounds. Take turns until one pet is knocked out - new skills unlock as you level up and with weapons and gadgets.; 5 new minigames to play with your pet: Treat Catch, Bonk the Bugs, Memory Match, Pet Says and Hop Hop. Best scores are saved and great scores earn a few coins (right-click → Games, or Hub → Play).; The Hub is simpler: 5 tabs - Friends, Chat (messages + groups), Play (arena, minigames, ranks), Shop and Me (profile + achievements).</a:t>
+                        <a:t>Clicking your pet now only tickles it - no window pops up. Double-click the pet to open the hub (or use the right-click menu).; The focus card and the dashboard stay hidden when Pips starts; open them only when you want them.; Prefer the old way? Right-click → Settings → When I click the pet.</a:t>
                       </a:r>
                     </a:p>
                   </a:txBody>
@@ -9155,7 +9155,7 @@
                           </a:solidFill>
                           <a:latin typeface="Segoe UI"/>
                         </a:rPr>
-                        <a:t>2.23.0</a:t>
+                        <a:t>2.24.0</a:t>
                       </a:r>
                     </a:p>
                   </a:txBody>
@@ -9199,7 +9199,7 @@
                           </a:solidFill>
                           <a:latin typeface="Segoe UI"/>
                         </a:rPr>
-                        <a:t>Weather on your desktop</a:t>
+                        <a:t>Skill battles, minigames &amp; a simpler Hub</a:t>
                       </a:r>
                     </a:p>
                     <a:p>
@@ -9210,7 +9210,7 @@
                           </a:solidFill>
                           <a:latin typeface="Segoe UI"/>
                         </a:rPr>
-                        <a:t>Your pet now shows the live weather right on your desktop: its own little rain cloud with an umbrella when it rains, a dark storm cloud with lightning, snow piling up at its feet, the sun, the moon and twinkling stars at night, drifting fog and leaves blowing in the wind. Prefer more? Switch the animation to the whole screen - or turn it off.; New right-click menu → Weather &amp; location: Follow my exact location (Windows location; a laptop is followed as you move), Approximate (from your internet connection), or Pick a place - search a city or paste exact coordinates from Google Maps. The pet tells you when the weather changes.; Works without Pips Friends (weather from Open-Meteo, no account needed). With Friends on, your profile city follows you too - but a city you hid stays hidden. If Windows location is turned off on your PC, Pips explains how to turn it on and uses your internet location meanwhile.</a:t>
+                        <a:t>Arena battles are now turn-based: before a fight compare both pets' stats (level + gear), pick 3 skills, and the challenger chooses best of 1, 3 or 5 rounds. Take turns until one pet is knocked out - new skills unlock as you level up and with weapons and gadgets.; 5 new minigames to play with your pet: Treat Catch, Bonk the Bugs, Memory Match, Pet Says and Hop Hop. Best scores are saved and great scores earn a few coins (right-click → Games, or Hub → Play).; The Hub is simpler: 5 tabs - Friends, Chat (messages + groups), Play (arena, minigames, ranks), Shop and Me (profile + achievements).</a:t>
                       </a:r>
                     </a:p>
                   </a:txBody>
@@ -9234,7 +9234,7 @@
                           </a:solidFill>
                           <a:latin typeface="Segoe UI"/>
                         </a:rPr>
-                        <a:t>2.22.0</a:t>
+                        <a:t>2.23.0</a:t>
                       </a:r>
                     </a:p>
                   </a:txBody>
@@ -9278,7 +9278,7 @@
                           </a:solidFill>
                           <a:latin typeface="Segoe UI"/>
                         </a:rPr>
-                        <a:t>Sing &amp; dance with music</a:t>
+                        <a:t>Weather on your desktop</a:t>
                       </a:r>
                     </a:p>
                     <a:p>
@@ -9289,7 +9289,7 @@
                           </a:solidFill>
                           <a:latin typeface="Segoe UI"/>
                         </a:rPr>
-                        <a:t>Sing, Dance, Moonwalk, Breakdance, Yoga, Rain dance and the show tricks now play real music. When your pet sings, it sings the melody in its own voice - a cat meows the tune, a frog ribbits it, a whale hums it - and when it dances, its animal call joins the beat.; Pick the song: right-click → Do a trick → Song for sing &amp; dance. Choose your animal's own song (every one of the 51 animals has its own tune), the song for its type (Meadow Hoedown for land, Ocean Calypso for water, Cloud Waltz for sky), Happy Pop, Disco Night, 8-bit Adventure, Lullaby, Lo-fi Chill, any other animal's song, Surprise me or No music.; Songs follow your sound settings (volume, sounds off, quiet during focus) and stop as soon as the trick is interrupted. Tricks your pet does by itself stay quiet.</a:t>
+                        <a:t>Your pet now shows the live weather right on your desktop: its own little rain cloud with an umbrella when it rains, a dark storm cloud with lightning, snow piling up at its feet, the sun, the moon and twinkling stars at night, drifting fog and leaves blowing in the wind. Prefer more? Switch the animation to the whole screen - or turn it off.; New right-click menu → Weather &amp; location: Follow my exact location (Windows location; a laptop is followed as you move), Approximate (from your internet connection), or Pick a place - search a city or paste exact coordinates from Google Maps. The pet tells you when the weather changes.; Works without Pips Friends (weather from Open-Meteo, no account needed). With Friends on, your profile city follows you too - but a city you hid stays hidden. If Windows location is turned off on your PC, Pips explains how to turn it on and uses your internet location meanwhile.</a:t>
                       </a:r>
                     </a:p>
                   </a:txBody>
@@ -9313,7 +9313,7 @@
                           </a:solidFill>
                           <a:latin typeface="Segoe UI"/>
                         </a:rPr>
-                        <a:t>2.21.0</a:t>
+                        <a:t>2.22.0</a:t>
                       </a:r>
                     </a:p>
                   </a:txBody>
@@ -9357,7 +9357,7 @@
                           </a:solidFill>
                           <a:latin typeface="Segoe UI"/>
                         </a:rPr>
-                        <a:t>Every animal has a voice</a:t>
+                        <a:t>Sing &amp; dance with music</a:t>
                       </a:r>
                     </a:p>
                     <a:p>
@@ -9368,7 +9368,7 @@
                           </a:solidFill>
                           <a:latin typeface="Segoe UI"/>
                         </a:rPr>
-                        <a:t>All 51 animals now have their own sound. Before, more than half of them borrowed the cat's meow - now the dog woofs, the cow moos, the sheep baas, the lion roars, the duck quacks, the dolphin clicks and whistles, the dragon flaps and roars with a puff of fire, the ghost goes wooo... and so on.; Every mood sounds different too: happy, sad, sleepy, hungry or grumpy. Petting, eating and snoring sound right for each kind of animal - furry ones purr and crunch, birds trill and peck, sea animals blow bubbles, bugs hum and magic pets chime.; A friend's pet that comes to visit now talks in its own voice: it says hi when it arrives and answers when you wave, pet it or give it a snack (it follows your sound settings).</a:t>
+                        <a:t>Sing, Dance, Moonwalk, Breakdance, Yoga, Rain dance and the show tricks now play real music. When your pet sings, it sings the melody in its own voice - a cat meows the tune, a frog ribbits it, a whale hums it - and when it dances, its animal call joins the beat.; Pick the song: right-click → Do a trick → Song for sing &amp; dance. Choose your animal's own song (every one of the 51 animals has its own tune), the song for its type (Meadow Hoedown for land, Ocean Calypso for water, Cloud Waltz for sky), Happy Pop, Disco Night, 8-bit Adventure, Lullaby, Lo-fi Chill, any other animal's song, Surprise me or No music.; Songs follow your sound settings (volume, sounds off, quiet during focus) and stop as soon as the trick is interrupted. Tricks your pet does by itself stay quiet.</a:t>
                       </a:r>
                     </a:p>
                   </a:txBody>
@@ -9392,7 +9392,7 @@
                           </a:solidFill>
                           <a:latin typeface="Segoe UI"/>
                         </a:rPr>
-                        <a:t>2.20.0</a:t>
+                        <a:t>2.21.0</a:t>
                       </a:r>
                     </a:p>
                   </a:txBody>
@@ -9436,7 +9436,7 @@
                           </a:solidFill>
                           <a:latin typeface="Segoe UI"/>
                         </a:rPr>
-                        <a:t>Come over</a:t>
+                        <a:t>Every animal has a voice</a:t>
                       </a:r>
                     </a:p>
                     <a:p>
@@ -9447,7 +9447,7 @@
                           </a:solidFill>
                           <a:latin typeface="Segoe UI"/>
                         </a:rPr>
-                        <a:t>When a friend's pet comes over it now wears a name tag: your friend's name (or the nickname you gave them), ♂/♀ and an online dot. It walks up to your pet, says hi, and looks at your mouse when you point at it.; Point at the visitor (or click its name tag) to open its card: whose pet it is, level, how close you two are, and buttons to wave, pet it, give it a snack, visit back or chat. It reacts to everything - hearts, crumbs, happy faces - and your friend sees it too.; Rub your mouse over the visitor to pet it. Playing with it makes it stay longer, and your pet comes down from a window or the sky to meet it.</a:t>
+                        <a:t>All 51 animals now have their own sound. Before, more than half of them borrowed the cat's meow - now the dog woofs, the cow moos, the sheep baas, the lion roars, the duck quacks, the dolphin clicks and whistles, the dragon flaps and roars with a puff of fire, the ghost goes wooo... and so on.; Every mood sounds different too: happy, sad, sleepy, hungry or grumpy. Petting, eating and snoring sound right for each kind of animal - furry ones purr and crunch, birds trill and peck, sea animals blow bubbles, bugs hum and magic pets chime.; A friend's pet that comes to visit now talks in its own voice: it says hi when it arrives and answers when you wave, pet it or give it a snack (it follows your sound settings).</a:t>
                       </a:r>
                     </a:p>
                   </a:txBody>
@@ -9471,7 +9471,7 @@
                           </a:solidFill>
                           <a:latin typeface="Segoe UI"/>
                         </a:rPr>
-                        <a:t>2.19.0</a:t>
+                        <a:t>2.20.0</a:t>
                       </a:r>
                     </a:p>
                   </a:txBody>
@@ -9515,7 +9515,7 @@
                           </a:solidFill>
                           <a:latin typeface="Segoe UI"/>
                         </a:rPr>
-                        <a:t>Land, sea &amp; sky</a:t>
+                        <a:t>Come over</a:t>
                       </a:r>
                     </a:p>
                     <a:p>
@@ -9526,7 +9526,7 @@
                           </a:solidFill>
                           <a:latin typeface="Segoe UI"/>
                         </a:rPr>
-                        <a:t>Land animals walk on the taskbar and on top of your open windows now: they jump up onto window edges, walk along them, ride along when you move the window and hop down when it closes, gets covered or is maximised. They always have gravity - let go of one in mid-air and it lands on the window below or on the taskbar.; Water animals swim along the taskbar (their water) and every now and then leap high out of it in a big arc, diving back in with a splash, ripples and spray. Drop one anywhere and it dives back into the water.; Flying animals fly anywhere on the screen: they flutter from place to place, hover, come say hi near your mouse, and sometimes perch on the taskbar or a window edge for a rest. Point at one and it waits for you; they glide down to a perch before a nap.; New menu moves: Jump onto a window, Splash jump!, Fly around / Rest on the taskbar. "Move around by myself" in Pet settings keeps your pet still if you prefer (the old Gravity option is gone - land animals always fall now).</a:t>
+                        <a:t>When a friend's pet comes over it now wears a name tag: your friend's name (or the nickname you gave them), ♂/♀ and an online dot. It walks up to your pet, says hi, and looks at your mouse when you point at it.; Point at the visitor (or click its name tag) to open its card: whose pet it is, level, how close you two are, and buttons to wave, pet it, give it a snack, visit back or chat. It reacts to everything - hearts, crumbs, happy faces - and your friend sees it too.; Rub your mouse over the visitor to pet it. Playing with it makes it stay longer, and your pet comes down from a window or the sky to meet it.</a:t>
                       </a:r>
                     </a:p>
                   </a:txBody>
@@ -9550,7 +9550,7 @@
                           </a:solidFill>
                           <a:latin typeface="Segoe UI"/>
                         </a:rPr>
-                        <a:t>2.18.0</a:t>
+                        <a:t>2.19.0</a:t>
                       </a:r>
                     </a:p>
                   </a:txBody>
@@ -9594,7 +9594,7 @@
                           </a:solidFill>
                           <a:latin typeface="Segoe UI"/>
                         </a:rPr>
-                        <a:t>Raise your pet</a:t>
+                        <a:t>Land, sea &amp; sky</a:t>
                       </a:r>
                     </a:p>
                     <a:p>
@@ -9605,7 +9605,7 @@
                           </a:solidFill>
                           <a:latin typeface="Segoe UI"/>
                         </a:rPr>
-                        <a:t>Boy or girl? Pick your pet's gender in Settings: boys get a little hair tuft, girls a pink bow and eyelashes, and a ♂ / ♀ shows next to its name. You can add your own gender to your profile too - friends see a small ♂ / ♀ next to your name.; Pets grow up now: baby → child → teen → grown-up. Focus sessions, opening Pips each day, games and cuddles help them grow - no care mistakes, no bad endings. Already have a grown-up pet? It will ask whether you'd like to raise it again from a baby (coins, items and stats stay).; Sick days: work 2.5 hours without a 5-minute break and your pet catches a little cold (sneezes, thermometer, slow steps). A short break cures it - or give medicine from the menu. You can turn this off in Settings.; New mini-game Left or Right? (pet menu → Play): guess which way your pet will look - 3 out of 5 wins, with coins for your first wins each day.</a:t>
+                        <a:t>Land animals walk on the taskbar and on top of your open windows now: they jump up onto window edges, walk along them, ride along when you move the window and hop down when it closes, gets covered or is maximised. They always have gravity - let go of one in mid-air and it lands on the window below or on the taskbar.; Water animals swim along the taskbar (their water) and every now and then leap high out of it in a big arc, diving back in with a splash, ripples and spray. Drop one anywhere and it dives back into the water.; Flying animals fly anywhere on the screen: they flutter from place to place, hover, come say hi near your mouse, and sometimes perch on the taskbar or a window edge for a rest. Point at one and it waits for you; they glide down to a perch before a nap.; New menu moves: Jump onto a window, Splash jump!, Fly around / Rest on the taskbar. "Move around by myself" in Pet settings keeps your pet still if you prefer (the old Gravity option is gone - land animals always fall now).</a:t>
                       </a:r>
                     </a:p>
                   </a:txBody>
@@ -9629,7 +9629,7 @@
                           </a:solidFill>
                           <a:latin typeface="Segoe UI"/>
                         </a:rPr>
-                        <a:t>2.17.0</a:t>
+                        <a:t>2.18.0</a:t>
                       </a:r>
                     </a:p>
                   </a:txBody>
@@ -9673,7 +9673,7 @@
                           </a:solidFill>
                           <a:latin typeface="Segoe UI"/>
                         </a:rPr>
-                        <a:t>Find your pet anytime</a:t>
+                        <a:t>Raise your pet</a:t>
                       </a:r>
                     </a:p>
                     <a:p>
@@ -9684,7 +9684,7 @@
                           </a:solidFill>
                           <a:latin typeface="Segoe UI"/>
                         </a:rPr>
-                        <a:t>Pips now has an icon next to the clock: click it to bring your pet back; right-click for the focus timer, Friends &amp; chat or Quit.; Press Ctrl+Alt+P anywhere to call your pet - it pops up on the screen you're using, even if it was hidden, asleep or behind a fullscreen app.; Opening Pips again from the Start menu or desktop does the same, and your pet walks back by itself if it ever ends up off-screen (e.g. after unplugging a monitor).; Hiding your pet now tells you how to bring it back.</a:t>
+                        <a:t>Boy or girl? Pick your pet's gender in Settings: boys get a little hair tuft, girls a pink bow and eyelashes, and a ♂ / ♀ shows next to its name. You can add your own gender to your profile too - friends see a small ♂ / ♀ next to your name.; Pets grow up now: baby → child → teen → grown-up. Focus sessions, opening Pips each day, games and cuddles help them grow - no care mistakes, no bad endings. Already have a grown-up pet? It will ask whether you'd like to raise it again from a baby (coins, items and stats stay).; Sick days: work 2.5 hours without a 5-minute break and your pet catches a little cold (sneezes, thermometer, slow steps). A short break cures it - or give medicine from the menu. You can turn this off in Settings.; New mini-game Left or Right? (pet menu → Play): guess which way your pet will look - 3 out of 5 wins, with coins for your first wins each day.</a:t>
                       </a:r>
                     </a:p>
                   </a:txBody>
@@ -9708,7 +9708,7 @@
                           </a:solidFill>
                           <a:latin typeface="Segoe UI"/>
                         </a:rPr>
-                        <a:t>2.16.0</a:t>
+                        <a:t>2.17.0</a:t>
                       </a:r>
                     </a:p>
                   </a:txBody>
@@ -9752,7 +9752,7 @@
                           </a:solidFill>
                           <a:latin typeface="Segoe UI"/>
                         </a:rPr>
-                        <a:t>Pips Community</a:t>
+                        <a:t>Find your pet anytime</a:t>
                       </a:r>
                     </a:p>
                     <a:p>
@@ -9763,7 +9763,7 @@
                           </a:solidFill>
                           <a:latin typeface="Segoe UI"/>
                         </a:rPr>
-                        <a:t>New Pips Community at the top of the Chat tab: a #general channel to chat with everyone who uses Pips, plus #announcements with news from the Pips team.; Every new Pips version is announced there automatically - see what's new and update with one click.; Type @name to ping someone in #general. Mute #general any time; owner and moderators can remove messages.; Open it from your pet's menu too (Pips Community). Fixed: chats no longer clear what you're typing when Pips refreshes in the background.</a:t>
+                        <a:t>Pips now has an icon next to the clock: click it to bring your pet back; right-click for the focus timer, Friends &amp; chat or Quit.; Press Ctrl+Alt+P anywhere to call your pet - it pops up on the screen you're using, even if it was hidden, asleep or behind a fullscreen app.; Opening Pips again from the Start menu or desktop does the same, and your pet walks back by itself if it ever ends up off-screen (e.g. after unplugging a monitor).; Hiding your pet now tells you how to bring it back.</a:t>
                       </a:r>
                     </a:p>
                   </a:txBody>
@@ -9787,7 +9787,7 @@
                           </a:solidFill>
                           <a:latin typeface="Segoe UI"/>
                         </a:rPr>
-                        <a:t>2.15.0</a:t>
+                        <a:t>2.16.0</a:t>
                       </a:r>
                     </a:p>
                   </a:txBody>
@@ -9831,7 +9831,7 @@
                           </a:solidFill>
                           <a:latin typeface="Segoe UI"/>
                         </a:rPr>
-                        <a:t>Update reminders</a:t>
+                        <a:t>Pips Community</a:t>
                       </a:r>
                     </a:p>
                     <a:p>
@@ -9842,7 +9842,7 @@
                           </a:solidFill>
                           <a:latin typeface="Segoe UI"/>
                         </a:rPr>
-                        <a:t>Owner &amp; moderators: the Mod tab now lists who hasn't updated Pips yet (their version and when they were last seen), with one-click reminders by e-mail (sent from your Outlook) or a ready-to-send Teams chat.; New Work e-mail field in your Profile, filled in from Outlook. Only the owner and moderators can see it (for update reminders and support) - clear it to hide it.; Pips now tells the Friends server which version it runs, so the update list is always accurate.; Friends keeps working when a local proxy tool stops answering - Pips falls back to the Windows proxy settings.</a:t>
+                        <a:t>New Pips Community at the top of the Chat tab: a #general channel to chat with everyone who uses Pips, plus #announcements with news from the Pips team.; Every new Pips version is announced there automatically - see what's new and update with one click.; Type @name to ping someone in #general. Mute #general any time; owner and moderators can remove messages.; Open it from your pet's menu too (Pips Community). Fixed: chats no longer clear what you're typing when Pips refreshes in the background.</a:t>
                       </a:r>
                     </a:p>
                   </a:txBody>
@@ -9866,7 +9866,7 @@
                           </a:solidFill>
                           <a:latin typeface="Segoe UI"/>
                         </a:rPr>
-                        <a:t>2.14.3</a:t>
+                        <a:t>2.15.0</a:t>
                       </a:r>
                     </a:p>
                   </a:txBody>
@@ -9910,7 +9910,7 @@
                           </a:solidFill>
                           <a:latin typeface="Segoe UI"/>
                         </a:rPr>
-                        <a:t>Tidy menus</a:t>
+                        <a:t>Update reminders</a:t>
                       </a:r>
                     </a:p>
                     <a:p>
@@ -9921,7 +9921,7 @@
                           </a:solidFill>
                           <a:latin typeface="Segoe UI"/>
                         </a:rPr>
-                        <a:t>Fixed: a submenu (e.g. Poke a friend) could stay floating on the screen after the right-click menu closed.; Menus now close by themselves when you move the mouse away and leave them for a few seconds.</a:t>
+                        <a:t>Owner &amp; moderators: the Mod tab now lists who hasn't updated Pips yet (their version and when they were last seen), with one-click reminders by e-mail (sent from your Outlook) or a ready-to-send Teams chat.; New Work e-mail field in your Profile, filled in from Outlook. Only the owner and moderators can see it (for update reminders and support) - clear it to hide it.; Pips now tells the Friends server which version it runs, so the update list is always accurate.; Friends keeps working when a local proxy tool stops answering - Pips falls back to the Windows proxy settings.</a:t>
                       </a:r>
                     </a:p>
                   </a:txBody>
@@ -9945,7 +9945,7 @@
                           </a:solidFill>
                           <a:latin typeface="Segoe UI"/>
                         </a:rPr>
-                        <a:t>2.14.2</a:t>
+                        <a:t>2.14.3</a:t>
                       </a:r>
                     </a:p>
                   </a:txBody>
@@ -9989,7 +9989,7 @@
                           </a:solidFill>
                           <a:latin typeface="Segoe UI"/>
                         </a:rPr>
-                        <a:t>Never miss an update</a:t>
+                        <a:t>Tidy menus</a:t>
                       </a:r>
                     </a:p>
                     <a:p>
@@ -10000,7 +10000,7 @@
                           </a:solidFill>
                           <a:latin typeface="Segoe UI"/>
                         </a:rPr>
-                        <a:t>Your pet now reminds you every 2 hours while a new version is waiting (instead of every 6 hours).; If the reminder can't show (fullscreen app, guided tour, another message), your pet tries again a few minutes later.; No internet when Pips starts (e.g. VPN off)? It checks again after an hour.</a:t>
+                        <a:t>Fixed: a submenu (e.g. Poke a friend) could stay floating on the screen after the right-click menu closed.; Menus now close by themselves when you move the mouse away and leave them for a few seconds.</a:t>
                       </a:r>
                     </a:p>
                   </a:txBody>
@@ -10024,7 +10024,7 @@
                           </a:solidFill>
                           <a:latin typeface="Segoe UI"/>
                         </a:rPr>
-                        <a:t>2.14.1</a:t>
+                        <a:t>2.14.2</a:t>
                       </a:r>
                     </a:p>
                   </a:txBody>
@@ -10068,7 +10068,7 @@
                           </a:solidFill>
                           <a:latin typeface="Segoe UI"/>
                         </a:rPr>
-                        <a:t>One pet at a time</a:t>
+                        <a:t>Never miss an update</a:t>
                       </a:r>
                     </a:p>
                     <a:p>
@@ -10079,7 +10079,7 @@
                           </a:solidFill>
                           <a:latin typeface="Segoe UI"/>
                         </a:rPr>
-                        <a:t>Opening Pips again (Desktop / Start Menu shortcut, autostart) no longer starts a second pet - your pet just pops up and says hi.; Fixes lag caused by two copies of Pips running at once.</a:t>
+                        <a:t>Your pet now reminds you every 2 hours while a new version is waiting (instead of every 6 hours).; If the reminder can't show (fullscreen app, guided tour, another message), your pet tries again a few minutes later.; No internet when Pips starts (e.g. VPN off)? It checks again after an hour.</a:t>
                       </a:r>
                     </a:p>
                   </a:txBody>
@@ -10103,7 +10103,7 @@
                           </a:solidFill>
                           <a:latin typeface="Segoe UI"/>
                         </a:rPr>
-                        <a:t>2.14.0</a:t>
+                        <a:t>2.14.1</a:t>
                       </a:r>
                     </a:p>
                   </a:txBody>
@@ -10147,7 +10147,7 @@
                           </a:solidFill>
                           <a:latin typeface="Segoe UI"/>
                         </a:rPr>
-                        <a:t>Pokes, tickles &amp; teases</a:t>
+                        <a:t>One pet at a time</a:t>
                       </a:r>
                     </a:p>
                     <a:p>
@@ -10158,7 +10158,7 @@
                           </a:solidFill>
                           <a:latin typeface="Segoe UI"/>
                         </a:rPr>
-                        <a:t>Poke, tickle, tease, boop or hug a friend from afar - no pet visit needed.; Right-click your pet → Poke a friend, or use the Poke button in Friends, chat and profiles.; Your friend gets a pop-up ("Wendy is teasing you!"), their pet reacts, and they can poke back with one click.; During a focus session pokes wait quietly until your break; when your pet is hidden they show in the screen corner.</a:t>
+                        <a:t>Opening Pips again (Desktop / Start Menu shortcut, autostart) no longer starts a second pet - your pet just pops up and says hi.; Fixes lag caused by two copies of Pips running at once.</a:t>
                       </a:r>
                     </a:p>
                   </a:txBody>
@@ -10182,7 +10182,7 @@
                           </a:solidFill>
                           <a:latin typeface="Segoe UI"/>
                         </a:rPr>
-                        <a:t>2.13.1</a:t>
+                        <a:t>2.14.0</a:t>
                       </a:r>
                     </a:p>
                   </a:txBody>
@@ -10204,7 +10204,7 @@
                           </a:solidFill>
                           <a:latin typeface="Segoe UI"/>
                         </a:rPr>
-                        <a:t>2026-10-28</a:t>
+                        <a:t>2026-10-29</a:t>
                       </a:r>
                     </a:p>
                   </a:txBody>
@@ -10226,7 +10226,7 @@
                           </a:solidFill>
                           <a:latin typeface="Segoe UI"/>
                         </a:rPr>
-                        <a:t>One-click Windows installer</a:t>
+                        <a:t>Pokes, tickles &amp; teases</a:t>
                       </a:r>
                     </a:p>
                     <a:p>
@@ -10237,7 +10237,7 @@
                           </a:solidFill>
                           <a:latin typeface="Segoe UI"/>
                         </a:rPr>
-                        <a:t>One Windows installer: no ZIP extraction, Python installation or command line. Download, open and click Install Pips.; Installs for your Windows account without administrator access, adds Desktop and Start Menu shortcuts, and opens Pips automatically.; Reinstalling in the same location keeps your settings and pet progress. Existing ZIP users can keep updating in place from Help → Check for updates.; A simpler download page and updated user guide; the bundled runtime stays separate from small in-app updates.</a:t>
+                        <a:t>Poke, tickle, tease, boop or hug a friend from afar - no pet visit needed.; Right-click your pet → Poke a friend, or use the Poke button in Friends, chat and profiles.; Your friend gets a pop-up ("Wendy is teasing you!"), their pet reacts, and they can poke back with one click.; During a focus session pokes wait quietly until your break; when your pet is hidden they show in the screen corner.</a:t>
                       </a:r>
                     </a:p>
                   </a:txBody>
@@ -10261,7 +10261,7 @@
                           </a:solidFill>
                           <a:latin typeface="Segoe UI"/>
                         </a:rPr>
-                        <a:t>2.13.0</a:t>
+                        <a:t>2.13.1</a:t>
                       </a:r>
                     </a:p>
                   </a:txBody>
@@ -10305,7 +10305,7 @@
                           </a:solidFill>
                           <a:latin typeface="Segoe UI"/>
                         </a:rPr>
-                        <a:t>Birthdays, parties &amp; gifts</a:t>
+                        <a:t>One-click Windows installer</a:t>
                       </a:r>
                     </a:p>
                     <a:p>
@@ -10316,7 +10316,7 @@
                           </a:solidFill>
                           <a:latin typeface="Segoe UI"/>
                         </a:rPr>
-                        <a:t>Set your birthday in Social → Profile (month + day, optionally visible to friends).; On your birthday Pips throws confetti and gives you 100 bonus coins.; Friends tab shows upcoming birthdays; you get reminders 3 days, 1 day and on the day.; Birthday parties: join a friend's party, see who's there, sign the guestbook and celebrate together.</a:t>
+                        <a:t>One Windows installer: no ZIP extraction, Python installation or command line. Download, open and click Install Pips.; Installs for your Windows account without administrator access, adds Desktop and Start Menu shortcuts, and opens Pips automatically.; Reinstalling in the same location keeps your settings and pet progress. Existing ZIP users can keep updating in place from Help → Check for updates.; A simpler download page and updated user guide; the bundled runtime stays separate from small in-app updates.</a:t>
                       </a:r>
                     </a:p>
                   </a:txBody>
@@ -10340,7 +10340,7 @@
                           </a:solidFill>
                           <a:latin typeface="Segoe UI"/>
                         </a:rPr>
-                        <a:t>2.12.0</a:t>
+                        <a:t>2.13.0</a:t>
                       </a:r>
                     </a:p>
                   </a:txBody>
@@ -10384,7 +10384,7 @@
                           </a:solidFill>
                           <a:latin typeface="Segoe UI"/>
                         </a:rPr>
-                        <a:t>Mega update: 28 new animals, 31 shop items, 13 moves</a:t>
+                        <a:t>Birthdays, parties &amp; gifts</a:t>
                       </a:r>
                     </a:p>
                     <a:p>
@@ -10395,7 +10395,7 @@
                           </a:solidFill>
                           <a:latin typeface="Segoe UI"/>
                         </a:rPr>
-                        <a:t>🦁 28 new animals (51 total): lion, tiger, unicorn, deer, sheep, cow, raccoon, red panda, monkey, hedgehog, dino, squirrel, mouse, koala, shark, dolphin, seal, otter, pufferfish, duck, crab, parrot, chick, ladybug, phoenix, pegasus, ghost and flamingo; 🎩 31 new shop items: top hat, cowboy, chef, pirate, Santa, viking, graduation cap, beret, bow, propeller cap, flower crown, nerd glasses, eyepatch, mustache, goggles, masquerade mask, tie, pearls, flower lei, gold chain, balloon, backpack, guitar, shield, butterfly / devil wings and more - plus Premium galaxy crown, galaxy cape and dragon wings; 💃 13 new moves: wave, jump, hearts, sing, yoga, zoomies, cartwheel, juggle, rain dance, breakdance, magic, confetti and the Premium rocket launch; The Shop is now split into sections (Hats, Face, Neck, Back, Moves, Arena gear) with an owned counter for each</a:t>
+                        <a:t>Set your birthday in Social → Profile (month + day, optionally visible to friends).; On your birthday Pips throws confetti and gives you 100 bonus coins.; Friends tab shows upcoming birthdays; you get reminders 3 days, 1 day and on the day.; Birthday parties: join a friend's party, see who's there, sign the guestbook and celebrate together.</a:t>
                       </a:r>
                     </a:p>
                   </a:txBody>
@@ -10419,7 +10419,7 @@
                           </a:solidFill>
                           <a:latin typeface="Segoe UI"/>
                         </a:rPr>
-                        <a:t>2.11.0</a:t>
+                        <a:t>2.12.0</a:t>
                       </a:r>
                     </a:p>
                   </a:txBody>
@@ -10463,7 +10463,7 @@
                           </a:solidFill>
                           <a:latin typeface="Segoe UI"/>
                         </a:rPr>
-                        <a:t>New right-click menus</a:t>
+                        <a:t>Mega update: 28 new animals, 31 shop items, 13 moves</a:t>
                       </a:r>
                     </a:p>
                     <a:p>
@@ -10474,7 +10474,7 @@
                           </a:solidFill>
                           <a:latin typeface="Segoe UI"/>
                         </a:rPr>
-                        <a:t>✨ Brand-new animated right-click menu for your pet: mood &amp; stat bars, quick-action tiles (Friends, Shop, Snack, Pat, Focus, Stats, Sleep, Taskbar), hover effects and smooth fly-out submenus; Pick colours from swatches, switch size with one click and flip Sounds / Dark mode with toggle switches - changes show instantly; Updates are highlighted: a glowing banner and NEW badge appear in the menu when a new version is ready; The focus card's right-click menu got the same new look; keyboard arrows, Enter and Esc work too</a:t>
+                        <a:t>🦁 28 new animals (51 total): lion, tiger, unicorn, deer, sheep, cow, raccoon, red panda, monkey, hedgehog, dino, squirrel, mouse, koala, shark, dolphin, seal, otter, pufferfish, duck, crab, parrot, chick, ladybug, phoenix, pegasus, ghost and flamingo; 🎩 31 new shop items: top hat, cowboy, chef, pirate, Santa, viking, graduation cap, beret, bow, propeller cap, flower crown, nerd glasses, eyepatch, mustache, goggles, masquerade mask, tie, pearls, flower lei, gold chain, balloon, backpack, guitar, shield, butterfly / devil wings and more - plus Premium galaxy crown, galaxy cape and dragon wings; 💃 13 new moves: wave, jump, hearts, sing, yoga, zoomies, cartwheel, juggle, rain dance, breakdance, magic, confetti and the Premium rocket launch; The Shop is now split into sections (Hats, Face, Neck, Back, Moves, Arena gear) with an owned counter for each</a:t>
                       </a:r>
                     </a:p>
                   </a:txBody>
@@ -10498,7 +10498,7 @@
                           </a:solidFill>
                           <a:latin typeface="Segoe UI"/>
                         </a:rPr>
-                        <a:t>2.10.0</a:t>
+                        <a:t>2.11.0</a:t>
                       </a:r>
                     </a:p>
                   </a:txBody>
@@ -10542,7 +10542,7 @@
                           </a:solidFill>
                           <a:latin typeface="Segoe UI"/>
                         </a:rPr>
-                        <a:t>Chat bots</a:t>
+                        <a:t>New right-click menus</a:t>
                       </a:r>
                     </a:p>
                     <a:p>
@@ -10553,7 +10553,7 @@
                           </a:solidFill>
                           <a:latin typeface="Segoe UI"/>
                         </a:rPr>
-                        <a:t>🤖 6 friendly chat bots in the Chat tab: Pip Helper (app questions), Coach Focus (focus tips from your real stats), Sunny (live weather for any city), Arena Master (battle tips + quick battle), Giggles (jokes &amp; games) and Guardian (safety &amp; reporting help); Private bot chats with suggestion chips, typing indicator and a clear button - your bot chats stay on your PC; Mention a bot in a group chat (e.g. @weather Batam) and it answers in the room for everyone; Bots reply in your app language; up to 120 bot messages per day</a:t>
+                        <a:t>✨ Brand-new animated right-click menu for your pet: mood &amp; stat bars, quick-action tiles (Friends, Shop, Snack, Pat, Focus, Stats, Sleep, Taskbar), hover effects and smooth fly-out submenus; Pick colours from swatches, switch size with one click and flip Sounds / Dark mode with toggle switches - changes show instantly; Updates are highlighted: a glowing banner and NEW badge appear in the menu when a new version is ready; The focus card's right-click menu got the same new look; keyboard arrows, Enter and Esc work too</a:t>
                       </a:r>
                     </a:p>
                   </a:txBody>
@@ -10577,7 +10577,7 @@
                           </a:solidFill>
                           <a:latin typeface="Segoe UI"/>
                         </a:rPr>
-                        <a:t>2.9.0</a:t>
+                        <a:t>2.10.0</a:t>
                       </a:r>
                     </a:p>
                   </a:txBody>
@@ -10621,7 +10621,7 @@
                           </a:solidFill>
                           <a:latin typeface="Segoe UI"/>
                         </a:rPr>
-                        <a:t>Location &amp; live weather</a:t>
+                        <a:t>Chat bots</a:t>
                       </a:r>
                     </a:p>
                     <a:p>
@@ -10632,7 +10632,7 @@
                           </a:solidFill>
                           <a:latin typeface="Segoe UI"/>
                         </a:rPr>
-                        <a:t>📍 Add your city in Profile → Location &amp; weather (auto-detect or search) - only your city and country are shown, never your exact position; Live weather banners on every profile with animations: rain, drizzle, thunderstorms with lightning, snow, fog, clouds, sunshine or a starry night - plus temperature, feels-like, humidity, wind and local time; Your own weather strip on top of the hub, and each friend's weather + local time in the friends list; Hide your location from others or remove it any time</a:t>
+                        <a:t>🤖 6 friendly chat bots in the Chat tab: Pip Helper (app questions), Coach Focus (focus tips from your real stats), Sunny (live weather for any city), Arena Master (battle tips + quick battle), Giggles (jokes &amp; games) and Guardian (safety &amp; reporting help); Private bot chats with suggestion chips, typing indicator and a clear button - your bot chats stay on your PC; Mention a bot in a group chat (e.g. @weather Batam) and it answers in the room for everyone; Bots reply in your app language; up to 120 bot messages per day</a:t>
                       </a:r>
                     </a:p>
                   </a:txBody>
@@ -10656,7 +10656,7 @@
                           </a:solidFill>
                           <a:latin typeface="Segoe UI"/>
                         </a:rPr>
-                        <a:t>2.8.0</a:t>
+                        <a:t>2.9.0</a:t>
                       </a:r>
                     </a:p>
                   </a:txBody>
@@ -10700,7 +10700,7 @@
                           </a:solidFill>
                           <a:latin typeface="Segoe UI"/>
                         </a:rPr>
-                        <a:t>Pips Arena - duels, gear &amp; live battles</a:t>
+                        <a:t>Location &amp; live weather</a:t>
                       </a:r>
                     </a:p>
                     <a:p>
@@ -10711,7 +10711,7 @@
                           </a:solidFill>
                           <a:latin typeface="Segoe UI"/>
                         </a:rPr>
-                        <a:t>⚔ New Arena tab: challenge friends or anyone in the arena to a live duel - each round pick Attack, Guard or Special within 12 seconds and watch your pets fight; ⚡ Quick battle: an instant auto-fight against anyone's fighter, even when they're offline; Arena gear in the Shop: 7 weapons (water pistol to rocket launcher), 5 armors and 5 gadgets that decide your special move - better gear and a higher level make a stronger fighter; Live duels can be watched by everyone, plus recent battle replays, top fighters, rating and win/loss records; wins earn coins</a:t>
+                        <a:t>📍 Add your city in Profile → Location &amp; weather (auto-detect or search) - only your city and country are shown, never your exact position; Live weather banners on every profile with animations: rain, drizzle, thunderstorms with lightning, snow, fog, clouds, sunshine or a starry night - plus temperature, feels-like, humidity, wind and local time; Your own weather strip on top of the hub, and each friend's weather + local time in the friends list; Hide your location from others or remove it any time</a:t>
                       </a:r>
                     </a:p>
                   </a:txBody>
@@ -10735,7 +10735,7 @@
                           </a:solidFill>
                           <a:latin typeface="Segoe UI"/>
                         </a:rPr>
-                        <a:t>2.7.0</a:t>
+                        <a:t>2.8.0</a:t>
                       </a:r>
                     </a:p>
                   </a:txBody>
@@ -10779,7 +10779,7 @@
                           </a:solidFill>
                           <a:latin typeface="Segoe UI"/>
                         </a:rPr>
-                        <a:t>Moderators &amp; Premium</a:t>
+                        <a:t>Pips Arena - duels, gear &amp; live battles</a:t>
                       </a:r>
                     </a:p>
                     <a:p>
@@ -10790,7 +10790,7 @@
                           </a:solidFill>
                           <a:latin typeface="Segoe UI"/>
                         </a:rPr>
-                        <a:t>★ Premium: a purple Premium badge, 4 exclusive props (tiara, star glasses, diamond necklace, fairy wings), the Fireworks move, +30 coins every day, double friend-interaction coins and room for 300 friends / 30 groups; Get Premium: Profile tab → Premium → "Ask to buy" emails the owner; after payment you receive a key (PIPS-XXXX-XXXX) to redeem right there; 🛡 Moderators: a blue Mod badge and a Mod tab with the report queue - warn, mute (1h / 24h / 7 days), clear a profile or reset a name; every action is logged; Report button on everyone's profile, so moderators can keep Pips friendly</a:t>
+                        <a:t>⚔ New Arena tab: challenge friends or anyone in the arena to a live duel - each round pick Attack, Guard or Special within 12 seconds and watch your pets fight; ⚡ Quick battle: an instant auto-fight against anyone's fighter, even when they're offline; Arena gear in the Shop: 7 weapons (water pistol to rocket launcher), 5 armors and 5 gadgets that decide your special move - better gear and a higher level make a stronger fighter; Live duels can be watched by everyone, plus recent battle replays, top fighters, rating and win/loss records; wins earn coins</a:t>
                       </a:r>
                     </a:p>
                   </a:txBody>
@@ -10814,7 +10814,7 @@
                           </a:solidFill>
                           <a:latin typeface="Segoe UI"/>
                         </a:rPr>
-                        <a:t>2.6.1</a:t>
+                        <a:t>2.7.0</a:t>
                       </a:r>
                     </a:p>
                   </a:txBody>
@@ -10858,7 +10858,7 @@
                           </a:solidFill>
                           <a:latin typeface="Segoe UI"/>
                         </a:rPr>
-                        <a:t>Owner badge &amp; credits</a:t>
+                        <a:t>Moderators &amp; Premium</a:t>
                       </a:r>
                     </a:p>
                     <a:p>
@@ -10869,7 +10869,7 @@
                           </a:solidFill>
                           <a:latin typeface="Segoe UI"/>
                         </a:rPr>
-                        <a:t>The creator of Pips (Juwen Lie) now shows a gold ♛ Owner badge on his profile, friend list and ranks; New About Pips card in the Profile tab: credits and how to contact the owner (Juwen_Lie@pegatroncorp.com) with Email and Copy buttons; Right-click the pet → Help → About now shows who made Pips and the contact email</a:t>
+                        <a:t>★ Premium: a purple Premium badge, 4 exclusive props (tiara, star glasses, diamond necklace, fairy wings), the Fireworks move, +30 coins every day, double friend-interaction coins and room for 300 friends / 30 groups; Get Premium: Profile tab → Premium → "Ask to buy" emails the owner; after payment you receive a key (PIPS-XXXX-XXXX) to redeem right there; 🛡 Moderators: a blue Mod badge and a Mod tab with the report queue - warn, mute (1h / 24h / 7 days), clear a profile or reset a name; every action is logged; Report button on everyone's profile, so moderators can keep Pips friendly</a:t>
                       </a:r>
                     </a:p>
                   </a:txBody>
@@ -10893,7 +10893,7 @@
                           </a:solidFill>
                           <a:latin typeface="Segoe UI"/>
                         </a:rPr>
-                        <a:t>2.6.0</a:t>
+                        <a:t>2.6.1</a:t>
                       </a:r>
                     </a:p>
                   </a:txBody>
@@ -10937,7 +10937,7 @@
                           </a:solidFill>
                           <a:latin typeface="Segoe UI"/>
                         </a:rPr>
-                        <a:t>Profiles, ranks, online status &amp; dark mode</a:t>
+                        <a:t>Owner badge &amp; credits</a:t>
                       </a:r>
                     </a:p>
                     <a:p>
@@ -10948,7 +10948,7 @@
                           </a:solidFill>
                           <a:latin typeface="Segoe UI"/>
                         </a:rPr>
-                        <a:t>Profile tab: profile picture (or your pet), about me, job, location, hobbies, birthday and a status message; Public or private: public profiles can be added directly and viewed in full; private profiles need a friend request that they accept, and strangers only see name, photo, pet, level and status; Click anyone to open their profile - badges, info, their friends - and add them, chat or wave from there; Ranks tab replaces Teams: everyone using Pips, sorted by XP, badges or streak</a:t>
+                        <a:t>The creator of Pips (Juwen Lie) now shows a gold ♛ Owner badge on his profile, friend list and ranks; New About Pips card in the Profile tab: credits and how to contact the owner (Juwen_Lie@pegatroncorp.com) with Email and Copy buttons; Right-click the pet → Help → About now shows who made Pips and the contact email</a:t>
                       </a:r>
                     </a:p>
                   </a:txBody>
@@ -10972,7 +10972,7 @@
                           </a:solidFill>
                           <a:latin typeface="Segoe UI"/>
                         </a:rPr>
-                        <a:t>2.5.1</a:t>
+                        <a:t>2.6.0</a:t>
                       </a:r>
                     </a:p>
                   </a:txBody>
@@ -11016,7 +11016,7 @@
                           </a:solidFill>
                           <a:latin typeface="Segoe UI"/>
                         </a:rPr>
-                        <a:t>New cute Pips logo</a:t>
+                        <a:t>Profiles, ranks, online status &amp; dark mode</a:t>
                       </a:r>
                     </a:p>
                     <a:p>
@@ -11027,7 +11027,7 @@
                           </a:solidFill>
                           <a:latin typeface="Segoe UI"/>
                         </a:rPr>
-                        <a:t>New Pips logo: Pip the cat on a Pips-red tile, matching the app colours (desktop shortcut, windows and website)</a:t>
+                        <a:t>Profile tab: profile picture (or your pet), about me, job, location, hobbies, birthday and a status message; Public or private: public profiles can be added directly and viewed in full; private profiles need a friend request that they accept, and strangers only see name, photo, pet, level and status; Click anyone to open their profile - badges, info, their friends - and add them, chat or wave from there; Ranks tab replaces Teams: everyone using Pips, sorted by XP, badges or streak</a:t>
                       </a:r>
                     </a:p>
                   </a:txBody>
@@ -11051,7 +11051,7 @@
                           </a:solidFill>
                           <a:latin typeface="Segoe UI"/>
                         </a:rPr>
-                        <a:t>2.5.0</a:t>
+                        <a:t>2.5.1</a:t>
                       </a:r>
                     </a:p>
                   </a:txBody>
@@ -11095,7 +11095,7 @@
                           </a:solidFill>
                           <a:latin typeface="Segoe UI"/>
                         </a:rPr>
-                        <a:t>Shop, coins, props &amp; moves</a:t>
+                        <a:t>New cute Pips logo</a:t>
                       </a:r>
                     </a:p>
                     <a:p>
@@ -11106,7 +11106,7 @@
                           </a:solidFill>
                           <a:latin typeface="Segoe UI"/>
                         </a:rPr>
-                        <a:t>Shop: earn coins and spend them on your pet - 17 props (crown, wizard hat, headphones, shades, scarf, cape, angel wings...) and 6 moves: spin, dance, moonwalk, backflip, kung fu and spider swing!; Coins come from leveling up (+40), badges (+25), opening Pips each day (+10), friendships (+15 per affinity level), waving / chatting / visiting friends (+2) and pomodoros (+5). Everyone starts with a 100-coin gift; Your friends see your props: on avatars in the hub and when your pet visits their desktop - it shows off one of your moves; Pips is now a social pet: clicking the pet opens the Pips hub (friends, chat, groups, shop, badges)</a:t>
+                        <a:t>New Pips logo: Pip the cat on a Pips-red tile, matching the app colours (desktop shortcut, windows and website)</a:t>
                       </a:r>
                     </a:p>
                   </a:txBody>
@@ -11130,7 +11130,7 @@
                           </a:solidFill>
                           <a:latin typeface="Segoe UI"/>
                         </a:rPr>
-                        <a:t>2.4.0</a:t>
+                        <a:t>2.5.0</a:t>
                       </a:r>
                     </a:p>
                   </a:txBody>
@@ -11174,7 +11174,7 @@
                           </a:solidFill>
                           <a:latin typeface="Segoe UI"/>
                         </a:rPr>
-                        <a:t>Chat, groups, affinity &amp; pet visits</a:t>
+                        <a:t>Shop, coins, props &amp; moves</a:t>
                       </a:r>
                     </a:p>
                     <a:p>
@@ -11185,7 +11185,7 @@
                           </a:solidFill>
                           <a:latin typeface="Segoe UI"/>
                         </a:rPr>
-                        <a:t>Chat: message your friends, and chat inside groups. Your pet pops up new messages as a bubble - click it to reply; Pet interactions: wave, pet their pet, send a snack, high five - or send your pet to visit: it walks onto your friend's desktop for a little while!; Affinity: every chat and interaction grows your friendship - Acquaintance → Buddy → Good friends → Close friends → Best friends → Soulmates; Your own groups: create a private group, invite your friends, they accept or decline. Group board + group chat; the owner can remove members</a:t>
+                        <a:t>Shop: earn coins and spend them on your pet - 17 props (crown, wizard hat, headphones, shades, scarf, cape, angel wings...) and 6 moves: spin, dance, moonwalk, backflip, kung fu and spider swing!; Coins come from leveling up (+40), badges (+25), opening Pips each day (+10), friendships (+15 per affinity level), waving / chatting / visiting friends (+2) and pomodoros (+5). Everyone starts with a 100-coin gift; Your friends see your props: on avatars in the hub and when your pet visits their desktop - it shows off one of your moves; Pips is now a social pet: clicking the pet opens the Pips hub (friends, chat, groups, shop, badges)</a:t>
                       </a:r>
                     </a:p>
                   </a:txBody>
@@ -11209,7 +11209,7 @@
                           </a:solidFill>
                           <a:latin typeface="Segoe UI"/>
                         </a:rPr>
-                        <a:t>2.3.0</a:t>
+                        <a:t>2.4.0</a:t>
                       </a:r>
                     </a:p>
                   </a:txBody>
@@ -11253,7 +11253,7 @@
                           </a:solidFill>
                           <a:latin typeface="Segoe UI"/>
                         </a:rPr>
-                        <a:t>Friends, levels &amp; achievements</a:t>
+                        <a:t>Chat, groups, affinity &amp; pet visits</a:t>
                       </a:r>
                     </a:p>
                     <a:p>
@@ -11264,7 +11264,7 @@
                           </a:solidFill>
                           <a:latin typeface="Segoe UI"/>
                         </a:rPr>
-                        <a:t>Levels &amp; XP: every finished pomodoro earns XP and your level grows - plus 20 achievements to unlock (first tomato, 8 in a day, 7-day streak, early bird, night owl, pet lover...). Your pet celebrates each one; Friends (optional, off by default): get a 6-letter friend code, add colleagues, see today's board and join a team board like PTB. Your pet tells you when a friend finishes a pomodoro; Privacy: only your name, pet, level, streak and pomodoro counts are shared - never apps, window titles or scores. One click turns it off and deletes your online data. Right-click the pet → Friends &amp; achievements…</a:t>
+                        <a:t>Chat: message your friends, and chat inside groups. Your pet pops up new messages as a bubble - click it to reply; Pet interactions: wave, pet their pet, send a snack, high five - or send your pet to visit: it walks onto your friend's desktop for a little while!; Affinity: every chat and interaction grows your friendship - Acquaintance → Buddy → Good friends → Close friends → Best friends → Soulmates; Your own groups: create a private group, invite your friends, they accept or decline. Group board + group chat; the owner can remove members</a:t>
                       </a:r>
                     </a:p>
                   </a:txBody>
@@ -11288,7 +11288,7 @@
                           </a:solidFill>
                           <a:latin typeface="Segoe UI"/>
                         </a:rPr>
-                        <a:t>2.2.0</a:t>
+                        <a:t>2.3.0</a:t>
                       </a:r>
                     </a:p>
                   </a:txBody>
@@ -11332,7 +11332,7 @@
                           </a:solidFill>
                           <a:latin typeface="Segoe UI"/>
                         </a:rPr>
-                        <a:t>Pet sounds</a:t>
+                        <a:t>Friends, levels &amp; achievements</a:t>
                       </a:r>
                     </a:p>
                     <a:p>
@@ -11343,7 +11343,7 @@
                           </a:solidFill>
                           <a:latin typeface="Segoe UI"/>
                         </a:rPr>
-                        <a:t>Your pet has a voice! Each of the 23 animals has its own sound (meow, woof, ribbit, hoot, buzz, oink, whale song...) and it changes with its mood: happy chirps, sad whimpers, sleepy yawns, hungry calls, grumpy huffs and soft snores; It also reacts with sound when you tickle, pet, feed, shake or wake it; Settings: right-click the pet → Sounds to switch on/off; Pet status &amp; settings has a volume slider, a ▶ Hear me button and "Stay quiet while I'm focusing" (on by default)</a:t>
+                        <a:t>Levels &amp; XP: every finished pomodoro earns XP and your level grows - plus 20 achievements to unlock (first tomato, 8 in a day, 7-day streak, early bird, night owl, pet lover...). Your pet celebrates each one; Friends (optional, off by default): get a 6-letter friend code, add colleagues, see today's board and join a team board like PTB. Your pet tells you when a friend finishes a pomodoro; Privacy: only your name, pet, level, streak and pomodoro counts are shared - never apps, window titles or scores. One click turns it off and deletes your online data. Right-click the pet → Friends &amp; achievements…</a:t>
                       </a:r>
                     </a:p>
                   </a:txBody>
@@ -11367,7 +11367,7 @@
                           </a:solidFill>
                           <a:latin typeface="Segoe UI"/>
                         </a:rPr>
-                        <a:t>2.1.2</a:t>
+                        <a:t>2.2.0</a:t>
                       </a:r>
                     </a:p>
                   </a:txBody>
@@ -11411,7 +11411,7 @@
                           </a:solidFill>
                           <a:latin typeface="Segoe UI"/>
                         </a:rPr>
-                        <a:t>Tickle-only mode</a:t>
+                        <a:t>Pet sounds</a:t>
                       </a:r>
                     </a:p>
                     <a:p>
@@ -11422,7 +11422,7 @@
                           </a:solidFill>
                           <a:latin typeface="Segoe UI"/>
                         </a:rPr>
-                        <a:t>New click option "Only tickle (never open Pips)": click and tickle your pet as much as you like - the Pomodoro window stays closed (open it from the right-click menu). Right-click the pet → When I click</a:t>
+                        <a:t>Your pet has a voice! Each of the 23 animals has its own sound (meow, woof, ribbit, hoot, buzz, oink, whale song...) and it changes with its mood: happy chirps, sad whimpers, sleepy yawns, hungry calls, grumpy huffs and soft snores; It also reacts with sound when you tickle, pet, feed, shake or wake it; Settings: right-click the pet → Sounds to switch on/off; Pet status &amp; settings has a volume slider, a ▶ Hear me button and "Stay quiet while I'm focusing" (on by default)</a:t>
                       </a:r>
                     </a:p>
                   </a:txBody>
@@ -11446,7 +11446,7 @@
                           </a:solidFill>
                           <a:latin typeface="Segoe UI"/>
                         </a:rPr>
-                        <a:t>2.1.1</a:t>
+                        <a:t>2.1.2</a:t>
                       </a:r>
                     </a:p>
                   </a:txBody>
@@ -11490,7 +11490,7 @@
                           </a:solidFill>
                           <a:latin typeface="Segoe UI"/>
                         </a:rPr>
-                        <a:t>Owner info</a:t>
+                        <a:t>Tickle-only mode</a:t>
                       </a:r>
                     </a:p>
                     <a:p>
@@ -11501,7 +11501,7 @@
                           </a:solidFill>
                           <a:latin typeface="Segoe UI"/>
                         </a:rPr>
-                        <a:t>About Pips now shows the owner: Juwen Lie (right-click the pet → Help → About)</a:t>
+                        <a:t>New click option "Only tickle (never open Pips)": click and tickle your pet as much as you like - the Pomodoro window stays closed (open it from the right-click menu). Right-click the pet → When I click</a:t>
                       </a:r>
                     </a:p>
                   </a:txBody>
@@ -11525,7 +11525,7 @@
                           </a:solidFill>
                           <a:latin typeface="Segoe UI"/>
                         </a:rPr>
-                        <a:t>2.1.0</a:t>
+                        <a:t>2.1.1</a:t>
                       </a:r>
                     </a:p>
                   </a:txBody>
@@ -11569,7 +11569,7 @@
                           </a:solidFill>
                           <a:latin typeface="Segoe UI"/>
                         </a:rPr>
-                        <a:t>Interactive guide &amp; in-app updates</a:t>
+                        <a:t>Owner info</a:t>
                       </a:r>
                     </a:p>
                     <a:p>
@@ -11580,7 +11580,7 @@
                           </a:solidFill>
                           <a:latin typeface="Segoe UI"/>
                         </a:rPr>
-                        <a:t>Interactive first-run guide: your pet walks you through clicking, dragging, petting and the right-click menu; In-app updates: Pips tells you when a new version is out - update with one click (your settings and data are kept); New Help menu: replay the guide, check for updates, see the version; Option to turn automatic update checks off</a:t>
+                        <a:t>About Pips now shows the owner: Juwen Lie (right-click the pet → Help → About)</a:t>
                       </a:r>
                     </a:p>
                   </a:txBody>
@@ -11604,7 +11604,7 @@
                           </a:solidFill>
                           <a:latin typeface="Segoe UI"/>
                         </a:rPr>
-                        <a:t>2.0.0</a:t>
+                        <a:t>2.1.0</a:t>
                       </a:r>
                     </a:p>
                   </a:txBody>
@@ -11648,7 +11648,7 @@
                           </a:solidFill>
                           <a:latin typeface="Segoe UI"/>
                         </a:rPr>
-                        <a:t>Desktop pet, 23 animals &amp; 4 languages</a:t>
+                        <a:t>Interactive guide &amp; in-app updates</a:t>
                       </a:r>
                     </a:p>
                     <a:p>
@@ -11659,7 +11659,7 @@
                           </a:solidFill>
                           <a:latin typeface="Segoe UI"/>
                         </a:rPr>
-                        <a:t>Desktop pet that lives on your desktop and taskbar - drag it, tickle it, pet it; 23 animals in 3 groups: Land walks, Water swims with bubbles, Sky hovers and flaps; Moods (happy, sad, tired, hungry, grumpy...), naps when you're away, wakes up when you're back; Cute chat-bubble reminders: breaks, water, 20-20-20 eye rest, pomodoro done, daily goal</a:t>
+                        <a:t>Interactive first-run guide: your pet walks you through clicking, dragging, petting and the right-click menu; In-app updates: Pips tells you when a new version is out - update with one click (your settings and data are kept); New Help menu: replay the guide, check for updates, see the version; Option to turn automatic update checks off</a:t>
                       </a:r>
                     </a:p>
                   </a:txBody>
@@ -11683,7 +11683,7 @@
                           </a:solidFill>
                           <a:latin typeface="Segoe UI"/>
                         </a:rPr>
-                        <a:t>1.5.0</a:t>
+                        <a:t>2.0.0</a:t>
                       </a:r>
                     </a:p>
                   </a:txBody>
@@ -11705,7 +11705,7 @@
                           </a:solidFill>
                           <a:latin typeface="Segoe UI"/>
                         </a:rPr>
-                        <a:t>2026-10-24</a:t>
+                        <a:t>2026-10-28</a:t>
                       </a:r>
                     </a:p>
                   </a:txBody>
@@ -11727,7 +11727,7 @@
                           </a:solidFill>
                           <a:latin typeface="Segoe UI"/>
                         </a:rPr>
-                        <a:t>Renamed to Pips + insights</a:t>
+                        <a:t>Desktop pet, 23 animals &amp; 4 languages</a:t>
                       </a:r>
                     </a:p>
                     <a:p>
@@ -11738,7 +11738,7 @@
                           </a:solidFill>
                           <a:latin typeface="Segoe UI"/>
                         </a:rPr>
-                        <a:t>Renamed from Productivity Widget to Pips; Dashboard charts: focus timeline, hour heatmap, 7-day score trend, pomodoros per day; AI token usage on the card and dashboard; Daily diary export and weekly / monthly reports</a:t>
+                        <a:t>Desktop pet that lives on your desktop and taskbar - drag it, tickle it, pet it; 23 animals in 3 groups: Land walks, Water swims with bubbles, Sky hovers and flaps; Moods (happy, sad, tired, hungry, grumpy...), naps when you're away, wakes up when you're back; Cute chat-bubble reminders: breaks, water, 20-20-20 eye rest, pomodoro done, daily goal</a:t>
                       </a:r>
                     </a:p>
                   </a:txBody>
@@ -11762,13 +11762,92 @@
                           </a:solidFill>
                           <a:latin typeface="Segoe UI"/>
                         </a:rPr>
+                        <a:t>1.5.0</a:t>
+                      </a:r>
+                    </a:p>
+                  </a:txBody>
+                  <a:tcPr marL="73152" marR="73152" marT="36576" marB="36576">
+                    <a:solidFill>
+                      <a:srgbClr val="F7F4EC"/>
+                    </a:solidFill>
+                  </a:tcPr>
+                </a:tc>
+                <a:tc>
+                  <a:txBody>
+                    <a:bodyPr wrap="square"/>
+                    <a:lstStyle/>
+                    <a:p>
+                      <a:r>
+                        <a:rPr sz="1200" b="0">
+                          <a:solidFill>
+                            <a:srgbClr val="2B2A28"/>
+                          </a:solidFill>
+                          <a:latin typeface="Segoe UI"/>
+                        </a:rPr>
+                        <a:t>2026-10-24</a:t>
+                      </a:r>
+                    </a:p>
+                  </a:txBody>
+                  <a:tcPr marL="73152" marR="73152" marT="36576" marB="36576">
+                    <a:solidFill>
+                      <a:srgbClr val="F7F4EC"/>
+                    </a:solidFill>
+                  </a:tcPr>
+                </a:tc>
+                <a:tc>
+                  <a:txBody>
+                    <a:bodyPr wrap="square"/>
+                    <a:lstStyle/>
+                    <a:p>
+                      <a:r>
+                        <a:rPr sz="1200" b="0">
+                          <a:solidFill>
+                            <a:srgbClr val="2B2A28"/>
+                          </a:solidFill>
+                          <a:latin typeface="Segoe UI"/>
+                        </a:rPr>
+                        <a:t>Renamed to Pips + insights</a:t>
+                      </a:r>
+                    </a:p>
+                    <a:p>
+                      <a:r>
+                        <a:rPr sz="1200" b="0">
+                          <a:solidFill>
+                            <a:srgbClr val="2B2A28"/>
+                          </a:solidFill>
+                          <a:latin typeface="Segoe UI"/>
+                        </a:rPr>
+                        <a:t>Renamed from Productivity Widget to Pips; Dashboard charts: focus timeline, hour heatmap, 7-day score trend, pomodoros per day; AI token usage on the card and dashboard; Daily diary export and weekly / monthly reports</a:t>
+                      </a:r>
+                    </a:p>
+                  </a:txBody>
+                  <a:tcPr marL="73152" marR="73152" marT="36576" marB="36576">
+                    <a:solidFill>
+                      <a:srgbClr val="F7F4EC"/>
+                    </a:solidFill>
+                  </a:tcPr>
+                </a:tc>
+              </a:tr>
+              <a:tr h="822960">
+                <a:tc>
+                  <a:txBody>
+                    <a:bodyPr wrap="square"/>
+                    <a:lstStyle/>
+                    <a:p>
+                      <a:r>
+                        <a:rPr sz="1200" b="1">
+                          <a:solidFill>
+                            <a:srgbClr val="2B2A28"/>
+                          </a:solidFill>
+                          <a:latin typeface="Segoe UI"/>
+                        </a:rPr>
                         <a:t>1.0.0</a:t>
                       </a:r>
                     </a:p>
                   </a:txBody>
                   <a:tcPr marL="73152" marR="73152" marT="36576" marB="36576">
                     <a:solidFill>
-                      <a:srgbClr val="F7F4EC"/>
+                      <a:srgbClr val="FFFDF8"/>
                     </a:solidFill>
                   </a:tcPr>
                 </a:tc>
@@ -11790,7 +11869,7 @@
                   </a:txBody>
                   <a:tcPr marL="73152" marR="73152" marT="36576" marB="36576">
                     <a:solidFill>
-                      <a:srgbClr val="F7F4EC"/>
+                      <a:srgbClr val="FFFDF8"/>
                     </a:solidFill>
                   </a:tcPr>
                 </a:tc>
@@ -11823,7 +11902,7 @@
                   </a:txBody>
                   <a:tcPr marL="73152" marR="73152" marT="36576" marB="36576">
                     <a:solidFill>
-                      <a:srgbClr val="F7F4EC"/>
+                      <a:srgbClr val="FFFDF8"/>
                     </a:solidFill>
                   </a:tcPr>
                 </a:tc>
@@ -15625,7 +15704,7 @@
                           </a:solidFill>
                           <a:latin typeface="Segoe UI"/>
                         </a:rPr>
-                        <a:t>Arena duels: compare stats (level + gear), pick 3 skills, choose best of 1/3/5 rounds and take turns until one pet is knocked out</a:t>
+                        <a:t>Arena duels: compare stats (level + gear), pick 3 skills, choose best of 1/3/5 rounds and take turns until one pet is knocked out - press the skills yourself or switch on 🤖 Auto</a:t>
                       </a:r>
                     </a:p>
                   </a:txBody>

</xml_diff>

<commit_message>
pips 2.25.0: Play with friends
</commit_message>
<xml_diff>
--- a/apps/pips/web/download/Pips-Guide.pptx
+++ b/apps/pips/web/download/Pips-Guide.pptx
@@ -3292,7 +3292,7 @@
                 </a:solidFill>
                 <a:latin typeface="Segoe UI"/>
               </a:rPr>
-              <a:t>Version 2.24.2  ·  2026-10-29  ·  Made by Juwen Lie (owner)</a:t>
+              <a:t>Version 2.25.0  ·  2026-10-30  ·  Made by Juwen Lie (owner)</a:t>
             </a:r>
           </a:p>
           <a:p>
@@ -8279,7 +8279,7 @@
                 </a:solidFill>
                 <a:latin typeface="Segoe UI"/>
               </a:rPr>
-              <a:t>What's new in 2.24.2</a:t>
+              <a:t>What's new in 2.25.0</a:t>
             </a:r>
           </a:p>
         </p:txBody>
@@ -8392,7 +8392,7 @@
                 </a:solidFill>
                 <a:latin typeface="Segoe UI"/>
               </a:rPr>
-              <a:t>Auto battle  ·  2026-10-29</a:t>
+              <a:t>Play with friends  ·  2026-10-30</a:t>
             </a:r>
           </a:p>
         </p:txBody>
@@ -8440,7 +8440,7 @@
                 </a:solidFill>
                 <a:latin typeface="Segoe UI"/>
               </a:rPr>
-              <a:t>Arena battles can now play themselves: switch on 🤖 Auto (button in the battle, the A key, or the tick box before a fight) and your pet picks its skills - it finishes off a weak opponent, heals when low and saves Focus for long fights.</a:t>
+              <a:t>All 5 minigames can now be played with friends: Hub → Play → Minigames → ＋ New game with friends, pick a game and up to 7 friends (8 players in total).</a:t>
             </a:r>
           </a:p>
           <a:p>
@@ -8465,7 +8465,7 @@
                 </a:solidFill>
                 <a:latin typeface="Segoe UI"/>
               </a:rPr>
-              <a:t>Prefer to play yourself? Leave Auto off and press the skill buttons (or keys 1-3) as before. You can switch any time, even mid-battle.</a:t>
+              <a:t>Everyone gets the same round at the same time (same treats, bugs, cards, pattern and obstacles) after a 3-2-1 countdown, and a live scoreboard shows how your friends are doing. Best score wins the round.</a:t>
             </a:r>
           </a:p>
           <a:p>
@@ -8490,7 +8490,57 @@
                 </a:solidFill>
                 <a:latin typeface="Segoe UI"/>
               </a:rPr>
-              <a:t>Your choice is remembered for the next fight.</a:t>
+              <a:t>Friends get the invite from their pet (Join / Later) or in the Minigames page. The host can start the next round or switch game in the same room; round wins are counted with a 👑.</a:t>
+            </a:r>
+          </a:p>
+          <a:p>
+            <a:pPr>
+              <a:spcAft>
+                <a:spcPts val="1000"/>
+              </a:spcAft>
+            </a:pPr>
+            <a:r>
+              <a:rPr sz="1700" b="1">
+                <a:solidFill>
+                  <a:srgbClr val="4CB86B"/>
+                </a:solidFill>
+                <a:latin typeface="Segoe UI"/>
+              </a:rPr>
+              <a:t>•  </a:t>
+            </a:r>
+            <a:r>
+              <a:rPr sz="1700">
+                <a:solidFill>
+                  <a:srgbClr val="2B2A28"/>
+                </a:solidFill>
+                <a:latin typeface="Segoe UI"/>
+              </a:rPr>
+              <a:t>While you play a minigame your pet leaves the desktop and jumps into the game window - it plays, watches and cheers (or pouts) inside the game, and walks back onto the desktop when you close it.</a:t>
+            </a:r>
+          </a:p>
+          <a:p>
+            <a:pPr>
+              <a:spcAft>
+                <a:spcPts val="1000"/>
+              </a:spcAft>
+            </a:pPr>
+            <a:r>
+              <a:rPr sz="1700" b="1">
+                <a:solidFill>
+                  <a:srgbClr val="4CB86B"/>
+                </a:solidFill>
+                <a:latin typeface="Segoe UI"/>
+              </a:rPr>
+              <a:t>•  </a:t>
+            </a:r>
+            <a:r>
+              <a:rPr sz="1700">
+                <a:solidFill>
+                  <a:srgbClr val="2B2A28"/>
+                </a:solidFill>
+                <a:latin typeface="Segoe UI"/>
+              </a:rPr>
+              <a:t>Pet Duel is now one of the games inside Minigames - the separate Arena tab is gone (challenges still show as a badge on Play → Minigames).</a:t>
             </a:r>
           </a:p>
         </p:txBody>
@@ -8621,7 +8671,7 @@
                 </a:solidFill>
                 <a:latin typeface="Segoe UI"/>
               </a:rPr>
-              <a:t>Duel arena kini bisa main sendiri: nyalakan 🤖 Otomatis (tombol di pertarungan, tombol A, atau centang sebelum bertarung) dan pet memilih skill sendiri - menghabisi lawan yang lemah, menyembuhkan diri saat HP rendah, dan memakai Fokus di pertarungan panjang.</a:t>
+              <a:t>Kelima minigame kini bisa dimainkan bersama teman: Hub → Main → Minigame → ＋ Main baru bersama teman, pilih permainan dan hingga 7 teman (total 8 pemain).</a:t>
             </a:r>
           </a:p>
           <a:p>
@@ -8646,7 +8696,7 @@
                 </a:solidFill>
                 <a:latin typeface="Segoe UI"/>
               </a:rPr>
-              <a:t>Mau main sendiri? Biarkan Otomatis mati dan tekan tombol skill (atau 1-3) seperti biasa. Bisa diganti kapan saja, bahkan di tengah pertarungan.</a:t>
+              <a:t>Semua mendapat ronde yang sama di waktu yang sama (camilan, serangga, kartu, pola, dan rintangan yang sama) setelah hitungan 3-2-1, dan papan skor langsung menunjukkan skor teman-temanmu. Skor terbaik memenangkan ronde.</a:t>
             </a:r>
           </a:p>
           <a:p>
@@ -8671,7 +8721,57 @@
                 </a:solidFill>
                 <a:latin typeface="Segoe UI"/>
               </a:rPr>
-              <a:t>Pilihanmu diingat untuk pertarungan berikutnya.</a:t>
+              <a:t>Teman mendapat undangan dari pet-nya (Gabung / Nanti) atau di halaman Minigame. Tuan rumah bisa memulai ronde berikutnya atau ganti permainan di ruang yang sama; kemenangan ronde dihitung dengan 👑.</a:t>
+            </a:r>
+          </a:p>
+          <a:p>
+            <a:pPr>
+              <a:spcAft>
+                <a:spcPts val="500"/>
+              </a:spcAft>
+            </a:pPr>
+            <a:r>
+              <a:rPr sz="1200" b="1">
+                <a:solidFill>
+                  <a:srgbClr val="4CB86B"/>
+                </a:solidFill>
+                <a:latin typeface="Segoe UI"/>
+              </a:rPr>
+              <a:t>•  </a:t>
+            </a:r>
+            <a:r>
+              <a:rPr sz="1200">
+                <a:solidFill>
+                  <a:srgbClr val="2B2A28"/>
+                </a:solidFill>
+                <a:latin typeface="Segoe UI"/>
+              </a:rPr>
+              <a:t>Saat kamu main minigame, pet-mu meninggalkan desktop dan masuk ke jendela permainan - ia bermain, menonton dan bersorak (atau cemberut) di dalam game, lalu kembali ke desktop saat jendela ditutup.</a:t>
+            </a:r>
+          </a:p>
+          <a:p>
+            <a:pPr>
+              <a:spcAft>
+                <a:spcPts val="500"/>
+              </a:spcAft>
+            </a:pPr>
+            <a:r>
+              <a:rPr sz="1200" b="1">
+                <a:solidFill>
+                  <a:srgbClr val="4CB86B"/>
+                </a:solidFill>
+                <a:latin typeface="Segoe UI"/>
+              </a:rPr>
+              <a:t>•  </a:t>
+            </a:r>
+            <a:r>
+              <a:rPr sz="1200">
+                <a:solidFill>
+                  <a:srgbClr val="2B2A28"/>
+                </a:solidFill>
+                <a:latin typeface="Segoe UI"/>
+              </a:rPr>
+              <a:t>Duel Pet kini menjadi salah satu permainan di Minigame - tab Arena terpisah sudah dihapus (tantangan tetap muncul sebagai lencana di Main → Minigame).</a:t>
             </a:r>
           </a:p>
         </p:txBody>
@@ -8903,7 +9003,7 @@
         </p:nvGraphicFramePr>
         <p:xfrm>
           <a:off x="548640" y="1645920"/>
-          <a:ext cx="11155680" cy="30833568"/>
+          <a:ext cx="11155680" cy="31656528"/>
         </p:xfrm>
         <a:graphic>
           <a:graphicData uri="http://schemas.openxmlformats.org/drawingml/2006/table">
@@ -8997,7 +9097,7 @@
                           </a:solidFill>
                           <a:latin typeface="Segoe UI"/>
                         </a:rPr>
-                        <a:t>2.24.2</a:t>
+                        <a:t>2.25.0</a:t>
                       </a:r>
                     </a:p>
                   </a:txBody>
@@ -9019,7 +9119,7 @@
                           </a:solidFill>
                           <a:latin typeface="Segoe UI"/>
                         </a:rPr>
-                        <a:t>2026-10-29</a:t>
+                        <a:t>2026-10-30</a:t>
                       </a:r>
                     </a:p>
                   </a:txBody>
@@ -9041,7 +9141,7 @@
                           </a:solidFill>
                           <a:latin typeface="Segoe UI"/>
                         </a:rPr>
-                        <a:t>Auto battle</a:t>
+                        <a:t>Play with friends</a:t>
                       </a:r>
                     </a:p>
                     <a:p>
@@ -9052,7 +9152,7 @@
                           </a:solidFill>
                           <a:latin typeface="Segoe UI"/>
                         </a:rPr>
-                        <a:t>Arena battles can now play themselves: switch on 🤖 Auto (button in the battle, the A key, or the tick box before a fight) and your pet picks its skills - it finishes off a weak opponent, heals when low and saves Focus for long fights.; Prefer to play yourself? Leave Auto off and press the skill buttons (or keys 1-3) as before. You can switch any time, even mid-battle.; Your choice is remembered for the next fight.</a:t>
+                        <a:t>All 5 minigames can now be played with friends: Hub → Play → Minigames → ＋ New game with friends, pick a game and up to 7 friends (8 players in total).; Everyone gets the same round at the same time (same treats, bugs, cards, pattern and obstacles) after a 3-2-1 countdown, and a live scoreboard shows how your friends are doing. Best score wins the round.; Friends get the invite from their pet (Join / Later) or in the Minigames page. The host can start the next round or switch game in the same room; round wins are counted with a 👑.; While you play a minigame your pet leaves the desktop and jumps into the game window - it plays, watches and cheers (or pouts) inside the game, and walks back onto the desktop when you close it.</a:t>
                       </a:r>
                     </a:p>
                   </a:txBody>
@@ -9076,7 +9176,7 @@
                           </a:solidFill>
                           <a:latin typeface="Segoe UI"/>
                         </a:rPr>
-                        <a:t>2.24.1</a:t>
+                        <a:t>2.24.2</a:t>
                       </a:r>
                     </a:p>
                   </a:txBody>
@@ -9120,7 +9220,7 @@
                           </a:solidFill>
                           <a:latin typeface="Segoe UI"/>
                         </a:rPr>
-                        <a:t>No more surprise pop-ups</a:t>
+                        <a:t>Auto battle</a:t>
                       </a:r>
                     </a:p>
                     <a:p>
@@ -9131,7 +9231,7 @@
                           </a:solidFill>
                           <a:latin typeface="Segoe UI"/>
                         </a:rPr>
-                        <a:t>Clicking your pet now only tickles it - no window pops up. Double-click the pet to open the hub (or use the right-click menu).; The focus card and the dashboard stay hidden when Pips starts; open them only when you want them.; Prefer the old way? Right-click → Settings → When I click the pet.</a:t>
+                        <a:t>Arena battles can now play themselves: switch on 🤖 Auto (button in the battle, the A key, or the tick box before a fight) and your pet picks its skills - it finishes off a weak opponent, heals when low and saves Focus for long fights.; Prefer to play yourself? Leave Auto off and press the skill buttons (or keys 1-3) as before. You can switch any time, even mid-battle.; Your choice is remembered for the next fight.</a:t>
                       </a:r>
                     </a:p>
                   </a:txBody>
@@ -9155,7 +9255,7 @@
                           </a:solidFill>
                           <a:latin typeface="Segoe UI"/>
                         </a:rPr>
-                        <a:t>2.24.0</a:t>
+                        <a:t>2.24.1</a:t>
                       </a:r>
                     </a:p>
                   </a:txBody>
@@ -9199,7 +9299,7 @@
                           </a:solidFill>
                           <a:latin typeface="Segoe UI"/>
                         </a:rPr>
-                        <a:t>Skill battles, minigames &amp; a simpler Hub</a:t>
+                        <a:t>No more surprise pop-ups</a:t>
                       </a:r>
                     </a:p>
                     <a:p>
@@ -9210,7 +9310,7 @@
                           </a:solidFill>
                           <a:latin typeface="Segoe UI"/>
                         </a:rPr>
-                        <a:t>Arena battles are now turn-based: before a fight compare both pets' stats (level + gear), pick 3 skills, and the challenger chooses best of 1, 3 or 5 rounds. Take turns until one pet is knocked out - new skills unlock as you level up and with weapons and gadgets.; 5 new minigames to play with your pet: Treat Catch, Bonk the Bugs, Memory Match, Pet Says and Hop Hop. Best scores are saved and great scores earn a few coins (right-click → Games, or Hub → Play).; The Hub is simpler: 5 tabs - Friends, Chat (messages + groups), Play (arena, minigames, ranks), Shop and Me (profile + achievements).</a:t>
+                        <a:t>Clicking your pet now only tickles it - no window pops up. Double-click the pet to open the hub (or use the right-click menu).; The focus card and the dashboard stay hidden when Pips starts; open them only when you want them.; Prefer the old way? Right-click → Settings → When I click the pet.</a:t>
                       </a:r>
                     </a:p>
                   </a:txBody>
@@ -9234,7 +9334,7 @@
                           </a:solidFill>
                           <a:latin typeface="Segoe UI"/>
                         </a:rPr>
-                        <a:t>2.23.0</a:t>
+                        <a:t>2.24.0</a:t>
                       </a:r>
                     </a:p>
                   </a:txBody>
@@ -9278,7 +9378,7 @@
                           </a:solidFill>
                           <a:latin typeface="Segoe UI"/>
                         </a:rPr>
-                        <a:t>Weather on your desktop</a:t>
+                        <a:t>Skill battles, minigames &amp; a simpler Hub</a:t>
                       </a:r>
                     </a:p>
                     <a:p>
@@ -9289,7 +9389,7 @@
                           </a:solidFill>
                           <a:latin typeface="Segoe UI"/>
                         </a:rPr>
-                        <a:t>Your pet now shows the live weather right on your desktop: its own little rain cloud with an umbrella when it rains, a dark storm cloud with lightning, snow piling up at its feet, the sun, the moon and twinkling stars at night, drifting fog and leaves blowing in the wind. Prefer more? Switch the animation to the whole screen - or turn it off.; New right-click menu → Weather &amp; location: Follow my exact location (Windows location; a laptop is followed as you move), Approximate (from your internet connection), or Pick a place - search a city or paste exact coordinates from Google Maps. The pet tells you when the weather changes.; Works without Pips Friends (weather from Open-Meteo, no account needed). With Friends on, your profile city follows you too - but a city you hid stays hidden. If Windows location is turned off on your PC, Pips explains how to turn it on and uses your internet location meanwhile.</a:t>
+                        <a:t>Arena battles are now turn-based: before a fight compare both pets' stats (level + gear), pick 3 skills, and the challenger chooses best of 1, 3 or 5 rounds. Take turns until one pet is knocked out - new skills unlock as you level up and with weapons and gadgets.; 5 new minigames to play with your pet: Treat Catch, Bonk the Bugs, Memory Match, Pet Says and Hop Hop. Best scores are saved and great scores earn a few coins (right-click → Games, or Hub → Play).; The Hub is simpler: 5 tabs - Friends, Chat (messages + groups), Play (arena, minigames, ranks), Shop and Me (profile + achievements).</a:t>
                       </a:r>
                     </a:p>
                   </a:txBody>
@@ -9313,7 +9413,7 @@
                           </a:solidFill>
                           <a:latin typeface="Segoe UI"/>
                         </a:rPr>
-                        <a:t>2.22.0</a:t>
+                        <a:t>2.23.0</a:t>
                       </a:r>
                     </a:p>
                   </a:txBody>
@@ -9357,7 +9457,7 @@
                           </a:solidFill>
                           <a:latin typeface="Segoe UI"/>
                         </a:rPr>
-                        <a:t>Sing &amp; dance with music</a:t>
+                        <a:t>Weather on your desktop</a:t>
                       </a:r>
                     </a:p>
                     <a:p>
@@ -9368,7 +9468,7 @@
                           </a:solidFill>
                           <a:latin typeface="Segoe UI"/>
                         </a:rPr>
-                        <a:t>Sing, Dance, Moonwalk, Breakdance, Yoga, Rain dance and the show tricks now play real music. When your pet sings, it sings the melody in its own voice - a cat meows the tune, a frog ribbits it, a whale hums it - and when it dances, its animal call joins the beat.; Pick the song: right-click → Do a trick → Song for sing &amp; dance. Choose your animal's own song (every one of the 51 animals has its own tune), the song for its type (Meadow Hoedown for land, Ocean Calypso for water, Cloud Waltz for sky), Happy Pop, Disco Night, 8-bit Adventure, Lullaby, Lo-fi Chill, any other animal's song, Surprise me or No music.; Songs follow your sound settings (volume, sounds off, quiet during focus) and stop as soon as the trick is interrupted. Tricks your pet does by itself stay quiet.</a:t>
+                        <a:t>Your pet now shows the live weather right on your desktop: its own little rain cloud with an umbrella when it rains, a dark storm cloud with lightning, snow piling up at its feet, the sun, the moon and twinkling stars at night, drifting fog and leaves blowing in the wind. Prefer more? Switch the animation to the whole screen - or turn it off.; New right-click menu → Weather &amp; location: Follow my exact location (Windows location; a laptop is followed as you move), Approximate (from your internet connection), or Pick a place - search a city or paste exact coordinates from Google Maps. The pet tells you when the weather changes.; Works without Pips Friends (weather from Open-Meteo, no account needed). With Friends on, your profile city follows you too - but a city you hid stays hidden. If Windows location is turned off on your PC, Pips explains how to turn it on and uses your internet location meanwhile.</a:t>
                       </a:r>
                     </a:p>
                   </a:txBody>
@@ -9392,7 +9492,7 @@
                           </a:solidFill>
                           <a:latin typeface="Segoe UI"/>
                         </a:rPr>
-                        <a:t>2.21.0</a:t>
+                        <a:t>2.22.0</a:t>
                       </a:r>
                     </a:p>
                   </a:txBody>
@@ -9436,7 +9536,7 @@
                           </a:solidFill>
                           <a:latin typeface="Segoe UI"/>
                         </a:rPr>
-                        <a:t>Every animal has a voice</a:t>
+                        <a:t>Sing &amp; dance with music</a:t>
                       </a:r>
                     </a:p>
                     <a:p>
@@ -9447,7 +9547,7 @@
                           </a:solidFill>
                           <a:latin typeface="Segoe UI"/>
                         </a:rPr>
-                        <a:t>All 51 animals now have their own sound. Before, more than half of them borrowed the cat's meow - now the dog woofs, the cow moos, the sheep baas, the lion roars, the duck quacks, the dolphin clicks and whistles, the dragon flaps and roars with a puff of fire, the ghost goes wooo... and so on.; Every mood sounds different too: happy, sad, sleepy, hungry or grumpy. Petting, eating and snoring sound right for each kind of animal - furry ones purr and crunch, birds trill and peck, sea animals blow bubbles, bugs hum and magic pets chime.; A friend's pet that comes to visit now talks in its own voice: it says hi when it arrives and answers when you wave, pet it or give it a snack (it follows your sound settings).</a:t>
+                        <a:t>Sing, Dance, Moonwalk, Breakdance, Yoga, Rain dance and the show tricks now play real music. When your pet sings, it sings the melody in its own voice - a cat meows the tune, a frog ribbits it, a whale hums it - and when it dances, its animal call joins the beat.; Pick the song: right-click → Do a trick → Song for sing &amp; dance. Choose your animal's own song (every one of the 51 animals has its own tune), the song for its type (Meadow Hoedown for land, Ocean Calypso for water, Cloud Waltz for sky), Happy Pop, Disco Night, 8-bit Adventure, Lullaby, Lo-fi Chill, any other animal's song, Surprise me or No music.; Songs follow your sound settings (volume, sounds off, quiet during focus) and stop as soon as the trick is interrupted. Tricks your pet does by itself stay quiet.</a:t>
                       </a:r>
                     </a:p>
                   </a:txBody>
@@ -9471,7 +9571,7 @@
                           </a:solidFill>
                           <a:latin typeface="Segoe UI"/>
                         </a:rPr>
-                        <a:t>2.20.0</a:t>
+                        <a:t>2.21.0</a:t>
                       </a:r>
                     </a:p>
                   </a:txBody>
@@ -9515,7 +9615,7 @@
                           </a:solidFill>
                           <a:latin typeface="Segoe UI"/>
                         </a:rPr>
-                        <a:t>Come over</a:t>
+                        <a:t>Every animal has a voice</a:t>
                       </a:r>
                     </a:p>
                     <a:p>
@@ -9526,7 +9626,7 @@
                           </a:solidFill>
                           <a:latin typeface="Segoe UI"/>
                         </a:rPr>
-                        <a:t>When a friend's pet comes over it now wears a name tag: your friend's name (or the nickname you gave them), ♂/♀ and an online dot. It walks up to your pet, says hi, and looks at your mouse when you point at it.; Point at the visitor (or click its name tag) to open its card: whose pet it is, level, how close you two are, and buttons to wave, pet it, give it a snack, visit back or chat. It reacts to everything - hearts, crumbs, happy faces - and your friend sees it too.; Rub your mouse over the visitor to pet it. Playing with it makes it stay longer, and your pet comes down from a window or the sky to meet it.</a:t>
+                        <a:t>All 51 animals now have their own sound. Before, more than half of them borrowed the cat's meow - now the dog woofs, the cow moos, the sheep baas, the lion roars, the duck quacks, the dolphin clicks and whistles, the dragon flaps and roars with a puff of fire, the ghost goes wooo... and so on.; Every mood sounds different too: happy, sad, sleepy, hungry or grumpy. Petting, eating and snoring sound right for each kind of animal - furry ones purr and crunch, birds trill and peck, sea animals blow bubbles, bugs hum and magic pets chime.; A friend's pet that comes to visit now talks in its own voice: it says hi when it arrives and answers when you wave, pet it or give it a snack (it follows your sound settings).</a:t>
                       </a:r>
                     </a:p>
                   </a:txBody>
@@ -9550,7 +9650,7 @@
                           </a:solidFill>
                           <a:latin typeface="Segoe UI"/>
                         </a:rPr>
-                        <a:t>2.19.0</a:t>
+                        <a:t>2.20.0</a:t>
                       </a:r>
                     </a:p>
                   </a:txBody>
@@ -9594,7 +9694,7 @@
                           </a:solidFill>
                           <a:latin typeface="Segoe UI"/>
                         </a:rPr>
-                        <a:t>Land, sea &amp; sky</a:t>
+                        <a:t>Come over</a:t>
                       </a:r>
                     </a:p>
                     <a:p>
@@ -9605,7 +9705,7 @@
                           </a:solidFill>
                           <a:latin typeface="Segoe UI"/>
                         </a:rPr>
-                        <a:t>Land animals walk on the taskbar and on top of your open windows now: they jump up onto window edges, walk along them, ride along when you move the window and hop down when it closes, gets covered or is maximised. They always have gravity - let go of one in mid-air and it lands on the window below or on the taskbar.; Water animals swim along the taskbar (their water) and every now and then leap high out of it in a big arc, diving back in with a splash, ripples and spray. Drop one anywhere and it dives back into the water.; Flying animals fly anywhere on the screen: they flutter from place to place, hover, come say hi near your mouse, and sometimes perch on the taskbar or a window edge for a rest. Point at one and it waits for you; they glide down to a perch before a nap.; New menu moves: Jump onto a window, Splash jump!, Fly around / Rest on the taskbar. "Move around by myself" in Pet settings keeps your pet still if you prefer (the old Gravity option is gone - land animals always fall now).</a:t>
+                        <a:t>When a friend's pet comes over it now wears a name tag: your friend's name (or the nickname you gave them), ♂/♀ and an online dot. It walks up to your pet, says hi, and looks at your mouse when you point at it.; Point at the visitor (or click its name tag) to open its card: whose pet it is, level, how close you two are, and buttons to wave, pet it, give it a snack, visit back or chat. It reacts to everything - hearts, crumbs, happy faces - and your friend sees it too.; Rub your mouse over the visitor to pet it. Playing with it makes it stay longer, and your pet comes down from a window or the sky to meet it.</a:t>
                       </a:r>
                     </a:p>
                   </a:txBody>
@@ -9629,7 +9729,7 @@
                           </a:solidFill>
                           <a:latin typeface="Segoe UI"/>
                         </a:rPr>
-                        <a:t>2.18.0</a:t>
+                        <a:t>2.19.0</a:t>
                       </a:r>
                     </a:p>
                   </a:txBody>
@@ -9673,7 +9773,7 @@
                           </a:solidFill>
                           <a:latin typeface="Segoe UI"/>
                         </a:rPr>
-                        <a:t>Raise your pet</a:t>
+                        <a:t>Land, sea &amp; sky</a:t>
                       </a:r>
                     </a:p>
                     <a:p>
@@ -9684,7 +9784,7 @@
                           </a:solidFill>
                           <a:latin typeface="Segoe UI"/>
                         </a:rPr>
-                        <a:t>Boy or girl? Pick your pet's gender in Settings: boys get a little hair tuft, girls a pink bow and eyelashes, and a ♂ / ♀ shows next to its name. You can add your own gender to your profile too - friends see a small ♂ / ♀ next to your name.; Pets grow up now: baby → child → teen → grown-up. Focus sessions, opening Pips each day, games and cuddles help them grow - no care mistakes, no bad endings. Already have a grown-up pet? It will ask whether you'd like to raise it again from a baby (coins, items and stats stay).; Sick days: work 2.5 hours without a 5-minute break and your pet catches a little cold (sneezes, thermometer, slow steps). A short break cures it - or give medicine from the menu. You can turn this off in Settings.; New mini-game Left or Right? (pet menu → Play): guess which way your pet will look - 3 out of 5 wins, with coins for your first wins each day.</a:t>
+                        <a:t>Land animals walk on the taskbar and on top of your open windows now: they jump up onto window edges, walk along them, ride along when you move the window and hop down when it closes, gets covered or is maximised. They always have gravity - let go of one in mid-air and it lands on the window below or on the taskbar.; Water animals swim along the taskbar (their water) and every now and then leap high out of it in a big arc, diving back in with a splash, ripples and spray. Drop one anywhere and it dives back into the water.; Flying animals fly anywhere on the screen: they flutter from place to place, hover, come say hi near your mouse, and sometimes perch on the taskbar or a window edge for a rest. Point at one and it waits for you; they glide down to a perch before a nap.; New menu moves: Jump onto a window, Splash jump!, Fly around / Rest on the taskbar. "Move around by myself" in Pet settings keeps your pet still if you prefer (the old Gravity option is gone - land animals always fall now).</a:t>
                       </a:r>
                     </a:p>
                   </a:txBody>
@@ -9708,7 +9808,7 @@
                           </a:solidFill>
                           <a:latin typeface="Segoe UI"/>
                         </a:rPr>
-                        <a:t>2.17.0</a:t>
+                        <a:t>2.18.0</a:t>
                       </a:r>
                     </a:p>
                   </a:txBody>
@@ -9752,7 +9852,7 @@
                           </a:solidFill>
                           <a:latin typeface="Segoe UI"/>
                         </a:rPr>
-                        <a:t>Find your pet anytime</a:t>
+                        <a:t>Raise your pet</a:t>
                       </a:r>
                     </a:p>
                     <a:p>
@@ -9763,7 +9863,7 @@
                           </a:solidFill>
                           <a:latin typeface="Segoe UI"/>
                         </a:rPr>
-                        <a:t>Pips now has an icon next to the clock: click it to bring your pet back; right-click for the focus timer, Friends &amp; chat or Quit.; Press Ctrl+Alt+P anywhere to call your pet - it pops up on the screen you're using, even if it was hidden, asleep or behind a fullscreen app.; Opening Pips again from the Start menu or desktop does the same, and your pet walks back by itself if it ever ends up off-screen (e.g. after unplugging a monitor).; Hiding your pet now tells you how to bring it back.</a:t>
+                        <a:t>Boy or girl? Pick your pet's gender in Settings: boys get a little hair tuft, girls a pink bow and eyelashes, and a ♂ / ♀ shows next to its name. You can add your own gender to your profile too - friends see a small ♂ / ♀ next to your name.; Pets grow up now: baby → child → teen → grown-up. Focus sessions, opening Pips each day, games and cuddles help them grow - no care mistakes, no bad endings. Already have a grown-up pet? It will ask whether you'd like to raise it again from a baby (coins, items and stats stay).; Sick days: work 2.5 hours without a 5-minute break and your pet catches a little cold (sneezes, thermometer, slow steps). A short break cures it - or give medicine from the menu. You can turn this off in Settings.; New mini-game Left or Right? (pet menu → Play): guess which way your pet will look - 3 out of 5 wins, with coins for your first wins each day.</a:t>
                       </a:r>
                     </a:p>
                   </a:txBody>
@@ -9787,7 +9887,7 @@
                           </a:solidFill>
                           <a:latin typeface="Segoe UI"/>
                         </a:rPr>
-                        <a:t>2.16.0</a:t>
+                        <a:t>2.17.0</a:t>
                       </a:r>
                     </a:p>
                   </a:txBody>
@@ -9831,7 +9931,7 @@
                           </a:solidFill>
                           <a:latin typeface="Segoe UI"/>
                         </a:rPr>
-                        <a:t>Pips Community</a:t>
+                        <a:t>Find your pet anytime</a:t>
                       </a:r>
                     </a:p>
                     <a:p>
@@ -9842,7 +9942,7 @@
                           </a:solidFill>
                           <a:latin typeface="Segoe UI"/>
                         </a:rPr>
-                        <a:t>New Pips Community at the top of the Chat tab: a #general channel to chat with everyone who uses Pips, plus #announcements with news from the Pips team.; Every new Pips version is announced there automatically - see what's new and update with one click.; Type @name to ping someone in #general. Mute #general any time; owner and moderators can remove messages.; Open it from your pet's menu too (Pips Community). Fixed: chats no longer clear what you're typing when Pips refreshes in the background.</a:t>
+                        <a:t>Pips now has an icon next to the clock: click it to bring your pet back; right-click for the focus timer, Friends &amp; chat or Quit.; Press Ctrl+Alt+P anywhere to call your pet - it pops up on the screen you're using, even if it was hidden, asleep or behind a fullscreen app.; Opening Pips again from the Start menu or desktop does the same, and your pet walks back by itself if it ever ends up off-screen (e.g. after unplugging a monitor).; Hiding your pet now tells you how to bring it back.</a:t>
                       </a:r>
                     </a:p>
                   </a:txBody>
@@ -9866,7 +9966,7 @@
                           </a:solidFill>
                           <a:latin typeface="Segoe UI"/>
                         </a:rPr>
-                        <a:t>2.15.0</a:t>
+                        <a:t>2.16.0</a:t>
                       </a:r>
                     </a:p>
                   </a:txBody>
@@ -9910,7 +10010,7 @@
                           </a:solidFill>
                           <a:latin typeface="Segoe UI"/>
                         </a:rPr>
-                        <a:t>Update reminders</a:t>
+                        <a:t>Pips Community</a:t>
                       </a:r>
                     </a:p>
                     <a:p>
@@ -9921,7 +10021,7 @@
                           </a:solidFill>
                           <a:latin typeface="Segoe UI"/>
                         </a:rPr>
-                        <a:t>Owner &amp; moderators: the Mod tab now lists who hasn't updated Pips yet (their version and when they were last seen), with one-click reminders by e-mail (sent from your Outlook) or a ready-to-send Teams chat.; New Work e-mail field in your Profile, filled in from Outlook. Only the owner and moderators can see it (for update reminders and support) - clear it to hide it.; Pips now tells the Friends server which version it runs, so the update list is always accurate.; Friends keeps working when a local proxy tool stops answering - Pips falls back to the Windows proxy settings.</a:t>
+                        <a:t>New Pips Community at the top of the Chat tab: a #general channel to chat with everyone who uses Pips, plus #announcements with news from the Pips team.; Every new Pips version is announced there automatically - see what's new and update with one click.; Type @name to ping someone in #general. Mute #general any time; owner and moderators can remove messages.; Open it from your pet's menu too (Pips Community). Fixed: chats no longer clear what you're typing when Pips refreshes in the background.</a:t>
                       </a:r>
                     </a:p>
                   </a:txBody>
@@ -9945,7 +10045,7 @@
                           </a:solidFill>
                           <a:latin typeface="Segoe UI"/>
                         </a:rPr>
-                        <a:t>2.14.3</a:t>
+                        <a:t>2.15.0</a:t>
                       </a:r>
                     </a:p>
                   </a:txBody>
@@ -9989,7 +10089,7 @@
                           </a:solidFill>
                           <a:latin typeface="Segoe UI"/>
                         </a:rPr>
-                        <a:t>Tidy menus</a:t>
+                        <a:t>Update reminders</a:t>
                       </a:r>
                     </a:p>
                     <a:p>
@@ -10000,7 +10100,7 @@
                           </a:solidFill>
                           <a:latin typeface="Segoe UI"/>
                         </a:rPr>
-                        <a:t>Fixed: a submenu (e.g. Poke a friend) could stay floating on the screen after the right-click menu closed.; Menus now close by themselves when you move the mouse away and leave them for a few seconds.</a:t>
+                        <a:t>Owner &amp; moderators: the Mod tab now lists who hasn't updated Pips yet (their version and when they were last seen), with one-click reminders by e-mail (sent from your Outlook) or a ready-to-send Teams chat.; New Work e-mail field in your Profile, filled in from Outlook. Only the owner and moderators can see it (for update reminders and support) - clear it to hide it.; Pips now tells the Friends server which version it runs, so the update list is always accurate.; Friends keeps working when a local proxy tool stops answering - Pips falls back to the Windows proxy settings.</a:t>
                       </a:r>
                     </a:p>
                   </a:txBody>
@@ -10024,7 +10124,7 @@
                           </a:solidFill>
                           <a:latin typeface="Segoe UI"/>
                         </a:rPr>
-                        <a:t>2.14.2</a:t>
+                        <a:t>2.14.3</a:t>
                       </a:r>
                     </a:p>
                   </a:txBody>
@@ -10068,7 +10168,7 @@
                           </a:solidFill>
                           <a:latin typeface="Segoe UI"/>
                         </a:rPr>
-                        <a:t>Never miss an update</a:t>
+                        <a:t>Tidy menus</a:t>
                       </a:r>
                     </a:p>
                     <a:p>
@@ -10079,7 +10179,7 @@
                           </a:solidFill>
                           <a:latin typeface="Segoe UI"/>
                         </a:rPr>
-                        <a:t>Your pet now reminds you every 2 hours while a new version is waiting (instead of every 6 hours).; If the reminder can't show (fullscreen app, guided tour, another message), your pet tries again a few minutes later.; No internet when Pips starts (e.g. VPN off)? It checks again after an hour.</a:t>
+                        <a:t>Fixed: a submenu (e.g. Poke a friend) could stay floating on the screen after the right-click menu closed.; Menus now close by themselves when you move the mouse away and leave them for a few seconds.</a:t>
                       </a:r>
                     </a:p>
                   </a:txBody>
@@ -10103,7 +10203,7 @@
                           </a:solidFill>
                           <a:latin typeface="Segoe UI"/>
                         </a:rPr>
-                        <a:t>2.14.1</a:t>
+                        <a:t>2.14.2</a:t>
                       </a:r>
                     </a:p>
                   </a:txBody>
@@ -10147,7 +10247,7 @@
                           </a:solidFill>
                           <a:latin typeface="Segoe UI"/>
                         </a:rPr>
-                        <a:t>One pet at a time</a:t>
+                        <a:t>Never miss an update</a:t>
                       </a:r>
                     </a:p>
                     <a:p>
@@ -10158,7 +10258,7 @@
                           </a:solidFill>
                           <a:latin typeface="Segoe UI"/>
                         </a:rPr>
-                        <a:t>Opening Pips again (Desktop / Start Menu shortcut, autostart) no longer starts a second pet - your pet just pops up and says hi.; Fixes lag caused by two copies of Pips running at once.</a:t>
+                        <a:t>Your pet now reminds you every 2 hours while a new version is waiting (instead of every 6 hours).; If the reminder can't show (fullscreen app, guided tour, another message), your pet tries again a few minutes later.; No internet when Pips starts (e.g. VPN off)? It checks again after an hour.</a:t>
                       </a:r>
                     </a:p>
                   </a:txBody>
@@ -10182,7 +10282,7 @@
                           </a:solidFill>
                           <a:latin typeface="Segoe UI"/>
                         </a:rPr>
-                        <a:t>2.14.0</a:t>
+                        <a:t>2.14.1</a:t>
                       </a:r>
                     </a:p>
                   </a:txBody>
@@ -10226,7 +10326,7 @@
                           </a:solidFill>
                           <a:latin typeface="Segoe UI"/>
                         </a:rPr>
-                        <a:t>Pokes, tickles &amp; teases</a:t>
+                        <a:t>One pet at a time</a:t>
                       </a:r>
                     </a:p>
                     <a:p>
@@ -10237,7 +10337,7 @@
                           </a:solidFill>
                           <a:latin typeface="Segoe UI"/>
                         </a:rPr>
-                        <a:t>Poke, tickle, tease, boop or hug a friend from afar - no pet visit needed.; Right-click your pet → Poke a friend, or use the Poke button in Friends, chat and profiles.; Your friend gets a pop-up ("Wendy is teasing you!"), their pet reacts, and they can poke back with one click.; During a focus session pokes wait quietly until your break; when your pet is hidden they show in the screen corner.</a:t>
+                        <a:t>Opening Pips again (Desktop / Start Menu shortcut, autostart) no longer starts a second pet - your pet just pops up and says hi.; Fixes lag caused by two copies of Pips running at once.</a:t>
                       </a:r>
                     </a:p>
                   </a:txBody>
@@ -10261,7 +10361,7 @@
                           </a:solidFill>
                           <a:latin typeface="Segoe UI"/>
                         </a:rPr>
-                        <a:t>2.13.1</a:t>
+                        <a:t>2.14.0</a:t>
                       </a:r>
                     </a:p>
                   </a:txBody>
@@ -10283,7 +10383,7 @@
                           </a:solidFill>
                           <a:latin typeface="Segoe UI"/>
                         </a:rPr>
-                        <a:t>2026-10-28</a:t>
+                        <a:t>2026-10-29</a:t>
                       </a:r>
                     </a:p>
                   </a:txBody>
@@ -10305,7 +10405,7 @@
                           </a:solidFill>
                           <a:latin typeface="Segoe UI"/>
                         </a:rPr>
-                        <a:t>One-click Windows installer</a:t>
+                        <a:t>Pokes, tickles &amp; teases</a:t>
                       </a:r>
                     </a:p>
                     <a:p>
@@ -10316,7 +10416,7 @@
                           </a:solidFill>
                           <a:latin typeface="Segoe UI"/>
                         </a:rPr>
-                        <a:t>One Windows installer: no ZIP extraction, Python installation or command line. Download, open and click Install Pips.; Installs for your Windows account without administrator access, adds Desktop and Start Menu shortcuts, and opens Pips automatically.; Reinstalling in the same location keeps your settings and pet progress. Existing ZIP users can keep updating in place from Help → Check for updates.; A simpler download page and updated user guide; the bundled runtime stays separate from small in-app updates.</a:t>
+                        <a:t>Poke, tickle, tease, boop or hug a friend from afar - no pet visit needed.; Right-click your pet → Poke a friend, or use the Poke button in Friends, chat and profiles.; Your friend gets a pop-up ("Wendy is teasing you!"), their pet reacts, and they can poke back with one click.; During a focus session pokes wait quietly until your break; when your pet is hidden they show in the screen corner.</a:t>
                       </a:r>
                     </a:p>
                   </a:txBody>
@@ -10340,7 +10440,7 @@
                           </a:solidFill>
                           <a:latin typeface="Segoe UI"/>
                         </a:rPr>
-                        <a:t>2.13.0</a:t>
+                        <a:t>2.13.1</a:t>
                       </a:r>
                     </a:p>
                   </a:txBody>
@@ -10384,7 +10484,7 @@
                           </a:solidFill>
                           <a:latin typeface="Segoe UI"/>
                         </a:rPr>
-                        <a:t>Birthdays, parties &amp; gifts</a:t>
+                        <a:t>One-click Windows installer</a:t>
                       </a:r>
                     </a:p>
                     <a:p>
@@ -10395,7 +10495,7 @@
                           </a:solidFill>
                           <a:latin typeface="Segoe UI"/>
                         </a:rPr>
-                        <a:t>Set your birthday in Social → Profile (month + day, optionally visible to friends).; On your birthday Pips throws confetti and gives you 100 bonus coins.; Friends tab shows upcoming birthdays; you get reminders 3 days, 1 day and on the day.; Birthday parties: join a friend's party, see who's there, sign the guestbook and celebrate together.</a:t>
+                        <a:t>One Windows installer: no ZIP extraction, Python installation or command line. Download, open and click Install Pips.; Installs for your Windows account without administrator access, adds Desktop and Start Menu shortcuts, and opens Pips automatically.; Reinstalling in the same location keeps your settings and pet progress. Existing ZIP users can keep updating in place from Help → Check for updates.; A simpler download page and updated user guide; the bundled runtime stays separate from small in-app updates.</a:t>
                       </a:r>
                     </a:p>
                   </a:txBody>
@@ -10419,7 +10519,7 @@
                           </a:solidFill>
                           <a:latin typeface="Segoe UI"/>
                         </a:rPr>
-                        <a:t>2.12.0</a:t>
+                        <a:t>2.13.0</a:t>
                       </a:r>
                     </a:p>
                   </a:txBody>
@@ -10463,7 +10563,7 @@
                           </a:solidFill>
                           <a:latin typeface="Segoe UI"/>
                         </a:rPr>
-                        <a:t>Mega update: 28 new animals, 31 shop items, 13 moves</a:t>
+                        <a:t>Birthdays, parties &amp; gifts</a:t>
                       </a:r>
                     </a:p>
                     <a:p>
@@ -10474,7 +10574,7 @@
                           </a:solidFill>
                           <a:latin typeface="Segoe UI"/>
                         </a:rPr>
-                        <a:t>🦁 28 new animals (51 total): lion, tiger, unicorn, deer, sheep, cow, raccoon, red panda, monkey, hedgehog, dino, squirrel, mouse, koala, shark, dolphin, seal, otter, pufferfish, duck, crab, parrot, chick, ladybug, phoenix, pegasus, ghost and flamingo; 🎩 31 new shop items: top hat, cowboy, chef, pirate, Santa, viking, graduation cap, beret, bow, propeller cap, flower crown, nerd glasses, eyepatch, mustache, goggles, masquerade mask, tie, pearls, flower lei, gold chain, balloon, backpack, guitar, shield, butterfly / devil wings and more - plus Premium galaxy crown, galaxy cape and dragon wings; 💃 13 new moves: wave, jump, hearts, sing, yoga, zoomies, cartwheel, juggle, rain dance, breakdance, magic, confetti and the Premium rocket launch; The Shop is now split into sections (Hats, Face, Neck, Back, Moves, Arena gear) with an owned counter for each</a:t>
+                        <a:t>Set your birthday in Social → Profile (month + day, optionally visible to friends).; On your birthday Pips throws confetti and gives you 100 bonus coins.; Friends tab shows upcoming birthdays; you get reminders 3 days, 1 day and on the day.; Birthday parties: join a friend's party, see who's there, sign the guestbook and celebrate together.</a:t>
                       </a:r>
                     </a:p>
                   </a:txBody>
@@ -10498,7 +10598,7 @@
                           </a:solidFill>
                           <a:latin typeface="Segoe UI"/>
                         </a:rPr>
-                        <a:t>2.11.0</a:t>
+                        <a:t>2.12.0</a:t>
                       </a:r>
                     </a:p>
                   </a:txBody>
@@ -10542,7 +10642,7 @@
                           </a:solidFill>
                           <a:latin typeface="Segoe UI"/>
                         </a:rPr>
-                        <a:t>New right-click menus</a:t>
+                        <a:t>Mega update: 28 new animals, 31 shop items, 13 moves</a:t>
                       </a:r>
                     </a:p>
                     <a:p>
@@ -10553,7 +10653,7 @@
                           </a:solidFill>
                           <a:latin typeface="Segoe UI"/>
                         </a:rPr>
-                        <a:t>✨ Brand-new animated right-click menu for your pet: mood &amp; stat bars, quick-action tiles (Friends, Shop, Snack, Pat, Focus, Stats, Sleep, Taskbar), hover effects and smooth fly-out submenus; Pick colours from swatches, switch size with one click and flip Sounds / Dark mode with toggle switches - changes show instantly; Updates are highlighted: a glowing banner and NEW badge appear in the menu when a new version is ready; The focus card's right-click menu got the same new look; keyboard arrows, Enter and Esc work too</a:t>
+                        <a:t>🦁 28 new animals (51 total): lion, tiger, unicorn, deer, sheep, cow, raccoon, red panda, monkey, hedgehog, dino, squirrel, mouse, koala, shark, dolphin, seal, otter, pufferfish, duck, crab, parrot, chick, ladybug, phoenix, pegasus, ghost and flamingo; 🎩 31 new shop items: top hat, cowboy, chef, pirate, Santa, viking, graduation cap, beret, bow, propeller cap, flower crown, nerd glasses, eyepatch, mustache, goggles, masquerade mask, tie, pearls, flower lei, gold chain, balloon, backpack, guitar, shield, butterfly / devil wings and more - plus Premium galaxy crown, galaxy cape and dragon wings; 💃 13 new moves: wave, jump, hearts, sing, yoga, zoomies, cartwheel, juggle, rain dance, breakdance, magic, confetti and the Premium rocket launch; The Shop is now split into sections (Hats, Face, Neck, Back, Moves, Arena gear) with an owned counter for each</a:t>
                       </a:r>
                     </a:p>
                   </a:txBody>
@@ -10577,7 +10677,7 @@
                           </a:solidFill>
                           <a:latin typeface="Segoe UI"/>
                         </a:rPr>
-                        <a:t>2.10.0</a:t>
+                        <a:t>2.11.0</a:t>
                       </a:r>
                     </a:p>
                   </a:txBody>
@@ -10621,7 +10721,7 @@
                           </a:solidFill>
                           <a:latin typeface="Segoe UI"/>
                         </a:rPr>
-                        <a:t>Chat bots</a:t>
+                        <a:t>New right-click menus</a:t>
                       </a:r>
                     </a:p>
                     <a:p>
@@ -10632,7 +10732,7 @@
                           </a:solidFill>
                           <a:latin typeface="Segoe UI"/>
                         </a:rPr>
-                        <a:t>🤖 6 friendly chat bots in the Chat tab: Pip Helper (app questions), Coach Focus (focus tips from your real stats), Sunny (live weather for any city), Arena Master (battle tips + quick battle), Giggles (jokes &amp; games) and Guardian (safety &amp; reporting help); Private bot chats with suggestion chips, typing indicator and a clear button - your bot chats stay on your PC; Mention a bot in a group chat (e.g. @weather Batam) and it answers in the room for everyone; Bots reply in your app language; up to 120 bot messages per day</a:t>
+                        <a:t>✨ Brand-new animated right-click menu for your pet: mood &amp; stat bars, quick-action tiles (Friends, Shop, Snack, Pat, Focus, Stats, Sleep, Taskbar), hover effects and smooth fly-out submenus; Pick colours from swatches, switch size with one click and flip Sounds / Dark mode with toggle switches - changes show instantly; Updates are highlighted: a glowing banner and NEW badge appear in the menu when a new version is ready; The focus card's right-click menu got the same new look; keyboard arrows, Enter and Esc work too</a:t>
                       </a:r>
                     </a:p>
                   </a:txBody>
@@ -10656,7 +10756,7 @@
                           </a:solidFill>
                           <a:latin typeface="Segoe UI"/>
                         </a:rPr>
-                        <a:t>2.9.0</a:t>
+                        <a:t>2.10.0</a:t>
                       </a:r>
                     </a:p>
                   </a:txBody>
@@ -10700,7 +10800,7 @@
                           </a:solidFill>
                           <a:latin typeface="Segoe UI"/>
                         </a:rPr>
-                        <a:t>Location &amp; live weather</a:t>
+                        <a:t>Chat bots</a:t>
                       </a:r>
                     </a:p>
                     <a:p>
@@ -10711,7 +10811,7 @@
                           </a:solidFill>
                           <a:latin typeface="Segoe UI"/>
                         </a:rPr>
-                        <a:t>📍 Add your city in Profile → Location &amp; weather (auto-detect or search) - only your city and country are shown, never your exact position; Live weather banners on every profile with animations: rain, drizzle, thunderstorms with lightning, snow, fog, clouds, sunshine or a starry night - plus temperature, feels-like, humidity, wind and local time; Your own weather strip on top of the hub, and each friend's weather + local time in the friends list; Hide your location from others or remove it any time</a:t>
+                        <a:t>🤖 6 friendly chat bots in the Chat tab: Pip Helper (app questions), Coach Focus (focus tips from your real stats), Sunny (live weather for any city), Arena Master (battle tips + quick battle), Giggles (jokes &amp; games) and Guardian (safety &amp; reporting help); Private bot chats with suggestion chips, typing indicator and a clear button - your bot chats stay on your PC; Mention a bot in a group chat (e.g. @weather Batam) and it answers in the room for everyone; Bots reply in your app language; up to 120 bot messages per day</a:t>
                       </a:r>
                     </a:p>
                   </a:txBody>
@@ -10735,7 +10835,7 @@
                           </a:solidFill>
                           <a:latin typeface="Segoe UI"/>
                         </a:rPr>
-                        <a:t>2.8.0</a:t>
+                        <a:t>2.9.0</a:t>
                       </a:r>
                     </a:p>
                   </a:txBody>
@@ -10779,7 +10879,7 @@
                           </a:solidFill>
                           <a:latin typeface="Segoe UI"/>
                         </a:rPr>
-                        <a:t>Pips Arena - duels, gear &amp; live battles</a:t>
+                        <a:t>Location &amp; live weather</a:t>
                       </a:r>
                     </a:p>
                     <a:p>
@@ -10790,7 +10890,7 @@
                           </a:solidFill>
                           <a:latin typeface="Segoe UI"/>
                         </a:rPr>
-                        <a:t>⚔ New Arena tab: challenge friends or anyone in the arena to a live duel - each round pick Attack, Guard or Special within 12 seconds and watch your pets fight; ⚡ Quick battle: an instant auto-fight against anyone's fighter, even when they're offline; Arena gear in the Shop: 7 weapons (water pistol to rocket launcher), 5 armors and 5 gadgets that decide your special move - better gear and a higher level make a stronger fighter; Live duels can be watched by everyone, plus recent battle replays, top fighters, rating and win/loss records; wins earn coins</a:t>
+                        <a:t>📍 Add your city in Profile → Location &amp; weather (auto-detect or search) - only your city and country are shown, never your exact position; Live weather banners on every profile with animations: rain, drizzle, thunderstorms with lightning, snow, fog, clouds, sunshine or a starry night - plus temperature, feels-like, humidity, wind and local time; Your own weather strip on top of the hub, and each friend's weather + local time in the friends list; Hide your location from others or remove it any time</a:t>
                       </a:r>
                     </a:p>
                   </a:txBody>
@@ -10814,7 +10914,7 @@
                           </a:solidFill>
                           <a:latin typeface="Segoe UI"/>
                         </a:rPr>
-                        <a:t>2.7.0</a:t>
+                        <a:t>2.8.0</a:t>
                       </a:r>
                     </a:p>
                   </a:txBody>
@@ -10858,7 +10958,7 @@
                           </a:solidFill>
                           <a:latin typeface="Segoe UI"/>
                         </a:rPr>
-                        <a:t>Moderators &amp; Premium</a:t>
+                        <a:t>Pips Arena - duels, gear &amp; live battles</a:t>
                       </a:r>
                     </a:p>
                     <a:p>
@@ -10869,7 +10969,7 @@
                           </a:solidFill>
                           <a:latin typeface="Segoe UI"/>
                         </a:rPr>
-                        <a:t>★ Premium: a purple Premium badge, 4 exclusive props (tiara, star glasses, diamond necklace, fairy wings), the Fireworks move, +30 coins every day, double friend-interaction coins and room for 300 friends / 30 groups; Get Premium: Profile tab → Premium → "Ask to buy" emails the owner; after payment you receive a key (PIPS-XXXX-XXXX) to redeem right there; 🛡 Moderators: a blue Mod badge and a Mod tab with the report queue - warn, mute (1h / 24h / 7 days), clear a profile or reset a name; every action is logged; Report button on everyone's profile, so moderators can keep Pips friendly</a:t>
+                        <a:t>⚔ New Arena tab: challenge friends or anyone in the arena to a live duel - each round pick Attack, Guard or Special within 12 seconds and watch your pets fight; ⚡ Quick battle: an instant auto-fight against anyone's fighter, even when they're offline; Arena gear in the Shop: 7 weapons (water pistol to rocket launcher), 5 armors and 5 gadgets that decide your special move - better gear and a higher level make a stronger fighter; Live duels can be watched by everyone, plus recent battle replays, top fighters, rating and win/loss records; wins earn coins</a:t>
                       </a:r>
                     </a:p>
                   </a:txBody>
@@ -10893,7 +10993,7 @@
                           </a:solidFill>
                           <a:latin typeface="Segoe UI"/>
                         </a:rPr>
-                        <a:t>2.6.1</a:t>
+                        <a:t>2.7.0</a:t>
                       </a:r>
                     </a:p>
                   </a:txBody>
@@ -10937,7 +11037,7 @@
                           </a:solidFill>
                           <a:latin typeface="Segoe UI"/>
                         </a:rPr>
-                        <a:t>Owner badge &amp; credits</a:t>
+                        <a:t>Moderators &amp; Premium</a:t>
                       </a:r>
                     </a:p>
                     <a:p>
@@ -10948,7 +11048,7 @@
                           </a:solidFill>
                           <a:latin typeface="Segoe UI"/>
                         </a:rPr>
-                        <a:t>The creator of Pips (Juwen Lie) now shows a gold ♛ Owner badge on his profile, friend list and ranks; New About Pips card in the Profile tab: credits and how to contact the owner (Juwen_Lie@pegatroncorp.com) with Email and Copy buttons; Right-click the pet → Help → About now shows who made Pips and the contact email</a:t>
+                        <a:t>★ Premium: a purple Premium badge, 4 exclusive props (tiara, star glasses, diamond necklace, fairy wings), the Fireworks move, +30 coins every day, double friend-interaction coins and room for 300 friends / 30 groups; Get Premium: Profile tab → Premium → "Ask to buy" emails the owner; after payment you receive a key (PIPS-XXXX-XXXX) to redeem right there; 🛡 Moderators: a blue Mod badge and a Mod tab with the report queue - warn, mute (1h / 24h / 7 days), clear a profile or reset a name; every action is logged; Report button on everyone's profile, so moderators can keep Pips friendly</a:t>
                       </a:r>
                     </a:p>
                   </a:txBody>
@@ -10972,7 +11072,7 @@
                           </a:solidFill>
                           <a:latin typeface="Segoe UI"/>
                         </a:rPr>
-                        <a:t>2.6.0</a:t>
+                        <a:t>2.6.1</a:t>
                       </a:r>
                     </a:p>
                   </a:txBody>
@@ -11016,7 +11116,7 @@
                           </a:solidFill>
                           <a:latin typeface="Segoe UI"/>
                         </a:rPr>
-                        <a:t>Profiles, ranks, online status &amp; dark mode</a:t>
+                        <a:t>Owner badge &amp; credits</a:t>
                       </a:r>
                     </a:p>
                     <a:p>
@@ -11027,7 +11127,7 @@
                           </a:solidFill>
                           <a:latin typeface="Segoe UI"/>
                         </a:rPr>
-                        <a:t>Profile tab: profile picture (or your pet), about me, job, location, hobbies, birthday and a status message; Public or private: public profiles can be added directly and viewed in full; private profiles need a friend request that they accept, and strangers only see name, photo, pet, level and status; Click anyone to open their profile - badges, info, their friends - and add them, chat or wave from there; Ranks tab replaces Teams: everyone using Pips, sorted by XP, badges or streak</a:t>
+                        <a:t>The creator of Pips (Juwen Lie) now shows a gold ♛ Owner badge on his profile, friend list and ranks; New About Pips card in the Profile tab: credits and how to contact the owner (Juwen_Lie@pegatroncorp.com) with Email and Copy buttons; Right-click the pet → Help → About now shows who made Pips and the contact email</a:t>
                       </a:r>
                     </a:p>
                   </a:txBody>
@@ -11051,7 +11151,7 @@
                           </a:solidFill>
                           <a:latin typeface="Segoe UI"/>
                         </a:rPr>
-                        <a:t>2.5.1</a:t>
+                        <a:t>2.6.0</a:t>
                       </a:r>
                     </a:p>
                   </a:txBody>
@@ -11095,7 +11195,7 @@
                           </a:solidFill>
                           <a:latin typeface="Segoe UI"/>
                         </a:rPr>
-                        <a:t>New cute Pips logo</a:t>
+                        <a:t>Profiles, ranks, online status &amp; dark mode</a:t>
                       </a:r>
                     </a:p>
                     <a:p>
@@ -11106,7 +11206,7 @@
                           </a:solidFill>
                           <a:latin typeface="Segoe UI"/>
                         </a:rPr>
-                        <a:t>New Pips logo: Pip the cat on a Pips-red tile, matching the app colours (desktop shortcut, windows and website)</a:t>
+                        <a:t>Profile tab: profile picture (or your pet), about me, job, location, hobbies, birthday and a status message; Public or private: public profiles can be added directly and viewed in full; private profiles need a friend request that they accept, and strangers only see name, photo, pet, level and status; Click anyone to open their profile - badges, info, their friends - and add them, chat or wave from there; Ranks tab replaces Teams: everyone using Pips, sorted by XP, badges or streak</a:t>
                       </a:r>
                     </a:p>
                   </a:txBody>
@@ -11130,7 +11230,7 @@
                           </a:solidFill>
                           <a:latin typeface="Segoe UI"/>
                         </a:rPr>
-                        <a:t>2.5.0</a:t>
+                        <a:t>2.5.1</a:t>
                       </a:r>
                     </a:p>
                   </a:txBody>
@@ -11174,7 +11274,7 @@
                           </a:solidFill>
                           <a:latin typeface="Segoe UI"/>
                         </a:rPr>
-                        <a:t>Shop, coins, props &amp; moves</a:t>
+                        <a:t>New cute Pips logo</a:t>
                       </a:r>
                     </a:p>
                     <a:p>
@@ -11185,7 +11285,7 @@
                           </a:solidFill>
                           <a:latin typeface="Segoe UI"/>
                         </a:rPr>
-                        <a:t>Shop: earn coins and spend them on your pet - 17 props (crown, wizard hat, headphones, shades, scarf, cape, angel wings...) and 6 moves: spin, dance, moonwalk, backflip, kung fu and spider swing!; Coins come from leveling up (+40), badges (+25), opening Pips each day (+10), friendships (+15 per affinity level), waving / chatting / visiting friends (+2) and pomodoros (+5). Everyone starts with a 100-coin gift; Your friends see your props: on avatars in the hub and when your pet visits their desktop - it shows off one of your moves; Pips is now a social pet: clicking the pet opens the Pips hub (friends, chat, groups, shop, badges)</a:t>
+                        <a:t>New Pips logo: Pip the cat on a Pips-red tile, matching the app colours (desktop shortcut, windows and website)</a:t>
                       </a:r>
                     </a:p>
                   </a:txBody>
@@ -11209,7 +11309,7 @@
                           </a:solidFill>
                           <a:latin typeface="Segoe UI"/>
                         </a:rPr>
-                        <a:t>2.4.0</a:t>
+                        <a:t>2.5.0</a:t>
                       </a:r>
                     </a:p>
                   </a:txBody>
@@ -11253,7 +11353,7 @@
                           </a:solidFill>
                           <a:latin typeface="Segoe UI"/>
                         </a:rPr>
-                        <a:t>Chat, groups, affinity &amp; pet visits</a:t>
+                        <a:t>Shop, coins, props &amp; moves</a:t>
                       </a:r>
                     </a:p>
                     <a:p>
@@ -11264,7 +11364,7 @@
                           </a:solidFill>
                           <a:latin typeface="Segoe UI"/>
                         </a:rPr>
-                        <a:t>Chat: message your friends, and chat inside groups. Your pet pops up new messages as a bubble - click it to reply; Pet interactions: wave, pet their pet, send a snack, high five - or send your pet to visit: it walks onto your friend's desktop for a little while!; Affinity: every chat and interaction grows your friendship - Acquaintance → Buddy → Good friends → Close friends → Best friends → Soulmates; Your own groups: create a private group, invite your friends, they accept or decline. Group board + group chat; the owner can remove members</a:t>
+                        <a:t>Shop: earn coins and spend them on your pet - 17 props (crown, wizard hat, headphones, shades, scarf, cape, angel wings...) and 6 moves: spin, dance, moonwalk, backflip, kung fu and spider swing!; Coins come from leveling up (+40), badges (+25), opening Pips each day (+10), friendships (+15 per affinity level), waving / chatting / visiting friends (+2) and pomodoros (+5). Everyone starts with a 100-coin gift; Your friends see your props: on avatars in the hub and when your pet visits their desktop - it shows off one of your moves; Pips is now a social pet: clicking the pet opens the Pips hub (friends, chat, groups, shop, badges)</a:t>
                       </a:r>
                     </a:p>
                   </a:txBody>
@@ -11288,7 +11388,7 @@
                           </a:solidFill>
                           <a:latin typeface="Segoe UI"/>
                         </a:rPr>
-                        <a:t>2.3.0</a:t>
+                        <a:t>2.4.0</a:t>
                       </a:r>
                     </a:p>
                   </a:txBody>
@@ -11332,7 +11432,7 @@
                           </a:solidFill>
                           <a:latin typeface="Segoe UI"/>
                         </a:rPr>
-                        <a:t>Friends, levels &amp; achievements</a:t>
+                        <a:t>Chat, groups, affinity &amp; pet visits</a:t>
                       </a:r>
                     </a:p>
                     <a:p>
@@ -11343,7 +11443,7 @@
                           </a:solidFill>
                           <a:latin typeface="Segoe UI"/>
                         </a:rPr>
-                        <a:t>Levels &amp; XP: every finished pomodoro earns XP and your level grows - plus 20 achievements to unlock (first tomato, 8 in a day, 7-day streak, early bird, night owl, pet lover...). Your pet celebrates each one; Friends (optional, off by default): get a 6-letter friend code, add colleagues, see today's board and join a team board like PTB. Your pet tells you when a friend finishes a pomodoro; Privacy: only your name, pet, level, streak and pomodoro counts are shared - never apps, window titles or scores. One click turns it off and deletes your online data. Right-click the pet → Friends &amp; achievements…</a:t>
+                        <a:t>Chat: message your friends, and chat inside groups. Your pet pops up new messages as a bubble - click it to reply; Pet interactions: wave, pet their pet, send a snack, high five - or send your pet to visit: it walks onto your friend's desktop for a little while!; Affinity: every chat and interaction grows your friendship - Acquaintance → Buddy → Good friends → Close friends → Best friends → Soulmates; Your own groups: create a private group, invite your friends, they accept or decline. Group board + group chat; the owner can remove members</a:t>
                       </a:r>
                     </a:p>
                   </a:txBody>
@@ -11367,7 +11467,7 @@
                           </a:solidFill>
                           <a:latin typeface="Segoe UI"/>
                         </a:rPr>
-                        <a:t>2.2.0</a:t>
+                        <a:t>2.3.0</a:t>
                       </a:r>
                     </a:p>
                   </a:txBody>
@@ -11411,7 +11511,7 @@
                           </a:solidFill>
                           <a:latin typeface="Segoe UI"/>
                         </a:rPr>
-                        <a:t>Pet sounds</a:t>
+                        <a:t>Friends, levels &amp; achievements</a:t>
                       </a:r>
                     </a:p>
                     <a:p>
@@ -11422,7 +11522,7 @@
                           </a:solidFill>
                           <a:latin typeface="Segoe UI"/>
                         </a:rPr>
-                        <a:t>Your pet has a voice! Each of the 23 animals has its own sound (meow, woof, ribbit, hoot, buzz, oink, whale song...) and it changes with its mood: happy chirps, sad whimpers, sleepy yawns, hungry calls, grumpy huffs and soft snores; It also reacts with sound when you tickle, pet, feed, shake or wake it; Settings: right-click the pet → Sounds to switch on/off; Pet status &amp; settings has a volume slider, a ▶ Hear me button and "Stay quiet while I'm focusing" (on by default)</a:t>
+                        <a:t>Levels &amp; XP: every finished pomodoro earns XP and your level grows - plus 20 achievements to unlock (first tomato, 8 in a day, 7-day streak, early bird, night owl, pet lover...). Your pet celebrates each one; Friends (optional, off by default): get a 6-letter friend code, add colleagues, see today's board and join a team board like PTB. Your pet tells you when a friend finishes a pomodoro; Privacy: only your name, pet, level, streak and pomodoro counts are shared - never apps, window titles or scores. One click turns it off and deletes your online data. Right-click the pet → Friends &amp; achievements…</a:t>
                       </a:r>
                     </a:p>
                   </a:txBody>
@@ -11446,7 +11546,7 @@
                           </a:solidFill>
                           <a:latin typeface="Segoe UI"/>
                         </a:rPr>
-                        <a:t>2.1.2</a:t>
+                        <a:t>2.2.0</a:t>
                       </a:r>
                     </a:p>
                   </a:txBody>
@@ -11490,7 +11590,7 @@
                           </a:solidFill>
                           <a:latin typeface="Segoe UI"/>
                         </a:rPr>
-                        <a:t>Tickle-only mode</a:t>
+                        <a:t>Pet sounds</a:t>
                       </a:r>
                     </a:p>
                     <a:p>
@@ -11501,7 +11601,7 @@
                           </a:solidFill>
                           <a:latin typeface="Segoe UI"/>
                         </a:rPr>
-                        <a:t>New click option "Only tickle (never open Pips)": click and tickle your pet as much as you like - the Pomodoro window stays closed (open it from the right-click menu). Right-click the pet → When I click</a:t>
+                        <a:t>Your pet has a voice! Each of the 23 animals has its own sound (meow, woof, ribbit, hoot, buzz, oink, whale song...) and it changes with its mood: happy chirps, sad whimpers, sleepy yawns, hungry calls, grumpy huffs and soft snores; It also reacts with sound when you tickle, pet, feed, shake or wake it; Settings: right-click the pet → Sounds to switch on/off; Pet status &amp; settings has a volume slider, a ▶ Hear me button and "Stay quiet while I'm focusing" (on by default)</a:t>
                       </a:r>
                     </a:p>
                   </a:txBody>
@@ -11525,7 +11625,7 @@
                           </a:solidFill>
                           <a:latin typeface="Segoe UI"/>
                         </a:rPr>
-                        <a:t>2.1.1</a:t>
+                        <a:t>2.1.2</a:t>
                       </a:r>
                     </a:p>
                   </a:txBody>
@@ -11569,7 +11669,7 @@
                           </a:solidFill>
                           <a:latin typeface="Segoe UI"/>
                         </a:rPr>
-                        <a:t>Owner info</a:t>
+                        <a:t>Tickle-only mode</a:t>
                       </a:r>
                     </a:p>
                     <a:p>
@@ -11580,7 +11680,7 @@
                           </a:solidFill>
                           <a:latin typeface="Segoe UI"/>
                         </a:rPr>
-                        <a:t>About Pips now shows the owner: Juwen Lie (right-click the pet → Help → About)</a:t>
+                        <a:t>New click option "Only tickle (never open Pips)": click and tickle your pet as much as you like - the Pomodoro window stays closed (open it from the right-click menu). Right-click the pet → When I click</a:t>
                       </a:r>
                     </a:p>
                   </a:txBody>
@@ -11604,7 +11704,7 @@
                           </a:solidFill>
                           <a:latin typeface="Segoe UI"/>
                         </a:rPr>
-                        <a:t>2.1.0</a:t>
+                        <a:t>2.1.1</a:t>
                       </a:r>
                     </a:p>
                   </a:txBody>
@@ -11648,7 +11748,7 @@
                           </a:solidFill>
                           <a:latin typeface="Segoe UI"/>
                         </a:rPr>
-                        <a:t>Interactive guide &amp; in-app updates</a:t>
+                        <a:t>Owner info</a:t>
                       </a:r>
                     </a:p>
                     <a:p>
@@ -11659,7 +11759,7 @@
                           </a:solidFill>
                           <a:latin typeface="Segoe UI"/>
                         </a:rPr>
-                        <a:t>Interactive first-run guide: your pet walks you through clicking, dragging, petting and the right-click menu; In-app updates: Pips tells you when a new version is out - update with one click (your settings and data are kept); New Help menu: replay the guide, check for updates, see the version; Option to turn automatic update checks off</a:t>
+                        <a:t>About Pips now shows the owner: Juwen Lie (right-click the pet → Help → About)</a:t>
                       </a:r>
                     </a:p>
                   </a:txBody>
@@ -11683,7 +11783,7 @@
                           </a:solidFill>
                           <a:latin typeface="Segoe UI"/>
                         </a:rPr>
-                        <a:t>2.0.0</a:t>
+                        <a:t>2.1.0</a:t>
                       </a:r>
                     </a:p>
                   </a:txBody>
@@ -11727,7 +11827,7 @@
                           </a:solidFill>
                           <a:latin typeface="Segoe UI"/>
                         </a:rPr>
-                        <a:t>Desktop pet, 23 animals &amp; 4 languages</a:t>
+                        <a:t>Interactive guide &amp; in-app updates</a:t>
                       </a:r>
                     </a:p>
                     <a:p>
@@ -11738,7 +11838,7 @@
                           </a:solidFill>
                           <a:latin typeface="Segoe UI"/>
                         </a:rPr>
-                        <a:t>Desktop pet that lives on your desktop and taskbar - drag it, tickle it, pet it; 23 animals in 3 groups: Land walks, Water swims with bubbles, Sky hovers and flaps; Moods (happy, sad, tired, hungry, grumpy...), naps when you're away, wakes up when you're back; Cute chat-bubble reminders: breaks, water, 20-20-20 eye rest, pomodoro done, daily goal</a:t>
+                        <a:t>Interactive first-run guide: your pet walks you through clicking, dragging, petting and the right-click menu; In-app updates: Pips tells you when a new version is out - update with one click (your settings and data are kept); New Help menu: replay the guide, check for updates, see the version; Option to turn automatic update checks off</a:t>
                       </a:r>
                     </a:p>
                   </a:txBody>
@@ -11762,7 +11862,7 @@
                           </a:solidFill>
                           <a:latin typeface="Segoe UI"/>
                         </a:rPr>
-                        <a:t>1.5.0</a:t>
+                        <a:t>2.0.0</a:t>
                       </a:r>
                     </a:p>
                   </a:txBody>
@@ -11784,7 +11884,7 @@
                           </a:solidFill>
                           <a:latin typeface="Segoe UI"/>
                         </a:rPr>
-                        <a:t>2026-10-24</a:t>
+                        <a:t>2026-10-28</a:t>
                       </a:r>
                     </a:p>
                   </a:txBody>
@@ -11806,7 +11906,7 @@
                           </a:solidFill>
                           <a:latin typeface="Segoe UI"/>
                         </a:rPr>
-                        <a:t>Renamed to Pips + insights</a:t>
+                        <a:t>Desktop pet, 23 animals &amp; 4 languages</a:t>
                       </a:r>
                     </a:p>
                     <a:p>
@@ -11817,7 +11917,7 @@
                           </a:solidFill>
                           <a:latin typeface="Segoe UI"/>
                         </a:rPr>
-                        <a:t>Renamed from Productivity Widget to Pips; Dashboard charts: focus timeline, hour heatmap, 7-day score trend, pomodoros per day; AI token usage on the card and dashboard; Daily diary export and weekly / monthly reports</a:t>
+                        <a:t>Desktop pet that lives on your desktop and taskbar - drag it, tickle it, pet it; 23 animals in 3 groups: Land walks, Water swims with bubbles, Sky hovers and flaps; Moods (happy, sad, tired, hungry, grumpy...), naps when you're away, wakes up when you're back; Cute chat-bubble reminders: breaks, water, 20-20-20 eye rest, pomodoro done, daily goal</a:t>
                       </a:r>
                     </a:p>
                   </a:txBody>
@@ -11841,13 +11941,92 @@
                           </a:solidFill>
                           <a:latin typeface="Segoe UI"/>
                         </a:rPr>
+                        <a:t>1.5.0</a:t>
+                      </a:r>
+                    </a:p>
+                  </a:txBody>
+                  <a:tcPr marL="73152" marR="73152" marT="36576" marB="36576">
+                    <a:solidFill>
+                      <a:srgbClr val="FFFDF8"/>
+                    </a:solidFill>
+                  </a:tcPr>
+                </a:tc>
+                <a:tc>
+                  <a:txBody>
+                    <a:bodyPr wrap="square"/>
+                    <a:lstStyle/>
+                    <a:p>
+                      <a:r>
+                        <a:rPr sz="1200" b="0">
+                          <a:solidFill>
+                            <a:srgbClr val="2B2A28"/>
+                          </a:solidFill>
+                          <a:latin typeface="Segoe UI"/>
+                        </a:rPr>
+                        <a:t>2026-10-24</a:t>
+                      </a:r>
+                    </a:p>
+                  </a:txBody>
+                  <a:tcPr marL="73152" marR="73152" marT="36576" marB="36576">
+                    <a:solidFill>
+                      <a:srgbClr val="FFFDF8"/>
+                    </a:solidFill>
+                  </a:tcPr>
+                </a:tc>
+                <a:tc>
+                  <a:txBody>
+                    <a:bodyPr wrap="square"/>
+                    <a:lstStyle/>
+                    <a:p>
+                      <a:r>
+                        <a:rPr sz="1200" b="0">
+                          <a:solidFill>
+                            <a:srgbClr val="2B2A28"/>
+                          </a:solidFill>
+                          <a:latin typeface="Segoe UI"/>
+                        </a:rPr>
+                        <a:t>Renamed to Pips + insights</a:t>
+                      </a:r>
+                    </a:p>
+                    <a:p>
+                      <a:r>
+                        <a:rPr sz="1200" b="0">
+                          <a:solidFill>
+                            <a:srgbClr val="2B2A28"/>
+                          </a:solidFill>
+                          <a:latin typeface="Segoe UI"/>
+                        </a:rPr>
+                        <a:t>Renamed from Productivity Widget to Pips; Dashboard charts: focus timeline, hour heatmap, 7-day score trend, pomodoros per day; AI token usage on the card and dashboard; Daily diary export and weekly / monthly reports</a:t>
+                      </a:r>
+                    </a:p>
+                  </a:txBody>
+                  <a:tcPr marL="73152" marR="73152" marT="36576" marB="36576">
+                    <a:solidFill>
+                      <a:srgbClr val="FFFDF8"/>
+                    </a:solidFill>
+                  </a:tcPr>
+                </a:tc>
+              </a:tr>
+              <a:tr h="822960">
+                <a:tc>
+                  <a:txBody>
+                    <a:bodyPr wrap="square"/>
+                    <a:lstStyle/>
+                    <a:p>
+                      <a:r>
+                        <a:rPr sz="1200" b="1">
+                          <a:solidFill>
+                            <a:srgbClr val="2B2A28"/>
+                          </a:solidFill>
+                          <a:latin typeface="Segoe UI"/>
+                        </a:rPr>
                         <a:t>1.0.0</a:t>
                       </a:r>
                     </a:p>
                   </a:txBody>
                   <a:tcPr marL="73152" marR="73152" marT="36576" marB="36576">
                     <a:solidFill>
-                      <a:srgbClr val="FFFDF8"/>
+                      <a:srgbClr val="F7F4EC"/>
                     </a:solidFill>
                   </a:tcPr>
                 </a:tc>
@@ -11869,7 +12048,7 @@
                   </a:txBody>
                   <a:tcPr marL="73152" marR="73152" marT="36576" marB="36576">
                     <a:solidFill>
-                      <a:srgbClr val="FFFDF8"/>
+                      <a:srgbClr val="F7F4EC"/>
                     </a:solidFill>
                   </a:tcPr>
                 </a:tc>
@@ -11902,7 +12081,7 @@
                   </a:txBody>
                   <a:tcPr marL="73152" marR="73152" marT="36576" marB="36576">
                     <a:solidFill>
-                      <a:srgbClr val="FFFDF8"/>
+                      <a:srgbClr val="F7F4EC"/>
                     </a:solidFill>
                   </a:tcPr>
                 </a:tc>
@@ -15750,7 +15929,7 @@
                           </a:solidFill>
                           <a:latin typeface="Segoe UI"/>
                         </a:rPr>
-                        <a:t>5 minigames - Treat Catch, Bonk the Bugs, Memory Match, Pet Says, Hop Hop (Hub → Play → Minigames or right-click → Games)</a:t>
+                        <a:t>5 minigames - Treat Catch, Bonk the Bugs, Memory Match, Pet Says, Hop Hop - alone or with up to 7 friends (same round, live scores), plus Pet Duel (Hub → Play → Minigames or right-click → Games)</a:t>
                       </a:r>
                     </a:p>
                   </a:txBody>

</xml_diff>

<commit_message>
pips 2.25.1: Quiet hide
</commit_message>
<xml_diff>
--- a/apps/pips/web/download/Pips-Guide.pptx
+++ b/apps/pips/web/download/Pips-Guide.pptx
@@ -3292,7 +3292,7 @@
                 </a:solidFill>
                 <a:latin typeface="Segoe UI"/>
               </a:rPr>
-              <a:t>Version 2.25.0  ·  2026-10-30  ·  Made by Juwen Lie (owner)</a:t>
+              <a:t>Version 2.25.1  ·  2026-10-30  ·  Made by Juwen Lie (owner)</a:t>
             </a:r>
           </a:p>
           <a:p>
@@ -8279,7 +8279,7 @@
                 </a:solidFill>
                 <a:latin typeface="Segoe UI"/>
               </a:rPr>
-              <a:t>What's new in 2.25.0</a:t>
+              <a:t>What's new in 2.25.1</a:t>
             </a:r>
           </a:p>
         </p:txBody>
@@ -8392,7 +8392,7 @@
                 </a:solidFill>
                 <a:latin typeface="Segoe UI"/>
               </a:rPr>
-              <a:t>Play with friends  ·  2026-10-30</a:t>
+              <a:t>Quiet hide  ·  2026-10-30</a:t>
             </a:r>
           </a:p>
         </p:txBody>
@@ -8440,107 +8440,7 @@
                 </a:solidFill>
                 <a:latin typeface="Segoe UI"/>
               </a:rPr>
-              <a:t>All 5 minigames can now be played with friends: Hub → Play → Minigames → ＋ New game with friends, pick a game and up to 7 friends (8 players in total).</a:t>
-            </a:r>
-          </a:p>
-          <a:p>
-            <a:pPr>
-              <a:spcAft>
-                <a:spcPts val="1000"/>
-              </a:spcAft>
-            </a:pPr>
-            <a:r>
-              <a:rPr sz="1700" b="1">
-                <a:solidFill>
-                  <a:srgbClr val="4CB86B"/>
-                </a:solidFill>
-                <a:latin typeface="Segoe UI"/>
-              </a:rPr>
-              <a:t>•  </a:t>
-            </a:r>
-            <a:r>
-              <a:rPr sz="1700">
-                <a:solidFill>
-                  <a:srgbClr val="2B2A28"/>
-                </a:solidFill>
-                <a:latin typeface="Segoe UI"/>
-              </a:rPr>
-              <a:t>Everyone gets the same round at the same time (same treats, bugs, cards, pattern and obstacles) after a 3-2-1 countdown, and a live scoreboard shows how your friends are doing. Best score wins the round.</a:t>
-            </a:r>
-          </a:p>
-          <a:p>
-            <a:pPr>
-              <a:spcAft>
-                <a:spcPts val="1000"/>
-              </a:spcAft>
-            </a:pPr>
-            <a:r>
-              <a:rPr sz="1700" b="1">
-                <a:solidFill>
-                  <a:srgbClr val="4CB86B"/>
-                </a:solidFill>
-                <a:latin typeface="Segoe UI"/>
-              </a:rPr>
-              <a:t>•  </a:t>
-            </a:r>
-            <a:r>
-              <a:rPr sz="1700">
-                <a:solidFill>
-                  <a:srgbClr val="2B2A28"/>
-                </a:solidFill>
-                <a:latin typeface="Segoe UI"/>
-              </a:rPr>
-              <a:t>Friends get the invite from their pet (Join / Later) or in the Minigames page. The host can start the next round or switch game in the same room; round wins are counted with a 👑.</a:t>
-            </a:r>
-          </a:p>
-          <a:p>
-            <a:pPr>
-              <a:spcAft>
-                <a:spcPts val="1000"/>
-              </a:spcAft>
-            </a:pPr>
-            <a:r>
-              <a:rPr sz="1700" b="1">
-                <a:solidFill>
-                  <a:srgbClr val="4CB86B"/>
-                </a:solidFill>
-                <a:latin typeface="Segoe UI"/>
-              </a:rPr>
-              <a:t>•  </a:t>
-            </a:r>
-            <a:r>
-              <a:rPr sz="1700">
-                <a:solidFill>
-                  <a:srgbClr val="2B2A28"/>
-                </a:solidFill>
-                <a:latin typeface="Segoe UI"/>
-              </a:rPr>
-              <a:t>While you play a minigame your pet leaves the desktop and jumps into the game window - it plays, watches and cheers (or pouts) inside the game, and walks back onto the desktop when you close it.</a:t>
-            </a:r>
-          </a:p>
-          <a:p>
-            <a:pPr>
-              <a:spcAft>
-                <a:spcPts val="1000"/>
-              </a:spcAft>
-            </a:pPr>
-            <a:r>
-              <a:rPr sz="1700" b="1">
-                <a:solidFill>
-                  <a:srgbClr val="4CB86B"/>
-                </a:solidFill>
-                <a:latin typeface="Segoe UI"/>
-              </a:rPr>
-              <a:t>•  </a:t>
-            </a:r>
-            <a:r>
-              <a:rPr sz="1700">
-                <a:solidFill>
-                  <a:srgbClr val="2B2A28"/>
-                </a:solidFill>
-                <a:latin typeface="Segoe UI"/>
-              </a:rPr>
-              <a:t>Pet Duel is now one of the games inside Minigames - the separate Arena tab is gone (challenges still show as a badge on Play → Minigames).</a:t>
+              <a:t>Hiding your pet no longer opens the Pomodoro card - the pet just disappears. Bring it back with the tray icon or the shortcut (Ctrl+Alt+P).</a:t>
             </a:r>
           </a:p>
         </p:txBody>
@@ -8671,107 +8571,7 @@
                 </a:solidFill>
                 <a:latin typeface="Segoe UI"/>
               </a:rPr>
-              <a:t>Kelima minigame kini bisa dimainkan bersama teman: Hub → Main → Minigame → ＋ Main baru bersama teman, pilih permainan dan hingga 7 teman (total 8 pemain).</a:t>
-            </a:r>
-          </a:p>
-          <a:p>
-            <a:pPr>
-              <a:spcAft>
-                <a:spcPts val="500"/>
-              </a:spcAft>
-            </a:pPr>
-            <a:r>
-              <a:rPr sz="1200" b="1">
-                <a:solidFill>
-                  <a:srgbClr val="4CB86B"/>
-                </a:solidFill>
-                <a:latin typeface="Segoe UI"/>
-              </a:rPr>
-              <a:t>•  </a:t>
-            </a:r>
-            <a:r>
-              <a:rPr sz="1200">
-                <a:solidFill>
-                  <a:srgbClr val="2B2A28"/>
-                </a:solidFill>
-                <a:latin typeface="Segoe UI"/>
-              </a:rPr>
-              <a:t>Semua mendapat ronde yang sama di waktu yang sama (camilan, serangga, kartu, pola, dan rintangan yang sama) setelah hitungan 3-2-1, dan papan skor langsung menunjukkan skor teman-temanmu. Skor terbaik memenangkan ronde.</a:t>
-            </a:r>
-          </a:p>
-          <a:p>
-            <a:pPr>
-              <a:spcAft>
-                <a:spcPts val="500"/>
-              </a:spcAft>
-            </a:pPr>
-            <a:r>
-              <a:rPr sz="1200" b="1">
-                <a:solidFill>
-                  <a:srgbClr val="4CB86B"/>
-                </a:solidFill>
-                <a:latin typeface="Segoe UI"/>
-              </a:rPr>
-              <a:t>•  </a:t>
-            </a:r>
-            <a:r>
-              <a:rPr sz="1200">
-                <a:solidFill>
-                  <a:srgbClr val="2B2A28"/>
-                </a:solidFill>
-                <a:latin typeface="Segoe UI"/>
-              </a:rPr>
-              <a:t>Teman mendapat undangan dari pet-nya (Gabung / Nanti) atau di halaman Minigame. Tuan rumah bisa memulai ronde berikutnya atau ganti permainan di ruang yang sama; kemenangan ronde dihitung dengan 👑.</a:t>
-            </a:r>
-          </a:p>
-          <a:p>
-            <a:pPr>
-              <a:spcAft>
-                <a:spcPts val="500"/>
-              </a:spcAft>
-            </a:pPr>
-            <a:r>
-              <a:rPr sz="1200" b="1">
-                <a:solidFill>
-                  <a:srgbClr val="4CB86B"/>
-                </a:solidFill>
-                <a:latin typeface="Segoe UI"/>
-              </a:rPr>
-              <a:t>•  </a:t>
-            </a:r>
-            <a:r>
-              <a:rPr sz="1200">
-                <a:solidFill>
-                  <a:srgbClr val="2B2A28"/>
-                </a:solidFill>
-                <a:latin typeface="Segoe UI"/>
-              </a:rPr>
-              <a:t>Saat kamu main minigame, pet-mu meninggalkan desktop dan masuk ke jendela permainan - ia bermain, menonton dan bersorak (atau cemberut) di dalam game, lalu kembali ke desktop saat jendela ditutup.</a:t>
-            </a:r>
-          </a:p>
-          <a:p>
-            <a:pPr>
-              <a:spcAft>
-                <a:spcPts val="500"/>
-              </a:spcAft>
-            </a:pPr>
-            <a:r>
-              <a:rPr sz="1200" b="1">
-                <a:solidFill>
-                  <a:srgbClr val="4CB86B"/>
-                </a:solidFill>
-                <a:latin typeface="Segoe UI"/>
-              </a:rPr>
-              <a:t>•  </a:t>
-            </a:r>
-            <a:r>
-              <a:rPr sz="1200">
-                <a:solidFill>
-                  <a:srgbClr val="2B2A28"/>
-                </a:solidFill>
-                <a:latin typeface="Segoe UI"/>
-              </a:rPr>
-              <a:t>Duel Pet kini menjadi salah satu permainan di Minigame - tab Arena terpisah sudah dihapus (tantangan tetap muncul sebagai lencana di Main → Minigame).</a:t>
+              <a:t>Menyembunyikan pet tidak lagi membuka kartu Pomodoro - pet langsung menghilang. Panggil kembali lewat ikon tray atau pintasan (Ctrl+Alt+P).</a:t>
             </a:r>
           </a:p>
         </p:txBody>
@@ -9003,7 +8803,7 @@
         </p:nvGraphicFramePr>
         <p:xfrm>
           <a:off x="548640" y="1645920"/>
-          <a:ext cx="11155680" cy="31656528"/>
+          <a:ext cx="11155680" cy="32479488"/>
         </p:xfrm>
         <a:graphic>
           <a:graphicData uri="http://schemas.openxmlformats.org/drawingml/2006/table">
@@ -9097,7 +8897,7 @@
                           </a:solidFill>
                           <a:latin typeface="Segoe UI"/>
                         </a:rPr>
-                        <a:t>2.25.0</a:t>
+                        <a:t>2.25.1</a:t>
                       </a:r>
                     </a:p>
                   </a:txBody>
@@ -9141,7 +8941,7 @@
                           </a:solidFill>
                           <a:latin typeface="Segoe UI"/>
                         </a:rPr>
-                        <a:t>Play with friends</a:t>
+                        <a:t>Quiet hide</a:t>
                       </a:r>
                     </a:p>
                     <a:p>
@@ -9152,7 +8952,7 @@
                           </a:solidFill>
                           <a:latin typeface="Segoe UI"/>
                         </a:rPr>
-                        <a:t>All 5 minigames can now be played with friends: Hub → Play → Minigames → ＋ New game with friends, pick a game and up to 7 friends (8 players in total).; Everyone gets the same round at the same time (same treats, bugs, cards, pattern and obstacles) after a 3-2-1 countdown, and a live scoreboard shows how your friends are doing. Best score wins the round.; Friends get the invite from their pet (Join / Later) or 